<commit_message>
Org slides: fit all teams side by side on one slide
Co-Authored-By: Claude Opus 5.5 <noreply@anthropic.com>
Claude-Session: https://claude.ai/code/session_01W7Er83FuNT4pLFShWidYHn
</commit_message>
<xml_diff>
--- a/presentation/out/koach-hitarvut.pptx
+++ b/presentation/out/koach-hitarvut.pptx
@@ -3335,8 +3335,8 @@
         </p:nvSpPr>
         <p:spPr>
           <a:xfrm>
-            <a:off x="411480" y="1097280"/>
-            <a:ext cx="11368735" cy="274320"/>
+            <a:off x="411480" y="1024128"/>
+            <a:ext cx="11368735" cy="256032"/>
           </a:xfrm>
           <a:prstGeom prst="rect">
             <a:avLst/>
@@ -3371,8 +3371,8 @@
         </p:nvSpPr>
         <p:spPr>
           <a:xfrm>
-            <a:off x="10265838" y="1417320"/>
-            <a:ext cx="1514377" cy="713232"/>
+            <a:off x="10250163" y="1298448"/>
+            <a:ext cx="1530052" cy="603504"/>
           </a:xfrm>
           <a:prstGeom prst="roundRect">
             <a:avLst>
@@ -3419,8 +3419,8 @@
         </p:nvSpPr>
         <p:spPr>
           <a:xfrm>
-            <a:off x="11716207" y="1490472"/>
-            <a:ext cx="45720" cy="566928"/>
+            <a:off x="11716207" y="1371600"/>
+            <a:ext cx="45720" cy="457200"/>
           </a:xfrm>
           <a:prstGeom prst="rect">
             <a:avLst/>
@@ -3463,8 +3463,8 @@
         </p:nvSpPr>
         <p:spPr>
           <a:xfrm>
-            <a:off x="10265838" y="1472184"/>
-            <a:ext cx="1514377" cy="370880"/>
+            <a:off x="10250163" y="1353312"/>
+            <a:ext cx="1530052" cy="313822"/>
           </a:xfrm>
           <a:prstGeom prst="rect">
             <a:avLst/>
@@ -3499,8 +3499,8 @@
         </p:nvSpPr>
         <p:spPr>
           <a:xfrm>
-            <a:off x="10265838" y="1809597"/>
-            <a:ext cx="1514377" cy="285292"/>
+            <a:off x="10250163" y="1630375"/>
+            <a:ext cx="1530052" cy="241401"/>
           </a:xfrm>
           <a:prstGeom prst="rect">
             <a:avLst/>
@@ -3535,15 +3535,17 @@
         </p:nvSpPr>
         <p:spPr>
           <a:xfrm>
-            <a:off x="8623445" y="1417320"/>
-            <a:ext cx="1514377" cy="713232"/>
+            <a:off x="8610383" y="1298448"/>
+            <a:ext cx="1530052" cy="603504"/>
           </a:xfrm>
           <a:prstGeom prst="roundRect">
             <a:avLst>
               <a:gd name="adj" fmla="val 18000"/>
             </a:avLst>
           </a:prstGeom>
-          <a:noFill/>
+          <a:solidFill>
+            <a:srgbClr val="F4F6FB"/>
+          </a:solidFill>
           <a:ln w="15875">
             <a:solidFill>
               <a:srgbClr val="8A94A8"/>
@@ -3582,8 +3584,8 @@
         </p:nvSpPr>
         <p:spPr>
           <a:xfrm>
-            <a:off x="8623445" y="1472184"/>
-            <a:ext cx="1514377" cy="370880"/>
+            <a:off x="8610383" y="1353312"/>
+            <a:ext cx="1530052" cy="313822"/>
           </a:xfrm>
           <a:prstGeom prst="rect">
             <a:avLst/>
@@ -3618,8 +3620,8 @@
         </p:nvSpPr>
         <p:spPr>
           <a:xfrm>
-            <a:off x="8623445" y="1809597"/>
-            <a:ext cx="1514377" cy="285292"/>
+            <a:off x="8610383" y="1630375"/>
+            <a:ext cx="1530052" cy="241401"/>
           </a:xfrm>
           <a:prstGeom prst="rect">
             <a:avLst/>
@@ -3654,15 +3656,17 @@
         </p:nvSpPr>
         <p:spPr>
           <a:xfrm>
-            <a:off x="6981052" y="1417320"/>
-            <a:ext cx="1514377" cy="713232"/>
+            <a:off x="6970603" y="1298448"/>
+            <a:ext cx="1530052" cy="603504"/>
           </a:xfrm>
           <a:prstGeom prst="roundRect">
             <a:avLst>
               <a:gd name="adj" fmla="val 18000"/>
             </a:avLst>
           </a:prstGeom>
-          <a:noFill/>
+          <a:solidFill>
+            <a:srgbClr val="F4F6FB"/>
+          </a:solidFill>
           <a:ln w="15875">
             <a:solidFill>
               <a:srgbClr val="8A94A8"/>
@@ -3701,8 +3705,8 @@
         </p:nvSpPr>
         <p:spPr>
           <a:xfrm>
-            <a:off x="6981052" y="1472184"/>
-            <a:ext cx="1514377" cy="370880"/>
+            <a:off x="6970603" y="1353312"/>
+            <a:ext cx="1530052" cy="313822"/>
           </a:xfrm>
           <a:prstGeom prst="rect">
             <a:avLst/>
@@ -3737,8 +3741,8 @@
         </p:nvSpPr>
         <p:spPr>
           <a:xfrm>
-            <a:off x="6981052" y="1809597"/>
-            <a:ext cx="1514377" cy="285292"/>
+            <a:off x="6970603" y="1630375"/>
+            <a:ext cx="1530052" cy="241401"/>
           </a:xfrm>
           <a:prstGeom prst="rect">
             <a:avLst/>
@@ -3773,15 +3777,17 @@
         </p:nvSpPr>
         <p:spPr>
           <a:xfrm>
-            <a:off x="5338659" y="1417320"/>
-            <a:ext cx="1514377" cy="713232"/>
+            <a:off x="5330823" y="1298448"/>
+            <a:ext cx="1530052" cy="603504"/>
           </a:xfrm>
           <a:prstGeom prst="roundRect">
             <a:avLst>
               <a:gd name="adj" fmla="val 18000"/>
             </a:avLst>
           </a:prstGeom>
-          <a:noFill/>
+          <a:solidFill>
+            <a:srgbClr val="F4F6FB"/>
+          </a:solidFill>
           <a:ln w="15875">
             <a:solidFill>
               <a:srgbClr val="8A94A8"/>
@@ -3820,8 +3826,8 @@
         </p:nvSpPr>
         <p:spPr>
           <a:xfrm>
-            <a:off x="5338659" y="1472184"/>
-            <a:ext cx="1514377" cy="370880"/>
+            <a:off x="5330823" y="1353312"/>
+            <a:ext cx="1530052" cy="313822"/>
           </a:xfrm>
           <a:prstGeom prst="rect">
             <a:avLst/>
@@ -3856,8 +3862,8 @@
         </p:nvSpPr>
         <p:spPr>
           <a:xfrm>
-            <a:off x="5338659" y="1809597"/>
-            <a:ext cx="1514377" cy="285292"/>
+            <a:off x="5330823" y="1630375"/>
+            <a:ext cx="1530052" cy="241401"/>
           </a:xfrm>
           <a:prstGeom prst="rect">
             <a:avLst/>
@@ -3892,15 +3898,17 @@
         </p:nvSpPr>
         <p:spPr>
           <a:xfrm>
-            <a:off x="3696266" y="1417320"/>
-            <a:ext cx="1514377" cy="713232"/>
+            <a:off x="3691043" y="1298448"/>
+            <a:ext cx="1530052" cy="603504"/>
           </a:xfrm>
           <a:prstGeom prst="roundRect">
             <a:avLst>
               <a:gd name="adj" fmla="val 18000"/>
             </a:avLst>
           </a:prstGeom>
-          <a:noFill/>
+          <a:solidFill>
+            <a:srgbClr val="F4F6FB"/>
+          </a:solidFill>
           <a:ln w="15875">
             <a:solidFill>
               <a:srgbClr val="8A94A8"/>
@@ -3939,8 +3947,8 @@
         </p:nvSpPr>
         <p:spPr>
           <a:xfrm>
-            <a:off x="3696266" y="1472184"/>
-            <a:ext cx="1514377" cy="370880"/>
+            <a:off x="3691043" y="1353312"/>
+            <a:ext cx="1530052" cy="313822"/>
           </a:xfrm>
           <a:prstGeom prst="rect">
             <a:avLst/>
@@ -3975,8 +3983,8 @@
         </p:nvSpPr>
         <p:spPr>
           <a:xfrm>
-            <a:off x="3696266" y="1809597"/>
-            <a:ext cx="1514377" cy="285292"/>
+            <a:off x="3691043" y="1630375"/>
+            <a:ext cx="1530052" cy="241401"/>
           </a:xfrm>
           <a:prstGeom prst="rect">
             <a:avLst/>
@@ -4011,15 +4019,17 @@
         </p:nvSpPr>
         <p:spPr>
           <a:xfrm>
-            <a:off x="2053873" y="1417320"/>
-            <a:ext cx="1514377" cy="713232"/>
+            <a:off x="2051263" y="1298448"/>
+            <a:ext cx="1530052" cy="603504"/>
           </a:xfrm>
           <a:prstGeom prst="roundRect">
             <a:avLst>
               <a:gd name="adj" fmla="val 18000"/>
             </a:avLst>
           </a:prstGeom>
-          <a:noFill/>
+          <a:solidFill>
+            <a:srgbClr val="F4F6FB"/>
+          </a:solidFill>
           <a:ln w="15875">
             <a:solidFill>
               <a:srgbClr val="8A94A8"/>
@@ -4058,8 +4068,8 @@
         </p:nvSpPr>
         <p:spPr>
           <a:xfrm>
-            <a:off x="2053873" y="1472184"/>
-            <a:ext cx="1514377" cy="370880"/>
+            <a:off x="2051263" y="1353312"/>
+            <a:ext cx="1530052" cy="313822"/>
           </a:xfrm>
           <a:prstGeom prst="rect">
             <a:avLst/>
@@ -4094,8 +4104,8 @@
         </p:nvSpPr>
         <p:spPr>
           <a:xfrm>
-            <a:off x="2053873" y="1809597"/>
-            <a:ext cx="1514377" cy="285292"/>
+            <a:off x="2051263" y="1630375"/>
+            <a:ext cx="1530052" cy="241401"/>
           </a:xfrm>
           <a:prstGeom prst="rect">
             <a:avLst/>
@@ -4130,15 +4140,17 @@
         </p:nvSpPr>
         <p:spPr>
           <a:xfrm>
-            <a:off x="411480" y="1417320"/>
-            <a:ext cx="1514377" cy="713232"/>
+            <a:off x="411483" y="1298448"/>
+            <a:ext cx="1530052" cy="603504"/>
           </a:xfrm>
           <a:prstGeom prst="roundRect">
             <a:avLst>
               <a:gd name="adj" fmla="val 18000"/>
             </a:avLst>
           </a:prstGeom>
-          <a:noFill/>
+          <a:solidFill>
+            <a:srgbClr val="F4F6FB"/>
+          </a:solidFill>
           <a:ln w="15875">
             <a:solidFill>
               <a:srgbClr val="8A94A8"/>
@@ -4177,8 +4189,8 @@
         </p:nvSpPr>
         <p:spPr>
           <a:xfrm>
-            <a:off x="411480" y="1472184"/>
-            <a:ext cx="1514377" cy="370880"/>
+            <a:off x="411483" y="1353312"/>
+            <a:ext cx="1530052" cy="313822"/>
           </a:xfrm>
           <a:prstGeom prst="rect">
             <a:avLst/>
@@ -4213,8 +4225,8 @@
         </p:nvSpPr>
         <p:spPr>
           <a:xfrm>
-            <a:off x="411480" y="1809597"/>
-            <a:ext cx="1514377" cy="285292"/>
+            <a:off x="411483" y="1630375"/>
+            <a:ext cx="1530052" cy="241401"/>
           </a:xfrm>
           <a:prstGeom prst="rect">
             <a:avLst/>
@@ -4241,41 +4253,52 @@
           </a:p>
         </p:txBody>
       </p:sp>
-      <p:cxnSp>
-        <p:nvCxnSpPr>
-          <p:cNvPr id="31" name="Connector 30"/>
-          <p:cNvCxnSpPr/>
-          <p:nvPr/>
-        </p:nvCxnSpPr>
-        <p:spPr>
-          <a:xfrm>
-            <a:off x="6095847" y="2130552"/>
-            <a:ext cx="0" cy="384048"/>
-          </a:xfrm>
-          <a:prstGeom prst="line">
-            <a:avLst/>
-          </a:prstGeom>
-          <a:ln w="19050">
+      <p:sp>
+        <p:nvSpPr>
+          <p:cNvPr id="31" name="Rounded Rectangle 30"/>
+          <p:cNvSpPr/>
+          <p:nvPr/>
+        </p:nvSpPr>
+        <p:spPr>
+          <a:xfrm>
+            <a:off x="3489807" y="2679192"/>
+            <a:ext cx="5212080" cy="3044952"/>
+          </a:xfrm>
+          <a:prstGeom prst="roundRect">
+            <a:avLst>
+              <a:gd name="adj" fmla="val 4000"/>
+            </a:avLst>
+          </a:prstGeom>
+          <a:noFill/>
+          <a:ln w="15875">
             <a:solidFill>
               <a:srgbClr val="C5CDDD"/>
             </a:solidFill>
           </a:ln>
+          <a:effectLst/>
         </p:spPr>
         <p:style>
-          <a:lnRef idx="2">
+          <a:lnRef idx="1">
             <a:schemeClr val="accent1"/>
           </a:lnRef>
-          <a:fillRef idx="0">
+          <a:fillRef idx="3">
             <a:schemeClr val="accent1"/>
           </a:fillRef>
-          <a:effectRef idx="1">
+          <a:effectRef idx="2">
             <a:schemeClr val="accent1"/>
           </a:effectRef>
           <a:fontRef idx="minor">
-            <a:schemeClr val="tx1"/>
+            <a:schemeClr val="lt1"/>
           </a:fontRef>
         </p:style>
-      </p:cxnSp>
+        <p:txBody>
+          <a:bodyPr rtlCol="0" anchor="ctr"/>
+          <a:lstStyle/>
+          <a:p>
+            <a:pPr algn="ctr"/>
+          </a:p>
+        </p:txBody>
+      </p:sp>
       <p:sp>
         <p:nvSpPr>
           <p:cNvPr id="32" name="Rounded Rectangle 31"/>
@@ -4284,8 +4307,8 @@
         </p:nvSpPr>
         <p:spPr>
           <a:xfrm>
-            <a:off x="4907127" y="2514600"/>
-            <a:ext cx="2377440" cy="731520"/>
+            <a:off x="4907127" y="2395728"/>
+            <a:ext cx="2377440" cy="566928"/>
           </a:xfrm>
           <a:prstGeom prst="roundRect">
             <a:avLst>
@@ -4332,8 +4355,8 @@
         </p:nvSpPr>
         <p:spPr>
           <a:xfrm>
-            <a:off x="7220559" y="2587752"/>
-            <a:ext cx="45720" cy="585216"/>
+            <a:off x="7220559" y="2468880"/>
+            <a:ext cx="45720" cy="420624"/>
           </a:xfrm>
           <a:prstGeom prst="rect">
             <a:avLst/>
@@ -4376,8 +4399,8 @@
         </p:nvSpPr>
         <p:spPr>
           <a:xfrm>
-            <a:off x="4907127" y="2569464"/>
-            <a:ext cx="2377440" cy="380390"/>
+            <a:off x="4907127" y="2450592"/>
+            <a:ext cx="2377440" cy="294802"/>
           </a:xfrm>
           <a:prstGeom prst="rect">
             <a:avLst/>
@@ -4412,8 +4435,8 @@
         </p:nvSpPr>
         <p:spPr>
           <a:xfrm>
-            <a:off x="4907127" y="2916936"/>
-            <a:ext cx="2377440" cy="292608"/>
+            <a:off x="4907127" y="2707538"/>
+            <a:ext cx="2377440" cy="226771"/>
           </a:xfrm>
           <a:prstGeom prst="rect">
             <a:avLst/>
@@ -4448,89 +4471,8 @@
         </p:nvSpPr>
         <p:spPr>
           <a:xfrm>
-            <a:off x="301752" y="3429000"/>
-            <a:ext cx="11588191" cy="2267712"/>
-          </a:xfrm>
-          <a:prstGeom prst="roundRect">
-            <a:avLst>
-              <a:gd name="adj" fmla="val 6000"/>
-            </a:avLst>
-          </a:prstGeom>
-          <a:noFill/>
-          <a:ln w="15875">
-            <a:solidFill>
-              <a:srgbClr val="C5CDDD"/>
-            </a:solidFill>
-          </a:ln>
-          <a:effectLst/>
-        </p:spPr>
-        <p:style>
-          <a:lnRef idx="1">
-            <a:schemeClr val="accent1"/>
-          </a:lnRef>
-          <a:fillRef idx="3">
-            <a:schemeClr val="accent1"/>
-          </a:fillRef>
-          <a:effectRef idx="2">
-            <a:schemeClr val="accent1"/>
-          </a:effectRef>
-          <a:fontRef idx="minor">
-            <a:schemeClr val="lt1"/>
-          </a:fontRef>
-        </p:style>
-        <p:txBody>
-          <a:bodyPr rtlCol="0" anchor="ctr"/>
-          <a:lstStyle/>
-          <a:p>
-            <a:pPr algn="ctr"/>
-          </a:p>
-        </p:txBody>
-      </p:sp>
-      <p:cxnSp>
-        <p:nvCxnSpPr>
-          <p:cNvPr id="37" name="Connector 36"/>
-          <p:cNvCxnSpPr/>
-          <p:nvPr/>
-        </p:nvCxnSpPr>
-        <p:spPr>
-          <a:xfrm>
-            <a:off x="6095847" y="3246120"/>
-            <a:ext cx="0" cy="182880"/>
-          </a:xfrm>
-          <a:prstGeom prst="line">
-            <a:avLst/>
-          </a:prstGeom>
-          <a:ln w="19050">
-            <a:solidFill>
-              <a:srgbClr val="C5CDDD"/>
-            </a:solidFill>
-          </a:ln>
-        </p:spPr>
-        <p:style>
-          <a:lnRef idx="2">
-            <a:schemeClr val="accent1"/>
-          </a:lnRef>
-          <a:fillRef idx="0">
-            <a:schemeClr val="accent1"/>
-          </a:fillRef>
-          <a:effectRef idx="1">
-            <a:schemeClr val="accent1"/>
-          </a:effectRef>
-          <a:fontRef idx="minor">
-            <a:schemeClr val="tx1"/>
-          </a:fontRef>
-        </p:style>
-      </p:cxnSp>
-      <p:sp>
-        <p:nvSpPr>
-          <p:cNvPr id="38" name="Rounded Rectangle 37"/>
-          <p:cNvSpPr/>
-          <p:nvPr/>
-        </p:nvSpPr>
-        <p:spPr>
-          <a:xfrm>
-            <a:off x="9992106" y="3611880"/>
-            <a:ext cx="1788109" cy="548640"/>
+            <a:off x="6982815" y="3255264"/>
+            <a:ext cx="1627632" cy="329184"/>
           </a:xfrm>
           <a:prstGeom prst="roundRect">
             <a:avLst>
@@ -4571,14 +4513,14 @@
       </p:sp>
       <p:sp>
         <p:nvSpPr>
-          <p:cNvPr id="39" name="Rectangle 38"/>
+          <p:cNvPr id="37" name="Rectangle 36"/>
           <p:cNvSpPr/>
           <p:nvPr/>
         </p:nvSpPr>
         <p:spPr>
           <a:xfrm>
-            <a:off x="11716207" y="3685032"/>
-            <a:ext cx="45720" cy="402336"/>
+            <a:off x="8546439" y="3328416"/>
+            <a:ext cx="45720" cy="182880"/>
           </a:xfrm>
           <a:prstGeom prst="rect">
             <a:avLst/>
@@ -4615,14 +4557,14 @@
       </p:sp>
       <p:sp>
         <p:nvSpPr>
-          <p:cNvPr id="40" name="TextBox 39"/>
+          <p:cNvPr id="38" name="TextBox 37"/>
           <p:cNvSpPr txBox="1"/>
           <p:nvPr/>
         </p:nvSpPr>
         <p:spPr>
           <a:xfrm>
-            <a:off x="9992106" y="3611880"/>
-            <a:ext cx="1788109" cy="548640"/>
+            <a:off x="6982815" y="3255264"/>
+            <a:ext cx="1627632" cy="329184"/>
           </a:xfrm>
           <a:prstGeom prst="rect">
             <a:avLst/>
@@ -4637,7 +4579,7 @@
           <a:p>
             <a:pPr algn="ctr" rtl="1"/>
             <a:r>
-              <a:rPr sz="1200" b="1">
+              <a:rPr sz="1100" b="1">
                 <a:solidFill>
                   <a:srgbClr val="1A2233"/>
                 </a:solidFill>
@@ -4651,14 +4593,14 @@
       </p:sp>
       <p:sp>
         <p:nvSpPr>
-          <p:cNvPr id="41" name="Rounded Rectangle 40"/>
+          <p:cNvPr id="39" name="Rounded Rectangle 38"/>
           <p:cNvSpPr/>
           <p:nvPr/>
         </p:nvSpPr>
         <p:spPr>
           <a:xfrm>
-            <a:off x="8075981" y="3611880"/>
-            <a:ext cx="1788109" cy="548640"/>
+            <a:off x="5282031" y="3255264"/>
+            <a:ext cx="1627632" cy="329184"/>
           </a:xfrm>
           <a:prstGeom prst="roundRect">
             <a:avLst>
@@ -4699,14 +4641,14 @@
       </p:sp>
       <p:sp>
         <p:nvSpPr>
-          <p:cNvPr id="42" name="Rectangle 41"/>
+          <p:cNvPr id="40" name="Rectangle 39"/>
           <p:cNvSpPr/>
           <p:nvPr/>
         </p:nvSpPr>
         <p:spPr>
           <a:xfrm>
-            <a:off x="9800082" y="3685032"/>
-            <a:ext cx="45720" cy="402336"/>
+            <a:off x="6845655" y="3328416"/>
+            <a:ext cx="45720" cy="182880"/>
           </a:xfrm>
           <a:prstGeom prst="rect">
             <a:avLst/>
@@ -4743,14 +4685,14 @@
       </p:sp>
       <p:sp>
         <p:nvSpPr>
-          <p:cNvPr id="43" name="TextBox 42"/>
+          <p:cNvPr id="41" name="TextBox 40"/>
           <p:cNvSpPr txBox="1"/>
           <p:nvPr/>
         </p:nvSpPr>
         <p:spPr>
           <a:xfrm>
-            <a:off x="8075981" y="3611880"/>
-            <a:ext cx="1788109" cy="548640"/>
+            <a:off x="5282031" y="3255264"/>
+            <a:ext cx="1627632" cy="329184"/>
           </a:xfrm>
           <a:prstGeom prst="rect">
             <a:avLst/>
@@ -4765,7 +4707,7 @@
           <a:p>
             <a:pPr algn="ctr" rtl="1"/>
             <a:r>
-              <a:rPr sz="1200" b="1">
+              <a:rPr sz="1100" b="1">
                 <a:solidFill>
                   <a:srgbClr val="1A2233"/>
                 </a:solidFill>
@@ -4779,14 +4721,14 @@
       </p:sp>
       <p:sp>
         <p:nvSpPr>
-          <p:cNvPr id="44" name="Rounded Rectangle 43"/>
+          <p:cNvPr id="42" name="Rounded Rectangle 41"/>
           <p:cNvSpPr/>
           <p:nvPr/>
         </p:nvSpPr>
         <p:spPr>
           <a:xfrm>
-            <a:off x="6159856" y="3611880"/>
-            <a:ext cx="1788109" cy="548640"/>
+            <a:off x="3581247" y="3255264"/>
+            <a:ext cx="1627632" cy="329184"/>
           </a:xfrm>
           <a:prstGeom prst="roundRect">
             <a:avLst>
@@ -4827,14 +4769,14 @@
       </p:sp>
       <p:sp>
         <p:nvSpPr>
-          <p:cNvPr id="45" name="Rectangle 44"/>
+          <p:cNvPr id="43" name="Rectangle 42"/>
           <p:cNvSpPr/>
           <p:nvPr/>
         </p:nvSpPr>
         <p:spPr>
           <a:xfrm>
-            <a:off x="7883957" y="3685032"/>
-            <a:ext cx="45720" cy="402336"/>
+            <a:off x="5144871" y="3328416"/>
+            <a:ext cx="45720" cy="182880"/>
           </a:xfrm>
           <a:prstGeom prst="rect">
             <a:avLst/>
@@ -4871,14 +4813,14 @@
       </p:sp>
       <p:sp>
         <p:nvSpPr>
-          <p:cNvPr id="46" name="TextBox 45"/>
+          <p:cNvPr id="44" name="TextBox 43"/>
           <p:cNvSpPr txBox="1"/>
           <p:nvPr/>
         </p:nvSpPr>
         <p:spPr>
           <a:xfrm>
-            <a:off x="6159856" y="3611880"/>
-            <a:ext cx="1788109" cy="548640"/>
+            <a:off x="3581247" y="3255264"/>
+            <a:ext cx="1627632" cy="329184"/>
           </a:xfrm>
           <a:prstGeom prst="rect">
             <a:avLst/>
@@ -4893,7 +4835,7 @@
           <a:p>
             <a:pPr algn="ctr" rtl="1"/>
             <a:r>
-              <a:rPr sz="1200" b="1">
+              <a:rPr sz="1100" b="1">
                 <a:solidFill>
                   <a:srgbClr val="1A2233"/>
                 </a:solidFill>
@@ -4907,14 +4849,14 @@
       </p:sp>
       <p:sp>
         <p:nvSpPr>
-          <p:cNvPr id="47" name="Rounded Rectangle 46"/>
+          <p:cNvPr id="45" name="Rounded Rectangle 44"/>
           <p:cNvSpPr/>
           <p:nvPr/>
         </p:nvSpPr>
         <p:spPr>
           <a:xfrm>
-            <a:off x="4243731" y="3611880"/>
-            <a:ext cx="1788109" cy="548640"/>
+            <a:off x="6982815" y="3657600"/>
+            <a:ext cx="1627632" cy="329184"/>
           </a:xfrm>
           <a:prstGeom prst="roundRect">
             <a:avLst>
@@ -4955,14 +4897,14 @@
       </p:sp>
       <p:sp>
         <p:nvSpPr>
-          <p:cNvPr id="48" name="Rectangle 47"/>
+          <p:cNvPr id="46" name="Rectangle 45"/>
           <p:cNvSpPr/>
           <p:nvPr/>
         </p:nvSpPr>
         <p:spPr>
           <a:xfrm>
-            <a:off x="5967832" y="3685032"/>
-            <a:ext cx="45720" cy="402336"/>
+            <a:off x="8546439" y="3730752"/>
+            <a:ext cx="45720" cy="182880"/>
           </a:xfrm>
           <a:prstGeom prst="rect">
             <a:avLst/>
@@ -4999,14 +4941,14 @@
       </p:sp>
       <p:sp>
         <p:nvSpPr>
-          <p:cNvPr id="49" name="TextBox 48"/>
+          <p:cNvPr id="47" name="TextBox 46"/>
           <p:cNvSpPr txBox="1"/>
           <p:nvPr/>
         </p:nvSpPr>
         <p:spPr>
           <a:xfrm>
-            <a:off x="4243731" y="3611880"/>
-            <a:ext cx="1788109" cy="548640"/>
+            <a:off x="6982815" y="3657600"/>
+            <a:ext cx="1627632" cy="329184"/>
           </a:xfrm>
           <a:prstGeom prst="rect">
             <a:avLst/>
@@ -5021,7 +4963,7 @@
           <a:p>
             <a:pPr algn="ctr" rtl="1"/>
             <a:r>
-              <a:rPr sz="1200" b="1">
+              <a:rPr sz="1100" b="1">
                 <a:solidFill>
                   <a:srgbClr val="1A2233"/>
                 </a:solidFill>
@@ -5035,14 +4977,14 @@
       </p:sp>
       <p:sp>
         <p:nvSpPr>
-          <p:cNvPr id="50" name="Rounded Rectangle 49"/>
+          <p:cNvPr id="48" name="Rounded Rectangle 47"/>
           <p:cNvSpPr/>
           <p:nvPr/>
         </p:nvSpPr>
         <p:spPr>
           <a:xfrm>
-            <a:off x="2327606" y="3611880"/>
-            <a:ext cx="1788109" cy="548640"/>
+            <a:off x="5282031" y="3657600"/>
+            <a:ext cx="1627632" cy="329184"/>
           </a:xfrm>
           <a:prstGeom prst="roundRect">
             <a:avLst>
@@ -5083,14 +5025,14 @@
       </p:sp>
       <p:sp>
         <p:nvSpPr>
-          <p:cNvPr id="51" name="Rectangle 50"/>
+          <p:cNvPr id="49" name="Rectangle 48"/>
           <p:cNvSpPr/>
           <p:nvPr/>
         </p:nvSpPr>
         <p:spPr>
           <a:xfrm>
-            <a:off x="4051707" y="3685032"/>
-            <a:ext cx="45720" cy="402336"/>
+            <a:off x="6845655" y="3730752"/>
+            <a:ext cx="45720" cy="182880"/>
           </a:xfrm>
           <a:prstGeom prst="rect">
             <a:avLst/>
@@ -5127,14 +5069,14 @@
       </p:sp>
       <p:sp>
         <p:nvSpPr>
-          <p:cNvPr id="52" name="TextBox 51"/>
+          <p:cNvPr id="50" name="TextBox 49"/>
           <p:cNvSpPr txBox="1"/>
           <p:nvPr/>
         </p:nvSpPr>
         <p:spPr>
           <a:xfrm>
-            <a:off x="2327606" y="3611880"/>
-            <a:ext cx="1788109" cy="548640"/>
+            <a:off x="5282031" y="3657600"/>
+            <a:ext cx="1627632" cy="329184"/>
           </a:xfrm>
           <a:prstGeom prst="rect">
             <a:avLst/>
@@ -5149,7 +5091,7 @@
           <a:p>
             <a:pPr algn="ctr" rtl="1"/>
             <a:r>
-              <a:rPr sz="1200" b="1">
+              <a:rPr sz="1100" b="1">
                 <a:solidFill>
                   <a:srgbClr val="1A2233"/>
                 </a:solidFill>
@@ -5163,14 +5105,14 @@
       </p:sp>
       <p:sp>
         <p:nvSpPr>
-          <p:cNvPr id="53" name="Rounded Rectangle 52"/>
+          <p:cNvPr id="51" name="Rounded Rectangle 50"/>
           <p:cNvSpPr/>
           <p:nvPr/>
         </p:nvSpPr>
         <p:spPr>
           <a:xfrm>
-            <a:off x="411481" y="3611880"/>
-            <a:ext cx="1788109" cy="548640"/>
+            <a:off x="3581247" y="3657600"/>
+            <a:ext cx="1627632" cy="329184"/>
           </a:xfrm>
           <a:prstGeom prst="roundRect">
             <a:avLst>
@@ -5211,14 +5153,14 @@
       </p:sp>
       <p:sp>
         <p:nvSpPr>
-          <p:cNvPr id="54" name="Rectangle 53"/>
+          <p:cNvPr id="52" name="Rectangle 51"/>
           <p:cNvSpPr/>
           <p:nvPr/>
         </p:nvSpPr>
         <p:spPr>
           <a:xfrm>
-            <a:off x="2135582" y="3685032"/>
-            <a:ext cx="45720" cy="402336"/>
+            <a:off x="5144871" y="3730752"/>
+            <a:ext cx="45720" cy="182880"/>
           </a:xfrm>
           <a:prstGeom prst="rect">
             <a:avLst/>
@@ -5255,14 +5197,14 @@
       </p:sp>
       <p:sp>
         <p:nvSpPr>
-          <p:cNvPr id="55" name="TextBox 54"/>
+          <p:cNvPr id="53" name="TextBox 52"/>
           <p:cNvSpPr txBox="1"/>
           <p:nvPr/>
         </p:nvSpPr>
         <p:spPr>
           <a:xfrm>
-            <a:off x="411481" y="3611880"/>
-            <a:ext cx="1788109" cy="548640"/>
+            <a:off x="3581247" y="3657600"/>
+            <a:ext cx="1627632" cy="329184"/>
           </a:xfrm>
           <a:prstGeom prst="rect">
             <a:avLst/>
@@ -5277,7 +5219,7 @@
           <a:p>
             <a:pPr algn="ctr" rtl="1"/>
             <a:r>
-              <a:rPr sz="1200" b="1">
+              <a:rPr sz="1100" b="1">
                 <a:solidFill>
                   <a:srgbClr val="1A2233"/>
                 </a:solidFill>
@@ -5291,14 +5233,14 @@
       </p:sp>
       <p:sp>
         <p:nvSpPr>
-          <p:cNvPr id="56" name="Rounded Rectangle 55"/>
+          <p:cNvPr id="54" name="Rounded Rectangle 53"/>
           <p:cNvSpPr/>
           <p:nvPr/>
         </p:nvSpPr>
         <p:spPr>
           <a:xfrm>
-            <a:off x="9992106" y="4288536"/>
-            <a:ext cx="1788109" cy="548640"/>
+            <a:off x="6982815" y="4059936"/>
+            <a:ext cx="1627632" cy="329184"/>
           </a:xfrm>
           <a:prstGeom prst="roundRect">
             <a:avLst>
@@ -5339,14 +5281,14 @@
       </p:sp>
       <p:sp>
         <p:nvSpPr>
-          <p:cNvPr id="57" name="Rectangle 56"/>
+          <p:cNvPr id="55" name="Rectangle 54"/>
           <p:cNvSpPr/>
           <p:nvPr/>
         </p:nvSpPr>
         <p:spPr>
           <a:xfrm>
-            <a:off x="11716207" y="4361688"/>
-            <a:ext cx="45720" cy="402336"/>
+            <a:off x="8546439" y="4133088"/>
+            <a:ext cx="45720" cy="182880"/>
           </a:xfrm>
           <a:prstGeom prst="rect">
             <a:avLst/>
@@ -5383,14 +5325,14 @@
       </p:sp>
       <p:sp>
         <p:nvSpPr>
-          <p:cNvPr id="58" name="TextBox 57"/>
+          <p:cNvPr id="56" name="TextBox 55"/>
           <p:cNvSpPr txBox="1"/>
           <p:nvPr/>
         </p:nvSpPr>
         <p:spPr>
           <a:xfrm>
-            <a:off x="9992106" y="4288536"/>
-            <a:ext cx="1788109" cy="548640"/>
+            <a:off x="6982815" y="4059936"/>
+            <a:ext cx="1627632" cy="329184"/>
           </a:xfrm>
           <a:prstGeom prst="rect">
             <a:avLst/>
@@ -5405,7 +5347,7 @@
           <a:p>
             <a:pPr algn="ctr" rtl="1"/>
             <a:r>
-              <a:rPr sz="1200" b="1">
+              <a:rPr sz="1100" b="1">
                 <a:solidFill>
                   <a:srgbClr val="1A2233"/>
                 </a:solidFill>
@@ -5419,14 +5361,14 @@
       </p:sp>
       <p:sp>
         <p:nvSpPr>
-          <p:cNvPr id="59" name="Rounded Rectangle 58"/>
+          <p:cNvPr id="57" name="Rounded Rectangle 56"/>
           <p:cNvSpPr/>
           <p:nvPr/>
         </p:nvSpPr>
         <p:spPr>
           <a:xfrm>
-            <a:off x="8075981" y="4288536"/>
-            <a:ext cx="1788109" cy="548640"/>
+            <a:off x="5282031" y="4059936"/>
+            <a:ext cx="1627632" cy="329184"/>
           </a:xfrm>
           <a:prstGeom prst="roundRect">
             <a:avLst>
@@ -5467,14 +5409,14 @@
       </p:sp>
       <p:sp>
         <p:nvSpPr>
-          <p:cNvPr id="60" name="Rectangle 59"/>
+          <p:cNvPr id="58" name="Rectangle 57"/>
           <p:cNvSpPr/>
           <p:nvPr/>
         </p:nvSpPr>
         <p:spPr>
           <a:xfrm>
-            <a:off x="9800082" y="4361688"/>
-            <a:ext cx="45720" cy="402336"/>
+            <a:off x="6845655" y="4133088"/>
+            <a:ext cx="45720" cy="182880"/>
           </a:xfrm>
           <a:prstGeom prst="rect">
             <a:avLst/>
@@ -5511,14 +5453,14 @@
       </p:sp>
       <p:sp>
         <p:nvSpPr>
-          <p:cNvPr id="61" name="TextBox 60"/>
+          <p:cNvPr id="59" name="TextBox 58"/>
           <p:cNvSpPr txBox="1"/>
           <p:nvPr/>
         </p:nvSpPr>
         <p:spPr>
           <a:xfrm>
-            <a:off x="8075981" y="4288536"/>
-            <a:ext cx="1788109" cy="548640"/>
+            <a:off x="5282031" y="4059936"/>
+            <a:ext cx="1627632" cy="329184"/>
           </a:xfrm>
           <a:prstGeom prst="rect">
             <a:avLst/>
@@ -5533,7 +5475,7 @@
           <a:p>
             <a:pPr algn="ctr" rtl="1"/>
             <a:r>
-              <a:rPr sz="1200" b="1">
+              <a:rPr sz="1100" b="1">
                 <a:solidFill>
                   <a:srgbClr val="1A2233"/>
                 </a:solidFill>
@@ -5547,14 +5489,14 @@
       </p:sp>
       <p:sp>
         <p:nvSpPr>
-          <p:cNvPr id="62" name="Rounded Rectangle 61"/>
+          <p:cNvPr id="60" name="Rounded Rectangle 59"/>
           <p:cNvSpPr/>
           <p:nvPr/>
         </p:nvSpPr>
         <p:spPr>
           <a:xfrm>
-            <a:off x="6159856" y="4288536"/>
-            <a:ext cx="1788109" cy="548640"/>
+            <a:off x="3581247" y="4059936"/>
+            <a:ext cx="1627632" cy="329184"/>
           </a:xfrm>
           <a:prstGeom prst="roundRect">
             <a:avLst>
@@ -5595,14 +5537,14 @@
       </p:sp>
       <p:sp>
         <p:nvSpPr>
-          <p:cNvPr id="63" name="Rectangle 62"/>
+          <p:cNvPr id="61" name="Rectangle 60"/>
           <p:cNvSpPr/>
           <p:nvPr/>
         </p:nvSpPr>
         <p:spPr>
           <a:xfrm>
-            <a:off x="7883957" y="4361688"/>
-            <a:ext cx="45720" cy="402336"/>
+            <a:off x="5144871" y="4133088"/>
+            <a:ext cx="45720" cy="182880"/>
           </a:xfrm>
           <a:prstGeom prst="rect">
             <a:avLst/>
@@ -5639,14 +5581,14 @@
       </p:sp>
       <p:sp>
         <p:nvSpPr>
-          <p:cNvPr id="64" name="TextBox 63"/>
+          <p:cNvPr id="62" name="TextBox 61"/>
           <p:cNvSpPr txBox="1"/>
           <p:nvPr/>
         </p:nvSpPr>
         <p:spPr>
           <a:xfrm>
-            <a:off x="6159856" y="4288536"/>
-            <a:ext cx="1788109" cy="548640"/>
+            <a:off x="3581247" y="4059936"/>
+            <a:ext cx="1627632" cy="329184"/>
           </a:xfrm>
           <a:prstGeom prst="rect">
             <a:avLst/>
@@ -5661,7 +5603,7 @@
           <a:p>
             <a:pPr algn="ctr" rtl="1"/>
             <a:r>
-              <a:rPr sz="1200" b="1">
+              <a:rPr sz="1100" b="1">
                 <a:solidFill>
                   <a:srgbClr val="1A2233"/>
                 </a:solidFill>
@@ -5675,14 +5617,14 @@
       </p:sp>
       <p:sp>
         <p:nvSpPr>
-          <p:cNvPr id="65" name="Rounded Rectangle 64"/>
+          <p:cNvPr id="63" name="Rounded Rectangle 62"/>
           <p:cNvSpPr/>
           <p:nvPr/>
         </p:nvSpPr>
         <p:spPr>
           <a:xfrm>
-            <a:off x="4243731" y="4288536"/>
-            <a:ext cx="1788109" cy="548640"/>
+            <a:off x="6982815" y="4462272"/>
+            <a:ext cx="1627632" cy="329184"/>
           </a:xfrm>
           <a:prstGeom prst="roundRect">
             <a:avLst>
@@ -5723,14 +5665,14 @@
       </p:sp>
       <p:sp>
         <p:nvSpPr>
-          <p:cNvPr id="66" name="Rectangle 65"/>
+          <p:cNvPr id="64" name="Rectangle 63"/>
           <p:cNvSpPr/>
           <p:nvPr/>
         </p:nvSpPr>
         <p:spPr>
           <a:xfrm>
-            <a:off x="5967832" y="4361688"/>
-            <a:ext cx="45720" cy="402336"/>
+            <a:off x="8546439" y="4535424"/>
+            <a:ext cx="45720" cy="182880"/>
           </a:xfrm>
           <a:prstGeom prst="rect">
             <a:avLst/>
@@ -5767,14 +5709,14 @@
       </p:sp>
       <p:sp>
         <p:nvSpPr>
-          <p:cNvPr id="67" name="TextBox 66"/>
+          <p:cNvPr id="65" name="TextBox 64"/>
           <p:cNvSpPr txBox="1"/>
           <p:nvPr/>
         </p:nvSpPr>
         <p:spPr>
           <a:xfrm>
-            <a:off x="4243731" y="4288536"/>
-            <a:ext cx="1788109" cy="548640"/>
+            <a:off x="6982815" y="4462272"/>
+            <a:ext cx="1627632" cy="329184"/>
           </a:xfrm>
           <a:prstGeom prst="rect">
             <a:avLst/>
@@ -5789,7 +5731,7 @@
           <a:p>
             <a:pPr algn="ctr" rtl="1"/>
             <a:r>
-              <a:rPr sz="1200" b="1">
+              <a:rPr sz="1100" b="1">
                 <a:solidFill>
                   <a:srgbClr val="1A2233"/>
                 </a:solidFill>
@@ -5803,14 +5745,14 @@
       </p:sp>
       <p:sp>
         <p:nvSpPr>
-          <p:cNvPr id="68" name="Rounded Rectangle 67"/>
+          <p:cNvPr id="66" name="Rounded Rectangle 65"/>
           <p:cNvSpPr/>
           <p:nvPr/>
         </p:nvSpPr>
         <p:spPr>
           <a:xfrm>
-            <a:off x="2327606" y="4288536"/>
-            <a:ext cx="1788109" cy="548640"/>
+            <a:off x="5282031" y="4462272"/>
+            <a:ext cx="1627632" cy="329184"/>
           </a:xfrm>
           <a:prstGeom prst="roundRect">
             <a:avLst>
@@ -5851,14 +5793,14 @@
       </p:sp>
       <p:sp>
         <p:nvSpPr>
-          <p:cNvPr id="69" name="Rectangle 68"/>
+          <p:cNvPr id="67" name="Rectangle 66"/>
           <p:cNvSpPr/>
           <p:nvPr/>
         </p:nvSpPr>
         <p:spPr>
           <a:xfrm>
-            <a:off x="4051707" y="4361688"/>
-            <a:ext cx="45720" cy="402336"/>
+            <a:off x="6845655" y="4535424"/>
+            <a:ext cx="45720" cy="182880"/>
           </a:xfrm>
           <a:prstGeom prst="rect">
             <a:avLst/>
@@ -5895,14 +5837,14 @@
       </p:sp>
       <p:sp>
         <p:nvSpPr>
-          <p:cNvPr id="70" name="TextBox 69"/>
+          <p:cNvPr id="68" name="TextBox 67"/>
           <p:cNvSpPr txBox="1"/>
           <p:nvPr/>
         </p:nvSpPr>
         <p:spPr>
           <a:xfrm>
-            <a:off x="2327606" y="4288536"/>
-            <a:ext cx="1788109" cy="548640"/>
+            <a:off x="5282031" y="4462272"/>
+            <a:ext cx="1627632" cy="329184"/>
           </a:xfrm>
           <a:prstGeom prst="rect">
             <a:avLst/>
@@ -5917,7 +5859,7 @@
           <a:p>
             <a:pPr algn="ctr" rtl="1"/>
             <a:r>
-              <a:rPr sz="1200" b="1">
+              <a:rPr sz="1100" b="1">
                 <a:solidFill>
                   <a:srgbClr val="1A2233"/>
                 </a:solidFill>
@@ -5931,14 +5873,14 @@
       </p:sp>
       <p:sp>
         <p:nvSpPr>
-          <p:cNvPr id="71" name="Rounded Rectangle 70"/>
+          <p:cNvPr id="69" name="Rounded Rectangle 68"/>
           <p:cNvSpPr/>
           <p:nvPr/>
         </p:nvSpPr>
         <p:spPr>
           <a:xfrm>
-            <a:off x="411481" y="4288536"/>
-            <a:ext cx="1788109" cy="548640"/>
+            <a:off x="3581247" y="4462272"/>
+            <a:ext cx="1627632" cy="329184"/>
           </a:xfrm>
           <a:prstGeom prst="roundRect">
             <a:avLst>
@@ -5979,14 +5921,14 @@
       </p:sp>
       <p:sp>
         <p:nvSpPr>
-          <p:cNvPr id="72" name="Rectangle 71"/>
+          <p:cNvPr id="70" name="Rectangle 69"/>
           <p:cNvSpPr/>
           <p:nvPr/>
         </p:nvSpPr>
         <p:spPr>
           <a:xfrm>
-            <a:off x="2135582" y="4361688"/>
-            <a:ext cx="45720" cy="402336"/>
+            <a:off x="5144871" y="4535424"/>
+            <a:ext cx="45720" cy="182880"/>
           </a:xfrm>
           <a:prstGeom prst="rect">
             <a:avLst/>
@@ -6023,14 +5965,14 @@
       </p:sp>
       <p:sp>
         <p:nvSpPr>
-          <p:cNvPr id="73" name="TextBox 72"/>
+          <p:cNvPr id="71" name="TextBox 70"/>
           <p:cNvSpPr txBox="1"/>
           <p:nvPr/>
         </p:nvSpPr>
         <p:spPr>
           <a:xfrm>
-            <a:off x="411481" y="4288536"/>
-            <a:ext cx="1788109" cy="548640"/>
+            <a:off x="3581247" y="4462272"/>
+            <a:ext cx="1627632" cy="329184"/>
           </a:xfrm>
           <a:prstGeom prst="rect">
             <a:avLst/>
@@ -6045,7 +5987,7 @@
           <a:p>
             <a:pPr algn="ctr" rtl="1"/>
             <a:r>
-              <a:rPr sz="1200" b="1">
+              <a:rPr sz="1100" b="1">
                 <a:solidFill>
                   <a:srgbClr val="1A2233"/>
                 </a:solidFill>
@@ -6059,14 +6001,14 @@
       </p:sp>
       <p:sp>
         <p:nvSpPr>
-          <p:cNvPr id="74" name="Rounded Rectangle 73"/>
+          <p:cNvPr id="72" name="Rounded Rectangle 71"/>
           <p:cNvSpPr/>
           <p:nvPr/>
         </p:nvSpPr>
         <p:spPr>
           <a:xfrm>
-            <a:off x="9992106" y="4965192"/>
-            <a:ext cx="1788109" cy="548640"/>
+            <a:off x="6982815" y="4864608"/>
+            <a:ext cx="1627632" cy="329184"/>
           </a:xfrm>
           <a:prstGeom prst="roundRect">
             <a:avLst>
@@ -6107,14 +6049,14 @@
       </p:sp>
       <p:sp>
         <p:nvSpPr>
-          <p:cNvPr id="75" name="Rectangle 74"/>
+          <p:cNvPr id="73" name="Rectangle 72"/>
           <p:cNvSpPr/>
           <p:nvPr/>
         </p:nvSpPr>
         <p:spPr>
           <a:xfrm>
-            <a:off x="11716207" y="5038344"/>
-            <a:ext cx="45720" cy="402336"/>
+            <a:off x="8546439" y="4937760"/>
+            <a:ext cx="45720" cy="182880"/>
           </a:xfrm>
           <a:prstGeom prst="rect">
             <a:avLst/>
@@ -6151,14 +6093,14 @@
       </p:sp>
       <p:sp>
         <p:nvSpPr>
-          <p:cNvPr id="76" name="TextBox 75"/>
+          <p:cNvPr id="74" name="TextBox 73"/>
           <p:cNvSpPr txBox="1"/>
           <p:nvPr/>
         </p:nvSpPr>
         <p:spPr>
           <a:xfrm>
-            <a:off x="9992106" y="4965192"/>
-            <a:ext cx="1788109" cy="548640"/>
+            <a:off x="6982815" y="4864608"/>
+            <a:ext cx="1627632" cy="329184"/>
           </a:xfrm>
           <a:prstGeom prst="rect">
             <a:avLst/>
@@ -6173,7 +6115,7 @@
           <a:p>
             <a:pPr algn="ctr" rtl="1"/>
             <a:r>
-              <a:rPr sz="1200" b="1">
+              <a:rPr sz="1100" b="1">
                 <a:solidFill>
                   <a:srgbClr val="1A2233"/>
                 </a:solidFill>
@@ -6187,14 +6129,14 @@
       </p:sp>
       <p:sp>
         <p:nvSpPr>
-          <p:cNvPr id="77" name="Rounded Rectangle 76"/>
+          <p:cNvPr id="75" name="Rounded Rectangle 74"/>
           <p:cNvSpPr/>
           <p:nvPr/>
         </p:nvSpPr>
         <p:spPr>
           <a:xfrm>
-            <a:off x="8075981" y="4965192"/>
-            <a:ext cx="1788109" cy="548640"/>
+            <a:off x="5282031" y="4864608"/>
+            <a:ext cx="1627632" cy="329184"/>
           </a:xfrm>
           <a:prstGeom prst="roundRect">
             <a:avLst>
@@ -6235,14 +6177,14 @@
       </p:sp>
       <p:sp>
         <p:nvSpPr>
-          <p:cNvPr id="78" name="Rectangle 77"/>
+          <p:cNvPr id="76" name="Rectangle 75"/>
           <p:cNvSpPr/>
           <p:nvPr/>
         </p:nvSpPr>
         <p:spPr>
           <a:xfrm>
-            <a:off x="9800082" y="5038344"/>
-            <a:ext cx="45720" cy="402336"/>
+            <a:off x="6845655" y="4937760"/>
+            <a:ext cx="45720" cy="182880"/>
           </a:xfrm>
           <a:prstGeom prst="rect">
             <a:avLst/>
@@ -6279,14 +6221,14 @@
       </p:sp>
       <p:sp>
         <p:nvSpPr>
-          <p:cNvPr id="79" name="TextBox 78"/>
+          <p:cNvPr id="77" name="TextBox 76"/>
           <p:cNvSpPr txBox="1"/>
           <p:nvPr/>
         </p:nvSpPr>
         <p:spPr>
           <a:xfrm>
-            <a:off x="8075981" y="4965192"/>
-            <a:ext cx="1788109" cy="548640"/>
+            <a:off x="5282031" y="4864608"/>
+            <a:ext cx="1627632" cy="329184"/>
           </a:xfrm>
           <a:prstGeom prst="rect">
             <a:avLst/>
@@ -6301,7 +6243,7 @@
           <a:p>
             <a:pPr algn="ctr" rtl="1"/>
             <a:r>
-              <a:rPr sz="1200" b="1">
+              <a:rPr sz="1100" b="1">
                 <a:solidFill>
                   <a:srgbClr val="1A2233"/>
                 </a:solidFill>
@@ -6315,14 +6257,14 @@
       </p:sp>
       <p:sp>
         <p:nvSpPr>
-          <p:cNvPr id="80" name="Rounded Rectangle 79"/>
+          <p:cNvPr id="78" name="Rounded Rectangle 77"/>
           <p:cNvSpPr/>
           <p:nvPr/>
         </p:nvSpPr>
         <p:spPr>
           <a:xfrm>
-            <a:off x="6159856" y="4965192"/>
-            <a:ext cx="1788109" cy="548640"/>
+            <a:off x="3581247" y="4864608"/>
+            <a:ext cx="1627632" cy="329184"/>
           </a:xfrm>
           <a:prstGeom prst="roundRect">
             <a:avLst>
@@ -6363,14 +6305,14 @@
       </p:sp>
       <p:sp>
         <p:nvSpPr>
-          <p:cNvPr id="81" name="Rectangle 80"/>
+          <p:cNvPr id="79" name="Rectangle 78"/>
           <p:cNvSpPr/>
           <p:nvPr/>
         </p:nvSpPr>
         <p:spPr>
           <a:xfrm>
-            <a:off x="7883957" y="5038344"/>
-            <a:ext cx="45720" cy="402336"/>
+            <a:off x="5144871" y="4937760"/>
+            <a:ext cx="45720" cy="182880"/>
           </a:xfrm>
           <a:prstGeom prst="rect">
             <a:avLst/>
@@ -6407,14 +6349,14 @@
       </p:sp>
       <p:sp>
         <p:nvSpPr>
-          <p:cNvPr id="82" name="TextBox 81"/>
+          <p:cNvPr id="80" name="TextBox 79"/>
           <p:cNvSpPr txBox="1"/>
           <p:nvPr/>
         </p:nvSpPr>
         <p:spPr>
           <a:xfrm>
-            <a:off x="6159856" y="4965192"/>
-            <a:ext cx="1788109" cy="548640"/>
+            <a:off x="3581247" y="4864608"/>
+            <a:ext cx="1627632" cy="329184"/>
           </a:xfrm>
           <a:prstGeom prst="rect">
             <a:avLst/>
@@ -6429,7 +6371,7 @@
           <a:p>
             <a:pPr algn="ctr" rtl="1"/>
             <a:r>
-              <a:rPr sz="1200" b="1">
+              <a:rPr sz="1100" b="1">
                 <a:solidFill>
                   <a:srgbClr val="1A2233"/>
                 </a:solidFill>
@@ -6443,14 +6385,14 @@
       </p:sp>
       <p:sp>
         <p:nvSpPr>
-          <p:cNvPr id="83" name="Rounded Rectangle 82"/>
+          <p:cNvPr id="81" name="Rounded Rectangle 80"/>
           <p:cNvSpPr/>
           <p:nvPr/>
         </p:nvSpPr>
         <p:spPr>
           <a:xfrm>
-            <a:off x="4243731" y="4965192"/>
-            <a:ext cx="1788109" cy="548640"/>
+            <a:off x="6982815" y="5266944"/>
+            <a:ext cx="1627632" cy="329184"/>
           </a:xfrm>
           <a:prstGeom prst="roundRect">
             <a:avLst>
@@ -6491,14 +6433,14 @@
       </p:sp>
       <p:sp>
         <p:nvSpPr>
-          <p:cNvPr id="84" name="Rectangle 83"/>
+          <p:cNvPr id="82" name="Rectangle 81"/>
           <p:cNvSpPr/>
           <p:nvPr/>
         </p:nvSpPr>
         <p:spPr>
           <a:xfrm>
-            <a:off x="5967832" y="5038344"/>
-            <a:ext cx="45720" cy="402336"/>
+            <a:off x="8546439" y="5340096"/>
+            <a:ext cx="45720" cy="182880"/>
           </a:xfrm>
           <a:prstGeom prst="rect">
             <a:avLst/>
@@ -6535,14 +6477,14 @@
       </p:sp>
       <p:sp>
         <p:nvSpPr>
-          <p:cNvPr id="85" name="TextBox 84"/>
+          <p:cNvPr id="83" name="TextBox 82"/>
           <p:cNvSpPr txBox="1"/>
           <p:nvPr/>
         </p:nvSpPr>
         <p:spPr>
           <a:xfrm>
-            <a:off x="4243731" y="4965192"/>
-            <a:ext cx="1788109" cy="548640"/>
+            <a:off x="6982815" y="5266944"/>
+            <a:ext cx="1627632" cy="329184"/>
           </a:xfrm>
           <a:prstGeom prst="rect">
             <a:avLst/>
@@ -6557,7 +6499,7 @@
           <a:p>
             <a:pPr algn="ctr" rtl="1"/>
             <a:r>
-              <a:rPr sz="1200" b="1">
+              <a:rPr sz="1100" b="1">
                 <a:solidFill>
                   <a:srgbClr val="1A2233"/>
                 </a:solidFill>
@@ -6571,14 +6513,14 @@
       </p:sp>
       <p:sp>
         <p:nvSpPr>
-          <p:cNvPr id="86" name="Rounded Rectangle 85"/>
+          <p:cNvPr id="84" name="Rounded Rectangle 83"/>
           <p:cNvSpPr/>
           <p:nvPr/>
         </p:nvSpPr>
         <p:spPr>
           <a:xfrm>
-            <a:off x="2327606" y="4965192"/>
-            <a:ext cx="1788109" cy="548640"/>
+            <a:off x="5282031" y="5266944"/>
+            <a:ext cx="1627632" cy="329184"/>
           </a:xfrm>
           <a:prstGeom prst="roundRect">
             <a:avLst>
@@ -6619,14 +6561,14 @@
       </p:sp>
       <p:sp>
         <p:nvSpPr>
-          <p:cNvPr id="87" name="Rectangle 86"/>
+          <p:cNvPr id="85" name="Rectangle 84"/>
           <p:cNvSpPr/>
           <p:nvPr/>
         </p:nvSpPr>
         <p:spPr>
           <a:xfrm>
-            <a:off x="4051707" y="5038344"/>
-            <a:ext cx="45720" cy="402336"/>
+            <a:off x="6845655" y="5340096"/>
+            <a:ext cx="45720" cy="182880"/>
           </a:xfrm>
           <a:prstGeom prst="rect">
             <a:avLst/>
@@ -6663,14 +6605,14 @@
       </p:sp>
       <p:sp>
         <p:nvSpPr>
-          <p:cNvPr id="88" name="TextBox 87"/>
+          <p:cNvPr id="86" name="TextBox 85"/>
           <p:cNvSpPr txBox="1"/>
           <p:nvPr/>
         </p:nvSpPr>
         <p:spPr>
           <a:xfrm>
-            <a:off x="2327606" y="4965192"/>
-            <a:ext cx="1788109" cy="548640"/>
+            <a:off x="5282031" y="5266944"/>
+            <a:ext cx="1627632" cy="329184"/>
           </a:xfrm>
           <a:prstGeom prst="rect">
             <a:avLst/>
@@ -6685,7 +6627,7 @@
           <a:p>
             <a:pPr algn="ctr" rtl="1"/>
             <a:r>
-              <a:rPr sz="1200" b="1">
+              <a:rPr sz="1100" b="1">
                 <a:solidFill>
                   <a:srgbClr val="1A2233"/>
                 </a:solidFill>
@@ -6699,14 +6641,14 @@
       </p:sp>
       <p:sp>
         <p:nvSpPr>
-          <p:cNvPr id="89" name="Rounded Rectangle 88"/>
+          <p:cNvPr id="87" name="Rounded Rectangle 86"/>
           <p:cNvSpPr/>
           <p:nvPr/>
         </p:nvSpPr>
         <p:spPr>
           <a:xfrm>
-            <a:off x="411481" y="4965192"/>
-            <a:ext cx="1788109" cy="548640"/>
+            <a:off x="3581247" y="5266944"/>
+            <a:ext cx="1627632" cy="329184"/>
           </a:xfrm>
           <a:prstGeom prst="roundRect">
             <a:avLst>
@@ -6747,14 +6689,14 @@
       </p:sp>
       <p:sp>
         <p:nvSpPr>
-          <p:cNvPr id="90" name="Rectangle 89"/>
+          <p:cNvPr id="88" name="Rectangle 87"/>
           <p:cNvSpPr/>
           <p:nvPr/>
         </p:nvSpPr>
         <p:spPr>
           <a:xfrm>
-            <a:off x="2135582" y="5038344"/>
-            <a:ext cx="45720" cy="402336"/>
+            <a:off x="5144871" y="5340096"/>
+            <a:ext cx="45720" cy="182880"/>
           </a:xfrm>
           <a:prstGeom prst="rect">
             <a:avLst/>
@@ -6791,14 +6733,14 @@
       </p:sp>
       <p:sp>
         <p:nvSpPr>
-          <p:cNvPr id="91" name="TextBox 90"/>
+          <p:cNvPr id="89" name="TextBox 88"/>
           <p:cNvSpPr txBox="1"/>
           <p:nvPr/>
         </p:nvSpPr>
         <p:spPr>
           <a:xfrm>
-            <a:off x="411481" y="4965192"/>
-            <a:ext cx="1788109" cy="548640"/>
+            <a:off x="3581247" y="5266944"/>
+            <a:ext cx="1627632" cy="329184"/>
           </a:xfrm>
           <a:prstGeom prst="rect">
             <a:avLst/>
@@ -6813,7 +6755,7 @@
           <a:p>
             <a:pPr algn="ctr" rtl="1"/>
             <a:r>
-              <a:rPr sz="1200" b="1">
+              <a:rPr sz="1100" b="1">
                 <a:solidFill>
                   <a:srgbClr val="1A2233"/>
                 </a:solidFill>
@@ -6825,6 +6767,76 @@
           </a:p>
         </p:txBody>
       </p:sp>
+      <p:cxnSp>
+        <p:nvCxnSpPr>
+          <p:cNvPr id="90" name="Connector 89"/>
+          <p:cNvCxnSpPr/>
+          <p:nvPr/>
+        </p:nvCxnSpPr>
+        <p:spPr>
+          <a:xfrm>
+            <a:off x="6095847" y="1901952"/>
+            <a:ext cx="0" cy="256032"/>
+          </a:xfrm>
+          <a:prstGeom prst="line">
+            <a:avLst/>
+          </a:prstGeom>
+          <a:ln w="19050">
+            <a:solidFill>
+              <a:srgbClr val="C5CDDD"/>
+            </a:solidFill>
+          </a:ln>
+        </p:spPr>
+        <p:style>
+          <a:lnRef idx="2">
+            <a:schemeClr val="accent1"/>
+          </a:lnRef>
+          <a:fillRef idx="0">
+            <a:schemeClr val="accent1"/>
+          </a:fillRef>
+          <a:effectRef idx="1">
+            <a:schemeClr val="accent1"/>
+          </a:effectRef>
+          <a:fontRef idx="minor">
+            <a:schemeClr val="tx1"/>
+          </a:fontRef>
+        </p:style>
+      </p:cxnSp>
+      <p:cxnSp>
+        <p:nvCxnSpPr>
+          <p:cNvPr id="91" name="Connector 90"/>
+          <p:cNvCxnSpPr/>
+          <p:nvPr/>
+        </p:nvCxnSpPr>
+        <p:spPr>
+          <a:xfrm>
+            <a:off x="6095847" y="2157984"/>
+            <a:ext cx="0" cy="237744"/>
+          </a:xfrm>
+          <a:prstGeom prst="line">
+            <a:avLst/>
+          </a:prstGeom>
+          <a:ln w="19050">
+            <a:solidFill>
+              <a:srgbClr val="C5CDDD"/>
+            </a:solidFill>
+          </a:ln>
+        </p:spPr>
+        <p:style>
+          <a:lnRef idx="2">
+            <a:schemeClr val="accent1"/>
+          </a:lnRef>
+          <a:fillRef idx="0">
+            <a:schemeClr val="accent1"/>
+          </a:fillRef>
+          <a:effectRef idx="1">
+            <a:schemeClr val="accent1"/>
+          </a:effectRef>
+          <a:fontRef idx="minor">
+            <a:schemeClr val="tx1"/>
+          </a:fontRef>
+        </p:style>
+      </p:cxnSp>
     </p:spTree>
   </p:cSld>
   <p:clrMapOvr>
@@ -7089,8 +7101,8 @@
         </p:nvSpPr>
         <p:spPr>
           <a:xfrm>
-            <a:off x="411480" y="1097280"/>
-            <a:ext cx="11368735" cy="274320"/>
+            <a:off x="411480" y="1024128"/>
+            <a:ext cx="11368735" cy="256032"/>
           </a:xfrm>
           <a:prstGeom prst="rect">
             <a:avLst/>
@@ -7125,8 +7137,8 @@
         </p:nvSpPr>
         <p:spPr>
           <a:xfrm>
-            <a:off x="10265838" y="1417320"/>
-            <a:ext cx="1514377" cy="713232"/>
+            <a:off x="10250163" y="1298448"/>
+            <a:ext cx="1530052" cy="603504"/>
           </a:xfrm>
           <a:prstGeom prst="roundRect">
             <a:avLst>
@@ -7171,8 +7183,8 @@
         </p:nvSpPr>
         <p:spPr>
           <a:xfrm>
-            <a:off x="10265838" y="1472184"/>
-            <a:ext cx="1514377" cy="370880"/>
+            <a:off x="10250163" y="1353312"/>
+            <a:ext cx="1530052" cy="313822"/>
           </a:xfrm>
           <a:prstGeom prst="rect">
             <a:avLst/>
@@ -7207,8 +7219,8 @@
         </p:nvSpPr>
         <p:spPr>
           <a:xfrm>
-            <a:off x="10265838" y="1809597"/>
-            <a:ext cx="1514377" cy="285292"/>
+            <a:off x="10250163" y="1630375"/>
+            <a:ext cx="1530052" cy="241401"/>
           </a:xfrm>
           <a:prstGeom prst="rect">
             <a:avLst/>
@@ -7243,8 +7255,8 @@
         </p:nvSpPr>
         <p:spPr>
           <a:xfrm>
-            <a:off x="8623445" y="1417320"/>
-            <a:ext cx="1514377" cy="713232"/>
+            <a:off x="8610383" y="1298448"/>
+            <a:ext cx="1530052" cy="603504"/>
           </a:xfrm>
           <a:prstGeom prst="roundRect">
             <a:avLst>
@@ -7289,8 +7301,8 @@
         </p:nvSpPr>
         <p:spPr>
           <a:xfrm>
-            <a:off x="8623445" y="1472184"/>
-            <a:ext cx="1514377" cy="370880"/>
+            <a:off x="8610383" y="1353312"/>
+            <a:ext cx="1530052" cy="313822"/>
           </a:xfrm>
           <a:prstGeom prst="rect">
             <a:avLst/>
@@ -7325,8 +7337,8 @@
         </p:nvSpPr>
         <p:spPr>
           <a:xfrm>
-            <a:off x="8623445" y="1809597"/>
-            <a:ext cx="1514377" cy="285292"/>
+            <a:off x="8610383" y="1630375"/>
+            <a:ext cx="1530052" cy="241401"/>
           </a:xfrm>
           <a:prstGeom prst="rect">
             <a:avLst/>
@@ -7361,8 +7373,8 @@
         </p:nvSpPr>
         <p:spPr>
           <a:xfrm>
-            <a:off x="6981052" y="1417320"/>
-            <a:ext cx="1514377" cy="713232"/>
+            <a:off x="6970603" y="1298448"/>
+            <a:ext cx="1530052" cy="603504"/>
           </a:xfrm>
           <a:prstGeom prst="roundRect">
             <a:avLst>
@@ -7407,8 +7419,8 @@
         </p:nvSpPr>
         <p:spPr>
           <a:xfrm>
-            <a:off x="6981052" y="1472184"/>
-            <a:ext cx="1514377" cy="370880"/>
+            <a:off x="6970603" y="1353312"/>
+            <a:ext cx="1530052" cy="313822"/>
           </a:xfrm>
           <a:prstGeom prst="rect">
             <a:avLst/>
@@ -7443,8 +7455,8 @@
         </p:nvSpPr>
         <p:spPr>
           <a:xfrm>
-            <a:off x="6981052" y="1809597"/>
-            <a:ext cx="1514377" cy="285292"/>
+            <a:off x="6970603" y="1630375"/>
+            <a:ext cx="1530052" cy="241401"/>
           </a:xfrm>
           <a:prstGeom prst="rect">
             <a:avLst/>
@@ -7479,8 +7491,8 @@
         </p:nvSpPr>
         <p:spPr>
           <a:xfrm>
-            <a:off x="5338659" y="1417320"/>
-            <a:ext cx="1514377" cy="713232"/>
+            <a:off x="5330823" y="1298448"/>
+            <a:ext cx="1530052" cy="603504"/>
           </a:xfrm>
           <a:prstGeom prst="roundRect">
             <a:avLst>
@@ -7525,8 +7537,8 @@
         </p:nvSpPr>
         <p:spPr>
           <a:xfrm>
-            <a:off x="5338659" y="1472184"/>
-            <a:ext cx="1514377" cy="370880"/>
+            <a:off x="5330823" y="1353312"/>
+            <a:ext cx="1530052" cy="313822"/>
           </a:xfrm>
           <a:prstGeom prst="rect">
             <a:avLst/>
@@ -7561,8 +7573,8 @@
         </p:nvSpPr>
         <p:spPr>
           <a:xfrm>
-            <a:off x="5338659" y="1809597"/>
-            <a:ext cx="1514377" cy="285292"/>
+            <a:off x="5330823" y="1630375"/>
+            <a:ext cx="1530052" cy="241401"/>
           </a:xfrm>
           <a:prstGeom prst="rect">
             <a:avLst/>
@@ -7597,8 +7609,8 @@
         </p:nvSpPr>
         <p:spPr>
           <a:xfrm>
-            <a:off x="3696266" y="1417320"/>
-            <a:ext cx="1514377" cy="713232"/>
+            <a:off x="3691043" y="1298448"/>
+            <a:ext cx="1530052" cy="603504"/>
           </a:xfrm>
           <a:prstGeom prst="roundRect">
             <a:avLst>
@@ -7643,8 +7655,8 @@
         </p:nvSpPr>
         <p:spPr>
           <a:xfrm>
-            <a:off x="3696266" y="1472184"/>
-            <a:ext cx="1514377" cy="370880"/>
+            <a:off x="3691043" y="1353312"/>
+            <a:ext cx="1530052" cy="313822"/>
           </a:xfrm>
           <a:prstGeom prst="rect">
             <a:avLst/>
@@ -7679,8 +7691,8 @@
         </p:nvSpPr>
         <p:spPr>
           <a:xfrm>
-            <a:off x="3696266" y="1809597"/>
-            <a:ext cx="1514377" cy="285292"/>
+            <a:off x="3691043" y="1630375"/>
+            <a:ext cx="1530052" cy="241401"/>
           </a:xfrm>
           <a:prstGeom prst="rect">
             <a:avLst/>
@@ -7715,8 +7727,8 @@
         </p:nvSpPr>
         <p:spPr>
           <a:xfrm>
-            <a:off x="2053873" y="1417320"/>
-            <a:ext cx="1514377" cy="713232"/>
+            <a:off x="2051263" y="1298448"/>
+            <a:ext cx="1530052" cy="603504"/>
           </a:xfrm>
           <a:prstGeom prst="roundRect">
             <a:avLst>
@@ -7761,8 +7773,8 @@
         </p:nvSpPr>
         <p:spPr>
           <a:xfrm>
-            <a:off x="2053873" y="1472184"/>
-            <a:ext cx="1514377" cy="370880"/>
+            <a:off x="2051263" y="1353312"/>
+            <a:ext cx="1530052" cy="313822"/>
           </a:xfrm>
           <a:prstGeom prst="rect">
             <a:avLst/>
@@ -7797,8 +7809,8 @@
         </p:nvSpPr>
         <p:spPr>
           <a:xfrm>
-            <a:off x="2053873" y="1809597"/>
-            <a:ext cx="1514377" cy="285292"/>
+            <a:off x="2051263" y="1630375"/>
+            <a:ext cx="1530052" cy="241401"/>
           </a:xfrm>
           <a:prstGeom prst="rect">
             <a:avLst/>
@@ -7833,8 +7845,8 @@
         </p:nvSpPr>
         <p:spPr>
           <a:xfrm>
-            <a:off x="411480" y="1417320"/>
-            <a:ext cx="1514377" cy="713232"/>
+            <a:off x="411483" y="1298448"/>
+            <a:ext cx="1530052" cy="603504"/>
           </a:xfrm>
           <a:prstGeom prst="roundRect">
             <a:avLst>
@@ -7879,8 +7891,8 @@
         </p:nvSpPr>
         <p:spPr>
           <a:xfrm>
-            <a:off x="411480" y="1472184"/>
-            <a:ext cx="1514377" cy="370880"/>
+            <a:off x="411483" y="1353312"/>
+            <a:ext cx="1530052" cy="313822"/>
           </a:xfrm>
           <a:prstGeom prst="rect">
             <a:avLst/>
@@ -7915,8 +7927,8 @@
         </p:nvSpPr>
         <p:spPr>
           <a:xfrm>
-            <a:off x="411480" y="1809597"/>
-            <a:ext cx="1514377" cy="285292"/>
+            <a:off x="411483" y="1630375"/>
+            <a:ext cx="1530052" cy="241401"/>
           </a:xfrm>
           <a:prstGeom prst="rect">
             <a:avLst/>
@@ -7943,41 +7955,52 @@
           </a:p>
         </p:txBody>
       </p:sp>
-      <p:cxnSp>
-        <p:nvCxnSpPr>
-          <p:cNvPr id="30" name="Connector 29"/>
-          <p:cNvCxnSpPr/>
-          <p:nvPr/>
-        </p:nvCxnSpPr>
-        <p:spPr>
-          <a:xfrm>
-            <a:off x="6095847" y="2130552"/>
-            <a:ext cx="0" cy="384048"/>
-          </a:xfrm>
-          <a:prstGeom prst="line">
-            <a:avLst/>
-          </a:prstGeom>
-          <a:ln w="19050">
+      <p:sp>
+        <p:nvSpPr>
+          <p:cNvPr id="30" name="Rounded Rectangle 29"/>
+          <p:cNvSpPr/>
+          <p:nvPr/>
+        </p:nvSpPr>
+        <p:spPr>
+          <a:xfrm>
+            <a:off x="3489807" y="2679192"/>
+            <a:ext cx="5212080" cy="3044952"/>
+          </a:xfrm>
+          <a:prstGeom prst="roundRect">
+            <a:avLst>
+              <a:gd name="adj" fmla="val 4000"/>
+            </a:avLst>
+          </a:prstGeom>
+          <a:noFill/>
+          <a:ln w="15875">
             <a:solidFill>
               <a:srgbClr val="C5CDDD"/>
             </a:solidFill>
           </a:ln>
+          <a:effectLst/>
         </p:spPr>
         <p:style>
-          <a:lnRef idx="2">
+          <a:lnRef idx="1">
             <a:schemeClr val="accent1"/>
           </a:lnRef>
-          <a:fillRef idx="0">
+          <a:fillRef idx="3">
             <a:schemeClr val="accent1"/>
           </a:fillRef>
-          <a:effectRef idx="1">
+          <a:effectRef idx="2">
             <a:schemeClr val="accent1"/>
           </a:effectRef>
           <a:fontRef idx="minor">
-            <a:schemeClr val="tx1"/>
+            <a:schemeClr val="lt1"/>
           </a:fontRef>
         </p:style>
-      </p:cxnSp>
+        <p:txBody>
+          <a:bodyPr rtlCol="0" anchor="ctr"/>
+          <a:lstStyle/>
+          <a:p>
+            <a:pPr algn="ctr"/>
+          </a:p>
+        </p:txBody>
+      </p:sp>
       <p:sp>
         <p:nvSpPr>
           <p:cNvPr id="31" name="Rounded Rectangle 30"/>
@@ -7986,8 +8009,8 @@
         </p:nvSpPr>
         <p:spPr>
           <a:xfrm>
-            <a:off x="4907127" y="2514600"/>
-            <a:ext cx="2377440" cy="731520"/>
+            <a:off x="4907127" y="2395728"/>
+            <a:ext cx="2377440" cy="566928"/>
           </a:xfrm>
           <a:prstGeom prst="roundRect">
             <a:avLst>
@@ -8032,8 +8055,8 @@
         </p:nvSpPr>
         <p:spPr>
           <a:xfrm>
-            <a:off x="4907127" y="2569464"/>
-            <a:ext cx="2377440" cy="380390"/>
+            <a:off x="4907127" y="2450592"/>
+            <a:ext cx="2377440" cy="294802"/>
           </a:xfrm>
           <a:prstGeom prst="rect">
             <a:avLst/>
@@ -8068,8 +8091,8 @@
         </p:nvSpPr>
         <p:spPr>
           <a:xfrm>
-            <a:off x="4907127" y="2916936"/>
-            <a:ext cx="2377440" cy="292608"/>
+            <a:off x="4907127" y="2707538"/>
+            <a:ext cx="2377440" cy="226771"/>
           </a:xfrm>
           <a:prstGeom prst="rect">
             <a:avLst/>
@@ -8104,89 +8127,8 @@
         </p:nvSpPr>
         <p:spPr>
           <a:xfrm>
-            <a:off x="301752" y="3429000"/>
-            <a:ext cx="11588191" cy="2267712"/>
-          </a:xfrm>
-          <a:prstGeom prst="roundRect">
-            <a:avLst>
-              <a:gd name="adj" fmla="val 6000"/>
-            </a:avLst>
-          </a:prstGeom>
-          <a:noFill/>
-          <a:ln w="15875">
-            <a:solidFill>
-              <a:srgbClr val="C5CDDD"/>
-            </a:solidFill>
-          </a:ln>
-          <a:effectLst/>
-        </p:spPr>
-        <p:style>
-          <a:lnRef idx="1">
-            <a:schemeClr val="accent1"/>
-          </a:lnRef>
-          <a:fillRef idx="3">
-            <a:schemeClr val="accent1"/>
-          </a:fillRef>
-          <a:effectRef idx="2">
-            <a:schemeClr val="accent1"/>
-          </a:effectRef>
-          <a:fontRef idx="minor">
-            <a:schemeClr val="lt1"/>
-          </a:fontRef>
-        </p:style>
-        <p:txBody>
-          <a:bodyPr rtlCol="0" anchor="ctr"/>
-          <a:lstStyle/>
-          <a:p>
-            <a:pPr algn="ctr"/>
-          </a:p>
-        </p:txBody>
-      </p:sp>
-      <p:cxnSp>
-        <p:nvCxnSpPr>
-          <p:cNvPr id="35" name="Connector 34"/>
-          <p:cNvCxnSpPr/>
-          <p:nvPr/>
-        </p:nvCxnSpPr>
-        <p:spPr>
-          <a:xfrm>
-            <a:off x="6095847" y="3246120"/>
-            <a:ext cx="0" cy="182880"/>
-          </a:xfrm>
-          <a:prstGeom prst="line">
-            <a:avLst/>
-          </a:prstGeom>
-          <a:ln w="19050">
-            <a:solidFill>
-              <a:srgbClr val="C5CDDD"/>
-            </a:solidFill>
-          </a:ln>
-        </p:spPr>
-        <p:style>
-          <a:lnRef idx="2">
-            <a:schemeClr val="accent1"/>
-          </a:lnRef>
-          <a:fillRef idx="0">
-            <a:schemeClr val="accent1"/>
-          </a:fillRef>
-          <a:effectRef idx="1">
-            <a:schemeClr val="accent1"/>
-          </a:effectRef>
-          <a:fontRef idx="minor">
-            <a:schemeClr val="tx1"/>
-          </a:fontRef>
-        </p:style>
-      </p:cxnSp>
-      <p:sp>
-        <p:nvSpPr>
-          <p:cNvPr id="36" name="Rounded Rectangle 35"/>
-          <p:cNvSpPr/>
-          <p:nvPr/>
-        </p:nvSpPr>
-        <p:spPr>
-          <a:xfrm>
-            <a:off x="9992106" y="3611880"/>
-            <a:ext cx="1788109" cy="548640"/>
+            <a:off x="6982815" y="3255264"/>
+            <a:ext cx="1627632" cy="329184"/>
           </a:xfrm>
           <a:prstGeom prst="roundRect">
             <a:avLst>
@@ -8225,14 +8167,14 @@
       </p:sp>
       <p:sp>
         <p:nvSpPr>
-          <p:cNvPr id="37" name="TextBox 36"/>
+          <p:cNvPr id="35" name="TextBox 34"/>
           <p:cNvSpPr txBox="1"/>
           <p:nvPr/>
         </p:nvSpPr>
         <p:spPr>
           <a:xfrm>
-            <a:off x="9992106" y="3611880"/>
-            <a:ext cx="1788109" cy="548640"/>
+            <a:off x="6982815" y="3255264"/>
+            <a:ext cx="1627632" cy="329184"/>
           </a:xfrm>
           <a:prstGeom prst="rect">
             <a:avLst/>
@@ -8247,7 +8189,7 @@
           <a:p>
             <a:pPr algn="ctr" rtl="1"/>
             <a:r>
-              <a:rPr sz="1200" b="1">
+              <a:rPr sz="1100" b="1">
                 <a:solidFill>
                   <a:srgbClr val="FFFFFF"/>
                 </a:solidFill>
@@ -8261,14 +8203,14 @@
       </p:sp>
       <p:sp>
         <p:nvSpPr>
-          <p:cNvPr id="38" name="Rounded Rectangle 37"/>
+          <p:cNvPr id="36" name="Rounded Rectangle 35"/>
           <p:cNvSpPr/>
           <p:nvPr/>
         </p:nvSpPr>
         <p:spPr>
           <a:xfrm>
-            <a:off x="8075981" y="3611880"/>
-            <a:ext cx="1788109" cy="548640"/>
+            <a:off x="5282031" y="3255264"/>
+            <a:ext cx="1627632" cy="329184"/>
           </a:xfrm>
           <a:prstGeom prst="roundRect">
             <a:avLst>
@@ -8307,14 +8249,14 @@
       </p:sp>
       <p:sp>
         <p:nvSpPr>
-          <p:cNvPr id="39" name="TextBox 38"/>
+          <p:cNvPr id="37" name="TextBox 36"/>
           <p:cNvSpPr txBox="1"/>
           <p:nvPr/>
         </p:nvSpPr>
         <p:spPr>
           <a:xfrm>
-            <a:off x="8075981" y="3611880"/>
-            <a:ext cx="1788109" cy="548640"/>
+            <a:off x="5282031" y="3255264"/>
+            <a:ext cx="1627632" cy="329184"/>
           </a:xfrm>
           <a:prstGeom prst="rect">
             <a:avLst/>
@@ -8329,7 +8271,7 @@
           <a:p>
             <a:pPr algn="ctr" rtl="1"/>
             <a:r>
-              <a:rPr sz="1200" b="1">
+              <a:rPr sz="1100" b="1">
                 <a:solidFill>
                   <a:srgbClr val="FFFFFF"/>
                 </a:solidFill>
@@ -8343,14 +8285,14 @@
       </p:sp>
       <p:sp>
         <p:nvSpPr>
-          <p:cNvPr id="40" name="Rounded Rectangle 39"/>
+          <p:cNvPr id="38" name="Rounded Rectangle 37"/>
           <p:cNvSpPr/>
           <p:nvPr/>
         </p:nvSpPr>
         <p:spPr>
           <a:xfrm>
-            <a:off x="6159856" y="3611880"/>
-            <a:ext cx="1788109" cy="548640"/>
+            <a:off x="3581247" y="3255264"/>
+            <a:ext cx="1627632" cy="329184"/>
           </a:xfrm>
           <a:prstGeom prst="roundRect">
             <a:avLst>
@@ -8389,14 +8331,14 @@
       </p:sp>
       <p:sp>
         <p:nvSpPr>
-          <p:cNvPr id="41" name="TextBox 40"/>
+          <p:cNvPr id="39" name="TextBox 38"/>
           <p:cNvSpPr txBox="1"/>
           <p:nvPr/>
         </p:nvSpPr>
         <p:spPr>
           <a:xfrm>
-            <a:off x="6159856" y="3611880"/>
-            <a:ext cx="1788109" cy="548640"/>
+            <a:off x="3581247" y="3255264"/>
+            <a:ext cx="1627632" cy="329184"/>
           </a:xfrm>
           <a:prstGeom prst="rect">
             <a:avLst/>
@@ -8411,7 +8353,7 @@
           <a:p>
             <a:pPr algn="ctr" rtl="1"/>
             <a:r>
-              <a:rPr sz="1200" b="1">
+              <a:rPr sz="1100" b="1">
                 <a:solidFill>
                   <a:srgbClr val="FFFFFF"/>
                 </a:solidFill>
@@ -8425,14 +8367,14 @@
       </p:sp>
       <p:sp>
         <p:nvSpPr>
-          <p:cNvPr id="42" name="Rounded Rectangle 41"/>
+          <p:cNvPr id="40" name="Rounded Rectangle 39"/>
           <p:cNvSpPr/>
           <p:nvPr/>
         </p:nvSpPr>
         <p:spPr>
           <a:xfrm>
-            <a:off x="4243731" y="3611880"/>
-            <a:ext cx="1788109" cy="548640"/>
+            <a:off x="6982815" y="3657600"/>
+            <a:ext cx="1627632" cy="329184"/>
           </a:xfrm>
           <a:prstGeom prst="roundRect">
             <a:avLst>
@@ -8471,14 +8413,14 @@
       </p:sp>
       <p:sp>
         <p:nvSpPr>
-          <p:cNvPr id="43" name="TextBox 42"/>
+          <p:cNvPr id="41" name="TextBox 40"/>
           <p:cNvSpPr txBox="1"/>
           <p:nvPr/>
         </p:nvSpPr>
         <p:spPr>
           <a:xfrm>
-            <a:off x="4243731" y="3611880"/>
-            <a:ext cx="1788109" cy="548640"/>
+            <a:off x="6982815" y="3657600"/>
+            <a:ext cx="1627632" cy="329184"/>
           </a:xfrm>
           <a:prstGeom prst="rect">
             <a:avLst/>
@@ -8493,7 +8435,7 @@
           <a:p>
             <a:pPr algn="ctr" rtl="1"/>
             <a:r>
-              <a:rPr sz="1200" b="1">
+              <a:rPr sz="1100" b="1">
                 <a:solidFill>
                   <a:srgbClr val="FFFFFF"/>
                 </a:solidFill>
@@ -8507,14 +8449,14 @@
       </p:sp>
       <p:sp>
         <p:nvSpPr>
-          <p:cNvPr id="44" name="Rounded Rectangle 43"/>
+          <p:cNvPr id="42" name="Rounded Rectangle 41"/>
           <p:cNvSpPr/>
           <p:nvPr/>
         </p:nvSpPr>
         <p:spPr>
           <a:xfrm>
-            <a:off x="2327606" y="3611880"/>
-            <a:ext cx="1788109" cy="548640"/>
+            <a:off x="5282031" y="3657600"/>
+            <a:ext cx="1627632" cy="329184"/>
           </a:xfrm>
           <a:prstGeom prst="roundRect">
             <a:avLst>
@@ -8553,14 +8495,14 @@
       </p:sp>
       <p:sp>
         <p:nvSpPr>
-          <p:cNvPr id="45" name="TextBox 44"/>
+          <p:cNvPr id="43" name="TextBox 42"/>
           <p:cNvSpPr txBox="1"/>
           <p:nvPr/>
         </p:nvSpPr>
         <p:spPr>
           <a:xfrm>
-            <a:off x="2327606" y="3611880"/>
-            <a:ext cx="1788109" cy="548640"/>
+            <a:off x="5282031" y="3657600"/>
+            <a:ext cx="1627632" cy="329184"/>
           </a:xfrm>
           <a:prstGeom prst="rect">
             <a:avLst/>
@@ -8575,7 +8517,7 @@
           <a:p>
             <a:pPr algn="ctr" rtl="1"/>
             <a:r>
-              <a:rPr sz="1200" b="1">
+              <a:rPr sz="1100" b="1">
                 <a:solidFill>
                   <a:srgbClr val="FFFFFF"/>
                 </a:solidFill>
@@ -8589,14 +8531,14 @@
       </p:sp>
       <p:sp>
         <p:nvSpPr>
-          <p:cNvPr id="46" name="Rounded Rectangle 45"/>
+          <p:cNvPr id="44" name="Rounded Rectangle 43"/>
           <p:cNvSpPr/>
           <p:nvPr/>
         </p:nvSpPr>
         <p:spPr>
           <a:xfrm>
-            <a:off x="411481" y="3611880"/>
-            <a:ext cx="1788109" cy="548640"/>
+            <a:off x="3581247" y="3657600"/>
+            <a:ext cx="1627632" cy="329184"/>
           </a:xfrm>
           <a:prstGeom prst="roundRect">
             <a:avLst>
@@ -8635,14 +8577,14 @@
       </p:sp>
       <p:sp>
         <p:nvSpPr>
-          <p:cNvPr id="47" name="TextBox 46"/>
+          <p:cNvPr id="45" name="TextBox 44"/>
           <p:cNvSpPr txBox="1"/>
           <p:nvPr/>
         </p:nvSpPr>
         <p:spPr>
           <a:xfrm>
-            <a:off x="411481" y="3611880"/>
-            <a:ext cx="1788109" cy="548640"/>
+            <a:off x="3581247" y="3657600"/>
+            <a:ext cx="1627632" cy="329184"/>
           </a:xfrm>
           <a:prstGeom prst="rect">
             <a:avLst/>
@@ -8657,7 +8599,7 @@
           <a:p>
             <a:pPr algn="ctr" rtl="1"/>
             <a:r>
-              <a:rPr sz="1200" b="1">
+              <a:rPr sz="1100" b="1">
                 <a:solidFill>
                   <a:srgbClr val="FFFFFF"/>
                 </a:solidFill>
@@ -8671,14 +8613,14 @@
       </p:sp>
       <p:sp>
         <p:nvSpPr>
-          <p:cNvPr id="48" name="Rounded Rectangle 47"/>
+          <p:cNvPr id="46" name="Rounded Rectangle 45"/>
           <p:cNvSpPr/>
           <p:nvPr/>
         </p:nvSpPr>
         <p:spPr>
           <a:xfrm>
-            <a:off x="9992106" y="4288536"/>
-            <a:ext cx="1788109" cy="548640"/>
+            <a:off x="6982815" y="4059936"/>
+            <a:ext cx="1627632" cy="329184"/>
           </a:xfrm>
           <a:prstGeom prst="roundRect">
             <a:avLst>
@@ -8717,14 +8659,14 @@
       </p:sp>
       <p:sp>
         <p:nvSpPr>
-          <p:cNvPr id="49" name="TextBox 48"/>
+          <p:cNvPr id="47" name="TextBox 46"/>
           <p:cNvSpPr txBox="1"/>
           <p:nvPr/>
         </p:nvSpPr>
         <p:spPr>
           <a:xfrm>
-            <a:off x="9992106" y="4288536"/>
-            <a:ext cx="1788109" cy="548640"/>
+            <a:off x="6982815" y="4059936"/>
+            <a:ext cx="1627632" cy="329184"/>
           </a:xfrm>
           <a:prstGeom prst="rect">
             <a:avLst/>
@@ -8739,7 +8681,7 @@
           <a:p>
             <a:pPr algn="ctr" rtl="1"/>
             <a:r>
-              <a:rPr sz="1200" b="1">
+              <a:rPr sz="1100" b="1">
                 <a:solidFill>
                   <a:srgbClr val="FFFFFF"/>
                 </a:solidFill>
@@ -8753,14 +8695,14 @@
       </p:sp>
       <p:sp>
         <p:nvSpPr>
-          <p:cNvPr id="50" name="Rounded Rectangle 49"/>
+          <p:cNvPr id="48" name="Rounded Rectangle 47"/>
           <p:cNvSpPr/>
           <p:nvPr/>
         </p:nvSpPr>
         <p:spPr>
           <a:xfrm>
-            <a:off x="8075981" y="4288536"/>
-            <a:ext cx="1788109" cy="548640"/>
+            <a:off x="5282031" y="4059936"/>
+            <a:ext cx="1627632" cy="329184"/>
           </a:xfrm>
           <a:prstGeom prst="roundRect">
             <a:avLst>
@@ -8799,14 +8741,14 @@
       </p:sp>
       <p:sp>
         <p:nvSpPr>
-          <p:cNvPr id="51" name="TextBox 50"/>
+          <p:cNvPr id="49" name="TextBox 48"/>
           <p:cNvSpPr txBox="1"/>
           <p:nvPr/>
         </p:nvSpPr>
         <p:spPr>
           <a:xfrm>
-            <a:off x="8075981" y="4288536"/>
-            <a:ext cx="1788109" cy="548640"/>
+            <a:off x="5282031" y="4059936"/>
+            <a:ext cx="1627632" cy="329184"/>
           </a:xfrm>
           <a:prstGeom prst="rect">
             <a:avLst/>
@@ -8821,7 +8763,7 @@
           <a:p>
             <a:pPr algn="ctr" rtl="1"/>
             <a:r>
-              <a:rPr sz="1200" b="1">
+              <a:rPr sz="1100" b="1">
                 <a:solidFill>
                   <a:srgbClr val="FFFFFF"/>
                 </a:solidFill>
@@ -8835,14 +8777,14 @@
       </p:sp>
       <p:sp>
         <p:nvSpPr>
-          <p:cNvPr id="52" name="Rounded Rectangle 51"/>
+          <p:cNvPr id="50" name="Rounded Rectangle 49"/>
           <p:cNvSpPr/>
           <p:nvPr/>
         </p:nvSpPr>
         <p:spPr>
           <a:xfrm>
-            <a:off x="6159856" y="4288536"/>
-            <a:ext cx="1788109" cy="548640"/>
+            <a:off x="3581247" y="4059936"/>
+            <a:ext cx="1627632" cy="329184"/>
           </a:xfrm>
           <a:prstGeom prst="roundRect">
             <a:avLst>
@@ -8881,14 +8823,14 @@
       </p:sp>
       <p:sp>
         <p:nvSpPr>
-          <p:cNvPr id="53" name="TextBox 52"/>
+          <p:cNvPr id="51" name="TextBox 50"/>
           <p:cNvSpPr txBox="1"/>
           <p:nvPr/>
         </p:nvSpPr>
         <p:spPr>
           <a:xfrm>
-            <a:off x="6159856" y="4288536"/>
-            <a:ext cx="1788109" cy="548640"/>
+            <a:off x="3581247" y="4059936"/>
+            <a:ext cx="1627632" cy="329184"/>
           </a:xfrm>
           <a:prstGeom prst="rect">
             <a:avLst/>
@@ -8903,7 +8845,7 @@
           <a:p>
             <a:pPr algn="ctr" rtl="1"/>
             <a:r>
-              <a:rPr sz="1200" b="1">
+              <a:rPr sz="1100" b="1">
                 <a:solidFill>
                   <a:srgbClr val="FFFFFF"/>
                 </a:solidFill>
@@ -8917,14 +8859,14 @@
       </p:sp>
       <p:sp>
         <p:nvSpPr>
-          <p:cNvPr id="54" name="Rounded Rectangle 53"/>
+          <p:cNvPr id="52" name="Rounded Rectangle 51"/>
           <p:cNvSpPr/>
           <p:nvPr/>
         </p:nvSpPr>
         <p:spPr>
           <a:xfrm>
-            <a:off x="4243731" y="4288536"/>
-            <a:ext cx="1788109" cy="548640"/>
+            <a:off x="6982815" y="4462272"/>
+            <a:ext cx="1627632" cy="329184"/>
           </a:xfrm>
           <a:prstGeom prst="roundRect">
             <a:avLst>
@@ -8963,14 +8905,14 @@
       </p:sp>
       <p:sp>
         <p:nvSpPr>
-          <p:cNvPr id="55" name="TextBox 54"/>
+          <p:cNvPr id="53" name="TextBox 52"/>
           <p:cNvSpPr txBox="1"/>
           <p:nvPr/>
         </p:nvSpPr>
         <p:spPr>
           <a:xfrm>
-            <a:off x="4243731" y="4288536"/>
-            <a:ext cx="1788109" cy="548640"/>
+            <a:off x="6982815" y="4462272"/>
+            <a:ext cx="1627632" cy="329184"/>
           </a:xfrm>
           <a:prstGeom prst="rect">
             <a:avLst/>
@@ -8985,7 +8927,7 @@
           <a:p>
             <a:pPr algn="ctr" rtl="1"/>
             <a:r>
-              <a:rPr sz="1200" b="1">
+              <a:rPr sz="1100" b="1">
                 <a:solidFill>
                   <a:srgbClr val="FFFFFF"/>
                 </a:solidFill>
@@ -8999,14 +8941,14 @@
       </p:sp>
       <p:sp>
         <p:nvSpPr>
-          <p:cNvPr id="56" name="Rounded Rectangle 55"/>
+          <p:cNvPr id="54" name="Rounded Rectangle 53"/>
           <p:cNvSpPr/>
           <p:nvPr/>
         </p:nvSpPr>
         <p:spPr>
           <a:xfrm>
-            <a:off x="2327606" y="4288536"/>
-            <a:ext cx="1788109" cy="548640"/>
+            <a:off x="5282031" y="4462272"/>
+            <a:ext cx="1627632" cy="329184"/>
           </a:xfrm>
           <a:prstGeom prst="roundRect">
             <a:avLst>
@@ -9045,14 +8987,14 @@
       </p:sp>
       <p:sp>
         <p:nvSpPr>
-          <p:cNvPr id="57" name="TextBox 56"/>
+          <p:cNvPr id="55" name="TextBox 54"/>
           <p:cNvSpPr txBox="1"/>
           <p:nvPr/>
         </p:nvSpPr>
         <p:spPr>
           <a:xfrm>
-            <a:off x="2327606" y="4288536"/>
-            <a:ext cx="1788109" cy="548640"/>
+            <a:off x="5282031" y="4462272"/>
+            <a:ext cx="1627632" cy="329184"/>
           </a:xfrm>
           <a:prstGeom prst="rect">
             <a:avLst/>
@@ -9067,7 +9009,7 @@
           <a:p>
             <a:pPr algn="ctr" rtl="1"/>
             <a:r>
-              <a:rPr sz="1200" b="1">
+              <a:rPr sz="1100" b="1">
                 <a:solidFill>
                   <a:srgbClr val="FFFFFF"/>
                 </a:solidFill>
@@ -9081,14 +9023,14 @@
       </p:sp>
       <p:sp>
         <p:nvSpPr>
-          <p:cNvPr id="58" name="Rounded Rectangle 57"/>
+          <p:cNvPr id="56" name="Rounded Rectangle 55"/>
           <p:cNvSpPr/>
           <p:nvPr/>
         </p:nvSpPr>
         <p:spPr>
           <a:xfrm>
-            <a:off x="411481" y="4288536"/>
-            <a:ext cx="1788109" cy="548640"/>
+            <a:off x="3581247" y="4462272"/>
+            <a:ext cx="1627632" cy="329184"/>
           </a:xfrm>
           <a:prstGeom prst="roundRect">
             <a:avLst>
@@ -9127,14 +9069,14 @@
       </p:sp>
       <p:sp>
         <p:nvSpPr>
-          <p:cNvPr id="59" name="TextBox 58"/>
+          <p:cNvPr id="57" name="TextBox 56"/>
           <p:cNvSpPr txBox="1"/>
           <p:nvPr/>
         </p:nvSpPr>
         <p:spPr>
           <a:xfrm>
-            <a:off x="411481" y="4288536"/>
-            <a:ext cx="1788109" cy="548640"/>
+            <a:off x="3581247" y="4462272"/>
+            <a:ext cx="1627632" cy="329184"/>
           </a:xfrm>
           <a:prstGeom prst="rect">
             <a:avLst/>
@@ -9149,7 +9091,7 @@
           <a:p>
             <a:pPr algn="ctr" rtl="1"/>
             <a:r>
-              <a:rPr sz="1200" b="1">
+              <a:rPr sz="1100" b="1">
                 <a:solidFill>
                   <a:srgbClr val="FFFFFF"/>
                 </a:solidFill>
@@ -9163,14 +9105,14 @@
       </p:sp>
       <p:sp>
         <p:nvSpPr>
-          <p:cNvPr id="60" name="Rounded Rectangle 59"/>
+          <p:cNvPr id="58" name="Rounded Rectangle 57"/>
           <p:cNvSpPr/>
           <p:nvPr/>
         </p:nvSpPr>
         <p:spPr>
           <a:xfrm>
-            <a:off x="9992106" y="4965192"/>
-            <a:ext cx="1788109" cy="548640"/>
+            <a:off x="6982815" y="4864608"/>
+            <a:ext cx="1627632" cy="329184"/>
           </a:xfrm>
           <a:prstGeom prst="roundRect">
             <a:avLst>
@@ -9209,14 +9151,14 @@
       </p:sp>
       <p:sp>
         <p:nvSpPr>
-          <p:cNvPr id="61" name="TextBox 60"/>
+          <p:cNvPr id="59" name="TextBox 58"/>
           <p:cNvSpPr txBox="1"/>
           <p:nvPr/>
         </p:nvSpPr>
         <p:spPr>
           <a:xfrm>
-            <a:off x="9992106" y="4965192"/>
-            <a:ext cx="1788109" cy="548640"/>
+            <a:off x="6982815" y="4864608"/>
+            <a:ext cx="1627632" cy="329184"/>
           </a:xfrm>
           <a:prstGeom prst="rect">
             <a:avLst/>
@@ -9231,7 +9173,7 @@
           <a:p>
             <a:pPr algn="ctr" rtl="1"/>
             <a:r>
-              <a:rPr sz="1200" b="1">
+              <a:rPr sz="1100" b="1">
                 <a:solidFill>
                   <a:srgbClr val="FFFFFF"/>
                 </a:solidFill>
@@ -9245,14 +9187,14 @@
       </p:sp>
       <p:sp>
         <p:nvSpPr>
-          <p:cNvPr id="62" name="Rounded Rectangle 61"/>
+          <p:cNvPr id="60" name="Rounded Rectangle 59"/>
           <p:cNvSpPr/>
           <p:nvPr/>
         </p:nvSpPr>
         <p:spPr>
           <a:xfrm>
-            <a:off x="8075981" y="4965192"/>
-            <a:ext cx="1788109" cy="548640"/>
+            <a:off x="5282031" y="4864608"/>
+            <a:ext cx="1627632" cy="329184"/>
           </a:xfrm>
           <a:prstGeom prst="roundRect">
             <a:avLst>
@@ -9291,14 +9233,14 @@
       </p:sp>
       <p:sp>
         <p:nvSpPr>
-          <p:cNvPr id="63" name="TextBox 62"/>
+          <p:cNvPr id="61" name="TextBox 60"/>
           <p:cNvSpPr txBox="1"/>
           <p:nvPr/>
         </p:nvSpPr>
         <p:spPr>
           <a:xfrm>
-            <a:off x="8075981" y="4965192"/>
-            <a:ext cx="1788109" cy="548640"/>
+            <a:off x="5282031" y="4864608"/>
+            <a:ext cx="1627632" cy="329184"/>
           </a:xfrm>
           <a:prstGeom prst="rect">
             <a:avLst/>
@@ -9313,7 +9255,7 @@
           <a:p>
             <a:pPr algn="ctr" rtl="1"/>
             <a:r>
-              <a:rPr sz="1200" b="1">
+              <a:rPr sz="1100" b="1">
                 <a:solidFill>
                   <a:srgbClr val="FFFFFF"/>
                 </a:solidFill>
@@ -9327,14 +9269,14 @@
       </p:sp>
       <p:sp>
         <p:nvSpPr>
-          <p:cNvPr id="64" name="Rounded Rectangle 63"/>
+          <p:cNvPr id="62" name="Rounded Rectangle 61"/>
           <p:cNvSpPr/>
           <p:nvPr/>
         </p:nvSpPr>
         <p:spPr>
           <a:xfrm>
-            <a:off x="6159856" y="4965192"/>
-            <a:ext cx="1788109" cy="548640"/>
+            <a:off x="3581247" y="4864608"/>
+            <a:ext cx="1627632" cy="329184"/>
           </a:xfrm>
           <a:prstGeom prst="roundRect">
             <a:avLst>
@@ -9373,14 +9315,14 @@
       </p:sp>
       <p:sp>
         <p:nvSpPr>
-          <p:cNvPr id="65" name="TextBox 64"/>
+          <p:cNvPr id="63" name="TextBox 62"/>
           <p:cNvSpPr txBox="1"/>
           <p:nvPr/>
         </p:nvSpPr>
         <p:spPr>
           <a:xfrm>
-            <a:off x="6159856" y="4965192"/>
-            <a:ext cx="1788109" cy="548640"/>
+            <a:off x="3581247" y="4864608"/>
+            <a:ext cx="1627632" cy="329184"/>
           </a:xfrm>
           <a:prstGeom prst="rect">
             <a:avLst/>
@@ -9395,7 +9337,7 @@
           <a:p>
             <a:pPr algn="ctr" rtl="1"/>
             <a:r>
-              <a:rPr sz="1200" b="1">
+              <a:rPr sz="1100" b="1">
                 <a:solidFill>
                   <a:srgbClr val="FFFFFF"/>
                 </a:solidFill>
@@ -9409,14 +9351,14 @@
       </p:sp>
       <p:sp>
         <p:nvSpPr>
-          <p:cNvPr id="66" name="Rounded Rectangle 65"/>
+          <p:cNvPr id="64" name="Rounded Rectangle 63"/>
           <p:cNvSpPr/>
           <p:nvPr/>
         </p:nvSpPr>
         <p:spPr>
           <a:xfrm>
-            <a:off x="4243731" y="4965192"/>
-            <a:ext cx="1788109" cy="548640"/>
+            <a:off x="6982815" y="5266944"/>
+            <a:ext cx="1627632" cy="329184"/>
           </a:xfrm>
           <a:prstGeom prst="roundRect">
             <a:avLst>
@@ -9455,14 +9397,14 @@
       </p:sp>
       <p:sp>
         <p:nvSpPr>
-          <p:cNvPr id="67" name="TextBox 66"/>
+          <p:cNvPr id="65" name="TextBox 64"/>
           <p:cNvSpPr txBox="1"/>
           <p:nvPr/>
         </p:nvSpPr>
         <p:spPr>
           <a:xfrm>
-            <a:off x="4243731" y="4965192"/>
-            <a:ext cx="1788109" cy="548640"/>
+            <a:off x="6982815" y="5266944"/>
+            <a:ext cx="1627632" cy="329184"/>
           </a:xfrm>
           <a:prstGeom prst="rect">
             <a:avLst/>
@@ -9477,7 +9419,7 @@
           <a:p>
             <a:pPr algn="ctr" rtl="1"/>
             <a:r>
-              <a:rPr sz="1200" b="1">
+              <a:rPr sz="1100" b="1">
                 <a:solidFill>
                   <a:srgbClr val="FFFFFF"/>
                 </a:solidFill>
@@ -9491,14 +9433,14 @@
       </p:sp>
       <p:sp>
         <p:nvSpPr>
-          <p:cNvPr id="68" name="Rounded Rectangle 67"/>
+          <p:cNvPr id="66" name="Rounded Rectangle 65"/>
           <p:cNvSpPr/>
           <p:nvPr/>
         </p:nvSpPr>
         <p:spPr>
           <a:xfrm>
-            <a:off x="2327606" y="4965192"/>
-            <a:ext cx="1788109" cy="548640"/>
+            <a:off x="5282031" y="5266944"/>
+            <a:ext cx="1627632" cy="329184"/>
           </a:xfrm>
           <a:prstGeom prst="roundRect">
             <a:avLst>
@@ -9537,14 +9479,14 @@
       </p:sp>
       <p:sp>
         <p:nvSpPr>
-          <p:cNvPr id="69" name="TextBox 68"/>
+          <p:cNvPr id="67" name="TextBox 66"/>
           <p:cNvSpPr txBox="1"/>
           <p:nvPr/>
         </p:nvSpPr>
         <p:spPr>
           <a:xfrm>
-            <a:off x="2327606" y="4965192"/>
-            <a:ext cx="1788109" cy="548640"/>
+            <a:off x="5282031" y="5266944"/>
+            <a:ext cx="1627632" cy="329184"/>
           </a:xfrm>
           <a:prstGeom prst="rect">
             <a:avLst/>
@@ -9559,7 +9501,7 @@
           <a:p>
             <a:pPr algn="ctr" rtl="1"/>
             <a:r>
-              <a:rPr sz="1200" b="1">
+              <a:rPr sz="1100" b="1">
                 <a:solidFill>
                   <a:srgbClr val="FFFFFF"/>
                 </a:solidFill>
@@ -9573,14 +9515,14 @@
       </p:sp>
       <p:sp>
         <p:nvSpPr>
-          <p:cNvPr id="70" name="Rounded Rectangle 69"/>
+          <p:cNvPr id="68" name="Rounded Rectangle 67"/>
           <p:cNvSpPr/>
           <p:nvPr/>
         </p:nvSpPr>
         <p:spPr>
           <a:xfrm>
-            <a:off x="411481" y="4965192"/>
-            <a:ext cx="1788109" cy="548640"/>
+            <a:off x="3581247" y="5266944"/>
+            <a:ext cx="1627632" cy="329184"/>
           </a:xfrm>
           <a:prstGeom prst="roundRect">
             <a:avLst>
@@ -9619,14 +9561,14 @@
       </p:sp>
       <p:sp>
         <p:nvSpPr>
-          <p:cNvPr id="71" name="TextBox 70"/>
+          <p:cNvPr id="69" name="TextBox 68"/>
           <p:cNvSpPr txBox="1"/>
           <p:nvPr/>
         </p:nvSpPr>
         <p:spPr>
           <a:xfrm>
-            <a:off x="411481" y="4965192"/>
-            <a:ext cx="1788109" cy="548640"/>
+            <a:off x="3581247" y="5266944"/>
+            <a:ext cx="1627632" cy="329184"/>
           </a:xfrm>
           <a:prstGeom prst="rect">
             <a:avLst/>
@@ -9641,7 +9583,7 @@
           <a:p>
             <a:pPr algn="ctr" rtl="1"/>
             <a:r>
-              <a:rPr sz="1200" b="1">
+              <a:rPr sz="1100" b="1">
                 <a:solidFill>
                   <a:srgbClr val="FFFFFF"/>
                 </a:solidFill>
@@ -9653,6 +9595,76 @@
           </a:p>
         </p:txBody>
       </p:sp>
+      <p:cxnSp>
+        <p:nvCxnSpPr>
+          <p:cNvPr id="70" name="Connector 69"/>
+          <p:cNvCxnSpPr/>
+          <p:nvPr/>
+        </p:nvCxnSpPr>
+        <p:spPr>
+          <a:xfrm>
+            <a:off x="6095847" y="1901952"/>
+            <a:ext cx="0" cy="256032"/>
+          </a:xfrm>
+          <a:prstGeom prst="line">
+            <a:avLst/>
+          </a:prstGeom>
+          <a:ln w="19050">
+            <a:solidFill>
+              <a:srgbClr val="C5CDDD"/>
+            </a:solidFill>
+          </a:ln>
+        </p:spPr>
+        <p:style>
+          <a:lnRef idx="2">
+            <a:schemeClr val="accent1"/>
+          </a:lnRef>
+          <a:fillRef idx="0">
+            <a:schemeClr val="accent1"/>
+          </a:fillRef>
+          <a:effectRef idx="1">
+            <a:schemeClr val="accent1"/>
+          </a:effectRef>
+          <a:fontRef idx="minor">
+            <a:schemeClr val="tx1"/>
+          </a:fontRef>
+        </p:style>
+      </p:cxnSp>
+      <p:cxnSp>
+        <p:nvCxnSpPr>
+          <p:cNvPr id="71" name="Connector 70"/>
+          <p:cNvCxnSpPr/>
+          <p:nvPr/>
+        </p:nvCxnSpPr>
+        <p:spPr>
+          <a:xfrm>
+            <a:off x="6095847" y="2157984"/>
+            <a:ext cx="0" cy="237744"/>
+          </a:xfrm>
+          <a:prstGeom prst="line">
+            <a:avLst/>
+          </a:prstGeom>
+          <a:ln w="19050">
+            <a:solidFill>
+              <a:srgbClr val="C5CDDD"/>
+            </a:solidFill>
+          </a:ln>
+        </p:spPr>
+        <p:style>
+          <a:lnRef idx="2">
+            <a:schemeClr val="accent1"/>
+          </a:lnRef>
+          <a:fillRef idx="0">
+            <a:schemeClr val="accent1"/>
+          </a:fillRef>
+          <a:effectRef idx="1">
+            <a:schemeClr val="accent1"/>
+          </a:effectRef>
+          <a:fontRef idx="minor">
+            <a:schemeClr val="tx1"/>
+          </a:fontRef>
+        </p:style>
+      </p:cxnSp>
       <p:sp>
         <p:nvSpPr>
           <p:cNvPr id="72" name="Oval 71"/>

</xml_diff>

<commit_message>
Add activists team to org slides
Co-Authored-By: Claude Opus 5.5 <noreply@anthropic.com>
Claude-Session: https://claude.ai/code/session_01W7Er83FuNT4pLFShWidYHn
</commit_message>
<xml_diff>
--- a/presentation/out/koach-hitarvut.pptx
+++ b/presentation/out/koach-hitarvut.pptx
@@ -4261,7 +4261,7 @@
         </p:nvSpPr>
         <p:spPr>
           <a:xfrm>
-            <a:off x="3489807" y="2679192"/>
+            <a:off x="4495647" y="2679192"/>
             <a:ext cx="5212080" cy="3044952"/>
           </a:xfrm>
           <a:prstGeom prst="roundRect">
@@ -4307,7 +4307,7 @@
         </p:nvSpPr>
         <p:spPr>
           <a:xfrm>
-            <a:off x="4907127" y="2395728"/>
+            <a:off x="5912967" y="2395728"/>
             <a:ext cx="2377440" cy="566928"/>
           </a:xfrm>
           <a:prstGeom prst="roundRect">
@@ -4355,7 +4355,7 @@
         </p:nvSpPr>
         <p:spPr>
           <a:xfrm>
-            <a:off x="7220559" y="2468880"/>
+            <a:off x="8226399" y="2468880"/>
             <a:ext cx="45720" cy="420624"/>
           </a:xfrm>
           <a:prstGeom prst="rect">
@@ -4399,7 +4399,7 @@
         </p:nvSpPr>
         <p:spPr>
           <a:xfrm>
-            <a:off x="4907127" y="2450592"/>
+            <a:off x="5912967" y="2450592"/>
             <a:ext cx="2377440" cy="294802"/>
           </a:xfrm>
           <a:prstGeom prst="rect">
@@ -4435,7 +4435,7 @@
         </p:nvSpPr>
         <p:spPr>
           <a:xfrm>
-            <a:off x="4907127" y="2707538"/>
+            <a:off x="5912967" y="2707538"/>
             <a:ext cx="2377440" cy="226771"/>
           </a:xfrm>
           <a:prstGeom prst="rect">
@@ -4471,7 +4471,7 @@
         </p:nvSpPr>
         <p:spPr>
           <a:xfrm>
-            <a:off x="6982815" y="3255264"/>
+            <a:off x="7988655" y="3255264"/>
             <a:ext cx="1627632" cy="329184"/>
           </a:xfrm>
           <a:prstGeom prst="roundRect">
@@ -4519,7 +4519,7 @@
         </p:nvSpPr>
         <p:spPr>
           <a:xfrm>
-            <a:off x="8546439" y="3328416"/>
+            <a:off x="9552279" y="3328416"/>
             <a:ext cx="45720" cy="182880"/>
           </a:xfrm>
           <a:prstGeom prst="rect">
@@ -4563,7 +4563,7 @@
         </p:nvSpPr>
         <p:spPr>
           <a:xfrm>
-            <a:off x="6982815" y="3255264"/>
+            <a:off x="7988655" y="3255264"/>
             <a:ext cx="1627632" cy="329184"/>
           </a:xfrm>
           <a:prstGeom prst="rect">
@@ -4599,7 +4599,7 @@
         </p:nvSpPr>
         <p:spPr>
           <a:xfrm>
-            <a:off x="5282031" y="3255264"/>
+            <a:off x="6287871" y="3255264"/>
             <a:ext cx="1627632" cy="329184"/>
           </a:xfrm>
           <a:prstGeom prst="roundRect">
@@ -4647,7 +4647,7 @@
         </p:nvSpPr>
         <p:spPr>
           <a:xfrm>
-            <a:off x="6845655" y="3328416"/>
+            <a:off x="7851495" y="3328416"/>
             <a:ext cx="45720" cy="182880"/>
           </a:xfrm>
           <a:prstGeom prst="rect">
@@ -4691,7 +4691,7 @@
         </p:nvSpPr>
         <p:spPr>
           <a:xfrm>
-            <a:off x="5282031" y="3255264"/>
+            <a:off x="6287871" y="3255264"/>
             <a:ext cx="1627632" cy="329184"/>
           </a:xfrm>
           <a:prstGeom prst="rect">
@@ -4727,7 +4727,7 @@
         </p:nvSpPr>
         <p:spPr>
           <a:xfrm>
-            <a:off x="3581247" y="3255264"/>
+            <a:off x="4587087" y="3255264"/>
             <a:ext cx="1627632" cy="329184"/>
           </a:xfrm>
           <a:prstGeom prst="roundRect">
@@ -4775,7 +4775,7 @@
         </p:nvSpPr>
         <p:spPr>
           <a:xfrm>
-            <a:off x="5144871" y="3328416"/>
+            <a:off x="6150711" y="3328416"/>
             <a:ext cx="45720" cy="182880"/>
           </a:xfrm>
           <a:prstGeom prst="rect">
@@ -4819,7 +4819,7 @@
         </p:nvSpPr>
         <p:spPr>
           <a:xfrm>
-            <a:off x="3581247" y="3255264"/>
+            <a:off x="4587087" y="3255264"/>
             <a:ext cx="1627632" cy="329184"/>
           </a:xfrm>
           <a:prstGeom prst="rect">
@@ -4855,7 +4855,7 @@
         </p:nvSpPr>
         <p:spPr>
           <a:xfrm>
-            <a:off x="6982815" y="3657600"/>
+            <a:off x="7988655" y="3657600"/>
             <a:ext cx="1627632" cy="329184"/>
           </a:xfrm>
           <a:prstGeom prst="roundRect">
@@ -4903,7 +4903,7 @@
         </p:nvSpPr>
         <p:spPr>
           <a:xfrm>
-            <a:off x="8546439" y="3730752"/>
+            <a:off x="9552279" y="3730752"/>
             <a:ext cx="45720" cy="182880"/>
           </a:xfrm>
           <a:prstGeom prst="rect">
@@ -4947,7 +4947,7 @@
         </p:nvSpPr>
         <p:spPr>
           <a:xfrm>
-            <a:off x="6982815" y="3657600"/>
+            <a:off x="7988655" y="3657600"/>
             <a:ext cx="1627632" cy="329184"/>
           </a:xfrm>
           <a:prstGeom prst="rect">
@@ -4983,7 +4983,7 @@
         </p:nvSpPr>
         <p:spPr>
           <a:xfrm>
-            <a:off x="5282031" y="3657600"/>
+            <a:off x="6287871" y="3657600"/>
             <a:ext cx="1627632" cy="329184"/>
           </a:xfrm>
           <a:prstGeom prst="roundRect">
@@ -5031,7 +5031,7 @@
         </p:nvSpPr>
         <p:spPr>
           <a:xfrm>
-            <a:off x="6845655" y="3730752"/>
+            <a:off x="7851495" y="3730752"/>
             <a:ext cx="45720" cy="182880"/>
           </a:xfrm>
           <a:prstGeom prst="rect">
@@ -5075,7 +5075,7 @@
         </p:nvSpPr>
         <p:spPr>
           <a:xfrm>
-            <a:off x="5282031" y="3657600"/>
+            <a:off x="6287871" y="3657600"/>
             <a:ext cx="1627632" cy="329184"/>
           </a:xfrm>
           <a:prstGeom prst="rect">
@@ -5111,7 +5111,7 @@
         </p:nvSpPr>
         <p:spPr>
           <a:xfrm>
-            <a:off x="3581247" y="3657600"/>
+            <a:off x="4587087" y="3657600"/>
             <a:ext cx="1627632" cy="329184"/>
           </a:xfrm>
           <a:prstGeom prst="roundRect">
@@ -5159,7 +5159,7 @@
         </p:nvSpPr>
         <p:spPr>
           <a:xfrm>
-            <a:off x="5144871" y="3730752"/>
+            <a:off x="6150711" y="3730752"/>
             <a:ext cx="45720" cy="182880"/>
           </a:xfrm>
           <a:prstGeom prst="rect">
@@ -5203,7 +5203,7 @@
         </p:nvSpPr>
         <p:spPr>
           <a:xfrm>
-            <a:off x="3581247" y="3657600"/>
+            <a:off x="4587087" y="3657600"/>
             <a:ext cx="1627632" cy="329184"/>
           </a:xfrm>
           <a:prstGeom prst="rect">
@@ -5239,7 +5239,7 @@
         </p:nvSpPr>
         <p:spPr>
           <a:xfrm>
-            <a:off x="6982815" y="4059936"/>
+            <a:off x="7988655" y="4059936"/>
             <a:ext cx="1627632" cy="329184"/>
           </a:xfrm>
           <a:prstGeom prst="roundRect">
@@ -5287,7 +5287,7 @@
         </p:nvSpPr>
         <p:spPr>
           <a:xfrm>
-            <a:off x="8546439" y="4133088"/>
+            <a:off x="9552279" y="4133088"/>
             <a:ext cx="45720" cy="182880"/>
           </a:xfrm>
           <a:prstGeom prst="rect">
@@ -5331,7 +5331,7 @@
         </p:nvSpPr>
         <p:spPr>
           <a:xfrm>
-            <a:off x="6982815" y="4059936"/>
+            <a:off x="7988655" y="4059936"/>
             <a:ext cx="1627632" cy="329184"/>
           </a:xfrm>
           <a:prstGeom prst="rect">
@@ -5367,7 +5367,7 @@
         </p:nvSpPr>
         <p:spPr>
           <a:xfrm>
-            <a:off x="5282031" y="4059936"/>
+            <a:off x="6287871" y="4059936"/>
             <a:ext cx="1627632" cy="329184"/>
           </a:xfrm>
           <a:prstGeom prst="roundRect">
@@ -5415,7 +5415,7 @@
         </p:nvSpPr>
         <p:spPr>
           <a:xfrm>
-            <a:off x="6845655" y="4133088"/>
+            <a:off x="7851495" y="4133088"/>
             <a:ext cx="45720" cy="182880"/>
           </a:xfrm>
           <a:prstGeom prst="rect">
@@ -5459,7 +5459,7 @@
         </p:nvSpPr>
         <p:spPr>
           <a:xfrm>
-            <a:off x="5282031" y="4059936"/>
+            <a:off x="6287871" y="4059936"/>
             <a:ext cx="1627632" cy="329184"/>
           </a:xfrm>
           <a:prstGeom prst="rect">
@@ -5495,7 +5495,7 @@
         </p:nvSpPr>
         <p:spPr>
           <a:xfrm>
-            <a:off x="3581247" y="4059936"/>
+            <a:off x="4587087" y="4059936"/>
             <a:ext cx="1627632" cy="329184"/>
           </a:xfrm>
           <a:prstGeom prst="roundRect">
@@ -5543,7 +5543,7 @@
         </p:nvSpPr>
         <p:spPr>
           <a:xfrm>
-            <a:off x="5144871" y="4133088"/>
+            <a:off x="6150711" y="4133088"/>
             <a:ext cx="45720" cy="182880"/>
           </a:xfrm>
           <a:prstGeom prst="rect">
@@ -5587,7 +5587,7 @@
         </p:nvSpPr>
         <p:spPr>
           <a:xfrm>
-            <a:off x="3581247" y="4059936"/>
+            <a:off x="4587087" y="4059936"/>
             <a:ext cx="1627632" cy="329184"/>
           </a:xfrm>
           <a:prstGeom prst="rect">
@@ -5623,7 +5623,7 @@
         </p:nvSpPr>
         <p:spPr>
           <a:xfrm>
-            <a:off x="6982815" y="4462272"/>
+            <a:off x="7988655" y="4462272"/>
             <a:ext cx="1627632" cy="329184"/>
           </a:xfrm>
           <a:prstGeom prst="roundRect">
@@ -5671,7 +5671,7 @@
         </p:nvSpPr>
         <p:spPr>
           <a:xfrm>
-            <a:off x="8546439" y="4535424"/>
+            <a:off x="9552279" y="4535424"/>
             <a:ext cx="45720" cy="182880"/>
           </a:xfrm>
           <a:prstGeom prst="rect">
@@ -5715,7 +5715,7 @@
         </p:nvSpPr>
         <p:spPr>
           <a:xfrm>
-            <a:off x="6982815" y="4462272"/>
+            <a:off x="7988655" y="4462272"/>
             <a:ext cx="1627632" cy="329184"/>
           </a:xfrm>
           <a:prstGeom prst="rect">
@@ -5751,7 +5751,7 @@
         </p:nvSpPr>
         <p:spPr>
           <a:xfrm>
-            <a:off x="5282031" y="4462272"/>
+            <a:off x="6287871" y="4462272"/>
             <a:ext cx="1627632" cy="329184"/>
           </a:xfrm>
           <a:prstGeom prst="roundRect">
@@ -5799,7 +5799,7 @@
         </p:nvSpPr>
         <p:spPr>
           <a:xfrm>
-            <a:off x="6845655" y="4535424"/>
+            <a:off x="7851495" y="4535424"/>
             <a:ext cx="45720" cy="182880"/>
           </a:xfrm>
           <a:prstGeom prst="rect">
@@ -5843,7 +5843,7 @@
         </p:nvSpPr>
         <p:spPr>
           <a:xfrm>
-            <a:off x="5282031" y="4462272"/>
+            <a:off x="6287871" y="4462272"/>
             <a:ext cx="1627632" cy="329184"/>
           </a:xfrm>
           <a:prstGeom prst="rect">
@@ -5879,7 +5879,7 @@
         </p:nvSpPr>
         <p:spPr>
           <a:xfrm>
-            <a:off x="3581247" y="4462272"/>
+            <a:off x="4587087" y="4462272"/>
             <a:ext cx="1627632" cy="329184"/>
           </a:xfrm>
           <a:prstGeom prst="roundRect">
@@ -5927,7 +5927,7 @@
         </p:nvSpPr>
         <p:spPr>
           <a:xfrm>
-            <a:off x="5144871" y="4535424"/>
+            <a:off x="6150711" y="4535424"/>
             <a:ext cx="45720" cy="182880"/>
           </a:xfrm>
           <a:prstGeom prst="rect">
@@ -5971,7 +5971,7 @@
         </p:nvSpPr>
         <p:spPr>
           <a:xfrm>
-            <a:off x="3581247" y="4462272"/>
+            <a:off x="4587087" y="4462272"/>
             <a:ext cx="1627632" cy="329184"/>
           </a:xfrm>
           <a:prstGeom prst="rect">
@@ -6007,7 +6007,7 @@
         </p:nvSpPr>
         <p:spPr>
           <a:xfrm>
-            <a:off x="6982815" y="4864608"/>
+            <a:off x="7988655" y="4864608"/>
             <a:ext cx="1627632" cy="329184"/>
           </a:xfrm>
           <a:prstGeom prst="roundRect">
@@ -6055,7 +6055,7 @@
         </p:nvSpPr>
         <p:spPr>
           <a:xfrm>
-            <a:off x="8546439" y="4937760"/>
+            <a:off x="9552279" y="4937760"/>
             <a:ext cx="45720" cy="182880"/>
           </a:xfrm>
           <a:prstGeom prst="rect">
@@ -6099,7 +6099,7 @@
         </p:nvSpPr>
         <p:spPr>
           <a:xfrm>
-            <a:off x="6982815" y="4864608"/>
+            <a:off x="7988655" y="4864608"/>
             <a:ext cx="1627632" cy="329184"/>
           </a:xfrm>
           <a:prstGeom prst="rect">
@@ -6135,7 +6135,7 @@
         </p:nvSpPr>
         <p:spPr>
           <a:xfrm>
-            <a:off x="5282031" y="4864608"/>
+            <a:off x="6287871" y="4864608"/>
             <a:ext cx="1627632" cy="329184"/>
           </a:xfrm>
           <a:prstGeom prst="roundRect">
@@ -6183,7 +6183,7 @@
         </p:nvSpPr>
         <p:spPr>
           <a:xfrm>
-            <a:off x="6845655" y="4937760"/>
+            <a:off x="7851495" y="4937760"/>
             <a:ext cx="45720" cy="182880"/>
           </a:xfrm>
           <a:prstGeom prst="rect">
@@ -6227,7 +6227,7 @@
         </p:nvSpPr>
         <p:spPr>
           <a:xfrm>
-            <a:off x="5282031" y="4864608"/>
+            <a:off x="6287871" y="4864608"/>
             <a:ext cx="1627632" cy="329184"/>
           </a:xfrm>
           <a:prstGeom prst="rect">
@@ -6263,7 +6263,7 @@
         </p:nvSpPr>
         <p:spPr>
           <a:xfrm>
-            <a:off x="3581247" y="4864608"/>
+            <a:off x="4587087" y="4864608"/>
             <a:ext cx="1627632" cy="329184"/>
           </a:xfrm>
           <a:prstGeom prst="roundRect">
@@ -6311,7 +6311,7 @@
         </p:nvSpPr>
         <p:spPr>
           <a:xfrm>
-            <a:off x="5144871" y="4937760"/>
+            <a:off x="6150711" y="4937760"/>
             <a:ext cx="45720" cy="182880"/>
           </a:xfrm>
           <a:prstGeom prst="rect">
@@ -6355,7 +6355,7 @@
         </p:nvSpPr>
         <p:spPr>
           <a:xfrm>
-            <a:off x="3581247" y="4864608"/>
+            <a:off x="4587087" y="4864608"/>
             <a:ext cx="1627632" cy="329184"/>
           </a:xfrm>
           <a:prstGeom prst="rect">
@@ -6391,7 +6391,7 @@
         </p:nvSpPr>
         <p:spPr>
           <a:xfrm>
-            <a:off x="6982815" y="5266944"/>
+            <a:off x="7988655" y="5266944"/>
             <a:ext cx="1627632" cy="329184"/>
           </a:xfrm>
           <a:prstGeom prst="roundRect">
@@ -6439,7 +6439,7 @@
         </p:nvSpPr>
         <p:spPr>
           <a:xfrm>
-            <a:off x="8546439" y="5340096"/>
+            <a:off x="9552279" y="5340096"/>
             <a:ext cx="45720" cy="182880"/>
           </a:xfrm>
           <a:prstGeom prst="rect">
@@ -6483,7 +6483,7 @@
         </p:nvSpPr>
         <p:spPr>
           <a:xfrm>
-            <a:off x="6982815" y="5266944"/>
+            <a:off x="7988655" y="5266944"/>
             <a:ext cx="1627632" cy="329184"/>
           </a:xfrm>
           <a:prstGeom prst="rect">
@@ -6519,7 +6519,7 @@
         </p:nvSpPr>
         <p:spPr>
           <a:xfrm>
-            <a:off x="5282031" y="5266944"/>
+            <a:off x="6287871" y="5266944"/>
             <a:ext cx="1627632" cy="329184"/>
           </a:xfrm>
           <a:prstGeom prst="roundRect">
@@ -6567,7 +6567,7 @@
         </p:nvSpPr>
         <p:spPr>
           <a:xfrm>
-            <a:off x="6845655" y="5340096"/>
+            <a:off x="7851495" y="5340096"/>
             <a:ext cx="45720" cy="182880"/>
           </a:xfrm>
           <a:prstGeom prst="rect">
@@ -6611,7 +6611,7 @@
         </p:nvSpPr>
         <p:spPr>
           <a:xfrm>
-            <a:off x="5282031" y="5266944"/>
+            <a:off x="6287871" y="5266944"/>
             <a:ext cx="1627632" cy="329184"/>
           </a:xfrm>
           <a:prstGeom prst="rect">
@@ -6647,7 +6647,7 @@
         </p:nvSpPr>
         <p:spPr>
           <a:xfrm>
-            <a:off x="3581247" y="5266944"/>
+            <a:off x="4587087" y="5266944"/>
             <a:ext cx="1627632" cy="329184"/>
           </a:xfrm>
           <a:prstGeom prst="roundRect">
@@ -6695,7 +6695,7 @@
         </p:nvSpPr>
         <p:spPr>
           <a:xfrm>
-            <a:off x="5144871" y="5340096"/>
+            <a:off x="6150711" y="5340096"/>
             <a:ext cx="45720" cy="182880"/>
           </a:xfrm>
           <a:prstGeom prst="rect">
@@ -6739,7 +6739,7 @@
         </p:nvSpPr>
         <p:spPr>
           <a:xfrm>
-            <a:off x="3581247" y="5266944"/>
+            <a:off x="4587087" y="5266944"/>
             <a:ext cx="1627632" cy="329184"/>
           </a:xfrm>
           <a:prstGeom prst="rect">
@@ -6767,9 +6767,1115 @@
           </a:p>
         </p:txBody>
       </p:sp>
+      <p:sp>
+        <p:nvSpPr>
+          <p:cNvPr id="90" name="Rounded Rectangle 89"/>
+          <p:cNvSpPr/>
+          <p:nvPr/>
+        </p:nvSpPr>
+        <p:spPr>
+          <a:xfrm>
+            <a:off x="2483967" y="2679192"/>
+            <a:ext cx="1737360" cy="3447288"/>
+          </a:xfrm>
+          <a:prstGeom prst="roundRect">
+            <a:avLst>
+              <a:gd name="adj" fmla="val 4000"/>
+            </a:avLst>
+          </a:prstGeom>
+          <a:noFill/>
+          <a:ln w="15875">
+            <a:solidFill>
+              <a:srgbClr val="C5CDDD"/>
+            </a:solidFill>
+          </a:ln>
+          <a:effectLst/>
+        </p:spPr>
+        <p:style>
+          <a:lnRef idx="1">
+            <a:schemeClr val="accent1"/>
+          </a:lnRef>
+          <a:fillRef idx="3">
+            <a:schemeClr val="accent1"/>
+          </a:fillRef>
+          <a:effectRef idx="2">
+            <a:schemeClr val="accent1"/>
+          </a:effectRef>
+          <a:fontRef idx="minor">
+            <a:schemeClr val="lt1"/>
+          </a:fontRef>
+        </p:style>
+        <p:txBody>
+          <a:bodyPr rtlCol="0" anchor="ctr"/>
+          <a:lstStyle/>
+          <a:p>
+            <a:pPr algn="ctr"/>
+          </a:p>
+        </p:txBody>
+      </p:sp>
+      <p:sp>
+        <p:nvSpPr>
+          <p:cNvPr id="91" name="Rounded Rectangle 90"/>
+          <p:cNvSpPr/>
+          <p:nvPr/>
+        </p:nvSpPr>
+        <p:spPr>
+          <a:xfrm>
+            <a:off x="2575407" y="2395728"/>
+            <a:ext cx="1554480" cy="566928"/>
+          </a:xfrm>
+          <a:prstGeom prst="roundRect">
+            <a:avLst>
+              <a:gd name="adj" fmla="val 18000"/>
+            </a:avLst>
+          </a:prstGeom>
+          <a:solidFill>
+            <a:srgbClr val="FFFFFF"/>
+          </a:solidFill>
+          <a:ln w="15875">
+            <a:solidFill>
+              <a:srgbClr val="C5CDDD"/>
+            </a:solidFill>
+          </a:ln>
+          <a:effectLst/>
+        </p:spPr>
+        <p:style>
+          <a:lnRef idx="1">
+            <a:schemeClr val="accent1"/>
+          </a:lnRef>
+          <a:fillRef idx="3">
+            <a:schemeClr val="accent1"/>
+          </a:fillRef>
+          <a:effectRef idx="2">
+            <a:schemeClr val="accent1"/>
+          </a:effectRef>
+          <a:fontRef idx="minor">
+            <a:schemeClr val="lt1"/>
+          </a:fontRef>
+        </p:style>
+        <p:txBody>
+          <a:bodyPr rtlCol="0" anchor="ctr"/>
+          <a:lstStyle/>
+          <a:p>
+            <a:pPr algn="ctr"/>
+          </a:p>
+        </p:txBody>
+      </p:sp>
+      <p:sp>
+        <p:nvSpPr>
+          <p:cNvPr id="92" name="Rectangle 91"/>
+          <p:cNvSpPr/>
+          <p:nvPr/>
+        </p:nvSpPr>
+        <p:spPr>
+          <a:xfrm>
+            <a:off x="4065879" y="2468880"/>
+            <a:ext cx="45720" cy="420624"/>
+          </a:xfrm>
+          <a:prstGeom prst="rect">
+            <a:avLst/>
+          </a:prstGeom>
+          <a:solidFill>
+            <a:srgbClr val="F0C000"/>
+          </a:solidFill>
+          <a:ln>
+            <a:noFill/>
+          </a:ln>
+          <a:effectLst/>
+        </p:spPr>
+        <p:style>
+          <a:lnRef idx="1">
+            <a:schemeClr val="accent1"/>
+          </a:lnRef>
+          <a:fillRef idx="3">
+            <a:schemeClr val="accent1"/>
+          </a:fillRef>
+          <a:effectRef idx="2">
+            <a:schemeClr val="accent1"/>
+          </a:effectRef>
+          <a:fontRef idx="minor">
+            <a:schemeClr val="lt1"/>
+          </a:fontRef>
+        </p:style>
+        <p:txBody>
+          <a:bodyPr rtlCol="0" anchor="ctr"/>
+          <a:lstStyle/>
+          <a:p>
+            <a:pPr algn="ctr"/>
+          </a:p>
+        </p:txBody>
+      </p:sp>
+      <p:sp>
+        <p:nvSpPr>
+          <p:cNvPr id="93" name="TextBox 92"/>
+          <p:cNvSpPr txBox="1"/>
+          <p:nvPr/>
+        </p:nvSpPr>
+        <p:spPr>
+          <a:xfrm>
+            <a:off x="2575407" y="2450592"/>
+            <a:ext cx="1554480" cy="294802"/>
+          </a:xfrm>
+          <a:prstGeom prst="rect">
+            <a:avLst/>
+          </a:prstGeom>
+          <a:noFill/>
+        </p:spPr>
+        <p:txBody>
+          <a:bodyPr wrap="square" anchor="b" lIns="36576" rIns="36576" tIns="0" bIns="0">
+            <a:spAutoFit/>
+          </a:bodyPr>
+          <a:lstStyle/>
+          <a:p>
+            <a:pPr algn="ctr" rtl="1"/>
+            <a:r>
+              <a:rPr sz="1200" b="1">
+                <a:solidFill>
+                  <a:srgbClr val="1A2233"/>
+                </a:solidFill>
+                <a:latin typeface="Heebo"/>
+                <a:cs typeface="Heebo"/>
+              </a:rPr>
+              <a:t>יהונתן יחזקאל</a:t>
+            </a:r>
+          </a:p>
+        </p:txBody>
+      </p:sp>
+      <p:sp>
+        <p:nvSpPr>
+          <p:cNvPr id="94" name="TextBox 93"/>
+          <p:cNvSpPr txBox="1"/>
+          <p:nvPr/>
+        </p:nvSpPr>
+        <p:spPr>
+          <a:xfrm>
+            <a:off x="2575407" y="2707538"/>
+            <a:ext cx="1554480" cy="226771"/>
+          </a:xfrm>
+          <a:prstGeom prst="rect">
+            <a:avLst/>
+          </a:prstGeom>
+          <a:noFill/>
+        </p:spPr>
+        <p:txBody>
+          <a:bodyPr wrap="square" anchor="t" lIns="36576" rIns="36576" tIns="0" bIns="0">
+            <a:spAutoFit/>
+          </a:bodyPr>
+          <a:lstStyle/>
+          <a:p>
+            <a:pPr algn="ctr" rtl="1"/>
+            <a:r>
+              <a:rPr sz="900" b="0">
+                <a:solidFill>
+                  <a:srgbClr val="8A94A8"/>
+                </a:solidFill>
+                <a:latin typeface="Heebo"/>
+                <a:cs typeface="Heebo"/>
+              </a:rPr>
+              <a:t>ראש צוות · צוות אקטיביסטים</a:t>
+            </a:r>
+          </a:p>
+        </p:txBody>
+      </p:sp>
+      <p:sp>
+        <p:nvSpPr>
+          <p:cNvPr id="95" name="Rounded Rectangle 94"/>
+          <p:cNvSpPr/>
+          <p:nvPr/>
+        </p:nvSpPr>
+        <p:spPr>
+          <a:xfrm>
+            <a:off x="2575407" y="3255264"/>
+            <a:ext cx="1554480" cy="329184"/>
+          </a:xfrm>
+          <a:prstGeom prst="roundRect">
+            <a:avLst>
+              <a:gd name="adj" fmla="val 18000"/>
+            </a:avLst>
+          </a:prstGeom>
+          <a:solidFill>
+            <a:srgbClr val="FFFFFF"/>
+          </a:solidFill>
+          <a:ln w="15875">
+            <a:solidFill>
+              <a:srgbClr val="C5CDDD"/>
+            </a:solidFill>
+          </a:ln>
+          <a:effectLst/>
+        </p:spPr>
+        <p:style>
+          <a:lnRef idx="1">
+            <a:schemeClr val="accent1"/>
+          </a:lnRef>
+          <a:fillRef idx="3">
+            <a:schemeClr val="accent1"/>
+          </a:fillRef>
+          <a:effectRef idx="2">
+            <a:schemeClr val="accent1"/>
+          </a:effectRef>
+          <a:fontRef idx="minor">
+            <a:schemeClr val="lt1"/>
+          </a:fontRef>
+        </p:style>
+        <p:txBody>
+          <a:bodyPr rtlCol="0" anchor="ctr"/>
+          <a:lstStyle/>
+          <a:p>
+            <a:pPr algn="ctr"/>
+          </a:p>
+        </p:txBody>
+      </p:sp>
+      <p:sp>
+        <p:nvSpPr>
+          <p:cNvPr id="96" name="Rectangle 95"/>
+          <p:cNvSpPr/>
+          <p:nvPr/>
+        </p:nvSpPr>
+        <p:spPr>
+          <a:xfrm>
+            <a:off x="4065879" y="3328416"/>
+            <a:ext cx="45720" cy="182880"/>
+          </a:xfrm>
+          <a:prstGeom prst="rect">
+            <a:avLst/>
+          </a:prstGeom>
+          <a:solidFill>
+            <a:srgbClr val="F0C000"/>
+          </a:solidFill>
+          <a:ln>
+            <a:noFill/>
+          </a:ln>
+          <a:effectLst/>
+        </p:spPr>
+        <p:style>
+          <a:lnRef idx="1">
+            <a:schemeClr val="accent1"/>
+          </a:lnRef>
+          <a:fillRef idx="3">
+            <a:schemeClr val="accent1"/>
+          </a:fillRef>
+          <a:effectRef idx="2">
+            <a:schemeClr val="accent1"/>
+          </a:effectRef>
+          <a:fontRef idx="minor">
+            <a:schemeClr val="lt1"/>
+          </a:fontRef>
+        </p:style>
+        <p:txBody>
+          <a:bodyPr rtlCol="0" anchor="ctr"/>
+          <a:lstStyle/>
+          <a:p>
+            <a:pPr algn="ctr"/>
+          </a:p>
+        </p:txBody>
+      </p:sp>
+      <p:sp>
+        <p:nvSpPr>
+          <p:cNvPr id="97" name="TextBox 96"/>
+          <p:cNvSpPr txBox="1"/>
+          <p:nvPr/>
+        </p:nvSpPr>
+        <p:spPr>
+          <a:xfrm>
+            <a:off x="2575407" y="3255264"/>
+            <a:ext cx="1554480" cy="329184"/>
+          </a:xfrm>
+          <a:prstGeom prst="rect">
+            <a:avLst/>
+          </a:prstGeom>
+          <a:noFill/>
+        </p:spPr>
+        <p:txBody>
+          <a:bodyPr wrap="square" anchor="ctr" lIns="36576" rIns="36576" tIns="0" bIns="0">
+            <a:spAutoFit/>
+          </a:bodyPr>
+          <a:lstStyle/>
+          <a:p>
+            <a:pPr algn="ctr" rtl="1"/>
+            <a:r>
+              <a:rPr sz="1100" b="1">
+                <a:solidFill>
+                  <a:srgbClr val="1A2233"/>
+                </a:solidFill>
+                <a:latin typeface="Heebo"/>
+                <a:cs typeface="Heebo"/>
+              </a:rPr>
+              <a:t>רוני מרטין</a:t>
+            </a:r>
+          </a:p>
+        </p:txBody>
+      </p:sp>
+      <p:sp>
+        <p:nvSpPr>
+          <p:cNvPr id="98" name="Rounded Rectangle 97"/>
+          <p:cNvSpPr/>
+          <p:nvPr/>
+        </p:nvSpPr>
+        <p:spPr>
+          <a:xfrm>
+            <a:off x="2575407" y="3657600"/>
+            <a:ext cx="1554480" cy="329184"/>
+          </a:xfrm>
+          <a:prstGeom prst="roundRect">
+            <a:avLst>
+              <a:gd name="adj" fmla="val 18000"/>
+            </a:avLst>
+          </a:prstGeom>
+          <a:solidFill>
+            <a:srgbClr val="FFFFFF"/>
+          </a:solidFill>
+          <a:ln w="15875">
+            <a:solidFill>
+              <a:srgbClr val="C5CDDD"/>
+            </a:solidFill>
+          </a:ln>
+          <a:effectLst/>
+        </p:spPr>
+        <p:style>
+          <a:lnRef idx="1">
+            <a:schemeClr val="accent1"/>
+          </a:lnRef>
+          <a:fillRef idx="3">
+            <a:schemeClr val="accent1"/>
+          </a:fillRef>
+          <a:effectRef idx="2">
+            <a:schemeClr val="accent1"/>
+          </a:effectRef>
+          <a:fontRef idx="minor">
+            <a:schemeClr val="lt1"/>
+          </a:fontRef>
+        </p:style>
+        <p:txBody>
+          <a:bodyPr rtlCol="0" anchor="ctr"/>
+          <a:lstStyle/>
+          <a:p>
+            <a:pPr algn="ctr"/>
+          </a:p>
+        </p:txBody>
+      </p:sp>
+      <p:sp>
+        <p:nvSpPr>
+          <p:cNvPr id="99" name="Rectangle 98"/>
+          <p:cNvSpPr/>
+          <p:nvPr/>
+        </p:nvSpPr>
+        <p:spPr>
+          <a:xfrm>
+            <a:off x="4065879" y="3730752"/>
+            <a:ext cx="45720" cy="182880"/>
+          </a:xfrm>
+          <a:prstGeom prst="rect">
+            <a:avLst/>
+          </a:prstGeom>
+          <a:solidFill>
+            <a:srgbClr val="F0C000"/>
+          </a:solidFill>
+          <a:ln>
+            <a:noFill/>
+          </a:ln>
+          <a:effectLst/>
+        </p:spPr>
+        <p:style>
+          <a:lnRef idx="1">
+            <a:schemeClr val="accent1"/>
+          </a:lnRef>
+          <a:fillRef idx="3">
+            <a:schemeClr val="accent1"/>
+          </a:fillRef>
+          <a:effectRef idx="2">
+            <a:schemeClr val="accent1"/>
+          </a:effectRef>
+          <a:fontRef idx="minor">
+            <a:schemeClr val="lt1"/>
+          </a:fontRef>
+        </p:style>
+        <p:txBody>
+          <a:bodyPr rtlCol="0" anchor="ctr"/>
+          <a:lstStyle/>
+          <a:p>
+            <a:pPr algn="ctr"/>
+          </a:p>
+        </p:txBody>
+      </p:sp>
+      <p:sp>
+        <p:nvSpPr>
+          <p:cNvPr id="100" name="TextBox 99"/>
+          <p:cNvSpPr txBox="1"/>
+          <p:nvPr/>
+        </p:nvSpPr>
+        <p:spPr>
+          <a:xfrm>
+            <a:off x="2575407" y="3657600"/>
+            <a:ext cx="1554480" cy="329184"/>
+          </a:xfrm>
+          <a:prstGeom prst="rect">
+            <a:avLst/>
+          </a:prstGeom>
+          <a:noFill/>
+        </p:spPr>
+        <p:txBody>
+          <a:bodyPr wrap="square" anchor="ctr" lIns="36576" rIns="36576" tIns="0" bIns="0">
+            <a:spAutoFit/>
+          </a:bodyPr>
+          <a:lstStyle/>
+          <a:p>
+            <a:pPr algn="ctr" rtl="1"/>
+            <a:r>
+              <a:rPr sz="1100" b="1">
+                <a:solidFill>
+                  <a:srgbClr val="1A2233"/>
+                </a:solidFill>
+                <a:latin typeface="Heebo"/>
+                <a:cs typeface="Heebo"/>
+              </a:rPr>
+              <a:t>בנימין שיפרין</a:t>
+            </a:r>
+          </a:p>
+        </p:txBody>
+      </p:sp>
+      <p:sp>
+        <p:nvSpPr>
+          <p:cNvPr id="101" name="Rounded Rectangle 100"/>
+          <p:cNvSpPr/>
+          <p:nvPr/>
+        </p:nvSpPr>
+        <p:spPr>
+          <a:xfrm>
+            <a:off x="2575407" y="4059936"/>
+            <a:ext cx="1554480" cy="329184"/>
+          </a:xfrm>
+          <a:prstGeom prst="roundRect">
+            <a:avLst>
+              <a:gd name="adj" fmla="val 18000"/>
+            </a:avLst>
+          </a:prstGeom>
+          <a:solidFill>
+            <a:srgbClr val="FFFFFF"/>
+          </a:solidFill>
+          <a:ln w="15875">
+            <a:solidFill>
+              <a:srgbClr val="C5CDDD"/>
+            </a:solidFill>
+          </a:ln>
+          <a:effectLst/>
+        </p:spPr>
+        <p:style>
+          <a:lnRef idx="1">
+            <a:schemeClr val="accent1"/>
+          </a:lnRef>
+          <a:fillRef idx="3">
+            <a:schemeClr val="accent1"/>
+          </a:fillRef>
+          <a:effectRef idx="2">
+            <a:schemeClr val="accent1"/>
+          </a:effectRef>
+          <a:fontRef idx="minor">
+            <a:schemeClr val="lt1"/>
+          </a:fontRef>
+        </p:style>
+        <p:txBody>
+          <a:bodyPr rtlCol="0" anchor="ctr"/>
+          <a:lstStyle/>
+          <a:p>
+            <a:pPr algn="ctr"/>
+          </a:p>
+        </p:txBody>
+      </p:sp>
+      <p:sp>
+        <p:nvSpPr>
+          <p:cNvPr id="102" name="Rectangle 101"/>
+          <p:cNvSpPr/>
+          <p:nvPr/>
+        </p:nvSpPr>
+        <p:spPr>
+          <a:xfrm>
+            <a:off x="4065879" y="4133088"/>
+            <a:ext cx="45720" cy="182880"/>
+          </a:xfrm>
+          <a:prstGeom prst="rect">
+            <a:avLst/>
+          </a:prstGeom>
+          <a:solidFill>
+            <a:srgbClr val="F0C000"/>
+          </a:solidFill>
+          <a:ln>
+            <a:noFill/>
+          </a:ln>
+          <a:effectLst/>
+        </p:spPr>
+        <p:style>
+          <a:lnRef idx="1">
+            <a:schemeClr val="accent1"/>
+          </a:lnRef>
+          <a:fillRef idx="3">
+            <a:schemeClr val="accent1"/>
+          </a:fillRef>
+          <a:effectRef idx="2">
+            <a:schemeClr val="accent1"/>
+          </a:effectRef>
+          <a:fontRef idx="minor">
+            <a:schemeClr val="lt1"/>
+          </a:fontRef>
+        </p:style>
+        <p:txBody>
+          <a:bodyPr rtlCol="0" anchor="ctr"/>
+          <a:lstStyle/>
+          <a:p>
+            <a:pPr algn="ctr"/>
+          </a:p>
+        </p:txBody>
+      </p:sp>
+      <p:sp>
+        <p:nvSpPr>
+          <p:cNvPr id="103" name="TextBox 102"/>
+          <p:cNvSpPr txBox="1"/>
+          <p:nvPr/>
+        </p:nvSpPr>
+        <p:spPr>
+          <a:xfrm>
+            <a:off x="2575407" y="4059936"/>
+            <a:ext cx="1554480" cy="329184"/>
+          </a:xfrm>
+          <a:prstGeom prst="rect">
+            <a:avLst/>
+          </a:prstGeom>
+          <a:noFill/>
+        </p:spPr>
+        <p:txBody>
+          <a:bodyPr wrap="square" anchor="ctr" lIns="36576" rIns="36576" tIns="0" bIns="0">
+            <a:spAutoFit/>
+          </a:bodyPr>
+          <a:lstStyle/>
+          <a:p>
+            <a:pPr algn="ctr" rtl="1"/>
+            <a:r>
+              <a:rPr sz="1100" b="1">
+                <a:solidFill>
+                  <a:srgbClr val="1A2233"/>
+                </a:solidFill>
+                <a:latin typeface="Heebo"/>
+                <a:cs typeface="Heebo"/>
+              </a:rPr>
+              <a:t>משה הלר</a:t>
+            </a:r>
+          </a:p>
+        </p:txBody>
+      </p:sp>
+      <p:sp>
+        <p:nvSpPr>
+          <p:cNvPr id="104" name="Rounded Rectangle 103"/>
+          <p:cNvSpPr/>
+          <p:nvPr/>
+        </p:nvSpPr>
+        <p:spPr>
+          <a:xfrm>
+            <a:off x="2575407" y="4462272"/>
+            <a:ext cx="1554480" cy="329184"/>
+          </a:xfrm>
+          <a:prstGeom prst="roundRect">
+            <a:avLst>
+              <a:gd name="adj" fmla="val 18000"/>
+            </a:avLst>
+          </a:prstGeom>
+          <a:solidFill>
+            <a:srgbClr val="FFFFFF"/>
+          </a:solidFill>
+          <a:ln w="15875">
+            <a:solidFill>
+              <a:srgbClr val="C5CDDD"/>
+            </a:solidFill>
+          </a:ln>
+          <a:effectLst/>
+        </p:spPr>
+        <p:style>
+          <a:lnRef idx="1">
+            <a:schemeClr val="accent1"/>
+          </a:lnRef>
+          <a:fillRef idx="3">
+            <a:schemeClr val="accent1"/>
+          </a:fillRef>
+          <a:effectRef idx="2">
+            <a:schemeClr val="accent1"/>
+          </a:effectRef>
+          <a:fontRef idx="minor">
+            <a:schemeClr val="lt1"/>
+          </a:fontRef>
+        </p:style>
+        <p:txBody>
+          <a:bodyPr rtlCol="0" anchor="ctr"/>
+          <a:lstStyle/>
+          <a:p>
+            <a:pPr algn="ctr"/>
+          </a:p>
+        </p:txBody>
+      </p:sp>
+      <p:sp>
+        <p:nvSpPr>
+          <p:cNvPr id="105" name="Rectangle 104"/>
+          <p:cNvSpPr/>
+          <p:nvPr/>
+        </p:nvSpPr>
+        <p:spPr>
+          <a:xfrm>
+            <a:off x="4065879" y="4535424"/>
+            <a:ext cx="45720" cy="182880"/>
+          </a:xfrm>
+          <a:prstGeom prst="rect">
+            <a:avLst/>
+          </a:prstGeom>
+          <a:solidFill>
+            <a:srgbClr val="F0C000"/>
+          </a:solidFill>
+          <a:ln>
+            <a:noFill/>
+          </a:ln>
+          <a:effectLst/>
+        </p:spPr>
+        <p:style>
+          <a:lnRef idx="1">
+            <a:schemeClr val="accent1"/>
+          </a:lnRef>
+          <a:fillRef idx="3">
+            <a:schemeClr val="accent1"/>
+          </a:fillRef>
+          <a:effectRef idx="2">
+            <a:schemeClr val="accent1"/>
+          </a:effectRef>
+          <a:fontRef idx="minor">
+            <a:schemeClr val="lt1"/>
+          </a:fontRef>
+        </p:style>
+        <p:txBody>
+          <a:bodyPr rtlCol="0" anchor="ctr"/>
+          <a:lstStyle/>
+          <a:p>
+            <a:pPr algn="ctr"/>
+          </a:p>
+        </p:txBody>
+      </p:sp>
+      <p:sp>
+        <p:nvSpPr>
+          <p:cNvPr id="106" name="TextBox 105"/>
+          <p:cNvSpPr txBox="1"/>
+          <p:nvPr/>
+        </p:nvSpPr>
+        <p:spPr>
+          <a:xfrm>
+            <a:off x="2575407" y="4462272"/>
+            <a:ext cx="1554480" cy="329184"/>
+          </a:xfrm>
+          <a:prstGeom prst="rect">
+            <a:avLst/>
+          </a:prstGeom>
+          <a:noFill/>
+        </p:spPr>
+        <p:txBody>
+          <a:bodyPr wrap="square" anchor="ctr" lIns="36576" rIns="36576" tIns="0" bIns="0">
+            <a:spAutoFit/>
+          </a:bodyPr>
+          <a:lstStyle/>
+          <a:p>
+            <a:pPr algn="ctr" rtl="1"/>
+            <a:r>
+              <a:rPr sz="1100" b="1">
+                <a:solidFill>
+                  <a:srgbClr val="1A2233"/>
+                </a:solidFill>
+                <a:latin typeface="Heebo"/>
+                <a:cs typeface="Heebo"/>
+              </a:rPr>
+              <a:t>יהודה שוורצמן</a:t>
+            </a:r>
+          </a:p>
+        </p:txBody>
+      </p:sp>
+      <p:sp>
+        <p:nvSpPr>
+          <p:cNvPr id="107" name="Rounded Rectangle 106"/>
+          <p:cNvSpPr/>
+          <p:nvPr/>
+        </p:nvSpPr>
+        <p:spPr>
+          <a:xfrm>
+            <a:off x="2575407" y="4864608"/>
+            <a:ext cx="1554480" cy="329184"/>
+          </a:xfrm>
+          <a:prstGeom prst="roundRect">
+            <a:avLst>
+              <a:gd name="adj" fmla="val 18000"/>
+            </a:avLst>
+          </a:prstGeom>
+          <a:solidFill>
+            <a:srgbClr val="FFFFFF"/>
+          </a:solidFill>
+          <a:ln w="15875">
+            <a:solidFill>
+              <a:srgbClr val="C5CDDD"/>
+            </a:solidFill>
+          </a:ln>
+          <a:effectLst/>
+        </p:spPr>
+        <p:style>
+          <a:lnRef idx="1">
+            <a:schemeClr val="accent1"/>
+          </a:lnRef>
+          <a:fillRef idx="3">
+            <a:schemeClr val="accent1"/>
+          </a:fillRef>
+          <a:effectRef idx="2">
+            <a:schemeClr val="accent1"/>
+          </a:effectRef>
+          <a:fontRef idx="minor">
+            <a:schemeClr val="lt1"/>
+          </a:fontRef>
+        </p:style>
+        <p:txBody>
+          <a:bodyPr rtlCol="0" anchor="ctr"/>
+          <a:lstStyle/>
+          <a:p>
+            <a:pPr algn="ctr"/>
+          </a:p>
+        </p:txBody>
+      </p:sp>
+      <p:sp>
+        <p:nvSpPr>
+          <p:cNvPr id="108" name="Rectangle 107"/>
+          <p:cNvSpPr/>
+          <p:nvPr/>
+        </p:nvSpPr>
+        <p:spPr>
+          <a:xfrm>
+            <a:off x="4065879" y="4937760"/>
+            <a:ext cx="45720" cy="182880"/>
+          </a:xfrm>
+          <a:prstGeom prst="rect">
+            <a:avLst/>
+          </a:prstGeom>
+          <a:solidFill>
+            <a:srgbClr val="F0C000"/>
+          </a:solidFill>
+          <a:ln>
+            <a:noFill/>
+          </a:ln>
+          <a:effectLst/>
+        </p:spPr>
+        <p:style>
+          <a:lnRef idx="1">
+            <a:schemeClr val="accent1"/>
+          </a:lnRef>
+          <a:fillRef idx="3">
+            <a:schemeClr val="accent1"/>
+          </a:fillRef>
+          <a:effectRef idx="2">
+            <a:schemeClr val="accent1"/>
+          </a:effectRef>
+          <a:fontRef idx="minor">
+            <a:schemeClr val="lt1"/>
+          </a:fontRef>
+        </p:style>
+        <p:txBody>
+          <a:bodyPr rtlCol="0" anchor="ctr"/>
+          <a:lstStyle/>
+          <a:p>
+            <a:pPr algn="ctr"/>
+          </a:p>
+        </p:txBody>
+      </p:sp>
+      <p:sp>
+        <p:nvSpPr>
+          <p:cNvPr id="109" name="TextBox 108"/>
+          <p:cNvSpPr txBox="1"/>
+          <p:nvPr/>
+        </p:nvSpPr>
+        <p:spPr>
+          <a:xfrm>
+            <a:off x="2575407" y="4864608"/>
+            <a:ext cx="1554480" cy="329184"/>
+          </a:xfrm>
+          <a:prstGeom prst="rect">
+            <a:avLst/>
+          </a:prstGeom>
+          <a:noFill/>
+        </p:spPr>
+        <p:txBody>
+          <a:bodyPr wrap="square" anchor="ctr" lIns="36576" rIns="36576" tIns="0" bIns="0">
+            <a:spAutoFit/>
+          </a:bodyPr>
+          <a:lstStyle/>
+          <a:p>
+            <a:pPr algn="ctr" rtl="1"/>
+            <a:r>
+              <a:rPr sz="1100" b="1">
+                <a:solidFill>
+                  <a:srgbClr val="1A2233"/>
+                </a:solidFill>
+                <a:latin typeface="Heebo"/>
+                <a:cs typeface="Heebo"/>
+              </a:rPr>
+              <a:t>צופיה צדוק</a:t>
+            </a:r>
+          </a:p>
+        </p:txBody>
+      </p:sp>
+      <p:sp>
+        <p:nvSpPr>
+          <p:cNvPr id="110" name="Rounded Rectangle 109"/>
+          <p:cNvSpPr/>
+          <p:nvPr/>
+        </p:nvSpPr>
+        <p:spPr>
+          <a:xfrm>
+            <a:off x="2575407" y="5266944"/>
+            <a:ext cx="1554480" cy="329184"/>
+          </a:xfrm>
+          <a:prstGeom prst="roundRect">
+            <a:avLst>
+              <a:gd name="adj" fmla="val 18000"/>
+            </a:avLst>
+          </a:prstGeom>
+          <a:solidFill>
+            <a:srgbClr val="FFFFFF"/>
+          </a:solidFill>
+          <a:ln w="15875">
+            <a:solidFill>
+              <a:srgbClr val="C5CDDD"/>
+            </a:solidFill>
+          </a:ln>
+          <a:effectLst/>
+        </p:spPr>
+        <p:style>
+          <a:lnRef idx="1">
+            <a:schemeClr val="accent1"/>
+          </a:lnRef>
+          <a:fillRef idx="3">
+            <a:schemeClr val="accent1"/>
+          </a:fillRef>
+          <a:effectRef idx="2">
+            <a:schemeClr val="accent1"/>
+          </a:effectRef>
+          <a:fontRef idx="minor">
+            <a:schemeClr val="lt1"/>
+          </a:fontRef>
+        </p:style>
+        <p:txBody>
+          <a:bodyPr rtlCol="0" anchor="ctr"/>
+          <a:lstStyle/>
+          <a:p>
+            <a:pPr algn="ctr"/>
+          </a:p>
+        </p:txBody>
+      </p:sp>
+      <p:sp>
+        <p:nvSpPr>
+          <p:cNvPr id="111" name="Rectangle 110"/>
+          <p:cNvSpPr/>
+          <p:nvPr/>
+        </p:nvSpPr>
+        <p:spPr>
+          <a:xfrm>
+            <a:off x="4065879" y="5340096"/>
+            <a:ext cx="45720" cy="182880"/>
+          </a:xfrm>
+          <a:prstGeom prst="rect">
+            <a:avLst/>
+          </a:prstGeom>
+          <a:solidFill>
+            <a:srgbClr val="F0C000"/>
+          </a:solidFill>
+          <a:ln>
+            <a:noFill/>
+          </a:ln>
+          <a:effectLst/>
+        </p:spPr>
+        <p:style>
+          <a:lnRef idx="1">
+            <a:schemeClr val="accent1"/>
+          </a:lnRef>
+          <a:fillRef idx="3">
+            <a:schemeClr val="accent1"/>
+          </a:fillRef>
+          <a:effectRef idx="2">
+            <a:schemeClr val="accent1"/>
+          </a:effectRef>
+          <a:fontRef idx="minor">
+            <a:schemeClr val="lt1"/>
+          </a:fontRef>
+        </p:style>
+        <p:txBody>
+          <a:bodyPr rtlCol="0" anchor="ctr"/>
+          <a:lstStyle/>
+          <a:p>
+            <a:pPr algn="ctr"/>
+          </a:p>
+        </p:txBody>
+      </p:sp>
+      <p:sp>
+        <p:nvSpPr>
+          <p:cNvPr id="112" name="TextBox 111"/>
+          <p:cNvSpPr txBox="1"/>
+          <p:nvPr/>
+        </p:nvSpPr>
+        <p:spPr>
+          <a:xfrm>
+            <a:off x="2575407" y="5266944"/>
+            <a:ext cx="1554480" cy="329184"/>
+          </a:xfrm>
+          <a:prstGeom prst="rect">
+            <a:avLst/>
+          </a:prstGeom>
+          <a:noFill/>
+        </p:spPr>
+        <p:txBody>
+          <a:bodyPr wrap="square" anchor="ctr" lIns="36576" rIns="36576" tIns="0" bIns="0">
+            <a:spAutoFit/>
+          </a:bodyPr>
+          <a:lstStyle/>
+          <a:p>
+            <a:pPr algn="ctr" rtl="1"/>
+            <a:r>
+              <a:rPr sz="1100" b="1">
+                <a:solidFill>
+                  <a:srgbClr val="1A2233"/>
+                </a:solidFill>
+                <a:latin typeface="Heebo"/>
+                <a:cs typeface="Heebo"/>
+              </a:rPr>
+              <a:t>יצחק פינק</a:t>
+            </a:r>
+          </a:p>
+        </p:txBody>
+      </p:sp>
+      <p:sp>
+        <p:nvSpPr>
+          <p:cNvPr id="113" name="Rounded Rectangle 112"/>
+          <p:cNvSpPr/>
+          <p:nvPr/>
+        </p:nvSpPr>
+        <p:spPr>
+          <a:xfrm>
+            <a:off x="2575407" y="5669280"/>
+            <a:ext cx="1554480" cy="329184"/>
+          </a:xfrm>
+          <a:prstGeom prst="roundRect">
+            <a:avLst>
+              <a:gd name="adj" fmla="val 18000"/>
+            </a:avLst>
+          </a:prstGeom>
+          <a:solidFill>
+            <a:srgbClr val="FFFFFF"/>
+          </a:solidFill>
+          <a:ln w="15875">
+            <a:solidFill>
+              <a:srgbClr val="C5CDDD"/>
+            </a:solidFill>
+          </a:ln>
+          <a:effectLst/>
+        </p:spPr>
+        <p:style>
+          <a:lnRef idx="1">
+            <a:schemeClr val="accent1"/>
+          </a:lnRef>
+          <a:fillRef idx="3">
+            <a:schemeClr val="accent1"/>
+          </a:fillRef>
+          <a:effectRef idx="2">
+            <a:schemeClr val="accent1"/>
+          </a:effectRef>
+          <a:fontRef idx="minor">
+            <a:schemeClr val="lt1"/>
+          </a:fontRef>
+        </p:style>
+        <p:txBody>
+          <a:bodyPr rtlCol="0" anchor="ctr"/>
+          <a:lstStyle/>
+          <a:p>
+            <a:pPr algn="ctr"/>
+          </a:p>
+        </p:txBody>
+      </p:sp>
+      <p:sp>
+        <p:nvSpPr>
+          <p:cNvPr id="114" name="Rectangle 113"/>
+          <p:cNvSpPr/>
+          <p:nvPr/>
+        </p:nvSpPr>
+        <p:spPr>
+          <a:xfrm>
+            <a:off x="4065879" y="5742432"/>
+            <a:ext cx="45720" cy="182880"/>
+          </a:xfrm>
+          <a:prstGeom prst="rect">
+            <a:avLst/>
+          </a:prstGeom>
+          <a:solidFill>
+            <a:srgbClr val="F0C000"/>
+          </a:solidFill>
+          <a:ln>
+            <a:noFill/>
+          </a:ln>
+          <a:effectLst/>
+        </p:spPr>
+        <p:style>
+          <a:lnRef idx="1">
+            <a:schemeClr val="accent1"/>
+          </a:lnRef>
+          <a:fillRef idx="3">
+            <a:schemeClr val="accent1"/>
+          </a:fillRef>
+          <a:effectRef idx="2">
+            <a:schemeClr val="accent1"/>
+          </a:effectRef>
+          <a:fontRef idx="minor">
+            <a:schemeClr val="lt1"/>
+          </a:fontRef>
+        </p:style>
+        <p:txBody>
+          <a:bodyPr rtlCol="0" anchor="ctr"/>
+          <a:lstStyle/>
+          <a:p>
+            <a:pPr algn="ctr"/>
+          </a:p>
+        </p:txBody>
+      </p:sp>
+      <p:sp>
+        <p:nvSpPr>
+          <p:cNvPr id="115" name="TextBox 114"/>
+          <p:cNvSpPr txBox="1"/>
+          <p:nvPr/>
+        </p:nvSpPr>
+        <p:spPr>
+          <a:xfrm>
+            <a:off x="2575407" y="5669280"/>
+            <a:ext cx="1554480" cy="329184"/>
+          </a:xfrm>
+          <a:prstGeom prst="rect">
+            <a:avLst/>
+          </a:prstGeom>
+          <a:noFill/>
+        </p:spPr>
+        <p:txBody>
+          <a:bodyPr wrap="square" anchor="ctr" lIns="36576" rIns="36576" tIns="0" bIns="0">
+            <a:spAutoFit/>
+          </a:bodyPr>
+          <a:lstStyle/>
+          <a:p>
+            <a:pPr algn="ctr" rtl="1"/>
+            <a:r>
+              <a:rPr sz="1100" b="1">
+                <a:solidFill>
+                  <a:srgbClr val="1A2233"/>
+                </a:solidFill>
+                <a:latin typeface="Heebo"/>
+                <a:cs typeface="Heebo"/>
+              </a:rPr>
+              <a:t>דובי ג'ייקובס</a:t>
+            </a:r>
+          </a:p>
+        </p:txBody>
+      </p:sp>
       <p:cxnSp>
         <p:nvCxnSpPr>
-          <p:cNvPr id="90" name="Connector 89"/>
+          <p:cNvPr id="116" name="Connector 115"/>
           <p:cNvCxnSpPr/>
           <p:nvPr/>
         </p:nvCxnSpPr>
@@ -6804,13 +7910,83 @@
       </p:cxnSp>
       <p:cxnSp>
         <p:nvCxnSpPr>
-          <p:cNvPr id="91" name="Connector 90"/>
+          <p:cNvPr id="117" name="Connector 116"/>
           <p:cNvCxnSpPr/>
           <p:nvPr/>
         </p:nvCxnSpPr>
         <p:spPr>
           <a:xfrm>
-            <a:off x="6095847" y="2157984"/>
+            <a:off x="3352647" y="2157984"/>
+            <a:ext cx="3749040" cy="0"/>
+          </a:xfrm>
+          <a:prstGeom prst="line">
+            <a:avLst/>
+          </a:prstGeom>
+          <a:ln w="19050">
+            <a:solidFill>
+              <a:srgbClr val="C5CDDD"/>
+            </a:solidFill>
+          </a:ln>
+        </p:spPr>
+        <p:style>
+          <a:lnRef idx="2">
+            <a:schemeClr val="accent1"/>
+          </a:lnRef>
+          <a:fillRef idx="0">
+            <a:schemeClr val="accent1"/>
+          </a:fillRef>
+          <a:effectRef idx="1">
+            <a:schemeClr val="accent1"/>
+          </a:effectRef>
+          <a:fontRef idx="minor">
+            <a:schemeClr val="tx1"/>
+          </a:fontRef>
+        </p:style>
+      </p:cxnSp>
+      <p:cxnSp>
+        <p:nvCxnSpPr>
+          <p:cNvPr id="118" name="Connector 117"/>
+          <p:cNvCxnSpPr/>
+          <p:nvPr/>
+        </p:nvCxnSpPr>
+        <p:spPr>
+          <a:xfrm>
+            <a:off x="7101687" y="2157984"/>
+            <a:ext cx="0" cy="237744"/>
+          </a:xfrm>
+          <a:prstGeom prst="line">
+            <a:avLst/>
+          </a:prstGeom>
+          <a:ln w="19050">
+            <a:solidFill>
+              <a:srgbClr val="C5CDDD"/>
+            </a:solidFill>
+          </a:ln>
+        </p:spPr>
+        <p:style>
+          <a:lnRef idx="2">
+            <a:schemeClr val="accent1"/>
+          </a:lnRef>
+          <a:fillRef idx="0">
+            <a:schemeClr val="accent1"/>
+          </a:fillRef>
+          <a:effectRef idx="1">
+            <a:schemeClr val="accent1"/>
+          </a:effectRef>
+          <a:fontRef idx="minor">
+            <a:schemeClr val="tx1"/>
+          </a:fontRef>
+        </p:style>
+      </p:cxnSp>
+      <p:cxnSp>
+        <p:nvCxnSpPr>
+          <p:cNvPr id="119" name="Connector 118"/>
+          <p:cNvCxnSpPr/>
+          <p:nvPr/>
+        </p:nvCxnSpPr>
+        <p:spPr>
+          <a:xfrm>
+            <a:off x="3352647" y="2157984"/>
             <a:ext cx="0" cy="237744"/>
           </a:xfrm>
           <a:prstGeom prst="line">
@@ -7963,7 +9139,7 @@
         </p:nvSpPr>
         <p:spPr>
           <a:xfrm>
-            <a:off x="3489807" y="2679192"/>
+            <a:off x="4495647" y="2679192"/>
             <a:ext cx="5212080" cy="3044952"/>
           </a:xfrm>
           <a:prstGeom prst="roundRect">
@@ -8009,7 +9185,7 @@
         </p:nvSpPr>
         <p:spPr>
           <a:xfrm>
-            <a:off x="4907127" y="2395728"/>
+            <a:off x="5912967" y="2395728"/>
             <a:ext cx="2377440" cy="566928"/>
           </a:xfrm>
           <a:prstGeom prst="roundRect">
@@ -8055,7 +9231,7 @@
         </p:nvSpPr>
         <p:spPr>
           <a:xfrm>
-            <a:off x="4907127" y="2450592"/>
+            <a:off x="5912967" y="2450592"/>
             <a:ext cx="2377440" cy="294802"/>
           </a:xfrm>
           <a:prstGeom prst="rect">
@@ -8091,7 +9267,7 @@
         </p:nvSpPr>
         <p:spPr>
           <a:xfrm>
-            <a:off x="4907127" y="2707538"/>
+            <a:off x="5912967" y="2707538"/>
             <a:ext cx="2377440" cy="226771"/>
           </a:xfrm>
           <a:prstGeom prst="rect">
@@ -8127,7 +9303,7 @@
         </p:nvSpPr>
         <p:spPr>
           <a:xfrm>
-            <a:off x="6982815" y="3255264"/>
+            <a:off x="7988655" y="3255264"/>
             <a:ext cx="1627632" cy="329184"/>
           </a:xfrm>
           <a:prstGeom prst="roundRect">
@@ -8173,7 +9349,7 @@
         </p:nvSpPr>
         <p:spPr>
           <a:xfrm>
-            <a:off x="6982815" y="3255264"/>
+            <a:off x="7988655" y="3255264"/>
             <a:ext cx="1627632" cy="329184"/>
           </a:xfrm>
           <a:prstGeom prst="rect">
@@ -8209,7 +9385,7 @@
         </p:nvSpPr>
         <p:spPr>
           <a:xfrm>
-            <a:off x="5282031" y="3255264"/>
+            <a:off x="6287871" y="3255264"/>
             <a:ext cx="1627632" cy="329184"/>
           </a:xfrm>
           <a:prstGeom prst="roundRect">
@@ -8255,7 +9431,7 @@
         </p:nvSpPr>
         <p:spPr>
           <a:xfrm>
-            <a:off x="5282031" y="3255264"/>
+            <a:off x="6287871" y="3255264"/>
             <a:ext cx="1627632" cy="329184"/>
           </a:xfrm>
           <a:prstGeom prst="rect">
@@ -8291,7 +9467,7 @@
         </p:nvSpPr>
         <p:spPr>
           <a:xfrm>
-            <a:off x="3581247" y="3255264"/>
+            <a:off x="4587087" y="3255264"/>
             <a:ext cx="1627632" cy="329184"/>
           </a:xfrm>
           <a:prstGeom prst="roundRect">
@@ -8337,7 +9513,7 @@
         </p:nvSpPr>
         <p:spPr>
           <a:xfrm>
-            <a:off x="3581247" y="3255264"/>
+            <a:off x="4587087" y="3255264"/>
             <a:ext cx="1627632" cy="329184"/>
           </a:xfrm>
           <a:prstGeom prst="rect">
@@ -8373,7 +9549,7 @@
         </p:nvSpPr>
         <p:spPr>
           <a:xfrm>
-            <a:off x="6982815" y="3657600"/>
+            <a:off x="7988655" y="3657600"/>
             <a:ext cx="1627632" cy="329184"/>
           </a:xfrm>
           <a:prstGeom prst="roundRect">
@@ -8419,7 +9595,7 @@
         </p:nvSpPr>
         <p:spPr>
           <a:xfrm>
-            <a:off x="6982815" y="3657600"/>
+            <a:off x="7988655" y="3657600"/>
             <a:ext cx="1627632" cy="329184"/>
           </a:xfrm>
           <a:prstGeom prst="rect">
@@ -8455,7 +9631,7 @@
         </p:nvSpPr>
         <p:spPr>
           <a:xfrm>
-            <a:off x="5282031" y="3657600"/>
+            <a:off x="6287871" y="3657600"/>
             <a:ext cx="1627632" cy="329184"/>
           </a:xfrm>
           <a:prstGeom prst="roundRect">
@@ -8501,7 +9677,7 @@
         </p:nvSpPr>
         <p:spPr>
           <a:xfrm>
-            <a:off x="5282031" y="3657600"/>
+            <a:off x="6287871" y="3657600"/>
             <a:ext cx="1627632" cy="329184"/>
           </a:xfrm>
           <a:prstGeom prst="rect">
@@ -8537,7 +9713,7 @@
         </p:nvSpPr>
         <p:spPr>
           <a:xfrm>
-            <a:off x="3581247" y="3657600"/>
+            <a:off x="4587087" y="3657600"/>
             <a:ext cx="1627632" cy="329184"/>
           </a:xfrm>
           <a:prstGeom prst="roundRect">
@@ -8583,7 +9759,7 @@
         </p:nvSpPr>
         <p:spPr>
           <a:xfrm>
-            <a:off x="3581247" y="3657600"/>
+            <a:off x="4587087" y="3657600"/>
             <a:ext cx="1627632" cy="329184"/>
           </a:xfrm>
           <a:prstGeom prst="rect">
@@ -8619,7 +9795,7 @@
         </p:nvSpPr>
         <p:spPr>
           <a:xfrm>
-            <a:off x="6982815" y="4059936"/>
+            <a:off x="7988655" y="4059936"/>
             <a:ext cx="1627632" cy="329184"/>
           </a:xfrm>
           <a:prstGeom prst="roundRect">
@@ -8665,7 +9841,7 @@
         </p:nvSpPr>
         <p:spPr>
           <a:xfrm>
-            <a:off x="6982815" y="4059936"/>
+            <a:off x="7988655" y="4059936"/>
             <a:ext cx="1627632" cy="329184"/>
           </a:xfrm>
           <a:prstGeom prst="rect">
@@ -8701,7 +9877,7 @@
         </p:nvSpPr>
         <p:spPr>
           <a:xfrm>
-            <a:off x="5282031" y="4059936"/>
+            <a:off x="6287871" y="4059936"/>
             <a:ext cx="1627632" cy="329184"/>
           </a:xfrm>
           <a:prstGeom prst="roundRect">
@@ -8747,7 +9923,7 @@
         </p:nvSpPr>
         <p:spPr>
           <a:xfrm>
-            <a:off x="5282031" y="4059936"/>
+            <a:off x="6287871" y="4059936"/>
             <a:ext cx="1627632" cy="329184"/>
           </a:xfrm>
           <a:prstGeom prst="rect">
@@ -8783,7 +9959,7 @@
         </p:nvSpPr>
         <p:spPr>
           <a:xfrm>
-            <a:off x="3581247" y="4059936"/>
+            <a:off x="4587087" y="4059936"/>
             <a:ext cx="1627632" cy="329184"/>
           </a:xfrm>
           <a:prstGeom prst="roundRect">
@@ -8829,7 +10005,7 @@
         </p:nvSpPr>
         <p:spPr>
           <a:xfrm>
-            <a:off x="3581247" y="4059936"/>
+            <a:off x="4587087" y="4059936"/>
             <a:ext cx="1627632" cy="329184"/>
           </a:xfrm>
           <a:prstGeom prst="rect">
@@ -8865,7 +10041,7 @@
         </p:nvSpPr>
         <p:spPr>
           <a:xfrm>
-            <a:off x="6982815" y="4462272"/>
+            <a:off x="7988655" y="4462272"/>
             <a:ext cx="1627632" cy="329184"/>
           </a:xfrm>
           <a:prstGeom prst="roundRect">
@@ -8911,7 +10087,7 @@
         </p:nvSpPr>
         <p:spPr>
           <a:xfrm>
-            <a:off x="6982815" y="4462272"/>
+            <a:off x="7988655" y="4462272"/>
             <a:ext cx="1627632" cy="329184"/>
           </a:xfrm>
           <a:prstGeom prst="rect">
@@ -8947,7 +10123,7 @@
         </p:nvSpPr>
         <p:spPr>
           <a:xfrm>
-            <a:off x="5282031" y="4462272"/>
+            <a:off x="6287871" y="4462272"/>
             <a:ext cx="1627632" cy="329184"/>
           </a:xfrm>
           <a:prstGeom prst="roundRect">
@@ -8993,7 +10169,7 @@
         </p:nvSpPr>
         <p:spPr>
           <a:xfrm>
-            <a:off x="5282031" y="4462272"/>
+            <a:off x="6287871" y="4462272"/>
             <a:ext cx="1627632" cy="329184"/>
           </a:xfrm>
           <a:prstGeom prst="rect">
@@ -9029,7 +10205,7 @@
         </p:nvSpPr>
         <p:spPr>
           <a:xfrm>
-            <a:off x="3581247" y="4462272"/>
+            <a:off x="4587087" y="4462272"/>
             <a:ext cx="1627632" cy="329184"/>
           </a:xfrm>
           <a:prstGeom prst="roundRect">
@@ -9075,7 +10251,7 @@
         </p:nvSpPr>
         <p:spPr>
           <a:xfrm>
-            <a:off x="3581247" y="4462272"/>
+            <a:off x="4587087" y="4462272"/>
             <a:ext cx="1627632" cy="329184"/>
           </a:xfrm>
           <a:prstGeom prst="rect">
@@ -9111,7 +10287,7 @@
         </p:nvSpPr>
         <p:spPr>
           <a:xfrm>
-            <a:off x="6982815" y="4864608"/>
+            <a:off x="7988655" y="4864608"/>
             <a:ext cx="1627632" cy="329184"/>
           </a:xfrm>
           <a:prstGeom prst="roundRect">
@@ -9157,7 +10333,7 @@
         </p:nvSpPr>
         <p:spPr>
           <a:xfrm>
-            <a:off x="6982815" y="4864608"/>
+            <a:off x="7988655" y="4864608"/>
             <a:ext cx="1627632" cy="329184"/>
           </a:xfrm>
           <a:prstGeom prst="rect">
@@ -9193,7 +10369,7 @@
         </p:nvSpPr>
         <p:spPr>
           <a:xfrm>
-            <a:off x="5282031" y="4864608"/>
+            <a:off x="6287871" y="4864608"/>
             <a:ext cx="1627632" cy="329184"/>
           </a:xfrm>
           <a:prstGeom prst="roundRect">
@@ -9239,7 +10415,7 @@
         </p:nvSpPr>
         <p:spPr>
           <a:xfrm>
-            <a:off x="5282031" y="4864608"/>
+            <a:off x="6287871" y="4864608"/>
             <a:ext cx="1627632" cy="329184"/>
           </a:xfrm>
           <a:prstGeom prst="rect">
@@ -9275,7 +10451,7 @@
         </p:nvSpPr>
         <p:spPr>
           <a:xfrm>
-            <a:off x="3581247" y="4864608"/>
+            <a:off x="4587087" y="4864608"/>
             <a:ext cx="1627632" cy="329184"/>
           </a:xfrm>
           <a:prstGeom prst="roundRect">
@@ -9321,7 +10497,7 @@
         </p:nvSpPr>
         <p:spPr>
           <a:xfrm>
-            <a:off x="3581247" y="4864608"/>
+            <a:off x="4587087" y="4864608"/>
             <a:ext cx="1627632" cy="329184"/>
           </a:xfrm>
           <a:prstGeom prst="rect">
@@ -9357,7 +10533,7 @@
         </p:nvSpPr>
         <p:spPr>
           <a:xfrm>
-            <a:off x="6982815" y="5266944"/>
+            <a:off x="7988655" y="5266944"/>
             <a:ext cx="1627632" cy="329184"/>
           </a:xfrm>
           <a:prstGeom prst="roundRect">
@@ -9403,7 +10579,7 @@
         </p:nvSpPr>
         <p:spPr>
           <a:xfrm>
-            <a:off x="6982815" y="5266944"/>
+            <a:off x="7988655" y="5266944"/>
             <a:ext cx="1627632" cy="329184"/>
           </a:xfrm>
           <a:prstGeom prst="rect">
@@ -9439,7 +10615,7 @@
         </p:nvSpPr>
         <p:spPr>
           <a:xfrm>
-            <a:off x="5282031" y="5266944"/>
+            <a:off x="6287871" y="5266944"/>
             <a:ext cx="1627632" cy="329184"/>
           </a:xfrm>
           <a:prstGeom prst="roundRect">
@@ -9485,7 +10661,7 @@
         </p:nvSpPr>
         <p:spPr>
           <a:xfrm>
-            <a:off x="5282031" y="5266944"/>
+            <a:off x="6287871" y="5266944"/>
             <a:ext cx="1627632" cy="329184"/>
           </a:xfrm>
           <a:prstGeom prst="rect">
@@ -9521,7 +10697,7 @@
         </p:nvSpPr>
         <p:spPr>
           <a:xfrm>
-            <a:off x="3581247" y="5266944"/>
+            <a:off x="4587087" y="5266944"/>
             <a:ext cx="1627632" cy="329184"/>
           </a:xfrm>
           <a:prstGeom prst="roundRect">
@@ -9567,7 +10743,7 @@
         </p:nvSpPr>
         <p:spPr>
           <a:xfrm>
-            <a:off x="3581247" y="5266944"/>
+            <a:off x="4587087" y="5266944"/>
             <a:ext cx="1627632" cy="329184"/>
           </a:xfrm>
           <a:prstGeom prst="rect">
@@ -9595,9 +10771,747 @@
           </a:p>
         </p:txBody>
       </p:sp>
+      <p:sp>
+        <p:nvSpPr>
+          <p:cNvPr id="70" name="Rounded Rectangle 69"/>
+          <p:cNvSpPr/>
+          <p:nvPr/>
+        </p:nvSpPr>
+        <p:spPr>
+          <a:xfrm>
+            <a:off x="2483967" y="2679192"/>
+            <a:ext cx="1737360" cy="3447288"/>
+          </a:xfrm>
+          <a:prstGeom prst="roundRect">
+            <a:avLst>
+              <a:gd name="adj" fmla="val 4000"/>
+            </a:avLst>
+          </a:prstGeom>
+          <a:noFill/>
+          <a:ln w="15875">
+            <a:solidFill>
+              <a:srgbClr val="C5CDDD"/>
+            </a:solidFill>
+          </a:ln>
+          <a:effectLst/>
+        </p:spPr>
+        <p:style>
+          <a:lnRef idx="1">
+            <a:schemeClr val="accent1"/>
+          </a:lnRef>
+          <a:fillRef idx="3">
+            <a:schemeClr val="accent1"/>
+          </a:fillRef>
+          <a:effectRef idx="2">
+            <a:schemeClr val="accent1"/>
+          </a:effectRef>
+          <a:fontRef idx="minor">
+            <a:schemeClr val="lt1"/>
+          </a:fontRef>
+        </p:style>
+        <p:txBody>
+          <a:bodyPr rtlCol="0" anchor="ctr"/>
+          <a:lstStyle/>
+          <a:p>
+            <a:pPr algn="ctr"/>
+          </a:p>
+        </p:txBody>
+      </p:sp>
+      <p:sp>
+        <p:nvSpPr>
+          <p:cNvPr id="71" name="Rounded Rectangle 70"/>
+          <p:cNvSpPr/>
+          <p:nvPr/>
+        </p:nvSpPr>
+        <p:spPr>
+          <a:xfrm>
+            <a:off x="2575407" y="2395728"/>
+            <a:ext cx="1554480" cy="566928"/>
+          </a:xfrm>
+          <a:prstGeom prst="roundRect">
+            <a:avLst>
+              <a:gd name="adj" fmla="val 18000"/>
+            </a:avLst>
+          </a:prstGeom>
+          <a:solidFill>
+            <a:srgbClr val="D64545"/>
+          </a:solidFill>
+          <a:ln>
+            <a:noFill/>
+          </a:ln>
+          <a:effectLst/>
+        </p:spPr>
+        <p:style>
+          <a:lnRef idx="1">
+            <a:schemeClr val="accent1"/>
+          </a:lnRef>
+          <a:fillRef idx="3">
+            <a:schemeClr val="accent1"/>
+          </a:fillRef>
+          <a:effectRef idx="2">
+            <a:schemeClr val="accent1"/>
+          </a:effectRef>
+          <a:fontRef idx="minor">
+            <a:schemeClr val="lt1"/>
+          </a:fontRef>
+        </p:style>
+        <p:txBody>
+          <a:bodyPr rtlCol="0" anchor="ctr"/>
+          <a:lstStyle/>
+          <a:p>
+            <a:pPr algn="ctr"/>
+          </a:p>
+        </p:txBody>
+      </p:sp>
+      <p:sp>
+        <p:nvSpPr>
+          <p:cNvPr id="72" name="TextBox 71"/>
+          <p:cNvSpPr txBox="1"/>
+          <p:nvPr/>
+        </p:nvSpPr>
+        <p:spPr>
+          <a:xfrm>
+            <a:off x="2575407" y="2450592"/>
+            <a:ext cx="1554480" cy="294802"/>
+          </a:xfrm>
+          <a:prstGeom prst="rect">
+            <a:avLst/>
+          </a:prstGeom>
+          <a:noFill/>
+        </p:spPr>
+        <p:txBody>
+          <a:bodyPr wrap="square" anchor="b" lIns="36576" rIns="36576" tIns="0" bIns="0">
+            <a:spAutoFit/>
+          </a:bodyPr>
+          <a:lstStyle/>
+          <a:p>
+            <a:pPr algn="ctr" rtl="1"/>
+            <a:r>
+              <a:rPr sz="1200" b="1">
+                <a:solidFill>
+                  <a:srgbClr val="FFFFFF"/>
+                </a:solidFill>
+                <a:latin typeface="Heebo"/>
+                <a:cs typeface="Heebo"/>
+              </a:rPr>
+              <a:t>יהונתן יחזקאל</a:t>
+            </a:r>
+          </a:p>
+        </p:txBody>
+      </p:sp>
+      <p:sp>
+        <p:nvSpPr>
+          <p:cNvPr id="73" name="TextBox 72"/>
+          <p:cNvSpPr txBox="1"/>
+          <p:nvPr/>
+        </p:nvSpPr>
+        <p:spPr>
+          <a:xfrm>
+            <a:off x="2575407" y="2707538"/>
+            <a:ext cx="1554480" cy="226771"/>
+          </a:xfrm>
+          <a:prstGeom prst="rect">
+            <a:avLst/>
+          </a:prstGeom>
+          <a:noFill/>
+        </p:spPr>
+        <p:txBody>
+          <a:bodyPr wrap="square" anchor="t" lIns="36576" rIns="36576" tIns="0" bIns="0">
+            <a:spAutoFit/>
+          </a:bodyPr>
+          <a:lstStyle/>
+          <a:p>
+            <a:pPr algn="ctr" rtl="1"/>
+            <a:r>
+              <a:rPr sz="900" b="0">
+                <a:solidFill>
+                  <a:srgbClr val="FFFFFF"/>
+                </a:solidFill>
+                <a:latin typeface="Heebo"/>
+                <a:cs typeface="Heebo"/>
+              </a:rPr>
+              <a:t>ראש צוות · צוות אקטיביסטים</a:t>
+            </a:r>
+          </a:p>
+        </p:txBody>
+      </p:sp>
+      <p:sp>
+        <p:nvSpPr>
+          <p:cNvPr id="74" name="Rounded Rectangle 73"/>
+          <p:cNvSpPr/>
+          <p:nvPr/>
+        </p:nvSpPr>
+        <p:spPr>
+          <a:xfrm>
+            <a:off x="2575407" y="3255264"/>
+            <a:ext cx="1554480" cy="329184"/>
+          </a:xfrm>
+          <a:prstGeom prst="roundRect">
+            <a:avLst>
+              <a:gd name="adj" fmla="val 18000"/>
+            </a:avLst>
+          </a:prstGeom>
+          <a:solidFill>
+            <a:srgbClr val="E8892B"/>
+          </a:solidFill>
+          <a:ln>
+            <a:noFill/>
+          </a:ln>
+          <a:effectLst/>
+        </p:spPr>
+        <p:style>
+          <a:lnRef idx="1">
+            <a:schemeClr val="accent1"/>
+          </a:lnRef>
+          <a:fillRef idx="3">
+            <a:schemeClr val="accent1"/>
+          </a:fillRef>
+          <a:effectRef idx="2">
+            <a:schemeClr val="accent1"/>
+          </a:effectRef>
+          <a:fontRef idx="minor">
+            <a:schemeClr val="lt1"/>
+          </a:fontRef>
+        </p:style>
+        <p:txBody>
+          <a:bodyPr rtlCol="0" anchor="ctr"/>
+          <a:lstStyle/>
+          <a:p>
+            <a:pPr algn="ctr"/>
+          </a:p>
+        </p:txBody>
+      </p:sp>
+      <p:sp>
+        <p:nvSpPr>
+          <p:cNvPr id="75" name="TextBox 74"/>
+          <p:cNvSpPr txBox="1"/>
+          <p:nvPr/>
+        </p:nvSpPr>
+        <p:spPr>
+          <a:xfrm>
+            <a:off x="2575407" y="3255264"/>
+            <a:ext cx="1554480" cy="329184"/>
+          </a:xfrm>
+          <a:prstGeom prst="rect">
+            <a:avLst/>
+          </a:prstGeom>
+          <a:noFill/>
+        </p:spPr>
+        <p:txBody>
+          <a:bodyPr wrap="square" anchor="ctr" lIns="36576" rIns="36576" tIns="0" bIns="0">
+            <a:spAutoFit/>
+          </a:bodyPr>
+          <a:lstStyle/>
+          <a:p>
+            <a:pPr algn="ctr" rtl="1"/>
+            <a:r>
+              <a:rPr sz="1100" b="1">
+                <a:solidFill>
+                  <a:srgbClr val="FFFFFF"/>
+                </a:solidFill>
+                <a:latin typeface="Heebo"/>
+                <a:cs typeface="Heebo"/>
+              </a:rPr>
+              <a:t>רוני מרטין</a:t>
+            </a:r>
+          </a:p>
+        </p:txBody>
+      </p:sp>
+      <p:sp>
+        <p:nvSpPr>
+          <p:cNvPr id="76" name="Rounded Rectangle 75"/>
+          <p:cNvSpPr/>
+          <p:nvPr/>
+        </p:nvSpPr>
+        <p:spPr>
+          <a:xfrm>
+            <a:off x="2575407" y="3657600"/>
+            <a:ext cx="1554480" cy="329184"/>
+          </a:xfrm>
+          <a:prstGeom prst="roundRect">
+            <a:avLst>
+              <a:gd name="adj" fmla="val 18000"/>
+            </a:avLst>
+          </a:prstGeom>
+          <a:solidFill>
+            <a:srgbClr val="E8892B"/>
+          </a:solidFill>
+          <a:ln>
+            <a:noFill/>
+          </a:ln>
+          <a:effectLst/>
+        </p:spPr>
+        <p:style>
+          <a:lnRef idx="1">
+            <a:schemeClr val="accent1"/>
+          </a:lnRef>
+          <a:fillRef idx="3">
+            <a:schemeClr val="accent1"/>
+          </a:fillRef>
+          <a:effectRef idx="2">
+            <a:schemeClr val="accent1"/>
+          </a:effectRef>
+          <a:fontRef idx="minor">
+            <a:schemeClr val="lt1"/>
+          </a:fontRef>
+        </p:style>
+        <p:txBody>
+          <a:bodyPr rtlCol="0" anchor="ctr"/>
+          <a:lstStyle/>
+          <a:p>
+            <a:pPr algn="ctr"/>
+          </a:p>
+        </p:txBody>
+      </p:sp>
+      <p:sp>
+        <p:nvSpPr>
+          <p:cNvPr id="77" name="TextBox 76"/>
+          <p:cNvSpPr txBox="1"/>
+          <p:nvPr/>
+        </p:nvSpPr>
+        <p:spPr>
+          <a:xfrm>
+            <a:off x="2575407" y="3657600"/>
+            <a:ext cx="1554480" cy="329184"/>
+          </a:xfrm>
+          <a:prstGeom prst="rect">
+            <a:avLst/>
+          </a:prstGeom>
+          <a:noFill/>
+        </p:spPr>
+        <p:txBody>
+          <a:bodyPr wrap="square" anchor="ctr" lIns="36576" rIns="36576" tIns="0" bIns="0">
+            <a:spAutoFit/>
+          </a:bodyPr>
+          <a:lstStyle/>
+          <a:p>
+            <a:pPr algn="ctr" rtl="1"/>
+            <a:r>
+              <a:rPr sz="1100" b="1">
+                <a:solidFill>
+                  <a:srgbClr val="FFFFFF"/>
+                </a:solidFill>
+                <a:latin typeface="Heebo"/>
+                <a:cs typeface="Heebo"/>
+              </a:rPr>
+              <a:t>בנימין שיפרין</a:t>
+            </a:r>
+          </a:p>
+        </p:txBody>
+      </p:sp>
+      <p:sp>
+        <p:nvSpPr>
+          <p:cNvPr id="78" name="Rounded Rectangle 77"/>
+          <p:cNvSpPr/>
+          <p:nvPr/>
+        </p:nvSpPr>
+        <p:spPr>
+          <a:xfrm>
+            <a:off x="2575407" y="4059936"/>
+            <a:ext cx="1554480" cy="329184"/>
+          </a:xfrm>
+          <a:prstGeom prst="roundRect">
+            <a:avLst>
+              <a:gd name="adj" fmla="val 18000"/>
+            </a:avLst>
+          </a:prstGeom>
+          <a:solidFill>
+            <a:srgbClr val="E8892B"/>
+          </a:solidFill>
+          <a:ln>
+            <a:noFill/>
+          </a:ln>
+          <a:effectLst/>
+        </p:spPr>
+        <p:style>
+          <a:lnRef idx="1">
+            <a:schemeClr val="accent1"/>
+          </a:lnRef>
+          <a:fillRef idx="3">
+            <a:schemeClr val="accent1"/>
+          </a:fillRef>
+          <a:effectRef idx="2">
+            <a:schemeClr val="accent1"/>
+          </a:effectRef>
+          <a:fontRef idx="minor">
+            <a:schemeClr val="lt1"/>
+          </a:fontRef>
+        </p:style>
+        <p:txBody>
+          <a:bodyPr rtlCol="0" anchor="ctr"/>
+          <a:lstStyle/>
+          <a:p>
+            <a:pPr algn="ctr"/>
+          </a:p>
+        </p:txBody>
+      </p:sp>
+      <p:sp>
+        <p:nvSpPr>
+          <p:cNvPr id="79" name="TextBox 78"/>
+          <p:cNvSpPr txBox="1"/>
+          <p:nvPr/>
+        </p:nvSpPr>
+        <p:spPr>
+          <a:xfrm>
+            <a:off x="2575407" y="4059936"/>
+            <a:ext cx="1554480" cy="329184"/>
+          </a:xfrm>
+          <a:prstGeom prst="rect">
+            <a:avLst/>
+          </a:prstGeom>
+          <a:noFill/>
+        </p:spPr>
+        <p:txBody>
+          <a:bodyPr wrap="square" anchor="ctr" lIns="36576" rIns="36576" tIns="0" bIns="0">
+            <a:spAutoFit/>
+          </a:bodyPr>
+          <a:lstStyle/>
+          <a:p>
+            <a:pPr algn="ctr" rtl="1"/>
+            <a:r>
+              <a:rPr sz="1100" b="1">
+                <a:solidFill>
+                  <a:srgbClr val="FFFFFF"/>
+                </a:solidFill>
+                <a:latin typeface="Heebo"/>
+                <a:cs typeface="Heebo"/>
+              </a:rPr>
+              <a:t>משה הלר</a:t>
+            </a:r>
+          </a:p>
+        </p:txBody>
+      </p:sp>
+      <p:sp>
+        <p:nvSpPr>
+          <p:cNvPr id="80" name="Rounded Rectangle 79"/>
+          <p:cNvSpPr/>
+          <p:nvPr/>
+        </p:nvSpPr>
+        <p:spPr>
+          <a:xfrm>
+            <a:off x="2575407" y="4462272"/>
+            <a:ext cx="1554480" cy="329184"/>
+          </a:xfrm>
+          <a:prstGeom prst="roundRect">
+            <a:avLst>
+              <a:gd name="adj" fmla="val 18000"/>
+            </a:avLst>
+          </a:prstGeom>
+          <a:solidFill>
+            <a:srgbClr val="E8892B"/>
+          </a:solidFill>
+          <a:ln>
+            <a:noFill/>
+          </a:ln>
+          <a:effectLst/>
+        </p:spPr>
+        <p:style>
+          <a:lnRef idx="1">
+            <a:schemeClr val="accent1"/>
+          </a:lnRef>
+          <a:fillRef idx="3">
+            <a:schemeClr val="accent1"/>
+          </a:fillRef>
+          <a:effectRef idx="2">
+            <a:schemeClr val="accent1"/>
+          </a:effectRef>
+          <a:fontRef idx="minor">
+            <a:schemeClr val="lt1"/>
+          </a:fontRef>
+        </p:style>
+        <p:txBody>
+          <a:bodyPr rtlCol="0" anchor="ctr"/>
+          <a:lstStyle/>
+          <a:p>
+            <a:pPr algn="ctr"/>
+          </a:p>
+        </p:txBody>
+      </p:sp>
+      <p:sp>
+        <p:nvSpPr>
+          <p:cNvPr id="81" name="TextBox 80"/>
+          <p:cNvSpPr txBox="1"/>
+          <p:nvPr/>
+        </p:nvSpPr>
+        <p:spPr>
+          <a:xfrm>
+            <a:off x="2575407" y="4462272"/>
+            <a:ext cx="1554480" cy="329184"/>
+          </a:xfrm>
+          <a:prstGeom prst="rect">
+            <a:avLst/>
+          </a:prstGeom>
+          <a:noFill/>
+        </p:spPr>
+        <p:txBody>
+          <a:bodyPr wrap="square" anchor="ctr" lIns="36576" rIns="36576" tIns="0" bIns="0">
+            <a:spAutoFit/>
+          </a:bodyPr>
+          <a:lstStyle/>
+          <a:p>
+            <a:pPr algn="ctr" rtl="1"/>
+            <a:r>
+              <a:rPr sz="1100" b="1">
+                <a:solidFill>
+                  <a:srgbClr val="FFFFFF"/>
+                </a:solidFill>
+                <a:latin typeface="Heebo"/>
+                <a:cs typeface="Heebo"/>
+              </a:rPr>
+              <a:t>יהודה שוורצמן</a:t>
+            </a:r>
+          </a:p>
+        </p:txBody>
+      </p:sp>
+      <p:sp>
+        <p:nvSpPr>
+          <p:cNvPr id="82" name="Rounded Rectangle 81"/>
+          <p:cNvSpPr/>
+          <p:nvPr/>
+        </p:nvSpPr>
+        <p:spPr>
+          <a:xfrm>
+            <a:off x="2575407" y="4864608"/>
+            <a:ext cx="1554480" cy="329184"/>
+          </a:xfrm>
+          <a:prstGeom prst="roundRect">
+            <a:avLst>
+              <a:gd name="adj" fmla="val 18000"/>
+            </a:avLst>
+          </a:prstGeom>
+          <a:solidFill>
+            <a:srgbClr val="E8892B"/>
+          </a:solidFill>
+          <a:ln>
+            <a:noFill/>
+          </a:ln>
+          <a:effectLst/>
+        </p:spPr>
+        <p:style>
+          <a:lnRef idx="1">
+            <a:schemeClr val="accent1"/>
+          </a:lnRef>
+          <a:fillRef idx="3">
+            <a:schemeClr val="accent1"/>
+          </a:fillRef>
+          <a:effectRef idx="2">
+            <a:schemeClr val="accent1"/>
+          </a:effectRef>
+          <a:fontRef idx="minor">
+            <a:schemeClr val="lt1"/>
+          </a:fontRef>
+        </p:style>
+        <p:txBody>
+          <a:bodyPr rtlCol="0" anchor="ctr"/>
+          <a:lstStyle/>
+          <a:p>
+            <a:pPr algn="ctr"/>
+          </a:p>
+        </p:txBody>
+      </p:sp>
+      <p:sp>
+        <p:nvSpPr>
+          <p:cNvPr id="83" name="TextBox 82"/>
+          <p:cNvSpPr txBox="1"/>
+          <p:nvPr/>
+        </p:nvSpPr>
+        <p:spPr>
+          <a:xfrm>
+            <a:off x="2575407" y="4864608"/>
+            <a:ext cx="1554480" cy="329184"/>
+          </a:xfrm>
+          <a:prstGeom prst="rect">
+            <a:avLst/>
+          </a:prstGeom>
+          <a:noFill/>
+        </p:spPr>
+        <p:txBody>
+          <a:bodyPr wrap="square" anchor="ctr" lIns="36576" rIns="36576" tIns="0" bIns="0">
+            <a:spAutoFit/>
+          </a:bodyPr>
+          <a:lstStyle/>
+          <a:p>
+            <a:pPr algn="ctr" rtl="1"/>
+            <a:r>
+              <a:rPr sz="1100" b="1">
+                <a:solidFill>
+                  <a:srgbClr val="FFFFFF"/>
+                </a:solidFill>
+                <a:latin typeface="Heebo"/>
+                <a:cs typeface="Heebo"/>
+              </a:rPr>
+              <a:t>צופיה צדוק</a:t>
+            </a:r>
+          </a:p>
+        </p:txBody>
+      </p:sp>
+      <p:sp>
+        <p:nvSpPr>
+          <p:cNvPr id="84" name="Rounded Rectangle 83"/>
+          <p:cNvSpPr/>
+          <p:nvPr/>
+        </p:nvSpPr>
+        <p:spPr>
+          <a:xfrm>
+            <a:off x="2575407" y="5266944"/>
+            <a:ext cx="1554480" cy="329184"/>
+          </a:xfrm>
+          <a:prstGeom prst="roundRect">
+            <a:avLst>
+              <a:gd name="adj" fmla="val 18000"/>
+            </a:avLst>
+          </a:prstGeom>
+          <a:solidFill>
+            <a:srgbClr val="E8892B"/>
+          </a:solidFill>
+          <a:ln>
+            <a:noFill/>
+          </a:ln>
+          <a:effectLst/>
+        </p:spPr>
+        <p:style>
+          <a:lnRef idx="1">
+            <a:schemeClr val="accent1"/>
+          </a:lnRef>
+          <a:fillRef idx="3">
+            <a:schemeClr val="accent1"/>
+          </a:fillRef>
+          <a:effectRef idx="2">
+            <a:schemeClr val="accent1"/>
+          </a:effectRef>
+          <a:fontRef idx="minor">
+            <a:schemeClr val="lt1"/>
+          </a:fontRef>
+        </p:style>
+        <p:txBody>
+          <a:bodyPr rtlCol="0" anchor="ctr"/>
+          <a:lstStyle/>
+          <a:p>
+            <a:pPr algn="ctr"/>
+          </a:p>
+        </p:txBody>
+      </p:sp>
+      <p:sp>
+        <p:nvSpPr>
+          <p:cNvPr id="85" name="TextBox 84"/>
+          <p:cNvSpPr txBox="1"/>
+          <p:nvPr/>
+        </p:nvSpPr>
+        <p:spPr>
+          <a:xfrm>
+            <a:off x="2575407" y="5266944"/>
+            <a:ext cx="1554480" cy="329184"/>
+          </a:xfrm>
+          <a:prstGeom prst="rect">
+            <a:avLst/>
+          </a:prstGeom>
+          <a:noFill/>
+        </p:spPr>
+        <p:txBody>
+          <a:bodyPr wrap="square" anchor="ctr" lIns="36576" rIns="36576" tIns="0" bIns="0">
+            <a:spAutoFit/>
+          </a:bodyPr>
+          <a:lstStyle/>
+          <a:p>
+            <a:pPr algn="ctr" rtl="1"/>
+            <a:r>
+              <a:rPr sz="1100" b="1">
+                <a:solidFill>
+                  <a:srgbClr val="FFFFFF"/>
+                </a:solidFill>
+                <a:latin typeface="Heebo"/>
+                <a:cs typeface="Heebo"/>
+              </a:rPr>
+              <a:t>יצחק פינק</a:t>
+            </a:r>
+          </a:p>
+        </p:txBody>
+      </p:sp>
+      <p:sp>
+        <p:nvSpPr>
+          <p:cNvPr id="86" name="Rounded Rectangle 85"/>
+          <p:cNvSpPr/>
+          <p:nvPr/>
+        </p:nvSpPr>
+        <p:spPr>
+          <a:xfrm>
+            <a:off x="2575407" y="5669280"/>
+            <a:ext cx="1554480" cy="329184"/>
+          </a:xfrm>
+          <a:prstGeom prst="roundRect">
+            <a:avLst>
+              <a:gd name="adj" fmla="val 18000"/>
+            </a:avLst>
+          </a:prstGeom>
+          <a:solidFill>
+            <a:srgbClr val="E8892B"/>
+          </a:solidFill>
+          <a:ln>
+            <a:noFill/>
+          </a:ln>
+          <a:effectLst/>
+        </p:spPr>
+        <p:style>
+          <a:lnRef idx="1">
+            <a:schemeClr val="accent1"/>
+          </a:lnRef>
+          <a:fillRef idx="3">
+            <a:schemeClr val="accent1"/>
+          </a:fillRef>
+          <a:effectRef idx="2">
+            <a:schemeClr val="accent1"/>
+          </a:effectRef>
+          <a:fontRef idx="minor">
+            <a:schemeClr val="lt1"/>
+          </a:fontRef>
+        </p:style>
+        <p:txBody>
+          <a:bodyPr rtlCol="0" anchor="ctr"/>
+          <a:lstStyle/>
+          <a:p>
+            <a:pPr algn="ctr"/>
+          </a:p>
+        </p:txBody>
+      </p:sp>
+      <p:sp>
+        <p:nvSpPr>
+          <p:cNvPr id="87" name="TextBox 86"/>
+          <p:cNvSpPr txBox="1"/>
+          <p:nvPr/>
+        </p:nvSpPr>
+        <p:spPr>
+          <a:xfrm>
+            <a:off x="2575407" y="5669280"/>
+            <a:ext cx="1554480" cy="329184"/>
+          </a:xfrm>
+          <a:prstGeom prst="rect">
+            <a:avLst/>
+          </a:prstGeom>
+          <a:noFill/>
+        </p:spPr>
+        <p:txBody>
+          <a:bodyPr wrap="square" anchor="ctr" lIns="36576" rIns="36576" tIns="0" bIns="0">
+            <a:spAutoFit/>
+          </a:bodyPr>
+          <a:lstStyle/>
+          <a:p>
+            <a:pPr algn="ctr" rtl="1"/>
+            <a:r>
+              <a:rPr sz="1100" b="1">
+                <a:solidFill>
+                  <a:srgbClr val="FFFFFF"/>
+                </a:solidFill>
+                <a:latin typeface="Heebo"/>
+                <a:cs typeface="Heebo"/>
+              </a:rPr>
+              <a:t>דובי ג'ייקובס</a:t>
+            </a:r>
+          </a:p>
+        </p:txBody>
+      </p:sp>
       <p:cxnSp>
         <p:nvCxnSpPr>
-          <p:cNvPr id="70" name="Connector 69"/>
+          <p:cNvPr id="88" name="Connector 87"/>
           <p:cNvCxnSpPr/>
           <p:nvPr/>
         </p:nvCxnSpPr>
@@ -9632,14 +11546,14 @@
       </p:cxnSp>
       <p:cxnSp>
         <p:nvCxnSpPr>
-          <p:cNvPr id="71" name="Connector 70"/>
+          <p:cNvPr id="89" name="Connector 88"/>
           <p:cNvCxnSpPr/>
           <p:nvPr/>
         </p:nvCxnSpPr>
         <p:spPr>
           <a:xfrm>
-            <a:off x="6095847" y="2157984"/>
-            <a:ext cx="0" cy="237744"/>
+            <a:off x="3352647" y="2157984"/>
+            <a:ext cx="3749040" cy="0"/>
           </a:xfrm>
           <a:prstGeom prst="line">
             <a:avLst/>
@@ -9665,9 +11579,79 @@
           </a:fontRef>
         </p:style>
       </p:cxnSp>
-      <p:sp>
-        <p:nvSpPr>
-          <p:cNvPr id="72" name="Oval 71"/>
+      <p:cxnSp>
+        <p:nvCxnSpPr>
+          <p:cNvPr id="90" name="Connector 89"/>
+          <p:cNvCxnSpPr/>
+          <p:nvPr/>
+        </p:nvCxnSpPr>
+        <p:spPr>
+          <a:xfrm>
+            <a:off x="7101687" y="2157984"/>
+            <a:ext cx="0" cy="237744"/>
+          </a:xfrm>
+          <a:prstGeom prst="line">
+            <a:avLst/>
+          </a:prstGeom>
+          <a:ln w="19050">
+            <a:solidFill>
+              <a:srgbClr val="C5CDDD"/>
+            </a:solidFill>
+          </a:ln>
+        </p:spPr>
+        <p:style>
+          <a:lnRef idx="2">
+            <a:schemeClr val="accent1"/>
+          </a:lnRef>
+          <a:fillRef idx="0">
+            <a:schemeClr val="accent1"/>
+          </a:fillRef>
+          <a:effectRef idx="1">
+            <a:schemeClr val="accent1"/>
+          </a:effectRef>
+          <a:fontRef idx="minor">
+            <a:schemeClr val="tx1"/>
+          </a:fontRef>
+        </p:style>
+      </p:cxnSp>
+      <p:cxnSp>
+        <p:nvCxnSpPr>
+          <p:cNvPr id="91" name="Connector 90"/>
+          <p:cNvCxnSpPr/>
+          <p:nvPr/>
+        </p:nvCxnSpPr>
+        <p:spPr>
+          <a:xfrm>
+            <a:off x="3352647" y="2157984"/>
+            <a:ext cx="0" cy="237744"/>
+          </a:xfrm>
+          <a:prstGeom prst="line">
+            <a:avLst/>
+          </a:prstGeom>
+          <a:ln w="19050">
+            <a:solidFill>
+              <a:srgbClr val="C5CDDD"/>
+            </a:solidFill>
+          </a:ln>
+        </p:spPr>
+        <p:style>
+          <a:lnRef idx="2">
+            <a:schemeClr val="accent1"/>
+          </a:lnRef>
+          <a:fillRef idx="0">
+            <a:schemeClr val="accent1"/>
+          </a:fillRef>
+          <a:effectRef idx="1">
+            <a:schemeClr val="accent1"/>
+          </a:effectRef>
+          <a:fontRef idx="minor">
+            <a:schemeClr val="tx1"/>
+          </a:fontRef>
+        </p:style>
+      </p:cxnSp>
+      <p:sp>
+        <p:nvSpPr>
+          <p:cNvPr id="92" name="Oval 91"/>
           <p:cNvSpPr/>
           <p:nvPr/>
         </p:nvSpPr>
@@ -9711,7 +11695,7 @@
       </p:sp>
       <p:sp>
         <p:nvSpPr>
-          <p:cNvPr id="73" name="TextBox 72"/>
+          <p:cNvPr id="93" name="TextBox 92"/>
           <p:cNvSpPr txBox="1"/>
           <p:nvPr/>
         </p:nvSpPr>
@@ -9747,7 +11731,7 @@
       </p:sp>
       <p:sp>
         <p:nvSpPr>
-          <p:cNvPr id="74" name="Oval 73"/>
+          <p:cNvPr id="94" name="Oval 93"/>
           <p:cNvSpPr/>
           <p:nvPr/>
         </p:nvSpPr>
@@ -9791,7 +11775,7 @@
       </p:sp>
       <p:sp>
         <p:nvSpPr>
-          <p:cNvPr id="75" name="TextBox 74"/>
+          <p:cNvPr id="95" name="TextBox 94"/>
           <p:cNvSpPr txBox="1"/>
           <p:nvPr/>
         </p:nvSpPr>
@@ -9827,7 +11811,7 @@
       </p:sp>
       <p:sp>
         <p:nvSpPr>
-          <p:cNvPr id="76" name="Oval 75"/>
+          <p:cNvPr id="96" name="Oval 95"/>
           <p:cNvSpPr/>
           <p:nvPr/>
         </p:nvSpPr>
@@ -9871,7 +11855,7 @@
       </p:sp>
       <p:sp>
         <p:nvSpPr>
-          <p:cNvPr id="77" name="TextBox 76"/>
+          <p:cNvPr id="97" name="TextBox 96"/>
           <p:cNvSpPr txBox="1"/>
           <p:nvPr/>
         </p:nvSpPr>
@@ -9907,7 +11891,7 @@
       </p:sp>
       <p:sp>
         <p:nvSpPr>
-          <p:cNvPr id="78" name="Oval 77"/>
+          <p:cNvPr id="98" name="Oval 97"/>
           <p:cNvSpPr/>
           <p:nvPr/>
         </p:nvSpPr>
@@ -9951,7 +11935,7 @@
       </p:sp>
       <p:sp>
         <p:nvSpPr>
-          <p:cNvPr id="79" name="TextBox 78"/>
+          <p:cNvPr id="99" name="TextBox 98"/>
           <p:cNvSpPr txBox="1"/>
           <p:nvPr/>
         </p:nvSpPr>

</xml_diff>

<commit_message>
Add CEO level to org slides
Co-Authored-By: Claude Opus 5.5 <noreply@anthropic.com>
Claude-Session: https://claude.ai/code/session_01W7Er83FuNT4pLFShWidYHn
</commit_message>
<xml_diff>
--- a/presentation/out/koach-hitarvut.pptx
+++ b/presentation/out/koach-hitarvut.pptx
@@ -4253,16 +4253,215 @@
           </a:p>
         </p:txBody>
       </p:sp>
-      <p:sp>
-        <p:nvSpPr>
-          <p:cNvPr id="31" name="Rounded Rectangle 30"/>
+      <p:cxnSp>
+        <p:nvCxnSpPr>
+          <p:cNvPr id="31" name="Connector 30"/>
+          <p:cNvCxnSpPr/>
+          <p:nvPr/>
+        </p:nvCxnSpPr>
+        <p:spPr>
+          <a:xfrm>
+            <a:off x="6095847" y="1901952"/>
+            <a:ext cx="0" cy="201168"/>
+          </a:xfrm>
+          <a:prstGeom prst="line">
+            <a:avLst/>
+          </a:prstGeom>
+          <a:ln w="19050">
+            <a:solidFill>
+              <a:srgbClr val="C5CDDD"/>
+            </a:solidFill>
+          </a:ln>
+        </p:spPr>
+        <p:style>
+          <a:lnRef idx="2">
+            <a:schemeClr val="accent1"/>
+          </a:lnRef>
+          <a:fillRef idx="0">
+            <a:schemeClr val="accent1"/>
+          </a:fillRef>
+          <a:effectRef idx="1">
+            <a:schemeClr val="accent1"/>
+          </a:effectRef>
+          <a:fontRef idx="minor">
+            <a:schemeClr val="tx1"/>
+          </a:fontRef>
+        </p:style>
+      </p:cxnSp>
+      <p:sp>
+        <p:nvSpPr>
+          <p:cNvPr id="32" name="Rounded Rectangle 31"/>
           <p:cNvSpPr/>
           <p:nvPr/>
         </p:nvSpPr>
         <p:spPr>
           <a:xfrm>
-            <a:off x="4495647" y="2679192"/>
-            <a:ext cx="5212080" cy="3044952"/>
+            <a:off x="4907127" y="2103120"/>
+            <a:ext cx="2377440" cy="512064"/>
+          </a:xfrm>
+          <a:prstGeom prst="roundRect">
+            <a:avLst>
+              <a:gd name="adj" fmla="val 18000"/>
+            </a:avLst>
+          </a:prstGeom>
+          <a:solidFill>
+            <a:srgbClr val="FFFFFF"/>
+          </a:solidFill>
+          <a:ln w="15875">
+            <a:solidFill>
+              <a:srgbClr val="C5CDDD"/>
+            </a:solidFill>
+          </a:ln>
+          <a:effectLst/>
+        </p:spPr>
+        <p:style>
+          <a:lnRef idx="1">
+            <a:schemeClr val="accent1"/>
+          </a:lnRef>
+          <a:fillRef idx="3">
+            <a:schemeClr val="accent1"/>
+          </a:fillRef>
+          <a:effectRef idx="2">
+            <a:schemeClr val="accent1"/>
+          </a:effectRef>
+          <a:fontRef idx="minor">
+            <a:schemeClr val="lt1"/>
+          </a:fontRef>
+        </p:style>
+        <p:txBody>
+          <a:bodyPr rtlCol="0" anchor="ctr"/>
+          <a:lstStyle/>
+          <a:p>
+            <a:pPr algn="ctr"/>
+          </a:p>
+        </p:txBody>
+      </p:sp>
+      <p:sp>
+        <p:nvSpPr>
+          <p:cNvPr id="33" name="Rectangle 32"/>
+          <p:cNvSpPr/>
+          <p:nvPr/>
+        </p:nvSpPr>
+        <p:spPr>
+          <a:xfrm>
+            <a:off x="7220559" y="2176272"/>
+            <a:ext cx="45720" cy="365760"/>
+          </a:xfrm>
+          <a:prstGeom prst="rect">
+            <a:avLst/>
+          </a:prstGeom>
+          <a:solidFill>
+            <a:srgbClr val="F0C000"/>
+          </a:solidFill>
+          <a:ln>
+            <a:noFill/>
+          </a:ln>
+          <a:effectLst/>
+        </p:spPr>
+        <p:style>
+          <a:lnRef idx="1">
+            <a:schemeClr val="accent1"/>
+          </a:lnRef>
+          <a:fillRef idx="3">
+            <a:schemeClr val="accent1"/>
+          </a:fillRef>
+          <a:effectRef idx="2">
+            <a:schemeClr val="accent1"/>
+          </a:effectRef>
+          <a:fontRef idx="minor">
+            <a:schemeClr val="lt1"/>
+          </a:fontRef>
+        </p:style>
+        <p:txBody>
+          <a:bodyPr rtlCol="0" anchor="ctr"/>
+          <a:lstStyle/>
+          <a:p>
+            <a:pPr algn="ctr"/>
+          </a:p>
+        </p:txBody>
+      </p:sp>
+      <p:sp>
+        <p:nvSpPr>
+          <p:cNvPr id="34" name="TextBox 33"/>
+          <p:cNvSpPr txBox="1"/>
+          <p:nvPr/>
+        </p:nvSpPr>
+        <p:spPr>
+          <a:xfrm>
+            <a:off x="4907127" y="2157984"/>
+            <a:ext cx="2377440" cy="266273"/>
+          </a:xfrm>
+          <a:prstGeom prst="rect">
+            <a:avLst/>
+          </a:prstGeom>
+          <a:noFill/>
+        </p:spPr>
+        <p:txBody>
+          <a:bodyPr wrap="square" anchor="b" lIns="36576" rIns="36576" tIns="0" bIns="0">
+            <a:spAutoFit/>
+          </a:bodyPr>
+          <a:lstStyle/>
+          <a:p>
+            <a:pPr algn="ctr" rtl="1"/>
+            <a:r>
+              <a:rPr sz="1200" b="1">
+                <a:solidFill>
+                  <a:srgbClr val="1A2233"/>
+                </a:solidFill>
+                <a:latin typeface="Heebo"/>
+                <a:cs typeface="Heebo"/>
+              </a:rPr>
+              <a:t>אדם קורגן</a:t>
+            </a:r>
+          </a:p>
+        </p:txBody>
+      </p:sp>
+      <p:sp>
+        <p:nvSpPr>
+          <p:cNvPr id="35" name="TextBox 34"/>
+          <p:cNvSpPr txBox="1"/>
+          <p:nvPr/>
+        </p:nvSpPr>
+        <p:spPr>
+          <a:xfrm>
+            <a:off x="4907127" y="2384755"/>
+            <a:ext cx="2377440" cy="204825"/>
+          </a:xfrm>
+          <a:prstGeom prst="rect">
+            <a:avLst/>
+          </a:prstGeom>
+          <a:noFill/>
+        </p:spPr>
+        <p:txBody>
+          <a:bodyPr wrap="square" anchor="t" lIns="36576" rIns="36576" tIns="0" bIns="0">
+            <a:spAutoFit/>
+          </a:bodyPr>
+          <a:lstStyle/>
+          <a:p>
+            <a:pPr algn="ctr" rtl="1"/>
+            <a:r>
+              <a:rPr sz="900" b="0">
+                <a:solidFill>
+                  <a:srgbClr val="8A94A8"/>
+                </a:solidFill>
+                <a:latin typeface="Heebo"/>
+                <a:cs typeface="Heebo"/>
+              </a:rPr>
+              <a:t>מנכ״ל</a:t>
+            </a:r>
+          </a:p>
+        </p:txBody>
+      </p:sp>
+      <p:sp>
+        <p:nvSpPr>
+          <p:cNvPr id="36" name="Rounded Rectangle 35"/>
+          <p:cNvSpPr/>
+          <p:nvPr/>
+        </p:nvSpPr>
+        <p:spPr>
+          <a:xfrm>
+            <a:off x="5364327" y="3182112"/>
+            <a:ext cx="5212080" cy="2962656"/>
           </a:xfrm>
           <a:prstGeom prst="roundRect">
             <a:avLst>
@@ -4301,14 +4500,14 @@
       </p:sp>
       <p:sp>
         <p:nvSpPr>
-          <p:cNvPr id="32" name="Rounded Rectangle 31"/>
+          <p:cNvPr id="37" name="Rounded Rectangle 36"/>
           <p:cNvSpPr/>
           <p:nvPr/>
         </p:nvSpPr>
         <p:spPr>
           <a:xfrm>
-            <a:off x="5912967" y="2395728"/>
-            <a:ext cx="2377440" cy="566928"/>
+            <a:off x="6781647" y="2926080"/>
+            <a:ext cx="2377440" cy="512064"/>
           </a:xfrm>
           <a:prstGeom prst="roundRect">
             <a:avLst>
@@ -4349,14 +4548,14 @@
       </p:sp>
       <p:sp>
         <p:nvSpPr>
-          <p:cNvPr id="33" name="Rectangle 32"/>
+          <p:cNvPr id="38" name="Rectangle 37"/>
           <p:cNvSpPr/>
           <p:nvPr/>
         </p:nvSpPr>
         <p:spPr>
           <a:xfrm>
-            <a:off x="8226399" y="2468880"/>
-            <a:ext cx="45720" cy="420624"/>
+            <a:off x="9095079" y="2999232"/>
+            <a:ext cx="45720" cy="365760"/>
           </a:xfrm>
           <a:prstGeom prst="rect">
             <a:avLst/>
@@ -4393,14 +4592,14 @@
       </p:sp>
       <p:sp>
         <p:nvSpPr>
-          <p:cNvPr id="34" name="TextBox 33"/>
+          <p:cNvPr id="39" name="TextBox 38"/>
           <p:cNvSpPr txBox="1"/>
           <p:nvPr/>
         </p:nvSpPr>
         <p:spPr>
           <a:xfrm>
-            <a:off x="5912967" y="2450592"/>
-            <a:ext cx="2377440" cy="294802"/>
+            <a:off x="6781647" y="2980944"/>
+            <a:ext cx="2377440" cy="266273"/>
           </a:xfrm>
           <a:prstGeom prst="rect">
             <a:avLst/>
@@ -4429,14 +4628,14 @@
       </p:sp>
       <p:sp>
         <p:nvSpPr>
-          <p:cNvPr id="35" name="TextBox 34"/>
+          <p:cNvPr id="40" name="TextBox 39"/>
           <p:cNvSpPr txBox="1"/>
           <p:nvPr/>
         </p:nvSpPr>
         <p:spPr>
           <a:xfrm>
-            <a:off x="5912967" y="2707538"/>
-            <a:ext cx="2377440" cy="226771"/>
+            <a:off x="6781647" y="3207715"/>
+            <a:ext cx="2377440" cy="204825"/>
           </a:xfrm>
           <a:prstGeom prst="rect">
             <a:avLst/>
@@ -4465,13 +4664,13 @@
       </p:sp>
       <p:sp>
         <p:nvSpPr>
-          <p:cNvPr id="36" name="Rounded Rectangle 35"/>
+          <p:cNvPr id="41" name="Rounded Rectangle 40"/>
           <p:cNvSpPr/>
           <p:nvPr/>
         </p:nvSpPr>
         <p:spPr>
           <a:xfrm>
-            <a:off x="7988655" y="3255264"/>
+            <a:off x="8857335" y="3675888"/>
             <a:ext cx="1627632" cy="329184"/>
           </a:xfrm>
           <a:prstGeom prst="roundRect">
@@ -4513,13 +4712,13 @@
       </p:sp>
       <p:sp>
         <p:nvSpPr>
-          <p:cNvPr id="37" name="Rectangle 36"/>
+          <p:cNvPr id="42" name="Rectangle 41"/>
           <p:cNvSpPr/>
           <p:nvPr/>
         </p:nvSpPr>
         <p:spPr>
           <a:xfrm>
-            <a:off x="9552279" y="3328416"/>
+            <a:off x="10420959" y="3749040"/>
             <a:ext cx="45720" cy="182880"/>
           </a:xfrm>
           <a:prstGeom prst="rect">
@@ -4557,13 +4756,13 @@
       </p:sp>
       <p:sp>
         <p:nvSpPr>
-          <p:cNvPr id="38" name="TextBox 37"/>
+          <p:cNvPr id="43" name="TextBox 42"/>
           <p:cNvSpPr txBox="1"/>
           <p:nvPr/>
         </p:nvSpPr>
         <p:spPr>
           <a:xfrm>
-            <a:off x="7988655" y="3255264"/>
+            <a:off x="8857335" y="3675888"/>
             <a:ext cx="1627632" cy="329184"/>
           </a:xfrm>
           <a:prstGeom prst="rect">
@@ -4593,13 +4792,13 @@
       </p:sp>
       <p:sp>
         <p:nvSpPr>
-          <p:cNvPr id="39" name="Rounded Rectangle 38"/>
+          <p:cNvPr id="44" name="Rounded Rectangle 43"/>
           <p:cNvSpPr/>
           <p:nvPr/>
         </p:nvSpPr>
         <p:spPr>
           <a:xfrm>
-            <a:off x="6287871" y="3255264"/>
+            <a:off x="7156551" y="3675888"/>
             <a:ext cx="1627632" cy="329184"/>
           </a:xfrm>
           <a:prstGeom prst="roundRect">
@@ -4641,13 +4840,13 @@
       </p:sp>
       <p:sp>
         <p:nvSpPr>
-          <p:cNvPr id="40" name="Rectangle 39"/>
+          <p:cNvPr id="45" name="Rectangle 44"/>
           <p:cNvSpPr/>
           <p:nvPr/>
         </p:nvSpPr>
         <p:spPr>
           <a:xfrm>
-            <a:off x="7851495" y="3328416"/>
+            <a:off x="8720175" y="3749040"/>
             <a:ext cx="45720" cy="182880"/>
           </a:xfrm>
           <a:prstGeom prst="rect">
@@ -4685,13 +4884,13 @@
       </p:sp>
       <p:sp>
         <p:nvSpPr>
-          <p:cNvPr id="41" name="TextBox 40"/>
+          <p:cNvPr id="46" name="TextBox 45"/>
           <p:cNvSpPr txBox="1"/>
           <p:nvPr/>
         </p:nvSpPr>
         <p:spPr>
           <a:xfrm>
-            <a:off x="6287871" y="3255264"/>
+            <a:off x="7156551" y="3675888"/>
             <a:ext cx="1627632" cy="329184"/>
           </a:xfrm>
           <a:prstGeom prst="rect">
@@ -4721,13 +4920,13 @@
       </p:sp>
       <p:sp>
         <p:nvSpPr>
-          <p:cNvPr id="42" name="Rounded Rectangle 41"/>
+          <p:cNvPr id="47" name="Rounded Rectangle 46"/>
           <p:cNvSpPr/>
           <p:nvPr/>
         </p:nvSpPr>
         <p:spPr>
           <a:xfrm>
-            <a:off x="4587087" y="3255264"/>
+            <a:off x="5455767" y="3675888"/>
             <a:ext cx="1627632" cy="329184"/>
           </a:xfrm>
           <a:prstGeom prst="roundRect">
@@ -4769,13 +4968,13 @@
       </p:sp>
       <p:sp>
         <p:nvSpPr>
-          <p:cNvPr id="43" name="Rectangle 42"/>
+          <p:cNvPr id="48" name="Rectangle 47"/>
           <p:cNvSpPr/>
           <p:nvPr/>
         </p:nvSpPr>
         <p:spPr>
           <a:xfrm>
-            <a:off x="6150711" y="3328416"/>
+            <a:off x="7019391" y="3749040"/>
             <a:ext cx="45720" cy="182880"/>
           </a:xfrm>
           <a:prstGeom prst="rect">
@@ -4813,13 +5012,13 @@
       </p:sp>
       <p:sp>
         <p:nvSpPr>
-          <p:cNvPr id="44" name="TextBox 43"/>
+          <p:cNvPr id="49" name="TextBox 48"/>
           <p:cNvSpPr txBox="1"/>
           <p:nvPr/>
         </p:nvSpPr>
         <p:spPr>
           <a:xfrm>
-            <a:off x="4587087" y="3255264"/>
+            <a:off x="5455767" y="3675888"/>
             <a:ext cx="1627632" cy="329184"/>
           </a:xfrm>
           <a:prstGeom prst="rect">
@@ -4849,13 +5048,13 @@
       </p:sp>
       <p:sp>
         <p:nvSpPr>
-          <p:cNvPr id="45" name="Rounded Rectangle 44"/>
+          <p:cNvPr id="50" name="Rounded Rectangle 49"/>
           <p:cNvSpPr/>
           <p:nvPr/>
         </p:nvSpPr>
         <p:spPr>
           <a:xfrm>
-            <a:off x="7988655" y="3657600"/>
+            <a:off x="8857335" y="4078224"/>
             <a:ext cx="1627632" cy="329184"/>
           </a:xfrm>
           <a:prstGeom prst="roundRect">
@@ -4897,13 +5096,13 @@
       </p:sp>
       <p:sp>
         <p:nvSpPr>
-          <p:cNvPr id="46" name="Rectangle 45"/>
+          <p:cNvPr id="51" name="Rectangle 50"/>
           <p:cNvSpPr/>
           <p:nvPr/>
         </p:nvSpPr>
         <p:spPr>
           <a:xfrm>
-            <a:off x="9552279" y="3730752"/>
+            <a:off x="10420959" y="4151376"/>
             <a:ext cx="45720" cy="182880"/>
           </a:xfrm>
           <a:prstGeom prst="rect">
@@ -4941,13 +5140,13 @@
       </p:sp>
       <p:sp>
         <p:nvSpPr>
-          <p:cNvPr id="47" name="TextBox 46"/>
+          <p:cNvPr id="52" name="TextBox 51"/>
           <p:cNvSpPr txBox="1"/>
           <p:nvPr/>
         </p:nvSpPr>
         <p:spPr>
           <a:xfrm>
-            <a:off x="7988655" y="3657600"/>
+            <a:off x="8857335" y="4078224"/>
             <a:ext cx="1627632" cy="329184"/>
           </a:xfrm>
           <a:prstGeom prst="rect">
@@ -4977,13 +5176,13 @@
       </p:sp>
       <p:sp>
         <p:nvSpPr>
-          <p:cNvPr id="48" name="Rounded Rectangle 47"/>
+          <p:cNvPr id="53" name="Rounded Rectangle 52"/>
           <p:cNvSpPr/>
           <p:nvPr/>
         </p:nvSpPr>
         <p:spPr>
           <a:xfrm>
-            <a:off x="6287871" y="3657600"/>
+            <a:off x="7156551" y="4078224"/>
             <a:ext cx="1627632" cy="329184"/>
           </a:xfrm>
           <a:prstGeom prst="roundRect">
@@ -5025,13 +5224,13 @@
       </p:sp>
       <p:sp>
         <p:nvSpPr>
-          <p:cNvPr id="49" name="Rectangle 48"/>
+          <p:cNvPr id="54" name="Rectangle 53"/>
           <p:cNvSpPr/>
           <p:nvPr/>
         </p:nvSpPr>
         <p:spPr>
           <a:xfrm>
-            <a:off x="7851495" y="3730752"/>
+            <a:off x="8720175" y="4151376"/>
             <a:ext cx="45720" cy="182880"/>
           </a:xfrm>
           <a:prstGeom prst="rect">
@@ -5069,13 +5268,13 @@
       </p:sp>
       <p:sp>
         <p:nvSpPr>
-          <p:cNvPr id="50" name="TextBox 49"/>
+          <p:cNvPr id="55" name="TextBox 54"/>
           <p:cNvSpPr txBox="1"/>
           <p:nvPr/>
         </p:nvSpPr>
         <p:spPr>
           <a:xfrm>
-            <a:off x="6287871" y="3657600"/>
+            <a:off x="7156551" y="4078224"/>
             <a:ext cx="1627632" cy="329184"/>
           </a:xfrm>
           <a:prstGeom prst="rect">
@@ -5105,13 +5304,13 @@
       </p:sp>
       <p:sp>
         <p:nvSpPr>
-          <p:cNvPr id="51" name="Rounded Rectangle 50"/>
+          <p:cNvPr id="56" name="Rounded Rectangle 55"/>
           <p:cNvSpPr/>
           <p:nvPr/>
         </p:nvSpPr>
         <p:spPr>
           <a:xfrm>
-            <a:off x="4587087" y="3657600"/>
+            <a:off x="5455767" y="4078224"/>
             <a:ext cx="1627632" cy="329184"/>
           </a:xfrm>
           <a:prstGeom prst="roundRect">
@@ -5153,13 +5352,13 @@
       </p:sp>
       <p:sp>
         <p:nvSpPr>
-          <p:cNvPr id="52" name="Rectangle 51"/>
+          <p:cNvPr id="57" name="Rectangle 56"/>
           <p:cNvSpPr/>
           <p:nvPr/>
         </p:nvSpPr>
         <p:spPr>
           <a:xfrm>
-            <a:off x="6150711" y="3730752"/>
+            <a:off x="7019391" y="4151376"/>
             <a:ext cx="45720" cy="182880"/>
           </a:xfrm>
           <a:prstGeom prst="rect">
@@ -5197,13 +5396,13 @@
       </p:sp>
       <p:sp>
         <p:nvSpPr>
-          <p:cNvPr id="53" name="TextBox 52"/>
+          <p:cNvPr id="58" name="TextBox 57"/>
           <p:cNvSpPr txBox="1"/>
           <p:nvPr/>
         </p:nvSpPr>
         <p:spPr>
           <a:xfrm>
-            <a:off x="4587087" y="3657600"/>
+            <a:off x="5455767" y="4078224"/>
             <a:ext cx="1627632" cy="329184"/>
           </a:xfrm>
           <a:prstGeom prst="rect">
@@ -5233,13 +5432,13 @@
       </p:sp>
       <p:sp>
         <p:nvSpPr>
-          <p:cNvPr id="54" name="Rounded Rectangle 53"/>
+          <p:cNvPr id="59" name="Rounded Rectangle 58"/>
           <p:cNvSpPr/>
           <p:nvPr/>
         </p:nvSpPr>
         <p:spPr>
           <a:xfrm>
-            <a:off x="7988655" y="4059936"/>
+            <a:off x="8857335" y="4480560"/>
             <a:ext cx="1627632" cy="329184"/>
           </a:xfrm>
           <a:prstGeom prst="roundRect">
@@ -5281,13 +5480,13 @@
       </p:sp>
       <p:sp>
         <p:nvSpPr>
-          <p:cNvPr id="55" name="Rectangle 54"/>
+          <p:cNvPr id="60" name="Rectangle 59"/>
           <p:cNvSpPr/>
           <p:nvPr/>
         </p:nvSpPr>
         <p:spPr>
           <a:xfrm>
-            <a:off x="9552279" y="4133088"/>
+            <a:off x="10420959" y="4553712"/>
             <a:ext cx="45720" cy="182880"/>
           </a:xfrm>
           <a:prstGeom prst="rect">
@@ -5325,13 +5524,13 @@
       </p:sp>
       <p:sp>
         <p:nvSpPr>
-          <p:cNvPr id="56" name="TextBox 55"/>
+          <p:cNvPr id="61" name="TextBox 60"/>
           <p:cNvSpPr txBox="1"/>
           <p:nvPr/>
         </p:nvSpPr>
         <p:spPr>
           <a:xfrm>
-            <a:off x="7988655" y="4059936"/>
+            <a:off x="8857335" y="4480560"/>
             <a:ext cx="1627632" cy="329184"/>
           </a:xfrm>
           <a:prstGeom prst="rect">
@@ -5361,13 +5560,13 @@
       </p:sp>
       <p:sp>
         <p:nvSpPr>
-          <p:cNvPr id="57" name="Rounded Rectangle 56"/>
+          <p:cNvPr id="62" name="Rounded Rectangle 61"/>
           <p:cNvSpPr/>
           <p:nvPr/>
         </p:nvSpPr>
         <p:spPr>
           <a:xfrm>
-            <a:off x="6287871" y="4059936"/>
+            <a:off x="7156551" y="4480560"/>
             <a:ext cx="1627632" cy="329184"/>
           </a:xfrm>
           <a:prstGeom prst="roundRect">
@@ -5409,13 +5608,13 @@
       </p:sp>
       <p:sp>
         <p:nvSpPr>
-          <p:cNvPr id="58" name="Rectangle 57"/>
+          <p:cNvPr id="63" name="Rectangle 62"/>
           <p:cNvSpPr/>
           <p:nvPr/>
         </p:nvSpPr>
         <p:spPr>
           <a:xfrm>
-            <a:off x="7851495" y="4133088"/>
+            <a:off x="8720175" y="4553712"/>
             <a:ext cx="45720" cy="182880"/>
           </a:xfrm>
           <a:prstGeom prst="rect">
@@ -5453,13 +5652,13 @@
       </p:sp>
       <p:sp>
         <p:nvSpPr>
-          <p:cNvPr id="59" name="TextBox 58"/>
+          <p:cNvPr id="64" name="TextBox 63"/>
           <p:cNvSpPr txBox="1"/>
           <p:nvPr/>
         </p:nvSpPr>
         <p:spPr>
           <a:xfrm>
-            <a:off x="6287871" y="4059936"/>
+            <a:off x="7156551" y="4480560"/>
             <a:ext cx="1627632" cy="329184"/>
           </a:xfrm>
           <a:prstGeom prst="rect">
@@ -5489,13 +5688,13 @@
       </p:sp>
       <p:sp>
         <p:nvSpPr>
-          <p:cNvPr id="60" name="Rounded Rectangle 59"/>
+          <p:cNvPr id="65" name="Rounded Rectangle 64"/>
           <p:cNvSpPr/>
           <p:nvPr/>
         </p:nvSpPr>
         <p:spPr>
           <a:xfrm>
-            <a:off x="4587087" y="4059936"/>
+            <a:off x="5455767" y="4480560"/>
             <a:ext cx="1627632" cy="329184"/>
           </a:xfrm>
           <a:prstGeom prst="roundRect">
@@ -5537,13 +5736,13 @@
       </p:sp>
       <p:sp>
         <p:nvSpPr>
-          <p:cNvPr id="61" name="Rectangle 60"/>
+          <p:cNvPr id="66" name="Rectangle 65"/>
           <p:cNvSpPr/>
           <p:nvPr/>
         </p:nvSpPr>
         <p:spPr>
           <a:xfrm>
-            <a:off x="6150711" y="4133088"/>
+            <a:off x="7019391" y="4553712"/>
             <a:ext cx="45720" cy="182880"/>
           </a:xfrm>
           <a:prstGeom prst="rect">
@@ -5581,13 +5780,13 @@
       </p:sp>
       <p:sp>
         <p:nvSpPr>
-          <p:cNvPr id="62" name="TextBox 61"/>
+          <p:cNvPr id="67" name="TextBox 66"/>
           <p:cNvSpPr txBox="1"/>
           <p:nvPr/>
         </p:nvSpPr>
         <p:spPr>
           <a:xfrm>
-            <a:off x="4587087" y="4059936"/>
+            <a:off x="5455767" y="4480560"/>
             <a:ext cx="1627632" cy="329184"/>
           </a:xfrm>
           <a:prstGeom prst="rect">
@@ -5617,13 +5816,13 @@
       </p:sp>
       <p:sp>
         <p:nvSpPr>
-          <p:cNvPr id="63" name="Rounded Rectangle 62"/>
+          <p:cNvPr id="68" name="Rounded Rectangle 67"/>
           <p:cNvSpPr/>
           <p:nvPr/>
         </p:nvSpPr>
         <p:spPr>
           <a:xfrm>
-            <a:off x="7988655" y="4462272"/>
+            <a:off x="8857335" y="4882896"/>
             <a:ext cx="1627632" cy="329184"/>
           </a:xfrm>
           <a:prstGeom prst="roundRect">
@@ -5665,13 +5864,13 @@
       </p:sp>
       <p:sp>
         <p:nvSpPr>
-          <p:cNvPr id="64" name="Rectangle 63"/>
+          <p:cNvPr id="69" name="Rectangle 68"/>
           <p:cNvSpPr/>
           <p:nvPr/>
         </p:nvSpPr>
         <p:spPr>
           <a:xfrm>
-            <a:off x="9552279" y="4535424"/>
+            <a:off x="10420959" y="4956048"/>
             <a:ext cx="45720" cy="182880"/>
           </a:xfrm>
           <a:prstGeom prst="rect">
@@ -5709,13 +5908,13 @@
       </p:sp>
       <p:sp>
         <p:nvSpPr>
-          <p:cNvPr id="65" name="TextBox 64"/>
+          <p:cNvPr id="70" name="TextBox 69"/>
           <p:cNvSpPr txBox="1"/>
           <p:nvPr/>
         </p:nvSpPr>
         <p:spPr>
           <a:xfrm>
-            <a:off x="7988655" y="4462272"/>
+            <a:off x="8857335" y="4882896"/>
             <a:ext cx="1627632" cy="329184"/>
           </a:xfrm>
           <a:prstGeom prst="rect">
@@ -5745,13 +5944,13 @@
       </p:sp>
       <p:sp>
         <p:nvSpPr>
-          <p:cNvPr id="66" name="Rounded Rectangle 65"/>
+          <p:cNvPr id="71" name="Rounded Rectangle 70"/>
           <p:cNvSpPr/>
           <p:nvPr/>
         </p:nvSpPr>
         <p:spPr>
           <a:xfrm>
-            <a:off x="6287871" y="4462272"/>
+            <a:off x="7156551" y="4882896"/>
             <a:ext cx="1627632" cy="329184"/>
           </a:xfrm>
           <a:prstGeom prst="roundRect">
@@ -5793,13 +5992,13 @@
       </p:sp>
       <p:sp>
         <p:nvSpPr>
-          <p:cNvPr id="67" name="Rectangle 66"/>
+          <p:cNvPr id="72" name="Rectangle 71"/>
           <p:cNvSpPr/>
           <p:nvPr/>
         </p:nvSpPr>
         <p:spPr>
           <a:xfrm>
-            <a:off x="7851495" y="4535424"/>
+            <a:off x="8720175" y="4956048"/>
             <a:ext cx="45720" cy="182880"/>
           </a:xfrm>
           <a:prstGeom prst="rect">
@@ -5837,13 +6036,13 @@
       </p:sp>
       <p:sp>
         <p:nvSpPr>
-          <p:cNvPr id="68" name="TextBox 67"/>
+          <p:cNvPr id="73" name="TextBox 72"/>
           <p:cNvSpPr txBox="1"/>
           <p:nvPr/>
         </p:nvSpPr>
         <p:spPr>
           <a:xfrm>
-            <a:off x="6287871" y="4462272"/>
+            <a:off x="7156551" y="4882896"/>
             <a:ext cx="1627632" cy="329184"/>
           </a:xfrm>
           <a:prstGeom prst="rect">
@@ -5873,13 +6072,13 @@
       </p:sp>
       <p:sp>
         <p:nvSpPr>
-          <p:cNvPr id="69" name="Rounded Rectangle 68"/>
+          <p:cNvPr id="74" name="Rounded Rectangle 73"/>
           <p:cNvSpPr/>
           <p:nvPr/>
         </p:nvSpPr>
         <p:spPr>
           <a:xfrm>
-            <a:off x="4587087" y="4462272"/>
+            <a:off x="5455767" y="4882896"/>
             <a:ext cx="1627632" cy="329184"/>
           </a:xfrm>
           <a:prstGeom prst="roundRect">
@@ -5921,13 +6120,13 @@
       </p:sp>
       <p:sp>
         <p:nvSpPr>
-          <p:cNvPr id="70" name="Rectangle 69"/>
+          <p:cNvPr id="75" name="Rectangle 74"/>
           <p:cNvSpPr/>
           <p:nvPr/>
         </p:nvSpPr>
         <p:spPr>
           <a:xfrm>
-            <a:off x="6150711" y="4535424"/>
+            <a:off x="7019391" y="4956048"/>
             <a:ext cx="45720" cy="182880"/>
           </a:xfrm>
           <a:prstGeom prst="rect">
@@ -5965,13 +6164,13 @@
       </p:sp>
       <p:sp>
         <p:nvSpPr>
-          <p:cNvPr id="71" name="TextBox 70"/>
+          <p:cNvPr id="76" name="TextBox 75"/>
           <p:cNvSpPr txBox="1"/>
           <p:nvPr/>
         </p:nvSpPr>
         <p:spPr>
           <a:xfrm>
-            <a:off x="4587087" y="4462272"/>
+            <a:off x="5455767" y="4882896"/>
             <a:ext cx="1627632" cy="329184"/>
           </a:xfrm>
           <a:prstGeom prst="rect">
@@ -6001,13 +6200,13 @@
       </p:sp>
       <p:sp>
         <p:nvSpPr>
-          <p:cNvPr id="72" name="Rounded Rectangle 71"/>
+          <p:cNvPr id="77" name="Rounded Rectangle 76"/>
           <p:cNvSpPr/>
           <p:nvPr/>
         </p:nvSpPr>
         <p:spPr>
           <a:xfrm>
-            <a:off x="7988655" y="4864608"/>
+            <a:off x="8857335" y="5285232"/>
             <a:ext cx="1627632" cy="329184"/>
           </a:xfrm>
           <a:prstGeom prst="roundRect">
@@ -6049,13 +6248,13 @@
       </p:sp>
       <p:sp>
         <p:nvSpPr>
-          <p:cNvPr id="73" name="Rectangle 72"/>
+          <p:cNvPr id="78" name="Rectangle 77"/>
           <p:cNvSpPr/>
           <p:nvPr/>
         </p:nvSpPr>
         <p:spPr>
           <a:xfrm>
-            <a:off x="9552279" y="4937760"/>
+            <a:off x="10420959" y="5358384"/>
             <a:ext cx="45720" cy="182880"/>
           </a:xfrm>
           <a:prstGeom prst="rect">
@@ -6093,13 +6292,13 @@
       </p:sp>
       <p:sp>
         <p:nvSpPr>
-          <p:cNvPr id="74" name="TextBox 73"/>
+          <p:cNvPr id="79" name="TextBox 78"/>
           <p:cNvSpPr txBox="1"/>
           <p:nvPr/>
         </p:nvSpPr>
         <p:spPr>
           <a:xfrm>
-            <a:off x="7988655" y="4864608"/>
+            <a:off x="8857335" y="5285232"/>
             <a:ext cx="1627632" cy="329184"/>
           </a:xfrm>
           <a:prstGeom prst="rect">
@@ -6129,13 +6328,13 @@
       </p:sp>
       <p:sp>
         <p:nvSpPr>
-          <p:cNvPr id="75" name="Rounded Rectangle 74"/>
+          <p:cNvPr id="80" name="Rounded Rectangle 79"/>
           <p:cNvSpPr/>
           <p:nvPr/>
         </p:nvSpPr>
         <p:spPr>
           <a:xfrm>
-            <a:off x="6287871" y="4864608"/>
+            <a:off x="7156551" y="5285232"/>
             <a:ext cx="1627632" cy="329184"/>
           </a:xfrm>
           <a:prstGeom prst="roundRect">
@@ -6177,13 +6376,13 @@
       </p:sp>
       <p:sp>
         <p:nvSpPr>
-          <p:cNvPr id="76" name="Rectangle 75"/>
+          <p:cNvPr id="81" name="Rectangle 80"/>
           <p:cNvSpPr/>
           <p:nvPr/>
         </p:nvSpPr>
         <p:spPr>
           <a:xfrm>
-            <a:off x="7851495" y="4937760"/>
+            <a:off x="8720175" y="5358384"/>
             <a:ext cx="45720" cy="182880"/>
           </a:xfrm>
           <a:prstGeom prst="rect">
@@ -6221,13 +6420,13 @@
       </p:sp>
       <p:sp>
         <p:nvSpPr>
-          <p:cNvPr id="77" name="TextBox 76"/>
+          <p:cNvPr id="82" name="TextBox 81"/>
           <p:cNvSpPr txBox="1"/>
           <p:nvPr/>
         </p:nvSpPr>
         <p:spPr>
           <a:xfrm>
-            <a:off x="6287871" y="4864608"/>
+            <a:off x="7156551" y="5285232"/>
             <a:ext cx="1627632" cy="329184"/>
           </a:xfrm>
           <a:prstGeom prst="rect">
@@ -6257,13 +6456,13 @@
       </p:sp>
       <p:sp>
         <p:nvSpPr>
-          <p:cNvPr id="78" name="Rounded Rectangle 77"/>
+          <p:cNvPr id="83" name="Rounded Rectangle 82"/>
           <p:cNvSpPr/>
           <p:nvPr/>
         </p:nvSpPr>
         <p:spPr>
           <a:xfrm>
-            <a:off x="4587087" y="4864608"/>
+            <a:off x="5455767" y="5285232"/>
             <a:ext cx="1627632" cy="329184"/>
           </a:xfrm>
           <a:prstGeom prst="roundRect">
@@ -6305,13 +6504,13 @@
       </p:sp>
       <p:sp>
         <p:nvSpPr>
-          <p:cNvPr id="79" name="Rectangle 78"/>
+          <p:cNvPr id="84" name="Rectangle 83"/>
           <p:cNvSpPr/>
           <p:nvPr/>
         </p:nvSpPr>
         <p:spPr>
           <a:xfrm>
-            <a:off x="6150711" y="4937760"/>
+            <a:off x="7019391" y="5358384"/>
             <a:ext cx="45720" cy="182880"/>
           </a:xfrm>
           <a:prstGeom prst="rect">
@@ -6349,13 +6548,13 @@
       </p:sp>
       <p:sp>
         <p:nvSpPr>
-          <p:cNvPr id="80" name="TextBox 79"/>
+          <p:cNvPr id="85" name="TextBox 84"/>
           <p:cNvSpPr txBox="1"/>
           <p:nvPr/>
         </p:nvSpPr>
         <p:spPr>
           <a:xfrm>
-            <a:off x="4587087" y="4864608"/>
+            <a:off x="5455767" y="5285232"/>
             <a:ext cx="1627632" cy="329184"/>
           </a:xfrm>
           <a:prstGeom prst="rect">
@@ -6385,13 +6584,13 @@
       </p:sp>
       <p:sp>
         <p:nvSpPr>
-          <p:cNvPr id="81" name="Rounded Rectangle 80"/>
+          <p:cNvPr id="86" name="Rounded Rectangle 85"/>
           <p:cNvSpPr/>
           <p:nvPr/>
         </p:nvSpPr>
         <p:spPr>
           <a:xfrm>
-            <a:off x="7988655" y="5266944"/>
+            <a:off x="8857335" y="5687568"/>
             <a:ext cx="1627632" cy="329184"/>
           </a:xfrm>
           <a:prstGeom prst="roundRect">
@@ -6433,13 +6632,13 @@
       </p:sp>
       <p:sp>
         <p:nvSpPr>
-          <p:cNvPr id="82" name="Rectangle 81"/>
+          <p:cNvPr id="87" name="Rectangle 86"/>
           <p:cNvSpPr/>
           <p:nvPr/>
         </p:nvSpPr>
         <p:spPr>
           <a:xfrm>
-            <a:off x="9552279" y="5340096"/>
+            <a:off x="10420959" y="5760720"/>
             <a:ext cx="45720" cy="182880"/>
           </a:xfrm>
           <a:prstGeom prst="rect">
@@ -6477,13 +6676,13 @@
       </p:sp>
       <p:sp>
         <p:nvSpPr>
-          <p:cNvPr id="83" name="TextBox 82"/>
+          <p:cNvPr id="88" name="TextBox 87"/>
           <p:cNvSpPr txBox="1"/>
           <p:nvPr/>
         </p:nvSpPr>
         <p:spPr>
           <a:xfrm>
-            <a:off x="7988655" y="5266944"/>
+            <a:off x="8857335" y="5687568"/>
             <a:ext cx="1627632" cy="329184"/>
           </a:xfrm>
           <a:prstGeom prst="rect">
@@ -6513,13 +6712,13 @@
       </p:sp>
       <p:sp>
         <p:nvSpPr>
-          <p:cNvPr id="84" name="Rounded Rectangle 83"/>
+          <p:cNvPr id="89" name="Rounded Rectangle 88"/>
           <p:cNvSpPr/>
           <p:nvPr/>
         </p:nvSpPr>
         <p:spPr>
           <a:xfrm>
-            <a:off x="6287871" y="5266944"/>
+            <a:off x="7156551" y="5687568"/>
             <a:ext cx="1627632" cy="329184"/>
           </a:xfrm>
           <a:prstGeom prst="roundRect">
@@ -6561,13 +6760,13 @@
       </p:sp>
       <p:sp>
         <p:nvSpPr>
-          <p:cNvPr id="85" name="Rectangle 84"/>
+          <p:cNvPr id="90" name="Rectangle 89"/>
           <p:cNvSpPr/>
           <p:nvPr/>
         </p:nvSpPr>
         <p:spPr>
           <a:xfrm>
-            <a:off x="7851495" y="5340096"/>
+            <a:off x="8720175" y="5760720"/>
             <a:ext cx="45720" cy="182880"/>
           </a:xfrm>
           <a:prstGeom prst="rect">
@@ -6605,13 +6804,13 @@
       </p:sp>
       <p:sp>
         <p:nvSpPr>
-          <p:cNvPr id="86" name="TextBox 85"/>
+          <p:cNvPr id="91" name="TextBox 90"/>
           <p:cNvSpPr txBox="1"/>
           <p:nvPr/>
         </p:nvSpPr>
         <p:spPr>
           <a:xfrm>
-            <a:off x="6287871" y="5266944"/>
+            <a:off x="7156551" y="5687568"/>
             <a:ext cx="1627632" cy="329184"/>
           </a:xfrm>
           <a:prstGeom prst="rect">
@@ -6641,13 +6840,13 @@
       </p:sp>
       <p:sp>
         <p:nvSpPr>
-          <p:cNvPr id="87" name="Rounded Rectangle 86"/>
+          <p:cNvPr id="92" name="Rounded Rectangle 91"/>
           <p:cNvSpPr/>
           <p:nvPr/>
         </p:nvSpPr>
         <p:spPr>
           <a:xfrm>
-            <a:off x="4587087" y="5266944"/>
+            <a:off x="5455767" y="5687568"/>
             <a:ext cx="1627632" cy="329184"/>
           </a:xfrm>
           <a:prstGeom prst="roundRect">
@@ -6689,13 +6888,13 @@
       </p:sp>
       <p:sp>
         <p:nvSpPr>
-          <p:cNvPr id="88" name="Rectangle 87"/>
+          <p:cNvPr id="93" name="Rectangle 92"/>
           <p:cNvSpPr/>
           <p:nvPr/>
         </p:nvSpPr>
         <p:spPr>
           <a:xfrm>
-            <a:off x="6150711" y="5340096"/>
+            <a:off x="7019391" y="5760720"/>
             <a:ext cx="45720" cy="182880"/>
           </a:xfrm>
           <a:prstGeom prst="rect">
@@ -6733,13 +6932,13 @@
       </p:sp>
       <p:sp>
         <p:nvSpPr>
-          <p:cNvPr id="89" name="TextBox 88"/>
+          <p:cNvPr id="94" name="TextBox 93"/>
           <p:cNvSpPr txBox="1"/>
           <p:nvPr/>
         </p:nvSpPr>
         <p:spPr>
           <a:xfrm>
-            <a:off x="4587087" y="5266944"/>
+            <a:off x="5455767" y="5687568"/>
             <a:ext cx="1627632" cy="329184"/>
           </a:xfrm>
           <a:prstGeom prst="rect">
@@ -6769,14 +6968,14 @@
       </p:sp>
       <p:sp>
         <p:nvSpPr>
-          <p:cNvPr id="90" name="Rounded Rectangle 89"/>
+          <p:cNvPr id="95" name="Rounded Rectangle 94"/>
           <p:cNvSpPr/>
           <p:nvPr/>
         </p:nvSpPr>
         <p:spPr>
           <a:xfrm>
-            <a:off x="2483967" y="2679192"/>
-            <a:ext cx="1737360" cy="3447288"/>
+            <a:off x="1615287" y="3182112"/>
+            <a:ext cx="3474720" cy="2157984"/>
           </a:xfrm>
           <a:prstGeom prst="roundRect">
             <a:avLst>
@@ -6815,14 +7014,14 @@
       </p:sp>
       <p:sp>
         <p:nvSpPr>
-          <p:cNvPr id="91" name="Rounded Rectangle 90"/>
+          <p:cNvPr id="96" name="Rounded Rectangle 95"/>
           <p:cNvSpPr/>
           <p:nvPr/>
         </p:nvSpPr>
         <p:spPr>
           <a:xfrm>
-            <a:off x="2575407" y="2395728"/>
-            <a:ext cx="1554480" cy="566928"/>
+            <a:off x="2163927" y="2926080"/>
+            <a:ext cx="2377440" cy="512064"/>
           </a:xfrm>
           <a:prstGeom prst="roundRect">
             <a:avLst>
@@ -6863,14 +7062,14 @@
       </p:sp>
       <p:sp>
         <p:nvSpPr>
-          <p:cNvPr id="92" name="Rectangle 91"/>
+          <p:cNvPr id="97" name="Rectangle 96"/>
           <p:cNvSpPr/>
           <p:nvPr/>
         </p:nvSpPr>
         <p:spPr>
           <a:xfrm>
-            <a:off x="4065879" y="2468880"/>
-            <a:ext cx="45720" cy="420624"/>
+            <a:off x="4477359" y="2999232"/>
+            <a:ext cx="45720" cy="365760"/>
           </a:xfrm>
           <a:prstGeom prst="rect">
             <a:avLst/>
@@ -6907,14 +7106,14 @@
       </p:sp>
       <p:sp>
         <p:nvSpPr>
-          <p:cNvPr id="93" name="TextBox 92"/>
+          <p:cNvPr id="98" name="TextBox 97"/>
           <p:cNvSpPr txBox="1"/>
           <p:nvPr/>
         </p:nvSpPr>
         <p:spPr>
           <a:xfrm>
-            <a:off x="2575407" y="2450592"/>
-            <a:ext cx="1554480" cy="294802"/>
+            <a:off x="2163927" y="2980944"/>
+            <a:ext cx="2377440" cy="266273"/>
           </a:xfrm>
           <a:prstGeom prst="rect">
             <a:avLst/>
@@ -6943,14 +7142,14 @@
       </p:sp>
       <p:sp>
         <p:nvSpPr>
-          <p:cNvPr id="94" name="TextBox 93"/>
+          <p:cNvPr id="99" name="TextBox 98"/>
           <p:cNvSpPr txBox="1"/>
           <p:nvPr/>
         </p:nvSpPr>
         <p:spPr>
           <a:xfrm>
-            <a:off x="2575407" y="2707538"/>
-            <a:ext cx="1554480" cy="226771"/>
+            <a:off x="2163927" y="3207715"/>
+            <a:ext cx="2377440" cy="204825"/>
           </a:xfrm>
           <a:prstGeom prst="rect">
             <a:avLst/>
@@ -6979,14 +7178,14 @@
       </p:sp>
       <p:sp>
         <p:nvSpPr>
-          <p:cNvPr id="95" name="Rounded Rectangle 94"/>
+          <p:cNvPr id="100" name="Rounded Rectangle 99"/>
           <p:cNvSpPr/>
           <p:nvPr/>
         </p:nvSpPr>
         <p:spPr>
           <a:xfrm>
-            <a:off x="2575407" y="3255264"/>
-            <a:ext cx="1554480" cy="329184"/>
+            <a:off x="3389223" y="3675888"/>
+            <a:ext cx="1609344" cy="329184"/>
           </a:xfrm>
           <a:prstGeom prst="roundRect">
             <a:avLst>
@@ -7027,13 +7226,13 @@
       </p:sp>
       <p:sp>
         <p:nvSpPr>
-          <p:cNvPr id="96" name="Rectangle 95"/>
+          <p:cNvPr id="101" name="Rectangle 100"/>
           <p:cNvSpPr/>
           <p:nvPr/>
         </p:nvSpPr>
         <p:spPr>
           <a:xfrm>
-            <a:off x="4065879" y="3328416"/>
+            <a:off x="4934559" y="3749040"/>
             <a:ext cx="45720" cy="182880"/>
           </a:xfrm>
           <a:prstGeom prst="rect">
@@ -7071,14 +7270,14 @@
       </p:sp>
       <p:sp>
         <p:nvSpPr>
-          <p:cNvPr id="97" name="TextBox 96"/>
+          <p:cNvPr id="102" name="TextBox 101"/>
           <p:cNvSpPr txBox="1"/>
           <p:nvPr/>
         </p:nvSpPr>
         <p:spPr>
           <a:xfrm>
-            <a:off x="2575407" y="3255264"/>
-            <a:ext cx="1554480" cy="329184"/>
+            <a:off x="3389223" y="3675888"/>
+            <a:ext cx="1609344" cy="329184"/>
           </a:xfrm>
           <a:prstGeom prst="rect">
             <a:avLst/>
@@ -7107,14 +7306,14 @@
       </p:sp>
       <p:sp>
         <p:nvSpPr>
-          <p:cNvPr id="98" name="Rounded Rectangle 97"/>
+          <p:cNvPr id="103" name="Rounded Rectangle 102"/>
           <p:cNvSpPr/>
           <p:nvPr/>
         </p:nvSpPr>
         <p:spPr>
           <a:xfrm>
-            <a:off x="2575407" y="3657600"/>
-            <a:ext cx="1554480" cy="329184"/>
+            <a:off x="1706727" y="3675888"/>
+            <a:ext cx="1609344" cy="329184"/>
           </a:xfrm>
           <a:prstGeom prst="roundRect">
             <a:avLst>
@@ -7155,13 +7354,13 @@
       </p:sp>
       <p:sp>
         <p:nvSpPr>
-          <p:cNvPr id="99" name="Rectangle 98"/>
+          <p:cNvPr id="104" name="Rectangle 103"/>
           <p:cNvSpPr/>
           <p:nvPr/>
         </p:nvSpPr>
         <p:spPr>
           <a:xfrm>
-            <a:off x="4065879" y="3730752"/>
+            <a:off x="3252063" y="3749040"/>
             <a:ext cx="45720" cy="182880"/>
           </a:xfrm>
           <a:prstGeom prst="rect">
@@ -7199,14 +7398,14 @@
       </p:sp>
       <p:sp>
         <p:nvSpPr>
-          <p:cNvPr id="100" name="TextBox 99"/>
+          <p:cNvPr id="105" name="TextBox 104"/>
           <p:cNvSpPr txBox="1"/>
           <p:nvPr/>
         </p:nvSpPr>
         <p:spPr>
           <a:xfrm>
-            <a:off x="2575407" y="3657600"/>
-            <a:ext cx="1554480" cy="329184"/>
+            <a:off x="1706727" y="3675888"/>
+            <a:ext cx="1609344" cy="329184"/>
           </a:xfrm>
           <a:prstGeom prst="rect">
             <a:avLst/>
@@ -7235,14 +7434,14 @@
       </p:sp>
       <p:sp>
         <p:nvSpPr>
-          <p:cNvPr id="101" name="Rounded Rectangle 100"/>
+          <p:cNvPr id="106" name="Rounded Rectangle 105"/>
           <p:cNvSpPr/>
           <p:nvPr/>
         </p:nvSpPr>
         <p:spPr>
           <a:xfrm>
-            <a:off x="2575407" y="4059936"/>
-            <a:ext cx="1554480" cy="329184"/>
+            <a:off x="3389223" y="4078224"/>
+            <a:ext cx="1609344" cy="329184"/>
           </a:xfrm>
           <a:prstGeom prst="roundRect">
             <a:avLst>
@@ -7283,13 +7482,13 @@
       </p:sp>
       <p:sp>
         <p:nvSpPr>
-          <p:cNvPr id="102" name="Rectangle 101"/>
+          <p:cNvPr id="107" name="Rectangle 106"/>
           <p:cNvSpPr/>
           <p:nvPr/>
         </p:nvSpPr>
         <p:spPr>
           <a:xfrm>
-            <a:off x="4065879" y="4133088"/>
+            <a:off x="4934559" y="4151376"/>
             <a:ext cx="45720" cy="182880"/>
           </a:xfrm>
           <a:prstGeom prst="rect">
@@ -7327,14 +7526,14 @@
       </p:sp>
       <p:sp>
         <p:nvSpPr>
-          <p:cNvPr id="103" name="TextBox 102"/>
+          <p:cNvPr id="108" name="TextBox 107"/>
           <p:cNvSpPr txBox="1"/>
           <p:nvPr/>
         </p:nvSpPr>
         <p:spPr>
           <a:xfrm>
-            <a:off x="2575407" y="4059936"/>
-            <a:ext cx="1554480" cy="329184"/>
+            <a:off x="3389223" y="4078224"/>
+            <a:ext cx="1609344" cy="329184"/>
           </a:xfrm>
           <a:prstGeom prst="rect">
             <a:avLst/>
@@ -7363,14 +7562,14 @@
       </p:sp>
       <p:sp>
         <p:nvSpPr>
-          <p:cNvPr id="104" name="Rounded Rectangle 103"/>
+          <p:cNvPr id="109" name="Rounded Rectangle 108"/>
           <p:cNvSpPr/>
           <p:nvPr/>
         </p:nvSpPr>
         <p:spPr>
           <a:xfrm>
-            <a:off x="2575407" y="4462272"/>
-            <a:ext cx="1554480" cy="329184"/>
+            <a:off x="1706727" y="4078224"/>
+            <a:ext cx="1609344" cy="329184"/>
           </a:xfrm>
           <a:prstGeom prst="roundRect">
             <a:avLst>
@@ -7411,13 +7610,13 @@
       </p:sp>
       <p:sp>
         <p:nvSpPr>
-          <p:cNvPr id="105" name="Rectangle 104"/>
+          <p:cNvPr id="110" name="Rectangle 109"/>
           <p:cNvSpPr/>
           <p:nvPr/>
         </p:nvSpPr>
         <p:spPr>
           <a:xfrm>
-            <a:off x="4065879" y="4535424"/>
+            <a:off x="3252063" y="4151376"/>
             <a:ext cx="45720" cy="182880"/>
           </a:xfrm>
           <a:prstGeom prst="rect">
@@ -7455,14 +7654,14 @@
       </p:sp>
       <p:sp>
         <p:nvSpPr>
-          <p:cNvPr id="106" name="TextBox 105"/>
+          <p:cNvPr id="111" name="TextBox 110"/>
           <p:cNvSpPr txBox="1"/>
           <p:nvPr/>
         </p:nvSpPr>
         <p:spPr>
           <a:xfrm>
-            <a:off x="2575407" y="4462272"/>
-            <a:ext cx="1554480" cy="329184"/>
+            <a:off x="1706727" y="4078224"/>
+            <a:ext cx="1609344" cy="329184"/>
           </a:xfrm>
           <a:prstGeom prst="rect">
             <a:avLst/>
@@ -7491,14 +7690,14 @@
       </p:sp>
       <p:sp>
         <p:nvSpPr>
-          <p:cNvPr id="107" name="Rounded Rectangle 106"/>
+          <p:cNvPr id="112" name="Rounded Rectangle 111"/>
           <p:cNvSpPr/>
           <p:nvPr/>
         </p:nvSpPr>
         <p:spPr>
           <a:xfrm>
-            <a:off x="2575407" y="4864608"/>
-            <a:ext cx="1554480" cy="329184"/>
+            <a:off x="3389223" y="4480560"/>
+            <a:ext cx="1609344" cy="329184"/>
           </a:xfrm>
           <a:prstGeom prst="roundRect">
             <a:avLst>
@@ -7539,13 +7738,13 @@
       </p:sp>
       <p:sp>
         <p:nvSpPr>
-          <p:cNvPr id="108" name="Rectangle 107"/>
+          <p:cNvPr id="113" name="Rectangle 112"/>
           <p:cNvSpPr/>
           <p:nvPr/>
         </p:nvSpPr>
         <p:spPr>
           <a:xfrm>
-            <a:off x="4065879" y="4937760"/>
+            <a:off x="4934559" y="4553712"/>
             <a:ext cx="45720" cy="182880"/>
           </a:xfrm>
           <a:prstGeom prst="rect">
@@ -7583,14 +7782,14 @@
       </p:sp>
       <p:sp>
         <p:nvSpPr>
-          <p:cNvPr id="109" name="TextBox 108"/>
+          <p:cNvPr id="114" name="TextBox 113"/>
           <p:cNvSpPr txBox="1"/>
           <p:nvPr/>
         </p:nvSpPr>
         <p:spPr>
           <a:xfrm>
-            <a:off x="2575407" y="4864608"/>
-            <a:ext cx="1554480" cy="329184"/>
+            <a:off x="3389223" y="4480560"/>
+            <a:ext cx="1609344" cy="329184"/>
           </a:xfrm>
           <a:prstGeom prst="rect">
             <a:avLst/>
@@ -7619,14 +7818,14 @@
       </p:sp>
       <p:sp>
         <p:nvSpPr>
-          <p:cNvPr id="110" name="Rounded Rectangle 109"/>
+          <p:cNvPr id="115" name="Rounded Rectangle 114"/>
           <p:cNvSpPr/>
           <p:nvPr/>
         </p:nvSpPr>
         <p:spPr>
           <a:xfrm>
-            <a:off x="2575407" y="5266944"/>
-            <a:ext cx="1554480" cy="329184"/>
+            <a:off x="1706727" y="4480560"/>
+            <a:ext cx="1609344" cy="329184"/>
           </a:xfrm>
           <a:prstGeom prst="roundRect">
             <a:avLst>
@@ -7667,13 +7866,13 @@
       </p:sp>
       <p:sp>
         <p:nvSpPr>
-          <p:cNvPr id="111" name="Rectangle 110"/>
+          <p:cNvPr id="116" name="Rectangle 115"/>
           <p:cNvSpPr/>
           <p:nvPr/>
         </p:nvSpPr>
         <p:spPr>
           <a:xfrm>
-            <a:off x="4065879" y="5340096"/>
+            <a:off x="3252063" y="4553712"/>
             <a:ext cx="45720" cy="182880"/>
           </a:xfrm>
           <a:prstGeom prst="rect">
@@ -7711,14 +7910,14 @@
       </p:sp>
       <p:sp>
         <p:nvSpPr>
-          <p:cNvPr id="112" name="TextBox 111"/>
+          <p:cNvPr id="117" name="TextBox 116"/>
           <p:cNvSpPr txBox="1"/>
           <p:nvPr/>
         </p:nvSpPr>
         <p:spPr>
           <a:xfrm>
-            <a:off x="2575407" y="5266944"/>
-            <a:ext cx="1554480" cy="329184"/>
+            <a:off x="1706727" y="4480560"/>
+            <a:ext cx="1609344" cy="329184"/>
           </a:xfrm>
           <a:prstGeom prst="rect">
             <a:avLst/>
@@ -7747,14 +7946,14 @@
       </p:sp>
       <p:sp>
         <p:nvSpPr>
-          <p:cNvPr id="113" name="Rounded Rectangle 112"/>
+          <p:cNvPr id="118" name="Rounded Rectangle 117"/>
           <p:cNvSpPr/>
           <p:nvPr/>
         </p:nvSpPr>
         <p:spPr>
           <a:xfrm>
-            <a:off x="2575407" y="5669280"/>
-            <a:ext cx="1554480" cy="329184"/>
+            <a:off x="3389223" y="4882896"/>
+            <a:ext cx="1609344" cy="329184"/>
           </a:xfrm>
           <a:prstGeom prst="roundRect">
             <a:avLst>
@@ -7795,13 +7994,13 @@
       </p:sp>
       <p:sp>
         <p:nvSpPr>
-          <p:cNvPr id="114" name="Rectangle 113"/>
+          <p:cNvPr id="119" name="Rectangle 118"/>
           <p:cNvSpPr/>
           <p:nvPr/>
         </p:nvSpPr>
         <p:spPr>
           <a:xfrm>
-            <a:off x="4065879" y="5742432"/>
+            <a:off x="4934559" y="4956048"/>
             <a:ext cx="45720" cy="182880"/>
           </a:xfrm>
           <a:prstGeom prst="rect">
@@ -7839,14 +8038,14 @@
       </p:sp>
       <p:sp>
         <p:nvSpPr>
-          <p:cNvPr id="115" name="TextBox 114"/>
+          <p:cNvPr id="120" name="TextBox 119"/>
           <p:cNvSpPr txBox="1"/>
           <p:nvPr/>
         </p:nvSpPr>
         <p:spPr>
           <a:xfrm>
-            <a:off x="2575407" y="5669280"/>
-            <a:ext cx="1554480" cy="329184"/>
+            <a:off x="3389223" y="4882896"/>
+            <a:ext cx="1609344" cy="329184"/>
           </a:xfrm>
           <a:prstGeom prst="rect">
             <a:avLst/>
@@ -7875,14 +8074,14 @@
       </p:sp>
       <p:cxnSp>
         <p:nvCxnSpPr>
-          <p:cNvPr id="116" name="Connector 115"/>
+          <p:cNvPr id="121" name="Connector 120"/>
           <p:cNvCxnSpPr/>
           <p:nvPr/>
         </p:nvCxnSpPr>
         <p:spPr>
           <a:xfrm>
-            <a:off x="6095847" y="1901952"/>
-            <a:ext cx="0" cy="256032"/>
+            <a:off x="6095847" y="2615184"/>
+            <a:ext cx="0" cy="155448"/>
           </a:xfrm>
           <a:prstGeom prst="line">
             <a:avLst/>
@@ -7910,14 +8109,14 @@
       </p:cxnSp>
       <p:cxnSp>
         <p:nvCxnSpPr>
-          <p:cNvPr id="117" name="Connector 116"/>
+          <p:cNvPr id="122" name="Connector 121"/>
           <p:cNvCxnSpPr/>
           <p:nvPr/>
         </p:nvCxnSpPr>
         <p:spPr>
           <a:xfrm>
-            <a:off x="3352647" y="2157984"/>
-            <a:ext cx="3749040" cy="0"/>
+            <a:off x="3352647" y="2770632"/>
+            <a:ext cx="4617720" cy="0"/>
           </a:xfrm>
           <a:prstGeom prst="line">
             <a:avLst/>
@@ -7945,14 +8144,14 @@
       </p:cxnSp>
       <p:cxnSp>
         <p:nvCxnSpPr>
-          <p:cNvPr id="118" name="Connector 117"/>
+          <p:cNvPr id="123" name="Connector 122"/>
           <p:cNvCxnSpPr/>
           <p:nvPr/>
         </p:nvCxnSpPr>
         <p:spPr>
           <a:xfrm>
-            <a:off x="7101687" y="2157984"/>
-            <a:ext cx="0" cy="237744"/>
+            <a:off x="7970367" y="2770632"/>
+            <a:ext cx="0" cy="155448"/>
           </a:xfrm>
           <a:prstGeom prst="line">
             <a:avLst/>
@@ -7980,14 +8179,14 @@
       </p:cxnSp>
       <p:cxnSp>
         <p:nvCxnSpPr>
-          <p:cNvPr id="119" name="Connector 118"/>
+          <p:cNvPr id="124" name="Connector 123"/>
           <p:cNvCxnSpPr/>
           <p:nvPr/>
         </p:nvCxnSpPr>
         <p:spPr>
           <a:xfrm>
-            <a:off x="3352647" y="2157984"/>
-            <a:ext cx="0" cy="237744"/>
+            <a:off x="3352647" y="2770632"/>
+            <a:ext cx="0" cy="155448"/>
           </a:xfrm>
           <a:prstGeom prst="line">
             <a:avLst/>
@@ -9131,16 +9330,169 @@
           </a:p>
         </p:txBody>
       </p:sp>
-      <p:sp>
-        <p:nvSpPr>
-          <p:cNvPr id="30" name="Rounded Rectangle 29"/>
+      <p:cxnSp>
+        <p:nvCxnSpPr>
+          <p:cNvPr id="30" name="Connector 29"/>
+          <p:cNvCxnSpPr/>
+          <p:nvPr/>
+        </p:nvCxnSpPr>
+        <p:spPr>
+          <a:xfrm>
+            <a:off x="6095847" y="1901952"/>
+            <a:ext cx="0" cy="201168"/>
+          </a:xfrm>
+          <a:prstGeom prst="line">
+            <a:avLst/>
+          </a:prstGeom>
+          <a:ln w="19050">
+            <a:solidFill>
+              <a:srgbClr val="C5CDDD"/>
+            </a:solidFill>
+          </a:ln>
+        </p:spPr>
+        <p:style>
+          <a:lnRef idx="2">
+            <a:schemeClr val="accent1"/>
+          </a:lnRef>
+          <a:fillRef idx="0">
+            <a:schemeClr val="accent1"/>
+          </a:fillRef>
+          <a:effectRef idx="1">
+            <a:schemeClr val="accent1"/>
+          </a:effectRef>
+          <a:fontRef idx="minor">
+            <a:schemeClr val="tx1"/>
+          </a:fontRef>
+        </p:style>
+      </p:cxnSp>
+      <p:sp>
+        <p:nvSpPr>
+          <p:cNvPr id="31" name="Rounded Rectangle 30"/>
           <p:cNvSpPr/>
           <p:nvPr/>
         </p:nvSpPr>
         <p:spPr>
           <a:xfrm>
-            <a:off x="4495647" y="2679192"/>
-            <a:ext cx="5212080" cy="3044952"/>
+            <a:off x="4907127" y="2103120"/>
+            <a:ext cx="2377440" cy="512064"/>
+          </a:xfrm>
+          <a:prstGeom prst="roundRect">
+            <a:avLst>
+              <a:gd name="adj" fmla="val 18000"/>
+            </a:avLst>
+          </a:prstGeom>
+          <a:solidFill>
+            <a:srgbClr val="B4BCCC"/>
+          </a:solidFill>
+          <a:ln>
+            <a:noFill/>
+          </a:ln>
+          <a:effectLst/>
+        </p:spPr>
+        <p:style>
+          <a:lnRef idx="1">
+            <a:schemeClr val="accent1"/>
+          </a:lnRef>
+          <a:fillRef idx="3">
+            <a:schemeClr val="accent1"/>
+          </a:fillRef>
+          <a:effectRef idx="2">
+            <a:schemeClr val="accent1"/>
+          </a:effectRef>
+          <a:fontRef idx="minor">
+            <a:schemeClr val="lt1"/>
+          </a:fontRef>
+        </p:style>
+        <p:txBody>
+          <a:bodyPr rtlCol="0" anchor="ctr"/>
+          <a:lstStyle/>
+          <a:p>
+            <a:pPr algn="ctr"/>
+          </a:p>
+        </p:txBody>
+      </p:sp>
+      <p:sp>
+        <p:nvSpPr>
+          <p:cNvPr id="32" name="TextBox 31"/>
+          <p:cNvSpPr txBox="1"/>
+          <p:nvPr/>
+        </p:nvSpPr>
+        <p:spPr>
+          <a:xfrm>
+            <a:off x="4907127" y="2157984"/>
+            <a:ext cx="2377440" cy="266273"/>
+          </a:xfrm>
+          <a:prstGeom prst="rect">
+            <a:avLst/>
+          </a:prstGeom>
+          <a:noFill/>
+        </p:spPr>
+        <p:txBody>
+          <a:bodyPr wrap="square" anchor="b" lIns="36576" rIns="36576" tIns="0" bIns="0">
+            <a:spAutoFit/>
+          </a:bodyPr>
+          <a:lstStyle/>
+          <a:p>
+            <a:pPr algn="ctr" rtl="1"/>
+            <a:r>
+              <a:rPr sz="1200" b="1">
+                <a:solidFill>
+                  <a:srgbClr val="FFFFFF"/>
+                </a:solidFill>
+                <a:latin typeface="Heebo"/>
+                <a:cs typeface="Heebo"/>
+              </a:rPr>
+              <a:t>אדם קורגן</a:t>
+            </a:r>
+          </a:p>
+        </p:txBody>
+      </p:sp>
+      <p:sp>
+        <p:nvSpPr>
+          <p:cNvPr id="33" name="TextBox 32"/>
+          <p:cNvSpPr txBox="1"/>
+          <p:nvPr/>
+        </p:nvSpPr>
+        <p:spPr>
+          <a:xfrm>
+            <a:off x="4907127" y="2384755"/>
+            <a:ext cx="2377440" cy="204825"/>
+          </a:xfrm>
+          <a:prstGeom prst="rect">
+            <a:avLst/>
+          </a:prstGeom>
+          <a:noFill/>
+        </p:spPr>
+        <p:txBody>
+          <a:bodyPr wrap="square" anchor="t" lIns="36576" rIns="36576" tIns="0" bIns="0">
+            <a:spAutoFit/>
+          </a:bodyPr>
+          <a:lstStyle/>
+          <a:p>
+            <a:pPr algn="ctr" rtl="1"/>
+            <a:r>
+              <a:rPr sz="900" b="0">
+                <a:solidFill>
+                  <a:srgbClr val="FFFFFF"/>
+                </a:solidFill>
+                <a:latin typeface="Heebo"/>
+                <a:cs typeface="Heebo"/>
+              </a:rPr>
+              <a:t>מנכ״ל</a:t>
+            </a:r>
+          </a:p>
+        </p:txBody>
+      </p:sp>
+      <p:sp>
+        <p:nvSpPr>
+          <p:cNvPr id="34" name="Rounded Rectangle 33"/>
+          <p:cNvSpPr/>
+          <p:nvPr/>
+        </p:nvSpPr>
+        <p:spPr>
+          <a:xfrm>
+            <a:off x="5364327" y="3182112"/>
+            <a:ext cx="5212080" cy="2962656"/>
           </a:xfrm>
           <a:prstGeom prst="roundRect">
             <a:avLst>
@@ -9179,14 +9531,14 @@
       </p:sp>
       <p:sp>
         <p:nvSpPr>
-          <p:cNvPr id="31" name="Rounded Rectangle 30"/>
+          <p:cNvPr id="35" name="Rounded Rectangle 34"/>
           <p:cNvSpPr/>
           <p:nvPr/>
         </p:nvSpPr>
         <p:spPr>
           <a:xfrm>
-            <a:off x="5912967" y="2395728"/>
-            <a:ext cx="2377440" cy="566928"/>
+            <a:off x="6781647" y="2926080"/>
+            <a:ext cx="2377440" cy="512064"/>
           </a:xfrm>
           <a:prstGeom prst="roundRect">
             <a:avLst>
@@ -9225,14 +9577,14 @@
       </p:sp>
       <p:sp>
         <p:nvSpPr>
-          <p:cNvPr id="32" name="TextBox 31"/>
+          <p:cNvPr id="36" name="TextBox 35"/>
           <p:cNvSpPr txBox="1"/>
           <p:nvPr/>
         </p:nvSpPr>
         <p:spPr>
           <a:xfrm>
-            <a:off x="5912967" y="2450592"/>
-            <a:ext cx="2377440" cy="294802"/>
+            <a:off x="6781647" y="2980944"/>
+            <a:ext cx="2377440" cy="266273"/>
           </a:xfrm>
           <a:prstGeom prst="rect">
             <a:avLst/>
@@ -9261,14 +9613,14 @@
       </p:sp>
       <p:sp>
         <p:nvSpPr>
-          <p:cNvPr id="33" name="TextBox 32"/>
+          <p:cNvPr id="37" name="TextBox 36"/>
           <p:cNvSpPr txBox="1"/>
           <p:nvPr/>
         </p:nvSpPr>
         <p:spPr>
           <a:xfrm>
-            <a:off x="5912967" y="2707538"/>
-            <a:ext cx="2377440" cy="226771"/>
+            <a:off x="6781647" y="3207715"/>
+            <a:ext cx="2377440" cy="204825"/>
           </a:xfrm>
           <a:prstGeom prst="rect">
             <a:avLst/>
@@ -9297,13 +9649,13 @@
       </p:sp>
       <p:sp>
         <p:nvSpPr>
-          <p:cNvPr id="34" name="Rounded Rectangle 33"/>
+          <p:cNvPr id="38" name="Rounded Rectangle 37"/>
           <p:cNvSpPr/>
           <p:nvPr/>
         </p:nvSpPr>
         <p:spPr>
           <a:xfrm>
-            <a:off x="7988655" y="3255264"/>
+            <a:off x="8857335" y="3675888"/>
             <a:ext cx="1627632" cy="329184"/>
           </a:xfrm>
           <a:prstGeom prst="roundRect">
@@ -9343,13 +9695,13 @@
       </p:sp>
       <p:sp>
         <p:nvSpPr>
-          <p:cNvPr id="35" name="TextBox 34"/>
+          <p:cNvPr id="39" name="TextBox 38"/>
           <p:cNvSpPr txBox="1"/>
           <p:nvPr/>
         </p:nvSpPr>
         <p:spPr>
           <a:xfrm>
-            <a:off x="7988655" y="3255264"/>
+            <a:off x="8857335" y="3675888"/>
             <a:ext cx="1627632" cy="329184"/>
           </a:xfrm>
           <a:prstGeom prst="rect">
@@ -9379,13 +9731,13 @@
       </p:sp>
       <p:sp>
         <p:nvSpPr>
-          <p:cNvPr id="36" name="Rounded Rectangle 35"/>
+          <p:cNvPr id="40" name="Rounded Rectangle 39"/>
           <p:cNvSpPr/>
           <p:nvPr/>
         </p:nvSpPr>
         <p:spPr>
           <a:xfrm>
-            <a:off x="6287871" y="3255264"/>
+            <a:off x="7156551" y="3675888"/>
             <a:ext cx="1627632" cy="329184"/>
           </a:xfrm>
           <a:prstGeom prst="roundRect">
@@ -9425,13 +9777,13 @@
       </p:sp>
       <p:sp>
         <p:nvSpPr>
-          <p:cNvPr id="37" name="TextBox 36"/>
+          <p:cNvPr id="41" name="TextBox 40"/>
           <p:cNvSpPr txBox="1"/>
           <p:nvPr/>
         </p:nvSpPr>
         <p:spPr>
           <a:xfrm>
-            <a:off x="6287871" y="3255264"/>
+            <a:off x="7156551" y="3675888"/>
             <a:ext cx="1627632" cy="329184"/>
           </a:xfrm>
           <a:prstGeom prst="rect">
@@ -9461,13 +9813,13 @@
       </p:sp>
       <p:sp>
         <p:nvSpPr>
-          <p:cNvPr id="38" name="Rounded Rectangle 37"/>
+          <p:cNvPr id="42" name="Rounded Rectangle 41"/>
           <p:cNvSpPr/>
           <p:nvPr/>
         </p:nvSpPr>
         <p:spPr>
           <a:xfrm>
-            <a:off x="4587087" y="3255264"/>
+            <a:off x="5455767" y="3675888"/>
             <a:ext cx="1627632" cy="329184"/>
           </a:xfrm>
           <a:prstGeom prst="roundRect">
@@ -9507,13 +9859,13 @@
       </p:sp>
       <p:sp>
         <p:nvSpPr>
-          <p:cNvPr id="39" name="TextBox 38"/>
+          <p:cNvPr id="43" name="TextBox 42"/>
           <p:cNvSpPr txBox="1"/>
           <p:nvPr/>
         </p:nvSpPr>
         <p:spPr>
           <a:xfrm>
-            <a:off x="4587087" y="3255264"/>
+            <a:off x="5455767" y="3675888"/>
             <a:ext cx="1627632" cy="329184"/>
           </a:xfrm>
           <a:prstGeom prst="rect">
@@ -9543,13 +9895,13 @@
       </p:sp>
       <p:sp>
         <p:nvSpPr>
-          <p:cNvPr id="40" name="Rounded Rectangle 39"/>
+          <p:cNvPr id="44" name="Rounded Rectangle 43"/>
           <p:cNvSpPr/>
           <p:nvPr/>
         </p:nvSpPr>
         <p:spPr>
           <a:xfrm>
-            <a:off x="7988655" y="3657600"/>
+            <a:off x="8857335" y="4078224"/>
             <a:ext cx="1627632" cy="329184"/>
           </a:xfrm>
           <a:prstGeom prst="roundRect">
@@ -9589,13 +9941,13 @@
       </p:sp>
       <p:sp>
         <p:nvSpPr>
-          <p:cNvPr id="41" name="TextBox 40"/>
+          <p:cNvPr id="45" name="TextBox 44"/>
           <p:cNvSpPr txBox="1"/>
           <p:nvPr/>
         </p:nvSpPr>
         <p:spPr>
           <a:xfrm>
-            <a:off x="7988655" y="3657600"/>
+            <a:off x="8857335" y="4078224"/>
             <a:ext cx="1627632" cy="329184"/>
           </a:xfrm>
           <a:prstGeom prst="rect">
@@ -9625,13 +9977,13 @@
       </p:sp>
       <p:sp>
         <p:nvSpPr>
-          <p:cNvPr id="42" name="Rounded Rectangle 41"/>
+          <p:cNvPr id="46" name="Rounded Rectangle 45"/>
           <p:cNvSpPr/>
           <p:nvPr/>
         </p:nvSpPr>
         <p:spPr>
           <a:xfrm>
-            <a:off x="6287871" y="3657600"/>
+            <a:off x="7156551" y="4078224"/>
             <a:ext cx="1627632" cy="329184"/>
           </a:xfrm>
           <a:prstGeom prst="roundRect">
@@ -9671,13 +10023,13 @@
       </p:sp>
       <p:sp>
         <p:nvSpPr>
-          <p:cNvPr id="43" name="TextBox 42"/>
+          <p:cNvPr id="47" name="TextBox 46"/>
           <p:cNvSpPr txBox="1"/>
           <p:nvPr/>
         </p:nvSpPr>
         <p:spPr>
           <a:xfrm>
-            <a:off x="6287871" y="3657600"/>
+            <a:off x="7156551" y="4078224"/>
             <a:ext cx="1627632" cy="329184"/>
           </a:xfrm>
           <a:prstGeom prst="rect">
@@ -9707,13 +10059,13 @@
       </p:sp>
       <p:sp>
         <p:nvSpPr>
-          <p:cNvPr id="44" name="Rounded Rectangle 43"/>
+          <p:cNvPr id="48" name="Rounded Rectangle 47"/>
           <p:cNvSpPr/>
           <p:nvPr/>
         </p:nvSpPr>
         <p:spPr>
           <a:xfrm>
-            <a:off x="4587087" y="3657600"/>
+            <a:off x="5455767" y="4078224"/>
             <a:ext cx="1627632" cy="329184"/>
           </a:xfrm>
           <a:prstGeom prst="roundRect">
@@ -9753,13 +10105,13 @@
       </p:sp>
       <p:sp>
         <p:nvSpPr>
-          <p:cNvPr id="45" name="TextBox 44"/>
+          <p:cNvPr id="49" name="TextBox 48"/>
           <p:cNvSpPr txBox="1"/>
           <p:nvPr/>
         </p:nvSpPr>
         <p:spPr>
           <a:xfrm>
-            <a:off x="4587087" y="3657600"/>
+            <a:off x="5455767" y="4078224"/>
             <a:ext cx="1627632" cy="329184"/>
           </a:xfrm>
           <a:prstGeom prst="rect">
@@ -9789,13 +10141,13 @@
       </p:sp>
       <p:sp>
         <p:nvSpPr>
-          <p:cNvPr id="46" name="Rounded Rectangle 45"/>
+          <p:cNvPr id="50" name="Rounded Rectangle 49"/>
           <p:cNvSpPr/>
           <p:nvPr/>
         </p:nvSpPr>
         <p:spPr>
           <a:xfrm>
-            <a:off x="7988655" y="4059936"/>
+            <a:off x="8857335" y="4480560"/>
             <a:ext cx="1627632" cy="329184"/>
           </a:xfrm>
           <a:prstGeom prst="roundRect">
@@ -9835,13 +10187,13 @@
       </p:sp>
       <p:sp>
         <p:nvSpPr>
-          <p:cNvPr id="47" name="TextBox 46"/>
+          <p:cNvPr id="51" name="TextBox 50"/>
           <p:cNvSpPr txBox="1"/>
           <p:nvPr/>
         </p:nvSpPr>
         <p:spPr>
           <a:xfrm>
-            <a:off x="7988655" y="4059936"/>
+            <a:off x="8857335" y="4480560"/>
             <a:ext cx="1627632" cy="329184"/>
           </a:xfrm>
           <a:prstGeom prst="rect">
@@ -9871,13 +10223,13 @@
       </p:sp>
       <p:sp>
         <p:nvSpPr>
-          <p:cNvPr id="48" name="Rounded Rectangle 47"/>
+          <p:cNvPr id="52" name="Rounded Rectangle 51"/>
           <p:cNvSpPr/>
           <p:nvPr/>
         </p:nvSpPr>
         <p:spPr>
           <a:xfrm>
-            <a:off x="6287871" y="4059936"/>
+            <a:off x="7156551" y="4480560"/>
             <a:ext cx="1627632" cy="329184"/>
           </a:xfrm>
           <a:prstGeom prst="roundRect">
@@ -9917,13 +10269,13 @@
       </p:sp>
       <p:sp>
         <p:nvSpPr>
-          <p:cNvPr id="49" name="TextBox 48"/>
+          <p:cNvPr id="53" name="TextBox 52"/>
           <p:cNvSpPr txBox="1"/>
           <p:nvPr/>
         </p:nvSpPr>
         <p:spPr>
           <a:xfrm>
-            <a:off x="6287871" y="4059936"/>
+            <a:off x="7156551" y="4480560"/>
             <a:ext cx="1627632" cy="329184"/>
           </a:xfrm>
           <a:prstGeom prst="rect">
@@ -9953,13 +10305,13 @@
       </p:sp>
       <p:sp>
         <p:nvSpPr>
-          <p:cNvPr id="50" name="Rounded Rectangle 49"/>
+          <p:cNvPr id="54" name="Rounded Rectangle 53"/>
           <p:cNvSpPr/>
           <p:nvPr/>
         </p:nvSpPr>
         <p:spPr>
           <a:xfrm>
-            <a:off x="4587087" y="4059936"/>
+            <a:off x="5455767" y="4480560"/>
             <a:ext cx="1627632" cy="329184"/>
           </a:xfrm>
           <a:prstGeom prst="roundRect">
@@ -9999,13 +10351,13 @@
       </p:sp>
       <p:sp>
         <p:nvSpPr>
-          <p:cNvPr id="51" name="TextBox 50"/>
+          <p:cNvPr id="55" name="TextBox 54"/>
           <p:cNvSpPr txBox="1"/>
           <p:nvPr/>
         </p:nvSpPr>
         <p:spPr>
           <a:xfrm>
-            <a:off x="4587087" y="4059936"/>
+            <a:off x="5455767" y="4480560"/>
             <a:ext cx="1627632" cy="329184"/>
           </a:xfrm>
           <a:prstGeom prst="rect">
@@ -10035,13 +10387,13 @@
       </p:sp>
       <p:sp>
         <p:nvSpPr>
-          <p:cNvPr id="52" name="Rounded Rectangle 51"/>
+          <p:cNvPr id="56" name="Rounded Rectangle 55"/>
           <p:cNvSpPr/>
           <p:nvPr/>
         </p:nvSpPr>
         <p:spPr>
           <a:xfrm>
-            <a:off x="7988655" y="4462272"/>
+            <a:off x="8857335" y="4882896"/>
             <a:ext cx="1627632" cy="329184"/>
           </a:xfrm>
           <a:prstGeom prst="roundRect">
@@ -10081,13 +10433,13 @@
       </p:sp>
       <p:sp>
         <p:nvSpPr>
-          <p:cNvPr id="53" name="TextBox 52"/>
+          <p:cNvPr id="57" name="TextBox 56"/>
           <p:cNvSpPr txBox="1"/>
           <p:nvPr/>
         </p:nvSpPr>
         <p:spPr>
           <a:xfrm>
-            <a:off x="7988655" y="4462272"/>
+            <a:off x="8857335" y="4882896"/>
             <a:ext cx="1627632" cy="329184"/>
           </a:xfrm>
           <a:prstGeom prst="rect">
@@ -10117,13 +10469,13 @@
       </p:sp>
       <p:sp>
         <p:nvSpPr>
-          <p:cNvPr id="54" name="Rounded Rectangle 53"/>
+          <p:cNvPr id="58" name="Rounded Rectangle 57"/>
           <p:cNvSpPr/>
           <p:nvPr/>
         </p:nvSpPr>
         <p:spPr>
           <a:xfrm>
-            <a:off x="6287871" y="4462272"/>
+            <a:off x="7156551" y="4882896"/>
             <a:ext cx="1627632" cy="329184"/>
           </a:xfrm>
           <a:prstGeom prst="roundRect">
@@ -10163,13 +10515,13 @@
       </p:sp>
       <p:sp>
         <p:nvSpPr>
-          <p:cNvPr id="55" name="TextBox 54"/>
+          <p:cNvPr id="59" name="TextBox 58"/>
           <p:cNvSpPr txBox="1"/>
           <p:nvPr/>
         </p:nvSpPr>
         <p:spPr>
           <a:xfrm>
-            <a:off x="6287871" y="4462272"/>
+            <a:off x="7156551" y="4882896"/>
             <a:ext cx="1627632" cy="329184"/>
           </a:xfrm>
           <a:prstGeom prst="rect">
@@ -10199,13 +10551,13 @@
       </p:sp>
       <p:sp>
         <p:nvSpPr>
-          <p:cNvPr id="56" name="Rounded Rectangle 55"/>
+          <p:cNvPr id="60" name="Rounded Rectangle 59"/>
           <p:cNvSpPr/>
           <p:nvPr/>
         </p:nvSpPr>
         <p:spPr>
           <a:xfrm>
-            <a:off x="4587087" y="4462272"/>
+            <a:off x="5455767" y="4882896"/>
             <a:ext cx="1627632" cy="329184"/>
           </a:xfrm>
           <a:prstGeom prst="roundRect">
@@ -10245,13 +10597,13 @@
       </p:sp>
       <p:sp>
         <p:nvSpPr>
-          <p:cNvPr id="57" name="TextBox 56"/>
+          <p:cNvPr id="61" name="TextBox 60"/>
           <p:cNvSpPr txBox="1"/>
           <p:nvPr/>
         </p:nvSpPr>
         <p:spPr>
           <a:xfrm>
-            <a:off x="4587087" y="4462272"/>
+            <a:off x="5455767" y="4882896"/>
             <a:ext cx="1627632" cy="329184"/>
           </a:xfrm>
           <a:prstGeom prst="rect">
@@ -10281,13 +10633,13 @@
       </p:sp>
       <p:sp>
         <p:nvSpPr>
-          <p:cNvPr id="58" name="Rounded Rectangle 57"/>
+          <p:cNvPr id="62" name="Rounded Rectangle 61"/>
           <p:cNvSpPr/>
           <p:nvPr/>
         </p:nvSpPr>
         <p:spPr>
           <a:xfrm>
-            <a:off x="7988655" y="4864608"/>
+            <a:off x="8857335" y="5285232"/>
             <a:ext cx="1627632" cy="329184"/>
           </a:xfrm>
           <a:prstGeom prst="roundRect">
@@ -10327,13 +10679,13 @@
       </p:sp>
       <p:sp>
         <p:nvSpPr>
-          <p:cNvPr id="59" name="TextBox 58"/>
+          <p:cNvPr id="63" name="TextBox 62"/>
           <p:cNvSpPr txBox="1"/>
           <p:nvPr/>
         </p:nvSpPr>
         <p:spPr>
           <a:xfrm>
-            <a:off x="7988655" y="4864608"/>
+            <a:off x="8857335" y="5285232"/>
             <a:ext cx="1627632" cy="329184"/>
           </a:xfrm>
           <a:prstGeom prst="rect">
@@ -10363,13 +10715,13 @@
       </p:sp>
       <p:sp>
         <p:nvSpPr>
-          <p:cNvPr id="60" name="Rounded Rectangle 59"/>
+          <p:cNvPr id="64" name="Rounded Rectangle 63"/>
           <p:cNvSpPr/>
           <p:nvPr/>
         </p:nvSpPr>
         <p:spPr>
           <a:xfrm>
-            <a:off x="6287871" y="4864608"/>
+            <a:off x="7156551" y="5285232"/>
             <a:ext cx="1627632" cy="329184"/>
           </a:xfrm>
           <a:prstGeom prst="roundRect">
@@ -10409,13 +10761,13 @@
       </p:sp>
       <p:sp>
         <p:nvSpPr>
-          <p:cNvPr id="61" name="TextBox 60"/>
+          <p:cNvPr id="65" name="TextBox 64"/>
           <p:cNvSpPr txBox="1"/>
           <p:nvPr/>
         </p:nvSpPr>
         <p:spPr>
           <a:xfrm>
-            <a:off x="6287871" y="4864608"/>
+            <a:off x="7156551" y="5285232"/>
             <a:ext cx="1627632" cy="329184"/>
           </a:xfrm>
           <a:prstGeom prst="rect">
@@ -10445,13 +10797,13 @@
       </p:sp>
       <p:sp>
         <p:nvSpPr>
-          <p:cNvPr id="62" name="Rounded Rectangle 61"/>
+          <p:cNvPr id="66" name="Rounded Rectangle 65"/>
           <p:cNvSpPr/>
           <p:nvPr/>
         </p:nvSpPr>
         <p:spPr>
           <a:xfrm>
-            <a:off x="4587087" y="4864608"/>
+            <a:off x="5455767" y="5285232"/>
             <a:ext cx="1627632" cy="329184"/>
           </a:xfrm>
           <a:prstGeom prst="roundRect">
@@ -10491,13 +10843,13 @@
       </p:sp>
       <p:sp>
         <p:nvSpPr>
-          <p:cNvPr id="63" name="TextBox 62"/>
+          <p:cNvPr id="67" name="TextBox 66"/>
           <p:cNvSpPr txBox="1"/>
           <p:nvPr/>
         </p:nvSpPr>
         <p:spPr>
           <a:xfrm>
-            <a:off x="4587087" y="4864608"/>
+            <a:off x="5455767" y="5285232"/>
             <a:ext cx="1627632" cy="329184"/>
           </a:xfrm>
           <a:prstGeom prst="rect">
@@ -10527,13 +10879,13 @@
       </p:sp>
       <p:sp>
         <p:nvSpPr>
-          <p:cNvPr id="64" name="Rounded Rectangle 63"/>
+          <p:cNvPr id="68" name="Rounded Rectangle 67"/>
           <p:cNvSpPr/>
           <p:nvPr/>
         </p:nvSpPr>
         <p:spPr>
           <a:xfrm>
-            <a:off x="7988655" y="5266944"/>
+            <a:off x="8857335" y="5687568"/>
             <a:ext cx="1627632" cy="329184"/>
           </a:xfrm>
           <a:prstGeom prst="roundRect">
@@ -10573,13 +10925,13 @@
       </p:sp>
       <p:sp>
         <p:nvSpPr>
-          <p:cNvPr id="65" name="TextBox 64"/>
+          <p:cNvPr id="69" name="TextBox 68"/>
           <p:cNvSpPr txBox="1"/>
           <p:nvPr/>
         </p:nvSpPr>
         <p:spPr>
           <a:xfrm>
-            <a:off x="7988655" y="5266944"/>
+            <a:off x="8857335" y="5687568"/>
             <a:ext cx="1627632" cy="329184"/>
           </a:xfrm>
           <a:prstGeom prst="rect">
@@ -10609,13 +10961,13 @@
       </p:sp>
       <p:sp>
         <p:nvSpPr>
-          <p:cNvPr id="66" name="Rounded Rectangle 65"/>
+          <p:cNvPr id="70" name="Rounded Rectangle 69"/>
           <p:cNvSpPr/>
           <p:nvPr/>
         </p:nvSpPr>
         <p:spPr>
           <a:xfrm>
-            <a:off x="6287871" y="5266944"/>
+            <a:off x="7156551" y="5687568"/>
             <a:ext cx="1627632" cy="329184"/>
           </a:xfrm>
           <a:prstGeom prst="roundRect">
@@ -10655,13 +11007,13 @@
       </p:sp>
       <p:sp>
         <p:nvSpPr>
-          <p:cNvPr id="67" name="TextBox 66"/>
+          <p:cNvPr id="71" name="TextBox 70"/>
           <p:cNvSpPr txBox="1"/>
           <p:nvPr/>
         </p:nvSpPr>
         <p:spPr>
           <a:xfrm>
-            <a:off x="6287871" y="5266944"/>
+            <a:off x="7156551" y="5687568"/>
             <a:ext cx="1627632" cy="329184"/>
           </a:xfrm>
           <a:prstGeom prst="rect">
@@ -10691,13 +11043,13 @@
       </p:sp>
       <p:sp>
         <p:nvSpPr>
-          <p:cNvPr id="68" name="Rounded Rectangle 67"/>
+          <p:cNvPr id="72" name="Rounded Rectangle 71"/>
           <p:cNvSpPr/>
           <p:nvPr/>
         </p:nvSpPr>
         <p:spPr>
           <a:xfrm>
-            <a:off x="4587087" y="5266944"/>
+            <a:off x="5455767" y="5687568"/>
             <a:ext cx="1627632" cy="329184"/>
           </a:xfrm>
           <a:prstGeom prst="roundRect">
@@ -10737,13 +11089,13 @@
       </p:sp>
       <p:sp>
         <p:nvSpPr>
-          <p:cNvPr id="69" name="TextBox 68"/>
+          <p:cNvPr id="73" name="TextBox 72"/>
           <p:cNvSpPr txBox="1"/>
           <p:nvPr/>
         </p:nvSpPr>
         <p:spPr>
           <a:xfrm>
-            <a:off x="4587087" y="5266944"/>
+            <a:off x="5455767" y="5687568"/>
             <a:ext cx="1627632" cy="329184"/>
           </a:xfrm>
           <a:prstGeom prst="rect">
@@ -10773,14 +11125,14 @@
       </p:sp>
       <p:sp>
         <p:nvSpPr>
-          <p:cNvPr id="70" name="Rounded Rectangle 69"/>
+          <p:cNvPr id="74" name="Rounded Rectangle 73"/>
           <p:cNvSpPr/>
           <p:nvPr/>
         </p:nvSpPr>
         <p:spPr>
           <a:xfrm>
-            <a:off x="2483967" y="2679192"/>
-            <a:ext cx="1737360" cy="3447288"/>
+            <a:off x="1615287" y="3182112"/>
+            <a:ext cx="3474720" cy="2157984"/>
           </a:xfrm>
           <a:prstGeom prst="roundRect">
             <a:avLst>
@@ -10819,14 +11171,14 @@
       </p:sp>
       <p:sp>
         <p:nvSpPr>
-          <p:cNvPr id="71" name="Rounded Rectangle 70"/>
+          <p:cNvPr id="75" name="Rounded Rectangle 74"/>
           <p:cNvSpPr/>
           <p:nvPr/>
         </p:nvSpPr>
         <p:spPr>
           <a:xfrm>
-            <a:off x="2575407" y="2395728"/>
-            <a:ext cx="1554480" cy="566928"/>
+            <a:off x="2163927" y="2926080"/>
+            <a:ext cx="2377440" cy="512064"/>
           </a:xfrm>
           <a:prstGeom prst="roundRect">
             <a:avLst>
@@ -10865,14 +11217,14 @@
       </p:sp>
       <p:sp>
         <p:nvSpPr>
-          <p:cNvPr id="72" name="TextBox 71"/>
+          <p:cNvPr id="76" name="TextBox 75"/>
           <p:cNvSpPr txBox="1"/>
           <p:nvPr/>
         </p:nvSpPr>
         <p:spPr>
           <a:xfrm>
-            <a:off x="2575407" y="2450592"/>
-            <a:ext cx="1554480" cy="294802"/>
+            <a:off x="2163927" y="2980944"/>
+            <a:ext cx="2377440" cy="266273"/>
           </a:xfrm>
           <a:prstGeom prst="rect">
             <a:avLst/>
@@ -10901,14 +11253,14 @@
       </p:sp>
       <p:sp>
         <p:nvSpPr>
-          <p:cNvPr id="73" name="TextBox 72"/>
+          <p:cNvPr id="77" name="TextBox 76"/>
           <p:cNvSpPr txBox="1"/>
           <p:nvPr/>
         </p:nvSpPr>
         <p:spPr>
           <a:xfrm>
-            <a:off x="2575407" y="2707538"/>
-            <a:ext cx="1554480" cy="226771"/>
+            <a:off x="2163927" y="3207715"/>
+            <a:ext cx="2377440" cy="204825"/>
           </a:xfrm>
           <a:prstGeom prst="rect">
             <a:avLst/>
@@ -10937,14 +11289,14 @@
       </p:sp>
       <p:sp>
         <p:nvSpPr>
-          <p:cNvPr id="74" name="Rounded Rectangle 73"/>
+          <p:cNvPr id="78" name="Rounded Rectangle 77"/>
           <p:cNvSpPr/>
           <p:nvPr/>
         </p:nvSpPr>
         <p:spPr>
           <a:xfrm>
-            <a:off x="2575407" y="3255264"/>
-            <a:ext cx="1554480" cy="329184"/>
+            <a:off x="3389223" y="3675888"/>
+            <a:ext cx="1609344" cy="329184"/>
           </a:xfrm>
           <a:prstGeom prst="roundRect">
             <a:avLst>
@@ -10983,14 +11335,14 @@
       </p:sp>
       <p:sp>
         <p:nvSpPr>
-          <p:cNvPr id="75" name="TextBox 74"/>
+          <p:cNvPr id="79" name="TextBox 78"/>
           <p:cNvSpPr txBox="1"/>
           <p:nvPr/>
         </p:nvSpPr>
         <p:spPr>
           <a:xfrm>
-            <a:off x="2575407" y="3255264"/>
-            <a:ext cx="1554480" cy="329184"/>
+            <a:off x="3389223" y="3675888"/>
+            <a:ext cx="1609344" cy="329184"/>
           </a:xfrm>
           <a:prstGeom prst="rect">
             <a:avLst/>
@@ -11019,14 +11371,14 @@
       </p:sp>
       <p:sp>
         <p:nvSpPr>
-          <p:cNvPr id="76" name="Rounded Rectangle 75"/>
+          <p:cNvPr id="80" name="Rounded Rectangle 79"/>
           <p:cNvSpPr/>
           <p:nvPr/>
         </p:nvSpPr>
         <p:spPr>
           <a:xfrm>
-            <a:off x="2575407" y="3657600"/>
-            <a:ext cx="1554480" cy="329184"/>
+            <a:off x="1706727" y="3675888"/>
+            <a:ext cx="1609344" cy="329184"/>
           </a:xfrm>
           <a:prstGeom prst="roundRect">
             <a:avLst>
@@ -11065,14 +11417,14 @@
       </p:sp>
       <p:sp>
         <p:nvSpPr>
-          <p:cNvPr id="77" name="TextBox 76"/>
+          <p:cNvPr id="81" name="TextBox 80"/>
           <p:cNvSpPr txBox="1"/>
           <p:nvPr/>
         </p:nvSpPr>
         <p:spPr>
           <a:xfrm>
-            <a:off x="2575407" y="3657600"/>
-            <a:ext cx="1554480" cy="329184"/>
+            <a:off x="1706727" y="3675888"/>
+            <a:ext cx="1609344" cy="329184"/>
           </a:xfrm>
           <a:prstGeom prst="rect">
             <a:avLst/>
@@ -11101,14 +11453,14 @@
       </p:sp>
       <p:sp>
         <p:nvSpPr>
-          <p:cNvPr id="78" name="Rounded Rectangle 77"/>
+          <p:cNvPr id="82" name="Rounded Rectangle 81"/>
           <p:cNvSpPr/>
           <p:nvPr/>
         </p:nvSpPr>
         <p:spPr>
           <a:xfrm>
-            <a:off x="2575407" y="4059936"/>
-            <a:ext cx="1554480" cy="329184"/>
+            <a:off x="3389223" y="4078224"/>
+            <a:ext cx="1609344" cy="329184"/>
           </a:xfrm>
           <a:prstGeom prst="roundRect">
             <a:avLst>
@@ -11147,14 +11499,14 @@
       </p:sp>
       <p:sp>
         <p:nvSpPr>
-          <p:cNvPr id="79" name="TextBox 78"/>
+          <p:cNvPr id="83" name="TextBox 82"/>
           <p:cNvSpPr txBox="1"/>
           <p:nvPr/>
         </p:nvSpPr>
         <p:spPr>
           <a:xfrm>
-            <a:off x="2575407" y="4059936"/>
-            <a:ext cx="1554480" cy="329184"/>
+            <a:off x="3389223" y="4078224"/>
+            <a:ext cx="1609344" cy="329184"/>
           </a:xfrm>
           <a:prstGeom prst="rect">
             <a:avLst/>
@@ -11183,14 +11535,14 @@
       </p:sp>
       <p:sp>
         <p:nvSpPr>
-          <p:cNvPr id="80" name="Rounded Rectangle 79"/>
+          <p:cNvPr id="84" name="Rounded Rectangle 83"/>
           <p:cNvSpPr/>
           <p:nvPr/>
         </p:nvSpPr>
         <p:spPr>
           <a:xfrm>
-            <a:off x="2575407" y="4462272"/>
-            <a:ext cx="1554480" cy="329184"/>
+            <a:off x="1706727" y="4078224"/>
+            <a:ext cx="1609344" cy="329184"/>
           </a:xfrm>
           <a:prstGeom prst="roundRect">
             <a:avLst>
@@ -11229,14 +11581,14 @@
       </p:sp>
       <p:sp>
         <p:nvSpPr>
-          <p:cNvPr id="81" name="TextBox 80"/>
+          <p:cNvPr id="85" name="TextBox 84"/>
           <p:cNvSpPr txBox="1"/>
           <p:nvPr/>
         </p:nvSpPr>
         <p:spPr>
           <a:xfrm>
-            <a:off x="2575407" y="4462272"/>
-            <a:ext cx="1554480" cy="329184"/>
+            <a:off x="1706727" y="4078224"/>
+            <a:ext cx="1609344" cy="329184"/>
           </a:xfrm>
           <a:prstGeom prst="rect">
             <a:avLst/>
@@ -11265,14 +11617,14 @@
       </p:sp>
       <p:sp>
         <p:nvSpPr>
-          <p:cNvPr id="82" name="Rounded Rectangle 81"/>
+          <p:cNvPr id="86" name="Rounded Rectangle 85"/>
           <p:cNvSpPr/>
           <p:nvPr/>
         </p:nvSpPr>
         <p:spPr>
           <a:xfrm>
-            <a:off x="2575407" y="4864608"/>
-            <a:ext cx="1554480" cy="329184"/>
+            <a:off x="3389223" y="4480560"/>
+            <a:ext cx="1609344" cy="329184"/>
           </a:xfrm>
           <a:prstGeom prst="roundRect">
             <a:avLst>
@@ -11311,14 +11663,14 @@
       </p:sp>
       <p:sp>
         <p:nvSpPr>
-          <p:cNvPr id="83" name="TextBox 82"/>
+          <p:cNvPr id="87" name="TextBox 86"/>
           <p:cNvSpPr txBox="1"/>
           <p:nvPr/>
         </p:nvSpPr>
         <p:spPr>
           <a:xfrm>
-            <a:off x="2575407" y="4864608"/>
-            <a:ext cx="1554480" cy="329184"/>
+            <a:off x="3389223" y="4480560"/>
+            <a:ext cx="1609344" cy="329184"/>
           </a:xfrm>
           <a:prstGeom prst="rect">
             <a:avLst/>
@@ -11347,14 +11699,14 @@
       </p:sp>
       <p:sp>
         <p:nvSpPr>
-          <p:cNvPr id="84" name="Rounded Rectangle 83"/>
+          <p:cNvPr id="88" name="Rounded Rectangle 87"/>
           <p:cNvSpPr/>
           <p:nvPr/>
         </p:nvSpPr>
         <p:spPr>
           <a:xfrm>
-            <a:off x="2575407" y="5266944"/>
-            <a:ext cx="1554480" cy="329184"/>
+            <a:off x="1706727" y="4480560"/>
+            <a:ext cx="1609344" cy="329184"/>
           </a:xfrm>
           <a:prstGeom prst="roundRect">
             <a:avLst>
@@ -11393,14 +11745,14 @@
       </p:sp>
       <p:sp>
         <p:nvSpPr>
-          <p:cNvPr id="85" name="TextBox 84"/>
+          <p:cNvPr id="89" name="TextBox 88"/>
           <p:cNvSpPr txBox="1"/>
           <p:nvPr/>
         </p:nvSpPr>
         <p:spPr>
           <a:xfrm>
-            <a:off x="2575407" y="5266944"/>
-            <a:ext cx="1554480" cy="329184"/>
+            <a:off x="1706727" y="4480560"/>
+            <a:ext cx="1609344" cy="329184"/>
           </a:xfrm>
           <a:prstGeom prst="rect">
             <a:avLst/>
@@ -11429,14 +11781,14 @@
       </p:sp>
       <p:sp>
         <p:nvSpPr>
-          <p:cNvPr id="86" name="Rounded Rectangle 85"/>
+          <p:cNvPr id="90" name="Rounded Rectangle 89"/>
           <p:cNvSpPr/>
           <p:nvPr/>
         </p:nvSpPr>
         <p:spPr>
           <a:xfrm>
-            <a:off x="2575407" y="5669280"/>
-            <a:ext cx="1554480" cy="329184"/>
+            <a:off x="3389223" y="4882896"/>
+            <a:ext cx="1609344" cy="329184"/>
           </a:xfrm>
           <a:prstGeom prst="roundRect">
             <a:avLst>
@@ -11475,14 +11827,14 @@
       </p:sp>
       <p:sp>
         <p:nvSpPr>
-          <p:cNvPr id="87" name="TextBox 86"/>
+          <p:cNvPr id="91" name="TextBox 90"/>
           <p:cNvSpPr txBox="1"/>
           <p:nvPr/>
         </p:nvSpPr>
         <p:spPr>
           <a:xfrm>
-            <a:off x="2575407" y="5669280"/>
-            <a:ext cx="1554480" cy="329184"/>
+            <a:off x="3389223" y="4882896"/>
+            <a:ext cx="1609344" cy="329184"/>
           </a:xfrm>
           <a:prstGeom prst="rect">
             <a:avLst/>
@@ -11511,14 +11863,14 @@
       </p:sp>
       <p:cxnSp>
         <p:nvCxnSpPr>
-          <p:cNvPr id="88" name="Connector 87"/>
+          <p:cNvPr id="92" name="Connector 91"/>
           <p:cNvCxnSpPr/>
           <p:nvPr/>
         </p:nvCxnSpPr>
         <p:spPr>
           <a:xfrm>
-            <a:off x="6095847" y="1901952"/>
-            <a:ext cx="0" cy="256032"/>
+            <a:off x="6095847" y="2615184"/>
+            <a:ext cx="0" cy="155448"/>
           </a:xfrm>
           <a:prstGeom prst="line">
             <a:avLst/>
@@ -11546,14 +11898,14 @@
       </p:cxnSp>
       <p:cxnSp>
         <p:nvCxnSpPr>
-          <p:cNvPr id="89" name="Connector 88"/>
+          <p:cNvPr id="93" name="Connector 92"/>
           <p:cNvCxnSpPr/>
           <p:nvPr/>
         </p:nvCxnSpPr>
         <p:spPr>
           <a:xfrm>
-            <a:off x="3352647" y="2157984"/>
-            <a:ext cx="3749040" cy="0"/>
+            <a:off x="3352647" y="2770632"/>
+            <a:ext cx="4617720" cy="0"/>
           </a:xfrm>
           <a:prstGeom prst="line">
             <a:avLst/>
@@ -11581,14 +11933,14 @@
       </p:cxnSp>
       <p:cxnSp>
         <p:nvCxnSpPr>
-          <p:cNvPr id="90" name="Connector 89"/>
+          <p:cNvPr id="94" name="Connector 93"/>
           <p:cNvCxnSpPr/>
           <p:nvPr/>
         </p:nvCxnSpPr>
         <p:spPr>
           <a:xfrm>
-            <a:off x="7101687" y="2157984"/>
-            <a:ext cx="0" cy="237744"/>
+            <a:off x="7970367" y="2770632"/>
+            <a:ext cx="0" cy="155448"/>
           </a:xfrm>
           <a:prstGeom prst="line">
             <a:avLst/>
@@ -11616,14 +11968,14 @@
       </p:cxnSp>
       <p:cxnSp>
         <p:nvCxnSpPr>
-          <p:cNvPr id="91" name="Connector 90"/>
+          <p:cNvPr id="95" name="Connector 94"/>
           <p:cNvCxnSpPr/>
           <p:nvPr/>
         </p:nvCxnSpPr>
         <p:spPr>
           <a:xfrm>
-            <a:off x="3352647" y="2157984"/>
-            <a:ext cx="0" cy="237744"/>
+            <a:off x="3352647" y="2770632"/>
+            <a:ext cx="0" cy="155448"/>
           </a:xfrm>
           <a:prstGeom prst="line">
             <a:avLst/>
@@ -11651,7 +12003,7 @@
       </p:cxnSp>
       <p:sp>
         <p:nvSpPr>
-          <p:cNvPr id="92" name="Oval 91"/>
+          <p:cNvPr id="96" name="Oval 95"/>
           <p:cNvSpPr/>
           <p:nvPr/>
         </p:nvSpPr>
@@ -11695,7 +12047,7 @@
       </p:sp>
       <p:sp>
         <p:nvSpPr>
-          <p:cNvPr id="93" name="TextBox 92"/>
+          <p:cNvPr id="97" name="TextBox 96"/>
           <p:cNvSpPr txBox="1"/>
           <p:nvPr/>
         </p:nvSpPr>
@@ -11731,7 +12083,7 @@
       </p:sp>
       <p:sp>
         <p:nvSpPr>
-          <p:cNvPr id="94" name="Oval 93"/>
+          <p:cNvPr id="98" name="Oval 97"/>
           <p:cNvSpPr/>
           <p:nvPr/>
         </p:nvSpPr>
@@ -11775,7 +12127,7 @@
       </p:sp>
       <p:sp>
         <p:nvSpPr>
-          <p:cNvPr id="95" name="TextBox 94"/>
+          <p:cNvPr id="99" name="TextBox 98"/>
           <p:cNvSpPr txBox="1"/>
           <p:nvPr/>
         </p:nvSpPr>
@@ -11811,7 +12163,7 @@
       </p:sp>
       <p:sp>
         <p:nvSpPr>
-          <p:cNvPr id="96" name="Oval 95"/>
+          <p:cNvPr id="100" name="Oval 99"/>
           <p:cNvSpPr/>
           <p:nvPr/>
         </p:nvSpPr>
@@ -11855,7 +12207,7 @@
       </p:sp>
       <p:sp>
         <p:nvSpPr>
-          <p:cNvPr id="97" name="TextBox 96"/>
+          <p:cNvPr id="101" name="TextBox 100"/>
           <p:cNvSpPr txBox="1"/>
           <p:nvPr/>
         </p:nvSpPr>
@@ -11891,7 +12243,7 @@
       </p:sp>
       <p:sp>
         <p:nvSpPr>
-          <p:cNvPr id="98" name="Oval 97"/>
+          <p:cNvPr id="102" name="Oval 101"/>
           <p:cNvSpPr/>
           <p:nvPr/>
         </p:nvSpPr>
@@ -11935,7 +12287,7 @@
       </p:sp>
       <p:sp>
         <p:nvSpPr>
-          <p:cNvPr id="99" name="TextBox 98"/>
+          <p:cNvPr id="103" name="TextBox 102"/>
           <p:cNvSpPr txBox="1"/>
           <p:nvPr/>
         </p:nvSpPr>

</xml_diff>

<commit_message>
Add digital team with responsibility notes
Co-Authored-By: Claude Opus 5.5 <noreply@anthropic.com>
Claude-Session: https://claude.ai/code/session_01W7Er83FuNT4pLFShWidYHn
</commit_message>
<xml_diff>
--- a/presentation/out/koach-hitarvut.pptx
+++ b/presentation/out/koach-hitarvut.pptx
@@ -4460,8 +4460,8 @@
         </p:nvSpPr>
         <p:spPr>
           <a:xfrm>
-            <a:off x="5364327" y="3182112"/>
-            <a:ext cx="5212080" cy="2962656"/>
+            <a:off x="7143031" y="3182112"/>
+            <a:ext cx="4637181" cy="2962656"/>
           </a:xfrm>
           <a:prstGeom prst="roundRect">
             <a:avLst>
@@ -4506,7 +4506,7 @@
         </p:nvSpPr>
         <p:spPr>
           <a:xfrm>
-            <a:off x="6781647" y="2926080"/>
+            <a:off x="8272901" y="2926080"/>
             <a:ext cx="2377440" cy="512064"/>
           </a:xfrm>
           <a:prstGeom prst="roundRect">
@@ -4554,7 +4554,7 @@
         </p:nvSpPr>
         <p:spPr>
           <a:xfrm>
-            <a:off x="9095079" y="2999232"/>
+            <a:off x="10586333" y="2999232"/>
             <a:ext cx="45720" cy="365760"/>
           </a:xfrm>
           <a:prstGeom prst="rect">
@@ -4598,7 +4598,7 @@
         </p:nvSpPr>
         <p:spPr>
           <a:xfrm>
-            <a:off x="6781647" y="2980944"/>
+            <a:off x="8272901" y="2980944"/>
             <a:ext cx="2377440" cy="266273"/>
           </a:xfrm>
           <a:prstGeom prst="rect">
@@ -4634,7 +4634,7 @@
         </p:nvSpPr>
         <p:spPr>
           <a:xfrm>
-            <a:off x="6781647" y="3207715"/>
+            <a:off x="8272901" y="3207715"/>
             <a:ext cx="2377440" cy="204825"/>
           </a:xfrm>
           <a:prstGeom prst="rect">
@@ -4670,8 +4670,8 @@
         </p:nvSpPr>
         <p:spPr>
           <a:xfrm>
-            <a:off x="8857335" y="3675888"/>
-            <a:ext cx="1627632" cy="329184"/>
+            <a:off x="10252773" y="3675888"/>
+            <a:ext cx="1435999" cy="329184"/>
           </a:xfrm>
           <a:prstGeom prst="roundRect">
             <a:avLst>
@@ -4718,7 +4718,7 @@
         </p:nvSpPr>
         <p:spPr>
           <a:xfrm>
-            <a:off x="10420959" y="3749040"/>
+            <a:off x="11624764" y="3749040"/>
             <a:ext cx="45720" cy="182880"/>
           </a:xfrm>
           <a:prstGeom prst="rect">
@@ -4762,8 +4762,8 @@
         </p:nvSpPr>
         <p:spPr>
           <a:xfrm>
-            <a:off x="8857335" y="3675888"/>
-            <a:ext cx="1627632" cy="329184"/>
+            <a:off x="10252773" y="3675888"/>
+            <a:ext cx="1435999" cy="329184"/>
           </a:xfrm>
           <a:prstGeom prst="rect">
             <a:avLst/>
@@ -4798,8 +4798,8 @@
         </p:nvSpPr>
         <p:spPr>
           <a:xfrm>
-            <a:off x="7156551" y="3675888"/>
-            <a:ext cx="1627632" cy="329184"/>
+            <a:off x="8743622" y="3675888"/>
+            <a:ext cx="1435999" cy="329184"/>
           </a:xfrm>
           <a:prstGeom prst="roundRect">
             <a:avLst>
@@ -4846,7 +4846,7 @@
         </p:nvSpPr>
         <p:spPr>
           <a:xfrm>
-            <a:off x="8720175" y="3749040"/>
+            <a:off x="10115613" y="3749040"/>
             <a:ext cx="45720" cy="182880"/>
           </a:xfrm>
           <a:prstGeom prst="rect">
@@ -4890,8 +4890,8 @@
         </p:nvSpPr>
         <p:spPr>
           <a:xfrm>
-            <a:off x="7156551" y="3675888"/>
-            <a:ext cx="1627632" cy="329184"/>
+            <a:off x="8743622" y="3675888"/>
+            <a:ext cx="1435999" cy="329184"/>
           </a:xfrm>
           <a:prstGeom prst="rect">
             <a:avLst/>
@@ -4913,7 +4913,7 @@
                 <a:latin typeface="Heebo"/>
                 <a:cs typeface="Heebo"/>
               </a:rPr>
-              <a:t>יואב</a:t>
+              <a:t>יואב קוסטינר</a:t>
             </a:r>
           </a:p>
         </p:txBody>
@@ -4926,8 +4926,8 @@
         </p:nvSpPr>
         <p:spPr>
           <a:xfrm>
-            <a:off x="5455767" y="3675888"/>
-            <a:ext cx="1627632" cy="329184"/>
+            <a:off x="7234471" y="3675888"/>
+            <a:ext cx="1435999" cy="329184"/>
           </a:xfrm>
           <a:prstGeom prst="roundRect">
             <a:avLst>
@@ -4974,7 +4974,7 @@
         </p:nvSpPr>
         <p:spPr>
           <a:xfrm>
-            <a:off x="7019391" y="3749040"/>
+            <a:off x="8606462" y="3749040"/>
             <a:ext cx="45720" cy="182880"/>
           </a:xfrm>
           <a:prstGeom prst="rect">
@@ -5018,8 +5018,8 @@
         </p:nvSpPr>
         <p:spPr>
           <a:xfrm>
-            <a:off x="5455767" y="3675888"/>
-            <a:ext cx="1627632" cy="329184"/>
+            <a:off x="7234471" y="3675888"/>
+            <a:ext cx="1435999" cy="329184"/>
           </a:xfrm>
           <a:prstGeom prst="rect">
             <a:avLst/>
@@ -5054,8 +5054,8 @@
         </p:nvSpPr>
         <p:spPr>
           <a:xfrm>
-            <a:off x="8857335" y="4078224"/>
-            <a:ext cx="1627632" cy="329184"/>
+            <a:off x="10252773" y="4078224"/>
+            <a:ext cx="1435999" cy="329184"/>
           </a:xfrm>
           <a:prstGeom prst="roundRect">
             <a:avLst>
@@ -5102,7 +5102,7 @@
         </p:nvSpPr>
         <p:spPr>
           <a:xfrm>
-            <a:off x="10420959" y="4151376"/>
+            <a:off x="11624764" y="4151376"/>
             <a:ext cx="45720" cy="182880"/>
           </a:xfrm>
           <a:prstGeom prst="rect">
@@ -5146,8 +5146,8 @@
         </p:nvSpPr>
         <p:spPr>
           <a:xfrm>
-            <a:off x="8857335" y="4078224"/>
-            <a:ext cx="1627632" cy="329184"/>
+            <a:off x="10252773" y="4078224"/>
+            <a:ext cx="1435999" cy="329184"/>
           </a:xfrm>
           <a:prstGeom prst="rect">
             <a:avLst/>
@@ -5182,8 +5182,8 @@
         </p:nvSpPr>
         <p:spPr>
           <a:xfrm>
-            <a:off x="7156551" y="4078224"/>
-            <a:ext cx="1627632" cy="329184"/>
+            <a:off x="8743622" y="4078224"/>
+            <a:ext cx="1435999" cy="329184"/>
           </a:xfrm>
           <a:prstGeom prst="roundRect">
             <a:avLst>
@@ -5230,7 +5230,7 @@
         </p:nvSpPr>
         <p:spPr>
           <a:xfrm>
-            <a:off x="8720175" y="4151376"/>
+            <a:off x="10115613" y="4151376"/>
             <a:ext cx="45720" cy="182880"/>
           </a:xfrm>
           <a:prstGeom prst="rect">
@@ -5274,8 +5274,8 @@
         </p:nvSpPr>
         <p:spPr>
           <a:xfrm>
-            <a:off x="7156551" y="4078224"/>
-            <a:ext cx="1627632" cy="329184"/>
+            <a:off x="8743622" y="4078224"/>
+            <a:ext cx="1435999" cy="329184"/>
           </a:xfrm>
           <a:prstGeom prst="rect">
             <a:avLst/>
@@ -5310,8 +5310,8 @@
         </p:nvSpPr>
         <p:spPr>
           <a:xfrm>
-            <a:off x="5455767" y="4078224"/>
-            <a:ext cx="1627632" cy="329184"/>
+            <a:off x="7234471" y="4078224"/>
+            <a:ext cx="1435999" cy="329184"/>
           </a:xfrm>
           <a:prstGeom prst="roundRect">
             <a:avLst>
@@ -5358,7 +5358,7 @@
         </p:nvSpPr>
         <p:spPr>
           <a:xfrm>
-            <a:off x="7019391" y="4151376"/>
+            <a:off x="8606462" y="4151376"/>
             <a:ext cx="45720" cy="182880"/>
           </a:xfrm>
           <a:prstGeom prst="rect">
@@ -5402,8 +5402,8 @@
         </p:nvSpPr>
         <p:spPr>
           <a:xfrm>
-            <a:off x="5455767" y="4078224"/>
-            <a:ext cx="1627632" cy="329184"/>
+            <a:off x="7234471" y="4078224"/>
+            <a:ext cx="1435999" cy="329184"/>
           </a:xfrm>
           <a:prstGeom prst="rect">
             <a:avLst/>
@@ -5438,8 +5438,8 @@
         </p:nvSpPr>
         <p:spPr>
           <a:xfrm>
-            <a:off x="8857335" y="4480560"/>
-            <a:ext cx="1627632" cy="329184"/>
+            <a:off x="10252773" y="4480560"/>
+            <a:ext cx="1435999" cy="329184"/>
           </a:xfrm>
           <a:prstGeom prst="roundRect">
             <a:avLst>
@@ -5486,7 +5486,7 @@
         </p:nvSpPr>
         <p:spPr>
           <a:xfrm>
-            <a:off x="10420959" y="4553712"/>
+            <a:off x="11624764" y="4553712"/>
             <a:ext cx="45720" cy="182880"/>
           </a:xfrm>
           <a:prstGeom prst="rect">
@@ -5530,8 +5530,8 @@
         </p:nvSpPr>
         <p:spPr>
           <a:xfrm>
-            <a:off x="8857335" y="4480560"/>
-            <a:ext cx="1627632" cy="329184"/>
+            <a:off x="10252773" y="4480560"/>
+            <a:ext cx="1435999" cy="329184"/>
           </a:xfrm>
           <a:prstGeom prst="rect">
             <a:avLst/>
@@ -5566,8 +5566,8 @@
         </p:nvSpPr>
         <p:spPr>
           <a:xfrm>
-            <a:off x="7156551" y="4480560"/>
-            <a:ext cx="1627632" cy="329184"/>
+            <a:off x="8743622" y="4480560"/>
+            <a:ext cx="1435999" cy="329184"/>
           </a:xfrm>
           <a:prstGeom prst="roundRect">
             <a:avLst>
@@ -5614,7 +5614,7 @@
         </p:nvSpPr>
         <p:spPr>
           <a:xfrm>
-            <a:off x="8720175" y="4553712"/>
+            <a:off x="10115613" y="4553712"/>
             <a:ext cx="45720" cy="182880"/>
           </a:xfrm>
           <a:prstGeom prst="rect">
@@ -5658,8 +5658,8 @@
         </p:nvSpPr>
         <p:spPr>
           <a:xfrm>
-            <a:off x="7156551" y="4480560"/>
-            <a:ext cx="1627632" cy="329184"/>
+            <a:off x="8743622" y="4480560"/>
+            <a:ext cx="1435999" cy="329184"/>
           </a:xfrm>
           <a:prstGeom prst="rect">
             <a:avLst/>
@@ -5694,8 +5694,8 @@
         </p:nvSpPr>
         <p:spPr>
           <a:xfrm>
-            <a:off x="5455767" y="4480560"/>
-            <a:ext cx="1627632" cy="329184"/>
+            <a:off x="7234471" y="4480560"/>
+            <a:ext cx="1435999" cy="329184"/>
           </a:xfrm>
           <a:prstGeom prst="roundRect">
             <a:avLst>
@@ -5742,7 +5742,7 @@
         </p:nvSpPr>
         <p:spPr>
           <a:xfrm>
-            <a:off x="7019391" y="4553712"/>
+            <a:off x="8606462" y="4553712"/>
             <a:ext cx="45720" cy="182880"/>
           </a:xfrm>
           <a:prstGeom prst="rect">
@@ -5786,8 +5786,8 @@
         </p:nvSpPr>
         <p:spPr>
           <a:xfrm>
-            <a:off x="5455767" y="4480560"/>
-            <a:ext cx="1627632" cy="329184"/>
+            <a:off x="7234471" y="4480560"/>
+            <a:ext cx="1435999" cy="329184"/>
           </a:xfrm>
           <a:prstGeom prst="rect">
             <a:avLst/>
@@ -5822,8 +5822,8 @@
         </p:nvSpPr>
         <p:spPr>
           <a:xfrm>
-            <a:off x="8857335" y="4882896"/>
-            <a:ext cx="1627632" cy="329184"/>
+            <a:off x="10252773" y="4882896"/>
+            <a:ext cx="1435999" cy="329184"/>
           </a:xfrm>
           <a:prstGeom prst="roundRect">
             <a:avLst>
@@ -5870,7 +5870,7 @@
         </p:nvSpPr>
         <p:spPr>
           <a:xfrm>
-            <a:off x="10420959" y="4956048"/>
+            <a:off x="11624764" y="4956048"/>
             <a:ext cx="45720" cy="182880"/>
           </a:xfrm>
           <a:prstGeom prst="rect">
@@ -5914,8 +5914,8 @@
         </p:nvSpPr>
         <p:spPr>
           <a:xfrm>
-            <a:off x="8857335" y="4882896"/>
-            <a:ext cx="1627632" cy="329184"/>
+            <a:off x="10252773" y="4882896"/>
+            <a:ext cx="1435999" cy="329184"/>
           </a:xfrm>
           <a:prstGeom prst="rect">
             <a:avLst/>
@@ -5950,8 +5950,8 @@
         </p:nvSpPr>
         <p:spPr>
           <a:xfrm>
-            <a:off x="7156551" y="4882896"/>
-            <a:ext cx="1627632" cy="329184"/>
+            <a:off x="8743622" y="4882896"/>
+            <a:ext cx="1435999" cy="329184"/>
           </a:xfrm>
           <a:prstGeom prst="roundRect">
             <a:avLst>
@@ -5998,7 +5998,7 @@
         </p:nvSpPr>
         <p:spPr>
           <a:xfrm>
-            <a:off x="8720175" y="4956048"/>
+            <a:off x="10115613" y="4956048"/>
             <a:ext cx="45720" cy="182880"/>
           </a:xfrm>
           <a:prstGeom prst="rect">
@@ -6042,8 +6042,8 @@
         </p:nvSpPr>
         <p:spPr>
           <a:xfrm>
-            <a:off x="7156551" y="4882896"/>
-            <a:ext cx="1627632" cy="329184"/>
+            <a:off x="8743622" y="4882896"/>
+            <a:ext cx="1435999" cy="329184"/>
           </a:xfrm>
           <a:prstGeom prst="rect">
             <a:avLst/>
@@ -6078,8 +6078,8 @@
         </p:nvSpPr>
         <p:spPr>
           <a:xfrm>
-            <a:off x="5455767" y="4882896"/>
-            <a:ext cx="1627632" cy="329184"/>
+            <a:off x="7234471" y="4882896"/>
+            <a:ext cx="1435999" cy="329184"/>
           </a:xfrm>
           <a:prstGeom prst="roundRect">
             <a:avLst>
@@ -6126,7 +6126,7 @@
         </p:nvSpPr>
         <p:spPr>
           <a:xfrm>
-            <a:off x="7019391" y="4956048"/>
+            <a:off x="8606462" y="4956048"/>
             <a:ext cx="45720" cy="182880"/>
           </a:xfrm>
           <a:prstGeom prst="rect">
@@ -6170,8 +6170,8 @@
         </p:nvSpPr>
         <p:spPr>
           <a:xfrm>
-            <a:off x="5455767" y="4882896"/>
-            <a:ext cx="1627632" cy="329184"/>
+            <a:off x="7234471" y="4882896"/>
+            <a:ext cx="1435999" cy="329184"/>
           </a:xfrm>
           <a:prstGeom prst="rect">
             <a:avLst/>
@@ -6206,8 +6206,8 @@
         </p:nvSpPr>
         <p:spPr>
           <a:xfrm>
-            <a:off x="8857335" y="5285232"/>
-            <a:ext cx="1627632" cy="329184"/>
+            <a:off x="10252773" y="5285232"/>
+            <a:ext cx="1435999" cy="329184"/>
           </a:xfrm>
           <a:prstGeom prst="roundRect">
             <a:avLst>
@@ -6254,7 +6254,7 @@
         </p:nvSpPr>
         <p:spPr>
           <a:xfrm>
-            <a:off x="10420959" y="5358384"/>
+            <a:off x="11624764" y="5358384"/>
             <a:ext cx="45720" cy="182880"/>
           </a:xfrm>
           <a:prstGeom prst="rect">
@@ -6298,8 +6298,8 @@
         </p:nvSpPr>
         <p:spPr>
           <a:xfrm>
-            <a:off x="8857335" y="5285232"/>
-            <a:ext cx="1627632" cy="329184"/>
+            <a:off x="10252773" y="5285232"/>
+            <a:ext cx="1435999" cy="329184"/>
           </a:xfrm>
           <a:prstGeom prst="rect">
             <a:avLst/>
@@ -6334,8 +6334,8 @@
         </p:nvSpPr>
         <p:spPr>
           <a:xfrm>
-            <a:off x="7156551" y="5285232"/>
-            <a:ext cx="1627632" cy="329184"/>
+            <a:off x="8743622" y="5285232"/>
+            <a:ext cx="1435999" cy="329184"/>
           </a:xfrm>
           <a:prstGeom prst="roundRect">
             <a:avLst>
@@ -6382,7 +6382,7 @@
         </p:nvSpPr>
         <p:spPr>
           <a:xfrm>
-            <a:off x="8720175" y="5358384"/>
+            <a:off x="10115613" y="5358384"/>
             <a:ext cx="45720" cy="182880"/>
           </a:xfrm>
           <a:prstGeom prst="rect">
@@ -6426,8 +6426,8 @@
         </p:nvSpPr>
         <p:spPr>
           <a:xfrm>
-            <a:off x="7156551" y="5285232"/>
-            <a:ext cx="1627632" cy="329184"/>
+            <a:off x="8743622" y="5285232"/>
+            <a:ext cx="1435999" cy="329184"/>
           </a:xfrm>
           <a:prstGeom prst="rect">
             <a:avLst/>
@@ -6462,8 +6462,8 @@
         </p:nvSpPr>
         <p:spPr>
           <a:xfrm>
-            <a:off x="5455767" y="5285232"/>
-            <a:ext cx="1627632" cy="329184"/>
+            <a:off x="7234471" y="5285232"/>
+            <a:ext cx="1435999" cy="329184"/>
           </a:xfrm>
           <a:prstGeom prst="roundRect">
             <a:avLst>
@@ -6510,7 +6510,7 @@
         </p:nvSpPr>
         <p:spPr>
           <a:xfrm>
-            <a:off x="7019391" y="5358384"/>
+            <a:off x="8606462" y="5358384"/>
             <a:ext cx="45720" cy="182880"/>
           </a:xfrm>
           <a:prstGeom prst="rect">
@@ -6554,8 +6554,8 @@
         </p:nvSpPr>
         <p:spPr>
           <a:xfrm>
-            <a:off x="5455767" y="5285232"/>
-            <a:ext cx="1627632" cy="329184"/>
+            <a:off x="7234471" y="5285232"/>
+            <a:ext cx="1435999" cy="329184"/>
           </a:xfrm>
           <a:prstGeom prst="rect">
             <a:avLst/>
@@ -6590,8 +6590,8 @@
         </p:nvSpPr>
         <p:spPr>
           <a:xfrm>
-            <a:off x="8857335" y="5687568"/>
-            <a:ext cx="1627632" cy="329184"/>
+            <a:off x="10252773" y="5687568"/>
+            <a:ext cx="1435999" cy="329184"/>
           </a:xfrm>
           <a:prstGeom prst="roundRect">
             <a:avLst>
@@ -6638,7 +6638,7 @@
         </p:nvSpPr>
         <p:spPr>
           <a:xfrm>
-            <a:off x="10420959" y="5760720"/>
+            <a:off x="11624764" y="5760720"/>
             <a:ext cx="45720" cy="182880"/>
           </a:xfrm>
           <a:prstGeom prst="rect">
@@ -6682,8 +6682,8 @@
         </p:nvSpPr>
         <p:spPr>
           <a:xfrm>
-            <a:off x="8857335" y="5687568"/>
-            <a:ext cx="1627632" cy="329184"/>
+            <a:off x="10252773" y="5687568"/>
+            <a:ext cx="1435999" cy="329184"/>
           </a:xfrm>
           <a:prstGeom prst="rect">
             <a:avLst/>
@@ -6718,8 +6718,8 @@
         </p:nvSpPr>
         <p:spPr>
           <a:xfrm>
-            <a:off x="7156551" y="5687568"/>
-            <a:ext cx="1627632" cy="329184"/>
+            <a:off x="8743622" y="5687568"/>
+            <a:ext cx="1435999" cy="329184"/>
           </a:xfrm>
           <a:prstGeom prst="roundRect">
             <a:avLst>
@@ -6766,7 +6766,7 @@
         </p:nvSpPr>
         <p:spPr>
           <a:xfrm>
-            <a:off x="8720175" y="5760720"/>
+            <a:off x="10115613" y="5760720"/>
             <a:ext cx="45720" cy="182880"/>
           </a:xfrm>
           <a:prstGeom prst="rect">
@@ -6810,8 +6810,8 @@
         </p:nvSpPr>
         <p:spPr>
           <a:xfrm>
-            <a:off x="7156551" y="5687568"/>
-            <a:ext cx="1627632" cy="329184"/>
+            <a:off x="8743622" y="5687568"/>
+            <a:ext cx="1435999" cy="329184"/>
           </a:xfrm>
           <a:prstGeom prst="rect">
             <a:avLst/>
@@ -6846,8 +6846,8 @@
         </p:nvSpPr>
         <p:spPr>
           <a:xfrm>
-            <a:off x="5455767" y="5687568"/>
-            <a:ext cx="1627632" cy="329184"/>
+            <a:off x="7234471" y="5687568"/>
+            <a:ext cx="1435999" cy="329184"/>
           </a:xfrm>
           <a:prstGeom prst="roundRect">
             <a:avLst>
@@ -6894,7 +6894,7 @@
         </p:nvSpPr>
         <p:spPr>
           <a:xfrm>
-            <a:off x="7019391" y="5760720"/>
+            <a:off x="8606462" y="5760720"/>
             <a:ext cx="45720" cy="182880"/>
           </a:xfrm>
           <a:prstGeom prst="rect">
@@ -6938,8 +6938,8 @@
         </p:nvSpPr>
         <p:spPr>
           <a:xfrm>
-            <a:off x="5455767" y="5687568"/>
-            <a:ext cx="1627632" cy="329184"/>
+            <a:off x="7234471" y="5687568"/>
+            <a:ext cx="1435999" cy="329184"/>
           </a:xfrm>
           <a:prstGeom prst="rect">
             <a:avLst/>
@@ -6974,8 +6974,8 @@
         </p:nvSpPr>
         <p:spPr>
           <a:xfrm>
-            <a:off x="1615287" y="3182112"/>
-            <a:ext cx="3474720" cy="2157984"/>
+            <a:off x="3777257" y="3182112"/>
+            <a:ext cx="3091454" cy="2157984"/>
           </a:xfrm>
           <a:prstGeom prst="roundRect">
             <a:avLst>
@@ -7020,7 +7020,7 @@
         </p:nvSpPr>
         <p:spPr>
           <a:xfrm>
-            <a:off x="2163927" y="2926080"/>
+            <a:off x="4134264" y="2926080"/>
             <a:ext cx="2377440" cy="512064"/>
           </a:xfrm>
           <a:prstGeom prst="roundRect">
@@ -7068,7 +7068,7 @@
         </p:nvSpPr>
         <p:spPr>
           <a:xfrm>
-            <a:off x="4477359" y="2999232"/>
+            <a:off x="6447696" y="2999232"/>
             <a:ext cx="45720" cy="365760"/>
           </a:xfrm>
           <a:prstGeom prst="rect">
@@ -7112,7 +7112,7 @@
         </p:nvSpPr>
         <p:spPr>
           <a:xfrm>
-            <a:off x="2163927" y="2980944"/>
+            <a:off x="4134264" y="2980944"/>
             <a:ext cx="2377440" cy="266273"/>
           </a:xfrm>
           <a:prstGeom prst="rect">
@@ -7148,7 +7148,7 @@
         </p:nvSpPr>
         <p:spPr>
           <a:xfrm>
-            <a:off x="2163927" y="3207715"/>
+            <a:off x="4134264" y="3207715"/>
             <a:ext cx="2377440" cy="204825"/>
           </a:xfrm>
           <a:prstGeom prst="rect">
@@ -7184,8 +7184,8 @@
         </p:nvSpPr>
         <p:spPr>
           <a:xfrm>
-            <a:off x="3389223" y="3675888"/>
-            <a:ext cx="1609344" cy="329184"/>
+            <a:off x="5359560" y="3675888"/>
+            <a:ext cx="1417711" cy="329184"/>
           </a:xfrm>
           <a:prstGeom prst="roundRect">
             <a:avLst>
@@ -7232,7 +7232,7 @@
         </p:nvSpPr>
         <p:spPr>
           <a:xfrm>
-            <a:off x="4934559" y="3749040"/>
+            <a:off x="6713263" y="3749040"/>
             <a:ext cx="45720" cy="182880"/>
           </a:xfrm>
           <a:prstGeom prst="rect">
@@ -7276,8 +7276,8 @@
         </p:nvSpPr>
         <p:spPr>
           <a:xfrm>
-            <a:off x="3389223" y="3675888"/>
-            <a:ext cx="1609344" cy="329184"/>
+            <a:off x="5359560" y="3675888"/>
+            <a:ext cx="1417711" cy="329184"/>
           </a:xfrm>
           <a:prstGeom prst="rect">
             <a:avLst/>
@@ -7312,8 +7312,8 @@
         </p:nvSpPr>
         <p:spPr>
           <a:xfrm>
-            <a:off x="1706727" y="3675888"/>
-            <a:ext cx="1609344" cy="329184"/>
+            <a:off x="3868697" y="3675888"/>
+            <a:ext cx="1417711" cy="329184"/>
           </a:xfrm>
           <a:prstGeom prst="roundRect">
             <a:avLst>
@@ -7360,7 +7360,7 @@
         </p:nvSpPr>
         <p:spPr>
           <a:xfrm>
-            <a:off x="3252063" y="3749040"/>
+            <a:off x="5222400" y="3749040"/>
             <a:ext cx="45720" cy="182880"/>
           </a:xfrm>
           <a:prstGeom prst="rect">
@@ -7404,8 +7404,8 @@
         </p:nvSpPr>
         <p:spPr>
           <a:xfrm>
-            <a:off x="1706727" y="3675888"/>
-            <a:ext cx="1609344" cy="329184"/>
+            <a:off x="3868697" y="3675888"/>
+            <a:ext cx="1417711" cy="329184"/>
           </a:xfrm>
           <a:prstGeom prst="rect">
             <a:avLst/>
@@ -7440,8 +7440,8 @@
         </p:nvSpPr>
         <p:spPr>
           <a:xfrm>
-            <a:off x="3389223" y="4078224"/>
-            <a:ext cx="1609344" cy="329184"/>
+            <a:off x="5359560" y="4078224"/>
+            <a:ext cx="1417711" cy="329184"/>
           </a:xfrm>
           <a:prstGeom prst="roundRect">
             <a:avLst>
@@ -7488,7 +7488,7 @@
         </p:nvSpPr>
         <p:spPr>
           <a:xfrm>
-            <a:off x="4934559" y="4151376"/>
+            <a:off x="6713263" y="4151376"/>
             <a:ext cx="45720" cy="182880"/>
           </a:xfrm>
           <a:prstGeom prst="rect">
@@ -7532,8 +7532,8 @@
         </p:nvSpPr>
         <p:spPr>
           <a:xfrm>
-            <a:off x="3389223" y="4078224"/>
-            <a:ext cx="1609344" cy="329184"/>
+            <a:off x="5359560" y="4078224"/>
+            <a:ext cx="1417711" cy="329184"/>
           </a:xfrm>
           <a:prstGeom prst="rect">
             <a:avLst/>
@@ -7568,8 +7568,8 @@
         </p:nvSpPr>
         <p:spPr>
           <a:xfrm>
-            <a:off x="1706727" y="4078224"/>
-            <a:ext cx="1609344" cy="329184"/>
+            <a:off x="3868697" y="4078224"/>
+            <a:ext cx="1417711" cy="329184"/>
           </a:xfrm>
           <a:prstGeom prst="roundRect">
             <a:avLst>
@@ -7616,7 +7616,7 @@
         </p:nvSpPr>
         <p:spPr>
           <a:xfrm>
-            <a:off x="3252063" y="4151376"/>
+            <a:off x="5222400" y="4151376"/>
             <a:ext cx="45720" cy="182880"/>
           </a:xfrm>
           <a:prstGeom prst="rect">
@@ -7660,8 +7660,8 @@
         </p:nvSpPr>
         <p:spPr>
           <a:xfrm>
-            <a:off x="1706727" y="4078224"/>
-            <a:ext cx="1609344" cy="329184"/>
+            <a:off x="3868697" y="4078224"/>
+            <a:ext cx="1417711" cy="329184"/>
           </a:xfrm>
           <a:prstGeom prst="rect">
             <a:avLst/>
@@ -7696,8 +7696,8 @@
         </p:nvSpPr>
         <p:spPr>
           <a:xfrm>
-            <a:off x="3389223" y="4480560"/>
-            <a:ext cx="1609344" cy="329184"/>
+            <a:off x="5359560" y="4480560"/>
+            <a:ext cx="1417711" cy="329184"/>
           </a:xfrm>
           <a:prstGeom prst="roundRect">
             <a:avLst>
@@ -7744,7 +7744,7 @@
         </p:nvSpPr>
         <p:spPr>
           <a:xfrm>
-            <a:off x="4934559" y="4553712"/>
+            <a:off x="6713263" y="4553712"/>
             <a:ext cx="45720" cy="182880"/>
           </a:xfrm>
           <a:prstGeom prst="rect">
@@ -7788,8 +7788,8 @@
         </p:nvSpPr>
         <p:spPr>
           <a:xfrm>
-            <a:off x="3389223" y="4480560"/>
-            <a:ext cx="1609344" cy="329184"/>
+            <a:off x="5359560" y="4480560"/>
+            <a:ext cx="1417711" cy="329184"/>
           </a:xfrm>
           <a:prstGeom prst="rect">
             <a:avLst/>
@@ -7824,8 +7824,8 @@
         </p:nvSpPr>
         <p:spPr>
           <a:xfrm>
-            <a:off x="1706727" y="4480560"/>
-            <a:ext cx="1609344" cy="329184"/>
+            <a:off x="3868697" y="4480560"/>
+            <a:ext cx="1417711" cy="329184"/>
           </a:xfrm>
           <a:prstGeom prst="roundRect">
             <a:avLst>
@@ -7872,7 +7872,7 @@
         </p:nvSpPr>
         <p:spPr>
           <a:xfrm>
-            <a:off x="3252063" y="4553712"/>
+            <a:off x="5222400" y="4553712"/>
             <a:ext cx="45720" cy="182880"/>
           </a:xfrm>
           <a:prstGeom prst="rect">
@@ -7916,8 +7916,8 @@
         </p:nvSpPr>
         <p:spPr>
           <a:xfrm>
-            <a:off x="1706727" y="4480560"/>
-            <a:ext cx="1609344" cy="329184"/>
+            <a:off x="3868697" y="4480560"/>
+            <a:ext cx="1417711" cy="329184"/>
           </a:xfrm>
           <a:prstGeom prst="rect">
             <a:avLst/>
@@ -7952,8 +7952,8 @@
         </p:nvSpPr>
         <p:spPr>
           <a:xfrm>
-            <a:off x="3389223" y="4882896"/>
-            <a:ext cx="1609344" cy="329184"/>
+            <a:off x="5359560" y="4882896"/>
+            <a:ext cx="1417711" cy="329184"/>
           </a:xfrm>
           <a:prstGeom prst="roundRect">
             <a:avLst>
@@ -8000,7 +8000,7 @@
         </p:nvSpPr>
         <p:spPr>
           <a:xfrm>
-            <a:off x="4934559" y="4956048"/>
+            <a:off x="6713263" y="4956048"/>
             <a:ext cx="45720" cy="182880"/>
           </a:xfrm>
           <a:prstGeom prst="rect">
@@ -8044,8 +8044,8 @@
         </p:nvSpPr>
         <p:spPr>
           <a:xfrm>
-            <a:off x="3389223" y="4882896"/>
-            <a:ext cx="1609344" cy="329184"/>
+            <a:off x="5359560" y="4882896"/>
+            <a:ext cx="1417711" cy="329184"/>
           </a:xfrm>
           <a:prstGeom prst="rect">
             <a:avLst/>
@@ -8072,9 +8072,1515 @@
           </a:p>
         </p:txBody>
       </p:sp>
+      <p:sp>
+        <p:nvSpPr>
+          <p:cNvPr id="121" name="Rounded Rectangle 120"/>
+          <p:cNvSpPr/>
+          <p:nvPr/>
+        </p:nvSpPr>
+        <p:spPr>
+          <a:xfrm>
+            <a:off x="411483" y="3182112"/>
+            <a:ext cx="3091454" cy="2560320"/>
+          </a:xfrm>
+          <a:prstGeom prst="roundRect">
+            <a:avLst>
+              <a:gd name="adj" fmla="val 4000"/>
+            </a:avLst>
+          </a:prstGeom>
+          <a:noFill/>
+          <a:ln w="15875">
+            <a:solidFill>
+              <a:srgbClr val="C5CDDD"/>
+            </a:solidFill>
+          </a:ln>
+          <a:effectLst/>
+        </p:spPr>
+        <p:style>
+          <a:lnRef idx="1">
+            <a:schemeClr val="accent1"/>
+          </a:lnRef>
+          <a:fillRef idx="3">
+            <a:schemeClr val="accent1"/>
+          </a:fillRef>
+          <a:effectRef idx="2">
+            <a:schemeClr val="accent1"/>
+          </a:effectRef>
+          <a:fontRef idx="minor">
+            <a:schemeClr val="lt1"/>
+          </a:fontRef>
+        </p:style>
+        <p:txBody>
+          <a:bodyPr rtlCol="0" anchor="ctr"/>
+          <a:lstStyle/>
+          <a:p>
+            <a:pPr algn="ctr"/>
+          </a:p>
+        </p:txBody>
+      </p:sp>
+      <p:sp>
+        <p:nvSpPr>
+          <p:cNvPr id="122" name="Rounded Rectangle 121"/>
+          <p:cNvSpPr/>
+          <p:nvPr/>
+        </p:nvSpPr>
+        <p:spPr>
+          <a:xfrm>
+            <a:off x="768490" y="2926080"/>
+            <a:ext cx="2377440" cy="512064"/>
+          </a:xfrm>
+          <a:prstGeom prst="roundRect">
+            <a:avLst>
+              <a:gd name="adj" fmla="val 18000"/>
+            </a:avLst>
+          </a:prstGeom>
+          <a:solidFill>
+            <a:srgbClr val="FFFFFF"/>
+          </a:solidFill>
+          <a:ln w="15875">
+            <a:solidFill>
+              <a:srgbClr val="C5CDDD"/>
+            </a:solidFill>
+          </a:ln>
+          <a:effectLst/>
+        </p:spPr>
+        <p:style>
+          <a:lnRef idx="1">
+            <a:schemeClr val="accent1"/>
+          </a:lnRef>
+          <a:fillRef idx="3">
+            <a:schemeClr val="accent1"/>
+          </a:fillRef>
+          <a:effectRef idx="2">
+            <a:schemeClr val="accent1"/>
+          </a:effectRef>
+          <a:fontRef idx="minor">
+            <a:schemeClr val="lt1"/>
+          </a:fontRef>
+        </p:style>
+        <p:txBody>
+          <a:bodyPr rtlCol="0" anchor="ctr"/>
+          <a:lstStyle/>
+          <a:p>
+            <a:pPr algn="ctr"/>
+          </a:p>
+        </p:txBody>
+      </p:sp>
+      <p:sp>
+        <p:nvSpPr>
+          <p:cNvPr id="123" name="Rectangle 122"/>
+          <p:cNvSpPr/>
+          <p:nvPr/>
+        </p:nvSpPr>
+        <p:spPr>
+          <a:xfrm>
+            <a:off x="3081922" y="2999232"/>
+            <a:ext cx="45720" cy="365760"/>
+          </a:xfrm>
+          <a:prstGeom prst="rect">
+            <a:avLst/>
+          </a:prstGeom>
+          <a:solidFill>
+            <a:srgbClr val="F0C000"/>
+          </a:solidFill>
+          <a:ln>
+            <a:noFill/>
+          </a:ln>
+          <a:effectLst/>
+        </p:spPr>
+        <p:style>
+          <a:lnRef idx="1">
+            <a:schemeClr val="accent1"/>
+          </a:lnRef>
+          <a:fillRef idx="3">
+            <a:schemeClr val="accent1"/>
+          </a:fillRef>
+          <a:effectRef idx="2">
+            <a:schemeClr val="accent1"/>
+          </a:effectRef>
+          <a:fontRef idx="minor">
+            <a:schemeClr val="lt1"/>
+          </a:fontRef>
+        </p:style>
+        <p:txBody>
+          <a:bodyPr rtlCol="0" anchor="ctr"/>
+          <a:lstStyle/>
+          <a:p>
+            <a:pPr algn="ctr"/>
+          </a:p>
+        </p:txBody>
+      </p:sp>
+      <p:sp>
+        <p:nvSpPr>
+          <p:cNvPr id="124" name="TextBox 123"/>
+          <p:cNvSpPr txBox="1"/>
+          <p:nvPr/>
+        </p:nvSpPr>
+        <p:spPr>
+          <a:xfrm>
+            <a:off x="768490" y="2980944"/>
+            <a:ext cx="2377440" cy="266273"/>
+          </a:xfrm>
+          <a:prstGeom prst="rect">
+            <a:avLst/>
+          </a:prstGeom>
+          <a:noFill/>
+        </p:spPr>
+        <p:txBody>
+          <a:bodyPr wrap="square" anchor="b" lIns="36576" rIns="36576" tIns="0" bIns="0">
+            <a:spAutoFit/>
+          </a:bodyPr>
+          <a:lstStyle/>
+          <a:p>
+            <a:pPr algn="ctr" rtl="1"/>
+            <a:r>
+              <a:rPr sz="1200" b="1">
+                <a:solidFill>
+                  <a:srgbClr val="1A2233"/>
+                </a:solidFill>
+                <a:latin typeface="Heebo"/>
+                <a:cs typeface="Heebo"/>
+              </a:rPr>
+              <a:t>איתמר כהן</a:t>
+            </a:r>
+          </a:p>
+        </p:txBody>
+      </p:sp>
+      <p:sp>
+        <p:nvSpPr>
+          <p:cNvPr id="125" name="TextBox 124"/>
+          <p:cNvSpPr txBox="1"/>
+          <p:nvPr/>
+        </p:nvSpPr>
+        <p:spPr>
+          <a:xfrm>
+            <a:off x="768490" y="3207715"/>
+            <a:ext cx="2377440" cy="204825"/>
+          </a:xfrm>
+          <a:prstGeom prst="rect">
+            <a:avLst/>
+          </a:prstGeom>
+          <a:noFill/>
+        </p:spPr>
+        <p:txBody>
+          <a:bodyPr wrap="square" anchor="t" lIns="36576" rIns="36576" tIns="0" bIns="0">
+            <a:spAutoFit/>
+          </a:bodyPr>
+          <a:lstStyle/>
+          <a:p>
+            <a:pPr algn="ctr" rtl="1"/>
+            <a:r>
+              <a:rPr sz="900" b="0">
+                <a:solidFill>
+                  <a:srgbClr val="8A94A8"/>
+                </a:solidFill>
+                <a:latin typeface="Heebo"/>
+                <a:cs typeface="Heebo"/>
+              </a:rPr>
+              <a:t>ראש צוות (טוויטר) · צוות דיגיטל</a:t>
+            </a:r>
+          </a:p>
+        </p:txBody>
+      </p:sp>
+      <p:sp>
+        <p:nvSpPr>
+          <p:cNvPr id="126" name="Rounded Rectangle 125"/>
+          <p:cNvSpPr/>
+          <p:nvPr/>
+        </p:nvSpPr>
+        <p:spPr>
+          <a:xfrm>
+            <a:off x="1993786" y="3675888"/>
+            <a:ext cx="1417711" cy="329184"/>
+          </a:xfrm>
+          <a:prstGeom prst="roundRect">
+            <a:avLst>
+              <a:gd name="adj" fmla="val 18000"/>
+            </a:avLst>
+          </a:prstGeom>
+          <a:solidFill>
+            <a:srgbClr val="FFFFFF"/>
+          </a:solidFill>
+          <a:ln w="15875">
+            <a:solidFill>
+              <a:srgbClr val="C5CDDD"/>
+            </a:solidFill>
+          </a:ln>
+          <a:effectLst/>
+        </p:spPr>
+        <p:style>
+          <a:lnRef idx="1">
+            <a:schemeClr val="accent1"/>
+          </a:lnRef>
+          <a:fillRef idx="3">
+            <a:schemeClr val="accent1"/>
+          </a:fillRef>
+          <a:effectRef idx="2">
+            <a:schemeClr val="accent1"/>
+          </a:effectRef>
+          <a:fontRef idx="minor">
+            <a:schemeClr val="lt1"/>
+          </a:fontRef>
+        </p:style>
+        <p:txBody>
+          <a:bodyPr rtlCol="0" anchor="ctr"/>
+          <a:lstStyle/>
+          <a:p>
+            <a:pPr algn="ctr"/>
+          </a:p>
+        </p:txBody>
+      </p:sp>
+      <p:sp>
+        <p:nvSpPr>
+          <p:cNvPr id="127" name="Rectangle 126"/>
+          <p:cNvSpPr/>
+          <p:nvPr/>
+        </p:nvSpPr>
+        <p:spPr>
+          <a:xfrm>
+            <a:off x="3347489" y="3749040"/>
+            <a:ext cx="45720" cy="182880"/>
+          </a:xfrm>
+          <a:prstGeom prst="rect">
+            <a:avLst/>
+          </a:prstGeom>
+          <a:solidFill>
+            <a:srgbClr val="F0C000"/>
+          </a:solidFill>
+          <a:ln>
+            <a:noFill/>
+          </a:ln>
+          <a:effectLst/>
+        </p:spPr>
+        <p:style>
+          <a:lnRef idx="1">
+            <a:schemeClr val="accent1"/>
+          </a:lnRef>
+          <a:fillRef idx="3">
+            <a:schemeClr val="accent1"/>
+          </a:fillRef>
+          <a:effectRef idx="2">
+            <a:schemeClr val="accent1"/>
+          </a:effectRef>
+          <a:fontRef idx="minor">
+            <a:schemeClr val="lt1"/>
+          </a:fontRef>
+        </p:style>
+        <p:txBody>
+          <a:bodyPr rtlCol="0" anchor="ctr"/>
+          <a:lstStyle/>
+          <a:p>
+            <a:pPr algn="ctr"/>
+          </a:p>
+        </p:txBody>
+      </p:sp>
+      <p:sp>
+        <p:nvSpPr>
+          <p:cNvPr id="128" name="TextBox 127"/>
+          <p:cNvSpPr txBox="1"/>
+          <p:nvPr/>
+        </p:nvSpPr>
+        <p:spPr>
+          <a:xfrm>
+            <a:off x="1993786" y="3675888"/>
+            <a:ext cx="1417711" cy="197510"/>
+          </a:xfrm>
+          <a:prstGeom prst="rect">
+            <a:avLst/>
+          </a:prstGeom>
+          <a:noFill/>
+        </p:spPr>
+        <p:txBody>
+          <a:bodyPr wrap="square" anchor="b" lIns="36576" rIns="36576" tIns="0" bIns="0">
+            <a:spAutoFit/>
+          </a:bodyPr>
+          <a:lstStyle/>
+          <a:p>
+            <a:pPr algn="ctr" rtl="1"/>
+            <a:r>
+              <a:rPr sz="1000" b="1">
+                <a:solidFill>
+                  <a:srgbClr val="1A2233"/>
+                </a:solidFill>
+                <a:latin typeface="Heebo"/>
+                <a:cs typeface="Heebo"/>
+              </a:rPr>
+              <a:t>אלתר כהן</a:t>
+            </a:r>
+          </a:p>
+        </p:txBody>
+      </p:sp>
+      <p:sp>
+        <p:nvSpPr>
+          <p:cNvPr id="129" name="TextBox 128"/>
+          <p:cNvSpPr txBox="1"/>
+          <p:nvPr/>
+        </p:nvSpPr>
+        <p:spPr>
+          <a:xfrm>
+            <a:off x="1993786" y="3866814"/>
+            <a:ext cx="1417711" cy="131673"/>
+          </a:xfrm>
+          <a:prstGeom prst="rect">
+            <a:avLst/>
+          </a:prstGeom>
+          <a:noFill/>
+        </p:spPr>
+        <p:txBody>
+          <a:bodyPr wrap="square" anchor="t" lIns="36576" rIns="36576" tIns="0" bIns="0">
+            <a:spAutoFit/>
+          </a:bodyPr>
+          <a:lstStyle/>
+          <a:p>
+            <a:pPr algn="ctr" rtl="1"/>
+            <a:r>
+              <a:rPr sz="800" b="0">
+                <a:solidFill>
+                  <a:srgbClr val="8A94A8"/>
+                </a:solidFill>
+                <a:latin typeface="Heebo"/>
+                <a:cs typeface="Heebo"/>
+              </a:rPr>
+              <a:t>(אינסטגרם)</a:t>
+            </a:r>
+          </a:p>
+        </p:txBody>
+      </p:sp>
+      <p:sp>
+        <p:nvSpPr>
+          <p:cNvPr id="130" name="Rounded Rectangle 129"/>
+          <p:cNvSpPr/>
+          <p:nvPr/>
+        </p:nvSpPr>
+        <p:spPr>
+          <a:xfrm>
+            <a:off x="502923" y="3675888"/>
+            <a:ext cx="1417711" cy="329184"/>
+          </a:xfrm>
+          <a:prstGeom prst="roundRect">
+            <a:avLst>
+              <a:gd name="adj" fmla="val 18000"/>
+            </a:avLst>
+          </a:prstGeom>
+          <a:solidFill>
+            <a:srgbClr val="FFFFFF"/>
+          </a:solidFill>
+          <a:ln w="15875">
+            <a:solidFill>
+              <a:srgbClr val="C5CDDD"/>
+            </a:solidFill>
+          </a:ln>
+          <a:effectLst/>
+        </p:spPr>
+        <p:style>
+          <a:lnRef idx="1">
+            <a:schemeClr val="accent1"/>
+          </a:lnRef>
+          <a:fillRef idx="3">
+            <a:schemeClr val="accent1"/>
+          </a:fillRef>
+          <a:effectRef idx="2">
+            <a:schemeClr val="accent1"/>
+          </a:effectRef>
+          <a:fontRef idx="minor">
+            <a:schemeClr val="lt1"/>
+          </a:fontRef>
+        </p:style>
+        <p:txBody>
+          <a:bodyPr rtlCol="0" anchor="ctr"/>
+          <a:lstStyle/>
+          <a:p>
+            <a:pPr algn="ctr"/>
+          </a:p>
+        </p:txBody>
+      </p:sp>
+      <p:sp>
+        <p:nvSpPr>
+          <p:cNvPr id="131" name="Rectangle 130"/>
+          <p:cNvSpPr/>
+          <p:nvPr/>
+        </p:nvSpPr>
+        <p:spPr>
+          <a:xfrm>
+            <a:off x="1856626" y="3749040"/>
+            <a:ext cx="45720" cy="182880"/>
+          </a:xfrm>
+          <a:prstGeom prst="rect">
+            <a:avLst/>
+          </a:prstGeom>
+          <a:solidFill>
+            <a:srgbClr val="F0C000"/>
+          </a:solidFill>
+          <a:ln>
+            <a:noFill/>
+          </a:ln>
+          <a:effectLst/>
+        </p:spPr>
+        <p:style>
+          <a:lnRef idx="1">
+            <a:schemeClr val="accent1"/>
+          </a:lnRef>
+          <a:fillRef idx="3">
+            <a:schemeClr val="accent1"/>
+          </a:fillRef>
+          <a:effectRef idx="2">
+            <a:schemeClr val="accent1"/>
+          </a:effectRef>
+          <a:fontRef idx="minor">
+            <a:schemeClr val="lt1"/>
+          </a:fontRef>
+        </p:style>
+        <p:txBody>
+          <a:bodyPr rtlCol="0" anchor="ctr"/>
+          <a:lstStyle/>
+          <a:p>
+            <a:pPr algn="ctr"/>
+          </a:p>
+        </p:txBody>
+      </p:sp>
+      <p:sp>
+        <p:nvSpPr>
+          <p:cNvPr id="132" name="TextBox 131"/>
+          <p:cNvSpPr txBox="1"/>
+          <p:nvPr/>
+        </p:nvSpPr>
+        <p:spPr>
+          <a:xfrm>
+            <a:off x="502923" y="3675888"/>
+            <a:ext cx="1417711" cy="197510"/>
+          </a:xfrm>
+          <a:prstGeom prst="rect">
+            <a:avLst/>
+          </a:prstGeom>
+          <a:noFill/>
+        </p:spPr>
+        <p:txBody>
+          <a:bodyPr wrap="square" anchor="b" lIns="36576" rIns="36576" tIns="0" bIns="0">
+            <a:spAutoFit/>
+          </a:bodyPr>
+          <a:lstStyle/>
+          <a:p>
+            <a:pPr algn="ctr" rtl="1"/>
+            <a:r>
+              <a:rPr sz="1000" b="1">
+                <a:solidFill>
+                  <a:srgbClr val="1A2233"/>
+                </a:solidFill>
+                <a:latin typeface="Heebo"/>
+                <a:cs typeface="Heebo"/>
+              </a:rPr>
+              <a:t>ישראל ציג</a:t>
+            </a:r>
+          </a:p>
+        </p:txBody>
+      </p:sp>
+      <p:sp>
+        <p:nvSpPr>
+          <p:cNvPr id="133" name="TextBox 132"/>
+          <p:cNvSpPr txBox="1"/>
+          <p:nvPr/>
+        </p:nvSpPr>
+        <p:spPr>
+          <a:xfrm>
+            <a:off x="502923" y="3866814"/>
+            <a:ext cx="1417711" cy="131673"/>
+          </a:xfrm>
+          <a:prstGeom prst="rect">
+            <a:avLst/>
+          </a:prstGeom>
+          <a:noFill/>
+        </p:spPr>
+        <p:txBody>
+          <a:bodyPr wrap="square" anchor="t" lIns="36576" rIns="36576" tIns="0" bIns="0">
+            <a:spAutoFit/>
+          </a:bodyPr>
+          <a:lstStyle/>
+          <a:p>
+            <a:pPr algn="ctr" rtl="1"/>
+            <a:r>
+              <a:rPr sz="800" b="0">
+                <a:solidFill>
+                  <a:srgbClr val="8A94A8"/>
+                </a:solidFill>
+                <a:latin typeface="Heebo"/>
+                <a:cs typeface="Heebo"/>
+              </a:rPr>
+              <a:t>(פייסבוק)</a:t>
+            </a:r>
+          </a:p>
+        </p:txBody>
+      </p:sp>
+      <p:sp>
+        <p:nvSpPr>
+          <p:cNvPr id="134" name="Rounded Rectangle 133"/>
+          <p:cNvSpPr/>
+          <p:nvPr/>
+        </p:nvSpPr>
+        <p:spPr>
+          <a:xfrm>
+            <a:off x="1993786" y="4078224"/>
+            <a:ext cx="1417711" cy="329184"/>
+          </a:xfrm>
+          <a:prstGeom prst="roundRect">
+            <a:avLst>
+              <a:gd name="adj" fmla="val 18000"/>
+            </a:avLst>
+          </a:prstGeom>
+          <a:solidFill>
+            <a:srgbClr val="FFFFFF"/>
+          </a:solidFill>
+          <a:ln w="15875">
+            <a:solidFill>
+              <a:srgbClr val="C5CDDD"/>
+            </a:solidFill>
+          </a:ln>
+          <a:effectLst/>
+        </p:spPr>
+        <p:style>
+          <a:lnRef idx="1">
+            <a:schemeClr val="accent1"/>
+          </a:lnRef>
+          <a:fillRef idx="3">
+            <a:schemeClr val="accent1"/>
+          </a:fillRef>
+          <a:effectRef idx="2">
+            <a:schemeClr val="accent1"/>
+          </a:effectRef>
+          <a:fontRef idx="minor">
+            <a:schemeClr val="lt1"/>
+          </a:fontRef>
+        </p:style>
+        <p:txBody>
+          <a:bodyPr rtlCol="0" anchor="ctr"/>
+          <a:lstStyle/>
+          <a:p>
+            <a:pPr algn="ctr"/>
+          </a:p>
+        </p:txBody>
+      </p:sp>
+      <p:sp>
+        <p:nvSpPr>
+          <p:cNvPr id="135" name="Rectangle 134"/>
+          <p:cNvSpPr/>
+          <p:nvPr/>
+        </p:nvSpPr>
+        <p:spPr>
+          <a:xfrm>
+            <a:off x="3347489" y="4151376"/>
+            <a:ext cx="45720" cy="182880"/>
+          </a:xfrm>
+          <a:prstGeom prst="rect">
+            <a:avLst/>
+          </a:prstGeom>
+          <a:solidFill>
+            <a:srgbClr val="F0C000"/>
+          </a:solidFill>
+          <a:ln>
+            <a:noFill/>
+          </a:ln>
+          <a:effectLst/>
+        </p:spPr>
+        <p:style>
+          <a:lnRef idx="1">
+            <a:schemeClr val="accent1"/>
+          </a:lnRef>
+          <a:fillRef idx="3">
+            <a:schemeClr val="accent1"/>
+          </a:fillRef>
+          <a:effectRef idx="2">
+            <a:schemeClr val="accent1"/>
+          </a:effectRef>
+          <a:fontRef idx="minor">
+            <a:schemeClr val="lt1"/>
+          </a:fontRef>
+        </p:style>
+        <p:txBody>
+          <a:bodyPr rtlCol="0" anchor="ctr"/>
+          <a:lstStyle/>
+          <a:p>
+            <a:pPr algn="ctr"/>
+          </a:p>
+        </p:txBody>
+      </p:sp>
+      <p:sp>
+        <p:nvSpPr>
+          <p:cNvPr id="136" name="TextBox 135"/>
+          <p:cNvSpPr txBox="1"/>
+          <p:nvPr/>
+        </p:nvSpPr>
+        <p:spPr>
+          <a:xfrm>
+            <a:off x="1993786" y="4078224"/>
+            <a:ext cx="1417711" cy="197510"/>
+          </a:xfrm>
+          <a:prstGeom prst="rect">
+            <a:avLst/>
+          </a:prstGeom>
+          <a:noFill/>
+        </p:spPr>
+        <p:txBody>
+          <a:bodyPr wrap="square" anchor="b" lIns="36576" rIns="36576" tIns="0" bIns="0">
+            <a:spAutoFit/>
+          </a:bodyPr>
+          <a:lstStyle/>
+          <a:p>
+            <a:pPr algn="ctr" rtl="1"/>
+            <a:r>
+              <a:rPr sz="1000" b="1">
+                <a:solidFill>
+                  <a:srgbClr val="1A2233"/>
+                </a:solidFill>
+                <a:latin typeface="Heebo"/>
+                <a:cs typeface="Heebo"/>
+              </a:rPr>
+              <a:t>מנחם זיבוטפסקי</a:t>
+            </a:r>
+          </a:p>
+        </p:txBody>
+      </p:sp>
+      <p:sp>
+        <p:nvSpPr>
+          <p:cNvPr id="137" name="TextBox 136"/>
+          <p:cNvSpPr txBox="1"/>
+          <p:nvPr/>
+        </p:nvSpPr>
+        <p:spPr>
+          <a:xfrm>
+            <a:off x="1993786" y="4269150"/>
+            <a:ext cx="1417711" cy="131673"/>
+          </a:xfrm>
+          <a:prstGeom prst="rect">
+            <a:avLst/>
+          </a:prstGeom>
+          <a:noFill/>
+        </p:spPr>
+        <p:txBody>
+          <a:bodyPr wrap="square" anchor="t" lIns="36576" rIns="36576" tIns="0" bIns="0">
+            <a:spAutoFit/>
+          </a:bodyPr>
+          <a:lstStyle/>
+          <a:p>
+            <a:pPr algn="ctr" rtl="1"/>
+            <a:r>
+              <a:rPr sz="800" b="0">
+                <a:solidFill>
+                  <a:srgbClr val="8A94A8"/>
+                </a:solidFill>
+                <a:latin typeface="Heebo"/>
+                <a:cs typeface="Heebo"/>
+              </a:rPr>
+              <a:t>(יוטיוב)</a:t>
+            </a:r>
+          </a:p>
+        </p:txBody>
+      </p:sp>
+      <p:sp>
+        <p:nvSpPr>
+          <p:cNvPr id="138" name="Rounded Rectangle 137"/>
+          <p:cNvSpPr/>
+          <p:nvPr/>
+        </p:nvSpPr>
+        <p:spPr>
+          <a:xfrm>
+            <a:off x="502923" y="4078224"/>
+            <a:ext cx="1417711" cy="329184"/>
+          </a:xfrm>
+          <a:prstGeom prst="roundRect">
+            <a:avLst>
+              <a:gd name="adj" fmla="val 18000"/>
+            </a:avLst>
+          </a:prstGeom>
+          <a:solidFill>
+            <a:srgbClr val="FFFFFF"/>
+          </a:solidFill>
+          <a:ln w="15875">
+            <a:solidFill>
+              <a:srgbClr val="C5CDDD"/>
+            </a:solidFill>
+          </a:ln>
+          <a:effectLst/>
+        </p:spPr>
+        <p:style>
+          <a:lnRef idx="1">
+            <a:schemeClr val="accent1"/>
+          </a:lnRef>
+          <a:fillRef idx="3">
+            <a:schemeClr val="accent1"/>
+          </a:fillRef>
+          <a:effectRef idx="2">
+            <a:schemeClr val="accent1"/>
+          </a:effectRef>
+          <a:fontRef idx="minor">
+            <a:schemeClr val="lt1"/>
+          </a:fontRef>
+        </p:style>
+        <p:txBody>
+          <a:bodyPr rtlCol="0" anchor="ctr"/>
+          <a:lstStyle/>
+          <a:p>
+            <a:pPr algn="ctr"/>
+          </a:p>
+        </p:txBody>
+      </p:sp>
+      <p:sp>
+        <p:nvSpPr>
+          <p:cNvPr id="139" name="Rectangle 138"/>
+          <p:cNvSpPr/>
+          <p:nvPr/>
+        </p:nvSpPr>
+        <p:spPr>
+          <a:xfrm>
+            <a:off x="1856626" y="4151376"/>
+            <a:ext cx="45720" cy="182880"/>
+          </a:xfrm>
+          <a:prstGeom prst="rect">
+            <a:avLst/>
+          </a:prstGeom>
+          <a:solidFill>
+            <a:srgbClr val="F0C000"/>
+          </a:solidFill>
+          <a:ln>
+            <a:noFill/>
+          </a:ln>
+          <a:effectLst/>
+        </p:spPr>
+        <p:style>
+          <a:lnRef idx="1">
+            <a:schemeClr val="accent1"/>
+          </a:lnRef>
+          <a:fillRef idx="3">
+            <a:schemeClr val="accent1"/>
+          </a:fillRef>
+          <a:effectRef idx="2">
+            <a:schemeClr val="accent1"/>
+          </a:effectRef>
+          <a:fontRef idx="minor">
+            <a:schemeClr val="lt1"/>
+          </a:fontRef>
+        </p:style>
+        <p:txBody>
+          <a:bodyPr rtlCol="0" anchor="ctr"/>
+          <a:lstStyle/>
+          <a:p>
+            <a:pPr algn="ctr"/>
+          </a:p>
+        </p:txBody>
+      </p:sp>
+      <p:sp>
+        <p:nvSpPr>
+          <p:cNvPr id="140" name="TextBox 139"/>
+          <p:cNvSpPr txBox="1"/>
+          <p:nvPr/>
+        </p:nvSpPr>
+        <p:spPr>
+          <a:xfrm>
+            <a:off x="502923" y="4078224"/>
+            <a:ext cx="1417711" cy="197510"/>
+          </a:xfrm>
+          <a:prstGeom prst="rect">
+            <a:avLst/>
+          </a:prstGeom>
+          <a:noFill/>
+        </p:spPr>
+        <p:txBody>
+          <a:bodyPr wrap="square" anchor="b" lIns="36576" rIns="36576" tIns="0" bIns="0">
+            <a:spAutoFit/>
+          </a:bodyPr>
+          <a:lstStyle/>
+          <a:p>
+            <a:pPr algn="ctr" rtl="1"/>
+            <a:r>
+              <a:rPr sz="1000" b="1">
+                <a:solidFill>
+                  <a:srgbClr val="1A2233"/>
+                </a:solidFill>
+                <a:latin typeface="Heebo"/>
+                <a:cs typeface="Heebo"/>
+              </a:rPr>
+              <a:t>יהודה חדאד</a:t>
+            </a:r>
+          </a:p>
+        </p:txBody>
+      </p:sp>
+      <p:sp>
+        <p:nvSpPr>
+          <p:cNvPr id="141" name="TextBox 140"/>
+          <p:cNvSpPr txBox="1"/>
+          <p:nvPr/>
+        </p:nvSpPr>
+        <p:spPr>
+          <a:xfrm>
+            <a:off x="502923" y="4269150"/>
+            <a:ext cx="1417711" cy="131673"/>
+          </a:xfrm>
+          <a:prstGeom prst="rect">
+            <a:avLst/>
+          </a:prstGeom>
+          <a:noFill/>
+        </p:spPr>
+        <p:txBody>
+          <a:bodyPr wrap="square" anchor="t" lIns="36576" rIns="36576" tIns="0" bIns="0">
+            <a:spAutoFit/>
+          </a:bodyPr>
+          <a:lstStyle/>
+          <a:p>
+            <a:pPr algn="ctr" rtl="1"/>
+            <a:r>
+              <a:rPr sz="800" b="0">
+                <a:solidFill>
+                  <a:srgbClr val="8A94A8"/>
+                </a:solidFill>
+                <a:latin typeface="Heebo"/>
+                <a:cs typeface="Heebo"/>
+              </a:rPr>
+              <a:t>(אתר)</a:t>
+            </a:r>
+          </a:p>
+        </p:txBody>
+      </p:sp>
+      <p:sp>
+        <p:nvSpPr>
+          <p:cNvPr id="142" name="Rounded Rectangle 141"/>
+          <p:cNvSpPr/>
+          <p:nvPr/>
+        </p:nvSpPr>
+        <p:spPr>
+          <a:xfrm>
+            <a:off x="1993786" y="4480560"/>
+            <a:ext cx="1417711" cy="329184"/>
+          </a:xfrm>
+          <a:prstGeom prst="roundRect">
+            <a:avLst>
+              <a:gd name="adj" fmla="val 18000"/>
+            </a:avLst>
+          </a:prstGeom>
+          <a:solidFill>
+            <a:srgbClr val="FFFFFF"/>
+          </a:solidFill>
+          <a:ln w="15875">
+            <a:solidFill>
+              <a:srgbClr val="C5CDDD"/>
+            </a:solidFill>
+          </a:ln>
+          <a:effectLst/>
+        </p:spPr>
+        <p:style>
+          <a:lnRef idx="1">
+            <a:schemeClr val="accent1"/>
+          </a:lnRef>
+          <a:fillRef idx="3">
+            <a:schemeClr val="accent1"/>
+          </a:fillRef>
+          <a:effectRef idx="2">
+            <a:schemeClr val="accent1"/>
+          </a:effectRef>
+          <a:fontRef idx="minor">
+            <a:schemeClr val="lt1"/>
+          </a:fontRef>
+        </p:style>
+        <p:txBody>
+          <a:bodyPr rtlCol="0" anchor="ctr"/>
+          <a:lstStyle/>
+          <a:p>
+            <a:pPr algn="ctr"/>
+          </a:p>
+        </p:txBody>
+      </p:sp>
+      <p:sp>
+        <p:nvSpPr>
+          <p:cNvPr id="143" name="Rectangle 142"/>
+          <p:cNvSpPr/>
+          <p:nvPr/>
+        </p:nvSpPr>
+        <p:spPr>
+          <a:xfrm>
+            <a:off x="3347489" y="4553712"/>
+            <a:ext cx="45720" cy="182880"/>
+          </a:xfrm>
+          <a:prstGeom prst="rect">
+            <a:avLst/>
+          </a:prstGeom>
+          <a:solidFill>
+            <a:srgbClr val="F0C000"/>
+          </a:solidFill>
+          <a:ln>
+            <a:noFill/>
+          </a:ln>
+          <a:effectLst/>
+        </p:spPr>
+        <p:style>
+          <a:lnRef idx="1">
+            <a:schemeClr val="accent1"/>
+          </a:lnRef>
+          <a:fillRef idx="3">
+            <a:schemeClr val="accent1"/>
+          </a:fillRef>
+          <a:effectRef idx="2">
+            <a:schemeClr val="accent1"/>
+          </a:effectRef>
+          <a:fontRef idx="minor">
+            <a:schemeClr val="lt1"/>
+          </a:fontRef>
+        </p:style>
+        <p:txBody>
+          <a:bodyPr rtlCol="0" anchor="ctr"/>
+          <a:lstStyle/>
+          <a:p>
+            <a:pPr algn="ctr"/>
+          </a:p>
+        </p:txBody>
+      </p:sp>
+      <p:sp>
+        <p:nvSpPr>
+          <p:cNvPr id="144" name="TextBox 143"/>
+          <p:cNvSpPr txBox="1"/>
+          <p:nvPr/>
+        </p:nvSpPr>
+        <p:spPr>
+          <a:xfrm>
+            <a:off x="1993786" y="4480560"/>
+            <a:ext cx="1417711" cy="329184"/>
+          </a:xfrm>
+          <a:prstGeom prst="rect">
+            <a:avLst/>
+          </a:prstGeom>
+          <a:noFill/>
+        </p:spPr>
+        <p:txBody>
+          <a:bodyPr wrap="square" anchor="ctr" lIns="36576" rIns="36576" tIns="0" bIns="0">
+            <a:spAutoFit/>
+          </a:bodyPr>
+          <a:lstStyle/>
+          <a:p>
+            <a:pPr algn="ctr" rtl="1"/>
+            <a:r>
+              <a:rPr sz="1100" b="1">
+                <a:solidFill>
+                  <a:srgbClr val="1A2233"/>
+                </a:solidFill>
+                <a:latin typeface="Heebo"/>
+                <a:cs typeface="Heebo"/>
+              </a:rPr>
+              <a:t>יוסף</a:t>
+            </a:r>
+          </a:p>
+        </p:txBody>
+      </p:sp>
+      <p:sp>
+        <p:nvSpPr>
+          <p:cNvPr id="145" name="Rounded Rectangle 144"/>
+          <p:cNvSpPr/>
+          <p:nvPr/>
+        </p:nvSpPr>
+        <p:spPr>
+          <a:xfrm>
+            <a:off x="502923" y="4480560"/>
+            <a:ext cx="1417711" cy="329184"/>
+          </a:xfrm>
+          <a:prstGeom prst="roundRect">
+            <a:avLst>
+              <a:gd name="adj" fmla="val 18000"/>
+            </a:avLst>
+          </a:prstGeom>
+          <a:solidFill>
+            <a:srgbClr val="FFFFFF"/>
+          </a:solidFill>
+          <a:ln w="15875">
+            <a:solidFill>
+              <a:srgbClr val="C5CDDD"/>
+            </a:solidFill>
+          </a:ln>
+          <a:effectLst/>
+        </p:spPr>
+        <p:style>
+          <a:lnRef idx="1">
+            <a:schemeClr val="accent1"/>
+          </a:lnRef>
+          <a:fillRef idx="3">
+            <a:schemeClr val="accent1"/>
+          </a:fillRef>
+          <a:effectRef idx="2">
+            <a:schemeClr val="accent1"/>
+          </a:effectRef>
+          <a:fontRef idx="minor">
+            <a:schemeClr val="lt1"/>
+          </a:fontRef>
+        </p:style>
+        <p:txBody>
+          <a:bodyPr rtlCol="0" anchor="ctr"/>
+          <a:lstStyle/>
+          <a:p>
+            <a:pPr algn="ctr"/>
+          </a:p>
+        </p:txBody>
+      </p:sp>
+      <p:sp>
+        <p:nvSpPr>
+          <p:cNvPr id="146" name="Rectangle 145"/>
+          <p:cNvSpPr/>
+          <p:nvPr/>
+        </p:nvSpPr>
+        <p:spPr>
+          <a:xfrm>
+            <a:off x="1856626" y="4553712"/>
+            <a:ext cx="45720" cy="182880"/>
+          </a:xfrm>
+          <a:prstGeom prst="rect">
+            <a:avLst/>
+          </a:prstGeom>
+          <a:solidFill>
+            <a:srgbClr val="F0C000"/>
+          </a:solidFill>
+          <a:ln>
+            <a:noFill/>
+          </a:ln>
+          <a:effectLst/>
+        </p:spPr>
+        <p:style>
+          <a:lnRef idx="1">
+            <a:schemeClr val="accent1"/>
+          </a:lnRef>
+          <a:fillRef idx="3">
+            <a:schemeClr val="accent1"/>
+          </a:fillRef>
+          <a:effectRef idx="2">
+            <a:schemeClr val="accent1"/>
+          </a:effectRef>
+          <a:fontRef idx="minor">
+            <a:schemeClr val="lt1"/>
+          </a:fontRef>
+        </p:style>
+        <p:txBody>
+          <a:bodyPr rtlCol="0" anchor="ctr"/>
+          <a:lstStyle/>
+          <a:p>
+            <a:pPr algn="ctr"/>
+          </a:p>
+        </p:txBody>
+      </p:sp>
+      <p:sp>
+        <p:nvSpPr>
+          <p:cNvPr id="147" name="TextBox 146"/>
+          <p:cNvSpPr txBox="1"/>
+          <p:nvPr/>
+        </p:nvSpPr>
+        <p:spPr>
+          <a:xfrm>
+            <a:off x="502923" y="4480560"/>
+            <a:ext cx="1417711" cy="329184"/>
+          </a:xfrm>
+          <a:prstGeom prst="rect">
+            <a:avLst/>
+          </a:prstGeom>
+          <a:noFill/>
+        </p:spPr>
+        <p:txBody>
+          <a:bodyPr wrap="square" anchor="ctr" lIns="36576" rIns="36576" tIns="0" bIns="0">
+            <a:spAutoFit/>
+          </a:bodyPr>
+          <a:lstStyle/>
+          <a:p>
+            <a:pPr algn="ctr" rtl="1"/>
+            <a:r>
+              <a:rPr sz="1100" b="1">
+                <a:solidFill>
+                  <a:srgbClr val="1A2233"/>
+                </a:solidFill>
+                <a:latin typeface="Heebo"/>
+                <a:cs typeface="Heebo"/>
+              </a:rPr>
+              <a:t>יהודה הנדלר</a:t>
+            </a:r>
+          </a:p>
+        </p:txBody>
+      </p:sp>
+      <p:sp>
+        <p:nvSpPr>
+          <p:cNvPr id="148" name="Rounded Rectangle 147"/>
+          <p:cNvSpPr/>
+          <p:nvPr/>
+        </p:nvSpPr>
+        <p:spPr>
+          <a:xfrm>
+            <a:off x="1993786" y="4882896"/>
+            <a:ext cx="1417711" cy="329184"/>
+          </a:xfrm>
+          <a:prstGeom prst="roundRect">
+            <a:avLst>
+              <a:gd name="adj" fmla="val 18000"/>
+            </a:avLst>
+          </a:prstGeom>
+          <a:solidFill>
+            <a:srgbClr val="FFFFFF"/>
+          </a:solidFill>
+          <a:ln w="15875">
+            <a:solidFill>
+              <a:srgbClr val="C5CDDD"/>
+            </a:solidFill>
+          </a:ln>
+          <a:effectLst/>
+        </p:spPr>
+        <p:style>
+          <a:lnRef idx="1">
+            <a:schemeClr val="accent1"/>
+          </a:lnRef>
+          <a:fillRef idx="3">
+            <a:schemeClr val="accent1"/>
+          </a:fillRef>
+          <a:effectRef idx="2">
+            <a:schemeClr val="accent1"/>
+          </a:effectRef>
+          <a:fontRef idx="minor">
+            <a:schemeClr val="lt1"/>
+          </a:fontRef>
+        </p:style>
+        <p:txBody>
+          <a:bodyPr rtlCol="0" anchor="ctr"/>
+          <a:lstStyle/>
+          <a:p>
+            <a:pPr algn="ctr"/>
+          </a:p>
+        </p:txBody>
+      </p:sp>
+      <p:sp>
+        <p:nvSpPr>
+          <p:cNvPr id="149" name="Rectangle 148"/>
+          <p:cNvSpPr/>
+          <p:nvPr/>
+        </p:nvSpPr>
+        <p:spPr>
+          <a:xfrm>
+            <a:off x="3347489" y="4956048"/>
+            <a:ext cx="45720" cy="182880"/>
+          </a:xfrm>
+          <a:prstGeom prst="rect">
+            <a:avLst/>
+          </a:prstGeom>
+          <a:solidFill>
+            <a:srgbClr val="F0C000"/>
+          </a:solidFill>
+          <a:ln>
+            <a:noFill/>
+          </a:ln>
+          <a:effectLst/>
+        </p:spPr>
+        <p:style>
+          <a:lnRef idx="1">
+            <a:schemeClr val="accent1"/>
+          </a:lnRef>
+          <a:fillRef idx="3">
+            <a:schemeClr val="accent1"/>
+          </a:fillRef>
+          <a:effectRef idx="2">
+            <a:schemeClr val="accent1"/>
+          </a:effectRef>
+          <a:fontRef idx="minor">
+            <a:schemeClr val="lt1"/>
+          </a:fontRef>
+        </p:style>
+        <p:txBody>
+          <a:bodyPr rtlCol="0" anchor="ctr"/>
+          <a:lstStyle/>
+          <a:p>
+            <a:pPr algn="ctr"/>
+          </a:p>
+        </p:txBody>
+      </p:sp>
+      <p:sp>
+        <p:nvSpPr>
+          <p:cNvPr id="150" name="TextBox 149"/>
+          <p:cNvSpPr txBox="1"/>
+          <p:nvPr/>
+        </p:nvSpPr>
+        <p:spPr>
+          <a:xfrm>
+            <a:off x="1993786" y="4882896"/>
+            <a:ext cx="1417711" cy="329184"/>
+          </a:xfrm>
+          <a:prstGeom prst="rect">
+            <a:avLst/>
+          </a:prstGeom>
+          <a:noFill/>
+        </p:spPr>
+        <p:txBody>
+          <a:bodyPr wrap="square" anchor="ctr" lIns="36576" rIns="36576" tIns="0" bIns="0">
+            <a:spAutoFit/>
+          </a:bodyPr>
+          <a:lstStyle/>
+          <a:p>
+            <a:pPr algn="ctr" rtl="1"/>
+            <a:r>
+              <a:rPr sz="1100" b="1">
+                <a:solidFill>
+                  <a:srgbClr val="1A2233"/>
+                </a:solidFill>
+                <a:latin typeface="Heebo"/>
+                <a:cs typeface="Heebo"/>
+              </a:rPr>
+              <a:t>יואב קוסטינר</a:t>
+            </a:r>
+          </a:p>
+        </p:txBody>
+      </p:sp>
+      <p:sp>
+        <p:nvSpPr>
+          <p:cNvPr id="151" name="Rounded Rectangle 150"/>
+          <p:cNvSpPr/>
+          <p:nvPr/>
+        </p:nvSpPr>
+        <p:spPr>
+          <a:xfrm>
+            <a:off x="502923" y="4882896"/>
+            <a:ext cx="1417711" cy="329184"/>
+          </a:xfrm>
+          <a:prstGeom prst="roundRect">
+            <a:avLst>
+              <a:gd name="adj" fmla="val 18000"/>
+            </a:avLst>
+          </a:prstGeom>
+          <a:solidFill>
+            <a:srgbClr val="FFFFFF"/>
+          </a:solidFill>
+          <a:ln w="15875">
+            <a:solidFill>
+              <a:srgbClr val="C5CDDD"/>
+            </a:solidFill>
+          </a:ln>
+          <a:effectLst/>
+        </p:spPr>
+        <p:style>
+          <a:lnRef idx="1">
+            <a:schemeClr val="accent1"/>
+          </a:lnRef>
+          <a:fillRef idx="3">
+            <a:schemeClr val="accent1"/>
+          </a:fillRef>
+          <a:effectRef idx="2">
+            <a:schemeClr val="accent1"/>
+          </a:effectRef>
+          <a:fontRef idx="minor">
+            <a:schemeClr val="lt1"/>
+          </a:fontRef>
+        </p:style>
+        <p:txBody>
+          <a:bodyPr rtlCol="0" anchor="ctr"/>
+          <a:lstStyle/>
+          <a:p>
+            <a:pPr algn="ctr"/>
+          </a:p>
+        </p:txBody>
+      </p:sp>
+      <p:sp>
+        <p:nvSpPr>
+          <p:cNvPr id="152" name="Rectangle 151"/>
+          <p:cNvSpPr/>
+          <p:nvPr/>
+        </p:nvSpPr>
+        <p:spPr>
+          <a:xfrm>
+            <a:off x="1856626" y="4956048"/>
+            <a:ext cx="45720" cy="182880"/>
+          </a:xfrm>
+          <a:prstGeom prst="rect">
+            <a:avLst/>
+          </a:prstGeom>
+          <a:solidFill>
+            <a:srgbClr val="F0C000"/>
+          </a:solidFill>
+          <a:ln>
+            <a:noFill/>
+          </a:ln>
+          <a:effectLst/>
+        </p:spPr>
+        <p:style>
+          <a:lnRef idx="1">
+            <a:schemeClr val="accent1"/>
+          </a:lnRef>
+          <a:fillRef idx="3">
+            <a:schemeClr val="accent1"/>
+          </a:fillRef>
+          <a:effectRef idx="2">
+            <a:schemeClr val="accent1"/>
+          </a:effectRef>
+          <a:fontRef idx="minor">
+            <a:schemeClr val="lt1"/>
+          </a:fontRef>
+        </p:style>
+        <p:txBody>
+          <a:bodyPr rtlCol="0" anchor="ctr"/>
+          <a:lstStyle/>
+          <a:p>
+            <a:pPr algn="ctr"/>
+          </a:p>
+        </p:txBody>
+      </p:sp>
+      <p:sp>
+        <p:nvSpPr>
+          <p:cNvPr id="153" name="TextBox 152"/>
+          <p:cNvSpPr txBox="1"/>
+          <p:nvPr/>
+        </p:nvSpPr>
+        <p:spPr>
+          <a:xfrm>
+            <a:off x="502923" y="4882896"/>
+            <a:ext cx="1417711" cy="329184"/>
+          </a:xfrm>
+          <a:prstGeom prst="rect">
+            <a:avLst/>
+          </a:prstGeom>
+          <a:noFill/>
+        </p:spPr>
+        <p:txBody>
+          <a:bodyPr wrap="square" anchor="ctr" lIns="36576" rIns="36576" tIns="0" bIns="0">
+            <a:spAutoFit/>
+          </a:bodyPr>
+          <a:lstStyle/>
+          <a:p>
+            <a:pPr algn="ctr" rtl="1"/>
+            <a:r>
+              <a:rPr sz="1100" b="1">
+                <a:solidFill>
+                  <a:srgbClr val="1A2233"/>
+                </a:solidFill>
+                <a:latin typeface="Heebo"/>
+                <a:cs typeface="Heebo"/>
+              </a:rPr>
+              <a:t>יוסף גוטויליג</a:t>
+            </a:r>
+          </a:p>
+        </p:txBody>
+      </p:sp>
+      <p:sp>
+        <p:nvSpPr>
+          <p:cNvPr id="154" name="Rounded Rectangle 153"/>
+          <p:cNvSpPr/>
+          <p:nvPr/>
+        </p:nvSpPr>
+        <p:spPr>
+          <a:xfrm>
+            <a:off x="1993786" y="5285232"/>
+            <a:ext cx="1417711" cy="329184"/>
+          </a:xfrm>
+          <a:prstGeom prst="roundRect">
+            <a:avLst>
+              <a:gd name="adj" fmla="val 18000"/>
+            </a:avLst>
+          </a:prstGeom>
+          <a:solidFill>
+            <a:srgbClr val="FFFFFF"/>
+          </a:solidFill>
+          <a:ln w="15875">
+            <a:solidFill>
+              <a:srgbClr val="C5CDDD"/>
+            </a:solidFill>
+          </a:ln>
+          <a:effectLst/>
+        </p:spPr>
+        <p:style>
+          <a:lnRef idx="1">
+            <a:schemeClr val="accent1"/>
+          </a:lnRef>
+          <a:fillRef idx="3">
+            <a:schemeClr val="accent1"/>
+          </a:fillRef>
+          <a:effectRef idx="2">
+            <a:schemeClr val="accent1"/>
+          </a:effectRef>
+          <a:fontRef idx="minor">
+            <a:schemeClr val="lt1"/>
+          </a:fontRef>
+        </p:style>
+        <p:txBody>
+          <a:bodyPr rtlCol="0" anchor="ctr"/>
+          <a:lstStyle/>
+          <a:p>
+            <a:pPr algn="ctr"/>
+          </a:p>
+        </p:txBody>
+      </p:sp>
+      <p:sp>
+        <p:nvSpPr>
+          <p:cNvPr id="155" name="Rectangle 154"/>
+          <p:cNvSpPr/>
+          <p:nvPr/>
+        </p:nvSpPr>
+        <p:spPr>
+          <a:xfrm>
+            <a:off x="3347489" y="5358384"/>
+            <a:ext cx="45720" cy="182880"/>
+          </a:xfrm>
+          <a:prstGeom prst="rect">
+            <a:avLst/>
+          </a:prstGeom>
+          <a:solidFill>
+            <a:srgbClr val="F0C000"/>
+          </a:solidFill>
+          <a:ln>
+            <a:noFill/>
+          </a:ln>
+          <a:effectLst/>
+        </p:spPr>
+        <p:style>
+          <a:lnRef idx="1">
+            <a:schemeClr val="accent1"/>
+          </a:lnRef>
+          <a:fillRef idx="3">
+            <a:schemeClr val="accent1"/>
+          </a:fillRef>
+          <a:effectRef idx="2">
+            <a:schemeClr val="accent1"/>
+          </a:effectRef>
+          <a:fontRef idx="minor">
+            <a:schemeClr val="lt1"/>
+          </a:fontRef>
+        </p:style>
+        <p:txBody>
+          <a:bodyPr rtlCol="0" anchor="ctr"/>
+          <a:lstStyle/>
+          <a:p>
+            <a:pPr algn="ctr"/>
+          </a:p>
+        </p:txBody>
+      </p:sp>
+      <p:sp>
+        <p:nvSpPr>
+          <p:cNvPr id="156" name="TextBox 155"/>
+          <p:cNvSpPr txBox="1"/>
+          <p:nvPr/>
+        </p:nvSpPr>
+        <p:spPr>
+          <a:xfrm>
+            <a:off x="1993786" y="5285232"/>
+            <a:ext cx="1417711" cy="329184"/>
+          </a:xfrm>
+          <a:prstGeom prst="rect">
+            <a:avLst/>
+          </a:prstGeom>
+          <a:noFill/>
+        </p:spPr>
+        <p:txBody>
+          <a:bodyPr wrap="square" anchor="ctr" lIns="36576" rIns="36576" tIns="0" bIns="0">
+            <a:spAutoFit/>
+          </a:bodyPr>
+          <a:lstStyle/>
+          <a:p>
+            <a:pPr algn="ctr" rtl="1"/>
+            <a:r>
+              <a:rPr sz="1100" b="1">
+                <a:solidFill>
+                  <a:srgbClr val="1A2233"/>
+                </a:solidFill>
+                <a:latin typeface="Heebo"/>
+                <a:cs typeface="Heebo"/>
+              </a:rPr>
+              <a:t>משה הלר</a:t>
+            </a:r>
+          </a:p>
+        </p:txBody>
+      </p:sp>
       <p:cxnSp>
         <p:nvCxnSpPr>
-          <p:cNvPr id="121" name="Connector 120"/>
+          <p:cNvPr id="157" name="Connector 156"/>
           <p:cNvCxnSpPr/>
           <p:nvPr/>
         </p:nvCxnSpPr>
@@ -8109,14 +9615,14 @@
       </p:cxnSp>
       <p:cxnSp>
         <p:nvCxnSpPr>
-          <p:cNvPr id="122" name="Connector 121"/>
+          <p:cNvPr id="158" name="Connector 157"/>
           <p:cNvCxnSpPr/>
           <p:nvPr/>
         </p:nvCxnSpPr>
         <p:spPr>
           <a:xfrm>
-            <a:off x="3352647" y="2770632"/>
-            <a:ext cx="4617720" cy="0"/>
+            <a:off x="1957210" y="2770632"/>
+            <a:ext cx="7504411" cy="0"/>
           </a:xfrm>
           <a:prstGeom prst="line">
             <a:avLst/>
@@ -8144,13 +9650,13 @@
       </p:cxnSp>
       <p:cxnSp>
         <p:nvCxnSpPr>
-          <p:cNvPr id="123" name="Connector 122"/>
+          <p:cNvPr id="159" name="Connector 158"/>
           <p:cNvCxnSpPr/>
           <p:nvPr/>
         </p:nvCxnSpPr>
         <p:spPr>
           <a:xfrm>
-            <a:off x="7970367" y="2770632"/>
+            <a:off x="9461621" y="2770632"/>
             <a:ext cx="0" cy="155448"/>
           </a:xfrm>
           <a:prstGeom prst="line">
@@ -8179,13 +9685,48 @@
       </p:cxnSp>
       <p:cxnSp>
         <p:nvCxnSpPr>
-          <p:cNvPr id="124" name="Connector 123"/>
+          <p:cNvPr id="160" name="Connector 159"/>
           <p:cNvCxnSpPr/>
           <p:nvPr/>
         </p:nvCxnSpPr>
         <p:spPr>
           <a:xfrm>
-            <a:off x="3352647" y="2770632"/>
+            <a:off x="5322984" y="2770632"/>
+            <a:ext cx="0" cy="155448"/>
+          </a:xfrm>
+          <a:prstGeom prst="line">
+            <a:avLst/>
+          </a:prstGeom>
+          <a:ln w="19050">
+            <a:solidFill>
+              <a:srgbClr val="C5CDDD"/>
+            </a:solidFill>
+          </a:ln>
+        </p:spPr>
+        <p:style>
+          <a:lnRef idx="2">
+            <a:schemeClr val="accent1"/>
+          </a:lnRef>
+          <a:fillRef idx="0">
+            <a:schemeClr val="accent1"/>
+          </a:fillRef>
+          <a:effectRef idx="1">
+            <a:schemeClr val="accent1"/>
+          </a:effectRef>
+          <a:fontRef idx="minor">
+            <a:schemeClr val="tx1"/>
+          </a:fontRef>
+        </p:style>
+      </p:cxnSp>
+      <p:cxnSp>
+        <p:nvCxnSpPr>
+          <p:cNvPr id="161" name="Connector 160"/>
+          <p:cNvCxnSpPr/>
+          <p:nvPr/>
+        </p:nvCxnSpPr>
+        <p:spPr>
+          <a:xfrm>
+            <a:off x="1957210" y="2770632"/>
             <a:ext cx="0" cy="155448"/>
           </a:xfrm>
           <a:prstGeom prst="line">
@@ -9491,8 +11032,8 @@
         </p:nvSpPr>
         <p:spPr>
           <a:xfrm>
-            <a:off x="5364327" y="3182112"/>
-            <a:ext cx="5212080" cy="2962656"/>
+            <a:off x="7143031" y="3182112"/>
+            <a:ext cx="4637181" cy="2962656"/>
           </a:xfrm>
           <a:prstGeom prst="roundRect">
             <a:avLst>
@@ -9537,7 +11078,7 @@
         </p:nvSpPr>
         <p:spPr>
           <a:xfrm>
-            <a:off x="6781647" y="2926080"/>
+            <a:off x="8272901" y="2926080"/>
             <a:ext cx="2377440" cy="512064"/>
           </a:xfrm>
           <a:prstGeom prst="roundRect">
@@ -9583,7 +11124,7 @@
         </p:nvSpPr>
         <p:spPr>
           <a:xfrm>
-            <a:off x="6781647" y="2980944"/>
+            <a:off x="8272901" y="2980944"/>
             <a:ext cx="2377440" cy="266273"/>
           </a:xfrm>
           <a:prstGeom prst="rect">
@@ -9619,7 +11160,7 @@
         </p:nvSpPr>
         <p:spPr>
           <a:xfrm>
-            <a:off x="6781647" y="3207715"/>
+            <a:off x="8272901" y="3207715"/>
             <a:ext cx="2377440" cy="204825"/>
           </a:xfrm>
           <a:prstGeom prst="rect">
@@ -9655,8 +11196,8 @@
         </p:nvSpPr>
         <p:spPr>
           <a:xfrm>
-            <a:off x="8857335" y="3675888"/>
-            <a:ext cx="1627632" cy="329184"/>
+            <a:off x="10252773" y="3675888"/>
+            <a:ext cx="1435999" cy="329184"/>
           </a:xfrm>
           <a:prstGeom prst="roundRect">
             <a:avLst>
@@ -9701,8 +11242,8 @@
         </p:nvSpPr>
         <p:spPr>
           <a:xfrm>
-            <a:off x="8857335" y="3675888"/>
-            <a:ext cx="1627632" cy="329184"/>
+            <a:off x="10252773" y="3675888"/>
+            <a:ext cx="1435999" cy="329184"/>
           </a:xfrm>
           <a:prstGeom prst="rect">
             <a:avLst/>
@@ -9737,8 +11278,8 @@
         </p:nvSpPr>
         <p:spPr>
           <a:xfrm>
-            <a:off x="7156551" y="3675888"/>
-            <a:ext cx="1627632" cy="329184"/>
+            <a:off x="8743622" y="3675888"/>
+            <a:ext cx="1435999" cy="329184"/>
           </a:xfrm>
           <a:prstGeom prst="roundRect">
             <a:avLst>
@@ -9783,8 +11324,8 @@
         </p:nvSpPr>
         <p:spPr>
           <a:xfrm>
-            <a:off x="7156551" y="3675888"/>
-            <a:ext cx="1627632" cy="329184"/>
+            <a:off x="8743622" y="3675888"/>
+            <a:ext cx="1435999" cy="329184"/>
           </a:xfrm>
           <a:prstGeom prst="rect">
             <a:avLst/>
@@ -9806,7 +11347,7 @@
                 <a:latin typeface="Heebo"/>
                 <a:cs typeface="Heebo"/>
               </a:rPr>
-              <a:t>יואב</a:t>
+              <a:t>יואב קוסטינר</a:t>
             </a:r>
           </a:p>
         </p:txBody>
@@ -9819,8 +11360,8 @@
         </p:nvSpPr>
         <p:spPr>
           <a:xfrm>
-            <a:off x="5455767" y="3675888"/>
-            <a:ext cx="1627632" cy="329184"/>
+            <a:off x="7234471" y="3675888"/>
+            <a:ext cx="1435999" cy="329184"/>
           </a:xfrm>
           <a:prstGeom prst="roundRect">
             <a:avLst>
@@ -9865,8 +11406,8 @@
         </p:nvSpPr>
         <p:spPr>
           <a:xfrm>
-            <a:off x="5455767" y="3675888"/>
-            <a:ext cx="1627632" cy="329184"/>
+            <a:off x="7234471" y="3675888"/>
+            <a:ext cx="1435999" cy="329184"/>
           </a:xfrm>
           <a:prstGeom prst="rect">
             <a:avLst/>
@@ -9901,8 +11442,8 @@
         </p:nvSpPr>
         <p:spPr>
           <a:xfrm>
-            <a:off x="8857335" y="4078224"/>
-            <a:ext cx="1627632" cy="329184"/>
+            <a:off x="10252773" y="4078224"/>
+            <a:ext cx="1435999" cy="329184"/>
           </a:xfrm>
           <a:prstGeom prst="roundRect">
             <a:avLst>
@@ -9947,8 +11488,8 @@
         </p:nvSpPr>
         <p:spPr>
           <a:xfrm>
-            <a:off x="8857335" y="4078224"/>
-            <a:ext cx="1627632" cy="329184"/>
+            <a:off x="10252773" y="4078224"/>
+            <a:ext cx="1435999" cy="329184"/>
           </a:xfrm>
           <a:prstGeom prst="rect">
             <a:avLst/>
@@ -9983,8 +11524,8 @@
         </p:nvSpPr>
         <p:spPr>
           <a:xfrm>
-            <a:off x="7156551" y="4078224"/>
-            <a:ext cx="1627632" cy="329184"/>
+            <a:off x="8743622" y="4078224"/>
+            <a:ext cx="1435999" cy="329184"/>
           </a:xfrm>
           <a:prstGeom prst="roundRect">
             <a:avLst>
@@ -10029,8 +11570,8 @@
         </p:nvSpPr>
         <p:spPr>
           <a:xfrm>
-            <a:off x="7156551" y="4078224"/>
-            <a:ext cx="1627632" cy="329184"/>
+            <a:off x="8743622" y="4078224"/>
+            <a:ext cx="1435999" cy="329184"/>
           </a:xfrm>
           <a:prstGeom prst="rect">
             <a:avLst/>
@@ -10065,8 +11606,8 @@
         </p:nvSpPr>
         <p:spPr>
           <a:xfrm>
-            <a:off x="5455767" y="4078224"/>
-            <a:ext cx="1627632" cy="329184"/>
+            <a:off x="7234471" y="4078224"/>
+            <a:ext cx="1435999" cy="329184"/>
           </a:xfrm>
           <a:prstGeom prst="roundRect">
             <a:avLst>
@@ -10111,8 +11652,8 @@
         </p:nvSpPr>
         <p:spPr>
           <a:xfrm>
-            <a:off x="5455767" y="4078224"/>
-            <a:ext cx="1627632" cy="329184"/>
+            <a:off x="7234471" y="4078224"/>
+            <a:ext cx="1435999" cy="329184"/>
           </a:xfrm>
           <a:prstGeom prst="rect">
             <a:avLst/>
@@ -10147,8 +11688,8 @@
         </p:nvSpPr>
         <p:spPr>
           <a:xfrm>
-            <a:off x="8857335" y="4480560"/>
-            <a:ext cx="1627632" cy="329184"/>
+            <a:off x="10252773" y="4480560"/>
+            <a:ext cx="1435999" cy="329184"/>
           </a:xfrm>
           <a:prstGeom prst="roundRect">
             <a:avLst>
@@ -10193,8 +11734,8 @@
         </p:nvSpPr>
         <p:spPr>
           <a:xfrm>
-            <a:off x="8857335" y="4480560"/>
-            <a:ext cx="1627632" cy="329184"/>
+            <a:off x="10252773" y="4480560"/>
+            <a:ext cx="1435999" cy="329184"/>
           </a:xfrm>
           <a:prstGeom prst="rect">
             <a:avLst/>
@@ -10229,8 +11770,8 @@
         </p:nvSpPr>
         <p:spPr>
           <a:xfrm>
-            <a:off x="7156551" y="4480560"/>
-            <a:ext cx="1627632" cy="329184"/>
+            <a:off x="8743622" y="4480560"/>
+            <a:ext cx="1435999" cy="329184"/>
           </a:xfrm>
           <a:prstGeom prst="roundRect">
             <a:avLst>
@@ -10275,8 +11816,8 @@
         </p:nvSpPr>
         <p:spPr>
           <a:xfrm>
-            <a:off x="7156551" y="4480560"/>
-            <a:ext cx="1627632" cy="329184"/>
+            <a:off x="8743622" y="4480560"/>
+            <a:ext cx="1435999" cy="329184"/>
           </a:xfrm>
           <a:prstGeom prst="rect">
             <a:avLst/>
@@ -10311,8 +11852,8 @@
         </p:nvSpPr>
         <p:spPr>
           <a:xfrm>
-            <a:off x="5455767" y="4480560"/>
-            <a:ext cx="1627632" cy="329184"/>
+            <a:off x="7234471" y="4480560"/>
+            <a:ext cx="1435999" cy="329184"/>
           </a:xfrm>
           <a:prstGeom prst="roundRect">
             <a:avLst>
@@ -10357,8 +11898,8 @@
         </p:nvSpPr>
         <p:spPr>
           <a:xfrm>
-            <a:off x="5455767" y="4480560"/>
-            <a:ext cx="1627632" cy="329184"/>
+            <a:off x="7234471" y="4480560"/>
+            <a:ext cx="1435999" cy="329184"/>
           </a:xfrm>
           <a:prstGeom prst="rect">
             <a:avLst/>
@@ -10393,8 +11934,8 @@
         </p:nvSpPr>
         <p:spPr>
           <a:xfrm>
-            <a:off x="8857335" y="4882896"/>
-            <a:ext cx="1627632" cy="329184"/>
+            <a:off x="10252773" y="4882896"/>
+            <a:ext cx="1435999" cy="329184"/>
           </a:xfrm>
           <a:prstGeom prst="roundRect">
             <a:avLst>
@@ -10439,8 +11980,8 @@
         </p:nvSpPr>
         <p:spPr>
           <a:xfrm>
-            <a:off x="8857335" y="4882896"/>
-            <a:ext cx="1627632" cy="329184"/>
+            <a:off x="10252773" y="4882896"/>
+            <a:ext cx="1435999" cy="329184"/>
           </a:xfrm>
           <a:prstGeom prst="rect">
             <a:avLst/>
@@ -10475,8 +12016,8 @@
         </p:nvSpPr>
         <p:spPr>
           <a:xfrm>
-            <a:off x="7156551" y="4882896"/>
-            <a:ext cx="1627632" cy="329184"/>
+            <a:off x="8743622" y="4882896"/>
+            <a:ext cx="1435999" cy="329184"/>
           </a:xfrm>
           <a:prstGeom prst="roundRect">
             <a:avLst>
@@ -10521,8 +12062,8 @@
         </p:nvSpPr>
         <p:spPr>
           <a:xfrm>
-            <a:off x="7156551" y="4882896"/>
-            <a:ext cx="1627632" cy="329184"/>
+            <a:off x="8743622" y="4882896"/>
+            <a:ext cx="1435999" cy="329184"/>
           </a:xfrm>
           <a:prstGeom prst="rect">
             <a:avLst/>
@@ -10557,8 +12098,8 @@
         </p:nvSpPr>
         <p:spPr>
           <a:xfrm>
-            <a:off x="5455767" y="4882896"/>
-            <a:ext cx="1627632" cy="329184"/>
+            <a:off x="7234471" y="4882896"/>
+            <a:ext cx="1435999" cy="329184"/>
           </a:xfrm>
           <a:prstGeom prst="roundRect">
             <a:avLst>
@@ -10603,8 +12144,8 @@
         </p:nvSpPr>
         <p:spPr>
           <a:xfrm>
-            <a:off x="5455767" y="4882896"/>
-            <a:ext cx="1627632" cy="329184"/>
+            <a:off x="7234471" y="4882896"/>
+            <a:ext cx="1435999" cy="329184"/>
           </a:xfrm>
           <a:prstGeom prst="rect">
             <a:avLst/>
@@ -10639,8 +12180,8 @@
         </p:nvSpPr>
         <p:spPr>
           <a:xfrm>
-            <a:off x="8857335" y="5285232"/>
-            <a:ext cx="1627632" cy="329184"/>
+            <a:off x="10252773" y="5285232"/>
+            <a:ext cx="1435999" cy="329184"/>
           </a:xfrm>
           <a:prstGeom prst="roundRect">
             <a:avLst>
@@ -10648,7 +12189,7 @@
             </a:avLst>
           </a:prstGeom>
           <a:solidFill>
-            <a:srgbClr val="D64545"/>
+            <a:srgbClr val="E8892B"/>
           </a:solidFill>
           <a:ln>
             <a:noFill/>
@@ -10685,8 +12226,8 @@
         </p:nvSpPr>
         <p:spPr>
           <a:xfrm>
-            <a:off x="8857335" y="5285232"/>
-            <a:ext cx="1627632" cy="329184"/>
+            <a:off x="10252773" y="5285232"/>
+            <a:ext cx="1435999" cy="329184"/>
           </a:xfrm>
           <a:prstGeom prst="rect">
             <a:avLst/>
@@ -10721,8 +12262,8 @@
         </p:nvSpPr>
         <p:spPr>
           <a:xfrm>
-            <a:off x="7156551" y="5285232"/>
-            <a:ext cx="1627632" cy="329184"/>
+            <a:off x="8743622" y="5285232"/>
+            <a:ext cx="1435999" cy="329184"/>
           </a:xfrm>
           <a:prstGeom prst="roundRect">
             <a:avLst>
@@ -10730,7 +12271,7 @@
             </a:avLst>
           </a:prstGeom>
           <a:solidFill>
-            <a:srgbClr val="E8892B"/>
+            <a:srgbClr val="D64545"/>
           </a:solidFill>
           <a:ln>
             <a:noFill/>
@@ -10767,8 +12308,8 @@
         </p:nvSpPr>
         <p:spPr>
           <a:xfrm>
-            <a:off x="7156551" y="5285232"/>
-            <a:ext cx="1627632" cy="329184"/>
+            <a:off x="8743622" y="5285232"/>
+            <a:ext cx="1435999" cy="329184"/>
           </a:xfrm>
           <a:prstGeom prst="rect">
             <a:avLst/>
@@ -10803,8 +12344,8 @@
         </p:nvSpPr>
         <p:spPr>
           <a:xfrm>
-            <a:off x="5455767" y="5285232"/>
-            <a:ext cx="1627632" cy="329184"/>
+            <a:off x="7234471" y="5285232"/>
+            <a:ext cx="1435999" cy="329184"/>
           </a:xfrm>
           <a:prstGeom prst="roundRect">
             <a:avLst>
@@ -10849,8 +12390,8 @@
         </p:nvSpPr>
         <p:spPr>
           <a:xfrm>
-            <a:off x="5455767" y="5285232"/>
-            <a:ext cx="1627632" cy="329184"/>
+            <a:off x="7234471" y="5285232"/>
+            <a:ext cx="1435999" cy="329184"/>
           </a:xfrm>
           <a:prstGeom prst="rect">
             <a:avLst/>
@@ -10885,8 +12426,8 @@
         </p:nvSpPr>
         <p:spPr>
           <a:xfrm>
-            <a:off x="8857335" y="5687568"/>
-            <a:ext cx="1627632" cy="329184"/>
+            <a:off x="10252773" y="5687568"/>
+            <a:ext cx="1435999" cy="329184"/>
           </a:xfrm>
           <a:prstGeom prst="roundRect">
             <a:avLst>
@@ -10931,8 +12472,8 @@
         </p:nvSpPr>
         <p:spPr>
           <a:xfrm>
-            <a:off x="8857335" y="5687568"/>
-            <a:ext cx="1627632" cy="329184"/>
+            <a:off x="10252773" y="5687568"/>
+            <a:ext cx="1435999" cy="329184"/>
           </a:xfrm>
           <a:prstGeom prst="rect">
             <a:avLst/>
@@ -10967,8 +12508,8 @@
         </p:nvSpPr>
         <p:spPr>
           <a:xfrm>
-            <a:off x="7156551" y="5687568"/>
-            <a:ext cx="1627632" cy="329184"/>
+            <a:off x="8743622" y="5687568"/>
+            <a:ext cx="1435999" cy="329184"/>
           </a:xfrm>
           <a:prstGeom prst="roundRect">
             <a:avLst>
@@ -11013,8 +12554,8 @@
         </p:nvSpPr>
         <p:spPr>
           <a:xfrm>
-            <a:off x="7156551" y="5687568"/>
-            <a:ext cx="1627632" cy="329184"/>
+            <a:off x="8743622" y="5687568"/>
+            <a:ext cx="1435999" cy="329184"/>
           </a:xfrm>
           <a:prstGeom prst="rect">
             <a:avLst/>
@@ -11049,8 +12590,8 @@
         </p:nvSpPr>
         <p:spPr>
           <a:xfrm>
-            <a:off x="5455767" y="5687568"/>
-            <a:ext cx="1627632" cy="329184"/>
+            <a:off x="7234471" y="5687568"/>
+            <a:ext cx="1435999" cy="329184"/>
           </a:xfrm>
           <a:prstGeom prst="roundRect">
             <a:avLst>
@@ -11095,8 +12636,8 @@
         </p:nvSpPr>
         <p:spPr>
           <a:xfrm>
-            <a:off x="5455767" y="5687568"/>
-            <a:ext cx="1627632" cy="329184"/>
+            <a:off x="7234471" y="5687568"/>
+            <a:ext cx="1435999" cy="329184"/>
           </a:xfrm>
           <a:prstGeom prst="rect">
             <a:avLst/>
@@ -11131,8 +12672,8 @@
         </p:nvSpPr>
         <p:spPr>
           <a:xfrm>
-            <a:off x="1615287" y="3182112"/>
-            <a:ext cx="3474720" cy="2157984"/>
+            <a:off x="3777257" y="3182112"/>
+            <a:ext cx="3091454" cy="2157984"/>
           </a:xfrm>
           <a:prstGeom prst="roundRect">
             <a:avLst>
@@ -11177,7 +12718,7 @@
         </p:nvSpPr>
         <p:spPr>
           <a:xfrm>
-            <a:off x="2163927" y="2926080"/>
+            <a:off x="4134264" y="2926080"/>
             <a:ext cx="2377440" cy="512064"/>
           </a:xfrm>
           <a:prstGeom prst="roundRect">
@@ -11223,7 +12764,7 @@
         </p:nvSpPr>
         <p:spPr>
           <a:xfrm>
-            <a:off x="2163927" y="2980944"/>
+            <a:off x="4134264" y="2980944"/>
             <a:ext cx="2377440" cy="266273"/>
           </a:xfrm>
           <a:prstGeom prst="rect">
@@ -11259,7 +12800,7 @@
         </p:nvSpPr>
         <p:spPr>
           <a:xfrm>
-            <a:off x="2163927" y="3207715"/>
+            <a:off x="4134264" y="3207715"/>
             <a:ext cx="2377440" cy="204825"/>
           </a:xfrm>
           <a:prstGeom prst="rect">
@@ -11295,8 +12836,8 @@
         </p:nvSpPr>
         <p:spPr>
           <a:xfrm>
-            <a:off x="3389223" y="3675888"/>
-            <a:ext cx="1609344" cy="329184"/>
+            <a:off x="5359560" y="3675888"/>
+            <a:ext cx="1417711" cy="329184"/>
           </a:xfrm>
           <a:prstGeom prst="roundRect">
             <a:avLst>
@@ -11341,8 +12882,8 @@
         </p:nvSpPr>
         <p:spPr>
           <a:xfrm>
-            <a:off x="3389223" y="3675888"/>
-            <a:ext cx="1609344" cy="329184"/>
+            <a:off x="5359560" y="3675888"/>
+            <a:ext cx="1417711" cy="329184"/>
           </a:xfrm>
           <a:prstGeom prst="rect">
             <a:avLst/>
@@ -11377,8 +12918,8 @@
         </p:nvSpPr>
         <p:spPr>
           <a:xfrm>
-            <a:off x="1706727" y="3675888"/>
-            <a:ext cx="1609344" cy="329184"/>
+            <a:off x="3868697" y="3675888"/>
+            <a:ext cx="1417711" cy="329184"/>
           </a:xfrm>
           <a:prstGeom prst="roundRect">
             <a:avLst>
@@ -11423,8 +12964,8 @@
         </p:nvSpPr>
         <p:spPr>
           <a:xfrm>
-            <a:off x="1706727" y="3675888"/>
-            <a:ext cx="1609344" cy="329184"/>
+            <a:off x="3868697" y="3675888"/>
+            <a:ext cx="1417711" cy="329184"/>
           </a:xfrm>
           <a:prstGeom prst="rect">
             <a:avLst/>
@@ -11459,8 +13000,8 @@
         </p:nvSpPr>
         <p:spPr>
           <a:xfrm>
-            <a:off x="3389223" y="4078224"/>
-            <a:ext cx="1609344" cy="329184"/>
+            <a:off x="5359560" y="4078224"/>
+            <a:ext cx="1417711" cy="329184"/>
           </a:xfrm>
           <a:prstGeom prst="roundRect">
             <a:avLst>
@@ -11505,8 +13046,8 @@
         </p:nvSpPr>
         <p:spPr>
           <a:xfrm>
-            <a:off x="3389223" y="4078224"/>
-            <a:ext cx="1609344" cy="329184"/>
+            <a:off x="5359560" y="4078224"/>
+            <a:ext cx="1417711" cy="329184"/>
           </a:xfrm>
           <a:prstGeom prst="rect">
             <a:avLst/>
@@ -11541,8 +13082,8 @@
         </p:nvSpPr>
         <p:spPr>
           <a:xfrm>
-            <a:off x="1706727" y="4078224"/>
-            <a:ext cx="1609344" cy="329184"/>
+            <a:off x="3868697" y="4078224"/>
+            <a:ext cx="1417711" cy="329184"/>
           </a:xfrm>
           <a:prstGeom prst="roundRect">
             <a:avLst>
@@ -11587,8 +13128,8 @@
         </p:nvSpPr>
         <p:spPr>
           <a:xfrm>
-            <a:off x="1706727" y="4078224"/>
-            <a:ext cx="1609344" cy="329184"/>
+            <a:off x="3868697" y="4078224"/>
+            <a:ext cx="1417711" cy="329184"/>
           </a:xfrm>
           <a:prstGeom prst="rect">
             <a:avLst/>
@@ -11623,8 +13164,8 @@
         </p:nvSpPr>
         <p:spPr>
           <a:xfrm>
-            <a:off x="3389223" y="4480560"/>
-            <a:ext cx="1609344" cy="329184"/>
+            <a:off x="5359560" y="4480560"/>
+            <a:ext cx="1417711" cy="329184"/>
           </a:xfrm>
           <a:prstGeom prst="roundRect">
             <a:avLst>
@@ -11669,8 +13210,8 @@
         </p:nvSpPr>
         <p:spPr>
           <a:xfrm>
-            <a:off x="3389223" y="4480560"/>
-            <a:ext cx="1609344" cy="329184"/>
+            <a:off x="5359560" y="4480560"/>
+            <a:ext cx="1417711" cy="329184"/>
           </a:xfrm>
           <a:prstGeom prst="rect">
             <a:avLst/>
@@ -11705,8 +13246,8 @@
         </p:nvSpPr>
         <p:spPr>
           <a:xfrm>
-            <a:off x="1706727" y="4480560"/>
-            <a:ext cx="1609344" cy="329184"/>
+            <a:off x="3868697" y="4480560"/>
+            <a:ext cx="1417711" cy="329184"/>
           </a:xfrm>
           <a:prstGeom prst="roundRect">
             <a:avLst>
@@ -11751,8 +13292,8 @@
         </p:nvSpPr>
         <p:spPr>
           <a:xfrm>
-            <a:off x="1706727" y="4480560"/>
-            <a:ext cx="1609344" cy="329184"/>
+            <a:off x="3868697" y="4480560"/>
+            <a:ext cx="1417711" cy="329184"/>
           </a:xfrm>
           <a:prstGeom prst="rect">
             <a:avLst/>
@@ -11787,8 +13328,8 @@
         </p:nvSpPr>
         <p:spPr>
           <a:xfrm>
-            <a:off x="3389223" y="4882896"/>
-            <a:ext cx="1609344" cy="329184"/>
+            <a:off x="5359560" y="4882896"/>
+            <a:ext cx="1417711" cy="329184"/>
           </a:xfrm>
           <a:prstGeom prst="roundRect">
             <a:avLst>
@@ -11833,8 +13374,8 @@
         </p:nvSpPr>
         <p:spPr>
           <a:xfrm>
-            <a:off x="3389223" y="4882896"/>
-            <a:ext cx="1609344" cy="329184"/>
+            <a:off x="5359560" y="4882896"/>
+            <a:ext cx="1417711" cy="329184"/>
           </a:xfrm>
           <a:prstGeom prst="rect">
             <a:avLst/>
@@ -11861,9 +13402,1055 @@
           </a:p>
         </p:txBody>
       </p:sp>
+      <p:sp>
+        <p:nvSpPr>
+          <p:cNvPr id="92" name="Rounded Rectangle 91"/>
+          <p:cNvSpPr/>
+          <p:nvPr/>
+        </p:nvSpPr>
+        <p:spPr>
+          <a:xfrm>
+            <a:off x="411483" y="3182112"/>
+            <a:ext cx="3091454" cy="2560320"/>
+          </a:xfrm>
+          <a:prstGeom prst="roundRect">
+            <a:avLst>
+              <a:gd name="adj" fmla="val 4000"/>
+            </a:avLst>
+          </a:prstGeom>
+          <a:noFill/>
+          <a:ln w="15875">
+            <a:solidFill>
+              <a:srgbClr val="C5CDDD"/>
+            </a:solidFill>
+          </a:ln>
+          <a:effectLst/>
+        </p:spPr>
+        <p:style>
+          <a:lnRef idx="1">
+            <a:schemeClr val="accent1"/>
+          </a:lnRef>
+          <a:fillRef idx="3">
+            <a:schemeClr val="accent1"/>
+          </a:fillRef>
+          <a:effectRef idx="2">
+            <a:schemeClr val="accent1"/>
+          </a:effectRef>
+          <a:fontRef idx="minor">
+            <a:schemeClr val="lt1"/>
+          </a:fontRef>
+        </p:style>
+        <p:txBody>
+          <a:bodyPr rtlCol="0" anchor="ctr"/>
+          <a:lstStyle/>
+          <a:p>
+            <a:pPr algn="ctr"/>
+          </a:p>
+        </p:txBody>
+      </p:sp>
+      <p:sp>
+        <p:nvSpPr>
+          <p:cNvPr id="93" name="Rounded Rectangle 92"/>
+          <p:cNvSpPr/>
+          <p:nvPr/>
+        </p:nvSpPr>
+        <p:spPr>
+          <a:xfrm>
+            <a:off x="768490" y="2926080"/>
+            <a:ext cx="2377440" cy="512064"/>
+          </a:xfrm>
+          <a:prstGeom prst="roundRect">
+            <a:avLst>
+              <a:gd name="adj" fmla="val 18000"/>
+            </a:avLst>
+          </a:prstGeom>
+          <a:solidFill>
+            <a:srgbClr val="E8892B"/>
+          </a:solidFill>
+          <a:ln>
+            <a:noFill/>
+          </a:ln>
+          <a:effectLst/>
+        </p:spPr>
+        <p:style>
+          <a:lnRef idx="1">
+            <a:schemeClr val="accent1"/>
+          </a:lnRef>
+          <a:fillRef idx="3">
+            <a:schemeClr val="accent1"/>
+          </a:fillRef>
+          <a:effectRef idx="2">
+            <a:schemeClr val="accent1"/>
+          </a:effectRef>
+          <a:fontRef idx="minor">
+            <a:schemeClr val="lt1"/>
+          </a:fontRef>
+        </p:style>
+        <p:txBody>
+          <a:bodyPr rtlCol="0" anchor="ctr"/>
+          <a:lstStyle/>
+          <a:p>
+            <a:pPr algn="ctr"/>
+          </a:p>
+        </p:txBody>
+      </p:sp>
+      <p:sp>
+        <p:nvSpPr>
+          <p:cNvPr id="94" name="TextBox 93"/>
+          <p:cNvSpPr txBox="1"/>
+          <p:nvPr/>
+        </p:nvSpPr>
+        <p:spPr>
+          <a:xfrm>
+            <a:off x="768490" y="2980944"/>
+            <a:ext cx="2377440" cy="266273"/>
+          </a:xfrm>
+          <a:prstGeom prst="rect">
+            <a:avLst/>
+          </a:prstGeom>
+          <a:noFill/>
+        </p:spPr>
+        <p:txBody>
+          <a:bodyPr wrap="square" anchor="b" lIns="36576" rIns="36576" tIns="0" bIns="0">
+            <a:spAutoFit/>
+          </a:bodyPr>
+          <a:lstStyle/>
+          <a:p>
+            <a:pPr algn="ctr" rtl="1"/>
+            <a:r>
+              <a:rPr sz="1200" b="1">
+                <a:solidFill>
+                  <a:srgbClr val="FFFFFF"/>
+                </a:solidFill>
+                <a:latin typeface="Heebo"/>
+                <a:cs typeface="Heebo"/>
+              </a:rPr>
+              <a:t>איתמר כהן</a:t>
+            </a:r>
+          </a:p>
+        </p:txBody>
+      </p:sp>
+      <p:sp>
+        <p:nvSpPr>
+          <p:cNvPr id="95" name="TextBox 94"/>
+          <p:cNvSpPr txBox="1"/>
+          <p:nvPr/>
+        </p:nvSpPr>
+        <p:spPr>
+          <a:xfrm>
+            <a:off x="768490" y="3207715"/>
+            <a:ext cx="2377440" cy="204825"/>
+          </a:xfrm>
+          <a:prstGeom prst="rect">
+            <a:avLst/>
+          </a:prstGeom>
+          <a:noFill/>
+        </p:spPr>
+        <p:txBody>
+          <a:bodyPr wrap="square" anchor="t" lIns="36576" rIns="36576" tIns="0" bIns="0">
+            <a:spAutoFit/>
+          </a:bodyPr>
+          <a:lstStyle/>
+          <a:p>
+            <a:pPr algn="ctr" rtl="1"/>
+            <a:r>
+              <a:rPr sz="900" b="0">
+                <a:solidFill>
+                  <a:srgbClr val="FFFFFF"/>
+                </a:solidFill>
+                <a:latin typeface="Heebo"/>
+                <a:cs typeface="Heebo"/>
+              </a:rPr>
+              <a:t>ראש צוות (טוויטר) · צוות דיגיטל</a:t>
+            </a:r>
+          </a:p>
+        </p:txBody>
+      </p:sp>
+      <p:sp>
+        <p:nvSpPr>
+          <p:cNvPr id="96" name="Rounded Rectangle 95"/>
+          <p:cNvSpPr/>
+          <p:nvPr/>
+        </p:nvSpPr>
+        <p:spPr>
+          <a:xfrm>
+            <a:off x="1993786" y="3675888"/>
+            <a:ext cx="1417711" cy="329184"/>
+          </a:xfrm>
+          <a:prstGeom prst="roundRect">
+            <a:avLst>
+              <a:gd name="adj" fmla="val 18000"/>
+            </a:avLst>
+          </a:prstGeom>
+          <a:solidFill>
+            <a:srgbClr val="E8892B"/>
+          </a:solidFill>
+          <a:ln>
+            <a:noFill/>
+          </a:ln>
+          <a:effectLst/>
+        </p:spPr>
+        <p:style>
+          <a:lnRef idx="1">
+            <a:schemeClr val="accent1"/>
+          </a:lnRef>
+          <a:fillRef idx="3">
+            <a:schemeClr val="accent1"/>
+          </a:fillRef>
+          <a:effectRef idx="2">
+            <a:schemeClr val="accent1"/>
+          </a:effectRef>
+          <a:fontRef idx="minor">
+            <a:schemeClr val="lt1"/>
+          </a:fontRef>
+        </p:style>
+        <p:txBody>
+          <a:bodyPr rtlCol="0" anchor="ctr"/>
+          <a:lstStyle/>
+          <a:p>
+            <a:pPr algn="ctr"/>
+          </a:p>
+        </p:txBody>
+      </p:sp>
+      <p:sp>
+        <p:nvSpPr>
+          <p:cNvPr id="97" name="TextBox 96"/>
+          <p:cNvSpPr txBox="1"/>
+          <p:nvPr/>
+        </p:nvSpPr>
+        <p:spPr>
+          <a:xfrm>
+            <a:off x="1993786" y="3675888"/>
+            <a:ext cx="1417711" cy="197510"/>
+          </a:xfrm>
+          <a:prstGeom prst="rect">
+            <a:avLst/>
+          </a:prstGeom>
+          <a:noFill/>
+        </p:spPr>
+        <p:txBody>
+          <a:bodyPr wrap="square" anchor="b" lIns="36576" rIns="36576" tIns="0" bIns="0">
+            <a:spAutoFit/>
+          </a:bodyPr>
+          <a:lstStyle/>
+          <a:p>
+            <a:pPr algn="ctr" rtl="1"/>
+            <a:r>
+              <a:rPr sz="1000" b="1">
+                <a:solidFill>
+                  <a:srgbClr val="FFFFFF"/>
+                </a:solidFill>
+                <a:latin typeface="Heebo"/>
+                <a:cs typeface="Heebo"/>
+              </a:rPr>
+              <a:t>אלתר כהן</a:t>
+            </a:r>
+          </a:p>
+        </p:txBody>
+      </p:sp>
+      <p:sp>
+        <p:nvSpPr>
+          <p:cNvPr id="98" name="TextBox 97"/>
+          <p:cNvSpPr txBox="1"/>
+          <p:nvPr/>
+        </p:nvSpPr>
+        <p:spPr>
+          <a:xfrm>
+            <a:off x="1993786" y="3866814"/>
+            <a:ext cx="1417711" cy="131673"/>
+          </a:xfrm>
+          <a:prstGeom prst="rect">
+            <a:avLst/>
+          </a:prstGeom>
+          <a:noFill/>
+        </p:spPr>
+        <p:txBody>
+          <a:bodyPr wrap="square" anchor="t" lIns="36576" rIns="36576" tIns="0" bIns="0">
+            <a:spAutoFit/>
+          </a:bodyPr>
+          <a:lstStyle/>
+          <a:p>
+            <a:pPr algn="ctr" rtl="1"/>
+            <a:r>
+              <a:rPr sz="800" b="0">
+                <a:solidFill>
+                  <a:srgbClr val="FFFFFF"/>
+                </a:solidFill>
+                <a:latin typeface="Heebo"/>
+                <a:cs typeface="Heebo"/>
+              </a:rPr>
+              <a:t>(אינסטגרם)</a:t>
+            </a:r>
+          </a:p>
+        </p:txBody>
+      </p:sp>
+      <p:sp>
+        <p:nvSpPr>
+          <p:cNvPr id="99" name="Rounded Rectangle 98"/>
+          <p:cNvSpPr/>
+          <p:nvPr/>
+        </p:nvSpPr>
+        <p:spPr>
+          <a:xfrm>
+            <a:off x="502923" y="3675888"/>
+            <a:ext cx="1417711" cy="329184"/>
+          </a:xfrm>
+          <a:prstGeom prst="roundRect">
+            <a:avLst>
+              <a:gd name="adj" fmla="val 18000"/>
+            </a:avLst>
+          </a:prstGeom>
+          <a:solidFill>
+            <a:srgbClr val="E8892B"/>
+          </a:solidFill>
+          <a:ln>
+            <a:noFill/>
+          </a:ln>
+          <a:effectLst/>
+        </p:spPr>
+        <p:style>
+          <a:lnRef idx="1">
+            <a:schemeClr val="accent1"/>
+          </a:lnRef>
+          <a:fillRef idx="3">
+            <a:schemeClr val="accent1"/>
+          </a:fillRef>
+          <a:effectRef idx="2">
+            <a:schemeClr val="accent1"/>
+          </a:effectRef>
+          <a:fontRef idx="minor">
+            <a:schemeClr val="lt1"/>
+          </a:fontRef>
+        </p:style>
+        <p:txBody>
+          <a:bodyPr rtlCol="0" anchor="ctr"/>
+          <a:lstStyle/>
+          <a:p>
+            <a:pPr algn="ctr"/>
+          </a:p>
+        </p:txBody>
+      </p:sp>
+      <p:sp>
+        <p:nvSpPr>
+          <p:cNvPr id="100" name="TextBox 99"/>
+          <p:cNvSpPr txBox="1"/>
+          <p:nvPr/>
+        </p:nvSpPr>
+        <p:spPr>
+          <a:xfrm>
+            <a:off x="502923" y="3675888"/>
+            <a:ext cx="1417711" cy="197510"/>
+          </a:xfrm>
+          <a:prstGeom prst="rect">
+            <a:avLst/>
+          </a:prstGeom>
+          <a:noFill/>
+        </p:spPr>
+        <p:txBody>
+          <a:bodyPr wrap="square" anchor="b" lIns="36576" rIns="36576" tIns="0" bIns="0">
+            <a:spAutoFit/>
+          </a:bodyPr>
+          <a:lstStyle/>
+          <a:p>
+            <a:pPr algn="ctr" rtl="1"/>
+            <a:r>
+              <a:rPr sz="1000" b="1">
+                <a:solidFill>
+                  <a:srgbClr val="FFFFFF"/>
+                </a:solidFill>
+                <a:latin typeface="Heebo"/>
+                <a:cs typeface="Heebo"/>
+              </a:rPr>
+              <a:t>ישראל ציג</a:t>
+            </a:r>
+          </a:p>
+        </p:txBody>
+      </p:sp>
+      <p:sp>
+        <p:nvSpPr>
+          <p:cNvPr id="101" name="TextBox 100"/>
+          <p:cNvSpPr txBox="1"/>
+          <p:nvPr/>
+        </p:nvSpPr>
+        <p:spPr>
+          <a:xfrm>
+            <a:off x="502923" y="3866814"/>
+            <a:ext cx="1417711" cy="131673"/>
+          </a:xfrm>
+          <a:prstGeom prst="rect">
+            <a:avLst/>
+          </a:prstGeom>
+          <a:noFill/>
+        </p:spPr>
+        <p:txBody>
+          <a:bodyPr wrap="square" anchor="t" lIns="36576" rIns="36576" tIns="0" bIns="0">
+            <a:spAutoFit/>
+          </a:bodyPr>
+          <a:lstStyle/>
+          <a:p>
+            <a:pPr algn="ctr" rtl="1"/>
+            <a:r>
+              <a:rPr sz="800" b="0">
+                <a:solidFill>
+                  <a:srgbClr val="FFFFFF"/>
+                </a:solidFill>
+                <a:latin typeface="Heebo"/>
+                <a:cs typeface="Heebo"/>
+              </a:rPr>
+              <a:t>(פייסבוק)</a:t>
+            </a:r>
+          </a:p>
+        </p:txBody>
+      </p:sp>
+      <p:sp>
+        <p:nvSpPr>
+          <p:cNvPr id="102" name="Rounded Rectangle 101"/>
+          <p:cNvSpPr/>
+          <p:nvPr/>
+        </p:nvSpPr>
+        <p:spPr>
+          <a:xfrm>
+            <a:off x="1993786" y="4078224"/>
+            <a:ext cx="1417711" cy="329184"/>
+          </a:xfrm>
+          <a:prstGeom prst="roundRect">
+            <a:avLst>
+              <a:gd name="adj" fmla="val 18000"/>
+            </a:avLst>
+          </a:prstGeom>
+          <a:solidFill>
+            <a:srgbClr val="E8892B"/>
+          </a:solidFill>
+          <a:ln>
+            <a:noFill/>
+          </a:ln>
+          <a:effectLst/>
+        </p:spPr>
+        <p:style>
+          <a:lnRef idx="1">
+            <a:schemeClr val="accent1"/>
+          </a:lnRef>
+          <a:fillRef idx="3">
+            <a:schemeClr val="accent1"/>
+          </a:fillRef>
+          <a:effectRef idx="2">
+            <a:schemeClr val="accent1"/>
+          </a:effectRef>
+          <a:fontRef idx="minor">
+            <a:schemeClr val="lt1"/>
+          </a:fontRef>
+        </p:style>
+        <p:txBody>
+          <a:bodyPr rtlCol="0" anchor="ctr"/>
+          <a:lstStyle/>
+          <a:p>
+            <a:pPr algn="ctr"/>
+          </a:p>
+        </p:txBody>
+      </p:sp>
+      <p:sp>
+        <p:nvSpPr>
+          <p:cNvPr id="103" name="TextBox 102"/>
+          <p:cNvSpPr txBox="1"/>
+          <p:nvPr/>
+        </p:nvSpPr>
+        <p:spPr>
+          <a:xfrm>
+            <a:off x="1993786" y="4078224"/>
+            <a:ext cx="1417711" cy="197510"/>
+          </a:xfrm>
+          <a:prstGeom prst="rect">
+            <a:avLst/>
+          </a:prstGeom>
+          <a:noFill/>
+        </p:spPr>
+        <p:txBody>
+          <a:bodyPr wrap="square" anchor="b" lIns="36576" rIns="36576" tIns="0" bIns="0">
+            <a:spAutoFit/>
+          </a:bodyPr>
+          <a:lstStyle/>
+          <a:p>
+            <a:pPr algn="ctr" rtl="1"/>
+            <a:r>
+              <a:rPr sz="1000" b="1">
+                <a:solidFill>
+                  <a:srgbClr val="FFFFFF"/>
+                </a:solidFill>
+                <a:latin typeface="Heebo"/>
+                <a:cs typeface="Heebo"/>
+              </a:rPr>
+              <a:t>מנחם זיבוטפסקי</a:t>
+            </a:r>
+          </a:p>
+        </p:txBody>
+      </p:sp>
+      <p:sp>
+        <p:nvSpPr>
+          <p:cNvPr id="104" name="TextBox 103"/>
+          <p:cNvSpPr txBox="1"/>
+          <p:nvPr/>
+        </p:nvSpPr>
+        <p:spPr>
+          <a:xfrm>
+            <a:off x="1993786" y="4269150"/>
+            <a:ext cx="1417711" cy="131673"/>
+          </a:xfrm>
+          <a:prstGeom prst="rect">
+            <a:avLst/>
+          </a:prstGeom>
+          <a:noFill/>
+        </p:spPr>
+        <p:txBody>
+          <a:bodyPr wrap="square" anchor="t" lIns="36576" rIns="36576" tIns="0" bIns="0">
+            <a:spAutoFit/>
+          </a:bodyPr>
+          <a:lstStyle/>
+          <a:p>
+            <a:pPr algn="ctr" rtl="1"/>
+            <a:r>
+              <a:rPr sz="800" b="0">
+                <a:solidFill>
+                  <a:srgbClr val="FFFFFF"/>
+                </a:solidFill>
+                <a:latin typeface="Heebo"/>
+                <a:cs typeface="Heebo"/>
+              </a:rPr>
+              <a:t>(יוטיוב)</a:t>
+            </a:r>
+          </a:p>
+        </p:txBody>
+      </p:sp>
+      <p:sp>
+        <p:nvSpPr>
+          <p:cNvPr id="105" name="Rounded Rectangle 104"/>
+          <p:cNvSpPr/>
+          <p:nvPr/>
+        </p:nvSpPr>
+        <p:spPr>
+          <a:xfrm>
+            <a:off x="502923" y="4078224"/>
+            <a:ext cx="1417711" cy="329184"/>
+          </a:xfrm>
+          <a:prstGeom prst="roundRect">
+            <a:avLst>
+              <a:gd name="adj" fmla="val 18000"/>
+            </a:avLst>
+          </a:prstGeom>
+          <a:solidFill>
+            <a:srgbClr val="E8892B"/>
+          </a:solidFill>
+          <a:ln>
+            <a:noFill/>
+          </a:ln>
+          <a:effectLst/>
+        </p:spPr>
+        <p:style>
+          <a:lnRef idx="1">
+            <a:schemeClr val="accent1"/>
+          </a:lnRef>
+          <a:fillRef idx="3">
+            <a:schemeClr val="accent1"/>
+          </a:fillRef>
+          <a:effectRef idx="2">
+            <a:schemeClr val="accent1"/>
+          </a:effectRef>
+          <a:fontRef idx="minor">
+            <a:schemeClr val="lt1"/>
+          </a:fontRef>
+        </p:style>
+        <p:txBody>
+          <a:bodyPr rtlCol="0" anchor="ctr"/>
+          <a:lstStyle/>
+          <a:p>
+            <a:pPr algn="ctr"/>
+          </a:p>
+        </p:txBody>
+      </p:sp>
+      <p:sp>
+        <p:nvSpPr>
+          <p:cNvPr id="106" name="TextBox 105"/>
+          <p:cNvSpPr txBox="1"/>
+          <p:nvPr/>
+        </p:nvSpPr>
+        <p:spPr>
+          <a:xfrm>
+            <a:off x="502923" y="4078224"/>
+            <a:ext cx="1417711" cy="197510"/>
+          </a:xfrm>
+          <a:prstGeom prst="rect">
+            <a:avLst/>
+          </a:prstGeom>
+          <a:noFill/>
+        </p:spPr>
+        <p:txBody>
+          <a:bodyPr wrap="square" anchor="b" lIns="36576" rIns="36576" tIns="0" bIns="0">
+            <a:spAutoFit/>
+          </a:bodyPr>
+          <a:lstStyle/>
+          <a:p>
+            <a:pPr algn="ctr" rtl="1"/>
+            <a:r>
+              <a:rPr sz="1000" b="1">
+                <a:solidFill>
+                  <a:srgbClr val="FFFFFF"/>
+                </a:solidFill>
+                <a:latin typeface="Heebo"/>
+                <a:cs typeface="Heebo"/>
+              </a:rPr>
+              <a:t>יהודה חדאד</a:t>
+            </a:r>
+          </a:p>
+        </p:txBody>
+      </p:sp>
+      <p:sp>
+        <p:nvSpPr>
+          <p:cNvPr id="107" name="TextBox 106"/>
+          <p:cNvSpPr txBox="1"/>
+          <p:nvPr/>
+        </p:nvSpPr>
+        <p:spPr>
+          <a:xfrm>
+            <a:off x="502923" y="4269150"/>
+            <a:ext cx="1417711" cy="131673"/>
+          </a:xfrm>
+          <a:prstGeom prst="rect">
+            <a:avLst/>
+          </a:prstGeom>
+          <a:noFill/>
+        </p:spPr>
+        <p:txBody>
+          <a:bodyPr wrap="square" anchor="t" lIns="36576" rIns="36576" tIns="0" bIns="0">
+            <a:spAutoFit/>
+          </a:bodyPr>
+          <a:lstStyle/>
+          <a:p>
+            <a:pPr algn="ctr" rtl="1"/>
+            <a:r>
+              <a:rPr sz="800" b="0">
+                <a:solidFill>
+                  <a:srgbClr val="FFFFFF"/>
+                </a:solidFill>
+                <a:latin typeface="Heebo"/>
+                <a:cs typeface="Heebo"/>
+              </a:rPr>
+              <a:t>(אתר)</a:t>
+            </a:r>
+          </a:p>
+        </p:txBody>
+      </p:sp>
+      <p:sp>
+        <p:nvSpPr>
+          <p:cNvPr id="108" name="Rounded Rectangle 107"/>
+          <p:cNvSpPr/>
+          <p:nvPr/>
+        </p:nvSpPr>
+        <p:spPr>
+          <a:xfrm>
+            <a:off x="1993786" y="4480560"/>
+            <a:ext cx="1417711" cy="329184"/>
+          </a:xfrm>
+          <a:prstGeom prst="roundRect">
+            <a:avLst>
+              <a:gd name="adj" fmla="val 18000"/>
+            </a:avLst>
+          </a:prstGeom>
+          <a:solidFill>
+            <a:srgbClr val="E8892B"/>
+          </a:solidFill>
+          <a:ln>
+            <a:noFill/>
+          </a:ln>
+          <a:effectLst/>
+        </p:spPr>
+        <p:style>
+          <a:lnRef idx="1">
+            <a:schemeClr val="accent1"/>
+          </a:lnRef>
+          <a:fillRef idx="3">
+            <a:schemeClr val="accent1"/>
+          </a:fillRef>
+          <a:effectRef idx="2">
+            <a:schemeClr val="accent1"/>
+          </a:effectRef>
+          <a:fontRef idx="minor">
+            <a:schemeClr val="lt1"/>
+          </a:fontRef>
+        </p:style>
+        <p:txBody>
+          <a:bodyPr rtlCol="0" anchor="ctr"/>
+          <a:lstStyle/>
+          <a:p>
+            <a:pPr algn="ctr"/>
+          </a:p>
+        </p:txBody>
+      </p:sp>
+      <p:sp>
+        <p:nvSpPr>
+          <p:cNvPr id="109" name="TextBox 108"/>
+          <p:cNvSpPr txBox="1"/>
+          <p:nvPr/>
+        </p:nvSpPr>
+        <p:spPr>
+          <a:xfrm>
+            <a:off x="1993786" y="4480560"/>
+            <a:ext cx="1417711" cy="329184"/>
+          </a:xfrm>
+          <a:prstGeom prst="rect">
+            <a:avLst/>
+          </a:prstGeom>
+          <a:noFill/>
+        </p:spPr>
+        <p:txBody>
+          <a:bodyPr wrap="square" anchor="ctr" lIns="36576" rIns="36576" tIns="0" bIns="0">
+            <a:spAutoFit/>
+          </a:bodyPr>
+          <a:lstStyle/>
+          <a:p>
+            <a:pPr algn="ctr" rtl="1"/>
+            <a:r>
+              <a:rPr sz="1100" b="1">
+                <a:solidFill>
+                  <a:srgbClr val="FFFFFF"/>
+                </a:solidFill>
+                <a:latin typeface="Heebo"/>
+                <a:cs typeface="Heebo"/>
+              </a:rPr>
+              <a:t>יוסף</a:t>
+            </a:r>
+          </a:p>
+        </p:txBody>
+      </p:sp>
+      <p:sp>
+        <p:nvSpPr>
+          <p:cNvPr id="110" name="Rounded Rectangle 109"/>
+          <p:cNvSpPr/>
+          <p:nvPr/>
+        </p:nvSpPr>
+        <p:spPr>
+          <a:xfrm>
+            <a:off x="502923" y="4480560"/>
+            <a:ext cx="1417711" cy="329184"/>
+          </a:xfrm>
+          <a:prstGeom prst="roundRect">
+            <a:avLst>
+              <a:gd name="adj" fmla="val 18000"/>
+            </a:avLst>
+          </a:prstGeom>
+          <a:solidFill>
+            <a:srgbClr val="E8892B"/>
+          </a:solidFill>
+          <a:ln>
+            <a:noFill/>
+          </a:ln>
+          <a:effectLst/>
+        </p:spPr>
+        <p:style>
+          <a:lnRef idx="1">
+            <a:schemeClr val="accent1"/>
+          </a:lnRef>
+          <a:fillRef idx="3">
+            <a:schemeClr val="accent1"/>
+          </a:fillRef>
+          <a:effectRef idx="2">
+            <a:schemeClr val="accent1"/>
+          </a:effectRef>
+          <a:fontRef idx="minor">
+            <a:schemeClr val="lt1"/>
+          </a:fontRef>
+        </p:style>
+        <p:txBody>
+          <a:bodyPr rtlCol="0" anchor="ctr"/>
+          <a:lstStyle/>
+          <a:p>
+            <a:pPr algn="ctr"/>
+          </a:p>
+        </p:txBody>
+      </p:sp>
+      <p:sp>
+        <p:nvSpPr>
+          <p:cNvPr id="111" name="TextBox 110"/>
+          <p:cNvSpPr txBox="1"/>
+          <p:nvPr/>
+        </p:nvSpPr>
+        <p:spPr>
+          <a:xfrm>
+            <a:off x="502923" y="4480560"/>
+            <a:ext cx="1417711" cy="329184"/>
+          </a:xfrm>
+          <a:prstGeom prst="rect">
+            <a:avLst/>
+          </a:prstGeom>
+          <a:noFill/>
+        </p:spPr>
+        <p:txBody>
+          <a:bodyPr wrap="square" anchor="ctr" lIns="36576" rIns="36576" tIns="0" bIns="0">
+            <a:spAutoFit/>
+          </a:bodyPr>
+          <a:lstStyle/>
+          <a:p>
+            <a:pPr algn="ctr" rtl="1"/>
+            <a:r>
+              <a:rPr sz="1100" b="1">
+                <a:solidFill>
+                  <a:srgbClr val="FFFFFF"/>
+                </a:solidFill>
+                <a:latin typeface="Heebo"/>
+                <a:cs typeface="Heebo"/>
+              </a:rPr>
+              <a:t>יהודה הנדלר</a:t>
+            </a:r>
+          </a:p>
+        </p:txBody>
+      </p:sp>
+      <p:sp>
+        <p:nvSpPr>
+          <p:cNvPr id="112" name="Rounded Rectangle 111"/>
+          <p:cNvSpPr/>
+          <p:nvPr/>
+        </p:nvSpPr>
+        <p:spPr>
+          <a:xfrm>
+            <a:off x="1993786" y="4882896"/>
+            <a:ext cx="1417711" cy="329184"/>
+          </a:xfrm>
+          <a:prstGeom prst="roundRect">
+            <a:avLst>
+              <a:gd name="adj" fmla="val 18000"/>
+            </a:avLst>
+          </a:prstGeom>
+          <a:solidFill>
+            <a:srgbClr val="E8892B"/>
+          </a:solidFill>
+          <a:ln>
+            <a:noFill/>
+          </a:ln>
+          <a:effectLst/>
+        </p:spPr>
+        <p:style>
+          <a:lnRef idx="1">
+            <a:schemeClr val="accent1"/>
+          </a:lnRef>
+          <a:fillRef idx="3">
+            <a:schemeClr val="accent1"/>
+          </a:fillRef>
+          <a:effectRef idx="2">
+            <a:schemeClr val="accent1"/>
+          </a:effectRef>
+          <a:fontRef idx="minor">
+            <a:schemeClr val="lt1"/>
+          </a:fontRef>
+        </p:style>
+        <p:txBody>
+          <a:bodyPr rtlCol="0" anchor="ctr"/>
+          <a:lstStyle/>
+          <a:p>
+            <a:pPr algn="ctr"/>
+          </a:p>
+        </p:txBody>
+      </p:sp>
+      <p:sp>
+        <p:nvSpPr>
+          <p:cNvPr id="113" name="TextBox 112"/>
+          <p:cNvSpPr txBox="1"/>
+          <p:nvPr/>
+        </p:nvSpPr>
+        <p:spPr>
+          <a:xfrm>
+            <a:off x="1993786" y="4882896"/>
+            <a:ext cx="1417711" cy="329184"/>
+          </a:xfrm>
+          <a:prstGeom prst="rect">
+            <a:avLst/>
+          </a:prstGeom>
+          <a:noFill/>
+        </p:spPr>
+        <p:txBody>
+          <a:bodyPr wrap="square" anchor="ctr" lIns="36576" rIns="36576" tIns="0" bIns="0">
+            <a:spAutoFit/>
+          </a:bodyPr>
+          <a:lstStyle/>
+          <a:p>
+            <a:pPr algn="ctr" rtl="1"/>
+            <a:r>
+              <a:rPr sz="1100" b="1">
+                <a:solidFill>
+                  <a:srgbClr val="FFFFFF"/>
+                </a:solidFill>
+                <a:latin typeface="Heebo"/>
+                <a:cs typeface="Heebo"/>
+              </a:rPr>
+              <a:t>יואב קוסטינר</a:t>
+            </a:r>
+          </a:p>
+        </p:txBody>
+      </p:sp>
+      <p:sp>
+        <p:nvSpPr>
+          <p:cNvPr id="114" name="Rounded Rectangle 113"/>
+          <p:cNvSpPr/>
+          <p:nvPr/>
+        </p:nvSpPr>
+        <p:spPr>
+          <a:xfrm>
+            <a:off x="502923" y="4882896"/>
+            <a:ext cx="1417711" cy="329184"/>
+          </a:xfrm>
+          <a:prstGeom prst="roundRect">
+            <a:avLst>
+              <a:gd name="adj" fmla="val 18000"/>
+            </a:avLst>
+          </a:prstGeom>
+          <a:solidFill>
+            <a:srgbClr val="E8892B"/>
+          </a:solidFill>
+          <a:ln>
+            <a:noFill/>
+          </a:ln>
+          <a:effectLst/>
+        </p:spPr>
+        <p:style>
+          <a:lnRef idx="1">
+            <a:schemeClr val="accent1"/>
+          </a:lnRef>
+          <a:fillRef idx="3">
+            <a:schemeClr val="accent1"/>
+          </a:fillRef>
+          <a:effectRef idx="2">
+            <a:schemeClr val="accent1"/>
+          </a:effectRef>
+          <a:fontRef idx="minor">
+            <a:schemeClr val="lt1"/>
+          </a:fontRef>
+        </p:style>
+        <p:txBody>
+          <a:bodyPr rtlCol="0" anchor="ctr"/>
+          <a:lstStyle/>
+          <a:p>
+            <a:pPr algn="ctr"/>
+          </a:p>
+        </p:txBody>
+      </p:sp>
+      <p:sp>
+        <p:nvSpPr>
+          <p:cNvPr id="115" name="TextBox 114"/>
+          <p:cNvSpPr txBox="1"/>
+          <p:nvPr/>
+        </p:nvSpPr>
+        <p:spPr>
+          <a:xfrm>
+            <a:off x="502923" y="4882896"/>
+            <a:ext cx="1417711" cy="329184"/>
+          </a:xfrm>
+          <a:prstGeom prst="rect">
+            <a:avLst/>
+          </a:prstGeom>
+          <a:noFill/>
+        </p:spPr>
+        <p:txBody>
+          <a:bodyPr wrap="square" anchor="ctr" lIns="36576" rIns="36576" tIns="0" bIns="0">
+            <a:spAutoFit/>
+          </a:bodyPr>
+          <a:lstStyle/>
+          <a:p>
+            <a:pPr algn="ctr" rtl="1"/>
+            <a:r>
+              <a:rPr sz="1100" b="1">
+                <a:solidFill>
+                  <a:srgbClr val="FFFFFF"/>
+                </a:solidFill>
+                <a:latin typeface="Heebo"/>
+                <a:cs typeface="Heebo"/>
+              </a:rPr>
+              <a:t>יוסף גוטויליג</a:t>
+            </a:r>
+          </a:p>
+        </p:txBody>
+      </p:sp>
+      <p:sp>
+        <p:nvSpPr>
+          <p:cNvPr id="116" name="Rounded Rectangle 115"/>
+          <p:cNvSpPr/>
+          <p:nvPr/>
+        </p:nvSpPr>
+        <p:spPr>
+          <a:xfrm>
+            <a:off x="1993786" y="5285232"/>
+            <a:ext cx="1417711" cy="329184"/>
+          </a:xfrm>
+          <a:prstGeom prst="roundRect">
+            <a:avLst>
+              <a:gd name="adj" fmla="val 18000"/>
+            </a:avLst>
+          </a:prstGeom>
+          <a:solidFill>
+            <a:srgbClr val="E8892B"/>
+          </a:solidFill>
+          <a:ln>
+            <a:noFill/>
+          </a:ln>
+          <a:effectLst/>
+        </p:spPr>
+        <p:style>
+          <a:lnRef idx="1">
+            <a:schemeClr val="accent1"/>
+          </a:lnRef>
+          <a:fillRef idx="3">
+            <a:schemeClr val="accent1"/>
+          </a:fillRef>
+          <a:effectRef idx="2">
+            <a:schemeClr val="accent1"/>
+          </a:effectRef>
+          <a:fontRef idx="minor">
+            <a:schemeClr val="lt1"/>
+          </a:fontRef>
+        </p:style>
+        <p:txBody>
+          <a:bodyPr rtlCol="0" anchor="ctr"/>
+          <a:lstStyle/>
+          <a:p>
+            <a:pPr algn="ctr"/>
+          </a:p>
+        </p:txBody>
+      </p:sp>
+      <p:sp>
+        <p:nvSpPr>
+          <p:cNvPr id="117" name="TextBox 116"/>
+          <p:cNvSpPr txBox="1"/>
+          <p:nvPr/>
+        </p:nvSpPr>
+        <p:spPr>
+          <a:xfrm>
+            <a:off x="1993786" y="5285232"/>
+            <a:ext cx="1417711" cy="329184"/>
+          </a:xfrm>
+          <a:prstGeom prst="rect">
+            <a:avLst/>
+          </a:prstGeom>
+          <a:noFill/>
+        </p:spPr>
+        <p:txBody>
+          <a:bodyPr wrap="square" anchor="ctr" lIns="36576" rIns="36576" tIns="0" bIns="0">
+            <a:spAutoFit/>
+          </a:bodyPr>
+          <a:lstStyle/>
+          <a:p>
+            <a:pPr algn="ctr" rtl="1"/>
+            <a:r>
+              <a:rPr sz="1100" b="1">
+                <a:solidFill>
+                  <a:srgbClr val="FFFFFF"/>
+                </a:solidFill>
+                <a:latin typeface="Heebo"/>
+                <a:cs typeface="Heebo"/>
+              </a:rPr>
+              <a:t>משה הלר</a:t>
+            </a:r>
+          </a:p>
+        </p:txBody>
+      </p:sp>
       <p:cxnSp>
         <p:nvCxnSpPr>
-          <p:cNvPr id="92" name="Connector 91"/>
+          <p:cNvPr id="118" name="Connector 117"/>
           <p:cNvCxnSpPr/>
           <p:nvPr/>
         </p:nvCxnSpPr>
@@ -11898,14 +14485,14 @@
       </p:cxnSp>
       <p:cxnSp>
         <p:nvCxnSpPr>
-          <p:cNvPr id="93" name="Connector 92"/>
+          <p:cNvPr id="119" name="Connector 118"/>
           <p:cNvCxnSpPr/>
           <p:nvPr/>
         </p:nvCxnSpPr>
         <p:spPr>
           <a:xfrm>
-            <a:off x="3352647" y="2770632"/>
-            <a:ext cx="4617720" cy="0"/>
+            <a:off x="1957210" y="2770632"/>
+            <a:ext cx="7504411" cy="0"/>
           </a:xfrm>
           <a:prstGeom prst="line">
             <a:avLst/>
@@ -11933,13 +14520,13 @@
       </p:cxnSp>
       <p:cxnSp>
         <p:nvCxnSpPr>
-          <p:cNvPr id="94" name="Connector 93"/>
+          <p:cNvPr id="120" name="Connector 119"/>
           <p:cNvCxnSpPr/>
           <p:nvPr/>
         </p:nvCxnSpPr>
         <p:spPr>
           <a:xfrm>
-            <a:off x="7970367" y="2770632"/>
+            <a:off x="9461621" y="2770632"/>
             <a:ext cx="0" cy="155448"/>
           </a:xfrm>
           <a:prstGeom prst="line">
@@ -11968,13 +14555,13 @@
       </p:cxnSp>
       <p:cxnSp>
         <p:nvCxnSpPr>
-          <p:cNvPr id="95" name="Connector 94"/>
+          <p:cNvPr id="121" name="Connector 120"/>
           <p:cNvCxnSpPr/>
           <p:nvPr/>
         </p:nvCxnSpPr>
         <p:spPr>
           <a:xfrm>
-            <a:off x="3352647" y="2770632"/>
+            <a:off x="5322984" y="2770632"/>
             <a:ext cx="0" cy="155448"/>
           </a:xfrm>
           <a:prstGeom prst="line">
@@ -12001,9 +14588,44 @@
           </a:fontRef>
         </p:style>
       </p:cxnSp>
-      <p:sp>
-        <p:nvSpPr>
-          <p:cNvPr id="96" name="Oval 95"/>
+      <p:cxnSp>
+        <p:nvCxnSpPr>
+          <p:cNvPr id="122" name="Connector 121"/>
+          <p:cNvCxnSpPr/>
+          <p:nvPr/>
+        </p:nvCxnSpPr>
+        <p:spPr>
+          <a:xfrm>
+            <a:off x="1957210" y="2770632"/>
+            <a:ext cx="0" cy="155448"/>
+          </a:xfrm>
+          <a:prstGeom prst="line">
+            <a:avLst/>
+          </a:prstGeom>
+          <a:ln w="19050">
+            <a:solidFill>
+              <a:srgbClr val="C5CDDD"/>
+            </a:solidFill>
+          </a:ln>
+        </p:spPr>
+        <p:style>
+          <a:lnRef idx="2">
+            <a:schemeClr val="accent1"/>
+          </a:lnRef>
+          <a:fillRef idx="0">
+            <a:schemeClr val="accent1"/>
+          </a:fillRef>
+          <a:effectRef idx="1">
+            <a:schemeClr val="accent1"/>
+          </a:effectRef>
+          <a:fontRef idx="minor">
+            <a:schemeClr val="tx1"/>
+          </a:fontRef>
+        </p:style>
+      </p:cxnSp>
+      <p:sp>
+        <p:nvSpPr>
+          <p:cNvPr id="123" name="Oval 122"/>
           <p:cNvSpPr/>
           <p:nvPr/>
         </p:nvSpPr>
@@ -12047,7 +14669,7 @@
       </p:sp>
       <p:sp>
         <p:nvSpPr>
-          <p:cNvPr id="97" name="TextBox 96"/>
+          <p:cNvPr id="124" name="TextBox 123"/>
           <p:cNvSpPr txBox="1"/>
           <p:nvPr/>
         </p:nvSpPr>
@@ -12083,7 +14705,7 @@
       </p:sp>
       <p:sp>
         <p:nvSpPr>
-          <p:cNvPr id="98" name="Oval 97"/>
+          <p:cNvPr id="125" name="Oval 124"/>
           <p:cNvSpPr/>
           <p:nvPr/>
         </p:nvSpPr>
@@ -12127,7 +14749,7 @@
       </p:sp>
       <p:sp>
         <p:nvSpPr>
-          <p:cNvPr id="99" name="TextBox 98"/>
+          <p:cNvPr id="126" name="TextBox 125"/>
           <p:cNvSpPr txBox="1"/>
           <p:nvPr/>
         </p:nvSpPr>
@@ -12163,7 +14785,7 @@
       </p:sp>
       <p:sp>
         <p:nvSpPr>
-          <p:cNvPr id="100" name="Oval 99"/>
+          <p:cNvPr id="127" name="Oval 126"/>
           <p:cNvSpPr/>
           <p:nvPr/>
         </p:nvSpPr>
@@ -12207,7 +14829,7 @@
       </p:sp>
       <p:sp>
         <p:nvSpPr>
-          <p:cNvPr id="101" name="TextBox 100"/>
+          <p:cNvPr id="128" name="TextBox 127"/>
           <p:cNvSpPr txBox="1"/>
           <p:nvPr/>
         </p:nvSpPr>
@@ -12243,7 +14865,7 @@
       </p:sp>
       <p:sp>
         <p:nvSpPr>
-          <p:cNvPr id="102" name="Oval 101"/>
+          <p:cNvPr id="129" name="Oval 128"/>
           <p:cNvSpPr/>
           <p:nvPr/>
         </p:nvSpPr>
@@ -12287,7 +14909,7 @@
       </p:sp>
       <p:sp>
         <p:nvSpPr>
-          <p:cNvPr id="103" name="TextBox 102"/>
+          <p:cNvPr id="130" name="TextBox 129"/>
           <p:cNvSpPr txBox="1"/>
           <p:nvPr/>
         </p:nvSpPr>

</xml_diff>

<commit_message>
Set one-third low availability in every team
Co-Authored-By: Claude Opus 5.5 <noreply@anthropic.com>
Claude-Session: https://claude.ai/code/session_01W7Er83FuNT4pLFShWidYHn
</commit_message>
<xml_diff>
--- a/presentation/out/koach-hitarvut.pptx
+++ b/presentation/out/koach-hitarvut.pptx
@@ -13091,7 +13091,7 @@
             </a:avLst>
           </a:prstGeom>
           <a:solidFill>
-            <a:srgbClr val="E8892B"/>
+            <a:srgbClr val="D64545"/>
           </a:solidFill>
           <a:ln>
             <a:noFill/>
@@ -13255,7 +13255,7 @@
             </a:avLst>
           </a:prstGeom>
           <a:solidFill>
-            <a:srgbClr val="E8892B"/>
+            <a:srgbClr val="D64545"/>
           </a:solidFill>
           <a:ln>
             <a:noFill/>
@@ -14137,7 +14137,7 @@
             </a:avLst>
           </a:prstGeom>
           <a:solidFill>
-            <a:srgbClr val="E8892B"/>
+            <a:srgbClr val="D64545"/>
           </a:solidFill>
           <a:ln>
             <a:noFill/>
@@ -14219,7 +14219,7 @@
             </a:avLst>
           </a:prstGeom>
           <a:solidFill>
-            <a:srgbClr val="E8892B"/>
+            <a:srgbClr val="D64545"/>
           </a:solidFill>
           <a:ln>
             <a:noFill/>
@@ -14301,7 +14301,7 @@
             </a:avLst>
           </a:prstGeom>
           <a:solidFill>
-            <a:srgbClr val="E8892B"/>
+            <a:srgbClr val="D64545"/>
           </a:solidFill>
           <a:ln>
             <a:noFill/>

</xml_diff>

<commit_message>
Fill in board of directors with roles and availability
Co-Authored-By: Claude Opus 5.5 <noreply@anthropic.com>
Claude-Session: https://claude.ai/code/session_01W7Er83FuNT4pLFShWidYHn
</commit_message>
<xml_diff>
--- a/presentation/out/koach-hitarvut.pptx
+++ b/presentation/out/koach-hitarvut.pptx
@@ -3486,7 +3486,7 @@
                 <a:latin typeface="Heebo"/>
                 <a:cs typeface="Heebo"/>
               </a:rPr>
-              <a:t>אודליה קדמי</a:t>
+              <a:t>תמיר דורטל</a:t>
             </a:r>
           </a:p>
         </p:txBody>
@@ -3500,6 +3500,170 @@
         <p:spPr>
           <a:xfrm>
             <a:off x="10250163" y="1630375"/>
+            <a:ext cx="1530052" cy="241401"/>
+          </a:xfrm>
+          <a:prstGeom prst="rect">
+            <a:avLst/>
+          </a:prstGeom>
+          <a:noFill/>
+        </p:spPr>
+        <p:txBody>
+          <a:bodyPr wrap="square" anchor="t" lIns="36576" rIns="36576" tIns="0" bIns="0">
+            <a:spAutoFit/>
+          </a:bodyPr>
+          <a:lstStyle/>
+          <a:p>
+            <a:pPr algn="ctr" rtl="1"/>
+            <a:r>
+              <a:rPr sz="900" b="0">
+                <a:solidFill>
+                  <a:srgbClr val="8A94A8"/>
+                </a:solidFill>
+                <a:latin typeface="Heebo"/>
+                <a:cs typeface="Heebo"/>
+              </a:rPr>
+              <a:t>מייסד · ראש תחום כלכלה</a:t>
+            </a:r>
+          </a:p>
+        </p:txBody>
+      </p:sp>
+      <p:sp>
+        <p:nvSpPr>
+          <p:cNvPr id="13" name="Rounded Rectangle 12"/>
+          <p:cNvSpPr/>
+          <p:nvPr/>
+        </p:nvSpPr>
+        <p:spPr>
+          <a:xfrm>
+            <a:off x="8610383" y="1298448"/>
+            <a:ext cx="1530052" cy="603504"/>
+          </a:xfrm>
+          <a:prstGeom prst="roundRect">
+            <a:avLst>
+              <a:gd name="adj" fmla="val 18000"/>
+            </a:avLst>
+          </a:prstGeom>
+          <a:solidFill>
+            <a:srgbClr val="FFFFFF"/>
+          </a:solidFill>
+          <a:ln w="15875">
+            <a:solidFill>
+              <a:srgbClr val="C5CDDD"/>
+            </a:solidFill>
+          </a:ln>
+          <a:effectLst/>
+        </p:spPr>
+        <p:style>
+          <a:lnRef idx="1">
+            <a:schemeClr val="accent1"/>
+          </a:lnRef>
+          <a:fillRef idx="3">
+            <a:schemeClr val="accent1"/>
+          </a:fillRef>
+          <a:effectRef idx="2">
+            <a:schemeClr val="accent1"/>
+          </a:effectRef>
+          <a:fontRef idx="minor">
+            <a:schemeClr val="lt1"/>
+          </a:fontRef>
+        </p:style>
+        <p:txBody>
+          <a:bodyPr rtlCol="0" anchor="ctr"/>
+          <a:lstStyle/>
+          <a:p>
+            <a:pPr algn="ctr"/>
+          </a:p>
+        </p:txBody>
+      </p:sp>
+      <p:sp>
+        <p:nvSpPr>
+          <p:cNvPr id="14" name="Rectangle 13"/>
+          <p:cNvSpPr/>
+          <p:nvPr/>
+        </p:nvSpPr>
+        <p:spPr>
+          <a:xfrm>
+            <a:off x="10076427" y="1371600"/>
+            <a:ext cx="45720" cy="457200"/>
+          </a:xfrm>
+          <a:prstGeom prst="rect">
+            <a:avLst/>
+          </a:prstGeom>
+          <a:solidFill>
+            <a:srgbClr val="F0C000"/>
+          </a:solidFill>
+          <a:ln>
+            <a:noFill/>
+          </a:ln>
+          <a:effectLst/>
+        </p:spPr>
+        <p:style>
+          <a:lnRef idx="1">
+            <a:schemeClr val="accent1"/>
+          </a:lnRef>
+          <a:fillRef idx="3">
+            <a:schemeClr val="accent1"/>
+          </a:fillRef>
+          <a:effectRef idx="2">
+            <a:schemeClr val="accent1"/>
+          </a:effectRef>
+          <a:fontRef idx="minor">
+            <a:schemeClr val="lt1"/>
+          </a:fontRef>
+        </p:style>
+        <p:txBody>
+          <a:bodyPr rtlCol="0" anchor="ctr"/>
+          <a:lstStyle/>
+          <a:p>
+            <a:pPr algn="ctr"/>
+          </a:p>
+        </p:txBody>
+      </p:sp>
+      <p:sp>
+        <p:nvSpPr>
+          <p:cNvPr id="15" name="TextBox 14"/>
+          <p:cNvSpPr txBox="1"/>
+          <p:nvPr/>
+        </p:nvSpPr>
+        <p:spPr>
+          <a:xfrm>
+            <a:off x="8610383" y="1353312"/>
+            <a:ext cx="1530052" cy="313822"/>
+          </a:xfrm>
+          <a:prstGeom prst="rect">
+            <a:avLst/>
+          </a:prstGeom>
+          <a:noFill/>
+        </p:spPr>
+        <p:txBody>
+          <a:bodyPr wrap="square" anchor="b" lIns="36576" rIns="36576" tIns="0" bIns="0">
+            <a:spAutoFit/>
+          </a:bodyPr>
+          <a:lstStyle/>
+          <a:p>
+            <a:pPr algn="ctr" rtl="1"/>
+            <a:r>
+              <a:rPr sz="1200" b="1">
+                <a:solidFill>
+                  <a:srgbClr val="1A2233"/>
+                </a:solidFill>
+                <a:latin typeface="Heebo"/>
+                <a:cs typeface="Heebo"/>
+              </a:rPr>
+              <a:t>עו״ד אודליה קדמי</a:t>
+            </a:r>
+          </a:p>
+        </p:txBody>
+      </p:sp>
+      <p:sp>
+        <p:nvSpPr>
+          <p:cNvPr id="16" name="TextBox 15"/>
+          <p:cNvSpPr txBox="1"/>
+          <p:nvPr/>
+        </p:nvSpPr>
+        <p:spPr>
+          <a:xfrm>
+            <a:off x="8610383" y="1630375"/>
             <a:ext cx="1530052" cy="241401"/>
           </a:xfrm>
           <a:prstGeom prst="rect">
@@ -3529,13 +3693,13 @@
       </p:sp>
       <p:sp>
         <p:nvSpPr>
-          <p:cNvPr id="13" name="Rounded Rectangle 12"/>
+          <p:cNvPr id="17" name="Rounded Rectangle 16"/>
           <p:cNvSpPr/>
           <p:nvPr/>
         </p:nvSpPr>
         <p:spPr>
           <a:xfrm>
-            <a:off x="8610383" y="1298448"/>
+            <a:off x="6970603" y="1298448"/>
             <a:ext cx="1530052" cy="603504"/>
           </a:xfrm>
           <a:prstGeom prst="roundRect">
@@ -3544,13 +3708,12 @@
             </a:avLst>
           </a:prstGeom>
           <a:solidFill>
-            <a:srgbClr val="F4F6FB"/>
+            <a:srgbClr val="FFFFFF"/>
           </a:solidFill>
           <a:ln w="15875">
             <a:solidFill>
-              <a:srgbClr val="8A94A8"/>
+              <a:srgbClr val="C5CDDD"/>
             </a:solidFill>
-            <a:prstDash val="dash"/>
           </a:ln>
           <a:effectLst/>
         </p:spPr>
@@ -3578,13 +3741,57 @@
       </p:sp>
       <p:sp>
         <p:nvSpPr>
-          <p:cNvPr id="14" name="TextBox 13"/>
+          <p:cNvPr id="18" name="Rectangle 17"/>
+          <p:cNvSpPr/>
+          <p:nvPr/>
+        </p:nvSpPr>
+        <p:spPr>
+          <a:xfrm>
+            <a:off x="8436647" y="1371600"/>
+            <a:ext cx="45720" cy="457200"/>
+          </a:xfrm>
+          <a:prstGeom prst="rect">
+            <a:avLst/>
+          </a:prstGeom>
+          <a:solidFill>
+            <a:srgbClr val="F0C000"/>
+          </a:solidFill>
+          <a:ln>
+            <a:noFill/>
+          </a:ln>
+          <a:effectLst/>
+        </p:spPr>
+        <p:style>
+          <a:lnRef idx="1">
+            <a:schemeClr val="accent1"/>
+          </a:lnRef>
+          <a:fillRef idx="3">
+            <a:schemeClr val="accent1"/>
+          </a:fillRef>
+          <a:effectRef idx="2">
+            <a:schemeClr val="accent1"/>
+          </a:effectRef>
+          <a:fontRef idx="minor">
+            <a:schemeClr val="lt1"/>
+          </a:fontRef>
+        </p:style>
+        <p:txBody>
+          <a:bodyPr rtlCol="0" anchor="ctr"/>
+          <a:lstStyle/>
+          <a:p>
+            <a:pPr algn="ctr"/>
+          </a:p>
+        </p:txBody>
+      </p:sp>
+      <p:sp>
+        <p:nvSpPr>
+          <p:cNvPr id="19" name="TextBox 18"/>
           <p:cNvSpPr txBox="1"/>
           <p:nvPr/>
         </p:nvSpPr>
         <p:spPr>
           <a:xfrm>
-            <a:off x="8610383" y="1353312"/>
+            <a:off x="6970603" y="1353312"/>
             <a:ext cx="1530052" cy="313822"/>
           </a:xfrm>
           <a:prstGeom prst="rect">
@@ -3602,25 +3809,25 @@
             <a:r>
               <a:rPr sz="1200" b="1">
                 <a:solidFill>
-                  <a:srgbClr val="8A94A8"/>
+                  <a:srgbClr val="1A2233"/>
                 </a:solidFill>
                 <a:latin typeface="Heebo"/>
                 <a:cs typeface="Heebo"/>
               </a:rPr>
-              <a:t>שם יעודכן</a:t>
-            </a:r>
-          </a:p>
-        </p:txBody>
-      </p:sp>
-      <p:sp>
-        <p:nvSpPr>
-          <p:cNvPr id="15" name="TextBox 14"/>
+              <a:t>ד״ר אמיר רובין</a:t>
+            </a:r>
+          </a:p>
+        </p:txBody>
+      </p:sp>
+      <p:sp>
+        <p:nvSpPr>
+          <p:cNvPr id="20" name="TextBox 19"/>
           <p:cNvSpPr txBox="1"/>
           <p:nvPr/>
         </p:nvSpPr>
         <p:spPr>
           <a:xfrm>
-            <a:off x="8610383" y="1630375"/>
+            <a:off x="6970603" y="1630375"/>
             <a:ext cx="1530052" cy="241401"/>
           </a:xfrm>
           <a:prstGeom prst="rect">
@@ -3643,20 +3850,20 @@
                 <a:latin typeface="Heebo"/>
                 <a:cs typeface="Heebo"/>
               </a:rPr>
-              <a:t>ראש תחום חינוך וזהות</a:t>
-            </a:r>
-          </a:p>
-        </p:txBody>
-      </p:sp>
-      <p:sp>
-        <p:nvSpPr>
-          <p:cNvPr id="16" name="Rounded Rectangle 15"/>
+              <a:t>ראש תחום רפואה</a:t>
+            </a:r>
+          </a:p>
+        </p:txBody>
+      </p:sp>
+      <p:sp>
+        <p:nvSpPr>
+          <p:cNvPr id="21" name="Rounded Rectangle 20"/>
           <p:cNvSpPr/>
           <p:nvPr/>
         </p:nvSpPr>
         <p:spPr>
           <a:xfrm>
-            <a:off x="6970603" y="1298448"/>
+            <a:off x="5330823" y="1298448"/>
             <a:ext cx="1530052" cy="603504"/>
           </a:xfrm>
           <a:prstGeom prst="roundRect">
@@ -3665,13 +3872,12 @@
             </a:avLst>
           </a:prstGeom>
           <a:solidFill>
-            <a:srgbClr val="F4F6FB"/>
+            <a:srgbClr val="FFFFFF"/>
           </a:solidFill>
           <a:ln w="15875">
             <a:solidFill>
-              <a:srgbClr val="8A94A8"/>
+              <a:srgbClr val="C5CDDD"/>
             </a:solidFill>
-            <a:prstDash val="dash"/>
           </a:ln>
           <a:effectLst/>
         </p:spPr>
@@ -3699,13 +3905,57 @@
       </p:sp>
       <p:sp>
         <p:nvSpPr>
-          <p:cNvPr id="17" name="TextBox 16"/>
+          <p:cNvPr id="22" name="Rectangle 21"/>
+          <p:cNvSpPr/>
+          <p:nvPr/>
+        </p:nvSpPr>
+        <p:spPr>
+          <a:xfrm>
+            <a:off x="6796867" y="1371600"/>
+            <a:ext cx="45720" cy="457200"/>
+          </a:xfrm>
+          <a:prstGeom prst="rect">
+            <a:avLst/>
+          </a:prstGeom>
+          <a:solidFill>
+            <a:srgbClr val="F0C000"/>
+          </a:solidFill>
+          <a:ln>
+            <a:noFill/>
+          </a:ln>
+          <a:effectLst/>
+        </p:spPr>
+        <p:style>
+          <a:lnRef idx="1">
+            <a:schemeClr val="accent1"/>
+          </a:lnRef>
+          <a:fillRef idx="3">
+            <a:schemeClr val="accent1"/>
+          </a:fillRef>
+          <a:effectRef idx="2">
+            <a:schemeClr val="accent1"/>
+          </a:effectRef>
+          <a:fontRef idx="minor">
+            <a:schemeClr val="lt1"/>
+          </a:fontRef>
+        </p:style>
+        <p:txBody>
+          <a:bodyPr rtlCol="0" anchor="ctr"/>
+          <a:lstStyle/>
+          <a:p>
+            <a:pPr algn="ctr"/>
+          </a:p>
+        </p:txBody>
+      </p:sp>
+      <p:sp>
+        <p:nvSpPr>
+          <p:cNvPr id="23" name="TextBox 22"/>
           <p:cNvSpPr txBox="1"/>
           <p:nvPr/>
         </p:nvSpPr>
         <p:spPr>
           <a:xfrm>
-            <a:off x="6970603" y="1353312"/>
+            <a:off x="5330823" y="1353312"/>
             <a:ext cx="1530052" cy="313822"/>
           </a:xfrm>
           <a:prstGeom prst="rect">
@@ -3723,25 +3973,25 @@
             <a:r>
               <a:rPr sz="1200" b="1">
                 <a:solidFill>
-                  <a:srgbClr val="8A94A8"/>
+                  <a:srgbClr val="1A2233"/>
                 </a:solidFill>
                 <a:latin typeface="Heebo"/>
                 <a:cs typeface="Heebo"/>
               </a:rPr>
-              <a:t>שם יעודכן</a:t>
-            </a:r>
-          </a:p>
-        </p:txBody>
-      </p:sp>
-      <p:sp>
-        <p:nvSpPr>
-          <p:cNvPr id="18" name="TextBox 17"/>
+              <a:t>נגה ארבל</a:t>
+            </a:r>
+          </a:p>
+        </p:txBody>
+      </p:sp>
+      <p:sp>
+        <p:nvSpPr>
+          <p:cNvPr id="24" name="TextBox 23"/>
           <p:cNvSpPr txBox="1"/>
           <p:nvPr/>
         </p:nvSpPr>
         <p:spPr>
           <a:xfrm>
-            <a:off x="6970603" y="1630375"/>
+            <a:off x="5330823" y="1630375"/>
             <a:ext cx="1530052" cy="241401"/>
           </a:xfrm>
           <a:prstGeom prst="rect">
@@ -3764,20 +4014,20 @@
                 <a:latin typeface="Heebo"/>
                 <a:cs typeface="Heebo"/>
               </a:rPr>
-              <a:t>ראש תחום התיישבות</a:t>
-            </a:r>
-          </a:p>
-        </p:txBody>
-      </p:sp>
-      <p:sp>
-        <p:nvSpPr>
-          <p:cNvPr id="19" name="Rounded Rectangle 18"/>
+              <a:t>ראש תחום חקיקה</a:t>
+            </a:r>
+          </a:p>
+        </p:txBody>
+      </p:sp>
+      <p:sp>
+        <p:nvSpPr>
+          <p:cNvPr id="25" name="Rounded Rectangle 24"/>
           <p:cNvSpPr/>
           <p:nvPr/>
         </p:nvSpPr>
         <p:spPr>
           <a:xfrm>
-            <a:off x="5330823" y="1298448"/>
+            <a:off x="3691043" y="1298448"/>
             <a:ext cx="1530052" cy="603504"/>
           </a:xfrm>
           <a:prstGeom prst="roundRect">
@@ -3786,13 +4036,12 @@
             </a:avLst>
           </a:prstGeom>
           <a:solidFill>
-            <a:srgbClr val="F4F6FB"/>
+            <a:srgbClr val="FFFFFF"/>
           </a:solidFill>
           <a:ln w="15875">
             <a:solidFill>
-              <a:srgbClr val="8A94A8"/>
+              <a:srgbClr val="C5CDDD"/>
             </a:solidFill>
-            <a:prstDash val="dash"/>
           </a:ln>
           <a:effectLst/>
         </p:spPr>
@@ -3820,13 +4069,57 @@
       </p:sp>
       <p:sp>
         <p:nvSpPr>
-          <p:cNvPr id="20" name="TextBox 19"/>
+          <p:cNvPr id="26" name="Rectangle 25"/>
+          <p:cNvSpPr/>
+          <p:nvPr/>
+        </p:nvSpPr>
+        <p:spPr>
+          <a:xfrm>
+            <a:off x="5157087" y="1371600"/>
+            <a:ext cx="45720" cy="457200"/>
+          </a:xfrm>
+          <a:prstGeom prst="rect">
+            <a:avLst/>
+          </a:prstGeom>
+          <a:solidFill>
+            <a:srgbClr val="F0C000"/>
+          </a:solidFill>
+          <a:ln>
+            <a:noFill/>
+          </a:ln>
+          <a:effectLst/>
+        </p:spPr>
+        <p:style>
+          <a:lnRef idx="1">
+            <a:schemeClr val="accent1"/>
+          </a:lnRef>
+          <a:fillRef idx="3">
+            <a:schemeClr val="accent1"/>
+          </a:fillRef>
+          <a:effectRef idx="2">
+            <a:schemeClr val="accent1"/>
+          </a:effectRef>
+          <a:fontRef idx="minor">
+            <a:schemeClr val="lt1"/>
+          </a:fontRef>
+        </p:style>
+        <p:txBody>
+          <a:bodyPr rtlCol="0" anchor="ctr"/>
+          <a:lstStyle/>
+          <a:p>
+            <a:pPr algn="ctr"/>
+          </a:p>
+        </p:txBody>
+      </p:sp>
+      <p:sp>
+        <p:nvSpPr>
+          <p:cNvPr id="27" name="TextBox 26"/>
           <p:cNvSpPr txBox="1"/>
           <p:nvPr/>
         </p:nvSpPr>
         <p:spPr>
           <a:xfrm>
-            <a:off x="5330823" y="1353312"/>
+            <a:off x="3691043" y="1353312"/>
             <a:ext cx="1530052" cy="313822"/>
           </a:xfrm>
           <a:prstGeom prst="rect">
@@ -3844,25 +4137,25 @@
             <a:r>
               <a:rPr sz="1200" b="1">
                 <a:solidFill>
-                  <a:srgbClr val="8A94A8"/>
+                  <a:srgbClr val="1A2233"/>
                 </a:solidFill>
                 <a:latin typeface="Heebo"/>
                 <a:cs typeface="Heebo"/>
               </a:rPr>
-              <a:t>שם יעודכן</a:t>
-            </a:r>
-          </a:p>
-        </p:txBody>
-      </p:sp>
-      <p:sp>
-        <p:nvSpPr>
-          <p:cNvPr id="21" name="TextBox 20"/>
+              <a:t>טל קופל</a:t>
+            </a:r>
+          </a:p>
+        </p:txBody>
+      </p:sp>
+      <p:sp>
+        <p:nvSpPr>
+          <p:cNvPr id="28" name="TextBox 27"/>
           <p:cNvSpPr txBox="1"/>
           <p:nvPr/>
         </p:nvSpPr>
         <p:spPr>
           <a:xfrm>
-            <a:off x="5330823" y="1630375"/>
+            <a:off x="3691043" y="1630375"/>
             <a:ext cx="1530052" cy="241401"/>
           </a:xfrm>
           <a:prstGeom prst="rect">
@@ -3885,20 +4178,20 @@
                 <a:latin typeface="Heebo"/>
                 <a:cs typeface="Heebo"/>
               </a:rPr>
-              <a:t>ראש תחום משפט וחוקה</a:t>
-            </a:r>
-          </a:p>
-        </p:txBody>
-      </p:sp>
-      <p:sp>
-        <p:nvSpPr>
-          <p:cNvPr id="22" name="Rounded Rectangle 21"/>
+              <a:t>ראש תחום חינוך ואתיקה</a:t>
+            </a:r>
+          </a:p>
+        </p:txBody>
+      </p:sp>
+      <p:sp>
+        <p:nvSpPr>
+          <p:cNvPr id="29" name="Rounded Rectangle 28"/>
           <p:cNvSpPr/>
           <p:nvPr/>
         </p:nvSpPr>
         <p:spPr>
           <a:xfrm>
-            <a:off x="3691043" y="1298448"/>
+            <a:off x="2051263" y="1298448"/>
             <a:ext cx="1530052" cy="603504"/>
           </a:xfrm>
           <a:prstGeom prst="roundRect">
@@ -3907,13 +4200,12 @@
             </a:avLst>
           </a:prstGeom>
           <a:solidFill>
-            <a:srgbClr val="F4F6FB"/>
+            <a:srgbClr val="FFFFFF"/>
           </a:solidFill>
           <a:ln w="15875">
             <a:solidFill>
-              <a:srgbClr val="8A94A8"/>
+              <a:srgbClr val="C5CDDD"/>
             </a:solidFill>
-            <a:prstDash val="dash"/>
           </a:ln>
           <a:effectLst/>
         </p:spPr>
@@ -3941,13 +4233,57 @@
       </p:sp>
       <p:sp>
         <p:nvSpPr>
-          <p:cNvPr id="23" name="TextBox 22"/>
+          <p:cNvPr id="30" name="Rectangle 29"/>
+          <p:cNvSpPr/>
+          <p:nvPr/>
+        </p:nvSpPr>
+        <p:spPr>
+          <a:xfrm>
+            <a:off x="3517307" y="1371600"/>
+            <a:ext cx="45720" cy="457200"/>
+          </a:xfrm>
+          <a:prstGeom prst="rect">
+            <a:avLst/>
+          </a:prstGeom>
+          <a:solidFill>
+            <a:srgbClr val="F0C000"/>
+          </a:solidFill>
+          <a:ln>
+            <a:noFill/>
+          </a:ln>
+          <a:effectLst/>
+        </p:spPr>
+        <p:style>
+          <a:lnRef idx="1">
+            <a:schemeClr val="accent1"/>
+          </a:lnRef>
+          <a:fillRef idx="3">
+            <a:schemeClr val="accent1"/>
+          </a:fillRef>
+          <a:effectRef idx="2">
+            <a:schemeClr val="accent1"/>
+          </a:effectRef>
+          <a:fontRef idx="minor">
+            <a:schemeClr val="lt1"/>
+          </a:fontRef>
+        </p:style>
+        <p:txBody>
+          <a:bodyPr rtlCol="0" anchor="ctr"/>
+          <a:lstStyle/>
+          <a:p>
+            <a:pPr algn="ctr"/>
+          </a:p>
+        </p:txBody>
+      </p:sp>
+      <p:sp>
+        <p:nvSpPr>
+          <p:cNvPr id="31" name="TextBox 30"/>
           <p:cNvSpPr txBox="1"/>
           <p:nvPr/>
         </p:nvSpPr>
         <p:spPr>
           <a:xfrm>
-            <a:off x="3691043" y="1353312"/>
+            <a:off x="2051263" y="1353312"/>
             <a:ext cx="1530052" cy="313822"/>
           </a:xfrm>
           <a:prstGeom prst="rect">
@@ -3965,25 +4301,25 @@
             <a:r>
               <a:rPr sz="1200" b="1">
                 <a:solidFill>
-                  <a:srgbClr val="8A94A8"/>
+                  <a:srgbClr val="1A2233"/>
                 </a:solidFill>
                 <a:latin typeface="Heebo"/>
                 <a:cs typeface="Heebo"/>
               </a:rPr>
-              <a:t>שם יעודכן</a:t>
-            </a:r>
-          </a:p>
-        </p:txBody>
-      </p:sp>
-      <p:sp>
-        <p:nvSpPr>
-          <p:cNvPr id="24" name="TextBox 23"/>
+              <a:t>עו״ד תמר ארבל</a:t>
+            </a:r>
+          </a:p>
+        </p:txBody>
+      </p:sp>
+      <p:sp>
+        <p:nvSpPr>
+          <p:cNvPr id="32" name="TextBox 31"/>
           <p:cNvSpPr txBox="1"/>
           <p:nvPr/>
         </p:nvSpPr>
         <p:spPr>
           <a:xfrm>
-            <a:off x="3691043" y="1630375"/>
+            <a:off x="2051263" y="1630375"/>
             <a:ext cx="1530052" cy="241401"/>
           </a:xfrm>
           <a:prstGeom prst="rect">
@@ -4006,20 +4342,20 @@
                 <a:latin typeface="Heebo"/>
                 <a:cs typeface="Heebo"/>
               </a:rPr>
-              <a:t>ראש תחום כלכלה ויוקר מחיה</a:t>
-            </a:r>
-          </a:p>
-        </p:txBody>
-      </p:sp>
-      <p:sp>
-        <p:nvSpPr>
-          <p:cNvPr id="25" name="Rounded Rectangle 24"/>
+              <a:t>ראש תחום משפט</a:t>
+            </a:r>
+          </a:p>
+        </p:txBody>
+      </p:sp>
+      <p:sp>
+        <p:nvSpPr>
+          <p:cNvPr id="33" name="Rounded Rectangle 32"/>
           <p:cNvSpPr/>
           <p:nvPr/>
         </p:nvSpPr>
         <p:spPr>
           <a:xfrm>
-            <a:off x="2051263" y="1298448"/>
+            <a:off x="411483" y="1298448"/>
             <a:ext cx="1530052" cy="603504"/>
           </a:xfrm>
           <a:prstGeom prst="roundRect">
@@ -4028,13 +4364,12 @@
             </a:avLst>
           </a:prstGeom>
           <a:solidFill>
-            <a:srgbClr val="F4F6FB"/>
+            <a:srgbClr val="FFFFFF"/>
           </a:solidFill>
           <a:ln w="15875">
             <a:solidFill>
-              <a:srgbClr val="8A94A8"/>
+              <a:srgbClr val="C5CDDD"/>
             </a:solidFill>
-            <a:prstDash val="dash"/>
           </a:ln>
           <a:effectLst/>
         </p:spPr>
@@ -4062,13 +4397,57 @@
       </p:sp>
       <p:sp>
         <p:nvSpPr>
-          <p:cNvPr id="26" name="TextBox 25"/>
+          <p:cNvPr id="34" name="Rectangle 33"/>
+          <p:cNvSpPr/>
+          <p:nvPr/>
+        </p:nvSpPr>
+        <p:spPr>
+          <a:xfrm>
+            <a:off x="1877527" y="1371600"/>
+            <a:ext cx="45720" cy="457200"/>
+          </a:xfrm>
+          <a:prstGeom prst="rect">
+            <a:avLst/>
+          </a:prstGeom>
+          <a:solidFill>
+            <a:srgbClr val="F0C000"/>
+          </a:solidFill>
+          <a:ln>
+            <a:noFill/>
+          </a:ln>
+          <a:effectLst/>
+        </p:spPr>
+        <p:style>
+          <a:lnRef idx="1">
+            <a:schemeClr val="accent1"/>
+          </a:lnRef>
+          <a:fillRef idx="3">
+            <a:schemeClr val="accent1"/>
+          </a:fillRef>
+          <a:effectRef idx="2">
+            <a:schemeClr val="accent1"/>
+          </a:effectRef>
+          <a:fontRef idx="minor">
+            <a:schemeClr val="lt1"/>
+          </a:fontRef>
+        </p:style>
+        <p:txBody>
+          <a:bodyPr rtlCol="0" anchor="ctr"/>
+          <a:lstStyle/>
+          <a:p>
+            <a:pPr algn="ctr"/>
+          </a:p>
+        </p:txBody>
+      </p:sp>
+      <p:sp>
+        <p:nvSpPr>
+          <p:cNvPr id="35" name="TextBox 34"/>
           <p:cNvSpPr txBox="1"/>
           <p:nvPr/>
         </p:nvSpPr>
         <p:spPr>
           <a:xfrm>
-            <a:off x="2051263" y="1353312"/>
+            <a:off x="411483" y="1353312"/>
             <a:ext cx="1530052" cy="313822"/>
           </a:xfrm>
           <a:prstGeom prst="rect">
@@ -4086,25 +4465,25 @@
             <a:r>
               <a:rPr sz="1200" b="1">
                 <a:solidFill>
-                  <a:srgbClr val="8A94A8"/>
+                  <a:srgbClr val="1A2233"/>
                 </a:solidFill>
                 <a:latin typeface="Heebo"/>
                 <a:cs typeface="Heebo"/>
               </a:rPr>
-              <a:t>שם יעודכן</a:t>
-            </a:r>
-          </a:p>
-        </p:txBody>
-      </p:sp>
-      <p:sp>
-        <p:nvSpPr>
-          <p:cNvPr id="27" name="TextBox 26"/>
+              <a:t>שלומית לביא</a:t>
+            </a:r>
+          </a:p>
+        </p:txBody>
+      </p:sp>
+      <p:sp>
+        <p:nvSpPr>
+          <p:cNvPr id="36" name="TextBox 35"/>
           <p:cNvSpPr txBox="1"/>
           <p:nvPr/>
         </p:nvSpPr>
         <p:spPr>
           <a:xfrm>
-            <a:off x="2051263" y="1630375"/>
+            <a:off x="411483" y="1630375"/>
             <a:ext cx="1530052" cy="241401"/>
           </a:xfrm>
           <a:prstGeom prst="rect">
@@ -4127,21 +4506,56 @@
                 <a:latin typeface="Heebo"/>
                 <a:cs typeface="Heebo"/>
               </a:rPr>
-              <a:t>ראש תחום עלייה וקליטה</a:t>
-            </a:r>
-          </a:p>
-        </p:txBody>
-      </p:sp>
-      <p:sp>
-        <p:nvSpPr>
-          <p:cNvPr id="28" name="Rounded Rectangle 27"/>
+              <a:t>ראש תחום רווחה</a:t>
+            </a:r>
+          </a:p>
+        </p:txBody>
+      </p:sp>
+      <p:cxnSp>
+        <p:nvCxnSpPr>
+          <p:cNvPr id="37" name="Connector 36"/>
+          <p:cNvCxnSpPr/>
+          <p:nvPr/>
+        </p:nvCxnSpPr>
+        <p:spPr>
+          <a:xfrm>
+            <a:off x="6095847" y="1901952"/>
+            <a:ext cx="0" cy="201168"/>
+          </a:xfrm>
+          <a:prstGeom prst="line">
+            <a:avLst/>
+          </a:prstGeom>
+          <a:ln w="19050">
+            <a:solidFill>
+              <a:srgbClr val="C5CDDD"/>
+            </a:solidFill>
+          </a:ln>
+        </p:spPr>
+        <p:style>
+          <a:lnRef idx="2">
+            <a:schemeClr val="accent1"/>
+          </a:lnRef>
+          <a:fillRef idx="0">
+            <a:schemeClr val="accent1"/>
+          </a:fillRef>
+          <a:effectRef idx="1">
+            <a:schemeClr val="accent1"/>
+          </a:effectRef>
+          <a:fontRef idx="minor">
+            <a:schemeClr val="tx1"/>
+          </a:fontRef>
+        </p:style>
+      </p:cxnSp>
+      <p:sp>
+        <p:nvSpPr>
+          <p:cNvPr id="38" name="Rounded Rectangle 37"/>
           <p:cNvSpPr/>
           <p:nvPr/>
         </p:nvSpPr>
         <p:spPr>
           <a:xfrm>
-            <a:off x="411483" y="1298448"/>
-            <a:ext cx="1530052" cy="603504"/>
+            <a:off x="4907127" y="2103120"/>
+            <a:ext cx="2377440" cy="512064"/>
           </a:xfrm>
           <a:prstGeom prst="roundRect">
             <a:avLst>
@@ -4149,162 +4563,6 @@
             </a:avLst>
           </a:prstGeom>
           <a:solidFill>
-            <a:srgbClr val="F4F6FB"/>
-          </a:solidFill>
-          <a:ln w="15875">
-            <a:solidFill>
-              <a:srgbClr val="8A94A8"/>
-            </a:solidFill>
-            <a:prstDash val="dash"/>
-          </a:ln>
-          <a:effectLst/>
-        </p:spPr>
-        <p:style>
-          <a:lnRef idx="1">
-            <a:schemeClr val="accent1"/>
-          </a:lnRef>
-          <a:fillRef idx="3">
-            <a:schemeClr val="accent1"/>
-          </a:fillRef>
-          <a:effectRef idx="2">
-            <a:schemeClr val="accent1"/>
-          </a:effectRef>
-          <a:fontRef idx="minor">
-            <a:schemeClr val="lt1"/>
-          </a:fontRef>
-        </p:style>
-        <p:txBody>
-          <a:bodyPr rtlCol="0" anchor="ctr"/>
-          <a:lstStyle/>
-          <a:p>
-            <a:pPr algn="ctr"/>
-          </a:p>
-        </p:txBody>
-      </p:sp>
-      <p:sp>
-        <p:nvSpPr>
-          <p:cNvPr id="29" name="TextBox 28"/>
-          <p:cNvSpPr txBox="1"/>
-          <p:nvPr/>
-        </p:nvSpPr>
-        <p:spPr>
-          <a:xfrm>
-            <a:off x="411483" y="1353312"/>
-            <a:ext cx="1530052" cy="313822"/>
-          </a:xfrm>
-          <a:prstGeom prst="rect">
-            <a:avLst/>
-          </a:prstGeom>
-          <a:noFill/>
-        </p:spPr>
-        <p:txBody>
-          <a:bodyPr wrap="square" anchor="b" lIns="36576" rIns="36576" tIns="0" bIns="0">
-            <a:spAutoFit/>
-          </a:bodyPr>
-          <a:lstStyle/>
-          <a:p>
-            <a:pPr algn="ctr" rtl="1"/>
-            <a:r>
-              <a:rPr sz="1200" b="1">
-                <a:solidFill>
-                  <a:srgbClr val="8A94A8"/>
-                </a:solidFill>
-                <a:latin typeface="Heebo"/>
-                <a:cs typeface="Heebo"/>
-              </a:rPr>
-              <a:t>שם יעודכן</a:t>
-            </a:r>
-          </a:p>
-        </p:txBody>
-      </p:sp>
-      <p:sp>
-        <p:nvSpPr>
-          <p:cNvPr id="30" name="TextBox 29"/>
-          <p:cNvSpPr txBox="1"/>
-          <p:nvPr/>
-        </p:nvSpPr>
-        <p:spPr>
-          <a:xfrm>
-            <a:off x="411483" y="1630375"/>
-            <a:ext cx="1530052" cy="241401"/>
-          </a:xfrm>
-          <a:prstGeom prst="rect">
-            <a:avLst/>
-          </a:prstGeom>
-          <a:noFill/>
-        </p:spPr>
-        <p:txBody>
-          <a:bodyPr wrap="square" anchor="t" lIns="36576" rIns="36576" tIns="0" bIns="0">
-            <a:spAutoFit/>
-          </a:bodyPr>
-          <a:lstStyle/>
-          <a:p>
-            <a:pPr algn="ctr" rtl="1"/>
-            <a:r>
-              <a:rPr sz="900" b="0">
-                <a:solidFill>
-                  <a:srgbClr val="8A94A8"/>
-                </a:solidFill>
-                <a:latin typeface="Heebo"/>
-                <a:cs typeface="Heebo"/>
-              </a:rPr>
-              <a:t>ראש תחום ביטחון לאומי</a:t>
-            </a:r>
-          </a:p>
-        </p:txBody>
-      </p:sp>
-      <p:cxnSp>
-        <p:nvCxnSpPr>
-          <p:cNvPr id="31" name="Connector 30"/>
-          <p:cNvCxnSpPr/>
-          <p:nvPr/>
-        </p:nvCxnSpPr>
-        <p:spPr>
-          <a:xfrm>
-            <a:off x="6095847" y="1901952"/>
-            <a:ext cx="0" cy="201168"/>
-          </a:xfrm>
-          <a:prstGeom prst="line">
-            <a:avLst/>
-          </a:prstGeom>
-          <a:ln w="19050">
-            <a:solidFill>
-              <a:srgbClr val="C5CDDD"/>
-            </a:solidFill>
-          </a:ln>
-        </p:spPr>
-        <p:style>
-          <a:lnRef idx="2">
-            <a:schemeClr val="accent1"/>
-          </a:lnRef>
-          <a:fillRef idx="0">
-            <a:schemeClr val="accent1"/>
-          </a:fillRef>
-          <a:effectRef idx="1">
-            <a:schemeClr val="accent1"/>
-          </a:effectRef>
-          <a:fontRef idx="minor">
-            <a:schemeClr val="tx1"/>
-          </a:fontRef>
-        </p:style>
-      </p:cxnSp>
-      <p:sp>
-        <p:nvSpPr>
-          <p:cNvPr id="32" name="Rounded Rectangle 31"/>
-          <p:cNvSpPr/>
-          <p:nvPr/>
-        </p:nvSpPr>
-        <p:spPr>
-          <a:xfrm>
-            <a:off x="4907127" y="2103120"/>
-            <a:ext cx="2377440" cy="512064"/>
-          </a:xfrm>
-          <a:prstGeom prst="roundRect">
-            <a:avLst>
-              <a:gd name="adj" fmla="val 18000"/>
-            </a:avLst>
-          </a:prstGeom>
-          <a:solidFill>
             <a:srgbClr val="FFFFFF"/>
           </a:solidFill>
           <a:ln w="15875">
@@ -4338,7 +4596,7 @@
       </p:sp>
       <p:sp>
         <p:nvSpPr>
-          <p:cNvPr id="33" name="Rectangle 32"/>
+          <p:cNvPr id="39" name="Rectangle 38"/>
           <p:cNvSpPr/>
           <p:nvPr/>
         </p:nvSpPr>
@@ -4382,7 +4640,7 @@
       </p:sp>
       <p:sp>
         <p:nvSpPr>
-          <p:cNvPr id="34" name="TextBox 33"/>
+          <p:cNvPr id="40" name="TextBox 39"/>
           <p:cNvSpPr txBox="1"/>
           <p:nvPr/>
         </p:nvSpPr>
@@ -4418,7 +4676,7 @@
       </p:sp>
       <p:sp>
         <p:nvSpPr>
-          <p:cNvPr id="35" name="TextBox 34"/>
+          <p:cNvPr id="41" name="TextBox 40"/>
           <p:cNvSpPr txBox="1"/>
           <p:nvPr/>
         </p:nvSpPr>
@@ -4454,7 +4712,7 @@
       </p:sp>
       <p:sp>
         <p:nvSpPr>
-          <p:cNvPr id="36" name="Rounded Rectangle 35"/>
+          <p:cNvPr id="42" name="Rounded Rectangle 41"/>
           <p:cNvSpPr/>
           <p:nvPr/>
         </p:nvSpPr>
@@ -4500,7 +4758,7 @@
       </p:sp>
       <p:sp>
         <p:nvSpPr>
-          <p:cNvPr id="37" name="Rounded Rectangle 36"/>
+          <p:cNvPr id="43" name="Rounded Rectangle 42"/>
           <p:cNvSpPr/>
           <p:nvPr/>
         </p:nvSpPr>
@@ -4548,7 +4806,7 @@
       </p:sp>
       <p:sp>
         <p:nvSpPr>
-          <p:cNvPr id="38" name="Rectangle 37"/>
+          <p:cNvPr id="44" name="Rectangle 43"/>
           <p:cNvSpPr/>
           <p:nvPr/>
         </p:nvSpPr>
@@ -4592,7 +4850,7 @@
       </p:sp>
       <p:sp>
         <p:nvSpPr>
-          <p:cNvPr id="39" name="TextBox 38"/>
+          <p:cNvPr id="45" name="TextBox 44"/>
           <p:cNvSpPr txBox="1"/>
           <p:nvPr/>
         </p:nvSpPr>
@@ -4628,7 +4886,7 @@
       </p:sp>
       <p:sp>
         <p:nvSpPr>
-          <p:cNvPr id="40" name="TextBox 39"/>
+          <p:cNvPr id="46" name="TextBox 45"/>
           <p:cNvSpPr txBox="1"/>
           <p:nvPr/>
         </p:nvSpPr>
@@ -4664,7 +4922,7 @@
       </p:sp>
       <p:sp>
         <p:nvSpPr>
-          <p:cNvPr id="41" name="Rounded Rectangle 40"/>
+          <p:cNvPr id="47" name="Rounded Rectangle 46"/>
           <p:cNvSpPr/>
           <p:nvPr/>
         </p:nvSpPr>
@@ -4712,7 +4970,7 @@
       </p:sp>
       <p:sp>
         <p:nvSpPr>
-          <p:cNvPr id="42" name="Rectangle 41"/>
+          <p:cNvPr id="48" name="Rectangle 47"/>
           <p:cNvSpPr/>
           <p:nvPr/>
         </p:nvSpPr>
@@ -4756,7 +5014,7 @@
       </p:sp>
       <p:sp>
         <p:nvSpPr>
-          <p:cNvPr id="43" name="TextBox 42"/>
+          <p:cNvPr id="49" name="TextBox 48"/>
           <p:cNvSpPr txBox="1"/>
           <p:nvPr/>
         </p:nvSpPr>
@@ -4792,7 +5050,7 @@
       </p:sp>
       <p:sp>
         <p:nvSpPr>
-          <p:cNvPr id="44" name="Rounded Rectangle 43"/>
+          <p:cNvPr id="50" name="Rounded Rectangle 49"/>
           <p:cNvSpPr/>
           <p:nvPr/>
         </p:nvSpPr>
@@ -4840,7 +5098,7 @@
       </p:sp>
       <p:sp>
         <p:nvSpPr>
-          <p:cNvPr id="45" name="Rectangle 44"/>
+          <p:cNvPr id="51" name="Rectangle 50"/>
           <p:cNvSpPr/>
           <p:nvPr/>
         </p:nvSpPr>
@@ -4884,7 +5142,7 @@
       </p:sp>
       <p:sp>
         <p:nvSpPr>
-          <p:cNvPr id="46" name="TextBox 45"/>
+          <p:cNvPr id="52" name="TextBox 51"/>
           <p:cNvSpPr txBox="1"/>
           <p:nvPr/>
         </p:nvSpPr>
@@ -4920,7 +5178,7 @@
       </p:sp>
       <p:sp>
         <p:nvSpPr>
-          <p:cNvPr id="47" name="Rounded Rectangle 46"/>
+          <p:cNvPr id="53" name="Rounded Rectangle 52"/>
           <p:cNvSpPr/>
           <p:nvPr/>
         </p:nvSpPr>
@@ -4968,7 +5226,7 @@
       </p:sp>
       <p:sp>
         <p:nvSpPr>
-          <p:cNvPr id="48" name="Rectangle 47"/>
+          <p:cNvPr id="54" name="Rectangle 53"/>
           <p:cNvSpPr/>
           <p:nvPr/>
         </p:nvSpPr>
@@ -5012,7 +5270,7 @@
       </p:sp>
       <p:sp>
         <p:nvSpPr>
-          <p:cNvPr id="49" name="TextBox 48"/>
+          <p:cNvPr id="55" name="TextBox 54"/>
           <p:cNvSpPr txBox="1"/>
           <p:nvPr/>
         </p:nvSpPr>
@@ -5048,7 +5306,7 @@
       </p:sp>
       <p:sp>
         <p:nvSpPr>
-          <p:cNvPr id="50" name="Rounded Rectangle 49"/>
+          <p:cNvPr id="56" name="Rounded Rectangle 55"/>
           <p:cNvSpPr/>
           <p:nvPr/>
         </p:nvSpPr>
@@ -5096,7 +5354,7 @@
       </p:sp>
       <p:sp>
         <p:nvSpPr>
-          <p:cNvPr id="51" name="Rectangle 50"/>
+          <p:cNvPr id="57" name="Rectangle 56"/>
           <p:cNvSpPr/>
           <p:nvPr/>
         </p:nvSpPr>
@@ -5140,7 +5398,7 @@
       </p:sp>
       <p:sp>
         <p:nvSpPr>
-          <p:cNvPr id="52" name="TextBox 51"/>
+          <p:cNvPr id="58" name="TextBox 57"/>
           <p:cNvSpPr txBox="1"/>
           <p:nvPr/>
         </p:nvSpPr>
@@ -5176,7 +5434,7 @@
       </p:sp>
       <p:sp>
         <p:nvSpPr>
-          <p:cNvPr id="53" name="Rounded Rectangle 52"/>
+          <p:cNvPr id="59" name="Rounded Rectangle 58"/>
           <p:cNvSpPr/>
           <p:nvPr/>
         </p:nvSpPr>
@@ -5224,7 +5482,7 @@
       </p:sp>
       <p:sp>
         <p:nvSpPr>
-          <p:cNvPr id="54" name="Rectangle 53"/>
+          <p:cNvPr id="60" name="Rectangle 59"/>
           <p:cNvSpPr/>
           <p:nvPr/>
         </p:nvSpPr>
@@ -5268,7 +5526,7 @@
       </p:sp>
       <p:sp>
         <p:nvSpPr>
-          <p:cNvPr id="55" name="TextBox 54"/>
+          <p:cNvPr id="61" name="TextBox 60"/>
           <p:cNvSpPr txBox="1"/>
           <p:nvPr/>
         </p:nvSpPr>
@@ -5304,7 +5562,7 @@
       </p:sp>
       <p:sp>
         <p:nvSpPr>
-          <p:cNvPr id="56" name="Rounded Rectangle 55"/>
+          <p:cNvPr id="62" name="Rounded Rectangle 61"/>
           <p:cNvSpPr/>
           <p:nvPr/>
         </p:nvSpPr>
@@ -5352,7 +5610,7 @@
       </p:sp>
       <p:sp>
         <p:nvSpPr>
-          <p:cNvPr id="57" name="Rectangle 56"/>
+          <p:cNvPr id="63" name="Rectangle 62"/>
           <p:cNvSpPr/>
           <p:nvPr/>
         </p:nvSpPr>
@@ -5396,7 +5654,7 @@
       </p:sp>
       <p:sp>
         <p:nvSpPr>
-          <p:cNvPr id="58" name="TextBox 57"/>
+          <p:cNvPr id="64" name="TextBox 63"/>
           <p:cNvSpPr txBox="1"/>
           <p:nvPr/>
         </p:nvSpPr>
@@ -5432,7 +5690,7 @@
       </p:sp>
       <p:sp>
         <p:nvSpPr>
-          <p:cNvPr id="59" name="Rounded Rectangle 58"/>
+          <p:cNvPr id="65" name="Rounded Rectangle 64"/>
           <p:cNvSpPr/>
           <p:nvPr/>
         </p:nvSpPr>
@@ -5480,7 +5738,7 @@
       </p:sp>
       <p:sp>
         <p:nvSpPr>
-          <p:cNvPr id="60" name="Rectangle 59"/>
+          <p:cNvPr id="66" name="Rectangle 65"/>
           <p:cNvSpPr/>
           <p:nvPr/>
         </p:nvSpPr>
@@ -5524,7 +5782,7 @@
       </p:sp>
       <p:sp>
         <p:nvSpPr>
-          <p:cNvPr id="61" name="TextBox 60"/>
+          <p:cNvPr id="67" name="TextBox 66"/>
           <p:cNvSpPr txBox="1"/>
           <p:nvPr/>
         </p:nvSpPr>
@@ -5560,7 +5818,7 @@
       </p:sp>
       <p:sp>
         <p:nvSpPr>
-          <p:cNvPr id="62" name="Rounded Rectangle 61"/>
+          <p:cNvPr id="68" name="Rounded Rectangle 67"/>
           <p:cNvSpPr/>
           <p:nvPr/>
         </p:nvSpPr>
@@ -5608,7 +5866,7 @@
       </p:sp>
       <p:sp>
         <p:nvSpPr>
-          <p:cNvPr id="63" name="Rectangle 62"/>
+          <p:cNvPr id="69" name="Rectangle 68"/>
           <p:cNvSpPr/>
           <p:nvPr/>
         </p:nvSpPr>
@@ -5652,7 +5910,7 @@
       </p:sp>
       <p:sp>
         <p:nvSpPr>
-          <p:cNvPr id="64" name="TextBox 63"/>
+          <p:cNvPr id="70" name="TextBox 69"/>
           <p:cNvSpPr txBox="1"/>
           <p:nvPr/>
         </p:nvSpPr>
@@ -5688,7 +5946,7 @@
       </p:sp>
       <p:sp>
         <p:nvSpPr>
-          <p:cNvPr id="65" name="Rounded Rectangle 64"/>
+          <p:cNvPr id="71" name="Rounded Rectangle 70"/>
           <p:cNvSpPr/>
           <p:nvPr/>
         </p:nvSpPr>
@@ -5736,7 +5994,7 @@
       </p:sp>
       <p:sp>
         <p:nvSpPr>
-          <p:cNvPr id="66" name="Rectangle 65"/>
+          <p:cNvPr id="72" name="Rectangle 71"/>
           <p:cNvSpPr/>
           <p:nvPr/>
         </p:nvSpPr>
@@ -5780,7 +6038,7 @@
       </p:sp>
       <p:sp>
         <p:nvSpPr>
-          <p:cNvPr id="67" name="TextBox 66"/>
+          <p:cNvPr id="73" name="TextBox 72"/>
           <p:cNvSpPr txBox="1"/>
           <p:nvPr/>
         </p:nvSpPr>
@@ -5816,7 +6074,7 @@
       </p:sp>
       <p:sp>
         <p:nvSpPr>
-          <p:cNvPr id="68" name="Rounded Rectangle 67"/>
+          <p:cNvPr id="74" name="Rounded Rectangle 73"/>
           <p:cNvSpPr/>
           <p:nvPr/>
         </p:nvSpPr>
@@ -5864,7 +6122,7 @@
       </p:sp>
       <p:sp>
         <p:nvSpPr>
-          <p:cNvPr id="69" name="Rectangle 68"/>
+          <p:cNvPr id="75" name="Rectangle 74"/>
           <p:cNvSpPr/>
           <p:nvPr/>
         </p:nvSpPr>
@@ -5908,7 +6166,7 @@
       </p:sp>
       <p:sp>
         <p:nvSpPr>
-          <p:cNvPr id="70" name="TextBox 69"/>
+          <p:cNvPr id="76" name="TextBox 75"/>
           <p:cNvSpPr txBox="1"/>
           <p:nvPr/>
         </p:nvSpPr>
@@ -5944,7 +6202,7 @@
       </p:sp>
       <p:sp>
         <p:nvSpPr>
-          <p:cNvPr id="71" name="Rounded Rectangle 70"/>
+          <p:cNvPr id="77" name="Rounded Rectangle 76"/>
           <p:cNvSpPr/>
           <p:nvPr/>
         </p:nvSpPr>
@@ -5992,7 +6250,7 @@
       </p:sp>
       <p:sp>
         <p:nvSpPr>
-          <p:cNvPr id="72" name="Rectangle 71"/>
+          <p:cNvPr id="78" name="Rectangle 77"/>
           <p:cNvSpPr/>
           <p:nvPr/>
         </p:nvSpPr>
@@ -6036,7 +6294,7 @@
       </p:sp>
       <p:sp>
         <p:nvSpPr>
-          <p:cNvPr id="73" name="TextBox 72"/>
+          <p:cNvPr id="79" name="TextBox 78"/>
           <p:cNvSpPr txBox="1"/>
           <p:nvPr/>
         </p:nvSpPr>
@@ -6072,7 +6330,7 @@
       </p:sp>
       <p:sp>
         <p:nvSpPr>
-          <p:cNvPr id="74" name="Rounded Rectangle 73"/>
+          <p:cNvPr id="80" name="Rounded Rectangle 79"/>
           <p:cNvSpPr/>
           <p:nvPr/>
         </p:nvSpPr>
@@ -6120,7 +6378,7 @@
       </p:sp>
       <p:sp>
         <p:nvSpPr>
-          <p:cNvPr id="75" name="Rectangle 74"/>
+          <p:cNvPr id="81" name="Rectangle 80"/>
           <p:cNvSpPr/>
           <p:nvPr/>
         </p:nvSpPr>
@@ -6164,7 +6422,7 @@
       </p:sp>
       <p:sp>
         <p:nvSpPr>
-          <p:cNvPr id="76" name="TextBox 75"/>
+          <p:cNvPr id="82" name="TextBox 81"/>
           <p:cNvSpPr txBox="1"/>
           <p:nvPr/>
         </p:nvSpPr>
@@ -6200,7 +6458,7 @@
       </p:sp>
       <p:sp>
         <p:nvSpPr>
-          <p:cNvPr id="77" name="Rounded Rectangle 76"/>
+          <p:cNvPr id="83" name="Rounded Rectangle 82"/>
           <p:cNvSpPr/>
           <p:nvPr/>
         </p:nvSpPr>
@@ -6248,7 +6506,7 @@
       </p:sp>
       <p:sp>
         <p:nvSpPr>
-          <p:cNvPr id="78" name="Rectangle 77"/>
+          <p:cNvPr id="84" name="Rectangle 83"/>
           <p:cNvSpPr/>
           <p:nvPr/>
         </p:nvSpPr>
@@ -6292,7 +6550,7 @@
       </p:sp>
       <p:sp>
         <p:nvSpPr>
-          <p:cNvPr id="79" name="TextBox 78"/>
+          <p:cNvPr id="85" name="TextBox 84"/>
           <p:cNvSpPr txBox="1"/>
           <p:nvPr/>
         </p:nvSpPr>
@@ -6328,7 +6586,7 @@
       </p:sp>
       <p:sp>
         <p:nvSpPr>
-          <p:cNvPr id="80" name="Rounded Rectangle 79"/>
+          <p:cNvPr id="86" name="Rounded Rectangle 85"/>
           <p:cNvSpPr/>
           <p:nvPr/>
         </p:nvSpPr>
@@ -6376,7 +6634,7 @@
       </p:sp>
       <p:sp>
         <p:nvSpPr>
-          <p:cNvPr id="81" name="Rectangle 80"/>
+          <p:cNvPr id="87" name="Rectangle 86"/>
           <p:cNvSpPr/>
           <p:nvPr/>
         </p:nvSpPr>
@@ -6420,7 +6678,7 @@
       </p:sp>
       <p:sp>
         <p:nvSpPr>
-          <p:cNvPr id="82" name="TextBox 81"/>
+          <p:cNvPr id="88" name="TextBox 87"/>
           <p:cNvSpPr txBox="1"/>
           <p:nvPr/>
         </p:nvSpPr>
@@ -6456,7 +6714,7 @@
       </p:sp>
       <p:sp>
         <p:nvSpPr>
-          <p:cNvPr id="83" name="Rounded Rectangle 82"/>
+          <p:cNvPr id="89" name="Rounded Rectangle 88"/>
           <p:cNvSpPr/>
           <p:nvPr/>
         </p:nvSpPr>
@@ -6504,7 +6762,7 @@
       </p:sp>
       <p:sp>
         <p:nvSpPr>
-          <p:cNvPr id="84" name="Rectangle 83"/>
+          <p:cNvPr id="90" name="Rectangle 89"/>
           <p:cNvSpPr/>
           <p:nvPr/>
         </p:nvSpPr>
@@ -6548,7 +6806,7 @@
       </p:sp>
       <p:sp>
         <p:nvSpPr>
-          <p:cNvPr id="85" name="TextBox 84"/>
+          <p:cNvPr id="91" name="TextBox 90"/>
           <p:cNvSpPr txBox="1"/>
           <p:nvPr/>
         </p:nvSpPr>
@@ -6584,7 +6842,7 @@
       </p:sp>
       <p:sp>
         <p:nvSpPr>
-          <p:cNvPr id="86" name="Rounded Rectangle 85"/>
+          <p:cNvPr id="92" name="Rounded Rectangle 91"/>
           <p:cNvSpPr/>
           <p:nvPr/>
         </p:nvSpPr>
@@ -6632,7 +6890,7 @@
       </p:sp>
       <p:sp>
         <p:nvSpPr>
-          <p:cNvPr id="87" name="Rectangle 86"/>
+          <p:cNvPr id="93" name="Rectangle 92"/>
           <p:cNvSpPr/>
           <p:nvPr/>
         </p:nvSpPr>
@@ -6676,7 +6934,7 @@
       </p:sp>
       <p:sp>
         <p:nvSpPr>
-          <p:cNvPr id="88" name="TextBox 87"/>
+          <p:cNvPr id="94" name="TextBox 93"/>
           <p:cNvSpPr txBox="1"/>
           <p:nvPr/>
         </p:nvSpPr>
@@ -6712,7 +6970,7 @@
       </p:sp>
       <p:sp>
         <p:nvSpPr>
-          <p:cNvPr id="89" name="Rounded Rectangle 88"/>
+          <p:cNvPr id="95" name="Rounded Rectangle 94"/>
           <p:cNvSpPr/>
           <p:nvPr/>
         </p:nvSpPr>
@@ -6760,7 +7018,7 @@
       </p:sp>
       <p:sp>
         <p:nvSpPr>
-          <p:cNvPr id="90" name="Rectangle 89"/>
+          <p:cNvPr id="96" name="Rectangle 95"/>
           <p:cNvSpPr/>
           <p:nvPr/>
         </p:nvSpPr>
@@ -6804,7 +7062,7 @@
       </p:sp>
       <p:sp>
         <p:nvSpPr>
-          <p:cNvPr id="91" name="TextBox 90"/>
+          <p:cNvPr id="97" name="TextBox 96"/>
           <p:cNvSpPr txBox="1"/>
           <p:nvPr/>
         </p:nvSpPr>
@@ -6840,7 +7098,7 @@
       </p:sp>
       <p:sp>
         <p:nvSpPr>
-          <p:cNvPr id="92" name="Rounded Rectangle 91"/>
+          <p:cNvPr id="98" name="Rounded Rectangle 97"/>
           <p:cNvSpPr/>
           <p:nvPr/>
         </p:nvSpPr>
@@ -6888,7 +7146,7 @@
       </p:sp>
       <p:sp>
         <p:nvSpPr>
-          <p:cNvPr id="93" name="Rectangle 92"/>
+          <p:cNvPr id="99" name="Rectangle 98"/>
           <p:cNvSpPr/>
           <p:nvPr/>
         </p:nvSpPr>
@@ -6932,7 +7190,7 @@
       </p:sp>
       <p:sp>
         <p:nvSpPr>
-          <p:cNvPr id="94" name="TextBox 93"/>
+          <p:cNvPr id="100" name="TextBox 99"/>
           <p:cNvSpPr txBox="1"/>
           <p:nvPr/>
         </p:nvSpPr>
@@ -6968,7 +7226,7 @@
       </p:sp>
       <p:sp>
         <p:nvSpPr>
-          <p:cNvPr id="95" name="Rounded Rectangle 94"/>
+          <p:cNvPr id="101" name="Rounded Rectangle 100"/>
           <p:cNvSpPr/>
           <p:nvPr/>
         </p:nvSpPr>
@@ -7014,7 +7272,7 @@
       </p:sp>
       <p:sp>
         <p:nvSpPr>
-          <p:cNvPr id="96" name="Rounded Rectangle 95"/>
+          <p:cNvPr id="102" name="Rounded Rectangle 101"/>
           <p:cNvSpPr/>
           <p:nvPr/>
         </p:nvSpPr>
@@ -7062,7 +7320,7 @@
       </p:sp>
       <p:sp>
         <p:nvSpPr>
-          <p:cNvPr id="97" name="Rectangle 96"/>
+          <p:cNvPr id="103" name="Rectangle 102"/>
           <p:cNvSpPr/>
           <p:nvPr/>
         </p:nvSpPr>
@@ -7106,7 +7364,7 @@
       </p:sp>
       <p:sp>
         <p:nvSpPr>
-          <p:cNvPr id="98" name="TextBox 97"/>
+          <p:cNvPr id="104" name="TextBox 103"/>
           <p:cNvSpPr txBox="1"/>
           <p:nvPr/>
         </p:nvSpPr>
@@ -7142,7 +7400,7 @@
       </p:sp>
       <p:sp>
         <p:nvSpPr>
-          <p:cNvPr id="99" name="TextBox 98"/>
+          <p:cNvPr id="105" name="TextBox 104"/>
           <p:cNvSpPr txBox="1"/>
           <p:nvPr/>
         </p:nvSpPr>
@@ -7178,7 +7436,7 @@
       </p:sp>
       <p:sp>
         <p:nvSpPr>
-          <p:cNvPr id="100" name="Rounded Rectangle 99"/>
+          <p:cNvPr id="106" name="Rounded Rectangle 105"/>
           <p:cNvSpPr/>
           <p:nvPr/>
         </p:nvSpPr>
@@ -7226,7 +7484,7 @@
       </p:sp>
       <p:sp>
         <p:nvSpPr>
-          <p:cNvPr id="101" name="Rectangle 100"/>
+          <p:cNvPr id="107" name="Rectangle 106"/>
           <p:cNvSpPr/>
           <p:nvPr/>
         </p:nvSpPr>
@@ -7270,7 +7528,7 @@
       </p:sp>
       <p:sp>
         <p:nvSpPr>
-          <p:cNvPr id="102" name="TextBox 101"/>
+          <p:cNvPr id="108" name="TextBox 107"/>
           <p:cNvSpPr txBox="1"/>
           <p:nvPr/>
         </p:nvSpPr>
@@ -7306,7 +7564,7 @@
       </p:sp>
       <p:sp>
         <p:nvSpPr>
-          <p:cNvPr id="103" name="Rounded Rectangle 102"/>
+          <p:cNvPr id="109" name="Rounded Rectangle 108"/>
           <p:cNvSpPr/>
           <p:nvPr/>
         </p:nvSpPr>
@@ -7354,7 +7612,7 @@
       </p:sp>
       <p:sp>
         <p:nvSpPr>
-          <p:cNvPr id="104" name="Rectangle 103"/>
+          <p:cNvPr id="110" name="Rectangle 109"/>
           <p:cNvSpPr/>
           <p:nvPr/>
         </p:nvSpPr>
@@ -7398,7 +7656,7 @@
       </p:sp>
       <p:sp>
         <p:nvSpPr>
-          <p:cNvPr id="105" name="TextBox 104"/>
+          <p:cNvPr id="111" name="TextBox 110"/>
           <p:cNvSpPr txBox="1"/>
           <p:nvPr/>
         </p:nvSpPr>
@@ -7434,7 +7692,7 @@
       </p:sp>
       <p:sp>
         <p:nvSpPr>
-          <p:cNvPr id="106" name="Rounded Rectangle 105"/>
+          <p:cNvPr id="112" name="Rounded Rectangle 111"/>
           <p:cNvSpPr/>
           <p:nvPr/>
         </p:nvSpPr>
@@ -7482,7 +7740,7 @@
       </p:sp>
       <p:sp>
         <p:nvSpPr>
-          <p:cNvPr id="107" name="Rectangle 106"/>
+          <p:cNvPr id="113" name="Rectangle 112"/>
           <p:cNvSpPr/>
           <p:nvPr/>
         </p:nvSpPr>
@@ -7526,7 +7784,7 @@
       </p:sp>
       <p:sp>
         <p:nvSpPr>
-          <p:cNvPr id="108" name="TextBox 107"/>
+          <p:cNvPr id="114" name="TextBox 113"/>
           <p:cNvSpPr txBox="1"/>
           <p:nvPr/>
         </p:nvSpPr>
@@ -7562,7 +7820,7 @@
       </p:sp>
       <p:sp>
         <p:nvSpPr>
-          <p:cNvPr id="109" name="Rounded Rectangle 108"/>
+          <p:cNvPr id="115" name="Rounded Rectangle 114"/>
           <p:cNvSpPr/>
           <p:nvPr/>
         </p:nvSpPr>
@@ -7610,7 +7868,7 @@
       </p:sp>
       <p:sp>
         <p:nvSpPr>
-          <p:cNvPr id="110" name="Rectangle 109"/>
+          <p:cNvPr id="116" name="Rectangle 115"/>
           <p:cNvSpPr/>
           <p:nvPr/>
         </p:nvSpPr>
@@ -7654,7 +7912,7 @@
       </p:sp>
       <p:sp>
         <p:nvSpPr>
-          <p:cNvPr id="111" name="TextBox 110"/>
+          <p:cNvPr id="117" name="TextBox 116"/>
           <p:cNvSpPr txBox="1"/>
           <p:nvPr/>
         </p:nvSpPr>
@@ -7690,7 +7948,7 @@
       </p:sp>
       <p:sp>
         <p:nvSpPr>
-          <p:cNvPr id="112" name="Rounded Rectangle 111"/>
+          <p:cNvPr id="118" name="Rounded Rectangle 117"/>
           <p:cNvSpPr/>
           <p:nvPr/>
         </p:nvSpPr>
@@ -7738,7 +7996,7 @@
       </p:sp>
       <p:sp>
         <p:nvSpPr>
-          <p:cNvPr id="113" name="Rectangle 112"/>
+          <p:cNvPr id="119" name="Rectangle 118"/>
           <p:cNvSpPr/>
           <p:nvPr/>
         </p:nvSpPr>
@@ -7782,7 +8040,7 @@
       </p:sp>
       <p:sp>
         <p:nvSpPr>
-          <p:cNvPr id="114" name="TextBox 113"/>
+          <p:cNvPr id="120" name="TextBox 119"/>
           <p:cNvSpPr txBox="1"/>
           <p:nvPr/>
         </p:nvSpPr>
@@ -7818,7 +8076,7 @@
       </p:sp>
       <p:sp>
         <p:nvSpPr>
-          <p:cNvPr id="115" name="Rounded Rectangle 114"/>
+          <p:cNvPr id="121" name="Rounded Rectangle 120"/>
           <p:cNvSpPr/>
           <p:nvPr/>
         </p:nvSpPr>
@@ -7866,7 +8124,7 @@
       </p:sp>
       <p:sp>
         <p:nvSpPr>
-          <p:cNvPr id="116" name="Rectangle 115"/>
+          <p:cNvPr id="122" name="Rectangle 121"/>
           <p:cNvSpPr/>
           <p:nvPr/>
         </p:nvSpPr>
@@ -7910,7 +8168,7 @@
       </p:sp>
       <p:sp>
         <p:nvSpPr>
-          <p:cNvPr id="117" name="TextBox 116"/>
+          <p:cNvPr id="123" name="TextBox 122"/>
           <p:cNvSpPr txBox="1"/>
           <p:nvPr/>
         </p:nvSpPr>
@@ -7946,7 +8204,7 @@
       </p:sp>
       <p:sp>
         <p:nvSpPr>
-          <p:cNvPr id="118" name="Rounded Rectangle 117"/>
+          <p:cNvPr id="124" name="Rounded Rectangle 123"/>
           <p:cNvSpPr/>
           <p:nvPr/>
         </p:nvSpPr>
@@ -7994,7 +8252,7 @@
       </p:sp>
       <p:sp>
         <p:nvSpPr>
-          <p:cNvPr id="119" name="Rectangle 118"/>
+          <p:cNvPr id="125" name="Rectangle 124"/>
           <p:cNvSpPr/>
           <p:nvPr/>
         </p:nvSpPr>
@@ -8038,7 +8296,7 @@
       </p:sp>
       <p:sp>
         <p:nvSpPr>
-          <p:cNvPr id="120" name="TextBox 119"/>
+          <p:cNvPr id="126" name="TextBox 125"/>
           <p:cNvSpPr txBox="1"/>
           <p:nvPr/>
         </p:nvSpPr>
@@ -8074,7 +8332,7 @@
       </p:sp>
       <p:sp>
         <p:nvSpPr>
-          <p:cNvPr id="121" name="Rounded Rectangle 120"/>
+          <p:cNvPr id="127" name="Rounded Rectangle 126"/>
           <p:cNvSpPr/>
           <p:nvPr/>
         </p:nvSpPr>
@@ -8120,7 +8378,7 @@
       </p:sp>
       <p:sp>
         <p:nvSpPr>
-          <p:cNvPr id="122" name="Rounded Rectangle 121"/>
+          <p:cNvPr id="128" name="Rounded Rectangle 127"/>
           <p:cNvSpPr/>
           <p:nvPr/>
         </p:nvSpPr>
@@ -8168,7 +8426,7 @@
       </p:sp>
       <p:sp>
         <p:nvSpPr>
-          <p:cNvPr id="123" name="Rectangle 122"/>
+          <p:cNvPr id="129" name="Rectangle 128"/>
           <p:cNvSpPr/>
           <p:nvPr/>
         </p:nvSpPr>
@@ -8212,7 +8470,7 @@
       </p:sp>
       <p:sp>
         <p:nvSpPr>
-          <p:cNvPr id="124" name="TextBox 123"/>
+          <p:cNvPr id="130" name="TextBox 129"/>
           <p:cNvSpPr txBox="1"/>
           <p:nvPr/>
         </p:nvSpPr>
@@ -8248,7 +8506,7 @@
       </p:sp>
       <p:sp>
         <p:nvSpPr>
-          <p:cNvPr id="125" name="TextBox 124"/>
+          <p:cNvPr id="131" name="TextBox 130"/>
           <p:cNvSpPr txBox="1"/>
           <p:nvPr/>
         </p:nvSpPr>
@@ -8284,7 +8542,7 @@
       </p:sp>
       <p:sp>
         <p:nvSpPr>
-          <p:cNvPr id="126" name="Rounded Rectangle 125"/>
+          <p:cNvPr id="132" name="Rounded Rectangle 131"/>
           <p:cNvSpPr/>
           <p:nvPr/>
         </p:nvSpPr>
@@ -8332,7 +8590,7 @@
       </p:sp>
       <p:sp>
         <p:nvSpPr>
-          <p:cNvPr id="127" name="Rectangle 126"/>
+          <p:cNvPr id="133" name="Rectangle 132"/>
           <p:cNvSpPr/>
           <p:nvPr/>
         </p:nvSpPr>
@@ -8376,7 +8634,7 @@
       </p:sp>
       <p:sp>
         <p:nvSpPr>
-          <p:cNvPr id="128" name="TextBox 127"/>
+          <p:cNvPr id="134" name="TextBox 133"/>
           <p:cNvSpPr txBox="1"/>
           <p:nvPr/>
         </p:nvSpPr>
@@ -8412,7 +8670,7 @@
       </p:sp>
       <p:sp>
         <p:nvSpPr>
-          <p:cNvPr id="129" name="TextBox 128"/>
+          <p:cNvPr id="135" name="TextBox 134"/>
           <p:cNvSpPr txBox="1"/>
           <p:nvPr/>
         </p:nvSpPr>
@@ -8448,7 +8706,7 @@
       </p:sp>
       <p:sp>
         <p:nvSpPr>
-          <p:cNvPr id="130" name="Rounded Rectangle 129"/>
+          <p:cNvPr id="136" name="Rounded Rectangle 135"/>
           <p:cNvSpPr/>
           <p:nvPr/>
         </p:nvSpPr>
@@ -8496,7 +8754,7 @@
       </p:sp>
       <p:sp>
         <p:nvSpPr>
-          <p:cNvPr id="131" name="Rectangle 130"/>
+          <p:cNvPr id="137" name="Rectangle 136"/>
           <p:cNvSpPr/>
           <p:nvPr/>
         </p:nvSpPr>
@@ -8540,7 +8798,7 @@
       </p:sp>
       <p:sp>
         <p:nvSpPr>
-          <p:cNvPr id="132" name="TextBox 131"/>
+          <p:cNvPr id="138" name="TextBox 137"/>
           <p:cNvSpPr txBox="1"/>
           <p:nvPr/>
         </p:nvSpPr>
@@ -8576,7 +8834,7 @@
       </p:sp>
       <p:sp>
         <p:nvSpPr>
-          <p:cNvPr id="133" name="TextBox 132"/>
+          <p:cNvPr id="139" name="TextBox 138"/>
           <p:cNvSpPr txBox="1"/>
           <p:nvPr/>
         </p:nvSpPr>
@@ -8612,7 +8870,7 @@
       </p:sp>
       <p:sp>
         <p:nvSpPr>
-          <p:cNvPr id="134" name="Rounded Rectangle 133"/>
+          <p:cNvPr id="140" name="Rounded Rectangle 139"/>
           <p:cNvSpPr/>
           <p:nvPr/>
         </p:nvSpPr>
@@ -8660,7 +8918,7 @@
       </p:sp>
       <p:sp>
         <p:nvSpPr>
-          <p:cNvPr id="135" name="Rectangle 134"/>
+          <p:cNvPr id="141" name="Rectangle 140"/>
           <p:cNvSpPr/>
           <p:nvPr/>
         </p:nvSpPr>
@@ -8704,7 +8962,7 @@
       </p:sp>
       <p:sp>
         <p:nvSpPr>
-          <p:cNvPr id="136" name="TextBox 135"/>
+          <p:cNvPr id="142" name="TextBox 141"/>
           <p:cNvSpPr txBox="1"/>
           <p:nvPr/>
         </p:nvSpPr>
@@ -8740,7 +8998,7 @@
       </p:sp>
       <p:sp>
         <p:nvSpPr>
-          <p:cNvPr id="137" name="TextBox 136"/>
+          <p:cNvPr id="143" name="TextBox 142"/>
           <p:cNvSpPr txBox="1"/>
           <p:nvPr/>
         </p:nvSpPr>
@@ -8776,7 +9034,7 @@
       </p:sp>
       <p:sp>
         <p:nvSpPr>
-          <p:cNvPr id="138" name="Rounded Rectangle 137"/>
+          <p:cNvPr id="144" name="Rounded Rectangle 143"/>
           <p:cNvSpPr/>
           <p:nvPr/>
         </p:nvSpPr>
@@ -8824,7 +9082,7 @@
       </p:sp>
       <p:sp>
         <p:nvSpPr>
-          <p:cNvPr id="139" name="Rectangle 138"/>
+          <p:cNvPr id="145" name="Rectangle 144"/>
           <p:cNvSpPr/>
           <p:nvPr/>
         </p:nvSpPr>
@@ -8868,7 +9126,7 @@
       </p:sp>
       <p:sp>
         <p:nvSpPr>
-          <p:cNvPr id="140" name="TextBox 139"/>
+          <p:cNvPr id="146" name="TextBox 145"/>
           <p:cNvSpPr txBox="1"/>
           <p:nvPr/>
         </p:nvSpPr>
@@ -8904,7 +9162,7 @@
       </p:sp>
       <p:sp>
         <p:nvSpPr>
-          <p:cNvPr id="141" name="TextBox 140"/>
+          <p:cNvPr id="147" name="TextBox 146"/>
           <p:cNvSpPr txBox="1"/>
           <p:nvPr/>
         </p:nvSpPr>
@@ -8940,7 +9198,7 @@
       </p:sp>
       <p:sp>
         <p:nvSpPr>
-          <p:cNvPr id="142" name="Rounded Rectangle 141"/>
+          <p:cNvPr id="148" name="Rounded Rectangle 147"/>
           <p:cNvSpPr/>
           <p:nvPr/>
         </p:nvSpPr>
@@ -8988,7 +9246,7 @@
       </p:sp>
       <p:sp>
         <p:nvSpPr>
-          <p:cNvPr id="143" name="Rectangle 142"/>
+          <p:cNvPr id="149" name="Rectangle 148"/>
           <p:cNvSpPr/>
           <p:nvPr/>
         </p:nvSpPr>
@@ -9032,7 +9290,7 @@
       </p:sp>
       <p:sp>
         <p:nvSpPr>
-          <p:cNvPr id="144" name="TextBox 143"/>
+          <p:cNvPr id="150" name="TextBox 149"/>
           <p:cNvSpPr txBox="1"/>
           <p:nvPr/>
         </p:nvSpPr>
@@ -9068,7 +9326,7 @@
       </p:sp>
       <p:sp>
         <p:nvSpPr>
-          <p:cNvPr id="145" name="Rounded Rectangle 144"/>
+          <p:cNvPr id="151" name="Rounded Rectangle 150"/>
           <p:cNvSpPr/>
           <p:nvPr/>
         </p:nvSpPr>
@@ -9116,7 +9374,7 @@
       </p:sp>
       <p:sp>
         <p:nvSpPr>
-          <p:cNvPr id="146" name="Rectangle 145"/>
+          <p:cNvPr id="152" name="Rectangle 151"/>
           <p:cNvSpPr/>
           <p:nvPr/>
         </p:nvSpPr>
@@ -9160,7 +9418,7 @@
       </p:sp>
       <p:sp>
         <p:nvSpPr>
-          <p:cNvPr id="147" name="TextBox 146"/>
+          <p:cNvPr id="153" name="TextBox 152"/>
           <p:cNvSpPr txBox="1"/>
           <p:nvPr/>
         </p:nvSpPr>
@@ -9196,7 +9454,7 @@
       </p:sp>
       <p:sp>
         <p:nvSpPr>
-          <p:cNvPr id="148" name="Rounded Rectangle 147"/>
+          <p:cNvPr id="154" name="Rounded Rectangle 153"/>
           <p:cNvSpPr/>
           <p:nvPr/>
         </p:nvSpPr>
@@ -9244,7 +9502,7 @@
       </p:sp>
       <p:sp>
         <p:nvSpPr>
-          <p:cNvPr id="149" name="Rectangle 148"/>
+          <p:cNvPr id="155" name="Rectangle 154"/>
           <p:cNvSpPr/>
           <p:nvPr/>
         </p:nvSpPr>
@@ -9288,7 +9546,7 @@
       </p:sp>
       <p:sp>
         <p:nvSpPr>
-          <p:cNvPr id="150" name="TextBox 149"/>
+          <p:cNvPr id="156" name="TextBox 155"/>
           <p:cNvSpPr txBox="1"/>
           <p:nvPr/>
         </p:nvSpPr>
@@ -9324,7 +9582,7 @@
       </p:sp>
       <p:sp>
         <p:nvSpPr>
-          <p:cNvPr id="151" name="Rounded Rectangle 150"/>
+          <p:cNvPr id="157" name="Rounded Rectangle 156"/>
           <p:cNvSpPr/>
           <p:nvPr/>
         </p:nvSpPr>
@@ -9372,7 +9630,7 @@
       </p:sp>
       <p:sp>
         <p:nvSpPr>
-          <p:cNvPr id="152" name="Rectangle 151"/>
+          <p:cNvPr id="158" name="Rectangle 157"/>
           <p:cNvSpPr/>
           <p:nvPr/>
         </p:nvSpPr>
@@ -9416,7 +9674,7 @@
       </p:sp>
       <p:sp>
         <p:nvSpPr>
-          <p:cNvPr id="153" name="TextBox 152"/>
+          <p:cNvPr id="159" name="TextBox 158"/>
           <p:cNvSpPr txBox="1"/>
           <p:nvPr/>
         </p:nvSpPr>
@@ -9452,7 +9710,7 @@
       </p:sp>
       <p:sp>
         <p:nvSpPr>
-          <p:cNvPr id="154" name="Rounded Rectangle 153"/>
+          <p:cNvPr id="160" name="Rounded Rectangle 159"/>
           <p:cNvSpPr/>
           <p:nvPr/>
         </p:nvSpPr>
@@ -9500,7 +9758,7 @@
       </p:sp>
       <p:sp>
         <p:nvSpPr>
-          <p:cNvPr id="155" name="Rectangle 154"/>
+          <p:cNvPr id="161" name="Rectangle 160"/>
           <p:cNvSpPr/>
           <p:nvPr/>
         </p:nvSpPr>
@@ -9544,7 +9802,7 @@
       </p:sp>
       <p:sp>
         <p:nvSpPr>
-          <p:cNvPr id="156" name="TextBox 155"/>
+          <p:cNvPr id="162" name="TextBox 161"/>
           <p:cNvSpPr txBox="1"/>
           <p:nvPr/>
         </p:nvSpPr>
@@ -9580,7 +9838,7 @@
       </p:sp>
       <p:cxnSp>
         <p:nvCxnSpPr>
-          <p:cNvPr id="157" name="Connector 156"/>
+          <p:cNvPr id="163" name="Connector 162"/>
           <p:cNvCxnSpPr/>
           <p:nvPr/>
         </p:nvCxnSpPr>
@@ -9615,7 +9873,7 @@
       </p:cxnSp>
       <p:cxnSp>
         <p:nvCxnSpPr>
-          <p:cNvPr id="158" name="Connector 157"/>
+          <p:cNvPr id="164" name="Connector 163"/>
           <p:cNvCxnSpPr/>
           <p:nvPr/>
         </p:nvCxnSpPr>
@@ -9650,7 +9908,7 @@
       </p:cxnSp>
       <p:cxnSp>
         <p:nvCxnSpPr>
-          <p:cNvPr id="159" name="Connector 158"/>
+          <p:cNvPr id="165" name="Connector 164"/>
           <p:cNvCxnSpPr/>
           <p:nvPr/>
         </p:nvCxnSpPr>
@@ -9685,7 +9943,7 @@
       </p:cxnSp>
       <p:cxnSp>
         <p:nvCxnSpPr>
-          <p:cNvPr id="160" name="Connector 159"/>
+          <p:cNvPr id="166" name="Connector 165"/>
           <p:cNvCxnSpPr/>
           <p:nvPr/>
         </p:nvCxnSpPr>
@@ -9720,7 +9978,7 @@
       </p:cxnSp>
       <p:cxnSp>
         <p:nvCxnSpPr>
-          <p:cNvPr id="161" name="Connector 160"/>
+          <p:cNvPr id="167" name="Connector 166"/>
           <p:cNvCxnSpPr/>
           <p:nvPr/>
         </p:nvCxnSpPr>
@@ -10062,7 +10320,7 @@
             </a:avLst>
           </a:prstGeom>
           <a:solidFill>
-            <a:srgbClr val="B4BCCC"/>
+            <a:srgbClr val="2E9E6A"/>
           </a:solidFill>
           <a:ln>
             <a:noFill/>
@@ -10122,7 +10380,7 @@
                 <a:latin typeface="Heebo"/>
                 <a:cs typeface="Heebo"/>
               </a:rPr>
-              <a:t>אודליה קדמי</a:t>
+              <a:t>תמיר דורטל</a:t>
             </a:r>
           </a:p>
         </p:txBody>
@@ -10136,6 +10394,124 @@
         <p:spPr>
           <a:xfrm>
             <a:off x="10250163" y="1630375"/>
+            <a:ext cx="1530052" cy="241401"/>
+          </a:xfrm>
+          <a:prstGeom prst="rect">
+            <a:avLst/>
+          </a:prstGeom>
+          <a:noFill/>
+        </p:spPr>
+        <p:txBody>
+          <a:bodyPr wrap="square" anchor="t" lIns="36576" rIns="36576" tIns="0" bIns="0">
+            <a:spAutoFit/>
+          </a:bodyPr>
+          <a:lstStyle/>
+          <a:p>
+            <a:pPr algn="ctr" rtl="1"/>
+            <a:r>
+              <a:rPr sz="900" b="0">
+                <a:solidFill>
+                  <a:srgbClr val="FFFFFF"/>
+                </a:solidFill>
+                <a:latin typeface="Heebo"/>
+                <a:cs typeface="Heebo"/>
+              </a:rPr>
+              <a:t>מייסד · ראש תחום כלכלה</a:t>
+            </a:r>
+          </a:p>
+        </p:txBody>
+      </p:sp>
+      <p:sp>
+        <p:nvSpPr>
+          <p:cNvPr id="12" name="Rounded Rectangle 11"/>
+          <p:cNvSpPr/>
+          <p:nvPr/>
+        </p:nvSpPr>
+        <p:spPr>
+          <a:xfrm>
+            <a:off x="8610383" y="1298448"/>
+            <a:ext cx="1530052" cy="603504"/>
+          </a:xfrm>
+          <a:prstGeom prst="roundRect">
+            <a:avLst>
+              <a:gd name="adj" fmla="val 18000"/>
+            </a:avLst>
+          </a:prstGeom>
+          <a:solidFill>
+            <a:srgbClr val="E8892B"/>
+          </a:solidFill>
+          <a:ln>
+            <a:noFill/>
+          </a:ln>
+          <a:effectLst/>
+        </p:spPr>
+        <p:style>
+          <a:lnRef idx="1">
+            <a:schemeClr val="accent1"/>
+          </a:lnRef>
+          <a:fillRef idx="3">
+            <a:schemeClr val="accent1"/>
+          </a:fillRef>
+          <a:effectRef idx="2">
+            <a:schemeClr val="accent1"/>
+          </a:effectRef>
+          <a:fontRef idx="minor">
+            <a:schemeClr val="lt1"/>
+          </a:fontRef>
+        </p:style>
+        <p:txBody>
+          <a:bodyPr rtlCol="0" anchor="ctr"/>
+          <a:lstStyle/>
+          <a:p>
+            <a:pPr algn="ctr"/>
+          </a:p>
+        </p:txBody>
+      </p:sp>
+      <p:sp>
+        <p:nvSpPr>
+          <p:cNvPr id="13" name="TextBox 12"/>
+          <p:cNvSpPr txBox="1"/>
+          <p:nvPr/>
+        </p:nvSpPr>
+        <p:spPr>
+          <a:xfrm>
+            <a:off x="8610383" y="1353312"/>
+            <a:ext cx="1530052" cy="313822"/>
+          </a:xfrm>
+          <a:prstGeom prst="rect">
+            <a:avLst/>
+          </a:prstGeom>
+          <a:noFill/>
+        </p:spPr>
+        <p:txBody>
+          <a:bodyPr wrap="square" anchor="b" lIns="36576" rIns="36576" tIns="0" bIns="0">
+            <a:spAutoFit/>
+          </a:bodyPr>
+          <a:lstStyle/>
+          <a:p>
+            <a:pPr algn="ctr" rtl="1"/>
+            <a:r>
+              <a:rPr sz="1200" b="1">
+                <a:solidFill>
+                  <a:srgbClr val="FFFFFF"/>
+                </a:solidFill>
+                <a:latin typeface="Heebo"/>
+                <a:cs typeface="Heebo"/>
+              </a:rPr>
+              <a:t>עו״ד אודליה קדמי</a:t>
+            </a:r>
+          </a:p>
+        </p:txBody>
+      </p:sp>
+      <p:sp>
+        <p:nvSpPr>
+          <p:cNvPr id="14" name="TextBox 13"/>
+          <p:cNvSpPr txBox="1"/>
+          <p:nvPr/>
+        </p:nvSpPr>
+        <p:spPr>
+          <a:xfrm>
+            <a:off x="8610383" y="1630375"/>
             <a:ext cx="1530052" cy="241401"/>
           </a:xfrm>
           <a:prstGeom prst="rect">
@@ -10165,13 +10541,13 @@
       </p:sp>
       <p:sp>
         <p:nvSpPr>
-          <p:cNvPr id="12" name="Rounded Rectangle 11"/>
+          <p:cNvPr id="15" name="Rounded Rectangle 14"/>
           <p:cNvSpPr/>
           <p:nvPr/>
         </p:nvSpPr>
         <p:spPr>
           <a:xfrm>
-            <a:off x="8610383" y="1298448"/>
+            <a:off x="6970603" y="1298448"/>
             <a:ext cx="1530052" cy="603504"/>
           </a:xfrm>
           <a:prstGeom prst="roundRect">
@@ -10180,7 +10556,7 @@
             </a:avLst>
           </a:prstGeom>
           <a:solidFill>
-            <a:srgbClr val="B4BCCC"/>
+            <a:srgbClr val="E8892B"/>
           </a:solidFill>
           <a:ln>
             <a:noFill/>
@@ -10211,13 +10587,13 @@
       </p:sp>
       <p:sp>
         <p:nvSpPr>
-          <p:cNvPr id="13" name="TextBox 12"/>
+          <p:cNvPr id="16" name="TextBox 15"/>
           <p:cNvSpPr txBox="1"/>
           <p:nvPr/>
         </p:nvSpPr>
         <p:spPr>
           <a:xfrm>
-            <a:off x="8610383" y="1353312"/>
+            <a:off x="6970603" y="1353312"/>
             <a:ext cx="1530052" cy="313822"/>
           </a:xfrm>
           <a:prstGeom prst="rect">
@@ -10240,20 +10616,20 @@
                 <a:latin typeface="Heebo"/>
                 <a:cs typeface="Heebo"/>
               </a:rPr>
-              <a:t>שם יעודכן</a:t>
-            </a:r>
-          </a:p>
-        </p:txBody>
-      </p:sp>
-      <p:sp>
-        <p:nvSpPr>
-          <p:cNvPr id="14" name="TextBox 13"/>
+              <a:t>ד״ר אמיר רובין</a:t>
+            </a:r>
+          </a:p>
+        </p:txBody>
+      </p:sp>
+      <p:sp>
+        <p:nvSpPr>
+          <p:cNvPr id="17" name="TextBox 16"/>
           <p:cNvSpPr txBox="1"/>
           <p:nvPr/>
         </p:nvSpPr>
         <p:spPr>
           <a:xfrm>
-            <a:off x="8610383" y="1630375"/>
+            <a:off x="6970603" y="1630375"/>
             <a:ext cx="1530052" cy="241401"/>
           </a:xfrm>
           <a:prstGeom prst="rect">
@@ -10276,20 +10652,20 @@
                 <a:latin typeface="Heebo"/>
                 <a:cs typeface="Heebo"/>
               </a:rPr>
-              <a:t>ראש תחום חינוך וזהות</a:t>
-            </a:r>
-          </a:p>
-        </p:txBody>
-      </p:sp>
-      <p:sp>
-        <p:nvSpPr>
-          <p:cNvPr id="15" name="Rounded Rectangle 14"/>
+              <a:t>ראש תחום רפואה</a:t>
+            </a:r>
+          </a:p>
+        </p:txBody>
+      </p:sp>
+      <p:sp>
+        <p:nvSpPr>
+          <p:cNvPr id="18" name="Rounded Rectangle 17"/>
           <p:cNvSpPr/>
           <p:nvPr/>
         </p:nvSpPr>
         <p:spPr>
           <a:xfrm>
-            <a:off x="6970603" y="1298448"/>
+            <a:off x="5330823" y="1298448"/>
             <a:ext cx="1530052" cy="603504"/>
           </a:xfrm>
           <a:prstGeom prst="roundRect">
@@ -10298,7 +10674,7 @@
             </a:avLst>
           </a:prstGeom>
           <a:solidFill>
-            <a:srgbClr val="B4BCCC"/>
+            <a:srgbClr val="E8892B"/>
           </a:solidFill>
           <a:ln>
             <a:noFill/>
@@ -10329,13 +10705,13 @@
       </p:sp>
       <p:sp>
         <p:nvSpPr>
-          <p:cNvPr id="16" name="TextBox 15"/>
+          <p:cNvPr id="19" name="TextBox 18"/>
           <p:cNvSpPr txBox="1"/>
           <p:nvPr/>
         </p:nvSpPr>
         <p:spPr>
           <a:xfrm>
-            <a:off x="6970603" y="1353312"/>
+            <a:off x="5330823" y="1353312"/>
             <a:ext cx="1530052" cy="313822"/>
           </a:xfrm>
           <a:prstGeom prst="rect">
@@ -10358,20 +10734,20 @@
                 <a:latin typeface="Heebo"/>
                 <a:cs typeface="Heebo"/>
               </a:rPr>
-              <a:t>שם יעודכן</a:t>
-            </a:r>
-          </a:p>
-        </p:txBody>
-      </p:sp>
-      <p:sp>
-        <p:nvSpPr>
-          <p:cNvPr id="17" name="TextBox 16"/>
+              <a:t>נגה ארבל</a:t>
+            </a:r>
+          </a:p>
+        </p:txBody>
+      </p:sp>
+      <p:sp>
+        <p:nvSpPr>
+          <p:cNvPr id="20" name="TextBox 19"/>
           <p:cNvSpPr txBox="1"/>
           <p:nvPr/>
         </p:nvSpPr>
         <p:spPr>
           <a:xfrm>
-            <a:off x="6970603" y="1630375"/>
+            <a:off x="5330823" y="1630375"/>
             <a:ext cx="1530052" cy="241401"/>
           </a:xfrm>
           <a:prstGeom prst="rect">
@@ -10394,20 +10770,20 @@
                 <a:latin typeface="Heebo"/>
                 <a:cs typeface="Heebo"/>
               </a:rPr>
-              <a:t>ראש תחום התיישבות</a:t>
-            </a:r>
-          </a:p>
-        </p:txBody>
-      </p:sp>
-      <p:sp>
-        <p:nvSpPr>
-          <p:cNvPr id="18" name="Rounded Rectangle 17"/>
+              <a:t>ראש תחום חקיקה</a:t>
+            </a:r>
+          </a:p>
+        </p:txBody>
+      </p:sp>
+      <p:sp>
+        <p:nvSpPr>
+          <p:cNvPr id="21" name="Rounded Rectangle 20"/>
           <p:cNvSpPr/>
           <p:nvPr/>
         </p:nvSpPr>
         <p:spPr>
           <a:xfrm>
-            <a:off x="5330823" y="1298448"/>
+            <a:off x="3691043" y="1298448"/>
             <a:ext cx="1530052" cy="603504"/>
           </a:xfrm>
           <a:prstGeom prst="roundRect">
@@ -10447,13 +10823,13 @@
       </p:sp>
       <p:sp>
         <p:nvSpPr>
-          <p:cNvPr id="19" name="TextBox 18"/>
+          <p:cNvPr id="22" name="TextBox 21"/>
           <p:cNvSpPr txBox="1"/>
           <p:nvPr/>
         </p:nvSpPr>
         <p:spPr>
           <a:xfrm>
-            <a:off x="5330823" y="1353312"/>
+            <a:off x="3691043" y="1353312"/>
             <a:ext cx="1530052" cy="313822"/>
           </a:xfrm>
           <a:prstGeom prst="rect">
@@ -10476,20 +10852,20 @@
                 <a:latin typeface="Heebo"/>
                 <a:cs typeface="Heebo"/>
               </a:rPr>
-              <a:t>שם יעודכן</a:t>
-            </a:r>
-          </a:p>
-        </p:txBody>
-      </p:sp>
-      <p:sp>
-        <p:nvSpPr>
-          <p:cNvPr id="20" name="TextBox 19"/>
+              <a:t>טל קופל</a:t>
+            </a:r>
+          </a:p>
+        </p:txBody>
+      </p:sp>
+      <p:sp>
+        <p:nvSpPr>
+          <p:cNvPr id="23" name="TextBox 22"/>
           <p:cNvSpPr txBox="1"/>
           <p:nvPr/>
         </p:nvSpPr>
         <p:spPr>
           <a:xfrm>
-            <a:off x="5330823" y="1630375"/>
+            <a:off x="3691043" y="1630375"/>
             <a:ext cx="1530052" cy="241401"/>
           </a:xfrm>
           <a:prstGeom prst="rect">
@@ -10512,20 +10888,20 @@
                 <a:latin typeface="Heebo"/>
                 <a:cs typeface="Heebo"/>
               </a:rPr>
-              <a:t>ראש תחום משפט וחוקה</a:t>
-            </a:r>
-          </a:p>
-        </p:txBody>
-      </p:sp>
-      <p:sp>
-        <p:nvSpPr>
-          <p:cNvPr id="21" name="Rounded Rectangle 20"/>
+              <a:t>ראש תחום חינוך ואתיקה</a:t>
+            </a:r>
+          </a:p>
+        </p:txBody>
+      </p:sp>
+      <p:sp>
+        <p:nvSpPr>
+          <p:cNvPr id="24" name="Rounded Rectangle 23"/>
           <p:cNvSpPr/>
           <p:nvPr/>
         </p:nvSpPr>
         <p:spPr>
           <a:xfrm>
-            <a:off x="3691043" y="1298448"/>
+            <a:off x="2051263" y="1298448"/>
             <a:ext cx="1530052" cy="603504"/>
           </a:xfrm>
           <a:prstGeom prst="roundRect">
@@ -10534,7 +10910,7 @@
             </a:avLst>
           </a:prstGeom>
           <a:solidFill>
-            <a:srgbClr val="B4BCCC"/>
+            <a:srgbClr val="D64545"/>
           </a:solidFill>
           <a:ln>
             <a:noFill/>
@@ -10565,13 +10941,13 @@
       </p:sp>
       <p:sp>
         <p:nvSpPr>
-          <p:cNvPr id="22" name="TextBox 21"/>
+          <p:cNvPr id="25" name="TextBox 24"/>
           <p:cNvSpPr txBox="1"/>
           <p:nvPr/>
         </p:nvSpPr>
         <p:spPr>
           <a:xfrm>
-            <a:off x="3691043" y="1353312"/>
+            <a:off x="2051263" y="1353312"/>
             <a:ext cx="1530052" cy="313822"/>
           </a:xfrm>
           <a:prstGeom prst="rect">
@@ -10594,20 +10970,20 @@
                 <a:latin typeface="Heebo"/>
                 <a:cs typeface="Heebo"/>
               </a:rPr>
-              <a:t>שם יעודכן</a:t>
-            </a:r>
-          </a:p>
-        </p:txBody>
-      </p:sp>
-      <p:sp>
-        <p:nvSpPr>
-          <p:cNvPr id="23" name="TextBox 22"/>
+              <a:t>עו״ד תמר ארבל</a:t>
+            </a:r>
+          </a:p>
+        </p:txBody>
+      </p:sp>
+      <p:sp>
+        <p:nvSpPr>
+          <p:cNvPr id="26" name="TextBox 25"/>
           <p:cNvSpPr txBox="1"/>
           <p:nvPr/>
         </p:nvSpPr>
         <p:spPr>
           <a:xfrm>
-            <a:off x="3691043" y="1630375"/>
+            <a:off x="2051263" y="1630375"/>
             <a:ext cx="1530052" cy="241401"/>
           </a:xfrm>
           <a:prstGeom prst="rect">
@@ -10630,20 +11006,20 @@
                 <a:latin typeface="Heebo"/>
                 <a:cs typeface="Heebo"/>
               </a:rPr>
-              <a:t>ראש תחום כלכלה ויוקר מחיה</a:t>
-            </a:r>
-          </a:p>
-        </p:txBody>
-      </p:sp>
-      <p:sp>
-        <p:nvSpPr>
-          <p:cNvPr id="24" name="Rounded Rectangle 23"/>
+              <a:t>ראש תחום משפט</a:t>
+            </a:r>
+          </a:p>
+        </p:txBody>
+      </p:sp>
+      <p:sp>
+        <p:nvSpPr>
+          <p:cNvPr id="27" name="Rounded Rectangle 26"/>
           <p:cNvSpPr/>
           <p:nvPr/>
         </p:nvSpPr>
         <p:spPr>
           <a:xfrm>
-            <a:off x="2051263" y="1298448"/>
+            <a:off x="411483" y="1298448"/>
             <a:ext cx="1530052" cy="603504"/>
           </a:xfrm>
           <a:prstGeom prst="roundRect">
@@ -10652,7 +11028,7 @@
             </a:avLst>
           </a:prstGeom>
           <a:solidFill>
-            <a:srgbClr val="B4BCCC"/>
+            <a:srgbClr val="E8892B"/>
           </a:solidFill>
           <a:ln>
             <a:noFill/>
@@ -10683,13 +11059,13 @@
       </p:sp>
       <p:sp>
         <p:nvSpPr>
-          <p:cNvPr id="25" name="TextBox 24"/>
+          <p:cNvPr id="28" name="TextBox 27"/>
           <p:cNvSpPr txBox="1"/>
           <p:nvPr/>
         </p:nvSpPr>
         <p:spPr>
           <a:xfrm>
-            <a:off x="2051263" y="1353312"/>
+            <a:off x="411483" y="1353312"/>
             <a:ext cx="1530052" cy="313822"/>
           </a:xfrm>
           <a:prstGeom prst="rect">
@@ -10712,20 +11088,20 @@
                 <a:latin typeface="Heebo"/>
                 <a:cs typeface="Heebo"/>
               </a:rPr>
-              <a:t>שם יעודכן</a:t>
-            </a:r>
-          </a:p>
-        </p:txBody>
-      </p:sp>
-      <p:sp>
-        <p:nvSpPr>
-          <p:cNvPr id="26" name="TextBox 25"/>
+              <a:t>שלומית לביא</a:t>
+            </a:r>
+          </a:p>
+        </p:txBody>
+      </p:sp>
+      <p:sp>
+        <p:nvSpPr>
+          <p:cNvPr id="29" name="TextBox 28"/>
           <p:cNvSpPr txBox="1"/>
           <p:nvPr/>
         </p:nvSpPr>
         <p:spPr>
           <a:xfrm>
-            <a:off x="2051263" y="1630375"/>
+            <a:off x="411483" y="1630375"/>
             <a:ext cx="1530052" cy="241401"/>
           </a:xfrm>
           <a:prstGeom prst="rect">
@@ -10748,125 +11124,7 @@
                 <a:latin typeface="Heebo"/>
                 <a:cs typeface="Heebo"/>
               </a:rPr>
-              <a:t>ראש תחום עלייה וקליטה</a:t>
-            </a:r>
-          </a:p>
-        </p:txBody>
-      </p:sp>
-      <p:sp>
-        <p:nvSpPr>
-          <p:cNvPr id="27" name="Rounded Rectangle 26"/>
-          <p:cNvSpPr/>
-          <p:nvPr/>
-        </p:nvSpPr>
-        <p:spPr>
-          <a:xfrm>
-            <a:off x="411483" y="1298448"/>
-            <a:ext cx="1530052" cy="603504"/>
-          </a:xfrm>
-          <a:prstGeom prst="roundRect">
-            <a:avLst>
-              <a:gd name="adj" fmla="val 18000"/>
-            </a:avLst>
-          </a:prstGeom>
-          <a:solidFill>
-            <a:srgbClr val="B4BCCC"/>
-          </a:solidFill>
-          <a:ln>
-            <a:noFill/>
-          </a:ln>
-          <a:effectLst/>
-        </p:spPr>
-        <p:style>
-          <a:lnRef idx="1">
-            <a:schemeClr val="accent1"/>
-          </a:lnRef>
-          <a:fillRef idx="3">
-            <a:schemeClr val="accent1"/>
-          </a:fillRef>
-          <a:effectRef idx="2">
-            <a:schemeClr val="accent1"/>
-          </a:effectRef>
-          <a:fontRef idx="minor">
-            <a:schemeClr val="lt1"/>
-          </a:fontRef>
-        </p:style>
-        <p:txBody>
-          <a:bodyPr rtlCol="0" anchor="ctr"/>
-          <a:lstStyle/>
-          <a:p>
-            <a:pPr algn="ctr"/>
-          </a:p>
-        </p:txBody>
-      </p:sp>
-      <p:sp>
-        <p:nvSpPr>
-          <p:cNvPr id="28" name="TextBox 27"/>
-          <p:cNvSpPr txBox="1"/>
-          <p:nvPr/>
-        </p:nvSpPr>
-        <p:spPr>
-          <a:xfrm>
-            <a:off x="411483" y="1353312"/>
-            <a:ext cx="1530052" cy="313822"/>
-          </a:xfrm>
-          <a:prstGeom prst="rect">
-            <a:avLst/>
-          </a:prstGeom>
-          <a:noFill/>
-        </p:spPr>
-        <p:txBody>
-          <a:bodyPr wrap="square" anchor="b" lIns="36576" rIns="36576" tIns="0" bIns="0">
-            <a:spAutoFit/>
-          </a:bodyPr>
-          <a:lstStyle/>
-          <a:p>
-            <a:pPr algn="ctr" rtl="1"/>
-            <a:r>
-              <a:rPr sz="1200" b="1">
-                <a:solidFill>
-                  <a:srgbClr val="FFFFFF"/>
-                </a:solidFill>
-                <a:latin typeface="Heebo"/>
-                <a:cs typeface="Heebo"/>
-              </a:rPr>
-              <a:t>שם יעודכן</a:t>
-            </a:r>
-          </a:p>
-        </p:txBody>
-      </p:sp>
-      <p:sp>
-        <p:nvSpPr>
-          <p:cNvPr id="29" name="TextBox 28"/>
-          <p:cNvSpPr txBox="1"/>
-          <p:nvPr/>
-        </p:nvSpPr>
-        <p:spPr>
-          <a:xfrm>
-            <a:off x="411483" y="1630375"/>
-            <a:ext cx="1530052" cy="241401"/>
-          </a:xfrm>
-          <a:prstGeom prst="rect">
-            <a:avLst/>
-          </a:prstGeom>
-          <a:noFill/>
-        </p:spPr>
-        <p:txBody>
-          <a:bodyPr wrap="square" anchor="t" lIns="36576" rIns="36576" tIns="0" bIns="0">
-            <a:spAutoFit/>
-          </a:bodyPr>
-          <a:lstStyle/>
-          <a:p>
-            <a:pPr algn="ctr" rtl="1"/>
-            <a:r>
-              <a:rPr sz="900" b="0">
-                <a:solidFill>
-                  <a:srgbClr val="FFFFFF"/>
-                </a:solidFill>
-                <a:latin typeface="Heebo"/>
-                <a:cs typeface="Heebo"/>
-              </a:rPr>
-              <a:t>ראש תחום ביטחון לאומי</a:t>
+              <a:t>ראש תחום רווחה</a:t>
             </a:r>
           </a:p>
         </p:txBody>

</xml_diff>

<commit_message>
Activists: add Stav Roth
Co-Authored-By: Claude Opus 5.5 <noreply@anthropic.com>
Claude-Session: https://claude.ai/code/session_01W7Er83FuNT4pLFShWidYHn
</commit_message>
<xml_diff>
--- a/presentation/out/koach-hitarvut.pptx
+++ b/presentation/out/koach-hitarvut.pptx
@@ -8338,6 +8338,134 @@
         </p:nvSpPr>
         <p:spPr>
           <a:xfrm>
+            <a:off x="3868697" y="4882896"/>
+            <a:ext cx="1417711" cy="329184"/>
+          </a:xfrm>
+          <a:prstGeom prst="roundRect">
+            <a:avLst>
+              <a:gd name="adj" fmla="val 18000"/>
+            </a:avLst>
+          </a:prstGeom>
+          <a:solidFill>
+            <a:srgbClr val="FFFFFF"/>
+          </a:solidFill>
+          <a:ln w="15875">
+            <a:solidFill>
+              <a:srgbClr val="C5CDDD"/>
+            </a:solidFill>
+          </a:ln>
+          <a:effectLst/>
+        </p:spPr>
+        <p:style>
+          <a:lnRef idx="1">
+            <a:schemeClr val="accent1"/>
+          </a:lnRef>
+          <a:fillRef idx="3">
+            <a:schemeClr val="accent1"/>
+          </a:fillRef>
+          <a:effectRef idx="2">
+            <a:schemeClr val="accent1"/>
+          </a:effectRef>
+          <a:fontRef idx="minor">
+            <a:schemeClr val="lt1"/>
+          </a:fontRef>
+        </p:style>
+        <p:txBody>
+          <a:bodyPr rtlCol="0" anchor="ctr"/>
+          <a:lstStyle/>
+          <a:p>
+            <a:pPr algn="ctr"/>
+          </a:p>
+        </p:txBody>
+      </p:sp>
+      <p:sp>
+        <p:nvSpPr>
+          <p:cNvPr id="128" name="Rectangle 127"/>
+          <p:cNvSpPr/>
+          <p:nvPr/>
+        </p:nvSpPr>
+        <p:spPr>
+          <a:xfrm>
+            <a:off x="5222400" y="4956048"/>
+            <a:ext cx="45720" cy="182880"/>
+          </a:xfrm>
+          <a:prstGeom prst="rect">
+            <a:avLst/>
+          </a:prstGeom>
+          <a:solidFill>
+            <a:srgbClr val="F0C000"/>
+          </a:solidFill>
+          <a:ln>
+            <a:noFill/>
+          </a:ln>
+          <a:effectLst/>
+        </p:spPr>
+        <p:style>
+          <a:lnRef idx="1">
+            <a:schemeClr val="accent1"/>
+          </a:lnRef>
+          <a:fillRef idx="3">
+            <a:schemeClr val="accent1"/>
+          </a:fillRef>
+          <a:effectRef idx="2">
+            <a:schemeClr val="accent1"/>
+          </a:effectRef>
+          <a:fontRef idx="minor">
+            <a:schemeClr val="lt1"/>
+          </a:fontRef>
+        </p:style>
+        <p:txBody>
+          <a:bodyPr rtlCol="0" anchor="ctr"/>
+          <a:lstStyle/>
+          <a:p>
+            <a:pPr algn="ctr"/>
+          </a:p>
+        </p:txBody>
+      </p:sp>
+      <p:sp>
+        <p:nvSpPr>
+          <p:cNvPr id="129" name="TextBox 128"/>
+          <p:cNvSpPr txBox="1"/>
+          <p:nvPr/>
+        </p:nvSpPr>
+        <p:spPr>
+          <a:xfrm>
+            <a:off x="3868697" y="4882896"/>
+            <a:ext cx="1417711" cy="329184"/>
+          </a:xfrm>
+          <a:prstGeom prst="rect">
+            <a:avLst/>
+          </a:prstGeom>
+          <a:noFill/>
+        </p:spPr>
+        <p:txBody>
+          <a:bodyPr wrap="square" anchor="ctr" lIns="36576" rIns="36576" tIns="0" bIns="0">
+            <a:spAutoFit/>
+          </a:bodyPr>
+          <a:lstStyle/>
+          <a:p>
+            <a:pPr algn="ctr" rtl="1"/>
+            <a:r>
+              <a:rPr sz="1100" b="1">
+                <a:solidFill>
+                  <a:srgbClr val="1A2233"/>
+                </a:solidFill>
+                <a:latin typeface="Heebo"/>
+                <a:cs typeface="Heebo"/>
+              </a:rPr>
+              <a:t>סתיו רוט</a:t>
+            </a:r>
+          </a:p>
+        </p:txBody>
+      </p:sp>
+      <p:sp>
+        <p:nvSpPr>
+          <p:cNvPr id="130" name="Rounded Rectangle 129"/>
+          <p:cNvSpPr/>
+          <p:nvPr/>
+        </p:nvSpPr>
+        <p:spPr>
+          <a:xfrm>
             <a:off x="411483" y="3182112"/>
             <a:ext cx="3091454" cy="2560320"/>
           </a:xfrm>
@@ -8378,7 +8506,7 @@
       </p:sp>
       <p:sp>
         <p:nvSpPr>
-          <p:cNvPr id="128" name="Rounded Rectangle 127"/>
+          <p:cNvPr id="131" name="Rounded Rectangle 130"/>
           <p:cNvSpPr/>
           <p:nvPr/>
         </p:nvSpPr>
@@ -8426,7 +8554,7 @@
       </p:sp>
       <p:sp>
         <p:nvSpPr>
-          <p:cNvPr id="129" name="Rectangle 128"/>
+          <p:cNvPr id="132" name="Rectangle 131"/>
           <p:cNvSpPr/>
           <p:nvPr/>
         </p:nvSpPr>
@@ -8470,7 +8598,7 @@
       </p:sp>
       <p:sp>
         <p:nvSpPr>
-          <p:cNvPr id="130" name="TextBox 129"/>
+          <p:cNvPr id="133" name="TextBox 132"/>
           <p:cNvSpPr txBox="1"/>
           <p:nvPr/>
         </p:nvSpPr>
@@ -8506,7 +8634,7 @@
       </p:sp>
       <p:sp>
         <p:nvSpPr>
-          <p:cNvPr id="131" name="TextBox 130"/>
+          <p:cNvPr id="134" name="TextBox 133"/>
           <p:cNvSpPr txBox="1"/>
           <p:nvPr/>
         </p:nvSpPr>
@@ -8542,7 +8670,7 @@
       </p:sp>
       <p:sp>
         <p:nvSpPr>
-          <p:cNvPr id="132" name="Rounded Rectangle 131"/>
+          <p:cNvPr id="135" name="Rounded Rectangle 134"/>
           <p:cNvSpPr/>
           <p:nvPr/>
         </p:nvSpPr>
@@ -8590,7 +8718,7 @@
       </p:sp>
       <p:sp>
         <p:nvSpPr>
-          <p:cNvPr id="133" name="Rectangle 132"/>
+          <p:cNvPr id="136" name="Rectangle 135"/>
           <p:cNvSpPr/>
           <p:nvPr/>
         </p:nvSpPr>
@@ -8634,7 +8762,7 @@
       </p:sp>
       <p:sp>
         <p:nvSpPr>
-          <p:cNvPr id="134" name="TextBox 133"/>
+          <p:cNvPr id="137" name="TextBox 136"/>
           <p:cNvSpPr txBox="1"/>
           <p:nvPr/>
         </p:nvSpPr>
@@ -8670,7 +8798,7 @@
       </p:sp>
       <p:sp>
         <p:nvSpPr>
-          <p:cNvPr id="135" name="TextBox 134"/>
+          <p:cNvPr id="138" name="TextBox 137"/>
           <p:cNvSpPr txBox="1"/>
           <p:nvPr/>
         </p:nvSpPr>
@@ -8706,7 +8834,7 @@
       </p:sp>
       <p:sp>
         <p:nvSpPr>
-          <p:cNvPr id="136" name="Rounded Rectangle 135"/>
+          <p:cNvPr id="139" name="Rounded Rectangle 138"/>
           <p:cNvSpPr/>
           <p:nvPr/>
         </p:nvSpPr>
@@ -8754,7 +8882,7 @@
       </p:sp>
       <p:sp>
         <p:nvSpPr>
-          <p:cNvPr id="137" name="Rectangle 136"/>
+          <p:cNvPr id="140" name="Rectangle 139"/>
           <p:cNvSpPr/>
           <p:nvPr/>
         </p:nvSpPr>
@@ -8798,7 +8926,7 @@
       </p:sp>
       <p:sp>
         <p:nvSpPr>
-          <p:cNvPr id="138" name="TextBox 137"/>
+          <p:cNvPr id="141" name="TextBox 140"/>
           <p:cNvSpPr txBox="1"/>
           <p:nvPr/>
         </p:nvSpPr>
@@ -8834,7 +8962,7 @@
       </p:sp>
       <p:sp>
         <p:nvSpPr>
-          <p:cNvPr id="139" name="TextBox 138"/>
+          <p:cNvPr id="142" name="TextBox 141"/>
           <p:cNvSpPr txBox="1"/>
           <p:nvPr/>
         </p:nvSpPr>
@@ -8870,7 +8998,7 @@
       </p:sp>
       <p:sp>
         <p:nvSpPr>
-          <p:cNvPr id="140" name="Rounded Rectangle 139"/>
+          <p:cNvPr id="143" name="Rounded Rectangle 142"/>
           <p:cNvSpPr/>
           <p:nvPr/>
         </p:nvSpPr>
@@ -8918,7 +9046,7 @@
       </p:sp>
       <p:sp>
         <p:nvSpPr>
-          <p:cNvPr id="141" name="Rectangle 140"/>
+          <p:cNvPr id="144" name="Rectangle 143"/>
           <p:cNvSpPr/>
           <p:nvPr/>
         </p:nvSpPr>
@@ -8962,7 +9090,7 @@
       </p:sp>
       <p:sp>
         <p:nvSpPr>
-          <p:cNvPr id="142" name="TextBox 141"/>
+          <p:cNvPr id="145" name="TextBox 144"/>
           <p:cNvSpPr txBox="1"/>
           <p:nvPr/>
         </p:nvSpPr>
@@ -8998,7 +9126,7 @@
       </p:sp>
       <p:sp>
         <p:nvSpPr>
-          <p:cNvPr id="143" name="TextBox 142"/>
+          <p:cNvPr id="146" name="TextBox 145"/>
           <p:cNvSpPr txBox="1"/>
           <p:nvPr/>
         </p:nvSpPr>
@@ -9034,7 +9162,7 @@
       </p:sp>
       <p:sp>
         <p:nvSpPr>
-          <p:cNvPr id="144" name="Rounded Rectangle 143"/>
+          <p:cNvPr id="147" name="Rounded Rectangle 146"/>
           <p:cNvSpPr/>
           <p:nvPr/>
         </p:nvSpPr>
@@ -9082,7 +9210,7 @@
       </p:sp>
       <p:sp>
         <p:nvSpPr>
-          <p:cNvPr id="145" name="Rectangle 144"/>
+          <p:cNvPr id="148" name="Rectangle 147"/>
           <p:cNvSpPr/>
           <p:nvPr/>
         </p:nvSpPr>
@@ -9126,7 +9254,7 @@
       </p:sp>
       <p:sp>
         <p:nvSpPr>
-          <p:cNvPr id="146" name="TextBox 145"/>
+          <p:cNvPr id="149" name="TextBox 148"/>
           <p:cNvSpPr txBox="1"/>
           <p:nvPr/>
         </p:nvSpPr>
@@ -9162,7 +9290,7 @@
       </p:sp>
       <p:sp>
         <p:nvSpPr>
-          <p:cNvPr id="147" name="TextBox 146"/>
+          <p:cNvPr id="150" name="TextBox 149"/>
           <p:cNvSpPr txBox="1"/>
           <p:nvPr/>
         </p:nvSpPr>
@@ -9198,7 +9326,7 @@
       </p:sp>
       <p:sp>
         <p:nvSpPr>
-          <p:cNvPr id="148" name="Rounded Rectangle 147"/>
+          <p:cNvPr id="151" name="Rounded Rectangle 150"/>
           <p:cNvSpPr/>
           <p:nvPr/>
         </p:nvSpPr>
@@ -9246,7 +9374,7 @@
       </p:sp>
       <p:sp>
         <p:nvSpPr>
-          <p:cNvPr id="149" name="Rectangle 148"/>
+          <p:cNvPr id="152" name="Rectangle 151"/>
           <p:cNvSpPr/>
           <p:nvPr/>
         </p:nvSpPr>
@@ -9290,7 +9418,7 @@
       </p:sp>
       <p:sp>
         <p:nvSpPr>
-          <p:cNvPr id="150" name="TextBox 149"/>
+          <p:cNvPr id="153" name="TextBox 152"/>
           <p:cNvSpPr txBox="1"/>
           <p:nvPr/>
         </p:nvSpPr>
@@ -9326,7 +9454,7 @@
       </p:sp>
       <p:sp>
         <p:nvSpPr>
-          <p:cNvPr id="151" name="Rounded Rectangle 150"/>
+          <p:cNvPr id="154" name="Rounded Rectangle 153"/>
           <p:cNvSpPr/>
           <p:nvPr/>
         </p:nvSpPr>
@@ -9374,7 +9502,7 @@
       </p:sp>
       <p:sp>
         <p:nvSpPr>
-          <p:cNvPr id="152" name="Rectangle 151"/>
+          <p:cNvPr id="155" name="Rectangle 154"/>
           <p:cNvSpPr/>
           <p:nvPr/>
         </p:nvSpPr>
@@ -9418,7 +9546,7 @@
       </p:sp>
       <p:sp>
         <p:nvSpPr>
-          <p:cNvPr id="153" name="TextBox 152"/>
+          <p:cNvPr id="156" name="TextBox 155"/>
           <p:cNvSpPr txBox="1"/>
           <p:nvPr/>
         </p:nvSpPr>
@@ -9454,7 +9582,7 @@
       </p:sp>
       <p:sp>
         <p:nvSpPr>
-          <p:cNvPr id="154" name="Rounded Rectangle 153"/>
+          <p:cNvPr id="157" name="Rounded Rectangle 156"/>
           <p:cNvSpPr/>
           <p:nvPr/>
         </p:nvSpPr>
@@ -9502,7 +9630,7 @@
       </p:sp>
       <p:sp>
         <p:nvSpPr>
-          <p:cNvPr id="155" name="Rectangle 154"/>
+          <p:cNvPr id="158" name="Rectangle 157"/>
           <p:cNvSpPr/>
           <p:nvPr/>
         </p:nvSpPr>
@@ -9546,7 +9674,7 @@
       </p:sp>
       <p:sp>
         <p:nvSpPr>
-          <p:cNvPr id="156" name="TextBox 155"/>
+          <p:cNvPr id="159" name="TextBox 158"/>
           <p:cNvSpPr txBox="1"/>
           <p:nvPr/>
         </p:nvSpPr>
@@ -9582,7 +9710,7 @@
       </p:sp>
       <p:sp>
         <p:nvSpPr>
-          <p:cNvPr id="157" name="Rounded Rectangle 156"/>
+          <p:cNvPr id="160" name="Rounded Rectangle 159"/>
           <p:cNvSpPr/>
           <p:nvPr/>
         </p:nvSpPr>
@@ -9630,7 +9758,7 @@
       </p:sp>
       <p:sp>
         <p:nvSpPr>
-          <p:cNvPr id="158" name="Rectangle 157"/>
+          <p:cNvPr id="161" name="Rectangle 160"/>
           <p:cNvSpPr/>
           <p:nvPr/>
         </p:nvSpPr>
@@ -9674,7 +9802,7 @@
       </p:sp>
       <p:sp>
         <p:nvSpPr>
-          <p:cNvPr id="159" name="TextBox 158"/>
+          <p:cNvPr id="162" name="TextBox 161"/>
           <p:cNvSpPr txBox="1"/>
           <p:nvPr/>
         </p:nvSpPr>
@@ -9710,7 +9838,7 @@
       </p:sp>
       <p:sp>
         <p:nvSpPr>
-          <p:cNvPr id="160" name="Rounded Rectangle 159"/>
+          <p:cNvPr id="163" name="Rounded Rectangle 162"/>
           <p:cNvSpPr/>
           <p:nvPr/>
         </p:nvSpPr>
@@ -9758,7 +9886,7 @@
       </p:sp>
       <p:sp>
         <p:nvSpPr>
-          <p:cNvPr id="161" name="Rectangle 160"/>
+          <p:cNvPr id="164" name="Rectangle 163"/>
           <p:cNvSpPr/>
           <p:nvPr/>
         </p:nvSpPr>
@@ -9802,7 +9930,7 @@
       </p:sp>
       <p:sp>
         <p:nvSpPr>
-          <p:cNvPr id="162" name="TextBox 161"/>
+          <p:cNvPr id="165" name="TextBox 164"/>
           <p:cNvSpPr txBox="1"/>
           <p:nvPr/>
         </p:nvSpPr>
@@ -9838,7 +9966,7 @@
       </p:sp>
       <p:cxnSp>
         <p:nvCxnSpPr>
-          <p:cNvPr id="163" name="Connector 162"/>
+          <p:cNvPr id="166" name="Connector 165"/>
           <p:cNvCxnSpPr/>
           <p:nvPr/>
         </p:nvCxnSpPr>
@@ -9873,7 +10001,7 @@
       </p:cxnSp>
       <p:cxnSp>
         <p:nvCxnSpPr>
-          <p:cNvPr id="164" name="Connector 163"/>
+          <p:cNvPr id="167" name="Connector 166"/>
           <p:cNvCxnSpPr/>
           <p:nvPr/>
         </p:nvCxnSpPr>
@@ -9908,7 +10036,7 @@
       </p:cxnSp>
       <p:cxnSp>
         <p:nvCxnSpPr>
-          <p:cNvPr id="165" name="Connector 164"/>
+          <p:cNvPr id="168" name="Connector 167"/>
           <p:cNvCxnSpPr/>
           <p:nvPr/>
         </p:nvCxnSpPr>
@@ -9943,7 +10071,7 @@
       </p:cxnSp>
       <p:cxnSp>
         <p:nvCxnSpPr>
-          <p:cNvPr id="166" name="Connector 165"/>
+          <p:cNvPr id="169" name="Connector 168"/>
           <p:cNvCxnSpPr/>
           <p:nvPr/>
         </p:nvCxnSpPr>
@@ -9978,7 +10106,7 @@
       </p:cxnSp>
       <p:cxnSp>
         <p:nvCxnSpPr>
-          <p:cNvPr id="167" name="Connector 166"/>
+          <p:cNvPr id="170" name="Connector 169"/>
           <p:cNvCxnSpPr/>
           <p:nvPr/>
         </p:nvCxnSpPr>
@@ -13668,6 +13796,88 @@
         </p:nvSpPr>
         <p:spPr>
           <a:xfrm>
+            <a:off x="3868697" y="4882896"/>
+            <a:ext cx="1417711" cy="329184"/>
+          </a:xfrm>
+          <a:prstGeom prst="roundRect">
+            <a:avLst>
+              <a:gd name="adj" fmla="val 18000"/>
+            </a:avLst>
+          </a:prstGeom>
+          <a:solidFill>
+            <a:srgbClr val="E8892B"/>
+          </a:solidFill>
+          <a:ln>
+            <a:noFill/>
+          </a:ln>
+          <a:effectLst/>
+        </p:spPr>
+        <p:style>
+          <a:lnRef idx="1">
+            <a:schemeClr val="accent1"/>
+          </a:lnRef>
+          <a:fillRef idx="3">
+            <a:schemeClr val="accent1"/>
+          </a:fillRef>
+          <a:effectRef idx="2">
+            <a:schemeClr val="accent1"/>
+          </a:effectRef>
+          <a:fontRef idx="minor">
+            <a:schemeClr val="lt1"/>
+          </a:fontRef>
+        </p:style>
+        <p:txBody>
+          <a:bodyPr rtlCol="0" anchor="ctr"/>
+          <a:lstStyle/>
+          <a:p>
+            <a:pPr algn="ctr"/>
+          </a:p>
+        </p:txBody>
+      </p:sp>
+      <p:sp>
+        <p:nvSpPr>
+          <p:cNvPr id="93" name="TextBox 92"/>
+          <p:cNvSpPr txBox="1"/>
+          <p:nvPr/>
+        </p:nvSpPr>
+        <p:spPr>
+          <a:xfrm>
+            <a:off x="3868697" y="4882896"/>
+            <a:ext cx="1417711" cy="329184"/>
+          </a:xfrm>
+          <a:prstGeom prst="rect">
+            <a:avLst/>
+          </a:prstGeom>
+          <a:noFill/>
+        </p:spPr>
+        <p:txBody>
+          <a:bodyPr wrap="square" anchor="ctr" lIns="36576" rIns="36576" tIns="0" bIns="0">
+            <a:spAutoFit/>
+          </a:bodyPr>
+          <a:lstStyle/>
+          <a:p>
+            <a:pPr algn="ctr" rtl="1"/>
+            <a:r>
+              <a:rPr sz="1100" b="1">
+                <a:solidFill>
+                  <a:srgbClr val="FFFFFF"/>
+                </a:solidFill>
+                <a:latin typeface="Heebo"/>
+                <a:cs typeface="Heebo"/>
+              </a:rPr>
+              <a:t>סתיו רוט</a:t>
+            </a:r>
+          </a:p>
+        </p:txBody>
+      </p:sp>
+      <p:sp>
+        <p:nvSpPr>
+          <p:cNvPr id="94" name="Rounded Rectangle 93"/>
+          <p:cNvSpPr/>
+          <p:nvPr/>
+        </p:nvSpPr>
+        <p:spPr>
+          <a:xfrm>
             <a:off x="411483" y="3182112"/>
             <a:ext cx="3091454" cy="2560320"/>
           </a:xfrm>
@@ -13708,7 +13918,7 @@
       </p:sp>
       <p:sp>
         <p:nvSpPr>
-          <p:cNvPr id="93" name="Rounded Rectangle 92"/>
+          <p:cNvPr id="95" name="Rounded Rectangle 94"/>
           <p:cNvSpPr/>
           <p:nvPr/>
         </p:nvSpPr>
@@ -13754,7 +13964,7 @@
       </p:sp>
       <p:sp>
         <p:nvSpPr>
-          <p:cNvPr id="94" name="TextBox 93"/>
+          <p:cNvPr id="96" name="TextBox 95"/>
           <p:cNvSpPr txBox="1"/>
           <p:nvPr/>
         </p:nvSpPr>
@@ -13790,7 +14000,7 @@
       </p:sp>
       <p:sp>
         <p:nvSpPr>
-          <p:cNvPr id="95" name="TextBox 94"/>
+          <p:cNvPr id="97" name="TextBox 96"/>
           <p:cNvSpPr txBox="1"/>
           <p:nvPr/>
         </p:nvSpPr>
@@ -13826,7 +14036,7 @@
       </p:sp>
       <p:sp>
         <p:nvSpPr>
-          <p:cNvPr id="96" name="Rounded Rectangle 95"/>
+          <p:cNvPr id="98" name="Rounded Rectangle 97"/>
           <p:cNvSpPr/>
           <p:nvPr/>
         </p:nvSpPr>
@@ -13872,7 +14082,7 @@
       </p:sp>
       <p:sp>
         <p:nvSpPr>
-          <p:cNvPr id="97" name="TextBox 96"/>
+          <p:cNvPr id="99" name="TextBox 98"/>
           <p:cNvSpPr txBox="1"/>
           <p:nvPr/>
         </p:nvSpPr>
@@ -13908,7 +14118,7 @@
       </p:sp>
       <p:sp>
         <p:nvSpPr>
-          <p:cNvPr id="98" name="TextBox 97"/>
+          <p:cNvPr id="100" name="TextBox 99"/>
           <p:cNvSpPr txBox="1"/>
           <p:nvPr/>
         </p:nvSpPr>
@@ -13944,7 +14154,7 @@
       </p:sp>
       <p:sp>
         <p:nvSpPr>
-          <p:cNvPr id="99" name="Rounded Rectangle 98"/>
+          <p:cNvPr id="101" name="Rounded Rectangle 100"/>
           <p:cNvSpPr/>
           <p:nvPr/>
         </p:nvSpPr>
@@ -13990,7 +14200,7 @@
       </p:sp>
       <p:sp>
         <p:nvSpPr>
-          <p:cNvPr id="100" name="TextBox 99"/>
+          <p:cNvPr id="102" name="TextBox 101"/>
           <p:cNvSpPr txBox="1"/>
           <p:nvPr/>
         </p:nvSpPr>
@@ -14026,7 +14236,7 @@
       </p:sp>
       <p:sp>
         <p:nvSpPr>
-          <p:cNvPr id="101" name="TextBox 100"/>
+          <p:cNvPr id="103" name="TextBox 102"/>
           <p:cNvSpPr txBox="1"/>
           <p:nvPr/>
         </p:nvSpPr>
@@ -14062,7 +14272,7 @@
       </p:sp>
       <p:sp>
         <p:nvSpPr>
-          <p:cNvPr id="102" name="Rounded Rectangle 101"/>
+          <p:cNvPr id="104" name="Rounded Rectangle 103"/>
           <p:cNvSpPr/>
           <p:nvPr/>
         </p:nvSpPr>
@@ -14108,7 +14318,7 @@
       </p:sp>
       <p:sp>
         <p:nvSpPr>
-          <p:cNvPr id="103" name="TextBox 102"/>
+          <p:cNvPr id="105" name="TextBox 104"/>
           <p:cNvSpPr txBox="1"/>
           <p:nvPr/>
         </p:nvSpPr>
@@ -14144,7 +14354,7 @@
       </p:sp>
       <p:sp>
         <p:nvSpPr>
-          <p:cNvPr id="104" name="TextBox 103"/>
+          <p:cNvPr id="106" name="TextBox 105"/>
           <p:cNvSpPr txBox="1"/>
           <p:nvPr/>
         </p:nvSpPr>
@@ -14180,7 +14390,7 @@
       </p:sp>
       <p:sp>
         <p:nvSpPr>
-          <p:cNvPr id="105" name="Rounded Rectangle 104"/>
+          <p:cNvPr id="107" name="Rounded Rectangle 106"/>
           <p:cNvSpPr/>
           <p:nvPr/>
         </p:nvSpPr>
@@ -14226,7 +14436,7 @@
       </p:sp>
       <p:sp>
         <p:nvSpPr>
-          <p:cNvPr id="106" name="TextBox 105"/>
+          <p:cNvPr id="108" name="TextBox 107"/>
           <p:cNvSpPr txBox="1"/>
           <p:nvPr/>
         </p:nvSpPr>
@@ -14262,7 +14472,7 @@
       </p:sp>
       <p:sp>
         <p:nvSpPr>
-          <p:cNvPr id="107" name="TextBox 106"/>
+          <p:cNvPr id="109" name="TextBox 108"/>
           <p:cNvSpPr txBox="1"/>
           <p:nvPr/>
         </p:nvSpPr>
@@ -14298,7 +14508,7 @@
       </p:sp>
       <p:sp>
         <p:nvSpPr>
-          <p:cNvPr id="108" name="Rounded Rectangle 107"/>
+          <p:cNvPr id="110" name="Rounded Rectangle 109"/>
           <p:cNvSpPr/>
           <p:nvPr/>
         </p:nvSpPr>
@@ -14344,7 +14554,7 @@
       </p:sp>
       <p:sp>
         <p:nvSpPr>
-          <p:cNvPr id="109" name="TextBox 108"/>
+          <p:cNvPr id="111" name="TextBox 110"/>
           <p:cNvSpPr txBox="1"/>
           <p:nvPr/>
         </p:nvSpPr>
@@ -14380,7 +14590,7 @@
       </p:sp>
       <p:sp>
         <p:nvSpPr>
-          <p:cNvPr id="110" name="Rounded Rectangle 109"/>
+          <p:cNvPr id="112" name="Rounded Rectangle 111"/>
           <p:cNvSpPr/>
           <p:nvPr/>
         </p:nvSpPr>
@@ -14426,7 +14636,7 @@
       </p:sp>
       <p:sp>
         <p:nvSpPr>
-          <p:cNvPr id="111" name="TextBox 110"/>
+          <p:cNvPr id="113" name="TextBox 112"/>
           <p:cNvSpPr txBox="1"/>
           <p:nvPr/>
         </p:nvSpPr>
@@ -14462,7 +14672,7 @@
       </p:sp>
       <p:sp>
         <p:nvSpPr>
-          <p:cNvPr id="112" name="Rounded Rectangle 111"/>
+          <p:cNvPr id="114" name="Rounded Rectangle 113"/>
           <p:cNvSpPr/>
           <p:nvPr/>
         </p:nvSpPr>
@@ -14508,7 +14718,7 @@
       </p:sp>
       <p:sp>
         <p:nvSpPr>
-          <p:cNvPr id="113" name="TextBox 112"/>
+          <p:cNvPr id="115" name="TextBox 114"/>
           <p:cNvSpPr txBox="1"/>
           <p:nvPr/>
         </p:nvSpPr>
@@ -14544,7 +14754,7 @@
       </p:sp>
       <p:sp>
         <p:nvSpPr>
-          <p:cNvPr id="114" name="Rounded Rectangle 113"/>
+          <p:cNvPr id="116" name="Rounded Rectangle 115"/>
           <p:cNvSpPr/>
           <p:nvPr/>
         </p:nvSpPr>
@@ -14590,7 +14800,7 @@
       </p:sp>
       <p:sp>
         <p:nvSpPr>
-          <p:cNvPr id="115" name="TextBox 114"/>
+          <p:cNvPr id="117" name="TextBox 116"/>
           <p:cNvSpPr txBox="1"/>
           <p:nvPr/>
         </p:nvSpPr>
@@ -14626,7 +14836,7 @@
       </p:sp>
       <p:sp>
         <p:nvSpPr>
-          <p:cNvPr id="116" name="Rounded Rectangle 115"/>
+          <p:cNvPr id="118" name="Rounded Rectangle 117"/>
           <p:cNvSpPr/>
           <p:nvPr/>
         </p:nvSpPr>
@@ -14672,7 +14882,7 @@
       </p:sp>
       <p:sp>
         <p:nvSpPr>
-          <p:cNvPr id="117" name="TextBox 116"/>
+          <p:cNvPr id="119" name="TextBox 118"/>
           <p:cNvSpPr txBox="1"/>
           <p:nvPr/>
         </p:nvSpPr>
@@ -14708,83 +14918,13 @@
       </p:sp>
       <p:cxnSp>
         <p:nvCxnSpPr>
-          <p:cNvPr id="118" name="Connector 117"/>
-          <p:cNvCxnSpPr/>
-          <p:nvPr/>
-        </p:nvCxnSpPr>
-        <p:spPr>
-          <a:xfrm>
-            <a:off x="6095847" y="2615184"/>
-            <a:ext cx="0" cy="155448"/>
-          </a:xfrm>
-          <a:prstGeom prst="line">
-            <a:avLst/>
-          </a:prstGeom>
-          <a:ln w="19050">
-            <a:solidFill>
-              <a:srgbClr val="C5CDDD"/>
-            </a:solidFill>
-          </a:ln>
-        </p:spPr>
-        <p:style>
-          <a:lnRef idx="2">
-            <a:schemeClr val="accent1"/>
-          </a:lnRef>
-          <a:fillRef idx="0">
-            <a:schemeClr val="accent1"/>
-          </a:fillRef>
-          <a:effectRef idx="1">
-            <a:schemeClr val="accent1"/>
-          </a:effectRef>
-          <a:fontRef idx="minor">
-            <a:schemeClr val="tx1"/>
-          </a:fontRef>
-        </p:style>
-      </p:cxnSp>
-      <p:cxnSp>
-        <p:nvCxnSpPr>
-          <p:cNvPr id="119" name="Connector 118"/>
-          <p:cNvCxnSpPr/>
-          <p:nvPr/>
-        </p:nvCxnSpPr>
-        <p:spPr>
-          <a:xfrm>
-            <a:off x="1957210" y="2770632"/>
-            <a:ext cx="7504411" cy="0"/>
-          </a:xfrm>
-          <a:prstGeom prst="line">
-            <a:avLst/>
-          </a:prstGeom>
-          <a:ln w="19050">
-            <a:solidFill>
-              <a:srgbClr val="C5CDDD"/>
-            </a:solidFill>
-          </a:ln>
-        </p:spPr>
-        <p:style>
-          <a:lnRef idx="2">
-            <a:schemeClr val="accent1"/>
-          </a:lnRef>
-          <a:fillRef idx="0">
-            <a:schemeClr val="accent1"/>
-          </a:fillRef>
-          <a:effectRef idx="1">
-            <a:schemeClr val="accent1"/>
-          </a:effectRef>
-          <a:fontRef idx="minor">
-            <a:schemeClr val="tx1"/>
-          </a:fontRef>
-        </p:style>
-      </p:cxnSp>
-      <p:cxnSp>
-        <p:nvCxnSpPr>
           <p:cNvPr id="120" name="Connector 119"/>
           <p:cNvCxnSpPr/>
           <p:nvPr/>
         </p:nvCxnSpPr>
         <p:spPr>
           <a:xfrm>
-            <a:off x="9461621" y="2770632"/>
+            <a:off x="6095847" y="2615184"/>
             <a:ext cx="0" cy="155448"/>
           </a:xfrm>
           <a:prstGeom prst="line">
@@ -14819,8 +14959,8 @@
         </p:nvCxnSpPr>
         <p:spPr>
           <a:xfrm>
-            <a:off x="5322984" y="2770632"/>
-            <a:ext cx="0" cy="155448"/>
+            <a:off x="1957210" y="2770632"/>
+            <a:ext cx="7504411" cy="0"/>
           </a:xfrm>
           <a:prstGeom prst="line">
             <a:avLst/>
@@ -14854,7 +14994,7 @@
         </p:nvCxnSpPr>
         <p:spPr>
           <a:xfrm>
-            <a:off x="1957210" y="2770632"/>
+            <a:off x="9461621" y="2770632"/>
             <a:ext cx="0" cy="155448"/>
           </a:xfrm>
           <a:prstGeom prst="line">
@@ -14881,9 +15021,79 @@
           </a:fontRef>
         </p:style>
       </p:cxnSp>
-      <p:sp>
-        <p:nvSpPr>
-          <p:cNvPr id="123" name="Oval 122"/>
+      <p:cxnSp>
+        <p:nvCxnSpPr>
+          <p:cNvPr id="123" name="Connector 122"/>
+          <p:cNvCxnSpPr/>
+          <p:nvPr/>
+        </p:nvCxnSpPr>
+        <p:spPr>
+          <a:xfrm>
+            <a:off x="5322984" y="2770632"/>
+            <a:ext cx="0" cy="155448"/>
+          </a:xfrm>
+          <a:prstGeom prst="line">
+            <a:avLst/>
+          </a:prstGeom>
+          <a:ln w="19050">
+            <a:solidFill>
+              <a:srgbClr val="C5CDDD"/>
+            </a:solidFill>
+          </a:ln>
+        </p:spPr>
+        <p:style>
+          <a:lnRef idx="2">
+            <a:schemeClr val="accent1"/>
+          </a:lnRef>
+          <a:fillRef idx="0">
+            <a:schemeClr val="accent1"/>
+          </a:fillRef>
+          <a:effectRef idx="1">
+            <a:schemeClr val="accent1"/>
+          </a:effectRef>
+          <a:fontRef idx="minor">
+            <a:schemeClr val="tx1"/>
+          </a:fontRef>
+        </p:style>
+      </p:cxnSp>
+      <p:cxnSp>
+        <p:nvCxnSpPr>
+          <p:cNvPr id="124" name="Connector 123"/>
+          <p:cNvCxnSpPr/>
+          <p:nvPr/>
+        </p:nvCxnSpPr>
+        <p:spPr>
+          <a:xfrm>
+            <a:off x="1957210" y="2770632"/>
+            <a:ext cx="0" cy="155448"/>
+          </a:xfrm>
+          <a:prstGeom prst="line">
+            <a:avLst/>
+          </a:prstGeom>
+          <a:ln w="19050">
+            <a:solidFill>
+              <a:srgbClr val="C5CDDD"/>
+            </a:solidFill>
+          </a:ln>
+        </p:spPr>
+        <p:style>
+          <a:lnRef idx="2">
+            <a:schemeClr val="accent1"/>
+          </a:lnRef>
+          <a:fillRef idx="0">
+            <a:schemeClr val="accent1"/>
+          </a:fillRef>
+          <a:effectRef idx="1">
+            <a:schemeClr val="accent1"/>
+          </a:effectRef>
+          <a:fontRef idx="minor">
+            <a:schemeClr val="tx1"/>
+          </a:fontRef>
+        </p:style>
+      </p:cxnSp>
+      <p:sp>
+        <p:nvSpPr>
+          <p:cNvPr id="125" name="Oval 124"/>
           <p:cNvSpPr/>
           <p:nvPr/>
         </p:nvSpPr>
@@ -14927,7 +15137,7 @@
       </p:sp>
       <p:sp>
         <p:nvSpPr>
-          <p:cNvPr id="124" name="TextBox 123"/>
+          <p:cNvPr id="126" name="TextBox 125"/>
           <p:cNvSpPr txBox="1"/>
           <p:nvPr/>
         </p:nvSpPr>
@@ -14963,7 +15173,7 @@
       </p:sp>
       <p:sp>
         <p:nvSpPr>
-          <p:cNvPr id="125" name="Oval 124"/>
+          <p:cNvPr id="127" name="Oval 126"/>
           <p:cNvSpPr/>
           <p:nvPr/>
         </p:nvSpPr>
@@ -15007,7 +15217,7 @@
       </p:sp>
       <p:sp>
         <p:nvSpPr>
-          <p:cNvPr id="126" name="TextBox 125"/>
+          <p:cNvPr id="128" name="TextBox 127"/>
           <p:cNvSpPr txBox="1"/>
           <p:nvPr/>
         </p:nvSpPr>
@@ -15043,7 +15253,7 @@
       </p:sp>
       <p:sp>
         <p:nvSpPr>
-          <p:cNvPr id="127" name="Oval 126"/>
+          <p:cNvPr id="129" name="Oval 128"/>
           <p:cNvSpPr/>
           <p:nvPr/>
         </p:nvSpPr>
@@ -15087,7 +15297,7 @@
       </p:sp>
       <p:sp>
         <p:nvSpPr>
-          <p:cNvPr id="128" name="TextBox 127"/>
+          <p:cNvPr id="130" name="TextBox 129"/>
           <p:cNvSpPr txBox="1"/>
           <p:nvPr/>
         </p:nvSpPr>
@@ -15123,7 +15333,7 @@
       </p:sp>
       <p:sp>
         <p:nvSpPr>
-          <p:cNvPr id="129" name="Oval 128"/>
+          <p:cNvPr id="131" name="Oval 130"/>
           <p:cNvSpPr/>
           <p:nvPr/>
         </p:nvSpPr>
@@ -15167,7 +15377,7 @@
       </p:sp>
       <p:sp>
         <p:nvSpPr>
-          <p:cNvPr id="130" name="TextBox 129"/>
+          <p:cNvPr id="132" name="TextBox 131"/>
           <p:cNvSpPr txBox="1"/>
           <p:nvPr/>
         </p:nvSpPr>

</xml_diff>

<commit_message>
Youth group: one-third low availability
Co-Authored-By: Claude Opus 5.5 <noreply@anthropic.com>
Claude-Session: https://claude.ai/code/session_01W7Er83FuNT4pLFShWidYHn
</commit_message>
<xml_diff>
--- a/presentation/out/koach-hitarvut.pptx
+++ b/presentation/out/koach-hitarvut.pptx
@@ -15473,7 +15473,7 @@
             </a:avLst>
           </a:prstGeom>
           <a:solidFill>
-            <a:srgbClr val="E8892B"/>
+            <a:srgbClr val="D64545"/>
           </a:solidFill>
           <a:ln>
             <a:noFill/>
@@ -15555,7 +15555,7 @@
             </a:avLst>
           </a:prstGeom>
           <a:solidFill>
-            <a:srgbClr val="E8892B"/>
+            <a:srgbClr val="D64545"/>
           </a:solidFill>
           <a:ln>
             <a:noFill/>
@@ -15637,7 +15637,7 @@
             </a:avLst>
           </a:prstGeom>
           <a:solidFill>
-            <a:srgbClr val="E8892B"/>
+            <a:srgbClr val="D64545"/>
           </a:solidFill>
           <a:ln>
             <a:noFill/>
@@ -16683,7 +16683,7 @@
             </a:avLst>
           </a:prstGeom>
           <a:solidFill>
-            <a:srgbClr val="E8892B"/>
+            <a:srgbClr val="D64545"/>
           </a:solidFill>
           <a:ln>
             <a:noFill/>

</xml_diff>

<commit_message>
Slide 1: drop subtitle
Co-Authored-By: Claude Opus 5.5 <noreply@anthropic.com>
Claude-Session: https://claude.ai/code/session_01W7Er83FuNT4pLFShWidYHn
</commit_message>
<xml_diff>
--- a/presentation/out/koach-hitarvut.pptx
+++ b/presentation/out/koach-hitarvut.pptx
@@ -3223,43 +3223,7 @@
       </p:sp>
       <p:sp>
         <p:nvSpPr>
-          <p:cNvPr id="5" name="TextBox 4"/>
-          <p:cNvSpPr txBox="1"/>
-          <p:nvPr/>
-        </p:nvSpPr>
-        <p:spPr>
-          <a:xfrm>
-            <a:off x="1280160" y="530352"/>
-            <a:ext cx="10515600" cy="274320"/>
-          </a:xfrm>
-          <a:prstGeom prst="rect">
-            <a:avLst/>
-          </a:prstGeom>
-          <a:noFill/>
-        </p:spPr>
-        <p:txBody>
-          <a:bodyPr wrap="square" anchor="ctr" lIns="36576" rIns="36576" tIns="0" bIns="0">
-            <a:spAutoFit/>
-          </a:bodyPr>
-          <a:lstStyle/>
-          <a:p>
-            <a:pPr algn="r" rtl="1"/>
-            <a:r>
-              <a:rPr sz="1200" b="0">
-                <a:solidFill>
-                  <a:srgbClr val="F0C000"/>
-                </a:solidFill>
-                <a:latin typeface="Heebo"/>
-                <a:cs typeface="Heebo"/>
-              </a:rPr>
-              <a:t>כח התערבות · כנסת 26</a:t>
-            </a:r>
-          </a:p>
-        </p:txBody>
-      </p:sp>
-      <p:sp>
-        <p:nvSpPr>
-          <p:cNvPr id="7" name="Rounded Rectangle 6"/>
+          <p:cNvPr id="6" name="Rounded Rectangle 5"/>
           <p:cNvSpPr/>
           <p:nvPr/>
         </p:nvSpPr>
@@ -3305,7 +3269,7 @@
       </p:sp>
       <p:pic>
         <p:nvPicPr>
-          <p:cNvPr id="6" name="Picture 5" descr="logo.png"/>
+          <p:cNvPr id="5" name="Picture 4" descr="logo.png"/>
           <p:cNvPicPr>
             <a:picLocks noChangeAspect="1"/>
           </p:cNvPicPr>
@@ -3329,7 +3293,7 @@
       </p:pic>
       <p:sp>
         <p:nvSpPr>
-          <p:cNvPr id="8" name="TextBox 7"/>
+          <p:cNvPr id="7" name="TextBox 6"/>
           <p:cNvSpPr txBox="1"/>
           <p:nvPr/>
         </p:nvSpPr>
@@ -3365,7 +3329,7 @@
       </p:sp>
       <p:sp>
         <p:nvSpPr>
-          <p:cNvPr id="9" name="Rounded Rectangle 8"/>
+          <p:cNvPr id="8" name="Rounded Rectangle 7"/>
           <p:cNvSpPr/>
           <p:nvPr/>
         </p:nvSpPr>
@@ -3413,7 +3377,7 @@
       </p:sp>
       <p:sp>
         <p:nvSpPr>
-          <p:cNvPr id="10" name="Rectangle 9"/>
+          <p:cNvPr id="9" name="Rectangle 8"/>
           <p:cNvSpPr/>
           <p:nvPr/>
         </p:nvSpPr>
@@ -3457,7 +3421,7 @@
       </p:sp>
       <p:sp>
         <p:nvSpPr>
-          <p:cNvPr id="11" name="TextBox 10"/>
+          <p:cNvPr id="10" name="TextBox 9"/>
           <p:cNvSpPr txBox="1"/>
           <p:nvPr/>
         </p:nvSpPr>
@@ -3493,7 +3457,7 @@
       </p:sp>
       <p:sp>
         <p:nvSpPr>
-          <p:cNvPr id="12" name="TextBox 11"/>
+          <p:cNvPr id="11" name="TextBox 10"/>
           <p:cNvSpPr txBox="1"/>
           <p:nvPr/>
         </p:nvSpPr>
@@ -3529,7 +3493,7 @@
       </p:sp>
       <p:sp>
         <p:nvSpPr>
-          <p:cNvPr id="13" name="Rounded Rectangle 12"/>
+          <p:cNvPr id="12" name="Rounded Rectangle 11"/>
           <p:cNvSpPr/>
           <p:nvPr/>
         </p:nvSpPr>
@@ -3577,7 +3541,7 @@
       </p:sp>
       <p:sp>
         <p:nvSpPr>
-          <p:cNvPr id="14" name="Rectangle 13"/>
+          <p:cNvPr id="13" name="Rectangle 12"/>
           <p:cNvSpPr/>
           <p:nvPr/>
         </p:nvSpPr>
@@ -3621,7 +3585,7 @@
       </p:sp>
       <p:sp>
         <p:nvSpPr>
-          <p:cNvPr id="15" name="TextBox 14"/>
+          <p:cNvPr id="14" name="TextBox 13"/>
           <p:cNvSpPr txBox="1"/>
           <p:nvPr/>
         </p:nvSpPr>
@@ -3657,7 +3621,7 @@
       </p:sp>
       <p:sp>
         <p:nvSpPr>
-          <p:cNvPr id="16" name="TextBox 15"/>
+          <p:cNvPr id="15" name="TextBox 14"/>
           <p:cNvSpPr txBox="1"/>
           <p:nvPr/>
         </p:nvSpPr>
@@ -3693,7 +3657,7 @@
       </p:sp>
       <p:sp>
         <p:nvSpPr>
-          <p:cNvPr id="17" name="Rounded Rectangle 16"/>
+          <p:cNvPr id="16" name="Rounded Rectangle 15"/>
           <p:cNvSpPr/>
           <p:nvPr/>
         </p:nvSpPr>
@@ -3741,7 +3705,7 @@
       </p:sp>
       <p:sp>
         <p:nvSpPr>
-          <p:cNvPr id="18" name="Rectangle 17"/>
+          <p:cNvPr id="17" name="Rectangle 16"/>
           <p:cNvSpPr/>
           <p:nvPr/>
         </p:nvSpPr>
@@ -3785,7 +3749,7 @@
       </p:sp>
       <p:sp>
         <p:nvSpPr>
-          <p:cNvPr id="19" name="TextBox 18"/>
+          <p:cNvPr id="18" name="TextBox 17"/>
           <p:cNvSpPr txBox="1"/>
           <p:nvPr/>
         </p:nvSpPr>
@@ -3821,7 +3785,7 @@
       </p:sp>
       <p:sp>
         <p:nvSpPr>
-          <p:cNvPr id="20" name="TextBox 19"/>
+          <p:cNvPr id="19" name="TextBox 18"/>
           <p:cNvSpPr txBox="1"/>
           <p:nvPr/>
         </p:nvSpPr>
@@ -3857,7 +3821,7 @@
       </p:sp>
       <p:sp>
         <p:nvSpPr>
-          <p:cNvPr id="21" name="Rounded Rectangle 20"/>
+          <p:cNvPr id="20" name="Rounded Rectangle 19"/>
           <p:cNvSpPr/>
           <p:nvPr/>
         </p:nvSpPr>
@@ -3905,7 +3869,7 @@
       </p:sp>
       <p:sp>
         <p:nvSpPr>
-          <p:cNvPr id="22" name="Rectangle 21"/>
+          <p:cNvPr id="21" name="Rectangle 20"/>
           <p:cNvSpPr/>
           <p:nvPr/>
         </p:nvSpPr>
@@ -3949,7 +3913,7 @@
       </p:sp>
       <p:sp>
         <p:nvSpPr>
-          <p:cNvPr id="23" name="TextBox 22"/>
+          <p:cNvPr id="22" name="TextBox 21"/>
           <p:cNvSpPr txBox="1"/>
           <p:nvPr/>
         </p:nvSpPr>
@@ -3985,7 +3949,7 @@
       </p:sp>
       <p:sp>
         <p:nvSpPr>
-          <p:cNvPr id="24" name="TextBox 23"/>
+          <p:cNvPr id="23" name="TextBox 22"/>
           <p:cNvSpPr txBox="1"/>
           <p:nvPr/>
         </p:nvSpPr>
@@ -4021,7 +3985,7 @@
       </p:sp>
       <p:sp>
         <p:nvSpPr>
-          <p:cNvPr id="25" name="Rounded Rectangle 24"/>
+          <p:cNvPr id="24" name="Rounded Rectangle 23"/>
           <p:cNvSpPr/>
           <p:nvPr/>
         </p:nvSpPr>
@@ -4069,7 +4033,7 @@
       </p:sp>
       <p:sp>
         <p:nvSpPr>
-          <p:cNvPr id="26" name="Rectangle 25"/>
+          <p:cNvPr id="25" name="Rectangle 24"/>
           <p:cNvSpPr/>
           <p:nvPr/>
         </p:nvSpPr>
@@ -4113,7 +4077,7 @@
       </p:sp>
       <p:sp>
         <p:nvSpPr>
-          <p:cNvPr id="27" name="TextBox 26"/>
+          <p:cNvPr id="26" name="TextBox 25"/>
           <p:cNvSpPr txBox="1"/>
           <p:nvPr/>
         </p:nvSpPr>
@@ -4149,7 +4113,7 @@
       </p:sp>
       <p:sp>
         <p:nvSpPr>
-          <p:cNvPr id="28" name="TextBox 27"/>
+          <p:cNvPr id="27" name="TextBox 26"/>
           <p:cNvSpPr txBox="1"/>
           <p:nvPr/>
         </p:nvSpPr>
@@ -4185,7 +4149,7 @@
       </p:sp>
       <p:sp>
         <p:nvSpPr>
-          <p:cNvPr id="29" name="Rounded Rectangle 28"/>
+          <p:cNvPr id="28" name="Rounded Rectangle 27"/>
           <p:cNvSpPr/>
           <p:nvPr/>
         </p:nvSpPr>
@@ -4233,7 +4197,7 @@
       </p:sp>
       <p:sp>
         <p:nvSpPr>
-          <p:cNvPr id="30" name="Rectangle 29"/>
+          <p:cNvPr id="29" name="Rectangle 28"/>
           <p:cNvSpPr/>
           <p:nvPr/>
         </p:nvSpPr>
@@ -4277,7 +4241,7 @@
       </p:sp>
       <p:sp>
         <p:nvSpPr>
-          <p:cNvPr id="31" name="TextBox 30"/>
+          <p:cNvPr id="30" name="TextBox 29"/>
           <p:cNvSpPr txBox="1"/>
           <p:nvPr/>
         </p:nvSpPr>
@@ -4313,7 +4277,7 @@
       </p:sp>
       <p:sp>
         <p:nvSpPr>
-          <p:cNvPr id="32" name="TextBox 31"/>
+          <p:cNvPr id="31" name="TextBox 30"/>
           <p:cNvSpPr txBox="1"/>
           <p:nvPr/>
         </p:nvSpPr>
@@ -4349,7 +4313,7 @@
       </p:sp>
       <p:sp>
         <p:nvSpPr>
-          <p:cNvPr id="33" name="Rounded Rectangle 32"/>
+          <p:cNvPr id="32" name="Rounded Rectangle 31"/>
           <p:cNvSpPr/>
           <p:nvPr/>
         </p:nvSpPr>
@@ -4397,7 +4361,7 @@
       </p:sp>
       <p:sp>
         <p:nvSpPr>
-          <p:cNvPr id="34" name="Rectangle 33"/>
+          <p:cNvPr id="33" name="Rectangle 32"/>
           <p:cNvSpPr/>
           <p:nvPr/>
         </p:nvSpPr>
@@ -4441,7 +4405,7 @@
       </p:sp>
       <p:sp>
         <p:nvSpPr>
-          <p:cNvPr id="35" name="TextBox 34"/>
+          <p:cNvPr id="34" name="TextBox 33"/>
           <p:cNvSpPr txBox="1"/>
           <p:nvPr/>
         </p:nvSpPr>
@@ -4477,7 +4441,7 @@
       </p:sp>
       <p:sp>
         <p:nvSpPr>
-          <p:cNvPr id="36" name="TextBox 35"/>
+          <p:cNvPr id="35" name="TextBox 34"/>
           <p:cNvSpPr txBox="1"/>
           <p:nvPr/>
         </p:nvSpPr>
@@ -4513,7 +4477,7 @@
       </p:sp>
       <p:cxnSp>
         <p:nvCxnSpPr>
-          <p:cNvPr id="37" name="Connector 36"/>
+          <p:cNvPr id="36" name="Connector 35"/>
           <p:cNvCxnSpPr/>
           <p:nvPr/>
         </p:nvCxnSpPr>
@@ -4548,7 +4512,7 @@
       </p:cxnSp>
       <p:sp>
         <p:nvSpPr>
-          <p:cNvPr id="38" name="Rounded Rectangle 37"/>
+          <p:cNvPr id="37" name="Rounded Rectangle 36"/>
           <p:cNvSpPr/>
           <p:nvPr/>
         </p:nvSpPr>
@@ -4596,7 +4560,7 @@
       </p:sp>
       <p:sp>
         <p:nvSpPr>
-          <p:cNvPr id="39" name="Rectangle 38"/>
+          <p:cNvPr id="38" name="Rectangle 37"/>
           <p:cNvSpPr/>
           <p:nvPr/>
         </p:nvSpPr>
@@ -4640,7 +4604,7 @@
       </p:sp>
       <p:sp>
         <p:nvSpPr>
-          <p:cNvPr id="40" name="TextBox 39"/>
+          <p:cNvPr id="39" name="TextBox 38"/>
           <p:cNvSpPr txBox="1"/>
           <p:nvPr/>
         </p:nvSpPr>
@@ -4676,7 +4640,7 @@
       </p:sp>
       <p:sp>
         <p:nvSpPr>
-          <p:cNvPr id="41" name="TextBox 40"/>
+          <p:cNvPr id="40" name="TextBox 39"/>
           <p:cNvSpPr txBox="1"/>
           <p:nvPr/>
         </p:nvSpPr>
@@ -4712,7 +4676,7 @@
       </p:sp>
       <p:sp>
         <p:nvSpPr>
-          <p:cNvPr id="42" name="Rounded Rectangle 41"/>
+          <p:cNvPr id="41" name="Rounded Rectangle 40"/>
           <p:cNvSpPr/>
           <p:nvPr/>
         </p:nvSpPr>
@@ -4758,7 +4722,7 @@
       </p:sp>
       <p:sp>
         <p:nvSpPr>
-          <p:cNvPr id="43" name="Rounded Rectangle 42"/>
+          <p:cNvPr id="42" name="Rounded Rectangle 41"/>
           <p:cNvSpPr/>
           <p:nvPr/>
         </p:nvSpPr>
@@ -4806,7 +4770,7 @@
       </p:sp>
       <p:sp>
         <p:nvSpPr>
-          <p:cNvPr id="44" name="Rectangle 43"/>
+          <p:cNvPr id="43" name="Rectangle 42"/>
           <p:cNvSpPr/>
           <p:nvPr/>
         </p:nvSpPr>
@@ -4850,7 +4814,7 @@
       </p:sp>
       <p:sp>
         <p:nvSpPr>
-          <p:cNvPr id="45" name="TextBox 44"/>
+          <p:cNvPr id="44" name="TextBox 43"/>
           <p:cNvSpPr txBox="1"/>
           <p:nvPr/>
         </p:nvSpPr>
@@ -4886,7 +4850,7 @@
       </p:sp>
       <p:sp>
         <p:nvSpPr>
-          <p:cNvPr id="46" name="TextBox 45"/>
+          <p:cNvPr id="45" name="TextBox 44"/>
           <p:cNvSpPr txBox="1"/>
           <p:nvPr/>
         </p:nvSpPr>
@@ -4922,7 +4886,7 @@
       </p:sp>
       <p:sp>
         <p:nvSpPr>
-          <p:cNvPr id="47" name="Rounded Rectangle 46"/>
+          <p:cNvPr id="46" name="Rounded Rectangle 45"/>
           <p:cNvSpPr/>
           <p:nvPr/>
         </p:nvSpPr>
@@ -4970,7 +4934,7 @@
       </p:sp>
       <p:sp>
         <p:nvSpPr>
-          <p:cNvPr id="48" name="Rectangle 47"/>
+          <p:cNvPr id="47" name="Rectangle 46"/>
           <p:cNvSpPr/>
           <p:nvPr/>
         </p:nvSpPr>
@@ -5014,7 +4978,7 @@
       </p:sp>
       <p:sp>
         <p:nvSpPr>
-          <p:cNvPr id="49" name="TextBox 48"/>
+          <p:cNvPr id="48" name="TextBox 47"/>
           <p:cNvSpPr txBox="1"/>
           <p:nvPr/>
         </p:nvSpPr>
@@ -5050,7 +5014,7 @@
       </p:sp>
       <p:sp>
         <p:nvSpPr>
-          <p:cNvPr id="50" name="Rounded Rectangle 49"/>
+          <p:cNvPr id="49" name="Rounded Rectangle 48"/>
           <p:cNvSpPr/>
           <p:nvPr/>
         </p:nvSpPr>
@@ -5098,7 +5062,7 @@
       </p:sp>
       <p:sp>
         <p:nvSpPr>
-          <p:cNvPr id="51" name="Rectangle 50"/>
+          <p:cNvPr id="50" name="Rectangle 49"/>
           <p:cNvSpPr/>
           <p:nvPr/>
         </p:nvSpPr>
@@ -5142,7 +5106,7 @@
       </p:sp>
       <p:sp>
         <p:nvSpPr>
-          <p:cNvPr id="52" name="TextBox 51"/>
+          <p:cNvPr id="51" name="TextBox 50"/>
           <p:cNvSpPr txBox="1"/>
           <p:nvPr/>
         </p:nvSpPr>
@@ -5178,7 +5142,7 @@
       </p:sp>
       <p:sp>
         <p:nvSpPr>
-          <p:cNvPr id="53" name="Rounded Rectangle 52"/>
+          <p:cNvPr id="52" name="Rounded Rectangle 51"/>
           <p:cNvSpPr/>
           <p:nvPr/>
         </p:nvSpPr>
@@ -5226,7 +5190,7 @@
       </p:sp>
       <p:sp>
         <p:nvSpPr>
-          <p:cNvPr id="54" name="Rectangle 53"/>
+          <p:cNvPr id="53" name="Rectangle 52"/>
           <p:cNvSpPr/>
           <p:nvPr/>
         </p:nvSpPr>
@@ -5270,7 +5234,7 @@
       </p:sp>
       <p:sp>
         <p:nvSpPr>
-          <p:cNvPr id="55" name="TextBox 54"/>
+          <p:cNvPr id="54" name="TextBox 53"/>
           <p:cNvSpPr txBox="1"/>
           <p:nvPr/>
         </p:nvSpPr>
@@ -5306,7 +5270,7 @@
       </p:sp>
       <p:sp>
         <p:nvSpPr>
-          <p:cNvPr id="56" name="Rounded Rectangle 55"/>
+          <p:cNvPr id="55" name="Rounded Rectangle 54"/>
           <p:cNvSpPr/>
           <p:nvPr/>
         </p:nvSpPr>
@@ -5354,7 +5318,7 @@
       </p:sp>
       <p:sp>
         <p:nvSpPr>
-          <p:cNvPr id="57" name="Rectangle 56"/>
+          <p:cNvPr id="56" name="Rectangle 55"/>
           <p:cNvSpPr/>
           <p:nvPr/>
         </p:nvSpPr>
@@ -5398,7 +5362,7 @@
       </p:sp>
       <p:sp>
         <p:nvSpPr>
-          <p:cNvPr id="58" name="TextBox 57"/>
+          <p:cNvPr id="57" name="TextBox 56"/>
           <p:cNvSpPr txBox="1"/>
           <p:nvPr/>
         </p:nvSpPr>
@@ -5434,7 +5398,7 @@
       </p:sp>
       <p:sp>
         <p:nvSpPr>
-          <p:cNvPr id="59" name="Rounded Rectangle 58"/>
+          <p:cNvPr id="58" name="Rounded Rectangle 57"/>
           <p:cNvSpPr/>
           <p:nvPr/>
         </p:nvSpPr>
@@ -5482,7 +5446,7 @@
       </p:sp>
       <p:sp>
         <p:nvSpPr>
-          <p:cNvPr id="60" name="Rectangle 59"/>
+          <p:cNvPr id="59" name="Rectangle 58"/>
           <p:cNvSpPr/>
           <p:nvPr/>
         </p:nvSpPr>
@@ -5526,7 +5490,7 @@
       </p:sp>
       <p:sp>
         <p:nvSpPr>
-          <p:cNvPr id="61" name="TextBox 60"/>
+          <p:cNvPr id="60" name="TextBox 59"/>
           <p:cNvSpPr txBox="1"/>
           <p:nvPr/>
         </p:nvSpPr>
@@ -5562,7 +5526,7 @@
       </p:sp>
       <p:sp>
         <p:nvSpPr>
-          <p:cNvPr id="62" name="Rounded Rectangle 61"/>
+          <p:cNvPr id="61" name="Rounded Rectangle 60"/>
           <p:cNvSpPr/>
           <p:nvPr/>
         </p:nvSpPr>
@@ -5610,7 +5574,7 @@
       </p:sp>
       <p:sp>
         <p:nvSpPr>
-          <p:cNvPr id="63" name="Rectangle 62"/>
+          <p:cNvPr id="62" name="Rectangle 61"/>
           <p:cNvSpPr/>
           <p:nvPr/>
         </p:nvSpPr>
@@ -5654,7 +5618,7 @@
       </p:sp>
       <p:sp>
         <p:nvSpPr>
-          <p:cNvPr id="64" name="TextBox 63"/>
+          <p:cNvPr id="63" name="TextBox 62"/>
           <p:cNvSpPr txBox="1"/>
           <p:nvPr/>
         </p:nvSpPr>
@@ -5690,7 +5654,7 @@
       </p:sp>
       <p:sp>
         <p:nvSpPr>
-          <p:cNvPr id="65" name="Rounded Rectangle 64"/>
+          <p:cNvPr id="64" name="Rounded Rectangle 63"/>
           <p:cNvSpPr/>
           <p:nvPr/>
         </p:nvSpPr>
@@ -5738,7 +5702,7 @@
       </p:sp>
       <p:sp>
         <p:nvSpPr>
-          <p:cNvPr id="66" name="Rectangle 65"/>
+          <p:cNvPr id="65" name="Rectangle 64"/>
           <p:cNvSpPr/>
           <p:nvPr/>
         </p:nvSpPr>
@@ -5782,7 +5746,7 @@
       </p:sp>
       <p:sp>
         <p:nvSpPr>
-          <p:cNvPr id="67" name="TextBox 66"/>
+          <p:cNvPr id="66" name="TextBox 65"/>
           <p:cNvSpPr txBox="1"/>
           <p:nvPr/>
         </p:nvSpPr>
@@ -5818,7 +5782,7 @@
       </p:sp>
       <p:sp>
         <p:nvSpPr>
-          <p:cNvPr id="68" name="Rounded Rectangle 67"/>
+          <p:cNvPr id="67" name="Rounded Rectangle 66"/>
           <p:cNvSpPr/>
           <p:nvPr/>
         </p:nvSpPr>
@@ -5866,7 +5830,7 @@
       </p:sp>
       <p:sp>
         <p:nvSpPr>
-          <p:cNvPr id="69" name="Rectangle 68"/>
+          <p:cNvPr id="68" name="Rectangle 67"/>
           <p:cNvSpPr/>
           <p:nvPr/>
         </p:nvSpPr>
@@ -5910,7 +5874,7 @@
       </p:sp>
       <p:sp>
         <p:nvSpPr>
-          <p:cNvPr id="70" name="TextBox 69"/>
+          <p:cNvPr id="69" name="TextBox 68"/>
           <p:cNvSpPr txBox="1"/>
           <p:nvPr/>
         </p:nvSpPr>
@@ -5946,7 +5910,7 @@
       </p:sp>
       <p:sp>
         <p:nvSpPr>
-          <p:cNvPr id="71" name="Rounded Rectangle 70"/>
+          <p:cNvPr id="70" name="Rounded Rectangle 69"/>
           <p:cNvSpPr/>
           <p:nvPr/>
         </p:nvSpPr>
@@ -5994,7 +5958,7 @@
       </p:sp>
       <p:sp>
         <p:nvSpPr>
-          <p:cNvPr id="72" name="Rectangle 71"/>
+          <p:cNvPr id="71" name="Rectangle 70"/>
           <p:cNvSpPr/>
           <p:nvPr/>
         </p:nvSpPr>
@@ -6038,7 +6002,7 @@
       </p:sp>
       <p:sp>
         <p:nvSpPr>
-          <p:cNvPr id="73" name="TextBox 72"/>
+          <p:cNvPr id="72" name="TextBox 71"/>
           <p:cNvSpPr txBox="1"/>
           <p:nvPr/>
         </p:nvSpPr>
@@ -6074,7 +6038,7 @@
       </p:sp>
       <p:sp>
         <p:nvSpPr>
-          <p:cNvPr id="74" name="Rounded Rectangle 73"/>
+          <p:cNvPr id="73" name="Rounded Rectangle 72"/>
           <p:cNvSpPr/>
           <p:nvPr/>
         </p:nvSpPr>
@@ -6122,7 +6086,7 @@
       </p:sp>
       <p:sp>
         <p:nvSpPr>
-          <p:cNvPr id="75" name="Rectangle 74"/>
+          <p:cNvPr id="74" name="Rectangle 73"/>
           <p:cNvSpPr/>
           <p:nvPr/>
         </p:nvSpPr>
@@ -6166,7 +6130,7 @@
       </p:sp>
       <p:sp>
         <p:nvSpPr>
-          <p:cNvPr id="76" name="TextBox 75"/>
+          <p:cNvPr id="75" name="TextBox 74"/>
           <p:cNvSpPr txBox="1"/>
           <p:nvPr/>
         </p:nvSpPr>
@@ -6202,7 +6166,7 @@
       </p:sp>
       <p:sp>
         <p:nvSpPr>
-          <p:cNvPr id="77" name="Rounded Rectangle 76"/>
+          <p:cNvPr id="76" name="Rounded Rectangle 75"/>
           <p:cNvSpPr/>
           <p:nvPr/>
         </p:nvSpPr>
@@ -6250,7 +6214,7 @@
       </p:sp>
       <p:sp>
         <p:nvSpPr>
-          <p:cNvPr id="78" name="Rectangle 77"/>
+          <p:cNvPr id="77" name="Rectangle 76"/>
           <p:cNvSpPr/>
           <p:nvPr/>
         </p:nvSpPr>
@@ -6294,7 +6258,7 @@
       </p:sp>
       <p:sp>
         <p:nvSpPr>
-          <p:cNvPr id="79" name="TextBox 78"/>
+          <p:cNvPr id="78" name="TextBox 77"/>
           <p:cNvSpPr txBox="1"/>
           <p:nvPr/>
         </p:nvSpPr>
@@ -6330,7 +6294,7 @@
       </p:sp>
       <p:sp>
         <p:nvSpPr>
-          <p:cNvPr id="80" name="Rounded Rectangle 79"/>
+          <p:cNvPr id="79" name="Rounded Rectangle 78"/>
           <p:cNvSpPr/>
           <p:nvPr/>
         </p:nvSpPr>
@@ -6378,7 +6342,7 @@
       </p:sp>
       <p:sp>
         <p:nvSpPr>
-          <p:cNvPr id="81" name="Rectangle 80"/>
+          <p:cNvPr id="80" name="Rectangle 79"/>
           <p:cNvSpPr/>
           <p:nvPr/>
         </p:nvSpPr>
@@ -6422,7 +6386,7 @@
       </p:sp>
       <p:sp>
         <p:nvSpPr>
-          <p:cNvPr id="82" name="TextBox 81"/>
+          <p:cNvPr id="81" name="TextBox 80"/>
           <p:cNvSpPr txBox="1"/>
           <p:nvPr/>
         </p:nvSpPr>
@@ -6458,7 +6422,7 @@
       </p:sp>
       <p:sp>
         <p:nvSpPr>
-          <p:cNvPr id="83" name="Rounded Rectangle 82"/>
+          <p:cNvPr id="82" name="Rounded Rectangle 81"/>
           <p:cNvSpPr/>
           <p:nvPr/>
         </p:nvSpPr>
@@ -6506,7 +6470,7 @@
       </p:sp>
       <p:sp>
         <p:nvSpPr>
-          <p:cNvPr id="84" name="Rectangle 83"/>
+          <p:cNvPr id="83" name="Rectangle 82"/>
           <p:cNvSpPr/>
           <p:nvPr/>
         </p:nvSpPr>
@@ -6550,7 +6514,7 @@
       </p:sp>
       <p:sp>
         <p:nvSpPr>
-          <p:cNvPr id="85" name="TextBox 84"/>
+          <p:cNvPr id="84" name="TextBox 83"/>
           <p:cNvSpPr txBox="1"/>
           <p:nvPr/>
         </p:nvSpPr>
@@ -6586,7 +6550,7 @@
       </p:sp>
       <p:sp>
         <p:nvSpPr>
-          <p:cNvPr id="86" name="Rounded Rectangle 85"/>
+          <p:cNvPr id="85" name="Rounded Rectangle 84"/>
           <p:cNvSpPr/>
           <p:nvPr/>
         </p:nvSpPr>
@@ -6634,7 +6598,7 @@
       </p:sp>
       <p:sp>
         <p:nvSpPr>
-          <p:cNvPr id="87" name="Rectangle 86"/>
+          <p:cNvPr id="86" name="Rectangle 85"/>
           <p:cNvSpPr/>
           <p:nvPr/>
         </p:nvSpPr>
@@ -6678,7 +6642,7 @@
       </p:sp>
       <p:sp>
         <p:nvSpPr>
-          <p:cNvPr id="88" name="TextBox 87"/>
+          <p:cNvPr id="87" name="TextBox 86"/>
           <p:cNvSpPr txBox="1"/>
           <p:nvPr/>
         </p:nvSpPr>
@@ -6714,7 +6678,7 @@
       </p:sp>
       <p:sp>
         <p:nvSpPr>
-          <p:cNvPr id="89" name="Rounded Rectangle 88"/>
+          <p:cNvPr id="88" name="Rounded Rectangle 87"/>
           <p:cNvSpPr/>
           <p:nvPr/>
         </p:nvSpPr>
@@ -6762,7 +6726,7 @@
       </p:sp>
       <p:sp>
         <p:nvSpPr>
-          <p:cNvPr id="90" name="Rectangle 89"/>
+          <p:cNvPr id="89" name="Rectangle 88"/>
           <p:cNvSpPr/>
           <p:nvPr/>
         </p:nvSpPr>
@@ -6806,7 +6770,7 @@
       </p:sp>
       <p:sp>
         <p:nvSpPr>
-          <p:cNvPr id="91" name="TextBox 90"/>
+          <p:cNvPr id="90" name="TextBox 89"/>
           <p:cNvSpPr txBox="1"/>
           <p:nvPr/>
         </p:nvSpPr>
@@ -6842,7 +6806,7 @@
       </p:sp>
       <p:sp>
         <p:nvSpPr>
-          <p:cNvPr id="92" name="Rounded Rectangle 91"/>
+          <p:cNvPr id="91" name="Rounded Rectangle 90"/>
           <p:cNvSpPr/>
           <p:nvPr/>
         </p:nvSpPr>
@@ -6890,7 +6854,7 @@
       </p:sp>
       <p:sp>
         <p:nvSpPr>
-          <p:cNvPr id="93" name="Rectangle 92"/>
+          <p:cNvPr id="92" name="Rectangle 91"/>
           <p:cNvSpPr/>
           <p:nvPr/>
         </p:nvSpPr>
@@ -6934,7 +6898,7 @@
       </p:sp>
       <p:sp>
         <p:nvSpPr>
-          <p:cNvPr id="94" name="TextBox 93"/>
+          <p:cNvPr id="93" name="TextBox 92"/>
           <p:cNvSpPr txBox="1"/>
           <p:nvPr/>
         </p:nvSpPr>
@@ -6970,7 +6934,7 @@
       </p:sp>
       <p:sp>
         <p:nvSpPr>
-          <p:cNvPr id="95" name="Rounded Rectangle 94"/>
+          <p:cNvPr id="94" name="Rounded Rectangle 93"/>
           <p:cNvSpPr/>
           <p:nvPr/>
         </p:nvSpPr>
@@ -7018,7 +6982,7 @@
       </p:sp>
       <p:sp>
         <p:nvSpPr>
-          <p:cNvPr id="96" name="Rectangle 95"/>
+          <p:cNvPr id="95" name="Rectangle 94"/>
           <p:cNvSpPr/>
           <p:nvPr/>
         </p:nvSpPr>
@@ -7062,7 +7026,7 @@
       </p:sp>
       <p:sp>
         <p:nvSpPr>
-          <p:cNvPr id="97" name="TextBox 96"/>
+          <p:cNvPr id="96" name="TextBox 95"/>
           <p:cNvSpPr txBox="1"/>
           <p:nvPr/>
         </p:nvSpPr>
@@ -7098,7 +7062,7 @@
       </p:sp>
       <p:sp>
         <p:nvSpPr>
-          <p:cNvPr id="98" name="Rounded Rectangle 97"/>
+          <p:cNvPr id="97" name="Rounded Rectangle 96"/>
           <p:cNvSpPr/>
           <p:nvPr/>
         </p:nvSpPr>
@@ -7146,7 +7110,7 @@
       </p:sp>
       <p:sp>
         <p:nvSpPr>
-          <p:cNvPr id="99" name="Rectangle 98"/>
+          <p:cNvPr id="98" name="Rectangle 97"/>
           <p:cNvSpPr/>
           <p:nvPr/>
         </p:nvSpPr>
@@ -7190,7 +7154,7 @@
       </p:sp>
       <p:sp>
         <p:nvSpPr>
-          <p:cNvPr id="100" name="TextBox 99"/>
+          <p:cNvPr id="99" name="TextBox 98"/>
           <p:cNvSpPr txBox="1"/>
           <p:nvPr/>
         </p:nvSpPr>
@@ -7226,7 +7190,7 @@
       </p:sp>
       <p:sp>
         <p:nvSpPr>
-          <p:cNvPr id="101" name="Rounded Rectangle 100"/>
+          <p:cNvPr id="100" name="Rounded Rectangle 99"/>
           <p:cNvSpPr/>
           <p:nvPr/>
         </p:nvSpPr>
@@ -7272,7 +7236,7 @@
       </p:sp>
       <p:sp>
         <p:nvSpPr>
-          <p:cNvPr id="102" name="Rounded Rectangle 101"/>
+          <p:cNvPr id="101" name="Rounded Rectangle 100"/>
           <p:cNvSpPr/>
           <p:nvPr/>
         </p:nvSpPr>
@@ -7320,7 +7284,7 @@
       </p:sp>
       <p:sp>
         <p:nvSpPr>
-          <p:cNvPr id="103" name="Rectangle 102"/>
+          <p:cNvPr id="102" name="Rectangle 101"/>
           <p:cNvSpPr/>
           <p:nvPr/>
         </p:nvSpPr>
@@ -7364,7 +7328,7 @@
       </p:sp>
       <p:sp>
         <p:nvSpPr>
-          <p:cNvPr id="104" name="TextBox 103"/>
+          <p:cNvPr id="103" name="TextBox 102"/>
           <p:cNvSpPr txBox="1"/>
           <p:nvPr/>
         </p:nvSpPr>
@@ -7400,7 +7364,7 @@
       </p:sp>
       <p:sp>
         <p:nvSpPr>
-          <p:cNvPr id="105" name="TextBox 104"/>
+          <p:cNvPr id="104" name="TextBox 103"/>
           <p:cNvSpPr txBox="1"/>
           <p:nvPr/>
         </p:nvSpPr>
@@ -7436,7 +7400,7 @@
       </p:sp>
       <p:sp>
         <p:nvSpPr>
-          <p:cNvPr id="106" name="Rounded Rectangle 105"/>
+          <p:cNvPr id="105" name="Rounded Rectangle 104"/>
           <p:cNvSpPr/>
           <p:nvPr/>
         </p:nvSpPr>
@@ -7484,7 +7448,7 @@
       </p:sp>
       <p:sp>
         <p:nvSpPr>
-          <p:cNvPr id="107" name="Rectangle 106"/>
+          <p:cNvPr id="106" name="Rectangle 105"/>
           <p:cNvSpPr/>
           <p:nvPr/>
         </p:nvSpPr>
@@ -7528,7 +7492,7 @@
       </p:sp>
       <p:sp>
         <p:nvSpPr>
-          <p:cNvPr id="108" name="TextBox 107"/>
+          <p:cNvPr id="107" name="TextBox 106"/>
           <p:cNvSpPr txBox="1"/>
           <p:nvPr/>
         </p:nvSpPr>
@@ -7564,7 +7528,7 @@
       </p:sp>
       <p:sp>
         <p:nvSpPr>
-          <p:cNvPr id="109" name="Rounded Rectangle 108"/>
+          <p:cNvPr id="108" name="Rounded Rectangle 107"/>
           <p:cNvSpPr/>
           <p:nvPr/>
         </p:nvSpPr>
@@ -7612,7 +7576,7 @@
       </p:sp>
       <p:sp>
         <p:nvSpPr>
-          <p:cNvPr id="110" name="Rectangle 109"/>
+          <p:cNvPr id="109" name="Rectangle 108"/>
           <p:cNvSpPr/>
           <p:nvPr/>
         </p:nvSpPr>
@@ -7656,7 +7620,7 @@
       </p:sp>
       <p:sp>
         <p:nvSpPr>
-          <p:cNvPr id="111" name="TextBox 110"/>
+          <p:cNvPr id="110" name="TextBox 109"/>
           <p:cNvSpPr txBox="1"/>
           <p:nvPr/>
         </p:nvSpPr>
@@ -7692,7 +7656,7 @@
       </p:sp>
       <p:sp>
         <p:nvSpPr>
-          <p:cNvPr id="112" name="Rounded Rectangle 111"/>
+          <p:cNvPr id="111" name="Rounded Rectangle 110"/>
           <p:cNvSpPr/>
           <p:nvPr/>
         </p:nvSpPr>
@@ -7740,7 +7704,7 @@
       </p:sp>
       <p:sp>
         <p:nvSpPr>
-          <p:cNvPr id="113" name="Rectangle 112"/>
+          <p:cNvPr id="112" name="Rectangle 111"/>
           <p:cNvSpPr/>
           <p:nvPr/>
         </p:nvSpPr>
@@ -7784,7 +7748,7 @@
       </p:sp>
       <p:sp>
         <p:nvSpPr>
-          <p:cNvPr id="114" name="TextBox 113"/>
+          <p:cNvPr id="113" name="TextBox 112"/>
           <p:cNvSpPr txBox="1"/>
           <p:nvPr/>
         </p:nvSpPr>
@@ -7820,7 +7784,7 @@
       </p:sp>
       <p:sp>
         <p:nvSpPr>
-          <p:cNvPr id="115" name="Rounded Rectangle 114"/>
+          <p:cNvPr id="114" name="Rounded Rectangle 113"/>
           <p:cNvSpPr/>
           <p:nvPr/>
         </p:nvSpPr>
@@ -7868,7 +7832,7 @@
       </p:sp>
       <p:sp>
         <p:nvSpPr>
-          <p:cNvPr id="116" name="Rectangle 115"/>
+          <p:cNvPr id="115" name="Rectangle 114"/>
           <p:cNvSpPr/>
           <p:nvPr/>
         </p:nvSpPr>
@@ -7912,7 +7876,7 @@
       </p:sp>
       <p:sp>
         <p:nvSpPr>
-          <p:cNvPr id="117" name="TextBox 116"/>
+          <p:cNvPr id="116" name="TextBox 115"/>
           <p:cNvSpPr txBox="1"/>
           <p:nvPr/>
         </p:nvSpPr>
@@ -7948,7 +7912,7 @@
       </p:sp>
       <p:sp>
         <p:nvSpPr>
-          <p:cNvPr id="118" name="Rounded Rectangle 117"/>
+          <p:cNvPr id="117" name="Rounded Rectangle 116"/>
           <p:cNvSpPr/>
           <p:nvPr/>
         </p:nvSpPr>
@@ -7996,7 +7960,7 @@
       </p:sp>
       <p:sp>
         <p:nvSpPr>
-          <p:cNvPr id="119" name="Rectangle 118"/>
+          <p:cNvPr id="118" name="Rectangle 117"/>
           <p:cNvSpPr/>
           <p:nvPr/>
         </p:nvSpPr>
@@ -8040,7 +8004,7 @@
       </p:sp>
       <p:sp>
         <p:nvSpPr>
-          <p:cNvPr id="120" name="TextBox 119"/>
+          <p:cNvPr id="119" name="TextBox 118"/>
           <p:cNvSpPr txBox="1"/>
           <p:nvPr/>
         </p:nvSpPr>
@@ -8076,7 +8040,7 @@
       </p:sp>
       <p:sp>
         <p:nvSpPr>
-          <p:cNvPr id="121" name="Rounded Rectangle 120"/>
+          <p:cNvPr id="120" name="Rounded Rectangle 119"/>
           <p:cNvSpPr/>
           <p:nvPr/>
         </p:nvSpPr>
@@ -8124,7 +8088,7 @@
       </p:sp>
       <p:sp>
         <p:nvSpPr>
-          <p:cNvPr id="122" name="Rectangle 121"/>
+          <p:cNvPr id="121" name="Rectangle 120"/>
           <p:cNvSpPr/>
           <p:nvPr/>
         </p:nvSpPr>
@@ -8168,7 +8132,7 @@
       </p:sp>
       <p:sp>
         <p:nvSpPr>
-          <p:cNvPr id="123" name="TextBox 122"/>
+          <p:cNvPr id="122" name="TextBox 121"/>
           <p:cNvSpPr txBox="1"/>
           <p:nvPr/>
         </p:nvSpPr>
@@ -8204,7 +8168,7 @@
       </p:sp>
       <p:sp>
         <p:nvSpPr>
-          <p:cNvPr id="124" name="Rounded Rectangle 123"/>
+          <p:cNvPr id="123" name="Rounded Rectangle 122"/>
           <p:cNvSpPr/>
           <p:nvPr/>
         </p:nvSpPr>
@@ -8252,7 +8216,7 @@
       </p:sp>
       <p:sp>
         <p:nvSpPr>
-          <p:cNvPr id="125" name="Rectangle 124"/>
+          <p:cNvPr id="124" name="Rectangle 123"/>
           <p:cNvSpPr/>
           <p:nvPr/>
         </p:nvSpPr>
@@ -8296,7 +8260,7 @@
       </p:sp>
       <p:sp>
         <p:nvSpPr>
-          <p:cNvPr id="126" name="TextBox 125"/>
+          <p:cNvPr id="125" name="TextBox 124"/>
           <p:cNvSpPr txBox="1"/>
           <p:nvPr/>
         </p:nvSpPr>
@@ -8332,7 +8296,7 @@
       </p:sp>
       <p:sp>
         <p:nvSpPr>
-          <p:cNvPr id="127" name="Rounded Rectangle 126"/>
+          <p:cNvPr id="126" name="Rounded Rectangle 125"/>
           <p:cNvSpPr/>
           <p:nvPr/>
         </p:nvSpPr>
@@ -8380,7 +8344,7 @@
       </p:sp>
       <p:sp>
         <p:nvSpPr>
-          <p:cNvPr id="128" name="Rectangle 127"/>
+          <p:cNvPr id="127" name="Rectangle 126"/>
           <p:cNvSpPr/>
           <p:nvPr/>
         </p:nvSpPr>
@@ -8424,7 +8388,7 @@
       </p:sp>
       <p:sp>
         <p:nvSpPr>
-          <p:cNvPr id="129" name="TextBox 128"/>
+          <p:cNvPr id="128" name="TextBox 127"/>
           <p:cNvSpPr txBox="1"/>
           <p:nvPr/>
         </p:nvSpPr>
@@ -8460,7 +8424,7 @@
       </p:sp>
       <p:cxnSp>
         <p:nvCxnSpPr>
-          <p:cNvPr id="130" name="Connector 129"/>
+          <p:cNvPr id="129" name="Connector 128"/>
           <p:cNvCxnSpPr/>
           <p:nvPr/>
         </p:nvCxnSpPr>
@@ -8495,7 +8459,7 @@
       </p:cxnSp>
       <p:sp>
         <p:nvSpPr>
-          <p:cNvPr id="131" name="Rounded Rectangle 130"/>
+          <p:cNvPr id="130" name="Rounded Rectangle 129"/>
           <p:cNvSpPr/>
           <p:nvPr/>
         </p:nvSpPr>
@@ -8541,7 +8505,7 @@
       </p:sp>
       <p:sp>
         <p:nvSpPr>
-          <p:cNvPr id="132" name="Rounded Rectangle 131"/>
+          <p:cNvPr id="131" name="Rounded Rectangle 130"/>
           <p:cNvSpPr/>
           <p:nvPr/>
         </p:nvSpPr>
@@ -8589,7 +8553,7 @@
       </p:sp>
       <p:sp>
         <p:nvSpPr>
-          <p:cNvPr id="133" name="Rectangle 132"/>
+          <p:cNvPr id="132" name="Rectangle 131"/>
           <p:cNvSpPr/>
           <p:nvPr/>
         </p:nvSpPr>
@@ -8633,7 +8597,7 @@
       </p:sp>
       <p:sp>
         <p:nvSpPr>
-          <p:cNvPr id="134" name="TextBox 133"/>
+          <p:cNvPr id="133" name="TextBox 132"/>
           <p:cNvSpPr txBox="1"/>
           <p:nvPr/>
         </p:nvSpPr>
@@ -8669,7 +8633,7 @@
       </p:sp>
       <p:sp>
         <p:nvSpPr>
-          <p:cNvPr id="135" name="TextBox 134"/>
+          <p:cNvPr id="134" name="TextBox 133"/>
           <p:cNvSpPr txBox="1"/>
           <p:nvPr/>
         </p:nvSpPr>
@@ -8705,7 +8669,7 @@
       </p:sp>
       <p:sp>
         <p:nvSpPr>
-          <p:cNvPr id="136" name="Rounded Rectangle 135"/>
+          <p:cNvPr id="135" name="Rounded Rectangle 134"/>
           <p:cNvSpPr/>
           <p:nvPr/>
         </p:nvSpPr>
@@ -8753,7 +8717,7 @@
       </p:sp>
       <p:sp>
         <p:nvSpPr>
-          <p:cNvPr id="137" name="Rectangle 136"/>
+          <p:cNvPr id="136" name="Rectangle 135"/>
           <p:cNvSpPr/>
           <p:nvPr/>
         </p:nvSpPr>
@@ -8797,7 +8761,7 @@
       </p:sp>
       <p:sp>
         <p:nvSpPr>
-          <p:cNvPr id="138" name="TextBox 137"/>
+          <p:cNvPr id="137" name="TextBox 136"/>
           <p:cNvSpPr txBox="1"/>
           <p:nvPr/>
         </p:nvSpPr>
@@ -8833,7 +8797,7 @@
       </p:sp>
       <p:sp>
         <p:nvSpPr>
-          <p:cNvPr id="139" name="Rounded Rectangle 138"/>
+          <p:cNvPr id="138" name="Rounded Rectangle 137"/>
           <p:cNvSpPr/>
           <p:nvPr/>
         </p:nvSpPr>
@@ -8881,7 +8845,7 @@
       </p:sp>
       <p:sp>
         <p:nvSpPr>
-          <p:cNvPr id="140" name="Rectangle 139"/>
+          <p:cNvPr id="139" name="Rectangle 138"/>
           <p:cNvSpPr/>
           <p:nvPr/>
         </p:nvSpPr>
@@ -8925,7 +8889,7 @@
       </p:sp>
       <p:sp>
         <p:nvSpPr>
-          <p:cNvPr id="141" name="TextBox 140"/>
+          <p:cNvPr id="140" name="TextBox 139"/>
           <p:cNvSpPr txBox="1"/>
           <p:nvPr/>
         </p:nvSpPr>
@@ -8961,7 +8925,7 @@
       </p:sp>
       <p:sp>
         <p:nvSpPr>
-          <p:cNvPr id="142" name="Rounded Rectangle 141"/>
+          <p:cNvPr id="141" name="Rounded Rectangle 140"/>
           <p:cNvSpPr/>
           <p:nvPr/>
         </p:nvSpPr>
@@ -9009,7 +8973,7 @@
       </p:sp>
       <p:sp>
         <p:nvSpPr>
-          <p:cNvPr id="143" name="Rectangle 142"/>
+          <p:cNvPr id="142" name="Rectangle 141"/>
           <p:cNvSpPr/>
           <p:nvPr/>
         </p:nvSpPr>
@@ -9053,7 +9017,7 @@
       </p:sp>
       <p:sp>
         <p:nvSpPr>
-          <p:cNvPr id="144" name="TextBox 143"/>
+          <p:cNvPr id="143" name="TextBox 142"/>
           <p:cNvSpPr txBox="1"/>
           <p:nvPr/>
         </p:nvSpPr>
@@ -9089,7 +9053,7 @@
       </p:sp>
       <p:sp>
         <p:nvSpPr>
-          <p:cNvPr id="145" name="Rounded Rectangle 144"/>
+          <p:cNvPr id="144" name="Rounded Rectangle 143"/>
           <p:cNvSpPr/>
           <p:nvPr/>
         </p:nvSpPr>
@@ -9137,7 +9101,7 @@
       </p:sp>
       <p:sp>
         <p:nvSpPr>
-          <p:cNvPr id="146" name="Rectangle 145"/>
+          <p:cNvPr id="145" name="Rectangle 144"/>
           <p:cNvSpPr/>
           <p:nvPr/>
         </p:nvSpPr>
@@ -9181,7 +9145,7 @@
       </p:sp>
       <p:sp>
         <p:nvSpPr>
-          <p:cNvPr id="147" name="TextBox 146"/>
+          <p:cNvPr id="146" name="TextBox 145"/>
           <p:cNvSpPr txBox="1"/>
           <p:nvPr/>
         </p:nvSpPr>
@@ -9217,7 +9181,7 @@
       </p:sp>
       <p:sp>
         <p:nvSpPr>
-          <p:cNvPr id="148" name="Rounded Rectangle 147"/>
+          <p:cNvPr id="147" name="Rounded Rectangle 146"/>
           <p:cNvSpPr/>
           <p:nvPr/>
         </p:nvSpPr>
@@ -9265,7 +9229,7 @@
       </p:sp>
       <p:sp>
         <p:nvSpPr>
-          <p:cNvPr id="149" name="Rectangle 148"/>
+          <p:cNvPr id="148" name="Rectangle 147"/>
           <p:cNvSpPr/>
           <p:nvPr/>
         </p:nvSpPr>
@@ -9309,7 +9273,7 @@
       </p:sp>
       <p:sp>
         <p:nvSpPr>
-          <p:cNvPr id="150" name="TextBox 149"/>
+          <p:cNvPr id="149" name="TextBox 148"/>
           <p:cNvSpPr txBox="1"/>
           <p:nvPr/>
         </p:nvSpPr>
@@ -9345,7 +9309,7 @@
       </p:sp>
       <p:sp>
         <p:nvSpPr>
-          <p:cNvPr id="151" name="Rounded Rectangle 150"/>
+          <p:cNvPr id="150" name="Rounded Rectangle 149"/>
           <p:cNvSpPr/>
           <p:nvPr/>
         </p:nvSpPr>
@@ -9393,7 +9357,7 @@
       </p:sp>
       <p:sp>
         <p:nvSpPr>
-          <p:cNvPr id="152" name="Rectangle 151"/>
+          <p:cNvPr id="151" name="Rectangle 150"/>
           <p:cNvSpPr/>
           <p:nvPr/>
         </p:nvSpPr>
@@ -9437,7 +9401,7 @@
       </p:sp>
       <p:sp>
         <p:nvSpPr>
-          <p:cNvPr id="153" name="TextBox 152"/>
+          <p:cNvPr id="152" name="TextBox 151"/>
           <p:cNvSpPr txBox="1"/>
           <p:nvPr/>
         </p:nvSpPr>
@@ -9473,7 +9437,7 @@
       </p:sp>
       <p:sp>
         <p:nvSpPr>
-          <p:cNvPr id="154" name="Rounded Rectangle 153"/>
+          <p:cNvPr id="153" name="Rounded Rectangle 152"/>
           <p:cNvSpPr/>
           <p:nvPr/>
         </p:nvSpPr>
@@ -9521,7 +9485,7 @@
       </p:sp>
       <p:sp>
         <p:nvSpPr>
-          <p:cNvPr id="155" name="Rectangle 154"/>
+          <p:cNvPr id="154" name="Rectangle 153"/>
           <p:cNvSpPr/>
           <p:nvPr/>
         </p:nvSpPr>
@@ -9565,7 +9529,7 @@
       </p:sp>
       <p:sp>
         <p:nvSpPr>
-          <p:cNvPr id="156" name="TextBox 155"/>
+          <p:cNvPr id="155" name="TextBox 154"/>
           <p:cNvSpPr txBox="1"/>
           <p:nvPr/>
         </p:nvSpPr>
@@ -9601,7 +9565,7 @@
       </p:sp>
       <p:sp>
         <p:nvSpPr>
-          <p:cNvPr id="157" name="Rounded Rectangle 156"/>
+          <p:cNvPr id="156" name="Rounded Rectangle 155"/>
           <p:cNvSpPr/>
           <p:nvPr/>
         </p:nvSpPr>
@@ -9647,7 +9611,7 @@
       </p:sp>
       <p:sp>
         <p:nvSpPr>
-          <p:cNvPr id="158" name="Rounded Rectangle 157"/>
+          <p:cNvPr id="157" name="Rounded Rectangle 156"/>
           <p:cNvSpPr/>
           <p:nvPr/>
         </p:nvSpPr>
@@ -9695,7 +9659,7 @@
       </p:sp>
       <p:sp>
         <p:nvSpPr>
-          <p:cNvPr id="159" name="Rectangle 158"/>
+          <p:cNvPr id="158" name="Rectangle 157"/>
           <p:cNvSpPr/>
           <p:nvPr/>
         </p:nvSpPr>
@@ -9739,7 +9703,7 @@
       </p:sp>
       <p:sp>
         <p:nvSpPr>
-          <p:cNvPr id="160" name="TextBox 159"/>
+          <p:cNvPr id="159" name="TextBox 158"/>
           <p:cNvSpPr txBox="1"/>
           <p:nvPr/>
         </p:nvSpPr>
@@ -9775,7 +9739,7 @@
       </p:sp>
       <p:sp>
         <p:nvSpPr>
-          <p:cNvPr id="161" name="TextBox 160"/>
+          <p:cNvPr id="160" name="TextBox 159"/>
           <p:cNvSpPr txBox="1"/>
           <p:nvPr/>
         </p:nvSpPr>
@@ -9811,7 +9775,7 @@
       </p:sp>
       <p:sp>
         <p:nvSpPr>
-          <p:cNvPr id="162" name="Rounded Rectangle 161"/>
+          <p:cNvPr id="161" name="Rounded Rectangle 160"/>
           <p:cNvSpPr/>
           <p:nvPr/>
         </p:nvSpPr>
@@ -9859,7 +9823,7 @@
       </p:sp>
       <p:sp>
         <p:nvSpPr>
-          <p:cNvPr id="163" name="Rectangle 162"/>
+          <p:cNvPr id="162" name="Rectangle 161"/>
           <p:cNvSpPr/>
           <p:nvPr/>
         </p:nvSpPr>
@@ -9903,7 +9867,7 @@
       </p:sp>
       <p:sp>
         <p:nvSpPr>
-          <p:cNvPr id="164" name="TextBox 163"/>
+          <p:cNvPr id="163" name="TextBox 162"/>
           <p:cNvSpPr txBox="1"/>
           <p:nvPr/>
         </p:nvSpPr>
@@ -9939,7 +9903,7 @@
       </p:sp>
       <p:sp>
         <p:nvSpPr>
-          <p:cNvPr id="165" name="TextBox 164"/>
+          <p:cNvPr id="164" name="TextBox 163"/>
           <p:cNvSpPr txBox="1"/>
           <p:nvPr/>
         </p:nvSpPr>
@@ -9975,7 +9939,7 @@
       </p:sp>
       <p:sp>
         <p:nvSpPr>
-          <p:cNvPr id="166" name="Rounded Rectangle 165"/>
+          <p:cNvPr id="165" name="Rounded Rectangle 164"/>
           <p:cNvSpPr/>
           <p:nvPr/>
         </p:nvSpPr>
@@ -10023,7 +9987,7 @@
       </p:sp>
       <p:sp>
         <p:nvSpPr>
-          <p:cNvPr id="167" name="Rectangle 166"/>
+          <p:cNvPr id="166" name="Rectangle 165"/>
           <p:cNvSpPr/>
           <p:nvPr/>
         </p:nvSpPr>
@@ -10067,7 +10031,7 @@
       </p:sp>
       <p:sp>
         <p:nvSpPr>
-          <p:cNvPr id="168" name="TextBox 167"/>
+          <p:cNvPr id="167" name="TextBox 166"/>
           <p:cNvSpPr txBox="1"/>
           <p:nvPr/>
         </p:nvSpPr>
@@ -10103,7 +10067,7 @@
       </p:sp>
       <p:sp>
         <p:nvSpPr>
-          <p:cNvPr id="169" name="TextBox 168"/>
+          <p:cNvPr id="168" name="TextBox 167"/>
           <p:cNvSpPr txBox="1"/>
           <p:nvPr/>
         </p:nvSpPr>
@@ -10139,7 +10103,7 @@
       </p:sp>
       <p:sp>
         <p:nvSpPr>
-          <p:cNvPr id="170" name="Rounded Rectangle 169"/>
+          <p:cNvPr id="169" name="Rounded Rectangle 168"/>
           <p:cNvSpPr/>
           <p:nvPr/>
         </p:nvSpPr>
@@ -10187,7 +10151,7 @@
       </p:sp>
       <p:sp>
         <p:nvSpPr>
-          <p:cNvPr id="171" name="Rectangle 170"/>
+          <p:cNvPr id="170" name="Rectangle 169"/>
           <p:cNvSpPr/>
           <p:nvPr/>
         </p:nvSpPr>
@@ -10231,7 +10195,7 @@
       </p:sp>
       <p:sp>
         <p:nvSpPr>
-          <p:cNvPr id="172" name="TextBox 171"/>
+          <p:cNvPr id="171" name="TextBox 170"/>
           <p:cNvSpPr txBox="1"/>
           <p:nvPr/>
         </p:nvSpPr>
@@ -10267,7 +10231,7 @@
       </p:sp>
       <p:sp>
         <p:nvSpPr>
-          <p:cNvPr id="173" name="TextBox 172"/>
+          <p:cNvPr id="172" name="TextBox 171"/>
           <p:cNvSpPr txBox="1"/>
           <p:nvPr/>
         </p:nvSpPr>
@@ -10303,7 +10267,7 @@
       </p:sp>
       <p:sp>
         <p:nvSpPr>
-          <p:cNvPr id="174" name="Rounded Rectangle 173"/>
+          <p:cNvPr id="173" name="Rounded Rectangle 172"/>
           <p:cNvSpPr/>
           <p:nvPr/>
         </p:nvSpPr>
@@ -10351,7 +10315,7 @@
       </p:sp>
       <p:sp>
         <p:nvSpPr>
-          <p:cNvPr id="175" name="Rectangle 174"/>
+          <p:cNvPr id="174" name="Rectangle 173"/>
           <p:cNvSpPr/>
           <p:nvPr/>
         </p:nvSpPr>
@@ -10395,7 +10359,7 @@
       </p:sp>
       <p:sp>
         <p:nvSpPr>
-          <p:cNvPr id="176" name="TextBox 175"/>
+          <p:cNvPr id="175" name="TextBox 174"/>
           <p:cNvSpPr txBox="1"/>
           <p:nvPr/>
         </p:nvSpPr>
@@ -10431,7 +10395,7 @@
       </p:sp>
       <p:sp>
         <p:nvSpPr>
-          <p:cNvPr id="177" name="TextBox 176"/>
+          <p:cNvPr id="176" name="TextBox 175"/>
           <p:cNvSpPr txBox="1"/>
           <p:nvPr/>
         </p:nvSpPr>
@@ -10467,7 +10431,7 @@
       </p:sp>
       <p:sp>
         <p:nvSpPr>
-          <p:cNvPr id="178" name="Rounded Rectangle 177"/>
+          <p:cNvPr id="177" name="Rounded Rectangle 176"/>
           <p:cNvSpPr/>
           <p:nvPr/>
         </p:nvSpPr>
@@ -10515,7 +10479,7 @@
       </p:sp>
       <p:sp>
         <p:nvSpPr>
-          <p:cNvPr id="179" name="Rectangle 178"/>
+          <p:cNvPr id="178" name="Rectangle 177"/>
           <p:cNvSpPr/>
           <p:nvPr/>
         </p:nvSpPr>
@@ -10559,7 +10523,7 @@
       </p:sp>
       <p:sp>
         <p:nvSpPr>
-          <p:cNvPr id="180" name="TextBox 179"/>
+          <p:cNvPr id="179" name="TextBox 178"/>
           <p:cNvSpPr txBox="1"/>
           <p:nvPr/>
         </p:nvSpPr>
@@ -10595,7 +10559,7 @@
       </p:sp>
       <p:sp>
         <p:nvSpPr>
-          <p:cNvPr id="181" name="Rounded Rectangle 180"/>
+          <p:cNvPr id="180" name="Rounded Rectangle 179"/>
           <p:cNvSpPr/>
           <p:nvPr/>
         </p:nvSpPr>
@@ -10643,7 +10607,7 @@
       </p:sp>
       <p:sp>
         <p:nvSpPr>
-          <p:cNvPr id="182" name="Rectangle 181"/>
+          <p:cNvPr id="181" name="Rectangle 180"/>
           <p:cNvSpPr/>
           <p:nvPr/>
         </p:nvSpPr>
@@ -10687,7 +10651,7 @@
       </p:sp>
       <p:sp>
         <p:nvSpPr>
-          <p:cNvPr id="183" name="TextBox 182"/>
+          <p:cNvPr id="182" name="TextBox 181"/>
           <p:cNvSpPr txBox="1"/>
           <p:nvPr/>
         </p:nvSpPr>
@@ -10723,7 +10687,7 @@
       </p:sp>
       <p:sp>
         <p:nvSpPr>
-          <p:cNvPr id="184" name="Rounded Rectangle 183"/>
+          <p:cNvPr id="183" name="Rounded Rectangle 182"/>
           <p:cNvSpPr/>
           <p:nvPr/>
         </p:nvSpPr>
@@ -10771,7 +10735,7 @@
       </p:sp>
       <p:sp>
         <p:nvSpPr>
-          <p:cNvPr id="185" name="Rectangle 184"/>
+          <p:cNvPr id="184" name="Rectangle 183"/>
           <p:cNvSpPr/>
           <p:nvPr/>
         </p:nvSpPr>
@@ -10815,7 +10779,7 @@
       </p:sp>
       <p:sp>
         <p:nvSpPr>
-          <p:cNvPr id="186" name="TextBox 185"/>
+          <p:cNvPr id="185" name="TextBox 184"/>
           <p:cNvSpPr txBox="1"/>
           <p:nvPr/>
         </p:nvSpPr>
@@ -10851,7 +10815,7 @@
       </p:sp>
       <p:sp>
         <p:nvSpPr>
-          <p:cNvPr id="187" name="Rounded Rectangle 186"/>
+          <p:cNvPr id="186" name="Rounded Rectangle 185"/>
           <p:cNvSpPr/>
           <p:nvPr/>
         </p:nvSpPr>
@@ -10899,7 +10863,7 @@
       </p:sp>
       <p:sp>
         <p:nvSpPr>
-          <p:cNvPr id="188" name="Rectangle 187"/>
+          <p:cNvPr id="187" name="Rectangle 186"/>
           <p:cNvSpPr/>
           <p:nvPr/>
         </p:nvSpPr>
@@ -10943,7 +10907,7 @@
       </p:sp>
       <p:sp>
         <p:nvSpPr>
-          <p:cNvPr id="189" name="TextBox 188"/>
+          <p:cNvPr id="188" name="TextBox 187"/>
           <p:cNvSpPr txBox="1"/>
           <p:nvPr/>
         </p:nvSpPr>
@@ -10979,7 +10943,7 @@
       </p:sp>
       <p:sp>
         <p:nvSpPr>
-          <p:cNvPr id="190" name="Rounded Rectangle 189"/>
+          <p:cNvPr id="189" name="Rounded Rectangle 188"/>
           <p:cNvSpPr/>
           <p:nvPr/>
         </p:nvSpPr>
@@ -11027,7 +10991,7 @@
       </p:sp>
       <p:sp>
         <p:nvSpPr>
-          <p:cNvPr id="191" name="Rectangle 190"/>
+          <p:cNvPr id="190" name="Rectangle 189"/>
           <p:cNvSpPr/>
           <p:nvPr/>
         </p:nvSpPr>
@@ -11071,7 +11035,7 @@
       </p:sp>
       <p:sp>
         <p:nvSpPr>
-          <p:cNvPr id="192" name="TextBox 191"/>
+          <p:cNvPr id="191" name="TextBox 190"/>
           <p:cNvSpPr txBox="1"/>
           <p:nvPr/>
         </p:nvSpPr>
@@ -11107,14 +11071,49 @@
       </p:sp>
       <p:cxnSp>
         <p:nvCxnSpPr>
+          <p:cNvPr id="192" name="Connector 191"/>
+          <p:cNvCxnSpPr/>
+          <p:nvPr/>
+        </p:nvCxnSpPr>
+        <p:spPr>
+          <a:xfrm>
+            <a:off x="6095847" y="2395728"/>
+            <a:ext cx="0" cy="109728"/>
+          </a:xfrm>
+          <a:prstGeom prst="line">
+            <a:avLst/>
+          </a:prstGeom>
+          <a:ln w="19050">
+            <a:solidFill>
+              <a:srgbClr val="C5CDDD"/>
+            </a:solidFill>
+          </a:ln>
+        </p:spPr>
+        <p:style>
+          <a:lnRef idx="2">
+            <a:schemeClr val="accent1"/>
+          </a:lnRef>
+          <a:fillRef idx="0">
+            <a:schemeClr val="accent1"/>
+          </a:fillRef>
+          <a:effectRef idx="1">
+            <a:schemeClr val="accent1"/>
+          </a:effectRef>
+          <a:fontRef idx="minor">
+            <a:schemeClr val="tx1"/>
+          </a:fontRef>
+        </p:style>
+      </p:cxnSp>
+      <p:cxnSp>
+        <p:nvCxnSpPr>
           <p:cNvPr id="193" name="Connector 192"/>
           <p:cNvCxnSpPr/>
           <p:nvPr/>
         </p:nvCxnSpPr>
         <p:spPr>
           <a:xfrm>
-            <a:off x="6095847" y="2395728"/>
-            <a:ext cx="0" cy="109728"/>
+            <a:off x="1763994" y="2505456"/>
+            <a:ext cx="7987450" cy="0"/>
           </a:xfrm>
           <a:prstGeom prst="line">
             <a:avLst/>
@@ -11148,8 +11147,8 @@
         </p:nvCxnSpPr>
         <p:spPr>
           <a:xfrm>
-            <a:off x="1763994" y="2505456"/>
-            <a:ext cx="7987450" cy="0"/>
+            <a:off x="9751444" y="2505456"/>
+            <a:ext cx="0" cy="109728"/>
           </a:xfrm>
           <a:prstGeom prst="line">
             <a:avLst/>
@@ -11183,7 +11182,7 @@
         </p:nvCxnSpPr>
         <p:spPr>
           <a:xfrm>
-            <a:off x="9751444" y="2505456"/>
+            <a:off x="5419591" y="2505456"/>
             <a:ext cx="0" cy="109728"/>
           </a:xfrm>
           <a:prstGeom prst="line">
@@ -11213,41 +11212,6 @@
       <p:cxnSp>
         <p:nvCxnSpPr>
           <p:cNvPr id="196" name="Connector 195"/>
-          <p:cNvCxnSpPr/>
-          <p:nvPr/>
-        </p:nvCxnSpPr>
-        <p:spPr>
-          <a:xfrm>
-            <a:off x="5419591" y="2505456"/>
-            <a:ext cx="0" cy="109728"/>
-          </a:xfrm>
-          <a:prstGeom prst="line">
-            <a:avLst/>
-          </a:prstGeom>
-          <a:ln w="19050">
-            <a:solidFill>
-              <a:srgbClr val="C5CDDD"/>
-            </a:solidFill>
-          </a:ln>
-        </p:spPr>
-        <p:style>
-          <a:lnRef idx="2">
-            <a:schemeClr val="accent1"/>
-          </a:lnRef>
-          <a:fillRef idx="0">
-            <a:schemeClr val="accent1"/>
-          </a:fillRef>
-          <a:effectRef idx="1">
-            <a:schemeClr val="accent1"/>
-          </a:effectRef>
-          <a:fontRef idx="minor">
-            <a:schemeClr val="tx1"/>
-          </a:fontRef>
-        </p:style>
-      </p:cxnSp>
-      <p:cxnSp>
-        <p:nvCxnSpPr>
-          <p:cNvPr id="197" name="Connector 196"/>
           <p:cNvCxnSpPr/>
           <p:nvPr/>
         </p:nvCxnSpPr>

</xml_diff>

<commit_message>
Add proposed Knesset structure slide
Co-Authored-By: Claude Opus 5.5 <noreply@anthropic.com>
Claude-Session: https://claude.ai/code/session_01W7Er83FuNT4pLFShWidYHn
</commit_message>
<xml_diff>
--- a/presentation/out/koach-hitarvut.pptx
+++ b/presentation/out/koach-hitarvut.pptx
@@ -7,6 +7,7 @@
   <p:sldIdLst>
     <p:sldId id="256" r:id="rId7"/>
     <p:sldId id="257" r:id="rId8"/>
+    <p:sldId id="258" r:id="rId9"/>
   </p:sldIdLst>
   <p:sldSz cx="12191695" cy="6858000" type="screen4x3"/>
   <p:notesSz cx="6858000" cy="9144000"/>
@@ -17285,6 +17286,3055 @@
                 <a:cs typeface="Heebo"/>
               </a:rPr>
               <a:t>טרם הוזן</a:t>
+            </a:r>
+          </a:p>
+        </p:txBody>
+      </p:sp>
+    </p:spTree>
+  </p:cSld>
+  <p:clrMapOvr>
+    <a:masterClrMapping/>
+  </p:clrMapOvr>
+</p:sld>
+</file>
+
+<file path=ppt/slides/slide3.xml><?xml version="1.0" encoding="utf-8"?>
+<p:sld xmlns:a="http://schemas.openxmlformats.org/drawingml/2006/main" xmlns:p="http://schemas.openxmlformats.org/presentationml/2006/main" xmlns:r="http://schemas.openxmlformats.org/officeDocument/2006/relationships">
+  <p:cSld>
+    <p:bg>
+      <p:bgPr>
+        <a:solidFill>
+          <a:srgbClr val="F4F6FB"/>
+        </a:solidFill>
+        <a:effectLst/>
+      </p:bgPr>
+    </p:bg>
+    <p:spTree>
+      <p:nvGrpSpPr>
+        <p:cNvPr id="1" name=""/>
+        <p:cNvGrpSpPr/>
+        <p:nvPr/>
+      </p:nvGrpSpPr>
+      <p:grpSpPr/>
+      <p:sp>
+        <p:nvSpPr>
+          <p:cNvPr id="2" name="Rectangle 1"/>
+          <p:cNvSpPr/>
+          <p:nvPr/>
+        </p:nvSpPr>
+        <p:spPr>
+          <a:xfrm>
+            <a:off x="0" y="0"/>
+            <a:ext cx="12191695" cy="868680"/>
+          </a:xfrm>
+          <a:prstGeom prst="rect">
+            <a:avLst/>
+          </a:prstGeom>
+          <a:solidFill>
+            <a:srgbClr val="1C3C7A"/>
+          </a:solidFill>
+          <a:ln>
+            <a:noFill/>
+          </a:ln>
+          <a:effectLst/>
+        </p:spPr>
+        <p:style>
+          <a:lnRef idx="1">
+            <a:schemeClr val="accent1"/>
+          </a:lnRef>
+          <a:fillRef idx="3">
+            <a:schemeClr val="accent1"/>
+          </a:fillRef>
+          <a:effectRef idx="2">
+            <a:schemeClr val="accent1"/>
+          </a:effectRef>
+          <a:fontRef idx="minor">
+            <a:schemeClr val="lt1"/>
+          </a:fontRef>
+        </p:style>
+        <p:txBody>
+          <a:bodyPr rtlCol="0" anchor="ctr"/>
+          <a:lstStyle/>
+          <a:p>
+            <a:pPr algn="ctr"/>
+          </a:p>
+        </p:txBody>
+      </p:sp>
+      <p:sp>
+        <p:nvSpPr>
+          <p:cNvPr id="3" name="Rectangle 2"/>
+          <p:cNvSpPr/>
+          <p:nvPr/>
+        </p:nvSpPr>
+        <p:spPr>
+          <a:xfrm>
+            <a:off x="0" y="868680"/>
+            <a:ext cx="12191695" cy="54864"/>
+          </a:xfrm>
+          <a:prstGeom prst="rect">
+            <a:avLst/>
+          </a:prstGeom>
+          <a:solidFill>
+            <a:srgbClr val="F0C000"/>
+          </a:solidFill>
+          <a:ln>
+            <a:noFill/>
+          </a:ln>
+          <a:effectLst/>
+        </p:spPr>
+        <p:style>
+          <a:lnRef idx="1">
+            <a:schemeClr val="accent1"/>
+          </a:lnRef>
+          <a:fillRef idx="3">
+            <a:schemeClr val="accent1"/>
+          </a:fillRef>
+          <a:effectRef idx="2">
+            <a:schemeClr val="accent1"/>
+          </a:effectRef>
+          <a:fontRef idx="minor">
+            <a:schemeClr val="lt1"/>
+          </a:fontRef>
+        </p:style>
+        <p:txBody>
+          <a:bodyPr rtlCol="0" anchor="ctr"/>
+          <a:lstStyle/>
+          <a:p>
+            <a:pPr algn="ctr"/>
+          </a:p>
+        </p:txBody>
+      </p:sp>
+      <p:sp>
+        <p:nvSpPr>
+          <p:cNvPr id="4" name="TextBox 3"/>
+          <p:cNvSpPr txBox="1"/>
+          <p:nvPr/>
+        </p:nvSpPr>
+        <p:spPr>
+          <a:xfrm>
+            <a:off x="1280160" y="109728"/>
+            <a:ext cx="10515600" cy="457200"/>
+          </a:xfrm>
+          <a:prstGeom prst="rect">
+            <a:avLst/>
+          </a:prstGeom>
+          <a:noFill/>
+        </p:spPr>
+        <p:txBody>
+          <a:bodyPr wrap="square" anchor="ctr" lIns="36576" rIns="36576" tIns="0" bIns="0">
+            <a:spAutoFit/>
+          </a:bodyPr>
+          <a:lstStyle/>
+          <a:p>
+            <a:pPr algn="r" rtl="1"/>
+            <a:r>
+              <a:rPr sz="2600" b="1">
+                <a:solidFill>
+                  <a:srgbClr val="FFFFFF"/>
+                </a:solidFill>
+                <a:latin typeface="Heebo"/>
+                <a:cs typeface="Heebo"/>
+              </a:rPr>
+              <a:t>מבנה ארגוני מוצע · עבודת הכנסת ה-26</a:t>
+            </a:r>
+          </a:p>
+        </p:txBody>
+      </p:sp>
+      <p:sp>
+        <p:nvSpPr>
+          <p:cNvPr id="5" name="TextBox 4"/>
+          <p:cNvSpPr txBox="1"/>
+          <p:nvPr/>
+        </p:nvSpPr>
+        <p:spPr>
+          <a:xfrm>
+            <a:off x="1280160" y="530352"/>
+            <a:ext cx="10515600" cy="274320"/>
+          </a:xfrm>
+          <a:prstGeom prst="rect">
+            <a:avLst/>
+          </a:prstGeom>
+          <a:noFill/>
+        </p:spPr>
+        <p:txBody>
+          <a:bodyPr wrap="square" anchor="ctr" lIns="36576" rIns="36576" tIns="0" bIns="0">
+            <a:spAutoFit/>
+          </a:bodyPr>
+          <a:lstStyle/>
+          <a:p>
+            <a:pPr algn="r" rtl="1"/>
+            <a:r>
+              <a:rPr sz="1200" b="0">
+                <a:solidFill>
+                  <a:srgbClr val="F0C000"/>
+                </a:solidFill>
+                <a:latin typeface="Heebo"/>
+                <a:cs typeface="Heebo"/>
+              </a:rPr>
+              <a:t>צוות קבוע בשכר בליבה, וכל השאר מזינים אותו</a:t>
+            </a:r>
+          </a:p>
+        </p:txBody>
+      </p:sp>
+      <p:sp>
+        <p:nvSpPr>
+          <p:cNvPr id="7" name="Rounded Rectangle 6"/>
+          <p:cNvSpPr/>
+          <p:nvPr/>
+        </p:nvSpPr>
+        <p:spPr>
+          <a:xfrm>
+            <a:off x="265176" y="54864"/>
+            <a:ext cx="910550" cy="768096"/>
+          </a:xfrm>
+          <a:prstGeom prst="roundRect">
+            <a:avLst>
+              <a:gd name="adj" fmla="val 12000"/>
+            </a:avLst>
+          </a:prstGeom>
+          <a:solidFill>
+            <a:srgbClr val="FFFFFF"/>
+          </a:solidFill>
+          <a:ln>
+            <a:noFill/>
+          </a:ln>
+          <a:effectLst/>
+        </p:spPr>
+        <p:style>
+          <a:lnRef idx="1">
+            <a:schemeClr val="accent1"/>
+          </a:lnRef>
+          <a:fillRef idx="3">
+            <a:schemeClr val="accent1"/>
+          </a:fillRef>
+          <a:effectRef idx="2">
+            <a:schemeClr val="accent1"/>
+          </a:effectRef>
+          <a:fontRef idx="minor">
+            <a:schemeClr val="lt1"/>
+          </a:fontRef>
+        </p:style>
+        <p:txBody>
+          <a:bodyPr rtlCol="0" anchor="ctr"/>
+          <a:lstStyle/>
+          <a:p>
+            <a:pPr algn="ctr"/>
+          </a:p>
+        </p:txBody>
+      </p:sp>
+      <p:pic>
+        <p:nvPicPr>
+          <p:cNvPr id="6" name="Picture 5" descr="logo.png"/>
+          <p:cNvPicPr>
+            <a:picLocks noChangeAspect="1"/>
+          </p:cNvPicPr>
+          <p:nvPr/>
+        </p:nvPicPr>
+        <p:blipFill>
+          <a:blip r:embed="rId2"/>
+          <a:stretch>
+            <a:fillRect/>
+          </a:stretch>
+        </p:blipFill>
+        <p:spPr>
+          <a:xfrm>
+            <a:off x="320040" y="73152"/>
+            <a:ext cx="800822" cy="731520"/>
+          </a:xfrm>
+          <a:prstGeom prst="rect">
+            <a:avLst/>
+          </a:prstGeom>
+        </p:spPr>
+      </p:pic>
+      <p:sp>
+        <p:nvSpPr>
+          <p:cNvPr id="8" name="TextBox 7"/>
+          <p:cNvSpPr txBox="1"/>
+          <p:nvPr/>
+        </p:nvSpPr>
+        <p:spPr>
+          <a:xfrm>
+            <a:off x="3063240" y="1005840"/>
+            <a:ext cx="8716975" cy="237744"/>
+          </a:xfrm>
+          <a:prstGeom prst="rect">
+            <a:avLst/>
+          </a:prstGeom>
+          <a:noFill/>
+        </p:spPr>
+        <p:txBody>
+          <a:bodyPr wrap="square" anchor="ctr" lIns="36576" rIns="36576" tIns="0" bIns="0">
+            <a:spAutoFit/>
+          </a:bodyPr>
+          <a:lstStyle/>
+          <a:p>
+            <a:pPr algn="r" rtl="1"/>
+            <a:r>
+              <a:rPr sz="1300" b="1">
+                <a:solidFill>
+                  <a:srgbClr val="1C3C7A"/>
+                </a:solidFill>
+                <a:latin typeface="Heebo"/>
+                <a:cs typeface="Heebo"/>
+              </a:rPr>
+              <a:t>דירקטוריון מצומצם</a:t>
+            </a:r>
+          </a:p>
+        </p:txBody>
+      </p:sp>
+      <p:sp>
+        <p:nvSpPr>
+          <p:cNvPr id="9" name="Rounded Rectangle 8"/>
+          <p:cNvSpPr/>
+          <p:nvPr/>
+        </p:nvSpPr>
+        <p:spPr>
+          <a:xfrm>
+            <a:off x="10124603" y="1280160"/>
+            <a:ext cx="1655612" cy="457200"/>
+          </a:xfrm>
+          <a:prstGeom prst="roundRect">
+            <a:avLst>
+              <a:gd name="adj" fmla="val 18000"/>
+            </a:avLst>
+          </a:prstGeom>
+          <a:solidFill>
+            <a:srgbClr val="FFFFFF"/>
+          </a:solidFill>
+          <a:ln w="15875">
+            <a:solidFill>
+              <a:srgbClr val="C5CDDD"/>
+            </a:solidFill>
+          </a:ln>
+          <a:effectLst/>
+        </p:spPr>
+        <p:style>
+          <a:lnRef idx="1">
+            <a:schemeClr val="accent1"/>
+          </a:lnRef>
+          <a:fillRef idx="3">
+            <a:schemeClr val="accent1"/>
+          </a:fillRef>
+          <a:effectRef idx="2">
+            <a:schemeClr val="accent1"/>
+          </a:effectRef>
+          <a:fontRef idx="minor">
+            <a:schemeClr val="lt1"/>
+          </a:fontRef>
+        </p:style>
+        <p:txBody>
+          <a:bodyPr rtlCol="0" anchor="ctr"/>
+          <a:lstStyle/>
+          <a:p>
+            <a:pPr algn="ctr"/>
+          </a:p>
+        </p:txBody>
+      </p:sp>
+      <p:sp>
+        <p:nvSpPr>
+          <p:cNvPr id="10" name="Rectangle 9"/>
+          <p:cNvSpPr/>
+          <p:nvPr/>
+        </p:nvSpPr>
+        <p:spPr>
+          <a:xfrm>
+            <a:off x="11716207" y="1353312"/>
+            <a:ext cx="45720" cy="310896"/>
+          </a:xfrm>
+          <a:prstGeom prst="rect">
+            <a:avLst/>
+          </a:prstGeom>
+          <a:solidFill>
+            <a:srgbClr val="F0C000"/>
+          </a:solidFill>
+          <a:ln>
+            <a:noFill/>
+          </a:ln>
+          <a:effectLst/>
+        </p:spPr>
+        <p:style>
+          <a:lnRef idx="1">
+            <a:schemeClr val="accent1"/>
+          </a:lnRef>
+          <a:fillRef idx="3">
+            <a:schemeClr val="accent1"/>
+          </a:fillRef>
+          <a:effectRef idx="2">
+            <a:schemeClr val="accent1"/>
+          </a:effectRef>
+          <a:fontRef idx="minor">
+            <a:schemeClr val="lt1"/>
+          </a:fontRef>
+        </p:style>
+        <p:txBody>
+          <a:bodyPr rtlCol="0" anchor="ctr"/>
+          <a:lstStyle/>
+          <a:p>
+            <a:pPr algn="ctr"/>
+          </a:p>
+        </p:txBody>
+      </p:sp>
+      <p:sp>
+        <p:nvSpPr>
+          <p:cNvPr id="11" name="TextBox 10"/>
+          <p:cNvSpPr txBox="1"/>
+          <p:nvPr/>
+        </p:nvSpPr>
+        <p:spPr>
+          <a:xfrm>
+            <a:off x="10124603" y="1280160"/>
+            <a:ext cx="1655612" cy="457200"/>
+          </a:xfrm>
+          <a:prstGeom prst="rect">
+            <a:avLst/>
+          </a:prstGeom>
+          <a:noFill/>
+        </p:spPr>
+        <p:txBody>
+          <a:bodyPr wrap="square" anchor="ctr" lIns="36576" rIns="36576" tIns="0" bIns="0">
+            <a:spAutoFit/>
+          </a:bodyPr>
+          <a:lstStyle/>
+          <a:p>
+            <a:pPr algn="ctr" rtl="1"/>
+            <a:r>
+              <a:rPr sz="1200" b="1">
+                <a:solidFill>
+                  <a:srgbClr val="1A2233"/>
+                </a:solidFill>
+                <a:latin typeface="Heebo"/>
+                <a:cs typeface="Heebo"/>
+              </a:rPr>
+              <a:t>תמיר דורטל</a:t>
+            </a:r>
+          </a:p>
+        </p:txBody>
+      </p:sp>
+      <p:sp>
+        <p:nvSpPr>
+          <p:cNvPr id="12" name="Rounded Rectangle 11"/>
+          <p:cNvSpPr/>
+          <p:nvPr/>
+        </p:nvSpPr>
+        <p:spPr>
+          <a:xfrm>
+            <a:off x="8359263" y="1280160"/>
+            <a:ext cx="1655612" cy="457200"/>
+          </a:xfrm>
+          <a:prstGeom prst="roundRect">
+            <a:avLst>
+              <a:gd name="adj" fmla="val 18000"/>
+            </a:avLst>
+          </a:prstGeom>
+          <a:solidFill>
+            <a:srgbClr val="FFFFFF"/>
+          </a:solidFill>
+          <a:ln w="15875">
+            <a:solidFill>
+              <a:srgbClr val="C5CDDD"/>
+            </a:solidFill>
+          </a:ln>
+          <a:effectLst/>
+        </p:spPr>
+        <p:style>
+          <a:lnRef idx="1">
+            <a:schemeClr val="accent1"/>
+          </a:lnRef>
+          <a:fillRef idx="3">
+            <a:schemeClr val="accent1"/>
+          </a:fillRef>
+          <a:effectRef idx="2">
+            <a:schemeClr val="accent1"/>
+          </a:effectRef>
+          <a:fontRef idx="minor">
+            <a:schemeClr val="lt1"/>
+          </a:fontRef>
+        </p:style>
+        <p:txBody>
+          <a:bodyPr rtlCol="0" anchor="ctr"/>
+          <a:lstStyle/>
+          <a:p>
+            <a:pPr algn="ctr"/>
+          </a:p>
+        </p:txBody>
+      </p:sp>
+      <p:sp>
+        <p:nvSpPr>
+          <p:cNvPr id="13" name="Rectangle 12"/>
+          <p:cNvSpPr/>
+          <p:nvPr/>
+        </p:nvSpPr>
+        <p:spPr>
+          <a:xfrm>
+            <a:off x="9950867" y="1353312"/>
+            <a:ext cx="45720" cy="310896"/>
+          </a:xfrm>
+          <a:prstGeom prst="rect">
+            <a:avLst/>
+          </a:prstGeom>
+          <a:solidFill>
+            <a:srgbClr val="F0C000"/>
+          </a:solidFill>
+          <a:ln>
+            <a:noFill/>
+          </a:ln>
+          <a:effectLst/>
+        </p:spPr>
+        <p:style>
+          <a:lnRef idx="1">
+            <a:schemeClr val="accent1"/>
+          </a:lnRef>
+          <a:fillRef idx="3">
+            <a:schemeClr val="accent1"/>
+          </a:fillRef>
+          <a:effectRef idx="2">
+            <a:schemeClr val="accent1"/>
+          </a:effectRef>
+          <a:fontRef idx="minor">
+            <a:schemeClr val="lt1"/>
+          </a:fontRef>
+        </p:style>
+        <p:txBody>
+          <a:bodyPr rtlCol="0" anchor="ctr"/>
+          <a:lstStyle/>
+          <a:p>
+            <a:pPr algn="ctr"/>
+          </a:p>
+        </p:txBody>
+      </p:sp>
+      <p:sp>
+        <p:nvSpPr>
+          <p:cNvPr id="14" name="TextBox 13"/>
+          <p:cNvSpPr txBox="1"/>
+          <p:nvPr/>
+        </p:nvSpPr>
+        <p:spPr>
+          <a:xfrm>
+            <a:off x="8359263" y="1280160"/>
+            <a:ext cx="1655612" cy="457200"/>
+          </a:xfrm>
+          <a:prstGeom prst="rect">
+            <a:avLst/>
+          </a:prstGeom>
+          <a:noFill/>
+        </p:spPr>
+        <p:txBody>
+          <a:bodyPr wrap="square" anchor="ctr" lIns="36576" rIns="36576" tIns="0" bIns="0">
+            <a:spAutoFit/>
+          </a:bodyPr>
+          <a:lstStyle/>
+          <a:p>
+            <a:pPr algn="ctr" rtl="1"/>
+            <a:r>
+              <a:rPr sz="1200" b="1">
+                <a:solidFill>
+                  <a:srgbClr val="1A2233"/>
+                </a:solidFill>
+                <a:latin typeface="Heebo"/>
+                <a:cs typeface="Heebo"/>
+              </a:rPr>
+              <a:t>עו״ד אודליה קדמי</a:t>
+            </a:r>
+          </a:p>
+        </p:txBody>
+      </p:sp>
+      <p:sp>
+        <p:nvSpPr>
+          <p:cNvPr id="15" name="Rounded Rectangle 14"/>
+          <p:cNvSpPr/>
+          <p:nvPr/>
+        </p:nvSpPr>
+        <p:spPr>
+          <a:xfrm>
+            <a:off x="6593923" y="1280160"/>
+            <a:ext cx="1655612" cy="457200"/>
+          </a:xfrm>
+          <a:prstGeom prst="roundRect">
+            <a:avLst>
+              <a:gd name="adj" fmla="val 18000"/>
+            </a:avLst>
+          </a:prstGeom>
+          <a:solidFill>
+            <a:srgbClr val="FFFFFF"/>
+          </a:solidFill>
+          <a:ln w="15875">
+            <a:solidFill>
+              <a:srgbClr val="C5CDDD"/>
+            </a:solidFill>
+          </a:ln>
+          <a:effectLst/>
+        </p:spPr>
+        <p:style>
+          <a:lnRef idx="1">
+            <a:schemeClr val="accent1"/>
+          </a:lnRef>
+          <a:fillRef idx="3">
+            <a:schemeClr val="accent1"/>
+          </a:fillRef>
+          <a:effectRef idx="2">
+            <a:schemeClr val="accent1"/>
+          </a:effectRef>
+          <a:fontRef idx="minor">
+            <a:schemeClr val="lt1"/>
+          </a:fontRef>
+        </p:style>
+        <p:txBody>
+          <a:bodyPr rtlCol="0" anchor="ctr"/>
+          <a:lstStyle/>
+          <a:p>
+            <a:pPr algn="ctr"/>
+          </a:p>
+        </p:txBody>
+      </p:sp>
+      <p:sp>
+        <p:nvSpPr>
+          <p:cNvPr id="16" name="Rectangle 15"/>
+          <p:cNvSpPr/>
+          <p:nvPr/>
+        </p:nvSpPr>
+        <p:spPr>
+          <a:xfrm>
+            <a:off x="8185527" y="1353312"/>
+            <a:ext cx="45720" cy="310896"/>
+          </a:xfrm>
+          <a:prstGeom prst="rect">
+            <a:avLst/>
+          </a:prstGeom>
+          <a:solidFill>
+            <a:srgbClr val="F0C000"/>
+          </a:solidFill>
+          <a:ln>
+            <a:noFill/>
+          </a:ln>
+          <a:effectLst/>
+        </p:spPr>
+        <p:style>
+          <a:lnRef idx="1">
+            <a:schemeClr val="accent1"/>
+          </a:lnRef>
+          <a:fillRef idx="3">
+            <a:schemeClr val="accent1"/>
+          </a:fillRef>
+          <a:effectRef idx="2">
+            <a:schemeClr val="accent1"/>
+          </a:effectRef>
+          <a:fontRef idx="minor">
+            <a:schemeClr val="lt1"/>
+          </a:fontRef>
+        </p:style>
+        <p:txBody>
+          <a:bodyPr rtlCol="0" anchor="ctr"/>
+          <a:lstStyle/>
+          <a:p>
+            <a:pPr algn="ctr"/>
+          </a:p>
+        </p:txBody>
+      </p:sp>
+      <p:sp>
+        <p:nvSpPr>
+          <p:cNvPr id="17" name="TextBox 16"/>
+          <p:cNvSpPr txBox="1"/>
+          <p:nvPr/>
+        </p:nvSpPr>
+        <p:spPr>
+          <a:xfrm>
+            <a:off x="6593923" y="1280160"/>
+            <a:ext cx="1655612" cy="457200"/>
+          </a:xfrm>
+          <a:prstGeom prst="rect">
+            <a:avLst/>
+          </a:prstGeom>
+          <a:noFill/>
+        </p:spPr>
+        <p:txBody>
+          <a:bodyPr wrap="square" anchor="ctr" lIns="36576" rIns="36576" tIns="0" bIns="0">
+            <a:spAutoFit/>
+          </a:bodyPr>
+          <a:lstStyle/>
+          <a:p>
+            <a:pPr algn="ctr" rtl="1"/>
+            <a:r>
+              <a:rPr sz="1200" b="1">
+                <a:solidFill>
+                  <a:srgbClr val="1A2233"/>
+                </a:solidFill>
+                <a:latin typeface="Heebo"/>
+                <a:cs typeface="Heebo"/>
+              </a:rPr>
+              <a:t>ד״ר אמיר רובין</a:t>
+            </a:r>
+          </a:p>
+        </p:txBody>
+      </p:sp>
+      <p:sp>
+        <p:nvSpPr>
+          <p:cNvPr id="18" name="Rounded Rectangle 17"/>
+          <p:cNvSpPr/>
+          <p:nvPr/>
+        </p:nvSpPr>
+        <p:spPr>
+          <a:xfrm>
+            <a:off x="4828583" y="1280160"/>
+            <a:ext cx="1655612" cy="457200"/>
+          </a:xfrm>
+          <a:prstGeom prst="roundRect">
+            <a:avLst>
+              <a:gd name="adj" fmla="val 18000"/>
+            </a:avLst>
+          </a:prstGeom>
+          <a:solidFill>
+            <a:srgbClr val="FFFFFF"/>
+          </a:solidFill>
+          <a:ln w="15875">
+            <a:solidFill>
+              <a:srgbClr val="C5CDDD"/>
+            </a:solidFill>
+          </a:ln>
+          <a:effectLst/>
+        </p:spPr>
+        <p:style>
+          <a:lnRef idx="1">
+            <a:schemeClr val="accent1"/>
+          </a:lnRef>
+          <a:fillRef idx="3">
+            <a:schemeClr val="accent1"/>
+          </a:fillRef>
+          <a:effectRef idx="2">
+            <a:schemeClr val="accent1"/>
+          </a:effectRef>
+          <a:fontRef idx="minor">
+            <a:schemeClr val="lt1"/>
+          </a:fontRef>
+        </p:style>
+        <p:txBody>
+          <a:bodyPr rtlCol="0" anchor="ctr"/>
+          <a:lstStyle/>
+          <a:p>
+            <a:pPr algn="ctr"/>
+          </a:p>
+        </p:txBody>
+      </p:sp>
+      <p:sp>
+        <p:nvSpPr>
+          <p:cNvPr id="19" name="Rectangle 18"/>
+          <p:cNvSpPr/>
+          <p:nvPr/>
+        </p:nvSpPr>
+        <p:spPr>
+          <a:xfrm>
+            <a:off x="6420187" y="1353312"/>
+            <a:ext cx="45720" cy="310896"/>
+          </a:xfrm>
+          <a:prstGeom prst="rect">
+            <a:avLst/>
+          </a:prstGeom>
+          <a:solidFill>
+            <a:srgbClr val="F0C000"/>
+          </a:solidFill>
+          <a:ln>
+            <a:noFill/>
+          </a:ln>
+          <a:effectLst/>
+        </p:spPr>
+        <p:style>
+          <a:lnRef idx="1">
+            <a:schemeClr val="accent1"/>
+          </a:lnRef>
+          <a:fillRef idx="3">
+            <a:schemeClr val="accent1"/>
+          </a:fillRef>
+          <a:effectRef idx="2">
+            <a:schemeClr val="accent1"/>
+          </a:effectRef>
+          <a:fontRef idx="minor">
+            <a:schemeClr val="lt1"/>
+          </a:fontRef>
+        </p:style>
+        <p:txBody>
+          <a:bodyPr rtlCol="0" anchor="ctr"/>
+          <a:lstStyle/>
+          <a:p>
+            <a:pPr algn="ctr"/>
+          </a:p>
+        </p:txBody>
+      </p:sp>
+      <p:sp>
+        <p:nvSpPr>
+          <p:cNvPr id="20" name="TextBox 19"/>
+          <p:cNvSpPr txBox="1"/>
+          <p:nvPr/>
+        </p:nvSpPr>
+        <p:spPr>
+          <a:xfrm>
+            <a:off x="4828583" y="1280160"/>
+            <a:ext cx="1655612" cy="457200"/>
+          </a:xfrm>
+          <a:prstGeom prst="rect">
+            <a:avLst/>
+          </a:prstGeom>
+          <a:noFill/>
+        </p:spPr>
+        <p:txBody>
+          <a:bodyPr wrap="square" anchor="ctr" lIns="36576" rIns="36576" tIns="0" bIns="0">
+            <a:spAutoFit/>
+          </a:bodyPr>
+          <a:lstStyle/>
+          <a:p>
+            <a:pPr algn="ctr" rtl="1"/>
+            <a:r>
+              <a:rPr sz="1200" b="1">
+                <a:solidFill>
+                  <a:srgbClr val="1A2233"/>
+                </a:solidFill>
+                <a:latin typeface="Heebo"/>
+                <a:cs typeface="Heebo"/>
+              </a:rPr>
+              <a:t>נגה ארבל</a:t>
+            </a:r>
+          </a:p>
+        </p:txBody>
+      </p:sp>
+      <p:sp>
+        <p:nvSpPr>
+          <p:cNvPr id="21" name="Rounded Rectangle 20"/>
+          <p:cNvSpPr/>
+          <p:nvPr/>
+        </p:nvSpPr>
+        <p:spPr>
+          <a:xfrm>
+            <a:off x="3063243" y="1280160"/>
+            <a:ext cx="1655612" cy="457200"/>
+          </a:xfrm>
+          <a:prstGeom prst="roundRect">
+            <a:avLst>
+              <a:gd name="adj" fmla="val 18000"/>
+            </a:avLst>
+          </a:prstGeom>
+          <a:solidFill>
+            <a:srgbClr val="FFFFFF"/>
+          </a:solidFill>
+          <a:ln w="15875">
+            <a:solidFill>
+              <a:srgbClr val="C5CDDD"/>
+            </a:solidFill>
+          </a:ln>
+          <a:effectLst/>
+        </p:spPr>
+        <p:style>
+          <a:lnRef idx="1">
+            <a:schemeClr val="accent1"/>
+          </a:lnRef>
+          <a:fillRef idx="3">
+            <a:schemeClr val="accent1"/>
+          </a:fillRef>
+          <a:effectRef idx="2">
+            <a:schemeClr val="accent1"/>
+          </a:effectRef>
+          <a:fontRef idx="minor">
+            <a:schemeClr val="lt1"/>
+          </a:fontRef>
+        </p:style>
+        <p:txBody>
+          <a:bodyPr rtlCol="0" anchor="ctr"/>
+          <a:lstStyle/>
+          <a:p>
+            <a:pPr algn="ctr"/>
+          </a:p>
+        </p:txBody>
+      </p:sp>
+      <p:sp>
+        <p:nvSpPr>
+          <p:cNvPr id="22" name="Rectangle 21"/>
+          <p:cNvSpPr/>
+          <p:nvPr/>
+        </p:nvSpPr>
+        <p:spPr>
+          <a:xfrm>
+            <a:off x="4654847" y="1353312"/>
+            <a:ext cx="45720" cy="310896"/>
+          </a:xfrm>
+          <a:prstGeom prst="rect">
+            <a:avLst/>
+          </a:prstGeom>
+          <a:solidFill>
+            <a:srgbClr val="F0C000"/>
+          </a:solidFill>
+          <a:ln>
+            <a:noFill/>
+          </a:ln>
+          <a:effectLst/>
+        </p:spPr>
+        <p:style>
+          <a:lnRef idx="1">
+            <a:schemeClr val="accent1"/>
+          </a:lnRef>
+          <a:fillRef idx="3">
+            <a:schemeClr val="accent1"/>
+          </a:fillRef>
+          <a:effectRef idx="2">
+            <a:schemeClr val="accent1"/>
+          </a:effectRef>
+          <a:fontRef idx="minor">
+            <a:schemeClr val="lt1"/>
+          </a:fontRef>
+        </p:style>
+        <p:txBody>
+          <a:bodyPr rtlCol="0" anchor="ctr"/>
+          <a:lstStyle/>
+          <a:p>
+            <a:pPr algn="ctr"/>
+          </a:p>
+        </p:txBody>
+      </p:sp>
+      <p:sp>
+        <p:nvSpPr>
+          <p:cNvPr id="23" name="TextBox 22"/>
+          <p:cNvSpPr txBox="1"/>
+          <p:nvPr/>
+        </p:nvSpPr>
+        <p:spPr>
+          <a:xfrm>
+            <a:off x="3063243" y="1280160"/>
+            <a:ext cx="1655612" cy="457200"/>
+          </a:xfrm>
+          <a:prstGeom prst="rect">
+            <a:avLst/>
+          </a:prstGeom>
+          <a:noFill/>
+        </p:spPr>
+        <p:txBody>
+          <a:bodyPr wrap="square" anchor="ctr" lIns="36576" rIns="36576" tIns="0" bIns="0">
+            <a:spAutoFit/>
+          </a:bodyPr>
+          <a:lstStyle/>
+          <a:p>
+            <a:pPr algn="ctr" rtl="1"/>
+            <a:r>
+              <a:rPr sz="1200" b="1">
+                <a:solidFill>
+                  <a:srgbClr val="1A2233"/>
+                </a:solidFill>
+                <a:latin typeface="Heebo"/>
+                <a:cs typeface="Heebo"/>
+              </a:rPr>
+              <a:t>שלומית לביא</a:t>
+            </a:r>
+          </a:p>
+        </p:txBody>
+      </p:sp>
+      <p:sp>
+        <p:nvSpPr>
+          <p:cNvPr id="24" name="Rounded Rectangle 23"/>
+          <p:cNvSpPr/>
+          <p:nvPr/>
+        </p:nvSpPr>
+        <p:spPr>
+          <a:xfrm>
+            <a:off x="411480" y="1078992"/>
+            <a:ext cx="2423160" cy="676656"/>
+          </a:xfrm>
+          <a:prstGeom prst="roundRect">
+            <a:avLst>
+              <a:gd name="adj" fmla="val 10000"/>
+            </a:avLst>
+          </a:prstGeom>
+          <a:noFill/>
+          <a:ln w="15875">
+            <a:solidFill>
+              <a:srgbClr val="F0C000"/>
+            </a:solidFill>
+            <a:prstDash val="dash"/>
+          </a:ln>
+          <a:effectLst/>
+        </p:spPr>
+        <p:style>
+          <a:lnRef idx="1">
+            <a:schemeClr val="accent1"/>
+          </a:lnRef>
+          <a:fillRef idx="3">
+            <a:schemeClr val="accent1"/>
+          </a:fillRef>
+          <a:effectRef idx="2">
+            <a:schemeClr val="accent1"/>
+          </a:effectRef>
+          <a:fontRef idx="minor">
+            <a:schemeClr val="lt1"/>
+          </a:fontRef>
+        </p:style>
+        <p:txBody>
+          <a:bodyPr rtlCol="0" anchor="ctr"/>
+          <a:lstStyle/>
+          <a:p>
+            <a:pPr algn="ctr"/>
+          </a:p>
+        </p:txBody>
+      </p:sp>
+      <p:sp>
+        <p:nvSpPr>
+          <p:cNvPr id="25" name="Rounded Rectangle 24"/>
+          <p:cNvSpPr/>
+          <p:nvPr/>
+        </p:nvSpPr>
+        <p:spPr>
+          <a:xfrm>
+            <a:off x="484632" y="969264"/>
+            <a:ext cx="502920" cy="219456"/>
+          </a:xfrm>
+          <a:prstGeom prst="roundRect">
+            <a:avLst>
+              <a:gd name="adj" fmla="val 50000"/>
+            </a:avLst>
+          </a:prstGeom>
+          <a:solidFill>
+            <a:srgbClr val="F0C000"/>
+          </a:solidFill>
+          <a:ln>
+            <a:noFill/>
+          </a:ln>
+          <a:effectLst/>
+        </p:spPr>
+        <p:style>
+          <a:lnRef idx="1">
+            <a:schemeClr val="accent1"/>
+          </a:lnRef>
+          <a:fillRef idx="3">
+            <a:schemeClr val="accent1"/>
+          </a:fillRef>
+          <a:effectRef idx="2">
+            <a:schemeClr val="accent1"/>
+          </a:effectRef>
+          <a:fontRef idx="minor">
+            <a:schemeClr val="lt1"/>
+          </a:fontRef>
+        </p:style>
+        <p:txBody>
+          <a:bodyPr rtlCol="0" anchor="ctr"/>
+          <a:lstStyle/>
+          <a:p>
+            <a:pPr algn="ctr"/>
+          </a:p>
+        </p:txBody>
+      </p:sp>
+      <p:sp>
+        <p:nvSpPr>
+          <p:cNvPr id="26" name="TextBox 25"/>
+          <p:cNvSpPr txBox="1"/>
+          <p:nvPr/>
+        </p:nvSpPr>
+        <p:spPr>
+          <a:xfrm>
+            <a:off x="484632" y="969264"/>
+            <a:ext cx="502920" cy="219456"/>
+          </a:xfrm>
+          <a:prstGeom prst="rect">
+            <a:avLst/>
+          </a:prstGeom>
+          <a:noFill/>
+        </p:spPr>
+        <p:txBody>
+          <a:bodyPr wrap="square" anchor="ctr" lIns="36576" rIns="36576" tIns="0" bIns="0">
+            <a:spAutoFit/>
+          </a:bodyPr>
+          <a:lstStyle/>
+          <a:p>
+            <a:pPr algn="ctr" rtl="1"/>
+            <a:r>
+              <a:rPr sz="900" b="1">
+                <a:solidFill>
+                  <a:srgbClr val="122755"/>
+                </a:solidFill>
+                <a:latin typeface="Heebo"/>
+                <a:cs typeface="Heebo"/>
+              </a:rPr>
+              <a:t>חדש</a:t>
+            </a:r>
+          </a:p>
+        </p:txBody>
+      </p:sp>
+      <p:sp>
+        <p:nvSpPr>
+          <p:cNvPr id="27" name="TextBox 26"/>
+          <p:cNvSpPr txBox="1"/>
+          <p:nvPr/>
+        </p:nvSpPr>
+        <p:spPr>
+          <a:xfrm>
+            <a:off x="411480" y="1097280"/>
+            <a:ext cx="2313432" cy="237744"/>
+          </a:xfrm>
+          <a:prstGeom prst="rect">
+            <a:avLst/>
+          </a:prstGeom>
+          <a:noFill/>
+        </p:spPr>
+        <p:txBody>
+          <a:bodyPr wrap="square" anchor="ctr" lIns="36576" rIns="36576" tIns="0" bIns="0">
+            <a:spAutoFit/>
+          </a:bodyPr>
+          <a:lstStyle/>
+          <a:p>
+            <a:pPr algn="r" rtl="1"/>
+            <a:r>
+              <a:rPr sz="1200" b="1">
+                <a:solidFill>
+                  <a:srgbClr val="1C3C7A"/>
+                </a:solidFill>
+                <a:latin typeface="Heebo"/>
+                <a:cs typeface="Heebo"/>
+              </a:rPr>
+              <a:t>יועצים מקצועיים</a:t>
+            </a:r>
+          </a:p>
+        </p:txBody>
+      </p:sp>
+      <p:sp>
+        <p:nvSpPr>
+          <p:cNvPr id="28" name="TextBox 27"/>
+          <p:cNvSpPr txBox="1"/>
+          <p:nvPr/>
+        </p:nvSpPr>
+        <p:spPr>
+          <a:xfrm>
+            <a:off x="411480" y="1325880"/>
+            <a:ext cx="2313432" cy="219456"/>
+          </a:xfrm>
+          <a:prstGeom prst="rect">
+            <a:avLst/>
+          </a:prstGeom>
+          <a:noFill/>
+        </p:spPr>
+        <p:txBody>
+          <a:bodyPr wrap="square" anchor="ctr" lIns="36576" rIns="36576" tIns="0" bIns="0">
+            <a:spAutoFit/>
+          </a:bodyPr>
+          <a:lstStyle/>
+          <a:p>
+            <a:pPr algn="r" rtl="1"/>
+            <a:r>
+              <a:rPr sz="1100" b="0">
+                <a:solidFill>
+                  <a:srgbClr val="1A2233"/>
+                </a:solidFill>
+                <a:latin typeface="Heebo"/>
+                <a:cs typeface="Heebo"/>
+              </a:rPr>
+              <a:t>טל קופל · עו״ד תמר ארבל</a:t>
+            </a:r>
+          </a:p>
+        </p:txBody>
+      </p:sp>
+      <p:sp>
+        <p:nvSpPr>
+          <p:cNvPr id="29" name="TextBox 28"/>
+          <p:cNvSpPr txBox="1"/>
+          <p:nvPr/>
+        </p:nvSpPr>
+        <p:spPr>
+          <a:xfrm>
+            <a:off x="411480" y="1527048"/>
+            <a:ext cx="2313432" cy="201168"/>
+          </a:xfrm>
+          <a:prstGeom prst="rect">
+            <a:avLst/>
+          </a:prstGeom>
+          <a:noFill/>
+        </p:spPr>
+        <p:txBody>
+          <a:bodyPr wrap="square" anchor="ctr" lIns="36576" rIns="36576" tIns="0" bIns="0">
+            <a:spAutoFit/>
+          </a:bodyPr>
+          <a:lstStyle/>
+          <a:p>
+            <a:pPr algn="r" rtl="1"/>
+            <a:r>
+              <a:rPr sz="900" b="0">
+                <a:solidFill>
+                  <a:srgbClr val="8A94A8"/>
+                </a:solidFill>
+                <a:latin typeface="Heebo"/>
+                <a:cs typeface="Heebo"/>
+              </a:rPr>
+              <a:t>מצטרפים לדיונים בתחומם</a:t>
+            </a:r>
+          </a:p>
+        </p:txBody>
+      </p:sp>
+      <p:cxnSp>
+        <p:nvCxnSpPr>
+          <p:cNvPr id="30" name="Connector 29"/>
+          <p:cNvCxnSpPr/>
+          <p:nvPr/>
+        </p:nvCxnSpPr>
+        <p:spPr>
+          <a:xfrm>
+            <a:off x="7010247" y="1737360"/>
+            <a:ext cx="0" cy="365760"/>
+          </a:xfrm>
+          <a:prstGeom prst="line">
+            <a:avLst/>
+          </a:prstGeom>
+          <a:ln w="19050">
+            <a:solidFill>
+              <a:srgbClr val="C5CDDD"/>
+            </a:solidFill>
+          </a:ln>
+        </p:spPr>
+        <p:style>
+          <a:lnRef idx="2">
+            <a:schemeClr val="accent1"/>
+          </a:lnRef>
+          <a:fillRef idx="0">
+            <a:schemeClr val="accent1"/>
+          </a:fillRef>
+          <a:effectRef idx="1">
+            <a:schemeClr val="accent1"/>
+          </a:effectRef>
+          <a:fontRef idx="minor">
+            <a:schemeClr val="tx1"/>
+          </a:fontRef>
+        </p:style>
+      </p:cxnSp>
+      <p:sp>
+        <p:nvSpPr>
+          <p:cNvPr id="31" name="Rounded Rectangle 30"/>
+          <p:cNvSpPr/>
+          <p:nvPr/>
+        </p:nvSpPr>
+        <p:spPr>
+          <a:xfrm>
+            <a:off x="3429000" y="2103120"/>
+            <a:ext cx="5330952" cy="2057400"/>
+          </a:xfrm>
+          <a:prstGeom prst="roundRect">
+            <a:avLst>
+              <a:gd name="adj" fmla="val 5000"/>
+            </a:avLst>
+          </a:prstGeom>
+          <a:solidFill>
+            <a:srgbClr val="FFFFFF"/>
+          </a:solidFill>
+          <a:ln w="31750">
+            <a:solidFill>
+              <a:srgbClr val="F0C000"/>
+            </a:solidFill>
+          </a:ln>
+          <a:effectLst/>
+        </p:spPr>
+        <p:style>
+          <a:lnRef idx="1">
+            <a:schemeClr val="accent1"/>
+          </a:lnRef>
+          <a:fillRef idx="3">
+            <a:schemeClr val="accent1"/>
+          </a:fillRef>
+          <a:effectRef idx="2">
+            <a:schemeClr val="accent1"/>
+          </a:effectRef>
+          <a:fontRef idx="minor">
+            <a:schemeClr val="lt1"/>
+          </a:fontRef>
+        </p:style>
+        <p:txBody>
+          <a:bodyPr rtlCol="0" anchor="ctr"/>
+          <a:lstStyle/>
+          <a:p>
+            <a:pPr algn="ctr"/>
+          </a:p>
+        </p:txBody>
+      </p:sp>
+      <p:sp>
+        <p:nvSpPr>
+          <p:cNvPr id="32" name="Rounded Rectangle 31"/>
+          <p:cNvSpPr/>
+          <p:nvPr/>
+        </p:nvSpPr>
+        <p:spPr>
+          <a:xfrm>
+            <a:off x="3538728" y="1993392"/>
+            <a:ext cx="502920" cy="219456"/>
+          </a:xfrm>
+          <a:prstGeom prst="roundRect">
+            <a:avLst>
+              <a:gd name="adj" fmla="val 50000"/>
+            </a:avLst>
+          </a:prstGeom>
+          <a:solidFill>
+            <a:srgbClr val="F0C000"/>
+          </a:solidFill>
+          <a:ln>
+            <a:noFill/>
+          </a:ln>
+          <a:effectLst/>
+        </p:spPr>
+        <p:style>
+          <a:lnRef idx="1">
+            <a:schemeClr val="accent1"/>
+          </a:lnRef>
+          <a:fillRef idx="3">
+            <a:schemeClr val="accent1"/>
+          </a:fillRef>
+          <a:effectRef idx="2">
+            <a:schemeClr val="accent1"/>
+          </a:effectRef>
+          <a:fontRef idx="minor">
+            <a:schemeClr val="lt1"/>
+          </a:fontRef>
+        </p:style>
+        <p:txBody>
+          <a:bodyPr rtlCol="0" anchor="ctr"/>
+          <a:lstStyle/>
+          <a:p>
+            <a:pPr algn="ctr"/>
+          </a:p>
+        </p:txBody>
+      </p:sp>
+      <p:sp>
+        <p:nvSpPr>
+          <p:cNvPr id="33" name="TextBox 32"/>
+          <p:cNvSpPr txBox="1"/>
+          <p:nvPr/>
+        </p:nvSpPr>
+        <p:spPr>
+          <a:xfrm>
+            <a:off x="3538728" y="1993392"/>
+            <a:ext cx="502920" cy="219456"/>
+          </a:xfrm>
+          <a:prstGeom prst="rect">
+            <a:avLst/>
+          </a:prstGeom>
+          <a:noFill/>
+        </p:spPr>
+        <p:txBody>
+          <a:bodyPr wrap="square" anchor="ctr" lIns="36576" rIns="36576" tIns="0" bIns="0">
+            <a:spAutoFit/>
+          </a:bodyPr>
+          <a:lstStyle/>
+          <a:p>
+            <a:pPr algn="ctr" rtl="1"/>
+            <a:r>
+              <a:rPr sz="900" b="1">
+                <a:solidFill>
+                  <a:srgbClr val="122755"/>
+                </a:solidFill>
+                <a:latin typeface="Heebo"/>
+                <a:cs typeface="Heebo"/>
+              </a:rPr>
+              <a:t>חדש</a:t>
+            </a:r>
+          </a:p>
+        </p:txBody>
+      </p:sp>
+      <p:sp>
+        <p:nvSpPr>
+          <p:cNvPr id="34" name="TextBox 33"/>
+          <p:cNvSpPr txBox="1"/>
+          <p:nvPr/>
+        </p:nvSpPr>
+        <p:spPr>
+          <a:xfrm>
+            <a:off x="3429000" y="2194560"/>
+            <a:ext cx="5330952" cy="329184"/>
+          </a:xfrm>
+          <a:prstGeom prst="rect">
+            <a:avLst/>
+          </a:prstGeom>
+          <a:noFill/>
+        </p:spPr>
+        <p:txBody>
+          <a:bodyPr wrap="square" anchor="ctr" lIns="36576" rIns="36576" tIns="0" bIns="0">
+            <a:spAutoFit/>
+          </a:bodyPr>
+          <a:lstStyle/>
+          <a:p>
+            <a:pPr algn="ctr" rtl="1"/>
+            <a:r>
+              <a:rPr sz="1700" b="1">
+                <a:solidFill>
+                  <a:srgbClr val="1C3C7A"/>
+                </a:solidFill>
+                <a:latin typeface="Heebo"/>
+                <a:cs typeface="Heebo"/>
+              </a:rPr>
+              <a:t>צוות הכנסת · קבוע ובשכר</a:t>
+            </a:r>
+          </a:p>
+        </p:txBody>
+      </p:sp>
+      <p:sp>
+        <p:nvSpPr>
+          <p:cNvPr id="35" name="Rounded Rectangle 34"/>
+          <p:cNvSpPr/>
+          <p:nvPr/>
+        </p:nvSpPr>
+        <p:spPr>
+          <a:xfrm>
+            <a:off x="7440930" y="2651760"/>
+            <a:ext cx="1181862" cy="566928"/>
+          </a:xfrm>
+          <a:prstGeom prst="roundRect">
+            <a:avLst>
+              <a:gd name="adj" fmla="val 18000"/>
+            </a:avLst>
+          </a:prstGeom>
+          <a:solidFill>
+            <a:srgbClr val="FFFFFF"/>
+          </a:solidFill>
+          <a:ln w="15875">
+            <a:solidFill>
+              <a:srgbClr val="C5CDDD"/>
+            </a:solidFill>
+          </a:ln>
+          <a:effectLst/>
+        </p:spPr>
+        <p:style>
+          <a:lnRef idx="1">
+            <a:schemeClr val="accent1"/>
+          </a:lnRef>
+          <a:fillRef idx="3">
+            <a:schemeClr val="accent1"/>
+          </a:fillRef>
+          <a:effectRef idx="2">
+            <a:schemeClr val="accent1"/>
+          </a:effectRef>
+          <a:fontRef idx="minor">
+            <a:schemeClr val="lt1"/>
+          </a:fontRef>
+        </p:style>
+        <p:txBody>
+          <a:bodyPr rtlCol="0" anchor="ctr"/>
+          <a:lstStyle/>
+          <a:p>
+            <a:pPr algn="ctr"/>
+          </a:p>
+        </p:txBody>
+      </p:sp>
+      <p:sp>
+        <p:nvSpPr>
+          <p:cNvPr id="36" name="Rectangle 35"/>
+          <p:cNvSpPr/>
+          <p:nvPr/>
+        </p:nvSpPr>
+        <p:spPr>
+          <a:xfrm>
+            <a:off x="8558784" y="2724912"/>
+            <a:ext cx="45720" cy="420624"/>
+          </a:xfrm>
+          <a:prstGeom prst="rect">
+            <a:avLst/>
+          </a:prstGeom>
+          <a:solidFill>
+            <a:srgbClr val="F0C000"/>
+          </a:solidFill>
+          <a:ln>
+            <a:noFill/>
+          </a:ln>
+          <a:effectLst/>
+        </p:spPr>
+        <p:style>
+          <a:lnRef idx="1">
+            <a:schemeClr val="accent1"/>
+          </a:lnRef>
+          <a:fillRef idx="3">
+            <a:schemeClr val="accent1"/>
+          </a:fillRef>
+          <a:effectRef idx="2">
+            <a:schemeClr val="accent1"/>
+          </a:effectRef>
+          <a:fontRef idx="minor">
+            <a:schemeClr val="lt1"/>
+          </a:fontRef>
+        </p:style>
+        <p:txBody>
+          <a:bodyPr rtlCol="0" anchor="ctr"/>
+          <a:lstStyle/>
+          <a:p>
+            <a:pPr algn="ctr"/>
+          </a:p>
+        </p:txBody>
+      </p:sp>
+      <p:sp>
+        <p:nvSpPr>
+          <p:cNvPr id="37" name="TextBox 36"/>
+          <p:cNvSpPr txBox="1"/>
+          <p:nvPr/>
+        </p:nvSpPr>
+        <p:spPr>
+          <a:xfrm>
+            <a:off x="7440930" y="2706624"/>
+            <a:ext cx="1181862" cy="294802"/>
+          </a:xfrm>
+          <a:prstGeom prst="rect">
+            <a:avLst/>
+          </a:prstGeom>
+          <a:noFill/>
+        </p:spPr>
+        <p:txBody>
+          <a:bodyPr wrap="square" anchor="b" lIns="36576" rIns="36576" tIns="0" bIns="0">
+            <a:spAutoFit/>
+          </a:bodyPr>
+          <a:lstStyle/>
+          <a:p>
+            <a:pPr algn="ctr" rtl="1"/>
+            <a:r>
+              <a:rPr sz="1200" b="1">
+                <a:solidFill>
+                  <a:srgbClr val="1A2233"/>
+                </a:solidFill>
+                <a:latin typeface="Heebo"/>
+                <a:cs typeface="Heebo"/>
+              </a:rPr>
+              <a:t>תמיר דורטל</a:t>
+            </a:r>
+          </a:p>
+        </p:txBody>
+      </p:sp>
+      <p:sp>
+        <p:nvSpPr>
+          <p:cNvPr id="38" name="TextBox 37"/>
+          <p:cNvSpPr txBox="1"/>
+          <p:nvPr/>
+        </p:nvSpPr>
+        <p:spPr>
+          <a:xfrm>
+            <a:off x="7440930" y="2963570"/>
+            <a:ext cx="1181862" cy="226771"/>
+          </a:xfrm>
+          <a:prstGeom prst="rect">
+            <a:avLst/>
+          </a:prstGeom>
+          <a:noFill/>
+        </p:spPr>
+        <p:txBody>
+          <a:bodyPr wrap="square" anchor="t" lIns="36576" rIns="36576" tIns="0" bIns="0">
+            <a:spAutoFit/>
+          </a:bodyPr>
+          <a:lstStyle/>
+          <a:p>
+            <a:pPr algn="ctr" rtl="1"/>
+            <a:r>
+              <a:rPr sz="900" b="0">
+                <a:solidFill>
+                  <a:srgbClr val="8A94A8"/>
+                </a:solidFill>
+                <a:latin typeface="Heebo"/>
+                <a:cs typeface="Heebo"/>
+              </a:rPr>
+              <a:t>נציג קבוע</a:t>
+            </a:r>
+          </a:p>
+        </p:txBody>
+      </p:sp>
+      <p:sp>
+        <p:nvSpPr>
+          <p:cNvPr id="39" name="Rounded Rectangle 38"/>
+          <p:cNvSpPr/>
+          <p:nvPr/>
+        </p:nvSpPr>
+        <p:spPr>
+          <a:xfrm>
+            <a:off x="6149340" y="2651760"/>
+            <a:ext cx="1181862" cy="566928"/>
+          </a:xfrm>
+          <a:prstGeom prst="roundRect">
+            <a:avLst>
+              <a:gd name="adj" fmla="val 18000"/>
+            </a:avLst>
+          </a:prstGeom>
+          <a:solidFill>
+            <a:srgbClr val="FFFFFF"/>
+          </a:solidFill>
+          <a:ln w="15875">
+            <a:solidFill>
+              <a:srgbClr val="C5CDDD"/>
+            </a:solidFill>
+          </a:ln>
+          <a:effectLst/>
+        </p:spPr>
+        <p:style>
+          <a:lnRef idx="1">
+            <a:schemeClr val="accent1"/>
+          </a:lnRef>
+          <a:fillRef idx="3">
+            <a:schemeClr val="accent1"/>
+          </a:fillRef>
+          <a:effectRef idx="2">
+            <a:schemeClr val="accent1"/>
+          </a:effectRef>
+          <a:fontRef idx="minor">
+            <a:schemeClr val="lt1"/>
+          </a:fontRef>
+        </p:style>
+        <p:txBody>
+          <a:bodyPr rtlCol="0" anchor="ctr"/>
+          <a:lstStyle/>
+          <a:p>
+            <a:pPr algn="ctr"/>
+          </a:p>
+        </p:txBody>
+      </p:sp>
+      <p:sp>
+        <p:nvSpPr>
+          <p:cNvPr id="40" name="Rectangle 39"/>
+          <p:cNvSpPr/>
+          <p:nvPr/>
+        </p:nvSpPr>
+        <p:spPr>
+          <a:xfrm>
+            <a:off x="7267194" y="2724912"/>
+            <a:ext cx="45720" cy="420624"/>
+          </a:xfrm>
+          <a:prstGeom prst="rect">
+            <a:avLst/>
+          </a:prstGeom>
+          <a:solidFill>
+            <a:srgbClr val="F0C000"/>
+          </a:solidFill>
+          <a:ln>
+            <a:noFill/>
+          </a:ln>
+          <a:effectLst/>
+        </p:spPr>
+        <p:style>
+          <a:lnRef idx="1">
+            <a:schemeClr val="accent1"/>
+          </a:lnRef>
+          <a:fillRef idx="3">
+            <a:schemeClr val="accent1"/>
+          </a:fillRef>
+          <a:effectRef idx="2">
+            <a:schemeClr val="accent1"/>
+          </a:effectRef>
+          <a:fontRef idx="minor">
+            <a:schemeClr val="lt1"/>
+          </a:fontRef>
+        </p:style>
+        <p:txBody>
+          <a:bodyPr rtlCol="0" anchor="ctr"/>
+          <a:lstStyle/>
+          <a:p>
+            <a:pPr algn="ctr"/>
+          </a:p>
+        </p:txBody>
+      </p:sp>
+      <p:sp>
+        <p:nvSpPr>
+          <p:cNvPr id="41" name="TextBox 40"/>
+          <p:cNvSpPr txBox="1"/>
+          <p:nvPr/>
+        </p:nvSpPr>
+        <p:spPr>
+          <a:xfrm>
+            <a:off x="6149340" y="2706624"/>
+            <a:ext cx="1181862" cy="294802"/>
+          </a:xfrm>
+          <a:prstGeom prst="rect">
+            <a:avLst/>
+          </a:prstGeom>
+          <a:noFill/>
+        </p:spPr>
+        <p:txBody>
+          <a:bodyPr wrap="square" anchor="b" lIns="36576" rIns="36576" tIns="0" bIns="0">
+            <a:spAutoFit/>
+          </a:bodyPr>
+          <a:lstStyle/>
+          <a:p>
+            <a:pPr algn="ctr" rtl="1"/>
+            <a:r>
+              <a:rPr sz="1200" b="1">
+                <a:solidFill>
+                  <a:srgbClr val="1A2233"/>
+                </a:solidFill>
+                <a:latin typeface="Heebo"/>
+                <a:cs typeface="Heebo"/>
+              </a:rPr>
+              <a:t>אדם קורגן</a:t>
+            </a:r>
+          </a:p>
+        </p:txBody>
+      </p:sp>
+      <p:sp>
+        <p:nvSpPr>
+          <p:cNvPr id="42" name="TextBox 41"/>
+          <p:cNvSpPr txBox="1"/>
+          <p:nvPr/>
+        </p:nvSpPr>
+        <p:spPr>
+          <a:xfrm>
+            <a:off x="6149340" y="2963570"/>
+            <a:ext cx="1181862" cy="226771"/>
+          </a:xfrm>
+          <a:prstGeom prst="rect">
+            <a:avLst/>
+          </a:prstGeom>
+          <a:noFill/>
+        </p:spPr>
+        <p:txBody>
+          <a:bodyPr wrap="square" anchor="t" lIns="36576" rIns="36576" tIns="0" bIns="0">
+            <a:spAutoFit/>
+          </a:bodyPr>
+          <a:lstStyle/>
+          <a:p>
+            <a:pPr algn="ctr" rtl="1"/>
+            <a:r>
+              <a:rPr sz="900" b="0">
+                <a:solidFill>
+                  <a:srgbClr val="8A94A8"/>
+                </a:solidFill>
+                <a:latin typeface="Heebo"/>
+                <a:cs typeface="Heebo"/>
+              </a:rPr>
+              <a:t>נציג קבוע</a:t>
+            </a:r>
+          </a:p>
+        </p:txBody>
+      </p:sp>
+      <p:sp>
+        <p:nvSpPr>
+          <p:cNvPr id="43" name="Rounded Rectangle 42"/>
+          <p:cNvSpPr/>
+          <p:nvPr/>
+        </p:nvSpPr>
+        <p:spPr>
+          <a:xfrm>
+            <a:off x="4857750" y="2651760"/>
+            <a:ext cx="1181862" cy="566928"/>
+          </a:xfrm>
+          <a:prstGeom prst="roundRect">
+            <a:avLst>
+              <a:gd name="adj" fmla="val 18000"/>
+            </a:avLst>
+          </a:prstGeom>
+          <a:solidFill>
+            <a:srgbClr val="FFFFFF"/>
+          </a:solidFill>
+          <a:ln w="15875">
+            <a:solidFill>
+              <a:srgbClr val="C5CDDD"/>
+            </a:solidFill>
+          </a:ln>
+          <a:effectLst/>
+        </p:spPr>
+        <p:style>
+          <a:lnRef idx="1">
+            <a:schemeClr val="accent1"/>
+          </a:lnRef>
+          <a:fillRef idx="3">
+            <a:schemeClr val="accent1"/>
+          </a:fillRef>
+          <a:effectRef idx="2">
+            <a:schemeClr val="accent1"/>
+          </a:effectRef>
+          <a:fontRef idx="minor">
+            <a:schemeClr val="lt1"/>
+          </a:fontRef>
+        </p:style>
+        <p:txBody>
+          <a:bodyPr rtlCol="0" anchor="ctr"/>
+          <a:lstStyle/>
+          <a:p>
+            <a:pPr algn="ctr"/>
+          </a:p>
+        </p:txBody>
+      </p:sp>
+      <p:sp>
+        <p:nvSpPr>
+          <p:cNvPr id="44" name="Rectangle 43"/>
+          <p:cNvSpPr/>
+          <p:nvPr/>
+        </p:nvSpPr>
+        <p:spPr>
+          <a:xfrm>
+            <a:off x="5975604" y="2724912"/>
+            <a:ext cx="45720" cy="420624"/>
+          </a:xfrm>
+          <a:prstGeom prst="rect">
+            <a:avLst/>
+          </a:prstGeom>
+          <a:solidFill>
+            <a:srgbClr val="F0C000"/>
+          </a:solidFill>
+          <a:ln>
+            <a:noFill/>
+          </a:ln>
+          <a:effectLst/>
+        </p:spPr>
+        <p:style>
+          <a:lnRef idx="1">
+            <a:schemeClr val="accent1"/>
+          </a:lnRef>
+          <a:fillRef idx="3">
+            <a:schemeClr val="accent1"/>
+          </a:fillRef>
+          <a:effectRef idx="2">
+            <a:schemeClr val="accent1"/>
+          </a:effectRef>
+          <a:fontRef idx="minor">
+            <a:schemeClr val="lt1"/>
+          </a:fontRef>
+        </p:style>
+        <p:txBody>
+          <a:bodyPr rtlCol="0" anchor="ctr"/>
+          <a:lstStyle/>
+          <a:p>
+            <a:pPr algn="ctr"/>
+          </a:p>
+        </p:txBody>
+      </p:sp>
+      <p:sp>
+        <p:nvSpPr>
+          <p:cNvPr id="45" name="TextBox 44"/>
+          <p:cNvSpPr txBox="1"/>
+          <p:nvPr/>
+        </p:nvSpPr>
+        <p:spPr>
+          <a:xfrm>
+            <a:off x="4857750" y="2706624"/>
+            <a:ext cx="1181862" cy="294802"/>
+          </a:xfrm>
+          <a:prstGeom prst="rect">
+            <a:avLst/>
+          </a:prstGeom>
+          <a:noFill/>
+        </p:spPr>
+        <p:txBody>
+          <a:bodyPr wrap="square" anchor="b" lIns="36576" rIns="36576" tIns="0" bIns="0">
+            <a:spAutoFit/>
+          </a:bodyPr>
+          <a:lstStyle/>
+          <a:p>
+            <a:pPr algn="ctr" rtl="1"/>
+            <a:r>
+              <a:rPr sz="1200" b="1">
+                <a:solidFill>
+                  <a:srgbClr val="1A2233"/>
+                </a:solidFill>
+                <a:latin typeface="Heebo"/>
+                <a:cs typeface="Heebo"/>
+              </a:rPr>
+              <a:t>ד״ר אמיר רובין</a:t>
+            </a:r>
+          </a:p>
+        </p:txBody>
+      </p:sp>
+      <p:sp>
+        <p:nvSpPr>
+          <p:cNvPr id="46" name="TextBox 45"/>
+          <p:cNvSpPr txBox="1"/>
+          <p:nvPr/>
+        </p:nvSpPr>
+        <p:spPr>
+          <a:xfrm>
+            <a:off x="4857750" y="2963570"/>
+            <a:ext cx="1181862" cy="226771"/>
+          </a:xfrm>
+          <a:prstGeom prst="rect">
+            <a:avLst/>
+          </a:prstGeom>
+          <a:noFill/>
+        </p:spPr>
+        <p:txBody>
+          <a:bodyPr wrap="square" anchor="t" lIns="36576" rIns="36576" tIns="0" bIns="0">
+            <a:spAutoFit/>
+          </a:bodyPr>
+          <a:lstStyle/>
+          <a:p>
+            <a:pPr algn="ctr" rtl="1"/>
+            <a:r>
+              <a:rPr sz="900" b="0">
+                <a:solidFill>
+                  <a:srgbClr val="8A94A8"/>
+                </a:solidFill>
+                <a:latin typeface="Heebo"/>
+                <a:cs typeface="Heebo"/>
+              </a:rPr>
+              <a:t>נציג קבוע</a:t>
+            </a:r>
+          </a:p>
+        </p:txBody>
+      </p:sp>
+      <p:sp>
+        <p:nvSpPr>
+          <p:cNvPr id="47" name="Rounded Rectangle 46"/>
+          <p:cNvSpPr/>
+          <p:nvPr/>
+        </p:nvSpPr>
+        <p:spPr>
+          <a:xfrm>
+            <a:off x="3566160" y="2651760"/>
+            <a:ext cx="1181862" cy="566928"/>
+          </a:xfrm>
+          <a:prstGeom prst="roundRect">
+            <a:avLst>
+              <a:gd name="adj" fmla="val 18000"/>
+            </a:avLst>
+          </a:prstGeom>
+          <a:noFill/>
+          <a:ln w="15875">
+            <a:solidFill>
+              <a:srgbClr val="F0C000"/>
+            </a:solidFill>
+            <a:prstDash val="dash"/>
+          </a:ln>
+          <a:effectLst/>
+        </p:spPr>
+        <p:style>
+          <a:lnRef idx="1">
+            <a:schemeClr val="accent1"/>
+          </a:lnRef>
+          <a:fillRef idx="3">
+            <a:schemeClr val="accent1"/>
+          </a:fillRef>
+          <a:effectRef idx="2">
+            <a:schemeClr val="accent1"/>
+          </a:effectRef>
+          <a:fontRef idx="minor">
+            <a:schemeClr val="lt1"/>
+          </a:fontRef>
+        </p:style>
+        <p:txBody>
+          <a:bodyPr rtlCol="0" anchor="ctr"/>
+          <a:lstStyle/>
+          <a:p>
+            <a:pPr algn="ctr"/>
+          </a:p>
+        </p:txBody>
+      </p:sp>
+      <p:sp>
+        <p:nvSpPr>
+          <p:cNvPr id="48" name="TextBox 47"/>
+          <p:cNvSpPr txBox="1"/>
+          <p:nvPr/>
+        </p:nvSpPr>
+        <p:spPr>
+          <a:xfrm>
+            <a:off x="3566160" y="2688336"/>
+            <a:ext cx="1181862" cy="292608"/>
+          </a:xfrm>
+          <a:prstGeom prst="rect">
+            <a:avLst/>
+          </a:prstGeom>
+          <a:noFill/>
+        </p:spPr>
+        <p:txBody>
+          <a:bodyPr wrap="square" anchor="b" lIns="36576" rIns="36576" tIns="0" bIns="0">
+            <a:spAutoFit/>
+          </a:bodyPr>
+          <a:lstStyle/>
+          <a:p>
+            <a:pPr algn="ctr" rtl="1"/>
+            <a:r>
+              <a:rPr sz="1200" b="1">
+                <a:solidFill>
+                  <a:srgbClr val="1C3C7A"/>
+                </a:solidFill>
+                <a:latin typeface="Heebo"/>
+                <a:cs typeface="Heebo"/>
+              </a:rPr>
+              <a:t>נציג רביעי</a:t>
+            </a:r>
+          </a:p>
+        </p:txBody>
+      </p:sp>
+      <p:sp>
+        <p:nvSpPr>
+          <p:cNvPr id="49" name="TextBox 48"/>
+          <p:cNvSpPr txBox="1"/>
+          <p:nvPr/>
+        </p:nvSpPr>
+        <p:spPr>
+          <a:xfrm>
+            <a:off x="3566160" y="2980944"/>
+            <a:ext cx="1181862" cy="219456"/>
+          </a:xfrm>
+          <a:prstGeom prst="rect">
+            <a:avLst/>
+          </a:prstGeom>
+          <a:noFill/>
+        </p:spPr>
+        <p:txBody>
+          <a:bodyPr wrap="square" anchor="t" lIns="36576" rIns="36576" tIns="0" bIns="0">
+            <a:spAutoFit/>
+          </a:bodyPr>
+          <a:lstStyle/>
+          <a:p>
+            <a:pPr algn="ctr" rtl="1"/>
+            <a:r>
+              <a:rPr sz="900" b="0">
+                <a:solidFill>
+                  <a:srgbClr val="8A94A8"/>
+                </a:solidFill>
+                <a:latin typeface="Heebo"/>
+                <a:cs typeface="Heebo"/>
+              </a:rPr>
+              <a:t>לגיוס</a:t>
+            </a:r>
+          </a:p>
+        </p:txBody>
+      </p:sp>
+      <p:sp>
+        <p:nvSpPr>
+          <p:cNvPr id="50" name="Rounded Rectangle 49"/>
+          <p:cNvSpPr/>
+          <p:nvPr/>
+        </p:nvSpPr>
+        <p:spPr>
+          <a:xfrm>
+            <a:off x="7010400" y="3429000"/>
+            <a:ext cx="1612392" cy="548640"/>
+          </a:xfrm>
+          <a:prstGeom prst="roundRect">
+            <a:avLst>
+              <a:gd name="adj" fmla="val 20000"/>
+            </a:avLst>
+          </a:prstGeom>
+          <a:solidFill>
+            <a:srgbClr val="1C3C7A"/>
+          </a:solidFill>
+          <a:ln>
+            <a:noFill/>
+          </a:ln>
+          <a:effectLst/>
+        </p:spPr>
+        <p:style>
+          <a:lnRef idx="1">
+            <a:schemeClr val="accent1"/>
+          </a:lnRef>
+          <a:fillRef idx="3">
+            <a:schemeClr val="accent1"/>
+          </a:fillRef>
+          <a:effectRef idx="2">
+            <a:schemeClr val="accent1"/>
+          </a:effectRef>
+          <a:fontRef idx="minor">
+            <a:schemeClr val="lt1"/>
+          </a:fontRef>
+        </p:style>
+        <p:txBody>
+          <a:bodyPr rtlCol="0" anchor="ctr"/>
+          <a:lstStyle/>
+          <a:p>
+            <a:pPr algn="ctr"/>
+          </a:p>
+        </p:txBody>
+      </p:sp>
+      <p:sp>
+        <p:nvSpPr>
+          <p:cNvPr id="51" name="TextBox 50"/>
+          <p:cNvSpPr txBox="1"/>
+          <p:nvPr/>
+        </p:nvSpPr>
+        <p:spPr>
+          <a:xfrm>
+            <a:off x="7010400" y="3429000"/>
+            <a:ext cx="1612392" cy="548640"/>
+          </a:xfrm>
+          <a:prstGeom prst="rect">
+            <a:avLst/>
+          </a:prstGeom>
+          <a:noFill/>
+        </p:spPr>
+        <p:txBody>
+          <a:bodyPr wrap="square" anchor="ctr" lIns="36576" rIns="36576" tIns="0" bIns="0">
+            <a:spAutoFit/>
+          </a:bodyPr>
+          <a:lstStyle/>
+          <a:p>
+            <a:pPr algn="ctr" rtl="1"/>
+            <a:r>
+              <a:rPr sz="1300" b="1">
+                <a:solidFill>
+                  <a:srgbClr val="FFFFFF"/>
+                </a:solidFill>
+                <a:latin typeface="Heebo"/>
+                <a:cs typeface="Heebo"/>
+              </a:rPr>
+              <a:t>בין 3 ל-4 דיונים בשבוע</a:t>
+            </a:r>
+          </a:p>
+        </p:txBody>
+      </p:sp>
+      <p:sp>
+        <p:nvSpPr>
+          <p:cNvPr id="52" name="Rounded Rectangle 51"/>
+          <p:cNvSpPr/>
+          <p:nvPr/>
+        </p:nvSpPr>
+        <p:spPr>
+          <a:xfrm>
+            <a:off x="5288280" y="3429000"/>
+            <a:ext cx="1612392" cy="548640"/>
+          </a:xfrm>
+          <a:prstGeom prst="roundRect">
+            <a:avLst>
+              <a:gd name="adj" fmla="val 20000"/>
+            </a:avLst>
+          </a:prstGeom>
+          <a:solidFill>
+            <a:srgbClr val="1C3C7A"/>
+          </a:solidFill>
+          <a:ln>
+            <a:noFill/>
+          </a:ln>
+          <a:effectLst/>
+        </p:spPr>
+        <p:style>
+          <a:lnRef idx="1">
+            <a:schemeClr val="accent1"/>
+          </a:lnRef>
+          <a:fillRef idx="3">
+            <a:schemeClr val="accent1"/>
+          </a:fillRef>
+          <a:effectRef idx="2">
+            <a:schemeClr val="accent1"/>
+          </a:effectRef>
+          <a:fontRef idx="minor">
+            <a:schemeClr val="lt1"/>
+          </a:fontRef>
+        </p:style>
+        <p:txBody>
+          <a:bodyPr rtlCol="0" anchor="ctr"/>
+          <a:lstStyle/>
+          <a:p>
+            <a:pPr algn="ctr"/>
+          </a:p>
+        </p:txBody>
+      </p:sp>
+      <p:sp>
+        <p:nvSpPr>
+          <p:cNvPr id="53" name="TextBox 52"/>
+          <p:cNvSpPr txBox="1"/>
+          <p:nvPr/>
+        </p:nvSpPr>
+        <p:spPr>
+          <a:xfrm>
+            <a:off x="5288280" y="3429000"/>
+            <a:ext cx="1612392" cy="548640"/>
+          </a:xfrm>
+          <a:prstGeom prst="rect">
+            <a:avLst/>
+          </a:prstGeom>
+          <a:noFill/>
+        </p:spPr>
+        <p:txBody>
+          <a:bodyPr wrap="square" anchor="ctr" lIns="36576" rIns="36576" tIns="0" bIns="0">
+            <a:spAutoFit/>
+          </a:bodyPr>
+          <a:lstStyle/>
+          <a:p>
+            <a:pPr algn="ctr" rtl="1"/>
+            <a:r>
+              <a:rPr sz="1300" b="1">
+                <a:solidFill>
+                  <a:srgbClr val="FFFFFF"/>
+                </a:solidFill>
+                <a:latin typeface="Heebo"/>
+                <a:cs typeface="Heebo"/>
+              </a:rPr>
+              <a:t>2 ימי כנסת מלאים</a:t>
+            </a:r>
+          </a:p>
+        </p:txBody>
+      </p:sp>
+      <p:sp>
+        <p:nvSpPr>
+          <p:cNvPr id="54" name="Rounded Rectangle 53"/>
+          <p:cNvSpPr/>
+          <p:nvPr/>
+        </p:nvSpPr>
+        <p:spPr>
+          <a:xfrm>
+            <a:off x="3566160" y="3429000"/>
+            <a:ext cx="1612392" cy="548640"/>
+          </a:xfrm>
+          <a:prstGeom prst="roundRect">
+            <a:avLst>
+              <a:gd name="adj" fmla="val 20000"/>
+            </a:avLst>
+          </a:prstGeom>
+          <a:solidFill>
+            <a:srgbClr val="1C3C7A"/>
+          </a:solidFill>
+          <a:ln>
+            <a:noFill/>
+          </a:ln>
+          <a:effectLst/>
+        </p:spPr>
+        <p:style>
+          <a:lnRef idx="1">
+            <a:schemeClr val="accent1"/>
+          </a:lnRef>
+          <a:fillRef idx="3">
+            <a:schemeClr val="accent1"/>
+          </a:fillRef>
+          <a:effectRef idx="2">
+            <a:schemeClr val="accent1"/>
+          </a:effectRef>
+          <a:fontRef idx="minor">
+            <a:schemeClr val="lt1"/>
+          </a:fontRef>
+        </p:style>
+        <p:txBody>
+          <a:bodyPr rtlCol="0" anchor="ctr"/>
+          <a:lstStyle/>
+          <a:p>
+            <a:pPr algn="ctr"/>
+          </a:p>
+        </p:txBody>
+      </p:sp>
+      <p:sp>
+        <p:nvSpPr>
+          <p:cNvPr id="55" name="TextBox 54"/>
+          <p:cNvSpPr txBox="1"/>
+          <p:nvPr/>
+        </p:nvSpPr>
+        <p:spPr>
+          <a:xfrm>
+            <a:off x="3566160" y="3429000"/>
+            <a:ext cx="1612392" cy="548640"/>
+          </a:xfrm>
+          <a:prstGeom prst="rect">
+            <a:avLst/>
+          </a:prstGeom>
+          <a:noFill/>
+        </p:spPr>
+        <p:txBody>
+          <a:bodyPr wrap="square" anchor="ctr" lIns="36576" rIns="36576" tIns="0" bIns="0">
+            <a:spAutoFit/>
+          </a:bodyPr>
+          <a:lstStyle/>
+          <a:p>
+            <a:pPr algn="ctr" rtl="1"/>
+            <a:r>
+              <a:rPr sz="1300" b="1">
+                <a:solidFill>
+                  <a:srgbClr val="FFFFFF"/>
+                </a:solidFill>
+                <a:latin typeface="Heebo"/>
+                <a:cs typeface="Heebo"/>
+              </a:rPr>
+              <a:t>4 משרות בשכר</a:t>
+            </a:r>
+          </a:p>
+        </p:txBody>
+      </p:sp>
+      <p:sp>
+        <p:nvSpPr>
+          <p:cNvPr id="56" name="Rounded Rectangle 55"/>
+          <p:cNvSpPr/>
+          <p:nvPr/>
+        </p:nvSpPr>
+        <p:spPr>
+          <a:xfrm>
+            <a:off x="9079992" y="2103120"/>
+            <a:ext cx="2700223" cy="1600200"/>
+          </a:xfrm>
+          <a:prstGeom prst="roundRect">
+            <a:avLst>
+              <a:gd name="adj" fmla="val 6000"/>
+            </a:avLst>
+          </a:prstGeom>
+          <a:solidFill>
+            <a:srgbClr val="FFFFFF"/>
+          </a:solidFill>
+          <a:ln w="15875">
+            <a:solidFill>
+              <a:srgbClr val="C5CDDD"/>
+            </a:solidFill>
+          </a:ln>
+          <a:effectLst/>
+        </p:spPr>
+        <p:style>
+          <a:lnRef idx="1">
+            <a:schemeClr val="accent1"/>
+          </a:lnRef>
+          <a:fillRef idx="3">
+            <a:schemeClr val="accent1"/>
+          </a:fillRef>
+          <a:effectRef idx="2">
+            <a:schemeClr val="accent1"/>
+          </a:effectRef>
+          <a:fontRef idx="minor">
+            <a:schemeClr val="lt1"/>
+          </a:fontRef>
+        </p:style>
+        <p:txBody>
+          <a:bodyPr rtlCol="0" anchor="ctr"/>
+          <a:lstStyle/>
+          <a:p>
+            <a:pPr algn="ctr"/>
+          </a:p>
+        </p:txBody>
+      </p:sp>
+      <p:sp>
+        <p:nvSpPr>
+          <p:cNvPr id="57" name="Rounded Rectangle 56"/>
+          <p:cNvSpPr/>
+          <p:nvPr/>
+        </p:nvSpPr>
+        <p:spPr>
+          <a:xfrm>
+            <a:off x="9079992" y="2103120"/>
+            <a:ext cx="2700223" cy="384048"/>
+          </a:xfrm>
+          <a:prstGeom prst="roundRect">
+            <a:avLst>
+              <a:gd name="adj" fmla="val 20000"/>
+            </a:avLst>
+          </a:prstGeom>
+          <a:solidFill>
+            <a:srgbClr val="1C3C7A"/>
+          </a:solidFill>
+          <a:ln>
+            <a:noFill/>
+          </a:ln>
+          <a:effectLst/>
+        </p:spPr>
+        <p:style>
+          <a:lnRef idx="1">
+            <a:schemeClr val="accent1"/>
+          </a:lnRef>
+          <a:fillRef idx="3">
+            <a:schemeClr val="accent1"/>
+          </a:fillRef>
+          <a:effectRef idx="2">
+            <a:schemeClr val="accent1"/>
+          </a:effectRef>
+          <a:fontRef idx="minor">
+            <a:schemeClr val="lt1"/>
+          </a:fontRef>
+        </p:style>
+        <p:txBody>
+          <a:bodyPr rtlCol="0" anchor="ctr"/>
+          <a:lstStyle/>
+          <a:p>
+            <a:pPr algn="ctr"/>
+          </a:p>
+        </p:txBody>
+      </p:sp>
+      <p:sp>
+        <p:nvSpPr>
+          <p:cNvPr id="58" name="TextBox 57"/>
+          <p:cNvSpPr txBox="1"/>
+          <p:nvPr/>
+        </p:nvSpPr>
+        <p:spPr>
+          <a:xfrm>
+            <a:off x="9079992" y="2103120"/>
+            <a:ext cx="2700223" cy="384048"/>
+          </a:xfrm>
+          <a:prstGeom prst="rect">
+            <a:avLst/>
+          </a:prstGeom>
+          <a:noFill/>
+        </p:spPr>
+        <p:txBody>
+          <a:bodyPr wrap="square" anchor="ctr" lIns="36576" rIns="36576" tIns="0" bIns="0">
+            <a:spAutoFit/>
+          </a:bodyPr>
+          <a:lstStyle/>
+          <a:p>
+            <a:pPr algn="ctr" rtl="1"/>
+            <a:r>
+              <a:rPr sz="1400" b="1">
+                <a:solidFill>
+                  <a:srgbClr val="FFFFFF"/>
+                </a:solidFill>
+                <a:latin typeface="Heebo"/>
+                <a:cs typeface="Heebo"/>
+              </a:rPr>
+              <a:t>צוות מחקר</a:t>
+            </a:r>
+          </a:p>
+        </p:txBody>
+      </p:sp>
+      <p:sp>
+        <p:nvSpPr>
+          <p:cNvPr id="59" name="TextBox 58"/>
+          <p:cNvSpPr txBox="1"/>
+          <p:nvPr/>
+        </p:nvSpPr>
+        <p:spPr>
+          <a:xfrm>
+            <a:off x="9079992" y="2560320"/>
+            <a:ext cx="2700223" cy="274320"/>
+          </a:xfrm>
+          <a:prstGeom prst="rect">
+            <a:avLst/>
+          </a:prstGeom>
+          <a:noFill/>
+        </p:spPr>
+        <p:txBody>
+          <a:bodyPr wrap="square" anchor="ctr" lIns="36576" rIns="36576" tIns="0" bIns="0">
+            <a:spAutoFit/>
+          </a:bodyPr>
+          <a:lstStyle/>
+          <a:p>
+            <a:pPr algn="ctr" rtl="1"/>
+            <a:r>
+              <a:rPr sz="1100" b="1">
+                <a:solidFill>
+                  <a:srgbClr val="1A2233"/>
+                </a:solidFill>
+                <a:latin typeface="Heebo"/>
+                <a:cs typeface="Heebo"/>
+              </a:rPr>
+              <a:t>טמיר שרגא</a:t>
+            </a:r>
+          </a:p>
+        </p:txBody>
+      </p:sp>
+      <p:sp>
+        <p:nvSpPr>
+          <p:cNvPr id="60" name="TextBox 59"/>
+          <p:cNvSpPr txBox="1"/>
+          <p:nvPr/>
+        </p:nvSpPr>
+        <p:spPr>
+          <a:xfrm>
+            <a:off x="9217152" y="2880360"/>
+            <a:ext cx="2425903" cy="274320"/>
+          </a:xfrm>
+          <a:prstGeom prst="rect">
+            <a:avLst/>
+          </a:prstGeom>
+          <a:noFill/>
+        </p:spPr>
+        <p:txBody>
+          <a:bodyPr wrap="square" anchor="ctr" lIns="36576" rIns="36576" tIns="0" bIns="0">
+            <a:spAutoFit/>
+          </a:bodyPr>
+          <a:lstStyle/>
+          <a:p>
+            <a:pPr algn="r" rtl="1"/>
+            <a:r>
+              <a:rPr sz="1100" b="0">
+                <a:solidFill>
+                  <a:srgbClr val="1A2233"/>
+                </a:solidFill>
+                <a:latin typeface="Heebo"/>
+                <a:cs typeface="Heebo"/>
+              </a:rPr>
+              <a:t>• ניירות עמדה</a:t>
+            </a:r>
+          </a:p>
+        </p:txBody>
+      </p:sp>
+      <p:sp>
+        <p:nvSpPr>
+          <p:cNvPr id="61" name="TextBox 60"/>
+          <p:cNvSpPr txBox="1"/>
+          <p:nvPr/>
+        </p:nvSpPr>
+        <p:spPr>
+          <a:xfrm>
+            <a:off x="9217152" y="3154680"/>
+            <a:ext cx="2425903" cy="274320"/>
+          </a:xfrm>
+          <a:prstGeom prst="rect">
+            <a:avLst/>
+          </a:prstGeom>
+          <a:noFill/>
+        </p:spPr>
+        <p:txBody>
+          <a:bodyPr wrap="square" anchor="ctr" lIns="36576" rIns="36576" tIns="0" bIns="0">
+            <a:spAutoFit/>
+          </a:bodyPr>
+          <a:lstStyle/>
+          <a:p>
+            <a:pPr algn="r" rtl="1"/>
+            <a:r>
+              <a:rPr sz="1100" b="0">
+                <a:solidFill>
+                  <a:srgbClr val="1A2233"/>
+                </a:solidFill>
+                <a:latin typeface="Heebo"/>
+                <a:cs typeface="Heebo"/>
+              </a:rPr>
+              <a:t>• הכנת הנציג לכל דיון</a:t>
+            </a:r>
+          </a:p>
+        </p:txBody>
+      </p:sp>
+      <p:cxnSp>
+        <p:nvCxnSpPr>
+          <p:cNvPr id="62" name="Connector 61"/>
+          <p:cNvCxnSpPr/>
+          <p:nvPr/>
+        </p:nvCxnSpPr>
+        <p:spPr>
+          <a:xfrm flipH="1">
+            <a:off x="8759952" y="2903220"/>
+            <a:ext cx="320040" cy="0"/>
+          </a:xfrm>
+          <a:prstGeom prst="line">
+            <a:avLst/>
+          </a:prstGeom>
+          <a:ln w="25400">
+            <a:solidFill>
+              <a:srgbClr val="1C3C7A"/>
+            </a:solidFill>
+            <a:tailEnd type="triangle" w="med" len="med"/>
+          </a:ln>
+        </p:spPr>
+        <p:style>
+          <a:lnRef idx="2">
+            <a:schemeClr val="accent1"/>
+          </a:lnRef>
+          <a:fillRef idx="0">
+            <a:schemeClr val="accent1"/>
+          </a:fillRef>
+          <a:effectRef idx="1">
+            <a:schemeClr val="accent1"/>
+          </a:effectRef>
+          <a:fontRef idx="minor">
+            <a:schemeClr val="tx1"/>
+          </a:fontRef>
+        </p:style>
+      </p:cxnSp>
+      <p:sp>
+        <p:nvSpPr>
+          <p:cNvPr id="63" name="Rounded Rectangle 62"/>
+          <p:cNvSpPr/>
+          <p:nvPr/>
+        </p:nvSpPr>
+        <p:spPr>
+          <a:xfrm>
+            <a:off x="411480" y="2103120"/>
+            <a:ext cx="2697480" cy="1600200"/>
+          </a:xfrm>
+          <a:prstGeom prst="roundRect">
+            <a:avLst>
+              <a:gd name="adj" fmla="val 6000"/>
+            </a:avLst>
+          </a:prstGeom>
+          <a:solidFill>
+            <a:srgbClr val="FFFFFF"/>
+          </a:solidFill>
+          <a:ln w="15875">
+            <a:solidFill>
+              <a:srgbClr val="C5CDDD"/>
+            </a:solidFill>
+          </a:ln>
+          <a:effectLst/>
+        </p:spPr>
+        <p:style>
+          <a:lnRef idx="1">
+            <a:schemeClr val="accent1"/>
+          </a:lnRef>
+          <a:fillRef idx="3">
+            <a:schemeClr val="accent1"/>
+          </a:fillRef>
+          <a:effectRef idx="2">
+            <a:schemeClr val="accent1"/>
+          </a:effectRef>
+          <a:fontRef idx="minor">
+            <a:schemeClr val="lt1"/>
+          </a:fontRef>
+        </p:style>
+        <p:txBody>
+          <a:bodyPr rtlCol="0" anchor="ctr"/>
+          <a:lstStyle/>
+          <a:p>
+            <a:pPr algn="ctr"/>
+          </a:p>
+        </p:txBody>
+      </p:sp>
+      <p:sp>
+        <p:nvSpPr>
+          <p:cNvPr id="64" name="Rounded Rectangle 63"/>
+          <p:cNvSpPr/>
+          <p:nvPr/>
+        </p:nvSpPr>
+        <p:spPr>
+          <a:xfrm>
+            <a:off x="411480" y="2103120"/>
+            <a:ext cx="2697480" cy="384048"/>
+          </a:xfrm>
+          <a:prstGeom prst="roundRect">
+            <a:avLst>
+              <a:gd name="adj" fmla="val 20000"/>
+            </a:avLst>
+          </a:prstGeom>
+          <a:solidFill>
+            <a:srgbClr val="1C3C7A"/>
+          </a:solidFill>
+          <a:ln>
+            <a:noFill/>
+          </a:ln>
+          <a:effectLst/>
+        </p:spPr>
+        <p:style>
+          <a:lnRef idx="1">
+            <a:schemeClr val="accent1"/>
+          </a:lnRef>
+          <a:fillRef idx="3">
+            <a:schemeClr val="accent1"/>
+          </a:fillRef>
+          <a:effectRef idx="2">
+            <a:schemeClr val="accent1"/>
+          </a:effectRef>
+          <a:fontRef idx="minor">
+            <a:schemeClr val="lt1"/>
+          </a:fontRef>
+        </p:style>
+        <p:txBody>
+          <a:bodyPr rtlCol="0" anchor="ctr"/>
+          <a:lstStyle/>
+          <a:p>
+            <a:pPr algn="ctr"/>
+          </a:p>
+        </p:txBody>
+      </p:sp>
+      <p:sp>
+        <p:nvSpPr>
+          <p:cNvPr id="65" name="TextBox 64"/>
+          <p:cNvSpPr txBox="1"/>
+          <p:nvPr/>
+        </p:nvSpPr>
+        <p:spPr>
+          <a:xfrm>
+            <a:off x="411480" y="2103120"/>
+            <a:ext cx="2697480" cy="384048"/>
+          </a:xfrm>
+          <a:prstGeom prst="rect">
+            <a:avLst/>
+          </a:prstGeom>
+          <a:noFill/>
+        </p:spPr>
+        <p:txBody>
+          <a:bodyPr wrap="square" anchor="ctr" lIns="36576" rIns="36576" tIns="0" bIns="0">
+            <a:spAutoFit/>
+          </a:bodyPr>
+          <a:lstStyle/>
+          <a:p>
+            <a:pPr algn="ctr" rtl="1"/>
+            <a:r>
+              <a:rPr sz="1400" b="1">
+                <a:solidFill>
+                  <a:srgbClr val="FFFFFF"/>
+                </a:solidFill>
+                <a:latin typeface="Heebo"/>
+                <a:cs typeface="Heebo"/>
+              </a:rPr>
+              <a:t>אקטיביסטים ונוער</a:t>
+            </a:r>
+          </a:p>
+        </p:txBody>
+      </p:sp>
+      <p:sp>
+        <p:nvSpPr>
+          <p:cNvPr id="66" name="TextBox 65"/>
+          <p:cNvSpPr txBox="1"/>
+          <p:nvPr/>
+        </p:nvSpPr>
+        <p:spPr>
+          <a:xfrm>
+            <a:off x="411480" y="2560320"/>
+            <a:ext cx="2697480" cy="274320"/>
+          </a:xfrm>
+          <a:prstGeom prst="rect">
+            <a:avLst/>
+          </a:prstGeom>
+          <a:noFill/>
+        </p:spPr>
+        <p:txBody>
+          <a:bodyPr wrap="square" anchor="ctr" lIns="36576" rIns="36576" tIns="0" bIns="0">
+            <a:spAutoFit/>
+          </a:bodyPr>
+          <a:lstStyle/>
+          <a:p>
+            <a:pPr algn="ctr" rtl="1"/>
+            <a:r>
+              <a:rPr sz="1100" b="1">
+                <a:solidFill>
+                  <a:srgbClr val="1A2233"/>
+                </a:solidFill>
+                <a:latin typeface="Heebo"/>
+                <a:cs typeface="Heebo"/>
+              </a:rPr>
+              <a:t>יהונתן יחזקאל · יהונתן אמתי</a:t>
+            </a:r>
+          </a:p>
+        </p:txBody>
+      </p:sp>
+      <p:sp>
+        <p:nvSpPr>
+          <p:cNvPr id="67" name="TextBox 66"/>
+          <p:cNvSpPr txBox="1"/>
+          <p:nvPr/>
+        </p:nvSpPr>
+        <p:spPr>
+          <a:xfrm>
+            <a:off x="548640" y="2880360"/>
+            <a:ext cx="2423160" cy="274320"/>
+          </a:xfrm>
+          <a:prstGeom prst="rect">
+            <a:avLst/>
+          </a:prstGeom>
+          <a:noFill/>
+        </p:spPr>
+        <p:txBody>
+          <a:bodyPr wrap="square" anchor="ctr" lIns="36576" rIns="36576" tIns="0" bIns="0">
+            <a:spAutoFit/>
+          </a:bodyPr>
+          <a:lstStyle/>
+          <a:p>
+            <a:pPr algn="r" rtl="1"/>
+            <a:r>
+              <a:rPr sz="1100" b="0">
+                <a:solidFill>
+                  <a:srgbClr val="1A2233"/>
+                </a:solidFill>
+                <a:latin typeface="Heebo"/>
+                <a:cs typeface="Heebo"/>
+              </a:rPr>
+              <a:t>• השלמת נוכחות בדיונים</a:t>
+            </a:r>
+          </a:p>
+        </p:txBody>
+      </p:sp>
+      <p:sp>
+        <p:nvSpPr>
+          <p:cNvPr id="68" name="TextBox 67"/>
+          <p:cNvSpPr txBox="1"/>
+          <p:nvPr/>
+        </p:nvSpPr>
+        <p:spPr>
+          <a:xfrm>
+            <a:off x="548640" y="3154680"/>
+            <a:ext cx="2423160" cy="274320"/>
+          </a:xfrm>
+          <a:prstGeom prst="rect">
+            <a:avLst/>
+          </a:prstGeom>
+          <a:noFill/>
+        </p:spPr>
+        <p:txBody>
+          <a:bodyPr wrap="square" anchor="ctr" lIns="36576" rIns="36576" tIns="0" bIns="0">
+            <a:spAutoFit/>
+          </a:bodyPr>
+          <a:lstStyle/>
+          <a:p>
+            <a:pPr algn="r" rtl="1"/>
+            <a:r>
+              <a:rPr sz="1100" b="0">
+                <a:solidFill>
+                  <a:srgbClr val="1A2233"/>
+                </a:solidFill>
+                <a:latin typeface="Heebo"/>
+                <a:cs typeface="Heebo"/>
+              </a:rPr>
+              <a:t>• הצטרפות לנציג בוועדה</a:t>
+            </a:r>
+          </a:p>
+        </p:txBody>
+      </p:sp>
+      <p:cxnSp>
+        <p:nvCxnSpPr>
+          <p:cNvPr id="69" name="Connector 68"/>
+          <p:cNvCxnSpPr/>
+          <p:nvPr/>
+        </p:nvCxnSpPr>
+        <p:spPr>
+          <a:xfrm>
+            <a:off x="3108960" y="2903220"/>
+            <a:ext cx="320040" cy="0"/>
+          </a:xfrm>
+          <a:prstGeom prst="line">
+            <a:avLst/>
+          </a:prstGeom>
+          <a:ln w="25400">
+            <a:solidFill>
+              <a:srgbClr val="1C3C7A"/>
+            </a:solidFill>
+            <a:tailEnd type="triangle" w="med" len="med"/>
+          </a:ln>
+        </p:spPr>
+        <p:style>
+          <a:lnRef idx="2">
+            <a:schemeClr val="accent1"/>
+          </a:lnRef>
+          <a:fillRef idx="0">
+            <a:schemeClr val="accent1"/>
+          </a:fillRef>
+          <a:effectRef idx="1">
+            <a:schemeClr val="accent1"/>
+          </a:effectRef>
+          <a:fontRef idx="minor">
+            <a:schemeClr val="tx1"/>
+          </a:fontRef>
+        </p:style>
+      </p:cxnSp>
+      <p:cxnSp>
+        <p:nvCxnSpPr>
+          <p:cNvPr id="70" name="Connector 69"/>
+          <p:cNvCxnSpPr/>
+          <p:nvPr/>
+        </p:nvCxnSpPr>
+        <p:spPr>
+          <a:xfrm>
+            <a:off x="6094476" y="4160520"/>
+            <a:ext cx="0" cy="365760"/>
+          </a:xfrm>
+          <a:prstGeom prst="line">
+            <a:avLst/>
+          </a:prstGeom>
+          <a:ln w="25400">
+            <a:solidFill>
+              <a:srgbClr val="1C3C7A"/>
+            </a:solidFill>
+            <a:tailEnd type="triangle" w="med" len="med"/>
+          </a:ln>
+        </p:spPr>
+        <p:style>
+          <a:lnRef idx="2">
+            <a:schemeClr val="accent1"/>
+          </a:lnRef>
+          <a:fillRef idx="0">
+            <a:schemeClr val="accent1"/>
+          </a:fillRef>
+          <a:effectRef idx="1">
+            <a:schemeClr val="accent1"/>
+          </a:effectRef>
+          <a:fontRef idx="minor">
+            <a:schemeClr val="tx1"/>
+          </a:fontRef>
+        </p:style>
+      </p:cxnSp>
+      <p:sp>
+        <p:nvSpPr>
+          <p:cNvPr id="71" name="Rounded Rectangle 70"/>
+          <p:cNvSpPr/>
+          <p:nvPr/>
+        </p:nvSpPr>
+        <p:spPr>
+          <a:xfrm>
+            <a:off x="3429000" y="4526280"/>
+            <a:ext cx="5330952" cy="566928"/>
+          </a:xfrm>
+          <a:prstGeom prst="roundRect">
+            <a:avLst>
+              <a:gd name="adj" fmla="val 20000"/>
+            </a:avLst>
+          </a:prstGeom>
+          <a:solidFill>
+            <a:srgbClr val="F0C000"/>
+          </a:solidFill>
+          <a:ln>
+            <a:noFill/>
+          </a:ln>
+          <a:effectLst/>
+        </p:spPr>
+        <p:style>
+          <a:lnRef idx="1">
+            <a:schemeClr val="accent1"/>
+          </a:lnRef>
+          <a:fillRef idx="3">
+            <a:schemeClr val="accent1"/>
+          </a:fillRef>
+          <a:effectRef idx="2">
+            <a:schemeClr val="accent1"/>
+          </a:effectRef>
+          <a:fontRef idx="minor">
+            <a:schemeClr val="lt1"/>
+          </a:fontRef>
+        </p:style>
+        <p:txBody>
+          <a:bodyPr rtlCol="0" anchor="ctr"/>
+          <a:lstStyle/>
+          <a:p>
+            <a:pPr algn="ctr"/>
+          </a:p>
+        </p:txBody>
+      </p:sp>
+      <p:sp>
+        <p:nvSpPr>
+          <p:cNvPr id="72" name="TextBox 71"/>
+          <p:cNvSpPr txBox="1"/>
+          <p:nvPr/>
+        </p:nvSpPr>
+        <p:spPr>
+          <a:xfrm>
+            <a:off x="3429000" y="4526280"/>
+            <a:ext cx="5330952" cy="566928"/>
+          </a:xfrm>
+          <a:prstGeom prst="rect">
+            <a:avLst/>
+          </a:prstGeom>
+          <a:noFill/>
+        </p:spPr>
+        <p:txBody>
+          <a:bodyPr wrap="square" anchor="ctr" lIns="36576" rIns="36576" tIns="0" bIns="0">
+            <a:spAutoFit/>
+          </a:bodyPr>
+          <a:lstStyle/>
+          <a:p>
+            <a:pPr algn="ctr" rtl="1"/>
+            <a:r>
+              <a:rPr sz="1600" b="1">
+                <a:solidFill>
+                  <a:srgbClr val="122755"/>
+                </a:solidFill>
+                <a:latin typeface="Heebo"/>
+                <a:cs typeface="Heebo"/>
+              </a:rPr>
+              <a:t>דיונים בוועדות הכנסת · פגישות עם חברי כנסת</a:t>
+            </a:r>
+          </a:p>
+        </p:txBody>
+      </p:sp>
+      <p:cxnSp>
+        <p:nvCxnSpPr>
+          <p:cNvPr id="73" name="Connector 72"/>
+          <p:cNvCxnSpPr/>
+          <p:nvPr/>
+        </p:nvCxnSpPr>
+        <p:spPr>
+          <a:xfrm>
+            <a:off x="6094476" y="5093208"/>
+            <a:ext cx="0" cy="256032"/>
+          </a:xfrm>
+          <a:prstGeom prst="line">
+            <a:avLst/>
+          </a:prstGeom>
+          <a:ln w="25400">
+            <a:solidFill>
+              <a:srgbClr val="1C3C7A"/>
+            </a:solidFill>
+            <a:tailEnd type="triangle" w="med" len="med"/>
+          </a:ln>
+        </p:spPr>
+        <p:style>
+          <a:lnRef idx="2">
+            <a:schemeClr val="accent1"/>
+          </a:lnRef>
+          <a:fillRef idx="0">
+            <a:schemeClr val="accent1"/>
+          </a:fillRef>
+          <a:effectRef idx="1">
+            <a:schemeClr val="accent1"/>
+          </a:effectRef>
+          <a:fontRef idx="minor">
+            <a:schemeClr val="tx1"/>
+          </a:fontRef>
+        </p:style>
+      </p:cxnSp>
+      <p:sp>
+        <p:nvSpPr>
+          <p:cNvPr id="74" name="Rounded Rectangle 73"/>
+          <p:cNvSpPr/>
+          <p:nvPr/>
+        </p:nvSpPr>
+        <p:spPr>
+          <a:xfrm>
+            <a:off x="4539996" y="5349240"/>
+            <a:ext cx="3108960" cy="868680"/>
+          </a:xfrm>
+          <a:prstGeom prst="roundRect">
+            <a:avLst>
+              <a:gd name="adj" fmla="val 8000"/>
+            </a:avLst>
+          </a:prstGeom>
+          <a:solidFill>
+            <a:srgbClr val="FFFFFF"/>
+          </a:solidFill>
+          <a:ln w="15875">
+            <a:solidFill>
+              <a:srgbClr val="C5CDDD"/>
+            </a:solidFill>
+          </a:ln>
+          <a:effectLst/>
+        </p:spPr>
+        <p:style>
+          <a:lnRef idx="1">
+            <a:schemeClr val="accent1"/>
+          </a:lnRef>
+          <a:fillRef idx="3">
+            <a:schemeClr val="accent1"/>
+          </a:fillRef>
+          <a:effectRef idx="2">
+            <a:schemeClr val="accent1"/>
+          </a:effectRef>
+          <a:fontRef idx="minor">
+            <a:schemeClr val="lt1"/>
+          </a:fontRef>
+        </p:style>
+        <p:txBody>
+          <a:bodyPr rtlCol="0" anchor="ctr"/>
+          <a:lstStyle/>
+          <a:p>
+            <a:pPr algn="ctr"/>
+          </a:p>
+        </p:txBody>
+      </p:sp>
+      <p:sp>
+        <p:nvSpPr>
+          <p:cNvPr id="75" name="TextBox 74"/>
+          <p:cNvSpPr txBox="1"/>
+          <p:nvPr/>
+        </p:nvSpPr>
+        <p:spPr>
+          <a:xfrm>
+            <a:off x="4539996" y="5422392"/>
+            <a:ext cx="3108960" cy="292608"/>
+          </a:xfrm>
+          <a:prstGeom prst="rect">
+            <a:avLst/>
+          </a:prstGeom>
+          <a:noFill/>
+        </p:spPr>
+        <p:txBody>
+          <a:bodyPr wrap="square" anchor="ctr" lIns="36576" rIns="36576" tIns="0" bIns="0">
+            <a:spAutoFit/>
+          </a:bodyPr>
+          <a:lstStyle/>
+          <a:p>
+            <a:pPr algn="ctr" rtl="1"/>
+            <a:r>
+              <a:rPr sz="1300" b="1">
+                <a:solidFill>
+                  <a:srgbClr val="1C3C7A"/>
+                </a:solidFill>
+                <a:latin typeface="Heebo"/>
+                <a:cs typeface="Heebo"/>
+              </a:rPr>
+              <a:t>צוות דיגיטל · איתמר כהן</a:t>
+            </a:r>
+          </a:p>
+        </p:txBody>
+      </p:sp>
+      <p:sp>
+        <p:nvSpPr>
+          <p:cNvPr id="76" name="TextBox 75"/>
+          <p:cNvSpPr txBox="1"/>
+          <p:nvPr/>
+        </p:nvSpPr>
+        <p:spPr>
+          <a:xfrm>
+            <a:off x="4539996" y="5760720"/>
+            <a:ext cx="3108960" cy="274320"/>
+          </a:xfrm>
+          <a:prstGeom prst="rect">
+            <a:avLst/>
+          </a:prstGeom>
+          <a:noFill/>
+        </p:spPr>
+        <p:txBody>
+          <a:bodyPr wrap="square" anchor="ctr" lIns="36576" rIns="36576" tIns="0" bIns="0">
+            <a:spAutoFit/>
+          </a:bodyPr>
+          <a:lstStyle/>
+          <a:p>
+            <a:pPr algn="ctr" rtl="1"/>
+            <a:r>
+              <a:rPr sz="1100" b="0">
+                <a:solidFill>
+                  <a:srgbClr val="1A2233"/>
+                </a:solidFill>
+                <a:latin typeface="Heebo"/>
+                <a:cs typeface="Heebo"/>
+              </a:rPr>
+              <a:t>הבאת הדיונים לציבור</a:t>
             </a:r>
           </a:p>
         </p:txBody>

</xml_diff>

<commit_message>
Proposal: split non-core people into domain leads and advisors
Co-Authored-By: Claude Opus 5.5 <noreply@anthropic.com>
Claude-Session: https://claude.ai/code/session_01W7Er83FuNT4pLFShWidYHn
</commit_message>
<xml_diff>
--- a/presentation/out/koach-hitarvut.pptx
+++ b/presentation/out/koach-hitarvut.pptx
@@ -17548,14 +17548,60 @@
       </p:pic>
       <p:sp>
         <p:nvSpPr>
-          <p:cNvPr id="8" name="TextBox 7"/>
+          <p:cNvPr id="8" name="Rounded Rectangle 7"/>
+          <p:cNvSpPr/>
+          <p:nvPr/>
+        </p:nvSpPr>
+        <p:spPr>
+          <a:xfrm>
+            <a:off x="5150998" y="1051560"/>
+            <a:ext cx="6629217" cy="841248"/>
+          </a:xfrm>
+          <a:prstGeom prst="roundRect">
+            <a:avLst>
+              <a:gd name="adj" fmla="val 8000"/>
+            </a:avLst>
+          </a:prstGeom>
+          <a:noFill/>
+          <a:ln w="15875">
+            <a:solidFill>
+              <a:srgbClr val="C5CDDD"/>
+            </a:solidFill>
+          </a:ln>
+          <a:effectLst/>
+        </p:spPr>
+        <p:style>
+          <a:lnRef idx="1">
+            <a:schemeClr val="accent1"/>
+          </a:lnRef>
+          <a:fillRef idx="3">
+            <a:schemeClr val="accent1"/>
+          </a:fillRef>
+          <a:effectRef idx="2">
+            <a:schemeClr val="accent1"/>
+          </a:effectRef>
+          <a:fontRef idx="minor">
+            <a:schemeClr val="lt1"/>
+          </a:fontRef>
+        </p:style>
+        <p:txBody>
+          <a:bodyPr rtlCol="0" anchor="ctr"/>
+          <a:lstStyle/>
+          <a:p>
+            <a:pPr algn="ctr"/>
+          </a:p>
+        </p:txBody>
+      </p:sp>
+      <p:sp>
+        <p:nvSpPr>
+          <p:cNvPr id="9" name="TextBox 8"/>
           <p:cNvSpPr txBox="1"/>
           <p:nvPr/>
         </p:nvSpPr>
         <p:spPr>
           <a:xfrm>
-            <a:off x="3063240" y="1005840"/>
-            <a:ext cx="8716975" cy="237744"/>
+            <a:off x="5242438" y="1088136"/>
+            <a:ext cx="6446337" cy="274320"/>
           </a:xfrm>
           <a:prstGeom prst="rect">
             <a:avLst/>
@@ -17577,21 +17623,57 @@
                 <a:latin typeface="Heebo"/>
                 <a:cs typeface="Heebo"/>
               </a:rPr>
-              <a:t>דירקטוריון מצומצם</a:t>
-            </a:r>
-          </a:p>
-        </p:txBody>
-      </p:sp>
-      <p:sp>
-        <p:nvSpPr>
-          <p:cNvPr id="9" name="Rounded Rectangle 8"/>
-          <p:cNvSpPr/>
-          <p:nvPr/>
-        </p:nvSpPr>
-        <p:spPr>
-          <a:xfrm>
-            <a:off x="10124603" y="1280160"/>
-            <a:ext cx="1655612" cy="457200"/>
+              <a:t>מובילות תחום</a:t>
+            </a:r>
+          </a:p>
+        </p:txBody>
+      </p:sp>
+      <p:sp>
+        <p:nvSpPr>
+          <p:cNvPr id="10" name="TextBox 9"/>
+          <p:cNvSpPr txBox="1"/>
+          <p:nvPr/>
+        </p:nvSpPr>
+        <p:spPr>
+          <a:xfrm>
+            <a:off x="5242438" y="1106424"/>
+            <a:ext cx="6446337" cy="256032"/>
+          </a:xfrm>
+          <a:prstGeom prst="rect">
+            <a:avLst/>
+          </a:prstGeom>
+          <a:noFill/>
+        </p:spPr>
+        <p:txBody>
+          <a:bodyPr wrap="square" anchor="ctr" lIns="36576" rIns="36576" tIns="0" bIns="0">
+            <a:spAutoFit/>
+          </a:bodyPr>
+          <a:lstStyle/>
+          <a:p>
+            <a:pPr algn="l" rtl="1"/>
+            <a:r>
+              <a:rPr sz="1000" b="0">
+                <a:solidFill>
+                  <a:srgbClr val="8A94A8"/>
+                </a:solidFill>
+                <a:latin typeface="Heebo"/>
+                <a:cs typeface="Heebo"/>
+              </a:rPr>
+              <a:t>מקדמות את התחום כולל הופעות בכנסת</a:t>
+            </a:r>
+          </a:p>
+        </p:txBody>
+      </p:sp>
+      <p:sp>
+        <p:nvSpPr>
+          <p:cNvPr id="11" name="Rounded Rectangle 10"/>
+          <p:cNvSpPr/>
+          <p:nvPr/>
+        </p:nvSpPr>
+        <p:spPr>
+          <a:xfrm>
+            <a:off x="9600956" y="1380744"/>
+            <a:ext cx="2087819" cy="457200"/>
           </a:xfrm>
           <a:prstGeom prst="roundRect">
             <a:avLst>
@@ -17632,13 +17714,13 @@
       </p:sp>
       <p:sp>
         <p:nvSpPr>
-          <p:cNvPr id="10" name="Rectangle 9"/>
-          <p:cNvSpPr/>
-          <p:nvPr/>
-        </p:nvSpPr>
-        <p:spPr>
-          <a:xfrm>
-            <a:off x="11716207" y="1353312"/>
+          <p:cNvPr id="12" name="Rectangle 11"/>
+          <p:cNvSpPr/>
+          <p:nvPr/>
+        </p:nvSpPr>
+        <p:spPr>
+          <a:xfrm>
+            <a:off x="11624767" y="1453896"/>
             <a:ext cx="45720" cy="310896"/>
           </a:xfrm>
           <a:prstGeom prst="rect">
@@ -17676,14 +17758,14 @@
       </p:sp>
       <p:sp>
         <p:nvSpPr>
-          <p:cNvPr id="11" name="TextBox 10"/>
+          <p:cNvPr id="13" name="TextBox 12"/>
           <p:cNvSpPr txBox="1"/>
           <p:nvPr/>
         </p:nvSpPr>
         <p:spPr>
           <a:xfrm>
-            <a:off x="10124603" y="1280160"/>
-            <a:ext cx="1655612" cy="457200"/>
+            <a:off x="9600956" y="1435608"/>
+            <a:ext cx="2087819" cy="237744"/>
           </a:xfrm>
           <a:prstGeom prst="rect">
             <a:avLst/>
@@ -17691,7 +17773,1146 @@
           <a:noFill/>
         </p:spPr>
         <p:txBody>
+          <a:bodyPr wrap="square" anchor="b" lIns="36576" rIns="36576" tIns="0" bIns="0">
+            <a:spAutoFit/>
+          </a:bodyPr>
+          <a:lstStyle/>
+          <a:p>
+            <a:pPr algn="ctr" rtl="1"/>
+            <a:r>
+              <a:rPr sz="1200" b="1">
+                <a:solidFill>
+                  <a:srgbClr val="1A2233"/>
+                </a:solidFill>
+                <a:latin typeface="Heebo"/>
+                <a:cs typeface="Heebo"/>
+              </a:rPr>
+              <a:t>עו״ד אודליה קדמי</a:t>
+            </a:r>
+          </a:p>
+        </p:txBody>
+      </p:sp>
+      <p:sp>
+        <p:nvSpPr>
+          <p:cNvPr id="14" name="TextBox 13"/>
+          <p:cNvSpPr txBox="1"/>
+          <p:nvPr/>
+        </p:nvSpPr>
+        <p:spPr>
+          <a:xfrm>
+            <a:off x="9600956" y="1632204"/>
+            <a:ext cx="2087819" cy="182880"/>
+          </a:xfrm>
+          <a:prstGeom prst="rect">
+            <a:avLst/>
+          </a:prstGeom>
+          <a:noFill/>
+        </p:spPr>
+        <p:txBody>
+          <a:bodyPr wrap="square" anchor="t" lIns="36576" rIns="36576" tIns="0" bIns="0">
+            <a:spAutoFit/>
+          </a:bodyPr>
+          <a:lstStyle/>
+          <a:p>
+            <a:pPr algn="ctr" rtl="1"/>
+            <a:r>
+              <a:rPr sz="900" b="0">
+                <a:solidFill>
+                  <a:srgbClr val="8A94A8"/>
+                </a:solidFill>
+                <a:latin typeface="Heebo"/>
+                <a:cs typeface="Heebo"/>
+              </a:rPr>
+              <a:t>ביטחון אישי</a:t>
+            </a:r>
+          </a:p>
+        </p:txBody>
+      </p:sp>
+      <p:sp>
+        <p:nvSpPr>
+          <p:cNvPr id="15" name="Rounded Rectangle 14"/>
+          <p:cNvSpPr/>
+          <p:nvPr/>
+        </p:nvSpPr>
+        <p:spPr>
+          <a:xfrm>
+            <a:off x="7421697" y="1380744"/>
+            <a:ext cx="2087819" cy="457200"/>
+          </a:xfrm>
+          <a:prstGeom prst="roundRect">
+            <a:avLst>
+              <a:gd name="adj" fmla="val 18000"/>
+            </a:avLst>
+          </a:prstGeom>
+          <a:solidFill>
+            <a:srgbClr val="FFFFFF"/>
+          </a:solidFill>
+          <a:ln w="15875">
+            <a:solidFill>
+              <a:srgbClr val="C5CDDD"/>
+            </a:solidFill>
+          </a:ln>
+          <a:effectLst/>
+        </p:spPr>
+        <p:style>
+          <a:lnRef idx="1">
+            <a:schemeClr val="accent1"/>
+          </a:lnRef>
+          <a:fillRef idx="3">
+            <a:schemeClr val="accent1"/>
+          </a:fillRef>
+          <a:effectRef idx="2">
+            <a:schemeClr val="accent1"/>
+          </a:effectRef>
+          <a:fontRef idx="minor">
+            <a:schemeClr val="lt1"/>
+          </a:fontRef>
+        </p:style>
+        <p:txBody>
+          <a:bodyPr rtlCol="0" anchor="ctr"/>
+          <a:lstStyle/>
+          <a:p>
+            <a:pPr algn="ctr"/>
+          </a:p>
+        </p:txBody>
+      </p:sp>
+      <p:sp>
+        <p:nvSpPr>
+          <p:cNvPr id="16" name="Rectangle 15"/>
+          <p:cNvSpPr/>
+          <p:nvPr/>
+        </p:nvSpPr>
+        <p:spPr>
+          <a:xfrm>
+            <a:off x="9445508" y="1453896"/>
+            <a:ext cx="45720" cy="310896"/>
+          </a:xfrm>
+          <a:prstGeom prst="rect">
+            <a:avLst/>
+          </a:prstGeom>
+          <a:solidFill>
+            <a:srgbClr val="F0C000"/>
+          </a:solidFill>
+          <a:ln>
+            <a:noFill/>
+          </a:ln>
+          <a:effectLst/>
+        </p:spPr>
+        <p:style>
+          <a:lnRef idx="1">
+            <a:schemeClr val="accent1"/>
+          </a:lnRef>
+          <a:fillRef idx="3">
+            <a:schemeClr val="accent1"/>
+          </a:fillRef>
+          <a:effectRef idx="2">
+            <a:schemeClr val="accent1"/>
+          </a:effectRef>
+          <a:fontRef idx="minor">
+            <a:schemeClr val="lt1"/>
+          </a:fontRef>
+        </p:style>
+        <p:txBody>
+          <a:bodyPr rtlCol="0" anchor="ctr"/>
+          <a:lstStyle/>
+          <a:p>
+            <a:pPr algn="ctr"/>
+          </a:p>
+        </p:txBody>
+      </p:sp>
+      <p:sp>
+        <p:nvSpPr>
+          <p:cNvPr id="17" name="TextBox 16"/>
+          <p:cNvSpPr txBox="1"/>
+          <p:nvPr/>
+        </p:nvSpPr>
+        <p:spPr>
+          <a:xfrm>
+            <a:off x="7421697" y="1435608"/>
+            <a:ext cx="2087819" cy="237744"/>
+          </a:xfrm>
+          <a:prstGeom prst="rect">
+            <a:avLst/>
+          </a:prstGeom>
+          <a:noFill/>
+        </p:spPr>
+        <p:txBody>
+          <a:bodyPr wrap="square" anchor="b" lIns="36576" rIns="36576" tIns="0" bIns="0">
+            <a:spAutoFit/>
+          </a:bodyPr>
+          <a:lstStyle/>
+          <a:p>
+            <a:pPr algn="ctr" rtl="1"/>
+            <a:r>
+              <a:rPr sz="1200" b="1">
+                <a:solidFill>
+                  <a:srgbClr val="1A2233"/>
+                </a:solidFill>
+                <a:latin typeface="Heebo"/>
+                <a:cs typeface="Heebo"/>
+              </a:rPr>
+              <a:t>נגה ארבל</a:t>
+            </a:r>
+          </a:p>
+        </p:txBody>
+      </p:sp>
+      <p:sp>
+        <p:nvSpPr>
+          <p:cNvPr id="18" name="TextBox 17"/>
+          <p:cNvSpPr txBox="1"/>
+          <p:nvPr/>
+        </p:nvSpPr>
+        <p:spPr>
+          <a:xfrm>
+            <a:off x="7421697" y="1632204"/>
+            <a:ext cx="2087819" cy="182880"/>
+          </a:xfrm>
+          <a:prstGeom prst="rect">
+            <a:avLst/>
+          </a:prstGeom>
+          <a:noFill/>
+        </p:spPr>
+        <p:txBody>
+          <a:bodyPr wrap="square" anchor="t" lIns="36576" rIns="36576" tIns="0" bIns="0">
+            <a:spAutoFit/>
+          </a:bodyPr>
+          <a:lstStyle/>
+          <a:p>
+            <a:pPr algn="ctr" rtl="1"/>
+            <a:r>
+              <a:rPr sz="900" b="0">
+                <a:solidFill>
+                  <a:srgbClr val="8A94A8"/>
+                </a:solidFill>
+                <a:latin typeface="Heebo"/>
+                <a:cs typeface="Heebo"/>
+              </a:rPr>
+              <a:t>חקיקה</a:t>
+            </a:r>
+          </a:p>
+        </p:txBody>
+      </p:sp>
+      <p:sp>
+        <p:nvSpPr>
+          <p:cNvPr id="19" name="Rounded Rectangle 18"/>
+          <p:cNvSpPr/>
+          <p:nvPr/>
+        </p:nvSpPr>
+        <p:spPr>
+          <a:xfrm>
+            <a:off x="5242438" y="1380744"/>
+            <a:ext cx="2087819" cy="457200"/>
+          </a:xfrm>
+          <a:prstGeom prst="roundRect">
+            <a:avLst>
+              <a:gd name="adj" fmla="val 18000"/>
+            </a:avLst>
+          </a:prstGeom>
+          <a:solidFill>
+            <a:srgbClr val="FFFFFF"/>
+          </a:solidFill>
+          <a:ln w="15875">
+            <a:solidFill>
+              <a:srgbClr val="C5CDDD"/>
+            </a:solidFill>
+          </a:ln>
+          <a:effectLst/>
+        </p:spPr>
+        <p:style>
+          <a:lnRef idx="1">
+            <a:schemeClr val="accent1"/>
+          </a:lnRef>
+          <a:fillRef idx="3">
+            <a:schemeClr val="accent1"/>
+          </a:fillRef>
+          <a:effectRef idx="2">
+            <a:schemeClr val="accent1"/>
+          </a:effectRef>
+          <a:fontRef idx="minor">
+            <a:schemeClr val="lt1"/>
+          </a:fontRef>
+        </p:style>
+        <p:txBody>
+          <a:bodyPr rtlCol="0" anchor="ctr"/>
+          <a:lstStyle/>
+          <a:p>
+            <a:pPr algn="ctr"/>
+          </a:p>
+        </p:txBody>
+      </p:sp>
+      <p:sp>
+        <p:nvSpPr>
+          <p:cNvPr id="20" name="Rectangle 19"/>
+          <p:cNvSpPr/>
+          <p:nvPr/>
+        </p:nvSpPr>
+        <p:spPr>
+          <a:xfrm>
+            <a:off x="7266249" y="1453896"/>
+            <a:ext cx="45720" cy="310896"/>
+          </a:xfrm>
+          <a:prstGeom prst="rect">
+            <a:avLst/>
+          </a:prstGeom>
+          <a:solidFill>
+            <a:srgbClr val="F0C000"/>
+          </a:solidFill>
+          <a:ln>
+            <a:noFill/>
+          </a:ln>
+          <a:effectLst/>
+        </p:spPr>
+        <p:style>
+          <a:lnRef idx="1">
+            <a:schemeClr val="accent1"/>
+          </a:lnRef>
+          <a:fillRef idx="3">
+            <a:schemeClr val="accent1"/>
+          </a:fillRef>
+          <a:effectRef idx="2">
+            <a:schemeClr val="accent1"/>
+          </a:effectRef>
+          <a:fontRef idx="minor">
+            <a:schemeClr val="lt1"/>
+          </a:fontRef>
+        </p:style>
+        <p:txBody>
+          <a:bodyPr rtlCol="0" anchor="ctr"/>
+          <a:lstStyle/>
+          <a:p>
+            <a:pPr algn="ctr"/>
+          </a:p>
+        </p:txBody>
+      </p:sp>
+      <p:sp>
+        <p:nvSpPr>
+          <p:cNvPr id="21" name="TextBox 20"/>
+          <p:cNvSpPr txBox="1"/>
+          <p:nvPr/>
+        </p:nvSpPr>
+        <p:spPr>
+          <a:xfrm>
+            <a:off x="5242438" y="1435608"/>
+            <a:ext cx="2087819" cy="237744"/>
+          </a:xfrm>
+          <a:prstGeom prst="rect">
+            <a:avLst/>
+          </a:prstGeom>
+          <a:noFill/>
+        </p:spPr>
+        <p:txBody>
+          <a:bodyPr wrap="square" anchor="b" lIns="36576" rIns="36576" tIns="0" bIns="0">
+            <a:spAutoFit/>
+          </a:bodyPr>
+          <a:lstStyle/>
+          <a:p>
+            <a:pPr algn="ctr" rtl="1"/>
+            <a:r>
+              <a:rPr sz="1200" b="1">
+                <a:solidFill>
+                  <a:srgbClr val="1A2233"/>
+                </a:solidFill>
+                <a:latin typeface="Heebo"/>
+                <a:cs typeface="Heebo"/>
+              </a:rPr>
+              <a:t>שלומית לביא</a:t>
+            </a:r>
+          </a:p>
+        </p:txBody>
+      </p:sp>
+      <p:sp>
+        <p:nvSpPr>
+          <p:cNvPr id="22" name="TextBox 21"/>
+          <p:cNvSpPr txBox="1"/>
+          <p:nvPr/>
+        </p:nvSpPr>
+        <p:spPr>
+          <a:xfrm>
+            <a:off x="5242438" y="1632204"/>
+            <a:ext cx="2087819" cy="182880"/>
+          </a:xfrm>
+          <a:prstGeom prst="rect">
+            <a:avLst/>
+          </a:prstGeom>
+          <a:noFill/>
+        </p:spPr>
+        <p:txBody>
+          <a:bodyPr wrap="square" anchor="t" lIns="36576" rIns="36576" tIns="0" bIns="0">
+            <a:spAutoFit/>
+          </a:bodyPr>
+          <a:lstStyle/>
+          <a:p>
+            <a:pPr algn="ctr" rtl="1"/>
+            <a:r>
+              <a:rPr sz="900" b="0">
+                <a:solidFill>
+                  <a:srgbClr val="8A94A8"/>
+                </a:solidFill>
+                <a:latin typeface="Heebo"/>
+                <a:cs typeface="Heebo"/>
+              </a:rPr>
+              <a:t>רווחה</a:t>
+            </a:r>
+          </a:p>
+        </p:txBody>
+      </p:sp>
+      <p:sp>
+        <p:nvSpPr>
+          <p:cNvPr id="23" name="Rounded Rectangle 22"/>
+          <p:cNvSpPr/>
+          <p:nvPr/>
+        </p:nvSpPr>
+        <p:spPr>
+          <a:xfrm>
+            <a:off x="411480" y="1051560"/>
+            <a:ext cx="4419478" cy="841248"/>
+          </a:xfrm>
+          <a:prstGeom prst="roundRect">
+            <a:avLst>
+              <a:gd name="adj" fmla="val 8000"/>
+            </a:avLst>
+          </a:prstGeom>
+          <a:noFill/>
+          <a:ln w="15875">
+            <a:solidFill>
+              <a:srgbClr val="C5CDDD"/>
+            </a:solidFill>
+          </a:ln>
+          <a:effectLst/>
+        </p:spPr>
+        <p:style>
+          <a:lnRef idx="1">
+            <a:schemeClr val="accent1"/>
+          </a:lnRef>
+          <a:fillRef idx="3">
+            <a:schemeClr val="accent1"/>
+          </a:fillRef>
+          <a:effectRef idx="2">
+            <a:schemeClr val="accent1"/>
+          </a:effectRef>
+          <a:fontRef idx="minor">
+            <a:schemeClr val="lt1"/>
+          </a:fontRef>
+        </p:style>
+        <p:txBody>
+          <a:bodyPr rtlCol="0" anchor="ctr"/>
+          <a:lstStyle/>
+          <a:p>
+            <a:pPr algn="ctr"/>
+          </a:p>
+        </p:txBody>
+      </p:sp>
+      <p:sp>
+        <p:nvSpPr>
+          <p:cNvPr id="24" name="TextBox 23"/>
+          <p:cNvSpPr txBox="1"/>
+          <p:nvPr/>
+        </p:nvSpPr>
+        <p:spPr>
+          <a:xfrm>
+            <a:off x="502920" y="1088136"/>
+            <a:ext cx="4236598" cy="274320"/>
+          </a:xfrm>
+          <a:prstGeom prst="rect">
+            <a:avLst/>
+          </a:prstGeom>
+          <a:noFill/>
+        </p:spPr>
+        <p:txBody>
           <a:bodyPr wrap="square" anchor="ctr" lIns="36576" rIns="36576" tIns="0" bIns="0">
+            <a:spAutoFit/>
+          </a:bodyPr>
+          <a:lstStyle/>
+          <a:p>
+            <a:pPr algn="r" rtl="1"/>
+            <a:r>
+              <a:rPr sz="1300" b="1">
+                <a:solidFill>
+                  <a:srgbClr val="1C3C7A"/>
+                </a:solidFill>
+                <a:latin typeface="Heebo"/>
+                <a:cs typeface="Heebo"/>
+              </a:rPr>
+              <a:t>יועצים</a:t>
+            </a:r>
+          </a:p>
+        </p:txBody>
+      </p:sp>
+      <p:sp>
+        <p:nvSpPr>
+          <p:cNvPr id="25" name="TextBox 24"/>
+          <p:cNvSpPr txBox="1"/>
+          <p:nvPr/>
+        </p:nvSpPr>
+        <p:spPr>
+          <a:xfrm>
+            <a:off x="502920" y="1106424"/>
+            <a:ext cx="4236598" cy="256032"/>
+          </a:xfrm>
+          <a:prstGeom prst="rect">
+            <a:avLst/>
+          </a:prstGeom>
+          <a:noFill/>
+        </p:spPr>
+        <p:txBody>
+          <a:bodyPr wrap="square" anchor="ctr" lIns="36576" rIns="36576" tIns="0" bIns="0">
+            <a:spAutoFit/>
+          </a:bodyPr>
+          <a:lstStyle/>
+          <a:p>
+            <a:pPr algn="l" rtl="1"/>
+            <a:r>
+              <a:rPr sz="1000" b="0">
+                <a:solidFill>
+                  <a:srgbClr val="8A94A8"/>
+                </a:solidFill>
+                <a:latin typeface="Heebo"/>
+                <a:cs typeface="Heebo"/>
+              </a:rPr>
+              <a:t>מקדמים את התוכניות האישיות שלהם</a:t>
+            </a:r>
+          </a:p>
+        </p:txBody>
+      </p:sp>
+      <p:sp>
+        <p:nvSpPr>
+          <p:cNvPr id="26" name="Rounded Rectangle 25"/>
+          <p:cNvSpPr/>
+          <p:nvPr/>
+        </p:nvSpPr>
+        <p:spPr>
+          <a:xfrm>
+            <a:off x="2666939" y="1380744"/>
+            <a:ext cx="2072579" cy="457200"/>
+          </a:xfrm>
+          <a:prstGeom prst="roundRect">
+            <a:avLst>
+              <a:gd name="adj" fmla="val 18000"/>
+            </a:avLst>
+          </a:prstGeom>
+          <a:solidFill>
+            <a:srgbClr val="FFFFFF"/>
+          </a:solidFill>
+          <a:ln w="15875">
+            <a:solidFill>
+              <a:srgbClr val="C5CDDD"/>
+            </a:solidFill>
+          </a:ln>
+          <a:effectLst/>
+        </p:spPr>
+        <p:style>
+          <a:lnRef idx="1">
+            <a:schemeClr val="accent1"/>
+          </a:lnRef>
+          <a:fillRef idx="3">
+            <a:schemeClr val="accent1"/>
+          </a:fillRef>
+          <a:effectRef idx="2">
+            <a:schemeClr val="accent1"/>
+          </a:effectRef>
+          <a:fontRef idx="minor">
+            <a:schemeClr val="lt1"/>
+          </a:fontRef>
+        </p:style>
+        <p:txBody>
+          <a:bodyPr rtlCol="0" anchor="ctr"/>
+          <a:lstStyle/>
+          <a:p>
+            <a:pPr algn="ctr"/>
+          </a:p>
+        </p:txBody>
+      </p:sp>
+      <p:sp>
+        <p:nvSpPr>
+          <p:cNvPr id="27" name="Rectangle 26"/>
+          <p:cNvSpPr/>
+          <p:nvPr/>
+        </p:nvSpPr>
+        <p:spPr>
+          <a:xfrm>
+            <a:off x="4675510" y="1453896"/>
+            <a:ext cx="45720" cy="310896"/>
+          </a:xfrm>
+          <a:prstGeom prst="rect">
+            <a:avLst/>
+          </a:prstGeom>
+          <a:solidFill>
+            <a:srgbClr val="F0C000"/>
+          </a:solidFill>
+          <a:ln>
+            <a:noFill/>
+          </a:ln>
+          <a:effectLst/>
+        </p:spPr>
+        <p:style>
+          <a:lnRef idx="1">
+            <a:schemeClr val="accent1"/>
+          </a:lnRef>
+          <a:fillRef idx="3">
+            <a:schemeClr val="accent1"/>
+          </a:fillRef>
+          <a:effectRef idx="2">
+            <a:schemeClr val="accent1"/>
+          </a:effectRef>
+          <a:fontRef idx="minor">
+            <a:schemeClr val="lt1"/>
+          </a:fontRef>
+        </p:style>
+        <p:txBody>
+          <a:bodyPr rtlCol="0" anchor="ctr"/>
+          <a:lstStyle/>
+          <a:p>
+            <a:pPr algn="ctr"/>
+          </a:p>
+        </p:txBody>
+      </p:sp>
+      <p:sp>
+        <p:nvSpPr>
+          <p:cNvPr id="28" name="TextBox 27"/>
+          <p:cNvSpPr txBox="1"/>
+          <p:nvPr/>
+        </p:nvSpPr>
+        <p:spPr>
+          <a:xfrm>
+            <a:off x="2666939" y="1435608"/>
+            <a:ext cx="2072579" cy="237744"/>
+          </a:xfrm>
+          <a:prstGeom prst="rect">
+            <a:avLst/>
+          </a:prstGeom>
+          <a:noFill/>
+        </p:spPr>
+        <p:txBody>
+          <a:bodyPr wrap="square" anchor="b" lIns="36576" rIns="36576" tIns="0" bIns="0">
+            <a:spAutoFit/>
+          </a:bodyPr>
+          <a:lstStyle/>
+          <a:p>
+            <a:pPr algn="ctr" rtl="1"/>
+            <a:r>
+              <a:rPr sz="1200" b="1">
+                <a:solidFill>
+                  <a:srgbClr val="1A2233"/>
+                </a:solidFill>
+                <a:latin typeface="Heebo"/>
+                <a:cs typeface="Heebo"/>
+              </a:rPr>
+              <a:t>טל קופל</a:t>
+            </a:r>
+          </a:p>
+        </p:txBody>
+      </p:sp>
+      <p:sp>
+        <p:nvSpPr>
+          <p:cNvPr id="29" name="TextBox 28"/>
+          <p:cNvSpPr txBox="1"/>
+          <p:nvPr/>
+        </p:nvSpPr>
+        <p:spPr>
+          <a:xfrm>
+            <a:off x="2666939" y="1632204"/>
+            <a:ext cx="2072579" cy="182880"/>
+          </a:xfrm>
+          <a:prstGeom prst="rect">
+            <a:avLst/>
+          </a:prstGeom>
+          <a:noFill/>
+        </p:spPr>
+        <p:txBody>
+          <a:bodyPr wrap="square" anchor="t" lIns="36576" rIns="36576" tIns="0" bIns="0">
+            <a:spAutoFit/>
+          </a:bodyPr>
+          <a:lstStyle/>
+          <a:p>
+            <a:pPr algn="ctr" rtl="1"/>
+            <a:r>
+              <a:rPr sz="900" b="0">
+                <a:solidFill>
+                  <a:srgbClr val="8A94A8"/>
+                </a:solidFill>
+                <a:latin typeface="Heebo"/>
+                <a:cs typeface="Heebo"/>
+              </a:rPr>
+              <a:t>חינוך ואתיקה</a:t>
+            </a:r>
+          </a:p>
+        </p:txBody>
+      </p:sp>
+      <p:sp>
+        <p:nvSpPr>
+          <p:cNvPr id="30" name="Rounded Rectangle 29"/>
+          <p:cNvSpPr/>
+          <p:nvPr/>
+        </p:nvSpPr>
+        <p:spPr>
+          <a:xfrm>
+            <a:off x="502920" y="1380744"/>
+            <a:ext cx="2072579" cy="457200"/>
+          </a:xfrm>
+          <a:prstGeom prst="roundRect">
+            <a:avLst>
+              <a:gd name="adj" fmla="val 18000"/>
+            </a:avLst>
+          </a:prstGeom>
+          <a:solidFill>
+            <a:srgbClr val="FFFFFF"/>
+          </a:solidFill>
+          <a:ln w="15875">
+            <a:solidFill>
+              <a:srgbClr val="C5CDDD"/>
+            </a:solidFill>
+          </a:ln>
+          <a:effectLst/>
+        </p:spPr>
+        <p:style>
+          <a:lnRef idx="1">
+            <a:schemeClr val="accent1"/>
+          </a:lnRef>
+          <a:fillRef idx="3">
+            <a:schemeClr val="accent1"/>
+          </a:fillRef>
+          <a:effectRef idx="2">
+            <a:schemeClr val="accent1"/>
+          </a:effectRef>
+          <a:fontRef idx="minor">
+            <a:schemeClr val="lt1"/>
+          </a:fontRef>
+        </p:style>
+        <p:txBody>
+          <a:bodyPr rtlCol="0" anchor="ctr"/>
+          <a:lstStyle/>
+          <a:p>
+            <a:pPr algn="ctr"/>
+          </a:p>
+        </p:txBody>
+      </p:sp>
+      <p:sp>
+        <p:nvSpPr>
+          <p:cNvPr id="31" name="Rectangle 30"/>
+          <p:cNvSpPr/>
+          <p:nvPr/>
+        </p:nvSpPr>
+        <p:spPr>
+          <a:xfrm>
+            <a:off x="2511491" y="1453896"/>
+            <a:ext cx="45720" cy="310896"/>
+          </a:xfrm>
+          <a:prstGeom prst="rect">
+            <a:avLst/>
+          </a:prstGeom>
+          <a:solidFill>
+            <a:srgbClr val="F0C000"/>
+          </a:solidFill>
+          <a:ln>
+            <a:noFill/>
+          </a:ln>
+          <a:effectLst/>
+        </p:spPr>
+        <p:style>
+          <a:lnRef idx="1">
+            <a:schemeClr val="accent1"/>
+          </a:lnRef>
+          <a:fillRef idx="3">
+            <a:schemeClr val="accent1"/>
+          </a:fillRef>
+          <a:effectRef idx="2">
+            <a:schemeClr val="accent1"/>
+          </a:effectRef>
+          <a:fontRef idx="minor">
+            <a:schemeClr val="lt1"/>
+          </a:fontRef>
+        </p:style>
+        <p:txBody>
+          <a:bodyPr rtlCol="0" anchor="ctr"/>
+          <a:lstStyle/>
+          <a:p>
+            <a:pPr algn="ctr"/>
+          </a:p>
+        </p:txBody>
+      </p:sp>
+      <p:sp>
+        <p:nvSpPr>
+          <p:cNvPr id="32" name="TextBox 31"/>
+          <p:cNvSpPr txBox="1"/>
+          <p:nvPr/>
+        </p:nvSpPr>
+        <p:spPr>
+          <a:xfrm>
+            <a:off x="502920" y="1435608"/>
+            <a:ext cx="2072579" cy="237744"/>
+          </a:xfrm>
+          <a:prstGeom prst="rect">
+            <a:avLst/>
+          </a:prstGeom>
+          <a:noFill/>
+        </p:spPr>
+        <p:txBody>
+          <a:bodyPr wrap="square" anchor="b" lIns="36576" rIns="36576" tIns="0" bIns="0">
+            <a:spAutoFit/>
+          </a:bodyPr>
+          <a:lstStyle/>
+          <a:p>
+            <a:pPr algn="ctr" rtl="1"/>
+            <a:r>
+              <a:rPr sz="1200" b="1">
+                <a:solidFill>
+                  <a:srgbClr val="1A2233"/>
+                </a:solidFill>
+                <a:latin typeface="Heebo"/>
+                <a:cs typeface="Heebo"/>
+              </a:rPr>
+              <a:t>עו״ד תמר ארבל</a:t>
+            </a:r>
+          </a:p>
+        </p:txBody>
+      </p:sp>
+      <p:sp>
+        <p:nvSpPr>
+          <p:cNvPr id="33" name="TextBox 32"/>
+          <p:cNvSpPr txBox="1"/>
+          <p:nvPr/>
+        </p:nvSpPr>
+        <p:spPr>
+          <a:xfrm>
+            <a:off x="502920" y="1632204"/>
+            <a:ext cx="2072579" cy="182880"/>
+          </a:xfrm>
+          <a:prstGeom prst="rect">
+            <a:avLst/>
+          </a:prstGeom>
+          <a:noFill/>
+        </p:spPr>
+        <p:txBody>
+          <a:bodyPr wrap="square" anchor="t" lIns="36576" rIns="36576" tIns="0" bIns="0">
+            <a:spAutoFit/>
+          </a:bodyPr>
+          <a:lstStyle/>
+          <a:p>
+            <a:pPr algn="ctr" rtl="1"/>
+            <a:r>
+              <a:rPr sz="900" b="0">
+                <a:solidFill>
+                  <a:srgbClr val="8A94A8"/>
+                </a:solidFill>
+                <a:latin typeface="Heebo"/>
+                <a:cs typeface="Heebo"/>
+              </a:rPr>
+              <a:t>משפט</a:t>
+            </a:r>
+          </a:p>
+        </p:txBody>
+      </p:sp>
+      <p:cxnSp>
+        <p:nvCxnSpPr>
+          <p:cNvPr id="34" name="Connector 33"/>
+          <p:cNvCxnSpPr/>
+          <p:nvPr/>
+        </p:nvCxnSpPr>
+        <p:spPr>
+          <a:xfrm>
+            <a:off x="6095847" y="1892808"/>
+            <a:ext cx="0" cy="210312"/>
+          </a:xfrm>
+          <a:prstGeom prst="line">
+            <a:avLst/>
+          </a:prstGeom>
+          <a:ln w="19050">
+            <a:solidFill>
+              <a:srgbClr val="C5CDDD"/>
+            </a:solidFill>
+          </a:ln>
+        </p:spPr>
+        <p:style>
+          <a:lnRef idx="2">
+            <a:schemeClr val="accent1"/>
+          </a:lnRef>
+          <a:fillRef idx="0">
+            <a:schemeClr val="accent1"/>
+          </a:fillRef>
+          <a:effectRef idx="1">
+            <a:schemeClr val="accent1"/>
+          </a:effectRef>
+          <a:fontRef idx="minor">
+            <a:schemeClr val="tx1"/>
+          </a:fontRef>
+        </p:style>
+      </p:cxnSp>
+      <p:sp>
+        <p:nvSpPr>
+          <p:cNvPr id="35" name="Rounded Rectangle 34"/>
+          <p:cNvSpPr/>
+          <p:nvPr/>
+        </p:nvSpPr>
+        <p:spPr>
+          <a:xfrm>
+            <a:off x="3429000" y="2103120"/>
+            <a:ext cx="5330952" cy="2057400"/>
+          </a:xfrm>
+          <a:prstGeom prst="roundRect">
+            <a:avLst>
+              <a:gd name="adj" fmla="val 5000"/>
+            </a:avLst>
+          </a:prstGeom>
+          <a:solidFill>
+            <a:srgbClr val="FFFFFF"/>
+          </a:solidFill>
+          <a:ln w="31750">
+            <a:solidFill>
+              <a:srgbClr val="F0C000"/>
+            </a:solidFill>
+          </a:ln>
+          <a:effectLst/>
+        </p:spPr>
+        <p:style>
+          <a:lnRef idx="1">
+            <a:schemeClr val="accent1"/>
+          </a:lnRef>
+          <a:fillRef idx="3">
+            <a:schemeClr val="accent1"/>
+          </a:fillRef>
+          <a:effectRef idx="2">
+            <a:schemeClr val="accent1"/>
+          </a:effectRef>
+          <a:fontRef idx="minor">
+            <a:schemeClr val="lt1"/>
+          </a:fontRef>
+        </p:style>
+        <p:txBody>
+          <a:bodyPr rtlCol="0" anchor="ctr"/>
+          <a:lstStyle/>
+          <a:p>
+            <a:pPr algn="ctr"/>
+          </a:p>
+        </p:txBody>
+      </p:sp>
+      <p:sp>
+        <p:nvSpPr>
+          <p:cNvPr id="36" name="Rounded Rectangle 35"/>
+          <p:cNvSpPr/>
+          <p:nvPr/>
+        </p:nvSpPr>
+        <p:spPr>
+          <a:xfrm>
+            <a:off x="3538728" y="1993392"/>
+            <a:ext cx="502920" cy="219456"/>
+          </a:xfrm>
+          <a:prstGeom prst="roundRect">
+            <a:avLst>
+              <a:gd name="adj" fmla="val 50000"/>
+            </a:avLst>
+          </a:prstGeom>
+          <a:solidFill>
+            <a:srgbClr val="F0C000"/>
+          </a:solidFill>
+          <a:ln>
+            <a:noFill/>
+          </a:ln>
+          <a:effectLst/>
+        </p:spPr>
+        <p:style>
+          <a:lnRef idx="1">
+            <a:schemeClr val="accent1"/>
+          </a:lnRef>
+          <a:fillRef idx="3">
+            <a:schemeClr val="accent1"/>
+          </a:fillRef>
+          <a:effectRef idx="2">
+            <a:schemeClr val="accent1"/>
+          </a:effectRef>
+          <a:fontRef idx="minor">
+            <a:schemeClr val="lt1"/>
+          </a:fontRef>
+        </p:style>
+        <p:txBody>
+          <a:bodyPr rtlCol="0" anchor="ctr"/>
+          <a:lstStyle/>
+          <a:p>
+            <a:pPr algn="ctr"/>
+          </a:p>
+        </p:txBody>
+      </p:sp>
+      <p:sp>
+        <p:nvSpPr>
+          <p:cNvPr id="37" name="TextBox 36"/>
+          <p:cNvSpPr txBox="1"/>
+          <p:nvPr/>
+        </p:nvSpPr>
+        <p:spPr>
+          <a:xfrm>
+            <a:off x="3538728" y="1993392"/>
+            <a:ext cx="502920" cy="219456"/>
+          </a:xfrm>
+          <a:prstGeom prst="rect">
+            <a:avLst/>
+          </a:prstGeom>
+          <a:noFill/>
+        </p:spPr>
+        <p:txBody>
+          <a:bodyPr wrap="square" anchor="ctr" lIns="36576" rIns="36576" tIns="0" bIns="0">
+            <a:spAutoFit/>
+          </a:bodyPr>
+          <a:lstStyle/>
+          <a:p>
+            <a:pPr algn="ctr" rtl="1"/>
+            <a:r>
+              <a:rPr sz="900" b="1">
+                <a:solidFill>
+                  <a:srgbClr val="122755"/>
+                </a:solidFill>
+                <a:latin typeface="Heebo"/>
+                <a:cs typeface="Heebo"/>
+              </a:rPr>
+              <a:t>חדש</a:t>
+            </a:r>
+          </a:p>
+        </p:txBody>
+      </p:sp>
+      <p:sp>
+        <p:nvSpPr>
+          <p:cNvPr id="38" name="TextBox 37"/>
+          <p:cNvSpPr txBox="1"/>
+          <p:nvPr/>
+        </p:nvSpPr>
+        <p:spPr>
+          <a:xfrm>
+            <a:off x="3429000" y="2194560"/>
+            <a:ext cx="5330952" cy="329184"/>
+          </a:xfrm>
+          <a:prstGeom prst="rect">
+            <a:avLst/>
+          </a:prstGeom>
+          <a:noFill/>
+        </p:spPr>
+        <p:txBody>
+          <a:bodyPr wrap="square" anchor="ctr" lIns="36576" rIns="36576" tIns="0" bIns="0">
+            <a:spAutoFit/>
+          </a:bodyPr>
+          <a:lstStyle/>
+          <a:p>
+            <a:pPr algn="ctr" rtl="1"/>
+            <a:r>
+              <a:rPr sz="1700" b="1">
+                <a:solidFill>
+                  <a:srgbClr val="1C3C7A"/>
+                </a:solidFill>
+                <a:latin typeface="Heebo"/>
+                <a:cs typeface="Heebo"/>
+              </a:rPr>
+              <a:t>צוות הכנסת · קבוע ובשכר</a:t>
+            </a:r>
+          </a:p>
+        </p:txBody>
+      </p:sp>
+      <p:sp>
+        <p:nvSpPr>
+          <p:cNvPr id="39" name="Rounded Rectangle 38"/>
+          <p:cNvSpPr/>
+          <p:nvPr/>
+        </p:nvSpPr>
+        <p:spPr>
+          <a:xfrm>
+            <a:off x="7440930" y="2651760"/>
+            <a:ext cx="1181862" cy="566928"/>
+          </a:xfrm>
+          <a:prstGeom prst="roundRect">
+            <a:avLst>
+              <a:gd name="adj" fmla="val 18000"/>
+            </a:avLst>
+          </a:prstGeom>
+          <a:solidFill>
+            <a:srgbClr val="FFFFFF"/>
+          </a:solidFill>
+          <a:ln w="15875">
+            <a:solidFill>
+              <a:srgbClr val="C5CDDD"/>
+            </a:solidFill>
+          </a:ln>
+          <a:effectLst/>
+        </p:spPr>
+        <p:style>
+          <a:lnRef idx="1">
+            <a:schemeClr val="accent1"/>
+          </a:lnRef>
+          <a:fillRef idx="3">
+            <a:schemeClr val="accent1"/>
+          </a:fillRef>
+          <a:effectRef idx="2">
+            <a:schemeClr val="accent1"/>
+          </a:effectRef>
+          <a:fontRef idx="minor">
+            <a:schemeClr val="lt1"/>
+          </a:fontRef>
+        </p:style>
+        <p:txBody>
+          <a:bodyPr rtlCol="0" anchor="ctr"/>
+          <a:lstStyle/>
+          <a:p>
+            <a:pPr algn="ctr"/>
+          </a:p>
+        </p:txBody>
+      </p:sp>
+      <p:sp>
+        <p:nvSpPr>
+          <p:cNvPr id="40" name="Rectangle 39"/>
+          <p:cNvSpPr/>
+          <p:nvPr/>
+        </p:nvSpPr>
+        <p:spPr>
+          <a:xfrm>
+            <a:off x="8558784" y="2724912"/>
+            <a:ext cx="45720" cy="420624"/>
+          </a:xfrm>
+          <a:prstGeom prst="rect">
+            <a:avLst/>
+          </a:prstGeom>
+          <a:solidFill>
+            <a:srgbClr val="F0C000"/>
+          </a:solidFill>
+          <a:ln>
+            <a:noFill/>
+          </a:ln>
+          <a:effectLst/>
+        </p:spPr>
+        <p:style>
+          <a:lnRef idx="1">
+            <a:schemeClr val="accent1"/>
+          </a:lnRef>
+          <a:fillRef idx="3">
+            <a:schemeClr val="accent1"/>
+          </a:fillRef>
+          <a:effectRef idx="2">
+            <a:schemeClr val="accent1"/>
+          </a:effectRef>
+          <a:fontRef idx="minor">
+            <a:schemeClr val="lt1"/>
+          </a:fontRef>
+        </p:style>
+        <p:txBody>
+          <a:bodyPr rtlCol="0" anchor="ctr"/>
+          <a:lstStyle/>
+          <a:p>
+            <a:pPr algn="ctr"/>
+          </a:p>
+        </p:txBody>
+      </p:sp>
+      <p:sp>
+        <p:nvSpPr>
+          <p:cNvPr id="41" name="TextBox 40"/>
+          <p:cNvSpPr txBox="1"/>
+          <p:nvPr/>
+        </p:nvSpPr>
+        <p:spPr>
+          <a:xfrm>
+            <a:off x="7440930" y="2706624"/>
+            <a:ext cx="1181862" cy="294802"/>
+          </a:xfrm>
+          <a:prstGeom prst="rect">
+            <a:avLst/>
+          </a:prstGeom>
+          <a:noFill/>
+        </p:spPr>
+        <p:txBody>
+          <a:bodyPr wrap="square" anchor="b" lIns="36576" rIns="36576" tIns="0" bIns="0">
             <a:spAutoFit/>
           </a:bodyPr>
           <a:lstStyle/>
@@ -17712,14 +18933,50 @@
       </p:sp>
       <p:sp>
         <p:nvSpPr>
-          <p:cNvPr id="12" name="Rounded Rectangle 11"/>
-          <p:cNvSpPr/>
-          <p:nvPr/>
-        </p:nvSpPr>
-        <p:spPr>
-          <a:xfrm>
-            <a:off x="8359263" y="1280160"/>
-            <a:ext cx="1655612" cy="457200"/>
+          <p:cNvPr id="42" name="TextBox 41"/>
+          <p:cNvSpPr txBox="1"/>
+          <p:nvPr/>
+        </p:nvSpPr>
+        <p:spPr>
+          <a:xfrm>
+            <a:off x="7440930" y="2963570"/>
+            <a:ext cx="1181862" cy="226771"/>
+          </a:xfrm>
+          <a:prstGeom prst="rect">
+            <a:avLst/>
+          </a:prstGeom>
+          <a:noFill/>
+        </p:spPr>
+        <p:txBody>
+          <a:bodyPr wrap="square" anchor="t" lIns="36576" rIns="36576" tIns="0" bIns="0">
+            <a:spAutoFit/>
+          </a:bodyPr>
+          <a:lstStyle/>
+          <a:p>
+            <a:pPr algn="ctr" rtl="1"/>
+            <a:r>
+              <a:rPr sz="900" b="0">
+                <a:solidFill>
+                  <a:srgbClr val="8A94A8"/>
+                </a:solidFill>
+                <a:latin typeface="Heebo"/>
+                <a:cs typeface="Heebo"/>
+              </a:rPr>
+              <a:t>נציג קבוע</a:t>
+            </a:r>
+          </a:p>
+        </p:txBody>
+      </p:sp>
+      <p:sp>
+        <p:nvSpPr>
+          <p:cNvPr id="43" name="Rounded Rectangle 42"/>
+          <p:cNvSpPr/>
+          <p:nvPr/>
+        </p:nvSpPr>
+        <p:spPr>
+          <a:xfrm>
+            <a:off x="6149340" y="2651760"/>
+            <a:ext cx="1181862" cy="566928"/>
           </a:xfrm>
           <a:prstGeom prst="roundRect">
             <a:avLst>
@@ -17760,14 +19017,14 @@
       </p:sp>
       <p:sp>
         <p:nvSpPr>
-          <p:cNvPr id="13" name="Rectangle 12"/>
-          <p:cNvSpPr/>
-          <p:nvPr/>
-        </p:nvSpPr>
-        <p:spPr>
-          <a:xfrm>
-            <a:off x="9950867" y="1353312"/>
-            <a:ext cx="45720" cy="310896"/>
+          <p:cNvPr id="44" name="Rectangle 43"/>
+          <p:cNvSpPr/>
+          <p:nvPr/>
+        </p:nvSpPr>
+        <p:spPr>
+          <a:xfrm>
+            <a:off x="7267194" y="2724912"/>
+            <a:ext cx="45720" cy="420624"/>
           </a:xfrm>
           <a:prstGeom prst="rect">
             <a:avLst/>
@@ -17804,14 +19061,14 @@
       </p:sp>
       <p:sp>
         <p:nvSpPr>
-          <p:cNvPr id="14" name="TextBox 13"/>
+          <p:cNvPr id="45" name="TextBox 44"/>
           <p:cNvSpPr txBox="1"/>
           <p:nvPr/>
         </p:nvSpPr>
         <p:spPr>
           <a:xfrm>
-            <a:off x="8359263" y="1280160"/>
-            <a:ext cx="1655612" cy="457200"/>
+            <a:off x="6149340" y="2706624"/>
+            <a:ext cx="1181862" cy="294802"/>
           </a:xfrm>
           <a:prstGeom prst="rect">
             <a:avLst/>
@@ -17819,7 +19076,7 @@
           <a:noFill/>
         </p:spPr>
         <p:txBody>
-          <a:bodyPr wrap="square" anchor="ctr" lIns="36576" rIns="36576" tIns="0" bIns="0">
+          <a:bodyPr wrap="square" anchor="b" lIns="36576" rIns="36576" tIns="0" bIns="0">
             <a:spAutoFit/>
           </a:bodyPr>
           <a:lstStyle/>
@@ -17833,21 +19090,57 @@
                 <a:latin typeface="Heebo"/>
                 <a:cs typeface="Heebo"/>
               </a:rPr>
-              <a:t>עו״ד אודליה קדמי</a:t>
-            </a:r>
-          </a:p>
-        </p:txBody>
-      </p:sp>
-      <p:sp>
-        <p:nvSpPr>
-          <p:cNvPr id="15" name="Rounded Rectangle 14"/>
-          <p:cNvSpPr/>
-          <p:nvPr/>
-        </p:nvSpPr>
-        <p:spPr>
-          <a:xfrm>
-            <a:off x="6593923" y="1280160"/>
-            <a:ext cx="1655612" cy="457200"/>
+              <a:t>אדם קורגן</a:t>
+            </a:r>
+          </a:p>
+        </p:txBody>
+      </p:sp>
+      <p:sp>
+        <p:nvSpPr>
+          <p:cNvPr id="46" name="TextBox 45"/>
+          <p:cNvSpPr txBox="1"/>
+          <p:nvPr/>
+        </p:nvSpPr>
+        <p:spPr>
+          <a:xfrm>
+            <a:off x="6149340" y="2963570"/>
+            <a:ext cx="1181862" cy="226771"/>
+          </a:xfrm>
+          <a:prstGeom prst="rect">
+            <a:avLst/>
+          </a:prstGeom>
+          <a:noFill/>
+        </p:spPr>
+        <p:txBody>
+          <a:bodyPr wrap="square" anchor="t" lIns="36576" rIns="36576" tIns="0" bIns="0">
+            <a:spAutoFit/>
+          </a:bodyPr>
+          <a:lstStyle/>
+          <a:p>
+            <a:pPr algn="ctr" rtl="1"/>
+            <a:r>
+              <a:rPr sz="900" b="0">
+                <a:solidFill>
+                  <a:srgbClr val="8A94A8"/>
+                </a:solidFill>
+                <a:latin typeface="Heebo"/>
+                <a:cs typeface="Heebo"/>
+              </a:rPr>
+              <a:t>נציג קבוע</a:t>
+            </a:r>
+          </a:p>
+        </p:txBody>
+      </p:sp>
+      <p:sp>
+        <p:nvSpPr>
+          <p:cNvPr id="47" name="Rounded Rectangle 46"/>
+          <p:cNvSpPr/>
+          <p:nvPr/>
+        </p:nvSpPr>
+        <p:spPr>
+          <a:xfrm>
+            <a:off x="4857750" y="2651760"/>
+            <a:ext cx="1181862" cy="566928"/>
           </a:xfrm>
           <a:prstGeom prst="roundRect">
             <a:avLst>
@@ -17888,14 +19181,14 @@
       </p:sp>
       <p:sp>
         <p:nvSpPr>
-          <p:cNvPr id="16" name="Rectangle 15"/>
-          <p:cNvSpPr/>
-          <p:nvPr/>
-        </p:nvSpPr>
-        <p:spPr>
-          <a:xfrm>
-            <a:off x="8185527" y="1353312"/>
-            <a:ext cx="45720" cy="310896"/>
+          <p:cNvPr id="48" name="Rectangle 47"/>
+          <p:cNvSpPr/>
+          <p:nvPr/>
+        </p:nvSpPr>
+        <p:spPr>
+          <a:xfrm>
+            <a:off x="5975604" y="2724912"/>
+            <a:ext cx="45720" cy="420624"/>
           </a:xfrm>
           <a:prstGeom prst="rect">
             <a:avLst/>
@@ -17932,14 +19225,14 @@
       </p:sp>
       <p:sp>
         <p:nvSpPr>
-          <p:cNvPr id="17" name="TextBox 16"/>
+          <p:cNvPr id="49" name="TextBox 48"/>
           <p:cNvSpPr txBox="1"/>
           <p:nvPr/>
         </p:nvSpPr>
         <p:spPr>
           <a:xfrm>
-            <a:off x="6593923" y="1280160"/>
-            <a:ext cx="1655612" cy="457200"/>
+            <a:off x="4857750" y="2706624"/>
+            <a:ext cx="1181862" cy="294802"/>
           </a:xfrm>
           <a:prstGeom prst="rect">
             <a:avLst/>
@@ -17947,7 +19240,7 @@
           <a:noFill/>
         </p:spPr>
         <p:txBody>
-          <a:bodyPr wrap="square" anchor="ctr" lIns="36576" rIns="36576" tIns="0" bIns="0">
+          <a:bodyPr wrap="square" anchor="b" lIns="36576" rIns="36576" tIns="0" bIns="0">
             <a:spAutoFit/>
           </a:bodyPr>
           <a:lstStyle/>
@@ -17968,274 +19261,54 @@
       </p:sp>
       <p:sp>
         <p:nvSpPr>
-          <p:cNvPr id="18" name="Rounded Rectangle 17"/>
-          <p:cNvSpPr/>
-          <p:nvPr/>
-        </p:nvSpPr>
-        <p:spPr>
-          <a:xfrm>
-            <a:off x="4828583" y="1280160"/>
-            <a:ext cx="1655612" cy="457200"/>
+          <p:cNvPr id="50" name="TextBox 49"/>
+          <p:cNvSpPr txBox="1"/>
+          <p:nvPr/>
+        </p:nvSpPr>
+        <p:spPr>
+          <a:xfrm>
+            <a:off x="4857750" y="2963570"/>
+            <a:ext cx="1181862" cy="226771"/>
+          </a:xfrm>
+          <a:prstGeom prst="rect">
+            <a:avLst/>
+          </a:prstGeom>
+          <a:noFill/>
+        </p:spPr>
+        <p:txBody>
+          <a:bodyPr wrap="square" anchor="t" lIns="36576" rIns="36576" tIns="0" bIns="0">
+            <a:spAutoFit/>
+          </a:bodyPr>
+          <a:lstStyle/>
+          <a:p>
+            <a:pPr algn="ctr" rtl="1"/>
+            <a:r>
+              <a:rPr sz="900" b="0">
+                <a:solidFill>
+                  <a:srgbClr val="8A94A8"/>
+                </a:solidFill>
+                <a:latin typeface="Heebo"/>
+                <a:cs typeface="Heebo"/>
+              </a:rPr>
+              <a:t>נציג קבוע</a:t>
+            </a:r>
+          </a:p>
+        </p:txBody>
+      </p:sp>
+      <p:sp>
+        <p:nvSpPr>
+          <p:cNvPr id="51" name="Rounded Rectangle 50"/>
+          <p:cNvSpPr/>
+          <p:nvPr/>
+        </p:nvSpPr>
+        <p:spPr>
+          <a:xfrm>
+            <a:off x="3566160" y="2651760"/>
+            <a:ext cx="1181862" cy="566928"/>
           </a:xfrm>
           <a:prstGeom prst="roundRect">
             <a:avLst>
               <a:gd name="adj" fmla="val 18000"/>
-            </a:avLst>
-          </a:prstGeom>
-          <a:solidFill>
-            <a:srgbClr val="FFFFFF"/>
-          </a:solidFill>
-          <a:ln w="15875">
-            <a:solidFill>
-              <a:srgbClr val="C5CDDD"/>
-            </a:solidFill>
-          </a:ln>
-          <a:effectLst/>
-        </p:spPr>
-        <p:style>
-          <a:lnRef idx="1">
-            <a:schemeClr val="accent1"/>
-          </a:lnRef>
-          <a:fillRef idx="3">
-            <a:schemeClr val="accent1"/>
-          </a:fillRef>
-          <a:effectRef idx="2">
-            <a:schemeClr val="accent1"/>
-          </a:effectRef>
-          <a:fontRef idx="minor">
-            <a:schemeClr val="lt1"/>
-          </a:fontRef>
-        </p:style>
-        <p:txBody>
-          <a:bodyPr rtlCol="0" anchor="ctr"/>
-          <a:lstStyle/>
-          <a:p>
-            <a:pPr algn="ctr"/>
-          </a:p>
-        </p:txBody>
-      </p:sp>
-      <p:sp>
-        <p:nvSpPr>
-          <p:cNvPr id="19" name="Rectangle 18"/>
-          <p:cNvSpPr/>
-          <p:nvPr/>
-        </p:nvSpPr>
-        <p:spPr>
-          <a:xfrm>
-            <a:off x="6420187" y="1353312"/>
-            <a:ext cx="45720" cy="310896"/>
-          </a:xfrm>
-          <a:prstGeom prst="rect">
-            <a:avLst/>
-          </a:prstGeom>
-          <a:solidFill>
-            <a:srgbClr val="F0C000"/>
-          </a:solidFill>
-          <a:ln>
-            <a:noFill/>
-          </a:ln>
-          <a:effectLst/>
-        </p:spPr>
-        <p:style>
-          <a:lnRef idx="1">
-            <a:schemeClr val="accent1"/>
-          </a:lnRef>
-          <a:fillRef idx="3">
-            <a:schemeClr val="accent1"/>
-          </a:fillRef>
-          <a:effectRef idx="2">
-            <a:schemeClr val="accent1"/>
-          </a:effectRef>
-          <a:fontRef idx="minor">
-            <a:schemeClr val="lt1"/>
-          </a:fontRef>
-        </p:style>
-        <p:txBody>
-          <a:bodyPr rtlCol="0" anchor="ctr"/>
-          <a:lstStyle/>
-          <a:p>
-            <a:pPr algn="ctr"/>
-          </a:p>
-        </p:txBody>
-      </p:sp>
-      <p:sp>
-        <p:nvSpPr>
-          <p:cNvPr id="20" name="TextBox 19"/>
-          <p:cNvSpPr txBox="1"/>
-          <p:nvPr/>
-        </p:nvSpPr>
-        <p:spPr>
-          <a:xfrm>
-            <a:off x="4828583" y="1280160"/>
-            <a:ext cx="1655612" cy="457200"/>
-          </a:xfrm>
-          <a:prstGeom prst="rect">
-            <a:avLst/>
-          </a:prstGeom>
-          <a:noFill/>
-        </p:spPr>
-        <p:txBody>
-          <a:bodyPr wrap="square" anchor="ctr" lIns="36576" rIns="36576" tIns="0" bIns="0">
-            <a:spAutoFit/>
-          </a:bodyPr>
-          <a:lstStyle/>
-          <a:p>
-            <a:pPr algn="ctr" rtl="1"/>
-            <a:r>
-              <a:rPr sz="1200" b="1">
-                <a:solidFill>
-                  <a:srgbClr val="1A2233"/>
-                </a:solidFill>
-                <a:latin typeface="Heebo"/>
-                <a:cs typeface="Heebo"/>
-              </a:rPr>
-              <a:t>נגה ארבל</a:t>
-            </a:r>
-          </a:p>
-        </p:txBody>
-      </p:sp>
-      <p:sp>
-        <p:nvSpPr>
-          <p:cNvPr id="21" name="Rounded Rectangle 20"/>
-          <p:cNvSpPr/>
-          <p:nvPr/>
-        </p:nvSpPr>
-        <p:spPr>
-          <a:xfrm>
-            <a:off x="3063243" y="1280160"/>
-            <a:ext cx="1655612" cy="457200"/>
-          </a:xfrm>
-          <a:prstGeom prst="roundRect">
-            <a:avLst>
-              <a:gd name="adj" fmla="val 18000"/>
-            </a:avLst>
-          </a:prstGeom>
-          <a:solidFill>
-            <a:srgbClr val="FFFFFF"/>
-          </a:solidFill>
-          <a:ln w="15875">
-            <a:solidFill>
-              <a:srgbClr val="C5CDDD"/>
-            </a:solidFill>
-          </a:ln>
-          <a:effectLst/>
-        </p:spPr>
-        <p:style>
-          <a:lnRef idx="1">
-            <a:schemeClr val="accent1"/>
-          </a:lnRef>
-          <a:fillRef idx="3">
-            <a:schemeClr val="accent1"/>
-          </a:fillRef>
-          <a:effectRef idx="2">
-            <a:schemeClr val="accent1"/>
-          </a:effectRef>
-          <a:fontRef idx="minor">
-            <a:schemeClr val="lt1"/>
-          </a:fontRef>
-        </p:style>
-        <p:txBody>
-          <a:bodyPr rtlCol="0" anchor="ctr"/>
-          <a:lstStyle/>
-          <a:p>
-            <a:pPr algn="ctr"/>
-          </a:p>
-        </p:txBody>
-      </p:sp>
-      <p:sp>
-        <p:nvSpPr>
-          <p:cNvPr id="22" name="Rectangle 21"/>
-          <p:cNvSpPr/>
-          <p:nvPr/>
-        </p:nvSpPr>
-        <p:spPr>
-          <a:xfrm>
-            <a:off x="4654847" y="1353312"/>
-            <a:ext cx="45720" cy="310896"/>
-          </a:xfrm>
-          <a:prstGeom prst="rect">
-            <a:avLst/>
-          </a:prstGeom>
-          <a:solidFill>
-            <a:srgbClr val="F0C000"/>
-          </a:solidFill>
-          <a:ln>
-            <a:noFill/>
-          </a:ln>
-          <a:effectLst/>
-        </p:spPr>
-        <p:style>
-          <a:lnRef idx="1">
-            <a:schemeClr val="accent1"/>
-          </a:lnRef>
-          <a:fillRef idx="3">
-            <a:schemeClr val="accent1"/>
-          </a:fillRef>
-          <a:effectRef idx="2">
-            <a:schemeClr val="accent1"/>
-          </a:effectRef>
-          <a:fontRef idx="minor">
-            <a:schemeClr val="lt1"/>
-          </a:fontRef>
-        </p:style>
-        <p:txBody>
-          <a:bodyPr rtlCol="0" anchor="ctr"/>
-          <a:lstStyle/>
-          <a:p>
-            <a:pPr algn="ctr"/>
-          </a:p>
-        </p:txBody>
-      </p:sp>
-      <p:sp>
-        <p:nvSpPr>
-          <p:cNvPr id="23" name="TextBox 22"/>
-          <p:cNvSpPr txBox="1"/>
-          <p:nvPr/>
-        </p:nvSpPr>
-        <p:spPr>
-          <a:xfrm>
-            <a:off x="3063243" y="1280160"/>
-            <a:ext cx="1655612" cy="457200"/>
-          </a:xfrm>
-          <a:prstGeom prst="rect">
-            <a:avLst/>
-          </a:prstGeom>
-          <a:noFill/>
-        </p:spPr>
-        <p:txBody>
-          <a:bodyPr wrap="square" anchor="ctr" lIns="36576" rIns="36576" tIns="0" bIns="0">
-            <a:spAutoFit/>
-          </a:bodyPr>
-          <a:lstStyle/>
-          <a:p>
-            <a:pPr algn="ctr" rtl="1"/>
-            <a:r>
-              <a:rPr sz="1200" b="1">
-                <a:solidFill>
-                  <a:srgbClr val="1A2233"/>
-                </a:solidFill>
-                <a:latin typeface="Heebo"/>
-                <a:cs typeface="Heebo"/>
-              </a:rPr>
-              <a:t>שלומית לביא</a:t>
-            </a:r>
-          </a:p>
-        </p:txBody>
-      </p:sp>
-      <p:sp>
-        <p:nvSpPr>
-          <p:cNvPr id="24" name="Rounded Rectangle 23"/>
-          <p:cNvSpPr/>
-          <p:nvPr/>
-        </p:nvSpPr>
-        <p:spPr>
-          <a:xfrm>
-            <a:off x="411480" y="1078992"/>
-            <a:ext cx="2423160" cy="676656"/>
-          </a:xfrm>
-          <a:prstGeom prst="roundRect">
-            <a:avLst>
-              <a:gd name="adj" fmla="val 10000"/>
             </a:avLst>
           </a:prstGeom>
           <a:noFill/>
@@ -18271,22 +19344,94 @@
       </p:sp>
       <p:sp>
         <p:nvSpPr>
-          <p:cNvPr id="25" name="Rounded Rectangle 24"/>
-          <p:cNvSpPr/>
-          <p:nvPr/>
-        </p:nvSpPr>
-        <p:spPr>
-          <a:xfrm>
-            <a:off x="484632" y="969264"/>
-            <a:ext cx="502920" cy="219456"/>
+          <p:cNvPr id="52" name="TextBox 51"/>
+          <p:cNvSpPr txBox="1"/>
+          <p:nvPr/>
+        </p:nvSpPr>
+        <p:spPr>
+          <a:xfrm>
+            <a:off x="3566160" y="2688336"/>
+            <a:ext cx="1181862" cy="292608"/>
+          </a:xfrm>
+          <a:prstGeom prst="rect">
+            <a:avLst/>
+          </a:prstGeom>
+          <a:noFill/>
+        </p:spPr>
+        <p:txBody>
+          <a:bodyPr wrap="square" anchor="b" lIns="36576" rIns="36576" tIns="0" bIns="0">
+            <a:spAutoFit/>
+          </a:bodyPr>
+          <a:lstStyle/>
+          <a:p>
+            <a:pPr algn="ctr" rtl="1"/>
+            <a:r>
+              <a:rPr sz="1200" b="1">
+                <a:solidFill>
+                  <a:srgbClr val="1C3C7A"/>
+                </a:solidFill>
+                <a:latin typeface="Heebo"/>
+                <a:cs typeface="Heebo"/>
+              </a:rPr>
+              <a:t>נציג רביעי</a:t>
+            </a:r>
+          </a:p>
+        </p:txBody>
+      </p:sp>
+      <p:sp>
+        <p:nvSpPr>
+          <p:cNvPr id="53" name="TextBox 52"/>
+          <p:cNvSpPr txBox="1"/>
+          <p:nvPr/>
+        </p:nvSpPr>
+        <p:spPr>
+          <a:xfrm>
+            <a:off x="3566160" y="2980944"/>
+            <a:ext cx="1181862" cy="219456"/>
+          </a:xfrm>
+          <a:prstGeom prst="rect">
+            <a:avLst/>
+          </a:prstGeom>
+          <a:noFill/>
+        </p:spPr>
+        <p:txBody>
+          <a:bodyPr wrap="square" anchor="t" lIns="36576" rIns="36576" tIns="0" bIns="0">
+            <a:spAutoFit/>
+          </a:bodyPr>
+          <a:lstStyle/>
+          <a:p>
+            <a:pPr algn="ctr" rtl="1"/>
+            <a:r>
+              <a:rPr sz="900" b="0">
+                <a:solidFill>
+                  <a:srgbClr val="8A94A8"/>
+                </a:solidFill>
+                <a:latin typeface="Heebo"/>
+                <a:cs typeface="Heebo"/>
+              </a:rPr>
+              <a:t>לגיוס</a:t>
+            </a:r>
+          </a:p>
+        </p:txBody>
+      </p:sp>
+      <p:sp>
+        <p:nvSpPr>
+          <p:cNvPr id="54" name="Rounded Rectangle 53"/>
+          <p:cNvSpPr/>
+          <p:nvPr/>
+        </p:nvSpPr>
+        <p:spPr>
+          <a:xfrm>
+            <a:off x="7010400" y="3429000"/>
+            <a:ext cx="1612392" cy="548640"/>
           </a:xfrm>
           <a:prstGeom prst="roundRect">
             <a:avLst>
-              <a:gd name="adj" fmla="val 50000"/>
+              <a:gd name="adj" fmla="val 20000"/>
             </a:avLst>
           </a:prstGeom>
           <a:solidFill>
-            <a:srgbClr val="F0C000"/>
+            <a:srgbClr val="1C3C7A"/>
           </a:solidFill>
           <a:ln>
             <a:noFill/>
@@ -18317,14 +19462,14 @@
       </p:sp>
       <p:sp>
         <p:nvSpPr>
-          <p:cNvPr id="26" name="TextBox 25"/>
+          <p:cNvPr id="55" name="TextBox 54"/>
           <p:cNvSpPr txBox="1"/>
           <p:nvPr/>
         </p:nvSpPr>
         <p:spPr>
           <a:xfrm>
-            <a:off x="484632" y="969264"/>
-            <a:ext cx="502920" cy="219456"/>
+            <a:off x="7010400" y="3429000"/>
+            <a:ext cx="1612392" cy="548640"/>
           </a:xfrm>
           <a:prstGeom prst="rect">
             <a:avLst/>
@@ -18339,28 +19484,74 @@
           <a:p>
             <a:pPr algn="ctr" rtl="1"/>
             <a:r>
-              <a:rPr sz="900" b="1">
-                <a:solidFill>
-                  <a:srgbClr val="122755"/>
+              <a:rPr sz="1300" b="1">
+                <a:solidFill>
+                  <a:srgbClr val="FFFFFF"/>
                 </a:solidFill>
                 <a:latin typeface="Heebo"/>
                 <a:cs typeface="Heebo"/>
               </a:rPr>
-              <a:t>חדש</a:t>
-            </a:r>
-          </a:p>
-        </p:txBody>
-      </p:sp>
-      <p:sp>
-        <p:nvSpPr>
-          <p:cNvPr id="27" name="TextBox 26"/>
+              <a:t>בין 3 ל-4 דיונים בשבוע</a:t>
+            </a:r>
+          </a:p>
+        </p:txBody>
+      </p:sp>
+      <p:sp>
+        <p:nvSpPr>
+          <p:cNvPr id="56" name="Rounded Rectangle 55"/>
+          <p:cNvSpPr/>
+          <p:nvPr/>
+        </p:nvSpPr>
+        <p:spPr>
+          <a:xfrm>
+            <a:off x="5288280" y="3429000"/>
+            <a:ext cx="1612392" cy="548640"/>
+          </a:xfrm>
+          <a:prstGeom prst="roundRect">
+            <a:avLst>
+              <a:gd name="adj" fmla="val 20000"/>
+            </a:avLst>
+          </a:prstGeom>
+          <a:solidFill>
+            <a:srgbClr val="1C3C7A"/>
+          </a:solidFill>
+          <a:ln>
+            <a:noFill/>
+          </a:ln>
+          <a:effectLst/>
+        </p:spPr>
+        <p:style>
+          <a:lnRef idx="1">
+            <a:schemeClr val="accent1"/>
+          </a:lnRef>
+          <a:fillRef idx="3">
+            <a:schemeClr val="accent1"/>
+          </a:fillRef>
+          <a:effectRef idx="2">
+            <a:schemeClr val="accent1"/>
+          </a:effectRef>
+          <a:fontRef idx="minor">
+            <a:schemeClr val="lt1"/>
+          </a:fontRef>
+        </p:style>
+        <p:txBody>
+          <a:bodyPr rtlCol="0" anchor="ctr"/>
+          <a:lstStyle/>
+          <a:p>
+            <a:pPr algn="ctr"/>
+          </a:p>
+        </p:txBody>
+      </p:sp>
+      <p:sp>
+        <p:nvSpPr>
+          <p:cNvPr id="57" name="TextBox 56"/>
           <p:cNvSpPr txBox="1"/>
           <p:nvPr/>
         </p:nvSpPr>
         <p:spPr>
           <a:xfrm>
-            <a:off x="411480" y="1097280"/>
-            <a:ext cx="2313432" cy="237744"/>
+            <a:off x="5288280" y="3429000"/>
+            <a:ext cx="1612392" cy="548640"/>
           </a:xfrm>
           <a:prstGeom prst="rect">
             <a:avLst/>
@@ -18373,30 +19564,76 @@
           </a:bodyPr>
           <a:lstStyle/>
           <a:p>
-            <a:pPr algn="r" rtl="1"/>
-            <a:r>
-              <a:rPr sz="1200" b="1">
-                <a:solidFill>
-                  <a:srgbClr val="1C3C7A"/>
+            <a:pPr algn="ctr" rtl="1"/>
+            <a:r>
+              <a:rPr sz="1300" b="1">
+                <a:solidFill>
+                  <a:srgbClr val="FFFFFF"/>
                 </a:solidFill>
                 <a:latin typeface="Heebo"/>
                 <a:cs typeface="Heebo"/>
               </a:rPr>
-              <a:t>יועצים מקצועיים</a:t>
-            </a:r>
-          </a:p>
-        </p:txBody>
-      </p:sp>
-      <p:sp>
-        <p:nvSpPr>
-          <p:cNvPr id="28" name="TextBox 27"/>
+              <a:t>2 ימי כנסת מלאים</a:t>
+            </a:r>
+          </a:p>
+        </p:txBody>
+      </p:sp>
+      <p:sp>
+        <p:nvSpPr>
+          <p:cNvPr id="58" name="Rounded Rectangle 57"/>
+          <p:cNvSpPr/>
+          <p:nvPr/>
+        </p:nvSpPr>
+        <p:spPr>
+          <a:xfrm>
+            <a:off x="3566160" y="3429000"/>
+            <a:ext cx="1612392" cy="548640"/>
+          </a:xfrm>
+          <a:prstGeom prst="roundRect">
+            <a:avLst>
+              <a:gd name="adj" fmla="val 20000"/>
+            </a:avLst>
+          </a:prstGeom>
+          <a:solidFill>
+            <a:srgbClr val="1C3C7A"/>
+          </a:solidFill>
+          <a:ln>
+            <a:noFill/>
+          </a:ln>
+          <a:effectLst/>
+        </p:spPr>
+        <p:style>
+          <a:lnRef idx="1">
+            <a:schemeClr val="accent1"/>
+          </a:lnRef>
+          <a:fillRef idx="3">
+            <a:schemeClr val="accent1"/>
+          </a:fillRef>
+          <a:effectRef idx="2">
+            <a:schemeClr val="accent1"/>
+          </a:effectRef>
+          <a:fontRef idx="minor">
+            <a:schemeClr val="lt1"/>
+          </a:fontRef>
+        </p:style>
+        <p:txBody>
+          <a:bodyPr rtlCol="0" anchor="ctr"/>
+          <a:lstStyle/>
+          <a:p>
+            <a:pPr algn="ctr"/>
+          </a:p>
+        </p:txBody>
+      </p:sp>
+      <p:sp>
+        <p:nvSpPr>
+          <p:cNvPr id="59" name="TextBox 58"/>
           <p:cNvSpPr txBox="1"/>
           <p:nvPr/>
         </p:nvSpPr>
         <p:spPr>
           <a:xfrm>
-            <a:off x="411480" y="1325880"/>
-            <a:ext cx="2313432" cy="219456"/>
+            <a:off x="3566160" y="3429000"/>
+            <a:ext cx="1612392" cy="548640"/>
           </a:xfrm>
           <a:prstGeom prst="rect">
             <a:avLst/>
@@ -18409,271 +19646,34 @@
           </a:bodyPr>
           <a:lstStyle/>
           <a:p>
-            <a:pPr algn="r" rtl="1"/>
-            <a:r>
-              <a:rPr sz="1100" b="0">
-                <a:solidFill>
-                  <a:srgbClr val="1A2233"/>
+            <a:pPr algn="ctr" rtl="1"/>
+            <a:r>
+              <a:rPr sz="1300" b="1">
+                <a:solidFill>
+                  <a:srgbClr val="FFFFFF"/>
                 </a:solidFill>
                 <a:latin typeface="Heebo"/>
                 <a:cs typeface="Heebo"/>
               </a:rPr>
-              <a:t>טל קופל · עו״ד תמר ארבל</a:t>
-            </a:r>
-          </a:p>
-        </p:txBody>
-      </p:sp>
-      <p:sp>
-        <p:nvSpPr>
-          <p:cNvPr id="29" name="TextBox 28"/>
-          <p:cNvSpPr txBox="1"/>
-          <p:nvPr/>
-        </p:nvSpPr>
-        <p:spPr>
-          <a:xfrm>
-            <a:off x="411480" y="1527048"/>
-            <a:ext cx="2313432" cy="201168"/>
-          </a:xfrm>
-          <a:prstGeom prst="rect">
-            <a:avLst/>
-          </a:prstGeom>
-          <a:noFill/>
-        </p:spPr>
-        <p:txBody>
-          <a:bodyPr wrap="square" anchor="ctr" lIns="36576" rIns="36576" tIns="0" bIns="0">
-            <a:spAutoFit/>
-          </a:bodyPr>
-          <a:lstStyle/>
-          <a:p>
-            <a:pPr algn="r" rtl="1"/>
-            <a:r>
-              <a:rPr sz="900" b="0">
-                <a:solidFill>
-                  <a:srgbClr val="8A94A8"/>
-                </a:solidFill>
-                <a:latin typeface="Heebo"/>
-                <a:cs typeface="Heebo"/>
-              </a:rPr>
-              <a:t>מצטרפים לדיונים בתחומם</a:t>
-            </a:r>
-          </a:p>
-        </p:txBody>
-      </p:sp>
-      <p:cxnSp>
-        <p:nvCxnSpPr>
-          <p:cNvPr id="30" name="Connector 29"/>
-          <p:cNvCxnSpPr/>
-          <p:nvPr/>
-        </p:nvCxnSpPr>
-        <p:spPr>
-          <a:xfrm>
-            <a:off x="7010247" y="1737360"/>
-            <a:ext cx="0" cy="365760"/>
-          </a:xfrm>
-          <a:prstGeom prst="line">
-            <a:avLst/>
-          </a:prstGeom>
-          <a:ln w="19050">
-            <a:solidFill>
-              <a:srgbClr val="C5CDDD"/>
-            </a:solidFill>
-          </a:ln>
-        </p:spPr>
-        <p:style>
-          <a:lnRef idx="2">
-            <a:schemeClr val="accent1"/>
-          </a:lnRef>
-          <a:fillRef idx="0">
-            <a:schemeClr val="accent1"/>
-          </a:fillRef>
-          <a:effectRef idx="1">
-            <a:schemeClr val="accent1"/>
-          </a:effectRef>
-          <a:fontRef idx="minor">
-            <a:schemeClr val="tx1"/>
-          </a:fontRef>
-        </p:style>
-      </p:cxnSp>
-      <p:sp>
-        <p:nvSpPr>
-          <p:cNvPr id="31" name="Rounded Rectangle 30"/>
-          <p:cNvSpPr/>
-          <p:nvPr/>
-        </p:nvSpPr>
-        <p:spPr>
-          <a:xfrm>
-            <a:off x="3429000" y="2103120"/>
-            <a:ext cx="5330952" cy="2057400"/>
+              <a:t>4 משרות בשכר</a:t>
+            </a:r>
+          </a:p>
+        </p:txBody>
+      </p:sp>
+      <p:sp>
+        <p:nvSpPr>
+          <p:cNvPr id="60" name="Rounded Rectangle 59"/>
+          <p:cNvSpPr/>
+          <p:nvPr/>
+        </p:nvSpPr>
+        <p:spPr>
+          <a:xfrm>
+            <a:off x="9079992" y="2103120"/>
+            <a:ext cx="2700223" cy="1600200"/>
           </a:xfrm>
           <a:prstGeom prst="roundRect">
             <a:avLst>
-              <a:gd name="adj" fmla="val 5000"/>
-            </a:avLst>
-          </a:prstGeom>
-          <a:solidFill>
-            <a:srgbClr val="FFFFFF"/>
-          </a:solidFill>
-          <a:ln w="31750">
-            <a:solidFill>
-              <a:srgbClr val="F0C000"/>
-            </a:solidFill>
-          </a:ln>
-          <a:effectLst/>
-        </p:spPr>
-        <p:style>
-          <a:lnRef idx="1">
-            <a:schemeClr val="accent1"/>
-          </a:lnRef>
-          <a:fillRef idx="3">
-            <a:schemeClr val="accent1"/>
-          </a:fillRef>
-          <a:effectRef idx="2">
-            <a:schemeClr val="accent1"/>
-          </a:effectRef>
-          <a:fontRef idx="minor">
-            <a:schemeClr val="lt1"/>
-          </a:fontRef>
-        </p:style>
-        <p:txBody>
-          <a:bodyPr rtlCol="0" anchor="ctr"/>
-          <a:lstStyle/>
-          <a:p>
-            <a:pPr algn="ctr"/>
-          </a:p>
-        </p:txBody>
-      </p:sp>
-      <p:sp>
-        <p:nvSpPr>
-          <p:cNvPr id="32" name="Rounded Rectangle 31"/>
-          <p:cNvSpPr/>
-          <p:nvPr/>
-        </p:nvSpPr>
-        <p:spPr>
-          <a:xfrm>
-            <a:off x="3538728" y="1993392"/>
-            <a:ext cx="502920" cy="219456"/>
-          </a:xfrm>
-          <a:prstGeom prst="roundRect">
-            <a:avLst>
-              <a:gd name="adj" fmla="val 50000"/>
-            </a:avLst>
-          </a:prstGeom>
-          <a:solidFill>
-            <a:srgbClr val="F0C000"/>
-          </a:solidFill>
-          <a:ln>
-            <a:noFill/>
-          </a:ln>
-          <a:effectLst/>
-        </p:spPr>
-        <p:style>
-          <a:lnRef idx="1">
-            <a:schemeClr val="accent1"/>
-          </a:lnRef>
-          <a:fillRef idx="3">
-            <a:schemeClr val="accent1"/>
-          </a:fillRef>
-          <a:effectRef idx="2">
-            <a:schemeClr val="accent1"/>
-          </a:effectRef>
-          <a:fontRef idx="minor">
-            <a:schemeClr val="lt1"/>
-          </a:fontRef>
-        </p:style>
-        <p:txBody>
-          <a:bodyPr rtlCol="0" anchor="ctr"/>
-          <a:lstStyle/>
-          <a:p>
-            <a:pPr algn="ctr"/>
-          </a:p>
-        </p:txBody>
-      </p:sp>
-      <p:sp>
-        <p:nvSpPr>
-          <p:cNvPr id="33" name="TextBox 32"/>
-          <p:cNvSpPr txBox="1"/>
-          <p:nvPr/>
-        </p:nvSpPr>
-        <p:spPr>
-          <a:xfrm>
-            <a:off x="3538728" y="1993392"/>
-            <a:ext cx="502920" cy="219456"/>
-          </a:xfrm>
-          <a:prstGeom prst="rect">
-            <a:avLst/>
-          </a:prstGeom>
-          <a:noFill/>
-        </p:spPr>
-        <p:txBody>
-          <a:bodyPr wrap="square" anchor="ctr" lIns="36576" rIns="36576" tIns="0" bIns="0">
-            <a:spAutoFit/>
-          </a:bodyPr>
-          <a:lstStyle/>
-          <a:p>
-            <a:pPr algn="ctr" rtl="1"/>
-            <a:r>
-              <a:rPr sz="900" b="1">
-                <a:solidFill>
-                  <a:srgbClr val="122755"/>
-                </a:solidFill>
-                <a:latin typeface="Heebo"/>
-                <a:cs typeface="Heebo"/>
-              </a:rPr>
-              <a:t>חדש</a:t>
-            </a:r>
-          </a:p>
-        </p:txBody>
-      </p:sp>
-      <p:sp>
-        <p:nvSpPr>
-          <p:cNvPr id="34" name="TextBox 33"/>
-          <p:cNvSpPr txBox="1"/>
-          <p:nvPr/>
-        </p:nvSpPr>
-        <p:spPr>
-          <a:xfrm>
-            <a:off x="3429000" y="2194560"/>
-            <a:ext cx="5330952" cy="329184"/>
-          </a:xfrm>
-          <a:prstGeom prst="rect">
-            <a:avLst/>
-          </a:prstGeom>
-          <a:noFill/>
-        </p:spPr>
-        <p:txBody>
-          <a:bodyPr wrap="square" anchor="ctr" lIns="36576" rIns="36576" tIns="0" bIns="0">
-            <a:spAutoFit/>
-          </a:bodyPr>
-          <a:lstStyle/>
-          <a:p>
-            <a:pPr algn="ctr" rtl="1"/>
-            <a:r>
-              <a:rPr sz="1700" b="1">
-                <a:solidFill>
-                  <a:srgbClr val="1C3C7A"/>
-                </a:solidFill>
-                <a:latin typeface="Heebo"/>
-                <a:cs typeface="Heebo"/>
-              </a:rPr>
-              <a:t>צוות הכנסת · קבוע ובשכר</a:t>
-            </a:r>
-          </a:p>
-        </p:txBody>
-      </p:sp>
-      <p:sp>
-        <p:nvSpPr>
-          <p:cNvPr id="35" name="Rounded Rectangle 34"/>
-          <p:cNvSpPr/>
-          <p:nvPr/>
-        </p:nvSpPr>
-        <p:spPr>
-          <a:xfrm>
-            <a:off x="7440930" y="2651760"/>
-            <a:ext cx="1181862" cy="566928"/>
-          </a:xfrm>
-          <a:prstGeom prst="roundRect">
-            <a:avLst>
-              <a:gd name="adj" fmla="val 18000"/>
+              <a:gd name="adj" fmla="val 6000"/>
             </a:avLst>
           </a:prstGeom>
           <a:solidFill>
@@ -18710,577 +19710,14 @@
       </p:sp>
       <p:sp>
         <p:nvSpPr>
-          <p:cNvPr id="36" name="Rectangle 35"/>
-          <p:cNvSpPr/>
-          <p:nvPr/>
-        </p:nvSpPr>
-        <p:spPr>
-          <a:xfrm>
-            <a:off x="8558784" y="2724912"/>
-            <a:ext cx="45720" cy="420624"/>
-          </a:xfrm>
-          <a:prstGeom prst="rect">
-            <a:avLst/>
-          </a:prstGeom>
-          <a:solidFill>
-            <a:srgbClr val="F0C000"/>
-          </a:solidFill>
-          <a:ln>
-            <a:noFill/>
-          </a:ln>
-          <a:effectLst/>
-        </p:spPr>
-        <p:style>
-          <a:lnRef idx="1">
-            <a:schemeClr val="accent1"/>
-          </a:lnRef>
-          <a:fillRef idx="3">
-            <a:schemeClr val="accent1"/>
-          </a:fillRef>
-          <a:effectRef idx="2">
-            <a:schemeClr val="accent1"/>
-          </a:effectRef>
-          <a:fontRef idx="minor">
-            <a:schemeClr val="lt1"/>
-          </a:fontRef>
-        </p:style>
-        <p:txBody>
-          <a:bodyPr rtlCol="0" anchor="ctr"/>
-          <a:lstStyle/>
-          <a:p>
-            <a:pPr algn="ctr"/>
-          </a:p>
-        </p:txBody>
-      </p:sp>
-      <p:sp>
-        <p:nvSpPr>
-          <p:cNvPr id="37" name="TextBox 36"/>
-          <p:cNvSpPr txBox="1"/>
-          <p:nvPr/>
-        </p:nvSpPr>
-        <p:spPr>
-          <a:xfrm>
-            <a:off x="7440930" y="2706624"/>
-            <a:ext cx="1181862" cy="294802"/>
-          </a:xfrm>
-          <a:prstGeom prst="rect">
-            <a:avLst/>
-          </a:prstGeom>
-          <a:noFill/>
-        </p:spPr>
-        <p:txBody>
-          <a:bodyPr wrap="square" anchor="b" lIns="36576" rIns="36576" tIns="0" bIns="0">
-            <a:spAutoFit/>
-          </a:bodyPr>
-          <a:lstStyle/>
-          <a:p>
-            <a:pPr algn="ctr" rtl="1"/>
-            <a:r>
-              <a:rPr sz="1200" b="1">
-                <a:solidFill>
-                  <a:srgbClr val="1A2233"/>
-                </a:solidFill>
-                <a:latin typeface="Heebo"/>
-                <a:cs typeface="Heebo"/>
-              </a:rPr>
-              <a:t>תמיר דורטל</a:t>
-            </a:r>
-          </a:p>
-        </p:txBody>
-      </p:sp>
-      <p:sp>
-        <p:nvSpPr>
-          <p:cNvPr id="38" name="TextBox 37"/>
-          <p:cNvSpPr txBox="1"/>
-          <p:nvPr/>
-        </p:nvSpPr>
-        <p:spPr>
-          <a:xfrm>
-            <a:off x="7440930" y="2963570"/>
-            <a:ext cx="1181862" cy="226771"/>
-          </a:xfrm>
-          <a:prstGeom prst="rect">
-            <a:avLst/>
-          </a:prstGeom>
-          <a:noFill/>
-        </p:spPr>
-        <p:txBody>
-          <a:bodyPr wrap="square" anchor="t" lIns="36576" rIns="36576" tIns="0" bIns="0">
-            <a:spAutoFit/>
-          </a:bodyPr>
-          <a:lstStyle/>
-          <a:p>
-            <a:pPr algn="ctr" rtl="1"/>
-            <a:r>
-              <a:rPr sz="900" b="0">
-                <a:solidFill>
-                  <a:srgbClr val="8A94A8"/>
-                </a:solidFill>
-                <a:latin typeface="Heebo"/>
-                <a:cs typeface="Heebo"/>
-              </a:rPr>
-              <a:t>נציג קבוע</a:t>
-            </a:r>
-          </a:p>
-        </p:txBody>
-      </p:sp>
-      <p:sp>
-        <p:nvSpPr>
-          <p:cNvPr id="39" name="Rounded Rectangle 38"/>
-          <p:cNvSpPr/>
-          <p:nvPr/>
-        </p:nvSpPr>
-        <p:spPr>
-          <a:xfrm>
-            <a:off x="6149340" y="2651760"/>
-            <a:ext cx="1181862" cy="566928"/>
-          </a:xfrm>
-          <a:prstGeom prst="roundRect">
-            <a:avLst>
-              <a:gd name="adj" fmla="val 18000"/>
-            </a:avLst>
-          </a:prstGeom>
-          <a:solidFill>
-            <a:srgbClr val="FFFFFF"/>
-          </a:solidFill>
-          <a:ln w="15875">
-            <a:solidFill>
-              <a:srgbClr val="C5CDDD"/>
-            </a:solidFill>
-          </a:ln>
-          <a:effectLst/>
-        </p:spPr>
-        <p:style>
-          <a:lnRef idx="1">
-            <a:schemeClr val="accent1"/>
-          </a:lnRef>
-          <a:fillRef idx="3">
-            <a:schemeClr val="accent1"/>
-          </a:fillRef>
-          <a:effectRef idx="2">
-            <a:schemeClr val="accent1"/>
-          </a:effectRef>
-          <a:fontRef idx="minor">
-            <a:schemeClr val="lt1"/>
-          </a:fontRef>
-        </p:style>
-        <p:txBody>
-          <a:bodyPr rtlCol="0" anchor="ctr"/>
-          <a:lstStyle/>
-          <a:p>
-            <a:pPr algn="ctr"/>
-          </a:p>
-        </p:txBody>
-      </p:sp>
-      <p:sp>
-        <p:nvSpPr>
-          <p:cNvPr id="40" name="Rectangle 39"/>
-          <p:cNvSpPr/>
-          <p:nvPr/>
-        </p:nvSpPr>
-        <p:spPr>
-          <a:xfrm>
-            <a:off x="7267194" y="2724912"/>
-            <a:ext cx="45720" cy="420624"/>
-          </a:xfrm>
-          <a:prstGeom prst="rect">
-            <a:avLst/>
-          </a:prstGeom>
-          <a:solidFill>
-            <a:srgbClr val="F0C000"/>
-          </a:solidFill>
-          <a:ln>
-            <a:noFill/>
-          </a:ln>
-          <a:effectLst/>
-        </p:spPr>
-        <p:style>
-          <a:lnRef idx="1">
-            <a:schemeClr val="accent1"/>
-          </a:lnRef>
-          <a:fillRef idx="3">
-            <a:schemeClr val="accent1"/>
-          </a:fillRef>
-          <a:effectRef idx="2">
-            <a:schemeClr val="accent1"/>
-          </a:effectRef>
-          <a:fontRef idx="minor">
-            <a:schemeClr val="lt1"/>
-          </a:fontRef>
-        </p:style>
-        <p:txBody>
-          <a:bodyPr rtlCol="0" anchor="ctr"/>
-          <a:lstStyle/>
-          <a:p>
-            <a:pPr algn="ctr"/>
-          </a:p>
-        </p:txBody>
-      </p:sp>
-      <p:sp>
-        <p:nvSpPr>
-          <p:cNvPr id="41" name="TextBox 40"/>
-          <p:cNvSpPr txBox="1"/>
-          <p:nvPr/>
-        </p:nvSpPr>
-        <p:spPr>
-          <a:xfrm>
-            <a:off x="6149340" y="2706624"/>
-            <a:ext cx="1181862" cy="294802"/>
-          </a:xfrm>
-          <a:prstGeom prst="rect">
-            <a:avLst/>
-          </a:prstGeom>
-          <a:noFill/>
-        </p:spPr>
-        <p:txBody>
-          <a:bodyPr wrap="square" anchor="b" lIns="36576" rIns="36576" tIns="0" bIns="0">
-            <a:spAutoFit/>
-          </a:bodyPr>
-          <a:lstStyle/>
-          <a:p>
-            <a:pPr algn="ctr" rtl="1"/>
-            <a:r>
-              <a:rPr sz="1200" b="1">
-                <a:solidFill>
-                  <a:srgbClr val="1A2233"/>
-                </a:solidFill>
-                <a:latin typeface="Heebo"/>
-                <a:cs typeface="Heebo"/>
-              </a:rPr>
-              <a:t>אדם קורגן</a:t>
-            </a:r>
-          </a:p>
-        </p:txBody>
-      </p:sp>
-      <p:sp>
-        <p:nvSpPr>
-          <p:cNvPr id="42" name="TextBox 41"/>
-          <p:cNvSpPr txBox="1"/>
-          <p:nvPr/>
-        </p:nvSpPr>
-        <p:spPr>
-          <a:xfrm>
-            <a:off x="6149340" y="2963570"/>
-            <a:ext cx="1181862" cy="226771"/>
-          </a:xfrm>
-          <a:prstGeom prst="rect">
-            <a:avLst/>
-          </a:prstGeom>
-          <a:noFill/>
-        </p:spPr>
-        <p:txBody>
-          <a:bodyPr wrap="square" anchor="t" lIns="36576" rIns="36576" tIns="0" bIns="0">
-            <a:spAutoFit/>
-          </a:bodyPr>
-          <a:lstStyle/>
-          <a:p>
-            <a:pPr algn="ctr" rtl="1"/>
-            <a:r>
-              <a:rPr sz="900" b="0">
-                <a:solidFill>
-                  <a:srgbClr val="8A94A8"/>
-                </a:solidFill>
-                <a:latin typeface="Heebo"/>
-                <a:cs typeface="Heebo"/>
-              </a:rPr>
-              <a:t>נציג קבוע</a:t>
-            </a:r>
-          </a:p>
-        </p:txBody>
-      </p:sp>
-      <p:sp>
-        <p:nvSpPr>
-          <p:cNvPr id="43" name="Rounded Rectangle 42"/>
-          <p:cNvSpPr/>
-          <p:nvPr/>
-        </p:nvSpPr>
-        <p:spPr>
-          <a:xfrm>
-            <a:off x="4857750" y="2651760"/>
-            <a:ext cx="1181862" cy="566928"/>
-          </a:xfrm>
-          <a:prstGeom prst="roundRect">
-            <a:avLst>
-              <a:gd name="adj" fmla="val 18000"/>
-            </a:avLst>
-          </a:prstGeom>
-          <a:solidFill>
-            <a:srgbClr val="FFFFFF"/>
-          </a:solidFill>
-          <a:ln w="15875">
-            <a:solidFill>
-              <a:srgbClr val="C5CDDD"/>
-            </a:solidFill>
-          </a:ln>
-          <a:effectLst/>
-        </p:spPr>
-        <p:style>
-          <a:lnRef idx="1">
-            <a:schemeClr val="accent1"/>
-          </a:lnRef>
-          <a:fillRef idx="3">
-            <a:schemeClr val="accent1"/>
-          </a:fillRef>
-          <a:effectRef idx="2">
-            <a:schemeClr val="accent1"/>
-          </a:effectRef>
-          <a:fontRef idx="minor">
-            <a:schemeClr val="lt1"/>
-          </a:fontRef>
-        </p:style>
-        <p:txBody>
-          <a:bodyPr rtlCol="0" anchor="ctr"/>
-          <a:lstStyle/>
-          <a:p>
-            <a:pPr algn="ctr"/>
-          </a:p>
-        </p:txBody>
-      </p:sp>
-      <p:sp>
-        <p:nvSpPr>
-          <p:cNvPr id="44" name="Rectangle 43"/>
-          <p:cNvSpPr/>
-          <p:nvPr/>
-        </p:nvSpPr>
-        <p:spPr>
-          <a:xfrm>
-            <a:off x="5975604" y="2724912"/>
-            <a:ext cx="45720" cy="420624"/>
-          </a:xfrm>
-          <a:prstGeom prst="rect">
-            <a:avLst/>
-          </a:prstGeom>
-          <a:solidFill>
-            <a:srgbClr val="F0C000"/>
-          </a:solidFill>
-          <a:ln>
-            <a:noFill/>
-          </a:ln>
-          <a:effectLst/>
-        </p:spPr>
-        <p:style>
-          <a:lnRef idx="1">
-            <a:schemeClr val="accent1"/>
-          </a:lnRef>
-          <a:fillRef idx="3">
-            <a:schemeClr val="accent1"/>
-          </a:fillRef>
-          <a:effectRef idx="2">
-            <a:schemeClr val="accent1"/>
-          </a:effectRef>
-          <a:fontRef idx="minor">
-            <a:schemeClr val="lt1"/>
-          </a:fontRef>
-        </p:style>
-        <p:txBody>
-          <a:bodyPr rtlCol="0" anchor="ctr"/>
-          <a:lstStyle/>
-          <a:p>
-            <a:pPr algn="ctr"/>
-          </a:p>
-        </p:txBody>
-      </p:sp>
-      <p:sp>
-        <p:nvSpPr>
-          <p:cNvPr id="45" name="TextBox 44"/>
-          <p:cNvSpPr txBox="1"/>
-          <p:nvPr/>
-        </p:nvSpPr>
-        <p:spPr>
-          <a:xfrm>
-            <a:off x="4857750" y="2706624"/>
-            <a:ext cx="1181862" cy="294802"/>
-          </a:xfrm>
-          <a:prstGeom prst="rect">
-            <a:avLst/>
-          </a:prstGeom>
-          <a:noFill/>
-        </p:spPr>
-        <p:txBody>
-          <a:bodyPr wrap="square" anchor="b" lIns="36576" rIns="36576" tIns="0" bIns="0">
-            <a:spAutoFit/>
-          </a:bodyPr>
-          <a:lstStyle/>
-          <a:p>
-            <a:pPr algn="ctr" rtl="1"/>
-            <a:r>
-              <a:rPr sz="1200" b="1">
-                <a:solidFill>
-                  <a:srgbClr val="1A2233"/>
-                </a:solidFill>
-                <a:latin typeface="Heebo"/>
-                <a:cs typeface="Heebo"/>
-              </a:rPr>
-              <a:t>ד״ר אמיר רובין</a:t>
-            </a:r>
-          </a:p>
-        </p:txBody>
-      </p:sp>
-      <p:sp>
-        <p:nvSpPr>
-          <p:cNvPr id="46" name="TextBox 45"/>
-          <p:cNvSpPr txBox="1"/>
-          <p:nvPr/>
-        </p:nvSpPr>
-        <p:spPr>
-          <a:xfrm>
-            <a:off x="4857750" y="2963570"/>
-            <a:ext cx="1181862" cy="226771"/>
-          </a:xfrm>
-          <a:prstGeom prst="rect">
-            <a:avLst/>
-          </a:prstGeom>
-          <a:noFill/>
-        </p:spPr>
-        <p:txBody>
-          <a:bodyPr wrap="square" anchor="t" lIns="36576" rIns="36576" tIns="0" bIns="0">
-            <a:spAutoFit/>
-          </a:bodyPr>
-          <a:lstStyle/>
-          <a:p>
-            <a:pPr algn="ctr" rtl="1"/>
-            <a:r>
-              <a:rPr sz="900" b="0">
-                <a:solidFill>
-                  <a:srgbClr val="8A94A8"/>
-                </a:solidFill>
-                <a:latin typeface="Heebo"/>
-                <a:cs typeface="Heebo"/>
-              </a:rPr>
-              <a:t>נציג קבוע</a:t>
-            </a:r>
-          </a:p>
-        </p:txBody>
-      </p:sp>
-      <p:sp>
-        <p:nvSpPr>
-          <p:cNvPr id="47" name="Rounded Rectangle 46"/>
-          <p:cNvSpPr/>
-          <p:nvPr/>
-        </p:nvSpPr>
-        <p:spPr>
-          <a:xfrm>
-            <a:off x="3566160" y="2651760"/>
-            <a:ext cx="1181862" cy="566928"/>
-          </a:xfrm>
-          <a:prstGeom prst="roundRect">
-            <a:avLst>
-              <a:gd name="adj" fmla="val 18000"/>
-            </a:avLst>
-          </a:prstGeom>
-          <a:noFill/>
-          <a:ln w="15875">
-            <a:solidFill>
-              <a:srgbClr val="F0C000"/>
-            </a:solidFill>
-            <a:prstDash val="dash"/>
-          </a:ln>
-          <a:effectLst/>
-        </p:spPr>
-        <p:style>
-          <a:lnRef idx="1">
-            <a:schemeClr val="accent1"/>
-          </a:lnRef>
-          <a:fillRef idx="3">
-            <a:schemeClr val="accent1"/>
-          </a:fillRef>
-          <a:effectRef idx="2">
-            <a:schemeClr val="accent1"/>
-          </a:effectRef>
-          <a:fontRef idx="minor">
-            <a:schemeClr val="lt1"/>
-          </a:fontRef>
-        </p:style>
-        <p:txBody>
-          <a:bodyPr rtlCol="0" anchor="ctr"/>
-          <a:lstStyle/>
-          <a:p>
-            <a:pPr algn="ctr"/>
-          </a:p>
-        </p:txBody>
-      </p:sp>
-      <p:sp>
-        <p:nvSpPr>
-          <p:cNvPr id="48" name="TextBox 47"/>
-          <p:cNvSpPr txBox="1"/>
-          <p:nvPr/>
-        </p:nvSpPr>
-        <p:spPr>
-          <a:xfrm>
-            <a:off x="3566160" y="2688336"/>
-            <a:ext cx="1181862" cy="292608"/>
-          </a:xfrm>
-          <a:prstGeom prst="rect">
-            <a:avLst/>
-          </a:prstGeom>
-          <a:noFill/>
-        </p:spPr>
-        <p:txBody>
-          <a:bodyPr wrap="square" anchor="b" lIns="36576" rIns="36576" tIns="0" bIns="0">
-            <a:spAutoFit/>
-          </a:bodyPr>
-          <a:lstStyle/>
-          <a:p>
-            <a:pPr algn="ctr" rtl="1"/>
-            <a:r>
-              <a:rPr sz="1200" b="1">
-                <a:solidFill>
-                  <a:srgbClr val="1C3C7A"/>
-                </a:solidFill>
-                <a:latin typeface="Heebo"/>
-                <a:cs typeface="Heebo"/>
-              </a:rPr>
-              <a:t>נציג רביעי</a:t>
-            </a:r>
-          </a:p>
-        </p:txBody>
-      </p:sp>
-      <p:sp>
-        <p:nvSpPr>
-          <p:cNvPr id="49" name="TextBox 48"/>
-          <p:cNvSpPr txBox="1"/>
-          <p:nvPr/>
-        </p:nvSpPr>
-        <p:spPr>
-          <a:xfrm>
-            <a:off x="3566160" y="2980944"/>
-            <a:ext cx="1181862" cy="219456"/>
-          </a:xfrm>
-          <a:prstGeom prst="rect">
-            <a:avLst/>
-          </a:prstGeom>
-          <a:noFill/>
-        </p:spPr>
-        <p:txBody>
-          <a:bodyPr wrap="square" anchor="t" lIns="36576" rIns="36576" tIns="0" bIns="0">
-            <a:spAutoFit/>
-          </a:bodyPr>
-          <a:lstStyle/>
-          <a:p>
-            <a:pPr algn="ctr" rtl="1"/>
-            <a:r>
-              <a:rPr sz="900" b="0">
-                <a:solidFill>
-                  <a:srgbClr val="8A94A8"/>
-                </a:solidFill>
-                <a:latin typeface="Heebo"/>
-                <a:cs typeface="Heebo"/>
-              </a:rPr>
-              <a:t>לגיוס</a:t>
-            </a:r>
-          </a:p>
-        </p:txBody>
-      </p:sp>
-      <p:sp>
-        <p:nvSpPr>
-          <p:cNvPr id="50" name="Rounded Rectangle 49"/>
-          <p:cNvSpPr/>
-          <p:nvPr/>
-        </p:nvSpPr>
-        <p:spPr>
-          <a:xfrm>
-            <a:off x="7010400" y="3429000"/>
-            <a:ext cx="1612392" cy="548640"/>
+          <p:cNvPr id="61" name="Rounded Rectangle 60"/>
+          <p:cNvSpPr/>
+          <p:nvPr/>
+        </p:nvSpPr>
+        <p:spPr>
+          <a:xfrm>
+            <a:off x="9079992" y="2103120"/>
+            <a:ext cx="2700223" cy="384048"/>
           </a:xfrm>
           <a:prstGeom prst="roundRect">
             <a:avLst>
@@ -19319,301 +19756,7 @@
       </p:sp>
       <p:sp>
         <p:nvSpPr>
-          <p:cNvPr id="51" name="TextBox 50"/>
-          <p:cNvSpPr txBox="1"/>
-          <p:nvPr/>
-        </p:nvSpPr>
-        <p:spPr>
-          <a:xfrm>
-            <a:off x="7010400" y="3429000"/>
-            <a:ext cx="1612392" cy="548640"/>
-          </a:xfrm>
-          <a:prstGeom prst="rect">
-            <a:avLst/>
-          </a:prstGeom>
-          <a:noFill/>
-        </p:spPr>
-        <p:txBody>
-          <a:bodyPr wrap="square" anchor="ctr" lIns="36576" rIns="36576" tIns="0" bIns="0">
-            <a:spAutoFit/>
-          </a:bodyPr>
-          <a:lstStyle/>
-          <a:p>
-            <a:pPr algn="ctr" rtl="1"/>
-            <a:r>
-              <a:rPr sz="1300" b="1">
-                <a:solidFill>
-                  <a:srgbClr val="FFFFFF"/>
-                </a:solidFill>
-                <a:latin typeface="Heebo"/>
-                <a:cs typeface="Heebo"/>
-              </a:rPr>
-              <a:t>בין 3 ל-4 דיונים בשבוע</a:t>
-            </a:r>
-          </a:p>
-        </p:txBody>
-      </p:sp>
-      <p:sp>
-        <p:nvSpPr>
-          <p:cNvPr id="52" name="Rounded Rectangle 51"/>
-          <p:cNvSpPr/>
-          <p:nvPr/>
-        </p:nvSpPr>
-        <p:spPr>
-          <a:xfrm>
-            <a:off x="5288280" y="3429000"/>
-            <a:ext cx="1612392" cy="548640"/>
-          </a:xfrm>
-          <a:prstGeom prst="roundRect">
-            <a:avLst>
-              <a:gd name="adj" fmla="val 20000"/>
-            </a:avLst>
-          </a:prstGeom>
-          <a:solidFill>
-            <a:srgbClr val="1C3C7A"/>
-          </a:solidFill>
-          <a:ln>
-            <a:noFill/>
-          </a:ln>
-          <a:effectLst/>
-        </p:spPr>
-        <p:style>
-          <a:lnRef idx="1">
-            <a:schemeClr val="accent1"/>
-          </a:lnRef>
-          <a:fillRef idx="3">
-            <a:schemeClr val="accent1"/>
-          </a:fillRef>
-          <a:effectRef idx="2">
-            <a:schemeClr val="accent1"/>
-          </a:effectRef>
-          <a:fontRef idx="minor">
-            <a:schemeClr val="lt1"/>
-          </a:fontRef>
-        </p:style>
-        <p:txBody>
-          <a:bodyPr rtlCol="0" anchor="ctr"/>
-          <a:lstStyle/>
-          <a:p>
-            <a:pPr algn="ctr"/>
-          </a:p>
-        </p:txBody>
-      </p:sp>
-      <p:sp>
-        <p:nvSpPr>
-          <p:cNvPr id="53" name="TextBox 52"/>
-          <p:cNvSpPr txBox="1"/>
-          <p:nvPr/>
-        </p:nvSpPr>
-        <p:spPr>
-          <a:xfrm>
-            <a:off x="5288280" y="3429000"/>
-            <a:ext cx="1612392" cy="548640"/>
-          </a:xfrm>
-          <a:prstGeom prst="rect">
-            <a:avLst/>
-          </a:prstGeom>
-          <a:noFill/>
-        </p:spPr>
-        <p:txBody>
-          <a:bodyPr wrap="square" anchor="ctr" lIns="36576" rIns="36576" tIns="0" bIns="0">
-            <a:spAutoFit/>
-          </a:bodyPr>
-          <a:lstStyle/>
-          <a:p>
-            <a:pPr algn="ctr" rtl="1"/>
-            <a:r>
-              <a:rPr sz="1300" b="1">
-                <a:solidFill>
-                  <a:srgbClr val="FFFFFF"/>
-                </a:solidFill>
-                <a:latin typeface="Heebo"/>
-                <a:cs typeface="Heebo"/>
-              </a:rPr>
-              <a:t>2 ימי כנסת מלאים</a:t>
-            </a:r>
-          </a:p>
-        </p:txBody>
-      </p:sp>
-      <p:sp>
-        <p:nvSpPr>
-          <p:cNvPr id="54" name="Rounded Rectangle 53"/>
-          <p:cNvSpPr/>
-          <p:nvPr/>
-        </p:nvSpPr>
-        <p:spPr>
-          <a:xfrm>
-            <a:off x="3566160" y="3429000"/>
-            <a:ext cx="1612392" cy="548640"/>
-          </a:xfrm>
-          <a:prstGeom prst="roundRect">
-            <a:avLst>
-              <a:gd name="adj" fmla="val 20000"/>
-            </a:avLst>
-          </a:prstGeom>
-          <a:solidFill>
-            <a:srgbClr val="1C3C7A"/>
-          </a:solidFill>
-          <a:ln>
-            <a:noFill/>
-          </a:ln>
-          <a:effectLst/>
-        </p:spPr>
-        <p:style>
-          <a:lnRef idx="1">
-            <a:schemeClr val="accent1"/>
-          </a:lnRef>
-          <a:fillRef idx="3">
-            <a:schemeClr val="accent1"/>
-          </a:fillRef>
-          <a:effectRef idx="2">
-            <a:schemeClr val="accent1"/>
-          </a:effectRef>
-          <a:fontRef idx="minor">
-            <a:schemeClr val="lt1"/>
-          </a:fontRef>
-        </p:style>
-        <p:txBody>
-          <a:bodyPr rtlCol="0" anchor="ctr"/>
-          <a:lstStyle/>
-          <a:p>
-            <a:pPr algn="ctr"/>
-          </a:p>
-        </p:txBody>
-      </p:sp>
-      <p:sp>
-        <p:nvSpPr>
-          <p:cNvPr id="55" name="TextBox 54"/>
-          <p:cNvSpPr txBox="1"/>
-          <p:nvPr/>
-        </p:nvSpPr>
-        <p:spPr>
-          <a:xfrm>
-            <a:off x="3566160" y="3429000"/>
-            <a:ext cx="1612392" cy="548640"/>
-          </a:xfrm>
-          <a:prstGeom prst="rect">
-            <a:avLst/>
-          </a:prstGeom>
-          <a:noFill/>
-        </p:spPr>
-        <p:txBody>
-          <a:bodyPr wrap="square" anchor="ctr" lIns="36576" rIns="36576" tIns="0" bIns="0">
-            <a:spAutoFit/>
-          </a:bodyPr>
-          <a:lstStyle/>
-          <a:p>
-            <a:pPr algn="ctr" rtl="1"/>
-            <a:r>
-              <a:rPr sz="1300" b="1">
-                <a:solidFill>
-                  <a:srgbClr val="FFFFFF"/>
-                </a:solidFill>
-                <a:latin typeface="Heebo"/>
-                <a:cs typeface="Heebo"/>
-              </a:rPr>
-              <a:t>4 משרות בשכר</a:t>
-            </a:r>
-          </a:p>
-        </p:txBody>
-      </p:sp>
-      <p:sp>
-        <p:nvSpPr>
-          <p:cNvPr id="56" name="Rounded Rectangle 55"/>
-          <p:cNvSpPr/>
-          <p:nvPr/>
-        </p:nvSpPr>
-        <p:spPr>
-          <a:xfrm>
-            <a:off x="9079992" y="2103120"/>
-            <a:ext cx="2700223" cy="1600200"/>
-          </a:xfrm>
-          <a:prstGeom prst="roundRect">
-            <a:avLst>
-              <a:gd name="adj" fmla="val 6000"/>
-            </a:avLst>
-          </a:prstGeom>
-          <a:solidFill>
-            <a:srgbClr val="FFFFFF"/>
-          </a:solidFill>
-          <a:ln w="15875">
-            <a:solidFill>
-              <a:srgbClr val="C5CDDD"/>
-            </a:solidFill>
-          </a:ln>
-          <a:effectLst/>
-        </p:spPr>
-        <p:style>
-          <a:lnRef idx="1">
-            <a:schemeClr val="accent1"/>
-          </a:lnRef>
-          <a:fillRef idx="3">
-            <a:schemeClr val="accent1"/>
-          </a:fillRef>
-          <a:effectRef idx="2">
-            <a:schemeClr val="accent1"/>
-          </a:effectRef>
-          <a:fontRef idx="minor">
-            <a:schemeClr val="lt1"/>
-          </a:fontRef>
-        </p:style>
-        <p:txBody>
-          <a:bodyPr rtlCol="0" anchor="ctr"/>
-          <a:lstStyle/>
-          <a:p>
-            <a:pPr algn="ctr"/>
-          </a:p>
-        </p:txBody>
-      </p:sp>
-      <p:sp>
-        <p:nvSpPr>
-          <p:cNvPr id="57" name="Rounded Rectangle 56"/>
-          <p:cNvSpPr/>
-          <p:nvPr/>
-        </p:nvSpPr>
-        <p:spPr>
-          <a:xfrm>
-            <a:off x="9079992" y="2103120"/>
-            <a:ext cx="2700223" cy="384048"/>
-          </a:xfrm>
-          <a:prstGeom prst="roundRect">
-            <a:avLst>
-              <a:gd name="adj" fmla="val 20000"/>
-            </a:avLst>
-          </a:prstGeom>
-          <a:solidFill>
-            <a:srgbClr val="1C3C7A"/>
-          </a:solidFill>
-          <a:ln>
-            <a:noFill/>
-          </a:ln>
-          <a:effectLst/>
-        </p:spPr>
-        <p:style>
-          <a:lnRef idx="1">
-            <a:schemeClr val="accent1"/>
-          </a:lnRef>
-          <a:fillRef idx="3">
-            <a:schemeClr val="accent1"/>
-          </a:fillRef>
-          <a:effectRef idx="2">
-            <a:schemeClr val="accent1"/>
-          </a:effectRef>
-          <a:fontRef idx="minor">
-            <a:schemeClr val="lt1"/>
-          </a:fontRef>
-        </p:style>
-        <p:txBody>
-          <a:bodyPr rtlCol="0" anchor="ctr"/>
-          <a:lstStyle/>
-          <a:p>
-            <a:pPr algn="ctr"/>
-          </a:p>
-        </p:txBody>
-      </p:sp>
-      <p:sp>
-        <p:nvSpPr>
-          <p:cNvPr id="58" name="TextBox 57"/>
+          <p:cNvPr id="62" name="TextBox 61"/>
           <p:cNvSpPr txBox="1"/>
           <p:nvPr/>
         </p:nvSpPr>
@@ -19649,7 +19792,7 @@
       </p:sp>
       <p:sp>
         <p:nvSpPr>
-          <p:cNvPr id="59" name="TextBox 58"/>
+          <p:cNvPr id="63" name="TextBox 62"/>
           <p:cNvSpPr txBox="1"/>
           <p:nvPr/>
         </p:nvSpPr>
@@ -19685,7 +19828,7 @@
       </p:sp>
       <p:sp>
         <p:nvSpPr>
-          <p:cNvPr id="60" name="TextBox 59"/>
+          <p:cNvPr id="64" name="TextBox 63"/>
           <p:cNvSpPr txBox="1"/>
           <p:nvPr/>
         </p:nvSpPr>
@@ -19721,7 +19864,7 @@
       </p:sp>
       <p:sp>
         <p:nvSpPr>
-          <p:cNvPr id="61" name="TextBox 60"/>
+          <p:cNvPr id="65" name="TextBox 64"/>
           <p:cNvSpPr txBox="1"/>
           <p:nvPr/>
         </p:nvSpPr>
@@ -19757,7 +19900,7 @@
       </p:sp>
       <p:cxnSp>
         <p:nvCxnSpPr>
-          <p:cNvPr id="62" name="Connector 61"/>
+          <p:cNvPr id="66" name="Connector 65"/>
           <p:cNvCxnSpPr/>
           <p:nvPr/>
         </p:nvCxnSpPr>
@@ -19793,7 +19936,7 @@
       </p:cxnSp>
       <p:sp>
         <p:nvSpPr>
-          <p:cNvPr id="63" name="Rounded Rectangle 62"/>
+          <p:cNvPr id="67" name="Rounded Rectangle 66"/>
           <p:cNvSpPr/>
           <p:nvPr/>
         </p:nvSpPr>
@@ -19841,7 +19984,7 @@
       </p:sp>
       <p:sp>
         <p:nvSpPr>
-          <p:cNvPr id="64" name="Rounded Rectangle 63"/>
+          <p:cNvPr id="68" name="Rounded Rectangle 67"/>
           <p:cNvSpPr/>
           <p:nvPr/>
         </p:nvSpPr>
@@ -19887,7 +20030,7 @@
       </p:sp>
       <p:sp>
         <p:nvSpPr>
-          <p:cNvPr id="65" name="TextBox 64"/>
+          <p:cNvPr id="69" name="TextBox 68"/>
           <p:cNvSpPr txBox="1"/>
           <p:nvPr/>
         </p:nvSpPr>
@@ -19923,7 +20066,7 @@
       </p:sp>
       <p:sp>
         <p:nvSpPr>
-          <p:cNvPr id="66" name="TextBox 65"/>
+          <p:cNvPr id="70" name="TextBox 69"/>
           <p:cNvSpPr txBox="1"/>
           <p:nvPr/>
         </p:nvSpPr>
@@ -19959,7 +20102,7 @@
       </p:sp>
       <p:sp>
         <p:nvSpPr>
-          <p:cNvPr id="67" name="TextBox 66"/>
+          <p:cNvPr id="71" name="TextBox 70"/>
           <p:cNvSpPr txBox="1"/>
           <p:nvPr/>
         </p:nvSpPr>
@@ -19995,7 +20138,7 @@
       </p:sp>
       <p:sp>
         <p:nvSpPr>
-          <p:cNvPr id="68" name="TextBox 67"/>
+          <p:cNvPr id="72" name="TextBox 71"/>
           <p:cNvSpPr txBox="1"/>
           <p:nvPr/>
         </p:nvSpPr>
@@ -20031,7 +20174,7 @@
       </p:sp>
       <p:cxnSp>
         <p:nvCxnSpPr>
-          <p:cNvPr id="69" name="Connector 68"/>
+          <p:cNvPr id="73" name="Connector 72"/>
           <p:cNvCxnSpPr/>
           <p:nvPr/>
         </p:nvCxnSpPr>
@@ -20067,7 +20210,7 @@
       </p:cxnSp>
       <p:cxnSp>
         <p:nvCxnSpPr>
-          <p:cNvPr id="70" name="Connector 69"/>
+          <p:cNvPr id="74" name="Connector 73"/>
           <p:cNvCxnSpPr/>
           <p:nvPr/>
         </p:nvCxnSpPr>
@@ -20103,7 +20246,7 @@
       </p:cxnSp>
       <p:sp>
         <p:nvSpPr>
-          <p:cNvPr id="71" name="Rounded Rectangle 70"/>
+          <p:cNvPr id="75" name="Rounded Rectangle 74"/>
           <p:cNvSpPr/>
           <p:nvPr/>
         </p:nvSpPr>
@@ -20149,7 +20292,7 @@
       </p:sp>
       <p:sp>
         <p:nvSpPr>
-          <p:cNvPr id="72" name="TextBox 71"/>
+          <p:cNvPr id="76" name="TextBox 75"/>
           <p:cNvSpPr txBox="1"/>
           <p:nvPr/>
         </p:nvSpPr>
@@ -20185,7 +20328,7 @@
       </p:sp>
       <p:cxnSp>
         <p:nvCxnSpPr>
-          <p:cNvPr id="73" name="Connector 72"/>
+          <p:cNvPr id="77" name="Connector 76"/>
           <p:cNvCxnSpPr/>
           <p:nvPr/>
         </p:nvCxnSpPr>
@@ -20221,7 +20364,7 @@
       </p:cxnSp>
       <p:sp>
         <p:nvSpPr>
-          <p:cNvPr id="74" name="Rounded Rectangle 73"/>
+          <p:cNvPr id="78" name="Rounded Rectangle 77"/>
           <p:cNvSpPr/>
           <p:nvPr/>
         </p:nvSpPr>
@@ -20269,7 +20412,7 @@
       </p:sp>
       <p:sp>
         <p:nvSpPr>
-          <p:cNvPr id="75" name="TextBox 74"/>
+          <p:cNvPr id="79" name="TextBox 78"/>
           <p:cNvSpPr txBox="1"/>
           <p:nvPr/>
         </p:nvSpPr>
@@ -20305,7 +20448,7 @@
       </p:sp>
       <p:sp>
         <p:nvSpPr>
-          <p:cNvPr id="76" name="TextBox 75"/>
+          <p:cNvPr id="80" name="TextBox 79"/>
           <p:cNvSpPr txBox="1"/>
           <p:nvPr/>
         </p:nvSpPr>

</xml_diff>

<commit_message>
Proposal: drop youth, reword domain leads
Co-Authored-By: Claude Opus 5.5 <noreply@anthropic.com>
Claude-Session: https://claude.ai/code/session_01W7Er83FuNT4pLFShWidYHn
</commit_message>
<xml_diff>
--- a/presentation/out/koach-hitarvut.pptx
+++ b/presentation/out/koach-hitarvut.pptx
@@ -17623,7 +17623,7 @@
                 <a:latin typeface="Heebo"/>
                 <a:cs typeface="Heebo"/>
               </a:rPr>
-              <a:t>מובילות תחום</a:t>
+              <a:t>מובילי תחום</a:t>
             </a:r>
           </a:p>
         </p:txBody>
@@ -17659,7 +17659,7 @@
                 <a:latin typeface="Heebo"/>
                 <a:cs typeface="Heebo"/>
               </a:rPr>
-              <a:t>מקדמות את התחום כולל הופעות בכנסת</a:t>
+              <a:t>מובילים את התוכניות שלהם + הופעות בכנסת</a:t>
             </a:r>
           </a:p>
         </p:txBody>
@@ -18269,7 +18269,7 @@
                 <a:latin typeface="Heebo"/>
                 <a:cs typeface="Heebo"/>
               </a:rPr>
-              <a:t>מקדמים את התוכניות האישיות שלהם</a:t>
+              <a:t>מובילים את התוכניות שלהם</a:t>
             </a:r>
           </a:p>
         </p:txBody>
@@ -20059,7 +20059,7 @@
                 <a:latin typeface="Heebo"/>
                 <a:cs typeface="Heebo"/>
               </a:rPr>
-              <a:t>אקטיביסטים ונוער</a:t>
+              <a:t>צוות אקטיביסטים</a:t>
             </a:r>
           </a:p>
         </p:txBody>
@@ -20095,7 +20095,7 @@
                 <a:latin typeface="Heebo"/>
                 <a:cs typeface="Heebo"/>
               </a:rPr>
-              <a:t>יהונתן יחזקאל · יהונתן אמתי</a:t>
+              <a:t>יהונתן יחזקאל</a:t>
             </a:r>
           </a:p>
         </p:txBody>

</xml_diff>

<commit_message>
Proposal: drop subtitle, salaried KPI and recruit label
Co-Authored-By: Claude Opus 5.5 <noreply@anthropic.com>
Claude-Session: https://claude.ai/code/session_01W7Er83FuNT4pLFShWidYHn
</commit_message>
<xml_diff>
--- a/presentation/out/koach-hitarvut.pptx
+++ b/presentation/out/koach-hitarvut.pptx
@@ -17442,43 +17442,7 @@
       </p:sp>
       <p:sp>
         <p:nvSpPr>
-          <p:cNvPr id="5" name="TextBox 4"/>
-          <p:cNvSpPr txBox="1"/>
-          <p:nvPr/>
-        </p:nvSpPr>
-        <p:spPr>
-          <a:xfrm>
-            <a:off x="1280160" y="530352"/>
-            <a:ext cx="10515600" cy="274320"/>
-          </a:xfrm>
-          <a:prstGeom prst="rect">
-            <a:avLst/>
-          </a:prstGeom>
-          <a:noFill/>
-        </p:spPr>
-        <p:txBody>
-          <a:bodyPr wrap="square" anchor="ctr" lIns="36576" rIns="36576" tIns="0" bIns="0">
-            <a:spAutoFit/>
-          </a:bodyPr>
-          <a:lstStyle/>
-          <a:p>
-            <a:pPr algn="r" rtl="1"/>
-            <a:r>
-              <a:rPr sz="1200" b="0">
-                <a:solidFill>
-                  <a:srgbClr val="F0C000"/>
-                </a:solidFill>
-                <a:latin typeface="Heebo"/>
-                <a:cs typeface="Heebo"/>
-              </a:rPr>
-              <a:t>צוות קבוע בשכר בליבה, וכל השאר מזינים אותו</a:t>
-            </a:r>
-          </a:p>
-        </p:txBody>
-      </p:sp>
-      <p:sp>
-        <p:nvSpPr>
-          <p:cNvPr id="7" name="Rounded Rectangle 6"/>
+          <p:cNvPr id="6" name="Rounded Rectangle 5"/>
           <p:cNvSpPr/>
           <p:nvPr/>
         </p:nvSpPr>
@@ -17524,7 +17488,7 @@
       </p:sp>
       <p:pic>
         <p:nvPicPr>
-          <p:cNvPr id="6" name="Picture 5" descr="logo.png"/>
+          <p:cNvPr id="5" name="Picture 4" descr="logo.png"/>
           <p:cNvPicPr>
             <a:picLocks noChangeAspect="1"/>
           </p:cNvPicPr>
@@ -17548,7 +17512,7 @@
       </p:pic>
       <p:sp>
         <p:nvSpPr>
-          <p:cNvPr id="8" name="Rounded Rectangle 7"/>
+          <p:cNvPr id="7" name="Rounded Rectangle 6"/>
           <p:cNvSpPr/>
           <p:nvPr/>
         </p:nvSpPr>
@@ -17594,7 +17558,7 @@
       </p:sp>
       <p:sp>
         <p:nvSpPr>
-          <p:cNvPr id="9" name="TextBox 8"/>
+          <p:cNvPr id="8" name="TextBox 7"/>
           <p:cNvSpPr txBox="1"/>
           <p:nvPr/>
         </p:nvSpPr>
@@ -17630,7 +17594,7 @@
       </p:sp>
       <p:sp>
         <p:nvSpPr>
-          <p:cNvPr id="10" name="TextBox 9"/>
+          <p:cNvPr id="9" name="TextBox 8"/>
           <p:cNvSpPr txBox="1"/>
           <p:nvPr/>
         </p:nvSpPr>
@@ -17666,7 +17630,7 @@
       </p:sp>
       <p:sp>
         <p:nvSpPr>
-          <p:cNvPr id="11" name="Rounded Rectangle 10"/>
+          <p:cNvPr id="10" name="Rounded Rectangle 9"/>
           <p:cNvSpPr/>
           <p:nvPr/>
         </p:nvSpPr>
@@ -17714,7 +17678,7 @@
       </p:sp>
       <p:sp>
         <p:nvSpPr>
-          <p:cNvPr id="12" name="Rectangle 11"/>
+          <p:cNvPr id="11" name="Rectangle 10"/>
           <p:cNvSpPr/>
           <p:nvPr/>
         </p:nvSpPr>
@@ -17758,7 +17722,7 @@
       </p:sp>
       <p:sp>
         <p:nvSpPr>
-          <p:cNvPr id="13" name="TextBox 12"/>
+          <p:cNvPr id="12" name="TextBox 11"/>
           <p:cNvSpPr txBox="1"/>
           <p:nvPr/>
         </p:nvSpPr>
@@ -17794,7 +17758,7 @@
       </p:sp>
       <p:sp>
         <p:nvSpPr>
-          <p:cNvPr id="14" name="TextBox 13"/>
+          <p:cNvPr id="13" name="TextBox 12"/>
           <p:cNvSpPr txBox="1"/>
           <p:nvPr/>
         </p:nvSpPr>
@@ -17830,7 +17794,7 @@
       </p:sp>
       <p:sp>
         <p:nvSpPr>
-          <p:cNvPr id="15" name="Rounded Rectangle 14"/>
+          <p:cNvPr id="14" name="Rounded Rectangle 13"/>
           <p:cNvSpPr/>
           <p:nvPr/>
         </p:nvSpPr>
@@ -17878,7 +17842,7 @@
       </p:sp>
       <p:sp>
         <p:nvSpPr>
-          <p:cNvPr id="16" name="Rectangle 15"/>
+          <p:cNvPr id="15" name="Rectangle 14"/>
           <p:cNvSpPr/>
           <p:nvPr/>
         </p:nvSpPr>
@@ -17922,7 +17886,7 @@
       </p:sp>
       <p:sp>
         <p:nvSpPr>
-          <p:cNvPr id="17" name="TextBox 16"/>
+          <p:cNvPr id="16" name="TextBox 15"/>
           <p:cNvSpPr txBox="1"/>
           <p:nvPr/>
         </p:nvSpPr>
@@ -17958,7 +17922,7 @@
       </p:sp>
       <p:sp>
         <p:nvSpPr>
-          <p:cNvPr id="18" name="TextBox 17"/>
+          <p:cNvPr id="17" name="TextBox 16"/>
           <p:cNvSpPr txBox="1"/>
           <p:nvPr/>
         </p:nvSpPr>
@@ -17994,7 +17958,7 @@
       </p:sp>
       <p:sp>
         <p:nvSpPr>
-          <p:cNvPr id="19" name="Rounded Rectangle 18"/>
+          <p:cNvPr id="18" name="Rounded Rectangle 17"/>
           <p:cNvSpPr/>
           <p:nvPr/>
         </p:nvSpPr>
@@ -18042,7 +18006,7 @@
       </p:sp>
       <p:sp>
         <p:nvSpPr>
-          <p:cNvPr id="20" name="Rectangle 19"/>
+          <p:cNvPr id="19" name="Rectangle 18"/>
           <p:cNvSpPr/>
           <p:nvPr/>
         </p:nvSpPr>
@@ -18086,7 +18050,7 @@
       </p:sp>
       <p:sp>
         <p:nvSpPr>
-          <p:cNvPr id="21" name="TextBox 20"/>
+          <p:cNvPr id="20" name="TextBox 19"/>
           <p:cNvSpPr txBox="1"/>
           <p:nvPr/>
         </p:nvSpPr>
@@ -18122,7 +18086,7 @@
       </p:sp>
       <p:sp>
         <p:nvSpPr>
-          <p:cNvPr id="22" name="TextBox 21"/>
+          <p:cNvPr id="21" name="TextBox 20"/>
           <p:cNvSpPr txBox="1"/>
           <p:nvPr/>
         </p:nvSpPr>
@@ -18158,7 +18122,7 @@
       </p:sp>
       <p:sp>
         <p:nvSpPr>
-          <p:cNvPr id="23" name="Rounded Rectangle 22"/>
+          <p:cNvPr id="22" name="Rounded Rectangle 21"/>
           <p:cNvSpPr/>
           <p:nvPr/>
         </p:nvSpPr>
@@ -18204,7 +18168,7 @@
       </p:sp>
       <p:sp>
         <p:nvSpPr>
-          <p:cNvPr id="24" name="TextBox 23"/>
+          <p:cNvPr id="23" name="TextBox 22"/>
           <p:cNvSpPr txBox="1"/>
           <p:nvPr/>
         </p:nvSpPr>
@@ -18240,7 +18204,7 @@
       </p:sp>
       <p:sp>
         <p:nvSpPr>
-          <p:cNvPr id="25" name="TextBox 24"/>
+          <p:cNvPr id="24" name="TextBox 23"/>
           <p:cNvSpPr txBox="1"/>
           <p:nvPr/>
         </p:nvSpPr>
@@ -18276,7 +18240,7 @@
       </p:sp>
       <p:sp>
         <p:nvSpPr>
-          <p:cNvPr id="26" name="Rounded Rectangle 25"/>
+          <p:cNvPr id="25" name="Rounded Rectangle 24"/>
           <p:cNvSpPr/>
           <p:nvPr/>
         </p:nvSpPr>
@@ -18324,7 +18288,7 @@
       </p:sp>
       <p:sp>
         <p:nvSpPr>
-          <p:cNvPr id="27" name="Rectangle 26"/>
+          <p:cNvPr id="26" name="Rectangle 25"/>
           <p:cNvSpPr/>
           <p:nvPr/>
         </p:nvSpPr>
@@ -18368,7 +18332,7 @@
       </p:sp>
       <p:sp>
         <p:nvSpPr>
-          <p:cNvPr id="28" name="TextBox 27"/>
+          <p:cNvPr id="27" name="TextBox 26"/>
           <p:cNvSpPr txBox="1"/>
           <p:nvPr/>
         </p:nvSpPr>
@@ -18404,7 +18368,7 @@
       </p:sp>
       <p:sp>
         <p:nvSpPr>
-          <p:cNvPr id="29" name="TextBox 28"/>
+          <p:cNvPr id="28" name="TextBox 27"/>
           <p:cNvSpPr txBox="1"/>
           <p:nvPr/>
         </p:nvSpPr>
@@ -18440,7 +18404,7 @@
       </p:sp>
       <p:sp>
         <p:nvSpPr>
-          <p:cNvPr id="30" name="Rounded Rectangle 29"/>
+          <p:cNvPr id="29" name="Rounded Rectangle 28"/>
           <p:cNvSpPr/>
           <p:nvPr/>
         </p:nvSpPr>
@@ -18488,7 +18452,7 @@
       </p:sp>
       <p:sp>
         <p:nvSpPr>
-          <p:cNvPr id="31" name="Rectangle 30"/>
+          <p:cNvPr id="30" name="Rectangle 29"/>
           <p:cNvSpPr/>
           <p:nvPr/>
         </p:nvSpPr>
@@ -18532,7 +18496,7 @@
       </p:sp>
       <p:sp>
         <p:nvSpPr>
-          <p:cNvPr id="32" name="TextBox 31"/>
+          <p:cNvPr id="31" name="TextBox 30"/>
           <p:cNvSpPr txBox="1"/>
           <p:nvPr/>
         </p:nvSpPr>
@@ -18568,7 +18532,7 @@
       </p:sp>
       <p:sp>
         <p:nvSpPr>
-          <p:cNvPr id="33" name="TextBox 32"/>
+          <p:cNvPr id="32" name="TextBox 31"/>
           <p:cNvSpPr txBox="1"/>
           <p:nvPr/>
         </p:nvSpPr>
@@ -18604,7 +18568,7 @@
       </p:sp>
       <p:cxnSp>
         <p:nvCxnSpPr>
-          <p:cNvPr id="34" name="Connector 33"/>
+          <p:cNvPr id="33" name="Connector 32"/>
           <p:cNvCxnSpPr/>
           <p:nvPr/>
         </p:nvCxnSpPr>
@@ -18639,7 +18603,7 @@
       </p:cxnSp>
       <p:sp>
         <p:nvSpPr>
-          <p:cNvPr id="35" name="Rounded Rectangle 34"/>
+          <p:cNvPr id="34" name="Rounded Rectangle 33"/>
           <p:cNvSpPr/>
           <p:nvPr/>
         </p:nvSpPr>
@@ -18687,7 +18651,7 @@
       </p:sp>
       <p:sp>
         <p:nvSpPr>
-          <p:cNvPr id="36" name="Rounded Rectangle 35"/>
+          <p:cNvPr id="35" name="Rounded Rectangle 34"/>
           <p:cNvSpPr/>
           <p:nvPr/>
         </p:nvSpPr>
@@ -18733,7 +18697,7 @@
       </p:sp>
       <p:sp>
         <p:nvSpPr>
-          <p:cNvPr id="37" name="TextBox 36"/>
+          <p:cNvPr id="36" name="TextBox 35"/>
           <p:cNvSpPr txBox="1"/>
           <p:nvPr/>
         </p:nvSpPr>
@@ -18769,7 +18733,7 @@
       </p:sp>
       <p:sp>
         <p:nvSpPr>
-          <p:cNvPr id="38" name="TextBox 37"/>
+          <p:cNvPr id="37" name="TextBox 36"/>
           <p:cNvSpPr txBox="1"/>
           <p:nvPr/>
         </p:nvSpPr>
@@ -18805,7 +18769,7 @@
       </p:sp>
       <p:sp>
         <p:nvSpPr>
-          <p:cNvPr id="39" name="Rounded Rectangle 38"/>
+          <p:cNvPr id="38" name="Rounded Rectangle 37"/>
           <p:cNvSpPr/>
           <p:nvPr/>
         </p:nvSpPr>
@@ -18853,7 +18817,7 @@
       </p:sp>
       <p:sp>
         <p:nvSpPr>
-          <p:cNvPr id="40" name="Rectangle 39"/>
+          <p:cNvPr id="39" name="Rectangle 38"/>
           <p:cNvSpPr/>
           <p:nvPr/>
         </p:nvSpPr>
@@ -18897,7 +18861,7 @@
       </p:sp>
       <p:sp>
         <p:nvSpPr>
-          <p:cNvPr id="41" name="TextBox 40"/>
+          <p:cNvPr id="40" name="TextBox 39"/>
           <p:cNvSpPr txBox="1"/>
           <p:nvPr/>
         </p:nvSpPr>
@@ -18933,7 +18897,7 @@
       </p:sp>
       <p:sp>
         <p:nvSpPr>
-          <p:cNvPr id="42" name="TextBox 41"/>
+          <p:cNvPr id="41" name="TextBox 40"/>
           <p:cNvSpPr txBox="1"/>
           <p:nvPr/>
         </p:nvSpPr>
@@ -18969,7 +18933,7 @@
       </p:sp>
       <p:sp>
         <p:nvSpPr>
-          <p:cNvPr id="43" name="Rounded Rectangle 42"/>
+          <p:cNvPr id="42" name="Rounded Rectangle 41"/>
           <p:cNvSpPr/>
           <p:nvPr/>
         </p:nvSpPr>
@@ -19017,7 +18981,7 @@
       </p:sp>
       <p:sp>
         <p:nvSpPr>
-          <p:cNvPr id="44" name="Rectangle 43"/>
+          <p:cNvPr id="43" name="Rectangle 42"/>
           <p:cNvSpPr/>
           <p:nvPr/>
         </p:nvSpPr>
@@ -19061,7 +19025,7 @@
       </p:sp>
       <p:sp>
         <p:nvSpPr>
-          <p:cNvPr id="45" name="TextBox 44"/>
+          <p:cNvPr id="44" name="TextBox 43"/>
           <p:cNvSpPr txBox="1"/>
           <p:nvPr/>
         </p:nvSpPr>
@@ -19097,7 +19061,7 @@
       </p:sp>
       <p:sp>
         <p:nvSpPr>
-          <p:cNvPr id="46" name="TextBox 45"/>
+          <p:cNvPr id="45" name="TextBox 44"/>
           <p:cNvSpPr txBox="1"/>
           <p:nvPr/>
         </p:nvSpPr>
@@ -19133,7 +19097,7 @@
       </p:sp>
       <p:sp>
         <p:nvSpPr>
-          <p:cNvPr id="47" name="Rounded Rectangle 46"/>
+          <p:cNvPr id="46" name="Rounded Rectangle 45"/>
           <p:cNvSpPr/>
           <p:nvPr/>
         </p:nvSpPr>
@@ -19181,7 +19145,7 @@
       </p:sp>
       <p:sp>
         <p:nvSpPr>
-          <p:cNvPr id="48" name="Rectangle 47"/>
+          <p:cNvPr id="47" name="Rectangle 46"/>
           <p:cNvSpPr/>
           <p:nvPr/>
         </p:nvSpPr>
@@ -19225,7 +19189,7 @@
       </p:sp>
       <p:sp>
         <p:nvSpPr>
-          <p:cNvPr id="49" name="TextBox 48"/>
+          <p:cNvPr id="48" name="TextBox 47"/>
           <p:cNvSpPr txBox="1"/>
           <p:nvPr/>
         </p:nvSpPr>
@@ -19261,7 +19225,7 @@
       </p:sp>
       <p:sp>
         <p:nvSpPr>
-          <p:cNvPr id="50" name="TextBox 49"/>
+          <p:cNvPr id="49" name="TextBox 48"/>
           <p:cNvSpPr txBox="1"/>
           <p:nvPr/>
         </p:nvSpPr>
@@ -19297,7 +19261,7 @@
       </p:sp>
       <p:sp>
         <p:nvSpPr>
-          <p:cNvPr id="51" name="Rounded Rectangle 50"/>
+          <p:cNvPr id="50" name="Rounded Rectangle 49"/>
           <p:cNvSpPr/>
           <p:nvPr/>
         </p:nvSpPr>
@@ -19344,14 +19308,14 @@
       </p:sp>
       <p:sp>
         <p:nvSpPr>
-          <p:cNvPr id="52" name="TextBox 51"/>
+          <p:cNvPr id="51" name="TextBox 50"/>
           <p:cNvSpPr txBox="1"/>
           <p:nvPr/>
         </p:nvSpPr>
         <p:spPr>
           <a:xfrm>
-            <a:off x="3566160" y="2688336"/>
-            <a:ext cx="1181862" cy="292608"/>
+            <a:off x="3566160" y="2651760"/>
+            <a:ext cx="1181862" cy="566928"/>
           </a:xfrm>
           <a:prstGeom prst="rect">
             <a:avLst/>
@@ -19359,7 +19323,7 @@
           <a:noFill/>
         </p:spPr>
         <p:txBody>
-          <a:bodyPr wrap="square" anchor="b" lIns="36576" rIns="36576" tIns="0" bIns="0">
+          <a:bodyPr wrap="square" anchor="ctr" lIns="36576" rIns="36576" tIns="0" bIns="0">
             <a:spAutoFit/>
           </a:bodyPr>
           <a:lstStyle/>
@@ -19380,50 +19344,14 @@
       </p:sp>
       <p:sp>
         <p:nvSpPr>
-          <p:cNvPr id="53" name="TextBox 52"/>
-          <p:cNvSpPr txBox="1"/>
-          <p:nvPr/>
-        </p:nvSpPr>
-        <p:spPr>
-          <a:xfrm>
-            <a:off x="3566160" y="2980944"/>
-            <a:ext cx="1181862" cy="219456"/>
-          </a:xfrm>
-          <a:prstGeom prst="rect">
-            <a:avLst/>
-          </a:prstGeom>
-          <a:noFill/>
-        </p:spPr>
-        <p:txBody>
-          <a:bodyPr wrap="square" anchor="t" lIns="36576" rIns="36576" tIns="0" bIns="0">
-            <a:spAutoFit/>
-          </a:bodyPr>
-          <a:lstStyle/>
-          <a:p>
-            <a:pPr algn="ctr" rtl="1"/>
-            <a:r>
-              <a:rPr sz="900" b="0">
-                <a:solidFill>
-                  <a:srgbClr val="8A94A8"/>
-                </a:solidFill>
-                <a:latin typeface="Heebo"/>
-                <a:cs typeface="Heebo"/>
-              </a:rPr>
-              <a:t>לגיוס</a:t>
-            </a:r>
-          </a:p>
-        </p:txBody>
-      </p:sp>
-      <p:sp>
-        <p:nvSpPr>
-          <p:cNvPr id="54" name="Rounded Rectangle 53"/>
-          <p:cNvSpPr/>
-          <p:nvPr/>
-        </p:nvSpPr>
-        <p:spPr>
-          <a:xfrm>
-            <a:off x="7010400" y="3429000"/>
-            <a:ext cx="1612392" cy="548640"/>
+          <p:cNvPr id="52" name="Rounded Rectangle 51"/>
+          <p:cNvSpPr/>
+          <p:nvPr/>
+        </p:nvSpPr>
+        <p:spPr>
+          <a:xfrm>
+            <a:off x="6149340" y="3429000"/>
+            <a:ext cx="2473452" cy="548640"/>
           </a:xfrm>
           <a:prstGeom prst="roundRect">
             <a:avLst>
@@ -19462,14 +19390,14 @@
       </p:sp>
       <p:sp>
         <p:nvSpPr>
-          <p:cNvPr id="55" name="TextBox 54"/>
+          <p:cNvPr id="53" name="TextBox 52"/>
           <p:cNvSpPr txBox="1"/>
           <p:nvPr/>
         </p:nvSpPr>
         <p:spPr>
           <a:xfrm>
-            <a:off x="7010400" y="3429000"/>
-            <a:ext cx="1612392" cy="548640"/>
+            <a:off x="6149340" y="3429000"/>
+            <a:ext cx="2473452" cy="548640"/>
           </a:xfrm>
           <a:prstGeom prst="rect">
             <a:avLst/>
@@ -19498,14 +19426,14 @@
       </p:sp>
       <p:sp>
         <p:nvSpPr>
-          <p:cNvPr id="56" name="Rounded Rectangle 55"/>
-          <p:cNvSpPr/>
-          <p:nvPr/>
-        </p:nvSpPr>
-        <p:spPr>
-          <a:xfrm>
-            <a:off x="5288280" y="3429000"/>
-            <a:ext cx="1612392" cy="548640"/>
+          <p:cNvPr id="54" name="Rounded Rectangle 53"/>
+          <p:cNvSpPr/>
+          <p:nvPr/>
+        </p:nvSpPr>
+        <p:spPr>
+          <a:xfrm>
+            <a:off x="3566160" y="3429000"/>
+            <a:ext cx="2473452" cy="548640"/>
           </a:xfrm>
           <a:prstGeom prst="roundRect">
             <a:avLst>
@@ -19544,14 +19472,14 @@
       </p:sp>
       <p:sp>
         <p:nvSpPr>
-          <p:cNvPr id="57" name="TextBox 56"/>
+          <p:cNvPr id="55" name="TextBox 54"/>
           <p:cNvSpPr txBox="1"/>
           <p:nvPr/>
         </p:nvSpPr>
         <p:spPr>
           <a:xfrm>
-            <a:off x="5288280" y="3429000"/>
-            <a:ext cx="1612392" cy="548640"/>
+            <a:off x="3566160" y="3429000"/>
+            <a:ext cx="2473452" cy="548640"/>
           </a:xfrm>
           <a:prstGeom prst="rect">
             <a:avLst/>
@@ -19580,14 +19508,62 @@
       </p:sp>
       <p:sp>
         <p:nvSpPr>
-          <p:cNvPr id="58" name="Rounded Rectangle 57"/>
-          <p:cNvSpPr/>
-          <p:nvPr/>
-        </p:nvSpPr>
-        <p:spPr>
-          <a:xfrm>
-            <a:off x="3566160" y="3429000"/>
-            <a:ext cx="1612392" cy="548640"/>
+          <p:cNvPr id="56" name="Rounded Rectangle 55"/>
+          <p:cNvSpPr/>
+          <p:nvPr/>
+        </p:nvSpPr>
+        <p:spPr>
+          <a:xfrm>
+            <a:off x="9079992" y="2103120"/>
+            <a:ext cx="2700223" cy="1600200"/>
+          </a:xfrm>
+          <a:prstGeom prst="roundRect">
+            <a:avLst>
+              <a:gd name="adj" fmla="val 6000"/>
+            </a:avLst>
+          </a:prstGeom>
+          <a:solidFill>
+            <a:srgbClr val="FFFFFF"/>
+          </a:solidFill>
+          <a:ln w="15875">
+            <a:solidFill>
+              <a:srgbClr val="C5CDDD"/>
+            </a:solidFill>
+          </a:ln>
+          <a:effectLst/>
+        </p:spPr>
+        <p:style>
+          <a:lnRef idx="1">
+            <a:schemeClr val="accent1"/>
+          </a:lnRef>
+          <a:fillRef idx="3">
+            <a:schemeClr val="accent1"/>
+          </a:fillRef>
+          <a:effectRef idx="2">
+            <a:schemeClr val="accent1"/>
+          </a:effectRef>
+          <a:fontRef idx="minor">
+            <a:schemeClr val="lt1"/>
+          </a:fontRef>
+        </p:style>
+        <p:txBody>
+          <a:bodyPr rtlCol="0" anchor="ctr"/>
+          <a:lstStyle/>
+          <a:p>
+            <a:pPr algn="ctr"/>
+          </a:p>
+        </p:txBody>
+      </p:sp>
+      <p:sp>
+        <p:nvSpPr>
+          <p:cNvPr id="57" name="Rounded Rectangle 56"/>
+          <p:cNvSpPr/>
+          <p:nvPr/>
+        </p:nvSpPr>
+        <p:spPr>
+          <a:xfrm>
+            <a:off x="9079992" y="2103120"/>
+            <a:ext cx="2700223" cy="384048"/>
           </a:xfrm>
           <a:prstGeom prst="roundRect">
             <a:avLst>
@@ -19626,137 +19602,7 @@
       </p:sp>
       <p:sp>
         <p:nvSpPr>
-          <p:cNvPr id="59" name="TextBox 58"/>
-          <p:cNvSpPr txBox="1"/>
-          <p:nvPr/>
-        </p:nvSpPr>
-        <p:spPr>
-          <a:xfrm>
-            <a:off x="3566160" y="3429000"/>
-            <a:ext cx="1612392" cy="548640"/>
-          </a:xfrm>
-          <a:prstGeom prst="rect">
-            <a:avLst/>
-          </a:prstGeom>
-          <a:noFill/>
-        </p:spPr>
-        <p:txBody>
-          <a:bodyPr wrap="square" anchor="ctr" lIns="36576" rIns="36576" tIns="0" bIns="0">
-            <a:spAutoFit/>
-          </a:bodyPr>
-          <a:lstStyle/>
-          <a:p>
-            <a:pPr algn="ctr" rtl="1"/>
-            <a:r>
-              <a:rPr sz="1300" b="1">
-                <a:solidFill>
-                  <a:srgbClr val="FFFFFF"/>
-                </a:solidFill>
-                <a:latin typeface="Heebo"/>
-                <a:cs typeface="Heebo"/>
-              </a:rPr>
-              <a:t>4 משרות בשכר</a:t>
-            </a:r>
-          </a:p>
-        </p:txBody>
-      </p:sp>
-      <p:sp>
-        <p:nvSpPr>
-          <p:cNvPr id="60" name="Rounded Rectangle 59"/>
-          <p:cNvSpPr/>
-          <p:nvPr/>
-        </p:nvSpPr>
-        <p:spPr>
-          <a:xfrm>
-            <a:off x="9079992" y="2103120"/>
-            <a:ext cx="2700223" cy="1600200"/>
-          </a:xfrm>
-          <a:prstGeom prst="roundRect">
-            <a:avLst>
-              <a:gd name="adj" fmla="val 6000"/>
-            </a:avLst>
-          </a:prstGeom>
-          <a:solidFill>
-            <a:srgbClr val="FFFFFF"/>
-          </a:solidFill>
-          <a:ln w="15875">
-            <a:solidFill>
-              <a:srgbClr val="C5CDDD"/>
-            </a:solidFill>
-          </a:ln>
-          <a:effectLst/>
-        </p:spPr>
-        <p:style>
-          <a:lnRef idx="1">
-            <a:schemeClr val="accent1"/>
-          </a:lnRef>
-          <a:fillRef idx="3">
-            <a:schemeClr val="accent1"/>
-          </a:fillRef>
-          <a:effectRef idx="2">
-            <a:schemeClr val="accent1"/>
-          </a:effectRef>
-          <a:fontRef idx="minor">
-            <a:schemeClr val="lt1"/>
-          </a:fontRef>
-        </p:style>
-        <p:txBody>
-          <a:bodyPr rtlCol="0" anchor="ctr"/>
-          <a:lstStyle/>
-          <a:p>
-            <a:pPr algn="ctr"/>
-          </a:p>
-        </p:txBody>
-      </p:sp>
-      <p:sp>
-        <p:nvSpPr>
-          <p:cNvPr id="61" name="Rounded Rectangle 60"/>
-          <p:cNvSpPr/>
-          <p:nvPr/>
-        </p:nvSpPr>
-        <p:spPr>
-          <a:xfrm>
-            <a:off x="9079992" y="2103120"/>
-            <a:ext cx="2700223" cy="384048"/>
-          </a:xfrm>
-          <a:prstGeom prst="roundRect">
-            <a:avLst>
-              <a:gd name="adj" fmla="val 20000"/>
-            </a:avLst>
-          </a:prstGeom>
-          <a:solidFill>
-            <a:srgbClr val="1C3C7A"/>
-          </a:solidFill>
-          <a:ln>
-            <a:noFill/>
-          </a:ln>
-          <a:effectLst/>
-        </p:spPr>
-        <p:style>
-          <a:lnRef idx="1">
-            <a:schemeClr val="accent1"/>
-          </a:lnRef>
-          <a:fillRef idx="3">
-            <a:schemeClr val="accent1"/>
-          </a:fillRef>
-          <a:effectRef idx="2">
-            <a:schemeClr val="accent1"/>
-          </a:effectRef>
-          <a:fontRef idx="minor">
-            <a:schemeClr val="lt1"/>
-          </a:fontRef>
-        </p:style>
-        <p:txBody>
-          <a:bodyPr rtlCol="0" anchor="ctr"/>
-          <a:lstStyle/>
-          <a:p>
-            <a:pPr algn="ctr"/>
-          </a:p>
-        </p:txBody>
-      </p:sp>
-      <p:sp>
-        <p:nvSpPr>
-          <p:cNvPr id="62" name="TextBox 61"/>
+          <p:cNvPr id="58" name="TextBox 57"/>
           <p:cNvSpPr txBox="1"/>
           <p:nvPr/>
         </p:nvSpPr>
@@ -19792,7 +19638,7 @@
       </p:sp>
       <p:sp>
         <p:nvSpPr>
-          <p:cNvPr id="63" name="TextBox 62"/>
+          <p:cNvPr id="59" name="TextBox 58"/>
           <p:cNvSpPr txBox="1"/>
           <p:nvPr/>
         </p:nvSpPr>
@@ -19828,7 +19674,7 @@
       </p:sp>
       <p:sp>
         <p:nvSpPr>
-          <p:cNvPr id="64" name="TextBox 63"/>
+          <p:cNvPr id="60" name="TextBox 59"/>
           <p:cNvSpPr txBox="1"/>
           <p:nvPr/>
         </p:nvSpPr>
@@ -19864,7 +19710,7 @@
       </p:sp>
       <p:sp>
         <p:nvSpPr>
-          <p:cNvPr id="65" name="TextBox 64"/>
+          <p:cNvPr id="61" name="TextBox 60"/>
           <p:cNvSpPr txBox="1"/>
           <p:nvPr/>
         </p:nvSpPr>
@@ -19900,7 +19746,7 @@
       </p:sp>
       <p:cxnSp>
         <p:nvCxnSpPr>
-          <p:cNvPr id="66" name="Connector 65"/>
+          <p:cNvPr id="62" name="Connector 61"/>
           <p:cNvCxnSpPr/>
           <p:nvPr/>
         </p:nvCxnSpPr>
@@ -19936,7 +19782,7 @@
       </p:cxnSp>
       <p:sp>
         <p:nvSpPr>
-          <p:cNvPr id="67" name="Rounded Rectangle 66"/>
+          <p:cNvPr id="63" name="Rounded Rectangle 62"/>
           <p:cNvSpPr/>
           <p:nvPr/>
         </p:nvSpPr>
@@ -19984,7 +19830,7 @@
       </p:sp>
       <p:sp>
         <p:nvSpPr>
-          <p:cNvPr id="68" name="Rounded Rectangle 67"/>
+          <p:cNvPr id="64" name="Rounded Rectangle 63"/>
           <p:cNvSpPr/>
           <p:nvPr/>
         </p:nvSpPr>
@@ -20030,7 +19876,7 @@
       </p:sp>
       <p:sp>
         <p:nvSpPr>
-          <p:cNvPr id="69" name="TextBox 68"/>
+          <p:cNvPr id="65" name="TextBox 64"/>
           <p:cNvSpPr txBox="1"/>
           <p:nvPr/>
         </p:nvSpPr>
@@ -20066,7 +19912,7 @@
       </p:sp>
       <p:sp>
         <p:nvSpPr>
-          <p:cNvPr id="70" name="TextBox 69"/>
+          <p:cNvPr id="66" name="TextBox 65"/>
           <p:cNvSpPr txBox="1"/>
           <p:nvPr/>
         </p:nvSpPr>
@@ -20102,7 +19948,7 @@
       </p:sp>
       <p:sp>
         <p:nvSpPr>
-          <p:cNvPr id="71" name="TextBox 70"/>
+          <p:cNvPr id="67" name="TextBox 66"/>
           <p:cNvSpPr txBox="1"/>
           <p:nvPr/>
         </p:nvSpPr>
@@ -20138,7 +19984,7 @@
       </p:sp>
       <p:sp>
         <p:nvSpPr>
-          <p:cNvPr id="72" name="TextBox 71"/>
+          <p:cNvPr id="68" name="TextBox 67"/>
           <p:cNvSpPr txBox="1"/>
           <p:nvPr/>
         </p:nvSpPr>
@@ -20174,7 +20020,7 @@
       </p:sp>
       <p:cxnSp>
         <p:nvCxnSpPr>
-          <p:cNvPr id="73" name="Connector 72"/>
+          <p:cNvPr id="69" name="Connector 68"/>
           <p:cNvCxnSpPr/>
           <p:nvPr/>
         </p:nvCxnSpPr>
@@ -20210,7 +20056,7 @@
       </p:cxnSp>
       <p:cxnSp>
         <p:nvCxnSpPr>
-          <p:cNvPr id="74" name="Connector 73"/>
+          <p:cNvPr id="70" name="Connector 69"/>
           <p:cNvCxnSpPr/>
           <p:nvPr/>
         </p:nvCxnSpPr>
@@ -20246,7 +20092,7 @@
       </p:cxnSp>
       <p:sp>
         <p:nvSpPr>
-          <p:cNvPr id="75" name="Rounded Rectangle 74"/>
+          <p:cNvPr id="71" name="Rounded Rectangle 70"/>
           <p:cNvSpPr/>
           <p:nvPr/>
         </p:nvSpPr>
@@ -20292,7 +20138,7 @@
       </p:sp>
       <p:sp>
         <p:nvSpPr>
-          <p:cNvPr id="76" name="TextBox 75"/>
+          <p:cNvPr id="72" name="TextBox 71"/>
           <p:cNvSpPr txBox="1"/>
           <p:nvPr/>
         </p:nvSpPr>
@@ -20328,7 +20174,7 @@
       </p:sp>
       <p:cxnSp>
         <p:nvCxnSpPr>
-          <p:cNvPr id="77" name="Connector 76"/>
+          <p:cNvPr id="73" name="Connector 72"/>
           <p:cNvCxnSpPr/>
           <p:nvPr/>
         </p:nvCxnSpPr>
@@ -20364,7 +20210,7 @@
       </p:cxnSp>
       <p:sp>
         <p:nvSpPr>
-          <p:cNvPr id="78" name="Rounded Rectangle 77"/>
+          <p:cNvPr id="74" name="Rounded Rectangle 73"/>
           <p:cNvSpPr/>
           <p:nvPr/>
         </p:nvSpPr>
@@ -20412,7 +20258,7 @@
       </p:sp>
       <p:sp>
         <p:nvSpPr>
-          <p:cNvPr id="79" name="TextBox 78"/>
+          <p:cNvPr id="75" name="TextBox 74"/>
           <p:cNvSpPr txBox="1"/>
           <p:nvPr/>
         </p:nvSpPr>
@@ -20448,7 +20294,7 @@
       </p:sp>
       <p:sp>
         <p:nvSpPr>
-          <p:cNvPr id="80" name="TextBox 79"/>
+          <p:cNvPr id="76" name="TextBox 75"/>
           <p:cNvSpPr txBox="1"/>
           <p:nvPr/>
         </p:nvSpPr>

</xml_diff>

<commit_message>
Proposal: paid content person alongside volunteer digital team
Co-Authored-By: Claude Opus 5.5 <noreply@anthropic.com>
Claude-Session: https://claude.ai/code/session_01W7Er83FuNT4pLFShWidYHn
</commit_message>
<xml_diff>
--- a/presentation/out/koach-hitarvut.pptx
+++ b/presentation/out/koach-hitarvut.pptx
@@ -20216,12 +20216,12 @@
         </p:nvSpPr>
         <p:spPr>
           <a:xfrm>
-            <a:off x="4539996" y="5349240"/>
-            <a:ext cx="3108960" cy="868680"/>
+            <a:off x="3429000" y="5349240"/>
+            <a:ext cx="5330952" cy="1005840"/>
           </a:xfrm>
           <a:prstGeom prst="roundRect">
             <a:avLst>
-              <a:gd name="adj" fmla="val 8000"/>
+              <a:gd name="adj" fmla="val 6000"/>
             </a:avLst>
           </a:prstGeom>
           <a:solidFill>
@@ -20264,8 +20264,8 @@
         </p:nvSpPr>
         <p:spPr>
           <a:xfrm>
-            <a:off x="4539996" y="5422392"/>
-            <a:ext cx="3108960" cy="292608"/>
+            <a:off x="3566160" y="5404104"/>
+            <a:ext cx="5056632" cy="256032"/>
           </a:xfrm>
           <a:prstGeom prst="rect">
             <a:avLst/>
@@ -20278,30 +20278,124 @@
           </a:bodyPr>
           <a:lstStyle/>
           <a:p>
-            <a:pPr algn="ctr" rtl="1"/>
-            <a:r>
-              <a:rPr sz="1300" b="1">
+            <a:pPr algn="r" rtl="1"/>
+            <a:r>
+              <a:rPr sz="1200" b="1">
                 <a:solidFill>
                   <a:srgbClr val="1C3C7A"/>
                 </a:solidFill>
                 <a:latin typeface="Heebo"/>
                 <a:cs typeface="Heebo"/>
               </a:rPr>
-              <a:t>צוות דיגיטל · איתמר כהן</a:t>
-            </a:r>
-          </a:p>
-        </p:txBody>
-      </p:sp>
-      <p:sp>
-        <p:nvSpPr>
-          <p:cNvPr id="76" name="TextBox 75"/>
+              <a:t>דיגיטל</a:t>
+            </a:r>
+          </a:p>
+        </p:txBody>
+      </p:sp>
+      <p:sp>
+        <p:nvSpPr>
+          <p:cNvPr id="76" name="Rounded Rectangle 75"/>
+          <p:cNvSpPr/>
+          <p:nvPr/>
+        </p:nvSpPr>
+        <p:spPr>
+          <a:xfrm>
+            <a:off x="6149340" y="5696712"/>
+            <a:ext cx="2473452" cy="566928"/>
+          </a:xfrm>
+          <a:prstGeom prst="roundRect">
+            <a:avLst>
+              <a:gd name="adj" fmla="val 18000"/>
+            </a:avLst>
+          </a:prstGeom>
+          <a:solidFill>
+            <a:srgbClr val="FFFFFF"/>
+          </a:solidFill>
+          <a:ln w="25400">
+            <a:solidFill>
+              <a:srgbClr val="F0C000"/>
+            </a:solidFill>
+          </a:ln>
+          <a:effectLst/>
+        </p:spPr>
+        <p:style>
+          <a:lnRef idx="1">
+            <a:schemeClr val="accent1"/>
+          </a:lnRef>
+          <a:fillRef idx="3">
+            <a:schemeClr val="accent1"/>
+          </a:fillRef>
+          <a:effectRef idx="2">
+            <a:schemeClr val="accent1"/>
+          </a:effectRef>
+          <a:fontRef idx="minor">
+            <a:schemeClr val="lt1"/>
+          </a:fontRef>
+        </p:style>
+        <p:txBody>
+          <a:bodyPr rtlCol="0" anchor="ctr"/>
+          <a:lstStyle/>
+          <a:p>
+            <a:pPr algn="ctr"/>
+          </a:p>
+        </p:txBody>
+      </p:sp>
+      <p:sp>
+        <p:nvSpPr>
+          <p:cNvPr id="77" name="Rounded Rectangle 76"/>
+          <p:cNvSpPr/>
+          <p:nvPr/>
+        </p:nvSpPr>
+        <p:spPr>
+          <a:xfrm>
+            <a:off x="6222492" y="5586984"/>
+            <a:ext cx="502920" cy="219456"/>
+          </a:xfrm>
+          <a:prstGeom prst="roundRect">
+            <a:avLst>
+              <a:gd name="adj" fmla="val 50000"/>
+            </a:avLst>
+          </a:prstGeom>
+          <a:solidFill>
+            <a:srgbClr val="F0C000"/>
+          </a:solidFill>
+          <a:ln>
+            <a:noFill/>
+          </a:ln>
+          <a:effectLst/>
+        </p:spPr>
+        <p:style>
+          <a:lnRef idx="1">
+            <a:schemeClr val="accent1"/>
+          </a:lnRef>
+          <a:fillRef idx="3">
+            <a:schemeClr val="accent1"/>
+          </a:fillRef>
+          <a:effectRef idx="2">
+            <a:schemeClr val="accent1"/>
+          </a:effectRef>
+          <a:fontRef idx="minor">
+            <a:schemeClr val="lt1"/>
+          </a:fontRef>
+        </p:style>
+        <p:txBody>
+          <a:bodyPr rtlCol="0" anchor="ctr"/>
+          <a:lstStyle/>
+          <a:p>
+            <a:pPr algn="ctr"/>
+          </a:p>
+        </p:txBody>
+      </p:sp>
+      <p:sp>
+        <p:nvSpPr>
+          <p:cNvPr id="78" name="TextBox 77"/>
           <p:cNvSpPr txBox="1"/>
           <p:nvPr/>
         </p:nvSpPr>
         <p:spPr>
           <a:xfrm>
-            <a:off x="4539996" y="5760720"/>
-            <a:ext cx="3108960" cy="274320"/>
+            <a:off x="6222492" y="5586984"/>
+            <a:ext cx="502920" cy="219456"/>
           </a:xfrm>
           <a:prstGeom prst="rect">
             <a:avLst/>
@@ -20316,14 +20410,206 @@
           <a:p>
             <a:pPr algn="ctr" rtl="1"/>
             <a:r>
-              <a:rPr sz="1100" b="0">
-                <a:solidFill>
-                  <a:srgbClr val="1A2233"/>
+              <a:rPr sz="900" b="1">
+                <a:solidFill>
+                  <a:srgbClr val="122755"/>
                 </a:solidFill>
                 <a:latin typeface="Heebo"/>
                 <a:cs typeface="Heebo"/>
               </a:rPr>
-              <a:t>הבאת הדיונים לציבור</a:t>
+              <a:t>חדש</a:t>
+            </a:r>
+          </a:p>
+        </p:txBody>
+      </p:sp>
+      <p:sp>
+        <p:nvSpPr>
+          <p:cNvPr id="79" name="TextBox 78"/>
+          <p:cNvSpPr txBox="1"/>
+          <p:nvPr/>
+        </p:nvSpPr>
+        <p:spPr>
+          <a:xfrm>
+            <a:off x="6149340" y="5742432"/>
+            <a:ext cx="2473452" cy="274320"/>
+          </a:xfrm>
+          <a:prstGeom prst="rect">
+            <a:avLst/>
+          </a:prstGeom>
+          <a:noFill/>
+        </p:spPr>
+        <p:txBody>
+          <a:bodyPr wrap="square" anchor="ctr" lIns="36576" rIns="36576" tIns="0" bIns="0">
+            <a:spAutoFit/>
+          </a:bodyPr>
+          <a:lstStyle/>
+          <a:p>
+            <a:pPr algn="ctr" rtl="1"/>
+            <a:r>
+              <a:rPr sz="1200" b="1">
+                <a:solidFill>
+                  <a:srgbClr val="1C3C7A"/>
+                </a:solidFill>
+                <a:latin typeface="Heebo"/>
+                <a:cs typeface="Heebo"/>
+              </a:rPr>
+              <a:t>איש תוכן קבוע · בשכר</a:t>
+            </a:r>
+          </a:p>
+        </p:txBody>
+      </p:sp>
+      <p:sp>
+        <p:nvSpPr>
+          <p:cNvPr id="80" name="TextBox 79"/>
+          <p:cNvSpPr txBox="1"/>
+          <p:nvPr/>
+        </p:nvSpPr>
+        <p:spPr>
+          <a:xfrm>
+            <a:off x="6149340" y="5998464"/>
+            <a:ext cx="2473452" cy="219456"/>
+          </a:xfrm>
+          <a:prstGeom prst="rect">
+            <a:avLst/>
+          </a:prstGeom>
+          <a:noFill/>
+        </p:spPr>
+        <p:txBody>
+          <a:bodyPr wrap="square" anchor="ctr" lIns="36576" rIns="36576" tIns="0" bIns="0">
+            <a:spAutoFit/>
+          </a:bodyPr>
+          <a:lstStyle/>
+          <a:p>
+            <a:pPr algn="ctr" rtl="1"/>
+            <a:r>
+              <a:rPr sz="900" b="0">
+                <a:solidFill>
+                  <a:srgbClr val="8A94A8"/>
+                </a:solidFill>
+                <a:latin typeface="Heebo"/>
+                <a:cs typeface="Heebo"/>
+              </a:rPr>
+              <a:t>חלק מסדר היום של כח התערבות</a:t>
+            </a:r>
+          </a:p>
+        </p:txBody>
+      </p:sp>
+      <p:sp>
+        <p:nvSpPr>
+          <p:cNvPr id="81" name="Rounded Rectangle 80"/>
+          <p:cNvSpPr/>
+          <p:nvPr/>
+        </p:nvSpPr>
+        <p:spPr>
+          <a:xfrm>
+            <a:off x="3566160" y="5696712"/>
+            <a:ext cx="2473452" cy="566928"/>
+          </a:xfrm>
+          <a:prstGeom prst="roundRect">
+            <a:avLst>
+              <a:gd name="adj" fmla="val 18000"/>
+            </a:avLst>
+          </a:prstGeom>
+          <a:solidFill>
+            <a:srgbClr val="F4F6FB"/>
+          </a:solidFill>
+          <a:ln w="15875">
+            <a:solidFill>
+              <a:srgbClr val="C5CDDD"/>
+            </a:solidFill>
+          </a:ln>
+          <a:effectLst/>
+        </p:spPr>
+        <p:style>
+          <a:lnRef idx="1">
+            <a:schemeClr val="accent1"/>
+          </a:lnRef>
+          <a:fillRef idx="3">
+            <a:schemeClr val="accent1"/>
+          </a:fillRef>
+          <a:effectRef idx="2">
+            <a:schemeClr val="accent1"/>
+          </a:effectRef>
+          <a:fontRef idx="minor">
+            <a:schemeClr val="lt1"/>
+          </a:fontRef>
+        </p:style>
+        <p:txBody>
+          <a:bodyPr rtlCol="0" anchor="ctr"/>
+          <a:lstStyle/>
+          <a:p>
+            <a:pPr algn="ctr"/>
+          </a:p>
+        </p:txBody>
+      </p:sp>
+      <p:sp>
+        <p:nvSpPr>
+          <p:cNvPr id="82" name="TextBox 81"/>
+          <p:cNvSpPr txBox="1"/>
+          <p:nvPr/>
+        </p:nvSpPr>
+        <p:spPr>
+          <a:xfrm>
+            <a:off x="3566160" y="5742432"/>
+            <a:ext cx="2473452" cy="274320"/>
+          </a:xfrm>
+          <a:prstGeom prst="rect">
+            <a:avLst/>
+          </a:prstGeom>
+          <a:noFill/>
+        </p:spPr>
+        <p:txBody>
+          <a:bodyPr wrap="square" anchor="ctr" lIns="36576" rIns="36576" tIns="0" bIns="0">
+            <a:spAutoFit/>
+          </a:bodyPr>
+          <a:lstStyle/>
+          <a:p>
+            <a:pPr algn="ctr" rtl="1"/>
+            <a:r>
+              <a:rPr sz="1200" b="1">
+                <a:solidFill>
+                  <a:srgbClr val="1A2233"/>
+                </a:solidFill>
+                <a:latin typeface="Heebo"/>
+                <a:cs typeface="Heebo"/>
+              </a:rPr>
+              <a:t>צוות מתנדבים · איתמר כהן</a:t>
+            </a:r>
+          </a:p>
+        </p:txBody>
+      </p:sp>
+      <p:sp>
+        <p:nvSpPr>
+          <p:cNvPr id="83" name="TextBox 82"/>
+          <p:cNvSpPr txBox="1"/>
+          <p:nvPr/>
+        </p:nvSpPr>
+        <p:spPr>
+          <a:xfrm>
+            <a:off x="3566160" y="5998464"/>
+            <a:ext cx="2473452" cy="219456"/>
+          </a:xfrm>
+          <a:prstGeom prst="rect">
+            <a:avLst/>
+          </a:prstGeom>
+          <a:noFill/>
+        </p:spPr>
+        <p:txBody>
+          <a:bodyPr wrap="square" anchor="ctr" lIns="36576" rIns="36576" tIns="0" bIns="0">
+            <a:spAutoFit/>
+          </a:bodyPr>
+          <a:lstStyle/>
+          <a:p>
+            <a:pPr algn="ctr" rtl="1"/>
+            <a:r>
+              <a:rPr sz="900" b="0">
+                <a:solidFill>
+                  <a:srgbClr val="8A94A8"/>
+                </a:solidFill>
+                <a:latin typeface="Heebo"/>
+                <a:cs typeface="Heebo"/>
+              </a:rPr>
+              <a:t>הפקה והפצה ברשתות</a:t>
             </a:r>
           </a:p>
         </p:txBody>

</xml_diff>

<commit_message>
Proposal: content person inside core team, drop committees bar
Co-Authored-By: Claude Opus 5.5 <noreply@anthropic.com>
Claude-Session: https://claude.ai/code/session_01W7Er83FuNT4pLFShWidYHn
</commit_message>
<xml_diff>
--- a/presentation/out/koach-hitarvut.pptx
+++ b/presentation/out/koach-hitarvut.pptx
@@ -18610,7 +18610,7 @@
         <p:spPr>
           <a:xfrm>
             <a:off x="3429000" y="2103120"/>
-            <a:ext cx="5330952" cy="2057400"/>
+            <a:ext cx="5330952" cy="2606040"/>
           </a:xfrm>
           <a:prstGeom prst="roundRect">
             <a:avLst>
@@ -19350,7 +19350,127 @@
         </p:nvSpPr>
         <p:spPr>
           <a:xfrm>
-            <a:off x="6149340" y="3429000"/>
+            <a:off x="3566160" y="3337560"/>
+            <a:ext cx="5056632" cy="566928"/>
+          </a:xfrm>
+          <a:prstGeom prst="roundRect">
+            <a:avLst>
+              <a:gd name="adj" fmla="val 18000"/>
+            </a:avLst>
+          </a:prstGeom>
+          <a:solidFill>
+            <a:srgbClr val="FFFFFF"/>
+          </a:solidFill>
+          <a:ln w="25400">
+            <a:solidFill>
+              <a:srgbClr val="F0C000"/>
+            </a:solidFill>
+          </a:ln>
+          <a:effectLst/>
+        </p:spPr>
+        <p:style>
+          <a:lnRef idx="1">
+            <a:schemeClr val="accent1"/>
+          </a:lnRef>
+          <a:fillRef idx="3">
+            <a:schemeClr val="accent1"/>
+          </a:fillRef>
+          <a:effectRef idx="2">
+            <a:schemeClr val="accent1"/>
+          </a:effectRef>
+          <a:fontRef idx="minor">
+            <a:schemeClr val="lt1"/>
+          </a:fontRef>
+        </p:style>
+        <p:txBody>
+          <a:bodyPr rtlCol="0" anchor="ctr"/>
+          <a:lstStyle/>
+          <a:p>
+            <a:pPr algn="ctr"/>
+          </a:p>
+        </p:txBody>
+      </p:sp>
+      <p:sp>
+        <p:nvSpPr>
+          <p:cNvPr id="53" name="TextBox 52"/>
+          <p:cNvSpPr txBox="1"/>
+          <p:nvPr/>
+        </p:nvSpPr>
+        <p:spPr>
+          <a:xfrm>
+            <a:off x="3566160" y="3383280"/>
+            <a:ext cx="5056632" cy="274320"/>
+          </a:xfrm>
+          <a:prstGeom prst="rect">
+            <a:avLst/>
+          </a:prstGeom>
+          <a:noFill/>
+        </p:spPr>
+        <p:txBody>
+          <a:bodyPr wrap="square" anchor="ctr" lIns="36576" rIns="36576" tIns="0" bIns="0">
+            <a:spAutoFit/>
+          </a:bodyPr>
+          <a:lstStyle/>
+          <a:p>
+            <a:pPr algn="ctr" rtl="1"/>
+            <a:r>
+              <a:rPr sz="1300" b="1">
+                <a:solidFill>
+                  <a:srgbClr val="1C3C7A"/>
+                </a:solidFill>
+                <a:latin typeface="Heebo"/>
+                <a:cs typeface="Heebo"/>
+              </a:rPr>
+              <a:t>איש תוכן קבוע</a:t>
+            </a:r>
+          </a:p>
+        </p:txBody>
+      </p:sp>
+      <p:sp>
+        <p:nvSpPr>
+          <p:cNvPr id="54" name="TextBox 53"/>
+          <p:cNvSpPr txBox="1"/>
+          <p:nvPr/>
+        </p:nvSpPr>
+        <p:spPr>
+          <a:xfrm>
+            <a:off x="3566160" y="3648456"/>
+            <a:ext cx="5056632" cy="219456"/>
+          </a:xfrm>
+          <a:prstGeom prst="rect">
+            <a:avLst/>
+          </a:prstGeom>
+          <a:noFill/>
+        </p:spPr>
+        <p:txBody>
+          <a:bodyPr wrap="square" anchor="ctr" lIns="36576" rIns="36576" tIns="0" bIns="0">
+            <a:spAutoFit/>
+          </a:bodyPr>
+          <a:lstStyle/>
+          <a:p>
+            <a:pPr algn="ctr" rtl="1"/>
+            <a:r>
+              <a:rPr sz="1000" b="0">
+                <a:solidFill>
+                  <a:srgbClr val="8A94A8"/>
+                </a:solidFill>
+                <a:latin typeface="Heebo"/>
+                <a:cs typeface="Heebo"/>
+              </a:rPr>
+              <a:t>חלק אינטגרלי מהצוות · מלווה את הנציגים ומפיק תוכן מהכנסת בזמן אמת</a:t>
+            </a:r>
+          </a:p>
+        </p:txBody>
+      </p:sp>
+      <p:sp>
+        <p:nvSpPr>
+          <p:cNvPr id="55" name="Rounded Rectangle 54"/>
+          <p:cNvSpPr/>
+          <p:nvPr/>
+        </p:nvSpPr>
+        <p:spPr>
+          <a:xfrm>
+            <a:off x="6149340" y="4023360"/>
             <a:ext cx="2473452" cy="548640"/>
           </a:xfrm>
           <a:prstGeom prst="roundRect">
@@ -19390,13 +19510,13 @@
       </p:sp>
       <p:sp>
         <p:nvSpPr>
-          <p:cNvPr id="53" name="TextBox 52"/>
+          <p:cNvPr id="56" name="TextBox 55"/>
           <p:cNvSpPr txBox="1"/>
           <p:nvPr/>
         </p:nvSpPr>
         <p:spPr>
           <a:xfrm>
-            <a:off x="6149340" y="3429000"/>
+            <a:off x="6149340" y="4023360"/>
             <a:ext cx="2473452" cy="548640"/>
           </a:xfrm>
           <a:prstGeom prst="rect">
@@ -19426,13 +19546,13 @@
       </p:sp>
       <p:sp>
         <p:nvSpPr>
-          <p:cNvPr id="54" name="Rounded Rectangle 53"/>
-          <p:cNvSpPr/>
-          <p:nvPr/>
-        </p:nvSpPr>
-        <p:spPr>
-          <a:xfrm>
-            <a:off x="3566160" y="3429000"/>
+          <p:cNvPr id="57" name="Rounded Rectangle 56"/>
+          <p:cNvSpPr/>
+          <p:nvPr/>
+        </p:nvSpPr>
+        <p:spPr>
+          <a:xfrm>
+            <a:off x="3566160" y="4023360"/>
             <a:ext cx="2473452" cy="548640"/>
           </a:xfrm>
           <a:prstGeom prst="roundRect">
@@ -19472,13 +19592,13 @@
       </p:sp>
       <p:sp>
         <p:nvSpPr>
-          <p:cNvPr id="55" name="TextBox 54"/>
+          <p:cNvPr id="58" name="TextBox 57"/>
           <p:cNvSpPr txBox="1"/>
           <p:nvPr/>
         </p:nvSpPr>
         <p:spPr>
           <a:xfrm>
-            <a:off x="3566160" y="3429000"/>
+            <a:off x="3566160" y="4023360"/>
             <a:ext cx="2473452" cy="548640"/>
           </a:xfrm>
           <a:prstGeom prst="rect">
@@ -19508,7 +19628,7 @@
       </p:sp>
       <p:sp>
         <p:nvSpPr>
-          <p:cNvPr id="56" name="Rounded Rectangle 55"/>
+          <p:cNvPr id="59" name="Rounded Rectangle 58"/>
           <p:cNvSpPr/>
           <p:nvPr/>
         </p:nvSpPr>
@@ -19556,7 +19676,7 @@
       </p:sp>
       <p:sp>
         <p:nvSpPr>
-          <p:cNvPr id="57" name="Rounded Rectangle 56"/>
+          <p:cNvPr id="60" name="Rounded Rectangle 59"/>
           <p:cNvSpPr/>
           <p:nvPr/>
         </p:nvSpPr>
@@ -19602,7 +19722,7 @@
       </p:sp>
       <p:sp>
         <p:nvSpPr>
-          <p:cNvPr id="58" name="TextBox 57"/>
+          <p:cNvPr id="61" name="TextBox 60"/>
           <p:cNvSpPr txBox="1"/>
           <p:nvPr/>
         </p:nvSpPr>
@@ -19638,7 +19758,7 @@
       </p:sp>
       <p:sp>
         <p:nvSpPr>
-          <p:cNvPr id="59" name="TextBox 58"/>
+          <p:cNvPr id="62" name="TextBox 61"/>
           <p:cNvSpPr txBox="1"/>
           <p:nvPr/>
         </p:nvSpPr>
@@ -19674,7 +19794,7 @@
       </p:sp>
       <p:sp>
         <p:nvSpPr>
-          <p:cNvPr id="60" name="TextBox 59"/>
+          <p:cNvPr id="63" name="TextBox 62"/>
           <p:cNvSpPr txBox="1"/>
           <p:nvPr/>
         </p:nvSpPr>
@@ -19710,7 +19830,7 @@
       </p:sp>
       <p:sp>
         <p:nvSpPr>
-          <p:cNvPr id="61" name="TextBox 60"/>
+          <p:cNvPr id="64" name="TextBox 63"/>
           <p:cNvSpPr txBox="1"/>
           <p:nvPr/>
         </p:nvSpPr>
@@ -19746,7 +19866,7 @@
       </p:sp>
       <p:cxnSp>
         <p:nvCxnSpPr>
-          <p:cNvPr id="62" name="Connector 61"/>
+          <p:cNvPr id="65" name="Connector 64"/>
           <p:cNvCxnSpPr/>
           <p:nvPr/>
         </p:nvCxnSpPr>
@@ -19782,7 +19902,7 @@
       </p:cxnSp>
       <p:sp>
         <p:nvSpPr>
-          <p:cNvPr id="63" name="Rounded Rectangle 62"/>
+          <p:cNvPr id="66" name="Rounded Rectangle 65"/>
           <p:cNvSpPr/>
           <p:nvPr/>
         </p:nvSpPr>
@@ -19830,7 +19950,7 @@
       </p:sp>
       <p:sp>
         <p:nvSpPr>
-          <p:cNvPr id="64" name="Rounded Rectangle 63"/>
+          <p:cNvPr id="67" name="Rounded Rectangle 66"/>
           <p:cNvSpPr/>
           <p:nvPr/>
         </p:nvSpPr>
@@ -19876,7 +19996,7 @@
       </p:sp>
       <p:sp>
         <p:nvSpPr>
-          <p:cNvPr id="65" name="TextBox 64"/>
+          <p:cNvPr id="68" name="TextBox 67"/>
           <p:cNvSpPr txBox="1"/>
           <p:nvPr/>
         </p:nvSpPr>
@@ -19912,7 +20032,7 @@
       </p:sp>
       <p:sp>
         <p:nvSpPr>
-          <p:cNvPr id="66" name="TextBox 65"/>
+          <p:cNvPr id="69" name="TextBox 68"/>
           <p:cNvSpPr txBox="1"/>
           <p:nvPr/>
         </p:nvSpPr>
@@ -19948,7 +20068,7 @@
       </p:sp>
       <p:sp>
         <p:nvSpPr>
-          <p:cNvPr id="67" name="TextBox 66"/>
+          <p:cNvPr id="70" name="TextBox 69"/>
           <p:cNvSpPr txBox="1"/>
           <p:nvPr/>
         </p:nvSpPr>
@@ -19984,7 +20104,7 @@
       </p:sp>
       <p:sp>
         <p:nvSpPr>
-          <p:cNvPr id="68" name="TextBox 67"/>
+          <p:cNvPr id="71" name="TextBox 70"/>
           <p:cNvSpPr txBox="1"/>
           <p:nvPr/>
         </p:nvSpPr>
@@ -20020,7 +20140,7 @@
       </p:sp>
       <p:cxnSp>
         <p:nvCxnSpPr>
-          <p:cNvPr id="69" name="Connector 68"/>
+          <p:cNvPr id="72" name="Connector 71"/>
           <p:cNvCxnSpPr/>
           <p:nvPr/>
         </p:nvCxnSpPr>
@@ -20056,14 +20176,14 @@
       </p:cxnSp>
       <p:cxnSp>
         <p:nvCxnSpPr>
-          <p:cNvPr id="70" name="Connector 69"/>
+          <p:cNvPr id="73" name="Connector 72"/>
           <p:cNvCxnSpPr/>
           <p:nvPr/>
         </p:nvCxnSpPr>
         <p:spPr>
           <a:xfrm>
-            <a:off x="6094476" y="4160520"/>
-            <a:ext cx="0" cy="365760"/>
+            <a:off x="6094476" y="4709160"/>
+            <a:ext cx="0" cy="320040"/>
           </a:xfrm>
           <a:prstGeom prst="line">
             <a:avLst/>
@@ -20092,136 +20212,18 @@
       </p:cxnSp>
       <p:sp>
         <p:nvSpPr>
-          <p:cNvPr id="71" name="Rounded Rectangle 70"/>
-          <p:cNvSpPr/>
-          <p:nvPr/>
-        </p:nvSpPr>
-        <p:spPr>
-          <a:xfrm>
-            <a:off x="3429000" y="4526280"/>
-            <a:ext cx="5330952" cy="566928"/>
+          <p:cNvPr id="74" name="Rounded Rectangle 73"/>
+          <p:cNvSpPr/>
+          <p:nvPr/>
+        </p:nvSpPr>
+        <p:spPr>
+          <a:xfrm>
+            <a:off x="4174236" y="5029200"/>
+            <a:ext cx="3840480" cy="731520"/>
           </a:xfrm>
           <a:prstGeom prst="roundRect">
             <a:avLst>
-              <a:gd name="adj" fmla="val 20000"/>
-            </a:avLst>
-          </a:prstGeom>
-          <a:solidFill>
-            <a:srgbClr val="F0C000"/>
-          </a:solidFill>
-          <a:ln>
-            <a:noFill/>
-          </a:ln>
-          <a:effectLst/>
-        </p:spPr>
-        <p:style>
-          <a:lnRef idx="1">
-            <a:schemeClr val="accent1"/>
-          </a:lnRef>
-          <a:fillRef idx="3">
-            <a:schemeClr val="accent1"/>
-          </a:fillRef>
-          <a:effectRef idx="2">
-            <a:schemeClr val="accent1"/>
-          </a:effectRef>
-          <a:fontRef idx="minor">
-            <a:schemeClr val="lt1"/>
-          </a:fontRef>
-        </p:style>
-        <p:txBody>
-          <a:bodyPr rtlCol="0" anchor="ctr"/>
-          <a:lstStyle/>
-          <a:p>
-            <a:pPr algn="ctr"/>
-          </a:p>
-        </p:txBody>
-      </p:sp>
-      <p:sp>
-        <p:nvSpPr>
-          <p:cNvPr id="72" name="TextBox 71"/>
-          <p:cNvSpPr txBox="1"/>
-          <p:nvPr/>
-        </p:nvSpPr>
-        <p:spPr>
-          <a:xfrm>
-            <a:off x="3429000" y="4526280"/>
-            <a:ext cx="5330952" cy="566928"/>
-          </a:xfrm>
-          <a:prstGeom prst="rect">
-            <a:avLst/>
-          </a:prstGeom>
-          <a:noFill/>
-        </p:spPr>
-        <p:txBody>
-          <a:bodyPr wrap="square" anchor="ctr" lIns="36576" rIns="36576" tIns="0" bIns="0">
-            <a:spAutoFit/>
-          </a:bodyPr>
-          <a:lstStyle/>
-          <a:p>
-            <a:pPr algn="ctr" rtl="1"/>
-            <a:r>
-              <a:rPr sz="1600" b="1">
-                <a:solidFill>
-                  <a:srgbClr val="122755"/>
-                </a:solidFill>
-                <a:latin typeface="Heebo"/>
-                <a:cs typeface="Heebo"/>
-              </a:rPr>
-              <a:t>דיונים בוועדות הכנסת · פגישות עם חברי כנסת</a:t>
-            </a:r>
-          </a:p>
-        </p:txBody>
-      </p:sp>
-      <p:cxnSp>
-        <p:nvCxnSpPr>
-          <p:cNvPr id="73" name="Connector 72"/>
-          <p:cNvCxnSpPr/>
-          <p:nvPr/>
-        </p:nvCxnSpPr>
-        <p:spPr>
-          <a:xfrm>
-            <a:off x="6094476" y="5093208"/>
-            <a:ext cx="0" cy="256032"/>
-          </a:xfrm>
-          <a:prstGeom prst="line">
-            <a:avLst/>
-          </a:prstGeom>
-          <a:ln w="25400">
-            <a:solidFill>
-              <a:srgbClr val="1C3C7A"/>
-            </a:solidFill>
-            <a:tailEnd type="triangle" w="med" len="med"/>
-          </a:ln>
-        </p:spPr>
-        <p:style>
-          <a:lnRef idx="2">
-            <a:schemeClr val="accent1"/>
-          </a:lnRef>
-          <a:fillRef idx="0">
-            <a:schemeClr val="accent1"/>
-          </a:fillRef>
-          <a:effectRef idx="1">
-            <a:schemeClr val="accent1"/>
-          </a:effectRef>
-          <a:fontRef idx="minor">
-            <a:schemeClr val="tx1"/>
-          </a:fontRef>
-        </p:style>
-      </p:cxnSp>
-      <p:sp>
-        <p:nvSpPr>
-          <p:cNvPr id="74" name="Rounded Rectangle 73"/>
-          <p:cNvSpPr/>
-          <p:nvPr/>
-        </p:nvSpPr>
-        <p:spPr>
-          <a:xfrm>
-            <a:off x="3429000" y="5349240"/>
-            <a:ext cx="5330952" cy="1005840"/>
-          </a:xfrm>
-          <a:prstGeom prst="roundRect">
-            <a:avLst>
-              <a:gd name="adj" fmla="val 6000"/>
+              <a:gd name="adj" fmla="val 8000"/>
             </a:avLst>
           </a:prstGeom>
           <a:solidFill>
@@ -20264,8 +20266,8 @@
         </p:nvSpPr>
         <p:spPr>
           <a:xfrm>
-            <a:off x="3566160" y="5404104"/>
-            <a:ext cx="5056632" cy="256032"/>
+            <a:off x="4174236" y="5102352"/>
+            <a:ext cx="3840480" cy="292608"/>
           </a:xfrm>
           <a:prstGeom prst="rect">
             <a:avLst/>
@@ -20278,124 +20280,30 @@
           </a:bodyPr>
           <a:lstStyle/>
           <a:p>
-            <a:pPr algn="r" rtl="1"/>
-            <a:r>
-              <a:rPr sz="1200" b="1">
+            <a:pPr algn="ctr" rtl="1"/>
+            <a:r>
+              <a:rPr sz="1300" b="1">
                 <a:solidFill>
                   <a:srgbClr val="1C3C7A"/>
                 </a:solidFill>
                 <a:latin typeface="Heebo"/>
                 <a:cs typeface="Heebo"/>
               </a:rPr>
-              <a:t>דיגיטל</a:t>
-            </a:r>
-          </a:p>
-        </p:txBody>
-      </p:sp>
-      <p:sp>
-        <p:nvSpPr>
-          <p:cNvPr id="76" name="Rounded Rectangle 75"/>
-          <p:cNvSpPr/>
-          <p:nvPr/>
-        </p:nvSpPr>
-        <p:spPr>
-          <a:xfrm>
-            <a:off x="6149340" y="5696712"/>
-            <a:ext cx="2473452" cy="566928"/>
-          </a:xfrm>
-          <a:prstGeom prst="roundRect">
-            <a:avLst>
-              <a:gd name="adj" fmla="val 18000"/>
-            </a:avLst>
-          </a:prstGeom>
-          <a:solidFill>
-            <a:srgbClr val="FFFFFF"/>
-          </a:solidFill>
-          <a:ln w="25400">
-            <a:solidFill>
-              <a:srgbClr val="F0C000"/>
-            </a:solidFill>
-          </a:ln>
-          <a:effectLst/>
-        </p:spPr>
-        <p:style>
-          <a:lnRef idx="1">
-            <a:schemeClr val="accent1"/>
-          </a:lnRef>
-          <a:fillRef idx="3">
-            <a:schemeClr val="accent1"/>
-          </a:fillRef>
-          <a:effectRef idx="2">
-            <a:schemeClr val="accent1"/>
-          </a:effectRef>
-          <a:fontRef idx="minor">
-            <a:schemeClr val="lt1"/>
-          </a:fontRef>
-        </p:style>
-        <p:txBody>
-          <a:bodyPr rtlCol="0" anchor="ctr"/>
-          <a:lstStyle/>
-          <a:p>
-            <a:pPr algn="ctr"/>
-          </a:p>
-        </p:txBody>
-      </p:sp>
-      <p:sp>
-        <p:nvSpPr>
-          <p:cNvPr id="77" name="Rounded Rectangle 76"/>
-          <p:cNvSpPr/>
-          <p:nvPr/>
-        </p:nvSpPr>
-        <p:spPr>
-          <a:xfrm>
-            <a:off x="6222492" y="5586984"/>
-            <a:ext cx="502920" cy="219456"/>
-          </a:xfrm>
-          <a:prstGeom prst="roundRect">
-            <a:avLst>
-              <a:gd name="adj" fmla="val 50000"/>
-            </a:avLst>
-          </a:prstGeom>
-          <a:solidFill>
-            <a:srgbClr val="F0C000"/>
-          </a:solidFill>
-          <a:ln>
-            <a:noFill/>
-          </a:ln>
-          <a:effectLst/>
-        </p:spPr>
-        <p:style>
-          <a:lnRef idx="1">
-            <a:schemeClr val="accent1"/>
-          </a:lnRef>
-          <a:fillRef idx="3">
-            <a:schemeClr val="accent1"/>
-          </a:fillRef>
-          <a:effectRef idx="2">
-            <a:schemeClr val="accent1"/>
-          </a:effectRef>
-          <a:fontRef idx="minor">
-            <a:schemeClr val="lt1"/>
-          </a:fontRef>
-        </p:style>
-        <p:txBody>
-          <a:bodyPr rtlCol="0" anchor="ctr"/>
-          <a:lstStyle/>
-          <a:p>
-            <a:pPr algn="ctr"/>
-          </a:p>
-        </p:txBody>
-      </p:sp>
-      <p:sp>
-        <p:nvSpPr>
-          <p:cNvPr id="78" name="TextBox 77"/>
+              <a:t>צוות דיגיטל · מתנדבים · איתמר כהן</a:t>
+            </a:r>
+          </a:p>
+        </p:txBody>
+      </p:sp>
+      <p:sp>
+        <p:nvSpPr>
+          <p:cNvPr id="76" name="TextBox 75"/>
           <p:cNvSpPr txBox="1"/>
           <p:nvPr/>
         </p:nvSpPr>
         <p:spPr>
           <a:xfrm>
-            <a:off x="6222492" y="5586984"/>
-            <a:ext cx="502920" cy="219456"/>
+            <a:off x="4174236" y="5431536"/>
+            <a:ext cx="3840480" cy="256032"/>
           </a:xfrm>
           <a:prstGeom prst="rect">
             <a:avLst/>
@@ -20410,206 +20318,14 @@
           <a:p>
             <a:pPr algn="ctr" rtl="1"/>
             <a:r>
-              <a:rPr sz="900" b="1">
-                <a:solidFill>
-                  <a:srgbClr val="122755"/>
+              <a:rPr sz="1100" b="0">
+                <a:solidFill>
+                  <a:srgbClr val="1A2233"/>
                 </a:solidFill>
                 <a:latin typeface="Heebo"/>
                 <a:cs typeface="Heebo"/>
               </a:rPr>
-              <a:t>חדש</a:t>
-            </a:r>
-          </a:p>
-        </p:txBody>
-      </p:sp>
-      <p:sp>
-        <p:nvSpPr>
-          <p:cNvPr id="79" name="TextBox 78"/>
-          <p:cNvSpPr txBox="1"/>
-          <p:nvPr/>
-        </p:nvSpPr>
-        <p:spPr>
-          <a:xfrm>
-            <a:off x="6149340" y="5742432"/>
-            <a:ext cx="2473452" cy="274320"/>
-          </a:xfrm>
-          <a:prstGeom prst="rect">
-            <a:avLst/>
-          </a:prstGeom>
-          <a:noFill/>
-        </p:spPr>
-        <p:txBody>
-          <a:bodyPr wrap="square" anchor="ctr" lIns="36576" rIns="36576" tIns="0" bIns="0">
-            <a:spAutoFit/>
-          </a:bodyPr>
-          <a:lstStyle/>
-          <a:p>
-            <a:pPr algn="ctr" rtl="1"/>
-            <a:r>
-              <a:rPr sz="1200" b="1">
-                <a:solidFill>
-                  <a:srgbClr val="1C3C7A"/>
-                </a:solidFill>
-                <a:latin typeface="Heebo"/>
-                <a:cs typeface="Heebo"/>
-              </a:rPr>
-              <a:t>איש תוכן קבוע · בשכר</a:t>
-            </a:r>
-          </a:p>
-        </p:txBody>
-      </p:sp>
-      <p:sp>
-        <p:nvSpPr>
-          <p:cNvPr id="80" name="TextBox 79"/>
-          <p:cNvSpPr txBox="1"/>
-          <p:nvPr/>
-        </p:nvSpPr>
-        <p:spPr>
-          <a:xfrm>
-            <a:off x="6149340" y="5998464"/>
-            <a:ext cx="2473452" cy="219456"/>
-          </a:xfrm>
-          <a:prstGeom prst="rect">
-            <a:avLst/>
-          </a:prstGeom>
-          <a:noFill/>
-        </p:spPr>
-        <p:txBody>
-          <a:bodyPr wrap="square" anchor="ctr" lIns="36576" rIns="36576" tIns="0" bIns="0">
-            <a:spAutoFit/>
-          </a:bodyPr>
-          <a:lstStyle/>
-          <a:p>
-            <a:pPr algn="ctr" rtl="1"/>
-            <a:r>
-              <a:rPr sz="900" b="0">
-                <a:solidFill>
-                  <a:srgbClr val="8A94A8"/>
-                </a:solidFill>
-                <a:latin typeface="Heebo"/>
-                <a:cs typeface="Heebo"/>
-              </a:rPr>
-              <a:t>חלק מסדר היום של כח התערבות</a:t>
-            </a:r>
-          </a:p>
-        </p:txBody>
-      </p:sp>
-      <p:sp>
-        <p:nvSpPr>
-          <p:cNvPr id="81" name="Rounded Rectangle 80"/>
-          <p:cNvSpPr/>
-          <p:nvPr/>
-        </p:nvSpPr>
-        <p:spPr>
-          <a:xfrm>
-            <a:off x="3566160" y="5696712"/>
-            <a:ext cx="2473452" cy="566928"/>
-          </a:xfrm>
-          <a:prstGeom prst="roundRect">
-            <a:avLst>
-              <a:gd name="adj" fmla="val 18000"/>
-            </a:avLst>
-          </a:prstGeom>
-          <a:solidFill>
-            <a:srgbClr val="F4F6FB"/>
-          </a:solidFill>
-          <a:ln w="15875">
-            <a:solidFill>
-              <a:srgbClr val="C5CDDD"/>
-            </a:solidFill>
-          </a:ln>
-          <a:effectLst/>
-        </p:spPr>
-        <p:style>
-          <a:lnRef idx="1">
-            <a:schemeClr val="accent1"/>
-          </a:lnRef>
-          <a:fillRef idx="3">
-            <a:schemeClr val="accent1"/>
-          </a:fillRef>
-          <a:effectRef idx="2">
-            <a:schemeClr val="accent1"/>
-          </a:effectRef>
-          <a:fontRef idx="minor">
-            <a:schemeClr val="lt1"/>
-          </a:fontRef>
-        </p:style>
-        <p:txBody>
-          <a:bodyPr rtlCol="0" anchor="ctr"/>
-          <a:lstStyle/>
-          <a:p>
-            <a:pPr algn="ctr"/>
-          </a:p>
-        </p:txBody>
-      </p:sp>
-      <p:sp>
-        <p:nvSpPr>
-          <p:cNvPr id="82" name="TextBox 81"/>
-          <p:cNvSpPr txBox="1"/>
-          <p:nvPr/>
-        </p:nvSpPr>
-        <p:spPr>
-          <a:xfrm>
-            <a:off x="3566160" y="5742432"/>
-            <a:ext cx="2473452" cy="274320"/>
-          </a:xfrm>
-          <a:prstGeom prst="rect">
-            <a:avLst/>
-          </a:prstGeom>
-          <a:noFill/>
-        </p:spPr>
-        <p:txBody>
-          <a:bodyPr wrap="square" anchor="ctr" lIns="36576" rIns="36576" tIns="0" bIns="0">
-            <a:spAutoFit/>
-          </a:bodyPr>
-          <a:lstStyle/>
-          <a:p>
-            <a:pPr algn="ctr" rtl="1"/>
-            <a:r>
-              <a:rPr sz="1200" b="1">
-                <a:solidFill>
-                  <a:srgbClr val="1A2233"/>
-                </a:solidFill>
-                <a:latin typeface="Heebo"/>
-                <a:cs typeface="Heebo"/>
-              </a:rPr>
-              <a:t>צוות מתנדבים · איתמר כהן</a:t>
-            </a:r>
-          </a:p>
-        </p:txBody>
-      </p:sp>
-      <p:sp>
-        <p:nvSpPr>
-          <p:cNvPr id="83" name="TextBox 82"/>
-          <p:cNvSpPr txBox="1"/>
-          <p:nvPr/>
-        </p:nvSpPr>
-        <p:spPr>
-          <a:xfrm>
-            <a:off x="3566160" y="5998464"/>
-            <a:ext cx="2473452" cy="219456"/>
-          </a:xfrm>
-          <a:prstGeom prst="rect">
-            <a:avLst/>
-          </a:prstGeom>
-          <a:noFill/>
-        </p:spPr>
-        <p:txBody>
-          <a:bodyPr wrap="square" anchor="ctr" lIns="36576" rIns="36576" tIns="0" bIns="0">
-            <a:spAutoFit/>
-          </a:bodyPr>
-          <a:lstStyle/>
-          <a:p>
-            <a:pPr algn="ctr" rtl="1"/>
-            <a:r>
-              <a:rPr sz="900" b="0">
-                <a:solidFill>
-                  <a:srgbClr val="8A94A8"/>
-                </a:solidFill>
-                <a:latin typeface="Heebo"/>
-                <a:cs typeface="Heebo"/>
-              </a:rPr>
-              <a:t>הפקה והפצה ברשתות</a:t>
+              <a:t>הפקה והפצה ברשתות של התוכן מהכנסת</a:t>
             </a:r>
           </a:p>
         </p:txBody>

</xml_diff>

<commit_message>
Proposal: remove 'new' badges
Co-Authored-By: Claude Opus 5.5 <noreply@anthropic.com>
Claude-Session: https://claude.ai/code/session_01W7Er83FuNT4pLFShWidYHn
</commit_message>
<xml_diff>
--- a/presentation/out/koach-hitarvut.pptx
+++ b/presentation/out/koach-hitarvut.pptx
@@ -18651,89 +18651,7 @@
       </p:sp>
       <p:sp>
         <p:nvSpPr>
-          <p:cNvPr id="35" name="Rounded Rectangle 34"/>
-          <p:cNvSpPr/>
-          <p:nvPr/>
-        </p:nvSpPr>
-        <p:spPr>
-          <a:xfrm>
-            <a:off x="3538728" y="1993392"/>
-            <a:ext cx="502920" cy="219456"/>
-          </a:xfrm>
-          <a:prstGeom prst="roundRect">
-            <a:avLst>
-              <a:gd name="adj" fmla="val 50000"/>
-            </a:avLst>
-          </a:prstGeom>
-          <a:solidFill>
-            <a:srgbClr val="F0C000"/>
-          </a:solidFill>
-          <a:ln>
-            <a:noFill/>
-          </a:ln>
-          <a:effectLst/>
-        </p:spPr>
-        <p:style>
-          <a:lnRef idx="1">
-            <a:schemeClr val="accent1"/>
-          </a:lnRef>
-          <a:fillRef idx="3">
-            <a:schemeClr val="accent1"/>
-          </a:fillRef>
-          <a:effectRef idx="2">
-            <a:schemeClr val="accent1"/>
-          </a:effectRef>
-          <a:fontRef idx="minor">
-            <a:schemeClr val="lt1"/>
-          </a:fontRef>
-        </p:style>
-        <p:txBody>
-          <a:bodyPr rtlCol="0" anchor="ctr"/>
-          <a:lstStyle/>
-          <a:p>
-            <a:pPr algn="ctr"/>
-          </a:p>
-        </p:txBody>
-      </p:sp>
-      <p:sp>
-        <p:nvSpPr>
-          <p:cNvPr id="36" name="TextBox 35"/>
-          <p:cNvSpPr txBox="1"/>
-          <p:nvPr/>
-        </p:nvSpPr>
-        <p:spPr>
-          <a:xfrm>
-            <a:off x="3538728" y="1993392"/>
-            <a:ext cx="502920" cy="219456"/>
-          </a:xfrm>
-          <a:prstGeom prst="rect">
-            <a:avLst/>
-          </a:prstGeom>
-          <a:noFill/>
-        </p:spPr>
-        <p:txBody>
-          <a:bodyPr wrap="square" anchor="ctr" lIns="36576" rIns="36576" tIns="0" bIns="0">
-            <a:spAutoFit/>
-          </a:bodyPr>
-          <a:lstStyle/>
-          <a:p>
-            <a:pPr algn="ctr" rtl="1"/>
-            <a:r>
-              <a:rPr sz="900" b="1">
-                <a:solidFill>
-                  <a:srgbClr val="122755"/>
-                </a:solidFill>
-                <a:latin typeface="Heebo"/>
-                <a:cs typeface="Heebo"/>
-              </a:rPr>
-              <a:t>חדש</a:t>
-            </a:r>
-          </a:p>
-        </p:txBody>
-      </p:sp>
-      <p:sp>
-        <p:nvSpPr>
-          <p:cNvPr id="37" name="TextBox 36"/>
+          <p:cNvPr id="35" name="TextBox 34"/>
           <p:cNvSpPr txBox="1"/>
           <p:nvPr/>
         </p:nvSpPr>
@@ -18769,7 +18687,7 @@
       </p:sp>
       <p:sp>
         <p:nvSpPr>
-          <p:cNvPr id="38" name="Rounded Rectangle 37"/>
+          <p:cNvPr id="36" name="Rounded Rectangle 35"/>
           <p:cNvSpPr/>
           <p:nvPr/>
         </p:nvSpPr>
@@ -18817,7 +18735,7 @@
       </p:sp>
       <p:sp>
         <p:nvSpPr>
-          <p:cNvPr id="39" name="Rectangle 38"/>
+          <p:cNvPr id="37" name="Rectangle 36"/>
           <p:cNvSpPr/>
           <p:nvPr/>
         </p:nvSpPr>
@@ -18861,7 +18779,7 @@
       </p:sp>
       <p:sp>
         <p:nvSpPr>
-          <p:cNvPr id="40" name="TextBox 39"/>
+          <p:cNvPr id="38" name="TextBox 37"/>
           <p:cNvSpPr txBox="1"/>
           <p:nvPr/>
         </p:nvSpPr>
@@ -18897,7 +18815,7 @@
       </p:sp>
       <p:sp>
         <p:nvSpPr>
-          <p:cNvPr id="41" name="TextBox 40"/>
+          <p:cNvPr id="39" name="TextBox 38"/>
           <p:cNvSpPr txBox="1"/>
           <p:nvPr/>
         </p:nvSpPr>
@@ -18933,7 +18851,7 @@
       </p:sp>
       <p:sp>
         <p:nvSpPr>
-          <p:cNvPr id="42" name="Rounded Rectangle 41"/>
+          <p:cNvPr id="40" name="Rounded Rectangle 39"/>
           <p:cNvSpPr/>
           <p:nvPr/>
         </p:nvSpPr>
@@ -18981,7 +18899,7 @@
       </p:sp>
       <p:sp>
         <p:nvSpPr>
-          <p:cNvPr id="43" name="Rectangle 42"/>
+          <p:cNvPr id="41" name="Rectangle 40"/>
           <p:cNvSpPr/>
           <p:nvPr/>
         </p:nvSpPr>
@@ -19025,7 +18943,7 @@
       </p:sp>
       <p:sp>
         <p:nvSpPr>
-          <p:cNvPr id="44" name="TextBox 43"/>
+          <p:cNvPr id="42" name="TextBox 41"/>
           <p:cNvSpPr txBox="1"/>
           <p:nvPr/>
         </p:nvSpPr>
@@ -19061,7 +18979,7 @@
       </p:sp>
       <p:sp>
         <p:nvSpPr>
-          <p:cNvPr id="45" name="TextBox 44"/>
+          <p:cNvPr id="43" name="TextBox 42"/>
           <p:cNvSpPr txBox="1"/>
           <p:nvPr/>
         </p:nvSpPr>
@@ -19097,7 +19015,7 @@
       </p:sp>
       <p:sp>
         <p:nvSpPr>
-          <p:cNvPr id="46" name="Rounded Rectangle 45"/>
+          <p:cNvPr id="44" name="Rounded Rectangle 43"/>
           <p:cNvSpPr/>
           <p:nvPr/>
         </p:nvSpPr>
@@ -19145,7 +19063,7 @@
       </p:sp>
       <p:sp>
         <p:nvSpPr>
-          <p:cNvPr id="47" name="Rectangle 46"/>
+          <p:cNvPr id="45" name="Rectangle 44"/>
           <p:cNvSpPr/>
           <p:nvPr/>
         </p:nvSpPr>
@@ -19189,7 +19107,7 @@
       </p:sp>
       <p:sp>
         <p:nvSpPr>
-          <p:cNvPr id="48" name="TextBox 47"/>
+          <p:cNvPr id="46" name="TextBox 45"/>
           <p:cNvSpPr txBox="1"/>
           <p:nvPr/>
         </p:nvSpPr>
@@ -19225,7 +19143,7 @@
       </p:sp>
       <p:sp>
         <p:nvSpPr>
-          <p:cNvPr id="49" name="TextBox 48"/>
+          <p:cNvPr id="47" name="TextBox 46"/>
           <p:cNvSpPr txBox="1"/>
           <p:nvPr/>
         </p:nvSpPr>
@@ -19261,7 +19179,7 @@
       </p:sp>
       <p:sp>
         <p:nvSpPr>
-          <p:cNvPr id="50" name="Rounded Rectangle 49"/>
+          <p:cNvPr id="48" name="Rounded Rectangle 47"/>
           <p:cNvSpPr/>
           <p:nvPr/>
         </p:nvSpPr>
@@ -19308,7 +19226,7 @@
       </p:sp>
       <p:sp>
         <p:nvSpPr>
-          <p:cNvPr id="51" name="TextBox 50"/>
+          <p:cNvPr id="49" name="TextBox 48"/>
           <p:cNvSpPr txBox="1"/>
           <p:nvPr/>
         </p:nvSpPr>
@@ -19344,7 +19262,7 @@
       </p:sp>
       <p:sp>
         <p:nvSpPr>
-          <p:cNvPr id="52" name="Rounded Rectangle 51"/>
+          <p:cNvPr id="50" name="Rounded Rectangle 49"/>
           <p:cNvSpPr/>
           <p:nvPr/>
         </p:nvSpPr>
@@ -19392,7 +19310,7 @@
       </p:sp>
       <p:sp>
         <p:nvSpPr>
-          <p:cNvPr id="53" name="TextBox 52"/>
+          <p:cNvPr id="51" name="TextBox 50"/>
           <p:cNvSpPr txBox="1"/>
           <p:nvPr/>
         </p:nvSpPr>
@@ -19428,7 +19346,7 @@
       </p:sp>
       <p:sp>
         <p:nvSpPr>
-          <p:cNvPr id="54" name="TextBox 53"/>
+          <p:cNvPr id="52" name="TextBox 51"/>
           <p:cNvSpPr txBox="1"/>
           <p:nvPr/>
         </p:nvSpPr>
@@ -19464,7 +19382,7 @@
       </p:sp>
       <p:sp>
         <p:nvSpPr>
-          <p:cNvPr id="55" name="Rounded Rectangle 54"/>
+          <p:cNvPr id="53" name="Rounded Rectangle 52"/>
           <p:cNvSpPr/>
           <p:nvPr/>
         </p:nvSpPr>
@@ -19510,7 +19428,7 @@
       </p:sp>
       <p:sp>
         <p:nvSpPr>
-          <p:cNvPr id="56" name="TextBox 55"/>
+          <p:cNvPr id="54" name="TextBox 53"/>
           <p:cNvSpPr txBox="1"/>
           <p:nvPr/>
         </p:nvSpPr>
@@ -19546,7 +19464,7 @@
       </p:sp>
       <p:sp>
         <p:nvSpPr>
-          <p:cNvPr id="57" name="Rounded Rectangle 56"/>
+          <p:cNvPr id="55" name="Rounded Rectangle 54"/>
           <p:cNvSpPr/>
           <p:nvPr/>
         </p:nvSpPr>
@@ -19592,7 +19510,7 @@
       </p:sp>
       <p:sp>
         <p:nvSpPr>
-          <p:cNvPr id="58" name="TextBox 57"/>
+          <p:cNvPr id="56" name="TextBox 55"/>
           <p:cNvSpPr txBox="1"/>
           <p:nvPr/>
         </p:nvSpPr>
@@ -19628,7 +19546,7 @@
       </p:sp>
       <p:sp>
         <p:nvSpPr>
-          <p:cNvPr id="59" name="Rounded Rectangle 58"/>
+          <p:cNvPr id="57" name="Rounded Rectangle 56"/>
           <p:cNvSpPr/>
           <p:nvPr/>
         </p:nvSpPr>
@@ -19676,7 +19594,7 @@
       </p:sp>
       <p:sp>
         <p:nvSpPr>
-          <p:cNvPr id="60" name="Rounded Rectangle 59"/>
+          <p:cNvPr id="58" name="Rounded Rectangle 57"/>
           <p:cNvSpPr/>
           <p:nvPr/>
         </p:nvSpPr>
@@ -19722,7 +19640,7 @@
       </p:sp>
       <p:sp>
         <p:nvSpPr>
-          <p:cNvPr id="61" name="TextBox 60"/>
+          <p:cNvPr id="59" name="TextBox 58"/>
           <p:cNvSpPr txBox="1"/>
           <p:nvPr/>
         </p:nvSpPr>
@@ -19758,7 +19676,7 @@
       </p:sp>
       <p:sp>
         <p:nvSpPr>
-          <p:cNvPr id="62" name="TextBox 61"/>
+          <p:cNvPr id="60" name="TextBox 59"/>
           <p:cNvSpPr txBox="1"/>
           <p:nvPr/>
         </p:nvSpPr>
@@ -19794,7 +19712,7 @@
       </p:sp>
       <p:sp>
         <p:nvSpPr>
-          <p:cNvPr id="63" name="TextBox 62"/>
+          <p:cNvPr id="61" name="TextBox 60"/>
           <p:cNvSpPr txBox="1"/>
           <p:nvPr/>
         </p:nvSpPr>
@@ -19830,7 +19748,7 @@
       </p:sp>
       <p:sp>
         <p:nvSpPr>
-          <p:cNvPr id="64" name="TextBox 63"/>
+          <p:cNvPr id="62" name="TextBox 61"/>
           <p:cNvSpPr txBox="1"/>
           <p:nvPr/>
         </p:nvSpPr>
@@ -19866,7 +19784,7 @@
       </p:sp>
       <p:cxnSp>
         <p:nvCxnSpPr>
-          <p:cNvPr id="65" name="Connector 64"/>
+          <p:cNvPr id="63" name="Connector 62"/>
           <p:cNvCxnSpPr/>
           <p:nvPr/>
         </p:nvCxnSpPr>
@@ -19902,7 +19820,7 @@
       </p:cxnSp>
       <p:sp>
         <p:nvSpPr>
-          <p:cNvPr id="66" name="Rounded Rectangle 65"/>
+          <p:cNvPr id="64" name="Rounded Rectangle 63"/>
           <p:cNvSpPr/>
           <p:nvPr/>
         </p:nvSpPr>
@@ -19950,7 +19868,7 @@
       </p:sp>
       <p:sp>
         <p:nvSpPr>
-          <p:cNvPr id="67" name="Rounded Rectangle 66"/>
+          <p:cNvPr id="65" name="Rounded Rectangle 64"/>
           <p:cNvSpPr/>
           <p:nvPr/>
         </p:nvSpPr>
@@ -19996,7 +19914,7 @@
       </p:sp>
       <p:sp>
         <p:nvSpPr>
-          <p:cNvPr id="68" name="TextBox 67"/>
+          <p:cNvPr id="66" name="TextBox 65"/>
           <p:cNvSpPr txBox="1"/>
           <p:nvPr/>
         </p:nvSpPr>
@@ -20032,7 +19950,7 @@
       </p:sp>
       <p:sp>
         <p:nvSpPr>
-          <p:cNvPr id="69" name="TextBox 68"/>
+          <p:cNvPr id="67" name="TextBox 66"/>
           <p:cNvSpPr txBox="1"/>
           <p:nvPr/>
         </p:nvSpPr>
@@ -20068,7 +19986,7 @@
       </p:sp>
       <p:sp>
         <p:nvSpPr>
-          <p:cNvPr id="70" name="TextBox 69"/>
+          <p:cNvPr id="68" name="TextBox 67"/>
           <p:cNvSpPr txBox="1"/>
           <p:nvPr/>
         </p:nvSpPr>
@@ -20104,7 +20022,7 @@
       </p:sp>
       <p:sp>
         <p:nvSpPr>
-          <p:cNvPr id="71" name="TextBox 70"/>
+          <p:cNvPr id="69" name="TextBox 68"/>
           <p:cNvSpPr txBox="1"/>
           <p:nvPr/>
         </p:nvSpPr>
@@ -20140,7 +20058,7 @@
       </p:sp>
       <p:cxnSp>
         <p:nvCxnSpPr>
-          <p:cNvPr id="72" name="Connector 71"/>
+          <p:cNvPr id="70" name="Connector 69"/>
           <p:cNvCxnSpPr/>
           <p:nvPr/>
         </p:nvCxnSpPr>
@@ -20176,7 +20094,7 @@
       </p:cxnSp>
       <p:cxnSp>
         <p:nvCxnSpPr>
-          <p:cNvPr id="73" name="Connector 72"/>
+          <p:cNvPr id="71" name="Connector 70"/>
           <p:cNvCxnSpPr/>
           <p:nvPr/>
         </p:nvCxnSpPr>
@@ -20212,7 +20130,7 @@
       </p:cxnSp>
       <p:sp>
         <p:nvSpPr>
-          <p:cNvPr id="74" name="Rounded Rectangle 73"/>
+          <p:cNvPr id="72" name="Rounded Rectangle 71"/>
           <p:cNvSpPr/>
           <p:nvPr/>
         </p:nvSpPr>
@@ -20260,7 +20178,7 @@
       </p:sp>
       <p:sp>
         <p:nvSpPr>
-          <p:cNvPr id="75" name="TextBox 74"/>
+          <p:cNvPr id="73" name="TextBox 72"/>
           <p:cNvSpPr txBox="1"/>
           <p:nvPr/>
         </p:nvSpPr>
@@ -20296,7 +20214,7 @@
       </p:sp>
       <p:sp>
         <p:nvSpPr>
-          <p:cNvPr id="76" name="TextBox 75"/>
+          <p:cNvPr id="74" name="TextBox 73"/>
           <p:cNvSpPr txBox="1"/>
           <p:nvPr/>
         </p:nvSpPr>

</xml_diff>

<commit_message>
Noga: self-defense as a basic right (US model)
Co-Authored-By: Claude Opus 5.5 <noreply@anthropic.com>
Claude-Session: https://claude.ai/code/session_01W7Er83FuNT4pLFShWidYHn
</commit_message>
<xml_diff>
--- a/presentation/out/koach-hitarvut.pptx
+++ b/presentation/out/koach-hitarvut.pptx
@@ -18272,7 +18272,7 @@
                 <a:latin typeface="Heebo"/>
                 <a:cs typeface="Heebo"/>
               </a:rPr>
-              <a:t>חוק הגנה עצמית</a:t>
+              <a:t>חוק הגנה עצמית: זכות יסוד</a:t>
             </a:r>
           </a:p>
         </p:txBody>
@@ -18354,7 +18354,7 @@
                 <a:latin typeface="Heebo"/>
                 <a:cs typeface="Heebo"/>
               </a:rPr>
-              <a:t>נייר: הדין הקיים והפסיקה</a:t>
+              <a:t>נייר: המודל האמריקאי מול הדין בישראל</a:t>
             </a:r>
           </a:p>
         </p:txBody>
@@ -18508,7 +18508,7 @@
                 <a:latin typeface="Heebo"/>
                 <a:cs typeface="Heebo"/>
               </a:rPr>
-              <a:t>נוסח: הרחבת ההגנה למתגונן</a:t>
+              <a:t>נוסח: חזקת הגנה עצמית וחסינות מהעמדה לדין</a:t>
             </a:r>
           </a:p>
         </p:txBody>
@@ -41775,7 +41775,7 @@
                 <a:latin typeface="Heebo"/>
                 <a:cs typeface="Heebo"/>
               </a:rPr>
-              <a:t>חוק הגנה עצמית</a:t>
+              <a:t>חוק הגנה עצמית: זכות יסוד, בדומה לארה״ב</a:t>
             </a:r>
           </a:p>
         </p:txBody>

</xml_diff>

<commit_message>
Add Knesset activity slide; part-time roles on proposal
Co-Authored-By: Claude Opus 5.5 <noreply@anthropic.com>
Claude-Session: https://claude.ai/code/session_01W7Er83FuNT4pLFShWidYHn
</commit_message>
<xml_diff>
--- a/presentation/out/koach-hitarvut.pptx
+++ b/presentation/out/koach-hitarvut.pptx
@@ -13,6 +13,7 @@
     <p:sldId id="261" r:id="rId12"/>
     <p:sldId id="262" r:id="rId13"/>
     <p:sldId id="263" r:id="rId14"/>
+    <p:sldId id="264" r:id="rId15"/>
   </p:sldIdLst>
   <p:sldSz cx="12191695" cy="6858000" type="screen4x3"/>
   <p:notesSz cx="6858000" cy="9144000"/>
@@ -19237,8 +19238,8 @@
         </p:nvSpPr>
         <p:spPr>
           <a:xfrm>
-            <a:off x="3566160" y="2651760"/>
-            <a:ext cx="1181862" cy="566928"/>
+            <a:off x="3566160" y="2688336"/>
+            <a:ext cx="1181862" cy="292608"/>
           </a:xfrm>
           <a:prstGeom prst="rect">
             <a:avLst/>
@@ -19246,7 +19247,7 @@
           <a:noFill/>
         </p:spPr>
         <p:txBody>
-          <a:bodyPr wrap="square" anchor="ctr" lIns="36576" rIns="36576" tIns="0" bIns="0">
+          <a:bodyPr wrap="square" anchor="b" lIns="36576" rIns="36576" tIns="0" bIns="0">
             <a:spAutoFit/>
           </a:bodyPr>
           <a:lstStyle/>
@@ -19267,7 +19268,43 @@
       </p:sp>
       <p:sp>
         <p:nvSpPr>
-          <p:cNvPr id="50" name="Rounded Rectangle 49"/>
+          <p:cNvPr id="50" name="TextBox 49"/>
+          <p:cNvSpPr txBox="1"/>
+          <p:nvPr/>
+        </p:nvSpPr>
+        <p:spPr>
+          <a:xfrm>
+            <a:off x="3566160" y="2980944"/>
+            <a:ext cx="1181862" cy="219456"/>
+          </a:xfrm>
+          <a:prstGeom prst="rect">
+            <a:avLst/>
+          </a:prstGeom>
+          <a:noFill/>
+        </p:spPr>
+        <p:txBody>
+          <a:bodyPr wrap="square" anchor="t" lIns="36576" rIns="36576" tIns="0" bIns="0">
+            <a:spAutoFit/>
+          </a:bodyPr>
+          <a:lstStyle/>
+          <a:p>
+            <a:pPr algn="ctr" rtl="1"/>
+            <a:r>
+              <a:rPr sz="900" b="0">
+                <a:solidFill>
+                  <a:srgbClr val="8A94A8"/>
+                </a:solidFill>
+                <a:latin typeface="Heebo"/>
+                <a:cs typeface="Heebo"/>
+              </a:rPr>
+              <a:t>משרה חלקית</a:t>
+            </a:r>
+          </a:p>
+        </p:txBody>
+      </p:sp>
+      <p:sp>
+        <p:nvSpPr>
+          <p:cNvPr id="51" name="Rounded Rectangle 50"/>
           <p:cNvSpPr/>
           <p:nvPr/>
         </p:nvSpPr>
@@ -19315,7 +19352,7 @@
       </p:sp>
       <p:sp>
         <p:nvSpPr>
-          <p:cNvPr id="51" name="TextBox 50"/>
+          <p:cNvPr id="52" name="TextBox 51"/>
           <p:cNvSpPr txBox="1"/>
           <p:nvPr/>
         </p:nvSpPr>
@@ -19344,14 +19381,14 @@
                 <a:latin typeface="Heebo"/>
                 <a:cs typeface="Heebo"/>
               </a:rPr>
-              <a:t>איש תוכן קבוע</a:t>
-            </a:r>
-          </a:p>
-        </p:txBody>
-      </p:sp>
-      <p:sp>
-        <p:nvSpPr>
-          <p:cNvPr id="52" name="TextBox 51"/>
+              <a:t>איש תוכן ותקשורת · משרה חלקית</a:t>
+            </a:r>
+          </a:p>
+        </p:txBody>
+      </p:sp>
+      <p:sp>
+        <p:nvSpPr>
+          <p:cNvPr id="53" name="TextBox 52"/>
           <p:cNvSpPr txBox="1"/>
           <p:nvPr/>
         </p:nvSpPr>
@@ -19380,14 +19417,14 @@
                 <a:latin typeface="Heebo"/>
                 <a:cs typeface="Heebo"/>
               </a:rPr>
-              <a:t>חלק אינטגרלי מהצוות · עוקב באופן עקבי אחרי סדר היום ומפיק תוכן בזמן אמת</a:t>
-            </a:r>
-          </a:p>
-        </p:txBody>
-      </p:sp>
-      <p:sp>
-        <p:nvSpPr>
-          <p:cNvPr id="53" name="Rounded Rectangle 52"/>
+              <a:t>לוקח חלק פעיל בסדר היום · איתו בונים את החשיפה בתקשורת וברשתות</a:t>
+            </a:r>
+          </a:p>
+        </p:txBody>
+      </p:sp>
+      <p:sp>
+        <p:nvSpPr>
+          <p:cNvPr id="54" name="Rounded Rectangle 53"/>
           <p:cNvSpPr/>
           <p:nvPr/>
         </p:nvSpPr>
@@ -19433,7 +19470,7 @@
       </p:sp>
       <p:sp>
         <p:nvSpPr>
-          <p:cNvPr id="54" name="TextBox 53"/>
+          <p:cNvPr id="55" name="TextBox 54"/>
           <p:cNvSpPr txBox="1"/>
           <p:nvPr/>
         </p:nvSpPr>
@@ -19469,7 +19506,7 @@
       </p:sp>
       <p:sp>
         <p:nvSpPr>
-          <p:cNvPr id="55" name="Rounded Rectangle 54"/>
+          <p:cNvPr id="56" name="Rounded Rectangle 55"/>
           <p:cNvSpPr/>
           <p:nvPr/>
         </p:nvSpPr>
@@ -19515,7 +19552,7 @@
       </p:sp>
       <p:sp>
         <p:nvSpPr>
-          <p:cNvPr id="56" name="TextBox 55"/>
+          <p:cNvPr id="57" name="TextBox 56"/>
           <p:cNvSpPr txBox="1"/>
           <p:nvPr/>
         </p:nvSpPr>
@@ -19551,7 +19588,7 @@
       </p:sp>
       <p:sp>
         <p:nvSpPr>
-          <p:cNvPr id="57" name="Rounded Rectangle 56"/>
+          <p:cNvPr id="58" name="Rounded Rectangle 57"/>
           <p:cNvSpPr/>
           <p:nvPr/>
         </p:nvSpPr>
@@ -19599,7 +19636,7 @@
       </p:sp>
       <p:sp>
         <p:nvSpPr>
-          <p:cNvPr id="58" name="Rounded Rectangle 57"/>
+          <p:cNvPr id="59" name="Rounded Rectangle 58"/>
           <p:cNvSpPr/>
           <p:nvPr/>
         </p:nvSpPr>
@@ -19645,7 +19682,7 @@
       </p:sp>
       <p:sp>
         <p:nvSpPr>
-          <p:cNvPr id="59" name="TextBox 58"/>
+          <p:cNvPr id="60" name="TextBox 59"/>
           <p:cNvSpPr txBox="1"/>
           <p:nvPr/>
         </p:nvSpPr>
@@ -19681,7 +19718,7 @@
       </p:sp>
       <p:sp>
         <p:nvSpPr>
-          <p:cNvPr id="60" name="TextBox 59"/>
+          <p:cNvPr id="61" name="TextBox 60"/>
           <p:cNvSpPr txBox="1"/>
           <p:nvPr/>
         </p:nvSpPr>
@@ -19717,7 +19754,7 @@
       </p:sp>
       <p:sp>
         <p:nvSpPr>
-          <p:cNvPr id="61" name="TextBox 60"/>
+          <p:cNvPr id="62" name="TextBox 61"/>
           <p:cNvSpPr txBox="1"/>
           <p:nvPr/>
         </p:nvSpPr>
@@ -19753,7 +19790,7 @@
       </p:sp>
       <p:sp>
         <p:nvSpPr>
-          <p:cNvPr id="62" name="TextBox 61"/>
+          <p:cNvPr id="63" name="TextBox 62"/>
           <p:cNvSpPr txBox="1"/>
           <p:nvPr/>
         </p:nvSpPr>
@@ -19789,7 +19826,7 @@
       </p:sp>
       <p:cxnSp>
         <p:nvCxnSpPr>
-          <p:cNvPr id="63" name="Connector 62"/>
+          <p:cNvPr id="64" name="Connector 63"/>
           <p:cNvCxnSpPr/>
           <p:nvPr/>
         </p:nvCxnSpPr>
@@ -19825,7 +19862,7 @@
       </p:cxnSp>
       <p:sp>
         <p:nvSpPr>
-          <p:cNvPr id="64" name="Rounded Rectangle 63"/>
+          <p:cNvPr id="65" name="Rounded Rectangle 64"/>
           <p:cNvSpPr/>
           <p:nvPr/>
         </p:nvSpPr>
@@ -19873,7 +19910,7 @@
       </p:sp>
       <p:sp>
         <p:nvSpPr>
-          <p:cNvPr id="65" name="Rounded Rectangle 64"/>
+          <p:cNvPr id="66" name="Rounded Rectangle 65"/>
           <p:cNvSpPr/>
           <p:nvPr/>
         </p:nvSpPr>
@@ -19919,7 +19956,7 @@
       </p:sp>
       <p:sp>
         <p:nvSpPr>
-          <p:cNvPr id="66" name="TextBox 65"/>
+          <p:cNvPr id="67" name="TextBox 66"/>
           <p:cNvSpPr txBox="1"/>
           <p:nvPr/>
         </p:nvSpPr>
@@ -19955,7 +19992,7 @@
       </p:sp>
       <p:sp>
         <p:nvSpPr>
-          <p:cNvPr id="67" name="TextBox 66"/>
+          <p:cNvPr id="68" name="TextBox 67"/>
           <p:cNvSpPr txBox="1"/>
           <p:nvPr/>
         </p:nvSpPr>
@@ -19991,7 +20028,7 @@
       </p:sp>
       <p:sp>
         <p:nvSpPr>
-          <p:cNvPr id="68" name="TextBox 67"/>
+          <p:cNvPr id="69" name="TextBox 68"/>
           <p:cNvSpPr txBox="1"/>
           <p:nvPr/>
         </p:nvSpPr>
@@ -20027,7 +20064,7 @@
       </p:sp>
       <p:sp>
         <p:nvSpPr>
-          <p:cNvPr id="69" name="TextBox 68"/>
+          <p:cNvPr id="70" name="TextBox 69"/>
           <p:cNvSpPr txBox="1"/>
           <p:nvPr/>
         </p:nvSpPr>
@@ -20063,7 +20100,7 @@
       </p:sp>
       <p:cxnSp>
         <p:nvCxnSpPr>
-          <p:cNvPr id="70" name="Connector 69"/>
+          <p:cNvPr id="71" name="Connector 70"/>
           <p:cNvCxnSpPr/>
           <p:nvPr/>
         </p:nvCxnSpPr>
@@ -20099,7 +20136,7 @@
       </p:cxnSp>
       <p:cxnSp>
         <p:nvCxnSpPr>
-          <p:cNvPr id="71" name="Connector 70"/>
+          <p:cNvPr id="72" name="Connector 71"/>
           <p:cNvCxnSpPr/>
           <p:nvPr/>
         </p:nvCxnSpPr>
@@ -20135,7 +20172,7 @@
       </p:cxnSp>
       <p:sp>
         <p:nvSpPr>
-          <p:cNvPr id="72" name="Rounded Rectangle 71"/>
+          <p:cNvPr id="73" name="Rounded Rectangle 72"/>
           <p:cNvSpPr/>
           <p:nvPr/>
         </p:nvSpPr>
@@ -20183,7 +20220,7 @@
       </p:sp>
       <p:sp>
         <p:nvSpPr>
-          <p:cNvPr id="73" name="TextBox 72"/>
+          <p:cNvPr id="74" name="TextBox 73"/>
           <p:cNvSpPr txBox="1"/>
           <p:nvPr/>
         </p:nvSpPr>
@@ -20219,7 +20256,7 @@
       </p:sp>
       <p:sp>
         <p:nvSpPr>
-          <p:cNvPr id="74" name="TextBox 73"/>
+          <p:cNvPr id="75" name="TextBox 74"/>
           <p:cNvSpPr txBox="1"/>
           <p:nvPr/>
         </p:nvSpPr>
@@ -25689,6 +25726,2217 @@
                 <a:cs typeface="Heebo"/>
               </a:rPr>
               <a:t>אקדמיה ומחקר: הפרדת ות״ת מהמל״ג ומוסד מחקר לאומי</a:t>
+            </a:r>
+          </a:p>
+        </p:txBody>
+      </p:sp>
+    </p:spTree>
+  </p:cSld>
+  <p:clrMapOvr>
+    <a:masterClrMapping/>
+  </p:clrMapOvr>
+</p:sld>
+</file>
+
+<file path=ppt/slides/slide9.xml><?xml version="1.0" encoding="utf-8"?>
+<p:sld xmlns:a="http://schemas.openxmlformats.org/drawingml/2006/main" xmlns:p="http://schemas.openxmlformats.org/presentationml/2006/main" xmlns:r="http://schemas.openxmlformats.org/officeDocument/2006/relationships">
+  <p:cSld>
+    <p:bg>
+      <p:bgPr>
+        <a:solidFill>
+          <a:srgbClr val="F4F6FB"/>
+        </a:solidFill>
+        <a:effectLst/>
+      </p:bgPr>
+    </p:bg>
+    <p:spTree>
+      <p:nvGrpSpPr>
+        <p:cNvPr id="1" name=""/>
+        <p:cNvGrpSpPr/>
+        <p:nvPr/>
+      </p:nvGrpSpPr>
+      <p:grpSpPr/>
+      <p:sp>
+        <p:nvSpPr>
+          <p:cNvPr id="2" name="Rectangle 1"/>
+          <p:cNvSpPr/>
+          <p:nvPr/>
+        </p:nvSpPr>
+        <p:spPr>
+          <a:xfrm>
+            <a:off x="0" y="0"/>
+            <a:ext cx="12191695" cy="868680"/>
+          </a:xfrm>
+          <a:prstGeom prst="rect">
+            <a:avLst/>
+          </a:prstGeom>
+          <a:solidFill>
+            <a:srgbClr val="1C3C7A"/>
+          </a:solidFill>
+          <a:ln>
+            <a:noFill/>
+          </a:ln>
+          <a:effectLst/>
+        </p:spPr>
+        <p:style>
+          <a:lnRef idx="1">
+            <a:schemeClr val="accent1"/>
+          </a:lnRef>
+          <a:fillRef idx="3">
+            <a:schemeClr val="accent1"/>
+          </a:fillRef>
+          <a:effectRef idx="2">
+            <a:schemeClr val="accent1"/>
+          </a:effectRef>
+          <a:fontRef idx="minor">
+            <a:schemeClr val="lt1"/>
+          </a:fontRef>
+        </p:style>
+        <p:txBody>
+          <a:bodyPr rtlCol="0" anchor="ctr"/>
+          <a:lstStyle/>
+          <a:p>
+            <a:pPr algn="ctr"/>
+          </a:p>
+        </p:txBody>
+      </p:sp>
+      <p:sp>
+        <p:nvSpPr>
+          <p:cNvPr id="3" name="Rectangle 2"/>
+          <p:cNvSpPr/>
+          <p:nvPr/>
+        </p:nvSpPr>
+        <p:spPr>
+          <a:xfrm>
+            <a:off x="0" y="868680"/>
+            <a:ext cx="12191695" cy="54864"/>
+          </a:xfrm>
+          <a:prstGeom prst="rect">
+            <a:avLst/>
+          </a:prstGeom>
+          <a:solidFill>
+            <a:srgbClr val="F0C000"/>
+          </a:solidFill>
+          <a:ln>
+            <a:noFill/>
+          </a:ln>
+          <a:effectLst/>
+        </p:spPr>
+        <p:style>
+          <a:lnRef idx="1">
+            <a:schemeClr val="accent1"/>
+          </a:lnRef>
+          <a:fillRef idx="3">
+            <a:schemeClr val="accent1"/>
+          </a:fillRef>
+          <a:effectRef idx="2">
+            <a:schemeClr val="accent1"/>
+          </a:effectRef>
+          <a:fontRef idx="minor">
+            <a:schemeClr val="lt1"/>
+          </a:fontRef>
+        </p:style>
+        <p:txBody>
+          <a:bodyPr rtlCol="0" anchor="ctr"/>
+          <a:lstStyle/>
+          <a:p>
+            <a:pPr algn="ctr"/>
+          </a:p>
+        </p:txBody>
+      </p:sp>
+      <p:sp>
+        <p:nvSpPr>
+          <p:cNvPr id="4" name="TextBox 3"/>
+          <p:cNvSpPr txBox="1"/>
+          <p:nvPr/>
+        </p:nvSpPr>
+        <p:spPr>
+          <a:xfrm>
+            <a:off x="1280160" y="109728"/>
+            <a:ext cx="10515600" cy="457200"/>
+          </a:xfrm>
+          <a:prstGeom prst="rect">
+            <a:avLst/>
+          </a:prstGeom>
+          <a:noFill/>
+        </p:spPr>
+        <p:txBody>
+          <a:bodyPr wrap="square" anchor="ctr" lIns="36576" rIns="36576" tIns="0" bIns="0">
+            <a:spAutoFit/>
+          </a:bodyPr>
+          <a:lstStyle/>
+          <a:p>
+            <a:pPr algn="r" rtl="1"/>
+            <a:r>
+              <a:rPr sz="2600" b="1">
+                <a:solidFill>
+                  <a:srgbClr val="FFFFFF"/>
+                </a:solidFill>
+                <a:latin typeface="Heebo"/>
+                <a:cs typeface="Heebo"/>
+              </a:rPr>
+              <a:t>פעילות כנסת · שבוע עבודה</a:t>
+            </a:r>
+          </a:p>
+        </p:txBody>
+      </p:sp>
+      <p:sp>
+        <p:nvSpPr>
+          <p:cNvPr id="6" name="Rounded Rectangle 5"/>
+          <p:cNvSpPr/>
+          <p:nvPr/>
+        </p:nvSpPr>
+        <p:spPr>
+          <a:xfrm>
+            <a:off x="265176" y="54864"/>
+            <a:ext cx="910550" cy="768096"/>
+          </a:xfrm>
+          <a:prstGeom prst="roundRect">
+            <a:avLst>
+              <a:gd name="adj" fmla="val 12000"/>
+            </a:avLst>
+          </a:prstGeom>
+          <a:solidFill>
+            <a:srgbClr val="FFFFFF"/>
+          </a:solidFill>
+          <a:ln>
+            <a:noFill/>
+          </a:ln>
+          <a:effectLst/>
+        </p:spPr>
+        <p:style>
+          <a:lnRef idx="1">
+            <a:schemeClr val="accent1"/>
+          </a:lnRef>
+          <a:fillRef idx="3">
+            <a:schemeClr val="accent1"/>
+          </a:fillRef>
+          <a:effectRef idx="2">
+            <a:schemeClr val="accent1"/>
+          </a:effectRef>
+          <a:fontRef idx="minor">
+            <a:schemeClr val="lt1"/>
+          </a:fontRef>
+        </p:style>
+        <p:txBody>
+          <a:bodyPr rtlCol="0" anchor="ctr"/>
+          <a:lstStyle/>
+          <a:p>
+            <a:pPr algn="ctr"/>
+          </a:p>
+        </p:txBody>
+      </p:sp>
+      <p:pic>
+        <p:nvPicPr>
+          <p:cNvPr id="5" name="Picture 4" descr="logo.png"/>
+          <p:cNvPicPr>
+            <a:picLocks noChangeAspect="1"/>
+          </p:cNvPicPr>
+          <p:nvPr/>
+        </p:nvPicPr>
+        <p:blipFill>
+          <a:blip r:embed="rId2"/>
+          <a:stretch>
+            <a:fillRect/>
+          </a:stretch>
+        </p:blipFill>
+        <p:spPr>
+          <a:xfrm>
+            <a:off x="320040" y="73152"/>
+            <a:ext cx="800822" cy="731520"/>
+          </a:xfrm>
+          <a:prstGeom prst="rect">
+            <a:avLst/>
+          </a:prstGeom>
+        </p:spPr>
+      </p:pic>
+      <p:sp>
+        <p:nvSpPr>
+          <p:cNvPr id="7" name="Rounded Rectangle 6"/>
+          <p:cNvSpPr/>
+          <p:nvPr/>
+        </p:nvSpPr>
+        <p:spPr>
+          <a:xfrm>
+            <a:off x="8112557" y="1143000"/>
+            <a:ext cx="3667658" cy="868680"/>
+          </a:xfrm>
+          <a:prstGeom prst="roundRect">
+            <a:avLst>
+              <a:gd name="adj" fmla="val 14000"/>
+            </a:avLst>
+          </a:prstGeom>
+          <a:solidFill>
+            <a:srgbClr val="1C3C7A"/>
+          </a:solidFill>
+          <a:ln>
+            <a:noFill/>
+          </a:ln>
+          <a:effectLst/>
+        </p:spPr>
+        <p:style>
+          <a:lnRef idx="1">
+            <a:schemeClr val="accent1"/>
+          </a:lnRef>
+          <a:fillRef idx="3">
+            <a:schemeClr val="accent1"/>
+          </a:fillRef>
+          <a:effectRef idx="2">
+            <a:schemeClr val="accent1"/>
+          </a:effectRef>
+          <a:fontRef idx="minor">
+            <a:schemeClr val="lt1"/>
+          </a:fontRef>
+        </p:style>
+        <p:txBody>
+          <a:bodyPr rtlCol="0" anchor="ctr"/>
+          <a:lstStyle/>
+          <a:p>
+            <a:pPr algn="ctr"/>
+          </a:p>
+        </p:txBody>
+      </p:sp>
+      <p:sp>
+        <p:nvSpPr>
+          <p:cNvPr id="8" name="TextBox 7"/>
+          <p:cNvSpPr txBox="1"/>
+          <p:nvPr/>
+        </p:nvSpPr>
+        <p:spPr>
+          <a:xfrm>
+            <a:off x="8112557" y="1234440"/>
+            <a:ext cx="3667658" cy="438912"/>
+          </a:xfrm>
+          <a:prstGeom prst="rect">
+            <a:avLst/>
+          </a:prstGeom>
+          <a:noFill/>
+        </p:spPr>
+        <p:txBody>
+          <a:bodyPr wrap="square" anchor="b" lIns="36576" rIns="36576" tIns="0" bIns="0">
+            <a:spAutoFit/>
+          </a:bodyPr>
+          <a:lstStyle/>
+          <a:p>
+            <a:pPr algn="ctr" rtl="1"/>
+            <a:r>
+              <a:rPr sz="2200" b="1">
+                <a:solidFill>
+                  <a:srgbClr val="FFFFFF"/>
+                </a:solidFill>
+                <a:latin typeface="Heebo"/>
+                <a:cs typeface="Heebo"/>
+              </a:rPr>
+              <a:t>בין 3 ל-4 דיונים</a:t>
+            </a:r>
+          </a:p>
+        </p:txBody>
+      </p:sp>
+      <p:sp>
+        <p:nvSpPr>
+          <p:cNvPr id="9" name="TextBox 8"/>
+          <p:cNvSpPr txBox="1"/>
+          <p:nvPr/>
+        </p:nvSpPr>
+        <p:spPr>
+          <a:xfrm>
+            <a:off x="8112557" y="1691640"/>
+            <a:ext cx="3667658" cy="256032"/>
+          </a:xfrm>
+          <a:prstGeom prst="rect">
+            <a:avLst/>
+          </a:prstGeom>
+          <a:noFill/>
+        </p:spPr>
+        <p:txBody>
+          <a:bodyPr wrap="square" anchor="t" lIns="36576" rIns="36576" tIns="0" bIns="0">
+            <a:spAutoFit/>
+          </a:bodyPr>
+          <a:lstStyle/>
+          <a:p>
+            <a:pPr algn="ctr" rtl="1"/>
+            <a:r>
+              <a:rPr sz="1200" b="0">
+                <a:solidFill>
+                  <a:srgbClr val="F0C000"/>
+                </a:solidFill>
+                <a:latin typeface="Heebo"/>
+                <a:cs typeface="Heebo"/>
+              </a:rPr>
+              <a:t>בכל שבוע</a:t>
+            </a:r>
+          </a:p>
+        </p:txBody>
+      </p:sp>
+      <p:sp>
+        <p:nvSpPr>
+          <p:cNvPr id="10" name="Rounded Rectangle 9"/>
+          <p:cNvSpPr/>
+          <p:nvPr/>
+        </p:nvSpPr>
+        <p:spPr>
+          <a:xfrm>
+            <a:off x="4262019" y="1143000"/>
+            <a:ext cx="3667658" cy="868680"/>
+          </a:xfrm>
+          <a:prstGeom prst="roundRect">
+            <a:avLst>
+              <a:gd name="adj" fmla="val 14000"/>
+            </a:avLst>
+          </a:prstGeom>
+          <a:solidFill>
+            <a:srgbClr val="1C3C7A"/>
+          </a:solidFill>
+          <a:ln>
+            <a:noFill/>
+          </a:ln>
+          <a:effectLst/>
+        </p:spPr>
+        <p:style>
+          <a:lnRef idx="1">
+            <a:schemeClr val="accent1"/>
+          </a:lnRef>
+          <a:fillRef idx="3">
+            <a:schemeClr val="accent1"/>
+          </a:fillRef>
+          <a:effectRef idx="2">
+            <a:schemeClr val="accent1"/>
+          </a:effectRef>
+          <a:fontRef idx="minor">
+            <a:schemeClr val="lt1"/>
+          </a:fontRef>
+        </p:style>
+        <p:txBody>
+          <a:bodyPr rtlCol="0" anchor="ctr"/>
+          <a:lstStyle/>
+          <a:p>
+            <a:pPr algn="ctr"/>
+          </a:p>
+        </p:txBody>
+      </p:sp>
+      <p:sp>
+        <p:nvSpPr>
+          <p:cNvPr id="11" name="TextBox 10"/>
+          <p:cNvSpPr txBox="1"/>
+          <p:nvPr/>
+        </p:nvSpPr>
+        <p:spPr>
+          <a:xfrm>
+            <a:off x="4262019" y="1234440"/>
+            <a:ext cx="3667658" cy="438912"/>
+          </a:xfrm>
+          <a:prstGeom prst="rect">
+            <a:avLst/>
+          </a:prstGeom>
+          <a:noFill/>
+        </p:spPr>
+        <p:txBody>
+          <a:bodyPr wrap="square" anchor="b" lIns="36576" rIns="36576" tIns="0" bIns="0">
+            <a:spAutoFit/>
+          </a:bodyPr>
+          <a:lstStyle/>
+          <a:p>
+            <a:pPr algn="ctr" rtl="1"/>
+            <a:r>
+              <a:rPr sz="2200" b="1">
+                <a:solidFill>
+                  <a:srgbClr val="FFFFFF"/>
+                </a:solidFill>
+                <a:latin typeface="Heebo"/>
+                <a:cs typeface="Heebo"/>
+              </a:rPr>
+              <a:t>2 ימי כנסת מלאים</a:t>
+            </a:r>
+          </a:p>
+        </p:txBody>
+      </p:sp>
+      <p:sp>
+        <p:nvSpPr>
+          <p:cNvPr id="12" name="TextBox 11"/>
+          <p:cNvSpPr txBox="1"/>
+          <p:nvPr/>
+        </p:nvSpPr>
+        <p:spPr>
+          <a:xfrm>
+            <a:off x="4262019" y="1691640"/>
+            <a:ext cx="3667658" cy="256032"/>
+          </a:xfrm>
+          <a:prstGeom prst="rect">
+            <a:avLst/>
+          </a:prstGeom>
+          <a:noFill/>
+        </p:spPr>
+        <p:txBody>
+          <a:bodyPr wrap="square" anchor="t" lIns="36576" rIns="36576" tIns="0" bIns="0">
+            <a:spAutoFit/>
+          </a:bodyPr>
+          <a:lstStyle/>
+          <a:p>
+            <a:pPr algn="ctr" rtl="1"/>
+            <a:r>
+              <a:rPr sz="1200" b="0">
+                <a:solidFill>
+                  <a:srgbClr val="F0C000"/>
+                </a:solidFill>
+                <a:latin typeface="Heebo"/>
+                <a:cs typeface="Heebo"/>
+              </a:rPr>
+              <a:t>דיונים, פגישות ושיחות</a:t>
+            </a:r>
+          </a:p>
+        </p:txBody>
+      </p:sp>
+      <p:sp>
+        <p:nvSpPr>
+          <p:cNvPr id="13" name="Rounded Rectangle 12"/>
+          <p:cNvSpPr/>
+          <p:nvPr/>
+        </p:nvSpPr>
+        <p:spPr>
+          <a:xfrm>
+            <a:off x="411481" y="1143000"/>
+            <a:ext cx="3667658" cy="868680"/>
+          </a:xfrm>
+          <a:prstGeom prst="roundRect">
+            <a:avLst>
+              <a:gd name="adj" fmla="val 14000"/>
+            </a:avLst>
+          </a:prstGeom>
+          <a:solidFill>
+            <a:srgbClr val="1C3C7A"/>
+          </a:solidFill>
+          <a:ln>
+            <a:noFill/>
+          </a:ln>
+          <a:effectLst/>
+        </p:spPr>
+        <p:style>
+          <a:lnRef idx="1">
+            <a:schemeClr val="accent1"/>
+          </a:lnRef>
+          <a:fillRef idx="3">
+            <a:schemeClr val="accent1"/>
+          </a:fillRef>
+          <a:effectRef idx="2">
+            <a:schemeClr val="accent1"/>
+          </a:effectRef>
+          <a:fontRef idx="minor">
+            <a:schemeClr val="lt1"/>
+          </a:fontRef>
+        </p:style>
+        <p:txBody>
+          <a:bodyPr rtlCol="0" anchor="ctr"/>
+          <a:lstStyle/>
+          <a:p>
+            <a:pPr algn="ctr"/>
+          </a:p>
+        </p:txBody>
+      </p:sp>
+      <p:sp>
+        <p:nvSpPr>
+          <p:cNvPr id="14" name="TextBox 13"/>
+          <p:cNvSpPr txBox="1"/>
+          <p:nvPr/>
+        </p:nvSpPr>
+        <p:spPr>
+          <a:xfrm>
+            <a:off x="411481" y="1234440"/>
+            <a:ext cx="3667658" cy="438912"/>
+          </a:xfrm>
+          <a:prstGeom prst="rect">
+            <a:avLst/>
+          </a:prstGeom>
+          <a:noFill/>
+        </p:spPr>
+        <p:txBody>
+          <a:bodyPr wrap="square" anchor="b" lIns="36576" rIns="36576" tIns="0" bIns="0">
+            <a:spAutoFit/>
+          </a:bodyPr>
+          <a:lstStyle/>
+          <a:p>
+            <a:pPr algn="ctr" rtl="1"/>
+            <a:r>
+              <a:rPr sz="2200" b="1">
+                <a:solidFill>
+                  <a:srgbClr val="FFFFFF"/>
+                </a:solidFill>
+                <a:latin typeface="Heebo"/>
+                <a:cs typeface="Heebo"/>
+              </a:rPr>
+              <a:t>בין 400 ל-600 ₪</a:t>
+            </a:r>
+          </a:p>
+        </p:txBody>
+      </p:sp>
+      <p:sp>
+        <p:nvSpPr>
+          <p:cNvPr id="15" name="TextBox 14"/>
+          <p:cNvSpPr txBox="1"/>
+          <p:nvPr/>
+        </p:nvSpPr>
+        <p:spPr>
+          <a:xfrm>
+            <a:off x="411481" y="1691640"/>
+            <a:ext cx="3667658" cy="256032"/>
+          </a:xfrm>
+          <a:prstGeom prst="rect">
+            <a:avLst/>
+          </a:prstGeom>
+          <a:noFill/>
+        </p:spPr>
+        <p:txBody>
+          <a:bodyPr wrap="square" anchor="t" lIns="36576" rIns="36576" tIns="0" bIns="0">
+            <a:spAutoFit/>
+          </a:bodyPr>
+          <a:lstStyle/>
+          <a:p>
+            <a:pPr algn="ctr" rtl="1"/>
+            <a:r>
+              <a:rPr sz="1200" b="0">
+                <a:solidFill>
+                  <a:srgbClr val="F0C000"/>
+                </a:solidFill>
+                <a:latin typeface="Heebo"/>
+                <a:cs typeface="Heebo"/>
+              </a:rPr>
+              <a:t>תגמול ליום כנסת · יום מלא או חצי יום</a:t>
+            </a:r>
+          </a:p>
+        </p:txBody>
+      </p:sp>
+      <p:sp>
+        <p:nvSpPr>
+          <p:cNvPr id="16" name="Rounded Rectangle 15"/>
+          <p:cNvSpPr/>
+          <p:nvPr/>
+        </p:nvSpPr>
+        <p:spPr>
+          <a:xfrm>
+            <a:off x="9608881" y="2240280"/>
+            <a:ext cx="2171334" cy="1463040"/>
+          </a:xfrm>
+          <a:prstGeom prst="roundRect">
+            <a:avLst>
+              <a:gd name="adj" fmla="val 10000"/>
+            </a:avLst>
+          </a:prstGeom>
+          <a:solidFill>
+            <a:srgbClr val="FFFFFF"/>
+          </a:solidFill>
+          <a:ln w="15875">
+            <a:solidFill>
+              <a:srgbClr val="C5CDDD"/>
+            </a:solidFill>
+          </a:ln>
+          <a:effectLst/>
+        </p:spPr>
+        <p:style>
+          <a:lnRef idx="1">
+            <a:schemeClr val="accent1"/>
+          </a:lnRef>
+          <a:fillRef idx="3">
+            <a:schemeClr val="accent1"/>
+          </a:fillRef>
+          <a:effectRef idx="2">
+            <a:schemeClr val="accent1"/>
+          </a:effectRef>
+          <a:fontRef idx="minor">
+            <a:schemeClr val="lt1"/>
+          </a:fontRef>
+        </p:style>
+        <p:txBody>
+          <a:bodyPr rtlCol="0" anchor="ctr"/>
+          <a:lstStyle/>
+          <a:p>
+            <a:pPr algn="ctr"/>
+          </a:p>
+        </p:txBody>
+      </p:sp>
+      <p:sp>
+        <p:nvSpPr>
+          <p:cNvPr id="17" name="TextBox 16"/>
+          <p:cNvSpPr txBox="1"/>
+          <p:nvPr/>
+        </p:nvSpPr>
+        <p:spPr>
+          <a:xfrm>
+            <a:off x="9608881" y="2331720"/>
+            <a:ext cx="2171334" cy="274320"/>
+          </a:xfrm>
+          <a:prstGeom prst="rect">
+            <a:avLst/>
+          </a:prstGeom>
+          <a:noFill/>
+        </p:spPr>
+        <p:txBody>
+          <a:bodyPr wrap="square" anchor="ctr" lIns="36576" rIns="36576" tIns="0" bIns="0">
+            <a:spAutoFit/>
+          </a:bodyPr>
+          <a:lstStyle/>
+          <a:p>
+            <a:pPr algn="ctr" rtl="1"/>
+            <a:r>
+              <a:rPr sz="1200" b="1">
+                <a:solidFill>
+                  <a:srgbClr val="8A94A8"/>
+                </a:solidFill>
+                <a:latin typeface="Heebo"/>
+                <a:cs typeface="Heebo"/>
+              </a:rPr>
+              <a:t>ראשון</a:t>
+            </a:r>
+          </a:p>
+        </p:txBody>
+      </p:sp>
+      <p:sp>
+        <p:nvSpPr>
+          <p:cNvPr id="18" name="TextBox 17"/>
+          <p:cNvSpPr txBox="1"/>
+          <p:nvPr/>
+        </p:nvSpPr>
+        <p:spPr>
+          <a:xfrm>
+            <a:off x="9700321" y="2624328"/>
+            <a:ext cx="1988454" cy="457200"/>
+          </a:xfrm>
+          <a:prstGeom prst="rect">
+            <a:avLst/>
+          </a:prstGeom>
+          <a:noFill/>
+        </p:spPr>
+        <p:txBody>
+          <a:bodyPr wrap="square" anchor="ctr" lIns="36576" rIns="36576" tIns="0" bIns="0">
+            <a:spAutoFit/>
+          </a:bodyPr>
+          <a:lstStyle/>
+          <a:p>
+            <a:pPr algn="ctr" rtl="1"/>
+            <a:r>
+              <a:rPr sz="1500" b="1">
+                <a:solidFill>
+                  <a:srgbClr val="1C3C7A"/>
+                </a:solidFill>
+                <a:latin typeface="Heebo"/>
+                <a:cs typeface="Heebo"/>
+              </a:rPr>
+              <a:t>הכנה</a:t>
+            </a:r>
+          </a:p>
+        </p:txBody>
+      </p:sp>
+      <p:sp>
+        <p:nvSpPr>
+          <p:cNvPr id="19" name="TextBox 18"/>
+          <p:cNvSpPr txBox="1"/>
+          <p:nvPr/>
+        </p:nvSpPr>
+        <p:spPr>
+          <a:xfrm>
+            <a:off x="9700321" y="3108960"/>
+            <a:ext cx="1988454" cy="502920"/>
+          </a:xfrm>
+          <a:prstGeom prst="rect">
+            <a:avLst/>
+          </a:prstGeom>
+          <a:noFill/>
+        </p:spPr>
+        <p:txBody>
+          <a:bodyPr wrap="square" anchor="t" lIns="36576" rIns="36576" tIns="0" bIns="0">
+            <a:spAutoFit/>
+          </a:bodyPr>
+          <a:lstStyle/>
+          <a:p>
+            <a:pPr algn="ctr" rtl="1"/>
+            <a:r>
+              <a:rPr sz="1100" b="0">
+                <a:solidFill>
+                  <a:srgbClr val="1A2233"/>
+                </a:solidFill>
+                <a:latin typeface="Heebo"/>
+                <a:cs typeface="Heebo"/>
+              </a:rPr>
+              <a:t>צוות המחקר מכין ניירות ותדריך לנציג</a:t>
+            </a:r>
+          </a:p>
+        </p:txBody>
+      </p:sp>
+      <p:sp>
+        <p:nvSpPr>
+          <p:cNvPr id="20" name="Rounded Rectangle 19"/>
+          <p:cNvSpPr/>
+          <p:nvPr/>
+        </p:nvSpPr>
+        <p:spPr>
+          <a:xfrm>
+            <a:off x="7309531" y="2240280"/>
+            <a:ext cx="2171334" cy="1463040"/>
+          </a:xfrm>
+          <a:prstGeom prst="roundRect">
+            <a:avLst>
+              <a:gd name="adj" fmla="val 10000"/>
+            </a:avLst>
+          </a:prstGeom>
+          <a:solidFill>
+            <a:srgbClr val="F0C000"/>
+          </a:solidFill>
+          <a:ln>
+            <a:noFill/>
+          </a:ln>
+          <a:effectLst/>
+        </p:spPr>
+        <p:style>
+          <a:lnRef idx="1">
+            <a:schemeClr val="accent1"/>
+          </a:lnRef>
+          <a:fillRef idx="3">
+            <a:schemeClr val="accent1"/>
+          </a:fillRef>
+          <a:effectRef idx="2">
+            <a:schemeClr val="accent1"/>
+          </a:effectRef>
+          <a:fontRef idx="minor">
+            <a:schemeClr val="lt1"/>
+          </a:fontRef>
+        </p:style>
+        <p:txBody>
+          <a:bodyPr rtlCol="0" anchor="ctr"/>
+          <a:lstStyle/>
+          <a:p>
+            <a:pPr algn="ctr"/>
+          </a:p>
+        </p:txBody>
+      </p:sp>
+      <p:sp>
+        <p:nvSpPr>
+          <p:cNvPr id="21" name="TextBox 20"/>
+          <p:cNvSpPr txBox="1"/>
+          <p:nvPr/>
+        </p:nvSpPr>
+        <p:spPr>
+          <a:xfrm>
+            <a:off x="7309531" y="2331720"/>
+            <a:ext cx="2171334" cy="274320"/>
+          </a:xfrm>
+          <a:prstGeom prst="rect">
+            <a:avLst/>
+          </a:prstGeom>
+          <a:noFill/>
+        </p:spPr>
+        <p:txBody>
+          <a:bodyPr wrap="square" anchor="ctr" lIns="36576" rIns="36576" tIns="0" bIns="0">
+            <a:spAutoFit/>
+          </a:bodyPr>
+          <a:lstStyle/>
+          <a:p>
+            <a:pPr algn="ctr" rtl="1"/>
+            <a:r>
+              <a:rPr sz="1200" b="1">
+                <a:solidFill>
+                  <a:srgbClr val="122755"/>
+                </a:solidFill>
+                <a:latin typeface="Heebo"/>
+                <a:cs typeface="Heebo"/>
+              </a:rPr>
+              <a:t>שני</a:t>
+            </a:r>
+          </a:p>
+        </p:txBody>
+      </p:sp>
+      <p:sp>
+        <p:nvSpPr>
+          <p:cNvPr id="22" name="TextBox 21"/>
+          <p:cNvSpPr txBox="1"/>
+          <p:nvPr/>
+        </p:nvSpPr>
+        <p:spPr>
+          <a:xfrm>
+            <a:off x="7400971" y="2624328"/>
+            <a:ext cx="1988454" cy="457200"/>
+          </a:xfrm>
+          <a:prstGeom prst="rect">
+            <a:avLst/>
+          </a:prstGeom>
+          <a:noFill/>
+        </p:spPr>
+        <p:txBody>
+          <a:bodyPr wrap="square" anchor="ctr" lIns="36576" rIns="36576" tIns="0" bIns="0">
+            <a:spAutoFit/>
+          </a:bodyPr>
+          <a:lstStyle/>
+          <a:p>
+            <a:pPr algn="ctr" rtl="1"/>
+            <a:r>
+              <a:rPr sz="1500" b="1">
+                <a:solidFill>
+                  <a:srgbClr val="122755"/>
+                </a:solidFill>
+                <a:latin typeface="Heebo"/>
+                <a:cs typeface="Heebo"/>
+              </a:rPr>
+              <a:t>יום כנסת מלא</a:t>
+            </a:r>
+          </a:p>
+        </p:txBody>
+      </p:sp>
+      <p:sp>
+        <p:nvSpPr>
+          <p:cNvPr id="23" name="TextBox 22"/>
+          <p:cNvSpPr txBox="1"/>
+          <p:nvPr/>
+        </p:nvSpPr>
+        <p:spPr>
+          <a:xfrm>
+            <a:off x="7400971" y="3108960"/>
+            <a:ext cx="1988454" cy="502920"/>
+          </a:xfrm>
+          <a:prstGeom prst="rect">
+            <a:avLst/>
+          </a:prstGeom>
+          <a:noFill/>
+        </p:spPr>
+        <p:txBody>
+          <a:bodyPr wrap="square" anchor="t" lIns="36576" rIns="36576" tIns="0" bIns="0">
+            <a:spAutoFit/>
+          </a:bodyPr>
+          <a:lstStyle/>
+          <a:p>
+            <a:pPr algn="ctr" rtl="1"/>
+            <a:r>
+              <a:rPr sz="1100" b="0">
+                <a:solidFill>
+                  <a:srgbClr val="122755"/>
+                </a:solidFill>
+                <a:latin typeface="Heebo"/>
+                <a:cs typeface="Heebo"/>
+              </a:rPr>
+              <a:t>דיונים בוועדות ופגישות עם חברי כנסת</a:t>
+            </a:r>
+          </a:p>
+        </p:txBody>
+      </p:sp>
+      <p:sp>
+        <p:nvSpPr>
+          <p:cNvPr id="24" name="Rounded Rectangle 23"/>
+          <p:cNvSpPr/>
+          <p:nvPr/>
+        </p:nvSpPr>
+        <p:spPr>
+          <a:xfrm>
+            <a:off x="5010181" y="2240280"/>
+            <a:ext cx="2171334" cy="1463040"/>
+          </a:xfrm>
+          <a:prstGeom prst="roundRect">
+            <a:avLst>
+              <a:gd name="adj" fmla="val 10000"/>
+            </a:avLst>
+          </a:prstGeom>
+          <a:solidFill>
+            <a:srgbClr val="F0C000"/>
+          </a:solidFill>
+          <a:ln>
+            <a:noFill/>
+          </a:ln>
+          <a:effectLst/>
+        </p:spPr>
+        <p:style>
+          <a:lnRef idx="1">
+            <a:schemeClr val="accent1"/>
+          </a:lnRef>
+          <a:fillRef idx="3">
+            <a:schemeClr val="accent1"/>
+          </a:fillRef>
+          <a:effectRef idx="2">
+            <a:schemeClr val="accent1"/>
+          </a:effectRef>
+          <a:fontRef idx="minor">
+            <a:schemeClr val="lt1"/>
+          </a:fontRef>
+        </p:style>
+        <p:txBody>
+          <a:bodyPr rtlCol="0" anchor="ctr"/>
+          <a:lstStyle/>
+          <a:p>
+            <a:pPr algn="ctr"/>
+          </a:p>
+        </p:txBody>
+      </p:sp>
+      <p:sp>
+        <p:nvSpPr>
+          <p:cNvPr id="25" name="TextBox 24"/>
+          <p:cNvSpPr txBox="1"/>
+          <p:nvPr/>
+        </p:nvSpPr>
+        <p:spPr>
+          <a:xfrm>
+            <a:off x="5010181" y="2331720"/>
+            <a:ext cx="2171334" cy="274320"/>
+          </a:xfrm>
+          <a:prstGeom prst="rect">
+            <a:avLst/>
+          </a:prstGeom>
+          <a:noFill/>
+        </p:spPr>
+        <p:txBody>
+          <a:bodyPr wrap="square" anchor="ctr" lIns="36576" rIns="36576" tIns="0" bIns="0">
+            <a:spAutoFit/>
+          </a:bodyPr>
+          <a:lstStyle/>
+          <a:p>
+            <a:pPr algn="ctr" rtl="1"/>
+            <a:r>
+              <a:rPr sz="1200" b="1">
+                <a:solidFill>
+                  <a:srgbClr val="122755"/>
+                </a:solidFill>
+                <a:latin typeface="Heebo"/>
+                <a:cs typeface="Heebo"/>
+              </a:rPr>
+              <a:t>שלישי</a:t>
+            </a:r>
+          </a:p>
+        </p:txBody>
+      </p:sp>
+      <p:sp>
+        <p:nvSpPr>
+          <p:cNvPr id="26" name="TextBox 25"/>
+          <p:cNvSpPr txBox="1"/>
+          <p:nvPr/>
+        </p:nvSpPr>
+        <p:spPr>
+          <a:xfrm>
+            <a:off x="5101621" y="2624328"/>
+            <a:ext cx="1988454" cy="457200"/>
+          </a:xfrm>
+          <a:prstGeom prst="rect">
+            <a:avLst/>
+          </a:prstGeom>
+          <a:noFill/>
+        </p:spPr>
+        <p:txBody>
+          <a:bodyPr wrap="square" anchor="ctr" lIns="36576" rIns="36576" tIns="0" bIns="0">
+            <a:spAutoFit/>
+          </a:bodyPr>
+          <a:lstStyle/>
+          <a:p>
+            <a:pPr algn="ctr" rtl="1"/>
+            <a:r>
+              <a:rPr sz="1500" b="1">
+                <a:solidFill>
+                  <a:srgbClr val="122755"/>
+                </a:solidFill>
+                <a:latin typeface="Heebo"/>
+                <a:cs typeface="Heebo"/>
+              </a:rPr>
+              <a:t>יום כנסת מלא</a:t>
+            </a:r>
+          </a:p>
+        </p:txBody>
+      </p:sp>
+      <p:sp>
+        <p:nvSpPr>
+          <p:cNvPr id="27" name="TextBox 26"/>
+          <p:cNvSpPr txBox="1"/>
+          <p:nvPr/>
+        </p:nvSpPr>
+        <p:spPr>
+          <a:xfrm>
+            <a:off x="5101621" y="3108960"/>
+            <a:ext cx="1988454" cy="502920"/>
+          </a:xfrm>
+          <a:prstGeom prst="rect">
+            <a:avLst/>
+          </a:prstGeom>
+          <a:noFill/>
+        </p:spPr>
+        <p:txBody>
+          <a:bodyPr wrap="square" anchor="t" lIns="36576" rIns="36576" tIns="0" bIns="0">
+            <a:spAutoFit/>
+          </a:bodyPr>
+          <a:lstStyle/>
+          <a:p>
+            <a:pPr algn="ctr" rtl="1"/>
+            <a:r>
+              <a:rPr sz="1100" b="0">
+                <a:solidFill>
+                  <a:srgbClr val="122755"/>
+                </a:solidFill>
+                <a:latin typeface="Heebo"/>
+                <a:cs typeface="Heebo"/>
+              </a:rPr>
+              <a:t>דיונים בוועדות ופגישות עם חברי כנסת</a:t>
+            </a:r>
+          </a:p>
+        </p:txBody>
+      </p:sp>
+      <p:sp>
+        <p:nvSpPr>
+          <p:cNvPr id="28" name="Rounded Rectangle 27"/>
+          <p:cNvSpPr/>
+          <p:nvPr/>
+        </p:nvSpPr>
+        <p:spPr>
+          <a:xfrm>
+            <a:off x="2710831" y="2240280"/>
+            <a:ext cx="2171334" cy="1463040"/>
+          </a:xfrm>
+          <a:prstGeom prst="roundRect">
+            <a:avLst>
+              <a:gd name="adj" fmla="val 10000"/>
+            </a:avLst>
+          </a:prstGeom>
+          <a:solidFill>
+            <a:srgbClr val="FFFFFF"/>
+          </a:solidFill>
+          <a:ln w="15875">
+            <a:solidFill>
+              <a:srgbClr val="C5CDDD"/>
+            </a:solidFill>
+          </a:ln>
+          <a:effectLst/>
+        </p:spPr>
+        <p:style>
+          <a:lnRef idx="1">
+            <a:schemeClr val="accent1"/>
+          </a:lnRef>
+          <a:fillRef idx="3">
+            <a:schemeClr val="accent1"/>
+          </a:fillRef>
+          <a:effectRef idx="2">
+            <a:schemeClr val="accent1"/>
+          </a:effectRef>
+          <a:fontRef idx="minor">
+            <a:schemeClr val="lt1"/>
+          </a:fontRef>
+        </p:style>
+        <p:txBody>
+          <a:bodyPr rtlCol="0" anchor="ctr"/>
+          <a:lstStyle/>
+          <a:p>
+            <a:pPr algn="ctr"/>
+          </a:p>
+        </p:txBody>
+      </p:sp>
+      <p:sp>
+        <p:nvSpPr>
+          <p:cNvPr id="29" name="TextBox 28"/>
+          <p:cNvSpPr txBox="1"/>
+          <p:nvPr/>
+        </p:nvSpPr>
+        <p:spPr>
+          <a:xfrm>
+            <a:off x="2710831" y="2331720"/>
+            <a:ext cx="2171334" cy="274320"/>
+          </a:xfrm>
+          <a:prstGeom prst="rect">
+            <a:avLst/>
+          </a:prstGeom>
+          <a:noFill/>
+        </p:spPr>
+        <p:txBody>
+          <a:bodyPr wrap="square" anchor="ctr" lIns="36576" rIns="36576" tIns="0" bIns="0">
+            <a:spAutoFit/>
+          </a:bodyPr>
+          <a:lstStyle/>
+          <a:p>
+            <a:pPr algn="ctr" rtl="1"/>
+            <a:r>
+              <a:rPr sz="1200" b="1">
+                <a:solidFill>
+                  <a:srgbClr val="8A94A8"/>
+                </a:solidFill>
+                <a:latin typeface="Heebo"/>
+                <a:cs typeface="Heebo"/>
+              </a:rPr>
+              <a:t>רביעי</a:t>
+            </a:r>
+          </a:p>
+        </p:txBody>
+      </p:sp>
+      <p:sp>
+        <p:nvSpPr>
+          <p:cNvPr id="30" name="TextBox 29"/>
+          <p:cNvSpPr txBox="1"/>
+          <p:nvPr/>
+        </p:nvSpPr>
+        <p:spPr>
+          <a:xfrm>
+            <a:off x="2802271" y="2624328"/>
+            <a:ext cx="1988454" cy="457200"/>
+          </a:xfrm>
+          <a:prstGeom prst="rect">
+            <a:avLst/>
+          </a:prstGeom>
+          <a:noFill/>
+        </p:spPr>
+        <p:txBody>
+          <a:bodyPr wrap="square" anchor="ctr" lIns="36576" rIns="36576" tIns="0" bIns="0">
+            <a:spAutoFit/>
+          </a:bodyPr>
+          <a:lstStyle/>
+          <a:p>
+            <a:pPr algn="ctr" rtl="1"/>
+            <a:r>
+              <a:rPr sz="1500" b="1">
+                <a:solidFill>
+                  <a:srgbClr val="1C3C7A"/>
+                </a:solidFill>
+                <a:latin typeface="Heebo"/>
+                <a:cs typeface="Heebo"/>
+              </a:rPr>
+              <a:t>דיון נוסף לפי הצורך</a:t>
+            </a:r>
+          </a:p>
+        </p:txBody>
+      </p:sp>
+      <p:sp>
+        <p:nvSpPr>
+          <p:cNvPr id="31" name="TextBox 30"/>
+          <p:cNvSpPr txBox="1"/>
+          <p:nvPr/>
+        </p:nvSpPr>
+        <p:spPr>
+          <a:xfrm>
+            <a:off x="2802271" y="3108960"/>
+            <a:ext cx="1988454" cy="502920"/>
+          </a:xfrm>
+          <a:prstGeom prst="rect">
+            <a:avLst/>
+          </a:prstGeom>
+          <a:noFill/>
+        </p:spPr>
+        <p:txBody>
+          <a:bodyPr wrap="square" anchor="t" lIns="36576" rIns="36576" tIns="0" bIns="0">
+            <a:spAutoFit/>
+          </a:bodyPr>
+          <a:lstStyle/>
+          <a:p>
+            <a:pPr algn="ctr" rtl="1"/>
+            <a:r>
+              <a:rPr sz="1100" b="0">
+                <a:solidFill>
+                  <a:srgbClr val="1A2233"/>
+                </a:solidFill>
+                <a:latin typeface="Heebo"/>
+                <a:cs typeface="Heebo"/>
+              </a:rPr>
+              <a:t>נציג, או אקטיביסט שמשלים</a:t>
+            </a:r>
+          </a:p>
+        </p:txBody>
+      </p:sp>
+      <p:sp>
+        <p:nvSpPr>
+          <p:cNvPr id="32" name="Rounded Rectangle 31"/>
+          <p:cNvSpPr/>
+          <p:nvPr/>
+        </p:nvSpPr>
+        <p:spPr>
+          <a:xfrm>
+            <a:off x="411481" y="2240280"/>
+            <a:ext cx="2171334" cy="1463040"/>
+          </a:xfrm>
+          <a:prstGeom prst="roundRect">
+            <a:avLst>
+              <a:gd name="adj" fmla="val 10000"/>
+            </a:avLst>
+          </a:prstGeom>
+          <a:solidFill>
+            <a:srgbClr val="FFFFFF"/>
+          </a:solidFill>
+          <a:ln w="15875">
+            <a:solidFill>
+              <a:srgbClr val="C5CDDD"/>
+            </a:solidFill>
+          </a:ln>
+          <a:effectLst/>
+        </p:spPr>
+        <p:style>
+          <a:lnRef idx="1">
+            <a:schemeClr val="accent1"/>
+          </a:lnRef>
+          <a:fillRef idx="3">
+            <a:schemeClr val="accent1"/>
+          </a:fillRef>
+          <a:effectRef idx="2">
+            <a:schemeClr val="accent1"/>
+          </a:effectRef>
+          <a:fontRef idx="minor">
+            <a:schemeClr val="lt1"/>
+          </a:fontRef>
+        </p:style>
+        <p:txBody>
+          <a:bodyPr rtlCol="0" anchor="ctr"/>
+          <a:lstStyle/>
+          <a:p>
+            <a:pPr algn="ctr"/>
+          </a:p>
+        </p:txBody>
+      </p:sp>
+      <p:sp>
+        <p:nvSpPr>
+          <p:cNvPr id="33" name="TextBox 32"/>
+          <p:cNvSpPr txBox="1"/>
+          <p:nvPr/>
+        </p:nvSpPr>
+        <p:spPr>
+          <a:xfrm>
+            <a:off x="411481" y="2331720"/>
+            <a:ext cx="2171334" cy="274320"/>
+          </a:xfrm>
+          <a:prstGeom prst="rect">
+            <a:avLst/>
+          </a:prstGeom>
+          <a:noFill/>
+        </p:spPr>
+        <p:txBody>
+          <a:bodyPr wrap="square" anchor="ctr" lIns="36576" rIns="36576" tIns="0" bIns="0">
+            <a:spAutoFit/>
+          </a:bodyPr>
+          <a:lstStyle/>
+          <a:p>
+            <a:pPr algn="ctr" rtl="1"/>
+            <a:r>
+              <a:rPr sz="1200" b="1">
+                <a:solidFill>
+                  <a:srgbClr val="8A94A8"/>
+                </a:solidFill>
+                <a:latin typeface="Heebo"/>
+                <a:cs typeface="Heebo"/>
+              </a:rPr>
+              <a:t>חמישי</a:t>
+            </a:r>
+          </a:p>
+        </p:txBody>
+      </p:sp>
+      <p:sp>
+        <p:nvSpPr>
+          <p:cNvPr id="34" name="TextBox 33"/>
+          <p:cNvSpPr txBox="1"/>
+          <p:nvPr/>
+        </p:nvSpPr>
+        <p:spPr>
+          <a:xfrm>
+            <a:off x="502921" y="2624328"/>
+            <a:ext cx="1988454" cy="457200"/>
+          </a:xfrm>
+          <a:prstGeom prst="rect">
+            <a:avLst/>
+          </a:prstGeom>
+          <a:noFill/>
+        </p:spPr>
+        <p:txBody>
+          <a:bodyPr wrap="square" anchor="ctr" lIns="36576" rIns="36576" tIns="0" bIns="0">
+            <a:spAutoFit/>
+          </a:bodyPr>
+          <a:lstStyle/>
+          <a:p>
+            <a:pPr algn="ctr" rtl="1"/>
+            <a:r>
+              <a:rPr sz="1500" b="1">
+                <a:solidFill>
+                  <a:srgbClr val="1C3C7A"/>
+                </a:solidFill>
+                <a:latin typeface="Heebo"/>
+                <a:cs typeface="Heebo"/>
+              </a:rPr>
+              <a:t>תוכן וסיכום</a:t>
+            </a:r>
+          </a:p>
+        </p:txBody>
+      </p:sp>
+      <p:sp>
+        <p:nvSpPr>
+          <p:cNvPr id="35" name="TextBox 34"/>
+          <p:cNvSpPr txBox="1"/>
+          <p:nvPr/>
+        </p:nvSpPr>
+        <p:spPr>
+          <a:xfrm>
+            <a:off x="502921" y="3108960"/>
+            <a:ext cx="1988454" cy="502920"/>
+          </a:xfrm>
+          <a:prstGeom prst="rect">
+            <a:avLst/>
+          </a:prstGeom>
+          <a:noFill/>
+        </p:spPr>
+        <p:txBody>
+          <a:bodyPr wrap="square" anchor="t" lIns="36576" rIns="36576" tIns="0" bIns="0">
+            <a:spAutoFit/>
+          </a:bodyPr>
+          <a:lstStyle/>
+          <a:p>
+            <a:pPr algn="ctr" rtl="1"/>
+            <a:r>
+              <a:rPr sz="1100" b="0">
+                <a:solidFill>
+                  <a:srgbClr val="1A2233"/>
+                </a:solidFill>
+                <a:latin typeface="Heebo"/>
+                <a:cs typeface="Heebo"/>
+              </a:rPr>
+              <a:t>איש התוכן מפיץ את פעילות השבוע</a:t>
+            </a:r>
+          </a:p>
+        </p:txBody>
+      </p:sp>
+      <p:sp>
+        <p:nvSpPr>
+          <p:cNvPr id="36" name="Rounded Rectangle 35"/>
+          <p:cNvSpPr/>
+          <p:nvPr/>
+        </p:nvSpPr>
+        <p:spPr>
+          <a:xfrm>
+            <a:off x="6187288" y="3931920"/>
+            <a:ext cx="5592927" cy="2514600"/>
+          </a:xfrm>
+          <a:prstGeom prst="roundRect">
+            <a:avLst>
+              <a:gd name="adj" fmla="val 6000"/>
+            </a:avLst>
+          </a:prstGeom>
+          <a:solidFill>
+            <a:srgbClr val="FFFFFF"/>
+          </a:solidFill>
+          <a:ln w="15875">
+            <a:solidFill>
+              <a:srgbClr val="C5CDDD"/>
+            </a:solidFill>
+          </a:ln>
+          <a:effectLst/>
+        </p:spPr>
+        <p:style>
+          <a:lnRef idx="1">
+            <a:schemeClr val="accent1"/>
+          </a:lnRef>
+          <a:fillRef idx="3">
+            <a:schemeClr val="accent1"/>
+          </a:fillRef>
+          <a:effectRef idx="2">
+            <a:schemeClr val="accent1"/>
+          </a:effectRef>
+          <a:fontRef idx="minor">
+            <a:schemeClr val="lt1"/>
+          </a:fontRef>
+        </p:style>
+        <p:txBody>
+          <a:bodyPr rtlCol="0" anchor="ctr"/>
+          <a:lstStyle/>
+          <a:p>
+            <a:pPr algn="ctr"/>
+          </a:p>
+        </p:txBody>
+      </p:sp>
+      <p:sp>
+        <p:nvSpPr>
+          <p:cNvPr id="37" name="TextBox 36"/>
+          <p:cNvSpPr txBox="1"/>
+          <p:nvPr/>
+        </p:nvSpPr>
+        <p:spPr>
+          <a:xfrm>
+            <a:off x="6370168" y="4041648"/>
+            <a:ext cx="5227167" cy="329184"/>
+          </a:xfrm>
+          <a:prstGeom prst="rect">
+            <a:avLst/>
+          </a:prstGeom>
+          <a:noFill/>
+        </p:spPr>
+        <p:txBody>
+          <a:bodyPr wrap="square" anchor="ctr" lIns="36576" rIns="36576" tIns="0" bIns="0">
+            <a:spAutoFit/>
+          </a:bodyPr>
+          <a:lstStyle/>
+          <a:p>
+            <a:pPr algn="r" rtl="1"/>
+            <a:r>
+              <a:rPr sz="1600" b="1">
+                <a:solidFill>
+                  <a:srgbClr val="1C3C7A"/>
+                </a:solidFill>
+                <a:latin typeface="Heebo"/>
+                <a:cs typeface="Heebo"/>
+              </a:rPr>
+              <a:t>מי הולך לכנסת</a:t>
+            </a:r>
+          </a:p>
+        </p:txBody>
+      </p:sp>
+      <p:sp>
+        <p:nvSpPr>
+          <p:cNvPr id="38" name="Rounded Rectangle 37"/>
+          <p:cNvSpPr/>
+          <p:nvPr/>
+        </p:nvSpPr>
+        <p:spPr>
+          <a:xfrm>
+            <a:off x="10359124" y="4480560"/>
+            <a:ext cx="1238211" cy="502920"/>
+          </a:xfrm>
+          <a:prstGeom prst="roundRect">
+            <a:avLst>
+              <a:gd name="adj" fmla="val 18000"/>
+            </a:avLst>
+          </a:prstGeom>
+          <a:solidFill>
+            <a:srgbClr val="FFFFFF"/>
+          </a:solidFill>
+          <a:ln w="15875">
+            <a:solidFill>
+              <a:srgbClr val="C5CDDD"/>
+            </a:solidFill>
+          </a:ln>
+          <a:effectLst/>
+        </p:spPr>
+        <p:style>
+          <a:lnRef idx="1">
+            <a:schemeClr val="accent1"/>
+          </a:lnRef>
+          <a:fillRef idx="3">
+            <a:schemeClr val="accent1"/>
+          </a:fillRef>
+          <a:effectRef idx="2">
+            <a:schemeClr val="accent1"/>
+          </a:effectRef>
+          <a:fontRef idx="minor">
+            <a:schemeClr val="lt1"/>
+          </a:fontRef>
+        </p:style>
+        <p:txBody>
+          <a:bodyPr rtlCol="0" anchor="ctr"/>
+          <a:lstStyle/>
+          <a:p>
+            <a:pPr algn="ctr"/>
+          </a:p>
+        </p:txBody>
+      </p:sp>
+      <p:sp>
+        <p:nvSpPr>
+          <p:cNvPr id="39" name="Rectangle 38"/>
+          <p:cNvSpPr/>
+          <p:nvPr/>
+        </p:nvSpPr>
+        <p:spPr>
+          <a:xfrm>
+            <a:off x="11533327" y="4553712"/>
+            <a:ext cx="45720" cy="356616"/>
+          </a:xfrm>
+          <a:prstGeom prst="rect">
+            <a:avLst/>
+          </a:prstGeom>
+          <a:solidFill>
+            <a:srgbClr val="F0C000"/>
+          </a:solidFill>
+          <a:ln>
+            <a:noFill/>
+          </a:ln>
+          <a:effectLst/>
+        </p:spPr>
+        <p:style>
+          <a:lnRef idx="1">
+            <a:schemeClr val="accent1"/>
+          </a:lnRef>
+          <a:fillRef idx="3">
+            <a:schemeClr val="accent1"/>
+          </a:fillRef>
+          <a:effectRef idx="2">
+            <a:schemeClr val="accent1"/>
+          </a:effectRef>
+          <a:fontRef idx="minor">
+            <a:schemeClr val="lt1"/>
+          </a:fontRef>
+        </p:style>
+        <p:txBody>
+          <a:bodyPr rtlCol="0" anchor="ctr"/>
+          <a:lstStyle/>
+          <a:p>
+            <a:pPr algn="ctr"/>
+          </a:p>
+        </p:txBody>
+      </p:sp>
+      <p:sp>
+        <p:nvSpPr>
+          <p:cNvPr id="40" name="TextBox 39"/>
+          <p:cNvSpPr txBox="1"/>
+          <p:nvPr/>
+        </p:nvSpPr>
+        <p:spPr>
+          <a:xfrm>
+            <a:off x="10359124" y="4480560"/>
+            <a:ext cx="1238211" cy="502920"/>
+          </a:xfrm>
+          <a:prstGeom prst="rect">
+            <a:avLst/>
+          </a:prstGeom>
+          <a:noFill/>
+        </p:spPr>
+        <p:txBody>
+          <a:bodyPr wrap="square" anchor="ctr" lIns="36576" rIns="36576" tIns="0" bIns="0">
+            <a:spAutoFit/>
+          </a:bodyPr>
+          <a:lstStyle/>
+          <a:p>
+            <a:pPr algn="ctr" rtl="1"/>
+            <a:r>
+              <a:rPr sz="1200" b="1">
+                <a:solidFill>
+                  <a:srgbClr val="1A2233"/>
+                </a:solidFill>
+                <a:latin typeface="Heebo"/>
+                <a:cs typeface="Heebo"/>
+              </a:rPr>
+              <a:t>תמיר דורטל</a:t>
+            </a:r>
+          </a:p>
+        </p:txBody>
+      </p:sp>
+      <p:sp>
+        <p:nvSpPr>
+          <p:cNvPr id="41" name="Rounded Rectangle 40"/>
+          <p:cNvSpPr/>
+          <p:nvPr/>
+        </p:nvSpPr>
+        <p:spPr>
+          <a:xfrm>
+            <a:off x="9029473" y="4480560"/>
+            <a:ext cx="1238211" cy="502920"/>
+          </a:xfrm>
+          <a:prstGeom prst="roundRect">
+            <a:avLst>
+              <a:gd name="adj" fmla="val 18000"/>
+            </a:avLst>
+          </a:prstGeom>
+          <a:solidFill>
+            <a:srgbClr val="FFFFFF"/>
+          </a:solidFill>
+          <a:ln w="15875">
+            <a:solidFill>
+              <a:srgbClr val="C5CDDD"/>
+            </a:solidFill>
+          </a:ln>
+          <a:effectLst/>
+        </p:spPr>
+        <p:style>
+          <a:lnRef idx="1">
+            <a:schemeClr val="accent1"/>
+          </a:lnRef>
+          <a:fillRef idx="3">
+            <a:schemeClr val="accent1"/>
+          </a:fillRef>
+          <a:effectRef idx="2">
+            <a:schemeClr val="accent1"/>
+          </a:effectRef>
+          <a:fontRef idx="minor">
+            <a:schemeClr val="lt1"/>
+          </a:fontRef>
+        </p:style>
+        <p:txBody>
+          <a:bodyPr rtlCol="0" anchor="ctr"/>
+          <a:lstStyle/>
+          <a:p>
+            <a:pPr algn="ctr"/>
+          </a:p>
+        </p:txBody>
+      </p:sp>
+      <p:sp>
+        <p:nvSpPr>
+          <p:cNvPr id="42" name="Rectangle 41"/>
+          <p:cNvSpPr/>
+          <p:nvPr/>
+        </p:nvSpPr>
+        <p:spPr>
+          <a:xfrm>
+            <a:off x="10203676" y="4553712"/>
+            <a:ext cx="45720" cy="356616"/>
+          </a:xfrm>
+          <a:prstGeom prst="rect">
+            <a:avLst/>
+          </a:prstGeom>
+          <a:solidFill>
+            <a:srgbClr val="F0C000"/>
+          </a:solidFill>
+          <a:ln>
+            <a:noFill/>
+          </a:ln>
+          <a:effectLst/>
+        </p:spPr>
+        <p:style>
+          <a:lnRef idx="1">
+            <a:schemeClr val="accent1"/>
+          </a:lnRef>
+          <a:fillRef idx="3">
+            <a:schemeClr val="accent1"/>
+          </a:fillRef>
+          <a:effectRef idx="2">
+            <a:schemeClr val="accent1"/>
+          </a:effectRef>
+          <a:fontRef idx="minor">
+            <a:schemeClr val="lt1"/>
+          </a:fontRef>
+        </p:style>
+        <p:txBody>
+          <a:bodyPr rtlCol="0" anchor="ctr"/>
+          <a:lstStyle/>
+          <a:p>
+            <a:pPr algn="ctr"/>
+          </a:p>
+        </p:txBody>
+      </p:sp>
+      <p:sp>
+        <p:nvSpPr>
+          <p:cNvPr id="43" name="TextBox 42"/>
+          <p:cNvSpPr txBox="1"/>
+          <p:nvPr/>
+        </p:nvSpPr>
+        <p:spPr>
+          <a:xfrm>
+            <a:off x="9029473" y="4480560"/>
+            <a:ext cx="1238211" cy="502920"/>
+          </a:xfrm>
+          <a:prstGeom prst="rect">
+            <a:avLst/>
+          </a:prstGeom>
+          <a:noFill/>
+        </p:spPr>
+        <p:txBody>
+          <a:bodyPr wrap="square" anchor="ctr" lIns="36576" rIns="36576" tIns="0" bIns="0">
+            <a:spAutoFit/>
+          </a:bodyPr>
+          <a:lstStyle/>
+          <a:p>
+            <a:pPr algn="ctr" rtl="1"/>
+            <a:r>
+              <a:rPr sz="1200" b="1">
+                <a:solidFill>
+                  <a:srgbClr val="1A2233"/>
+                </a:solidFill>
+                <a:latin typeface="Heebo"/>
+                <a:cs typeface="Heebo"/>
+              </a:rPr>
+              <a:t>אדם קורגן</a:t>
+            </a:r>
+          </a:p>
+        </p:txBody>
+      </p:sp>
+      <p:sp>
+        <p:nvSpPr>
+          <p:cNvPr id="44" name="Rounded Rectangle 43"/>
+          <p:cNvSpPr/>
+          <p:nvPr/>
+        </p:nvSpPr>
+        <p:spPr>
+          <a:xfrm>
+            <a:off x="7699822" y="4480560"/>
+            <a:ext cx="1238211" cy="502920"/>
+          </a:xfrm>
+          <a:prstGeom prst="roundRect">
+            <a:avLst>
+              <a:gd name="adj" fmla="val 18000"/>
+            </a:avLst>
+          </a:prstGeom>
+          <a:solidFill>
+            <a:srgbClr val="FFFFFF"/>
+          </a:solidFill>
+          <a:ln w="15875">
+            <a:solidFill>
+              <a:srgbClr val="C5CDDD"/>
+            </a:solidFill>
+          </a:ln>
+          <a:effectLst/>
+        </p:spPr>
+        <p:style>
+          <a:lnRef idx="1">
+            <a:schemeClr val="accent1"/>
+          </a:lnRef>
+          <a:fillRef idx="3">
+            <a:schemeClr val="accent1"/>
+          </a:fillRef>
+          <a:effectRef idx="2">
+            <a:schemeClr val="accent1"/>
+          </a:effectRef>
+          <a:fontRef idx="minor">
+            <a:schemeClr val="lt1"/>
+          </a:fontRef>
+        </p:style>
+        <p:txBody>
+          <a:bodyPr rtlCol="0" anchor="ctr"/>
+          <a:lstStyle/>
+          <a:p>
+            <a:pPr algn="ctr"/>
+          </a:p>
+        </p:txBody>
+      </p:sp>
+      <p:sp>
+        <p:nvSpPr>
+          <p:cNvPr id="45" name="Rectangle 44"/>
+          <p:cNvSpPr/>
+          <p:nvPr/>
+        </p:nvSpPr>
+        <p:spPr>
+          <a:xfrm>
+            <a:off x="8874025" y="4553712"/>
+            <a:ext cx="45720" cy="356616"/>
+          </a:xfrm>
+          <a:prstGeom prst="rect">
+            <a:avLst/>
+          </a:prstGeom>
+          <a:solidFill>
+            <a:srgbClr val="F0C000"/>
+          </a:solidFill>
+          <a:ln>
+            <a:noFill/>
+          </a:ln>
+          <a:effectLst/>
+        </p:spPr>
+        <p:style>
+          <a:lnRef idx="1">
+            <a:schemeClr val="accent1"/>
+          </a:lnRef>
+          <a:fillRef idx="3">
+            <a:schemeClr val="accent1"/>
+          </a:fillRef>
+          <a:effectRef idx="2">
+            <a:schemeClr val="accent1"/>
+          </a:effectRef>
+          <a:fontRef idx="minor">
+            <a:schemeClr val="lt1"/>
+          </a:fontRef>
+        </p:style>
+        <p:txBody>
+          <a:bodyPr rtlCol="0" anchor="ctr"/>
+          <a:lstStyle/>
+          <a:p>
+            <a:pPr algn="ctr"/>
+          </a:p>
+        </p:txBody>
+      </p:sp>
+      <p:sp>
+        <p:nvSpPr>
+          <p:cNvPr id="46" name="TextBox 45"/>
+          <p:cNvSpPr txBox="1"/>
+          <p:nvPr/>
+        </p:nvSpPr>
+        <p:spPr>
+          <a:xfrm>
+            <a:off x="7699822" y="4480560"/>
+            <a:ext cx="1238211" cy="502920"/>
+          </a:xfrm>
+          <a:prstGeom prst="rect">
+            <a:avLst/>
+          </a:prstGeom>
+          <a:noFill/>
+        </p:spPr>
+        <p:txBody>
+          <a:bodyPr wrap="square" anchor="ctr" lIns="36576" rIns="36576" tIns="0" bIns="0">
+            <a:spAutoFit/>
+          </a:bodyPr>
+          <a:lstStyle/>
+          <a:p>
+            <a:pPr algn="ctr" rtl="1"/>
+            <a:r>
+              <a:rPr sz="1200" b="1">
+                <a:solidFill>
+                  <a:srgbClr val="1A2233"/>
+                </a:solidFill>
+                <a:latin typeface="Heebo"/>
+                <a:cs typeface="Heebo"/>
+              </a:rPr>
+              <a:t>ד״ר אמיר רובין</a:t>
+            </a:r>
+          </a:p>
+        </p:txBody>
+      </p:sp>
+      <p:sp>
+        <p:nvSpPr>
+          <p:cNvPr id="47" name="Rounded Rectangle 46"/>
+          <p:cNvSpPr/>
+          <p:nvPr/>
+        </p:nvSpPr>
+        <p:spPr>
+          <a:xfrm>
+            <a:off x="6370171" y="4480560"/>
+            <a:ext cx="1238211" cy="502920"/>
+          </a:xfrm>
+          <a:prstGeom prst="roundRect">
+            <a:avLst>
+              <a:gd name="adj" fmla="val 18000"/>
+            </a:avLst>
+          </a:prstGeom>
+          <a:noFill/>
+          <a:ln w="15875">
+            <a:solidFill>
+              <a:srgbClr val="F0C000"/>
+            </a:solidFill>
+            <a:prstDash val="dash"/>
+          </a:ln>
+          <a:effectLst/>
+        </p:spPr>
+        <p:style>
+          <a:lnRef idx="1">
+            <a:schemeClr val="accent1"/>
+          </a:lnRef>
+          <a:fillRef idx="3">
+            <a:schemeClr val="accent1"/>
+          </a:fillRef>
+          <a:effectRef idx="2">
+            <a:schemeClr val="accent1"/>
+          </a:effectRef>
+          <a:fontRef idx="minor">
+            <a:schemeClr val="lt1"/>
+          </a:fontRef>
+        </p:style>
+        <p:txBody>
+          <a:bodyPr rtlCol="0" anchor="ctr"/>
+          <a:lstStyle/>
+          <a:p>
+            <a:pPr algn="ctr"/>
+          </a:p>
+        </p:txBody>
+      </p:sp>
+      <p:sp>
+        <p:nvSpPr>
+          <p:cNvPr id="48" name="TextBox 47"/>
+          <p:cNvSpPr txBox="1"/>
+          <p:nvPr/>
+        </p:nvSpPr>
+        <p:spPr>
+          <a:xfrm>
+            <a:off x="6370171" y="4480560"/>
+            <a:ext cx="1238211" cy="502920"/>
+          </a:xfrm>
+          <a:prstGeom prst="rect">
+            <a:avLst/>
+          </a:prstGeom>
+          <a:noFill/>
+        </p:spPr>
+        <p:txBody>
+          <a:bodyPr wrap="square" anchor="ctr" lIns="36576" rIns="36576" tIns="0" bIns="0">
+            <a:spAutoFit/>
+          </a:bodyPr>
+          <a:lstStyle/>
+          <a:p>
+            <a:pPr algn="ctr" rtl="1"/>
+            <a:r>
+              <a:rPr sz="1200" b="1">
+                <a:solidFill>
+                  <a:srgbClr val="1C3C7A"/>
+                </a:solidFill>
+                <a:latin typeface="Heebo"/>
+                <a:cs typeface="Heebo"/>
+              </a:rPr>
+              <a:t>נציג רביעי</a:t>
+            </a:r>
+          </a:p>
+        </p:txBody>
+      </p:sp>
+      <p:sp>
+        <p:nvSpPr>
+          <p:cNvPr id="49" name="TextBox 48"/>
+          <p:cNvSpPr txBox="1"/>
+          <p:nvPr/>
+        </p:nvSpPr>
+        <p:spPr>
+          <a:xfrm>
+            <a:off x="6370168" y="5120640"/>
+            <a:ext cx="5227167" cy="274320"/>
+          </a:xfrm>
+          <a:prstGeom prst="rect">
+            <a:avLst/>
+          </a:prstGeom>
+          <a:noFill/>
+        </p:spPr>
+        <p:txBody>
+          <a:bodyPr wrap="square" anchor="ctr" lIns="36576" rIns="36576" tIns="0" bIns="0">
+            <a:spAutoFit/>
+          </a:bodyPr>
+          <a:lstStyle/>
+          <a:p>
+            <a:pPr algn="r" rtl="1"/>
+            <a:r>
+              <a:rPr sz="1100" b="0">
+                <a:solidFill>
+                  <a:srgbClr val="8A94A8"/>
+                </a:solidFill>
+                <a:latin typeface="Heebo"/>
+                <a:cs typeface="Heebo"/>
+              </a:rPr>
+              <a:t>נציג רביעי: משרה חלקית, או בשילוב עם תפקיד איש התוכן</a:t>
+            </a:r>
+          </a:p>
+        </p:txBody>
+      </p:sp>
+      <p:sp>
+        <p:nvSpPr>
+          <p:cNvPr id="50" name="Rounded Rectangle 49"/>
+          <p:cNvSpPr/>
+          <p:nvPr/>
+        </p:nvSpPr>
+        <p:spPr>
+          <a:xfrm>
+            <a:off x="6370168" y="5532120"/>
+            <a:ext cx="5227167" cy="640080"/>
+          </a:xfrm>
+          <a:prstGeom prst="roundRect">
+            <a:avLst>
+              <a:gd name="adj" fmla="val 15000"/>
+            </a:avLst>
+          </a:prstGeom>
+          <a:solidFill>
+            <a:srgbClr val="F4F6FB"/>
+          </a:solidFill>
+          <a:ln>
+            <a:noFill/>
+          </a:ln>
+          <a:effectLst/>
+        </p:spPr>
+        <p:style>
+          <a:lnRef idx="1">
+            <a:schemeClr val="accent1"/>
+          </a:lnRef>
+          <a:fillRef idx="3">
+            <a:schemeClr val="accent1"/>
+          </a:fillRef>
+          <a:effectRef idx="2">
+            <a:schemeClr val="accent1"/>
+          </a:effectRef>
+          <a:fontRef idx="minor">
+            <a:schemeClr val="lt1"/>
+          </a:fontRef>
+        </p:style>
+        <p:txBody>
+          <a:bodyPr rtlCol="0" anchor="ctr"/>
+          <a:lstStyle/>
+          <a:p>
+            <a:pPr algn="ctr"/>
+          </a:p>
+        </p:txBody>
+      </p:sp>
+      <p:sp>
+        <p:nvSpPr>
+          <p:cNvPr id="51" name="TextBox 50"/>
+          <p:cNvSpPr txBox="1"/>
+          <p:nvPr/>
+        </p:nvSpPr>
+        <p:spPr>
+          <a:xfrm>
+            <a:off x="6461608" y="5532120"/>
+            <a:ext cx="5044287" cy="640080"/>
+          </a:xfrm>
+          <a:prstGeom prst="rect">
+            <a:avLst/>
+          </a:prstGeom>
+          <a:noFill/>
+        </p:spPr>
+        <p:txBody>
+          <a:bodyPr wrap="square" anchor="ctr" lIns="36576" rIns="36576" tIns="0" bIns="0">
+            <a:spAutoFit/>
+          </a:bodyPr>
+          <a:lstStyle/>
+          <a:p>
+            <a:pPr algn="r" rtl="1"/>
+            <a:r>
+              <a:rPr sz="1300" b="1">
+                <a:solidFill>
+                  <a:srgbClr val="1A2233"/>
+                </a:solidFill>
+                <a:latin typeface="Heebo"/>
+                <a:cs typeface="Heebo"/>
+              </a:rPr>
+              <a:t>+ אקטיביסטים משלימים חורים ומצטרפים לנציג</a:t>
+            </a:r>
+          </a:p>
+        </p:txBody>
+      </p:sp>
+      <p:sp>
+        <p:nvSpPr>
+          <p:cNvPr id="52" name="Rounded Rectangle 51"/>
+          <p:cNvSpPr/>
+          <p:nvPr/>
+        </p:nvSpPr>
+        <p:spPr>
+          <a:xfrm>
+            <a:off x="411480" y="3931920"/>
+            <a:ext cx="5592927" cy="2514600"/>
+          </a:xfrm>
+          <a:prstGeom prst="roundRect">
+            <a:avLst>
+              <a:gd name="adj" fmla="val 6000"/>
+            </a:avLst>
+          </a:prstGeom>
+          <a:solidFill>
+            <a:srgbClr val="FFFFFF"/>
+          </a:solidFill>
+          <a:ln w="31750">
+            <a:solidFill>
+              <a:srgbClr val="F0C000"/>
+            </a:solidFill>
+          </a:ln>
+          <a:effectLst/>
+        </p:spPr>
+        <p:style>
+          <a:lnRef idx="1">
+            <a:schemeClr val="accent1"/>
+          </a:lnRef>
+          <a:fillRef idx="3">
+            <a:schemeClr val="accent1"/>
+          </a:fillRef>
+          <a:effectRef idx="2">
+            <a:schemeClr val="accent1"/>
+          </a:effectRef>
+          <a:fontRef idx="minor">
+            <a:schemeClr val="lt1"/>
+          </a:fontRef>
+        </p:style>
+        <p:txBody>
+          <a:bodyPr rtlCol="0" anchor="ctr"/>
+          <a:lstStyle/>
+          <a:p>
+            <a:pPr algn="ctr"/>
+          </a:p>
+        </p:txBody>
+      </p:sp>
+      <p:sp>
+        <p:nvSpPr>
+          <p:cNvPr id="53" name="TextBox 52"/>
+          <p:cNvSpPr txBox="1"/>
+          <p:nvPr/>
+        </p:nvSpPr>
+        <p:spPr>
+          <a:xfrm>
+            <a:off x="594360" y="4041648"/>
+            <a:ext cx="5227167" cy="329184"/>
+          </a:xfrm>
+          <a:prstGeom prst="rect">
+            <a:avLst/>
+          </a:prstGeom>
+          <a:noFill/>
+        </p:spPr>
+        <p:txBody>
+          <a:bodyPr wrap="square" anchor="ctr" lIns="36576" rIns="36576" tIns="0" bIns="0">
+            <a:spAutoFit/>
+          </a:bodyPr>
+          <a:lstStyle/>
+          <a:p>
+            <a:pPr algn="r" rtl="1"/>
+            <a:r>
+              <a:rPr sz="1600" b="1">
+                <a:solidFill>
+                  <a:srgbClr val="1C3C7A"/>
+                </a:solidFill>
+                <a:latin typeface="Heebo"/>
+                <a:cs typeface="Heebo"/>
+              </a:rPr>
+              <a:t>איש תוכן ותקשורת</a:t>
+            </a:r>
+          </a:p>
+        </p:txBody>
+      </p:sp>
+      <p:sp>
+        <p:nvSpPr>
+          <p:cNvPr id="54" name="TextBox 53"/>
+          <p:cNvSpPr txBox="1"/>
+          <p:nvPr/>
+        </p:nvSpPr>
+        <p:spPr>
+          <a:xfrm>
+            <a:off x="594360" y="4389120"/>
+            <a:ext cx="5227167" cy="274320"/>
+          </a:xfrm>
+          <a:prstGeom prst="rect">
+            <a:avLst/>
+          </a:prstGeom>
+          <a:noFill/>
+        </p:spPr>
+        <p:txBody>
+          <a:bodyPr wrap="square" anchor="ctr" lIns="36576" rIns="36576" tIns="0" bIns="0">
+            <a:spAutoFit/>
+          </a:bodyPr>
+          <a:lstStyle/>
+          <a:p>
+            <a:pPr algn="r" rtl="1"/>
+            <a:r>
+              <a:rPr sz="1100" b="0">
+                <a:solidFill>
+                  <a:srgbClr val="8A94A8"/>
+                </a:solidFill>
+                <a:latin typeface="Heebo"/>
+                <a:cs typeface="Heebo"/>
+              </a:rPr>
+              <a:t>משרה חלקית בכח התערבות · אפשר בשילוב עם 'על המשמעות'</a:t>
+            </a:r>
+          </a:p>
+        </p:txBody>
+      </p:sp>
+      <p:sp>
+        <p:nvSpPr>
+          <p:cNvPr id="55" name="TextBox 54"/>
+          <p:cNvSpPr txBox="1"/>
+          <p:nvPr/>
+        </p:nvSpPr>
+        <p:spPr>
+          <a:xfrm>
+            <a:off x="640080" y="4846320"/>
+            <a:ext cx="5135727" cy="457200"/>
+          </a:xfrm>
+          <a:prstGeom prst="rect">
+            <a:avLst/>
+          </a:prstGeom>
+          <a:noFill/>
+        </p:spPr>
+        <p:txBody>
+          <a:bodyPr wrap="square" anchor="ctr" lIns="36576" rIns="36576" tIns="0" bIns="0">
+            <a:spAutoFit/>
+          </a:bodyPr>
+          <a:lstStyle/>
+          <a:p>
+            <a:pPr algn="r" rtl="1"/>
+            <a:r>
+              <a:rPr sz="1500" b="1">
+                <a:solidFill>
+                  <a:srgbClr val="1A2233"/>
+                </a:solidFill>
+                <a:latin typeface="Heebo"/>
+                <a:cs typeface="Heebo"/>
+              </a:rPr>
+              <a:t>• לוקח חלק פעיל בסדר היום של הארגון</a:t>
+            </a:r>
+          </a:p>
+        </p:txBody>
+      </p:sp>
+      <p:sp>
+        <p:nvSpPr>
+          <p:cNvPr id="56" name="TextBox 55"/>
+          <p:cNvSpPr txBox="1"/>
+          <p:nvPr/>
+        </p:nvSpPr>
+        <p:spPr>
+          <a:xfrm>
+            <a:off x="640080" y="5394960"/>
+            <a:ext cx="5135727" cy="457200"/>
+          </a:xfrm>
+          <a:prstGeom prst="rect">
+            <a:avLst/>
+          </a:prstGeom>
+          <a:noFill/>
+        </p:spPr>
+        <p:txBody>
+          <a:bodyPr wrap="square" anchor="ctr" lIns="36576" rIns="36576" tIns="0" bIns="0">
+            <a:spAutoFit/>
+          </a:bodyPr>
+          <a:lstStyle/>
+          <a:p>
+            <a:pPr algn="r" rtl="1"/>
+            <a:r>
+              <a:rPr sz="1500" b="1">
+                <a:solidFill>
+                  <a:srgbClr val="1A2233"/>
+                </a:solidFill>
+                <a:latin typeface="Heebo"/>
+                <a:cs typeface="Heebo"/>
+              </a:rPr>
+              <a:t>• איתו בונים את החשיפה בתקשורת וברשתות</a:t>
             </a:r>
           </a:p>
         </p:txBody>

</xml_diff>

<commit_message>
Third representative: Amir Rubin or Odelia Kadmi
Co-Authored-By: Claude Opus 5.5 <noreply@anthropic.com>
Claude-Session: https://claude.ai/code/session_01W7Er83FuNT4pLFShWidYHn
</commit_message>
<xml_diff>
--- a/presentation/out/koach-hitarvut.pptx
+++ b/presentation/out/koach-hitarvut.pptx
@@ -19178,7 +19178,7 @@
                 <a:latin typeface="Heebo"/>
                 <a:cs typeface="Heebo"/>
               </a:rPr>
-              <a:t>נציג קבוע</a:t>
+              <a:t>או עו״ד אודליה קדמי</a:t>
             </a:r>
           </a:p>
         </p:txBody>
@@ -27520,8 +27520,8 @@
         </p:nvSpPr>
         <p:spPr>
           <a:xfrm>
-            <a:off x="7699822" y="4480560"/>
-            <a:ext cx="1238211" cy="502920"/>
+            <a:off x="7699822" y="4535424"/>
+            <a:ext cx="1238211" cy="261518"/>
           </a:xfrm>
           <a:prstGeom prst="rect">
             <a:avLst/>
@@ -27529,7 +27529,7 @@
           <a:noFill/>
         </p:spPr>
         <p:txBody>
-          <a:bodyPr wrap="square" anchor="ctr" lIns="36576" rIns="36576" tIns="0" bIns="0">
+          <a:bodyPr wrap="square" anchor="b" lIns="36576" rIns="36576" tIns="0" bIns="0">
             <a:spAutoFit/>
           </a:bodyPr>
           <a:lstStyle/>
@@ -27550,7 +27550,43 @@
       </p:sp>
       <p:sp>
         <p:nvSpPr>
-          <p:cNvPr id="47" name="Rounded Rectangle 46"/>
+          <p:cNvPr id="47" name="TextBox 46"/>
+          <p:cNvSpPr txBox="1"/>
+          <p:nvPr/>
+        </p:nvSpPr>
+        <p:spPr>
+          <a:xfrm>
+            <a:off x="7699822" y="4757166"/>
+            <a:ext cx="1238211" cy="201168"/>
+          </a:xfrm>
+          <a:prstGeom prst="rect">
+            <a:avLst/>
+          </a:prstGeom>
+          <a:noFill/>
+        </p:spPr>
+        <p:txBody>
+          <a:bodyPr wrap="square" anchor="t" lIns="36576" rIns="36576" tIns="0" bIns="0">
+            <a:spAutoFit/>
+          </a:bodyPr>
+          <a:lstStyle/>
+          <a:p>
+            <a:pPr algn="ctr" rtl="1"/>
+            <a:r>
+              <a:rPr sz="900" b="0">
+                <a:solidFill>
+                  <a:srgbClr val="8A94A8"/>
+                </a:solidFill>
+                <a:latin typeface="Heebo"/>
+                <a:cs typeface="Heebo"/>
+              </a:rPr>
+              <a:t>או עו״ד אודליה קדמי</a:t>
+            </a:r>
+          </a:p>
+        </p:txBody>
+      </p:sp>
+      <p:sp>
+        <p:nvSpPr>
+          <p:cNvPr id="48" name="Rounded Rectangle 47"/>
           <p:cNvSpPr/>
           <p:nvPr/>
         </p:nvSpPr>
@@ -27597,7 +27633,7 @@
       </p:sp>
       <p:sp>
         <p:nvSpPr>
-          <p:cNvPr id="48" name="TextBox 47"/>
+          <p:cNvPr id="49" name="TextBox 48"/>
           <p:cNvSpPr txBox="1"/>
           <p:nvPr/>
         </p:nvSpPr>
@@ -27633,7 +27669,7 @@
       </p:sp>
       <p:sp>
         <p:nvSpPr>
-          <p:cNvPr id="49" name="TextBox 48"/>
+          <p:cNvPr id="50" name="TextBox 49"/>
           <p:cNvSpPr txBox="1"/>
           <p:nvPr/>
         </p:nvSpPr>
@@ -27669,7 +27705,7 @@
       </p:sp>
       <p:sp>
         <p:nvSpPr>
-          <p:cNvPr id="50" name="Rounded Rectangle 49"/>
+          <p:cNvPr id="51" name="Rounded Rectangle 50"/>
           <p:cNvSpPr/>
           <p:nvPr/>
         </p:nvSpPr>
@@ -27715,7 +27751,7 @@
       </p:sp>
       <p:sp>
         <p:nvSpPr>
-          <p:cNvPr id="51" name="TextBox 50"/>
+          <p:cNvPr id="52" name="TextBox 51"/>
           <p:cNvSpPr txBox="1"/>
           <p:nvPr/>
         </p:nvSpPr>
@@ -27751,7 +27787,7 @@
       </p:sp>
       <p:sp>
         <p:nvSpPr>
-          <p:cNvPr id="52" name="Rounded Rectangle 51"/>
+          <p:cNvPr id="53" name="Rounded Rectangle 52"/>
           <p:cNvSpPr/>
           <p:nvPr/>
         </p:nvSpPr>
@@ -27799,7 +27835,7 @@
       </p:sp>
       <p:sp>
         <p:nvSpPr>
-          <p:cNvPr id="53" name="TextBox 52"/>
+          <p:cNvPr id="54" name="TextBox 53"/>
           <p:cNvSpPr txBox="1"/>
           <p:nvPr/>
         </p:nvSpPr>
@@ -27835,7 +27871,7 @@
       </p:sp>
       <p:sp>
         <p:nvSpPr>
-          <p:cNvPr id="54" name="TextBox 53"/>
+          <p:cNvPr id="55" name="TextBox 54"/>
           <p:cNvSpPr txBox="1"/>
           <p:nvPr/>
         </p:nvSpPr>
@@ -27871,7 +27907,7 @@
       </p:sp>
       <p:sp>
         <p:nvSpPr>
-          <p:cNvPr id="55" name="TextBox 54"/>
+          <p:cNvPr id="56" name="TextBox 55"/>
           <p:cNvSpPr txBox="1"/>
           <p:nvPr/>
         </p:nvSpPr>
@@ -27907,7 +27943,7 @@
       </p:sp>
       <p:sp>
         <p:nvSpPr>
-          <p:cNvPr id="56" name="TextBox 55"/>
+          <p:cNvPr id="57" name="TextBox 56"/>
           <p:cNvSpPr txBox="1"/>
           <p:nvPr/>
         </p:nvSpPr>

</xml_diff>

<commit_message>
Activity slide: weekly Knesset schedule and agenda planning
Co-Authored-By: Claude Opus 5.5 <noreply@anthropic.com>
Claude-Session: https://claude.ai/code/session_01W7Er83FuNT4pLFShWidYHn
</commit_message>
<xml_diff>
--- a/presentation/out/koach-hitarvut.pptx
+++ b/presentation/out/koach-hitarvut.pptx
@@ -26145,7 +26145,7 @@
                 <a:latin typeface="Heebo"/>
                 <a:cs typeface="Heebo"/>
               </a:rPr>
-              <a:t>2 ימי כנסת מלאים</a:t>
+              <a:t>לפחות 2 ימי כנסת מלאים</a:t>
             </a:r>
           </a:p>
         </p:txBody>
@@ -26312,8 +26312,8 @@
         </p:nvSpPr>
         <p:spPr>
           <a:xfrm>
-            <a:off x="9608881" y="2240280"/>
-            <a:ext cx="2171334" cy="1463040"/>
+            <a:off x="9608881" y="2194560"/>
+            <a:ext cx="2171334" cy="1188720"/>
           </a:xfrm>
           <a:prstGeom prst="roundRect">
             <a:avLst>
@@ -26360,7 +26360,7 @@
         </p:nvSpPr>
         <p:spPr>
           <a:xfrm>
-            <a:off x="9608881" y="2331720"/>
+            <a:off x="9608881" y="2286000"/>
             <a:ext cx="2171334" cy="274320"/>
           </a:xfrm>
           <a:prstGeom prst="rect">
@@ -26396,8 +26396,8 @@
         </p:nvSpPr>
         <p:spPr>
           <a:xfrm>
-            <a:off x="9700321" y="2624328"/>
-            <a:ext cx="1988454" cy="457200"/>
+            <a:off x="9700321" y="2542032"/>
+            <a:ext cx="1988454" cy="411480"/>
           </a:xfrm>
           <a:prstGeom prst="rect">
             <a:avLst/>
@@ -26432,8 +26432,8 @@
         </p:nvSpPr>
         <p:spPr>
           <a:xfrm>
-            <a:off x="9700321" y="3108960"/>
-            <a:ext cx="1988454" cy="502920"/>
+            <a:off x="9700321" y="2944368"/>
+            <a:ext cx="1988454" cy="411480"/>
           </a:xfrm>
           <a:prstGeom prst="rect">
             <a:avLst/>
@@ -26455,7 +26455,7 @@
                 <a:latin typeface="Heebo"/>
                 <a:cs typeface="Heebo"/>
               </a:rPr>
-              <a:t>צוות המחקר מכין ניירות ותדריך לנציג</a:t>
+              <a:t>דיון במידה ויש · צוות המחקר מכין ניירות ותדריך</a:t>
             </a:r>
           </a:p>
         </p:txBody>
@@ -26468,8 +26468,8 @@
         </p:nvSpPr>
         <p:spPr>
           <a:xfrm>
-            <a:off x="7309531" y="2240280"/>
-            <a:ext cx="2171334" cy="1463040"/>
+            <a:off x="7309531" y="2194560"/>
+            <a:ext cx="2171334" cy="1188720"/>
           </a:xfrm>
           <a:prstGeom prst="roundRect">
             <a:avLst>
@@ -26514,7 +26514,7 @@
         </p:nvSpPr>
         <p:spPr>
           <a:xfrm>
-            <a:off x="7309531" y="2331720"/>
+            <a:off x="7309531" y="2286000"/>
             <a:ext cx="2171334" cy="274320"/>
           </a:xfrm>
           <a:prstGeom prst="rect">
@@ -26550,8 +26550,8 @@
         </p:nvSpPr>
         <p:spPr>
           <a:xfrm>
-            <a:off x="7400971" y="2624328"/>
-            <a:ext cx="1988454" cy="457200"/>
+            <a:off x="7400971" y="2542032"/>
+            <a:ext cx="1988454" cy="411480"/>
           </a:xfrm>
           <a:prstGeom prst="rect">
             <a:avLst/>
@@ -26573,7 +26573,7 @@
                 <a:latin typeface="Heebo"/>
                 <a:cs typeface="Heebo"/>
               </a:rPr>
-              <a:t>יום כנסת מלא</a:t>
+              <a:t>דיונים</a:t>
             </a:r>
           </a:p>
         </p:txBody>
@@ -26586,8 +26586,8 @@
         </p:nvSpPr>
         <p:spPr>
           <a:xfrm>
-            <a:off x="7400971" y="3108960"/>
-            <a:ext cx="1988454" cy="502920"/>
+            <a:off x="7400971" y="2944368"/>
+            <a:ext cx="1988454" cy="411480"/>
           </a:xfrm>
           <a:prstGeom prst="rect">
             <a:avLst/>
@@ -26609,7 +26609,7 @@
                 <a:latin typeface="Heebo"/>
                 <a:cs typeface="Heebo"/>
               </a:rPr>
-              <a:t>דיונים בוועדות ופגישות עם חברי כנסת</a:t>
+              <a:t>בוועדות הכנסת</a:t>
             </a:r>
           </a:p>
         </p:txBody>
@@ -26622,8 +26622,8 @@
         </p:nvSpPr>
         <p:spPr>
           <a:xfrm>
-            <a:off x="5010181" y="2240280"/>
-            <a:ext cx="2171334" cy="1463040"/>
+            <a:off x="5010181" y="2194560"/>
+            <a:ext cx="2171334" cy="1188720"/>
           </a:xfrm>
           <a:prstGeom prst="roundRect">
             <a:avLst>
@@ -26668,7 +26668,7 @@
         </p:nvSpPr>
         <p:spPr>
           <a:xfrm>
-            <a:off x="5010181" y="2331720"/>
+            <a:off x="5010181" y="2286000"/>
             <a:ext cx="2171334" cy="274320"/>
           </a:xfrm>
           <a:prstGeom prst="rect">
@@ -26704,8 +26704,8 @@
         </p:nvSpPr>
         <p:spPr>
           <a:xfrm>
-            <a:off x="5101621" y="2624328"/>
-            <a:ext cx="1988454" cy="457200"/>
+            <a:off x="5101621" y="2542032"/>
+            <a:ext cx="1988454" cy="411480"/>
           </a:xfrm>
           <a:prstGeom prst="rect">
             <a:avLst/>
@@ -26727,7 +26727,7 @@
                 <a:latin typeface="Heebo"/>
                 <a:cs typeface="Heebo"/>
               </a:rPr>
-              <a:t>יום כנסת מלא</a:t>
+              <a:t>דיונים</a:t>
             </a:r>
           </a:p>
         </p:txBody>
@@ -26740,8 +26740,8 @@
         </p:nvSpPr>
         <p:spPr>
           <a:xfrm>
-            <a:off x="5101621" y="3108960"/>
-            <a:ext cx="1988454" cy="502920"/>
+            <a:off x="5101621" y="2944368"/>
+            <a:ext cx="1988454" cy="411480"/>
           </a:xfrm>
           <a:prstGeom prst="rect">
             <a:avLst/>
@@ -26763,7 +26763,7 @@
                 <a:latin typeface="Heebo"/>
                 <a:cs typeface="Heebo"/>
               </a:rPr>
-              <a:t>דיונים בוועדות ופגישות עם חברי כנסת</a:t>
+              <a:t>בוועדות הכנסת</a:t>
             </a:r>
           </a:p>
         </p:txBody>
@@ -26776,8 +26776,8 @@
         </p:nvSpPr>
         <p:spPr>
           <a:xfrm>
-            <a:off x="2710831" y="2240280"/>
-            <a:ext cx="2171334" cy="1463040"/>
+            <a:off x="2710831" y="2194560"/>
+            <a:ext cx="2171334" cy="1188720"/>
           </a:xfrm>
           <a:prstGeom prst="roundRect">
             <a:avLst>
@@ -26785,6 +26785,432 @@
             </a:avLst>
           </a:prstGeom>
           <a:solidFill>
+            <a:srgbClr val="F0C000"/>
+          </a:solidFill>
+          <a:ln>
+            <a:noFill/>
+          </a:ln>
+          <a:effectLst/>
+        </p:spPr>
+        <p:style>
+          <a:lnRef idx="1">
+            <a:schemeClr val="accent1"/>
+          </a:lnRef>
+          <a:fillRef idx="3">
+            <a:schemeClr val="accent1"/>
+          </a:fillRef>
+          <a:effectRef idx="2">
+            <a:schemeClr val="accent1"/>
+          </a:effectRef>
+          <a:fontRef idx="minor">
+            <a:schemeClr val="lt1"/>
+          </a:fontRef>
+        </p:style>
+        <p:txBody>
+          <a:bodyPr rtlCol="0" anchor="ctr"/>
+          <a:lstStyle/>
+          <a:p>
+            <a:pPr algn="ctr"/>
+          </a:p>
+        </p:txBody>
+      </p:sp>
+      <p:sp>
+        <p:nvSpPr>
+          <p:cNvPr id="29" name="TextBox 28"/>
+          <p:cNvSpPr txBox="1"/>
+          <p:nvPr/>
+        </p:nvSpPr>
+        <p:spPr>
+          <a:xfrm>
+            <a:off x="2710831" y="2286000"/>
+            <a:ext cx="2171334" cy="274320"/>
+          </a:xfrm>
+          <a:prstGeom prst="rect">
+            <a:avLst/>
+          </a:prstGeom>
+          <a:noFill/>
+        </p:spPr>
+        <p:txBody>
+          <a:bodyPr wrap="square" anchor="ctr" lIns="36576" rIns="36576" tIns="0" bIns="0">
+            <a:spAutoFit/>
+          </a:bodyPr>
+          <a:lstStyle/>
+          <a:p>
+            <a:pPr algn="ctr" rtl="1"/>
+            <a:r>
+              <a:rPr sz="1200" b="1">
+                <a:solidFill>
+                  <a:srgbClr val="122755"/>
+                </a:solidFill>
+                <a:latin typeface="Heebo"/>
+                <a:cs typeface="Heebo"/>
+              </a:rPr>
+              <a:t>רביעי</a:t>
+            </a:r>
+          </a:p>
+        </p:txBody>
+      </p:sp>
+      <p:sp>
+        <p:nvSpPr>
+          <p:cNvPr id="30" name="TextBox 29"/>
+          <p:cNvSpPr txBox="1"/>
+          <p:nvPr/>
+        </p:nvSpPr>
+        <p:spPr>
+          <a:xfrm>
+            <a:off x="2802271" y="2542032"/>
+            <a:ext cx="1988454" cy="411480"/>
+          </a:xfrm>
+          <a:prstGeom prst="rect">
+            <a:avLst/>
+          </a:prstGeom>
+          <a:noFill/>
+        </p:spPr>
+        <p:txBody>
+          <a:bodyPr wrap="square" anchor="ctr" lIns="36576" rIns="36576" tIns="0" bIns="0">
+            <a:spAutoFit/>
+          </a:bodyPr>
+          <a:lstStyle/>
+          <a:p>
+            <a:pPr algn="ctr" rtl="1"/>
+            <a:r>
+              <a:rPr sz="1500" b="1">
+                <a:solidFill>
+                  <a:srgbClr val="122755"/>
+                </a:solidFill>
+                <a:latin typeface="Heebo"/>
+                <a:cs typeface="Heebo"/>
+              </a:rPr>
+              <a:t>דיונים</a:t>
+            </a:r>
+          </a:p>
+        </p:txBody>
+      </p:sp>
+      <p:sp>
+        <p:nvSpPr>
+          <p:cNvPr id="31" name="TextBox 30"/>
+          <p:cNvSpPr txBox="1"/>
+          <p:nvPr/>
+        </p:nvSpPr>
+        <p:spPr>
+          <a:xfrm>
+            <a:off x="2802271" y="2944368"/>
+            <a:ext cx="1988454" cy="411480"/>
+          </a:xfrm>
+          <a:prstGeom prst="rect">
+            <a:avLst/>
+          </a:prstGeom>
+          <a:noFill/>
+        </p:spPr>
+        <p:txBody>
+          <a:bodyPr wrap="square" anchor="t" lIns="36576" rIns="36576" tIns="0" bIns="0">
+            <a:spAutoFit/>
+          </a:bodyPr>
+          <a:lstStyle/>
+          <a:p>
+            <a:pPr algn="ctr" rtl="1"/>
+            <a:r>
+              <a:rPr sz="1100" b="0">
+                <a:solidFill>
+                  <a:srgbClr val="122755"/>
+                </a:solidFill>
+                <a:latin typeface="Heebo"/>
+                <a:cs typeface="Heebo"/>
+              </a:rPr>
+              <a:t>בוועדות הכנסת</a:t>
+            </a:r>
+          </a:p>
+        </p:txBody>
+      </p:sp>
+      <p:sp>
+        <p:nvSpPr>
+          <p:cNvPr id="32" name="Rounded Rectangle 31"/>
+          <p:cNvSpPr/>
+          <p:nvPr/>
+        </p:nvSpPr>
+        <p:spPr>
+          <a:xfrm>
+            <a:off x="411481" y="2194560"/>
+            <a:ext cx="2171334" cy="1188720"/>
+          </a:xfrm>
+          <a:prstGeom prst="roundRect">
+            <a:avLst>
+              <a:gd name="adj" fmla="val 10000"/>
+            </a:avLst>
+          </a:prstGeom>
+          <a:solidFill>
+            <a:srgbClr val="F0C000"/>
+          </a:solidFill>
+          <a:ln>
+            <a:noFill/>
+          </a:ln>
+          <a:effectLst/>
+        </p:spPr>
+        <p:style>
+          <a:lnRef idx="1">
+            <a:schemeClr val="accent1"/>
+          </a:lnRef>
+          <a:fillRef idx="3">
+            <a:schemeClr val="accent1"/>
+          </a:fillRef>
+          <a:effectRef idx="2">
+            <a:schemeClr val="accent1"/>
+          </a:effectRef>
+          <a:fontRef idx="minor">
+            <a:schemeClr val="lt1"/>
+          </a:fontRef>
+        </p:style>
+        <p:txBody>
+          <a:bodyPr rtlCol="0" anchor="ctr"/>
+          <a:lstStyle/>
+          <a:p>
+            <a:pPr algn="ctr"/>
+          </a:p>
+        </p:txBody>
+      </p:sp>
+      <p:sp>
+        <p:nvSpPr>
+          <p:cNvPr id="33" name="TextBox 32"/>
+          <p:cNvSpPr txBox="1"/>
+          <p:nvPr/>
+        </p:nvSpPr>
+        <p:spPr>
+          <a:xfrm>
+            <a:off x="411481" y="2286000"/>
+            <a:ext cx="2171334" cy="274320"/>
+          </a:xfrm>
+          <a:prstGeom prst="rect">
+            <a:avLst/>
+          </a:prstGeom>
+          <a:noFill/>
+        </p:spPr>
+        <p:txBody>
+          <a:bodyPr wrap="square" anchor="ctr" lIns="36576" rIns="36576" tIns="0" bIns="0">
+            <a:spAutoFit/>
+          </a:bodyPr>
+          <a:lstStyle/>
+          <a:p>
+            <a:pPr algn="ctr" rtl="1"/>
+            <a:r>
+              <a:rPr sz="1200" b="1">
+                <a:solidFill>
+                  <a:srgbClr val="122755"/>
+                </a:solidFill>
+                <a:latin typeface="Heebo"/>
+                <a:cs typeface="Heebo"/>
+              </a:rPr>
+              <a:t>חמישי</a:t>
+            </a:r>
+          </a:p>
+        </p:txBody>
+      </p:sp>
+      <p:sp>
+        <p:nvSpPr>
+          <p:cNvPr id="34" name="TextBox 33"/>
+          <p:cNvSpPr txBox="1"/>
+          <p:nvPr/>
+        </p:nvSpPr>
+        <p:spPr>
+          <a:xfrm>
+            <a:off x="502921" y="2542032"/>
+            <a:ext cx="1988454" cy="411480"/>
+          </a:xfrm>
+          <a:prstGeom prst="rect">
+            <a:avLst/>
+          </a:prstGeom>
+          <a:noFill/>
+        </p:spPr>
+        <p:txBody>
+          <a:bodyPr wrap="square" anchor="ctr" lIns="36576" rIns="36576" tIns="0" bIns="0">
+            <a:spAutoFit/>
+          </a:bodyPr>
+          <a:lstStyle/>
+          <a:p>
+            <a:pPr algn="ctr" rtl="1"/>
+            <a:r>
+              <a:rPr sz="1500" b="1">
+                <a:solidFill>
+                  <a:srgbClr val="122755"/>
+                </a:solidFill>
+                <a:latin typeface="Heebo"/>
+                <a:cs typeface="Heebo"/>
+              </a:rPr>
+              <a:t>דיונים</a:t>
+            </a:r>
+          </a:p>
+        </p:txBody>
+      </p:sp>
+      <p:sp>
+        <p:nvSpPr>
+          <p:cNvPr id="35" name="TextBox 34"/>
+          <p:cNvSpPr txBox="1"/>
+          <p:nvPr/>
+        </p:nvSpPr>
+        <p:spPr>
+          <a:xfrm>
+            <a:off x="502921" y="2944368"/>
+            <a:ext cx="1988454" cy="411480"/>
+          </a:xfrm>
+          <a:prstGeom prst="rect">
+            <a:avLst/>
+          </a:prstGeom>
+          <a:noFill/>
+        </p:spPr>
+        <p:txBody>
+          <a:bodyPr wrap="square" anchor="t" lIns="36576" rIns="36576" tIns="0" bIns="0">
+            <a:spAutoFit/>
+          </a:bodyPr>
+          <a:lstStyle/>
+          <a:p>
+            <a:pPr algn="ctr" rtl="1"/>
+            <a:r>
+              <a:rPr sz="1100" b="0">
+                <a:solidFill>
+                  <a:srgbClr val="122755"/>
+                </a:solidFill>
+                <a:latin typeface="Heebo"/>
+                <a:cs typeface="Heebo"/>
+              </a:rPr>
+              <a:t>בוועדות הכנסת</a:t>
+            </a:r>
+          </a:p>
+        </p:txBody>
+      </p:sp>
+      <p:sp>
+        <p:nvSpPr>
+          <p:cNvPr id="36" name="Rounded Rectangle 35"/>
+          <p:cNvSpPr/>
+          <p:nvPr/>
+        </p:nvSpPr>
+        <p:spPr>
+          <a:xfrm>
+            <a:off x="411481" y="3474720"/>
+            <a:ext cx="4470684" cy="566928"/>
+          </a:xfrm>
+          <a:prstGeom prst="roundRect">
+            <a:avLst>
+              <a:gd name="adj" fmla="val 18000"/>
+            </a:avLst>
+          </a:prstGeom>
+          <a:solidFill>
+            <a:srgbClr val="1C3C7A"/>
+          </a:solidFill>
+          <a:ln>
+            <a:noFill/>
+          </a:ln>
+          <a:effectLst/>
+        </p:spPr>
+        <p:style>
+          <a:lnRef idx="1">
+            <a:schemeClr val="accent1"/>
+          </a:lnRef>
+          <a:fillRef idx="3">
+            <a:schemeClr val="accent1"/>
+          </a:fillRef>
+          <a:effectRef idx="2">
+            <a:schemeClr val="accent1"/>
+          </a:effectRef>
+          <a:fontRef idx="minor">
+            <a:schemeClr val="lt1"/>
+          </a:fontRef>
+        </p:style>
+        <p:txBody>
+          <a:bodyPr rtlCol="0" anchor="ctr"/>
+          <a:lstStyle/>
+          <a:p>
+            <a:pPr algn="ctr"/>
+          </a:p>
+        </p:txBody>
+      </p:sp>
+      <p:sp>
+        <p:nvSpPr>
+          <p:cNvPr id="37" name="TextBox 36"/>
+          <p:cNvSpPr txBox="1"/>
+          <p:nvPr/>
+        </p:nvSpPr>
+        <p:spPr>
+          <a:xfrm>
+            <a:off x="548641" y="3511296"/>
+            <a:ext cx="4196364" cy="274320"/>
+          </a:xfrm>
+          <a:prstGeom prst="rect">
+            <a:avLst/>
+          </a:prstGeom>
+          <a:noFill/>
+        </p:spPr>
+        <p:txBody>
+          <a:bodyPr wrap="square" anchor="ctr" lIns="36576" rIns="36576" tIns="0" bIns="0">
+            <a:spAutoFit/>
+          </a:bodyPr>
+          <a:lstStyle/>
+          <a:p>
+            <a:pPr algn="ctr" rtl="1"/>
+            <a:r>
+              <a:rPr sz="1300" b="1">
+                <a:solidFill>
+                  <a:srgbClr val="FFFFFF"/>
+                </a:solidFill>
+                <a:latin typeface="Heebo"/>
+                <a:cs typeface="Heebo"/>
+              </a:rPr>
+              <a:t>קביעת סדר היום לשבוע הבא</a:t>
+            </a:r>
+          </a:p>
+        </p:txBody>
+      </p:sp>
+      <p:sp>
+        <p:nvSpPr>
+          <p:cNvPr id="38" name="TextBox 37"/>
+          <p:cNvSpPr txBox="1"/>
+          <p:nvPr/>
+        </p:nvSpPr>
+        <p:spPr>
+          <a:xfrm>
+            <a:off x="548641" y="3767328"/>
+            <a:ext cx="4196364" cy="237744"/>
+          </a:xfrm>
+          <a:prstGeom prst="rect">
+            <a:avLst/>
+          </a:prstGeom>
+          <a:noFill/>
+        </p:spPr>
+        <p:txBody>
+          <a:bodyPr wrap="square" anchor="ctr" lIns="36576" rIns="36576" tIns="0" bIns="0">
+            <a:spAutoFit/>
+          </a:bodyPr>
+          <a:lstStyle/>
+          <a:p>
+            <a:pPr algn="ctr" rtl="1"/>
+            <a:r>
+              <a:rPr sz="1000" b="0">
+                <a:solidFill>
+                  <a:srgbClr val="F0C000"/>
+                </a:solidFill>
+                <a:latin typeface="Heebo"/>
+                <a:cs typeface="Heebo"/>
+              </a:rPr>
+              <a:t>העברה לצוות המחקר ושיבוץ לדיונים · לא יאוחר מחמישי בבוקר</a:t>
+            </a:r>
+          </a:p>
+        </p:txBody>
+      </p:sp>
+      <p:sp>
+        <p:nvSpPr>
+          <p:cNvPr id="39" name="Rounded Rectangle 38"/>
+          <p:cNvSpPr/>
+          <p:nvPr/>
+        </p:nvSpPr>
+        <p:spPr>
+          <a:xfrm>
+            <a:off x="6187288" y="4160520"/>
+            <a:ext cx="5592927" cy="2331720"/>
+          </a:xfrm>
+          <a:prstGeom prst="roundRect">
+            <a:avLst>
+              <a:gd name="adj" fmla="val 6000"/>
+            </a:avLst>
+          </a:prstGeom>
+          <a:solidFill>
             <a:srgbClr val="FFFFFF"/>
           </a:solidFill>
           <a:ln w="15875">
@@ -26818,14 +27244,14 @@
       </p:sp>
       <p:sp>
         <p:nvSpPr>
-          <p:cNvPr id="29" name="TextBox 28"/>
+          <p:cNvPr id="40" name="TextBox 39"/>
           <p:cNvSpPr txBox="1"/>
           <p:nvPr/>
         </p:nvSpPr>
         <p:spPr>
           <a:xfrm>
-            <a:off x="2710831" y="2331720"/>
-            <a:ext cx="2171334" cy="274320"/>
+            <a:off x="6370168" y="4270248"/>
+            <a:ext cx="5227167" cy="329184"/>
           </a:xfrm>
           <a:prstGeom prst="rect">
             <a:avLst/>
@@ -26838,106 +27264,34 @@
           </a:bodyPr>
           <a:lstStyle/>
           <a:p>
-            <a:pPr algn="ctr" rtl="1"/>
-            <a:r>
-              <a:rPr sz="1200" b="1">
-                <a:solidFill>
-                  <a:srgbClr val="8A94A8"/>
+            <a:pPr algn="r" rtl="1"/>
+            <a:r>
+              <a:rPr sz="1600" b="1">
+                <a:solidFill>
+                  <a:srgbClr val="1C3C7A"/>
                 </a:solidFill>
                 <a:latin typeface="Heebo"/>
                 <a:cs typeface="Heebo"/>
               </a:rPr>
-              <a:t>רביעי</a:t>
-            </a:r>
-          </a:p>
-        </p:txBody>
-      </p:sp>
-      <p:sp>
-        <p:nvSpPr>
-          <p:cNvPr id="30" name="TextBox 29"/>
-          <p:cNvSpPr txBox="1"/>
-          <p:nvPr/>
-        </p:nvSpPr>
-        <p:spPr>
-          <a:xfrm>
-            <a:off x="2802271" y="2624328"/>
-            <a:ext cx="1988454" cy="457200"/>
-          </a:xfrm>
-          <a:prstGeom prst="rect">
-            <a:avLst/>
-          </a:prstGeom>
-          <a:noFill/>
-        </p:spPr>
-        <p:txBody>
-          <a:bodyPr wrap="square" anchor="ctr" lIns="36576" rIns="36576" tIns="0" bIns="0">
-            <a:spAutoFit/>
-          </a:bodyPr>
-          <a:lstStyle/>
-          <a:p>
-            <a:pPr algn="ctr" rtl="1"/>
-            <a:r>
-              <a:rPr sz="1500" b="1">
-                <a:solidFill>
-                  <a:srgbClr val="1C3C7A"/>
-                </a:solidFill>
-                <a:latin typeface="Heebo"/>
-                <a:cs typeface="Heebo"/>
-              </a:rPr>
-              <a:t>דיון נוסף לפי הצורך</a:t>
-            </a:r>
-          </a:p>
-        </p:txBody>
-      </p:sp>
-      <p:sp>
-        <p:nvSpPr>
-          <p:cNvPr id="31" name="TextBox 30"/>
-          <p:cNvSpPr txBox="1"/>
-          <p:nvPr/>
-        </p:nvSpPr>
-        <p:spPr>
-          <a:xfrm>
-            <a:off x="2802271" y="3108960"/>
-            <a:ext cx="1988454" cy="502920"/>
-          </a:xfrm>
-          <a:prstGeom prst="rect">
-            <a:avLst/>
-          </a:prstGeom>
-          <a:noFill/>
-        </p:spPr>
-        <p:txBody>
-          <a:bodyPr wrap="square" anchor="t" lIns="36576" rIns="36576" tIns="0" bIns="0">
-            <a:spAutoFit/>
-          </a:bodyPr>
-          <a:lstStyle/>
-          <a:p>
-            <a:pPr algn="ctr" rtl="1"/>
-            <a:r>
-              <a:rPr sz="1100" b="0">
-                <a:solidFill>
-                  <a:srgbClr val="1A2233"/>
-                </a:solidFill>
-                <a:latin typeface="Heebo"/>
-                <a:cs typeface="Heebo"/>
-              </a:rPr>
-              <a:t>נציג, או אקטיביסט שמשלים</a:t>
-            </a:r>
-          </a:p>
-        </p:txBody>
-      </p:sp>
-      <p:sp>
-        <p:nvSpPr>
-          <p:cNvPr id="32" name="Rounded Rectangle 31"/>
-          <p:cNvSpPr/>
-          <p:nvPr/>
-        </p:nvSpPr>
-        <p:spPr>
-          <a:xfrm>
-            <a:off x="411481" y="2240280"/>
-            <a:ext cx="2171334" cy="1463040"/>
+              <a:t>מי הולך לכנסת</a:t>
+            </a:r>
+          </a:p>
+        </p:txBody>
+      </p:sp>
+      <p:sp>
+        <p:nvSpPr>
+          <p:cNvPr id="41" name="Rounded Rectangle 40"/>
+          <p:cNvSpPr/>
+          <p:nvPr/>
+        </p:nvSpPr>
+        <p:spPr>
+          <a:xfrm>
+            <a:off x="10359124" y="4709160"/>
+            <a:ext cx="1238211" cy="502920"/>
           </a:xfrm>
           <a:prstGeom prst="roundRect">
             <a:avLst>
-              <a:gd name="adj" fmla="val 10000"/>
+              <a:gd name="adj" fmla="val 18000"/>
             </a:avLst>
           </a:prstGeom>
           <a:solidFill>
@@ -26974,14 +27328,58 @@
       </p:sp>
       <p:sp>
         <p:nvSpPr>
-          <p:cNvPr id="33" name="TextBox 32"/>
+          <p:cNvPr id="42" name="Rectangle 41"/>
+          <p:cNvSpPr/>
+          <p:nvPr/>
+        </p:nvSpPr>
+        <p:spPr>
+          <a:xfrm>
+            <a:off x="11533327" y="4782312"/>
+            <a:ext cx="45720" cy="356616"/>
+          </a:xfrm>
+          <a:prstGeom prst="rect">
+            <a:avLst/>
+          </a:prstGeom>
+          <a:solidFill>
+            <a:srgbClr val="F0C000"/>
+          </a:solidFill>
+          <a:ln>
+            <a:noFill/>
+          </a:ln>
+          <a:effectLst/>
+        </p:spPr>
+        <p:style>
+          <a:lnRef idx="1">
+            <a:schemeClr val="accent1"/>
+          </a:lnRef>
+          <a:fillRef idx="3">
+            <a:schemeClr val="accent1"/>
+          </a:fillRef>
+          <a:effectRef idx="2">
+            <a:schemeClr val="accent1"/>
+          </a:effectRef>
+          <a:fontRef idx="minor">
+            <a:schemeClr val="lt1"/>
+          </a:fontRef>
+        </p:style>
+        <p:txBody>
+          <a:bodyPr rtlCol="0" anchor="ctr"/>
+          <a:lstStyle/>
+          <a:p>
+            <a:pPr algn="ctr"/>
+          </a:p>
+        </p:txBody>
+      </p:sp>
+      <p:sp>
+        <p:nvSpPr>
+          <p:cNvPr id="43" name="TextBox 42"/>
           <p:cNvSpPr txBox="1"/>
           <p:nvPr/>
         </p:nvSpPr>
         <p:spPr>
           <a:xfrm>
-            <a:off x="411481" y="2331720"/>
-            <a:ext cx="2171334" cy="274320"/>
+            <a:off x="10359124" y="4709160"/>
+            <a:ext cx="1238211" cy="502920"/>
           </a:xfrm>
           <a:prstGeom prst="rect">
             <a:avLst/>
@@ -26998,102 +27396,30 @@
             <a:r>
               <a:rPr sz="1200" b="1">
                 <a:solidFill>
-                  <a:srgbClr val="8A94A8"/>
+                  <a:srgbClr val="1A2233"/>
                 </a:solidFill>
                 <a:latin typeface="Heebo"/>
                 <a:cs typeface="Heebo"/>
               </a:rPr>
-              <a:t>חמישי</a:t>
-            </a:r>
-          </a:p>
-        </p:txBody>
-      </p:sp>
-      <p:sp>
-        <p:nvSpPr>
-          <p:cNvPr id="34" name="TextBox 33"/>
-          <p:cNvSpPr txBox="1"/>
-          <p:nvPr/>
-        </p:nvSpPr>
-        <p:spPr>
-          <a:xfrm>
-            <a:off x="502921" y="2624328"/>
-            <a:ext cx="1988454" cy="457200"/>
-          </a:xfrm>
-          <a:prstGeom prst="rect">
-            <a:avLst/>
-          </a:prstGeom>
-          <a:noFill/>
-        </p:spPr>
-        <p:txBody>
-          <a:bodyPr wrap="square" anchor="ctr" lIns="36576" rIns="36576" tIns="0" bIns="0">
-            <a:spAutoFit/>
-          </a:bodyPr>
-          <a:lstStyle/>
-          <a:p>
-            <a:pPr algn="ctr" rtl="1"/>
-            <a:r>
-              <a:rPr sz="1500" b="1">
-                <a:solidFill>
-                  <a:srgbClr val="1C3C7A"/>
-                </a:solidFill>
-                <a:latin typeface="Heebo"/>
-                <a:cs typeface="Heebo"/>
-              </a:rPr>
-              <a:t>תוכן וסיכום</a:t>
-            </a:r>
-          </a:p>
-        </p:txBody>
-      </p:sp>
-      <p:sp>
-        <p:nvSpPr>
-          <p:cNvPr id="35" name="TextBox 34"/>
-          <p:cNvSpPr txBox="1"/>
-          <p:nvPr/>
-        </p:nvSpPr>
-        <p:spPr>
-          <a:xfrm>
-            <a:off x="502921" y="3108960"/>
-            <a:ext cx="1988454" cy="502920"/>
-          </a:xfrm>
-          <a:prstGeom prst="rect">
-            <a:avLst/>
-          </a:prstGeom>
-          <a:noFill/>
-        </p:spPr>
-        <p:txBody>
-          <a:bodyPr wrap="square" anchor="t" lIns="36576" rIns="36576" tIns="0" bIns="0">
-            <a:spAutoFit/>
-          </a:bodyPr>
-          <a:lstStyle/>
-          <a:p>
-            <a:pPr algn="ctr" rtl="1"/>
-            <a:r>
-              <a:rPr sz="1100" b="0">
-                <a:solidFill>
-                  <a:srgbClr val="1A2233"/>
-                </a:solidFill>
-                <a:latin typeface="Heebo"/>
-                <a:cs typeface="Heebo"/>
-              </a:rPr>
-              <a:t>איש התוכן מפיץ את פעילות השבוע</a:t>
-            </a:r>
-          </a:p>
-        </p:txBody>
-      </p:sp>
-      <p:sp>
-        <p:nvSpPr>
-          <p:cNvPr id="36" name="Rounded Rectangle 35"/>
-          <p:cNvSpPr/>
-          <p:nvPr/>
-        </p:nvSpPr>
-        <p:spPr>
-          <a:xfrm>
-            <a:off x="6187288" y="3931920"/>
-            <a:ext cx="5592927" cy="2514600"/>
+              <a:t>תמיר דורטל</a:t>
+            </a:r>
+          </a:p>
+        </p:txBody>
+      </p:sp>
+      <p:sp>
+        <p:nvSpPr>
+          <p:cNvPr id="44" name="Rounded Rectangle 43"/>
+          <p:cNvSpPr/>
+          <p:nvPr/>
+        </p:nvSpPr>
+        <p:spPr>
+          <a:xfrm>
+            <a:off x="9029473" y="4709160"/>
+            <a:ext cx="1238211" cy="502920"/>
           </a:xfrm>
           <a:prstGeom prst="roundRect">
             <a:avLst>
-              <a:gd name="adj" fmla="val 6000"/>
+              <a:gd name="adj" fmla="val 18000"/>
             </a:avLst>
           </a:prstGeom>
           <a:solidFill>
@@ -27130,14 +27456,58 @@
       </p:sp>
       <p:sp>
         <p:nvSpPr>
-          <p:cNvPr id="37" name="TextBox 36"/>
+          <p:cNvPr id="45" name="Rectangle 44"/>
+          <p:cNvSpPr/>
+          <p:nvPr/>
+        </p:nvSpPr>
+        <p:spPr>
+          <a:xfrm>
+            <a:off x="10203676" y="4782312"/>
+            <a:ext cx="45720" cy="356616"/>
+          </a:xfrm>
+          <a:prstGeom prst="rect">
+            <a:avLst/>
+          </a:prstGeom>
+          <a:solidFill>
+            <a:srgbClr val="F0C000"/>
+          </a:solidFill>
+          <a:ln>
+            <a:noFill/>
+          </a:ln>
+          <a:effectLst/>
+        </p:spPr>
+        <p:style>
+          <a:lnRef idx="1">
+            <a:schemeClr val="accent1"/>
+          </a:lnRef>
+          <a:fillRef idx="3">
+            <a:schemeClr val="accent1"/>
+          </a:fillRef>
+          <a:effectRef idx="2">
+            <a:schemeClr val="accent1"/>
+          </a:effectRef>
+          <a:fontRef idx="minor">
+            <a:schemeClr val="lt1"/>
+          </a:fontRef>
+        </p:style>
+        <p:txBody>
+          <a:bodyPr rtlCol="0" anchor="ctr"/>
+          <a:lstStyle/>
+          <a:p>
+            <a:pPr algn="ctr"/>
+          </a:p>
+        </p:txBody>
+      </p:sp>
+      <p:sp>
+        <p:nvSpPr>
+          <p:cNvPr id="46" name="TextBox 45"/>
           <p:cNvSpPr txBox="1"/>
           <p:nvPr/>
         </p:nvSpPr>
         <p:spPr>
           <a:xfrm>
-            <a:off x="6370168" y="4041648"/>
-            <a:ext cx="5227167" cy="329184"/>
+            <a:off x="9029473" y="4709160"/>
+            <a:ext cx="1238211" cy="502920"/>
           </a:xfrm>
           <a:prstGeom prst="rect">
             <a:avLst/>
@@ -27150,29 +27520,29 @@
           </a:bodyPr>
           <a:lstStyle/>
           <a:p>
-            <a:pPr algn="r" rtl="1"/>
-            <a:r>
-              <a:rPr sz="1600" b="1">
-                <a:solidFill>
-                  <a:srgbClr val="1C3C7A"/>
+            <a:pPr algn="ctr" rtl="1"/>
+            <a:r>
+              <a:rPr sz="1200" b="1">
+                <a:solidFill>
+                  <a:srgbClr val="1A2233"/>
                 </a:solidFill>
                 <a:latin typeface="Heebo"/>
                 <a:cs typeface="Heebo"/>
               </a:rPr>
-              <a:t>מי הולך לכנסת</a:t>
-            </a:r>
-          </a:p>
-        </p:txBody>
-      </p:sp>
-      <p:sp>
-        <p:nvSpPr>
-          <p:cNvPr id="38" name="Rounded Rectangle 37"/>
-          <p:cNvSpPr/>
-          <p:nvPr/>
-        </p:nvSpPr>
-        <p:spPr>
-          <a:xfrm>
-            <a:off x="10359124" y="4480560"/>
+              <a:t>אדם קורגן</a:t>
+            </a:r>
+          </a:p>
+        </p:txBody>
+      </p:sp>
+      <p:sp>
+        <p:nvSpPr>
+          <p:cNvPr id="47" name="Rounded Rectangle 46"/>
+          <p:cNvSpPr/>
+          <p:nvPr/>
+        </p:nvSpPr>
+        <p:spPr>
+          <a:xfrm>
+            <a:off x="7699822" y="4709160"/>
             <a:ext cx="1238211" cy="502920"/>
           </a:xfrm>
           <a:prstGeom prst="roundRect">
@@ -27214,13 +27584,13 @@
       </p:sp>
       <p:sp>
         <p:nvSpPr>
-          <p:cNvPr id="39" name="Rectangle 38"/>
-          <p:cNvSpPr/>
-          <p:nvPr/>
-        </p:nvSpPr>
-        <p:spPr>
-          <a:xfrm>
-            <a:off x="11533327" y="4553712"/>
+          <p:cNvPr id="48" name="Rectangle 47"/>
+          <p:cNvSpPr/>
+          <p:nvPr/>
+        </p:nvSpPr>
+        <p:spPr>
+          <a:xfrm>
+            <a:off x="8874025" y="4782312"/>
             <a:ext cx="45720" cy="356616"/>
           </a:xfrm>
           <a:prstGeom prst="rect">
@@ -27258,269 +27628,13 @@
       </p:sp>
       <p:sp>
         <p:nvSpPr>
-          <p:cNvPr id="40" name="TextBox 39"/>
+          <p:cNvPr id="49" name="TextBox 48"/>
           <p:cNvSpPr txBox="1"/>
           <p:nvPr/>
         </p:nvSpPr>
         <p:spPr>
           <a:xfrm>
-            <a:off x="10359124" y="4480560"/>
-            <a:ext cx="1238211" cy="502920"/>
-          </a:xfrm>
-          <a:prstGeom prst="rect">
-            <a:avLst/>
-          </a:prstGeom>
-          <a:noFill/>
-        </p:spPr>
-        <p:txBody>
-          <a:bodyPr wrap="square" anchor="ctr" lIns="36576" rIns="36576" tIns="0" bIns="0">
-            <a:spAutoFit/>
-          </a:bodyPr>
-          <a:lstStyle/>
-          <a:p>
-            <a:pPr algn="ctr" rtl="1"/>
-            <a:r>
-              <a:rPr sz="1200" b="1">
-                <a:solidFill>
-                  <a:srgbClr val="1A2233"/>
-                </a:solidFill>
-                <a:latin typeface="Heebo"/>
-                <a:cs typeface="Heebo"/>
-              </a:rPr>
-              <a:t>תמיר דורטל</a:t>
-            </a:r>
-          </a:p>
-        </p:txBody>
-      </p:sp>
-      <p:sp>
-        <p:nvSpPr>
-          <p:cNvPr id="41" name="Rounded Rectangle 40"/>
-          <p:cNvSpPr/>
-          <p:nvPr/>
-        </p:nvSpPr>
-        <p:spPr>
-          <a:xfrm>
-            <a:off x="9029473" y="4480560"/>
-            <a:ext cx="1238211" cy="502920"/>
-          </a:xfrm>
-          <a:prstGeom prst="roundRect">
-            <a:avLst>
-              <a:gd name="adj" fmla="val 18000"/>
-            </a:avLst>
-          </a:prstGeom>
-          <a:solidFill>
-            <a:srgbClr val="FFFFFF"/>
-          </a:solidFill>
-          <a:ln w="15875">
-            <a:solidFill>
-              <a:srgbClr val="C5CDDD"/>
-            </a:solidFill>
-          </a:ln>
-          <a:effectLst/>
-        </p:spPr>
-        <p:style>
-          <a:lnRef idx="1">
-            <a:schemeClr val="accent1"/>
-          </a:lnRef>
-          <a:fillRef idx="3">
-            <a:schemeClr val="accent1"/>
-          </a:fillRef>
-          <a:effectRef idx="2">
-            <a:schemeClr val="accent1"/>
-          </a:effectRef>
-          <a:fontRef idx="minor">
-            <a:schemeClr val="lt1"/>
-          </a:fontRef>
-        </p:style>
-        <p:txBody>
-          <a:bodyPr rtlCol="0" anchor="ctr"/>
-          <a:lstStyle/>
-          <a:p>
-            <a:pPr algn="ctr"/>
-          </a:p>
-        </p:txBody>
-      </p:sp>
-      <p:sp>
-        <p:nvSpPr>
-          <p:cNvPr id="42" name="Rectangle 41"/>
-          <p:cNvSpPr/>
-          <p:nvPr/>
-        </p:nvSpPr>
-        <p:spPr>
-          <a:xfrm>
-            <a:off x="10203676" y="4553712"/>
-            <a:ext cx="45720" cy="356616"/>
-          </a:xfrm>
-          <a:prstGeom prst="rect">
-            <a:avLst/>
-          </a:prstGeom>
-          <a:solidFill>
-            <a:srgbClr val="F0C000"/>
-          </a:solidFill>
-          <a:ln>
-            <a:noFill/>
-          </a:ln>
-          <a:effectLst/>
-        </p:spPr>
-        <p:style>
-          <a:lnRef idx="1">
-            <a:schemeClr val="accent1"/>
-          </a:lnRef>
-          <a:fillRef idx="3">
-            <a:schemeClr val="accent1"/>
-          </a:fillRef>
-          <a:effectRef idx="2">
-            <a:schemeClr val="accent1"/>
-          </a:effectRef>
-          <a:fontRef idx="minor">
-            <a:schemeClr val="lt1"/>
-          </a:fontRef>
-        </p:style>
-        <p:txBody>
-          <a:bodyPr rtlCol="0" anchor="ctr"/>
-          <a:lstStyle/>
-          <a:p>
-            <a:pPr algn="ctr"/>
-          </a:p>
-        </p:txBody>
-      </p:sp>
-      <p:sp>
-        <p:nvSpPr>
-          <p:cNvPr id="43" name="TextBox 42"/>
-          <p:cNvSpPr txBox="1"/>
-          <p:nvPr/>
-        </p:nvSpPr>
-        <p:spPr>
-          <a:xfrm>
-            <a:off x="9029473" y="4480560"/>
-            <a:ext cx="1238211" cy="502920"/>
-          </a:xfrm>
-          <a:prstGeom prst="rect">
-            <a:avLst/>
-          </a:prstGeom>
-          <a:noFill/>
-        </p:spPr>
-        <p:txBody>
-          <a:bodyPr wrap="square" anchor="ctr" lIns="36576" rIns="36576" tIns="0" bIns="0">
-            <a:spAutoFit/>
-          </a:bodyPr>
-          <a:lstStyle/>
-          <a:p>
-            <a:pPr algn="ctr" rtl="1"/>
-            <a:r>
-              <a:rPr sz="1200" b="1">
-                <a:solidFill>
-                  <a:srgbClr val="1A2233"/>
-                </a:solidFill>
-                <a:latin typeface="Heebo"/>
-                <a:cs typeface="Heebo"/>
-              </a:rPr>
-              <a:t>אדם קורגן</a:t>
-            </a:r>
-          </a:p>
-        </p:txBody>
-      </p:sp>
-      <p:sp>
-        <p:nvSpPr>
-          <p:cNvPr id="44" name="Rounded Rectangle 43"/>
-          <p:cNvSpPr/>
-          <p:nvPr/>
-        </p:nvSpPr>
-        <p:spPr>
-          <a:xfrm>
-            <a:off x="7699822" y="4480560"/>
-            <a:ext cx="1238211" cy="502920"/>
-          </a:xfrm>
-          <a:prstGeom prst="roundRect">
-            <a:avLst>
-              <a:gd name="adj" fmla="val 18000"/>
-            </a:avLst>
-          </a:prstGeom>
-          <a:solidFill>
-            <a:srgbClr val="FFFFFF"/>
-          </a:solidFill>
-          <a:ln w="15875">
-            <a:solidFill>
-              <a:srgbClr val="C5CDDD"/>
-            </a:solidFill>
-          </a:ln>
-          <a:effectLst/>
-        </p:spPr>
-        <p:style>
-          <a:lnRef idx="1">
-            <a:schemeClr val="accent1"/>
-          </a:lnRef>
-          <a:fillRef idx="3">
-            <a:schemeClr val="accent1"/>
-          </a:fillRef>
-          <a:effectRef idx="2">
-            <a:schemeClr val="accent1"/>
-          </a:effectRef>
-          <a:fontRef idx="minor">
-            <a:schemeClr val="lt1"/>
-          </a:fontRef>
-        </p:style>
-        <p:txBody>
-          <a:bodyPr rtlCol="0" anchor="ctr"/>
-          <a:lstStyle/>
-          <a:p>
-            <a:pPr algn="ctr"/>
-          </a:p>
-        </p:txBody>
-      </p:sp>
-      <p:sp>
-        <p:nvSpPr>
-          <p:cNvPr id="45" name="Rectangle 44"/>
-          <p:cNvSpPr/>
-          <p:nvPr/>
-        </p:nvSpPr>
-        <p:spPr>
-          <a:xfrm>
-            <a:off x="8874025" y="4553712"/>
-            <a:ext cx="45720" cy="356616"/>
-          </a:xfrm>
-          <a:prstGeom prst="rect">
-            <a:avLst/>
-          </a:prstGeom>
-          <a:solidFill>
-            <a:srgbClr val="F0C000"/>
-          </a:solidFill>
-          <a:ln>
-            <a:noFill/>
-          </a:ln>
-          <a:effectLst/>
-        </p:spPr>
-        <p:style>
-          <a:lnRef idx="1">
-            <a:schemeClr val="accent1"/>
-          </a:lnRef>
-          <a:fillRef idx="3">
-            <a:schemeClr val="accent1"/>
-          </a:fillRef>
-          <a:effectRef idx="2">
-            <a:schemeClr val="accent1"/>
-          </a:effectRef>
-          <a:fontRef idx="minor">
-            <a:schemeClr val="lt1"/>
-          </a:fontRef>
-        </p:style>
-        <p:txBody>
-          <a:bodyPr rtlCol="0" anchor="ctr"/>
-          <a:lstStyle/>
-          <a:p>
-            <a:pPr algn="ctr"/>
-          </a:p>
-        </p:txBody>
-      </p:sp>
-      <p:sp>
-        <p:nvSpPr>
-          <p:cNvPr id="46" name="TextBox 45"/>
-          <p:cNvSpPr txBox="1"/>
-          <p:nvPr/>
-        </p:nvSpPr>
-        <p:spPr>
-          <a:xfrm>
-            <a:off x="7699822" y="4535424"/>
+            <a:off x="7699822" y="4764024"/>
             <a:ext cx="1238211" cy="261518"/>
           </a:xfrm>
           <a:prstGeom prst="rect">
@@ -27550,13 +27664,13 @@
       </p:sp>
       <p:sp>
         <p:nvSpPr>
-          <p:cNvPr id="47" name="TextBox 46"/>
+          <p:cNvPr id="50" name="TextBox 49"/>
           <p:cNvSpPr txBox="1"/>
           <p:nvPr/>
         </p:nvSpPr>
         <p:spPr>
           <a:xfrm>
-            <a:off x="7699822" y="4757166"/>
+            <a:off x="7699822" y="4985766"/>
             <a:ext cx="1238211" cy="201168"/>
           </a:xfrm>
           <a:prstGeom prst="rect">
@@ -27586,13 +27700,13 @@
       </p:sp>
       <p:sp>
         <p:nvSpPr>
-          <p:cNvPr id="48" name="Rounded Rectangle 47"/>
-          <p:cNvSpPr/>
-          <p:nvPr/>
-        </p:nvSpPr>
-        <p:spPr>
-          <a:xfrm>
-            <a:off x="6370171" y="4480560"/>
+          <p:cNvPr id="51" name="Rounded Rectangle 50"/>
+          <p:cNvSpPr/>
+          <p:nvPr/>
+        </p:nvSpPr>
+        <p:spPr>
+          <a:xfrm>
+            <a:off x="6370171" y="4709160"/>
             <a:ext cx="1238211" cy="502920"/>
           </a:xfrm>
           <a:prstGeom prst="roundRect">
@@ -27633,13 +27747,13 @@
       </p:sp>
       <p:sp>
         <p:nvSpPr>
-          <p:cNvPr id="49" name="TextBox 48"/>
+          <p:cNvPr id="52" name="TextBox 51"/>
           <p:cNvSpPr txBox="1"/>
           <p:nvPr/>
         </p:nvSpPr>
         <p:spPr>
           <a:xfrm>
-            <a:off x="6370171" y="4480560"/>
+            <a:off x="6370171" y="4709160"/>
             <a:ext cx="1238211" cy="502920"/>
           </a:xfrm>
           <a:prstGeom prst="rect">
@@ -27669,13 +27783,13 @@
       </p:sp>
       <p:sp>
         <p:nvSpPr>
-          <p:cNvPr id="50" name="TextBox 49"/>
+          <p:cNvPr id="53" name="TextBox 52"/>
           <p:cNvSpPr txBox="1"/>
           <p:nvPr/>
         </p:nvSpPr>
         <p:spPr>
           <a:xfrm>
-            <a:off x="6370168" y="5120640"/>
+            <a:off x="6370168" y="5349240"/>
             <a:ext cx="5227167" cy="274320"/>
           </a:xfrm>
           <a:prstGeom prst="rect">
@@ -27705,13 +27819,13 @@
       </p:sp>
       <p:sp>
         <p:nvSpPr>
-          <p:cNvPr id="51" name="Rounded Rectangle 50"/>
-          <p:cNvSpPr/>
-          <p:nvPr/>
-        </p:nvSpPr>
-        <p:spPr>
-          <a:xfrm>
-            <a:off x="6370168" y="5532120"/>
+          <p:cNvPr id="54" name="Rounded Rectangle 53"/>
+          <p:cNvSpPr/>
+          <p:nvPr/>
+        </p:nvSpPr>
+        <p:spPr>
+          <a:xfrm>
+            <a:off x="6370168" y="5760720"/>
             <a:ext cx="5227167" cy="640080"/>
           </a:xfrm>
           <a:prstGeom prst="roundRect">
@@ -27751,13 +27865,13 @@
       </p:sp>
       <p:sp>
         <p:nvSpPr>
-          <p:cNvPr id="52" name="TextBox 51"/>
+          <p:cNvPr id="55" name="TextBox 54"/>
           <p:cNvSpPr txBox="1"/>
           <p:nvPr/>
         </p:nvSpPr>
         <p:spPr>
           <a:xfrm>
-            <a:off x="6461608" y="5532120"/>
+            <a:off x="6461608" y="5760720"/>
             <a:ext cx="5044287" cy="640080"/>
           </a:xfrm>
           <a:prstGeom prst="rect">
@@ -27787,14 +27901,14 @@
       </p:sp>
       <p:sp>
         <p:nvSpPr>
-          <p:cNvPr id="53" name="Rounded Rectangle 52"/>
-          <p:cNvSpPr/>
-          <p:nvPr/>
-        </p:nvSpPr>
-        <p:spPr>
-          <a:xfrm>
-            <a:off x="411480" y="3931920"/>
-            <a:ext cx="5592927" cy="2514600"/>
+          <p:cNvPr id="56" name="Rounded Rectangle 55"/>
+          <p:cNvSpPr/>
+          <p:nvPr/>
+        </p:nvSpPr>
+        <p:spPr>
+          <a:xfrm>
+            <a:off x="411480" y="4160520"/>
+            <a:ext cx="5592927" cy="2331720"/>
           </a:xfrm>
           <a:prstGeom prst="roundRect">
             <a:avLst>
@@ -27835,13 +27949,13 @@
       </p:sp>
       <p:sp>
         <p:nvSpPr>
-          <p:cNvPr id="54" name="TextBox 53"/>
+          <p:cNvPr id="57" name="TextBox 56"/>
           <p:cNvSpPr txBox="1"/>
           <p:nvPr/>
         </p:nvSpPr>
         <p:spPr>
           <a:xfrm>
-            <a:off x="594360" y="4041648"/>
+            <a:off x="594360" y="4270248"/>
             <a:ext cx="5227167" cy="329184"/>
           </a:xfrm>
           <a:prstGeom prst="rect">
@@ -27871,13 +27985,13 @@
       </p:sp>
       <p:sp>
         <p:nvSpPr>
-          <p:cNvPr id="55" name="TextBox 54"/>
+          <p:cNvPr id="58" name="TextBox 57"/>
           <p:cNvSpPr txBox="1"/>
           <p:nvPr/>
         </p:nvSpPr>
         <p:spPr>
           <a:xfrm>
-            <a:off x="594360" y="4389120"/>
+            <a:off x="594360" y="4617720"/>
             <a:ext cx="5227167" cy="274320"/>
           </a:xfrm>
           <a:prstGeom prst="rect">
@@ -27907,13 +28021,13 @@
       </p:sp>
       <p:sp>
         <p:nvSpPr>
-          <p:cNvPr id="56" name="TextBox 55"/>
+          <p:cNvPr id="59" name="TextBox 58"/>
           <p:cNvSpPr txBox="1"/>
           <p:nvPr/>
         </p:nvSpPr>
         <p:spPr>
           <a:xfrm>
-            <a:off x="640080" y="4846320"/>
+            <a:off x="640080" y="5074920"/>
             <a:ext cx="5135727" cy="457200"/>
           </a:xfrm>
           <a:prstGeom prst="rect">
@@ -27943,13 +28057,13 @@
       </p:sp>
       <p:sp>
         <p:nvSpPr>
-          <p:cNvPr id="57" name="TextBox 56"/>
+          <p:cNvPr id="60" name="TextBox 59"/>
           <p:cNvSpPr txBox="1"/>
           <p:nvPr/>
         </p:nvSpPr>
         <p:spPr>
           <a:xfrm>
-            <a:off x="640080" y="5394960"/>
+            <a:off x="640080" y="5623560"/>
             <a:ext cx="5135727" cy="457200"/>
           </a:xfrm>
           <a:prstGeom prst="rect">

</xml_diff>

<commit_message>
Proposal: warning note on volunteers attending alone
Co-Authored-By: Claude Opus 5.5 <noreply@anthropic.com>
Claude-Session: https://claude.ai/code/session_01W7Er83FuNT4pLFShWidYHn
</commit_message>
<xml_diff>
--- a/presentation/out/koach-hitarvut.pptx
+++ b/presentation/out/koach-hitarvut.pptx
@@ -20286,6 +20286,206 @@
                 <a:cs typeface="Heebo"/>
               </a:rPr>
               <a:t>הפקה והפצה ברשתות של התוכן מהכנסת</a:t>
+            </a:r>
+          </a:p>
+        </p:txBody>
+      </p:sp>
+      <p:sp>
+        <p:nvSpPr>
+          <p:cNvPr id="76" name="Rounded Rectangle 75"/>
+          <p:cNvSpPr/>
+          <p:nvPr/>
+        </p:nvSpPr>
+        <p:spPr>
+          <a:xfrm>
+            <a:off x="411480" y="5989320"/>
+            <a:ext cx="11368735" cy="658368"/>
+          </a:xfrm>
+          <a:prstGeom prst="roundRect">
+            <a:avLst>
+              <a:gd name="adj" fmla="val 14000"/>
+            </a:avLst>
+          </a:prstGeom>
+          <a:solidFill>
+            <a:srgbClr val="FFFFFF"/>
+          </a:solidFill>
+          <a:ln w="22225">
+            <a:solidFill>
+              <a:srgbClr val="1C3C7A"/>
+            </a:solidFill>
+          </a:ln>
+          <a:effectLst/>
+        </p:spPr>
+        <p:style>
+          <a:lnRef idx="1">
+            <a:schemeClr val="accent1"/>
+          </a:lnRef>
+          <a:fillRef idx="3">
+            <a:schemeClr val="accent1"/>
+          </a:fillRef>
+          <a:effectRef idx="2">
+            <a:schemeClr val="accent1"/>
+          </a:effectRef>
+          <a:fontRef idx="minor">
+            <a:schemeClr val="lt1"/>
+          </a:fontRef>
+        </p:style>
+        <p:txBody>
+          <a:bodyPr rtlCol="0" anchor="ctr"/>
+          <a:lstStyle/>
+          <a:p>
+            <a:pPr algn="ctr"/>
+          </a:p>
+        </p:txBody>
+      </p:sp>
+      <p:sp>
+        <p:nvSpPr>
+          <p:cNvPr id="77" name="Oval 76"/>
+          <p:cNvSpPr/>
+          <p:nvPr/>
+        </p:nvSpPr>
+        <p:spPr>
+          <a:xfrm>
+            <a:off x="11231575" y="6135624"/>
+            <a:ext cx="365760" cy="365760"/>
+          </a:xfrm>
+          <a:prstGeom prst="ellipse">
+            <a:avLst/>
+          </a:prstGeom>
+          <a:solidFill>
+            <a:srgbClr val="F0C000"/>
+          </a:solidFill>
+          <a:ln>
+            <a:noFill/>
+          </a:ln>
+          <a:effectLst/>
+        </p:spPr>
+        <p:style>
+          <a:lnRef idx="1">
+            <a:schemeClr val="accent1"/>
+          </a:lnRef>
+          <a:fillRef idx="3">
+            <a:schemeClr val="accent1"/>
+          </a:fillRef>
+          <a:effectRef idx="2">
+            <a:schemeClr val="accent1"/>
+          </a:effectRef>
+          <a:fontRef idx="minor">
+            <a:schemeClr val="lt1"/>
+          </a:fontRef>
+        </p:style>
+        <p:txBody>
+          <a:bodyPr rtlCol="0" anchor="ctr"/>
+          <a:lstStyle/>
+          <a:p>
+            <a:pPr algn="ctr"/>
+          </a:p>
+        </p:txBody>
+      </p:sp>
+      <p:sp>
+        <p:nvSpPr>
+          <p:cNvPr id="78" name="TextBox 77"/>
+          <p:cNvSpPr txBox="1"/>
+          <p:nvPr/>
+        </p:nvSpPr>
+        <p:spPr>
+          <a:xfrm>
+            <a:off x="11140135" y="6135624"/>
+            <a:ext cx="548640" cy="365760"/>
+          </a:xfrm>
+          <a:prstGeom prst="rect">
+            <a:avLst/>
+          </a:prstGeom>
+          <a:noFill/>
+        </p:spPr>
+        <p:txBody>
+          <a:bodyPr wrap="square" anchor="ctr" lIns="36576" rIns="36576" tIns="0" bIns="0">
+            <a:spAutoFit/>
+          </a:bodyPr>
+          <a:lstStyle/>
+          <a:p>
+            <a:pPr algn="ctr" rtl="0"/>
+            <a:r>
+              <a:rPr sz="1200" b="1">
+                <a:solidFill>
+                  <a:srgbClr val="122755"/>
+                </a:solidFill>
+                <a:latin typeface="Heebo"/>
+                <a:cs typeface="Heebo"/>
+              </a:rPr>
+              <a:t>!</a:t>
+            </a:r>
+          </a:p>
+        </p:txBody>
+      </p:sp>
+      <p:sp>
+        <p:nvSpPr>
+          <p:cNvPr id="79" name="TextBox 78"/>
+          <p:cNvSpPr txBox="1"/>
+          <p:nvPr/>
+        </p:nvSpPr>
+        <p:spPr>
+          <a:xfrm>
+            <a:off x="594360" y="6044184"/>
+            <a:ext cx="10500055" cy="292608"/>
+          </a:xfrm>
+          <a:prstGeom prst="rect">
+            <a:avLst/>
+          </a:prstGeom>
+          <a:noFill/>
+        </p:spPr>
+        <p:txBody>
+          <a:bodyPr wrap="square" anchor="ctr" lIns="36576" rIns="36576" tIns="0" bIns="0">
+            <a:spAutoFit/>
+          </a:bodyPr>
+          <a:lstStyle/>
+          <a:p>
+            <a:pPr algn="r" rtl="1"/>
+            <a:r>
+              <a:rPr sz="1400" b="1">
+                <a:solidFill>
+                  <a:srgbClr val="1C3C7A"/>
+                </a:solidFill>
+                <a:latin typeface="Heebo"/>
+                <a:cs typeface="Heebo"/>
+              </a:rPr>
+              <a:t>אקטיביסט הולך לדיון לבד רק אם אין בשום אופן נציג אחר.</a:t>
+            </a:r>
+          </a:p>
+        </p:txBody>
+      </p:sp>
+      <p:sp>
+        <p:nvSpPr>
+          <p:cNvPr id="80" name="TextBox 79"/>
+          <p:cNvSpPr txBox="1"/>
+          <p:nvPr/>
+        </p:nvSpPr>
+        <p:spPr>
+          <a:xfrm>
+            <a:off x="594360" y="6336792"/>
+            <a:ext cx="10500055" cy="256032"/>
+          </a:xfrm>
+          <a:prstGeom prst="rect">
+            <a:avLst/>
+          </a:prstGeom>
+          <a:noFill/>
+        </p:spPr>
+        <p:txBody>
+          <a:bodyPr wrap="square" anchor="ctr" lIns="36576" rIns="36576" tIns="0" bIns="0">
+            <a:spAutoFit/>
+          </a:bodyPr>
+          <a:lstStyle/>
+          <a:p>
+            <a:pPr algn="r" rtl="1"/>
+            <a:r>
+              <a:rPr sz="1200" b="0">
+                <a:solidFill>
+                  <a:srgbClr val="1A2233"/>
+                </a:solidFill>
+                <a:latin typeface="Heebo"/>
+                <a:cs typeface="Heebo"/>
+              </a:rPr>
+              <a:t>מערך שמאויש במתנדבים יקרוס, וייחסל את הפעילות בחיתוליה, גם תדמיתית וגם אופרטיבית.</a:t>
             </a:r>
           </a:p>
         </p:txBody>

</xml_diff>

<commit_message>
Proposal: management (CEO + assistant seat) and two red notes
Co-Authored-By: Claude Opus 5.5 <noreply@anthropic.com>
Claude-Session: https://claude.ai/code/session_01W7Er83FuNT4pLFShWidYHn
</commit_message>
<xml_diff>
--- a/presentation/out/koach-hitarvut.pptx
+++ b/presentation/out/koach-hitarvut.pptx
@@ -17524,8 +17524,8 @@
         </p:nvSpPr>
         <p:spPr>
           <a:xfrm>
-            <a:off x="5150998" y="1051560"/>
-            <a:ext cx="6629217" cy="841248"/>
+            <a:off x="8714885" y="1051560"/>
+            <a:ext cx="3065330" cy="841248"/>
           </a:xfrm>
           <a:prstGeom prst="roundRect">
             <a:avLst>
@@ -17570,8 +17570,8 @@
         </p:nvSpPr>
         <p:spPr>
           <a:xfrm>
-            <a:off x="5242438" y="1088136"/>
-            <a:ext cx="6446337" cy="274320"/>
+            <a:off x="8806325" y="1088136"/>
+            <a:ext cx="2882450" cy="274320"/>
           </a:xfrm>
           <a:prstGeom prst="rect">
             <a:avLst/>
@@ -17593,7 +17593,7 @@
                 <a:latin typeface="Heebo"/>
                 <a:cs typeface="Heebo"/>
               </a:rPr>
-              <a:t>מובילי תחום</a:t>
+              <a:t>הנהלה</a:t>
             </a:r>
           </a:p>
         </p:txBody>
@@ -17606,8 +17606,8 @@
         </p:nvSpPr>
         <p:spPr>
           <a:xfrm>
-            <a:off x="5242438" y="1106424"/>
-            <a:ext cx="6446337" cy="256032"/>
+            <a:off x="8806325" y="1106424"/>
+            <a:ext cx="2882450" cy="256032"/>
           </a:xfrm>
           <a:prstGeom prst="rect">
             <a:avLst/>
@@ -17629,7 +17629,7 @@
                 <a:latin typeface="Heebo"/>
                 <a:cs typeface="Heebo"/>
               </a:rPr>
-              <a:t>מובילים את התוכניות שלהם + הופעות בכנסת</a:t>
+              <a:t>חלוקת העבודה והתפקידים ביניהם</a:t>
             </a:r>
           </a:p>
         </p:txBody>
@@ -17642,8 +17642,8 @@
         </p:nvSpPr>
         <p:spPr>
           <a:xfrm>
-            <a:off x="9600956" y="1380744"/>
-            <a:ext cx="2087819" cy="457200"/>
+            <a:off x="10293270" y="1380744"/>
+            <a:ext cx="1395505" cy="457200"/>
           </a:xfrm>
           <a:prstGeom prst="roundRect">
             <a:avLst>
@@ -17734,1229 +17734,8 @@
         </p:nvSpPr>
         <p:spPr>
           <a:xfrm>
-            <a:off x="9600956" y="1435608"/>
-            <a:ext cx="2087819" cy="237744"/>
-          </a:xfrm>
-          <a:prstGeom prst="rect">
-            <a:avLst/>
-          </a:prstGeom>
-          <a:noFill/>
-        </p:spPr>
-        <p:txBody>
-          <a:bodyPr wrap="square" anchor="b" lIns="36576" rIns="36576" tIns="0" bIns="0">
-            <a:spAutoFit/>
-          </a:bodyPr>
-          <a:lstStyle/>
-          <a:p>
-            <a:pPr algn="ctr" rtl="1"/>
-            <a:r>
-              <a:rPr sz="1200" b="1">
-                <a:solidFill>
-                  <a:srgbClr val="1A2233"/>
-                </a:solidFill>
-                <a:latin typeface="Heebo"/>
-                <a:cs typeface="Heebo"/>
-              </a:rPr>
-              <a:t>עו״ד אודליה קדמי</a:t>
-            </a:r>
-          </a:p>
-        </p:txBody>
-      </p:sp>
-      <p:sp>
-        <p:nvSpPr>
-          <p:cNvPr id="13" name="TextBox 12"/>
-          <p:cNvSpPr txBox="1"/>
-          <p:nvPr/>
-        </p:nvSpPr>
-        <p:spPr>
-          <a:xfrm>
-            <a:off x="9600956" y="1632204"/>
-            <a:ext cx="2087819" cy="182880"/>
-          </a:xfrm>
-          <a:prstGeom prst="rect">
-            <a:avLst/>
-          </a:prstGeom>
-          <a:noFill/>
-        </p:spPr>
-        <p:txBody>
-          <a:bodyPr wrap="square" anchor="t" lIns="36576" rIns="36576" tIns="0" bIns="0">
-            <a:spAutoFit/>
-          </a:bodyPr>
-          <a:lstStyle/>
-          <a:p>
-            <a:pPr algn="ctr" rtl="1"/>
-            <a:r>
-              <a:rPr sz="900" b="0">
-                <a:solidFill>
-                  <a:srgbClr val="8A94A8"/>
-                </a:solidFill>
-                <a:latin typeface="Heebo"/>
-                <a:cs typeface="Heebo"/>
-              </a:rPr>
-              <a:t>ביטחון אישי</a:t>
-            </a:r>
-          </a:p>
-        </p:txBody>
-      </p:sp>
-      <p:sp>
-        <p:nvSpPr>
-          <p:cNvPr id="14" name="Rounded Rectangle 13"/>
-          <p:cNvSpPr/>
-          <p:nvPr/>
-        </p:nvSpPr>
-        <p:spPr>
-          <a:xfrm>
-            <a:off x="7421697" y="1380744"/>
-            <a:ext cx="2087819" cy="457200"/>
-          </a:xfrm>
-          <a:prstGeom prst="roundRect">
-            <a:avLst>
-              <a:gd name="adj" fmla="val 18000"/>
-            </a:avLst>
-          </a:prstGeom>
-          <a:solidFill>
-            <a:srgbClr val="FFFFFF"/>
-          </a:solidFill>
-          <a:ln w="15875">
-            <a:solidFill>
-              <a:srgbClr val="C5CDDD"/>
-            </a:solidFill>
-          </a:ln>
-          <a:effectLst/>
-        </p:spPr>
-        <p:style>
-          <a:lnRef idx="1">
-            <a:schemeClr val="accent1"/>
-          </a:lnRef>
-          <a:fillRef idx="3">
-            <a:schemeClr val="accent1"/>
-          </a:fillRef>
-          <a:effectRef idx="2">
-            <a:schemeClr val="accent1"/>
-          </a:effectRef>
-          <a:fontRef idx="minor">
-            <a:schemeClr val="lt1"/>
-          </a:fontRef>
-        </p:style>
-        <p:txBody>
-          <a:bodyPr rtlCol="0" anchor="ctr"/>
-          <a:lstStyle/>
-          <a:p>
-            <a:pPr algn="ctr"/>
-          </a:p>
-        </p:txBody>
-      </p:sp>
-      <p:sp>
-        <p:nvSpPr>
-          <p:cNvPr id="15" name="Rectangle 14"/>
-          <p:cNvSpPr/>
-          <p:nvPr/>
-        </p:nvSpPr>
-        <p:spPr>
-          <a:xfrm>
-            <a:off x="9445508" y="1453896"/>
-            <a:ext cx="45720" cy="310896"/>
-          </a:xfrm>
-          <a:prstGeom prst="rect">
-            <a:avLst/>
-          </a:prstGeom>
-          <a:solidFill>
-            <a:srgbClr val="F0C000"/>
-          </a:solidFill>
-          <a:ln>
-            <a:noFill/>
-          </a:ln>
-          <a:effectLst/>
-        </p:spPr>
-        <p:style>
-          <a:lnRef idx="1">
-            <a:schemeClr val="accent1"/>
-          </a:lnRef>
-          <a:fillRef idx="3">
-            <a:schemeClr val="accent1"/>
-          </a:fillRef>
-          <a:effectRef idx="2">
-            <a:schemeClr val="accent1"/>
-          </a:effectRef>
-          <a:fontRef idx="minor">
-            <a:schemeClr val="lt1"/>
-          </a:fontRef>
-        </p:style>
-        <p:txBody>
-          <a:bodyPr rtlCol="0" anchor="ctr"/>
-          <a:lstStyle/>
-          <a:p>
-            <a:pPr algn="ctr"/>
-          </a:p>
-        </p:txBody>
-      </p:sp>
-      <p:sp>
-        <p:nvSpPr>
-          <p:cNvPr id="16" name="TextBox 15"/>
-          <p:cNvSpPr txBox="1"/>
-          <p:nvPr/>
-        </p:nvSpPr>
-        <p:spPr>
-          <a:xfrm>
-            <a:off x="7421697" y="1435608"/>
-            <a:ext cx="2087819" cy="237744"/>
-          </a:xfrm>
-          <a:prstGeom prst="rect">
-            <a:avLst/>
-          </a:prstGeom>
-          <a:noFill/>
-        </p:spPr>
-        <p:txBody>
-          <a:bodyPr wrap="square" anchor="b" lIns="36576" rIns="36576" tIns="0" bIns="0">
-            <a:spAutoFit/>
-          </a:bodyPr>
-          <a:lstStyle/>
-          <a:p>
-            <a:pPr algn="ctr" rtl="1"/>
-            <a:r>
-              <a:rPr sz="1200" b="1">
-                <a:solidFill>
-                  <a:srgbClr val="1A2233"/>
-                </a:solidFill>
-                <a:latin typeface="Heebo"/>
-                <a:cs typeface="Heebo"/>
-              </a:rPr>
-              <a:t>נגה ארבל</a:t>
-            </a:r>
-          </a:p>
-        </p:txBody>
-      </p:sp>
-      <p:sp>
-        <p:nvSpPr>
-          <p:cNvPr id="17" name="TextBox 16"/>
-          <p:cNvSpPr txBox="1"/>
-          <p:nvPr/>
-        </p:nvSpPr>
-        <p:spPr>
-          <a:xfrm>
-            <a:off x="7421697" y="1632204"/>
-            <a:ext cx="2087819" cy="182880"/>
-          </a:xfrm>
-          <a:prstGeom prst="rect">
-            <a:avLst/>
-          </a:prstGeom>
-          <a:noFill/>
-        </p:spPr>
-        <p:txBody>
-          <a:bodyPr wrap="square" anchor="t" lIns="36576" rIns="36576" tIns="0" bIns="0">
-            <a:spAutoFit/>
-          </a:bodyPr>
-          <a:lstStyle/>
-          <a:p>
-            <a:pPr algn="ctr" rtl="1"/>
-            <a:r>
-              <a:rPr sz="900" b="0">
-                <a:solidFill>
-                  <a:srgbClr val="8A94A8"/>
-                </a:solidFill>
-                <a:latin typeface="Heebo"/>
-                <a:cs typeface="Heebo"/>
-              </a:rPr>
-              <a:t>חקיקה</a:t>
-            </a:r>
-          </a:p>
-        </p:txBody>
-      </p:sp>
-      <p:sp>
-        <p:nvSpPr>
-          <p:cNvPr id="18" name="Rounded Rectangle 17"/>
-          <p:cNvSpPr/>
-          <p:nvPr/>
-        </p:nvSpPr>
-        <p:spPr>
-          <a:xfrm>
-            <a:off x="5242438" y="1380744"/>
-            <a:ext cx="2087819" cy="457200"/>
-          </a:xfrm>
-          <a:prstGeom prst="roundRect">
-            <a:avLst>
-              <a:gd name="adj" fmla="val 18000"/>
-            </a:avLst>
-          </a:prstGeom>
-          <a:solidFill>
-            <a:srgbClr val="FFFFFF"/>
-          </a:solidFill>
-          <a:ln w="15875">
-            <a:solidFill>
-              <a:srgbClr val="C5CDDD"/>
-            </a:solidFill>
-          </a:ln>
-          <a:effectLst/>
-        </p:spPr>
-        <p:style>
-          <a:lnRef idx="1">
-            <a:schemeClr val="accent1"/>
-          </a:lnRef>
-          <a:fillRef idx="3">
-            <a:schemeClr val="accent1"/>
-          </a:fillRef>
-          <a:effectRef idx="2">
-            <a:schemeClr val="accent1"/>
-          </a:effectRef>
-          <a:fontRef idx="minor">
-            <a:schemeClr val="lt1"/>
-          </a:fontRef>
-        </p:style>
-        <p:txBody>
-          <a:bodyPr rtlCol="0" anchor="ctr"/>
-          <a:lstStyle/>
-          <a:p>
-            <a:pPr algn="ctr"/>
-          </a:p>
-        </p:txBody>
-      </p:sp>
-      <p:sp>
-        <p:nvSpPr>
-          <p:cNvPr id="19" name="Rectangle 18"/>
-          <p:cNvSpPr/>
-          <p:nvPr/>
-        </p:nvSpPr>
-        <p:spPr>
-          <a:xfrm>
-            <a:off x="7266249" y="1453896"/>
-            <a:ext cx="45720" cy="310896"/>
-          </a:xfrm>
-          <a:prstGeom prst="rect">
-            <a:avLst/>
-          </a:prstGeom>
-          <a:solidFill>
-            <a:srgbClr val="F0C000"/>
-          </a:solidFill>
-          <a:ln>
-            <a:noFill/>
-          </a:ln>
-          <a:effectLst/>
-        </p:spPr>
-        <p:style>
-          <a:lnRef idx="1">
-            <a:schemeClr val="accent1"/>
-          </a:lnRef>
-          <a:fillRef idx="3">
-            <a:schemeClr val="accent1"/>
-          </a:fillRef>
-          <a:effectRef idx="2">
-            <a:schemeClr val="accent1"/>
-          </a:effectRef>
-          <a:fontRef idx="minor">
-            <a:schemeClr val="lt1"/>
-          </a:fontRef>
-        </p:style>
-        <p:txBody>
-          <a:bodyPr rtlCol="0" anchor="ctr"/>
-          <a:lstStyle/>
-          <a:p>
-            <a:pPr algn="ctr"/>
-          </a:p>
-        </p:txBody>
-      </p:sp>
-      <p:sp>
-        <p:nvSpPr>
-          <p:cNvPr id="20" name="TextBox 19"/>
-          <p:cNvSpPr txBox="1"/>
-          <p:nvPr/>
-        </p:nvSpPr>
-        <p:spPr>
-          <a:xfrm>
-            <a:off x="5242438" y="1435608"/>
-            <a:ext cx="2087819" cy="237744"/>
-          </a:xfrm>
-          <a:prstGeom prst="rect">
-            <a:avLst/>
-          </a:prstGeom>
-          <a:noFill/>
-        </p:spPr>
-        <p:txBody>
-          <a:bodyPr wrap="square" anchor="b" lIns="36576" rIns="36576" tIns="0" bIns="0">
-            <a:spAutoFit/>
-          </a:bodyPr>
-          <a:lstStyle/>
-          <a:p>
-            <a:pPr algn="ctr" rtl="1"/>
-            <a:r>
-              <a:rPr sz="1200" b="1">
-                <a:solidFill>
-                  <a:srgbClr val="1A2233"/>
-                </a:solidFill>
-                <a:latin typeface="Heebo"/>
-                <a:cs typeface="Heebo"/>
-              </a:rPr>
-              <a:t>שלומית לביא</a:t>
-            </a:r>
-          </a:p>
-        </p:txBody>
-      </p:sp>
-      <p:sp>
-        <p:nvSpPr>
-          <p:cNvPr id="21" name="TextBox 20"/>
-          <p:cNvSpPr txBox="1"/>
-          <p:nvPr/>
-        </p:nvSpPr>
-        <p:spPr>
-          <a:xfrm>
-            <a:off x="5242438" y="1632204"/>
-            <a:ext cx="2087819" cy="182880"/>
-          </a:xfrm>
-          <a:prstGeom prst="rect">
-            <a:avLst/>
-          </a:prstGeom>
-          <a:noFill/>
-        </p:spPr>
-        <p:txBody>
-          <a:bodyPr wrap="square" anchor="t" lIns="36576" rIns="36576" tIns="0" bIns="0">
-            <a:spAutoFit/>
-          </a:bodyPr>
-          <a:lstStyle/>
-          <a:p>
-            <a:pPr algn="ctr" rtl="1"/>
-            <a:r>
-              <a:rPr sz="900" b="0">
-                <a:solidFill>
-                  <a:srgbClr val="8A94A8"/>
-                </a:solidFill>
-                <a:latin typeface="Heebo"/>
-                <a:cs typeface="Heebo"/>
-              </a:rPr>
-              <a:t>רווחה</a:t>
-            </a:r>
-          </a:p>
-        </p:txBody>
-      </p:sp>
-      <p:sp>
-        <p:nvSpPr>
-          <p:cNvPr id="22" name="Rounded Rectangle 21"/>
-          <p:cNvSpPr/>
-          <p:nvPr/>
-        </p:nvSpPr>
-        <p:spPr>
-          <a:xfrm>
-            <a:off x="411480" y="1051560"/>
-            <a:ext cx="4419478" cy="841248"/>
-          </a:xfrm>
-          <a:prstGeom prst="roundRect">
-            <a:avLst>
-              <a:gd name="adj" fmla="val 8000"/>
-            </a:avLst>
-          </a:prstGeom>
-          <a:noFill/>
-          <a:ln w="15875">
-            <a:solidFill>
-              <a:srgbClr val="C5CDDD"/>
-            </a:solidFill>
-          </a:ln>
-          <a:effectLst/>
-        </p:spPr>
-        <p:style>
-          <a:lnRef idx="1">
-            <a:schemeClr val="accent1"/>
-          </a:lnRef>
-          <a:fillRef idx="3">
-            <a:schemeClr val="accent1"/>
-          </a:fillRef>
-          <a:effectRef idx="2">
-            <a:schemeClr val="accent1"/>
-          </a:effectRef>
-          <a:fontRef idx="minor">
-            <a:schemeClr val="lt1"/>
-          </a:fontRef>
-        </p:style>
-        <p:txBody>
-          <a:bodyPr rtlCol="0" anchor="ctr"/>
-          <a:lstStyle/>
-          <a:p>
-            <a:pPr algn="ctr"/>
-          </a:p>
-        </p:txBody>
-      </p:sp>
-      <p:sp>
-        <p:nvSpPr>
-          <p:cNvPr id="23" name="TextBox 22"/>
-          <p:cNvSpPr txBox="1"/>
-          <p:nvPr/>
-        </p:nvSpPr>
-        <p:spPr>
-          <a:xfrm>
-            <a:off x="502920" y="1088136"/>
-            <a:ext cx="4236598" cy="274320"/>
-          </a:xfrm>
-          <a:prstGeom prst="rect">
-            <a:avLst/>
-          </a:prstGeom>
-          <a:noFill/>
-        </p:spPr>
-        <p:txBody>
-          <a:bodyPr wrap="square" anchor="ctr" lIns="36576" rIns="36576" tIns="0" bIns="0">
-            <a:spAutoFit/>
-          </a:bodyPr>
-          <a:lstStyle/>
-          <a:p>
-            <a:pPr algn="r" rtl="1"/>
-            <a:r>
-              <a:rPr sz="1300" b="1">
-                <a:solidFill>
-                  <a:srgbClr val="1C3C7A"/>
-                </a:solidFill>
-                <a:latin typeface="Heebo"/>
-                <a:cs typeface="Heebo"/>
-              </a:rPr>
-              <a:t>יועצים</a:t>
-            </a:r>
-          </a:p>
-        </p:txBody>
-      </p:sp>
-      <p:sp>
-        <p:nvSpPr>
-          <p:cNvPr id="24" name="TextBox 23"/>
-          <p:cNvSpPr txBox="1"/>
-          <p:nvPr/>
-        </p:nvSpPr>
-        <p:spPr>
-          <a:xfrm>
-            <a:off x="502920" y="1106424"/>
-            <a:ext cx="4236598" cy="256032"/>
-          </a:xfrm>
-          <a:prstGeom prst="rect">
-            <a:avLst/>
-          </a:prstGeom>
-          <a:noFill/>
-        </p:spPr>
-        <p:txBody>
-          <a:bodyPr wrap="square" anchor="ctr" lIns="36576" rIns="36576" tIns="0" bIns="0">
-            <a:spAutoFit/>
-          </a:bodyPr>
-          <a:lstStyle/>
-          <a:p>
-            <a:pPr algn="l" rtl="1"/>
-            <a:r>
-              <a:rPr sz="1000" b="0">
-                <a:solidFill>
-                  <a:srgbClr val="8A94A8"/>
-                </a:solidFill>
-                <a:latin typeface="Heebo"/>
-                <a:cs typeface="Heebo"/>
-              </a:rPr>
-              <a:t>מובילים את התוכניות שלהם</a:t>
-            </a:r>
-          </a:p>
-        </p:txBody>
-      </p:sp>
-      <p:sp>
-        <p:nvSpPr>
-          <p:cNvPr id="25" name="Rounded Rectangle 24"/>
-          <p:cNvSpPr/>
-          <p:nvPr/>
-        </p:nvSpPr>
-        <p:spPr>
-          <a:xfrm>
-            <a:off x="2666939" y="1380744"/>
-            <a:ext cx="2072579" cy="457200"/>
-          </a:xfrm>
-          <a:prstGeom prst="roundRect">
-            <a:avLst>
-              <a:gd name="adj" fmla="val 18000"/>
-            </a:avLst>
-          </a:prstGeom>
-          <a:solidFill>
-            <a:srgbClr val="FFFFFF"/>
-          </a:solidFill>
-          <a:ln w="15875">
-            <a:solidFill>
-              <a:srgbClr val="C5CDDD"/>
-            </a:solidFill>
-          </a:ln>
-          <a:effectLst/>
-        </p:spPr>
-        <p:style>
-          <a:lnRef idx="1">
-            <a:schemeClr val="accent1"/>
-          </a:lnRef>
-          <a:fillRef idx="3">
-            <a:schemeClr val="accent1"/>
-          </a:fillRef>
-          <a:effectRef idx="2">
-            <a:schemeClr val="accent1"/>
-          </a:effectRef>
-          <a:fontRef idx="minor">
-            <a:schemeClr val="lt1"/>
-          </a:fontRef>
-        </p:style>
-        <p:txBody>
-          <a:bodyPr rtlCol="0" anchor="ctr"/>
-          <a:lstStyle/>
-          <a:p>
-            <a:pPr algn="ctr"/>
-          </a:p>
-        </p:txBody>
-      </p:sp>
-      <p:sp>
-        <p:nvSpPr>
-          <p:cNvPr id="26" name="Rectangle 25"/>
-          <p:cNvSpPr/>
-          <p:nvPr/>
-        </p:nvSpPr>
-        <p:spPr>
-          <a:xfrm>
-            <a:off x="4675510" y="1453896"/>
-            <a:ext cx="45720" cy="310896"/>
-          </a:xfrm>
-          <a:prstGeom prst="rect">
-            <a:avLst/>
-          </a:prstGeom>
-          <a:solidFill>
-            <a:srgbClr val="F0C000"/>
-          </a:solidFill>
-          <a:ln>
-            <a:noFill/>
-          </a:ln>
-          <a:effectLst/>
-        </p:spPr>
-        <p:style>
-          <a:lnRef idx="1">
-            <a:schemeClr val="accent1"/>
-          </a:lnRef>
-          <a:fillRef idx="3">
-            <a:schemeClr val="accent1"/>
-          </a:fillRef>
-          <a:effectRef idx="2">
-            <a:schemeClr val="accent1"/>
-          </a:effectRef>
-          <a:fontRef idx="minor">
-            <a:schemeClr val="lt1"/>
-          </a:fontRef>
-        </p:style>
-        <p:txBody>
-          <a:bodyPr rtlCol="0" anchor="ctr"/>
-          <a:lstStyle/>
-          <a:p>
-            <a:pPr algn="ctr"/>
-          </a:p>
-        </p:txBody>
-      </p:sp>
-      <p:sp>
-        <p:nvSpPr>
-          <p:cNvPr id="27" name="TextBox 26"/>
-          <p:cNvSpPr txBox="1"/>
-          <p:nvPr/>
-        </p:nvSpPr>
-        <p:spPr>
-          <a:xfrm>
-            <a:off x="2666939" y="1435608"/>
-            <a:ext cx="2072579" cy="237744"/>
-          </a:xfrm>
-          <a:prstGeom prst="rect">
-            <a:avLst/>
-          </a:prstGeom>
-          <a:noFill/>
-        </p:spPr>
-        <p:txBody>
-          <a:bodyPr wrap="square" anchor="b" lIns="36576" rIns="36576" tIns="0" bIns="0">
-            <a:spAutoFit/>
-          </a:bodyPr>
-          <a:lstStyle/>
-          <a:p>
-            <a:pPr algn="ctr" rtl="1"/>
-            <a:r>
-              <a:rPr sz="1200" b="1">
-                <a:solidFill>
-                  <a:srgbClr val="1A2233"/>
-                </a:solidFill>
-                <a:latin typeface="Heebo"/>
-                <a:cs typeface="Heebo"/>
-              </a:rPr>
-              <a:t>טל קופל</a:t>
-            </a:r>
-          </a:p>
-        </p:txBody>
-      </p:sp>
-      <p:sp>
-        <p:nvSpPr>
-          <p:cNvPr id="28" name="TextBox 27"/>
-          <p:cNvSpPr txBox="1"/>
-          <p:nvPr/>
-        </p:nvSpPr>
-        <p:spPr>
-          <a:xfrm>
-            <a:off x="2666939" y="1632204"/>
-            <a:ext cx="2072579" cy="182880"/>
-          </a:xfrm>
-          <a:prstGeom prst="rect">
-            <a:avLst/>
-          </a:prstGeom>
-          <a:noFill/>
-        </p:spPr>
-        <p:txBody>
-          <a:bodyPr wrap="square" anchor="t" lIns="36576" rIns="36576" tIns="0" bIns="0">
-            <a:spAutoFit/>
-          </a:bodyPr>
-          <a:lstStyle/>
-          <a:p>
-            <a:pPr algn="ctr" rtl="1"/>
-            <a:r>
-              <a:rPr sz="900" b="0">
-                <a:solidFill>
-                  <a:srgbClr val="8A94A8"/>
-                </a:solidFill>
-                <a:latin typeface="Heebo"/>
-                <a:cs typeface="Heebo"/>
-              </a:rPr>
-              <a:t>חינוך ואתיקה</a:t>
-            </a:r>
-          </a:p>
-        </p:txBody>
-      </p:sp>
-      <p:sp>
-        <p:nvSpPr>
-          <p:cNvPr id="29" name="Rounded Rectangle 28"/>
-          <p:cNvSpPr/>
-          <p:nvPr/>
-        </p:nvSpPr>
-        <p:spPr>
-          <a:xfrm>
-            <a:off x="502920" y="1380744"/>
-            <a:ext cx="2072579" cy="457200"/>
-          </a:xfrm>
-          <a:prstGeom prst="roundRect">
-            <a:avLst>
-              <a:gd name="adj" fmla="val 18000"/>
-            </a:avLst>
-          </a:prstGeom>
-          <a:solidFill>
-            <a:srgbClr val="FFFFFF"/>
-          </a:solidFill>
-          <a:ln w="15875">
-            <a:solidFill>
-              <a:srgbClr val="C5CDDD"/>
-            </a:solidFill>
-          </a:ln>
-          <a:effectLst/>
-        </p:spPr>
-        <p:style>
-          <a:lnRef idx="1">
-            <a:schemeClr val="accent1"/>
-          </a:lnRef>
-          <a:fillRef idx="3">
-            <a:schemeClr val="accent1"/>
-          </a:fillRef>
-          <a:effectRef idx="2">
-            <a:schemeClr val="accent1"/>
-          </a:effectRef>
-          <a:fontRef idx="minor">
-            <a:schemeClr val="lt1"/>
-          </a:fontRef>
-        </p:style>
-        <p:txBody>
-          <a:bodyPr rtlCol="0" anchor="ctr"/>
-          <a:lstStyle/>
-          <a:p>
-            <a:pPr algn="ctr"/>
-          </a:p>
-        </p:txBody>
-      </p:sp>
-      <p:sp>
-        <p:nvSpPr>
-          <p:cNvPr id="30" name="Rectangle 29"/>
-          <p:cNvSpPr/>
-          <p:nvPr/>
-        </p:nvSpPr>
-        <p:spPr>
-          <a:xfrm>
-            <a:off x="2511491" y="1453896"/>
-            <a:ext cx="45720" cy="310896"/>
-          </a:xfrm>
-          <a:prstGeom prst="rect">
-            <a:avLst/>
-          </a:prstGeom>
-          <a:solidFill>
-            <a:srgbClr val="F0C000"/>
-          </a:solidFill>
-          <a:ln>
-            <a:noFill/>
-          </a:ln>
-          <a:effectLst/>
-        </p:spPr>
-        <p:style>
-          <a:lnRef idx="1">
-            <a:schemeClr val="accent1"/>
-          </a:lnRef>
-          <a:fillRef idx="3">
-            <a:schemeClr val="accent1"/>
-          </a:fillRef>
-          <a:effectRef idx="2">
-            <a:schemeClr val="accent1"/>
-          </a:effectRef>
-          <a:fontRef idx="minor">
-            <a:schemeClr val="lt1"/>
-          </a:fontRef>
-        </p:style>
-        <p:txBody>
-          <a:bodyPr rtlCol="0" anchor="ctr"/>
-          <a:lstStyle/>
-          <a:p>
-            <a:pPr algn="ctr"/>
-          </a:p>
-        </p:txBody>
-      </p:sp>
-      <p:sp>
-        <p:nvSpPr>
-          <p:cNvPr id="31" name="TextBox 30"/>
-          <p:cNvSpPr txBox="1"/>
-          <p:nvPr/>
-        </p:nvSpPr>
-        <p:spPr>
-          <a:xfrm>
-            <a:off x="502920" y="1435608"/>
-            <a:ext cx="2072579" cy="237744"/>
-          </a:xfrm>
-          <a:prstGeom prst="rect">
-            <a:avLst/>
-          </a:prstGeom>
-          <a:noFill/>
-        </p:spPr>
-        <p:txBody>
-          <a:bodyPr wrap="square" anchor="b" lIns="36576" rIns="36576" tIns="0" bIns="0">
-            <a:spAutoFit/>
-          </a:bodyPr>
-          <a:lstStyle/>
-          <a:p>
-            <a:pPr algn="ctr" rtl="1"/>
-            <a:r>
-              <a:rPr sz="1200" b="1">
-                <a:solidFill>
-                  <a:srgbClr val="1A2233"/>
-                </a:solidFill>
-                <a:latin typeface="Heebo"/>
-                <a:cs typeface="Heebo"/>
-              </a:rPr>
-              <a:t>עו״ד תמר ארבל</a:t>
-            </a:r>
-          </a:p>
-        </p:txBody>
-      </p:sp>
-      <p:sp>
-        <p:nvSpPr>
-          <p:cNvPr id="32" name="TextBox 31"/>
-          <p:cNvSpPr txBox="1"/>
-          <p:nvPr/>
-        </p:nvSpPr>
-        <p:spPr>
-          <a:xfrm>
-            <a:off x="502920" y="1632204"/>
-            <a:ext cx="2072579" cy="182880"/>
-          </a:xfrm>
-          <a:prstGeom prst="rect">
-            <a:avLst/>
-          </a:prstGeom>
-          <a:noFill/>
-        </p:spPr>
-        <p:txBody>
-          <a:bodyPr wrap="square" anchor="t" lIns="36576" rIns="36576" tIns="0" bIns="0">
-            <a:spAutoFit/>
-          </a:bodyPr>
-          <a:lstStyle/>
-          <a:p>
-            <a:pPr algn="ctr" rtl="1"/>
-            <a:r>
-              <a:rPr sz="900" b="0">
-                <a:solidFill>
-                  <a:srgbClr val="8A94A8"/>
-                </a:solidFill>
-                <a:latin typeface="Heebo"/>
-                <a:cs typeface="Heebo"/>
-              </a:rPr>
-              <a:t>משפט</a:t>
-            </a:r>
-          </a:p>
-        </p:txBody>
-      </p:sp>
-      <p:cxnSp>
-        <p:nvCxnSpPr>
-          <p:cNvPr id="33" name="Connector 32"/>
-          <p:cNvCxnSpPr/>
-          <p:nvPr/>
-        </p:nvCxnSpPr>
-        <p:spPr>
-          <a:xfrm>
-            <a:off x="6095847" y="1892808"/>
-            <a:ext cx="0" cy="210312"/>
-          </a:xfrm>
-          <a:prstGeom prst="line">
-            <a:avLst/>
-          </a:prstGeom>
-          <a:ln w="19050">
-            <a:solidFill>
-              <a:srgbClr val="C5CDDD"/>
-            </a:solidFill>
-          </a:ln>
-        </p:spPr>
-        <p:style>
-          <a:lnRef idx="2">
-            <a:schemeClr val="accent1"/>
-          </a:lnRef>
-          <a:fillRef idx="0">
-            <a:schemeClr val="accent1"/>
-          </a:fillRef>
-          <a:effectRef idx="1">
-            <a:schemeClr val="accent1"/>
-          </a:effectRef>
-          <a:fontRef idx="minor">
-            <a:schemeClr val="tx1"/>
-          </a:fontRef>
-        </p:style>
-      </p:cxnSp>
-      <p:sp>
-        <p:nvSpPr>
-          <p:cNvPr id="34" name="Rounded Rectangle 33"/>
-          <p:cNvSpPr/>
-          <p:nvPr/>
-        </p:nvSpPr>
-        <p:spPr>
-          <a:xfrm>
-            <a:off x="3429000" y="2103120"/>
-            <a:ext cx="5330952" cy="2606040"/>
-          </a:xfrm>
-          <a:prstGeom prst="roundRect">
-            <a:avLst>
-              <a:gd name="adj" fmla="val 5000"/>
-            </a:avLst>
-          </a:prstGeom>
-          <a:solidFill>
-            <a:srgbClr val="FFFFFF"/>
-          </a:solidFill>
-          <a:ln w="31750">
-            <a:solidFill>
-              <a:srgbClr val="F0C000"/>
-            </a:solidFill>
-          </a:ln>
-          <a:effectLst/>
-        </p:spPr>
-        <p:style>
-          <a:lnRef idx="1">
-            <a:schemeClr val="accent1"/>
-          </a:lnRef>
-          <a:fillRef idx="3">
-            <a:schemeClr val="accent1"/>
-          </a:fillRef>
-          <a:effectRef idx="2">
-            <a:schemeClr val="accent1"/>
-          </a:effectRef>
-          <a:fontRef idx="minor">
-            <a:schemeClr val="lt1"/>
-          </a:fontRef>
-        </p:style>
-        <p:txBody>
-          <a:bodyPr rtlCol="0" anchor="ctr"/>
-          <a:lstStyle/>
-          <a:p>
-            <a:pPr algn="ctr"/>
-          </a:p>
-        </p:txBody>
-      </p:sp>
-      <p:sp>
-        <p:nvSpPr>
-          <p:cNvPr id="35" name="TextBox 34"/>
-          <p:cNvSpPr txBox="1"/>
-          <p:nvPr/>
-        </p:nvSpPr>
-        <p:spPr>
-          <a:xfrm>
-            <a:off x="3429000" y="2194560"/>
-            <a:ext cx="5330952" cy="329184"/>
-          </a:xfrm>
-          <a:prstGeom prst="rect">
-            <a:avLst/>
-          </a:prstGeom>
-          <a:noFill/>
-        </p:spPr>
-        <p:txBody>
-          <a:bodyPr wrap="square" anchor="ctr" lIns="36576" rIns="36576" tIns="0" bIns="0">
-            <a:spAutoFit/>
-          </a:bodyPr>
-          <a:lstStyle/>
-          <a:p>
-            <a:pPr algn="ctr" rtl="1"/>
-            <a:r>
-              <a:rPr sz="1700" b="1">
-                <a:solidFill>
-                  <a:srgbClr val="1C3C7A"/>
-                </a:solidFill>
-                <a:latin typeface="Heebo"/>
-                <a:cs typeface="Heebo"/>
-              </a:rPr>
-              <a:t>צוות הכנסת · קבוע ובשכר</a:t>
-            </a:r>
-          </a:p>
-        </p:txBody>
-      </p:sp>
-      <p:sp>
-        <p:nvSpPr>
-          <p:cNvPr id="36" name="Rounded Rectangle 35"/>
-          <p:cNvSpPr/>
-          <p:nvPr/>
-        </p:nvSpPr>
-        <p:spPr>
-          <a:xfrm>
-            <a:off x="7440930" y="2651760"/>
-            <a:ext cx="1181862" cy="566928"/>
-          </a:xfrm>
-          <a:prstGeom prst="roundRect">
-            <a:avLst>
-              <a:gd name="adj" fmla="val 18000"/>
-            </a:avLst>
-          </a:prstGeom>
-          <a:solidFill>
-            <a:srgbClr val="FFFFFF"/>
-          </a:solidFill>
-          <a:ln w="15875">
-            <a:solidFill>
-              <a:srgbClr val="C5CDDD"/>
-            </a:solidFill>
-          </a:ln>
-          <a:effectLst/>
-        </p:spPr>
-        <p:style>
-          <a:lnRef idx="1">
-            <a:schemeClr val="accent1"/>
-          </a:lnRef>
-          <a:fillRef idx="3">
-            <a:schemeClr val="accent1"/>
-          </a:fillRef>
-          <a:effectRef idx="2">
-            <a:schemeClr val="accent1"/>
-          </a:effectRef>
-          <a:fontRef idx="minor">
-            <a:schemeClr val="lt1"/>
-          </a:fontRef>
-        </p:style>
-        <p:txBody>
-          <a:bodyPr rtlCol="0" anchor="ctr"/>
-          <a:lstStyle/>
-          <a:p>
-            <a:pPr algn="ctr"/>
-          </a:p>
-        </p:txBody>
-      </p:sp>
-      <p:sp>
-        <p:nvSpPr>
-          <p:cNvPr id="37" name="Rectangle 36"/>
-          <p:cNvSpPr/>
-          <p:nvPr/>
-        </p:nvSpPr>
-        <p:spPr>
-          <a:xfrm>
-            <a:off x="8558784" y="2724912"/>
-            <a:ext cx="45720" cy="420624"/>
-          </a:xfrm>
-          <a:prstGeom prst="rect">
-            <a:avLst/>
-          </a:prstGeom>
-          <a:solidFill>
-            <a:srgbClr val="F0C000"/>
-          </a:solidFill>
-          <a:ln>
-            <a:noFill/>
-          </a:ln>
-          <a:effectLst/>
-        </p:spPr>
-        <p:style>
-          <a:lnRef idx="1">
-            <a:schemeClr val="accent1"/>
-          </a:lnRef>
-          <a:fillRef idx="3">
-            <a:schemeClr val="accent1"/>
-          </a:fillRef>
-          <a:effectRef idx="2">
-            <a:schemeClr val="accent1"/>
-          </a:effectRef>
-          <a:fontRef idx="minor">
-            <a:schemeClr val="lt1"/>
-          </a:fontRef>
-        </p:style>
-        <p:txBody>
-          <a:bodyPr rtlCol="0" anchor="ctr"/>
-          <a:lstStyle/>
-          <a:p>
-            <a:pPr algn="ctr"/>
-          </a:p>
-        </p:txBody>
-      </p:sp>
-      <p:sp>
-        <p:nvSpPr>
-          <p:cNvPr id="38" name="TextBox 37"/>
-          <p:cNvSpPr txBox="1"/>
-          <p:nvPr/>
-        </p:nvSpPr>
-        <p:spPr>
-          <a:xfrm>
-            <a:off x="7440930" y="2706624"/>
-            <a:ext cx="1181862" cy="294802"/>
-          </a:xfrm>
-          <a:prstGeom prst="rect">
-            <a:avLst/>
-          </a:prstGeom>
-          <a:noFill/>
-        </p:spPr>
-        <p:txBody>
-          <a:bodyPr wrap="square" anchor="b" lIns="36576" rIns="36576" tIns="0" bIns="0">
-            <a:spAutoFit/>
-          </a:bodyPr>
-          <a:lstStyle/>
-          <a:p>
-            <a:pPr algn="ctr" rtl="1"/>
-            <a:r>
-              <a:rPr sz="1200" b="1">
-                <a:solidFill>
-                  <a:srgbClr val="1A2233"/>
-                </a:solidFill>
-                <a:latin typeface="Heebo"/>
-                <a:cs typeface="Heebo"/>
-              </a:rPr>
-              <a:t>תמיר דורטל</a:t>
-            </a:r>
-          </a:p>
-        </p:txBody>
-      </p:sp>
-      <p:sp>
-        <p:nvSpPr>
-          <p:cNvPr id="39" name="TextBox 38"/>
-          <p:cNvSpPr txBox="1"/>
-          <p:nvPr/>
-        </p:nvSpPr>
-        <p:spPr>
-          <a:xfrm>
-            <a:off x="7440930" y="2963570"/>
-            <a:ext cx="1181862" cy="226771"/>
-          </a:xfrm>
-          <a:prstGeom prst="rect">
-            <a:avLst/>
-          </a:prstGeom>
-          <a:noFill/>
-        </p:spPr>
-        <p:txBody>
-          <a:bodyPr wrap="square" anchor="t" lIns="36576" rIns="36576" tIns="0" bIns="0">
-            <a:spAutoFit/>
-          </a:bodyPr>
-          <a:lstStyle/>
-          <a:p>
-            <a:pPr algn="ctr" rtl="1"/>
-            <a:r>
-              <a:rPr sz="900" b="0">
-                <a:solidFill>
-                  <a:srgbClr val="8A94A8"/>
-                </a:solidFill>
-                <a:latin typeface="Heebo"/>
-                <a:cs typeface="Heebo"/>
-              </a:rPr>
-              <a:t>נציג קבוע</a:t>
-            </a:r>
-          </a:p>
-        </p:txBody>
-      </p:sp>
-      <p:sp>
-        <p:nvSpPr>
-          <p:cNvPr id="40" name="Rounded Rectangle 39"/>
-          <p:cNvSpPr/>
-          <p:nvPr/>
-        </p:nvSpPr>
-        <p:spPr>
-          <a:xfrm>
-            <a:off x="6149340" y="2651760"/>
-            <a:ext cx="1181862" cy="566928"/>
-          </a:xfrm>
-          <a:prstGeom prst="roundRect">
-            <a:avLst>
-              <a:gd name="adj" fmla="val 18000"/>
-            </a:avLst>
-          </a:prstGeom>
-          <a:solidFill>
-            <a:srgbClr val="FFFFFF"/>
-          </a:solidFill>
-          <a:ln w="15875">
-            <a:solidFill>
-              <a:srgbClr val="C5CDDD"/>
-            </a:solidFill>
-          </a:ln>
-          <a:effectLst/>
-        </p:spPr>
-        <p:style>
-          <a:lnRef idx="1">
-            <a:schemeClr val="accent1"/>
-          </a:lnRef>
-          <a:fillRef idx="3">
-            <a:schemeClr val="accent1"/>
-          </a:fillRef>
-          <a:effectRef idx="2">
-            <a:schemeClr val="accent1"/>
-          </a:effectRef>
-          <a:fontRef idx="minor">
-            <a:schemeClr val="lt1"/>
-          </a:fontRef>
-        </p:style>
-        <p:txBody>
-          <a:bodyPr rtlCol="0" anchor="ctr"/>
-          <a:lstStyle/>
-          <a:p>
-            <a:pPr algn="ctr"/>
-          </a:p>
-        </p:txBody>
-      </p:sp>
-      <p:sp>
-        <p:nvSpPr>
-          <p:cNvPr id="41" name="Rectangle 40"/>
-          <p:cNvSpPr/>
-          <p:nvPr/>
-        </p:nvSpPr>
-        <p:spPr>
-          <a:xfrm>
-            <a:off x="7267194" y="2724912"/>
-            <a:ext cx="45720" cy="420624"/>
-          </a:xfrm>
-          <a:prstGeom prst="rect">
-            <a:avLst/>
-          </a:prstGeom>
-          <a:solidFill>
-            <a:srgbClr val="F0C000"/>
-          </a:solidFill>
-          <a:ln>
-            <a:noFill/>
-          </a:ln>
-          <a:effectLst/>
-        </p:spPr>
-        <p:style>
-          <a:lnRef idx="1">
-            <a:schemeClr val="accent1"/>
-          </a:lnRef>
-          <a:fillRef idx="3">
-            <a:schemeClr val="accent1"/>
-          </a:fillRef>
-          <a:effectRef idx="2">
-            <a:schemeClr val="accent1"/>
-          </a:effectRef>
-          <a:fontRef idx="minor">
-            <a:schemeClr val="lt1"/>
-          </a:fontRef>
-        </p:style>
-        <p:txBody>
-          <a:bodyPr rtlCol="0" anchor="ctr"/>
-          <a:lstStyle/>
-          <a:p>
-            <a:pPr algn="ctr"/>
-          </a:p>
-        </p:txBody>
-      </p:sp>
-      <p:sp>
-        <p:nvSpPr>
-          <p:cNvPr id="42" name="TextBox 41"/>
-          <p:cNvSpPr txBox="1"/>
-          <p:nvPr/>
-        </p:nvSpPr>
-        <p:spPr>
-          <a:xfrm>
-            <a:off x="6149340" y="2706624"/>
-            <a:ext cx="1181862" cy="294802"/>
+            <a:off x="10293270" y="1435608"/>
+            <a:ext cx="1395505" cy="237744"/>
           </a:xfrm>
           <a:prstGeom prst="rect">
             <a:avLst/>
@@ -18985,14 +17764,14 @@
       </p:sp>
       <p:sp>
         <p:nvSpPr>
-          <p:cNvPr id="43" name="TextBox 42"/>
+          <p:cNvPr id="13" name="TextBox 12"/>
           <p:cNvSpPr txBox="1"/>
           <p:nvPr/>
         </p:nvSpPr>
         <p:spPr>
           <a:xfrm>
-            <a:off x="6149340" y="2963570"/>
-            <a:ext cx="1181862" cy="226771"/>
+            <a:off x="10293270" y="1632204"/>
+            <a:ext cx="1395505" cy="182880"/>
           </a:xfrm>
           <a:prstGeom prst="rect">
             <a:avLst/>
@@ -19014,185 +17793,21 @@
                 <a:latin typeface="Heebo"/>
                 <a:cs typeface="Heebo"/>
               </a:rPr>
-              <a:t>נציג קבוע</a:t>
-            </a:r>
-          </a:p>
-        </p:txBody>
-      </p:sp>
-      <p:sp>
-        <p:nvSpPr>
-          <p:cNvPr id="44" name="Rounded Rectangle 43"/>
-          <p:cNvSpPr/>
-          <p:nvPr/>
-        </p:nvSpPr>
-        <p:spPr>
-          <a:xfrm>
-            <a:off x="4857750" y="2651760"/>
-            <a:ext cx="1181862" cy="566928"/>
-          </a:xfrm>
-          <a:prstGeom prst="roundRect">
-            <a:avLst>
-              <a:gd name="adj" fmla="val 18000"/>
-            </a:avLst>
-          </a:prstGeom>
-          <a:solidFill>
-            <a:srgbClr val="FFFFFF"/>
-          </a:solidFill>
-          <a:ln w="15875">
-            <a:solidFill>
-              <a:srgbClr val="C5CDDD"/>
-            </a:solidFill>
-          </a:ln>
-          <a:effectLst/>
-        </p:spPr>
-        <p:style>
-          <a:lnRef idx="1">
-            <a:schemeClr val="accent1"/>
-          </a:lnRef>
-          <a:fillRef idx="3">
-            <a:schemeClr val="accent1"/>
-          </a:fillRef>
-          <a:effectRef idx="2">
-            <a:schemeClr val="accent1"/>
-          </a:effectRef>
-          <a:fontRef idx="minor">
-            <a:schemeClr val="lt1"/>
-          </a:fontRef>
-        </p:style>
-        <p:txBody>
-          <a:bodyPr rtlCol="0" anchor="ctr"/>
-          <a:lstStyle/>
-          <a:p>
-            <a:pPr algn="ctr"/>
-          </a:p>
-        </p:txBody>
-      </p:sp>
-      <p:sp>
-        <p:nvSpPr>
-          <p:cNvPr id="45" name="Rectangle 44"/>
-          <p:cNvSpPr/>
-          <p:nvPr/>
-        </p:nvSpPr>
-        <p:spPr>
-          <a:xfrm>
-            <a:off x="5975604" y="2724912"/>
-            <a:ext cx="45720" cy="420624"/>
-          </a:xfrm>
-          <a:prstGeom prst="rect">
-            <a:avLst/>
-          </a:prstGeom>
-          <a:solidFill>
-            <a:srgbClr val="F0C000"/>
-          </a:solidFill>
-          <a:ln>
-            <a:noFill/>
-          </a:ln>
-          <a:effectLst/>
-        </p:spPr>
-        <p:style>
-          <a:lnRef idx="1">
-            <a:schemeClr val="accent1"/>
-          </a:lnRef>
-          <a:fillRef idx="3">
-            <a:schemeClr val="accent1"/>
-          </a:fillRef>
-          <a:effectRef idx="2">
-            <a:schemeClr val="accent1"/>
-          </a:effectRef>
-          <a:fontRef idx="minor">
-            <a:schemeClr val="lt1"/>
-          </a:fontRef>
-        </p:style>
-        <p:txBody>
-          <a:bodyPr rtlCol="0" anchor="ctr"/>
-          <a:lstStyle/>
-          <a:p>
-            <a:pPr algn="ctr"/>
-          </a:p>
-        </p:txBody>
-      </p:sp>
-      <p:sp>
-        <p:nvSpPr>
-          <p:cNvPr id="46" name="TextBox 45"/>
-          <p:cNvSpPr txBox="1"/>
-          <p:nvPr/>
-        </p:nvSpPr>
-        <p:spPr>
-          <a:xfrm>
-            <a:off x="4857750" y="2706624"/>
-            <a:ext cx="1181862" cy="294802"/>
-          </a:xfrm>
-          <a:prstGeom prst="rect">
-            <a:avLst/>
-          </a:prstGeom>
-          <a:noFill/>
-        </p:spPr>
-        <p:txBody>
-          <a:bodyPr wrap="square" anchor="b" lIns="36576" rIns="36576" tIns="0" bIns="0">
-            <a:spAutoFit/>
-          </a:bodyPr>
-          <a:lstStyle/>
-          <a:p>
-            <a:pPr algn="ctr" rtl="1"/>
-            <a:r>
-              <a:rPr sz="1200" b="1">
-                <a:solidFill>
-                  <a:srgbClr val="1A2233"/>
-                </a:solidFill>
-                <a:latin typeface="Heebo"/>
-                <a:cs typeface="Heebo"/>
-              </a:rPr>
-              <a:t>ד״ר אמיר רובין</a:t>
-            </a:r>
-          </a:p>
-        </p:txBody>
-      </p:sp>
-      <p:sp>
-        <p:nvSpPr>
-          <p:cNvPr id="47" name="TextBox 46"/>
-          <p:cNvSpPr txBox="1"/>
-          <p:nvPr/>
-        </p:nvSpPr>
-        <p:spPr>
-          <a:xfrm>
-            <a:off x="4857750" y="2963570"/>
-            <a:ext cx="1181862" cy="226771"/>
-          </a:xfrm>
-          <a:prstGeom prst="rect">
-            <a:avLst/>
-          </a:prstGeom>
-          <a:noFill/>
-        </p:spPr>
-        <p:txBody>
-          <a:bodyPr wrap="square" anchor="t" lIns="36576" rIns="36576" tIns="0" bIns="0">
-            <a:spAutoFit/>
-          </a:bodyPr>
-          <a:lstStyle/>
-          <a:p>
-            <a:pPr algn="ctr" rtl="1"/>
-            <a:r>
-              <a:rPr sz="900" b="0">
-                <a:solidFill>
-                  <a:srgbClr val="8A94A8"/>
-                </a:solidFill>
-                <a:latin typeface="Heebo"/>
-                <a:cs typeface="Heebo"/>
-              </a:rPr>
-              <a:t>או עו״ד אודליה קדמי</a:t>
-            </a:r>
-          </a:p>
-        </p:txBody>
-      </p:sp>
-      <p:sp>
-        <p:nvSpPr>
-          <p:cNvPr id="48" name="Rounded Rectangle 47"/>
-          <p:cNvSpPr/>
-          <p:nvPr/>
-        </p:nvSpPr>
-        <p:spPr>
-          <a:xfrm>
-            <a:off x="3566160" y="2651760"/>
-            <a:ext cx="1181862" cy="566928"/>
+              <a:t>מנכ״ל</a:t>
+            </a:r>
+          </a:p>
+        </p:txBody>
+      </p:sp>
+      <p:sp>
+        <p:nvSpPr>
+          <p:cNvPr id="14" name="Rounded Rectangle 13"/>
+          <p:cNvSpPr/>
+          <p:nvPr/>
+        </p:nvSpPr>
+        <p:spPr>
+          <a:xfrm>
+            <a:off x="8806325" y="1380744"/>
+            <a:ext cx="1395505" cy="457200"/>
           </a:xfrm>
           <a:prstGeom prst="roundRect">
             <a:avLst>
@@ -19232,7 +17847,1793 @@
       </p:sp>
       <p:sp>
         <p:nvSpPr>
+          <p:cNvPr id="15" name="TextBox 14"/>
+          <p:cNvSpPr txBox="1"/>
+          <p:nvPr/>
+        </p:nvSpPr>
+        <p:spPr>
+          <a:xfrm>
+            <a:off x="8806325" y="1408176"/>
+            <a:ext cx="1395505" cy="237744"/>
+          </a:xfrm>
+          <a:prstGeom prst="rect">
+            <a:avLst/>
+          </a:prstGeom>
+          <a:noFill/>
+        </p:spPr>
+        <p:txBody>
+          <a:bodyPr wrap="square" anchor="b" lIns="36576" rIns="36576" tIns="0" bIns="0">
+            <a:spAutoFit/>
+          </a:bodyPr>
+          <a:lstStyle/>
+          <a:p>
+            <a:pPr algn="ctr" rtl="1"/>
+            <a:r>
+              <a:rPr sz="1200" b="1">
+                <a:solidFill>
+                  <a:srgbClr val="1C3C7A"/>
+                </a:solidFill>
+                <a:latin typeface="Heebo"/>
+                <a:cs typeface="Heebo"/>
+              </a:rPr>
+              <a:t>עוזר מנכ״ל</a:t>
+            </a:r>
+          </a:p>
+        </p:txBody>
+      </p:sp>
+      <p:sp>
+        <p:nvSpPr>
+          <p:cNvPr id="16" name="TextBox 15"/>
+          <p:cNvSpPr txBox="1"/>
+          <p:nvPr/>
+        </p:nvSpPr>
+        <p:spPr>
+          <a:xfrm>
+            <a:off x="8806325" y="1632204"/>
+            <a:ext cx="1395505" cy="182880"/>
+          </a:xfrm>
+          <a:prstGeom prst="rect">
+            <a:avLst/>
+          </a:prstGeom>
+          <a:noFill/>
+        </p:spPr>
+        <p:txBody>
+          <a:bodyPr wrap="square" anchor="t" lIns="36576" rIns="36576" tIns="0" bIns="0">
+            <a:spAutoFit/>
+          </a:bodyPr>
+          <a:lstStyle/>
+          <a:p>
+            <a:pPr algn="ctr" rtl="1"/>
+            <a:r>
+              <a:rPr sz="900" b="0">
+                <a:solidFill>
+                  <a:srgbClr val="8A94A8"/>
+                </a:solidFill>
+                <a:latin typeface="Heebo"/>
+                <a:cs typeface="Heebo"/>
+              </a:rPr>
+              <a:t>לאיוש</a:t>
+            </a:r>
+          </a:p>
+        </p:txBody>
+      </p:sp>
+      <p:sp>
+        <p:nvSpPr>
+          <p:cNvPr id="17" name="Rounded Rectangle 16"/>
+          <p:cNvSpPr/>
+          <p:nvPr/>
+        </p:nvSpPr>
+        <p:spPr>
+          <a:xfrm>
+            <a:off x="3796850" y="1051560"/>
+            <a:ext cx="4597995" cy="841248"/>
+          </a:xfrm>
+          <a:prstGeom prst="roundRect">
+            <a:avLst>
+              <a:gd name="adj" fmla="val 8000"/>
+            </a:avLst>
+          </a:prstGeom>
+          <a:noFill/>
+          <a:ln w="15875">
+            <a:solidFill>
+              <a:srgbClr val="C5CDDD"/>
+            </a:solidFill>
+          </a:ln>
+          <a:effectLst/>
+        </p:spPr>
+        <p:style>
+          <a:lnRef idx="1">
+            <a:schemeClr val="accent1"/>
+          </a:lnRef>
+          <a:fillRef idx="3">
+            <a:schemeClr val="accent1"/>
+          </a:fillRef>
+          <a:effectRef idx="2">
+            <a:schemeClr val="accent1"/>
+          </a:effectRef>
+          <a:fontRef idx="minor">
+            <a:schemeClr val="lt1"/>
+          </a:fontRef>
+        </p:style>
+        <p:txBody>
+          <a:bodyPr rtlCol="0" anchor="ctr"/>
+          <a:lstStyle/>
+          <a:p>
+            <a:pPr algn="ctr"/>
+          </a:p>
+        </p:txBody>
+      </p:sp>
+      <p:sp>
+        <p:nvSpPr>
+          <p:cNvPr id="18" name="TextBox 17"/>
+          <p:cNvSpPr txBox="1"/>
+          <p:nvPr/>
+        </p:nvSpPr>
+        <p:spPr>
+          <a:xfrm>
+            <a:off x="3888290" y="1088136"/>
+            <a:ext cx="4415115" cy="274320"/>
+          </a:xfrm>
+          <a:prstGeom prst="rect">
+            <a:avLst/>
+          </a:prstGeom>
+          <a:noFill/>
+        </p:spPr>
+        <p:txBody>
+          <a:bodyPr wrap="square" anchor="ctr" lIns="36576" rIns="36576" tIns="0" bIns="0">
+            <a:spAutoFit/>
+          </a:bodyPr>
+          <a:lstStyle/>
+          <a:p>
+            <a:pPr algn="r" rtl="1"/>
+            <a:r>
+              <a:rPr sz="1300" b="1">
+                <a:solidFill>
+                  <a:srgbClr val="1C3C7A"/>
+                </a:solidFill>
+                <a:latin typeface="Heebo"/>
+                <a:cs typeface="Heebo"/>
+              </a:rPr>
+              <a:t>מובילי תחום</a:t>
+            </a:r>
+          </a:p>
+        </p:txBody>
+      </p:sp>
+      <p:sp>
+        <p:nvSpPr>
+          <p:cNvPr id="19" name="TextBox 18"/>
+          <p:cNvSpPr txBox="1"/>
+          <p:nvPr/>
+        </p:nvSpPr>
+        <p:spPr>
+          <a:xfrm>
+            <a:off x="3888290" y="1106424"/>
+            <a:ext cx="4415115" cy="256032"/>
+          </a:xfrm>
+          <a:prstGeom prst="rect">
+            <a:avLst/>
+          </a:prstGeom>
+          <a:noFill/>
+        </p:spPr>
+        <p:txBody>
+          <a:bodyPr wrap="square" anchor="ctr" lIns="36576" rIns="36576" tIns="0" bIns="0">
+            <a:spAutoFit/>
+          </a:bodyPr>
+          <a:lstStyle/>
+          <a:p>
+            <a:pPr algn="l" rtl="1"/>
+            <a:r>
+              <a:rPr sz="1000" b="0">
+                <a:solidFill>
+                  <a:srgbClr val="8A94A8"/>
+                </a:solidFill>
+                <a:latin typeface="Heebo"/>
+                <a:cs typeface="Heebo"/>
+              </a:rPr>
+              <a:t>מובילים את התוכניות שלהם + הופעות בכנסת</a:t>
+            </a:r>
+          </a:p>
+        </p:txBody>
+      </p:sp>
+      <p:sp>
+        <p:nvSpPr>
+          <p:cNvPr id="20" name="Rounded Rectangle 19"/>
+          <p:cNvSpPr/>
+          <p:nvPr/>
+        </p:nvSpPr>
+        <p:spPr>
+          <a:xfrm>
+            <a:off x="6892660" y="1380744"/>
+            <a:ext cx="1410745" cy="457200"/>
+          </a:xfrm>
+          <a:prstGeom prst="roundRect">
+            <a:avLst>
+              <a:gd name="adj" fmla="val 18000"/>
+            </a:avLst>
+          </a:prstGeom>
+          <a:solidFill>
+            <a:srgbClr val="FFFFFF"/>
+          </a:solidFill>
+          <a:ln w="15875">
+            <a:solidFill>
+              <a:srgbClr val="C5CDDD"/>
+            </a:solidFill>
+          </a:ln>
+          <a:effectLst/>
+        </p:spPr>
+        <p:style>
+          <a:lnRef idx="1">
+            <a:schemeClr val="accent1"/>
+          </a:lnRef>
+          <a:fillRef idx="3">
+            <a:schemeClr val="accent1"/>
+          </a:fillRef>
+          <a:effectRef idx="2">
+            <a:schemeClr val="accent1"/>
+          </a:effectRef>
+          <a:fontRef idx="minor">
+            <a:schemeClr val="lt1"/>
+          </a:fontRef>
+        </p:style>
+        <p:txBody>
+          <a:bodyPr rtlCol="0" anchor="ctr"/>
+          <a:lstStyle/>
+          <a:p>
+            <a:pPr algn="ctr"/>
+          </a:p>
+        </p:txBody>
+      </p:sp>
+      <p:sp>
+        <p:nvSpPr>
+          <p:cNvPr id="21" name="Rectangle 20"/>
+          <p:cNvSpPr/>
+          <p:nvPr/>
+        </p:nvSpPr>
+        <p:spPr>
+          <a:xfrm>
+            <a:off x="8239397" y="1453896"/>
+            <a:ext cx="45720" cy="310896"/>
+          </a:xfrm>
+          <a:prstGeom prst="rect">
+            <a:avLst/>
+          </a:prstGeom>
+          <a:solidFill>
+            <a:srgbClr val="F0C000"/>
+          </a:solidFill>
+          <a:ln>
+            <a:noFill/>
+          </a:ln>
+          <a:effectLst/>
+        </p:spPr>
+        <p:style>
+          <a:lnRef idx="1">
+            <a:schemeClr val="accent1"/>
+          </a:lnRef>
+          <a:fillRef idx="3">
+            <a:schemeClr val="accent1"/>
+          </a:fillRef>
+          <a:effectRef idx="2">
+            <a:schemeClr val="accent1"/>
+          </a:effectRef>
+          <a:fontRef idx="minor">
+            <a:schemeClr val="lt1"/>
+          </a:fontRef>
+        </p:style>
+        <p:txBody>
+          <a:bodyPr rtlCol="0" anchor="ctr"/>
+          <a:lstStyle/>
+          <a:p>
+            <a:pPr algn="ctr"/>
+          </a:p>
+        </p:txBody>
+      </p:sp>
+      <p:sp>
+        <p:nvSpPr>
+          <p:cNvPr id="22" name="TextBox 21"/>
+          <p:cNvSpPr txBox="1"/>
+          <p:nvPr/>
+        </p:nvSpPr>
+        <p:spPr>
+          <a:xfrm>
+            <a:off x="6892660" y="1435608"/>
+            <a:ext cx="1410745" cy="237744"/>
+          </a:xfrm>
+          <a:prstGeom prst="rect">
+            <a:avLst/>
+          </a:prstGeom>
+          <a:noFill/>
+        </p:spPr>
+        <p:txBody>
+          <a:bodyPr wrap="square" anchor="b" lIns="36576" rIns="36576" tIns="0" bIns="0">
+            <a:spAutoFit/>
+          </a:bodyPr>
+          <a:lstStyle/>
+          <a:p>
+            <a:pPr algn="ctr" rtl="1"/>
+            <a:r>
+              <a:rPr sz="1200" b="1">
+                <a:solidFill>
+                  <a:srgbClr val="1A2233"/>
+                </a:solidFill>
+                <a:latin typeface="Heebo"/>
+                <a:cs typeface="Heebo"/>
+              </a:rPr>
+              <a:t>עו״ד אודליה קדמי</a:t>
+            </a:r>
+          </a:p>
+        </p:txBody>
+      </p:sp>
+      <p:sp>
+        <p:nvSpPr>
+          <p:cNvPr id="23" name="TextBox 22"/>
+          <p:cNvSpPr txBox="1"/>
+          <p:nvPr/>
+        </p:nvSpPr>
+        <p:spPr>
+          <a:xfrm>
+            <a:off x="6892660" y="1632204"/>
+            <a:ext cx="1410745" cy="182880"/>
+          </a:xfrm>
+          <a:prstGeom prst="rect">
+            <a:avLst/>
+          </a:prstGeom>
+          <a:noFill/>
+        </p:spPr>
+        <p:txBody>
+          <a:bodyPr wrap="square" anchor="t" lIns="36576" rIns="36576" tIns="0" bIns="0">
+            <a:spAutoFit/>
+          </a:bodyPr>
+          <a:lstStyle/>
+          <a:p>
+            <a:pPr algn="ctr" rtl="1"/>
+            <a:r>
+              <a:rPr sz="900" b="0">
+                <a:solidFill>
+                  <a:srgbClr val="8A94A8"/>
+                </a:solidFill>
+                <a:latin typeface="Heebo"/>
+                <a:cs typeface="Heebo"/>
+              </a:rPr>
+              <a:t>ביטחון אישי</a:t>
+            </a:r>
+          </a:p>
+        </p:txBody>
+      </p:sp>
+      <p:sp>
+        <p:nvSpPr>
+          <p:cNvPr id="24" name="Rounded Rectangle 23"/>
+          <p:cNvSpPr/>
+          <p:nvPr/>
+        </p:nvSpPr>
+        <p:spPr>
+          <a:xfrm>
+            <a:off x="5390475" y="1380744"/>
+            <a:ext cx="1410745" cy="457200"/>
+          </a:xfrm>
+          <a:prstGeom prst="roundRect">
+            <a:avLst>
+              <a:gd name="adj" fmla="val 18000"/>
+            </a:avLst>
+          </a:prstGeom>
+          <a:solidFill>
+            <a:srgbClr val="FFFFFF"/>
+          </a:solidFill>
+          <a:ln w="15875">
+            <a:solidFill>
+              <a:srgbClr val="C5CDDD"/>
+            </a:solidFill>
+          </a:ln>
+          <a:effectLst/>
+        </p:spPr>
+        <p:style>
+          <a:lnRef idx="1">
+            <a:schemeClr val="accent1"/>
+          </a:lnRef>
+          <a:fillRef idx="3">
+            <a:schemeClr val="accent1"/>
+          </a:fillRef>
+          <a:effectRef idx="2">
+            <a:schemeClr val="accent1"/>
+          </a:effectRef>
+          <a:fontRef idx="minor">
+            <a:schemeClr val="lt1"/>
+          </a:fontRef>
+        </p:style>
+        <p:txBody>
+          <a:bodyPr rtlCol="0" anchor="ctr"/>
+          <a:lstStyle/>
+          <a:p>
+            <a:pPr algn="ctr"/>
+          </a:p>
+        </p:txBody>
+      </p:sp>
+      <p:sp>
+        <p:nvSpPr>
+          <p:cNvPr id="25" name="Rectangle 24"/>
+          <p:cNvSpPr/>
+          <p:nvPr/>
+        </p:nvSpPr>
+        <p:spPr>
+          <a:xfrm>
+            <a:off x="6737212" y="1453896"/>
+            <a:ext cx="45720" cy="310896"/>
+          </a:xfrm>
+          <a:prstGeom prst="rect">
+            <a:avLst/>
+          </a:prstGeom>
+          <a:solidFill>
+            <a:srgbClr val="F0C000"/>
+          </a:solidFill>
+          <a:ln>
+            <a:noFill/>
+          </a:ln>
+          <a:effectLst/>
+        </p:spPr>
+        <p:style>
+          <a:lnRef idx="1">
+            <a:schemeClr val="accent1"/>
+          </a:lnRef>
+          <a:fillRef idx="3">
+            <a:schemeClr val="accent1"/>
+          </a:fillRef>
+          <a:effectRef idx="2">
+            <a:schemeClr val="accent1"/>
+          </a:effectRef>
+          <a:fontRef idx="minor">
+            <a:schemeClr val="lt1"/>
+          </a:fontRef>
+        </p:style>
+        <p:txBody>
+          <a:bodyPr rtlCol="0" anchor="ctr"/>
+          <a:lstStyle/>
+          <a:p>
+            <a:pPr algn="ctr"/>
+          </a:p>
+        </p:txBody>
+      </p:sp>
+      <p:sp>
+        <p:nvSpPr>
+          <p:cNvPr id="26" name="TextBox 25"/>
+          <p:cNvSpPr txBox="1"/>
+          <p:nvPr/>
+        </p:nvSpPr>
+        <p:spPr>
+          <a:xfrm>
+            <a:off x="5390475" y="1435608"/>
+            <a:ext cx="1410745" cy="237744"/>
+          </a:xfrm>
+          <a:prstGeom prst="rect">
+            <a:avLst/>
+          </a:prstGeom>
+          <a:noFill/>
+        </p:spPr>
+        <p:txBody>
+          <a:bodyPr wrap="square" anchor="b" lIns="36576" rIns="36576" tIns="0" bIns="0">
+            <a:spAutoFit/>
+          </a:bodyPr>
+          <a:lstStyle/>
+          <a:p>
+            <a:pPr algn="ctr" rtl="1"/>
+            <a:r>
+              <a:rPr sz="1200" b="1">
+                <a:solidFill>
+                  <a:srgbClr val="1A2233"/>
+                </a:solidFill>
+                <a:latin typeface="Heebo"/>
+                <a:cs typeface="Heebo"/>
+              </a:rPr>
+              <a:t>נגה ארבל</a:t>
+            </a:r>
+          </a:p>
+        </p:txBody>
+      </p:sp>
+      <p:sp>
+        <p:nvSpPr>
+          <p:cNvPr id="27" name="TextBox 26"/>
+          <p:cNvSpPr txBox="1"/>
+          <p:nvPr/>
+        </p:nvSpPr>
+        <p:spPr>
+          <a:xfrm>
+            <a:off x="5390475" y="1632204"/>
+            <a:ext cx="1410745" cy="182880"/>
+          </a:xfrm>
+          <a:prstGeom prst="rect">
+            <a:avLst/>
+          </a:prstGeom>
+          <a:noFill/>
+        </p:spPr>
+        <p:txBody>
+          <a:bodyPr wrap="square" anchor="t" lIns="36576" rIns="36576" tIns="0" bIns="0">
+            <a:spAutoFit/>
+          </a:bodyPr>
+          <a:lstStyle/>
+          <a:p>
+            <a:pPr algn="ctr" rtl="1"/>
+            <a:r>
+              <a:rPr sz="900" b="0">
+                <a:solidFill>
+                  <a:srgbClr val="8A94A8"/>
+                </a:solidFill>
+                <a:latin typeface="Heebo"/>
+                <a:cs typeface="Heebo"/>
+              </a:rPr>
+              <a:t>חקיקה</a:t>
+            </a:r>
+          </a:p>
+        </p:txBody>
+      </p:sp>
+      <p:sp>
+        <p:nvSpPr>
+          <p:cNvPr id="28" name="Rounded Rectangle 27"/>
+          <p:cNvSpPr/>
+          <p:nvPr/>
+        </p:nvSpPr>
+        <p:spPr>
+          <a:xfrm>
+            <a:off x="3888290" y="1380744"/>
+            <a:ext cx="1410745" cy="457200"/>
+          </a:xfrm>
+          <a:prstGeom prst="roundRect">
+            <a:avLst>
+              <a:gd name="adj" fmla="val 18000"/>
+            </a:avLst>
+          </a:prstGeom>
+          <a:solidFill>
+            <a:srgbClr val="FFFFFF"/>
+          </a:solidFill>
+          <a:ln w="15875">
+            <a:solidFill>
+              <a:srgbClr val="C5CDDD"/>
+            </a:solidFill>
+          </a:ln>
+          <a:effectLst/>
+        </p:spPr>
+        <p:style>
+          <a:lnRef idx="1">
+            <a:schemeClr val="accent1"/>
+          </a:lnRef>
+          <a:fillRef idx="3">
+            <a:schemeClr val="accent1"/>
+          </a:fillRef>
+          <a:effectRef idx="2">
+            <a:schemeClr val="accent1"/>
+          </a:effectRef>
+          <a:fontRef idx="minor">
+            <a:schemeClr val="lt1"/>
+          </a:fontRef>
+        </p:style>
+        <p:txBody>
+          <a:bodyPr rtlCol="0" anchor="ctr"/>
+          <a:lstStyle/>
+          <a:p>
+            <a:pPr algn="ctr"/>
+          </a:p>
+        </p:txBody>
+      </p:sp>
+      <p:sp>
+        <p:nvSpPr>
+          <p:cNvPr id="29" name="Rectangle 28"/>
+          <p:cNvSpPr/>
+          <p:nvPr/>
+        </p:nvSpPr>
+        <p:spPr>
+          <a:xfrm>
+            <a:off x="5235027" y="1453896"/>
+            <a:ext cx="45720" cy="310896"/>
+          </a:xfrm>
+          <a:prstGeom prst="rect">
+            <a:avLst/>
+          </a:prstGeom>
+          <a:solidFill>
+            <a:srgbClr val="F0C000"/>
+          </a:solidFill>
+          <a:ln>
+            <a:noFill/>
+          </a:ln>
+          <a:effectLst/>
+        </p:spPr>
+        <p:style>
+          <a:lnRef idx="1">
+            <a:schemeClr val="accent1"/>
+          </a:lnRef>
+          <a:fillRef idx="3">
+            <a:schemeClr val="accent1"/>
+          </a:fillRef>
+          <a:effectRef idx="2">
+            <a:schemeClr val="accent1"/>
+          </a:effectRef>
+          <a:fontRef idx="minor">
+            <a:schemeClr val="lt1"/>
+          </a:fontRef>
+        </p:style>
+        <p:txBody>
+          <a:bodyPr rtlCol="0" anchor="ctr"/>
+          <a:lstStyle/>
+          <a:p>
+            <a:pPr algn="ctr"/>
+          </a:p>
+        </p:txBody>
+      </p:sp>
+      <p:sp>
+        <p:nvSpPr>
+          <p:cNvPr id="30" name="TextBox 29"/>
+          <p:cNvSpPr txBox="1"/>
+          <p:nvPr/>
+        </p:nvSpPr>
+        <p:spPr>
+          <a:xfrm>
+            <a:off x="3888290" y="1435608"/>
+            <a:ext cx="1410745" cy="237744"/>
+          </a:xfrm>
+          <a:prstGeom prst="rect">
+            <a:avLst/>
+          </a:prstGeom>
+          <a:noFill/>
+        </p:spPr>
+        <p:txBody>
+          <a:bodyPr wrap="square" anchor="b" lIns="36576" rIns="36576" tIns="0" bIns="0">
+            <a:spAutoFit/>
+          </a:bodyPr>
+          <a:lstStyle/>
+          <a:p>
+            <a:pPr algn="ctr" rtl="1"/>
+            <a:r>
+              <a:rPr sz="1200" b="1">
+                <a:solidFill>
+                  <a:srgbClr val="1A2233"/>
+                </a:solidFill>
+                <a:latin typeface="Heebo"/>
+                <a:cs typeface="Heebo"/>
+              </a:rPr>
+              <a:t>שלומית לביא</a:t>
+            </a:r>
+          </a:p>
+        </p:txBody>
+      </p:sp>
+      <p:sp>
+        <p:nvSpPr>
+          <p:cNvPr id="31" name="TextBox 30"/>
+          <p:cNvSpPr txBox="1"/>
+          <p:nvPr/>
+        </p:nvSpPr>
+        <p:spPr>
+          <a:xfrm>
+            <a:off x="3888290" y="1632204"/>
+            <a:ext cx="1410745" cy="182880"/>
+          </a:xfrm>
+          <a:prstGeom prst="rect">
+            <a:avLst/>
+          </a:prstGeom>
+          <a:noFill/>
+        </p:spPr>
+        <p:txBody>
+          <a:bodyPr wrap="square" anchor="t" lIns="36576" rIns="36576" tIns="0" bIns="0">
+            <a:spAutoFit/>
+          </a:bodyPr>
+          <a:lstStyle/>
+          <a:p>
+            <a:pPr algn="ctr" rtl="1"/>
+            <a:r>
+              <a:rPr sz="900" b="0">
+                <a:solidFill>
+                  <a:srgbClr val="8A94A8"/>
+                </a:solidFill>
+                <a:latin typeface="Heebo"/>
+                <a:cs typeface="Heebo"/>
+              </a:rPr>
+              <a:t>רווחה</a:t>
+            </a:r>
+          </a:p>
+        </p:txBody>
+      </p:sp>
+      <p:sp>
+        <p:nvSpPr>
+          <p:cNvPr id="32" name="Rounded Rectangle 31"/>
+          <p:cNvSpPr/>
+          <p:nvPr/>
+        </p:nvSpPr>
+        <p:spPr>
+          <a:xfrm>
+            <a:off x="411480" y="1051560"/>
+            <a:ext cx="3065330" cy="841248"/>
+          </a:xfrm>
+          <a:prstGeom prst="roundRect">
+            <a:avLst>
+              <a:gd name="adj" fmla="val 8000"/>
+            </a:avLst>
+          </a:prstGeom>
+          <a:noFill/>
+          <a:ln w="15875">
+            <a:solidFill>
+              <a:srgbClr val="C5CDDD"/>
+            </a:solidFill>
+          </a:ln>
+          <a:effectLst/>
+        </p:spPr>
+        <p:style>
+          <a:lnRef idx="1">
+            <a:schemeClr val="accent1"/>
+          </a:lnRef>
+          <a:fillRef idx="3">
+            <a:schemeClr val="accent1"/>
+          </a:fillRef>
+          <a:effectRef idx="2">
+            <a:schemeClr val="accent1"/>
+          </a:effectRef>
+          <a:fontRef idx="minor">
+            <a:schemeClr val="lt1"/>
+          </a:fontRef>
+        </p:style>
+        <p:txBody>
+          <a:bodyPr rtlCol="0" anchor="ctr"/>
+          <a:lstStyle/>
+          <a:p>
+            <a:pPr algn="ctr"/>
+          </a:p>
+        </p:txBody>
+      </p:sp>
+      <p:sp>
+        <p:nvSpPr>
+          <p:cNvPr id="33" name="TextBox 32"/>
+          <p:cNvSpPr txBox="1"/>
+          <p:nvPr/>
+        </p:nvSpPr>
+        <p:spPr>
+          <a:xfrm>
+            <a:off x="502920" y="1088136"/>
+            <a:ext cx="2882450" cy="274320"/>
+          </a:xfrm>
+          <a:prstGeom prst="rect">
+            <a:avLst/>
+          </a:prstGeom>
+          <a:noFill/>
+        </p:spPr>
+        <p:txBody>
+          <a:bodyPr wrap="square" anchor="ctr" lIns="36576" rIns="36576" tIns="0" bIns="0">
+            <a:spAutoFit/>
+          </a:bodyPr>
+          <a:lstStyle/>
+          <a:p>
+            <a:pPr algn="r" rtl="1"/>
+            <a:r>
+              <a:rPr sz="1300" b="1">
+                <a:solidFill>
+                  <a:srgbClr val="1C3C7A"/>
+                </a:solidFill>
+                <a:latin typeface="Heebo"/>
+                <a:cs typeface="Heebo"/>
+              </a:rPr>
+              <a:t>יועצים</a:t>
+            </a:r>
+          </a:p>
+        </p:txBody>
+      </p:sp>
+      <p:sp>
+        <p:nvSpPr>
+          <p:cNvPr id="34" name="TextBox 33"/>
+          <p:cNvSpPr txBox="1"/>
+          <p:nvPr/>
+        </p:nvSpPr>
+        <p:spPr>
+          <a:xfrm>
+            <a:off x="502920" y="1106424"/>
+            <a:ext cx="2882450" cy="256032"/>
+          </a:xfrm>
+          <a:prstGeom prst="rect">
+            <a:avLst/>
+          </a:prstGeom>
+          <a:noFill/>
+        </p:spPr>
+        <p:txBody>
+          <a:bodyPr wrap="square" anchor="ctr" lIns="36576" rIns="36576" tIns="0" bIns="0">
+            <a:spAutoFit/>
+          </a:bodyPr>
+          <a:lstStyle/>
+          <a:p>
+            <a:pPr algn="l" rtl="1"/>
+            <a:r>
+              <a:rPr sz="1000" b="0">
+                <a:solidFill>
+                  <a:srgbClr val="8A94A8"/>
+                </a:solidFill>
+                <a:latin typeface="Heebo"/>
+                <a:cs typeface="Heebo"/>
+              </a:rPr>
+              <a:t>מובילים את התוכניות שלהם</a:t>
+            </a:r>
+          </a:p>
+        </p:txBody>
+      </p:sp>
+      <p:sp>
+        <p:nvSpPr>
+          <p:cNvPr id="35" name="Rounded Rectangle 34"/>
+          <p:cNvSpPr/>
+          <p:nvPr/>
+        </p:nvSpPr>
+        <p:spPr>
+          <a:xfrm>
+            <a:off x="1989865" y="1380744"/>
+            <a:ext cx="1395505" cy="457200"/>
+          </a:xfrm>
+          <a:prstGeom prst="roundRect">
+            <a:avLst>
+              <a:gd name="adj" fmla="val 18000"/>
+            </a:avLst>
+          </a:prstGeom>
+          <a:solidFill>
+            <a:srgbClr val="FFFFFF"/>
+          </a:solidFill>
+          <a:ln w="15875">
+            <a:solidFill>
+              <a:srgbClr val="C5CDDD"/>
+            </a:solidFill>
+          </a:ln>
+          <a:effectLst/>
+        </p:spPr>
+        <p:style>
+          <a:lnRef idx="1">
+            <a:schemeClr val="accent1"/>
+          </a:lnRef>
+          <a:fillRef idx="3">
+            <a:schemeClr val="accent1"/>
+          </a:fillRef>
+          <a:effectRef idx="2">
+            <a:schemeClr val="accent1"/>
+          </a:effectRef>
+          <a:fontRef idx="minor">
+            <a:schemeClr val="lt1"/>
+          </a:fontRef>
+        </p:style>
+        <p:txBody>
+          <a:bodyPr rtlCol="0" anchor="ctr"/>
+          <a:lstStyle/>
+          <a:p>
+            <a:pPr algn="ctr"/>
+          </a:p>
+        </p:txBody>
+      </p:sp>
+      <p:sp>
+        <p:nvSpPr>
+          <p:cNvPr id="36" name="Rectangle 35"/>
+          <p:cNvSpPr/>
+          <p:nvPr/>
+        </p:nvSpPr>
+        <p:spPr>
+          <a:xfrm>
+            <a:off x="3321362" y="1453896"/>
+            <a:ext cx="45720" cy="310896"/>
+          </a:xfrm>
+          <a:prstGeom prst="rect">
+            <a:avLst/>
+          </a:prstGeom>
+          <a:solidFill>
+            <a:srgbClr val="F0C000"/>
+          </a:solidFill>
+          <a:ln>
+            <a:noFill/>
+          </a:ln>
+          <a:effectLst/>
+        </p:spPr>
+        <p:style>
+          <a:lnRef idx="1">
+            <a:schemeClr val="accent1"/>
+          </a:lnRef>
+          <a:fillRef idx="3">
+            <a:schemeClr val="accent1"/>
+          </a:fillRef>
+          <a:effectRef idx="2">
+            <a:schemeClr val="accent1"/>
+          </a:effectRef>
+          <a:fontRef idx="minor">
+            <a:schemeClr val="lt1"/>
+          </a:fontRef>
+        </p:style>
+        <p:txBody>
+          <a:bodyPr rtlCol="0" anchor="ctr"/>
+          <a:lstStyle/>
+          <a:p>
+            <a:pPr algn="ctr"/>
+          </a:p>
+        </p:txBody>
+      </p:sp>
+      <p:sp>
+        <p:nvSpPr>
+          <p:cNvPr id="37" name="TextBox 36"/>
+          <p:cNvSpPr txBox="1"/>
+          <p:nvPr/>
+        </p:nvSpPr>
+        <p:spPr>
+          <a:xfrm>
+            <a:off x="1989865" y="1435608"/>
+            <a:ext cx="1395505" cy="237744"/>
+          </a:xfrm>
+          <a:prstGeom prst="rect">
+            <a:avLst/>
+          </a:prstGeom>
+          <a:noFill/>
+        </p:spPr>
+        <p:txBody>
+          <a:bodyPr wrap="square" anchor="b" lIns="36576" rIns="36576" tIns="0" bIns="0">
+            <a:spAutoFit/>
+          </a:bodyPr>
+          <a:lstStyle/>
+          <a:p>
+            <a:pPr algn="ctr" rtl="1"/>
+            <a:r>
+              <a:rPr sz="1200" b="1">
+                <a:solidFill>
+                  <a:srgbClr val="1A2233"/>
+                </a:solidFill>
+                <a:latin typeface="Heebo"/>
+                <a:cs typeface="Heebo"/>
+              </a:rPr>
+              <a:t>טל קופל</a:t>
+            </a:r>
+          </a:p>
+        </p:txBody>
+      </p:sp>
+      <p:sp>
+        <p:nvSpPr>
+          <p:cNvPr id="38" name="TextBox 37"/>
+          <p:cNvSpPr txBox="1"/>
+          <p:nvPr/>
+        </p:nvSpPr>
+        <p:spPr>
+          <a:xfrm>
+            <a:off x="1989865" y="1632204"/>
+            <a:ext cx="1395505" cy="182880"/>
+          </a:xfrm>
+          <a:prstGeom prst="rect">
+            <a:avLst/>
+          </a:prstGeom>
+          <a:noFill/>
+        </p:spPr>
+        <p:txBody>
+          <a:bodyPr wrap="square" anchor="t" lIns="36576" rIns="36576" tIns="0" bIns="0">
+            <a:spAutoFit/>
+          </a:bodyPr>
+          <a:lstStyle/>
+          <a:p>
+            <a:pPr algn="ctr" rtl="1"/>
+            <a:r>
+              <a:rPr sz="900" b="0">
+                <a:solidFill>
+                  <a:srgbClr val="8A94A8"/>
+                </a:solidFill>
+                <a:latin typeface="Heebo"/>
+                <a:cs typeface="Heebo"/>
+              </a:rPr>
+              <a:t>חינוך ואתיקה</a:t>
+            </a:r>
+          </a:p>
+        </p:txBody>
+      </p:sp>
+      <p:sp>
+        <p:nvSpPr>
+          <p:cNvPr id="39" name="Rounded Rectangle 38"/>
+          <p:cNvSpPr/>
+          <p:nvPr/>
+        </p:nvSpPr>
+        <p:spPr>
+          <a:xfrm>
+            <a:off x="502920" y="1380744"/>
+            <a:ext cx="1395505" cy="457200"/>
+          </a:xfrm>
+          <a:prstGeom prst="roundRect">
+            <a:avLst>
+              <a:gd name="adj" fmla="val 18000"/>
+            </a:avLst>
+          </a:prstGeom>
+          <a:solidFill>
+            <a:srgbClr val="FFFFFF"/>
+          </a:solidFill>
+          <a:ln w="15875">
+            <a:solidFill>
+              <a:srgbClr val="C5CDDD"/>
+            </a:solidFill>
+          </a:ln>
+          <a:effectLst/>
+        </p:spPr>
+        <p:style>
+          <a:lnRef idx="1">
+            <a:schemeClr val="accent1"/>
+          </a:lnRef>
+          <a:fillRef idx="3">
+            <a:schemeClr val="accent1"/>
+          </a:fillRef>
+          <a:effectRef idx="2">
+            <a:schemeClr val="accent1"/>
+          </a:effectRef>
+          <a:fontRef idx="minor">
+            <a:schemeClr val="lt1"/>
+          </a:fontRef>
+        </p:style>
+        <p:txBody>
+          <a:bodyPr rtlCol="0" anchor="ctr"/>
+          <a:lstStyle/>
+          <a:p>
+            <a:pPr algn="ctr"/>
+          </a:p>
+        </p:txBody>
+      </p:sp>
+      <p:sp>
+        <p:nvSpPr>
+          <p:cNvPr id="40" name="Rectangle 39"/>
+          <p:cNvSpPr/>
+          <p:nvPr/>
+        </p:nvSpPr>
+        <p:spPr>
+          <a:xfrm>
+            <a:off x="1834417" y="1453896"/>
+            <a:ext cx="45720" cy="310896"/>
+          </a:xfrm>
+          <a:prstGeom prst="rect">
+            <a:avLst/>
+          </a:prstGeom>
+          <a:solidFill>
+            <a:srgbClr val="F0C000"/>
+          </a:solidFill>
+          <a:ln>
+            <a:noFill/>
+          </a:ln>
+          <a:effectLst/>
+        </p:spPr>
+        <p:style>
+          <a:lnRef idx="1">
+            <a:schemeClr val="accent1"/>
+          </a:lnRef>
+          <a:fillRef idx="3">
+            <a:schemeClr val="accent1"/>
+          </a:fillRef>
+          <a:effectRef idx="2">
+            <a:schemeClr val="accent1"/>
+          </a:effectRef>
+          <a:fontRef idx="minor">
+            <a:schemeClr val="lt1"/>
+          </a:fontRef>
+        </p:style>
+        <p:txBody>
+          <a:bodyPr rtlCol="0" anchor="ctr"/>
+          <a:lstStyle/>
+          <a:p>
+            <a:pPr algn="ctr"/>
+          </a:p>
+        </p:txBody>
+      </p:sp>
+      <p:sp>
+        <p:nvSpPr>
+          <p:cNvPr id="41" name="TextBox 40"/>
+          <p:cNvSpPr txBox="1"/>
+          <p:nvPr/>
+        </p:nvSpPr>
+        <p:spPr>
+          <a:xfrm>
+            <a:off x="502920" y="1435608"/>
+            <a:ext cx="1395505" cy="237744"/>
+          </a:xfrm>
+          <a:prstGeom prst="rect">
+            <a:avLst/>
+          </a:prstGeom>
+          <a:noFill/>
+        </p:spPr>
+        <p:txBody>
+          <a:bodyPr wrap="square" anchor="b" lIns="36576" rIns="36576" tIns="0" bIns="0">
+            <a:spAutoFit/>
+          </a:bodyPr>
+          <a:lstStyle/>
+          <a:p>
+            <a:pPr algn="ctr" rtl="1"/>
+            <a:r>
+              <a:rPr sz="1200" b="1">
+                <a:solidFill>
+                  <a:srgbClr val="1A2233"/>
+                </a:solidFill>
+                <a:latin typeface="Heebo"/>
+                <a:cs typeface="Heebo"/>
+              </a:rPr>
+              <a:t>עו״ד תמר ארבל</a:t>
+            </a:r>
+          </a:p>
+        </p:txBody>
+      </p:sp>
+      <p:sp>
+        <p:nvSpPr>
+          <p:cNvPr id="42" name="TextBox 41"/>
+          <p:cNvSpPr txBox="1"/>
+          <p:nvPr/>
+        </p:nvSpPr>
+        <p:spPr>
+          <a:xfrm>
+            <a:off x="502920" y="1632204"/>
+            <a:ext cx="1395505" cy="182880"/>
+          </a:xfrm>
+          <a:prstGeom prst="rect">
+            <a:avLst/>
+          </a:prstGeom>
+          <a:noFill/>
+        </p:spPr>
+        <p:txBody>
+          <a:bodyPr wrap="square" anchor="t" lIns="36576" rIns="36576" tIns="0" bIns="0">
+            <a:spAutoFit/>
+          </a:bodyPr>
+          <a:lstStyle/>
+          <a:p>
+            <a:pPr algn="ctr" rtl="1"/>
+            <a:r>
+              <a:rPr sz="900" b="0">
+                <a:solidFill>
+                  <a:srgbClr val="8A94A8"/>
+                </a:solidFill>
+                <a:latin typeface="Heebo"/>
+                <a:cs typeface="Heebo"/>
+              </a:rPr>
+              <a:t>משפט</a:t>
+            </a:r>
+          </a:p>
+        </p:txBody>
+      </p:sp>
+      <p:cxnSp>
+        <p:nvCxnSpPr>
+          <p:cNvPr id="43" name="Connector 42"/>
+          <p:cNvCxnSpPr/>
+          <p:nvPr/>
+        </p:nvCxnSpPr>
+        <p:spPr>
+          <a:xfrm>
+            <a:off x="6095847" y="1892808"/>
+            <a:ext cx="0" cy="210312"/>
+          </a:xfrm>
+          <a:prstGeom prst="line">
+            <a:avLst/>
+          </a:prstGeom>
+          <a:ln w="19050">
+            <a:solidFill>
+              <a:srgbClr val="C5CDDD"/>
+            </a:solidFill>
+          </a:ln>
+        </p:spPr>
+        <p:style>
+          <a:lnRef idx="2">
+            <a:schemeClr val="accent1"/>
+          </a:lnRef>
+          <a:fillRef idx="0">
+            <a:schemeClr val="accent1"/>
+          </a:fillRef>
+          <a:effectRef idx="1">
+            <a:schemeClr val="accent1"/>
+          </a:effectRef>
+          <a:fontRef idx="minor">
+            <a:schemeClr val="tx1"/>
+          </a:fontRef>
+        </p:style>
+      </p:cxnSp>
+      <p:sp>
+        <p:nvSpPr>
+          <p:cNvPr id="44" name="Rounded Rectangle 43"/>
+          <p:cNvSpPr/>
+          <p:nvPr/>
+        </p:nvSpPr>
+        <p:spPr>
+          <a:xfrm>
+            <a:off x="3429000" y="2103120"/>
+            <a:ext cx="5330952" cy="2606040"/>
+          </a:xfrm>
+          <a:prstGeom prst="roundRect">
+            <a:avLst>
+              <a:gd name="adj" fmla="val 5000"/>
+            </a:avLst>
+          </a:prstGeom>
+          <a:solidFill>
+            <a:srgbClr val="FFFFFF"/>
+          </a:solidFill>
+          <a:ln w="31750">
+            <a:solidFill>
+              <a:srgbClr val="F0C000"/>
+            </a:solidFill>
+          </a:ln>
+          <a:effectLst/>
+        </p:spPr>
+        <p:style>
+          <a:lnRef idx="1">
+            <a:schemeClr val="accent1"/>
+          </a:lnRef>
+          <a:fillRef idx="3">
+            <a:schemeClr val="accent1"/>
+          </a:fillRef>
+          <a:effectRef idx="2">
+            <a:schemeClr val="accent1"/>
+          </a:effectRef>
+          <a:fontRef idx="minor">
+            <a:schemeClr val="lt1"/>
+          </a:fontRef>
+        </p:style>
+        <p:txBody>
+          <a:bodyPr rtlCol="0" anchor="ctr"/>
+          <a:lstStyle/>
+          <a:p>
+            <a:pPr algn="ctr"/>
+          </a:p>
+        </p:txBody>
+      </p:sp>
+      <p:sp>
+        <p:nvSpPr>
+          <p:cNvPr id="45" name="TextBox 44"/>
+          <p:cNvSpPr txBox="1"/>
+          <p:nvPr/>
+        </p:nvSpPr>
+        <p:spPr>
+          <a:xfrm>
+            <a:off x="3429000" y="2194560"/>
+            <a:ext cx="5330952" cy="329184"/>
+          </a:xfrm>
+          <a:prstGeom prst="rect">
+            <a:avLst/>
+          </a:prstGeom>
+          <a:noFill/>
+        </p:spPr>
+        <p:txBody>
+          <a:bodyPr wrap="square" anchor="ctr" lIns="36576" rIns="36576" tIns="0" bIns="0">
+            <a:spAutoFit/>
+          </a:bodyPr>
+          <a:lstStyle/>
+          <a:p>
+            <a:pPr algn="ctr" rtl="1"/>
+            <a:r>
+              <a:rPr sz="1700" b="1">
+                <a:solidFill>
+                  <a:srgbClr val="1C3C7A"/>
+                </a:solidFill>
+                <a:latin typeface="Heebo"/>
+                <a:cs typeface="Heebo"/>
+              </a:rPr>
+              <a:t>צוות הכנסת · קבוע ובשכר</a:t>
+            </a:r>
+          </a:p>
+        </p:txBody>
+      </p:sp>
+      <p:sp>
+        <p:nvSpPr>
+          <p:cNvPr id="46" name="Rounded Rectangle 45"/>
+          <p:cNvSpPr/>
+          <p:nvPr/>
+        </p:nvSpPr>
+        <p:spPr>
+          <a:xfrm>
+            <a:off x="7440930" y="2651760"/>
+            <a:ext cx="1181862" cy="566928"/>
+          </a:xfrm>
+          <a:prstGeom prst="roundRect">
+            <a:avLst>
+              <a:gd name="adj" fmla="val 18000"/>
+            </a:avLst>
+          </a:prstGeom>
+          <a:solidFill>
+            <a:srgbClr val="FFFFFF"/>
+          </a:solidFill>
+          <a:ln w="15875">
+            <a:solidFill>
+              <a:srgbClr val="C5CDDD"/>
+            </a:solidFill>
+          </a:ln>
+          <a:effectLst/>
+        </p:spPr>
+        <p:style>
+          <a:lnRef idx="1">
+            <a:schemeClr val="accent1"/>
+          </a:lnRef>
+          <a:fillRef idx="3">
+            <a:schemeClr val="accent1"/>
+          </a:fillRef>
+          <a:effectRef idx="2">
+            <a:schemeClr val="accent1"/>
+          </a:effectRef>
+          <a:fontRef idx="minor">
+            <a:schemeClr val="lt1"/>
+          </a:fontRef>
+        </p:style>
+        <p:txBody>
+          <a:bodyPr rtlCol="0" anchor="ctr"/>
+          <a:lstStyle/>
+          <a:p>
+            <a:pPr algn="ctr"/>
+          </a:p>
+        </p:txBody>
+      </p:sp>
+      <p:sp>
+        <p:nvSpPr>
+          <p:cNvPr id="47" name="Rectangle 46"/>
+          <p:cNvSpPr/>
+          <p:nvPr/>
+        </p:nvSpPr>
+        <p:spPr>
+          <a:xfrm>
+            <a:off x="8558784" y="2724912"/>
+            <a:ext cx="45720" cy="420624"/>
+          </a:xfrm>
+          <a:prstGeom prst="rect">
+            <a:avLst/>
+          </a:prstGeom>
+          <a:solidFill>
+            <a:srgbClr val="F0C000"/>
+          </a:solidFill>
+          <a:ln>
+            <a:noFill/>
+          </a:ln>
+          <a:effectLst/>
+        </p:spPr>
+        <p:style>
+          <a:lnRef idx="1">
+            <a:schemeClr val="accent1"/>
+          </a:lnRef>
+          <a:fillRef idx="3">
+            <a:schemeClr val="accent1"/>
+          </a:fillRef>
+          <a:effectRef idx="2">
+            <a:schemeClr val="accent1"/>
+          </a:effectRef>
+          <a:fontRef idx="minor">
+            <a:schemeClr val="lt1"/>
+          </a:fontRef>
+        </p:style>
+        <p:txBody>
+          <a:bodyPr rtlCol="0" anchor="ctr"/>
+          <a:lstStyle/>
+          <a:p>
+            <a:pPr algn="ctr"/>
+          </a:p>
+        </p:txBody>
+      </p:sp>
+      <p:sp>
+        <p:nvSpPr>
+          <p:cNvPr id="48" name="TextBox 47"/>
+          <p:cNvSpPr txBox="1"/>
+          <p:nvPr/>
+        </p:nvSpPr>
+        <p:spPr>
+          <a:xfrm>
+            <a:off x="7440930" y="2706624"/>
+            <a:ext cx="1181862" cy="294802"/>
+          </a:xfrm>
+          <a:prstGeom prst="rect">
+            <a:avLst/>
+          </a:prstGeom>
+          <a:noFill/>
+        </p:spPr>
+        <p:txBody>
+          <a:bodyPr wrap="square" anchor="b" lIns="36576" rIns="36576" tIns="0" bIns="0">
+            <a:spAutoFit/>
+          </a:bodyPr>
+          <a:lstStyle/>
+          <a:p>
+            <a:pPr algn="ctr" rtl="1"/>
+            <a:r>
+              <a:rPr sz="1200" b="1">
+                <a:solidFill>
+                  <a:srgbClr val="1A2233"/>
+                </a:solidFill>
+                <a:latin typeface="Heebo"/>
+                <a:cs typeface="Heebo"/>
+              </a:rPr>
+              <a:t>תמיר דורטל</a:t>
+            </a:r>
+          </a:p>
+        </p:txBody>
+      </p:sp>
+      <p:sp>
+        <p:nvSpPr>
           <p:cNvPr id="49" name="TextBox 48"/>
+          <p:cNvSpPr txBox="1"/>
+          <p:nvPr/>
+        </p:nvSpPr>
+        <p:spPr>
+          <a:xfrm>
+            <a:off x="7440930" y="2963570"/>
+            <a:ext cx="1181862" cy="226771"/>
+          </a:xfrm>
+          <a:prstGeom prst="rect">
+            <a:avLst/>
+          </a:prstGeom>
+          <a:noFill/>
+        </p:spPr>
+        <p:txBody>
+          <a:bodyPr wrap="square" anchor="t" lIns="36576" rIns="36576" tIns="0" bIns="0">
+            <a:spAutoFit/>
+          </a:bodyPr>
+          <a:lstStyle/>
+          <a:p>
+            <a:pPr algn="ctr" rtl="1"/>
+            <a:r>
+              <a:rPr sz="900" b="0">
+                <a:solidFill>
+                  <a:srgbClr val="8A94A8"/>
+                </a:solidFill>
+                <a:latin typeface="Heebo"/>
+                <a:cs typeface="Heebo"/>
+              </a:rPr>
+              <a:t>נציג קבוע</a:t>
+            </a:r>
+          </a:p>
+        </p:txBody>
+      </p:sp>
+      <p:sp>
+        <p:nvSpPr>
+          <p:cNvPr id="50" name="Rounded Rectangle 49"/>
+          <p:cNvSpPr/>
+          <p:nvPr/>
+        </p:nvSpPr>
+        <p:spPr>
+          <a:xfrm>
+            <a:off x="6149340" y="2651760"/>
+            <a:ext cx="1181862" cy="566928"/>
+          </a:xfrm>
+          <a:prstGeom prst="roundRect">
+            <a:avLst>
+              <a:gd name="adj" fmla="val 18000"/>
+            </a:avLst>
+          </a:prstGeom>
+          <a:solidFill>
+            <a:srgbClr val="FFFFFF"/>
+          </a:solidFill>
+          <a:ln w="15875">
+            <a:solidFill>
+              <a:srgbClr val="C5CDDD"/>
+            </a:solidFill>
+          </a:ln>
+          <a:effectLst/>
+        </p:spPr>
+        <p:style>
+          <a:lnRef idx="1">
+            <a:schemeClr val="accent1"/>
+          </a:lnRef>
+          <a:fillRef idx="3">
+            <a:schemeClr val="accent1"/>
+          </a:fillRef>
+          <a:effectRef idx="2">
+            <a:schemeClr val="accent1"/>
+          </a:effectRef>
+          <a:fontRef idx="minor">
+            <a:schemeClr val="lt1"/>
+          </a:fontRef>
+        </p:style>
+        <p:txBody>
+          <a:bodyPr rtlCol="0" anchor="ctr"/>
+          <a:lstStyle/>
+          <a:p>
+            <a:pPr algn="ctr"/>
+          </a:p>
+        </p:txBody>
+      </p:sp>
+      <p:sp>
+        <p:nvSpPr>
+          <p:cNvPr id="51" name="Rectangle 50"/>
+          <p:cNvSpPr/>
+          <p:nvPr/>
+        </p:nvSpPr>
+        <p:spPr>
+          <a:xfrm>
+            <a:off x="7267194" y="2724912"/>
+            <a:ext cx="45720" cy="420624"/>
+          </a:xfrm>
+          <a:prstGeom prst="rect">
+            <a:avLst/>
+          </a:prstGeom>
+          <a:solidFill>
+            <a:srgbClr val="F0C000"/>
+          </a:solidFill>
+          <a:ln>
+            <a:noFill/>
+          </a:ln>
+          <a:effectLst/>
+        </p:spPr>
+        <p:style>
+          <a:lnRef idx="1">
+            <a:schemeClr val="accent1"/>
+          </a:lnRef>
+          <a:fillRef idx="3">
+            <a:schemeClr val="accent1"/>
+          </a:fillRef>
+          <a:effectRef idx="2">
+            <a:schemeClr val="accent1"/>
+          </a:effectRef>
+          <a:fontRef idx="minor">
+            <a:schemeClr val="lt1"/>
+          </a:fontRef>
+        </p:style>
+        <p:txBody>
+          <a:bodyPr rtlCol="0" anchor="ctr"/>
+          <a:lstStyle/>
+          <a:p>
+            <a:pPr algn="ctr"/>
+          </a:p>
+        </p:txBody>
+      </p:sp>
+      <p:sp>
+        <p:nvSpPr>
+          <p:cNvPr id="52" name="TextBox 51"/>
+          <p:cNvSpPr txBox="1"/>
+          <p:nvPr/>
+        </p:nvSpPr>
+        <p:spPr>
+          <a:xfrm>
+            <a:off x="6149340" y="2706624"/>
+            <a:ext cx="1181862" cy="294802"/>
+          </a:xfrm>
+          <a:prstGeom prst="rect">
+            <a:avLst/>
+          </a:prstGeom>
+          <a:noFill/>
+        </p:spPr>
+        <p:txBody>
+          <a:bodyPr wrap="square" anchor="b" lIns="36576" rIns="36576" tIns="0" bIns="0">
+            <a:spAutoFit/>
+          </a:bodyPr>
+          <a:lstStyle/>
+          <a:p>
+            <a:pPr algn="ctr" rtl="1"/>
+            <a:r>
+              <a:rPr sz="1200" b="1">
+                <a:solidFill>
+                  <a:srgbClr val="1A2233"/>
+                </a:solidFill>
+                <a:latin typeface="Heebo"/>
+                <a:cs typeface="Heebo"/>
+              </a:rPr>
+              <a:t>אדם קורגן</a:t>
+            </a:r>
+          </a:p>
+        </p:txBody>
+      </p:sp>
+      <p:sp>
+        <p:nvSpPr>
+          <p:cNvPr id="53" name="TextBox 52"/>
+          <p:cNvSpPr txBox="1"/>
+          <p:nvPr/>
+        </p:nvSpPr>
+        <p:spPr>
+          <a:xfrm>
+            <a:off x="6149340" y="2963570"/>
+            <a:ext cx="1181862" cy="226771"/>
+          </a:xfrm>
+          <a:prstGeom prst="rect">
+            <a:avLst/>
+          </a:prstGeom>
+          <a:noFill/>
+        </p:spPr>
+        <p:txBody>
+          <a:bodyPr wrap="square" anchor="t" lIns="36576" rIns="36576" tIns="0" bIns="0">
+            <a:spAutoFit/>
+          </a:bodyPr>
+          <a:lstStyle/>
+          <a:p>
+            <a:pPr algn="ctr" rtl="1"/>
+            <a:r>
+              <a:rPr sz="900" b="0">
+                <a:solidFill>
+                  <a:srgbClr val="8A94A8"/>
+                </a:solidFill>
+                <a:latin typeface="Heebo"/>
+                <a:cs typeface="Heebo"/>
+              </a:rPr>
+              <a:t>נציג קבוע</a:t>
+            </a:r>
+          </a:p>
+        </p:txBody>
+      </p:sp>
+      <p:sp>
+        <p:nvSpPr>
+          <p:cNvPr id="54" name="Rounded Rectangle 53"/>
+          <p:cNvSpPr/>
+          <p:nvPr/>
+        </p:nvSpPr>
+        <p:spPr>
+          <a:xfrm>
+            <a:off x="4857750" y="2651760"/>
+            <a:ext cx="1181862" cy="566928"/>
+          </a:xfrm>
+          <a:prstGeom prst="roundRect">
+            <a:avLst>
+              <a:gd name="adj" fmla="val 18000"/>
+            </a:avLst>
+          </a:prstGeom>
+          <a:solidFill>
+            <a:srgbClr val="FFFFFF"/>
+          </a:solidFill>
+          <a:ln w="15875">
+            <a:solidFill>
+              <a:srgbClr val="C5CDDD"/>
+            </a:solidFill>
+          </a:ln>
+          <a:effectLst/>
+        </p:spPr>
+        <p:style>
+          <a:lnRef idx="1">
+            <a:schemeClr val="accent1"/>
+          </a:lnRef>
+          <a:fillRef idx="3">
+            <a:schemeClr val="accent1"/>
+          </a:fillRef>
+          <a:effectRef idx="2">
+            <a:schemeClr val="accent1"/>
+          </a:effectRef>
+          <a:fontRef idx="minor">
+            <a:schemeClr val="lt1"/>
+          </a:fontRef>
+        </p:style>
+        <p:txBody>
+          <a:bodyPr rtlCol="0" anchor="ctr"/>
+          <a:lstStyle/>
+          <a:p>
+            <a:pPr algn="ctr"/>
+          </a:p>
+        </p:txBody>
+      </p:sp>
+      <p:sp>
+        <p:nvSpPr>
+          <p:cNvPr id="55" name="Rectangle 54"/>
+          <p:cNvSpPr/>
+          <p:nvPr/>
+        </p:nvSpPr>
+        <p:spPr>
+          <a:xfrm>
+            <a:off x="5975604" y="2724912"/>
+            <a:ext cx="45720" cy="420624"/>
+          </a:xfrm>
+          <a:prstGeom prst="rect">
+            <a:avLst/>
+          </a:prstGeom>
+          <a:solidFill>
+            <a:srgbClr val="F0C000"/>
+          </a:solidFill>
+          <a:ln>
+            <a:noFill/>
+          </a:ln>
+          <a:effectLst/>
+        </p:spPr>
+        <p:style>
+          <a:lnRef idx="1">
+            <a:schemeClr val="accent1"/>
+          </a:lnRef>
+          <a:fillRef idx="3">
+            <a:schemeClr val="accent1"/>
+          </a:fillRef>
+          <a:effectRef idx="2">
+            <a:schemeClr val="accent1"/>
+          </a:effectRef>
+          <a:fontRef idx="minor">
+            <a:schemeClr val="lt1"/>
+          </a:fontRef>
+        </p:style>
+        <p:txBody>
+          <a:bodyPr rtlCol="0" anchor="ctr"/>
+          <a:lstStyle/>
+          <a:p>
+            <a:pPr algn="ctr"/>
+          </a:p>
+        </p:txBody>
+      </p:sp>
+      <p:sp>
+        <p:nvSpPr>
+          <p:cNvPr id="56" name="TextBox 55"/>
+          <p:cNvSpPr txBox="1"/>
+          <p:nvPr/>
+        </p:nvSpPr>
+        <p:spPr>
+          <a:xfrm>
+            <a:off x="4857750" y="2706624"/>
+            <a:ext cx="1181862" cy="294802"/>
+          </a:xfrm>
+          <a:prstGeom prst="rect">
+            <a:avLst/>
+          </a:prstGeom>
+          <a:noFill/>
+        </p:spPr>
+        <p:txBody>
+          <a:bodyPr wrap="square" anchor="b" lIns="36576" rIns="36576" tIns="0" bIns="0">
+            <a:spAutoFit/>
+          </a:bodyPr>
+          <a:lstStyle/>
+          <a:p>
+            <a:pPr algn="ctr" rtl="1"/>
+            <a:r>
+              <a:rPr sz="1200" b="1">
+                <a:solidFill>
+                  <a:srgbClr val="1A2233"/>
+                </a:solidFill>
+                <a:latin typeface="Heebo"/>
+                <a:cs typeface="Heebo"/>
+              </a:rPr>
+              <a:t>ד״ר אמיר רובין</a:t>
+            </a:r>
+          </a:p>
+        </p:txBody>
+      </p:sp>
+      <p:sp>
+        <p:nvSpPr>
+          <p:cNvPr id="57" name="TextBox 56"/>
+          <p:cNvSpPr txBox="1"/>
+          <p:nvPr/>
+        </p:nvSpPr>
+        <p:spPr>
+          <a:xfrm>
+            <a:off x="4857750" y="2963570"/>
+            <a:ext cx="1181862" cy="226771"/>
+          </a:xfrm>
+          <a:prstGeom prst="rect">
+            <a:avLst/>
+          </a:prstGeom>
+          <a:noFill/>
+        </p:spPr>
+        <p:txBody>
+          <a:bodyPr wrap="square" anchor="t" lIns="36576" rIns="36576" tIns="0" bIns="0">
+            <a:spAutoFit/>
+          </a:bodyPr>
+          <a:lstStyle/>
+          <a:p>
+            <a:pPr algn="ctr" rtl="1"/>
+            <a:r>
+              <a:rPr sz="900" b="0">
+                <a:solidFill>
+                  <a:srgbClr val="8A94A8"/>
+                </a:solidFill>
+                <a:latin typeface="Heebo"/>
+                <a:cs typeface="Heebo"/>
+              </a:rPr>
+              <a:t>או עו״ד אודליה קדמי</a:t>
+            </a:r>
+          </a:p>
+        </p:txBody>
+      </p:sp>
+      <p:sp>
+        <p:nvSpPr>
+          <p:cNvPr id="58" name="Rounded Rectangle 57"/>
+          <p:cNvSpPr/>
+          <p:nvPr/>
+        </p:nvSpPr>
+        <p:spPr>
+          <a:xfrm>
+            <a:off x="3566160" y="2651760"/>
+            <a:ext cx="1181862" cy="566928"/>
+          </a:xfrm>
+          <a:prstGeom prst="roundRect">
+            <a:avLst>
+              <a:gd name="adj" fmla="val 18000"/>
+            </a:avLst>
+          </a:prstGeom>
+          <a:noFill/>
+          <a:ln w="15875">
+            <a:solidFill>
+              <a:srgbClr val="F0C000"/>
+            </a:solidFill>
+            <a:prstDash val="dash"/>
+          </a:ln>
+          <a:effectLst/>
+        </p:spPr>
+        <p:style>
+          <a:lnRef idx="1">
+            <a:schemeClr val="accent1"/>
+          </a:lnRef>
+          <a:fillRef idx="3">
+            <a:schemeClr val="accent1"/>
+          </a:fillRef>
+          <a:effectRef idx="2">
+            <a:schemeClr val="accent1"/>
+          </a:effectRef>
+          <a:fontRef idx="minor">
+            <a:schemeClr val="lt1"/>
+          </a:fontRef>
+        </p:style>
+        <p:txBody>
+          <a:bodyPr rtlCol="0" anchor="ctr"/>
+          <a:lstStyle/>
+          <a:p>
+            <a:pPr algn="ctr"/>
+          </a:p>
+        </p:txBody>
+      </p:sp>
+      <p:sp>
+        <p:nvSpPr>
+          <p:cNvPr id="59" name="TextBox 58"/>
           <p:cNvSpPr txBox="1"/>
           <p:nvPr/>
         </p:nvSpPr>
@@ -19268,7 +19669,7 @@
       </p:sp>
       <p:sp>
         <p:nvSpPr>
-          <p:cNvPr id="50" name="TextBox 49"/>
+          <p:cNvPr id="60" name="TextBox 59"/>
           <p:cNvSpPr txBox="1"/>
           <p:nvPr/>
         </p:nvSpPr>
@@ -19304,7 +19705,7 @@
       </p:sp>
       <p:sp>
         <p:nvSpPr>
-          <p:cNvPr id="51" name="Rounded Rectangle 50"/>
+          <p:cNvPr id="61" name="Rounded Rectangle 60"/>
           <p:cNvSpPr/>
           <p:nvPr/>
         </p:nvSpPr>
@@ -19352,7 +19753,7 @@
       </p:sp>
       <p:sp>
         <p:nvSpPr>
-          <p:cNvPr id="52" name="TextBox 51"/>
+          <p:cNvPr id="62" name="TextBox 61"/>
           <p:cNvSpPr txBox="1"/>
           <p:nvPr/>
         </p:nvSpPr>
@@ -19388,7 +19789,7 @@
       </p:sp>
       <p:sp>
         <p:nvSpPr>
-          <p:cNvPr id="53" name="TextBox 52"/>
+          <p:cNvPr id="63" name="TextBox 62"/>
           <p:cNvSpPr txBox="1"/>
           <p:nvPr/>
         </p:nvSpPr>
@@ -19424,7 +19825,7 @@
       </p:sp>
       <p:sp>
         <p:nvSpPr>
-          <p:cNvPr id="54" name="Rounded Rectangle 53"/>
+          <p:cNvPr id="64" name="Rounded Rectangle 63"/>
           <p:cNvSpPr/>
           <p:nvPr/>
         </p:nvSpPr>
@@ -19470,7 +19871,7 @@
       </p:sp>
       <p:sp>
         <p:nvSpPr>
-          <p:cNvPr id="55" name="TextBox 54"/>
+          <p:cNvPr id="65" name="TextBox 64"/>
           <p:cNvSpPr txBox="1"/>
           <p:nvPr/>
         </p:nvSpPr>
@@ -19506,7 +19907,7 @@
       </p:sp>
       <p:sp>
         <p:nvSpPr>
-          <p:cNvPr id="56" name="Rounded Rectangle 55"/>
+          <p:cNvPr id="66" name="Rounded Rectangle 65"/>
           <p:cNvSpPr/>
           <p:nvPr/>
         </p:nvSpPr>
@@ -19552,7 +19953,7 @@
       </p:sp>
       <p:sp>
         <p:nvSpPr>
-          <p:cNvPr id="57" name="TextBox 56"/>
+          <p:cNvPr id="67" name="TextBox 66"/>
           <p:cNvSpPr txBox="1"/>
           <p:nvPr/>
         </p:nvSpPr>
@@ -19588,7 +19989,7 @@
       </p:sp>
       <p:sp>
         <p:nvSpPr>
-          <p:cNvPr id="58" name="Rounded Rectangle 57"/>
+          <p:cNvPr id="68" name="Rounded Rectangle 67"/>
           <p:cNvSpPr/>
           <p:nvPr/>
         </p:nvSpPr>
@@ -19636,7 +20037,7 @@
       </p:sp>
       <p:sp>
         <p:nvSpPr>
-          <p:cNvPr id="59" name="Rounded Rectangle 58"/>
+          <p:cNvPr id="69" name="Rounded Rectangle 68"/>
           <p:cNvSpPr/>
           <p:nvPr/>
         </p:nvSpPr>
@@ -19682,7 +20083,7 @@
       </p:sp>
       <p:sp>
         <p:nvSpPr>
-          <p:cNvPr id="60" name="TextBox 59"/>
+          <p:cNvPr id="70" name="TextBox 69"/>
           <p:cNvSpPr txBox="1"/>
           <p:nvPr/>
         </p:nvSpPr>
@@ -19718,7 +20119,7 @@
       </p:sp>
       <p:sp>
         <p:nvSpPr>
-          <p:cNvPr id="61" name="TextBox 60"/>
+          <p:cNvPr id="71" name="TextBox 70"/>
           <p:cNvSpPr txBox="1"/>
           <p:nvPr/>
         </p:nvSpPr>
@@ -19754,7 +20155,7 @@
       </p:sp>
       <p:sp>
         <p:nvSpPr>
-          <p:cNvPr id="62" name="TextBox 61"/>
+          <p:cNvPr id="72" name="TextBox 71"/>
           <p:cNvSpPr txBox="1"/>
           <p:nvPr/>
         </p:nvSpPr>
@@ -19790,7 +20191,7 @@
       </p:sp>
       <p:sp>
         <p:nvSpPr>
-          <p:cNvPr id="63" name="TextBox 62"/>
+          <p:cNvPr id="73" name="TextBox 72"/>
           <p:cNvSpPr txBox="1"/>
           <p:nvPr/>
         </p:nvSpPr>
@@ -19826,7 +20227,7 @@
       </p:sp>
       <p:cxnSp>
         <p:nvCxnSpPr>
-          <p:cNvPr id="64" name="Connector 63"/>
+          <p:cNvPr id="74" name="Connector 73"/>
           <p:cNvCxnSpPr/>
           <p:nvPr/>
         </p:nvCxnSpPr>
@@ -19862,7 +20263,7 @@
       </p:cxnSp>
       <p:sp>
         <p:nvSpPr>
-          <p:cNvPr id="65" name="Rounded Rectangle 64"/>
+          <p:cNvPr id="75" name="Rounded Rectangle 74"/>
           <p:cNvSpPr/>
           <p:nvPr/>
         </p:nvSpPr>
@@ -19910,7 +20311,7 @@
       </p:sp>
       <p:sp>
         <p:nvSpPr>
-          <p:cNvPr id="66" name="Rounded Rectangle 65"/>
+          <p:cNvPr id="76" name="Rounded Rectangle 75"/>
           <p:cNvSpPr/>
           <p:nvPr/>
         </p:nvSpPr>
@@ -19956,7 +20357,7 @@
       </p:sp>
       <p:sp>
         <p:nvSpPr>
-          <p:cNvPr id="67" name="TextBox 66"/>
+          <p:cNvPr id="77" name="TextBox 76"/>
           <p:cNvSpPr txBox="1"/>
           <p:nvPr/>
         </p:nvSpPr>
@@ -19992,7 +20393,7 @@
       </p:sp>
       <p:sp>
         <p:nvSpPr>
-          <p:cNvPr id="68" name="TextBox 67"/>
+          <p:cNvPr id="78" name="TextBox 77"/>
           <p:cNvSpPr txBox="1"/>
           <p:nvPr/>
         </p:nvSpPr>
@@ -20028,7 +20429,7 @@
       </p:sp>
       <p:sp>
         <p:nvSpPr>
-          <p:cNvPr id="69" name="TextBox 68"/>
+          <p:cNvPr id="79" name="TextBox 78"/>
           <p:cNvSpPr txBox="1"/>
           <p:nvPr/>
         </p:nvSpPr>
@@ -20064,7 +20465,7 @@
       </p:sp>
       <p:sp>
         <p:nvSpPr>
-          <p:cNvPr id="70" name="TextBox 69"/>
+          <p:cNvPr id="80" name="TextBox 79"/>
           <p:cNvSpPr txBox="1"/>
           <p:nvPr/>
         </p:nvSpPr>
@@ -20100,7 +20501,7 @@
       </p:sp>
       <p:cxnSp>
         <p:nvCxnSpPr>
-          <p:cNvPr id="71" name="Connector 70"/>
+          <p:cNvPr id="81" name="Connector 80"/>
           <p:cNvCxnSpPr/>
           <p:nvPr/>
         </p:nvCxnSpPr>
@@ -20136,7 +20537,7 @@
       </p:cxnSp>
       <p:cxnSp>
         <p:nvCxnSpPr>
-          <p:cNvPr id="72" name="Connector 71"/>
+          <p:cNvPr id="82" name="Connector 81"/>
           <p:cNvCxnSpPr/>
           <p:nvPr/>
         </p:nvCxnSpPr>
@@ -20172,7 +20573,7 @@
       </p:cxnSp>
       <p:sp>
         <p:nvSpPr>
-          <p:cNvPr id="73" name="Rounded Rectangle 72"/>
+          <p:cNvPr id="83" name="Rounded Rectangle 82"/>
           <p:cNvSpPr/>
           <p:nvPr/>
         </p:nvSpPr>
@@ -20220,7 +20621,7 @@
       </p:sp>
       <p:sp>
         <p:nvSpPr>
-          <p:cNvPr id="74" name="TextBox 73"/>
+          <p:cNvPr id="84" name="TextBox 83"/>
           <p:cNvSpPr txBox="1"/>
           <p:nvPr/>
         </p:nvSpPr>
@@ -20256,7 +20657,7 @@
       </p:sp>
       <p:sp>
         <p:nvSpPr>
-          <p:cNvPr id="75" name="TextBox 74"/>
+          <p:cNvPr id="85" name="TextBox 84"/>
           <p:cNvSpPr txBox="1"/>
           <p:nvPr/>
         </p:nvSpPr>
@@ -20292,26 +20693,26 @@
       </p:sp>
       <p:sp>
         <p:nvSpPr>
-          <p:cNvPr id="76" name="Rounded Rectangle 75"/>
-          <p:cNvSpPr/>
-          <p:nvPr/>
-        </p:nvSpPr>
-        <p:spPr>
-          <a:xfrm>
-            <a:off x="411480" y="5989320"/>
-            <a:ext cx="11368735" cy="658368"/>
+          <p:cNvPr id="86" name="Rounded Rectangle 85"/>
+          <p:cNvSpPr/>
+          <p:nvPr/>
+        </p:nvSpPr>
+        <p:spPr>
+          <a:xfrm>
+            <a:off x="6187288" y="5897880"/>
+            <a:ext cx="5592927" cy="841248"/>
           </a:xfrm>
           <a:prstGeom prst="roundRect">
             <a:avLst>
-              <a:gd name="adj" fmla="val 14000"/>
+              <a:gd name="adj" fmla="val 12000"/>
             </a:avLst>
           </a:prstGeom>
           <a:solidFill>
             <a:srgbClr val="FFFFFF"/>
           </a:solidFill>
-          <a:ln w="22225">
+          <a:ln w="25400">
             <a:solidFill>
-              <a:srgbClr val="1C3C7A"/>
+              <a:srgbClr val="D64545"/>
             </a:solidFill>
           </a:ln>
           <a:effectLst/>
@@ -20340,20 +20741,20 @@
       </p:sp>
       <p:sp>
         <p:nvSpPr>
-          <p:cNvPr id="77" name="Oval 76"/>
-          <p:cNvSpPr/>
-          <p:nvPr/>
-        </p:nvSpPr>
-        <p:spPr>
-          <a:xfrm>
-            <a:off x="11231575" y="6135624"/>
-            <a:ext cx="365760" cy="365760"/>
+          <p:cNvPr id="87" name="Oval 86"/>
+          <p:cNvSpPr/>
+          <p:nvPr/>
+        </p:nvSpPr>
+        <p:spPr>
+          <a:xfrm>
+            <a:off x="11323015" y="6007608"/>
+            <a:ext cx="329184" cy="329184"/>
           </a:xfrm>
           <a:prstGeom prst="ellipse">
             <a:avLst/>
           </a:prstGeom>
           <a:solidFill>
-            <a:srgbClr val="F0C000"/>
+            <a:srgbClr val="D64545"/>
           </a:solidFill>
           <a:ln>
             <a:noFill/>
@@ -20384,14 +20785,14 @@
       </p:sp>
       <p:sp>
         <p:nvSpPr>
-          <p:cNvPr id="78" name="TextBox 77"/>
+          <p:cNvPr id="88" name="TextBox 87"/>
           <p:cNvSpPr txBox="1"/>
           <p:nvPr/>
         </p:nvSpPr>
         <p:spPr>
           <a:xfrm>
-            <a:off x="11140135" y="6135624"/>
-            <a:ext cx="548640" cy="365760"/>
+            <a:off x="11231575" y="6007608"/>
+            <a:ext cx="512064" cy="329184"/>
           </a:xfrm>
           <a:prstGeom prst="rect">
             <a:avLst/>
@@ -20408,7 +20809,7 @@
             <a:r>
               <a:rPr sz="1200" b="1">
                 <a:solidFill>
-                  <a:srgbClr val="122755"/>
+                  <a:srgbClr val="FFFFFF"/>
                 </a:solidFill>
                 <a:latin typeface="Heebo"/>
                 <a:cs typeface="Heebo"/>
@@ -20420,14 +20821,14 @@
       </p:sp>
       <p:sp>
         <p:nvSpPr>
-          <p:cNvPr id="79" name="TextBox 78"/>
+          <p:cNvPr id="89" name="TextBox 88"/>
           <p:cNvSpPr txBox="1"/>
           <p:nvPr/>
         </p:nvSpPr>
         <p:spPr>
           <a:xfrm>
-            <a:off x="594360" y="6044184"/>
-            <a:ext cx="10500055" cy="292608"/>
+            <a:off x="6324448" y="5989320"/>
+            <a:ext cx="4907127" cy="329184"/>
           </a:xfrm>
           <a:prstGeom prst="rect">
             <a:avLst/>
@@ -20444,26 +20845,154 @@
             <a:r>
               <a:rPr sz="1400" b="1">
                 <a:solidFill>
-                  <a:srgbClr val="1C3C7A"/>
+                  <a:srgbClr val="D64545"/>
                 </a:solidFill>
                 <a:latin typeface="Heebo"/>
                 <a:cs typeface="Heebo"/>
               </a:rPr>
-              <a:t>אקטיביסט הולך לדיון לבד רק אם אין בשום אופן נציג אחר.</a:t>
-            </a:r>
-          </a:p>
-        </p:txBody>
-      </p:sp>
-      <p:sp>
-        <p:nvSpPr>
-          <p:cNvPr id="80" name="TextBox 79"/>
+              <a:t>נציג קבוע בכל דיון: זה מה שבונה אמינות</a:t>
+            </a:r>
+          </a:p>
+        </p:txBody>
+      </p:sp>
+      <p:sp>
+        <p:nvSpPr>
+          <p:cNvPr id="90" name="TextBox 89"/>
           <p:cNvSpPr txBox="1"/>
           <p:nvPr/>
         </p:nvSpPr>
         <p:spPr>
           <a:xfrm>
-            <a:off x="594360" y="6336792"/>
-            <a:ext cx="10500055" cy="256032"/>
+            <a:off x="6324448" y="6318504"/>
+            <a:ext cx="5318607" cy="384048"/>
+          </a:xfrm>
+          <a:prstGeom prst="rect">
+            <a:avLst/>
+          </a:prstGeom>
+          <a:noFill/>
+        </p:spPr>
+        <p:txBody>
+          <a:bodyPr wrap="square" anchor="t" lIns="36576" rIns="36576" tIns="0" bIns="0">
+            <a:spAutoFit/>
+          </a:bodyPr>
+          <a:lstStyle/>
+          <a:p>
+            <a:pPr algn="r" rtl="1"/>
+            <a:r>
+              <a:rPr sz="1100" b="0">
+                <a:solidFill>
+                  <a:srgbClr val="1A2233"/>
+                </a:solidFill>
+                <a:latin typeface="Heebo"/>
+                <a:cs typeface="Heebo"/>
+              </a:rPr>
+              <a:t>אקטיביסט יגיע לדיון לבד רק כשאין בשום אופן נציג אחר. מערך שנשען על מתנדבים יקרוס בחיתוליו, גם תדמיתית וגם אופרטיבית.</a:t>
+            </a:r>
+          </a:p>
+        </p:txBody>
+      </p:sp>
+      <p:sp>
+        <p:nvSpPr>
+          <p:cNvPr id="91" name="Rounded Rectangle 90"/>
+          <p:cNvSpPr/>
+          <p:nvPr/>
+        </p:nvSpPr>
+        <p:spPr>
+          <a:xfrm>
+            <a:off x="411481" y="5897880"/>
+            <a:ext cx="5592927" cy="841248"/>
+          </a:xfrm>
+          <a:prstGeom prst="roundRect">
+            <a:avLst>
+              <a:gd name="adj" fmla="val 12000"/>
+            </a:avLst>
+          </a:prstGeom>
+          <a:solidFill>
+            <a:srgbClr val="FFFFFF"/>
+          </a:solidFill>
+          <a:ln w="25400">
+            <a:solidFill>
+              <a:srgbClr val="D64545"/>
+            </a:solidFill>
+          </a:ln>
+          <a:effectLst/>
+        </p:spPr>
+        <p:style>
+          <a:lnRef idx="1">
+            <a:schemeClr val="accent1"/>
+          </a:lnRef>
+          <a:fillRef idx="3">
+            <a:schemeClr val="accent1"/>
+          </a:fillRef>
+          <a:effectRef idx="2">
+            <a:schemeClr val="accent1"/>
+          </a:effectRef>
+          <a:fontRef idx="minor">
+            <a:schemeClr val="lt1"/>
+          </a:fontRef>
+        </p:style>
+        <p:txBody>
+          <a:bodyPr rtlCol="0" anchor="ctr"/>
+          <a:lstStyle/>
+          <a:p>
+            <a:pPr algn="ctr"/>
+          </a:p>
+        </p:txBody>
+      </p:sp>
+      <p:sp>
+        <p:nvSpPr>
+          <p:cNvPr id="92" name="Oval 91"/>
+          <p:cNvSpPr/>
+          <p:nvPr/>
+        </p:nvSpPr>
+        <p:spPr>
+          <a:xfrm>
+            <a:off x="5547208" y="6007608"/>
+            <a:ext cx="329184" cy="329184"/>
+          </a:xfrm>
+          <a:prstGeom prst="ellipse">
+            <a:avLst/>
+          </a:prstGeom>
+          <a:solidFill>
+            <a:srgbClr val="D64545"/>
+          </a:solidFill>
+          <a:ln>
+            <a:noFill/>
+          </a:ln>
+          <a:effectLst/>
+        </p:spPr>
+        <p:style>
+          <a:lnRef idx="1">
+            <a:schemeClr val="accent1"/>
+          </a:lnRef>
+          <a:fillRef idx="3">
+            <a:schemeClr val="accent1"/>
+          </a:fillRef>
+          <a:effectRef idx="2">
+            <a:schemeClr val="accent1"/>
+          </a:effectRef>
+          <a:fontRef idx="minor">
+            <a:schemeClr val="lt1"/>
+          </a:fontRef>
+        </p:style>
+        <p:txBody>
+          <a:bodyPr rtlCol="0" anchor="ctr"/>
+          <a:lstStyle/>
+          <a:p>
+            <a:pPr algn="ctr"/>
+          </a:p>
+        </p:txBody>
+      </p:sp>
+      <p:sp>
+        <p:nvSpPr>
+          <p:cNvPr id="93" name="TextBox 92"/>
+          <p:cNvSpPr txBox="1"/>
+          <p:nvPr/>
+        </p:nvSpPr>
+        <p:spPr>
+          <a:xfrm>
+            <a:off x="5455768" y="6007608"/>
+            <a:ext cx="512064" cy="329184"/>
           </a:xfrm>
           <a:prstGeom prst="rect">
             <a:avLst/>
@@ -20476,16 +21005,88 @@
           </a:bodyPr>
           <a:lstStyle/>
           <a:p>
-            <a:pPr algn="r" rtl="1"/>
-            <a:r>
-              <a:rPr sz="1200" b="0">
-                <a:solidFill>
-                  <a:srgbClr val="1A2233"/>
+            <a:pPr algn="ctr" rtl="0"/>
+            <a:r>
+              <a:rPr sz="1200" b="1">
+                <a:solidFill>
+                  <a:srgbClr val="FFFFFF"/>
                 </a:solidFill>
                 <a:latin typeface="Heebo"/>
                 <a:cs typeface="Heebo"/>
               </a:rPr>
-              <a:t>מערך שמאויש במתנדבים יקרוס, וייחסל את הפעילות בחיתוליה, גם תדמיתית וגם אופרטיבית.</a:t>
+              <a:t>!</a:t>
+            </a:r>
+          </a:p>
+        </p:txBody>
+      </p:sp>
+      <p:sp>
+        <p:nvSpPr>
+          <p:cNvPr id="94" name="TextBox 93"/>
+          <p:cNvSpPr txBox="1"/>
+          <p:nvPr/>
+        </p:nvSpPr>
+        <p:spPr>
+          <a:xfrm>
+            <a:off x="548641" y="5989320"/>
+            <a:ext cx="4907127" cy="329184"/>
+          </a:xfrm>
+          <a:prstGeom prst="rect">
+            <a:avLst/>
+          </a:prstGeom>
+          <a:noFill/>
+        </p:spPr>
+        <p:txBody>
+          <a:bodyPr wrap="square" anchor="ctr" lIns="36576" rIns="36576" tIns="0" bIns="0">
+            <a:spAutoFit/>
+          </a:bodyPr>
+          <a:lstStyle/>
+          <a:p>
+            <a:pPr algn="r" rtl="1"/>
+            <a:r>
+              <a:rPr sz="1400" b="1">
+                <a:solidFill>
+                  <a:srgbClr val="D64545"/>
+                </a:solidFill>
+                <a:latin typeface="Heebo"/>
+                <a:cs typeface="Heebo"/>
+              </a:rPr>
+              <a:t>איש התוכן הוא חלק מהצוות, לא ספק חיצוני</a:t>
+            </a:r>
+          </a:p>
+        </p:txBody>
+      </p:sp>
+      <p:sp>
+        <p:nvSpPr>
+          <p:cNvPr id="95" name="TextBox 94"/>
+          <p:cNvSpPr txBox="1"/>
+          <p:nvPr/>
+        </p:nvSpPr>
+        <p:spPr>
+          <a:xfrm>
+            <a:off x="548641" y="6318504"/>
+            <a:ext cx="5318607" cy="384048"/>
+          </a:xfrm>
+          <a:prstGeom prst="rect">
+            <a:avLst/>
+          </a:prstGeom>
+          <a:noFill/>
+        </p:spPr>
+        <p:txBody>
+          <a:bodyPr wrap="square" anchor="t" lIns="36576" rIns="36576" tIns="0" bIns="0">
+            <a:spAutoFit/>
+          </a:bodyPr>
+          <a:lstStyle/>
+          <a:p>
+            <a:pPr algn="r" rtl="1"/>
+            <a:r>
+              <a:rPr sz="1100" b="0">
+                <a:solidFill>
+                  <a:srgbClr val="1A2233"/>
+                </a:solidFill>
+                <a:latin typeface="Heebo"/>
+                <a:cs typeface="Heebo"/>
+              </a:rPr>
+              <a:t>רק מי שיושב בסדר היום מבפנים יכול להפוך כל דיון בכנסת לחשיפה: מהר, מדויק ואמין.</a:t>
             </a:r>
           </a:p>
         </p:txBody>

</xml_diff>

<commit_message>
Slide 1: drop permanent-reps stat
Co-Authored-By: Claude Opus 5.5 <noreply@anthropic.com>
Claude-Session: https://claude.ai/code/session_01W7Er83FuNT4pLFShWidYHn
</commit_message>
<xml_diff>
--- a/presentation/out/koach-hitarvut.pptx
+++ b/presentation/out/koach-hitarvut.pptx
@@ -3396,51 +3396,6 @@
         </p:nvSpPr>
         <p:spPr>
           <a:xfrm>
-            <a:off x="2148840" y="201168"/>
-            <a:ext cx="2148840" cy="457200"/>
-          </a:xfrm>
-          <a:prstGeom prst="rect">
-            <a:avLst/>
-          </a:prstGeom>
-          <a:noFill/>
-        </p:spPr>
-        <p:txBody>
-          <a:bodyPr wrap="square" anchor="ctr" lIns="36576" rIns="36576" tIns="0" bIns="0">
-            <a:spAutoFit/>
-          </a:bodyPr>
-          <a:lstStyle/>
-          <a:p>
-            <a:pPr algn="r" rtl="1"/>
-            <a:r>
-              <a:rPr sz="2200" b="1">
-                <a:solidFill>
-                  <a:srgbClr val="F0C000"/>
-                </a:solidFill>
-                <a:latin typeface="Heebo"/>
-                <a:cs typeface="Heebo"/>
-              </a:rPr>
-              <a:t>0</a:t>
-            </a:r>
-            <a:r>
-              <a:rPr sz="1300">
-                <a:solidFill>
-                  <a:srgbClr val="FFFFFF"/>
-                </a:solidFill>
-                <a:latin typeface="Heebo"/>
-              </a:rPr>
-              <a:t> נציגים קבועים בכנסת</a:t>
-            </a:r>
-          </a:p>
-        </p:txBody>
-      </p:sp>
-      <p:sp>
-        <p:nvSpPr>
-          <p:cNvPr id="10" name="TextBox 9"/>
-          <p:cNvSpPr txBox="1"/>
-          <p:nvPr/>
-        </p:nvSpPr>
-        <p:spPr>
-          <a:xfrm>
             <a:off x="411480" y="987552"/>
             <a:ext cx="11368735" cy="237744"/>
           </a:xfrm>
@@ -3471,7 +3426,7 @@
       </p:sp>
       <p:sp>
         <p:nvSpPr>
-          <p:cNvPr id="11" name="Rounded Rectangle 10"/>
+          <p:cNvPr id="10" name="Rounded Rectangle 9"/>
           <p:cNvSpPr/>
           <p:nvPr/>
         </p:nvSpPr>
@@ -3517,7 +3472,7 @@
       </p:sp>
       <p:sp>
         <p:nvSpPr>
-          <p:cNvPr id="12" name="TextBox 11"/>
+          <p:cNvPr id="11" name="TextBox 10"/>
           <p:cNvSpPr txBox="1"/>
           <p:nvPr/>
         </p:nvSpPr>
@@ -3553,7 +3508,7 @@
       </p:sp>
       <p:sp>
         <p:nvSpPr>
-          <p:cNvPr id="13" name="TextBox 12"/>
+          <p:cNvPr id="12" name="TextBox 11"/>
           <p:cNvSpPr txBox="1"/>
           <p:nvPr/>
         </p:nvSpPr>
@@ -3589,7 +3544,7 @@
       </p:sp>
       <p:sp>
         <p:nvSpPr>
-          <p:cNvPr id="14" name="Rounded Rectangle 13"/>
+          <p:cNvPr id="13" name="Rounded Rectangle 12"/>
           <p:cNvSpPr/>
           <p:nvPr/>
         </p:nvSpPr>
@@ -3635,7 +3590,7 @@
       </p:sp>
       <p:sp>
         <p:nvSpPr>
-          <p:cNvPr id="15" name="TextBox 14"/>
+          <p:cNvPr id="14" name="TextBox 13"/>
           <p:cNvSpPr txBox="1"/>
           <p:nvPr/>
         </p:nvSpPr>
@@ -3671,7 +3626,7 @@
       </p:sp>
       <p:sp>
         <p:nvSpPr>
-          <p:cNvPr id="16" name="TextBox 15"/>
+          <p:cNvPr id="15" name="TextBox 14"/>
           <p:cNvSpPr txBox="1"/>
           <p:nvPr/>
         </p:nvSpPr>
@@ -3707,7 +3662,7 @@
       </p:sp>
       <p:sp>
         <p:nvSpPr>
-          <p:cNvPr id="17" name="Rounded Rectangle 16"/>
+          <p:cNvPr id="16" name="Rounded Rectangle 15"/>
           <p:cNvSpPr/>
           <p:nvPr/>
         </p:nvSpPr>
@@ -3753,7 +3708,7 @@
       </p:sp>
       <p:sp>
         <p:nvSpPr>
-          <p:cNvPr id="18" name="TextBox 17"/>
+          <p:cNvPr id="17" name="TextBox 16"/>
           <p:cNvSpPr txBox="1"/>
           <p:nvPr/>
         </p:nvSpPr>
@@ -3789,7 +3744,7 @@
       </p:sp>
       <p:sp>
         <p:nvSpPr>
-          <p:cNvPr id="19" name="TextBox 18"/>
+          <p:cNvPr id="18" name="TextBox 17"/>
           <p:cNvSpPr txBox="1"/>
           <p:nvPr/>
         </p:nvSpPr>
@@ -3825,7 +3780,7 @@
       </p:sp>
       <p:sp>
         <p:nvSpPr>
-          <p:cNvPr id="20" name="Rounded Rectangle 19"/>
+          <p:cNvPr id="19" name="Rounded Rectangle 18"/>
           <p:cNvSpPr/>
           <p:nvPr/>
         </p:nvSpPr>
@@ -3871,7 +3826,7 @@
       </p:sp>
       <p:sp>
         <p:nvSpPr>
-          <p:cNvPr id="21" name="TextBox 20"/>
+          <p:cNvPr id="20" name="TextBox 19"/>
           <p:cNvSpPr txBox="1"/>
           <p:nvPr/>
         </p:nvSpPr>
@@ -3907,7 +3862,7 @@
       </p:sp>
       <p:sp>
         <p:nvSpPr>
-          <p:cNvPr id="22" name="TextBox 21"/>
+          <p:cNvPr id="21" name="TextBox 20"/>
           <p:cNvSpPr txBox="1"/>
           <p:nvPr/>
         </p:nvSpPr>
@@ -3943,7 +3898,7 @@
       </p:sp>
       <p:sp>
         <p:nvSpPr>
-          <p:cNvPr id="23" name="Rounded Rectangle 22"/>
+          <p:cNvPr id="22" name="Rounded Rectangle 21"/>
           <p:cNvSpPr/>
           <p:nvPr/>
         </p:nvSpPr>
@@ -3989,7 +3944,7 @@
       </p:sp>
       <p:sp>
         <p:nvSpPr>
-          <p:cNvPr id="24" name="TextBox 23"/>
+          <p:cNvPr id="23" name="TextBox 22"/>
           <p:cNvSpPr txBox="1"/>
           <p:nvPr/>
         </p:nvSpPr>
@@ -4025,7 +3980,7 @@
       </p:sp>
       <p:sp>
         <p:nvSpPr>
-          <p:cNvPr id="25" name="TextBox 24"/>
+          <p:cNvPr id="24" name="TextBox 23"/>
           <p:cNvSpPr txBox="1"/>
           <p:nvPr/>
         </p:nvSpPr>
@@ -4061,7 +4016,7 @@
       </p:sp>
       <p:sp>
         <p:nvSpPr>
-          <p:cNvPr id="26" name="Rounded Rectangle 25"/>
+          <p:cNvPr id="25" name="Rounded Rectangle 24"/>
           <p:cNvSpPr/>
           <p:nvPr/>
         </p:nvSpPr>
@@ -4107,7 +4062,7 @@
       </p:sp>
       <p:sp>
         <p:nvSpPr>
-          <p:cNvPr id="27" name="TextBox 26"/>
+          <p:cNvPr id="26" name="TextBox 25"/>
           <p:cNvSpPr txBox="1"/>
           <p:nvPr/>
         </p:nvSpPr>
@@ -4143,7 +4098,7 @@
       </p:sp>
       <p:sp>
         <p:nvSpPr>
-          <p:cNvPr id="28" name="TextBox 27"/>
+          <p:cNvPr id="27" name="TextBox 26"/>
           <p:cNvSpPr txBox="1"/>
           <p:nvPr/>
         </p:nvSpPr>
@@ -4179,7 +4134,7 @@
       </p:sp>
       <p:sp>
         <p:nvSpPr>
-          <p:cNvPr id="29" name="Rounded Rectangle 28"/>
+          <p:cNvPr id="28" name="Rounded Rectangle 27"/>
           <p:cNvSpPr/>
           <p:nvPr/>
         </p:nvSpPr>
@@ -4225,7 +4180,7 @@
       </p:sp>
       <p:sp>
         <p:nvSpPr>
-          <p:cNvPr id="30" name="TextBox 29"/>
+          <p:cNvPr id="29" name="TextBox 28"/>
           <p:cNvSpPr txBox="1"/>
           <p:nvPr/>
         </p:nvSpPr>
@@ -4261,7 +4216,7 @@
       </p:sp>
       <p:sp>
         <p:nvSpPr>
-          <p:cNvPr id="31" name="TextBox 30"/>
+          <p:cNvPr id="30" name="TextBox 29"/>
           <p:cNvSpPr txBox="1"/>
           <p:nvPr/>
         </p:nvSpPr>
@@ -4297,7 +4252,7 @@
       </p:sp>
       <p:cxnSp>
         <p:nvCxnSpPr>
-          <p:cNvPr id="32" name="Connector 31"/>
+          <p:cNvPr id="31" name="Connector 30"/>
           <p:cNvCxnSpPr/>
           <p:nvPr/>
         </p:nvCxnSpPr>
@@ -4332,7 +4287,7 @@
       </p:cxnSp>
       <p:sp>
         <p:nvSpPr>
-          <p:cNvPr id="33" name="Rounded Rectangle 32"/>
+          <p:cNvPr id="32" name="Rounded Rectangle 31"/>
           <p:cNvSpPr/>
           <p:nvPr/>
         </p:nvSpPr>
@@ -4378,7 +4333,7 @@
       </p:sp>
       <p:sp>
         <p:nvSpPr>
-          <p:cNvPr id="34" name="TextBox 33"/>
+          <p:cNvPr id="33" name="TextBox 32"/>
           <p:cNvSpPr txBox="1"/>
           <p:nvPr/>
         </p:nvSpPr>
@@ -4414,7 +4369,7 @@
       </p:sp>
       <p:sp>
         <p:nvSpPr>
-          <p:cNvPr id="35" name="TextBox 34"/>
+          <p:cNvPr id="34" name="TextBox 33"/>
           <p:cNvSpPr txBox="1"/>
           <p:nvPr/>
         </p:nvSpPr>
@@ -4450,7 +4405,7 @@
       </p:sp>
       <p:sp>
         <p:nvSpPr>
-          <p:cNvPr id="36" name="Rounded Rectangle 35"/>
+          <p:cNvPr id="35" name="Rounded Rectangle 34"/>
           <p:cNvSpPr/>
           <p:nvPr/>
         </p:nvSpPr>
@@ -4496,7 +4451,7 @@
       </p:sp>
       <p:sp>
         <p:nvSpPr>
-          <p:cNvPr id="37" name="Rounded Rectangle 36"/>
+          <p:cNvPr id="36" name="Rounded Rectangle 35"/>
           <p:cNvSpPr/>
           <p:nvPr/>
         </p:nvSpPr>
@@ -4542,7 +4497,7 @@
       </p:sp>
       <p:sp>
         <p:nvSpPr>
-          <p:cNvPr id="38" name="TextBox 37"/>
+          <p:cNvPr id="37" name="TextBox 36"/>
           <p:cNvSpPr txBox="1"/>
           <p:nvPr/>
         </p:nvSpPr>
@@ -4578,7 +4533,7 @@
       </p:sp>
       <p:sp>
         <p:nvSpPr>
-          <p:cNvPr id="39" name="TextBox 38"/>
+          <p:cNvPr id="38" name="TextBox 37"/>
           <p:cNvSpPr txBox="1"/>
           <p:nvPr/>
         </p:nvSpPr>
@@ -4614,7 +4569,7 @@
       </p:sp>
       <p:sp>
         <p:nvSpPr>
-          <p:cNvPr id="40" name="Rounded Rectangle 39"/>
+          <p:cNvPr id="39" name="Rounded Rectangle 38"/>
           <p:cNvSpPr/>
           <p:nvPr/>
         </p:nvSpPr>
@@ -4660,7 +4615,7 @@
       </p:sp>
       <p:sp>
         <p:nvSpPr>
-          <p:cNvPr id="41" name="TextBox 40"/>
+          <p:cNvPr id="40" name="TextBox 39"/>
           <p:cNvSpPr txBox="1"/>
           <p:nvPr/>
         </p:nvSpPr>
@@ -4696,7 +4651,7 @@
       </p:sp>
       <p:sp>
         <p:nvSpPr>
-          <p:cNvPr id="42" name="Rounded Rectangle 41"/>
+          <p:cNvPr id="41" name="Rounded Rectangle 40"/>
           <p:cNvSpPr/>
           <p:nvPr/>
         </p:nvSpPr>
@@ -4742,7 +4697,7 @@
       </p:sp>
       <p:sp>
         <p:nvSpPr>
-          <p:cNvPr id="43" name="TextBox 42"/>
+          <p:cNvPr id="42" name="TextBox 41"/>
           <p:cNvSpPr txBox="1"/>
           <p:nvPr/>
         </p:nvSpPr>
@@ -4778,7 +4733,7 @@
       </p:sp>
       <p:sp>
         <p:nvSpPr>
-          <p:cNvPr id="44" name="Rounded Rectangle 43"/>
+          <p:cNvPr id="43" name="Rounded Rectangle 42"/>
           <p:cNvSpPr/>
           <p:nvPr/>
         </p:nvSpPr>
@@ -4824,7 +4779,7 @@
       </p:sp>
       <p:sp>
         <p:nvSpPr>
-          <p:cNvPr id="45" name="TextBox 44"/>
+          <p:cNvPr id="44" name="TextBox 43"/>
           <p:cNvSpPr txBox="1"/>
           <p:nvPr/>
         </p:nvSpPr>
@@ -4860,7 +4815,7 @@
       </p:sp>
       <p:sp>
         <p:nvSpPr>
-          <p:cNvPr id="46" name="Rounded Rectangle 45"/>
+          <p:cNvPr id="45" name="Rounded Rectangle 44"/>
           <p:cNvSpPr/>
           <p:nvPr/>
         </p:nvSpPr>
@@ -4906,7 +4861,7 @@
       </p:sp>
       <p:sp>
         <p:nvSpPr>
-          <p:cNvPr id="47" name="TextBox 46"/>
+          <p:cNvPr id="46" name="TextBox 45"/>
           <p:cNvSpPr txBox="1"/>
           <p:nvPr/>
         </p:nvSpPr>
@@ -4942,7 +4897,7 @@
       </p:sp>
       <p:sp>
         <p:nvSpPr>
-          <p:cNvPr id="48" name="Rounded Rectangle 47"/>
+          <p:cNvPr id="47" name="Rounded Rectangle 46"/>
           <p:cNvSpPr/>
           <p:nvPr/>
         </p:nvSpPr>
@@ -4988,7 +4943,7 @@
       </p:sp>
       <p:sp>
         <p:nvSpPr>
-          <p:cNvPr id="49" name="TextBox 48"/>
+          <p:cNvPr id="48" name="TextBox 47"/>
           <p:cNvSpPr txBox="1"/>
           <p:nvPr/>
         </p:nvSpPr>
@@ -5024,7 +4979,7 @@
       </p:sp>
       <p:sp>
         <p:nvSpPr>
-          <p:cNvPr id="50" name="Rounded Rectangle 49"/>
+          <p:cNvPr id="49" name="Rounded Rectangle 48"/>
           <p:cNvSpPr/>
           <p:nvPr/>
         </p:nvSpPr>
@@ -5070,7 +5025,7 @@
       </p:sp>
       <p:sp>
         <p:nvSpPr>
-          <p:cNvPr id="51" name="TextBox 50"/>
+          <p:cNvPr id="50" name="TextBox 49"/>
           <p:cNvSpPr txBox="1"/>
           <p:nvPr/>
         </p:nvSpPr>
@@ -5106,7 +5061,7 @@
       </p:sp>
       <p:sp>
         <p:nvSpPr>
-          <p:cNvPr id="52" name="Rounded Rectangle 51"/>
+          <p:cNvPr id="51" name="Rounded Rectangle 50"/>
           <p:cNvSpPr/>
           <p:nvPr/>
         </p:nvSpPr>
@@ -5152,7 +5107,7 @@
       </p:sp>
       <p:sp>
         <p:nvSpPr>
-          <p:cNvPr id="53" name="TextBox 52"/>
+          <p:cNvPr id="52" name="TextBox 51"/>
           <p:cNvSpPr txBox="1"/>
           <p:nvPr/>
         </p:nvSpPr>
@@ -5188,7 +5143,7 @@
       </p:sp>
       <p:sp>
         <p:nvSpPr>
-          <p:cNvPr id="54" name="Rounded Rectangle 53"/>
+          <p:cNvPr id="53" name="Rounded Rectangle 52"/>
           <p:cNvSpPr/>
           <p:nvPr/>
         </p:nvSpPr>
@@ -5234,7 +5189,7 @@
       </p:sp>
       <p:sp>
         <p:nvSpPr>
-          <p:cNvPr id="55" name="TextBox 54"/>
+          <p:cNvPr id="54" name="TextBox 53"/>
           <p:cNvSpPr txBox="1"/>
           <p:nvPr/>
         </p:nvSpPr>
@@ -5270,7 +5225,7 @@
       </p:sp>
       <p:sp>
         <p:nvSpPr>
-          <p:cNvPr id="56" name="Rounded Rectangle 55"/>
+          <p:cNvPr id="55" name="Rounded Rectangle 54"/>
           <p:cNvSpPr/>
           <p:nvPr/>
         </p:nvSpPr>
@@ -5316,7 +5271,7 @@
       </p:sp>
       <p:sp>
         <p:nvSpPr>
-          <p:cNvPr id="57" name="TextBox 56"/>
+          <p:cNvPr id="56" name="TextBox 55"/>
           <p:cNvSpPr txBox="1"/>
           <p:nvPr/>
         </p:nvSpPr>
@@ -5352,7 +5307,7 @@
       </p:sp>
       <p:sp>
         <p:nvSpPr>
-          <p:cNvPr id="58" name="Rounded Rectangle 57"/>
+          <p:cNvPr id="57" name="Rounded Rectangle 56"/>
           <p:cNvSpPr/>
           <p:nvPr/>
         </p:nvSpPr>
@@ -5398,7 +5353,7 @@
       </p:sp>
       <p:sp>
         <p:nvSpPr>
-          <p:cNvPr id="59" name="TextBox 58"/>
+          <p:cNvPr id="58" name="TextBox 57"/>
           <p:cNvSpPr txBox="1"/>
           <p:nvPr/>
         </p:nvSpPr>
@@ -5434,7 +5389,7 @@
       </p:sp>
       <p:sp>
         <p:nvSpPr>
-          <p:cNvPr id="60" name="Rounded Rectangle 59"/>
+          <p:cNvPr id="59" name="Rounded Rectangle 58"/>
           <p:cNvSpPr/>
           <p:nvPr/>
         </p:nvSpPr>
@@ -5480,7 +5435,7 @@
       </p:sp>
       <p:sp>
         <p:nvSpPr>
-          <p:cNvPr id="61" name="TextBox 60"/>
+          <p:cNvPr id="60" name="TextBox 59"/>
           <p:cNvSpPr txBox="1"/>
           <p:nvPr/>
         </p:nvSpPr>
@@ -5516,7 +5471,7 @@
       </p:sp>
       <p:sp>
         <p:nvSpPr>
-          <p:cNvPr id="62" name="Rounded Rectangle 61"/>
+          <p:cNvPr id="61" name="Rounded Rectangle 60"/>
           <p:cNvSpPr/>
           <p:nvPr/>
         </p:nvSpPr>
@@ -5562,7 +5517,7 @@
       </p:sp>
       <p:sp>
         <p:nvSpPr>
-          <p:cNvPr id="63" name="TextBox 62"/>
+          <p:cNvPr id="62" name="TextBox 61"/>
           <p:cNvSpPr txBox="1"/>
           <p:nvPr/>
         </p:nvSpPr>
@@ -5598,7 +5553,7 @@
       </p:sp>
       <p:sp>
         <p:nvSpPr>
-          <p:cNvPr id="64" name="Rounded Rectangle 63"/>
+          <p:cNvPr id="63" name="Rounded Rectangle 62"/>
           <p:cNvSpPr/>
           <p:nvPr/>
         </p:nvSpPr>
@@ -5644,7 +5599,7 @@
       </p:sp>
       <p:sp>
         <p:nvSpPr>
-          <p:cNvPr id="65" name="TextBox 64"/>
+          <p:cNvPr id="64" name="TextBox 63"/>
           <p:cNvSpPr txBox="1"/>
           <p:nvPr/>
         </p:nvSpPr>
@@ -5680,7 +5635,7 @@
       </p:sp>
       <p:sp>
         <p:nvSpPr>
-          <p:cNvPr id="66" name="Rounded Rectangle 65"/>
+          <p:cNvPr id="65" name="Rounded Rectangle 64"/>
           <p:cNvSpPr/>
           <p:nvPr/>
         </p:nvSpPr>
@@ -5726,7 +5681,7 @@
       </p:sp>
       <p:sp>
         <p:nvSpPr>
-          <p:cNvPr id="67" name="TextBox 66"/>
+          <p:cNvPr id="66" name="TextBox 65"/>
           <p:cNvSpPr txBox="1"/>
           <p:nvPr/>
         </p:nvSpPr>
@@ -5762,7 +5717,7 @@
       </p:sp>
       <p:sp>
         <p:nvSpPr>
-          <p:cNvPr id="68" name="Rounded Rectangle 67"/>
+          <p:cNvPr id="67" name="Rounded Rectangle 66"/>
           <p:cNvSpPr/>
           <p:nvPr/>
         </p:nvSpPr>
@@ -5808,7 +5763,7 @@
       </p:sp>
       <p:sp>
         <p:nvSpPr>
-          <p:cNvPr id="69" name="TextBox 68"/>
+          <p:cNvPr id="68" name="TextBox 67"/>
           <p:cNvSpPr txBox="1"/>
           <p:nvPr/>
         </p:nvSpPr>
@@ -5844,7 +5799,7 @@
       </p:sp>
       <p:sp>
         <p:nvSpPr>
-          <p:cNvPr id="70" name="Rounded Rectangle 69"/>
+          <p:cNvPr id="69" name="Rounded Rectangle 68"/>
           <p:cNvSpPr/>
           <p:nvPr/>
         </p:nvSpPr>
@@ -5890,7 +5845,7 @@
       </p:sp>
       <p:sp>
         <p:nvSpPr>
-          <p:cNvPr id="71" name="TextBox 70"/>
+          <p:cNvPr id="70" name="TextBox 69"/>
           <p:cNvSpPr txBox="1"/>
           <p:nvPr/>
         </p:nvSpPr>
@@ -5926,7 +5881,7 @@
       </p:sp>
       <p:sp>
         <p:nvSpPr>
-          <p:cNvPr id="72" name="Rounded Rectangle 71"/>
+          <p:cNvPr id="71" name="Rounded Rectangle 70"/>
           <p:cNvSpPr/>
           <p:nvPr/>
         </p:nvSpPr>
@@ -5972,7 +5927,7 @@
       </p:sp>
       <p:sp>
         <p:nvSpPr>
-          <p:cNvPr id="73" name="TextBox 72"/>
+          <p:cNvPr id="72" name="TextBox 71"/>
           <p:cNvSpPr txBox="1"/>
           <p:nvPr/>
         </p:nvSpPr>
@@ -6008,7 +5963,7 @@
       </p:sp>
       <p:sp>
         <p:nvSpPr>
-          <p:cNvPr id="74" name="Rounded Rectangle 73"/>
+          <p:cNvPr id="73" name="Rounded Rectangle 72"/>
           <p:cNvSpPr/>
           <p:nvPr/>
         </p:nvSpPr>
@@ -6054,7 +6009,7 @@
       </p:sp>
       <p:sp>
         <p:nvSpPr>
-          <p:cNvPr id="75" name="TextBox 74"/>
+          <p:cNvPr id="74" name="TextBox 73"/>
           <p:cNvSpPr txBox="1"/>
           <p:nvPr/>
         </p:nvSpPr>
@@ -6090,7 +6045,7 @@
       </p:sp>
       <p:sp>
         <p:nvSpPr>
-          <p:cNvPr id="76" name="Rounded Rectangle 75"/>
+          <p:cNvPr id="75" name="Rounded Rectangle 74"/>
           <p:cNvSpPr/>
           <p:nvPr/>
         </p:nvSpPr>
@@ -6136,7 +6091,7 @@
       </p:sp>
       <p:sp>
         <p:nvSpPr>
-          <p:cNvPr id="77" name="Rounded Rectangle 76"/>
+          <p:cNvPr id="76" name="Rounded Rectangle 75"/>
           <p:cNvSpPr/>
           <p:nvPr/>
         </p:nvSpPr>
@@ -6182,7 +6137,7 @@
       </p:sp>
       <p:sp>
         <p:nvSpPr>
-          <p:cNvPr id="78" name="TextBox 77"/>
+          <p:cNvPr id="77" name="TextBox 76"/>
           <p:cNvSpPr txBox="1"/>
           <p:nvPr/>
         </p:nvSpPr>
@@ -6218,7 +6173,7 @@
       </p:sp>
       <p:sp>
         <p:nvSpPr>
-          <p:cNvPr id="79" name="TextBox 78"/>
+          <p:cNvPr id="78" name="TextBox 77"/>
           <p:cNvSpPr txBox="1"/>
           <p:nvPr/>
         </p:nvSpPr>
@@ -6254,7 +6209,7 @@
       </p:sp>
       <p:sp>
         <p:nvSpPr>
-          <p:cNvPr id="80" name="Rounded Rectangle 79"/>
+          <p:cNvPr id="79" name="Rounded Rectangle 78"/>
           <p:cNvSpPr/>
           <p:nvPr/>
         </p:nvSpPr>
@@ -6300,7 +6255,7 @@
       </p:sp>
       <p:sp>
         <p:nvSpPr>
-          <p:cNvPr id="81" name="TextBox 80"/>
+          <p:cNvPr id="80" name="TextBox 79"/>
           <p:cNvSpPr txBox="1"/>
           <p:nvPr/>
         </p:nvSpPr>
@@ -6336,7 +6291,7 @@
       </p:sp>
       <p:sp>
         <p:nvSpPr>
-          <p:cNvPr id="82" name="Rounded Rectangle 81"/>
+          <p:cNvPr id="81" name="Rounded Rectangle 80"/>
           <p:cNvSpPr/>
           <p:nvPr/>
         </p:nvSpPr>
@@ -6382,7 +6337,7 @@
       </p:sp>
       <p:sp>
         <p:nvSpPr>
-          <p:cNvPr id="83" name="TextBox 82"/>
+          <p:cNvPr id="82" name="TextBox 81"/>
           <p:cNvSpPr txBox="1"/>
           <p:nvPr/>
         </p:nvSpPr>
@@ -6418,7 +6373,7 @@
       </p:sp>
       <p:sp>
         <p:nvSpPr>
-          <p:cNvPr id="84" name="Rounded Rectangle 83"/>
+          <p:cNvPr id="83" name="Rounded Rectangle 82"/>
           <p:cNvSpPr/>
           <p:nvPr/>
         </p:nvSpPr>
@@ -6464,7 +6419,7 @@
       </p:sp>
       <p:sp>
         <p:nvSpPr>
-          <p:cNvPr id="85" name="TextBox 84"/>
+          <p:cNvPr id="84" name="TextBox 83"/>
           <p:cNvSpPr txBox="1"/>
           <p:nvPr/>
         </p:nvSpPr>
@@ -6500,7 +6455,7 @@
       </p:sp>
       <p:sp>
         <p:nvSpPr>
-          <p:cNvPr id="86" name="Rounded Rectangle 85"/>
+          <p:cNvPr id="85" name="Rounded Rectangle 84"/>
           <p:cNvSpPr/>
           <p:nvPr/>
         </p:nvSpPr>
@@ -6546,7 +6501,7 @@
       </p:sp>
       <p:sp>
         <p:nvSpPr>
-          <p:cNvPr id="87" name="TextBox 86"/>
+          <p:cNvPr id="86" name="TextBox 85"/>
           <p:cNvSpPr txBox="1"/>
           <p:nvPr/>
         </p:nvSpPr>
@@ -6582,7 +6537,7 @@
       </p:sp>
       <p:sp>
         <p:nvSpPr>
-          <p:cNvPr id="88" name="Rounded Rectangle 87"/>
+          <p:cNvPr id="87" name="Rounded Rectangle 86"/>
           <p:cNvSpPr/>
           <p:nvPr/>
         </p:nvSpPr>
@@ -6628,7 +6583,7 @@
       </p:sp>
       <p:sp>
         <p:nvSpPr>
-          <p:cNvPr id="89" name="TextBox 88"/>
+          <p:cNvPr id="88" name="TextBox 87"/>
           <p:cNvSpPr txBox="1"/>
           <p:nvPr/>
         </p:nvSpPr>
@@ -6664,7 +6619,7 @@
       </p:sp>
       <p:sp>
         <p:nvSpPr>
-          <p:cNvPr id="90" name="Rounded Rectangle 89"/>
+          <p:cNvPr id="89" name="Rounded Rectangle 88"/>
           <p:cNvSpPr/>
           <p:nvPr/>
         </p:nvSpPr>
@@ -6710,7 +6665,7 @@
       </p:sp>
       <p:sp>
         <p:nvSpPr>
-          <p:cNvPr id="91" name="TextBox 90"/>
+          <p:cNvPr id="90" name="TextBox 89"/>
           <p:cNvSpPr txBox="1"/>
           <p:nvPr/>
         </p:nvSpPr>
@@ -6746,7 +6701,7 @@
       </p:sp>
       <p:sp>
         <p:nvSpPr>
-          <p:cNvPr id="92" name="Rounded Rectangle 91"/>
+          <p:cNvPr id="91" name="Rounded Rectangle 90"/>
           <p:cNvSpPr/>
           <p:nvPr/>
         </p:nvSpPr>
@@ -6792,7 +6747,7 @@
       </p:sp>
       <p:sp>
         <p:nvSpPr>
-          <p:cNvPr id="93" name="TextBox 92"/>
+          <p:cNvPr id="92" name="TextBox 91"/>
           <p:cNvSpPr txBox="1"/>
           <p:nvPr/>
         </p:nvSpPr>
@@ -6828,7 +6783,7 @@
       </p:sp>
       <p:sp>
         <p:nvSpPr>
-          <p:cNvPr id="94" name="Rounded Rectangle 93"/>
+          <p:cNvPr id="93" name="Rounded Rectangle 92"/>
           <p:cNvSpPr/>
           <p:nvPr/>
         </p:nvSpPr>
@@ -6874,7 +6829,7 @@
       </p:sp>
       <p:sp>
         <p:nvSpPr>
-          <p:cNvPr id="95" name="TextBox 94"/>
+          <p:cNvPr id="94" name="TextBox 93"/>
           <p:cNvSpPr txBox="1"/>
           <p:nvPr/>
         </p:nvSpPr>
@@ -6910,7 +6865,7 @@
       </p:sp>
       <p:cxnSp>
         <p:nvCxnSpPr>
-          <p:cNvPr id="96" name="Connector 95"/>
+          <p:cNvPr id="95" name="Connector 94"/>
           <p:cNvCxnSpPr/>
           <p:nvPr/>
         </p:nvCxnSpPr>
@@ -6945,7 +6900,7 @@
       </p:cxnSp>
       <p:sp>
         <p:nvSpPr>
-          <p:cNvPr id="97" name="Rounded Rectangle 96"/>
+          <p:cNvPr id="96" name="Rounded Rectangle 95"/>
           <p:cNvSpPr/>
           <p:nvPr/>
         </p:nvSpPr>
@@ -6991,7 +6946,7 @@
       </p:sp>
       <p:sp>
         <p:nvSpPr>
-          <p:cNvPr id="98" name="Rounded Rectangle 97"/>
+          <p:cNvPr id="97" name="Rounded Rectangle 96"/>
           <p:cNvSpPr/>
           <p:nvPr/>
         </p:nvSpPr>
@@ -7037,7 +6992,7 @@
       </p:sp>
       <p:sp>
         <p:nvSpPr>
-          <p:cNvPr id="99" name="TextBox 98"/>
+          <p:cNvPr id="98" name="TextBox 97"/>
           <p:cNvSpPr txBox="1"/>
           <p:nvPr/>
         </p:nvSpPr>
@@ -7073,7 +7028,7 @@
       </p:sp>
       <p:sp>
         <p:nvSpPr>
-          <p:cNvPr id="100" name="TextBox 99"/>
+          <p:cNvPr id="99" name="TextBox 98"/>
           <p:cNvSpPr txBox="1"/>
           <p:nvPr/>
         </p:nvSpPr>
@@ -7109,7 +7064,7 @@
       </p:sp>
       <p:sp>
         <p:nvSpPr>
-          <p:cNvPr id="101" name="Rounded Rectangle 100"/>
+          <p:cNvPr id="100" name="Rounded Rectangle 99"/>
           <p:cNvSpPr/>
           <p:nvPr/>
         </p:nvSpPr>
@@ -7155,7 +7110,7 @@
       </p:sp>
       <p:sp>
         <p:nvSpPr>
-          <p:cNvPr id="102" name="TextBox 101"/>
+          <p:cNvPr id="101" name="TextBox 100"/>
           <p:cNvSpPr txBox="1"/>
           <p:nvPr/>
         </p:nvSpPr>
@@ -7191,7 +7146,7 @@
       </p:sp>
       <p:sp>
         <p:nvSpPr>
-          <p:cNvPr id="103" name="Rounded Rectangle 102"/>
+          <p:cNvPr id="102" name="Rounded Rectangle 101"/>
           <p:cNvSpPr/>
           <p:nvPr/>
         </p:nvSpPr>
@@ -7237,7 +7192,7 @@
       </p:sp>
       <p:sp>
         <p:nvSpPr>
-          <p:cNvPr id="104" name="TextBox 103"/>
+          <p:cNvPr id="103" name="TextBox 102"/>
           <p:cNvSpPr txBox="1"/>
           <p:nvPr/>
         </p:nvSpPr>
@@ -7273,7 +7228,7 @@
       </p:sp>
       <p:sp>
         <p:nvSpPr>
-          <p:cNvPr id="105" name="Rounded Rectangle 104"/>
+          <p:cNvPr id="104" name="Rounded Rectangle 103"/>
           <p:cNvSpPr/>
           <p:nvPr/>
         </p:nvSpPr>
@@ -7319,7 +7274,7 @@
       </p:sp>
       <p:sp>
         <p:nvSpPr>
-          <p:cNvPr id="106" name="TextBox 105"/>
+          <p:cNvPr id="105" name="TextBox 104"/>
           <p:cNvSpPr txBox="1"/>
           <p:nvPr/>
         </p:nvSpPr>
@@ -7355,7 +7310,7 @@
       </p:sp>
       <p:sp>
         <p:nvSpPr>
-          <p:cNvPr id="107" name="Rounded Rectangle 106"/>
+          <p:cNvPr id="106" name="Rounded Rectangle 105"/>
           <p:cNvSpPr/>
           <p:nvPr/>
         </p:nvSpPr>
@@ -7401,7 +7356,7 @@
       </p:sp>
       <p:sp>
         <p:nvSpPr>
-          <p:cNvPr id="108" name="TextBox 107"/>
+          <p:cNvPr id="107" name="TextBox 106"/>
           <p:cNvSpPr txBox="1"/>
           <p:nvPr/>
         </p:nvSpPr>
@@ -7437,7 +7392,7 @@
       </p:sp>
       <p:sp>
         <p:nvSpPr>
-          <p:cNvPr id="109" name="Rounded Rectangle 108"/>
+          <p:cNvPr id="108" name="Rounded Rectangle 107"/>
           <p:cNvSpPr/>
           <p:nvPr/>
         </p:nvSpPr>
@@ -7483,7 +7438,7 @@
       </p:sp>
       <p:sp>
         <p:nvSpPr>
-          <p:cNvPr id="110" name="TextBox 109"/>
+          <p:cNvPr id="109" name="TextBox 108"/>
           <p:cNvSpPr txBox="1"/>
           <p:nvPr/>
         </p:nvSpPr>
@@ -7519,7 +7474,7 @@
       </p:sp>
       <p:sp>
         <p:nvSpPr>
-          <p:cNvPr id="111" name="Rounded Rectangle 110"/>
+          <p:cNvPr id="110" name="Rounded Rectangle 109"/>
           <p:cNvSpPr/>
           <p:nvPr/>
         </p:nvSpPr>
@@ -7565,7 +7520,7 @@
       </p:sp>
       <p:sp>
         <p:nvSpPr>
-          <p:cNvPr id="112" name="TextBox 111"/>
+          <p:cNvPr id="111" name="TextBox 110"/>
           <p:cNvSpPr txBox="1"/>
           <p:nvPr/>
         </p:nvSpPr>
@@ -7601,7 +7556,7 @@
       </p:sp>
       <p:sp>
         <p:nvSpPr>
-          <p:cNvPr id="113" name="Rounded Rectangle 112"/>
+          <p:cNvPr id="112" name="Rounded Rectangle 111"/>
           <p:cNvSpPr/>
           <p:nvPr/>
         </p:nvSpPr>
@@ -7647,7 +7602,7 @@
       </p:sp>
       <p:sp>
         <p:nvSpPr>
-          <p:cNvPr id="114" name="TextBox 113"/>
+          <p:cNvPr id="113" name="TextBox 112"/>
           <p:cNvSpPr txBox="1"/>
           <p:nvPr/>
         </p:nvSpPr>
@@ -7683,7 +7638,7 @@
       </p:sp>
       <p:sp>
         <p:nvSpPr>
-          <p:cNvPr id="115" name="Rounded Rectangle 114"/>
+          <p:cNvPr id="114" name="Rounded Rectangle 113"/>
           <p:cNvSpPr/>
           <p:nvPr/>
         </p:nvSpPr>
@@ -7729,7 +7684,7 @@
       </p:sp>
       <p:sp>
         <p:nvSpPr>
-          <p:cNvPr id="116" name="Rounded Rectangle 115"/>
+          <p:cNvPr id="115" name="Rounded Rectangle 114"/>
           <p:cNvSpPr/>
           <p:nvPr/>
         </p:nvSpPr>
@@ -7775,7 +7730,7 @@
       </p:sp>
       <p:sp>
         <p:nvSpPr>
-          <p:cNvPr id="117" name="TextBox 116"/>
+          <p:cNvPr id="116" name="TextBox 115"/>
           <p:cNvSpPr txBox="1"/>
           <p:nvPr/>
         </p:nvSpPr>
@@ -7811,7 +7766,7 @@
       </p:sp>
       <p:sp>
         <p:nvSpPr>
-          <p:cNvPr id="118" name="TextBox 117"/>
+          <p:cNvPr id="117" name="TextBox 116"/>
           <p:cNvSpPr txBox="1"/>
           <p:nvPr/>
         </p:nvSpPr>
@@ -7847,7 +7802,7 @@
       </p:sp>
       <p:sp>
         <p:nvSpPr>
-          <p:cNvPr id="119" name="Rounded Rectangle 118"/>
+          <p:cNvPr id="118" name="Rounded Rectangle 117"/>
           <p:cNvSpPr/>
           <p:nvPr/>
         </p:nvSpPr>
@@ -7893,7 +7848,7 @@
       </p:sp>
       <p:sp>
         <p:nvSpPr>
-          <p:cNvPr id="120" name="TextBox 119"/>
+          <p:cNvPr id="119" name="TextBox 118"/>
           <p:cNvSpPr txBox="1"/>
           <p:nvPr/>
         </p:nvSpPr>
@@ -7929,7 +7884,7 @@
       </p:sp>
       <p:sp>
         <p:nvSpPr>
-          <p:cNvPr id="121" name="TextBox 120"/>
+          <p:cNvPr id="120" name="TextBox 119"/>
           <p:cNvSpPr txBox="1"/>
           <p:nvPr/>
         </p:nvSpPr>
@@ -7965,7 +7920,7 @@
       </p:sp>
       <p:sp>
         <p:nvSpPr>
-          <p:cNvPr id="122" name="Rounded Rectangle 121"/>
+          <p:cNvPr id="121" name="Rounded Rectangle 120"/>
           <p:cNvSpPr/>
           <p:nvPr/>
         </p:nvSpPr>
@@ -8011,7 +7966,7 @@
       </p:sp>
       <p:sp>
         <p:nvSpPr>
-          <p:cNvPr id="123" name="TextBox 122"/>
+          <p:cNvPr id="122" name="TextBox 121"/>
           <p:cNvSpPr txBox="1"/>
           <p:nvPr/>
         </p:nvSpPr>
@@ -8047,7 +8002,7 @@
       </p:sp>
       <p:sp>
         <p:nvSpPr>
-          <p:cNvPr id="124" name="TextBox 123"/>
+          <p:cNvPr id="123" name="TextBox 122"/>
           <p:cNvSpPr txBox="1"/>
           <p:nvPr/>
         </p:nvSpPr>
@@ -8083,7 +8038,7 @@
       </p:sp>
       <p:sp>
         <p:nvSpPr>
-          <p:cNvPr id="125" name="Rounded Rectangle 124"/>
+          <p:cNvPr id="124" name="Rounded Rectangle 123"/>
           <p:cNvSpPr/>
           <p:nvPr/>
         </p:nvSpPr>
@@ -8129,7 +8084,7 @@
       </p:sp>
       <p:sp>
         <p:nvSpPr>
-          <p:cNvPr id="126" name="TextBox 125"/>
+          <p:cNvPr id="125" name="TextBox 124"/>
           <p:cNvSpPr txBox="1"/>
           <p:nvPr/>
         </p:nvSpPr>
@@ -8165,7 +8120,7 @@
       </p:sp>
       <p:sp>
         <p:nvSpPr>
-          <p:cNvPr id="127" name="TextBox 126"/>
+          <p:cNvPr id="126" name="TextBox 125"/>
           <p:cNvSpPr txBox="1"/>
           <p:nvPr/>
         </p:nvSpPr>
@@ -8201,7 +8156,7 @@
       </p:sp>
       <p:sp>
         <p:nvSpPr>
-          <p:cNvPr id="128" name="Rounded Rectangle 127"/>
+          <p:cNvPr id="127" name="Rounded Rectangle 126"/>
           <p:cNvSpPr/>
           <p:nvPr/>
         </p:nvSpPr>
@@ -8247,7 +8202,7 @@
       </p:sp>
       <p:sp>
         <p:nvSpPr>
-          <p:cNvPr id="129" name="TextBox 128"/>
+          <p:cNvPr id="128" name="TextBox 127"/>
           <p:cNvSpPr txBox="1"/>
           <p:nvPr/>
         </p:nvSpPr>
@@ -8283,7 +8238,7 @@
       </p:sp>
       <p:sp>
         <p:nvSpPr>
-          <p:cNvPr id="130" name="TextBox 129"/>
+          <p:cNvPr id="129" name="TextBox 128"/>
           <p:cNvSpPr txBox="1"/>
           <p:nvPr/>
         </p:nvSpPr>
@@ -8319,7 +8274,7 @@
       </p:sp>
       <p:sp>
         <p:nvSpPr>
-          <p:cNvPr id="131" name="Rounded Rectangle 130"/>
+          <p:cNvPr id="130" name="Rounded Rectangle 129"/>
           <p:cNvSpPr/>
           <p:nvPr/>
         </p:nvSpPr>
@@ -8365,7 +8320,7 @@
       </p:sp>
       <p:sp>
         <p:nvSpPr>
-          <p:cNvPr id="132" name="TextBox 131"/>
+          <p:cNvPr id="131" name="TextBox 130"/>
           <p:cNvSpPr txBox="1"/>
           <p:nvPr/>
         </p:nvSpPr>
@@ -8401,7 +8356,7 @@
       </p:sp>
       <p:sp>
         <p:nvSpPr>
-          <p:cNvPr id="133" name="Rounded Rectangle 132"/>
+          <p:cNvPr id="132" name="Rounded Rectangle 131"/>
           <p:cNvSpPr/>
           <p:nvPr/>
         </p:nvSpPr>
@@ -8447,7 +8402,7 @@
       </p:sp>
       <p:sp>
         <p:nvSpPr>
-          <p:cNvPr id="134" name="TextBox 133"/>
+          <p:cNvPr id="133" name="TextBox 132"/>
           <p:cNvSpPr txBox="1"/>
           <p:nvPr/>
         </p:nvSpPr>
@@ -8483,7 +8438,7 @@
       </p:sp>
       <p:sp>
         <p:nvSpPr>
-          <p:cNvPr id="135" name="Rounded Rectangle 134"/>
+          <p:cNvPr id="134" name="Rounded Rectangle 133"/>
           <p:cNvSpPr/>
           <p:nvPr/>
         </p:nvSpPr>
@@ -8529,7 +8484,7 @@
       </p:sp>
       <p:sp>
         <p:nvSpPr>
-          <p:cNvPr id="136" name="TextBox 135"/>
+          <p:cNvPr id="135" name="TextBox 134"/>
           <p:cNvSpPr txBox="1"/>
           <p:nvPr/>
         </p:nvSpPr>
@@ -8565,7 +8520,7 @@
       </p:sp>
       <p:sp>
         <p:nvSpPr>
-          <p:cNvPr id="137" name="Rounded Rectangle 136"/>
+          <p:cNvPr id="136" name="Rounded Rectangle 135"/>
           <p:cNvSpPr/>
           <p:nvPr/>
         </p:nvSpPr>
@@ -8611,7 +8566,7 @@
       </p:sp>
       <p:sp>
         <p:nvSpPr>
-          <p:cNvPr id="138" name="TextBox 137"/>
+          <p:cNvPr id="137" name="TextBox 136"/>
           <p:cNvSpPr txBox="1"/>
           <p:nvPr/>
         </p:nvSpPr>
@@ -8647,7 +8602,7 @@
       </p:sp>
       <p:sp>
         <p:nvSpPr>
-          <p:cNvPr id="139" name="Rounded Rectangle 138"/>
+          <p:cNvPr id="138" name="Rounded Rectangle 137"/>
           <p:cNvSpPr/>
           <p:nvPr/>
         </p:nvSpPr>
@@ -8693,7 +8648,7 @@
       </p:sp>
       <p:sp>
         <p:nvSpPr>
-          <p:cNvPr id="140" name="TextBox 139"/>
+          <p:cNvPr id="139" name="TextBox 138"/>
           <p:cNvSpPr txBox="1"/>
           <p:nvPr/>
         </p:nvSpPr>
@@ -8727,6 +8682,41 @@
           </a:p>
         </p:txBody>
       </p:sp>
+      <p:cxnSp>
+        <p:nvCxnSpPr>
+          <p:cNvPr id="140" name="Connector 139"/>
+          <p:cNvCxnSpPr/>
+          <p:nvPr/>
+        </p:nvCxnSpPr>
+        <p:spPr>
+          <a:xfrm>
+            <a:off x="6095847" y="2395728"/>
+            <a:ext cx="0" cy="109728"/>
+          </a:xfrm>
+          <a:prstGeom prst="line">
+            <a:avLst/>
+          </a:prstGeom>
+          <a:ln w="19050">
+            <a:solidFill>
+              <a:srgbClr val="C5CDDD"/>
+            </a:solidFill>
+          </a:ln>
+        </p:spPr>
+        <p:style>
+          <a:lnRef idx="2">
+            <a:schemeClr val="accent1"/>
+          </a:lnRef>
+          <a:fillRef idx="0">
+            <a:schemeClr val="accent1"/>
+          </a:fillRef>
+          <a:effectRef idx="1">
+            <a:schemeClr val="accent1"/>
+          </a:effectRef>
+          <a:fontRef idx="minor">
+            <a:schemeClr val="tx1"/>
+          </a:fontRef>
+        </p:style>
+      </p:cxnSp>
       <p:cxnSp>
         <p:nvCxnSpPr>
           <p:cNvPr id="141" name="Connector 140"/>
@@ -8735,8 +8725,8 @@
         </p:nvCxnSpPr>
         <p:spPr>
           <a:xfrm>
-            <a:off x="6095847" y="2395728"/>
-            <a:ext cx="0" cy="109728"/>
+            <a:off x="1763994" y="2505456"/>
+            <a:ext cx="7987450" cy="0"/>
           </a:xfrm>
           <a:prstGeom prst="line">
             <a:avLst/>
@@ -8770,8 +8760,8 @@
         </p:nvCxnSpPr>
         <p:spPr>
           <a:xfrm>
-            <a:off x="1763994" y="2505456"/>
-            <a:ext cx="7987450" cy="0"/>
+            <a:off x="9751444" y="2505456"/>
+            <a:ext cx="0" cy="109728"/>
           </a:xfrm>
           <a:prstGeom prst="line">
             <a:avLst/>
@@ -8805,7 +8795,7 @@
         </p:nvCxnSpPr>
         <p:spPr>
           <a:xfrm>
-            <a:off x="9751444" y="2505456"/>
+            <a:off x="5419591" y="2505456"/>
             <a:ext cx="0" cy="109728"/>
           </a:xfrm>
           <a:prstGeom prst="line">
@@ -8835,41 +8825,6 @@
       <p:cxnSp>
         <p:nvCxnSpPr>
           <p:cNvPr id="144" name="Connector 143"/>
-          <p:cNvCxnSpPr/>
-          <p:nvPr/>
-        </p:nvCxnSpPr>
-        <p:spPr>
-          <a:xfrm>
-            <a:off x="5419591" y="2505456"/>
-            <a:ext cx="0" cy="109728"/>
-          </a:xfrm>
-          <a:prstGeom prst="line">
-            <a:avLst/>
-          </a:prstGeom>
-          <a:ln w="19050">
-            <a:solidFill>
-              <a:srgbClr val="C5CDDD"/>
-            </a:solidFill>
-          </a:ln>
-        </p:spPr>
-        <p:style>
-          <a:lnRef idx="2">
-            <a:schemeClr val="accent1"/>
-          </a:lnRef>
-          <a:fillRef idx="0">
-            <a:schemeClr val="accent1"/>
-          </a:fillRef>
-          <a:effectRef idx="1">
-            <a:schemeClr val="accent1"/>
-          </a:effectRef>
-          <a:fontRef idx="minor">
-            <a:schemeClr val="tx1"/>
-          </a:fontRef>
-        </p:style>
-      </p:cxnSp>
-      <p:cxnSp>
-        <p:nvCxnSpPr>
-          <p:cNvPr id="145" name="Connector 144"/>
           <p:cNvCxnSpPr/>
           <p:nvPr/>
         </p:nvCxnSpPr>

</xml_diff>

<commit_message>
Add costs slide comparing ideal, intermediate and lean models
Co-Authored-By: Claude Opus 5.5 <noreply@anthropic.com>
Claude-Session: https://claude.ai/code/session_01W7Er83FuNT4pLFShWidYHn
</commit_message>
<xml_diff>
--- a/presentation/out/koach-hitarvut.pptx
+++ b/presentation/out/koach-hitarvut.pptx
@@ -14,6 +14,7 @@
     <p:sldId id="262" r:id="rId13"/>
     <p:sldId id="263" r:id="rId14"/>
     <p:sldId id="264" r:id="rId15"/>
+    <p:sldId id="265" r:id="rId16"/>
   </p:sldIdLst>
   <p:sldSz cx="12191695" cy="6858000" type="screen4x3"/>
   <p:notesSz cx="6858000" cy="9144000"/>
@@ -8857,6 +8858,3587 @@
           </a:fontRef>
         </p:style>
       </p:cxnSp>
+    </p:spTree>
+  </p:cSld>
+  <p:clrMapOvr>
+    <a:masterClrMapping/>
+  </p:clrMapOvr>
+</p:sld>
+</file>
+
+<file path=ppt/slides/slide10.xml><?xml version="1.0" encoding="utf-8"?>
+<p:sld xmlns:a="http://schemas.openxmlformats.org/drawingml/2006/main" xmlns:p="http://schemas.openxmlformats.org/presentationml/2006/main" xmlns:r="http://schemas.openxmlformats.org/officeDocument/2006/relationships">
+  <p:cSld>
+    <p:bg>
+      <p:bgPr>
+        <a:solidFill>
+          <a:srgbClr val="F4F6FB"/>
+        </a:solidFill>
+        <a:effectLst/>
+      </p:bgPr>
+    </p:bg>
+    <p:spTree>
+      <p:nvGrpSpPr>
+        <p:cNvPr id="1" name=""/>
+        <p:cNvGrpSpPr/>
+        <p:nvPr/>
+      </p:nvGrpSpPr>
+      <p:grpSpPr/>
+      <p:sp>
+        <p:nvSpPr>
+          <p:cNvPr id="2" name="Rectangle 1"/>
+          <p:cNvSpPr/>
+          <p:nvPr/>
+        </p:nvSpPr>
+        <p:spPr>
+          <a:xfrm>
+            <a:off x="0" y="0"/>
+            <a:ext cx="12191695" cy="868680"/>
+          </a:xfrm>
+          <a:prstGeom prst="rect">
+            <a:avLst/>
+          </a:prstGeom>
+          <a:solidFill>
+            <a:srgbClr val="1C3C7A"/>
+          </a:solidFill>
+          <a:ln>
+            <a:noFill/>
+          </a:ln>
+          <a:effectLst/>
+        </p:spPr>
+        <p:style>
+          <a:lnRef idx="1">
+            <a:schemeClr val="accent1"/>
+          </a:lnRef>
+          <a:fillRef idx="3">
+            <a:schemeClr val="accent1"/>
+          </a:fillRef>
+          <a:effectRef idx="2">
+            <a:schemeClr val="accent1"/>
+          </a:effectRef>
+          <a:fontRef idx="minor">
+            <a:schemeClr val="lt1"/>
+          </a:fontRef>
+        </p:style>
+        <p:txBody>
+          <a:bodyPr rtlCol="0" anchor="ctr"/>
+          <a:lstStyle/>
+          <a:p>
+            <a:pPr algn="ctr"/>
+          </a:p>
+        </p:txBody>
+      </p:sp>
+      <p:sp>
+        <p:nvSpPr>
+          <p:cNvPr id="3" name="Rectangle 2"/>
+          <p:cNvSpPr/>
+          <p:nvPr/>
+        </p:nvSpPr>
+        <p:spPr>
+          <a:xfrm>
+            <a:off x="0" y="868680"/>
+            <a:ext cx="12191695" cy="54864"/>
+          </a:xfrm>
+          <a:prstGeom prst="rect">
+            <a:avLst/>
+          </a:prstGeom>
+          <a:solidFill>
+            <a:srgbClr val="F0C000"/>
+          </a:solidFill>
+          <a:ln>
+            <a:noFill/>
+          </a:ln>
+          <a:effectLst/>
+        </p:spPr>
+        <p:style>
+          <a:lnRef idx="1">
+            <a:schemeClr val="accent1"/>
+          </a:lnRef>
+          <a:fillRef idx="3">
+            <a:schemeClr val="accent1"/>
+          </a:fillRef>
+          <a:effectRef idx="2">
+            <a:schemeClr val="accent1"/>
+          </a:effectRef>
+          <a:fontRef idx="minor">
+            <a:schemeClr val="lt1"/>
+          </a:fontRef>
+        </p:style>
+        <p:txBody>
+          <a:bodyPr rtlCol="0" anchor="ctr"/>
+          <a:lstStyle/>
+          <a:p>
+            <a:pPr algn="ctr"/>
+          </a:p>
+        </p:txBody>
+      </p:sp>
+      <p:sp>
+        <p:nvSpPr>
+          <p:cNvPr id="4" name="TextBox 3"/>
+          <p:cNvSpPr txBox="1"/>
+          <p:nvPr/>
+        </p:nvSpPr>
+        <p:spPr>
+          <a:xfrm>
+            <a:off x="1280160" y="109728"/>
+            <a:ext cx="10515600" cy="457200"/>
+          </a:xfrm>
+          <a:prstGeom prst="rect">
+            <a:avLst/>
+          </a:prstGeom>
+          <a:noFill/>
+        </p:spPr>
+        <p:txBody>
+          <a:bodyPr wrap="square" anchor="ctr" lIns="36576" rIns="36576" tIns="0" bIns="0">
+            <a:spAutoFit/>
+          </a:bodyPr>
+          <a:lstStyle/>
+          <a:p>
+            <a:pPr algn="r" rtl="1"/>
+            <a:r>
+              <a:rPr sz="2600" b="1">
+                <a:solidFill>
+                  <a:srgbClr val="FFFFFF"/>
+                </a:solidFill>
+                <a:latin typeface="Heebo"/>
+                <a:cs typeface="Heebo"/>
+              </a:rPr>
+              <a:t>הוצאות · שלושה מודלים</a:t>
+            </a:r>
+          </a:p>
+        </p:txBody>
+      </p:sp>
+      <p:sp>
+        <p:nvSpPr>
+          <p:cNvPr id="6" name="Rounded Rectangle 5"/>
+          <p:cNvSpPr/>
+          <p:nvPr/>
+        </p:nvSpPr>
+        <p:spPr>
+          <a:xfrm>
+            <a:off x="265176" y="54864"/>
+            <a:ext cx="910550" cy="768096"/>
+          </a:xfrm>
+          <a:prstGeom prst="roundRect">
+            <a:avLst>
+              <a:gd name="adj" fmla="val 12000"/>
+            </a:avLst>
+          </a:prstGeom>
+          <a:solidFill>
+            <a:srgbClr val="FFFFFF"/>
+          </a:solidFill>
+          <a:ln>
+            <a:noFill/>
+          </a:ln>
+          <a:effectLst/>
+        </p:spPr>
+        <p:style>
+          <a:lnRef idx="1">
+            <a:schemeClr val="accent1"/>
+          </a:lnRef>
+          <a:fillRef idx="3">
+            <a:schemeClr val="accent1"/>
+          </a:fillRef>
+          <a:effectRef idx="2">
+            <a:schemeClr val="accent1"/>
+          </a:effectRef>
+          <a:fontRef idx="minor">
+            <a:schemeClr val="lt1"/>
+          </a:fontRef>
+        </p:style>
+        <p:txBody>
+          <a:bodyPr rtlCol="0" anchor="ctr"/>
+          <a:lstStyle/>
+          <a:p>
+            <a:pPr algn="ctr"/>
+          </a:p>
+        </p:txBody>
+      </p:sp>
+      <p:pic>
+        <p:nvPicPr>
+          <p:cNvPr id="5" name="Picture 4" descr="logo.png"/>
+          <p:cNvPicPr>
+            <a:picLocks noChangeAspect="1"/>
+          </p:cNvPicPr>
+          <p:nvPr/>
+        </p:nvPicPr>
+        <p:blipFill>
+          <a:blip r:embed="rId2"/>
+          <a:stretch>
+            <a:fillRect/>
+          </a:stretch>
+        </p:blipFill>
+        <p:spPr>
+          <a:xfrm>
+            <a:off x="320040" y="73152"/>
+            <a:ext cx="800822" cy="731520"/>
+          </a:xfrm>
+          <a:prstGeom prst="rect">
+            <a:avLst/>
+          </a:prstGeom>
+        </p:spPr>
+      </p:pic>
+      <p:sp>
+        <p:nvSpPr>
+          <p:cNvPr id="7" name="Rounded Rectangle 6"/>
+          <p:cNvSpPr/>
+          <p:nvPr/>
+        </p:nvSpPr>
+        <p:spPr>
+          <a:xfrm>
+            <a:off x="8143037" y="1188720"/>
+            <a:ext cx="3637178" cy="5120640"/>
+          </a:xfrm>
+          <a:prstGeom prst="roundRect">
+            <a:avLst>
+              <a:gd name="adj" fmla="val 5000"/>
+            </a:avLst>
+          </a:prstGeom>
+          <a:solidFill>
+            <a:srgbClr val="FFFFFF"/>
+          </a:solidFill>
+          <a:ln w="15875">
+            <a:solidFill>
+              <a:srgbClr val="C5CDDD"/>
+            </a:solidFill>
+          </a:ln>
+          <a:effectLst/>
+        </p:spPr>
+        <p:style>
+          <a:lnRef idx="1">
+            <a:schemeClr val="accent1"/>
+          </a:lnRef>
+          <a:fillRef idx="3">
+            <a:schemeClr val="accent1"/>
+          </a:fillRef>
+          <a:effectRef idx="2">
+            <a:schemeClr val="accent1"/>
+          </a:effectRef>
+          <a:fontRef idx="minor">
+            <a:schemeClr val="lt1"/>
+          </a:fontRef>
+        </p:style>
+        <p:txBody>
+          <a:bodyPr rtlCol="0" anchor="ctr"/>
+          <a:lstStyle/>
+          <a:p>
+            <a:pPr algn="ctr"/>
+          </a:p>
+        </p:txBody>
+      </p:sp>
+      <p:sp>
+        <p:nvSpPr>
+          <p:cNvPr id="8" name="Rounded Rectangle 7"/>
+          <p:cNvSpPr/>
+          <p:nvPr/>
+        </p:nvSpPr>
+        <p:spPr>
+          <a:xfrm>
+            <a:off x="8143037" y="1188720"/>
+            <a:ext cx="3637178" cy="868680"/>
+          </a:xfrm>
+          <a:prstGeom prst="roundRect">
+            <a:avLst>
+              <a:gd name="adj" fmla="val 12000"/>
+            </a:avLst>
+          </a:prstGeom>
+          <a:solidFill>
+            <a:srgbClr val="4A5568"/>
+          </a:solidFill>
+          <a:ln>
+            <a:noFill/>
+          </a:ln>
+          <a:effectLst/>
+        </p:spPr>
+        <p:style>
+          <a:lnRef idx="1">
+            <a:schemeClr val="accent1"/>
+          </a:lnRef>
+          <a:fillRef idx="3">
+            <a:schemeClr val="accent1"/>
+          </a:fillRef>
+          <a:effectRef idx="2">
+            <a:schemeClr val="accent1"/>
+          </a:effectRef>
+          <a:fontRef idx="minor">
+            <a:schemeClr val="lt1"/>
+          </a:fontRef>
+        </p:style>
+        <p:txBody>
+          <a:bodyPr rtlCol="0" anchor="ctr"/>
+          <a:lstStyle/>
+          <a:p>
+            <a:pPr algn="ctr"/>
+          </a:p>
+        </p:txBody>
+      </p:sp>
+      <p:sp>
+        <p:nvSpPr>
+          <p:cNvPr id="9" name="TextBox 8"/>
+          <p:cNvSpPr txBox="1"/>
+          <p:nvPr/>
+        </p:nvSpPr>
+        <p:spPr>
+          <a:xfrm>
+            <a:off x="8143037" y="1280160"/>
+            <a:ext cx="3637178" cy="384048"/>
+          </a:xfrm>
+          <a:prstGeom prst="rect">
+            <a:avLst/>
+          </a:prstGeom>
+          <a:noFill/>
+        </p:spPr>
+        <p:txBody>
+          <a:bodyPr wrap="square" anchor="ctr" lIns="36576" rIns="36576" tIns="0" bIns="0">
+            <a:spAutoFit/>
+          </a:bodyPr>
+          <a:lstStyle/>
+          <a:p>
+            <a:pPr algn="ctr" rtl="1"/>
+            <a:r>
+              <a:rPr sz="2000" b="1">
+                <a:solidFill>
+                  <a:srgbClr val="FFFFFF"/>
+                </a:solidFill>
+                <a:latin typeface="Heebo"/>
+                <a:cs typeface="Heebo"/>
+              </a:rPr>
+              <a:t>מודל אידיאלי</a:t>
+            </a:r>
+          </a:p>
+        </p:txBody>
+      </p:sp>
+      <p:sp>
+        <p:nvSpPr>
+          <p:cNvPr id="10" name="TextBox 9"/>
+          <p:cNvSpPr txBox="1"/>
+          <p:nvPr/>
+        </p:nvSpPr>
+        <p:spPr>
+          <a:xfrm>
+            <a:off x="8234477" y="1664208"/>
+            <a:ext cx="3454298" cy="329184"/>
+          </a:xfrm>
+          <a:prstGeom prst="rect">
+            <a:avLst/>
+          </a:prstGeom>
+          <a:noFill/>
+        </p:spPr>
+        <p:txBody>
+          <a:bodyPr wrap="square" anchor="ctr" lIns="36576" rIns="36576" tIns="0" bIns="0">
+            <a:spAutoFit/>
+          </a:bodyPr>
+          <a:lstStyle/>
+          <a:p>
+            <a:pPr algn="ctr" rtl="1"/>
+            <a:r>
+              <a:rPr sz="1000" b="0">
+                <a:solidFill>
+                  <a:srgbClr val="F0C000"/>
+                </a:solidFill>
+                <a:latin typeface="Heebo"/>
+                <a:cs typeface="Heebo"/>
+              </a:rPr>
+              <a:t>צוות מלא בשכר מלא</a:t>
+            </a:r>
+          </a:p>
+        </p:txBody>
+      </p:sp>
+      <p:sp>
+        <p:nvSpPr>
+          <p:cNvPr id="11" name="TextBox 10"/>
+          <p:cNvSpPr txBox="1"/>
+          <p:nvPr/>
+        </p:nvSpPr>
+        <p:spPr>
+          <a:xfrm>
+            <a:off x="8143037" y="2148840"/>
+            <a:ext cx="3637178" cy="640080"/>
+          </a:xfrm>
+          <a:prstGeom prst="rect">
+            <a:avLst/>
+          </a:prstGeom>
+          <a:noFill/>
+        </p:spPr>
+        <p:txBody>
+          <a:bodyPr wrap="square" anchor="ctr" lIns="36576" rIns="36576" tIns="0" bIns="0">
+            <a:spAutoFit/>
+          </a:bodyPr>
+          <a:lstStyle/>
+          <a:p>
+            <a:pPr algn="ctr" rtl="1"/>
+            <a:r>
+              <a:rPr sz="3600" b="1">
+                <a:solidFill>
+                  <a:srgbClr val="1C3C7A"/>
+                </a:solidFill>
+                <a:latin typeface="Heebo"/>
+                <a:cs typeface="Heebo"/>
+              </a:rPr>
+              <a:t>25,600 ₪</a:t>
+            </a:r>
+          </a:p>
+        </p:txBody>
+      </p:sp>
+      <p:sp>
+        <p:nvSpPr>
+          <p:cNvPr id="12" name="TextBox 11"/>
+          <p:cNvSpPr txBox="1"/>
+          <p:nvPr/>
+        </p:nvSpPr>
+        <p:spPr>
+          <a:xfrm>
+            <a:off x="8143037" y="2743200"/>
+            <a:ext cx="3637178" cy="274320"/>
+          </a:xfrm>
+          <a:prstGeom prst="rect">
+            <a:avLst/>
+          </a:prstGeom>
+          <a:noFill/>
+        </p:spPr>
+        <p:txBody>
+          <a:bodyPr wrap="square" anchor="ctr" lIns="36576" rIns="36576" tIns="0" bIns="0">
+            <a:spAutoFit/>
+          </a:bodyPr>
+          <a:lstStyle/>
+          <a:p>
+            <a:pPr algn="ctr" rtl="1"/>
+            <a:r>
+              <a:rPr sz="1200" b="0">
+                <a:solidFill>
+                  <a:srgbClr val="8A94A8"/>
+                </a:solidFill>
+                <a:latin typeface="Heebo"/>
+                <a:cs typeface="Heebo"/>
+              </a:rPr>
+              <a:t>לחודש · 307,200 ₪ בשנה</a:t>
+            </a:r>
+          </a:p>
+        </p:txBody>
+      </p:sp>
+      <p:sp>
+        <p:nvSpPr>
+          <p:cNvPr id="13" name="Rounded Rectangle 12"/>
+          <p:cNvSpPr/>
+          <p:nvPr/>
+        </p:nvSpPr>
+        <p:spPr>
+          <a:xfrm>
+            <a:off x="10007346" y="3108960"/>
+            <a:ext cx="1589989" cy="658368"/>
+          </a:xfrm>
+          <a:prstGeom prst="roundRect">
+            <a:avLst>
+              <a:gd name="adj" fmla="val 15000"/>
+            </a:avLst>
+          </a:prstGeom>
+          <a:solidFill>
+            <a:srgbClr val="F4F6FB"/>
+          </a:solidFill>
+          <a:ln>
+            <a:noFill/>
+          </a:ln>
+          <a:effectLst/>
+        </p:spPr>
+        <p:style>
+          <a:lnRef idx="1">
+            <a:schemeClr val="accent1"/>
+          </a:lnRef>
+          <a:fillRef idx="3">
+            <a:schemeClr val="accent1"/>
+          </a:fillRef>
+          <a:effectRef idx="2">
+            <a:schemeClr val="accent1"/>
+          </a:effectRef>
+          <a:fontRef idx="minor">
+            <a:schemeClr val="lt1"/>
+          </a:fontRef>
+        </p:style>
+        <p:txBody>
+          <a:bodyPr rtlCol="0" anchor="ctr"/>
+          <a:lstStyle/>
+          <a:p>
+            <a:pPr algn="ctr"/>
+          </a:p>
+        </p:txBody>
+      </p:sp>
+      <p:sp>
+        <p:nvSpPr>
+          <p:cNvPr id="14" name="TextBox 13"/>
+          <p:cNvSpPr txBox="1"/>
+          <p:nvPr/>
+        </p:nvSpPr>
+        <p:spPr>
+          <a:xfrm>
+            <a:off x="10007346" y="3136392"/>
+            <a:ext cx="1589989" cy="347472"/>
+          </a:xfrm>
+          <a:prstGeom prst="rect">
+            <a:avLst/>
+          </a:prstGeom>
+          <a:noFill/>
+        </p:spPr>
+        <p:txBody>
+          <a:bodyPr wrap="square" anchor="ctr" lIns="36576" rIns="36576" tIns="0" bIns="0">
+            <a:spAutoFit/>
+          </a:bodyPr>
+          <a:lstStyle/>
+          <a:p>
+            <a:pPr algn="ctr" rtl="1"/>
+            <a:r>
+              <a:rPr sz="1700" b="1">
+                <a:solidFill>
+                  <a:srgbClr val="1C3C7A"/>
+                </a:solidFill>
+                <a:latin typeface="Heebo"/>
+                <a:cs typeface="Heebo"/>
+              </a:rPr>
+              <a:t>16</a:t>
+            </a:r>
+          </a:p>
+        </p:txBody>
+      </p:sp>
+      <p:sp>
+        <p:nvSpPr>
+          <p:cNvPr id="15" name="TextBox 14"/>
+          <p:cNvSpPr txBox="1"/>
+          <p:nvPr/>
+        </p:nvSpPr>
+        <p:spPr>
+          <a:xfrm>
+            <a:off x="10007346" y="3474720"/>
+            <a:ext cx="1589989" cy="256032"/>
+          </a:xfrm>
+          <a:prstGeom prst="rect">
+            <a:avLst/>
+          </a:prstGeom>
+          <a:noFill/>
+        </p:spPr>
+        <p:txBody>
+          <a:bodyPr wrap="square" anchor="ctr" lIns="36576" rIns="36576" tIns="0" bIns="0">
+            <a:spAutoFit/>
+          </a:bodyPr>
+          <a:lstStyle/>
+          <a:p>
+            <a:pPr algn="ctr" rtl="1"/>
+            <a:r>
+              <a:rPr sz="1000" b="0">
+                <a:solidFill>
+                  <a:srgbClr val="8A94A8"/>
+                </a:solidFill>
+                <a:latin typeface="Heebo"/>
+                <a:cs typeface="Heebo"/>
+              </a:rPr>
+              <a:t>דיונים בחודש</a:t>
+            </a:r>
+          </a:p>
+        </p:txBody>
+      </p:sp>
+      <p:sp>
+        <p:nvSpPr>
+          <p:cNvPr id="16" name="Rounded Rectangle 15"/>
+          <p:cNvSpPr/>
+          <p:nvPr/>
+        </p:nvSpPr>
+        <p:spPr>
+          <a:xfrm>
+            <a:off x="8325917" y="3108960"/>
+            <a:ext cx="1589989" cy="658368"/>
+          </a:xfrm>
+          <a:prstGeom prst="roundRect">
+            <a:avLst>
+              <a:gd name="adj" fmla="val 15000"/>
+            </a:avLst>
+          </a:prstGeom>
+          <a:solidFill>
+            <a:srgbClr val="F4F6FB"/>
+          </a:solidFill>
+          <a:ln>
+            <a:noFill/>
+          </a:ln>
+          <a:effectLst/>
+        </p:spPr>
+        <p:style>
+          <a:lnRef idx="1">
+            <a:schemeClr val="accent1"/>
+          </a:lnRef>
+          <a:fillRef idx="3">
+            <a:schemeClr val="accent1"/>
+          </a:fillRef>
+          <a:effectRef idx="2">
+            <a:schemeClr val="accent1"/>
+          </a:effectRef>
+          <a:fontRef idx="minor">
+            <a:schemeClr val="lt1"/>
+          </a:fontRef>
+        </p:style>
+        <p:txBody>
+          <a:bodyPr rtlCol="0" anchor="ctr"/>
+          <a:lstStyle/>
+          <a:p>
+            <a:pPr algn="ctr"/>
+          </a:p>
+        </p:txBody>
+      </p:sp>
+      <p:sp>
+        <p:nvSpPr>
+          <p:cNvPr id="17" name="TextBox 16"/>
+          <p:cNvSpPr txBox="1"/>
+          <p:nvPr/>
+        </p:nvSpPr>
+        <p:spPr>
+          <a:xfrm>
+            <a:off x="8325917" y="3136392"/>
+            <a:ext cx="1589989" cy="347472"/>
+          </a:xfrm>
+          <a:prstGeom prst="rect">
+            <a:avLst/>
+          </a:prstGeom>
+          <a:noFill/>
+        </p:spPr>
+        <p:txBody>
+          <a:bodyPr wrap="square" anchor="ctr" lIns="36576" rIns="36576" tIns="0" bIns="0">
+            <a:spAutoFit/>
+          </a:bodyPr>
+          <a:lstStyle/>
+          <a:p>
+            <a:pPr algn="ctr" rtl="1"/>
+            <a:r>
+              <a:rPr sz="1700" b="1">
+                <a:solidFill>
+                  <a:srgbClr val="1C3C7A"/>
+                </a:solidFill>
+                <a:latin typeface="Heebo"/>
+                <a:cs typeface="Heebo"/>
+              </a:rPr>
+              <a:t>1,600 ₪</a:t>
+            </a:r>
+          </a:p>
+        </p:txBody>
+      </p:sp>
+      <p:sp>
+        <p:nvSpPr>
+          <p:cNvPr id="18" name="TextBox 17"/>
+          <p:cNvSpPr txBox="1"/>
+          <p:nvPr/>
+        </p:nvSpPr>
+        <p:spPr>
+          <a:xfrm>
+            <a:off x="8325917" y="3474720"/>
+            <a:ext cx="1589989" cy="256032"/>
+          </a:xfrm>
+          <a:prstGeom prst="rect">
+            <a:avLst/>
+          </a:prstGeom>
+          <a:noFill/>
+        </p:spPr>
+        <p:txBody>
+          <a:bodyPr wrap="square" anchor="ctr" lIns="36576" rIns="36576" tIns="0" bIns="0">
+            <a:spAutoFit/>
+          </a:bodyPr>
+          <a:lstStyle/>
+          <a:p>
+            <a:pPr algn="ctr" rtl="1"/>
+            <a:r>
+              <a:rPr sz="1000" b="0">
+                <a:solidFill>
+                  <a:srgbClr val="8A94A8"/>
+                </a:solidFill>
+                <a:latin typeface="Heebo"/>
+                <a:cs typeface="Heebo"/>
+              </a:rPr>
+              <a:t>לדיון</a:t>
+            </a:r>
+          </a:p>
+        </p:txBody>
+      </p:sp>
+      <p:sp>
+        <p:nvSpPr>
+          <p:cNvPr id="19" name="TextBox 18"/>
+          <p:cNvSpPr txBox="1"/>
+          <p:nvPr/>
+        </p:nvSpPr>
+        <p:spPr>
+          <a:xfrm>
+            <a:off x="9377477" y="3931920"/>
+            <a:ext cx="2219858" cy="310896"/>
+          </a:xfrm>
+          <a:prstGeom prst="rect">
+            <a:avLst/>
+          </a:prstGeom>
+          <a:noFill/>
+        </p:spPr>
+        <p:txBody>
+          <a:bodyPr wrap="square" anchor="ctr" lIns="36576" rIns="36576" tIns="0" bIns="0">
+            <a:spAutoFit/>
+          </a:bodyPr>
+          <a:lstStyle/>
+          <a:p>
+            <a:pPr algn="r" rtl="1"/>
+            <a:r>
+              <a:rPr sz="1100" b="0">
+                <a:solidFill>
+                  <a:srgbClr val="1A2233"/>
+                </a:solidFill>
+                <a:latin typeface="Heebo"/>
+                <a:cs typeface="Heebo"/>
+              </a:rPr>
+              <a:t>מנכ״ל</a:t>
+            </a:r>
+          </a:p>
+        </p:txBody>
+      </p:sp>
+      <p:sp>
+        <p:nvSpPr>
+          <p:cNvPr id="20" name="TextBox 19"/>
+          <p:cNvSpPr txBox="1"/>
+          <p:nvPr/>
+        </p:nvSpPr>
+        <p:spPr>
+          <a:xfrm>
+            <a:off x="8280197" y="3931920"/>
+            <a:ext cx="1097280" cy="310896"/>
+          </a:xfrm>
+          <a:prstGeom prst="rect">
+            <a:avLst/>
+          </a:prstGeom>
+          <a:noFill/>
+        </p:spPr>
+        <p:txBody>
+          <a:bodyPr wrap="square" anchor="ctr" lIns="36576" rIns="36576" tIns="0" bIns="0">
+            <a:spAutoFit/>
+          </a:bodyPr>
+          <a:lstStyle/>
+          <a:p>
+            <a:pPr algn="l" rtl="1"/>
+            <a:r>
+              <a:rPr sz="1100" b="1">
+                <a:solidFill>
+                  <a:srgbClr val="1C3C7A"/>
+                </a:solidFill>
+                <a:latin typeface="Heebo"/>
+                <a:cs typeface="Heebo"/>
+              </a:rPr>
+              <a:t>12,000 ₪</a:t>
+            </a:r>
+          </a:p>
+        </p:txBody>
+      </p:sp>
+      <p:cxnSp>
+        <p:nvCxnSpPr>
+          <p:cNvPr id="21" name="Connector 20"/>
+          <p:cNvCxnSpPr/>
+          <p:nvPr/>
+        </p:nvCxnSpPr>
+        <p:spPr>
+          <a:xfrm>
+            <a:off x="8325917" y="4270248"/>
+            <a:ext cx="3271418" cy="0"/>
+          </a:xfrm>
+          <a:prstGeom prst="line">
+            <a:avLst/>
+          </a:prstGeom>
+          <a:ln w="9525">
+            <a:solidFill>
+              <a:srgbClr val="C5CDDD"/>
+            </a:solidFill>
+          </a:ln>
+        </p:spPr>
+        <p:style>
+          <a:lnRef idx="2">
+            <a:schemeClr val="accent1"/>
+          </a:lnRef>
+          <a:fillRef idx="0">
+            <a:schemeClr val="accent1"/>
+          </a:fillRef>
+          <a:effectRef idx="1">
+            <a:schemeClr val="accent1"/>
+          </a:effectRef>
+          <a:fontRef idx="minor">
+            <a:schemeClr val="tx1"/>
+          </a:fontRef>
+        </p:style>
+      </p:cxnSp>
+      <p:sp>
+        <p:nvSpPr>
+          <p:cNvPr id="22" name="TextBox 21"/>
+          <p:cNvSpPr txBox="1"/>
+          <p:nvPr/>
+        </p:nvSpPr>
+        <p:spPr>
+          <a:xfrm>
+            <a:off x="9377477" y="4297680"/>
+            <a:ext cx="2219858" cy="310896"/>
+          </a:xfrm>
+          <a:prstGeom prst="rect">
+            <a:avLst/>
+          </a:prstGeom>
+          <a:noFill/>
+        </p:spPr>
+        <p:txBody>
+          <a:bodyPr wrap="square" anchor="ctr" lIns="36576" rIns="36576" tIns="0" bIns="0">
+            <a:spAutoFit/>
+          </a:bodyPr>
+          <a:lstStyle/>
+          <a:p>
+            <a:pPr algn="r" rtl="1"/>
+            <a:r>
+              <a:rPr sz="1100" b="0">
+                <a:solidFill>
+                  <a:srgbClr val="1A2233"/>
+                </a:solidFill>
+                <a:latin typeface="Heebo"/>
+                <a:cs typeface="Heebo"/>
+              </a:rPr>
+              <a:t>עוזר מנכ״ל · חצי משרה</a:t>
+            </a:r>
+          </a:p>
+        </p:txBody>
+      </p:sp>
+      <p:sp>
+        <p:nvSpPr>
+          <p:cNvPr id="23" name="TextBox 22"/>
+          <p:cNvSpPr txBox="1"/>
+          <p:nvPr/>
+        </p:nvSpPr>
+        <p:spPr>
+          <a:xfrm>
+            <a:off x="8280197" y="4297680"/>
+            <a:ext cx="1097280" cy="310896"/>
+          </a:xfrm>
+          <a:prstGeom prst="rect">
+            <a:avLst/>
+          </a:prstGeom>
+          <a:noFill/>
+        </p:spPr>
+        <p:txBody>
+          <a:bodyPr wrap="square" anchor="ctr" lIns="36576" rIns="36576" tIns="0" bIns="0">
+            <a:spAutoFit/>
+          </a:bodyPr>
+          <a:lstStyle/>
+          <a:p>
+            <a:pPr algn="l" rtl="1"/>
+            <a:r>
+              <a:rPr sz="1100" b="1">
+                <a:solidFill>
+                  <a:srgbClr val="1C3C7A"/>
+                </a:solidFill>
+                <a:latin typeface="Heebo"/>
+                <a:cs typeface="Heebo"/>
+              </a:rPr>
+              <a:t>5,000 ₪</a:t>
+            </a:r>
+          </a:p>
+        </p:txBody>
+      </p:sp>
+      <p:cxnSp>
+        <p:nvCxnSpPr>
+          <p:cNvPr id="24" name="Connector 23"/>
+          <p:cNvCxnSpPr/>
+          <p:nvPr/>
+        </p:nvCxnSpPr>
+        <p:spPr>
+          <a:xfrm>
+            <a:off x="8325917" y="4636008"/>
+            <a:ext cx="3271418" cy="0"/>
+          </a:xfrm>
+          <a:prstGeom prst="line">
+            <a:avLst/>
+          </a:prstGeom>
+          <a:ln w="9525">
+            <a:solidFill>
+              <a:srgbClr val="C5CDDD"/>
+            </a:solidFill>
+          </a:ln>
+        </p:spPr>
+        <p:style>
+          <a:lnRef idx="2">
+            <a:schemeClr val="accent1"/>
+          </a:lnRef>
+          <a:fillRef idx="0">
+            <a:schemeClr val="accent1"/>
+          </a:fillRef>
+          <a:effectRef idx="1">
+            <a:schemeClr val="accent1"/>
+          </a:effectRef>
+          <a:fontRef idx="minor">
+            <a:schemeClr val="tx1"/>
+          </a:fontRef>
+        </p:style>
+      </p:cxnSp>
+      <p:sp>
+        <p:nvSpPr>
+          <p:cNvPr id="25" name="TextBox 24"/>
+          <p:cNvSpPr txBox="1"/>
+          <p:nvPr/>
+        </p:nvSpPr>
+        <p:spPr>
+          <a:xfrm>
+            <a:off x="9377477" y="4663440"/>
+            <a:ext cx="2219858" cy="310896"/>
+          </a:xfrm>
+          <a:prstGeom prst="rect">
+            <a:avLst/>
+          </a:prstGeom>
+          <a:noFill/>
+        </p:spPr>
+        <p:txBody>
+          <a:bodyPr wrap="square" anchor="ctr" lIns="36576" rIns="36576" tIns="0" bIns="0">
+            <a:spAutoFit/>
+          </a:bodyPr>
+          <a:lstStyle/>
+          <a:p>
+            <a:pPr algn="r" rtl="1"/>
+            <a:r>
+              <a:rPr sz="1100" b="0">
+                <a:solidFill>
+                  <a:srgbClr val="1A2233"/>
+                </a:solidFill>
+                <a:latin typeface="Heebo"/>
+                <a:cs typeface="Heebo"/>
+              </a:rPr>
+              <a:t>מנהל תוכן · חצי משרה</a:t>
+            </a:r>
+          </a:p>
+        </p:txBody>
+      </p:sp>
+      <p:sp>
+        <p:nvSpPr>
+          <p:cNvPr id="26" name="TextBox 25"/>
+          <p:cNvSpPr txBox="1"/>
+          <p:nvPr/>
+        </p:nvSpPr>
+        <p:spPr>
+          <a:xfrm>
+            <a:off x="8280197" y="4663440"/>
+            <a:ext cx="1097280" cy="310896"/>
+          </a:xfrm>
+          <a:prstGeom prst="rect">
+            <a:avLst/>
+          </a:prstGeom>
+          <a:noFill/>
+        </p:spPr>
+        <p:txBody>
+          <a:bodyPr wrap="square" anchor="ctr" lIns="36576" rIns="36576" tIns="0" bIns="0">
+            <a:spAutoFit/>
+          </a:bodyPr>
+          <a:lstStyle/>
+          <a:p>
+            <a:pPr algn="l" rtl="1"/>
+            <a:r>
+              <a:rPr sz="1100" b="1">
+                <a:solidFill>
+                  <a:srgbClr val="1C3C7A"/>
+                </a:solidFill>
+                <a:latin typeface="Heebo"/>
+                <a:cs typeface="Heebo"/>
+              </a:rPr>
+              <a:t>5,000 ₪</a:t>
+            </a:r>
+          </a:p>
+        </p:txBody>
+      </p:sp>
+      <p:cxnSp>
+        <p:nvCxnSpPr>
+          <p:cNvPr id="27" name="Connector 26"/>
+          <p:cNvCxnSpPr/>
+          <p:nvPr/>
+        </p:nvCxnSpPr>
+        <p:spPr>
+          <a:xfrm>
+            <a:off x="8325917" y="5001768"/>
+            <a:ext cx="3271418" cy="0"/>
+          </a:xfrm>
+          <a:prstGeom prst="line">
+            <a:avLst/>
+          </a:prstGeom>
+          <a:ln w="9525">
+            <a:solidFill>
+              <a:srgbClr val="C5CDDD"/>
+            </a:solidFill>
+          </a:ln>
+        </p:spPr>
+        <p:style>
+          <a:lnRef idx="2">
+            <a:schemeClr val="accent1"/>
+          </a:lnRef>
+          <a:fillRef idx="0">
+            <a:schemeClr val="accent1"/>
+          </a:fillRef>
+          <a:effectRef idx="1">
+            <a:schemeClr val="accent1"/>
+          </a:effectRef>
+          <a:fontRef idx="minor">
+            <a:schemeClr val="tx1"/>
+          </a:fontRef>
+        </p:style>
+      </p:cxnSp>
+      <p:sp>
+        <p:nvSpPr>
+          <p:cNvPr id="28" name="TextBox 27"/>
+          <p:cNvSpPr txBox="1"/>
+          <p:nvPr/>
+        </p:nvSpPr>
+        <p:spPr>
+          <a:xfrm>
+            <a:off x="9377477" y="5029200"/>
+            <a:ext cx="2219858" cy="310896"/>
+          </a:xfrm>
+          <a:prstGeom prst="rect">
+            <a:avLst/>
+          </a:prstGeom>
+          <a:noFill/>
+        </p:spPr>
+        <p:txBody>
+          <a:bodyPr wrap="square" anchor="ctr" lIns="36576" rIns="36576" tIns="0" bIns="0">
+            <a:spAutoFit/>
+          </a:bodyPr>
+          <a:lstStyle/>
+          <a:p>
+            <a:pPr algn="r" rtl="1"/>
+            <a:r>
+              <a:rPr sz="1100" b="0">
+                <a:solidFill>
+                  <a:srgbClr val="1A2233"/>
+                </a:solidFill>
+                <a:latin typeface="Heebo"/>
+                <a:cs typeface="Heebo"/>
+              </a:rPr>
+              <a:t>נציג 3 · 4 דיונים</a:t>
+            </a:r>
+          </a:p>
+        </p:txBody>
+      </p:sp>
+      <p:sp>
+        <p:nvSpPr>
+          <p:cNvPr id="29" name="TextBox 28"/>
+          <p:cNvSpPr txBox="1"/>
+          <p:nvPr/>
+        </p:nvSpPr>
+        <p:spPr>
+          <a:xfrm>
+            <a:off x="8280197" y="5029200"/>
+            <a:ext cx="1097280" cy="310896"/>
+          </a:xfrm>
+          <a:prstGeom prst="rect">
+            <a:avLst/>
+          </a:prstGeom>
+          <a:noFill/>
+        </p:spPr>
+        <p:txBody>
+          <a:bodyPr wrap="square" anchor="ctr" lIns="36576" rIns="36576" tIns="0" bIns="0">
+            <a:spAutoFit/>
+          </a:bodyPr>
+          <a:lstStyle/>
+          <a:p>
+            <a:pPr algn="l" rtl="1"/>
+            <a:r>
+              <a:rPr sz="1100" b="1">
+                <a:solidFill>
+                  <a:srgbClr val="1C3C7A"/>
+                </a:solidFill>
+                <a:latin typeface="Heebo"/>
+                <a:cs typeface="Heebo"/>
+              </a:rPr>
+              <a:t>1,800 ₪</a:t>
+            </a:r>
+          </a:p>
+        </p:txBody>
+      </p:sp>
+      <p:cxnSp>
+        <p:nvCxnSpPr>
+          <p:cNvPr id="30" name="Connector 29"/>
+          <p:cNvCxnSpPr/>
+          <p:nvPr/>
+        </p:nvCxnSpPr>
+        <p:spPr>
+          <a:xfrm>
+            <a:off x="8325917" y="5367528"/>
+            <a:ext cx="3271418" cy="0"/>
+          </a:xfrm>
+          <a:prstGeom prst="line">
+            <a:avLst/>
+          </a:prstGeom>
+          <a:ln w="9525">
+            <a:solidFill>
+              <a:srgbClr val="C5CDDD"/>
+            </a:solidFill>
+          </a:ln>
+        </p:spPr>
+        <p:style>
+          <a:lnRef idx="2">
+            <a:schemeClr val="accent1"/>
+          </a:lnRef>
+          <a:fillRef idx="0">
+            <a:schemeClr val="accent1"/>
+          </a:fillRef>
+          <a:effectRef idx="1">
+            <a:schemeClr val="accent1"/>
+          </a:effectRef>
+          <a:fontRef idx="minor">
+            <a:schemeClr val="tx1"/>
+          </a:fontRef>
+        </p:style>
+      </p:cxnSp>
+      <p:sp>
+        <p:nvSpPr>
+          <p:cNvPr id="31" name="TextBox 30"/>
+          <p:cNvSpPr txBox="1"/>
+          <p:nvPr/>
+        </p:nvSpPr>
+        <p:spPr>
+          <a:xfrm>
+            <a:off x="9377477" y="5394960"/>
+            <a:ext cx="2219858" cy="310896"/>
+          </a:xfrm>
+          <a:prstGeom prst="rect">
+            <a:avLst/>
+          </a:prstGeom>
+          <a:noFill/>
+        </p:spPr>
+        <p:txBody>
+          <a:bodyPr wrap="square" anchor="ctr" lIns="36576" rIns="36576" tIns="0" bIns="0">
+            <a:spAutoFit/>
+          </a:bodyPr>
+          <a:lstStyle/>
+          <a:p>
+            <a:pPr algn="r" rtl="1"/>
+            <a:r>
+              <a:rPr sz="1100" b="0">
+                <a:solidFill>
+                  <a:srgbClr val="1A2233"/>
+                </a:solidFill>
+                <a:latin typeface="Heebo"/>
+                <a:cs typeface="Heebo"/>
+              </a:rPr>
+              <a:t>נציג 4 · 4 דיונים</a:t>
+            </a:r>
+          </a:p>
+        </p:txBody>
+      </p:sp>
+      <p:sp>
+        <p:nvSpPr>
+          <p:cNvPr id="32" name="TextBox 31"/>
+          <p:cNvSpPr txBox="1"/>
+          <p:nvPr/>
+        </p:nvSpPr>
+        <p:spPr>
+          <a:xfrm>
+            <a:off x="8280197" y="5394960"/>
+            <a:ext cx="1097280" cy="310896"/>
+          </a:xfrm>
+          <a:prstGeom prst="rect">
+            <a:avLst/>
+          </a:prstGeom>
+          <a:noFill/>
+        </p:spPr>
+        <p:txBody>
+          <a:bodyPr wrap="square" anchor="ctr" lIns="36576" rIns="36576" tIns="0" bIns="0">
+            <a:spAutoFit/>
+          </a:bodyPr>
+          <a:lstStyle/>
+          <a:p>
+            <a:pPr algn="l" rtl="1"/>
+            <a:r>
+              <a:rPr sz="1100" b="1">
+                <a:solidFill>
+                  <a:srgbClr val="1C3C7A"/>
+                </a:solidFill>
+                <a:latin typeface="Heebo"/>
+                <a:cs typeface="Heebo"/>
+              </a:rPr>
+              <a:t>1,800 ₪</a:t>
+            </a:r>
+          </a:p>
+        </p:txBody>
+      </p:sp>
+      <p:cxnSp>
+        <p:nvCxnSpPr>
+          <p:cNvPr id="33" name="Connector 32"/>
+          <p:cNvCxnSpPr/>
+          <p:nvPr/>
+        </p:nvCxnSpPr>
+        <p:spPr>
+          <a:xfrm>
+            <a:off x="8325917" y="5733288"/>
+            <a:ext cx="3271418" cy="0"/>
+          </a:xfrm>
+          <a:prstGeom prst="line">
+            <a:avLst/>
+          </a:prstGeom>
+          <a:ln w="9525">
+            <a:solidFill>
+              <a:srgbClr val="C5CDDD"/>
+            </a:solidFill>
+          </a:ln>
+        </p:spPr>
+        <p:style>
+          <a:lnRef idx="2">
+            <a:schemeClr val="accent1"/>
+          </a:lnRef>
+          <a:fillRef idx="0">
+            <a:schemeClr val="accent1"/>
+          </a:fillRef>
+          <a:effectRef idx="1">
+            <a:schemeClr val="accent1"/>
+          </a:effectRef>
+          <a:fontRef idx="minor">
+            <a:schemeClr val="tx1"/>
+          </a:fontRef>
+        </p:style>
+      </p:cxnSp>
+      <p:sp>
+        <p:nvSpPr>
+          <p:cNvPr id="34" name="TextBox 33"/>
+          <p:cNvSpPr txBox="1"/>
+          <p:nvPr/>
+        </p:nvSpPr>
+        <p:spPr>
+          <a:xfrm>
+            <a:off x="8325917" y="5806440"/>
+            <a:ext cx="3271418" cy="256032"/>
+          </a:xfrm>
+          <a:prstGeom prst="rect">
+            <a:avLst/>
+          </a:prstGeom>
+          <a:noFill/>
+        </p:spPr>
+        <p:txBody>
+          <a:bodyPr wrap="square" anchor="ctr" lIns="36576" rIns="36576" tIns="0" bIns="0">
+            <a:spAutoFit/>
+          </a:bodyPr>
+          <a:lstStyle/>
+          <a:p>
+            <a:pPr algn="r" rtl="1"/>
+            <a:r>
+              <a:rPr sz="1000" b="0">
+                <a:solidFill>
+                  <a:srgbClr val="8A94A8"/>
+                </a:solidFill>
+                <a:latin typeface="Heebo"/>
+                <a:cs typeface="Heebo"/>
+              </a:rPr>
+              <a:t>תעריף: 400 ₪ חצי יום · 600 ₪ יום מלא</a:t>
+            </a:r>
+          </a:p>
+        </p:txBody>
+      </p:sp>
+      <p:sp>
+        <p:nvSpPr>
+          <p:cNvPr id="35" name="TextBox 34"/>
+          <p:cNvSpPr txBox="1"/>
+          <p:nvPr/>
+        </p:nvSpPr>
+        <p:spPr>
+          <a:xfrm>
+            <a:off x="8325917" y="6080760"/>
+            <a:ext cx="3271418" cy="274320"/>
+          </a:xfrm>
+          <a:prstGeom prst="rect">
+            <a:avLst/>
+          </a:prstGeom>
+          <a:noFill/>
+        </p:spPr>
+        <p:txBody>
+          <a:bodyPr wrap="square" anchor="ctr" lIns="36576" rIns="36576" tIns="0" bIns="0">
+            <a:spAutoFit/>
+          </a:bodyPr>
+          <a:lstStyle/>
+          <a:p>
+            <a:pPr algn="r" rtl="1"/>
+            <a:r>
+              <a:rPr sz="1100" b="1">
+                <a:solidFill>
+                  <a:srgbClr val="1C3C7A"/>
+                </a:solidFill>
+                <a:latin typeface="Heebo"/>
+                <a:cs typeface="Heebo"/>
+              </a:rPr>
+              <a:t>מימון: כ-5 שותפים מייסדים</a:t>
+            </a:r>
+          </a:p>
+        </p:txBody>
+      </p:sp>
+      <p:sp>
+        <p:nvSpPr>
+          <p:cNvPr id="36" name="Rounded Rectangle 35"/>
+          <p:cNvSpPr/>
+          <p:nvPr/>
+        </p:nvSpPr>
+        <p:spPr>
+          <a:xfrm>
+            <a:off x="4277259" y="1188720"/>
+            <a:ext cx="3637178" cy="5120640"/>
+          </a:xfrm>
+          <a:prstGeom prst="roundRect">
+            <a:avLst>
+              <a:gd name="adj" fmla="val 5000"/>
+            </a:avLst>
+          </a:prstGeom>
+          <a:solidFill>
+            <a:srgbClr val="FFFFFF"/>
+          </a:solidFill>
+          <a:ln w="38100">
+            <a:solidFill>
+              <a:srgbClr val="F0C000"/>
+            </a:solidFill>
+          </a:ln>
+          <a:effectLst/>
+        </p:spPr>
+        <p:style>
+          <a:lnRef idx="1">
+            <a:schemeClr val="accent1"/>
+          </a:lnRef>
+          <a:fillRef idx="3">
+            <a:schemeClr val="accent1"/>
+          </a:fillRef>
+          <a:effectRef idx="2">
+            <a:schemeClr val="accent1"/>
+          </a:effectRef>
+          <a:fontRef idx="minor">
+            <a:schemeClr val="lt1"/>
+          </a:fontRef>
+        </p:style>
+        <p:txBody>
+          <a:bodyPr rtlCol="0" anchor="ctr"/>
+          <a:lstStyle/>
+          <a:p>
+            <a:pPr algn="ctr"/>
+          </a:p>
+        </p:txBody>
+      </p:sp>
+      <p:sp>
+        <p:nvSpPr>
+          <p:cNvPr id="37" name="Rounded Rectangle 36"/>
+          <p:cNvSpPr/>
+          <p:nvPr/>
+        </p:nvSpPr>
+        <p:spPr>
+          <a:xfrm>
+            <a:off x="4277259" y="1188720"/>
+            <a:ext cx="3637178" cy="868680"/>
+          </a:xfrm>
+          <a:prstGeom prst="roundRect">
+            <a:avLst>
+              <a:gd name="adj" fmla="val 12000"/>
+            </a:avLst>
+          </a:prstGeom>
+          <a:solidFill>
+            <a:srgbClr val="1C3C7A"/>
+          </a:solidFill>
+          <a:ln>
+            <a:noFill/>
+          </a:ln>
+          <a:effectLst/>
+        </p:spPr>
+        <p:style>
+          <a:lnRef idx="1">
+            <a:schemeClr val="accent1"/>
+          </a:lnRef>
+          <a:fillRef idx="3">
+            <a:schemeClr val="accent1"/>
+          </a:fillRef>
+          <a:effectRef idx="2">
+            <a:schemeClr val="accent1"/>
+          </a:effectRef>
+          <a:fontRef idx="minor">
+            <a:schemeClr val="lt1"/>
+          </a:fontRef>
+        </p:style>
+        <p:txBody>
+          <a:bodyPr rtlCol="0" anchor="ctr"/>
+          <a:lstStyle/>
+          <a:p>
+            <a:pPr algn="ctr"/>
+          </a:p>
+        </p:txBody>
+      </p:sp>
+      <p:sp>
+        <p:nvSpPr>
+          <p:cNvPr id="38" name="TextBox 37"/>
+          <p:cNvSpPr txBox="1"/>
+          <p:nvPr/>
+        </p:nvSpPr>
+        <p:spPr>
+          <a:xfrm>
+            <a:off x="4277259" y="1280160"/>
+            <a:ext cx="3637178" cy="384048"/>
+          </a:xfrm>
+          <a:prstGeom prst="rect">
+            <a:avLst/>
+          </a:prstGeom>
+          <a:noFill/>
+        </p:spPr>
+        <p:txBody>
+          <a:bodyPr wrap="square" anchor="ctr" lIns="36576" rIns="36576" tIns="0" bIns="0">
+            <a:spAutoFit/>
+          </a:bodyPr>
+          <a:lstStyle/>
+          <a:p>
+            <a:pPr algn="ctr" rtl="1"/>
+            <a:r>
+              <a:rPr sz="2000" b="1">
+                <a:solidFill>
+                  <a:srgbClr val="FFFFFF"/>
+                </a:solidFill>
+                <a:latin typeface="Heebo"/>
+                <a:cs typeface="Heebo"/>
+              </a:rPr>
+              <a:t>מודל ביניים</a:t>
+            </a:r>
+          </a:p>
+        </p:txBody>
+      </p:sp>
+      <p:sp>
+        <p:nvSpPr>
+          <p:cNvPr id="39" name="TextBox 38"/>
+          <p:cNvSpPr txBox="1"/>
+          <p:nvPr/>
+        </p:nvSpPr>
+        <p:spPr>
+          <a:xfrm>
+            <a:off x="4368699" y="1664208"/>
+            <a:ext cx="3454298" cy="329184"/>
+          </a:xfrm>
+          <a:prstGeom prst="rect">
+            <a:avLst/>
+          </a:prstGeom>
+          <a:noFill/>
+        </p:spPr>
+        <p:txBody>
+          <a:bodyPr wrap="square" anchor="ctr" lIns="36576" rIns="36576" tIns="0" bIns="0">
+            <a:spAutoFit/>
+          </a:bodyPr>
+          <a:lstStyle/>
+          <a:p>
+            <a:pPr algn="ctr" rtl="1"/>
+            <a:r>
+              <a:rPr sz="1000" b="0">
+                <a:solidFill>
+                  <a:srgbClr val="F0C000"/>
+                </a:solidFill>
+                <a:latin typeface="Heebo"/>
+                <a:cs typeface="Heebo"/>
+              </a:rPr>
+              <a:t>בלי נציג 4 · דירקטוריון ואקטיביסטים משלימים</a:t>
+            </a:r>
+          </a:p>
+        </p:txBody>
+      </p:sp>
+      <p:sp>
+        <p:nvSpPr>
+          <p:cNvPr id="40" name="Rounded Rectangle 39"/>
+          <p:cNvSpPr/>
+          <p:nvPr/>
+        </p:nvSpPr>
+        <p:spPr>
+          <a:xfrm>
+            <a:off x="5455768" y="1033272"/>
+            <a:ext cx="1280160" cy="310896"/>
+          </a:xfrm>
+          <a:prstGeom prst="roundRect">
+            <a:avLst>
+              <a:gd name="adj" fmla="val 50000"/>
+            </a:avLst>
+          </a:prstGeom>
+          <a:solidFill>
+            <a:srgbClr val="F0C000"/>
+          </a:solidFill>
+          <a:ln>
+            <a:noFill/>
+          </a:ln>
+          <a:effectLst/>
+        </p:spPr>
+        <p:style>
+          <a:lnRef idx="1">
+            <a:schemeClr val="accent1"/>
+          </a:lnRef>
+          <a:fillRef idx="3">
+            <a:schemeClr val="accent1"/>
+          </a:fillRef>
+          <a:effectRef idx="2">
+            <a:schemeClr val="accent1"/>
+          </a:effectRef>
+          <a:fontRef idx="minor">
+            <a:schemeClr val="lt1"/>
+          </a:fontRef>
+        </p:style>
+        <p:txBody>
+          <a:bodyPr rtlCol="0" anchor="ctr"/>
+          <a:lstStyle/>
+          <a:p>
+            <a:pPr algn="ctr"/>
+          </a:p>
+        </p:txBody>
+      </p:sp>
+      <p:sp>
+        <p:nvSpPr>
+          <p:cNvPr id="41" name="TextBox 40"/>
+          <p:cNvSpPr txBox="1"/>
+          <p:nvPr/>
+        </p:nvSpPr>
+        <p:spPr>
+          <a:xfrm>
+            <a:off x="5455768" y="1033272"/>
+            <a:ext cx="1280160" cy="310896"/>
+          </a:xfrm>
+          <a:prstGeom prst="rect">
+            <a:avLst/>
+          </a:prstGeom>
+          <a:noFill/>
+        </p:spPr>
+        <p:txBody>
+          <a:bodyPr wrap="square" anchor="ctr" lIns="36576" rIns="36576" tIns="0" bIns="0">
+            <a:spAutoFit/>
+          </a:bodyPr>
+          <a:lstStyle/>
+          <a:p>
+            <a:pPr algn="ctr" rtl="1"/>
+            <a:r>
+              <a:rPr sz="1200" b="1">
+                <a:solidFill>
+                  <a:srgbClr val="122755"/>
+                </a:solidFill>
+                <a:latin typeface="Heebo"/>
+                <a:cs typeface="Heebo"/>
+              </a:rPr>
+              <a:t>המלצה</a:t>
+            </a:r>
+          </a:p>
+        </p:txBody>
+      </p:sp>
+      <p:sp>
+        <p:nvSpPr>
+          <p:cNvPr id="42" name="TextBox 41"/>
+          <p:cNvSpPr txBox="1"/>
+          <p:nvPr/>
+        </p:nvSpPr>
+        <p:spPr>
+          <a:xfrm>
+            <a:off x="4277259" y="2148840"/>
+            <a:ext cx="3637178" cy="640080"/>
+          </a:xfrm>
+          <a:prstGeom prst="rect">
+            <a:avLst/>
+          </a:prstGeom>
+          <a:noFill/>
+        </p:spPr>
+        <p:txBody>
+          <a:bodyPr wrap="square" anchor="ctr" lIns="36576" rIns="36576" tIns="0" bIns="0">
+            <a:spAutoFit/>
+          </a:bodyPr>
+          <a:lstStyle/>
+          <a:p>
+            <a:pPr algn="ctr" rtl="1"/>
+            <a:r>
+              <a:rPr sz="3600" b="1">
+                <a:solidFill>
+                  <a:srgbClr val="1C3C7A"/>
+                </a:solidFill>
+                <a:latin typeface="Heebo"/>
+                <a:cs typeface="Heebo"/>
+              </a:rPr>
+              <a:t>23,050 ₪</a:t>
+            </a:r>
+          </a:p>
+        </p:txBody>
+      </p:sp>
+      <p:sp>
+        <p:nvSpPr>
+          <p:cNvPr id="43" name="TextBox 42"/>
+          <p:cNvSpPr txBox="1"/>
+          <p:nvPr/>
+        </p:nvSpPr>
+        <p:spPr>
+          <a:xfrm>
+            <a:off x="4277259" y="2743200"/>
+            <a:ext cx="3637178" cy="274320"/>
+          </a:xfrm>
+          <a:prstGeom prst="rect">
+            <a:avLst/>
+          </a:prstGeom>
+          <a:noFill/>
+        </p:spPr>
+        <p:txBody>
+          <a:bodyPr wrap="square" anchor="ctr" lIns="36576" rIns="36576" tIns="0" bIns="0">
+            <a:spAutoFit/>
+          </a:bodyPr>
+          <a:lstStyle/>
+          <a:p>
+            <a:pPr algn="ctr" rtl="1"/>
+            <a:r>
+              <a:rPr sz="1200" b="0">
+                <a:solidFill>
+                  <a:srgbClr val="8A94A8"/>
+                </a:solidFill>
+                <a:latin typeface="Heebo"/>
+                <a:cs typeface="Heebo"/>
+              </a:rPr>
+              <a:t>לחודש · 276,600 ₪ בשנה</a:t>
+            </a:r>
+          </a:p>
+        </p:txBody>
+      </p:sp>
+      <p:sp>
+        <p:nvSpPr>
+          <p:cNvPr id="44" name="Rounded Rectangle 43"/>
+          <p:cNvSpPr/>
+          <p:nvPr/>
+        </p:nvSpPr>
+        <p:spPr>
+          <a:xfrm>
+            <a:off x="6141568" y="3108960"/>
+            <a:ext cx="1589989" cy="658368"/>
+          </a:xfrm>
+          <a:prstGeom prst="roundRect">
+            <a:avLst>
+              <a:gd name="adj" fmla="val 15000"/>
+            </a:avLst>
+          </a:prstGeom>
+          <a:solidFill>
+            <a:srgbClr val="F4F6FB"/>
+          </a:solidFill>
+          <a:ln>
+            <a:noFill/>
+          </a:ln>
+          <a:effectLst/>
+        </p:spPr>
+        <p:style>
+          <a:lnRef idx="1">
+            <a:schemeClr val="accent1"/>
+          </a:lnRef>
+          <a:fillRef idx="3">
+            <a:schemeClr val="accent1"/>
+          </a:fillRef>
+          <a:effectRef idx="2">
+            <a:schemeClr val="accent1"/>
+          </a:effectRef>
+          <a:fontRef idx="minor">
+            <a:schemeClr val="lt1"/>
+          </a:fontRef>
+        </p:style>
+        <p:txBody>
+          <a:bodyPr rtlCol="0" anchor="ctr"/>
+          <a:lstStyle/>
+          <a:p>
+            <a:pPr algn="ctr"/>
+          </a:p>
+        </p:txBody>
+      </p:sp>
+      <p:sp>
+        <p:nvSpPr>
+          <p:cNvPr id="45" name="TextBox 44"/>
+          <p:cNvSpPr txBox="1"/>
+          <p:nvPr/>
+        </p:nvSpPr>
+        <p:spPr>
+          <a:xfrm>
+            <a:off x="6141568" y="3136392"/>
+            <a:ext cx="1589989" cy="347472"/>
+          </a:xfrm>
+          <a:prstGeom prst="rect">
+            <a:avLst/>
+          </a:prstGeom>
+          <a:noFill/>
+        </p:spPr>
+        <p:txBody>
+          <a:bodyPr wrap="square" anchor="ctr" lIns="36576" rIns="36576" tIns="0" bIns="0">
+            <a:spAutoFit/>
+          </a:bodyPr>
+          <a:lstStyle/>
+          <a:p>
+            <a:pPr algn="ctr" rtl="1"/>
+            <a:r>
+              <a:rPr sz="1700" b="1">
+                <a:solidFill>
+                  <a:srgbClr val="1C3C7A"/>
+                </a:solidFill>
+                <a:latin typeface="Heebo"/>
+                <a:cs typeface="Heebo"/>
+              </a:rPr>
+              <a:t>16</a:t>
+            </a:r>
+          </a:p>
+        </p:txBody>
+      </p:sp>
+      <p:sp>
+        <p:nvSpPr>
+          <p:cNvPr id="46" name="TextBox 45"/>
+          <p:cNvSpPr txBox="1"/>
+          <p:nvPr/>
+        </p:nvSpPr>
+        <p:spPr>
+          <a:xfrm>
+            <a:off x="6141568" y="3474720"/>
+            <a:ext cx="1589989" cy="256032"/>
+          </a:xfrm>
+          <a:prstGeom prst="rect">
+            <a:avLst/>
+          </a:prstGeom>
+          <a:noFill/>
+        </p:spPr>
+        <p:txBody>
+          <a:bodyPr wrap="square" anchor="ctr" lIns="36576" rIns="36576" tIns="0" bIns="0">
+            <a:spAutoFit/>
+          </a:bodyPr>
+          <a:lstStyle/>
+          <a:p>
+            <a:pPr algn="ctr" rtl="1"/>
+            <a:r>
+              <a:rPr sz="1000" b="0">
+                <a:solidFill>
+                  <a:srgbClr val="8A94A8"/>
+                </a:solidFill>
+                <a:latin typeface="Heebo"/>
+                <a:cs typeface="Heebo"/>
+              </a:rPr>
+              <a:t>דיונים בחודש</a:t>
+            </a:r>
+          </a:p>
+        </p:txBody>
+      </p:sp>
+      <p:sp>
+        <p:nvSpPr>
+          <p:cNvPr id="47" name="Rounded Rectangle 46"/>
+          <p:cNvSpPr/>
+          <p:nvPr/>
+        </p:nvSpPr>
+        <p:spPr>
+          <a:xfrm>
+            <a:off x="4460139" y="3108960"/>
+            <a:ext cx="1589989" cy="658368"/>
+          </a:xfrm>
+          <a:prstGeom prst="roundRect">
+            <a:avLst>
+              <a:gd name="adj" fmla="val 15000"/>
+            </a:avLst>
+          </a:prstGeom>
+          <a:solidFill>
+            <a:srgbClr val="F4F6FB"/>
+          </a:solidFill>
+          <a:ln>
+            <a:noFill/>
+          </a:ln>
+          <a:effectLst/>
+        </p:spPr>
+        <p:style>
+          <a:lnRef idx="1">
+            <a:schemeClr val="accent1"/>
+          </a:lnRef>
+          <a:fillRef idx="3">
+            <a:schemeClr val="accent1"/>
+          </a:fillRef>
+          <a:effectRef idx="2">
+            <a:schemeClr val="accent1"/>
+          </a:effectRef>
+          <a:fontRef idx="minor">
+            <a:schemeClr val="lt1"/>
+          </a:fontRef>
+        </p:style>
+        <p:txBody>
+          <a:bodyPr rtlCol="0" anchor="ctr"/>
+          <a:lstStyle/>
+          <a:p>
+            <a:pPr algn="ctr"/>
+          </a:p>
+        </p:txBody>
+      </p:sp>
+      <p:sp>
+        <p:nvSpPr>
+          <p:cNvPr id="48" name="TextBox 47"/>
+          <p:cNvSpPr txBox="1"/>
+          <p:nvPr/>
+        </p:nvSpPr>
+        <p:spPr>
+          <a:xfrm>
+            <a:off x="4460139" y="3136392"/>
+            <a:ext cx="1589989" cy="347472"/>
+          </a:xfrm>
+          <a:prstGeom prst="rect">
+            <a:avLst/>
+          </a:prstGeom>
+          <a:noFill/>
+        </p:spPr>
+        <p:txBody>
+          <a:bodyPr wrap="square" anchor="ctr" lIns="36576" rIns="36576" tIns="0" bIns="0">
+            <a:spAutoFit/>
+          </a:bodyPr>
+          <a:lstStyle/>
+          <a:p>
+            <a:pPr algn="ctr" rtl="1"/>
+            <a:r>
+              <a:rPr sz="1700" b="1">
+                <a:solidFill>
+                  <a:srgbClr val="1C3C7A"/>
+                </a:solidFill>
+                <a:latin typeface="Heebo"/>
+                <a:cs typeface="Heebo"/>
+              </a:rPr>
+              <a:t>1,440 ₪</a:t>
+            </a:r>
+          </a:p>
+        </p:txBody>
+      </p:sp>
+      <p:sp>
+        <p:nvSpPr>
+          <p:cNvPr id="49" name="TextBox 48"/>
+          <p:cNvSpPr txBox="1"/>
+          <p:nvPr/>
+        </p:nvSpPr>
+        <p:spPr>
+          <a:xfrm>
+            <a:off x="4460139" y="3474720"/>
+            <a:ext cx="1589989" cy="256032"/>
+          </a:xfrm>
+          <a:prstGeom prst="rect">
+            <a:avLst/>
+          </a:prstGeom>
+          <a:noFill/>
+        </p:spPr>
+        <p:txBody>
+          <a:bodyPr wrap="square" anchor="ctr" lIns="36576" rIns="36576" tIns="0" bIns="0">
+            <a:spAutoFit/>
+          </a:bodyPr>
+          <a:lstStyle/>
+          <a:p>
+            <a:pPr algn="ctr" rtl="1"/>
+            <a:r>
+              <a:rPr sz="1000" b="0">
+                <a:solidFill>
+                  <a:srgbClr val="8A94A8"/>
+                </a:solidFill>
+                <a:latin typeface="Heebo"/>
+                <a:cs typeface="Heebo"/>
+              </a:rPr>
+              <a:t>לדיון</a:t>
+            </a:r>
+          </a:p>
+        </p:txBody>
+      </p:sp>
+      <p:sp>
+        <p:nvSpPr>
+          <p:cNvPr id="50" name="TextBox 49"/>
+          <p:cNvSpPr txBox="1"/>
+          <p:nvPr/>
+        </p:nvSpPr>
+        <p:spPr>
+          <a:xfrm>
+            <a:off x="5511699" y="3931920"/>
+            <a:ext cx="2219858" cy="310896"/>
+          </a:xfrm>
+          <a:prstGeom prst="rect">
+            <a:avLst/>
+          </a:prstGeom>
+          <a:noFill/>
+        </p:spPr>
+        <p:txBody>
+          <a:bodyPr wrap="square" anchor="ctr" lIns="36576" rIns="36576" tIns="0" bIns="0">
+            <a:spAutoFit/>
+          </a:bodyPr>
+          <a:lstStyle/>
+          <a:p>
+            <a:pPr algn="r" rtl="1"/>
+            <a:r>
+              <a:rPr sz="1100" b="0">
+                <a:solidFill>
+                  <a:srgbClr val="1A2233"/>
+                </a:solidFill>
+                <a:latin typeface="Heebo"/>
+                <a:cs typeface="Heebo"/>
+              </a:rPr>
+              <a:t>מנכ״ל</a:t>
+            </a:r>
+          </a:p>
+        </p:txBody>
+      </p:sp>
+      <p:sp>
+        <p:nvSpPr>
+          <p:cNvPr id="51" name="TextBox 50"/>
+          <p:cNvSpPr txBox="1"/>
+          <p:nvPr/>
+        </p:nvSpPr>
+        <p:spPr>
+          <a:xfrm>
+            <a:off x="4414419" y="3931920"/>
+            <a:ext cx="1097280" cy="310896"/>
+          </a:xfrm>
+          <a:prstGeom prst="rect">
+            <a:avLst/>
+          </a:prstGeom>
+          <a:noFill/>
+        </p:spPr>
+        <p:txBody>
+          <a:bodyPr wrap="square" anchor="ctr" lIns="36576" rIns="36576" tIns="0" bIns="0">
+            <a:spAutoFit/>
+          </a:bodyPr>
+          <a:lstStyle/>
+          <a:p>
+            <a:pPr algn="l" rtl="1"/>
+            <a:r>
+              <a:rPr sz="1100" b="1">
+                <a:solidFill>
+                  <a:srgbClr val="1C3C7A"/>
+                </a:solidFill>
+                <a:latin typeface="Heebo"/>
+                <a:cs typeface="Heebo"/>
+              </a:rPr>
+              <a:t>12,000 ₪</a:t>
+            </a:r>
+          </a:p>
+        </p:txBody>
+      </p:sp>
+      <p:cxnSp>
+        <p:nvCxnSpPr>
+          <p:cNvPr id="52" name="Connector 51"/>
+          <p:cNvCxnSpPr/>
+          <p:nvPr/>
+        </p:nvCxnSpPr>
+        <p:spPr>
+          <a:xfrm>
+            <a:off x="4460139" y="4270248"/>
+            <a:ext cx="3271418" cy="0"/>
+          </a:xfrm>
+          <a:prstGeom prst="line">
+            <a:avLst/>
+          </a:prstGeom>
+          <a:ln w="9525">
+            <a:solidFill>
+              <a:srgbClr val="C5CDDD"/>
+            </a:solidFill>
+          </a:ln>
+        </p:spPr>
+        <p:style>
+          <a:lnRef idx="2">
+            <a:schemeClr val="accent1"/>
+          </a:lnRef>
+          <a:fillRef idx="0">
+            <a:schemeClr val="accent1"/>
+          </a:fillRef>
+          <a:effectRef idx="1">
+            <a:schemeClr val="accent1"/>
+          </a:effectRef>
+          <a:fontRef idx="minor">
+            <a:schemeClr val="tx1"/>
+          </a:fontRef>
+        </p:style>
+      </p:cxnSp>
+      <p:sp>
+        <p:nvSpPr>
+          <p:cNvPr id="53" name="TextBox 52"/>
+          <p:cNvSpPr txBox="1"/>
+          <p:nvPr/>
+        </p:nvSpPr>
+        <p:spPr>
+          <a:xfrm>
+            <a:off x="5511699" y="4297680"/>
+            <a:ext cx="2219858" cy="310896"/>
+          </a:xfrm>
+          <a:prstGeom prst="rect">
+            <a:avLst/>
+          </a:prstGeom>
+          <a:noFill/>
+        </p:spPr>
+        <p:txBody>
+          <a:bodyPr wrap="square" anchor="ctr" lIns="36576" rIns="36576" tIns="0" bIns="0">
+            <a:spAutoFit/>
+          </a:bodyPr>
+          <a:lstStyle/>
+          <a:p>
+            <a:pPr algn="r" rtl="1"/>
+            <a:r>
+              <a:rPr sz="1100" b="0">
+                <a:solidFill>
+                  <a:srgbClr val="1A2233"/>
+                </a:solidFill>
+                <a:latin typeface="Heebo"/>
+                <a:cs typeface="Heebo"/>
+              </a:rPr>
+              <a:t>עוזר מנכ״ל · חצי משרה</a:t>
+            </a:r>
+          </a:p>
+        </p:txBody>
+      </p:sp>
+      <p:sp>
+        <p:nvSpPr>
+          <p:cNvPr id="54" name="TextBox 53"/>
+          <p:cNvSpPr txBox="1"/>
+          <p:nvPr/>
+        </p:nvSpPr>
+        <p:spPr>
+          <a:xfrm>
+            <a:off x="4414419" y="4297680"/>
+            <a:ext cx="1097280" cy="310896"/>
+          </a:xfrm>
+          <a:prstGeom prst="rect">
+            <a:avLst/>
+          </a:prstGeom>
+          <a:noFill/>
+        </p:spPr>
+        <p:txBody>
+          <a:bodyPr wrap="square" anchor="ctr" lIns="36576" rIns="36576" tIns="0" bIns="0">
+            <a:spAutoFit/>
+          </a:bodyPr>
+          <a:lstStyle/>
+          <a:p>
+            <a:pPr algn="l" rtl="1"/>
+            <a:r>
+              <a:rPr sz="1100" b="1">
+                <a:solidFill>
+                  <a:srgbClr val="1C3C7A"/>
+                </a:solidFill>
+                <a:latin typeface="Heebo"/>
+                <a:cs typeface="Heebo"/>
+              </a:rPr>
+              <a:t>5,000 ₪</a:t>
+            </a:r>
+          </a:p>
+        </p:txBody>
+      </p:sp>
+      <p:cxnSp>
+        <p:nvCxnSpPr>
+          <p:cNvPr id="55" name="Connector 54"/>
+          <p:cNvCxnSpPr/>
+          <p:nvPr/>
+        </p:nvCxnSpPr>
+        <p:spPr>
+          <a:xfrm>
+            <a:off x="4460139" y="4636008"/>
+            <a:ext cx="3271418" cy="0"/>
+          </a:xfrm>
+          <a:prstGeom prst="line">
+            <a:avLst/>
+          </a:prstGeom>
+          <a:ln w="9525">
+            <a:solidFill>
+              <a:srgbClr val="C5CDDD"/>
+            </a:solidFill>
+          </a:ln>
+        </p:spPr>
+        <p:style>
+          <a:lnRef idx="2">
+            <a:schemeClr val="accent1"/>
+          </a:lnRef>
+          <a:fillRef idx="0">
+            <a:schemeClr val="accent1"/>
+          </a:fillRef>
+          <a:effectRef idx="1">
+            <a:schemeClr val="accent1"/>
+          </a:effectRef>
+          <a:fontRef idx="minor">
+            <a:schemeClr val="tx1"/>
+          </a:fontRef>
+        </p:style>
+      </p:cxnSp>
+      <p:sp>
+        <p:nvSpPr>
+          <p:cNvPr id="56" name="TextBox 55"/>
+          <p:cNvSpPr txBox="1"/>
+          <p:nvPr/>
+        </p:nvSpPr>
+        <p:spPr>
+          <a:xfrm>
+            <a:off x="5511699" y="4663440"/>
+            <a:ext cx="2219858" cy="310896"/>
+          </a:xfrm>
+          <a:prstGeom prst="rect">
+            <a:avLst/>
+          </a:prstGeom>
+          <a:noFill/>
+        </p:spPr>
+        <p:txBody>
+          <a:bodyPr wrap="square" anchor="ctr" lIns="36576" rIns="36576" tIns="0" bIns="0">
+            <a:spAutoFit/>
+          </a:bodyPr>
+          <a:lstStyle/>
+          <a:p>
+            <a:pPr algn="r" rtl="1"/>
+            <a:r>
+              <a:rPr sz="1100" b="0">
+                <a:solidFill>
+                  <a:srgbClr val="1A2233"/>
+                </a:solidFill>
+                <a:latin typeface="Heebo"/>
+                <a:cs typeface="Heebo"/>
+              </a:rPr>
+              <a:t>מנהל תוכן · חצי משרה</a:t>
+            </a:r>
+          </a:p>
+        </p:txBody>
+      </p:sp>
+      <p:sp>
+        <p:nvSpPr>
+          <p:cNvPr id="57" name="TextBox 56"/>
+          <p:cNvSpPr txBox="1"/>
+          <p:nvPr/>
+        </p:nvSpPr>
+        <p:spPr>
+          <a:xfrm>
+            <a:off x="4414419" y="4663440"/>
+            <a:ext cx="1097280" cy="310896"/>
+          </a:xfrm>
+          <a:prstGeom prst="rect">
+            <a:avLst/>
+          </a:prstGeom>
+          <a:noFill/>
+        </p:spPr>
+        <p:txBody>
+          <a:bodyPr wrap="square" anchor="ctr" lIns="36576" rIns="36576" tIns="0" bIns="0">
+            <a:spAutoFit/>
+          </a:bodyPr>
+          <a:lstStyle/>
+          <a:p>
+            <a:pPr algn="l" rtl="1"/>
+            <a:r>
+              <a:rPr sz="1100" b="1">
+                <a:solidFill>
+                  <a:srgbClr val="1C3C7A"/>
+                </a:solidFill>
+                <a:latin typeface="Heebo"/>
+                <a:cs typeface="Heebo"/>
+              </a:rPr>
+              <a:t>5,000 ₪</a:t>
+            </a:r>
+          </a:p>
+        </p:txBody>
+      </p:sp>
+      <p:cxnSp>
+        <p:nvCxnSpPr>
+          <p:cNvPr id="58" name="Connector 57"/>
+          <p:cNvCxnSpPr/>
+          <p:nvPr/>
+        </p:nvCxnSpPr>
+        <p:spPr>
+          <a:xfrm>
+            <a:off x="4460139" y="5001768"/>
+            <a:ext cx="3271418" cy="0"/>
+          </a:xfrm>
+          <a:prstGeom prst="line">
+            <a:avLst/>
+          </a:prstGeom>
+          <a:ln w="9525">
+            <a:solidFill>
+              <a:srgbClr val="C5CDDD"/>
+            </a:solidFill>
+          </a:ln>
+        </p:spPr>
+        <p:style>
+          <a:lnRef idx="2">
+            <a:schemeClr val="accent1"/>
+          </a:lnRef>
+          <a:fillRef idx="0">
+            <a:schemeClr val="accent1"/>
+          </a:fillRef>
+          <a:effectRef idx="1">
+            <a:schemeClr val="accent1"/>
+          </a:effectRef>
+          <a:fontRef idx="minor">
+            <a:schemeClr val="tx1"/>
+          </a:fontRef>
+        </p:style>
+      </p:cxnSp>
+      <p:sp>
+        <p:nvSpPr>
+          <p:cNvPr id="59" name="TextBox 58"/>
+          <p:cNvSpPr txBox="1"/>
+          <p:nvPr/>
+        </p:nvSpPr>
+        <p:spPr>
+          <a:xfrm>
+            <a:off x="5511699" y="5029200"/>
+            <a:ext cx="2219858" cy="310896"/>
+          </a:xfrm>
+          <a:prstGeom prst="rect">
+            <a:avLst/>
+          </a:prstGeom>
+          <a:noFill/>
+        </p:spPr>
+        <p:txBody>
+          <a:bodyPr wrap="square" anchor="ctr" lIns="36576" rIns="36576" tIns="0" bIns="0">
+            <a:spAutoFit/>
+          </a:bodyPr>
+          <a:lstStyle/>
+          <a:p>
+            <a:pPr algn="r" rtl="1"/>
+            <a:r>
+              <a:rPr sz="1100" b="0">
+                <a:solidFill>
+                  <a:srgbClr val="1A2233"/>
+                </a:solidFill>
+                <a:latin typeface="Heebo"/>
+                <a:cs typeface="Heebo"/>
+              </a:rPr>
+              <a:t>חברי דירקטוריון · 3 דיונים</a:t>
+            </a:r>
+          </a:p>
+        </p:txBody>
+      </p:sp>
+      <p:sp>
+        <p:nvSpPr>
+          <p:cNvPr id="60" name="TextBox 59"/>
+          <p:cNvSpPr txBox="1"/>
+          <p:nvPr/>
+        </p:nvSpPr>
+        <p:spPr>
+          <a:xfrm>
+            <a:off x="4414419" y="5029200"/>
+            <a:ext cx="1097280" cy="310896"/>
+          </a:xfrm>
+          <a:prstGeom prst="rect">
+            <a:avLst/>
+          </a:prstGeom>
+          <a:noFill/>
+        </p:spPr>
+        <p:txBody>
+          <a:bodyPr wrap="square" anchor="ctr" lIns="36576" rIns="36576" tIns="0" bIns="0">
+            <a:spAutoFit/>
+          </a:bodyPr>
+          <a:lstStyle/>
+          <a:p>
+            <a:pPr algn="l" rtl="1"/>
+            <a:r>
+              <a:rPr sz="1100" b="1">
+                <a:solidFill>
+                  <a:srgbClr val="1C3C7A"/>
+                </a:solidFill>
+                <a:latin typeface="Heebo"/>
+                <a:cs typeface="Heebo"/>
+              </a:rPr>
+              <a:t>1,050 ₪</a:t>
+            </a:r>
+          </a:p>
+        </p:txBody>
+      </p:sp>
+      <p:cxnSp>
+        <p:nvCxnSpPr>
+          <p:cNvPr id="61" name="Connector 60"/>
+          <p:cNvCxnSpPr/>
+          <p:nvPr/>
+        </p:nvCxnSpPr>
+        <p:spPr>
+          <a:xfrm>
+            <a:off x="4460139" y="5367528"/>
+            <a:ext cx="3271418" cy="0"/>
+          </a:xfrm>
+          <a:prstGeom prst="line">
+            <a:avLst/>
+          </a:prstGeom>
+          <a:ln w="9525">
+            <a:solidFill>
+              <a:srgbClr val="C5CDDD"/>
+            </a:solidFill>
+          </a:ln>
+        </p:spPr>
+        <p:style>
+          <a:lnRef idx="2">
+            <a:schemeClr val="accent1"/>
+          </a:lnRef>
+          <a:fillRef idx="0">
+            <a:schemeClr val="accent1"/>
+          </a:fillRef>
+          <a:effectRef idx="1">
+            <a:schemeClr val="accent1"/>
+          </a:effectRef>
+          <a:fontRef idx="minor">
+            <a:schemeClr val="tx1"/>
+          </a:fontRef>
+        </p:style>
+      </p:cxnSp>
+      <p:sp>
+        <p:nvSpPr>
+          <p:cNvPr id="62" name="TextBox 61"/>
+          <p:cNvSpPr txBox="1"/>
+          <p:nvPr/>
+        </p:nvSpPr>
+        <p:spPr>
+          <a:xfrm>
+            <a:off x="5511699" y="5394960"/>
+            <a:ext cx="2219858" cy="310896"/>
+          </a:xfrm>
+          <a:prstGeom prst="rect">
+            <a:avLst/>
+          </a:prstGeom>
+          <a:noFill/>
+        </p:spPr>
+        <p:txBody>
+          <a:bodyPr wrap="square" anchor="ctr" lIns="36576" rIns="36576" tIns="0" bIns="0">
+            <a:spAutoFit/>
+          </a:bodyPr>
+          <a:lstStyle/>
+          <a:p>
+            <a:pPr algn="r" rtl="1"/>
+            <a:r>
+              <a:rPr sz="1100" b="0">
+                <a:solidFill>
+                  <a:srgbClr val="1A2233"/>
+                </a:solidFill>
+                <a:latin typeface="Heebo"/>
+                <a:cs typeface="Heebo"/>
+              </a:rPr>
+              <a:t>אקטיביסטים · 3 דיונים</a:t>
+            </a:r>
+          </a:p>
+        </p:txBody>
+      </p:sp>
+      <p:sp>
+        <p:nvSpPr>
+          <p:cNvPr id="63" name="TextBox 62"/>
+          <p:cNvSpPr txBox="1"/>
+          <p:nvPr/>
+        </p:nvSpPr>
+        <p:spPr>
+          <a:xfrm>
+            <a:off x="4414419" y="5394960"/>
+            <a:ext cx="1097280" cy="310896"/>
+          </a:xfrm>
+          <a:prstGeom prst="rect">
+            <a:avLst/>
+          </a:prstGeom>
+          <a:noFill/>
+        </p:spPr>
+        <p:txBody>
+          <a:bodyPr wrap="square" anchor="ctr" lIns="36576" rIns="36576" tIns="0" bIns="0">
+            <a:spAutoFit/>
+          </a:bodyPr>
+          <a:lstStyle/>
+          <a:p>
+            <a:pPr algn="l" rtl="1"/>
+            <a:r>
+              <a:rPr sz="1100" b="0">
+                <a:solidFill>
+                  <a:srgbClr val="8A94A8"/>
+                </a:solidFill>
+                <a:latin typeface="Heebo"/>
+                <a:cs typeface="Heebo"/>
+              </a:rPr>
+              <a:t>בהתנדבות</a:t>
+            </a:r>
+          </a:p>
+        </p:txBody>
+      </p:sp>
+      <p:cxnSp>
+        <p:nvCxnSpPr>
+          <p:cNvPr id="64" name="Connector 63"/>
+          <p:cNvCxnSpPr/>
+          <p:nvPr/>
+        </p:nvCxnSpPr>
+        <p:spPr>
+          <a:xfrm>
+            <a:off x="4460139" y="5733288"/>
+            <a:ext cx="3271418" cy="0"/>
+          </a:xfrm>
+          <a:prstGeom prst="line">
+            <a:avLst/>
+          </a:prstGeom>
+          <a:ln w="9525">
+            <a:solidFill>
+              <a:srgbClr val="C5CDDD"/>
+            </a:solidFill>
+          </a:ln>
+        </p:spPr>
+        <p:style>
+          <a:lnRef idx="2">
+            <a:schemeClr val="accent1"/>
+          </a:lnRef>
+          <a:fillRef idx="0">
+            <a:schemeClr val="accent1"/>
+          </a:fillRef>
+          <a:effectRef idx="1">
+            <a:schemeClr val="accent1"/>
+          </a:effectRef>
+          <a:fontRef idx="minor">
+            <a:schemeClr val="tx1"/>
+          </a:fontRef>
+        </p:style>
+      </p:cxnSp>
+      <p:sp>
+        <p:nvSpPr>
+          <p:cNvPr id="65" name="TextBox 64"/>
+          <p:cNvSpPr txBox="1"/>
+          <p:nvPr/>
+        </p:nvSpPr>
+        <p:spPr>
+          <a:xfrm>
+            <a:off x="4460139" y="5806440"/>
+            <a:ext cx="3271418" cy="256032"/>
+          </a:xfrm>
+          <a:prstGeom prst="rect">
+            <a:avLst/>
+          </a:prstGeom>
+          <a:noFill/>
+        </p:spPr>
+        <p:txBody>
+          <a:bodyPr wrap="square" anchor="ctr" lIns="36576" rIns="36576" tIns="0" bIns="0">
+            <a:spAutoFit/>
+          </a:bodyPr>
+          <a:lstStyle/>
+          <a:p>
+            <a:pPr algn="r" rtl="1"/>
+            <a:r>
+              <a:rPr sz="1000" b="0">
+                <a:solidFill>
+                  <a:srgbClr val="8A94A8"/>
+                </a:solidFill>
+                <a:latin typeface="Heebo"/>
+                <a:cs typeface="Heebo"/>
+              </a:rPr>
+              <a:t>תעריף: 300 ₪ חצי יום · 450 ₪ יום מלא</a:t>
+            </a:r>
+          </a:p>
+        </p:txBody>
+      </p:sp>
+      <p:sp>
+        <p:nvSpPr>
+          <p:cNvPr id="66" name="TextBox 65"/>
+          <p:cNvSpPr txBox="1"/>
+          <p:nvPr/>
+        </p:nvSpPr>
+        <p:spPr>
+          <a:xfrm>
+            <a:off x="4460139" y="6080760"/>
+            <a:ext cx="3271418" cy="274320"/>
+          </a:xfrm>
+          <a:prstGeom prst="rect">
+            <a:avLst/>
+          </a:prstGeom>
+          <a:noFill/>
+        </p:spPr>
+        <p:txBody>
+          <a:bodyPr wrap="square" anchor="ctr" lIns="36576" rIns="36576" tIns="0" bIns="0">
+            <a:spAutoFit/>
+          </a:bodyPr>
+          <a:lstStyle/>
+          <a:p>
+            <a:pPr algn="r" rtl="1"/>
+            <a:r>
+              <a:rPr sz="1100" b="1">
+                <a:solidFill>
+                  <a:srgbClr val="1C3C7A"/>
+                </a:solidFill>
+                <a:latin typeface="Heebo"/>
+                <a:cs typeface="Heebo"/>
+              </a:rPr>
+              <a:t>מימון: כ-5 שותפים מייסדים</a:t>
+            </a:r>
+          </a:p>
+        </p:txBody>
+      </p:sp>
+      <p:sp>
+        <p:nvSpPr>
+          <p:cNvPr id="67" name="Rounded Rectangle 66"/>
+          <p:cNvSpPr/>
+          <p:nvPr/>
+        </p:nvSpPr>
+        <p:spPr>
+          <a:xfrm>
+            <a:off x="411481" y="1188720"/>
+            <a:ext cx="3637178" cy="5120640"/>
+          </a:xfrm>
+          <a:prstGeom prst="roundRect">
+            <a:avLst>
+              <a:gd name="adj" fmla="val 5000"/>
+            </a:avLst>
+          </a:prstGeom>
+          <a:solidFill>
+            <a:srgbClr val="FFFFFF"/>
+          </a:solidFill>
+          <a:ln w="15875">
+            <a:solidFill>
+              <a:srgbClr val="C5CDDD"/>
+            </a:solidFill>
+          </a:ln>
+          <a:effectLst/>
+        </p:spPr>
+        <p:style>
+          <a:lnRef idx="1">
+            <a:schemeClr val="accent1"/>
+          </a:lnRef>
+          <a:fillRef idx="3">
+            <a:schemeClr val="accent1"/>
+          </a:fillRef>
+          <a:effectRef idx="2">
+            <a:schemeClr val="accent1"/>
+          </a:effectRef>
+          <a:fontRef idx="minor">
+            <a:schemeClr val="lt1"/>
+          </a:fontRef>
+        </p:style>
+        <p:txBody>
+          <a:bodyPr rtlCol="0" anchor="ctr"/>
+          <a:lstStyle/>
+          <a:p>
+            <a:pPr algn="ctr"/>
+          </a:p>
+        </p:txBody>
+      </p:sp>
+      <p:sp>
+        <p:nvSpPr>
+          <p:cNvPr id="68" name="Rounded Rectangle 67"/>
+          <p:cNvSpPr/>
+          <p:nvPr/>
+        </p:nvSpPr>
+        <p:spPr>
+          <a:xfrm>
+            <a:off x="411481" y="1188720"/>
+            <a:ext cx="3637178" cy="868680"/>
+          </a:xfrm>
+          <a:prstGeom prst="roundRect">
+            <a:avLst>
+              <a:gd name="adj" fmla="val 12000"/>
+            </a:avLst>
+          </a:prstGeom>
+          <a:solidFill>
+            <a:srgbClr val="4A5568"/>
+          </a:solidFill>
+          <a:ln>
+            <a:noFill/>
+          </a:ln>
+          <a:effectLst/>
+        </p:spPr>
+        <p:style>
+          <a:lnRef idx="1">
+            <a:schemeClr val="accent1"/>
+          </a:lnRef>
+          <a:fillRef idx="3">
+            <a:schemeClr val="accent1"/>
+          </a:fillRef>
+          <a:effectRef idx="2">
+            <a:schemeClr val="accent1"/>
+          </a:effectRef>
+          <a:fontRef idx="minor">
+            <a:schemeClr val="lt1"/>
+          </a:fontRef>
+        </p:style>
+        <p:txBody>
+          <a:bodyPr rtlCol="0" anchor="ctr"/>
+          <a:lstStyle/>
+          <a:p>
+            <a:pPr algn="ctr"/>
+          </a:p>
+        </p:txBody>
+      </p:sp>
+      <p:sp>
+        <p:nvSpPr>
+          <p:cNvPr id="69" name="TextBox 68"/>
+          <p:cNvSpPr txBox="1"/>
+          <p:nvPr/>
+        </p:nvSpPr>
+        <p:spPr>
+          <a:xfrm>
+            <a:off x="411481" y="1280160"/>
+            <a:ext cx="3637178" cy="384048"/>
+          </a:xfrm>
+          <a:prstGeom prst="rect">
+            <a:avLst/>
+          </a:prstGeom>
+          <a:noFill/>
+        </p:spPr>
+        <p:txBody>
+          <a:bodyPr wrap="square" anchor="ctr" lIns="36576" rIns="36576" tIns="0" bIns="0">
+            <a:spAutoFit/>
+          </a:bodyPr>
+          <a:lstStyle/>
+          <a:p>
+            <a:pPr algn="ctr" rtl="1"/>
+            <a:r>
+              <a:rPr sz="2000" b="1">
+                <a:solidFill>
+                  <a:srgbClr val="FFFFFF"/>
+                </a:solidFill>
+                <a:latin typeface="Heebo"/>
+                <a:cs typeface="Heebo"/>
+              </a:rPr>
+              <a:t>מודל רזה</a:t>
+            </a:r>
+          </a:p>
+        </p:txBody>
+      </p:sp>
+      <p:sp>
+        <p:nvSpPr>
+          <p:cNvPr id="70" name="TextBox 69"/>
+          <p:cNvSpPr txBox="1"/>
+          <p:nvPr/>
+        </p:nvSpPr>
+        <p:spPr>
+          <a:xfrm>
+            <a:off x="502921" y="1664208"/>
+            <a:ext cx="3454298" cy="329184"/>
+          </a:xfrm>
+          <a:prstGeom prst="rect">
+            <a:avLst/>
+          </a:prstGeom>
+          <a:noFill/>
+        </p:spPr>
+        <p:txBody>
+          <a:bodyPr wrap="square" anchor="ctr" lIns="36576" rIns="36576" tIns="0" bIns="0">
+            <a:spAutoFit/>
+          </a:bodyPr>
+          <a:lstStyle/>
+          <a:p>
+            <a:pPr algn="ctr" rtl="1"/>
+            <a:r>
+              <a:rPr sz="1000" b="0">
+                <a:solidFill>
+                  <a:srgbClr val="F0C000"/>
+                </a:solidFill>
+                <a:latin typeface="Heebo"/>
+                <a:cs typeface="Heebo"/>
+              </a:rPr>
+              <a:t>מינימום דיונים · איש תוכן משותף עם 'על המשמעות'</a:t>
+            </a:r>
+          </a:p>
+        </p:txBody>
+      </p:sp>
+      <p:sp>
+        <p:nvSpPr>
+          <p:cNvPr id="71" name="TextBox 70"/>
+          <p:cNvSpPr txBox="1"/>
+          <p:nvPr/>
+        </p:nvSpPr>
+        <p:spPr>
+          <a:xfrm>
+            <a:off x="411481" y="2148840"/>
+            <a:ext cx="3637178" cy="640080"/>
+          </a:xfrm>
+          <a:prstGeom prst="rect">
+            <a:avLst/>
+          </a:prstGeom>
+          <a:noFill/>
+        </p:spPr>
+        <p:txBody>
+          <a:bodyPr wrap="square" anchor="ctr" lIns="36576" rIns="36576" tIns="0" bIns="0">
+            <a:spAutoFit/>
+          </a:bodyPr>
+          <a:lstStyle/>
+          <a:p>
+            <a:pPr algn="ctr" rtl="1"/>
+            <a:r>
+              <a:rPr sz="3600" b="1">
+                <a:solidFill>
+                  <a:srgbClr val="1C3C7A"/>
+                </a:solidFill>
+                <a:latin typeface="Heebo"/>
+                <a:cs typeface="Heebo"/>
+              </a:rPr>
+              <a:t>20,250 ₪</a:t>
+            </a:r>
+          </a:p>
+        </p:txBody>
+      </p:sp>
+      <p:sp>
+        <p:nvSpPr>
+          <p:cNvPr id="72" name="TextBox 71"/>
+          <p:cNvSpPr txBox="1"/>
+          <p:nvPr/>
+        </p:nvSpPr>
+        <p:spPr>
+          <a:xfrm>
+            <a:off x="411481" y="2743200"/>
+            <a:ext cx="3637178" cy="274320"/>
+          </a:xfrm>
+          <a:prstGeom prst="rect">
+            <a:avLst/>
+          </a:prstGeom>
+          <a:noFill/>
+        </p:spPr>
+        <p:txBody>
+          <a:bodyPr wrap="square" anchor="ctr" lIns="36576" rIns="36576" tIns="0" bIns="0">
+            <a:spAutoFit/>
+          </a:bodyPr>
+          <a:lstStyle/>
+          <a:p>
+            <a:pPr algn="ctr" rtl="1"/>
+            <a:r>
+              <a:rPr sz="1200" b="0">
+                <a:solidFill>
+                  <a:srgbClr val="8A94A8"/>
+                </a:solidFill>
+                <a:latin typeface="Heebo"/>
+                <a:cs typeface="Heebo"/>
+              </a:rPr>
+              <a:t>לחודש · 243,000 ₪ בשנה</a:t>
+            </a:r>
+          </a:p>
+        </p:txBody>
+      </p:sp>
+      <p:sp>
+        <p:nvSpPr>
+          <p:cNvPr id="73" name="Rounded Rectangle 72"/>
+          <p:cNvSpPr/>
+          <p:nvPr/>
+        </p:nvSpPr>
+        <p:spPr>
+          <a:xfrm>
+            <a:off x="2275790" y="3108960"/>
+            <a:ext cx="1589989" cy="658368"/>
+          </a:xfrm>
+          <a:prstGeom prst="roundRect">
+            <a:avLst>
+              <a:gd name="adj" fmla="val 15000"/>
+            </a:avLst>
+          </a:prstGeom>
+          <a:solidFill>
+            <a:srgbClr val="F4F6FB"/>
+          </a:solidFill>
+          <a:ln>
+            <a:noFill/>
+          </a:ln>
+          <a:effectLst/>
+        </p:spPr>
+        <p:style>
+          <a:lnRef idx="1">
+            <a:schemeClr val="accent1"/>
+          </a:lnRef>
+          <a:fillRef idx="3">
+            <a:schemeClr val="accent1"/>
+          </a:fillRef>
+          <a:effectRef idx="2">
+            <a:schemeClr val="accent1"/>
+          </a:effectRef>
+          <a:fontRef idx="minor">
+            <a:schemeClr val="lt1"/>
+          </a:fontRef>
+        </p:style>
+        <p:txBody>
+          <a:bodyPr rtlCol="0" anchor="ctr"/>
+          <a:lstStyle/>
+          <a:p>
+            <a:pPr algn="ctr"/>
+          </a:p>
+        </p:txBody>
+      </p:sp>
+      <p:sp>
+        <p:nvSpPr>
+          <p:cNvPr id="74" name="TextBox 73"/>
+          <p:cNvSpPr txBox="1"/>
+          <p:nvPr/>
+        </p:nvSpPr>
+        <p:spPr>
+          <a:xfrm>
+            <a:off x="2275790" y="3136392"/>
+            <a:ext cx="1589989" cy="347472"/>
+          </a:xfrm>
+          <a:prstGeom prst="rect">
+            <a:avLst/>
+          </a:prstGeom>
+          <a:noFill/>
+        </p:spPr>
+        <p:txBody>
+          <a:bodyPr wrap="square" anchor="ctr" lIns="36576" rIns="36576" tIns="0" bIns="0">
+            <a:spAutoFit/>
+          </a:bodyPr>
+          <a:lstStyle/>
+          <a:p>
+            <a:pPr algn="ctr" rtl="1"/>
+            <a:r>
+              <a:rPr sz="1700" b="1">
+                <a:solidFill>
+                  <a:srgbClr val="1C3C7A"/>
+                </a:solidFill>
+                <a:latin typeface="Heebo"/>
+                <a:cs typeface="Heebo"/>
+              </a:rPr>
+              <a:t>13</a:t>
+            </a:r>
+          </a:p>
+        </p:txBody>
+      </p:sp>
+      <p:sp>
+        <p:nvSpPr>
+          <p:cNvPr id="75" name="TextBox 74"/>
+          <p:cNvSpPr txBox="1"/>
+          <p:nvPr/>
+        </p:nvSpPr>
+        <p:spPr>
+          <a:xfrm>
+            <a:off x="2275790" y="3474720"/>
+            <a:ext cx="1589989" cy="256032"/>
+          </a:xfrm>
+          <a:prstGeom prst="rect">
+            <a:avLst/>
+          </a:prstGeom>
+          <a:noFill/>
+        </p:spPr>
+        <p:txBody>
+          <a:bodyPr wrap="square" anchor="ctr" lIns="36576" rIns="36576" tIns="0" bIns="0">
+            <a:spAutoFit/>
+          </a:bodyPr>
+          <a:lstStyle/>
+          <a:p>
+            <a:pPr algn="ctr" rtl="1"/>
+            <a:r>
+              <a:rPr sz="1000" b="0">
+                <a:solidFill>
+                  <a:srgbClr val="8A94A8"/>
+                </a:solidFill>
+                <a:latin typeface="Heebo"/>
+                <a:cs typeface="Heebo"/>
+              </a:rPr>
+              <a:t>דיונים בחודש</a:t>
+            </a:r>
+          </a:p>
+        </p:txBody>
+      </p:sp>
+      <p:sp>
+        <p:nvSpPr>
+          <p:cNvPr id="76" name="Rounded Rectangle 75"/>
+          <p:cNvSpPr/>
+          <p:nvPr/>
+        </p:nvSpPr>
+        <p:spPr>
+          <a:xfrm>
+            <a:off x="594361" y="3108960"/>
+            <a:ext cx="1589989" cy="658368"/>
+          </a:xfrm>
+          <a:prstGeom prst="roundRect">
+            <a:avLst>
+              <a:gd name="adj" fmla="val 15000"/>
+            </a:avLst>
+          </a:prstGeom>
+          <a:solidFill>
+            <a:srgbClr val="F4F6FB"/>
+          </a:solidFill>
+          <a:ln>
+            <a:noFill/>
+          </a:ln>
+          <a:effectLst/>
+        </p:spPr>
+        <p:style>
+          <a:lnRef idx="1">
+            <a:schemeClr val="accent1"/>
+          </a:lnRef>
+          <a:fillRef idx="3">
+            <a:schemeClr val="accent1"/>
+          </a:fillRef>
+          <a:effectRef idx="2">
+            <a:schemeClr val="accent1"/>
+          </a:effectRef>
+          <a:fontRef idx="minor">
+            <a:schemeClr val="lt1"/>
+          </a:fontRef>
+        </p:style>
+        <p:txBody>
+          <a:bodyPr rtlCol="0" anchor="ctr"/>
+          <a:lstStyle/>
+          <a:p>
+            <a:pPr algn="ctr"/>
+          </a:p>
+        </p:txBody>
+      </p:sp>
+      <p:sp>
+        <p:nvSpPr>
+          <p:cNvPr id="77" name="TextBox 76"/>
+          <p:cNvSpPr txBox="1"/>
+          <p:nvPr/>
+        </p:nvSpPr>
+        <p:spPr>
+          <a:xfrm>
+            <a:off x="594361" y="3136392"/>
+            <a:ext cx="1589989" cy="347472"/>
+          </a:xfrm>
+          <a:prstGeom prst="rect">
+            <a:avLst/>
+          </a:prstGeom>
+          <a:noFill/>
+        </p:spPr>
+        <p:txBody>
+          <a:bodyPr wrap="square" anchor="ctr" lIns="36576" rIns="36576" tIns="0" bIns="0">
+            <a:spAutoFit/>
+          </a:bodyPr>
+          <a:lstStyle/>
+          <a:p>
+            <a:pPr algn="ctr" rtl="1"/>
+            <a:r>
+              <a:rPr sz="1700" b="1">
+                <a:solidFill>
+                  <a:srgbClr val="1C3C7A"/>
+                </a:solidFill>
+                <a:latin typeface="Heebo"/>
+                <a:cs typeface="Heebo"/>
+              </a:rPr>
+              <a:t>1,560 ₪</a:t>
+            </a:r>
+          </a:p>
+        </p:txBody>
+      </p:sp>
+      <p:sp>
+        <p:nvSpPr>
+          <p:cNvPr id="78" name="TextBox 77"/>
+          <p:cNvSpPr txBox="1"/>
+          <p:nvPr/>
+        </p:nvSpPr>
+        <p:spPr>
+          <a:xfrm>
+            <a:off x="594361" y="3474720"/>
+            <a:ext cx="1589989" cy="256032"/>
+          </a:xfrm>
+          <a:prstGeom prst="rect">
+            <a:avLst/>
+          </a:prstGeom>
+          <a:noFill/>
+        </p:spPr>
+        <p:txBody>
+          <a:bodyPr wrap="square" anchor="ctr" lIns="36576" rIns="36576" tIns="0" bIns="0">
+            <a:spAutoFit/>
+          </a:bodyPr>
+          <a:lstStyle/>
+          <a:p>
+            <a:pPr algn="ctr" rtl="1"/>
+            <a:r>
+              <a:rPr sz="1000" b="0">
+                <a:solidFill>
+                  <a:srgbClr val="8A94A8"/>
+                </a:solidFill>
+                <a:latin typeface="Heebo"/>
+                <a:cs typeface="Heebo"/>
+              </a:rPr>
+              <a:t>לדיון</a:t>
+            </a:r>
+          </a:p>
+        </p:txBody>
+      </p:sp>
+      <p:sp>
+        <p:nvSpPr>
+          <p:cNvPr id="79" name="TextBox 78"/>
+          <p:cNvSpPr txBox="1"/>
+          <p:nvPr/>
+        </p:nvSpPr>
+        <p:spPr>
+          <a:xfrm>
+            <a:off x="1645921" y="3931920"/>
+            <a:ext cx="2219858" cy="310896"/>
+          </a:xfrm>
+          <a:prstGeom prst="rect">
+            <a:avLst/>
+          </a:prstGeom>
+          <a:noFill/>
+        </p:spPr>
+        <p:txBody>
+          <a:bodyPr wrap="square" anchor="ctr" lIns="36576" rIns="36576" tIns="0" bIns="0">
+            <a:spAutoFit/>
+          </a:bodyPr>
+          <a:lstStyle/>
+          <a:p>
+            <a:pPr algn="r" rtl="1"/>
+            <a:r>
+              <a:rPr sz="1100" b="0">
+                <a:solidFill>
+                  <a:srgbClr val="1A2233"/>
+                </a:solidFill>
+                <a:latin typeface="Heebo"/>
+                <a:cs typeface="Heebo"/>
+              </a:rPr>
+              <a:t>מנכ״ל</a:t>
+            </a:r>
+          </a:p>
+        </p:txBody>
+      </p:sp>
+      <p:sp>
+        <p:nvSpPr>
+          <p:cNvPr id="80" name="TextBox 79"/>
+          <p:cNvSpPr txBox="1"/>
+          <p:nvPr/>
+        </p:nvSpPr>
+        <p:spPr>
+          <a:xfrm>
+            <a:off x="548641" y="3931920"/>
+            <a:ext cx="1097280" cy="310896"/>
+          </a:xfrm>
+          <a:prstGeom prst="rect">
+            <a:avLst/>
+          </a:prstGeom>
+          <a:noFill/>
+        </p:spPr>
+        <p:txBody>
+          <a:bodyPr wrap="square" anchor="ctr" lIns="36576" rIns="36576" tIns="0" bIns="0">
+            <a:spAutoFit/>
+          </a:bodyPr>
+          <a:lstStyle/>
+          <a:p>
+            <a:pPr algn="l" rtl="1"/>
+            <a:r>
+              <a:rPr sz="1100" b="1">
+                <a:solidFill>
+                  <a:srgbClr val="1C3C7A"/>
+                </a:solidFill>
+                <a:latin typeface="Heebo"/>
+                <a:cs typeface="Heebo"/>
+              </a:rPr>
+              <a:t>12,000 ₪</a:t>
+            </a:r>
+          </a:p>
+        </p:txBody>
+      </p:sp>
+      <p:cxnSp>
+        <p:nvCxnSpPr>
+          <p:cNvPr id="81" name="Connector 80"/>
+          <p:cNvCxnSpPr/>
+          <p:nvPr/>
+        </p:nvCxnSpPr>
+        <p:spPr>
+          <a:xfrm>
+            <a:off x="594361" y="4270248"/>
+            <a:ext cx="3271418" cy="0"/>
+          </a:xfrm>
+          <a:prstGeom prst="line">
+            <a:avLst/>
+          </a:prstGeom>
+          <a:ln w="9525">
+            <a:solidFill>
+              <a:srgbClr val="C5CDDD"/>
+            </a:solidFill>
+          </a:ln>
+        </p:spPr>
+        <p:style>
+          <a:lnRef idx="2">
+            <a:schemeClr val="accent1"/>
+          </a:lnRef>
+          <a:fillRef idx="0">
+            <a:schemeClr val="accent1"/>
+          </a:fillRef>
+          <a:effectRef idx="1">
+            <a:schemeClr val="accent1"/>
+          </a:effectRef>
+          <a:fontRef idx="minor">
+            <a:schemeClr val="tx1"/>
+          </a:fontRef>
+        </p:style>
+      </p:cxnSp>
+      <p:sp>
+        <p:nvSpPr>
+          <p:cNvPr id="82" name="TextBox 81"/>
+          <p:cNvSpPr txBox="1"/>
+          <p:nvPr/>
+        </p:nvSpPr>
+        <p:spPr>
+          <a:xfrm>
+            <a:off x="1645921" y="4297680"/>
+            <a:ext cx="2219858" cy="310896"/>
+          </a:xfrm>
+          <a:prstGeom prst="rect">
+            <a:avLst/>
+          </a:prstGeom>
+          <a:noFill/>
+        </p:spPr>
+        <p:txBody>
+          <a:bodyPr wrap="square" anchor="ctr" lIns="36576" rIns="36576" tIns="0" bIns="0">
+            <a:spAutoFit/>
+          </a:bodyPr>
+          <a:lstStyle/>
+          <a:p>
+            <a:pPr algn="r" rtl="1"/>
+            <a:r>
+              <a:rPr sz="1100" b="0">
+                <a:solidFill>
+                  <a:srgbClr val="1A2233"/>
+                </a:solidFill>
+                <a:latin typeface="Heebo"/>
+                <a:cs typeface="Heebo"/>
+              </a:rPr>
+              <a:t>עוזר מנכ״ל · חצי משרה</a:t>
+            </a:r>
+          </a:p>
+        </p:txBody>
+      </p:sp>
+      <p:sp>
+        <p:nvSpPr>
+          <p:cNvPr id="83" name="TextBox 82"/>
+          <p:cNvSpPr txBox="1"/>
+          <p:nvPr/>
+        </p:nvSpPr>
+        <p:spPr>
+          <a:xfrm>
+            <a:off x="548641" y="4297680"/>
+            <a:ext cx="1097280" cy="310896"/>
+          </a:xfrm>
+          <a:prstGeom prst="rect">
+            <a:avLst/>
+          </a:prstGeom>
+          <a:noFill/>
+        </p:spPr>
+        <p:txBody>
+          <a:bodyPr wrap="square" anchor="ctr" lIns="36576" rIns="36576" tIns="0" bIns="0">
+            <a:spAutoFit/>
+          </a:bodyPr>
+          <a:lstStyle/>
+          <a:p>
+            <a:pPr algn="l" rtl="1"/>
+            <a:r>
+              <a:rPr sz="1100" b="1">
+                <a:solidFill>
+                  <a:srgbClr val="1C3C7A"/>
+                </a:solidFill>
+                <a:latin typeface="Heebo"/>
+                <a:cs typeface="Heebo"/>
+              </a:rPr>
+              <a:t>5,000 ₪</a:t>
+            </a:r>
+          </a:p>
+        </p:txBody>
+      </p:sp>
+      <p:cxnSp>
+        <p:nvCxnSpPr>
+          <p:cNvPr id="84" name="Connector 83"/>
+          <p:cNvCxnSpPr/>
+          <p:nvPr/>
+        </p:nvCxnSpPr>
+        <p:spPr>
+          <a:xfrm>
+            <a:off x="594361" y="4636008"/>
+            <a:ext cx="3271418" cy="0"/>
+          </a:xfrm>
+          <a:prstGeom prst="line">
+            <a:avLst/>
+          </a:prstGeom>
+          <a:ln w="9525">
+            <a:solidFill>
+              <a:srgbClr val="C5CDDD"/>
+            </a:solidFill>
+          </a:ln>
+        </p:spPr>
+        <p:style>
+          <a:lnRef idx="2">
+            <a:schemeClr val="accent1"/>
+          </a:lnRef>
+          <a:fillRef idx="0">
+            <a:schemeClr val="accent1"/>
+          </a:fillRef>
+          <a:effectRef idx="1">
+            <a:schemeClr val="accent1"/>
+          </a:effectRef>
+          <a:fontRef idx="minor">
+            <a:schemeClr val="tx1"/>
+          </a:fontRef>
+        </p:style>
+      </p:cxnSp>
+      <p:sp>
+        <p:nvSpPr>
+          <p:cNvPr id="85" name="TextBox 84"/>
+          <p:cNvSpPr txBox="1"/>
+          <p:nvPr/>
+        </p:nvSpPr>
+        <p:spPr>
+          <a:xfrm>
+            <a:off x="1645921" y="4663440"/>
+            <a:ext cx="2219858" cy="310896"/>
+          </a:xfrm>
+          <a:prstGeom prst="rect">
+            <a:avLst/>
+          </a:prstGeom>
+          <a:noFill/>
+        </p:spPr>
+        <p:txBody>
+          <a:bodyPr wrap="square" anchor="ctr" lIns="36576" rIns="36576" tIns="0" bIns="0">
+            <a:spAutoFit/>
+          </a:bodyPr>
+          <a:lstStyle/>
+          <a:p>
+            <a:pPr algn="r" rtl="1"/>
+            <a:r>
+              <a:rPr sz="1100" b="0">
+                <a:solidFill>
+                  <a:srgbClr val="1A2233"/>
+                </a:solidFill>
+                <a:latin typeface="Heebo"/>
+                <a:cs typeface="Heebo"/>
+              </a:rPr>
+              <a:t>מנהל תוכן · משותף</a:t>
+            </a:r>
+          </a:p>
+        </p:txBody>
+      </p:sp>
+      <p:sp>
+        <p:nvSpPr>
+          <p:cNvPr id="86" name="TextBox 85"/>
+          <p:cNvSpPr txBox="1"/>
+          <p:nvPr/>
+        </p:nvSpPr>
+        <p:spPr>
+          <a:xfrm>
+            <a:off x="548641" y="4663440"/>
+            <a:ext cx="1097280" cy="310896"/>
+          </a:xfrm>
+          <a:prstGeom prst="rect">
+            <a:avLst/>
+          </a:prstGeom>
+          <a:noFill/>
+        </p:spPr>
+        <p:txBody>
+          <a:bodyPr wrap="square" anchor="ctr" lIns="36576" rIns="36576" tIns="0" bIns="0">
+            <a:spAutoFit/>
+          </a:bodyPr>
+          <a:lstStyle/>
+          <a:p>
+            <a:pPr algn="l" rtl="1"/>
+            <a:r>
+              <a:rPr sz="1100" b="1">
+                <a:solidFill>
+                  <a:srgbClr val="1C3C7A"/>
+                </a:solidFill>
+                <a:latin typeface="Heebo"/>
+                <a:cs typeface="Heebo"/>
+              </a:rPr>
+              <a:t>2,500 ₪</a:t>
+            </a:r>
+          </a:p>
+        </p:txBody>
+      </p:sp>
+      <p:cxnSp>
+        <p:nvCxnSpPr>
+          <p:cNvPr id="87" name="Connector 86"/>
+          <p:cNvCxnSpPr/>
+          <p:nvPr/>
+        </p:nvCxnSpPr>
+        <p:spPr>
+          <a:xfrm>
+            <a:off x="594361" y="5001768"/>
+            <a:ext cx="3271418" cy="0"/>
+          </a:xfrm>
+          <a:prstGeom prst="line">
+            <a:avLst/>
+          </a:prstGeom>
+          <a:ln w="9525">
+            <a:solidFill>
+              <a:srgbClr val="C5CDDD"/>
+            </a:solidFill>
+          </a:ln>
+        </p:spPr>
+        <p:style>
+          <a:lnRef idx="2">
+            <a:schemeClr val="accent1"/>
+          </a:lnRef>
+          <a:fillRef idx="0">
+            <a:schemeClr val="accent1"/>
+          </a:fillRef>
+          <a:effectRef idx="1">
+            <a:schemeClr val="accent1"/>
+          </a:effectRef>
+          <a:fontRef idx="minor">
+            <a:schemeClr val="tx1"/>
+          </a:fontRef>
+        </p:style>
+      </p:cxnSp>
+      <p:sp>
+        <p:nvSpPr>
+          <p:cNvPr id="88" name="TextBox 87"/>
+          <p:cNvSpPr txBox="1"/>
+          <p:nvPr/>
+        </p:nvSpPr>
+        <p:spPr>
+          <a:xfrm>
+            <a:off x="1645921" y="5029200"/>
+            <a:ext cx="2219858" cy="310896"/>
+          </a:xfrm>
+          <a:prstGeom prst="rect">
+            <a:avLst/>
+          </a:prstGeom>
+          <a:noFill/>
+        </p:spPr>
+        <p:txBody>
+          <a:bodyPr wrap="square" anchor="ctr" lIns="36576" rIns="36576" tIns="0" bIns="0">
+            <a:spAutoFit/>
+          </a:bodyPr>
+          <a:lstStyle/>
+          <a:p>
+            <a:pPr algn="r" rtl="1"/>
+            <a:r>
+              <a:rPr sz="1100" b="0">
+                <a:solidFill>
+                  <a:srgbClr val="1A2233"/>
+                </a:solidFill>
+                <a:latin typeface="Heebo"/>
+                <a:cs typeface="Heebo"/>
+              </a:rPr>
+              <a:t>חברי דירקטוריון · 2 דיונים</a:t>
+            </a:r>
+          </a:p>
+        </p:txBody>
+      </p:sp>
+      <p:sp>
+        <p:nvSpPr>
+          <p:cNvPr id="89" name="TextBox 88"/>
+          <p:cNvSpPr txBox="1"/>
+          <p:nvPr/>
+        </p:nvSpPr>
+        <p:spPr>
+          <a:xfrm>
+            <a:off x="548641" y="5029200"/>
+            <a:ext cx="1097280" cy="310896"/>
+          </a:xfrm>
+          <a:prstGeom prst="rect">
+            <a:avLst/>
+          </a:prstGeom>
+          <a:noFill/>
+        </p:spPr>
+        <p:txBody>
+          <a:bodyPr wrap="square" anchor="ctr" lIns="36576" rIns="36576" tIns="0" bIns="0">
+            <a:spAutoFit/>
+          </a:bodyPr>
+          <a:lstStyle/>
+          <a:p>
+            <a:pPr algn="l" rtl="1"/>
+            <a:r>
+              <a:rPr sz="1100" b="1">
+                <a:solidFill>
+                  <a:srgbClr val="1C3C7A"/>
+                </a:solidFill>
+                <a:latin typeface="Heebo"/>
+                <a:cs typeface="Heebo"/>
+              </a:rPr>
+              <a:t>750 ₪</a:t>
+            </a:r>
+          </a:p>
+        </p:txBody>
+      </p:sp>
+      <p:cxnSp>
+        <p:nvCxnSpPr>
+          <p:cNvPr id="90" name="Connector 89"/>
+          <p:cNvCxnSpPr/>
+          <p:nvPr/>
+        </p:nvCxnSpPr>
+        <p:spPr>
+          <a:xfrm>
+            <a:off x="594361" y="5367528"/>
+            <a:ext cx="3271418" cy="0"/>
+          </a:xfrm>
+          <a:prstGeom prst="line">
+            <a:avLst/>
+          </a:prstGeom>
+          <a:ln w="9525">
+            <a:solidFill>
+              <a:srgbClr val="C5CDDD"/>
+            </a:solidFill>
+          </a:ln>
+        </p:spPr>
+        <p:style>
+          <a:lnRef idx="2">
+            <a:schemeClr val="accent1"/>
+          </a:lnRef>
+          <a:fillRef idx="0">
+            <a:schemeClr val="accent1"/>
+          </a:fillRef>
+          <a:effectRef idx="1">
+            <a:schemeClr val="accent1"/>
+          </a:effectRef>
+          <a:fontRef idx="minor">
+            <a:schemeClr val="tx1"/>
+          </a:fontRef>
+        </p:style>
+      </p:cxnSp>
+      <p:sp>
+        <p:nvSpPr>
+          <p:cNvPr id="91" name="TextBox 90"/>
+          <p:cNvSpPr txBox="1"/>
+          <p:nvPr/>
+        </p:nvSpPr>
+        <p:spPr>
+          <a:xfrm>
+            <a:off x="1645921" y="5394960"/>
+            <a:ext cx="2219858" cy="310896"/>
+          </a:xfrm>
+          <a:prstGeom prst="rect">
+            <a:avLst/>
+          </a:prstGeom>
+          <a:noFill/>
+        </p:spPr>
+        <p:txBody>
+          <a:bodyPr wrap="square" anchor="ctr" lIns="36576" rIns="36576" tIns="0" bIns="0">
+            <a:spAutoFit/>
+          </a:bodyPr>
+          <a:lstStyle/>
+          <a:p>
+            <a:pPr algn="r" rtl="1"/>
+            <a:r>
+              <a:rPr sz="1100" b="0">
+                <a:solidFill>
+                  <a:srgbClr val="1A2233"/>
+                </a:solidFill>
+                <a:latin typeface="Heebo"/>
+                <a:cs typeface="Heebo"/>
+              </a:rPr>
+              <a:t>אקטיביסטים · 2 דיונים</a:t>
+            </a:r>
+          </a:p>
+        </p:txBody>
+      </p:sp>
+      <p:sp>
+        <p:nvSpPr>
+          <p:cNvPr id="92" name="TextBox 91"/>
+          <p:cNvSpPr txBox="1"/>
+          <p:nvPr/>
+        </p:nvSpPr>
+        <p:spPr>
+          <a:xfrm>
+            <a:off x="548641" y="5394960"/>
+            <a:ext cx="1097280" cy="310896"/>
+          </a:xfrm>
+          <a:prstGeom prst="rect">
+            <a:avLst/>
+          </a:prstGeom>
+          <a:noFill/>
+        </p:spPr>
+        <p:txBody>
+          <a:bodyPr wrap="square" anchor="ctr" lIns="36576" rIns="36576" tIns="0" bIns="0">
+            <a:spAutoFit/>
+          </a:bodyPr>
+          <a:lstStyle/>
+          <a:p>
+            <a:pPr algn="l" rtl="1"/>
+            <a:r>
+              <a:rPr sz="1100" b="0">
+                <a:solidFill>
+                  <a:srgbClr val="8A94A8"/>
+                </a:solidFill>
+                <a:latin typeface="Heebo"/>
+                <a:cs typeface="Heebo"/>
+              </a:rPr>
+              <a:t>בהתנדבות</a:t>
+            </a:r>
+          </a:p>
+        </p:txBody>
+      </p:sp>
+      <p:cxnSp>
+        <p:nvCxnSpPr>
+          <p:cNvPr id="93" name="Connector 92"/>
+          <p:cNvCxnSpPr/>
+          <p:nvPr/>
+        </p:nvCxnSpPr>
+        <p:spPr>
+          <a:xfrm>
+            <a:off x="594361" y="5733288"/>
+            <a:ext cx="3271418" cy="0"/>
+          </a:xfrm>
+          <a:prstGeom prst="line">
+            <a:avLst/>
+          </a:prstGeom>
+          <a:ln w="9525">
+            <a:solidFill>
+              <a:srgbClr val="C5CDDD"/>
+            </a:solidFill>
+          </a:ln>
+        </p:spPr>
+        <p:style>
+          <a:lnRef idx="2">
+            <a:schemeClr val="accent1"/>
+          </a:lnRef>
+          <a:fillRef idx="0">
+            <a:schemeClr val="accent1"/>
+          </a:fillRef>
+          <a:effectRef idx="1">
+            <a:schemeClr val="accent1"/>
+          </a:effectRef>
+          <a:fontRef idx="minor">
+            <a:schemeClr val="tx1"/>
+          </a:fontRef>
+        </p:style>
+      </p:cxnSp>
+      <p:sp>
+        <p:nvSpPr>
+          <p:cNvPr id="94" name="TextBox 93"/>
+          <p:cNvSpPr txBox="1"/>
+          <p:nvPr/>
+        </p:nvSpPr>
+        <p:spPr>
+          <a:xfrm>
+            <a:off x="594361" y="5806440"/>
+            <a:ext cx="3271418" cy="256032"/>
+          </a:xfrm>
+          <a:prstGeom prst="rect">
+            <a:avLst/>
+          </a:prstGeom>
+          <a:noFill/>
+        </p:spPr>
+        <p:txBody>
+          <a:bodyPr wrap="square" anchor="ctr" lIns="36576" rIns="36576" tIns="0" bIns="0">
+            <a:spAutoFit/>
+          </a:bodyPr>
+          <a:lstStyle/>
+          <a:p>
+            <a:pPr algn="r" rtl="1"/>
+            <a:r>
+              <a:rPr sz="1000" b="0">
+                <a:solidFill>
+                  <a:srgbClr val="8A94A8"/>
+                </a:solidFill>
+                <a:latin typeface="Heebo"/>
+                <a:cs typeface="Heebo"/>
+              </a:rPr>
+              <a:t>תעריף: 300 ₪ חצי יום · 450 ₪ יום מלא</a:t>
+            </a:r>
+          </a:p>
+        </p:txBody>
+      </p:sp>
+      <p:sp>
+        <p:nvSpPr>
+          <p:cNvPr id="95" name="TextBox 94"/>
+          <p:cNvSpPr txBox="1"/>
+          <p:nvPr/>
+        </p:nvSpPr>
+        <p:spPr>
+          <a:xfrm>
+            <a:off x="594361" y="6080760"/>
+            <a:ext cx="3271418" cy="274320"/>
+          </a:xfrm>
+          <a:prstGeom prst="rect">
+            <a:avLst/>
+          </a:prstGeom>
+          <a:noFill/>
+        </p:spPr>
+        <p:txBody>
+          <a:bodyPr wrap="square" anchor="ctr" lIns="36576" rIns="36576" tIns="0" bIns="0">
+            <a:spAutoFit/>
+          </a:bodyPr>
+          <a:lstStyle/>
+          <a:p>
+            <a:pPr algn="r" rtl="1"/>
+            <a:r>
+              <a:rPr sz="1100" b="1">
+                <a:solidFill>
+                  <a:srgbClr val="1C3C7A"/>
+                </a:solidFill>
+                <a:latin typeface="Heebo"/>
+                <a:cs typeface="Heebo"/>
+              </a:rPr>
+              <a:t>מימון: כ-4 שותפים מייסדים</a:t>
+            </a:r>
+          </a:p>
+        </p:txBody>
+      </p:sp>
+      <p:sp>
+        <p:nvSpPr>
+          <p:cNvPr id="96" name="TextBox 95"/>
+          <p:cNvSpPr txBox="1"/>
+          <p:nvPr/>
+        </p:nvSpPr>
+        <p:spPr>
+          <a:xfrm>
+            <a:off x="411480" y="6419088"/>
+            <a:ext cx="11368735" cy="274320"/>
+          </a:xfrm>
+          <a:prstGeom prst="rect">
+            <a:avLst/>
+          </a:prstGeom>
+          <a:noFill/>
+        </p:spPr>
+        <p:txBody>
+          <a:bodyPr wrap="square" anchor="ctr" lIns="36576" rIns="36576" tIns="0" bIns="0">
+            <a:spAutoFit/>
+          </a:bodyPr>
+          <a:lstStyle/>
+          <a:p>
+            <a:pPr algn="ctr" rtl="1"/>
+            <a:r>
+              <a:rPr sz="1000" b="0">
+                <a:solidFill>
+                  <a:srgbClr val="8A94A8"/>
+                </a:solidFill>
+                <a:latin typeface="Heebo"/>
+                <a:cs typeface="Heebo"/>
+              </a:rPr>
+              <a:t>כל נותני השירות פרילנסרים · תמיר דורטל ללא שכר · שותף מייסד = 5,000 ₪ בחודש</a:t>
+            </a:r>
+          </a:p>
+        </p:txBody>
+      </p:sp>
     </p:spTree>
   </p:cSld>
   <p:clrMapOvr>

</xml_diff>

<commit_message>
Lean model: CEO 10,000
Co-Authored-By: Claude Opus 5.5 <noreply@anthropic.com>
Claude-Session: https://claude.ai/code/session_01W7Er83FuNT4pLFShWidYHn
</commit_message>
<xml_diff>
--- a/presentation/out/koach-hitarvut.pptx
+++ b/presentation/out/koach-hitarvut.pptx
@@ -11519,7 +11519,7 @@
                 <a:latin typeface="Heebo"/>
                 <a:cs typeface="Heebo"/>
               </a:rPr>
-              <a:t>20,250 ₪</a:t>
+              <a:t>18,250 ₪</a:t>
             </a:r>
           </a:p>
         </p:txBody>
@@ -11555,7 +11555,7 @@
                 <a:latin typeface="Heebo"/>
                 <a:cs typeface="Heebo"/>
               </a:rPr>
-              <a:t>לחודש · 243,000 ₪ בשנה</a:t>
+              <a:t>לחודש · 219,000 ₪ בשנה</a:t>
             </a:r>
           </a:p>
         </p:txBody>
@@ -11755,7 +11755,7 @@
                 <a:latin typeface="Heebo"/>
                 <a:cs typeface="Heebo"/>
               </a:rPr>
-              <a:t>1,560 ₪</a:t>
+              <a:t>1,400 ₪</a:t>
             </a:r>
           </a:p>
         </p:txBody>
@@ -11863,7 +11863,7 @@
                 <a:latin typeface="Heebo"/>
                 <a:cs typeface="Heebo"/>
               </a:rPr>
-              <a:t>12,000 ₪</a:t>
+              <a:t>10,000 ₪</a:t>
             </a:r>
           </a:p>
         </p:txBody>

</xml_diff>

<commit_message>
Add stage A (structural) and stage B (adequate pay) budget slides; update ideal model
Co-Authored-By: Claude Opus 5.5 <noreply@anthropic.com>
Claude-Session: https://claude.ai/code/session_01W7Er83FuNT4pLFShWidYHn
</commit_message>
<xml_diff>
--- a/presentation/out/koach-hitarvut.pptx
+++ b/presentation/out/koach-hitarvut.pptx
@@ -15,6 +15,8 @@
     <p:sldId id="263" r:id="rId14"/>
     <p:sldId id="264" r:id="rId15"/>
     <p:sldId id="265" r:id="rId16"/>
+    <p:sldId id="266" r:id="rId17"/>
+    <p:sldId id="267" r:id="rId18"/>
   </p:sldIdLst>
   <p:sldSz cx="12191695" cy="6858000" type="screen4x3"/>
   <p:notesSz cx="6858000" cy="9144000"/>
@@ -9003,7 +9005,7 @@
                 <a:latin typeface="Heebo"/>
                 <a:cs typeface="Heebo"/>
               </a:rPr>
-              <a:t>הוצאות · שלושה מודלים</a:t>
+              <a:t>שלב א׳ · שינוי מבני, בלי לגעת בשכר</a:t>
             </a:r>
           </a:p>
         </p:txBody>
@@ -9086,12 +9088,166 @@
         </p:nvSpPr>
         <p:spPr>
           <a:xfrm>
-            <a:off x="8143037" y="1188720"/>
-            <a:ext cx="3637178" cy="5120640"/>
+            <a:off x="5440680" y="1188720"/>
+            <a:ext cx="6339535" cy="384048"/>
           </a:xfrm>
           <a:prstGeom prst="roundRect">
             <a:avLst>
-              <a:gd name="adj" fmla="val 5000"/>
+              <a:gd name="adj" fmla="val 20000"/>
+            </a:avLst>
+          </a:prstGeom>
+          <a:solidFill>
+            <a:srgbClr val="1C3C7A"/>
+          </a:solidFill>
+          <a:ln>
+            <a:noFill/>
+          </a:ln>
+          <a:effectLst/>
+        </p:spPr>
+        <p:style>
+          <a:lnRef idx="1">
+            <a:schemeClr val="accent1"/>
+          </a:lnRef>
+          <a:fillRef idx="3">
+            <a:schemeClr val="accent1"/>
+          </a:fillRef>
+          <a:effectRef idx="2">
+            <a:schemeClr val="accent1"/>
+          </a:effectRef>
+          <a:fontRef idx="minor">
+            <a:schemeClr val="lt1"/>
+          </a:fontRef>
+        </p:style>
+        <p:txBody>
+          <a:bodyPr rtlCol="0" anchor="ctr"/>
+          <a:lstStyle/>
+          <a:p>
+            <a:pPr algn="ctr"/>
+          </a:p>
+        </p:txBody>
+      </p:sp>
+      <p:sp>
+        <p:nvSpPr>
+          <p:cNvPr id="8" name="TextBox 7"/>
+          <p:cNvSpPr txBox="1"/>
+          <p:nvPr/>
+        </p:nvSpPr>
+        <p:spPr>
+          <a:xfrm>
+            <a:off x="5623560" y="1188720"/>
+            <a:ext cx="3413455" cy="384048"/>
+          </a:xfrm>
+          <a:prstGeom prst="rect">
+            <a:avLst/>
+          </a:prstGeom>
+          <a:noFill/>
+        </p:spPr>
+        <p:txBody>
+          <a:bodyPr wrap="square" anchor="ctr" lIns="36576" rIns="36576" tIns="0" bIns="0">
+            <a:spAutoFit/>
+          </a:bodyPr>
+          <a:lstStyle/>
+          <a:p>
+            <a:pPr algn="r" rtl="1"/>
+            <a:r>
+              <a:rPr sz="1200" b="1">
+                <a:solidFill>
+                  <a:srgbClr val="FFFFFF"/>
+                </a:solidFill>
+                <a:latin typeface="Heebo"/>
+                <a:cs typeface="Heebo"/>
+              </a:rPr>
+              <a:t>תפקיד</a:t>
+            </a:r>
+          </a:p>
+        </p:txBody>
+      </p:sp>
+      <p:sp>
+        <p:nvSpPr>
+          <p:cNvPr id="9" name="TextBox 8"/>
+          <p:cNvSpPr txBox="1"/>
+          <p:nvPr/>
+        </p:nvSpPr>
+        <p:spPr>
+          <a:xfrm>
+            <a:off x="6903720" y="1188720"/>
+            <a:ext cx="1280160" cy="384048"/>
+          </a:xfrm>
+          <a:prstGeom prst="rect">
+            <a:avLst/>
+          </a:prstGeom>
+          <a:noFill/>
+        </p:spPr>
+        <p:txBody>
+          <a:bodyPr wrap="square" anchor="ctr" lIns="36576" rIns="36576" tIns="0" bIns="0">
+            <a:spAutoFit/>
+          </a:bodyPr>
+          <a:lstStyle/>
+          <a:p>
+            <a:pPr algn="ctr" rtl="1"/>
+            <a:r>
+              <a:rPr sz="1200" b="1">
+                <a:solidFill>
+                  <a:srgbClr val="FFFFFF"/>
+                </a:solidFill>
+                <a:latin typeface="Heebo"/>
+                <a:cs typeface="Heebo"/>
+              </a:rPr>
+              <a:t>לחודש</a:t>
+            </a:r>
+          </a:p>
+        </p:txBody>
+      </p:sp>
+      <p:sp>
+        <p:nvSpPr>
+          <p:cNvPr id="10" name="TextBox 9"/>
+          <p:cNvSpPr txBox="1"/>
+          <p:nvPr/>
+        </p:nvSpPr>
+        <p:spPr>
+          <a:xfrm>
+            <a:off x="5532120" y="1188720"/>
+            <a:ext cx="1371600" cy="384048"/>
+          </a:xfrm>
+          <a:prstGeom prst="rect">
+            <a:avLst/>
+          </a:prstGeom>
+          <a:noFill/>
+        </p:spPr>
+        <p:txBody>
+          <a:bodyPr wrap="square" anchor="ctr" lIns="36576" rIns="36576" tIns="0" bIns="0">
+            <a:spAutoFit/>
+          </a:bodyPr>
+          <a:lstStyle/>
+          <a:p>
+            <a:pPr algn="ctr" rtl="1"/>
+            <a:r>
+              <a:rPr sz="1200" b="1">
+                <a:solidFill>
+                  <a:srgbClr val="FFFFFF"/>
+                </a:solidFill>
+                <a:latin typeface="Heebo"/>
+                <a:cs typeface="Heebo"/>
+              </a:rPr>
+              <a:t>שינוי</a:t>
+            </a:r>
+          </a:p>
+        </p:txBody>
+      </p:sp>
+      <p:sp>
+        <p:nvSpPr>
+          <p:cNvPr id="11" name="Rounded Rectangle 10"/>
+          <p:cNvSpPr/>
+          <p:nvPr/>
+        </p:nvSpPr>
+        <p:spPr>
+          <a:xfrm>
+            <a:off x="5440680" y="1664208"/>
+            <a:ext cx="6339535" cy="512064"/>
+          </a:xfrm>
+          <a:prstGeom prst="roundRect">
+            <a:avLst>
+              <a:gd name="adj" fmla="val 15000"/>
             </a:avLst>
           </a:prstGeom>
           <a:solidFill>
@@ -9128,6 +9284,4188 @@
       </p:sp>
       <p:sp>
         <p:nvSpPr>
+          <p:cNvPr id="12" name="TextBox 11"/>
+          <p:cNvSpPr txBox="1"/>
+          <p:nvPr/>
+        </p:nvSpPr>
+        <p:spPr>
+          <a:xfrm>
+            <a:off x="8275320" y="1664208"/>
+            <a:ext cx="3322015" cy="512064"/>
+          </a:xfrm>
+          <a:prstGeom prst="rect">
+            <a:avLst/>
+          </a:prstGeom>
+          <a:noFill/>
+        </p:spPr>
+        <p:txBody>
+          <a:bodyPr wrap="square" anchor="ctr" lIns="36576" rIns="36576" tIns="0" bIns="0">
+            <a:spAutoFit/>
+          </a:bodyPr>
+          <a:lstStyle/>
+          <a:p>
+            <a:pPr algn="r" rtl="1"/>
+            <a:r>
+              <a:rPr sz="1300" b="1">
+                <a:solidFill>
+                  <a:srgbClr val="1A2233"/>
+                </a:solidFill>
+                <a:latin typeface="Heebo"/>
+                <a:cs typeface="Heebo"/>
+              </a:rPr>
+              <a:t>מנכ״ל · אדם קורגן</a:t>
+            </a:r>
+          </a:p>
+        </p:txBody>
+      </p:sp>
+      <p:sp>
+        <p:nvSpPr>
+          <p:cNvPr id="13" name="TextBox 12"/>
+          <p:cNvSpPr txBox="1"/>
+          <p:nvPr/>
+        </p:nvSpPr>
+        <p:spPr>
+          <a:xfrm>
+            <a:off x="6903720" y="1664208"/>
+            <a:ext cx="1280160" cy="512064"/>
+          </a:xfrm>
+          <a:prstGeom prst="rect">
+            <a:avLst/>
+          </a:prstGeom>
+          <a:noFill/>
+        </p:spPr>
+        <p:txBody>
+          <a:bodyPr wrap="square" anchor="ctr" lIns="36576" rIns="36576" tIns="0" bIns="0">
+            <a:spAutoFit/>
+          </a:bodyPr>
+          <a:lstStyle/>
+          <a:p>
+            <a:pPr algn="ctr" rtl="1"/>
+            <a:r>
+              <a:rPr sz="1400" b="1">
+                <a:solidFill>
+                  <a:srgbClr val="1C3C7A"/>
+                </a:solidFill>
+                <a:latin typeface="Heebo"/>
+                <a:cs typeface="Heebo"/>
+              </a:rPr>
+              <a:t>12,000 ₪</a:t>
+            </a:r>
+          </a:p>
+        </p:txBody>
+      </p:sp>
+      <p:sp>
+        <p:nvSpPr>
+          <p:cNvPr id="14" name="Rounded Rectangle 13"/>
+          <p:cNvSpPr/>
+          <p:nvPr/>
+        </p:nvSpPr>
+        <p:spPr>
+          <a:xfrm>
+            <a:off x="5577840" y="1773936"/>
+            <a:ext cx="1234440" cy="292608"/>
+          </a:xfrm>
+          <a:prstGeom prst="roundRect">
+            <a:avLst>
+              <a:gd name="adj" fmla="val 50000"/>
+            </a:avLst>
+          </a:prstGeom>
+          <a:solidFill>
+            <a:srgbClr val="F4F6FB"/>
+          </a:solidFill>
+          <a:ln>
+            <a:noFill/>
+          </a:ln>
+          <a:effectLst/>
+        </p:spPr>
+        <p:style>
+          <a:lnRef idx="1">
+            <a:schemeClr val="accent1"/>
+          </a:lnRef>
+          <a:fillRef idx="3">
+            <a:schemeClr val="accent1"/>
+          </a:fillRef>
+          <a:effectRef idx="2">
+            <a:schemeClr val="accent1"/>
+          </a:effectRef>
+          <a:fontRef idx="minor">
+            <a:schemeClr val="lt1"/>
+          </a:fontRef>
+        </p:style>
+        <p:txBody>
+          <a:bodyPr rtlCol="0" anchor="ctr"/>
+          <a:lstStyle/>
+          <a:p>
+            <a:pPr algn="ctr"/>
+          </a:p>
+        </p:txBody>
+      </p:sp>
+      <p:sp>
+        <p:nvSpPr>
+          <p:cNvPr id="15" name="TextBox 14"/>
+          <p:cNvSpPr txBox="1"/>
+          <p:nvPr/>
+        </p:nvSpPr>
+        <p:spPr>
+          <a:xfrm>
+            <a:off x="5577840" y="1773936"/>
+            <a:ext cx="1234440" cy="292608"/>
+          </a:xfrm>
+          <a:prstGeom prst="rect">
+            <a:avLst/>
+          </a:prstGeom>
+          <a:noFill/>
+        </p:spPr>
+        <p:txBody>
+          <a:bodyPr wrap="square" anchor="ctr" lIns="36576" rIns="36576" tIns="0" bIns="0">
+            <a:spAutoFit/>
+          </a:bodyPr>
+          <a:lstStyle/>
+          <a:p>
+            <a:pPr algn="ctr" rtl="1"/>
+            <a:r>
+              <a:rPr sz="1000" b="0">
+                <a:solidFill>
+                  <a:srgbClr val="8A94A8"/>
+                </a:solidFill>
+                <a:latin typeface="Heebo"/>
+                <a:cs typeface="Heebo"/>
+              </a:rPr>
+              <a:t>ללא שינוי</a:t>
+            </a:r>
+          </a:p>
+        </p:txBody>
+      </p:sp>
+      <p:sp>
+        <p:nvSpPr>
+          <p:cNvPr id="16" name="Rounded Rectangle 15"/>
+          <p:cNvSpPr/>
+          <p:nvPr/>
+        </p:nvSpPr>
+        <p:spPr>
+          <a:xfrm>
+            <a:off x="5440680" y="2249424"/>
+            <a:ext cx="6339535" cy="512064"/>
+          </a:xfrm>
+          <a:prstGeom prst="roundRect">
+            <a:avLst>
+              <a:gd name="adj" fmla="val 15000"/>
+            </a:avLst>
+          </a:prstGeom>
+          <a:solidFill>
+            <a:srgbClr val="FFFFFF"/>
+          </a:solidFill>
+          <a:ln w="15875">
+            <a:solidFill>
+              <a:srgbClr val="C5CDDD"/>
+            </a:solidFill>
+          </a:ln>
+          <a:effectLst/>
+        </p:spPr>
+        <p:style>
+          <a:lnRef idx="1">
+            <a:schemeClr val="accent1"/>
+          </a:lnRef>
+          <a:fillRef idx="3">
+            <a:schemeClr val="accent1"/>
+          </a:fillRef>
+          <a:effectRef idx="2">
+            <a:schemeClr val="accent1"/>
+          </a:effectRef>
+          <a:fontRef idx="minor">
+            <a:schemeClr val="lt1"/>
+          </a:fontRef>
+        </p:style>
+        <p:txBody>
+          <a:bodyPr rtlCol="0" anchor="ctr"/>
+          <a:lstStyle/>
+          <a:p>
+            <a:pPr algn="ctr"/>
+          </a:p>
+        </p:txBody>
+      </p:sp>
+      <p:sp>
+        <p:nvSpPr>
+          <p:cNvPr id="17" name="TextBox 16"/>
+          <p:cNvSpPr txBox="1"/>
+          <p:nvPr/>
+        </p:nvSpPr>
+        <p:spPr>
+          <a:xfrm>
+            <a:off x="8275320" y="2249424"/>
+            <a:ext cx="3322015" cy="512064"/>
+          </a:xfrm>
+          <a:prstGeom prst="rect">
+            <a:avLst/>
+          </a:prstGeom>
+          <a:noFill/>
+        </p:spPr>
+        <p:txBody>
+          <a:bodyPr wrap="square" anchor="ctr" lIns="36576" rIns="36576" tIns="0" bIns="0">
+            <a:spAutoFit/>
+          </a:bodyPr>
+          <a:lstStyle/>
+          <a:p>
+            <a:pPr algn="r" rtl="1"/>
+            <a:r>
+              <a:rPr sz="1300" b="1">
+                <a:solidFill>
+                  <a:srgbClr val="1A2233"/>
+                </a:solidFill>
+                <a:latin typeface="Heebo"/>
+                <a:cs typeface="Heebo"/>
+              </a:rPr>
+              <a:t>עוזר מנכ״ל · חצי משרה</a:t>
+            </a:r>
+          </a:p>
+        </p:txBody>
+      </p:sp>
+      <p:sp>
+        <p:nvSpPr>
+          <p:cNvPr id="18" name="TextBox 17"/>
+          <p:cNvSpPr txBox="1"/>
+          <p:nvPr/>
+        </p:nvSpPr>
+        <p:spPr>
+          <a:xfrm>
+            <a:off x="6903720" y="2249424"/>
+            <a:ext cx="1280160" cy="512064"/>
+          </a:xfrm>
+          <a:prstGeom prst="rect">
+            <a:avLst/>
+          </a:prstGeom>
+          <a:noFill/>
+        </p:spPr>
+        <p:txBody>
+          <a:bodyPr wrap="square" anchor="ctr" lIns="36576" rIns="36576" tIns="0" bIns="0">
+            <a:spAutoFit/>
+          </a:bodyPr>
+          <a:lstStyle/>
+          <a:p>
+            <a:pPr algn="ctr" rtl="1"/>
+            <a:r>
+              <a:rPr sz="1400" b="1">
+                <a:solidFill>
+                  <a:srgbClr val="1C3C7A"/>
+                </a:solidFill>
+                <a:latin typeface="Heebo"/>
+                <a:cs typeface="Heebo"/>
+              </a:rPr>
+              <a:t>5,000 ₪</a:t>
+            </a:r>
+          </a:p>
+        </p:txBody>
+      </p:sp>
+      <p:sp>
+        <p:nvSpPr>
+          <p:cNvPr id="19" name="Rounded Rectangle 18"/>
+          <p:cNvSpPr/>
+          <p:nvPr/>
+        </p:nvSpPr>
+        <p:spPr>
+          <a:xfrm>
+            <a:off x="5577840" y="2359152"/>
+            <a:ext cx="1234440" cy="292608"/>
+          </a:xfrm>
+          <a:prstGeom prst="roundRect">
+            <a:avLst>
+              <a:gd name="adj" fmla="val 50000"/>
+            </a:avLst>
+          </a:prstGeom>
+          <a:solidFill>
+            <a:srgbClr val="F4F6FB"/>
+          </a:solidFill>
+          <a:ln>
+            <a:noFill/>
+          </a:ln>
+          <a:effectLst/>
+        </p:spPr>
+        <p:style>
+          <a:lnRef idx="1">
+            <a:schemeClr val="accent1"/>
+          </a:lnRef>
+          <a:fillRef idx="3">
+            <a:schemeClr val="accent1"/>
+          </a:fillRef>
+          <a:effectRef idx="2">
+            <a:schemeClr val="accent1"/>
+          </a:effectRef>
+          <a:fontRef idx="minor">
+            <a:schemeClr val="lt1"/>
+          </a:fontRef>
+        </p:style>
+        <p:txBody>
+          <a:bodyPr rtlCol="0" anchor="ctr"/>
+          <a:lstStyle/>
+          <a:p>
+            <a:pPr algn="ctr"/>
+          </a:p>
+        </p:txBody>
+      </p:sp>
+      <p:sp>
+        <p:nvSpPr>
+          <p:cNvPr id="20" name="TextBox 19"/>
+          <p:cNvSpPr txBox="1"/>
+          <p:nvPr/>
+        </p:nvSpPr>
+        <p:spPr>
+          <a:xfrm>
+            <a:off x="5577840" y="2359152"/>
+            <a:ext cx="1234440" cy="292608"/>
+          </a:xfrm>
+          <a:prstGeom prst="rect">
+            <a:avLst/>
+          </a:prstGeom>
+          <a:noFill/>
+        </p:spPr>
+        <p:txBody>
+          <a:bodyPr wrap="square" anchor="ctr" lIns="36576" rIns="36576" tIns="0" bIns="0">
+            <a:spAutoFit/>
+          </a:bodyPr>
+          <a:lstStyle/>
+          <a:p>
+            <a:pPr algn="ctr" rtl="1"/>
+            <a:r>
+              <a:rPr sz="1000" b="0">
+                <a:solidFill>
+                  <a:srgbClr val="8A94A8"/>
+                </a:solidFill>
+                <a:latin typeface="Heebo"/>
+                <a:cs typeface="Heebo"/>
+              </a:rPr>
+              <a:t>ללא שינוי</a:t>
+            </a:r>
+          </a:p>
+        </p:txBody>
+      </p:sp>
+      <p:sp>
+        <p:nvSpPr>
+          <p:cNvPr id="21" name="Rounded Rectangle 20"/>
+          <p:cNvSpPr/>
+          <p:nvPr/>
+        </p:nvSpPr>
+        <p:spPr>
+          <a:xfrm>
+            <a:off x="5440680" y="2834640"/>
+            <a:ext cx="6339535" cy="512064"/>
+          </a:xfrm>
+          <a:prstGeom prst="roundRect">
+            <a:avLst>
+              <a:gd name="adj" fmla="val 15000"/>
+            </a:avLst>
+          </a:prstGeom>
+          <a:solidFill>
+            <a:srgbClr val="FFFFFF"/>
+          </a:solidFill>
+          <a:ln w="15875">
+            <a:solidFill>
+              <a:srgbClr val="C5CDDD"/>
+            </a:solidFill>
+          </a:ln>
+          <a:effectLst/>
+        </p:spPr>
+        <p:style>
+          <a:lnRef idx="1">
+            <a:schemeClr val="accent1"/>
+          </a:lnRef>
+          <a:fillRef idx="3">
+            <a:schemeClr val="accent1"/>
+          </a:fillRef>
+          <a:effectRef idx="2">
+            <a:schemeClr val="accent1"/>
+          </a:effectRef>
+          <a:fontRef idx="minor">
+            <a:schemeClr val="lt1"/>
+          </a:fontRef>
+        </p:style>
+        <p:txBody>
+          <a:bodyPr rtlCol="0" anchor="ctr"/>
+          <a:lstStyle/>
+          <a:p>
+            <a:pPr algn="ctr"/>
+          </a:p>
+        </p:txBody>
+      </p:sp>
+      <p:sp>
+        <p:nvSpPr>
+          <p:cNvPr id="22" name="TextBox 21"/>
+          <p:cNvSpPr txBox="1"/>
+          <p:nvPr/>
+        </p:nvSpPr>
+        <p:spPr>
+          <a:xfrm>
+            <a:off x="8275320" y="2834640"/>
+            <a:ext cx="3322015" cy="512064"/>
+          </a:xfrm>
+          <a:prstGeom prst="rect">
+            <a:avLst/>
+          </a:prstGeom>
+          <a:noFill/>
+        </p:spPr>
+        <p:txBody>
+          <a:bodyPr wrap="square" anchor="ctr" lIns="36576" rIns="36576" tIns="0" bIns="0">
+            <a:spAutoFit/>
+          </a:bodyPr>
+          <a:lstStyle/>
+          <a:p>
+            <a:pPr algn="r" rtl="1"/>
+            <a:r>
+              <a:rPr sz="1300" b="1">
+                <a:solidFill>
+                  <a:srgbClr val="1A2233"/>
+                </a:solidFill>
+                <a:latin typeface="Heebo"/>
+                <a:cs typeface="Heebo"/>
+              </a:rPr>
+              <a:t>מנהל תוכן · חצי משרה</a:t>
+            </a:r>
+          </a:p>
+        </p:txBody>
+      </p:sp>
+      <p:sp>
+        <p:nvSpPr>
+          <p:cNvPr id="23" name="TextBox 22"/>
+          <p:cNvSpPr txBox="1"/>
+          <p:nvPr/>
+        </p:nvSpPr>
+        <p:spPr>
+          <a:xfrm>
+            <a:off x="6903720" y="2834640"/>
+            <a:ext cx="1280160" cy="512064"/>
+          </a:xfrm>
+          <a:prstGeom prst="rect">
+            <a:avLst/>
+          </a:prstGeom>
+          <a:noFill/>
+        </p:spPr>
+        <p:txBody>
+          <a:bodyPr wrap="square" anchor="ctr" lIns="36576" rIns="36576" tIns="0" bIns="0">
+            <a:spAutoFit/>
+          </a:bodyPr>
+          <a:lstStyle/>
+          <a:p>
+            <a:pPr algn="ctr" rtl="1"/>
+            <a:r>
+              <a:rPr sz="1400" b="1">
+                <a:solidFill>
+                  <a:srgbClr val="1C3C7A"/>
+                </a:solidFill>
+                <a:latin typeface="Heebo"/>
+                <a:cs typeface="Heebo"/>
+              </a:rPr>
+              <a:t>5,000 ₪</a:t>
+            </a:r>
+          </a:p>
+        </p:txBody>
+      </p:sp>
+      <p:sp>
+        <p:nvSpPr>
+          <p:cNvPr id="24" name="Rounded Rectangle 23"/>
+          <p:cNvSpPr/>
+          <p:nvPr/>
+        </p:nvSpPr>
+        <p:spPr>
+          <a:xfrm>
+            <a:off x="5577840" y="2944368"/>
+            <a:ext cx="1234440" cy="292608"/>
+          </a:xfrm>
+          <a:prstGeom prst="roundRect">
+            <a:avLst>
+              <a:gd name="adj" fmla="val 50000"/>
+            </a:avLst>
+          </a:prstGeom>
+          <a:solidFill>
+            <a:srgbClr val="F4F6FB"/>
+          </a:solidFill>
+          <a:ln>
+            <a:noFill/>
+          </a:ln>
+          <a:effectLst/>
+        </p:spPr>
+        <p:style>
+          <a:lnRef idx="1">
+            <a:schemeClr val="accent1"/>
+          </a:lnRef>
+          <a:fillRef idx="3">
+            <a:schemeClr val="accent1"/>
+          </a:fillRef>
+          <a:effectRef idx="2">
+            <a:schemeClr val="accent1"/>
+          </a:effectRef>
+          <a:fontRef idx="minor">
+            <a:schemeClr val="lt1"/>
+          </a:fontRef>
+        </p:style>
+        <p:txBody>
+          <a:bodyPr rtlCol="0" anchor="ctr"/>
+          <a:lstStyle/>
+          <a:p>
+            <a:pPr algn="ctr"/>
+          </a:p>
+        </p:txBody>
+      </p:sp>
+      <p:sp>
+        <p:nvSpPr>
+          <p:cNvPr id="25" name="TextBox 24"/>
+          <p:cNvSpPr txBox="1"/>
+          <p:nvPr/>
+        </p:nvSpPr>
+        <p:spPr>
+          <a:xfrm>
+            <a:off x="5577840" y="2944368"/>
+            <a:ext cx="1234440" cy="292608"/>
+          </a:xfrm>
+          <a:prstGeom prst="rect">
+            <a:avLst/>
+          </a:prstGeom>
+          <a:noFill/>
+        </p:spPr>
+        <p:txBody>
+          <a:bodyPr wrap="square" anchor="ctr" lIns="36576" rIns="36576" tIns="0" bIns="0">
+            <a:spAutoFit/>
+          </a:bodyPr>
+          <a:lstStyle/>
+          <a:p>
+            <a:pPr algn="ctr" rtl="1"/>
+            <a:r>
+              <a:rPr sz="1000" b="0">
+                <a:solidFill>
+                  <a:srgbClr val="8A94A8"/>
+                </a:solidFill>
+                <a:latin typeface="Heebo"/>
+                <a:cs typeface="Heebo"/>
+              </a:rPr>
+              <a:t>ללא שינוי</a:t>
+            </a:r>
+          </a:p>
+        </p:txBody>
+      </p:sp>
+      <p:sp>
+        <p:nvSpPr>
+          <p:cNvPr id="26" name="Rounded Rectangle 25"/>
+          <p:cNvSpPr/>
+          <p:nvPr/>
+        </p:nvSpPr>
+        <p:spPr>
+          <a:xfrm>
+            <a:off x="5440680" y="3419856"/>
+            <a:ext cx="6339535" cy="512064"/>
+          </a:xfrm>
+          <a:prstGeom prst="roundRect">
+            <a:avLst>
+              <a:gd name="adj" fmla="val 15000"/>
+            </a:avLst>
+          </a:prstGeom>
+          <a:solidFill>
+            <a:srgbClr val="FFFFFF"/>
+          </a:solidFill>
+          <a:ln w="15875">
+            <a:solidFill>
+              <a:srgbClr val="C5CDDD"/>
+            </a:solidFill>
+          </a:ln>
+          <a:effectLst/>
+        </p:spPr>
+        <p:style>
+          <a:lnRef idx="1">
+            <a:schemeClr val="accent1"/>
+          </a:lnRef>
+          <a:fillRef idx="3">
+            <a:schemeClr val="accent1"/>
+          </a:fillRef>
+          <a:effectRef idx="2">
+            <a:schemeClr val="accent1"/>
+          </a:effectRef>
+          <a:fontRef idx="minor">
+            <a:schemeClr val="lt1"/>
+          </a:fontRef>
+        </p:style>
+        <p:txBody>
+          <a:bodyPr rtlCol="0" anchor="ctr"/>
+          <a:lstStyle/>
+          <a:p>
+            <a:pPr algn="ctr"/>
+          </a:p>
+        </p:txBody>
+      </p:sp>
+      <p:sp>
+        <p:nvSpPr>
+          <p:cNvPr id="27" name="TextBox 26"/>
+          <p:cNvSpPr txBox="1"/>
+          <p:nvPr/>
+        </p:nvSpPr>
+        <p:spPr>
+          <a:xfrm>
+            <a:off x="8275320" y="3419856"/>
+            <a:ext cx="3322015" cy="512064"/>
+          </a:xfrm>
+          <a:prstGeom prst="rect">
+            <a:avLst/>
+          </a:prstGeom>
+          <a:noFill/>
+        </p:spPr>
+        <p:txBody>
+          <a:bodyPr wrap="square" anchor="ctr" lIns="36576" rIns="36576" tIns="0" bIns="0">
+            <a:spAutoFit/>
+          </a:bodyPr>
+          <a:lstStyle/>
+          <a:p>
+            <a:pPr algn="r" rtl="1"/>
+            <a:r>
+              <a:rPr sz="1300" b="1">
+                <a:solidFill>
+                  <a:srgbClr val="1A2233"/>
+                </a:solidFill>
+                <a:latin typeface="Heebo"/>
+                <a:cs typeface="Heebo"/>
+              </a:rPr>
+              <a:t>חברי דירקטוריון · 2 דיונים</a:t>
+            </a:r>
+          </a:p>
+        </p:txBody>
+      </p:sp>
+      <p:sp>
+        <p:nvSpPr>
+          <p:cNvPr id="28" name="TextBox 27"/>
+          <p:cNvSpPr txBox="1"/>
+          <p:nvPr/>
+        </p:nvSpPr>
+        <p:spPr>
+          <a:xfrm>
+            <a:off x="6903720" y="3419856"/>
+            <a:ext cx="1280160" cy="512064"/>
+          </a:xfrm>
+          <a:prstGeom prst="rect">
+            <a:avLst/>
+          </a:prstGeom>
+          <a:noFill/>
+        </p:spPr>
+        <p:txBody>
+          <a:bodyPr wrap="square" anchor="ctr" lIns="36576" rIns="36576" tIns="0" bIns="0">
+            <a:spAutoFit/>
+          </a:bodyPr>
+          <a:lstStyle/>
+          <a:p>
+            <a:pPr algn="ctr" rtl="1"/>
+            <a:r>
+              <a:rPr sz="1400" b="1">
+                <a:solidFill>
+                  <a:srgbClr val="1C3C7A"/>
+                </a:solidFill>
+                <a:latin typeface="Heebo"/>
+                <a:cs typeface="Heebo"/>
+              </a:rPr>
+              <a:t>750 ₪</a:t>
+            </a:r>
+          </a:p>
+        </p:txBody>
+      </p:sp>
+      <p:sp>
+        <p:nvSpPr>
+          <p:cNvPr id="29" name="Rounded Rectangle 28"/>
+          <p:cNvSpPr/>
+          <p:nvPr/>
+        </p:nvSpPr>
+        <p:spPr>
+          <a:xfrm>
+            <a:off x="5577840" y="3529584"/>
+            <a:ext cx="1234440" cy="292608"/>
+          </a:xfrm>
+          <a:prstGeom prst="roundRect">
+            <a:avLst>
+              <a:gd name="adj" fmla="val 50000"/>
+            </a:avLst>
+          </a:prstGeom>
+          <a:solidFill>
+            <a:srgbClr val="F4F6FB"/>
+          </a:solidFill>
+          <a:ln>
+            <a:noFill/>
+          </a:ln>
+          <a:effectLst/>
+        </p:spPr>
+        <p:style>
+          <a:lnRef idx="1">
+            <a:schemeClr val="accent1"/>
+          </a:lnRef>
+          <a:fillRef idx="3">
+            <a:schemeClr val="accent1"/>
+          </a:fillRef>
+          <a:effectRef idx="2">
+            <a:schemeClr val="accent1"/>
+          </a:effectRef>
+          <a:fontRef idx="minor">
+            <a:schemeClr val="lt1"/>
+          </a:fontRef>
+        </p:style>
+        <p:txBody>
+          <a:bodyPr rtlCol="0" anchor="ctr"/>
+          <a:lstStyle/>
+          <a:p>
+            <a:pPr algn="ctr"/>
+          </a:p>
+        </p:txBody>
+      </p:sp>
+      <p:sp>
+        <p:nvSpPr>
+          <p:cNvPr id="30" name="TextBox 29"/>
+          <p:cNvSpPr txBox="1"/>
+          <p:nvPr/>
+        </p:nvSpPr>
+        <p:spPr>
+          <a:xfrm>
+            <a:off x="5577840" y="3529584"/>
+            <a:ext cx="1234440" cy="292608"/>
+          </a:xfrm>
+          <a:prstGeom prst="rect">
+            <a:avLst/>
+          </a:prstGeom>
+          <a:noFill/>
+        </p:spPr>
+        <p:txBody>
+          <a:bodyPr wrap="square" anchor="ctr" lIns="36576" rIns="36576" tIns="0" bIns="0">
+            <a:spAutoFit/>
+          </a:bodyPr>
+          <a:lstStyle/>
+          <a:p>
+            <a:pPr algn="ctr" rtl="1"/>
+            <a:r>
+              <a:rPr sz="1000" b="0">
+                <a:solidFill>
+                  <a:srgbClr val="8A94A8"/>
+                </a:solidFill>
+                <a:latin typeface="Heebo"/>
+                <a:cs typeface="Heebo"/>
+              </a:rPr>
+              <a:t>במקום נציג 4</a:t>
+            </a:r>
+          </a:p>
+        </p:txBody>
+      </p:sp>
+      <p:sp>
+        <p:nvSpPr>
+          <p:cNvPr id="31" name="Rounded Rectangle 30"/>
+          <p:cNvSpPr/>
+          <p:nvPr/>
+        </p:nvSpPr>
+        <p:spPr>
+          <a:xfrm>
+            <a:off x="5440680" y="4005072"/>
+            <a:ext cx="6339535" cy="512064"/>
+          </a:xfrm>
+          <a:prstGeom prst="roundRect">
+            <a:avLst>
+              <a:gd name="adj" fmla="val 15000"/>
+            </a:avLst>
+          </a:prstGeom>
+          <a:solidFill>
+            <a:srgbClr val="FFFFFF"/>
+          </a:solidFill>
+          <a:ln w="15875">
+            <a:solidFill>
+              <a:srgbClr val="C5CDDD"/>
+            </a:solidFill>
+          </a:ln>
+          <a:effectLst/>
+        </p:spPr>
+        <p:style>
+          <a:lnRef idx="1">
+            <a:schemeClr val="accent1"/>
+          </a:lnRef>
+          <a:fillRef idx="3">
+            <a:schemeClr val="accent1"/>
+          </a:fillRef>
+          <a:effectRef idx="2">
+            <a:schemeClr val="accent1"/>
+          </a:effectRef>
+          <a:fontRef idx="minor">
+            <a:schemeClr val="lt1"/>
+          </a:fontRef>
+        </p:style>
+        <p:txBody>
+          <a:bodyPr rtlCol="0" anchor="ctr"/>
+          <a:lstStyle/>
+          <a:p>
+            <a:pPr algn="ctr"/>
+          </a:p>
+        </p:txBody>
+      </p:sp>
+      <p:sp>
+        <p:nvSpPr>
+          <p:cNvPr id="32" name="TextBox 31"/>
+          <p:cNvSpPr txBox="1"/>
+          <p:nvPr/>
+        </p:nvSpPr>
+        <p:spPr>
+          <a:xfrm>
+            <a:off x="8275320" y="4005072"/>
+            <a:ext cx="3322015" cy="512064"/>
+          </a:xfrm>
+          <a:prstGeom prst="rect">
+            <a:avLst/>
+          </a:prstGeom>
+          <a:noFill/>
+        </p:spPr>
+        <p:txBody>
+          <a:bodyPr wrap="square" anchor="ctr" lIns="36576" rIns="36576" tIns="0" bIns="0">
+            <a:spAutoFit/>
+          </a:bodyPr>
+          <a:lstStyle/>
+          <a:p>
+            <a:pPr algn="r" rtl="1"/>
+            <a:r>
+              <a:rPr sz="1300" b="1">
+                <a:solidFill>
+                  <a:srgbClr val="1A2233"/>
+                </a:solidFill>
+                <a:latin typeface="Heebo"/>
+                <a:cs typeface="Heebo"/>
+              </a:rPr>
+              <a:t>אקטיביסטים · 2 דיונים</a:t>
+            </a:r>
+          </a:p>
+        </p:txBody>
+      </p:sp>
+      <p:sp>
+        <p:nvSpPr>
+          <p:cNvPr id="33" name="TextBox 32"/>
+          <p:cNvSpPr txBox="1"/>
+          <p:nvPr/>
+        </p:nvSpPr>
+        <p:spPr>
+          <a:xfrm>
+            <a:off x="6903720" y="4005072"/>
+            <a:ext cx="1280160" cy="512064"/>
+          </a:xfrm>
+          <a:prstGeom prst="rect">
+            <a:avLst/>
+          </a:prstGeom>
+          <a:noFill/>
+        </p:spPr>
+        <p:txBody>
+          <a:bodyPr wrap="square" anchor="ctr" lIns="36576" rIns="36576" tIns="0" bIns="0">
+            <a:spAutoFit/>
+          </a:bodyPr>
+          <a:lstStyle/>
+          <a:p>
+            <a:pPr algn="ctr" rtl="1"/>
+            <a:r>
+              <a:rPr sz="1400" b="1">
+                <a:solidFill>
+                  <a:srgbClr val="1C3C7A"/>
+                </a:solidFill>
+                <a:latin typeface="Heebo"/>
+                <a:cs typeface="Heebo"/>
+              </a:rPr>
+              <a:t>בהתנדבות</a:t>
+            </a:r>
+          </a:p>
+        </p:txBody>
+      </p:sp>
+      <p:sp>
+        <p:nvSpPr>
+          <p:cNvPr id="34" name="Rounded Rectangle 33"/>
+          <p:cNvSpPr/>
+          <p:nvPr/>
+        </p:nvSpPr>
+        <p:spPr>
+          <a:xfrm>
+            <a:off x="5577840" y="4114800"/>
+            <a:ext cx="1234440" cy="292608"/>
+          </a:xfrm>
+          <a:prstGeom prst="roundRect">
+            <a:avLst>
+              <a:gd name="adj" fmla="val 50000"/>
+            </a:avLst>
+          </a:prstGeom>
+          <a:solidFill>
+            <a:srgbClr val="F4F6FB"/>
+          </a:solidFill>
+          <a:ln>
+            <a:noFill/>
+          </a:ln>
+          <a:effectLst/>
+        </p:spPr>
+        <p:style>
+          <a:lnRef idx="1">
+            <a:schemeClr val="accent1"/>
+          </a:lnRef>
+          <a:fillRef idx="3">
+            <a:schemeClr val="accent1"/>
+          </a:fillRef>
+          <a:effectRef idx="2">
+            <a:schemeClr val="accent1"/>
+          </a:effectRef>
+          <a:fontRef idx="minor">
+            <a:schemeClr val="lt1"/>
+          </a:fontRef>
+        </p:style>
+        <p:txBody>
+          <a:bodyPr rtlCol="0" anchor="ctr"/>
+          <a:lstStyle/>
+          <a:p>
+            <a:pPr algn="ctr"/>
+          </a:p>
+        </p:txBody>
+      </p:sp>
+      <p:sp>
+        <p:nvSpPr>
+          <p:cNvPr id="35" name="TextBox 34"/>
+          <p:cNvSpPr txBox="1"/>
+          <p:nvPr/>
+        </p:nvSpPr>
+        <p:spPr>
+          <a:xfrm>
+            <a:off x="5577840" y="4114800"/>
+            <a:ext cx="1234440" cy="292608"/>
+          </a:xfrm>
+          <a:prstGeom prst="rect">
+            <a:avLst/>
+          </a:prstGeom>
+          <a:noFill/>
+        </p:spPr>
+        <p:txBody>
+          <a:bodyPr wrap="square" anchor="ctr" lIns="36576" rIns="36576" tIns="0" bIns="0">
+            <a:spAutoFit/>
+          </a:bodyPr>
+          <a:lstStyle/>
+          <a:p>
+            <a:pPr algn="ctr" rtl="1"/>
+            <a:r>
+              <a:rPr sz="1000" b="0">
+                <a:solidFill>
+                  <a:srgbClr val="8A94A8"/>
+                </a:solidFill>
+                <a:latin typeface="Heebo"/>
+                <a:cs typeface="Heebo"/>
+              </a:rPr>
+              <a:t>חדש</a:t>
+            </a:r>
+          </a:p>
+        </p:txBody>
+      </p:sp>
+      <p:sp>
+        <p:nvSpPr>
+          <p:cNvPr id="36" name="Rounded Rectangle 35"/>
+          <p:cNvSpPr/>
+          <p:nvPr/>
+        </p:nvSpPr>
+        <p:spPr>
+          <a:xfrm>
+            <a:off x="5440680" y="4590288"/>
+            <a:ext cx="6339535" cy="512064"/>
+          </a:xfrm>
+          <a:prstGeom prst="roundRect">
+            <a:avLst>
+              <a:gd name="adj" fmla="val 15000"/>
+            </a:avLst>
+          </a:prstGeom>
+          <a:solidFill>
+            <a:srgbClr val="FFFFFF"/>
+          </a:solidFill>
+          <a:ln w="15875">
+            <a:solidFill>
+              <a:srgbClr val="C5CDDD"/>
+            </a:solidFill>
+          </a:ln>
+          <a:effectLst/>
+        </p:spPr>
+        <p:style>
+          <a:lnRef idx="1">
+            <a:schemeClr val="accent1"/>
+          </a:lnRef>
+          <a:fillRef idx="3">
+            <a:schemeClr val="accent1"/>
+          </a:fillRef>
+          <a:effectRef idx="2">
+            <a:schemeClr val="accent1"/>
+          </a:effectRef>
+          <a:fontRef idx="minor">
+            <a:schemeClr val="lt1"/>
+          </a:fontRef>
+        </p:style>
+        <p:txBody>
+          <a:bodyPr rtlCol="0" anchor="ctr"/>
+          <a:lstStyle/>
+          <a:p>
+            <a:pPr algn="ctr"/>
+          </a:p>
+        </p:txBody>
+      </p:sp>
+      <p:sp>
+        <p:nvSpPr>
+          <p:cNvPr id="37" name="TextBox 36"/>
+          <p:cNvSpPr txBox="1"/>
+          <p:nvPr/>
+        </p:nvSpPr>
+        <p:spPr>
+          <a:xfrm>
+            <a:off x="8275320" y="4590288"/>
+            <a:ext cx="3322015" cy="512064"/>
+          </a:xfrm>
+          <a:prstGeom prst="rect">
+            <a:avLst/>
+          </a:prstGeom>
+          <a:noFill/>
+        </p:spPr>
+        <p:txBody>
+          <a:bodyPr wrap="square" anchor="ctr" lIns="36576" rIns="36576" tIns="0" bIns="0">
+            <a:spAutoFit/>
+          </a:bodyPr>
+          <a:lstStyle/>
+          <a:p>
+            <a:pPr algn="r" rtl="1"/>
+            <a:r>
+              <a:rPr sz="1300" b="1">
+                <a:solidFill>
+                  <a:srgbClr val="1A2233"/>
+                </a:solidFill>
+                <a:latin typeface="Heebo"/>
+                <a:cs typeface="Heebo"/>
+              </a:rPr>
+              <a:t>תמיר דורטל · 4 דיונים</a:t>
+            </a:r>
+          </a:p>
+        </p:txBody>
+      </p:sp>
+      <p:sp>
+        <p:nvSpPr>
+          <p:cNvPr id="38" name="TextBox 37"/>
+          <p:cNvSpPr txBox="1"/>
+          <p:nvPr/>
+        </p:nvSpPr>
+        <p:spPr>
+          <a:xfrm>
+            <a:off x="6903720" y="4590288"/>
+            <a:ext cx="1280160" cy="512064"/>
+          </a:xfrm>
+          <a:prstGeom prst="rect">
+            <a:avLst/>
+          </a:prstGeom>
+          <a:noFill/>
+        </p:spPr>
+        <p:txBody>
+          <a:bodyPr wrap="square" anchor="ctr" lIns="36576" rIns="36576" tIns="0" bIns="0">
+            <a:spAutoFit/>
+          </a:bodyPr>
+          <a:lstStyle/>
+          <a:p>
+            <a:pPr algn="ctr" rtl="1"/>
+            <a:r>
+              <a:rPr sz="1400" b="1">
+                <a:solidFill>
+                  <a:srgbClr val="1C3C7A"/>
+                </a:solidFill>
+                <a:latin typeface="Heebo"/>
+                <a:cs typeface="Heebo"/>
+              </a:rPr>
+              <a:t>—</a:t>
+            </a:r>
+          </a:p>
+        </p:txBody>
+      </p:sp>
+      <p:sp>
+        <p:nvSpPr>
+          <p:cNvPr id="39" name="Rounded Rectangle 38"/>
+          <p:cNvSpPr/>
+          <p:nvPr/>
+        </p:nvSpPr>
+        <p:spPr>
+          <a:xfrm>
+            <a:off x="5577840" y="4700016"/>
+            <a:ext cx="1234440" cy="292608"/>
+          </a:xfrm>
+          <a:prstGeom prst="roundRect">
+            <a:avLst>
+              <a:gd name="adj" fmla="val 50000"/>
+            </a:avLst>
+          </a:prstGeom>
+          <a:solidFill>
+            <a:srgbClr val="F4F6FB"/>
+          </a:solidFill>
+          <a:ln>
+            <a:noFill/>
+          </a:ln>
+          <a:effectLst/>
+        </p:spPr>
+        <p:style>
+          <a:lnRef idx="1">
+            <a:schemeClr val="accent1"/>
+          </a:lnRef>
+          <a:fillRef idx="3">
+            <a:schemeClr val="accent1"/>
+          </a:fillRef>
+          <a:effectRef idx="2">
+            <a:schemeClr val="accent1"/>
+          </a:effectRef>
+          <a:fontRef idx="minor">
+            <a:schemeClr val="lt1"/>
+          </a:fontRef>
+        </p:style>
+        <p:txBody>
+          <a:bodyPr rtlCol="0" anchor="ctr"/>
+          <a:lstStyle/>
+          <a:p>
+            <a:pPr algn="ctr"/>
+          </a:p>
+        </p:txBody>
+      </p:sp>
+      <p:sp>
+        <p:nvSpPr>
+          <p:cNvPr id="40" name="TextBox 39"/>
+          <p:cNvSpPr txBox="1"/>
+          <p:nvPr/>
+        </p:nvSpPr>
+        <p:spPr>
+          <a:xfrm>
+            <a:off x="5577840" y="4700016"/>
+            <a:ext cx="1234440" cy="292608"/>
+          </a:xfrm>
+          <a:prstGeom prst="rect">
+            <a:avLst/>
+          </a:prstGeom>
+          <a:noFill/>
+        </p:spPr>
+        <p:txBody>
+          <a:bodyPr wrap="square" anchor="ctr" lIns="36576" rIns="36576" tIns="0" bIns="0">
+            <a:spAutoFit/>
+          </a:bodyPr>
+          <a:lstStyle/>
+          <a:p>
+            <a:pPr algn="ctr" rtl="1"/>
+            <a:r>
+              <a:rPr sz="1000" b="0">
+                <a:solidFill>
+                  <a:srgbClr val="8A94A8"/>
+                </a:solidFill>
+                <a:latin typeface="Heebo"/>
+                <a:cs typeface="Heebo"/>
+              </a:rPr>
+              <a:t>בעלים</a:t>
+            </a:r>
+          </a:p>
+        </p:txBody>
+      </p:sp>
+      <p:sp>
+        <p:nvSpPr>
+          <p:cNvPr id="41" name="Rounded Rectangle 40"/>
+          <p:cNvSpPr/>
+          <p:nvPr/>
+        </p:nvSpPr>
+        <p:spPr>
+          <a:xfrm>
+            <a:off x="411480" y="1188720"/>
+            <a:ext cx="4754880" cy="2331720"/>
+          </a:xfrm>
+          <a:prstGeom prst="roundRect">
+            <a:avLst>
+              <a:gd name="adj" fmla="val 6000"/>
+            </a:avLst>
+          </a:prstGeom>
+          <a:solidFill>
+            <a:srgbClr val="1C3C7A"/>
+          </a:solidFill>
+          <a:ln>
+            <a:noFill/>
+          </a:ln>
+          <a:effectLst/>
+        </p:spPr>
+        <p:style>
+          <a:lnRef idx="1">
+            <a:schemeClr val="accent1"/>
+          </a:lnRef>
+          <a:fillRef idx="3">
+            <a:schemeClr val="accent1"/>
+          </a:fillRef>
+          <a:effectRef idx="2">
+            <a:schemeClr val="accent1"/>
+          </a:effectRef>
+          <a:fontRef idx="minor">
+            <a:schemeClr val="lt1"/>
+          </a:fontRef>
+        </p:style>
+        <p:txBody>
+          <a:bodyPr rtlCol="0" anchor="ctr"/>
+          <a:lstStyle/>
+          <a:p>
+            <a:pPr algn="ctr"/>
+          </a:p>
+        </p:txBody>
+      </p:sp>
+      <p:sp>
+        <p:nvSpPr>
+          <p:cNvPr id="42" name="TextBox 41"/>
+          <p:cNvSpPr txBox="1"/>
+          <p:nvPr/>
+        </p:nvSpPr>
+        <p:spPr>
+          <a:xfrm>
+            <a:off x="411480" y="1325880"/>
+            <a:ext cx="4754880" cy="274320"/>
+          </a:xfrm>
+          <a:prstGeom prst="rect">
+            <a:avLst/>
+          </a:prstGeom>
+          <a:noFill/>
+        </p:spPr>
+        <p:txBody>
+          <a:bodyPr wrap="square" anchor="ctr" lIns="36576" rIns="36576" tIns="0" bIns="0">
+            <a:spAutoFit/>
+          </a:bodyPr>
+          <a:lstStyle/>
+          <a:p>
+            <a:pPr algn="ctr" rtl="1"/>
+            <a:r>
+              <a:rPr sz="1300" b="0">
+                <a:solidFill>
+                  <a:srgbClr val="F0C000"/>
+                </a:solidFill>
+                <a:latin typeface="Heebo"/>
+                <a:cs typeface="Heebo"/>
+              </a:rPr>
+              <a:t>עלות חודשית</a:t>
+            </a:r>
+          </a:p>
+        </p:txBody>
+      </p:sp>
+      <p:sp>
+        <p:nvSpPr>
+          <p:cNvPr id="43" name="TextBox 42"/>
+          <p:cNvSpPr txBox="1"/>
+          <p:nvPr/>
+        </p:nvSpPr>
+        <p:spPr>
+          <a:xfrm>
+            <a:off x="411480" y="1600200"/>
+            <a:ext cx="4754880" cy="731520"/>
+          </a:xfrm>
+          <a:prstGeom prst="rect">
+            <a:avLst/>
+          </a:prstGeom>
+          <a:noFill/>
+        </p:spPr>
+        <p:txBody>
+          <a:bodyPr wrap="square" anchor="ctr" lIns="36576" rIns="36576" tIns="0" bIns="0">
+            <a:spAutoFit/>
+          </a:bodyPr>
+          <a:lstStyle/>
+          <a:p>
+            <a:pPr algn="ctr" rtl="1"/>
+            <a:r>
+              <a:rPr sz="4400" b="1">
+                <a:solidFill>
+                  <a:srgbClr val="FFFFFF"/>
+                </a:solidFill>
+                <a:latin typeface="Heebo"/>
+                <a:cs typeface="Heebo"/>
+              </a:rPr>
+              <a:t>22,750 ₪</a:t>
+            </a:r>
+          </a:p>
+        </p:txBody>
+      </p:sp>
+      <p:sp>
+        <p:nvSpPr>
+          <p:cNvPr id="44" name="TextBox 43"/>
+          <p:cNvSpPr txBox="1"/>
+          <p:nvPr/>
+        </p:nvSpPr>
+        <p:spPr>
+          <a:xfrm>
+            <a:off x="411480" y="2304288"/>
+            <a:ext cx="4754880" cy="274320"/>
+          </a:xfrm>
+          <a:prstGeom prst="rect">
+            <a:avLst/>
+          </a:prstGeom>
+          <a:noFill/>
+        </p:spPr>
+        <p:txBody>
+          <a:bodyPr wrap="square" anchor="ctr" lIns="36576" rIns="36576" tIns="0" bIns="0">
+            <a:spAutoFit/>
+          </a:bodyPr>
+          <a:lstStyle/>
+          <a:p>
+            <a:pPr algn="ctr" rtl="1"/>
+            <a:r>
+              <a:rPr sz="1300" b="0">
+                <a:solidFill>
+                  <a:srgbClr val="FFFFFF"/>
+                </a:solidFill>
+                <a:latin typeface="Heebo"/>
+                <a:cs typeface="Heebo"/>
+              </a:rPr>
+              <a:t>273,000 ₪ בשנה</a:t>
+            </a:r>
+          </a:p>
+        </p:txBody>
+      </p:sp>
+      <p:sp>
+        <p:nvSpPr>
+          <p:cNvPr id="45" name="Rounded Rectangle 44"/>
+          <p:cNvSpPr/>
+          <p:nvPr/>
+        </p:nvSpPr>
+        <p:spPr>
+          <a:xfrm>
+            <a:off x="2834640" y="2697480"/>
+            <a:ext cx="2148840" cy="658368"/>
+          </a:xfrm>
+          <a:prstGeom prst="roundRect">
+            <a:avLst>
+              <a:gd name="adj" fmla="val 15000"/>
+            </a:avLst>
+          </a:prstGeom>
+          <a:solidFill>
+            <a:srgbClr val="2A4C8C"/>
+          </a:solidFill>
+          <a:ln>
+            <a:noFill/>
+          </a:ln>
+          <a:effectLst/>
+        </p:spPr>
+        <p:style>
+          <a:lnRef idx="1">
+            <a:schemeClr val="accent1"/>
+          </a:lnRef>
+          <a:fillRef idx="3">
+            <a:schemeClr val="accent1"/>
+          </a:fillRef>
+          <a:effectRef idx="2">
+            <a:schemeClr val="accent1"/>
+          </a:effectRef>
+          <a:fontRef idx="minor">
+            <a:schemeClr val="lt1"/>
+          </a:fontRef>
+        </p:style>
+        <p:txBody>
+          <a:bodyPr rtlCol="0" anchor="ctr"/>
+          <a:lstStyle/>
+          <a:p>
+            <a:pPr algn="ctr"/>
+          </a:p>
+        </p:txBody>
+      </p:sp>
+      <p:sp>
+        <p:nvSpPr>
+          <p:cNvPr id="46" name="TextBox 45"/>
+          <p:cNvSpPr txBox="1"/>
+          <p:nvPr/>
+        </p:nvSpPr>
+        <p:spPr>
+          <a:xfrm>
+            <a:off x="2834640" y="2715768"/>
+            <a:ext cx="2148840" cy="347472"/>
+          </a:xfrm>
+          <a:prstGeom prst="rect">
+            <a:avLst/>
+          </a:prstGeom>
+          <a:noFill/>
+        </p:spPr>
+        <p:txBody>
+          <a:bodyPr wrap="square" anchor="ctr" lIns="36576" rIns="36576" tIns="0" bIns="0">
+            <a:spAutoFit/>
+          </a:bodyPr>
+          <a:lstStyle/>
+          <a:p>
+            <a:pPr algn="ctr" rtl="1"/>
+            <a:r>
+              <a:rPr sz="1700" b="1">
+                <a:solidFill>
+                  <a:srgbClr val="FFFFFF"/>
+                </a:solidFill>
+                <a:latin typeface="Heebo"/>
+                <a:cs typeface="Heebo"/>
+              </a:rPr>
+              <a:t>13</a:t>
+            </a:r>
+          </a:p>
+        </p:txBody>
+      </p:sp>
+      <p:sp>
+        <p:nvSpPr>
+          <p:cNvPr id="47" name="TextBox 46"/>
+          <p:cNvSpPr txBox="1"/>
+          <p:nvPr/>
+        </p:nvSpPr>
+        <p:spPr>
+          <a:xfrm>
+            <a:off x="2834640" y="3054096"/>
+            <a:ext cx="2148840" cy="256032"/>
+          </a:xfrm>
+          <a:prstGeom prst="rect">
+            <a:avLst/>
+          </a:prstGeom>
+          <a:noFill/>
+        </p:spPr>
+        <p:txBody>
+          <a:bodyPr wrap="square" anchor="ctr" lIns="36576" rIns="36576" tIns="0" bIns="0">
+            <a:spAutoFit/>
+          </a:bodyPr>
+          <a:lstStyle/>
+          <a:p>
+            <a:pPr algn="ctr" rtl="1"/>
+            <a:r>
+              <a:rPr sz="1000" b="0">
+                <a:solidFill>
+                  <a:srgbClr val="F0C000"/>
+                </a:solidFill>
+                <a:latin typeface="Heebo"/>
+                <a:cs typeface="Heebo"/>
+              </a:rPr>
+              <a:t>דיונים בחודש</a:t>
+            </a:r>
+          </a:p>
+        </p:txBody>
+      </p:sp>
+      <p:sp>
+        <p:nvSpPr>
+          <p:cNvPr id="48" name="Rounded Rectangle 47"/>
+          <p:cNvSpPr/>
+          <p:nvPr/>
+        </p:nvSpPr>
+        <p:spPr>
+          <a:xfrm>
+            <a:off x="594360" y="2697480"/>
+            <a:ext cx="2148840" cy="658368"/>
+          </a:xfrm>
+          <a:prstGeom prst="roundRect">
+            <a:avLst>
+              <a:gd name="adj" fmla="val 15000"/>
+            </a:avLst>
+          </a:prstGeom>
+          <a:solidFill>
+            <a:srgbClr val="2A4C8C"/>
+          </a:solidFill>
+          <a:ln>
+            <a:noFill/>
+          </a:ln>
+          <a:effectLst/>
+        </p:spPr>
+        <p:style>
+          <a:lnRef idx="1">
+            <a:schemeClr val="accent1"/>
+          </a:lnRef>
+          <a:fillRef idx="3">
+            <a:schemeClr val="accent1"/>
+          </a:fillRef>
+          <a:effectRef idx="2">
+            <a:schemeClr val="accent1"/>
+          </a:effectRef>
+          <a:fontRef idx="minor">
+            <a:schemeClr val="lt1"/>
+          </a:fontRef>
+        </p:style>
+        <p:txBody>
+          <a:bodyPr rtlCol="0" anchor="ctr"/>
+          <a:lstStyle/>
+          <a:p>
+            <a:pPr algn="ctr"/>
+          </a:p>
+        </p:txBody>
+      </p:sp>
+      <p:sp>
+        <p:nvSpPr>
+          <p:cNvPr id="49" name="TextBox 48"/>
+          <p:cNvSpPr txBox="1"/>
+          <p:nvPr/>
+        </p:nvSpPr>
+        <p:spPr>
+          <a:xfrm>
+            <a:off x="594360" y="2715768"/>
+            <a:ext cx="2148840" cy="347472"/>
+          </a:xfrm>
+          <a:prstGeom prst="rect">
+            <a:avLst/>
+          </a:prstGeom>
+          <a:noFill/>
+        </p:spPr>
+        <p:txBody>
+          <a:bodyPr wrap="square" anchor="ctr" lIns="36576" rIns="36576" tIns="0" bIns="0">
+            <a:spAutoFit/>
+          </a:bodyPr>
+          <a:lstStyle/>
+          <a:p>
+            <a:pPr algn="ctr" rtl="1"/>
+            <a:r>
+              <a:rPr sz="1700" b="1">
+                <a:solidFill>
+                  <a:srgbClr val="FFFFFF"/>
+                </a:solidFill>
+                <a:latin typeface="Heebo"/>
+                <a:cs typeface="Heebo"/>
+              </a:rPr>
+              <a:t>1,750 ₪</a:t>
+            </a:r>
+          </a:p>
+        </p:txBody>
+      </p:sp>
+      <p:sp>
+        <p:nvSpPr>
+          <p:cNvPr id="50" name="TextBox 49"/>
+          <p:cNvSpPr txBox="1"/>
+          <p:nvPr/>
+        </p:nvSpPr>
+        <p:spPr>
+          <a:xfrm>
+            <a:off x="594360" y="3054096"/>
+            <a:ext cx="2148840" cy="256032"/>
+          </a:xfrm>
+          <a:prstGeom prst="rect">
+            <a:avLst/>
+          </a:prstGeom>
+          <a:noFill/>
+        </p:spPr>
+        <p:txBody>
+          <a:bodyPr wrap="square" anchor="ctr" lIns="36576" rIns="36576" tIns="0" bIns="0">
+            <a:spAutoFit/>
+          </a:bodyPr>
+          <a:lstStyle/>
+          <a:p>
+            <a:pPr algn="ctr" rtl="1"/>
+            <a:r>
+              <a:rPr sz="1000" b="0">
+                <a:solidFill>
+                  <a:srgbClr val="F0C000"/>
+                </a:solidFill>
+                <a:latin typeface="Heebo"/>
+                <a:cs typeface="Heebo"/>
+              </a:rPr>
+              <a:t>לדיון</a:t>
+            </a:r>
+          </a:p>
+        </p:txBody>
+      </p:sp>
+      <p:sp>
+        <p:nvSpPr>
+          <p:cNvPr id="51" name="Rounded Rectangle 50"/>
+          <p:cNvSpPr/>
+          <p:nvPr/>
+        </p:nvSpPr>
+        <p:spPr>
+          <a:xfrm>
+            <a:off x="411480" y="3703320"/>
+            <a:ext cx="4754880" cy="2926080"/>
+          </a:xfrm>
+          <a:prstGeom prst="roundRect">
+            <a:avLst>
+              <a:gd name="adj" fmla="val 6000"/>
+            </a:avLst>
+          </a:prstGeom>
+          <a:solidFill>
+            <a:srgbClr val="FFFFFF"/>
+          </a:solidFill>
+          <a:ln w="15875">
+            <a:solidFill>
+              <a:srgbClr val="C5CDDD"/>
+            </a:solidFill>
+          </a:ln>
+          <a:effectLst/>
+        </p:spPr>
+        <p:style>
+          <a:lnRef idx="1">
+            <a:schemeClr val="accent1"/>
+          </a:lnRef>
+          <a:fillRef idx="3">
+            <a:schemeClr val="accent1"/>
+          </a:fillRef>
+          <a:effectRef idx="2">
+            <a:schemeClr val="accent1"/>
+          </a:effectRef>
+          <a:fontRef idx="minor">
+            <a:schemeClr val="lt1"/>
+          </a:fontRef>
+        </p:style>
+        <p:txBody>
+          <a:bodyPr rtlCol="0" anchor="ctr"/>
+          <a:lstStyle/>
+          <a:p>
+            <a:pPr algn="ctr"/>
+          </a:p>
+        </p:txBody>
+      </p:sp>
+      <p:sp>
+        <p:nvSpPr>
+          <p:cNvPr id="52" name="TextBox 51"/>
+          <p:cNvSpPr txBox="1"/>
+          <p:nvPr/>
+        </p:nvSpPr>
+        <p:spPr>
+          <a:xfrm>
+            <a:off x="594360" y="3813048"/>
+            <a:ext cx="4389120" cy="566928"/>
+          </a:xfrm>
+          <a:prstGeom prst="rect">
+            <a:avLst/>
+          </a:prstGeom>
+          <a:noFill/>
+        </p:spPr>
+        <p:txBody>
+          <a:bodyPr wrap="square" anchor="ctr" lIns="36576" rIns="36576" tIns="0" bIns="0">
+            <a:spAutoFit/>
+          </a:bodyPr>
+          <a:lstStyle/>
+          <a:p>
+            <a:pPr algn="r" rtl="1"/>
+            <a:r>
+              <a:rPr sz="1400" b="1">
+                <a:solidFill>
+                  <a:srgbClr val="1C3C7A"/>
+                </a:solidFill>
+                <a:latin typeface="Heebo"/>
+                <a:cs typeface="Heebo"/>
+              </a:rPr>
+              <a:t>מה משתנה בשלב הזה</a:t>
+            </a:r>
+          </a:p>
+        </p:txBody>
+      </p:sp>
+      <p:sp>
+        <p:nvSpPr>
+          <p:cNvPr id="53" name="TextBox 52"/>
+          <p:cNvSpPr txBox="1"/>
+          <p:nvPr/>
+        </p:nvSpPr>
+        <p:spPr>
+          <a:xfrm>
+            <a:off x="640080" y="4434840"/>
+            <a:ext cx="4297680" cy="548640"/>
+          </a:xfrm>
+          <a:prstGeom prst="rect">
+            <a:avLst/>
+          </a:prstGeom>
+          <a:noFill/>
+        </p:spPr>
+        <p:txBody>
+          <a:bodyPr wrap="square" anchor="t" lIns="36576" rIns="36576" tIns="0" bIns="0">
+            <a:spAutoFit/>
+          </a:bodyPr>
+          <a:lstStyle/>
+          <a:p>
+            <a:pPr algn="r" rtl="1"/>
+            <a:r>
+              <a:rPr sz="1200" b="0">
+                <a:solidFill>
+                  <a:srgbClr val="1A2233"/>
+                </a:solidFill>
+                <a:latin typeface="Heebo"/>
+                <a:cs typeface="Heebo"/>
+              </a:rPr>
+              <a:t>• אין נציג 4: הדיונים מתחלקים בין הצוות, הדירקטוריון והאקטיביסטים</a:t>
+            </a:r>
+          </a:p>
+        </p:txBody>
+      </p:sp>
+      <p:sp>
+        <p:nvSpPr>
+          <p:cNvPr id="54" name="TextBox 53"/>
+          <p:cNvSpPr txBox="1"/>
+          <p:nvPr/>
+        </p:nvSpPr>
+        <p:spPr>
+          <a:xfrm>
+            <a:off x="640080" y="5056632"/>
+            <a:ext cx="4297680" cy="548640"/>
+          </a:xfrm>
+          <a:prstGeom prst="rect">
+            <a:avLst/>
+          </a:prstGeom>
+          <a:noFill/>
+        </p:spPr>
+        <p:txBody>
+          <a:bodyPr wrap="square" anchor="t" lIns="36576" rIns="36576" tIns="0" bIns="0">
+            <a:spAutoFit/>
+          </a:bodyPr>
+          <a:lstStyle/>
+          <a:p>
+            <a:pPr algn="r" rtl="1"/>
+            <a:r>
+              <a:rPr sz="1200" b="0">
+                <a:solidFill>
+                  <a:srgbClr val="1A2233"/>
+                </a:solidFill>
+                <a:latin typeface="Heebo"/>
+                <a:cs typeface="Heebo"/>
+              </a:rPr>
+              <a:t>• תעריף פתיחה ליום כנסת: 300 ₪ חצי יום · 450 ₪ יום מלא</a:t>
+            </a:r>
+          </a:p>
+        </p:txBody>
+      </p:sp>
+      <p:sp>
+        <p:nvSpPr>
+          <p:cNvPr id="55" name="TextBox 54"/>
+          <p:cNvSpPr txBox="1"/>
+          <p:nvPr/>
+        </p:nvSpPr>
+        <p:spPr>
+          <a:xfrm>
+            <a:off x="640080" y="5678424"/>
+            <a:ext cx="4297680" cy="548640"/>
+          </a:xfrm>
+          <a:prstGeom prst="rect">
+            <a:avLst/>
+          </a:prstGeom>
+          <a:noFill/>
+        </p:spPr>
+        <p:txBody>
+          <a:bodyPr wrap="square" anchor="t" lIns="36576" rIns="36576" tIns="0" bIns="0">
+            <a:spAutoFit/>
+          </a:bodyPr>
+          <a:lstStyle/>
+          <a:p>
+            <a:pPr algn="r" rtl="1"/>
+            <a:r>
+              <a:rPr sz="1200" b="0">
+                <a:solidFill>
+                  <a:srgbClr val="1A2233"/>
+                </a:solidFill>
+                <a:latin typeface="Heebo"/>
+                <a:cs typeface="Heebo"/>
+              </a:rPr>
+              <a:t>• סדר היום לשבוע הבא נסגר עד חמישי בבוקר</a:t>
+            </a:r>
+          </a:p>
+        </p:txBody>
+      </p:sp>
+    </p:spTree>
+  </p:cSld>
+  <p:clrMapOvr>
+    <a:masterClrMapping/>
+  </p:clrMapOvr>
+</p:sld>
+</file>
+
+<file path=ppt/slides/slide11.xml><?xml version="1.0" encoding="utf-8"?>
+<p:sld xmlns:a="http://schemas.openxmlformats.org/drawingml/2006/main" xmlns:p="http://schemas.openxmlformats.org/presentationml/2006/main" xmlns:r="http://schemas.openxmlformats.org/officeDocument/2006/relationships">
+  <p:cSld>
+    <p:bg>
+      <p:bgPr>
+        <a:solidFill>
+          <a:srgbClr val="F4F6FB"/>
+        </a:solidFill>
+        <a:effectLst/>
+      </p:bgPr>
+    </p:bg>
+    <p:spTree>
+      <p:nvGrpSpPr>
+        <p:cNvPr id="1" name=""/>
+        <p:cNvGrpSpPr/>
+        <p:nvPr/>
+      </p:nvGrpSpPr>
+      <p:grpSpPr/>
+      <p:sp>
+        <p:nvSpPr>
+          <p:cNvPr id="2" name="Rectangle 1"/>
+          <p:cNvSpPr/>
+          <p:nvPr/>
+        </p:nvSpPr>
+        <p:spPr>
+          <a:xfrm>
+            <a:off x="0" y="0"/>
+            <a:ext cx="12191695" cy="868680"/>
+          </a:xfrm>
+          <a:prstGeom prst="rect">
+            <a:avLst/>
+          </a:prstGeom>
+          <a:solidFill>
+            <a:srgbClr val="1C3C7A"/>
+          </a:solidFill>
+          <a:ln>
+            <a:noFill/>
+          </a:ln>
+          <a:effectLst/>
+        </p:spPr>
+        <p:style>
+          <a:lnRef idx="1">
+            <a:schemeClr val="accent1"/>
+          </a:lnRef>
+          <a:fillRef idx="3">
+            <a:schemeClr val="accent1"/>
+          </a:fillRef>
+          <a:effectRef idx="2">
+            <a:schemeClr val="accent1"/>
+          </a:effectRef>
+          <a:fontRef idx="minor">
+            <a:schemeClr val="lt1"/>
+          </a:fontRef>
+        </p:style>
+        <p:txBody>
+          <a:bodyPr rtlCol="0" anchor="ctr"/>
+          <a:lstStyle/>
+          <a:p>
+            <a:pPr algn="ctr"/>
+          </a:p>
+        </p:txBody>
+      </p:sp>
+      <p:sp>
+        <p:nvSpPr>
+          <p:cNvPr id="3" name="Rectangle 2"/>
+          <p:cNvSpPr/>
+          <p:nvPr/>
+        </p:nvSpPr>
+        <p:spPr>
+          <a:xfrm>
+            <a:off x="0" y="868680"/>
+            <a:ext cx="12191695" cy="54864"/>
+          </a:xfrm>
+          <a:prstGeom prst="rect">
+            <a:avLst/>
+          </a:prstGeom>
+          <a:solidFill>
+            <a:srgbClr val="F0C000"/>
+          </a:solidFill>
+          <a:ln>
+            <a:noFill/>
+          </a:ln>
+          <a:effectLst/>
+        </p:spPr>
+        <p:style>
+          <a:lnRef idx="1">
+            <a:schemeClr val="accent1"/>
+          </a:lnRef>
+          <a:fillRef idx="3">
+            <a:schemeClr val="accent1"/>
+          </a:fillRef>
+          <a:effectRef idx="2">
+            <a:schemeClr val="accent1"/>
+          </a:effectRef>
+          <a:fontRef idx="minor">
+            <a:schemeClr val="lt1"/>
+          </a:fontRef>
+        </p:style>
+        <p:txBody>
+          <a:bodyPr rtlCol="0" anchor="ctr"/>
+          <a:lstStyle/>
+          <a:p>
+            <a:pPr algn="ctr"/>
+          </a:p>
+        </p:txBody>
+      </p:sp>
+      <p:sp>
+        <p:nvSpPr>
+          <p:cNvPr id="4" name="TextBox 3"/>
+          <p:cNvSpPr txBox="1"/>
+          <p:nvPr/>
+        </p:nvSpPr>
+        <p:spPr>
+          <a:xfrm>
+            <a:off x="1280160" y="109728"/>
+            <a:ext cx="10515600" cy="457200"/>
+          </a:xfrm>
+          <a:prstGeom prst="rect">
+            <a:avLst/>
+          </a:prstGeom>
+          <a:noFill/>
+        </p:spPr>
+        <p:txBody>
+          <a:bodyPr wrap="square" anchor="ctr" lIns="36576" rIns="36576" tIns="0" bIns="0">
+            <a:spAutoFit/>
+          </a:bodyPr>
+          <a:lstStyle/>
+          <a:p>
+            <a:pPr algn="r" rtl="1"/>
+            <a:r>
+              <a:rPr sz="2600" b="1">
+                <a:solidFill>
+                  <a:srgbClr val="FFFFFF"/>
+                </a:solidFill>
+                <a:latin typeface="Heebo"/>
+                <a:cs typeface="Heebo"/>
+              </a:rPr>
+              <a:t>שלב ב׳ · שכר מספק למערך מלא</a:t>
+            </a:r>
+          </a:p>
+        </p:txBody>
+      </p:sp>
+      <p:sp>
+        <p:nvSpPr>
+          <p:cNvPr id="6" name="Rounded Rectangle 5"/>
+          <p:cNvSpPr/>
+          <p:nvPr/>
+        </p:nvSpPr>
+        <p:spPr>
+          <a:xfrm>
+            <a:off x="265176" y="54864"/>
+            <a:ext cx="910550" cy="768096"/>
+          </a:xfrm>
+          <a:prstGeom prst="roundRect">
+            <a:avLst>
+              <a:gd name="adj" fmla="val 12000"/>
+            </a:avLst>
+          </a:prstGeom>
+          <a:solidFill>
+            <a:srgbClr val="FFFFFF"/>
+          </a:solidFill>
+          <a:ln>
+            <a:noFill/>
+          </a:ln>
+          <a:effectLst/>
+        </p:spPr>
+        <p:style>
+          <a:lnRef idx="1">
+            <a:schemeClr val="accent1"/>
+          </a:lnRef>
+          <a:fillRef idx="3">
+            <a:schemeClr val="accent1"/>
+          </a:fillRef>
+          <a:effectRef idx="2">
+            <a:schemeClr val="accent1"/>
+          </a:effectRef>
+          <a:fontRef idx="minor">
+            <a:schemeClr val="lt1"/>
+          </a:fontRef>
+        </p:style>
+        <p:txBody>
+          <a:bodyPr rtlCol="0" anchor="ctr"/>
+          <a:lstStyle/>
+          <a:p>
+            <a:pPr algn="ctr"/>
+          </a:p>
+        </p:txBody>
+      </p:sp>
+      <p:pic>
+        <p:nvPicPr>
+          <p:cNvPr id="5" name="Picture 4" descr="logo.png"/>
+          <p:cNvPicPr>
+            <a:picLocks noChangeAspect="1"/>
+          </p:cNvPicPr>
+          <p:nvPr/>
+        </p:nvPicPr>
+        <p:blipFill>
+          <a:blip r:embed="rId2"/>
+          <a:stretch>
+            <a:fillRect/>
+          </a:stretch>
+        </p:blipFill>
+        <p:spPr>
+          <a:xfrm>
+            <a:off x="320040" y="73152"/>
+            <a:ext cx="800822" cy="731520"/>
+          </a:xfrm>
+          <a:prstGeom prst="rect">
+            <a:avLst/>
+          </a:prstGeom>
+        </p:spPr>
+      </p:pic>
+      <p:sp>
+        <p:nvSpPr>
+          <p:cNvPr id="7" name="Rounded Rectangle 6"/>
+          <p:cNvSpPr/>
+          <p:nvPr/>
+        </p:nvSpPr>
+        <p:spPr>
+          <a:xfrm>
+            <a:off x="5440680" y="1188720"/>
+            <a:ext cx="6339535" cy="384048"/>
+          </a:xfrm>
+          <a:prstGeom prst="roundRect">
+            <a:avLst>
+              <a:gd name="adj" fmla="val 20000"/>
+            </a:avLst>
+          </a:prstGeom>
+          <a:solidFill>
+            <a:srgbClr val="1C3C7A"/>
+          </a:solidFill>
+          <a:ln>
+            <a:noFill/>
+          </a:ln>
+          <a:effectLst/>
+        </p:spPr>
+        <p:style>
+          <a:lnRef idx="1">
+            <a:schemeClr val="accent1"/>
+          </a:lnRef>
+          <a:fillRef idx="3">
+            <a:schemeClr val="accent1"/>
+          </a:fillRef>
+          <a:effectRef idx="2">
+            <a:schemeClr val="accent1"/>
+          </a:effectRef>
+          <a:fontRef idx="minor">
+            <a:schemeClr val="lt1"/>
+          </a:fontRef>
+        </p:style>
+        <p:txBody>
+          <a:bodyPr rtlCol="0" anchor="ctr"/>
+          <a:lstStyle/>
+          <a:p>
+            <a:pPr algn="ctr"/>
+          </a:p>
+        </p:txBody>
+      </p:sp>
+      <p:sp>
+        <p:nvSpPr>
+          <p:cNvPr id="8" name="TextBox 7"/>
+          <p:cNvSpPr txBox="1"/>
+          <p:nvPr/>
+        </p:nvSpPr>
+        <p:spPr>
+          <a:xfrm>
+            <a:off x="5623560" y="1188720"/>
+            <a:ext cx="3413455" cy="384048"/>
+          </a:xfrm>
+          <a:prstGeom prst="rect">
+            <a:avLst/>
+          </a:prstGeom>
+          <a:noFill/>
+        </p:spPr>
+        <p:txBody>
+          <a:bodyPr wrap="square" anchor="ctr" lIns="36576" rIns="36576" tIns="0" bIns="0">
+            <a:spAutoFit/>
+          </a:bodyPr>
+          <a:lstStyle/>
+          <a:p>
+            <a:pPr algn="r" rtl="1"/>
+            <a:r>
+              <a:rPr sz="1200" b="1">
+                <a:solidFill>
+                  <a:srgbClr val="FFFFFF"/>
+                </a:solidFill>
+                <a:latin typeface="Heebo"/>
+                <a:cs typeface="Heebo"/>
+              </a:rPr>
+              <a:t>תפקיד</a:t>
+            </a:r>
+          </a:p>
+        </p:txBody>
+      </p:sp>
+      <p:sp>
+        <p:nvSpPr>
+          <p:cNvPr id="9" name="TextBox 8"/>
+          <p:cNvSpPr txBox="1"/>
+          <p:nvPr/>
+        </p:nvSpPr>
+        <p:spPr>
+          <a:xfrm>
+            <a:off x="6903720" y="1188720"/>
+            <a:ext cx="1280160" cy="384048"/>
+          </a:xfrm>
+          <a:prstGeom prst="rect">
+            <a:avLst/>
+          </a:prstGeom>
+          <a:noFill/>
+        </p:spPr>
+        <p:txBody>
+          <a:bodyPr wrap="square" anchor="ctr" lIns="36576" rIns="36576" tIns="0" bIns="0">
+            <a:spAutoFit/>
+          </a:bodyPr>
+          <a:lstStyle/>
+          <a:p>
+            <a:pPr algn="ctr" rtl="1"/>
+            <a:r>
+              <a:rPr sz="1200" b="1">
+                <a:solidFill>
+                  <a:srgbClr val="FFFFFF"/>
+                </a:solidFill>
+                <a:latin typeface="Heebo"/>
+                <a:cs typeface="Heebo"/>
+              </a:rPr>
+              <a:t>לחודש</a:t>
+            </a:r>
+          </a:p>
+        </p:txBody>
+      </p:sp>
+      <p:sp>
+        <p:nvSpPr>
+          <p:cNvPr id="10" name="TextBox 9"/>
+          <p:cNvSpPr txBox="1"/>
+          <p:nvPr/>
+        </p:nvSpPr>
+        <p:spPr>
+          <a:xfrm>
+            <a:off x="5532120" y="1188720"/>
+            <a:ext cx="1371600" cy="384048"/>
+          </a:xfrm>
+          <a:prstGeom prst="rect">
+            <a:avLst/>
+          </a:prstGeom>
+          <a:noFill/>
+        </p:spPr>
+        <p:txBody>
+          <a:bodyPr wrap="square" anchor="ctr" lIns="36576" rIns="36576" tIns="0" bIns="0">
+            <a:spAutoFit/>
+          </a:bodyPr>
+          <a:lstStyle/>
+          <a:p>
+            <a:pPr algn="ctr" rtl="1"/>
+            <a:r>
+              <a:rPr sz="1200" b="1">
+                <a:solidFill>
+                  <a:srgbClr val="FFFFFF"/>
+                </a:solidFill>
+                <a:latin typeface="Heebo"/>
+                <a:cs typeface="Heebo"/>
+              </a:rPr>
+              <a:t>שינוי</a:t>
+            </a:r>
+          </a:p>
+        </p:txBody>
+      </p:sp>
+      <p:sp>
+        <p:nvSpPr>
+          <p:cNvPr id="11" name="Rounded Rectangle 10"/>
+          <p:cNvSpPr/>
+          <p:nvPr/>
+        </p:nvSpPr>
+        <p:spPr>
+          <a:xfrm>
+            <a:off x="5440680" y="1664208"/>
+            <a:ext cx="6339535" cy="512064"/>
+          </a:xfrm>
+          <a:prstGeom prst="roundRect">
+            <a:avLst>
+              <a:gd name="adj" fmla="val 15000"/>
+            </a:avLst>
+          </a:prstGeom>
+          <a:solidFill>
+            <a:srgbClr val="FFFFFF"/>
+          </a:solidFill>
+          <a:ln w="15875">
+            <a:solidFill>
+              <a:srgbClr val="C5CDDD"/>
+            </a:solidFill>
+          </a:ln>
+          <a:effectLst/>
+        </p:spPr>
+        <p:style>
+          <a:lnRef idx="1">
+            <a:schemeClr val="accent1"/>
+          </a:lnRef>
+          <a:fillRef idx="3">
+            <a:schemeClr val="accent1"/>
+          </a:fillRef>
+          <a:effectRef idx="2">
+            <a:schemeClr val="accent1"/>
+          </a:effectRef>
+          <a:fontRef idx="minor">
+            <a:schemeClr val="lt1"/>
+          </a:fontRef>
+        </p:style>
+        <p:txBody>
+          <a:bodyPr rtlCol="0" anchor="ctr"/>
+          <a:lstStyle/>
+          <a:p>
+            <a:pPr algn="ctr"/>
+          </a:p>
+        </p:txBody>
+      </p:sp>
+      <p:sp>
+        <p:nvSpPr>
+          <p:cNvPr id="12" name="TextBox 11"/>
+          <p:cNvSpPr txBox="1"/>
+          <p:nvPr/>
+        </p:nvSpPr>
+        <p:spPr>
+          <a:xfrm>
+            <a:off x="8275320" y="1664208"/>
+            <a:ext cx="3322015" cy="512064"/>
+          </a:xfrm>
+          <a:prstGeom prst="rect">
+            <a:avLst/>
+          </a:prstGeom>
+          <a:noFill/>
+        </p:spPr>
+        <p:txBody>
+          <a:bodyPr wrap="square" anchor="ctr" lIns="36576" rIns="36576" tIns="0" bIns="0">
+            <a:spAutoFit/>
+          </a:bodyPr>
+          <a:lstStyle/>
+          <a:p>
+            <a:pPr algn="r" rtl="1"/>
+            <a:r>
+              <a:rPr sz="1300" b="1">
+                <a:solidFill>
+                  <a:srgbClr val="1A2233"/>
+                </a:solidFill>
+                <a:latin typeface="Heebo"/>
+                <a:cs typeface="Heebo"/>
+              </a:rPr>
+              <a:t>מנכ״ל · אדם קורגן</a:t>
+            </a:r>
+          </a:p>
+        </p:txBody>
+      </p:sp>
+      <p:sp>
+        <p:nvSpPr>
+          <p:cNvPr id="13" name="TextBox 12"/>
+          <p:cNvSpPr txBox="1"/>
+          <p:nvPr/>
+        </p:nvSpPr>
+        <p:spPr>
+          <a:xfrm>
+            <a:off x="6903720" y="1664208"/>
+            <a:ext cx="1280160" cy="512064"/>
+          </a:xfrm>
+          <a:prstGeom prst="rect">
+            <a:avLst/>
+          </a:prstGeom>
+          <a:noFill/>
+        </p:spPr>
+        <p:txBody>
+          <a:bodyPr wrap="square" anchor="ctr" lIns="36576" rIns="36576" tIns="0" bIns="0">
+            <a:spAutoFit/>
+          </a:bodyPr>
+          <a:lstStyle/>
+          <a:p>
+            <a:pPr algn="ctr" rtl="1"/>
+            <a:r>
+              <a:rPr sz="1400" b="1">
+                <a:solidFill>
+                  <a:srgbClr val="1C3C7A"/>
+                </a:solidFill>
+                <a:latin typeface="Heebo"/>
+                <a:cs typeface="Heebo"/>
+              </a:rPr>
+              <a:t>15,000 ₪</a:t>
+            </a:r>
+          </a:p>
+        </p:txBody>
+      </p:sp>
+      <p:sp>
+        <p:nvSpPr>
+          <p:cNvPr id="14" name="Rounded Rectangle 13"/>
+          <p:cNvSpPr/>
+          <p:nvPr/>
+        </p:nvSpPr>
+        <p:spPr>
+          <a:xfrm>
+            <a:off x="5577840" y="1773936"/>
+            <a:ext cx="1234440" cy="292608"/>
+          </a:xfrm>
+          <a:prstGeom prst="roundRect">
+            <a:avLst>
+              <a:gd name="adj" fmla="val 50000"/>
+            </a:avLst>
+          </a:prstGeom>
+          <a:solidFill>
+            <a:srgbClr val="F0C000"/>
+          </a:solidFill>
+          <a:ln>
+            <a:noFill/>
+          </a:ln>
+          <a:effectLst/>
+        </p:spPr>
+        <p:style>
+          <a:lnRef idx="1">
+            <a:schemeClr val="accent1"/>
+          </a:lnRef>
+          <a:fillRef idx="3">
+            <a:schemeClr val="accent1"/>
+          </a:fillRef>
+          <a:effectRef idx="2">
+            <a:schemeClr val="accent1"/>
+          </a:effectRef>
+          <a:fontRef idx="minor">
+            <a:schemeClr val="lt1"/>
+          </a:fontRef>
+        </p:style>
+        <p:txBody>
+          <a:bodyPr rtlCol="0" anchor="ctr"/>
+          <a:lstStyle/>
+          <a:p>
+            <a:pPr algn="ctr"/>
+          </a:p>
+        </p:txBody>
+      </p:sp>
+      <p:sp>
+        <p:nvSpPr>
+          <p:cNvPr id="15" name="TextBox 14"/>
+          <p:cNvSpPr txBox="1"/>
+          <p:nvPr/>
+        </p:nvSpPr>
+        <p:spPr>
+          <a:xfrm>
+            <a:off x="5577840" y="1773936"/>
+            <a:ext cx="1234440" cy="292608"/>
+          </a:xfrm>
+          <a:prstGeom prst="rect">
+            <a:avLst/>
+          </a:prstGeom>
+          <a:noFill/>
+        </p:spPr>
+        <p:txBody>
+          <a:bodyPr wrap="square" anchor="ctr" lIns="36576" rIns="36576" tIns="0" bIns="0">
+            <a:spAutoFit/>
+          </a:bodyPr>
+          <a:lstStyle/>
+          <a:p>
+            <a:pPr algn="ctr" rtl="0"/>
+            <a:r>
+              <a:rPr sz="1000" b="1">
+                <a:solidFill>
+                  <a:srgbClr val="122755"/>
+                </a:solidFill>
+                <a:latin typeface="Heebo"/>
+                <a:cs typeface="Heebo"/>
+              </a:rPr>
+              <a:t>+3,000</a:t>
+            </a:r>
+          </a:p>
+        </p:txBody>
+      </p:sp>
+      <p:sp>
+        <p:nvSpPr>
+          <p:cNvPr id="16" name="Rounded Rectangle 15"/>
+          <p:cNvSpPr/>
+          <p:nvPr/>
+        </p:nvSpPr>
+        <p:spPr>
+          <a:xfrm>
+            <a:off x="5440680" y="2249424"/>
+            <a:ext cx="6339535" cy="512064"/>
+          </a:xfrm>
+          <a:prstGeom prst="roundRect">
+            <a:avLst>
+              <a:gd name="adj" fmla="val 15000"/>
+            </a:avLst>
+          </a:prstGeom>
+          <a:solidFill>
+            <a:srgbClr val="FFFFFF"/>
+          </a:solidFill>
+          <a:ln w="15875">
+            <a:solidFill>
+              <a:srgbClr val="C5CDDD"/>
+            </a:solidFill>
+          </a:ln>
+          <a:effectLst/>
+        </p:spPr>
+        <p:style>
+          <a:lnRef idx="1">
+            <a:schemeClr val="accent1"/>
+          </a:lnRef>
+          <a:fillRef idx="3">
+            <a:schemeClr val="accent1"/>
+          </a:fillRef>
+          <a:effectRef idx="2">
+            <a:schemeClr val="accent1"/>
+          </a:effectRef>
+          <a:fontRef idx="minor">
+            <a:schemeClr val="lt1"/>
+          </a:fontRef>
+        </p:style>
+        <p:txBody>
+          <a:bodyPr rtlCol="0" anchor="ctr"/>
+          <a:lstStyle/>
+          <a:p>
+            <a:pPr algn="ctr"/>
+          </a:p>
+        </p:txBody>
+      </p:sp>
+      <p:sp>
+        <p:nvSpPr>
+          <p:cNvPr id="17" name="TextBox 16"/>
+          <p:cNvSpPr txBox="1"/>
+          <p:nvPr/>
+        </p:nvSpPr>
+        <p:spPr>
+          <a:xfrm>
+            <a:off x="8275320" y="2249424"/>
+            <a:ext cx="3322015" cy="512064"/>
+          </a:xfrm>
+          <a:prstGeom prst="rect">
+            <a:avLst/>
+          </a:prstGeom>
+          <a:noFill/>
+        </p:spPr>
+        <p:txBody>
+          <a:bodyPr wrap="square" anchor="ctr" lIns="36576" rIns="36576" tIns="0" bIns="0">
+            <a:spAutoFit/>
+          </a:bodyPr>
+          <a:lstStyle/>
+          <a:p>
+            <a:pPr algn="r" rtl="1"/>
+            <a:r>
+              <a:rPr sz="1300" b="1">
+                <a:solidFill>
+                  <a:srgbClr val="1A2233"/>
+                </a:solidFill>
+                <a:latin typeface="Heebo"/>
+                <a:cs typeface="Heebo"/>
+              </a:rPr>
+              <a:t>עוזר מנכ״ל · חצי משרה</a:t>
+            </a:r>
+          </a:p>
+        </p:txBody>
+      </p:sp>
+      <p:sp>
+        <p:nvSpPr>
+          <p:cNvPr id="18" name="TextBox 17"/>
+          <p:cNvSpPr txBox="1"/>
+          <p:nvPr/>
+        </p:nvSpPr>
+        <p:spPr>
+          <a:xfrm>
+            <a:off x="6903720" y="2249424"/>
+            <a:ext cx="1280160" cy="512064"/>
+          </a:xfrm>
+          <a:prstGeom prst="rect">
+            <a:avLst/>
+          </a:prstGeom>
+          <a:noFill/>
+        </p:spPr>
+        <p:txBody>
+          <a:bodyPr wrap="square" anchor="ctr" lIns="36576" rIns="36576" tIns="0" bIns="0">
+            <a:spAutoFit/>
+          </a:bodyPr>
+          <a:lstStyle/>
+          <a:p>
+            <a:pPr algn="ctr" rtl="1"/>
+            <a:r>
+              <a:rPr sz="1400" b="1">
+                <a:solidFill>
+                  <a:srgbClr val="1C3C7A"/>
+                </a:solidFill>
+                <a:latin typeface="Heebo"/>
+                <a:cs typeface="Heebo"/>
+              </a:rPr>
+              <a:t>7,000 ₪</a:t>
+            </a:r>
+          </a:p>
+        </p:txBody>
+      </p:sp>
+      <p:sp>
+        <p:nvSpPr>
+          <p:cNvPr id="19" name="Rounded Rectangle 18"/>
+          <p:cNvSpPr/>
+          <p:nvPr/>
+        </p:nvSpPr>
+        <p:spPr>
+          <a:xfrm>
+            <a:off x="5577840" y="2359152"/>
+            <a:ext cx="1234440" cy="292608"/>
+          </a:xfrm>
+          <a:prstGeom prst="roundRect">
+            <a:avLst>
+              <a:gd name="adj" fmla="val 50000"/>
+            </a:avLst>
+          </a:prstGeom>
+          <a:solidFill>
+            <a:srgbClr val="F0C000"/>
+          </a:solidFill>
+          <a:ln>
+            <a:noFill/>
+          </a:ln>
+          <a:effectLst/>
+        </p:spPr>
+        <p:style>
+          <a:lnRef idx="1">
+            <a:schemeClr val="accent1"/>
+          </a:lnRef>
+          <a:fillRef idx="3">
+            <a:schemeClr val="accent1"/>
+          </a:fillRef>
+          <a:effectRef idx="2">
+            <a:schemeClr val="accent1"/>
+          </a:effectRef>
+          <a:fontRef idx="minor">
+            <a:schemeClr val="lt1"/>
+          </a:fontRef>
+        </p:style>
+        <p:txBody>
+          <a:bodyPr rtlCol="0" anchor="ctr"/>
+          <a:lstStyle/>
+          <a:p>
+            <a:pPr algn="ctr"/>
+          </a:p>
+        </p:txBody>
+      </p:sp>
+      <p:sp>
+        <p:nvSpPr>
+          <p:cNvPr id="20" name="TextBox 19"/>
+          <p:cNvSpPr txBox="1"/>
+          <p:nvPr/>
+        </p:nvSpPr>
+        <p:spPr>
+          <a:xfrm>
+            <a:off x="5577840" y="2359152"/>
+            <a:ext cx="1234440" cy="292608"/>
+          </a:xfrm>
+          <a:prstGeom prst="rect">
+            <a:avLst/>
+          </a:prstGeom>
+          <a:noFill/>
+        </p:spPr>
+        <p:txBody>
+          <a:bodyPr wrap="square" anchor="ctr" lIns="36576" rIns="36576" tIns="0" bIns="0">
+            <a:spAutoFit/>
+          </a:bodyPr>
+          <a:lstStyle/>
+          <a:p>
+            <a:pPr algn="ctr" rtl="0"/>
+            <a:r>
+              <a:rPr sz="1000" b="1">
+                <a:solidFill>
+                  <a:srgbClr val="122755"/>
+                </a:solidFill>
+                <a:latin typeface="Heebo"/>
+                <a:cs typeface="Heebo"/>
+              </a:rPr>
+              <a:t>+2,000</a:t>
+            </a:r>
+          </a:p>
+        </p:txBody>
+      </p:sp>
+      <p:sp>
+        <p:nvSpPr>
+          <p:cNvPr id="21" name="Rounded Rectangle 20"/>
+          <p:cNvSpPr/>
+          <p:nvPr/>
+        </p:nvSpPr>
+        <p:spPr>
+          <a:xfrm>
+            <a:off x="5440680" y="2834640"/>
+            <a:ext cx="6339535" cy="512064"/>
+          </a:xfrm>
+          <a:prstGeom prst="roundRect">
+            <a:avLst>
+              <a:gd name="adj" fmla="val 15000"/>
+            </a:avLst>
+          </a:prstGeom>
+          <a:solidFill>
+            <a:srgbClr val="FFFFFF"/>
+          </a:solidFill>
+          <a:ln w="15875">
+            <a:solidFill>
+              <a:srgbClr val="C5CDDD"/>
+            </a:solidFill>
+          </a:ln>
+          <a:effectLst/>
+        </p:spPr>
+        <p:style>
+          <a:lnRef idx="1">
+            <a:schemeClr val="accent1"/>
+          </a:lnRef>
+          <a:fillRef idx="3">
+            <a:schemeClr val="accent1"/>
+          </a:fillRef>
+          <a:effectRef idx="2">
+            <a:schemeClr val="accent1"/>
+          </a:effectRef>
+          <a:fontRef idx="minor">
+            <a:schemeClr val="lt1"/>
+          </a:fontRef>
+        </p:style>
+        <p:txBody>
+          <a:bodyPr rtlCol="0" anchor="ctr"/>
+          <a:lstStyle/>
+          <a:p>
+            <a:pPr algn="ctr"/>
+          </a:p>
+        </p:txBody>
+      </p:sp>
+      <p:sp>
+        <p:nvSpPr>
+          <p:cNvPr id="22" name="TextBox 21"/>
+          <p:cNvSpPr txBox="1"/>
+          <p:nvPr/>
+        </p:nvSpPr>
+        <p:spPr>
+          <a:xfrm>
+            <a:off x="8275320" y="2834640"/>
+            <a:ext cx="3322015" cy="512064"/>
+          </a:xfrm>
+          <a:prstGeom prst="rect">
+            <a:avLst/>
+          </a:prstGeom>
+          <a:noFill/>
+        </p:spPr>
+        <p:txBody>
+          <a:bodyPr wrap="square" anchor="ctr" lIns="36576" rIns="36576" tIns="0" bIns="0">
+            <a:spAutoFit/>
+          </a:bodyPr>
+          <a:lstStyle/>
+          <a:p>
+            <a:pPr algn="r" rtl="1"/>
+            <a:r>
+              <a:rPr sz="1300" b="1">
+                <a:solidFill>
+                  <a:srgbClr val="1A2233"/>
+                </a:solidFill>
+                <a:latin typeface="Heebo"/>
+                <a:cs typeface="Heebo"/>
+              </a:rPr>
+              <a:t>מנהל תוכן · חצי משרה</a:t>
+            </a:r>
+          </a:p>
+        </p:txBody>
+      </p:sp>
+      <p:sp>
+        <p:nvSpPr>
+          <p:cNvPr id="23" name="TextBox 22"/>
+          <p:cNvSpPr txBox="1"/>
+          <p:nvPr/>
+        </p:nvSpPr>
+        <p:spPr>
+          <a:xfrm>
+            <a:off x="6903720" y="2834640"/>
+            <a:ext cx="1280160" cy="512064"/>
+          </a:xfrm>
+          <a:prstGeom prst="rect">
+            <a:avLst/>
+          </a:prstGeom>
+          <a:noFill/>
+        </p:spPr>
+        <p:txBody>
+          <a:bodyPr wrap="square" anchor="ctr" lIns="36576" rIns="36576" tIns="0" bIns="0">
+            <a:spAutoFit/>
+          </a:bodyPr>
+          <a:lstStyle/>
+          <a:p>
+            <a:pPr algn="ctr" rtl="1"/>
+            <a:r>
+              <a:rPr sz="1400" b="1">
+                <a:solidFill>
+                  <a:srgbClr val="1C3C7A"/>
+                </a:solidFill>
+                <a:latin typeface="Heebo"/>
+                <a:cs typeface="Heebo"/>
+              </a:rPr>
+              <a:t>6,000 ₪</a:t>
+            </a:r>
+          </a:p>
+        </p:txBody>
+      </p:sp>
+      <p:sp>
+        <p:nvSpPr>
+          <p:cNvPr id="24" name="Rounded Rectangle 23"/>
+          <p:cNvSpPr/>
+          <p:nvPr/>
+        </p:nvSpPr>
+        <p:spPr>
+          <a:xfrm>
+            <a:off x="5577840" y="2944368"/>
+            <a:ext cx="1234440" cy="292608"/>
+          </a:xfrm>
+          <a:prstGeom prst="roundRect">
+            <a:avLst>
+              <a:gd name="adj" fmla="val 50000"/>
+            </a:avLst>
+          </a:prstGeom>
+          <a:solidFill>
+            <a:srgbClr val="F0C000"/>
+          </a:solidFill>
+          <a:ln>
+            <a:noFill/>
+          </a:ln>
+          <a:effectLst/>
+        </p:spPr>
+        <p:style>
+          <a:lnRef idx="1">
+            <a:schemeClr val="accent1"/>
+          </a:lnRef>
+          <a:fillRef idx="3">
+            <a:schemeClr val="accent1"/>
+          </a:fillRef>
+          <a:effectRef idx="2">
+            <a:schemeClr val="accent1"/>
+          </a:effectRef>
+          <a:fontRef idx="minor">
+            <a:schemeClr val="lt1"/>
+          </a:fontRef>
+        </p:style>
+        <p:txBody>
+          <a:bodyPr rtlCol="0" anchor="ctr"/>
+          <a:lstStyle/>
+          <a:p>
+            <a:pPr algn="ctr"/>
+          </a:p>
+        </p:txBody>
+      </p:sp>
+      <p:sp>
+        <p:nvSpPr>
+          <p:cNvPr id="25" name="TextBox 24"/>
+          <p:cNvSpPr txBox="1"/>
+          <p:nvPr/>
+        </p:nvSpPr>
+        <p:spPr>
+          <a:xfrm>
+            <a:off x="5577840" y="2944368"/>
+            <a:ext cx="1234440" cy="292608"/>
+          </a:xfrm>
+          <a:prstGeom prst="rect">
+            <a:avLst/>
+          </a:prstGeom>
+          <a:noFill/>
+        </p:spPr>
+        <p:txBody>
+          <a:bodyPr wrap="square" anchor="ctr" lIns="36576" rIns="36576" tIns="0" bIns="0">
+            <a:spAutoFit/>
+          </a:bodyPr>
+          <a:lstStyle/>
+          <a:p>
+            <a:pPr algn="ctr" rtl="0"/>
+            <a:r>
+              <a:rPr sz="1000" b="1">
+                <a:solidFill>
+                  <a:srgbClr val="122755"/>
+                </a:solidFill>
+                <a:latin typeface="Heebo"/>
+                <a:cs typeface="Heebo"/>
+              </a:rPr>
+              <a:t>+1,000</a:t>
+            </a:r>
+          </a:p>
+        </p:txBody>
+      </p:sp>
+      <p:sp>
+        <p:nvSpPr>
+          <p:cNvPr id="26" name="Rounded Rectangle 25"/>
+          <p:cNvSpPr/>
+          <p:nvPr/>
+        </p:nvSpPr>
+        <p:spPr>
+          <a:xfrm>
+            <a:off x="5440680" y="3419856"/>
+            <a:ext cx="6339535" cy="512064"/>
+          </a:xfrm>
+          <a:prstGeom prst="roundRect">
+            <a:avLst>
+              <a:gd name="adj" fmla="val 15000"/>
+            </a:avLst>
+          </a:prstGeom>
+          <a:solidFill>
+            <a:srgbClr val="FFFFFF"/>
+          </a:solidFill>
+          <a:ln w="15875">
+            <a:solidFill>
+              <a:srgbClr val="C5CDDD"/>
+            </a:solidFill>
+          </a:ln>
+          <a:effectLst/>
+        </p:spPr>
+        <p:style>
+          <a:lnRef idx="1">
+            <a:schemeClr val="accent1"/>
+          </a:lnRef>
+          <a:fillRef idx="3">
+            <a:schemeClr val="accent1"/>
+          </a:fillRef>
+          <a:effectRef idx="2">
+            <a:schemeClr val="accent1"/>
+          </a:effectRef>
+          <a:fontRef idx="minor">
+            <a:schemeClr val="lt1"/>
+          </a:fontRef>
+        </p:style>
+        <p:txBody>
+          <a:bodyPr rtlCol="0" anchor="ctr"/>
+          <a:lstStyle/>
+          <a:p>
+            <a:pPr algn="ctr"/>
+          </a:p>
+        </p:txBody>
+      </p:sp>
+      <p:sp>
+        <p:nvSpPr>
+          <p:cNvPr id="27" name="TextBox 26"/>
+          <p:cNvSpPr txBox="1"/>
+          <p:nvPr/>
+        </p:nvSpPr>
+        <p:spPr>
+          <a:xfrm>
+            <a:off x="8275320" y="3419856"/>
+            <a:ext cx="3322015" cy="512064"/>
+          </a:xfrm>
+          <a:prstGeom prst="rect">
+            <a:avLst/>
+          </a:prstGeom>
+          <a:noFill/>
+        </p:spPr>
+        <p:txBody>
+          <a:bodyPr wrap="square" anchor="ctr" lIns="36576" rIns="36576" tIns="0" bIns="0">
+            <a:spAutoFit/>
+          </a:bodyPr>
+          <a:lstStyle/>
+          <a:p>
+            <a:pPr algn="r" rtl="1"/>
+            <a:r>
+              <a:rPr sz="1300" b="1">
+                <a:solidFill>
+                  <a:srgbClr val="1A2233"/>
+                </a:solidFill>
+                <a:latin typeface="Heebo"/>
+                <a:cs typeface="Heebo"/>
+              </a:rPr>
+              <a:t>נציג 3 · 4 דיונים</a:t>
+            </a:r>
+          </a:p>
+        </p:txBody>
+      </p:sp>
+      <p:sp>
+        <p:nvSpPr>
+          <p:cNvPr id="28" name="TextBox 27"/>
+          <p:cNvSpPr txBox="1"/>
+          <p:nvPr/>
+        </p:nvSpPr>
+        <p:spPr>
+          <a:xfrm>
+            <a:off x="6903720" y="3419856"/>
+            <a:ext cx="1280160" cy="512064"/>
+          </a:xfrm>
+          <a:prstGeom prst="rect">
+            <a:avLst/>
+          </a:prstGeom>
+          <a:noFill/>
+        </p:spPr>
+        <p:txBody>
+          <a:bodyPr wrap="square" anchor="ctr" lIns="36576" rIns="36576" tIns="0" bIns="0">
+            <a:spAutoFit/>
+          </a:bodyPr>
+          <a:lstStyle/>
+          <a:p>
+            <a:pPr algn="ctr" rtl="1"/>
+            <a:r>
+              <a:rPr sz="1400" b="1">
+                <a:solidFill>
+                  <a:srgbClr val="1C3C7A"/>
+                </a:solidFill>
+                <a:latin typeface="Heebo"/>
+                <a:cs typeface="Heebo"/>
+              </a:rPr>
+              <a:t>1,800 ₪</a:t>
+            </a:r>
+          </a:p>
+        </p:txBody>
+      </p:sp>
+      <p:sp>
+        <p:nvSpPr>
+          <p:cNvPr id="29" name="Rounded Rectangle 28"/>
+          <p:cNvSpPr/>
+          <p:nvPr/>
+        </p:nvSpPr>
+        <p:spPr>
+          <a:xfrm>
+            <a:off x="5577840" y="3529584"/>
+            <a:ext cx="1234440" cy="292608"/>
+          </a:xfrm>
+          <a:prstGeom prst="roundRect">
+            <a:avLst>
+              <a:gd name="adj" fmla="val 50000"/>
+            </a:avLst>
+          </a:prstGeom>
+          <a:solidFill>
+            <a:srgbClr val="F4F6FB"/>
+          </a:solidFill>
+          <a:ln>
+            <a:noFill/>
+          </a:ln>
+          <a:effectLst/>
+        </p:spPr>
+        <p:style>
+          <a:lnRef idx="1">
+            <a:schemeClr val="accent1"/>
+          </a:lnRef>
+          <a:fillRef idx="3">
+            <a:schemeClr val="accent1"/>
+          </a:fillRef>
+          <a:effectRef idx="2">
+            <a:schemeClr val="accent1"/>
+          </a:effectRef>
+          <a:fontRef idx="minor">
+            <a:schemeClr val="lt1"/>
+          </a:fontRef>
+        </p:style>
+        <p:txBody>
+          <a:bodyPr rtlCol="0" anchor="ctr"/>
+          <a:lstStyle/>
+          <a:p>
+            <a:pPr algn="ctr"/>
+          </a:p>
+        </p:txBody>
+      </p:sp>
+      <p:sp>
+        <p:nvSpPr>
+          <p:cNvPr id="30" name="TextBox 29"/>
+          <p:cNvSpPr txBox="1"/>
+          <p:nvPr/>
+        </p:nvSpPr>
+        <p:spPr>
+          <a:xfrm>
+            <a:off x="5577840" y="3529584"/>
+            <a:ext cx="1234440" cy="292608"/>
+          </a:xfrm>
+          <a:prstGeom prst="rect">
+            <a:avLst/>
+          </a:prstGeom>
+          <a:noFill/>
+        </p:spPr>
+        <p:txBody>
+          <a:bodyPr wrap="square" anchor="ctr" lIns="36576" rIns="36576" tIns="0" bIns="0">
+            <a:spAutoFit/>
+          </a:bodyPr>
+          <a:lstStyle/>
+          <a:p>
+            <a:pPr algn="ctr" rtl="1"/>
+            <a:r>
+              <a:rPr sz="1000" b="0">
+                <a:solidFill>
+                  <a:srgbClr val="8A94A8"/>
+                </a:solidFill>
+                <a:latin typeface="Heebo"/>
+                <a:cs typeface="Heebo"/>
+              </a:rPr>
+              <a:t>תעריף מלא</a:t>
+            </a:r>
+          </a:p>
+        </p:txBody>
+      </p:sp>
+      <p:sp>
+        <p:nvSpPr>
+          <p:cNvPr id="31" name="Rounded Rectangle 30"/>
+          <p:cNvSpPr/>
+          <p:nvPr/>
+        </p:nvSpPr>
+        <p:spPr>
+          <a:xfrm>
+            <a:off x="5440680" y="4005072"/>
+            <a:ext cx="6339535" cy="512064"/>
+          </a:xfrm>
+          <a:prstGeom prst="roundRect">
+            <a:avLst>
+              <a:gd name="adj" fmla="val 15000"/>
+            </a:avLst>
+          </a:prstGeom>
+          <a:solidFill>
+            <a:srgbClr val="FFFFFF"/>
+          </a:solidFill>
+          <a:ln w="15875">
+            <a:solidFill>
+              <a:srgbClr val="C5CDDD"/>
+            </a:solidFill>
+          </a:ln>
+          <a:effectLst/>
+        </p:spPr>
+        <p:style>
+          <a:lnRef idx="1">
+            <a:schemeClr val="accent1"/>
+          </a:lnRef>
+          <a:fillRef idx="3">
+            <a:schemeClr val="accent1"/>
+          </a:fillRef>
+          <a:effectRef idx="2">
+            <a:schemeClr val="accent1"/>
+          </a:effectRef>
+          <a:fontRef idx="minor">
+            <a:schemeClr val="lt1"/>
+          </a:fontRef>
+        </p:style>
+        <p:txBody>
+          <a:bodyPr rtlCol="0" anchor="ctr"/>
+          <a:lstStyle/>
+          <a:p>
+            <a:pPr algn="ctr"/>
+          </a:p>
+        </p:txBody>
+      </p:sp>
+      <p:sp>
+        <p:nvSpPr>
+          <p:cNvPr id="32" name="TextBox 31"/>
+          <p:cNvSpPr txBox="1"/>
+          <p:nvPr/>
+        </p:nvSpPr>
+        <p:spPr>
+          <a:xfrm>
+            <a:off x="8275320" y="4005072"/>
+            <a:ext cx="3322015" cy="512064"/>
+          </a:xfrm>
+          <a:prstGeom prst="rect">
+            <a:avLst/>
+          </a:prstGeom>
+          <a:noFill/>
+        </p:spPr>
+        <p:txBody>
+          <a:bodyPr wrap="square" anchor="ctr" lIns="36576" rIns="36576" tIns="0" bIns="0">
+            <a:spAutoFit/>
+          </a:bodyPr>
+          <a:lstStyle/>
+          <a:p>
+            <a:pPr algn="r" rtl="1"/>
+            <a:r>
+              <a:rPr sz="1300" b="1">
+                <a:solidFill>
+                  <a:srgbClr val="1A2233"/>
+                </a:solidFill>
+                <a:latin typeface="Heebo"/>
+                <a:cs typeface="Heebo"/>
+              </a:rPr>
+              <a:t>נציג 4 · 4 דיונים</a:t>
+            </a:r>
+          </a:p>
+        </p:txBody>
+      </p:sp>
+      <p:sp>
+        <p:nvSpPr>
+          <p:cNvPr id="33" name="TextBox 32"/>
+          <p:cNvSpPr txBox="1"/>
+          <p:nvPr/>
+        </p:nvSpPr>
+        <p:spPr>
+          <a:xfrm>
+            <a:off x="6903720" y="4005072"/>
+            <a:ext cx="1280160" cy="512064"/>
+          </a:xfrm>
+          <a:prstGeom prst="rect">
+            <a:avLst/>
+          </a:prstGeom>
+          <a:noFill/>
+        </p:spPr>
+        <p:txBody>
+          <a:bodyPr wrap="square" anchor="ctr" lIns="36576" rIns="36576" tIns="0" bIns="0">
+            <a:spAutoFit/>
+          </a:bodyPr>
+          <a:lstStyle/>
+          <a:p>
+            <a:pPr algn="ctr" rtl="1"/>
+            <a:r>
+              <a:rPr sz="1400" b="1">
+                <a:solidFill>
+                  <a:srgbClr val="1C3C7A"/>
+                </a:solidFill>
+                <a:latin typeface="Heebo"/>
+                <a:cs typeface="Heebo"/>
+              </a:rPr>
+              <a:t>1,800 ₪</a:t>
+            </a:r>
+          </a:p>
+        </p:txBody>
+      </p:sp>
+      <p:sp>
+        <p:nvSpPr>
+          <p:cNvPr id="34" name="Rounded Rectangle 33"/>
+          <p:cNvSpPr/>
+          <p:nvPr/>
+        </p:nvSpPr>
+        <p:spPr>
+          <a:xfrm>
+            <a:off x="5577840" y="4114800"/>
+            <a:ext cx="1234440" cy="292608"/>
+          </a:xfrm>
+          <a:prstGeom prst="roundRect">
+            <a:avLst>
+              <a:gd name="adj" fmla="val 50000"/>
+            </a:avLst>
+          </a:prstGeom>
+          <a:solidFill>
+            <a:srgbClr val="F4F6FB"/>
+          </a:solidFill>
+          <a:ln>
+            <a:noFill/>
+          </a:ln>
+          <a:effectLst/>
+        </p:spPr>
+        <p:style>
+          <a:lnRef idx="1">
+            <a:schemeClr val="accent1"/>
+          </a:lnRef>
+          <a:fillRef idx="3">
+            <a:schemeClr val="accent1"/>
+          </a:fillRef>
+          <a:effectRef idx="2">
+            <a:schemeClr val="accent1"/>
+          </a:effectRef>
+          <a:fontRef idx="minor">
+            <a:schemeClr val="lt1"/>
+          </a:fontRef>
+        </p:style>
+        <p:txBody>
+          <a:bodyPr rtlCol="0" anchor="ctr"/>
+          <a:lstStyle/>
+          <a:p>
+            <a:pPr algn="ctr"/>
+          </a:p>
+        </p:txBody>
+      </p:sp>
+      <p:sp>
+        <p:nvSpPr>
+          <p:cNvPr id="35" name="TextBox 34"/>
+          <p:cNvSpPr txBox="1"/>
+          <p:nvPr/>
+        </p:nvSpPr>
+        <p:spPr>
+          <a:xfrm>
+            <a:off x="5577840" y="4114800"/>
+            <a:ext cx="1234440" cy="292608"/>
+          </a:xfrm>
+          <a:prstGeom prst="rect">
+            <a:avLst/>
+          </a:prstGeom>
+          <a:noFill/>
+        </p:spPr>
+        <p:txBody>
+          <a:bodyPr wrap="square" anchor="ctr" lIns="36576" rIns="36576" tIns="0" bIns="0">
+            <a:spAutoFit/>
+          </a:bodyPr>
+          <a:lstStyle/>
+          <a:p>
+            <a:pPr algn="ctr" rtl="1"/>
+            <a:r>
+              <a:rPr sz="1000" b="0">
+                <a:solidFill>
+                  <a:srgbClr val="8A94A8"/>
+                </a:solidFill>
+                <a:latin typeface="Heebo"/>
+                <a:cs typeface="Heebo"/>
+              </a:rPr>
+              <a:t>חוזר</a:t>
+            </a:r>
+          </a:p>
+        </p:txBody>
+      </p:sp>
+      <p:sp>
+        <p:nvSpPr>
+          <p:cNvPr id="36" name="Rounded Rectangle 35"/>
+          <p:cNvSpPr/>
+          <p:nvPr/>
+        </p:nvSpPr>
+        <p:spPr>
+          <a:xfrm>
+            <a:off x="5440680" y="4590288"/>
+            <a:ext cx="6339535" cy="512064"/>
+          </a:xfrm>
+          <a:prstGeom prst="roundRect">
+            <a:avLst>
+              <a:gd name="adj" fmla="val 15000"/>
+            </a:avLst>
+          </a:prstGeom>
+          <a:solidFill>
+            <a:srgbClr val="FFFFFF"/>
+          </a:solidFill>
+          <a:ln w="15875">
+            <a:solidFill>
+              <a:srgbClr val="C5CDDD"/>
+            </a:solidFill>
+          </a:ln>
+          <a:effectLst/>
+        </p:spPr>
+        <p:style>
+          <a:lnRef idx="1">
+            <a:schemeClr val="accent1"/>
+          </a:lnRef>
+          <a:fillRef idx="3">
+            <a:schemeClr val="accent1"/>
+          </a:fillRef>
+          <a:effectRef idx="2">
+            <a:schemeClr val="accent1"/>
+          </a:effectRef>
+          <a:fontRef idx="minor">
+            <a:schemeClr val="lt1"/>
+          </a:fontRef>
+        </p:style>
+        <p:txBody>
+          <a:bodyPr rtlCol="0" anchor="ctr"/>
+          <a:lstStyle/>
+          <a:p>
+            <a:pPr algn="ctr"/>
+          </a:p>
+        </p:txBody>
+      </p:sp>
+      <p:sp>
+        <p:nvSpPr>
+          <p:cNvPr id="37" name="TextBox 36"/>
+          <p:cNvSpPr txBox="1"/>
+          <p:nvPr/>
+        </p:nvSpPr>
+        <p:spPr>
+          <a:xfrm>
+            <a:off x="8275320" y="4590288"/>
+            <a:ext cx="3322015" cy="512064"/>
+          </a:xfrm>
+          <a:prstGeom prst="rect">
+            <a:avLst/>
+          </a:prstGeom>
+          <a:noFill/>
+        </p:spPr>
+        <p:txBody>
+          <a:bodyPr wrap="square" anchor="ctr" lIns="36576" rIns="36576" tIns="0" bIns="0">
+            <a:spAutoFit/>
+          </a:bodyPr>
+          <a:lstStyle/>
+          <a:p>
+            <a:pPr algn="r" rtl="1"/>
+            <a:r>
+              <a:rPr sz="1300" b="1">
+                <a:solidFill>
+                  <a:srgbClr val="1A2233"/>
+                </a:solidFill>
+                <a:latin typeface="Heebo"/>
+                <a:cs typeface="Heebo"/>
+              </a:rPr>
+              <a:t>תמיר דורטל · 4 דיונים</a:t>
+            </a:r>
+          </a:p>
+        </p:txBody>
+      </p:sp>
+      <p:sp>
+        <p:nvSpPr>
+          <p:cNvPr id="38" name="TextBox 37"/>
+          <p:cNvSpPr txBox="1"/>
+          <p:nvPr/>
+        </p:nvSpPr>
+        <p:spPr>
+          <a:xfrm>
+            <a:off x="6903720" y="4590288"/>
+            <a:ext cx="1280160" cy="512064"/>
+          </a:xfrm>
+          <a:prstGeom prst="rect">
+            <a:avLst/>
+          </a:prstGeom>
+          <a:noFill/>
+        </p:spPr>
+        <p:txBody>
+          <a:bodyPr wrap="square" anchor="ctr" lIns="36576" rIns="36576" tIns="0" bIns="0">
+            <a:spAutoFit/>
+          </a:bodyPr>
+          <a:lstStyle/>
+          <a:p>
+            <a:pPr algn="ctr" rtl="1"/>
+            <a:r>
+              <a:rPr sz="1400" b="1">
+                <a:solidFill>
+                  <a:srgbClr val="1C3C7A"/>
+                </a:solidFill>
+                <a:latin typeface="Heebo"/>
+                <a:cs typeface="Heebo"/>
+              </a:rPr>
+              <a:t>—</a:t>
+            </a:r>
+          </a:p>
+        </p:txBody>
+      </p:sp>
+      <p:sp>
+        <p:nvSpPr>
+          <p:cNvPr id="39" name="Rounded Rectangle 38"/>
+          <p:cNvSpPr/>
+          <p:nvPr/>
+        </p:nvSpPr>
+        <p:spPr>
+          <a:xfrm>
+            <a:off x="5577840" y="4700016"/>
+            <a:ext cx="1234440" cy="292608"/>
+          </a:xfrm>
+          <a:prstGeom prst="roundRect">
+            <a:avLst>
+              <a:gd name="adj" fmla="val 50000"/>
+            </a:avLst>
+          </a:prstGeom>
+          <a:solidFill>
+            <a:srgbClr val="F4F6FB"/>
+          </a:solidFill>
+          <a:ln>
+            <a:noFill/>
+          </a:ln>
+          <a:effectLst/>
+        </p:spPr>
+        <p:style>
+          <a:lnRef idx="1">
+            <a:schemeClr val="accent1"/>
+          </a:lnRef>
+          <a:fillRef idx="3">
+            <a:schemeClr val="accent1"/>
+          </a:fillRef>
+          <a:effectRef idx="2">
+            <a:schemeClr val="accent1"/>
+          </a:effectRef>
+          <a:fontRef idx="minor">
+            <a:schemeClr val="lt1"/>
+          </a:fontRef>
+        </p:style>
+        <p:txBody>
+          <a:bodyPr rtlCol="0" anchor="ctr"/>
+          <a:lstStyle/>
+          <a:p>
+            <a:pPr algn="ctr"/>
+          </a:p>
+        </p:txBody>
+      </p:sp>
+      <p:sp>
+        <p:nvSpPr>
+          <p:cNvPr id="40" name="TextBox 39"/>
+          <p:cNvSpPr txBox="1"/>
+          <p:nvPr/>
+        </p:nvSpPr>
+        <p:spPr>
+          <a:xfrm>
+            <a:off x="5577840" y="4700016"/>
+            <a:ext cx="1234440" cy="292608"/>
+          </a:xfrm>
+          <a:prstGeom prst="rect">
+            <a:avLst/>
+          </a:prstGeom>
+          <a:noFill/>
+        </p:spPr>
+        <p:txBody>
+          <a:bodyPr wrap="square" anchor="ctr" lIns="36576" rIns="36576" tIns="0" bIns="0">
+            <a:spAutoFit/>
+          </a:bodyPr>
+          <a:lstStyle/>
+          <a:p>
+            <a:pPr algn="ctr" rtl="1"/>
+            <a:r>
+              <a:rPr sz="1000" b="0">
+                <a:solidFill>
+                  <a:srgbClr val="8A94A8"/>
+                </a:solidFill>
+                <a:latin typeface="Heebo"/>
+                <a:cs typeface="Heebo"/>
+              </a:rPr>
+              <a:t>בעלים</a:t>
+            </a:r>
+          </a:p>
+        </p:txBody>
+      </p:sp>
+      <p:sp>
+        <p:nvSpPr>
+          <p:cNvPr id="41" name="Rounded Rectangle 40"/>
+          <p:cNvSpPr/>
+          <p:nvPr/>
+        </p:nvSpPr>
+        <p:spPr>
+          <a:xfrm>
+            <a:off x="411480" y="1188720"/>
+            <a:ext cx="4754880" cy="2331720"/>
+          </a:xfrm>
+          <a:prstGeom prst="roundRect">
+            <a:avLst>
+              <a:gd name="adj" fmla="val 6000"/>
+            </a:avLst>
+          </a:prstGeom>
+          <a:solidFill>
+            <a:srgbClr val="1C3C7A"/>
+          </a:solidFill>
+          <a:ln>
+            <a:noFill/>
+          </a:ln>
+          <a:effectLst/>
+        </p:spPr>
+        <p:style>
+          <a:lnRef idx="1">
+            <a:schemeClr val="accent1"/>
+          </a:lnRef>
+          <a:fillRef idx="3">
+            <a:schemeClr val="accent1"/>
+          </a:fillRef>
+          <a:effectRef idx="2">
+            <a:schemeClr val="accent1"/>
+          </a:effectRef>
+          <a:fontRef idx="minor">
+            <a:schemeClr val="lt1"/>
+          </a:fontRef>
+        </p:style>
+        <p:txBody>
+          <a:bodyPr rtlCol="0" anchor="ctr"/>
+          <a:lstStyle/>
+          <a:p>
+            <a:pPr algn="ctr"/>
+          </a:p>
+        </p:txBody>
+      </p:sp>
+      <p:sp>
+        <p:nvSpPr>
+          <p:cNvPr id="42" name="TextBox 41"/>
+          <p:cNvSpPr txBox="1"/>
+          <p:nvPr/>
+        </p:nvSpPr>
+        <p:spPr>
+          <a:xfrm>
+            <a:off x="411480" y="1325880"/>
+            <a:ext cx="4754880" cy="274320"/>
+          </a:xfrm>
+          <a:prstGeom prst="rect">
+            <a:avLst/>
+          </a:prstGeom>
+          <a:noFill/>
+        </p:spPr>
+        <p:txBody>
+          <a:bodyPr wrap="square" anchor="ctr" lIns="36576" rIns="36576" tIns="0" bIns="0">
+            <a:spAutoFit/>
+          </a:bodyPr>
+          <a:lstStyle/>
+          <a:p>
+            <a:pPr algn="ctr" rtl="1"/>
+            <a:r>
+              <a:rPr sz="1300" b="0">
+                <a:solidFill>
+                  <a:srgbClr val="F0C000"/>
+                </a:solidFill>
+                <a:latin typeface="Heebo"/>
+                <a:cs typeface="Heebo"/>
+              </a:rPr>
+              <a:t>עלות חודשית</a:t>
+            </a:r>
+          </a:p>
+        </p:txBody>
+      </p:sp>
+      <p:sp>
+        <p:nvSpPr>
+          <p:cNvPr id="43" name="TextBox 42"/>
+          <p:cNvSpPr txBox="1"/>
+          <p:nvPr/>
+        </p:nvSpPr>
+        <p:spPr>
+          <a:xfrm>
+            <a:off x="411480" y="1600200"/>
+            <a:ext cx="4754880" cy="731520"/>
+          </a:xfrm>
+          <a:prstGeom prst="rect">
+            <a:avLst/>
+          </a:prstGeom>
+          <a:noFill/>
+        </p:spPr>
+        <p:txBody>
+          <a:bodyPr wrap="square" anchor="ctr" lIns="36576" rIns="36576" tIns="0" bIns="0">
+            <a:spAutoFit/>
+          </a:bodyPr>
+          <a:lstStyle/>
+          <a:p>
+            <a:pPr algn="ctr" rtl="1"/>
+            <a:r>
+              <a:rPr sz="4400" b="1">
+                <a:solidFill>
+                  <a:srgbClr val="FFFFFF"/>
+                </a:solidFill>
+                <a:latin typeface="Heebo"/>
+                <a:cs typeface="Heebo"/>
+              </a:rPr>
+              <a:t>31,600 ₪</a:t>
+            </a:r>
+          </a:p>
+        </p:txBody>
+      </p:sp>
+      <p:sp>
+        <p:nvSpPr>
+          <p:cNvPr id="44" name="TextBox 43"/>
+          <p:cNvSpPr txBox="1"/>
+          <p:nvPr/>
+        </p:nvSpPr>
+        <p:spPr>
+          <a:xfrm>
+            <a:off x="411480" y="2304288"/>
+            <a:ext cx="4754880" cy="274320"/>
+          </a:xfrm>
+          <a:prstGeom prst="rect">
+            <a:avLst/>
+          </a:prstGeom>
+          <a:noFill/>
+        </p:spPr>
+        <p:txBody>
+          <a:bodyPr wrap="square" anchor="ctr" lIns="36576" rIns="36576" tIns="0" bIns="0">
+            <a:spAutoFit/>
+          </a:bodyPr>
+          <a:lstStyle/>
+          <a:p>
+            <a:pPr algn="ctr" rtl="1"/>
+            <a:r>
+              <a:rPr sz="1300" b="0">
+                <a:solidFill>
+                  <a:srgbClr val="FFFFFF"/>
+                </a:solidFill>
+                <a:latin typeface="Heebo"/>
+                <a:cs typeface="Heebo"/>
+              </a:rPr>
+              <a:t>379,200 ₪ בשנה</a:t>
+            </a:r>
+          </a:p>
+        </p:txBody>
+      </p:sp>
+      <p:sp>
+        <p:nvSpPr>
+          <p:cNvPr id="45" name="Rounded Rectangle 44"/>
+          <p:cNvSpPr/>
+          <p:nvPr/>
+        </p:nvSpPr>
+        <p:spPr>
+          <a:xfrm>
+            <a:off x="2834640" y="2697480"/>
+            <a:ext cx="2148840" cy="658368"/>
+          </a:xfrm>
+          <a:prstGeom prst="roundRect">
+            <a:avLst>
+              <a:gd name="adj" fmla="val 15000"/>
+            </a:avLst>
+          </a:prstGeom>
+          <a:solidFill>
+            <a:srgbClr val="2A4C8C"/>
+          </a:solidFill>
+          <a:ln>
+            <a:noFill/>
+          </a:ln>
+          <a:effectLst/>
+        </p:spPr>
+        <p:style>
+          <a:lnRef idx="1">
+            <a:schemeClr val="accent1"/>
+          </a:lnRef>
+          <a:fillRef idx="3">
+            <a:schemeClr val="accent1"/>
+          </a:fillRef>
+          <a:effectRef idx="2">
+            <a:schemeClr val="accent1"/>
+          </a:effectRef>
+          <a:fontRef idx="minor">
+            <a:schemeClr val="lt1"/>
+          </a:fontRef>
+        </p:style>
+        <p:txBody>
+          <a:bodyPr rtlCol="0" anchor="ctr"/>
+          <a:lstStyle/>
+          <a:p>
+            <a:pPr algn="ctr"/>
+          </a:p>
+        </p:txBody>
+      </p:sp>
+      <p:sp>
+        <p:nvSpPr>
+          <p:cNvPr id="46" name="TextBox 45"/>
+          <p:cNvSpPr txBox="1"/>
+          <p:nvPr/>
+        </p:nvSpPr>
+        <p:spPr>
+          <a:xfrm>
+            <a:off x="2834640" y="2715768"/>
+            <a:ext cx="2148840" cy="347472"/>
+          </a:xfrm>
+          <a:prstGeom prst="rect">
+            <a:avLst/>
+          </a:prstGeom>
+          <a:noFill/>
+        </p:spPr>
+        <p:txBody>
+          <a:bodyPr wrap="square" anchor="ctr" lIns="36576" rIns="36576" tIns="0" bIns="0">
+            <a:spAutoFit/>
+          </a:bodyPr>
+          <a:lstStyle/>
+          <a:p>
+            <a:pPr algn="ctr" rtl="1"/>
+            <a:r>
+              <a:rPr sz="1700" b="1">
+                <a:solidFill>
+                  <a:srgbClr val="FFFFFF"/>
+                </a:solidFill>
+                <a:latin typeface="Heebo"/>
+                <a:cs typeface="Heebo"/>
+              </a:rPr>
+              <a:t>16</a:t>
+            </a:r>
+          </a:p>
+        </p:txBody>
+      </p:sp>
+      <p:sp>
+        <p:nvSpPr>
+          <p:cNvPr id="47" name="TextBox 46"/>
+          <p:cNvSpPr txBox="1"/>
+          <p:nvPr/>
+        </p:nvSpPr>
+        <p:spPr>
+          <a:xfrm>
+            <a:off x="2834640" y="3054096"/>
+            <a:ext cx="2148840" cy="256032"/>
+          </a:xfrm>
+          <a:prstGeom prst="rect">
+            <a:avLst/>
+          </a:prstGeom>
+          <a:noFill/>
+        </p:spPr>
+        <p:txBody>
+          <a:bodyPr wrap="square" anchor="ctr" lIns="36576" rIns="36576" tIns="0" bIns="0">
+            <a:spAutoFit/>
+          </a:bodyPr>
+          <a:lstStyle/>
+          <a:p>
+            <a:pPr algn="ctr" rtl="1"/>
+            <a:r>
+              <a:rPr sz="1000" b="0">
+                <a:solidFill>
+                  <a:srgbClr val="F0C000"/>
+                </a:solidFill>
+                <a:latin typeface="Heebo"/>
+                <a:cs typeface="Heebo"/>
+              </a:rPr>
+              <a:t>דיונים בחודש</a:t>
+            </a:r>
+          </a:p>
+        </p:txBody>
+      </p:sp>
+      <p:sp>
+        <p:nvSpPr>
+          <p:cNvPr id="48" name="Rounded Rectangle 47"/>
+          <p:cNvSpPr/>
+          <p:nvPr/>
+        </p:nvSpPr>
+        <p:spPr>
+          <a:xfrm>
+            <a:off x="594360" y="2697480"/>
+            <a:ext cx="2148840" cy="658368"/>
+          </a:xfrm>
+          <a:prstGeom prst="roundRect">
+            <a:avLst>
+              <a:gd name="adj" fmla="val 15000"/>
+            </a:avLst>
+          </a:prstGeom>
+          <a:solidFill>
+            <a:srgbClr val="2A4C8C"/>
+          </a:solidFill>
+          <a:ln>
+            <a:noFill/>
+          </a:ln>
+          <a:effectLst/>
+        </p:spPr>
+        <p:style>
+          <a:lnRef idx="1">
+            <a:schemeClr val="accent1"/>
+          </a:lnRef>
+          <a:fillRef idx="3">
+            <a:schemeClr val="accent1"/>
+          </a:fillRef>
+          <a:effectRef idx="2">
+            <a:schemeClr val="accent1"/>
+          </a:effectRef>
+          <a:fontRef idx="minor">
+            <a:schemeClr val="lt1"/>
+          </a:fontRef>
+        </p:style>
+        <p:txBody>
+          <a:bodyPr rtlCol="0" anchor="ctr"/>
+          <a:lstStyle/>
+          <a:p>
+            <a:pPr algn="ctr"/>
+          </a:p>
+        </p:txBody>
+      </p:sp>
+      <p:sp>
+        <p:nvSpPr>
+          <p:cNvPr id="49" name="TextBox 48"/>
+          <p:cNvSpPr txBox="1"/>
+          <p:nvPr/>
+        </p:nvSpPr>
+        <p:spPr>
+          <a:xfrm>
+            <a:off x="594360" y="2715768"/>
+            <a:ext cx="2148840" cy="347472"/>
+          </a:xfrm>
+          <a:prstGeom prst="rect">
+            <a:avLst/>
+          </a:prstGeom>
+          <a:noFill/>
+        </p:spPr>
+        <p:txBody>
+          <a:bodyPr wrap="square" anchor="ctr" lIns="36576" rIns="36576" tIns="0" bIns="0">
+            <a:spAutoFit/>
+          </a:bodyPr>
+          <a:lstStyle/>
+          <a:p>
+            <a:pPr algn="ctr" rtl="1"/>
+            <a:r>
+              <a:rPr sz="1700" b="1">
+                <a:solidFill>
+                  <a:srgbClr val="FFFFFF"/>
+                </a:solidFill>
+                <a:latin typeface="Heebo"/>
+                <a:cs typeface="Heebo"/>
+              </a:rPr>
+              <a:t>1,975 ₪</a:t>
+            </a:r>
+          </a:p>
+        </p:txBody>
+      </p:sp>
+      <p:sp>
+        <p:nvSpPr>
+          <p:cNvPr id="50" name="TextBox 49"/>
+          <p:cNvSpPr txBox="1"/>
+          <p:nvPr/>
+        </p:nvSpPr>
+        <p:spPr>
+          <a:xfrm>
+            <a:off x="594360" y="3054096"/>
+            <a:ext cx="2148840" cy="256032"/>
+          </a:xfrm>
+          <a:prstGeom prst="rect">
+            <a:avLst/>
+          </a:prstGeom>
+          <a:noFill/>
+        </p:spPr>
+        <p:txBody>
+          <a:bodyPr wrap="square" anchor="ctr" lIns="36576" rIns="36576" tIns="0" bIns="0">
+            <a:spAutoFit/>
+          </a:bodyPr>
+          <a:lstStyle/>
+          <a:p>
+            <a:pPr algn="ctr" rtl="1"/>
+            <a:r>
+              <a:rPr sz="1000" b="0">
+                <a:solidFill>
+                  <a:srgbClr val="F0C000"/>
+                </a:solidFill>
+                <a:latin typeface="Heebo"/>
+                <a:cs typeface="Heebo"/>
+              </a:rPr>
+              <a:t>לדיון</a:t>
+            </a:r>
+          </a:p>
+        </p:txBody>
+      </p:sp>
+      <p:sp>
+        <p:nvSpPr>
+          <p:cNvPr id="51" name="Rounded Rectangle 50"/>
+          <p:cNvSpPr/>
+          <p:nvPr/>
+        </p:nvSpPr>
+        <p:spPr>
+          <a:xfrm>
+            <a:off x="411480" y="3703320"/>
+            <a:ext cx="4754880" cy="2926080"/>
+          </a:xfrm>
+          <a:prstGeom prst="roundRect">
+            <a:avLst>
+              <a:gd name="adj" fmla="val 6000"/>
+            </a:avLst>
+          </a:prstGeom>
+          <a:solidFill>
+            <a:srgbClr val="FFFFFF"/>
+          </a:solidFill>
+          <a:ln w="38100">
+            <a:solidFill>
+              <a:srgbClr val="F0C000"/>
+            </a:solidFill>
+          </a:ln>
+          <a:effectLst/>
+        </p:spPr>
+        <p:style>
+          <a:lnRef idx="1">
+            <a:schemeClr val="accent1"/>
+          </a:lnRef>
+          <a:fillRef idx="3">
+            <a:schemeClr val="accent1"/>
+          </a:fillRef>
+          <a:effectRef idx="2">
+            <a:schemeClr val="accent1"/>
+          </a:effectRef>
+          <a:fontRef idx="minor">
+            <a:schemeClr val="lt1"/>
+          </a:fontRef>
+        </p:style>
+        <p:txBody>
+          <a:bodyPr rtlCol="0" anchor="ctr"/>
+          <a:lstStyle/>
+          <a:p>
+            <a:pPr algn="ctr"/>
+          </a:p>
+        </p:txBody>
+      </p:sp>
+      <p:sp>
+        <p:nvSpPr>
+          <p:cNvPr id="52" name="TextBox 51"/>
+          <p:cNvSpPr txBox="1"/>
+          <p:nvPr/>
+        </p:nvSpPr>
+        <p:spPr>
+          <a:xfrm>
+            <a:off x="594360" y="3813048"/>
+            <a:ext cx="4389120" cy="566928"/>
+          </a:xfrm>
+          <a:prstGeom prst="rect">
+            <a:avLst/>
+          </a:prstGeom>
+          <a:noFill/>
+        </p:spPr>
+        <p:txBody>
+          <a:bodyPr wrap="square" anchor="ctr" lIns="36576" rIns="36576" tIns="0" bIns="0">
+            <a:spAutoFit/>
+          </a:bodyPr>
+          <a:lstStyle/>
+          <a:p>
+            <a:pPr algn="r" rtl="1"/>
+            <a:r>
+              <a:rPr sz="1500" b="1">
+                <a:solidFill>
+                  <a:srgbClr val="1C3C7A"/>
+                </a:solidFill>
+                <a:latin typeface="Heebo"/>
+                <a:cs typeface="Heebo"/>
+              </a:rPr>
+              <a:t>שכר מספק הוא השקעה, לא הוצאה</a:t>
+            </a:r>
+          </a:p>
+        </p:txBody>
+      </p:sp>
+      <p:sp>
+        <p:nvSpPr>
+          <p:cNvPr id="53" name="TextBox 52"/>
+          <p:cNvSpPr txBox="1"/>
+          <p:nvPr/>
+        </p:nvSpPr>
+        <p:spPr>
+          <a:xfrm>
+            <a:off x="640080" y="4434840"/>
+            <a:ext cx="4297680" cy="548640"/>
+          </a:xfrm>
+          <a:prstGeom prst="rect">
+            <a:avLst/>
+          </a:prstGeom>
+          <a:noFill/>
+        </p:spPr>
+        <p:txBody>
+          <a:bodyPr wrap="square" anchor="t" lIns="36576" rIns="36576" tIns="0" bIns="0">
+            <a:spAutoFit/>
+          </a:bodyPr>
+          <a:lstStyle/>
+          <a:p>
+            <a:pPr algn="r" rtl="1"/>
+            <a:r>
+              <a:rPr sz="1200" b="1">
+                <a:solidFill>
+                  <a:srgbClr val="1A2233"/>
+                </a:solidFill>
+                <a:latin typeface="Heebo"/>
+                <a:cs typeface="Heebo"/>
+              </a:rPr>
+              <a:t>• מי שמתפרנס מהתפקיד מתחייב אליו: מגיע לכל דיון, מוכן, ולאורך זמן</a:t>
+            </a:r>
+          </a:p>
+        </p:txBody>
+      </p:sp>
+      <p:sp>
+        <p:nvSpPr>
+          <p:cNvPr id="54" name="TextBox 53"/>
+          <p:cNvSpPr txBox="1"/>
+          <p:nvPr/>
+        </p:nvSpPr>
+        <p:spPr>
+          <a:xfrm>
+            <a:off x="640080" y="5056632"/>
+            <a:ext cx="4297680" cy="548640"/>
+          </a:xfrm>
+          <a:prstGeom prst="rect">
+            <a:avLst/>
+          </a:prstGeom>
+          <a:noFill/>
+        </p:spPr>
+        <p:txBody>
+          <a:bodyPr wrap="square" anchor="t" lIns="36576" rIns="36576" tIns="0" bIns="0">
+            <a:spAutoFit/>
+          </a:bodyPr>
+          <a:lstStyle/>
+          <a:p>
+            <a:pPr algn="r" rtl="1"/>
+            <a:r>
+              <a:rPr sz="1200" b="1">
+                <a:solidFill>
+                  <a:srgbClr val="1A2233"/>
+                </a:solidFill>
+                <a:latin typeface="Heebo"/>
+                <a:cs typeface="Heebo"/>
+              </a:rPr>
+              <a:t>• פחות תחלופה = פחות חפיפות, ויותר היכרות אישית עם חברי הכנסת והיועצים</a:t>
+            </a:r>
+          </a:p>
+        </p:txBody>
+      </p:sp>
+      <p:sp>
+        <p:nvSpPr>
+          <p:cNvPr id="55" name="TextBox 54"/>
+          <p:cNvSpPr txBox="1"/>
+          <p:nvPr/>
+        </p:nvSpPr>
+        <p:spPr>
+          <a:xfrm>
+            <a:off x="640080" y="5678424"/>
+            <a:ext cx="4297680" cy="548640"/>
+          </a:xfrm>
+          <a:prstGeom prst="rect">
+            <a:avLst/>
+          </a:prstGeom>
+          <a:noFill/>
+        </p:spPr>
+        <p:txBody>
+          <a:bodyPr wrap="square" anchor="t" lIns="36576" rIns="36576" tIns="0" bIns="0">
+            <a:spAutoFit/>
+          </a:bodyPr>
+          <a:lstStyle/>
+          <a:p>
+            <a:pPr algn="r" rtl="1"/>
+            <a:r>
+              <a:rPr sz="1200" b="1">
+                <a:solidFill>
+                  <a:srgbClr val="1A2233"/>
+                </a:solidFill>
+                <a:latin typeface="Heebo"/>
+                <a:cs typeface="Heebo"/>
+              </a:rPr>
+              <a:t>• דיון שחסכנו עליו עולה מעט. דיון שפספסנו עולה בחוק שעבר בלעדינו</a:t>
+            </a:r>
+          </a:p>
+        </p:txBody>
+      </p:sp>
+    </p:spTree>
+  </p:cSld>
+  <p:clrMapOvr>
+    <a:masterClrMapping/>
+  </p:clrMapOvr>
+</p:sld>
+</file>
+
+<file path=ppt/slides/slide12.xml><?xml version="1.0" encoding="utf-8"?>
+<p:sld xmlns:a="http://schemas.openxmlformats.org/drawingml/2006/main" xmlns:p="http://schemas.openxmlformats.org/presentationml/2006/main" xmlns:r="http://schemas.openxmlformats.org/officeDocument/2006/relationships">
+  <p:cSld>
+    <p:bg>
+      <p:bgPr>
+        <a:solidFill>
+          <a:srgbClr val="F4F6FB"/>
+        </a:solidFill>
+        <a:effectLst/>
+      </p:bgPr>
+    </p:bg>
+    <p:spTree>
+      <p:nvGrpSpPr>
+        <p:cNvPr id="1" name=""/>
+        <p:cNvGrpSpPr/>
+        <p:nvPr/>
+      </p:nvGrpSpPr>
+      <p:grpSpPr/>
+      <p:sp>
+        <p:nvSpPr>
+          <p:cNvPr id="2" name="Rectangle 1"/>
+          <p:cNvSpPr/>
+          <p:nvPr/>
+        </p:nvSpPr>
+        <p:spPr>
+          <a:xfrm>
+            <a:off x="0" y="0"/>
+            <a:ext cx="12191695" cy="868680"/>
+          </a:xfrm>
+          <a:prstGeom prst="rect">
+            <a:avLst/>
+          </a:prstGeom>
+          <a:solidFill>
+            <a:srgbClr val="1C3C7A"/>
+          </a:solidFill>
+          <a:ln>
+            <a:noFill/>
+          </a:ln>
+          <a:effectLst/>
+        </p:spPr>
+        <p:style>
+          <a:lnRef idx="1">
+            <a:schemeClr val="accent1"/>
+          </a:lnRef>
+          <a:fillRef idx="3">
+            <a:schemeClr val="accent1"/>
+          </a:fillRef>
+          <a:effectRef idx="2">
+            <a:schemeClr val="accent1"/>
+          </a:effectRef>
+          <a:fontRef idx="minor">
+            <a:schemeClr val="lt1"/>
+          </a:fontRef>
+        </p:style>
+        <p:txBody>
+          <a:bodyPr rtlCol="0" anchor="ctr"/>
+          <a:lstStyle/>
+          <a:p>
+            <a:pPr algn="ctr"/>
+          </a:p>
+        </p:txBody>
+      </p:sp>
+      <p:sp>
+        <p:nvSpPr>
+          <p:cNvPr id="3" name="Rectangle 2"/>
+          <p:cNvSpPr/>
+          <p:nvPr/>
+        </p:nvSpPr>
+        <p:spPr>
+          <a:xfrm>
+            <a:off x="0" y="868680"/>
+            <a:ext cx="12191695" cy="54864"/>
+          </a:xfrm>
+          <a:prstGeom prst="rect">
+            <a:avLst/>
+          </a:prstGeom>
+          <a:solidFill>
+            <a:srgbClr val="F0C000"/>
+          </a:solidFill>
+          <a:ln>
+            <a:noFill/>
+          </a:ln>
+          <a:effectLst/>
+        </p:spPr>
+        <p:style>
+          <a:lnRef idx="1">
+            <a:schemeClr val="accent1"/>
+          </a:lnRef>
+          <a:fillRef idx="3">
+            <a:schemeClr val="accent1"/>
+          </a:fillRef>
+          <a:effectRef idx="2">
+            <a:schemeClr val="accent1"/>
+          </a:effectRef>
+          <a:fontRef idx="minor">
+            <a:schemeClr val="lt1"/>
+          </a:fontRef>
+        </p:style>
+        <p:txBody>
+          <a:bodyPr rtlCol="0" anchor="ctr"/>
+          <a:lstStyle/>
+          <a:p>
+            <a:pPr algn="ctr"/>
+          </a:p>
+        </p:txBody>
+      </p:sp>
+      <p:sp>
+        <p:nvSpPr>
+          <p:cNvPr id="4" name="TextBox 3"/>
+          <p:cNvSpPr txBox="1"/>
+          <p:nvPr/>
+        </p:nvSpPr>
+        <p:spPr>
+          <a:xfrm>
+            <a:off x="1280160" y="109728"/>
+            <a:ext cx="10515600" cy="457200"/>
+          </a:xfrm>
+          <a:prstGeom prst="rect">
+            <a:avLst/>
+          </a:prstGeom>
+          <a:noFill/>
+        </p:spPr>
+        <p:txBody>
+          <a:bodyPr wrap="square" anchor="ctr" lIns="36576" rIns="36576" tIns="0" bIns="0">
+            <a:spAutoFit/>
+          </a:bodyPr>
+          <a:lstStyle/>
+          <a:p>
+            <a:pPr algn="r" rtl="1"/>
+            <a:r>
+              <a:rPr sz="2600" b="1">
+                <a:solidFill>
+                  <a:srgbClr val="FFFFFF"/>
+                </a:solidFill>
+                <a:latin typeface="Heebo"/>
+                <a:cs typeface="Heebo"/>
+              </a:rPr>
+              <a:t>הוצאות · שלושה מודלים</a:t>
+            </a:r>
+          </a:p>
+        </p:txBody>
+      </p:sp>
+      <p:sp>
+        <p:nvSpPr>
+          <p:cNvPr id="6" name="Rounded Rectangle 5"/>
+          <p:cNvSpPr/>
+          <p:nvPr/>
+        </p:nvSpPr>
+        <p:spPr>
+          <a:xfrm>
+            <a:off x="265176" y="54864"/>
+            <a:ext cx="910550" cy="768096"/>
+          </a:xfrm>
+          <a:prstGeom prst="roundRect">
+            <a:avLst>
+              <a:gd name="adj" fmla="val 12000"/>
+            </a:avLst>
+          </a:prstGeom>
+          <a:solidFill>
+            <a:srgbClr val="FFFFFF"/>
+          </a:solidFill>
+          <a:ln>
+            <a:noFill/>
+          </a:ln>
+          <a:effectLst/>
+        </p:spPr>
+        <p:style>
+          <a:lnRef idx="1">
+            <a:schemeClr val="accent1"/>
+          </a:lnRef>
+          <a:fillRef idx="3">
+            <a:schemeClr val="accent1"/>
+          </a:fillRef>
+          <a:effectRef idx="2">
+            <a:schemeClr val="accent1"/>
+          </a:effectRef>
+          <a:fontRef idx="minor">
+            <a:schemeClr val="lt1"/>
+          </a:fontRef>
+        </p:style>
+        <p:txBody>
+          <a:bodyPr rtlCol="0" anchor="ctr"/>
+          <a:lstStyle/>
+          <a:p>
+            <a:pPr algn="ctr"/>
+          </a:p>
+        </p:txBody>
+      </p:sp>
+      <p:pic>
+        <p:nvPicPr>
+          <p:cNvPr id="5" name="Picture 4" descr="logo.png"/>
+          <p:cNvPicPr>
+            <a:picLocks noChangeAspect="1"/>
+          </p:cNvPicPr>
+          <p:nvPr/>
+        </p:nvPicPr>
+        <p:blipFill>
+          <a:blip r:embed="rId2"/>
+          <a:stretch>
+            <a:fillRect/>
+          </a:stretch>
+        </p:blipFill>
+        <p:spPr>
+          <a:xfrm>
+            <a:off x="320040" y="73152"/>
+            <a:ext cx="800822" cy="731520"/>
+          </a:xfrm>
+          <a:prstGeom prst="rect">
+            <a:avLst/>
+          </a:prstGeom>
+        </p:spPr>
+      </p:pic>
+      <p:sp>
+        <p:nvSpPr>
+          <p:cNvPr id="7" name="Rounded Rectangle 6"/>
+          <p:cNvSpPr/>
+          <p:nvPr/>
+        </p:nvSpPr>
+        <p:spPr>
+          <a:xfrm>
+            <a:off x="8143037" y="1188720"/>
+            <a:ext cx="3637178" cy="5120640"/>
+          </a:xfrm>
+          <a:prstGeom prst="roundRect">
+            <a:avLst>
+              <a:gd name="adj" fmla="val 5000"/>
+            </a:avLst>
+          </a:prstGeom>
+          <a:solidFill>
+            <a:srgbClr val="FFFFFF"/>
+          </a:solidFill>
+          <a:ln w="15875">
+            <a:solidFill>
+              <a:srgbClr val="C5CDDD"/>
+            </a:solidFill>
+          </a:ln>
+          <a:effectLst/>
+        </p:spPr>
+        <p:style>
+          <a:lnRef idx="1">
+            <a:schemeClr val="accent1"/>
+          </a:lnRef>
+          <a:fillRef idx="3">
+            <a:schemeClr val="accent1"/>
+          </a:fillRef>
+          <a:effectRef idx="2">
+            <a:schemeClr val="accent1"/>
+          </a:effectRef>
+          <a:fontRef idx="minor">
+            <a:schemeClr val="lt1"/>
+          </a:fontRef>
+        </p:style>
+        <p:txBody>
+          <a:bodyPr rtlCol="0" anchor="ctr"/>
+          <a:lstStyle/>
+          <a:p>
+            <a:pPr algn="ctr"/>
+          </a:p>
+        </p:txBody>
+      </p:sp>
+      <p:sp>
+        <p:nvSpPr>
           <p:cNvPr id="8" name="Rounded Rectangle 7"/>
           <p:cNvSpPr/>
           <p:nvPr/>
@@ -9239,7 +13577,7 @@
                 <a:latin typeface="Heebo"/>
                 <a:cs typeface="Heebo"/>
               </a:rPr>
-              <a:t>צוות מלא בשכר מלא</a:t>
+              <a:t>צוות מלא בשכר מספק</a:t>
             </a:r>
           </a:p>
         </p:txBody>
@@ -9275,7 +13613,7 @@
                 <a:latin typeface="Heebo"/>
                 <a:cs typeface="Heebo"/>
               </a:rPr>
-              <a:t>25,600 ₪</a:t>
+              <a:t>31,600 ₪</a:t>
             </a:r>
           </a:p>
         </p:txBody>
@@ -9311,7 +13649,7 @@
                 <a:latin typeface="Heebo"/>
                 <a:cs typeface="Heebo"/>
               </a:rPr>
-              <a:t>לחודש · 307,200 ₪ בשנה</a:t>
+              <a:t>לחודש · 379,200 ₪ בשנה</a:t>
             </a:r>
           </a:p>
         </p:txBody>
@@ -9511,7 +13849,7 @@
                 <a:latin typeface="Heebo"/>
                 <a:cs typeface="Heebo"/>
               </a:rPr>
-              <a:t>1,600 ₪</a:t>
+              <a:t>1,975 ₪</a:t>
             </a:r>
           </a:p>
         </p:txBody>
@@ -9619,7 +13957,7 @@
                 <a:latin typeface="Heebo"/>
                 <a:cs typeface="Heebo"/>
               </a:rPr>
-              <a:t>12,000 ₪</a:t>
+              <a:t>15,000 ₪</a:t>
             </a:r>
           </a:p>
         </p:txBody>
@@ -9726,7 +14064,7 @@
                 <a:latin typeface="Heebo"/>
                 <a:cs typeface="Heebo"/>
               </a:rPr>
-              <a:t>5,000 ₪</a:t>
+              <a:t>7,000 ₪</a:t>
             </a:r>
           </a:p>
         </p:txBody>
@@ -9833,7 +14171,7 @@
                 <a:latin typeface="Heebo"/>
                 <a:cs typeface="Heebo"/>
               </a:rPr>
-              <a:t>5,000 ₪</a:t>
+              <a:t>6,000 ₪</a:t>
             </a:r>
           </a:p>
         </p:txBody>
@@ -10154,7 +14492,7 @@
                 <a:latin typeface="Heebo"/>
                 <a:cs typeface="Heebo"/>
               </a:rPr>
-              <a:t>מימון: כ-5 שותפים מייסדים</a:t>
+              <a:t>מימון: כ-6 שותפים מייסדים</a:t>
             </a:r>
           </a:p>
         </p:txBody>

</xml_diff>

<commit_message>
Program slides: leader name in title, domain headline and per-program tags
Co-Authored-By: Claude Opus 5.5 <noreply@anthropic.com>
Claude-Session: https://claude.ai/code/session_01W7Er83FuNT4pLFShWidYHn
</commit_message>
<xml_diff>
--- a/presentation/out/koach-hitarvut.pptx
+++ b/presentation/out/koach-hitarvut.pptx
@@ -24737,7 +24737,7 @@
                 <a:latin typeface="Heebo"/>
                 <a:cs typeface="Heebo"/>
               </a:rPr>
-              <a:t>תוכניות כנסת 26 · כלכלה</a:t>
+              <a:t>תוכניות כנסת 26 · תמיר דורטל</a:t>
             </a:r>
           </a:p>
         </p:txBody>
@@ -24773,7 +24773,7 @@
                 <a:latin typeface="Heebo"/>
                 <a:cs typeface="Heebo"/>
               </a:rPr>
-              <a:t>תמיר דורטל</a:t>
+              <a:t>מייסד · כלכלה, רגולציה וביטחון אישי</a:t>
             </a:r>
           </a:p>
         </p:txBody>
@@ -25022,14 +25022,62 @@
       </p:sp>
       <p:sp>
         <p:nvSpPr>
-          <p:cNvPr id="12" name="TextBox 11"/>
-          <p:cNvSpPr txBox="1"/>
-          <p:nvPr/>
-        </p:nvSpPr>
-        <p:spPr>
-          <a:xfrm>
-            <a:off x="594360" y="1234440"/>
-            <a:ext cx="10362895" cy="2011680"/>
+          <p:cNvPr id="12" name="Rounded Rectangle 11"/>
+          <p:cNvSpPr/>
+          <p:nvPr/>
+        </p:nvSpPr>
+        <p:spPr>
+          <a:xfrm>
+            <a:off x="594360" y="2075688"/>
+            <a:ext cx="1737360" cy="329184"/>
+          </a:xfrm>
+          <a:prstGeom prst="roundRect">
+            <a:avLst>
+              <a:gd name="adj" fmla="val 50000"/>
+            </a:avLst>
+          </a:prstGeom>
+          <a:solidFill>
+            <a:srgbClr val="F4F6FB"/>
+          </a:solidFill>
+          <a:ln w="15875">
+            <a:solidFill>
+              <a:srgbClr val="F0C000"/>
+            </a:solidFill>
+          </a:ln>
+          <a:effectLst/>
+        </p:spPr>
+        <p:style>
+          <a:lnRef idx="1">
+            <a:schemeClr val="accent1"/>
+          </a:lnRef>
+          <a:fillRef idx="3">
+            <a:schemeClr val="accent1"/>
+          </a:fillRef>
+          <a:effectRef idx="2">
+            <a:schemeClr val="accent1"/>
+          </a:effectRef>
+          <a:fontRef idx="minor">
+            <a:schemeClr val="lt1"/>
+          </a:fontRef>
+        </p:style>
+        <p:txBody>
+          <a:bodyPr rtlCol="0" anchor="ctr"/>
+          <a:lstStyle/>
+          <a:p>
+            <a:pPr algn="ctr"/>
+          </a:p>
+        </p:txBody>
+      </p:sp>
+      <p:sp>
+        <p:nvSpPr>
+          <p:cNvPr id="13" name="TextBox 12"/>
+          <p:cNvSpPr txBox="1"/>
+          <p:nvPr/>
+        </p:nvSpPr>
+        <p:spPr>
+          <a:xfrm>
+            <a:off x="594360" y="2075688"/>
+            <a:ext cx="1737360" cy="329184"/>
           </a:xfrm>
           <a:prstGeom prst="rect">
             <a:avLst/>
@@ -25042,6 +25090,42 @@
           </a:bodyPr>
           <a:lstStyle/>
           <a:p>
+            <a:pPr algn="ctr" rtl="1"/>
+            <a:r>
+              <a:rPr sz="1100" b="1">
+                <a:solidFill>
+                  <a:srgbClr val="1C3C7A"/>
+                </a:solidFill>
+                <a:latin typeface="Heebo"/>
+                <a:cs typeface="Heebo"/>
+              </a:rPr>
+              <a:t>ביטחון אישי</a:t>
+            </a:r>
+          </a:p>
+        </p:txBody>
+      </p:sp>
+      <p:sp>
+        <p:nvSpPr>
+          <p:cNvPr id="14" name="TextBox 13"/>
+          <p:cNvSpPr txBox="1"/>
+          <p:nvPr/>
+        </p:nvSpPr>
+        <p:spPr>
+          <a:xfrm>
+            <a:off x="2423160" y="1234440"/>
+            <a:ext cx="8534095" cy="2011680"/>
+          </a:xfrm>
+          <a:prstGeom prst="rect">
+            <a:avLst/>
+          </a:prstGeom>
+          <a:noFill/>
+        </p:spPr>
+        <p:txBody>
+          <a:bodyPr wrap="square" anchor="ctr" lIns="36576" rIns="36576" tIns="0" bIns="0">
+            <a:spAutoFit/>
+          </a:bodyPr>
+          <a:lstStyle/>
+          <a:p>
             <a:pPr algn="r" rtl="1"/>
             <a:r>
               <a:rPr sz="2400" b="1">
@@ -25058,7 +25142,7 @@
       </p:sp>
       <p:sp>
         <p:nvSpPr>
-          <p:cNvPr id="13" name="Rounded Rectangle 12"/>
+          <p:cNvPr id="15" name="Rounded Rectangle 14"/>
           <p:cNvSpPr/>
           <p:nvPr/>
         </p:nvSpPr>
@@ -25106,7 +25190,7 @@
       </p:sp>
       <p:sp>
         <p:nvSpPr>
-          <p:cNvPr id="14" name="Rectangle 13"/>
+          <p:cNvPr id="16" name="Rectangle 15"/>
           <p:cNvSpPr/>
           <p:nvPr/>
         </p:nvSpPr>
@@ -25150,7 +25234,7 @@
       </p:sp>
       <p:sp>
         <p:nvSpPr>
-          <p:cNvPr id="15" name="Oval 14"/>
+          <p:cNvPr id="17" name="Oval 16"/>
           <p:cNvSpPr/>
           <p:nvPr/>
         </p:nvSpPr>
@@ -25194,7 +25278,7 @@
       </p:sp>
       <p:sp>
         <p:nvSpPr>
-          <p:cNvPr id="16" name="TextBox 15"/>
+          <p:cNvPr id="18" name="TextBox 17"/>
           <p:cNvSpPr txBox="1"/>
           <p:nvPr/>
         </p:nvSpPr>
@@ -25230,14 +25314,98 @@
       </p:sp>
       <p:sp>
         <p:nvSpPr>
-          <p:cNvPr id="17" name="TextBox 16"/>
-          <p:cNvSpPr txBox="1"/>
-          <p:nvPr/>
-        </p:nvSpPr>
-        <p:spPr>
-          <a:xfrm>
-            <a:off x="594360" y="3392424"/>
-            <a:ext cx="10362895" cy="2011680"/>
+          <p:cNvPr id="19" name="Rounded Rectangle 18"/>
+          <p:cNvSpPr/>
+          <p:nvPr/>
+        </p:nvSpPr>
+        <p:spPr>
+          <a:xfrm>
+            <a:off x="594360" y="4233672"/>
+            <a:ext cx="1737360" cy="329184"/>
+          </a:xfrm>
+          <a:prstGeom prst="roundRect">
+            <a:avLst>
+              <a:gd name="adj" fmla="val 50000"/>
+            </a:avLst>
+          </a:prstGeom>
+          <a:solidFill>
+            <a:srgbClr val="F4F6FB"/>
+          </a:solidFill>
+          <a:ln w="15875">
+            <a:solidFill>
+              <a:srgbClr val="F0C000"/>
+            </a:solidFill>
+          </a:ln>
+          <a:effectLst/>
+        </p:spPr>
+        <p:style>
+          <a:lnRef idx="1">
+            <a:schemeClr val="accent1"/>
+          </a:lnRef>
+          <a:fillRef idx="3">
+            <a:schemeClr val="accent1"/>
+          </a:fillRef>
+          <a:effectRef idx="2">
+            <a:schemeClr val="accent1"/>
+          </a:effectRef>
+          <a:fontRef idx="minor">
+            <a:schemeClr val="lt1"/>
+          </a:fontRef>
+        </p:style>
+        <p:txBody>
+          <a:bodyPr rtlCol="0" anchor="ctr"/>
+          <a:lstStyle/>
+          <a:p>
+            <a:pPr algn="ctr"/>
+          </a:p>
+        </p:txBody>
+      </p:sp>
+      <p:sp>
+        <p:nvSpPr>
+          <p:cNvPr id="20" name="TextBox 19"/>
+          <p:cNvSpPr txBox="1"/>
+          <p:nvPr/>
+        </p:nvSpPr>
+        <p:spPr>
+          <a:xfrm>
+            <a:off x="594360" y="4233672"/>
+            <a:ext cx="1737360" cy="329184"/>
+          </a:xfrm>
+          <a:prstGeom prst="rect">
+            <a:avLst/>
+          </a:prstGeom>
+          <a:noFill/>
+        </p:spPr>
+        <p:txBody>
+          <a:bodyPr wrap="square" anchor="ctr" lIns="36576" rIns="36576" tIns="0" bIns="0">
+            <a:spAutoFit/>
+          </a:bodyPr>
+          <a:lstStyle/>
+          <a:p>
+            <a:pPr algn="ctr" rtl="1"/>
+            <a:r>
+              <a:rPr sz="1100" b="1">
+                <a:solidFill>
+                  <a:srgbClr val="1C3C7A"/>
+                </a:solidFill>
+                <a:latin typeface="Heebo"/>
+                <a:cs typeface="Heebo"/>
+              </a:rPr>
+              <a:t>רגולציה</a:t>
+            </a:r>
+          </a:p>
+        </p:txBody>
+      </p:sp>
+      <p:sp>
+        <p:nvSpPr>
+          <p:cNvPr id="21" name="TextBox 20"/>
+          <p:cNvSpPr txBox="1"/>
+          <p:nvPr/>
+        </p:nvSpPr>
+        <p:spPr>
+          <a:xfrm>
+            <a:off x="2423160" y="3392424"/>
+            <a:ext cx="8534095" cy="2011680"/>
           </a:xfrm>
           <a:prstGeom prst="rect">
             <a:avLst/>
@@ -25409,7 +25577,7 @@
                 <a:latin typeface="Heebo"/>
                 <a:cs typeface="Heebo"/>
               </a:rPr>
-              <a:t>תוכניות כנסת 26 · ביטחון אישי</a:t>
+              <a:t>תוכניות כנסת 26 · עו״ד אודליה קדמי</a:t>
             </a:r>
           </a:p>
         </p:txBody>
@@ -25445,7 +25613,7 @@
                 <a:latin typeface="Heebo"/>
                 <a:cs typeface="Heebo"/>
               </a:rPr>
-              <a:t>עו״ד אודליה קדמי</a:t>
+              <a:t>ביטחון אישי</a:t>
             </a:r>
           </a:p>
         </p:txBody>
@@ -25694,14 +25862,62 @@
       </p:sp>
       <p:sp>
         <p:nvSpPr>
-          <p:cNvPr id="12" name="TextBox 11"/>
-          <p:cNvSpPr txBox="1"/>
-          <p:nvPr/>
-        </p:nvSpPr>
-        <p:spPr>
-          <a:xfrm>
-            <a:off x="594360" y="1234440"/>
-            <a:ext cx="10362895" cy="2011680"/>
+          <p:cNvPr id="12" name="Rounded Rectangle 11"/>
+          <p:cNvSpPr/>
+          <p:nvPr/>
+        </p:nvSpPr>
+        <p:spPr>
+          <a:xfrm>
+            <a:off x="594360" y="2075688"/>
+            <a:ext cx="1737360" cy="329184"/>
+          </a:xfrm>
+          <a:prstGeom prst="roundRect">
+            <a:avLst>
+              <a:gd name="adj" fmla="val 50000"/>
+            </a:avLst>
+          </a:prstGeom>
+          <a:solidFill>
+            <a:srgbClr val="F4F6FB"/>
+          </a:solidFill>
+          <a:ln w="15875">
+            <a:solidFill>
+              <a:srgbClr val="F0C000"/>
+            </a:solidFill>
+          </a:ln>
+          <a:effectLst/>
+        </p:spPr>
+        <p:style>
+          <a:lnRef idx="1">
+            <a:schemeClr val="accent1"/>
+          </a:lnRef>
+          <a:fillRef idx="3">
+            <a:schemeClr val="accent1"/>
+          </a:fillRef>
+          <a:effectRef idx="2">
+            <a:schemeClr val="accent1"/>
+          </a:effectRef>
+          <a:fontRef idx="minor">
+            <a:schemeClr val="lt1"/>
+          </a:fontRef>
+        </p:style>
+        <p:txBody>
+          <a:bodyPr rtlCol="0" anchor="ctr"/>
+          <a:lstStyle/>
+          <a:p>
+            <a:pPr algn="ctr"/>
+          </a:p>
+        </p:txBody>
+      </p:sp>
+      <p:sp>
+        <p:nvSpPr>
+          <p:cNvPr id="13" name="TextBox 12"/>
+          <p:cNvSpPr txBox="1"/>
+          <p:nvPr/>
+        </p:nvSpPr>
+        <p:spPr>
+          <a:xfrm>
+            <a:off x="594360" y="2075688"/>
+            <a:ext cx="1737360" cy="329184"/>
           </a:xfrm>
           <a:prstGeom prst="rect">
             <a:avLst/>
@@ -25714,6 +25930,42 @@
           </a:bodyPr>
           <a:lstStyle/>
           <a:p>
+            <a:pPr algn="ctr" rtl="1"/>
+            <a:r>
+              <a:rPr sz="1100" b="1">
+                <a:solidFill>
+                  <a:srgbClr val="1C3C7A"/>
+                </a:solidFill>
+                <a:latin typeface="Heebo"/>
+                <a:cs typeface="Heebo"/>
+              </a:rPr>
+              <a:t>ביטחון אישי</a:t>
+            </a:r>
+          </a:p>
+        </p:txBody>
+      </p:sp>
+      <p:sp>
+        <p:nvSpPr>
+          <p:cNvPr id="14" name="TextBox 13"/>
+          <p:cNvSpPr txBox="1"/>
+          <p:nvPr/>
+        </p:nvSpPr>
+        <p:spPr>
+          <a:xfrm>
+            <a:off x="2423160" y="1234440"/>
+            <a:ext cx="8534095" cy="2011680"/>
+          </a:xfrm>
+          <a:prstGeom prst="rect">
+            <a:avLst/>
+          </a:prstGeom>
+          <a:noFill/>
+        </p:spPr>
+        <p:txBody>
+          <a:bodyPr wrap="square" anchor="ctr" lIns="36576" rIns="36576" tIns="0" bIns="0">
+            <a:spAutoFit/>
+          </a:bodyPr>
+          <a:lstStyle/>
+          <a:p>
             <a:pPr algn="r" rtl="1"/>
             <a:r>
               <a:rPr sz="2400" b="1">
@@ -25730,7 +25982,7 @@
       </p:sp>
       <p:sp>
         <p:nvSpPr>
-          <p:cNvPr id="13" name="Rounded Rectangle 12"/>
+          <p:cNvPr id="15" name="Rounded Rectangle 14"/>
           <p:cNvSpPr/>
           <p:nvPr/>
         </p:nvSpPr>
@@ -25778,7 +26030,7 @@
       </p:sp>
       <p:sp>
         <p:nvSpPr>
-          <p:cNvPr id="14" name="Rectangle 13"/>
+          <p:cNvPr id="16" name="Rectangle 15"/>
           <p:cNvSpPr/>
           <p:nvPr/>
         </p:nvSpPr>
@@ -25822,7 +26074,7 @@
       </p:sp>
       <p:sp>
         <p:nvSpPr>
-          <p:cNvPr id="15" name="Oval 14"/>
+          <p:cNvPr id="17" name="Oval 16"/>
           <p:cNvSpPr/>
           <p:nvPr/>
         </p:nvSpPr>
@@ -25866,7 +26118,7 @@
       </p:sp>
       <p:sp>
         <p:nvSpPr>
-          <p:cNvPr id="16" name="TextBox 15"/>
+          <p:cNvPr id="18" name="TextBox 17"/>
           <p:cNvSpPr txBox="1"/>
           <p:nvPr/>
         </p:nvSpPr>
@@ -25902,14 +26154,98 @@
       </p:sp>
       <p:sp>
         <p:nvSpPr>
-          <p:cNvPr id="17" name="TextBox 16"/>
-          <p:cNvSpPr txBox="1"/>
-          <p:nvPr/>
-        </p:nvSpPr>
-        <p:spPr>
-          <a:xfrm>
-            <a:off x="594360" y="3392424"/>
-            <a:ext cx="10362895" cy="2011680"/>
+          <p:cNvPr id="19" name="Rounded Rectangle 18"/>
+          <p:cNvSpPr/>
+          <p:nvPr/>
+        </p:nvSpPr>
+        <p:spPr>
+          <a:xfrm>
+            <a:off x="594360" y="4233672"/>
+            <a:ext cx="1737360" cy="329184"/>
+          </a:xfrm>
+          <a:prstGeom prst="roundRect">
+            <a:avLst>
+              <a:gd name="adj" fmla="val 50000"/>
+            </a:avLst>
+          </a:prstGeom>
+          <a:solidFill>
+            <a:srgbClr val="F4F6FB"/>
+          </a:solidFill>
+          <a:ln w="15875">
+            <a:solidFill>
+              <a:srgbClr val="F0C000"/>
+            </a:solidFill>
+          </a:ln>
+          <a:effectLst/>
+        </p:spPr>
+        <p:style>
+          <a:lnRef idx="1">
+            <a:schemeClr val="accent1"/>
+          </a:lnRef>
+          <a:fillRef idx="3">
+            <a:schemeClr val="accent1"/>
+          </a:fillRef>
+          <a:effectRef idx="2">
+            <a:schemeClr val="accent1"/>
+          </a:effectRef>
+          <a:fontRef idx="minor">
+            <a:schemeClr val="lt1"/>
+          </a:fontRef>
+        </p:style>
+        <p:txBody>
+          <a:bodyPr rtlCol="0" anchor="ctr"/>
+          <a:lstStyle/>
+          <a:p>
+            <a:pPr algn="ctr"/>
+          </a:p>
+        </p:txBody>
+      </p:sp>
+      <p:sp>
+        <p:nvSpPr>
+          <p:cNvPr id="20" name="TextBox 19"/>
+          <p:cNvSpPr txBox="1"/>
+          <p:nvPr/>
+        </p:nvSpPr>
+        <p:spPr>
+          <a:xfrm>
+            <a:off x="594360" y="4233672"/>
+            <a:ext cx="1737360" cy="329184"/>
+          </a:xfrm>
+          <a:prstGeom prst="rect">
+            <a:avLst/>
+          </a:prstGeom>
+          <a:noFill/>
+        </p:spPr>
+        <p:txBody>
+          <a:bodyPr wrap="square" anchor="ctr" lIns="36576" rIns="36576" tIns="0" bIns="0">
+            <a:spAutoFit/>
+          </a:bodyPr>
+          <a:lstStyle/>
+          <a:p>
+            <a:pPr algn="ctr" rtl="1"/>
+            <a:r>
+              <a:rPr sz="1100" b="1">
+                <a:solidFill>
+                  <a:srgbClr val="1C3C7A"/>
+                </a:solidFill>
+                <a:latin typeface="Heebo"/>
+                <a:cs typeface="Heebo"/>
+              </a:rPr>
+              <a:t>כוחות הביטחון</a:t>
+            </a:r>
+          </a:p>
+        </p:txBody>
+      </p:sp>
+      <p:sp>
+        <p:nvSpPr>
+          <p:cNvPr id="21" name="TextBox 20"/>
+          <p:cNvSpPr txBox="1"/>
+          <p:nvPr/>
+        </p:nvSpPr>
+        <p:spPr>
+          <a:xfrm>
+            <a:off x="2423160" y="3392424"/>
+            <a:ext cx="8534095" cy="2011680"/>
           </a:xfrm>
           <a:prstGeom prst="rect">
             <a:avLst/>
@@ -26081,7 +26417,7 @@
                 <a:latin typeface="Heebo"/>
                 <a:cs typeface="Heebo"/>
               </a:rPr>
-              <a:t>תוכניות כנסת 26 · רווחה</a:t>
+              <a:t>תוכניות כנסת 26 · שלומית לביא</a:t>
             </a:r>
           </a:p>
         </p:txBody>
@@ -26117,7 +26453,7 @@
                 <a:latin typeface="Heebo"/>
                 <a:cs typeface="Heebo"/>
               </a:rPr>
-              <a:t>שלומית לביא</a:t>
+              <a:t>רווחה ומשפחה</a:t>
             </a:r>
           </a:p>
         </p:txBody>
@@ -26366,14 +26702,62 @@
       </p:sp>
       <p:sp>
         <p:nvSpPr>
-          <p:cNvPr id="12" name="TextBox 11"/>
-          <p:cNvSpPr txBox="1"/>
-          <p:nvPr/>
-        </p:nvSpPr>
-        <p:spPr>
-          <a:xfrm>
-            <a:off x="594360" y="1234440"/>
-            <a:ext cx="10362895" cy="934516"/>
+          <p:cNvPr id="12" name="Rounded Rectangle 11"/>
+          <p:cNvSpPr/>
+          <p:nvPr/>
+        </p:nvSpPr>
+        <p:spPr>
+          <a:xfrm>
+            <a:off x="594360" y="1537106"/>
+            <a:ext cx="1737360" cy="329184"/>
+          </a:xfrm>
+          <a:prstGeom prst="roundRect">
+            <a:avLst>
+              <a:gd name="adj" fmla="val 50000"/>
+            </a:avLst>
+          </a:prstGeom>
+          <a:solidFill>
+            <a:srgbClr val="F4F6FB"/>
+          </a:solidFill>
+          <a:ln w="15875">
+            <a:solidFill>
+              <a:srgbClr val="F0C000"/>
+            </a:solidFill>
+          </a:ln>
+          <a:effectLst/>
+        </p:spPr>
+        <p:style>
+          <a:lnRef idx="1">
+            <a:schemeClr val="accent1"/>
+          </a:lnRef>
+          <a:fillRef idx="3">
+            <a:schemeClr val="accent1"/>
+          </a:fillRef>
+          <a:effectRef idx="2">
+            <a:schemeClr val="accent1"/>
+          </a:effectRef>
+          <a:fontRef idx="minor">
+            <a:schemeClr val="lt1"/>
+          </a:fontRef>
+        </p:style>
+        <p:txBody>
+          <a:bodyPr rtlCol="0" anchor="ctr"/>
+          <a:lstStyle/>
+          <a:p>
+            <a:pPr algn="ctr"/>
+          </a:p>
+        </p:txBody>
+      </p:sp>
+      <p:sp>
+        <p:nvSpPr>
+          <p:cNvPr id="13" name="TextBox 12"/>
+          <p:cNvSpPr txBox="1"/>
+          <p:nvPr/>
+        </p:nvSpPr>
+        <p:spPr>
+          <a:xfrm>
+            <a:off x="594360" y="1537106"/>
+            <a:ext cx="1737360" cy="329184"/>
           </a:xfrm>
           <a:prstGeom prst="rect">
             <a:avLst/>
@@ -26386,6 +26770,42 @@
           </a:bodyPr>
           <a:lstStyle/>
           <a:p>
+            <a:pPr algn="ctr" rtl="1"/>
+            <a:r>
+              <a:rPr sz="1100" b="1">
+                <a:solidFill>
+                  <a:srgbClr val="1C3C7A"/>
+                </a:solidFill>
+                <a:latin typeface="Heebo"/>
+                <a:cs typeface="Heebo"/>
+              </a:rPr>
+              <a:t>זכויות</a:t>
+            </a:r>
+          </a:p>
+        </p:txBody>
+      </p:sp>
+      <p:sp>
+        <p:nvSpPr>
+          <p:cNvPr id="14" name="TextBox 13"/>
+          <p:cNvSpPr txBox="1"/>
+          <p:nvPr/>
+        </p:nvSpPr>
+        <p:spPr>
+          <a:xfrm>
+            <a:off x="2423160" y="1234440"/>
+            <a:ext cx="8534095" cy="934516"/>
+          </a:xfrm>
+          <a:prstGeom prst="rect">
+            <a:avLst/>
+          </a:prstGeom>
+          <a:noFill/>
+        </p:spPr>
+        <p:txBody>
+          <a:bodyPr wrap="square" anchor="ctr" lIns="36576" rIns="36576" tIns="0" bIns="0">
+            <a:spAutoFit/>
+          </a:bodyPr>
+          <a:lstStyle/>
+          <a:p>
             <a:pPr algn="r" rtl="1"/>
             <a:r>
               <a:rPr sz="1600" b="1">
@@ -26402,7 +26822,7 @@
       </p:sp>
       <p:sp>
         <p:nvSpPr>
-          <p:cNvPr id="13" name="Rounded Rectangle 12"/>
+          <p:cNvPr id="15" name="Rounded Rectangle 14"/>
           <p:cNvSpPr/>
           <p:nvPr/>
         </p:nvSpPr>
@@ -26450,7 +26870,7 @@
       </p:sp>
       <p:sp>
         <p:nvSpPr>
-          <p:cNvPr id="14" name="Rectangle 13"/>
+          <p:cNvPr id="16" name="Rectangle 15"/>
           <p:cNvSpPr/>
           <p:nvPr/>
         </p:nvSpPr>
@@ -26494,7 +26914,7 @@
       </p:sp>
       <p:sp>
         <p:nvSpPr>
-          <p:cNvPr id="15" name="Oval 14"/>
+          <p:cNvPr id="17" name="Oval 16"/>
           <p:cNvSpPr/>
           <p:nvPr/>
         </p:nvSpPr>
@@ -26538,7 +26958,7 @@
       </p:sp>
       <p:sp>
         <p:nvSpPr>
-          <p:cNvPr id="16" name="TextBox 15"/>
+          <p:cNvPr id="18" name="TextBox 17"/>
           <p:cNvSpPr txBox="1"/>
           <p:nvPr/>
         </p:nvSpPr>
@@ -26574,14 +26994,62 @@
       </p:sp>
       <p:sp>
         <p:nvSpPr>
-          <p:cNvPr id="17" name="TextBox 16"/>
-          <p:cNvSpPr txBox="1"/>
-          <p:nvPr/>
-        </p:nvSpPr>
-        <p:spPr>
-          <a:xfrm>
-            <a:off x="594360" y="2315260"/>
-            <a:ext cx="10362895" cy="934516"/>
+          <p:cNvPr id="19" name="Rounded Rectangle 18"/>
+          <p:cNvSpPr/>
+          <p:nvPr/>
+        </p:nvSpPr>
+        <p:spPr>
+          <a:xfrm>
+            <a:off x="594360" y="2617926"/>
+            <a:ext cx="1737360" cy="329184"/>
+          </a:xfrm>
+          <a:prstGeom prst="roundRect">
+            <a:avLst>
+              <a:gd name="adj" fmla="val 50000"/>
+            </a:avLst>
+          </a:prstGeom>
+          <a:solidFill>
+            <a:srgbClr val="F4F6FB"/>
+          </a:solidFill>
+          <a:ln w="15875">
+            <a:solidFill>
+              <a:srgbClr val="F0C000"/>
+            </a:solidFill>
+          </a:ln>
+          <a:effectLst/>
+        </p:spPr>
+        <p:style>
+          <a:lnRef idx="1">
+            <a:schemeClr val="accent1"/>
+          </a:lnRef>
+          <a:fillRef idx="3">
+            <a:schemeClr val="accent1"/>
+          </a:fillRef>
+          <a:effectRef idx="2">
+            <a:schemeClr val="accent1"/>
+          </a:effectRef>
+          <a:fontRef idx="minor">
+            <a:schemeClr val="lt1"/>
+          </a:fontRef>
+        </p:style>
+        <p:txBody>
+          <a:bodyPr rtlCol="0" anchor="ctr"/>
+          <a:lstStyle/>
+          <a:p>
+            <a:pPr algn="ctr"/>
+          </a:p>
+        </p:txBody>
+      </p:sp>
+      <p:sp>
+        <p:nvSpPr>
+          <p:cNvPr id="20" name="TextBox 19"/>
+          <p:cNvSpPr txBox="1"/>
+          <p:nvPr/>
+        </p:nvSpPr>
+        <p:spPr>
+          <a:xfrm>
+            <a:off x="594360" y="2617926"/>
+            <a:ext cx="1737360" cy="329184"/>
           </a:xfrm>
           <a:prstGeom prst="rect">
             <a:avLst/>
@@ -26594,6 +27062,42 @@
           </a:bodyPr>
           <a:lstStyle/>
           <a:p>
+            <a:pPr algn="ctr" rtl="1"/>
+            <a:r>
+              <a:rPr sz="1100" b="1">
+                <a:solidFill>
+                  <a:srgbClr val="1C3C7A"/>
+                </a:solidFill>
+                <a:latin typeface="Heebo"/>
+                <a:cs typeface="Heebo"/>
+              </a:rPr>
+              <a:t>זכויות</a:t>
+            </a:r>
+          </a:p>
+        </p:txBody>
+      </p:sp>
+      <p:sp>
+        <p:nvSpPr>
+          <p:cNvPr id="21" name="TextBox 20"/>
+          <p:cNvSpPr txBox="1"/>
+          <p:nvPr/>
+        </p:nvSpPr>
+        <p:spPr>
+          <a:xfrm>
+            <a:off x="2423160" y="2315260"/>
+            <a:ext cx="8534095" cy="934516"/>
+          </a:xfrm>
+          <a:prstGeom prst="rect">
+            <a:avLst/>
+          </a:prstGeom>
+          <a:noFill/>
+        </p:spPr>
+        <p:txBody>
+          <a:bodyPr wrap="square" anchor="ctr" lIns="36576" rIns="36576" tIns="0" bIns="0">
+            <a:spAutoFit/>
+          </a:bodyPr>
+          <a:lstStyle/>
+          <a:p>
             <a:pPr algn="r" rtl="1"/>
             <a:r>
               <a:rPr sz="1600" b="1">
@@ -26610,7 +27114,7 @@
       </p:sp>
       <p:sp>
         <p:nvSpPr>
-          <p:cNvPr id="18" name="Rounded Rectangle 17"/>
+          <p:cNvPr id="22" name="Rounded Rectangle 21"/>
           <p:cNvSpPr/>
           <p:nvPr/>
         </p:nvSpPr>
@@ -26658,7 +27162,7 @@
       </p:sp>
       <p:sp>
         <p:nvSpPr>
-          <p:cNvPr id="19" name="Rectangle 18"/>
+          <p:cNvPr id="23" name="Rectangle 22"/>
           <p:cNvSpPr/>
           <p:nvPr/>
         </p:nvSpPr>
@@ -26702,7 +27206,7 @@
       </p:sp>
       <p:sp>
         <p:nvSpPr>
-          <p:cNvPr id="20" name="Oval 19"/>
+          <p:cNvPr id="24" name="Oval 23"/>
           <p:cNvSpPr/>
           <p:nvPr/>
         </p:nvSpPr>
@@ -26746,7 +27250,7 @@
       </p:sp>
       <p:sp>
         <p:nvSpPr>
-          <p:cNvPr id="21" name="TextBox 20"/>
+          <p:cNvPr id="25" name="TextBox 24"/>
           <p:cNvSpPr txBox="1"/>
           <p:nvPr/>
         </p:nvSpPr>
@@ -26782,14 +27286,62 @@
       </p:sp>
       <p:sp>
         <p:nvSpPr>
-          <p:cNvPr id="22" name="TextBox 21"/>
-          <p:cNvSpPr txBox="1"/>
-          <p:nvPr/>
-        </p:nvSpPr>
-        <p:spPr>
-          <a:xfrm>
-            <a:off x="594360" y="3396080"/>
-            <a:ext cx="10362895" cy="934516"/>
+          <p:cNvPr id="26" name="Rounded Rectangle 25"/>
+          <p:cNvSpPr/>
+          <p:nvPr/>
+        </p:nvSpPr>
+        <p:spPr>
+          <a:xfrm>
+            <a:off x="594360" y="3698746"/>
+            <a:ext cx="1737360" cy="329184"/>
+          </a:xfrm>
+          <a:prstGeom prst="roundRect">
+            <a:avLst>
+              <a:gd name="adj" fmla="val 50000"/>
+            </a:avLst>
+          </a:prstGeom>
+          <a:solidFill>
+            <a:srgbClr val="F4F6FB"/>
+          </a:solidFill>
+          <a:ln w="15875">
+            <a:solidFill>
+              <a:srgbClr val="F0C000"/>
+            </a:solidFill>
+          </a:ln>
+          <a:effectLst/>
+        </p:spPr>
+        <p:style>
+          <a:lnRef idx="1">
+            <a:schemeClr val="accent1"/>
+          </a:lnRef>
+          <a:fillRef idx="3">
+            <a:schemeClr val="accent1"/>
+          </a:fillRef>
+          <a:effectRef idx="2">
+            <a:schemeClr val="accent1"/>
+          </a:effectRef>
+          <a:fontRef idx="minor">
+            <a:schemeClr val="lt1"/>
+          </a:fontRef>
+        </p:style>
+        <p:txBody>
+          <a:bodyPr rtlCol="0" anchor="ctr"/>
+          <a:lstStyle/>
+          <a:p>
+            <a:pPr algn="ctr"/>
+          </a:p>
+        </p:txBody>
+      </p:sp>
+      <p:sp>
+        <p:nvSpPr>
+          <p:cNvPr id="27" name="TextBox 26"/>
+          <p:cNvSpPr txBox="1"/>
+          <p:nvPr/>
+        </p:nvSpPr>
+        <p:spPr>
+          <a:xfrm>
+            <a:off x="594360" y="3698746"/>
+            <a:ext cx="1737360" cy="329184"/>
           </a:xfrm>
           <a:prstGeom prst="rect">
             <a:avLst/>
@@ -26802,6 +27354,42 @@
           </a:bodyPr>
           <a:lstStyle/>
           <a:p>
+            <a:pPr algn="ctr" rtl="1"/>
+            <a:r>
+              <a:rPr sz="1100" b="1">
+                <a:solidFill>
+                  <a:srgbClr val="1C3C7A"/>
+                </a:solidFill>
+                <a:latin typeface="Heebo"/>
+                <a:cs typeface="Heebo"/>
+              </a:rPr>
+              <a:t>מחקר ומדיניות</a:t>
+            </a:r>
+          </a:p>
+        </p:txBody>
+      </p:sp>
+      <p:sp>
+        <p:nvSpPr>
+          <p:cNvPr id="28" name="TextBox 27"/>
+          <p:cNvSpPr txBox="1"/>
+          <p:nvPr/>
+        </p:nvSpPr>
+        <p:spPr>
+          <a:xfrm>
+            <a:off x="2423160" y="3396080"/>
+            <a:ext cx="8534095" cy="934516"/>
+          </a:xfrm>
+          <a:prstGeom prst="rect">
+            <a:avLst/>
+          </a:prstGeom>
+          <a:noFill/>
+        </p:spPr>
+        <p:txBody>
+          <a:bodyPr wrap="square" anchor="ctr" lIns="36576" rIns="36576" tIns="0" bIns="0">
+            <a:spAutoFit/>
+          </a:bodyPr>
+          <a:lstStyle/>
+          <a:p>
             <a:pPr algn="r" rtl="1"/>
             <a:r>
               <a:rPr sz="1600" b="1">
@@ -26818,7 +27406,7 @@
       </p:sp>
       <p:sp>
         <p:nvSpPr>
-          <p:cNvPr id="23" name="Rounded Rectangle 22"/>
+          <p:cNvPr id="29" name="Rounded Rectangle 28"/>
           <p:cNvSpPr/>
           <p:nvPr/>
         </p:nvSpPr>
@@ -26866,7 +27454,7 @@
       </p:sp>
       <p:sp>
         <p:nvSpPr>
-          <p:cNvPr id="24" name="Rectangle 23"/>
+          <p:cNvPr id="30" name="Rectangle 29"/>
           <p:cNvSpPr/>
           <p:nvPr/>
         </p:nvSpPr>
@@ -26910,7 +27498,7 @@
       </p:sp>
       <p:sp>
         <p:nvSpPr>
-          <p:cNvPr id="25" name="Oval 24"/>
+          <p:cNvPr id="31" name="Oval 30"/>
           <p:cNvSpPr/>
           <p:nvPr/>
         </p:nvSpPr>
@@ -26954,7 +27542,7 @@
       </p:sp>
       <p:sp>
         <p:nvSpPr>
-          <p:cNvPr id="26" name="TextBox 25"/>
+          <p:cNvPr id="32" name="TextBox 31"/>
           <p:cNvSpPr txBox="1"/>
           <p:nvPr/>
         </p:nvSpPr>
@@ -26990,14 +27578,62 @@
       </p:sp>
       <p:sp>
         <p:nvSpPr>
-          <p:cNvPr id="27" name="TextBox 26"/>
-          <p:cNvSpPr txBox="1"/>
-          <p:nvPr/>
-        </p:nvSpPr>
-        <p:spPr>
-          <a:xfrm>
-            <a:off x="594360" y="4476900"/>
-            <a:ext cx="10362895" cy="934516"/>
+          <p:cNvPr id="33" name="Rounded Rectangle 32"/>
+          <p:cNvSpPr/>
+          <p:nvPr/>
+        </p:nvSpPr>
+        <p:spPr>
+          <a:xfrm>
+            <a:off x="594360" y="4779566"/>
+            <a:ext cx="1737360" cy="329184"/>
+          </a:xfrm>
+          <a:prstGeom prst="roundRect">
+            <a:avLst>
+              <a:gd name="adj" fmla="val 50000"/>
+            </a:avLst>
+          </a:prstGeom>
+          <a:solidFill>
+            <a:srgbClr val="F4F6FB"/>
+          </a:solidFill>
+          <a:ln w="15875">
+            <a:solidFill>
+              <a:srgbClr val="F0C000"/>
+            </a:solidFill>
+          </a:ln>
+          <a:effectLst/>
+        </p:spPr>
+        <p:style>
+          <a:lnRef idx="1">
+            <a:schemeClr val="accent1"/>
+          </a:lnRef>
+          <a:fillRef idx="3">
+            <a:schemeClr val="accent1"/>
+          </a:fillRef>
+          <a:effectRef idx="2">
+            <a:schemeClr val="accent1"/>
+          </a:effectRef>
+          <a:fontRef idx="minor">
+            <a:schemeClr val="lt1"/>
+          </a:fontRef>
+        </p:style>
+        <p:txBody>
+          <a:bodyPr rtlCol="0" anchor="ctr"/>
+          <a:lstStyle/>
+          <a:p>
+            <a:pPr algn="ctr"/>
+          </a:p>
+        </p:txBody>
+      </p:sp>
+      <p:sp>
+        <p:nvSpPr>
+          <p:cNvPr id="34" name="TextBox 33"/>
+          <p:cNvSpPr txBox="1"/>
+          <p:nvPr/>
+        </p:nvSpPr>
+        <p:spPr>
+          <a:xfrm>
+            <a:off x="594360" y="4779566"/>
+            <a:ext cx="1737360" cy="329184"/>
           </a:xfrm>
           <a:prstGeom prst="rect">
             <a:avLst/>
@@ -27010,6 +27646,42 @@
           </a:bodyPr>
           <a:lstStyle/>
           <a:p>
+            <a:pPr algn="ctr" rtl="1"/>
+            <a:r>
+              <a:rPr sz="1100" b="1">
+                <a:solidFill>
+                  <a:srgbClr val="1C3C7A"/>
+                </a:solidFill>
+                <a:latin typeface="Heebo"/>
+                <a:cs typeface="Heebo"/>
+              </a:rPr>
+              <a:t>פיקוח</a:t>
+            </a:r>
+          </a:p>
+        </p:txBody>
+      </p:sp>
+      <p:sp>
+        <p:nvSpPr>
+          <p:cNvPr id="35" name="TextBox 34"/>
+          <p:cNvSpPr txBox="1"/>
+          <p:nvPr/>
+        </p:nvSpPr>
+        <p:spPr>
+          <a:xfrm>
+            <a:off x="2423160" y="4476900"/>
+            <a:ext cx="8534095" cy="934516"/>
+          </a:xfrm>
+          <a:prstGeom prst="rect">
+            <a:avLst/>
+          </a:prstGeom>
+          <a:noFill/>
+        </p:spPr>
+        <p:txBody>
+          <a:bodyPr wrap="square" anchor="ctr" lIns="36576" rIns="36576" tIns="0" bIns="0">
+            <a:spAutoFit/>
+          </a:bodyPr>
+          <a:lstStyle/>
+          <a:p>
             <a:pPr algn="r" rtl="1"/>
             <a:r>
               <a:rPr sz="1600" b="1">
@@ -27026,7 +27698,7 @@
       </p:sp>
       <p:sp>
         <p:nvSpPr>
-          <p:cNvPr id="28" name="Rounded Rectangle 27"/>
+          <p:cNvPr id="36" name="Rounded Rectangle 35"/>
           <p:cNvSpPr/>
           <p:nvPr/>
         </p:nvSpPr>
@@ -27074,7 +27746,7 @@
       </p:sp>
       <p:sp>
         <p:nvSpPr>
-          <p:cNvPr id="29" name="Rectangle 28"/>
+          <p:cNvPr id="37" name="Rectangle 36"/>
           <p:cNvSpPr/>
           <p:nvPr/>
         </p:nvSpPr>
@@ -27118,7 +27790,7 @@
       </p:sp>
       <p:sp>
         <p:nvSpPr>
-          <p:cNvPr id="30" name="Oval 29"/>
+          <p:cNvPr id="38" name="Oval 37"/>
           <p:cNvSpPr/>
           <p:nvPr/>
         </p:nvSpPr>
@@ -27162,7 +27834,7 @@
       </p:sp>
       <p:sp>
         <p:nvSpPr>
-          <p:cNvPr id="31" name="TextBox 30"/>
+          <p:cNvPr id="39" name="TextBox 38"/>
           <p:cNvSpPr txBox="1"/>
           <p:nvPr/>
         </p:nvSpPr>
@@ -27198,14 +27870,98 @@
       </p:sp>
       <p:sp>
         <p:nvSpPr>
-          <p:cNvPr id="32" name="TextBox 31"/>
-          <p:cNvSpPr txBox="1"/>
-          <p:nvPr/>
-        </p:nvSpPr>
-        <p:spPr>
-          <a:xfrm>
-            <a:off x="594360" y="5557720"/>
-            <a:ext cx="10362895" cy="934516"/>
+          <p:cNvPr id="40" name="Rounded Rectangle 39"/>
+          <p:cNvSpPr/>
+          <p:nvPr/>
+        </p:nvSpPr>
+        <p:spPr>
+          <a:xfrm>
+            <a:off x="594360" y="5860386"/>
+            <a:ext cx="1737360" cy="329184"/>
+          </a:xfrm>
+          <a:prstGeom prst="roundRect">
+            <a:avLst>
+              <a:gd name="adj" fmla="val 50000"/>
+            </a:avLst>
+          </a:prstGeom>
+          <a:solidFill>
+            <a:srgbClr val="F4F6FB"/>
+          </a:solidFill>
+          <a:ln w="15875">
+            <a:solidFill>
+              <a:srgbClr val="F0C000"/>
+            </a:solidFill>
+          </a:ln>
+          <a:effectLst/>
+        </p:spPr>
+        <p:style>
+          <a:lnRef idx="1">
+            <a:schemeClr val="accent1"/>
+          </a:lnRef>
+          <a:fillRef idx="3">
+            <a:schemeClr val="accent1"/>
+          </a:fillRef>
+          <a:effectRef idx="2">
+            <a:schemeClr val="accent1"/>
+          </a:effectRef>
+          <a:fontRef idx="minor">
+            <a:schemeClr val="lt1"/>
+          </a:fontRef>
+        </p:style>
+        <p:txBody>
+          <a:bodyPr rtlCol="0" anchor="ctr"/>
+          <a:lstStyle/>
+          <a:p>
+            <a:pPr algn="ctr"/>
+          </a:p>
+        </p:txBody>
+      </p:sp>
+      <p:sp>
+        <p:nvSpPr>
+          <p:cNvPr id="41" name="TextBox 40"/>
+          <p:cNvSpPr txBox="1"/>
+          <p:nvPr/>
+        </p:nvSpPr>
+        <p:spPr>
+          <a:xfrm>
+            <a:off x="594360" y="5860386"/>
+            <a:ext cx="1737360" cy="329184"/>
+          </a:xfrm>
+          <a:prstGeom prst="rect">
+            <a:avLst/>
+          </a:prstGeom>
+          <a:noFill/>
+        </p:spPr>
+        <p:txBody>
+          <a:bodyPr wrap="square" anchor="ctr" lIns="36576" rIns="36576" tIns="0" bIns="0">
+            <a:spAutoFit/>
+          </a:bodyPr>
+          <a:lstStyle/>
+          <a:p>
+            <a:pPr algn="ctr" rtl="1"/>
+            <a:r>
+              <a:rPr sz="1100" b="1">
+                <a:solidFill>
+                  <a:srgbClr val="1C3C7A"/>
+                </a:solidFill>
+                <a:latin typeface="Heebo"/>
+                <a:cs typeface="Heebo"/>
+              </a:rPr>
+              <a:t>פיקוח</a:t>
+            </a:r>
+          </a:p>
+        </p:txBody>
+      </p:sp>
+      <p:sp>
+        <p:nvSpPr>
+          <p:cNvPr id="42" name="TextBox 41"/>
+          <p:cNvSpPr txBox="1"/>
+          <p:nvPr/>
+        </p:nvSpPr>
+        <p:spPr>
+          <a:xfrm>
+            <a:off x="2423160" y="5557720"/>
+            <a:ext cx="8534095" cy="934516"/>
           </a:xfrm>
           <a:prstGeom prst="rect">
             <a:avLst/>
@@ -27377,7 +28133,7 @@
                 <a:latin typeface="Heebo"/>
                 <a:cs typeface="Heebo"/>
               </a:rPr>
-              <a:t>תוכניות כנסת 26 · חקיקה</a:t>
+              <a:t>תוכניות כנסת 26 · נגה ארבל</a:t>
             </a:r>
           </a:p>
         </p:txBody>
@@ -27413,7 +28169,7 @@
                 <a:latin typeface="Heebo"/>
                 <a:cs typeface="Heebo"/>
               </a:rPr>
-              <a:t>נגה ארבל</a:t>
+              <a:t>חקיקה · ביטחון אישי, ריבונות, צה״ל וחינוך</a:t>
             </a:r>
           </a:p>
         </p:txBody>
@@ -27662,14 +28418,62 @@
       </p:sp>
       <p:sp>
         <p:nvSpPr>
-          <p:cNvPr id="12" name="TextBox 11"/>
-          <p:cNvSpPr txBox="1"/>
-          <p:nvPr/>
-        </p:nvSpPr>
-        <p:spPr>
-          <a:xfrm>
-            <a:off x="6351880" y="1234440"/>
-            <a:ext cx="4733391" cy="1005840"/>
+          <p:cNvPr id="12" name="Rounded Rectangle 11"/>
+          <p:cNvSpPr/>
+          <p:nvPr/>
+        </p:nvSpPr>
+        <p:spPr>
+          <a:xfrm>
+            <a:off x="6351880" y="1600200"/>
+            <a:ext cx="1325880" cy="274320"/>
+          </a:xfrm>
+          <a:prstGeom prst="roundRect">
+            <a:avLst>
+              <a:gd name="adj" fmla="val 50000"/>
+            </a:avLst>
+          </a:prstGeom>
+          <a:solidFill>
+            <a:srgbClr val="F4F6FB"/>
+          </a:solidFill>
+          <a:ln w="15875">
+            <a:solidFill>
+              <a:srgbClr val="F0C000"/>
+            </a:solidFill>
+          </a:ln>
+          <a:effectLst/>
+        </p:spPr>
+        <p:style>
+          <a:lnRef idx="1">
+            <a:schemeClr val="accent1"/>
+          </a:lnRef>
+          <a:fillRef idx="3">
+            <a:schemeClr val="accent1"/>
+          </a:fillRef>
+          <a:effectRef idx="2">
+            <a:schemeClr val="accent1"/>
+          </a:effectRef>
+          <a:fontRef idx="minor">
+            <a:schemeClr val="lt1"/>
+          </a:fontRef>
+        </p:style>
+        <p:txBody>
+          <a:bodyPr rtlCol="0" anchor="ctr"/>
+          <a:lstStyle/>
+          <a:p>
+            <a:pPr algn="ctr"/>
+          </a:p>
+        </p:txBody>
+      </p:sp>
+      <p:sp>
+        <p:nvSpPr>
+          <p:cNvPr id="13" name="TextBox 12"/>
+          <p:cNvSpPr txBox="1"/>
+          <p:nvPr/>
+        </p:nvSpPr>
+        <p:spPr>
+          <a:xfrm>
+            <a:off x="6351880" y="1600200"/>
+            <a:ext cx="1325880" cy="274320"/>
           </a:xfrm>
           <a:prstGeom prst="rect">
             <a:avLst/>
@@ -27682,6 +28486,42 @@
           </a:bodyPr>
           <a:lstStyle/>
           <a:p>
+            <a:pPr algn="ctr" rtl="1"/>
+            <a:r>
+              <a:rPr sz="900" b="1">
+                <a:solidFill>
+                  <a:srgbClr val="1C3C7A"/>
+                </a:solidFill>
+                <a:latin typeface="Heebo"/>
+                <a:cs typeface="Heebo"/>
+              </a:rPr>
+              <a:t>ביטחון אישי</a:t>
+            </a:r>
+          </a:p>
+        </p:txBody>
+      </p:sp>
+      <p:sp>
+        <p:nvSpPr>
+          <p:cNvPr id="14" name="TextBox 13"/>
+          <p:cNvSpPr txBox="1"/>
+          <p:nvPr/>
+        </p:nvSpPr>
+        <p:spPr>
+          <a:xfrm>
+            <a:off x="7769200" y="1234440"/>
+            <a:ext cx="3316071" cy="1005840"/>
+          </a:xfrm>
+          <a:prstGeom prst="rect">
+            <a:avLst/>
+          </a:prstGeom>
+          <a:noFill/>
+        </p:spPr>
+        <p:txBody>
+          <a:bodyPr wrap="square" anchor="ctr" lIns="36576" rIns="36576" tIns="0" bIns="0">
+            <a:spAutoFit/>
+          </a:bodyPr>
+          <a:lstStyle/>
+          <a:p>
             <a:pPr algn="r" rtl="1"/>
             <a:r>
               <a:rPr sz="1200" b="1">
@@ -27698,7 +28538,7 @@
       </p:sp>
       <p:sp>
         <p:nvSpPr>
-          <p:cNvPr id="13" name="Rounded Rectangle 12"/>
+          <p:cNvPr id="15" name="Rounded Rectangle 14"/>
           <p:cNvSpPr/>
           <p:nvPr/>
         </p:nvSpPr>
@@ -27746,7 +28586,7 @@
       </p:sp>
       <p:sp>
         <p:nvSpPr>
-          <p:cNvPr id="14" name="Rectangle 13"/>
+          <p:cNvPr id="16" name="Rectangle 15"/>
           <p:cNvSpPr/>
           <p:nvPr/>
         </p:nvSpPr>
@@ -27790,7 +28630,7 @@
       </p:sp>
       <p:sp>
         <p:nvSpPr>
-          <p:cNvPr id="15" name="Oval 14"/>
+          <p:cNvPr id="17" name="Oval 16"/>
           <p:cNvSpPr/>
           <p:nvPr/>
         </p:nvSpPr>
@@ -27834,7 +28674,7 @@
       </p:sp>
       <p:sp>
         <p:nvSpPr>
-          <p:cNvPr id="16" name="TextBox 15"/>
+          <p:cNvPr id="18" name="TextBox 17"/>
           <p:cNvSpPr txBox="1"/>
           <p:nvPr/>
         </p:nvSpPr>
@@ -27870,14 +28710,62 @@
       </p:sp>
       <p:sp>
         <p:nvSpPr>
-          <p:cNvPr id="17" name="TextBox 16"/>
-          <p:cNvSpPr txBox="1"/>
-          <p:nvPr/>
-        </p:nvSpPr>
-        <p:spPr>
-          <a:xfrm>
-            <a:off x="6351880" y="2386584"/>
-            <a:ext cx="4733391" cy="1005840"/>
+          <p:cNvPr id="19" name="Rounded Rectangle 18"/>
+          <p:cNvSpPr/>
+          <p:nvPr/>
+        </p:nvSpPr>
+        <p:spPr>
+          <a:xfrm>
+            <a:off x="6351880" y="2752344"/>
+            <a:ext cx="1325880" cy="274320"/>
+          </a:xfrm>
+          <a:prstGeom prst="roundRect">
+            <a:avLst>
+              <a:gd name="adj" fmla="val 50000"/>
+            </a:avLst>
+          </a:prstGeom>
+          <a:solidFill>
+            <a:srgbClr val="F4F6FB"/>
+          </a:solidFill>
+          <a:ln w="15875">
+            <a:solidFill>
+              <a:srgbClr val="F0C000"/>
+            </a:solidFill>
+          </a:ln>
+          <a:effectLst/>
+        </p:spPr>
+        <p:style>
+          <a:lnRef idx="1">
+            <a:schemeClr val="accent1"/>
+          </a:lnRef>
+          <a:fillRef idx="3">
+            <a:schemeClr val="accent1"/>
+          </a:fillRef>
+          <a:effectRef idx="2">
+            <a:schemeClr val="accent1"/>
+          </a:effectRef>
+          <a:fontRef idx="minor">
+            <a:schemeClr val="lt1"/>
+          </a:fontRef>
+        </p:style>
+        <p:txBody>
+          <a:bodyPr rtlCol="0" anchor="ctr"/>
+          <a:lstStyle/>
+          <a:p>
+            <a:pPr algn="ctr"/>
+          </a:p>
+        </p:txBody>
+      </p:sp>
+      <p:sp>
+        <p:nvSpPr>
+          <p:cNvPr id="20" name="TextBox 19"/>
+          <p:cNvSpPr txBox="1"/>
+          <p:nvPr/>
+        </p:nvSpPr>
+        <p:spPr>
+          <a:xfrm>
+            <a:off x="6351880" y="2752344"/>
+            <a:ext cx="1325880" cy="274320"/>
           </a:xfrm>
           <a:prstGeom prst="rect">
             <a:avLst/>
@@ -27890,6 +28778,42 @@
           </a:bodyPr>
           <a:lstStyle/>
           <a:p>
+            <a:pPr algn="ctr" rtl="1"/>
+            <a:r>
+              <a:rPr sz="900" b="1">
+                <a:solidFill>
+                  <a:srgbClr val="1C3C7A"/>
+                </a:solidFill>
+                <a:latin typeface="Heebo"/>
+                <a:cs typeface="Heebo"/>
+              </a:rPr>
+              <a:t>טכנולוגיה</a:t>
+            </a:r>
+          </a:p>
+        </p:txBody>
+      </p:sp>
+      <p:sp>
+        <p:nvSpPr>
+          <p:cNvPr id="21" name="TextBox 20"/>
+          <p:cNvSpPr txBox="1"/>
+          <p:nvPr/>
+        </p:nvSpPr>
+        <p:spPr>
+          <a:xfrm>
+            <a:off x="7769200" y="2386584"/>
+            <a:ext cx="3316071" cy="1005840"/>
+          </a:xfrm>
+          <a:prstGeom prst="rect">
+            <a:avLst/>
+          </a:prstGeom>
+          <a:noFill/>
+        </p:spPr>
+        <p:txBody>
+          <a:bodyPr wrap="square" anchor="ctr" lIns="36576" rIns="36576" tIns="0" bIns="0">
+            <a:spAutoFit/>
+          </a:bodyPr>
+          <a:lstStyle/>
+          <a:p>
             <a:pPr algn="r" rtl="1"/>
             <a:r>
               <a:rPr sz="1200" b="1">
@@ -27906,7 +28830,7 @@
       </p:sp>
       <p:sp>
         <p:nvSpPr>
-          <p:cNvPr id="18" name="Rounded Rectangle 17"/>
+          <p:cNvPr id="22" name="Rounded Rectangle 21"/>
           <p:cNvSpPr/>
           <p:nvPr/>
         </p:nvSpPr>
@@ -27954,7 +28878,7 @@
       </p:sp>
       <p:sp>
         <p:nvSpPr>
-          <p:cNvPr id="19" name="Rectangle 18"/>
+          <p:cNvPr id="23" name="Rectangle 22"/>
           <p:cNvSpPr/>
           <p:nvPr/>
         </p:nvSpPr>
@@ -27998,7 +28922,7 @@
       </p:sp>
       <p:sp>
         <p:nvSpPr>
-          <p:cNvPr id="20" name="Oval 19"/>
+          <p:cNvPr id="24" name="Oval 23"/>
           <p:cNvSpPr/>
           <p:nvPr/>
         </p:nvSpPr>
@@ -28042,7 +28966,7 @@
       </p:sp>
       <p:sp>
         <p:nvSpPr>
-          <p:cNvPr id="21" name="TextBox 20"/>
+          <p:cNvPr id="25" name="TextBox 24"/>
           <p:cNvSpPr txBox="1"/>
           <p:nvPr/>
         </p:nvSpPr>
@@ -28078,14 +29002,62 @@
       </p:sp>
       <p:sp>
         <p:nvSpPr>
-          <p:cNvPr id="22" name="TextBox 21"/>
-          <p:cNvSpPr txBox="1"/>
-          <p:nvPr/>
-        </p:nvSpPr>
-        <p:spPr>
-          <a:xfrm>
-            <a:off x="6351880" y="3538728"/>
-            <a:ext cx="4733391" cy="1005840"/>
+          <p:cNvPr id="26" name="Rounded Rectangle 25"/>
+          <p:cNvSpPr/>
+          <p:nvPr/>
+        </p:nvSpPr>
+        <p:spPr>
+          <a:xfrm>
+            <a:off x="6351880" y="3904488"/>
+            <a:ext cx="1325880" cy="274320"/>
+          </a:xfrm>
+          <a:prstGeom prst="roundRect">
+            <a:avLst>
+              <a:gd name="adj" fmla="val 50000"/>
+            </a:avLst>
+          </a:prstGeom>
+          <a:solidFill>
+            <a:srgbClr val="F4F6FB"/>
+          </a:solidFill>
+          <a:ln w="15875">
+            <a:solidFill>
+              <a:srgbClr val="F0C000"/>
+            </a:solidFill>
+          </a:ln>
+          <a:effectLst/>
+        </p:spPr>
+        <p:style>
+          <a:lnRef idx="1">
+            <a:schemeClr val="accent1"/>
+          </a:lnRef>
+          <a:fillRef idx="3">
+            <a:schemeClr val="accent1"/>
+          </a:fillRef>
+          <a:effectRef idx="2">
+            <a:schemeClr val="accent1"/>
+          </a:effectRef>
+          <a:fontRef idx="minor">
+            <a:schemeClr val="lt1"/>
+          </a:fontRef>
+        </p:style>
+        <p:txBody>
+          <a:bodyPr rtlCol="0" anchor="ctr"/>
+          <a:lstStyle/>
+          <a:p>
+            <a:pPr algn="ctr"/>
+          </a:p>
+        </p:txBody>
+      </p:sp>
+      <p:sp>
+        <p:nvSpPr>
+          <p:cNvPr id="27" name="TextBox 26"/>
+          <p:cNvSpPr txBox="1"/>
+          <p:nvPr/>
+        </p:nvSpPr>
+        <p:spPr>
+          <a:xfrm>
+            <a:off x="6351880" y="3904488"/>
+            <a:ext cx="1325880" cy="274320"/>
           </a:xfrm>
           <a:prstGeom prst="rect">
             <a:avLst/>
@@ -28098,6 +29070,42 @@
           </a:bodyPr>
           <a:lstStyle/>
           <a:p>
+            <a:pPr algn="ctr" rtl="1"/>
+            <a:r>
+              <a:rPr sz="900" b="1">
+                <a:solidFill>
+                  <a:srgbClr val="1C3C7A"/>
+                </a:solidFill>
+                <a:latin typeface="Heebo"/>
+                <a:cs typeface="Heebo"/>
+              </a:rPr>
+              <a:t>רווחה</a:t>
+            </a:r>
+          </a:p>
+        </p:txBody>
+      </p:sp>
+      <p:sp>
+        <p:nvSpPr>
+          <p:cNvPr id="28" name="TextBox 27"/>
+          <p:cNvSpPr txBox="1"/>
+          <p:nvPr/>
+        </p:nvSpPr>
+        <p:spPr>
+          <a:xfrm>
+            <a:off x="7769200" y="3538728"/>
+            <a:ext cx="3316071" cy="1005840"/>
+          </a:xfrm>
+          <a:prstGeom prst="rect">
+            <a:avLst/>
+          </a:prstGeom>
+          <a:noFill/>
+        </p:spPr>
+        <p:txBody>
+          <a:bodyPr wrap="square" anchor="ctr" lIns="36576" rIns="36576" tIns="0" bIns="0">
+            <a:spAutoFit/>
+          </a:bodyPr>
+          <a:lstStyle/>
+          <a:p>
             <a:pPr algn="r" rtl="1"/>
             <a:r>
               <a:rPr sz="1200" b="1">
@@ -28114,7 +29122,7 @@
       </p:sp>
       <p:sp>
         <p:nvSpPr>
-          <p:cNvPr id="23" name="Rounded Rectangle 22"/>
+          <p:cNvPr id="29" name="Rounded Rectangle 28"/>
           <p:cNvSpPr/>
           <p:nvPr/>
         </p:nvSpPr>
@@ -28162,7 +29170,7 @@
       </p:sp>
       <p:sp>
         <p:nvSpPr>
-          <p:cNvPr id="24" name="Rectangle 23"/>
+          <p:cNvPr id="30" name="Rectangle 29"/>
           <p:cNvSpPr/>
           <p:nvPr/>
         </p:nvSpPr>
@@ -28206,7 +29214,7 @@
       </p:sp>
       <p:sp>
         <p:nvSpPr>
-          <p:cNvPr id="25" name="Oval 24"/>
+          <p:cNvPr id="31" name="Oval 30"/>
           <p:cNvSpPr/>
           <p:nvPr/>
         </p:nvSpPr>
@@ -28250,7 +29258,7 @@
       </p:sp>
       <p:sp>
         <p:nvSpPr>
-          <p:cNvPr id="26" name="TextBox 25"/>
+          <p:cNvPr id="32" name="TextBox 31"/>
           <p:cNvSpPr txBox="1"/>
           <p:nvPr/>
         </p:nvSpPr>
@@ -28286,14 +29294,62 @@
       </p:sp>
       <p:sp>
         <p:nvSpPr>
-          <p:cNvPr id="27" name="TextBox 26"/>
-          <p:cNvSpPr txBox="1"/>
-          <p:nvPr/>
-        </p:nvSpPr>
-        <p:spPr>
-          <a:xfrm>
-            <a:off x="594361" y="1234440"/>
-            <a:ext cx="4733391" cy="1005840"/>
+          <p:cNvPr id="33" name="Rounded Rectangle 32"/>
+          <p:cNvSpPr/>
+          <p:nvPr/>
+        </p:nvSpPr>
+        <p:spPr>
+          <a:xfrm>
+            <a:off x="594361" y="1600200"/>
+            <a:ext cx="1325880" cy="274320"/>
+          </a:xfrm>
+          <a:prstGeom prst="roundRect">
+            <a:avLst>
+              <a:gd name="adj" fmla="val 50000"/>
+            </a:avLst>
+          </a:prstGeom>
+          <a:solidFill>
+            <a:srgbClr val="F4F6FB"/>
+          </a:solidFill>
+          <a:ln w="15875">
+            <a:solidFill>
+              <a:srgbClr val="F0C000"/>
+            </a:solidFill>
+          </a:ln>
+          <a:effectLst/>
+        </p:spPr>
+        <p:style>
+          <a:lnRef idx="1">
+            <a:schemeClr val="accent1"/>
+          </a:lnRef>
+          <a:fillRef idx="3">
+            <a:schemeClr val="accent1"/>
+          </a:fillRef>
+          <a:effectRef idx="2">
+            <a:schemeClr val="accent1"/>
+          </a:effectRef>
+          <a:fontRef idx="minor">
+            <a:schemeClr val="lt1"/>
+          </a:fontRef>
+        </p:style>
+        <p:txBody>
+          <a:bodyPr rtlCol="0" anchor="ctr"/>
+          <a:lstStyle/>
+          <a:p>
+            <a:pPr algn="ctr"/>
+          </a:p>
+        </p:txBody>
+      </p:sp>
+      <p:sp>
+        <p:nvSpPr>
+          <p:cNvPr id="34" name="TextBox 33"/>
+          <p:cNvSpPr txBox="1"/>
+          <p:nvPr/>
+        </p:nvSpPr>
+        <p:spPr>
+          <a:xfrm>
+            <a:off x="594361" y="1600200"/>
+            <a:ext cx="1325880" cy="274320"/>
           </a:xfrm>
           <a:prstGeom prst="rect">
             <a:avLst/>
@@ -28306,6 +29362,42 @@
           </a:bodyPr>
           <a:lstStyle/>
           <a:p>
+            <a:pPr algn="ctr" rtl="1"/>
+            <a:r>
+              <a:rPr sz="900" b="1">
+                <a:solidFill>
+                  <a:srgbClr val="1C3C7A"/>
+                </a:solidFill>
+                <a:latin typeface="Heebo"/>
+                <a:cs typeface="Heebo"/>
+              </a:rPr>
+              <a:t>צה״ל</a:t>
+            </a:r>
+          </a:p>
+        </p:txBody>
+      </p:sp>
+      <p:sp>
+        <p:nvSpPr>
+          <p:cNvPr id="35" name="TextBox 34"/>
+          <p:cNvSpPr txBox="1"/>
+          <p:nvPr/>
+        </p:nvSpPr>
+        <p:spPr>
+          <a:xfrm>
+            <a:off x="2011681" y="1234440"/>
+            <a:ext cx="3316071" cy="1005840"/>
+          </a:xfrm>
+          <a:prstGeom prst="rect">
+            <a:avLst/>
+          </a:prstGeom>
+          <a:noFill/>
+        </p:spPr>
+        <p:txBody>
+          <a:bodyPr wrap="square" anchor="ctr" lIns="36576" rIns="36576" tIns="0" bIns="0">
+            <a:spAutoFit/>
+          </a:bodyPr>
+          <a:lstStyle/>
+          <a:p>
             <a:pPr algn="r" rtl="1"/>
             <a:r>
               <a:rPr sz="1200" b="1">
@@ -28322,7 +29414,7 @@
       </p:sp>
       <p:sp>
         <p:nvSpPr>
-          <p:cNvPr id="28" name="Rounded Rectangle 27"/>
+          <p:cNvPr id="36" name="Rounded Rectangle 35"/>
           <p:cNvSpPr/>
           <p:nvPr/>
         </p:nvSpPr>
@@ -28370,7 +29462,7 @@
       </p:sp>
       <p:sp>
         <p:nvSpPr>
-          <p:cNvPr id="29" name="Rectangle 28"/>
+          <p:cNvPr id="37" name="Rectangle 36"/>
           <p:cNvSpPr/>
           <p:nvPr/>
         </p:nvSpPr>
@@ -28414,7 +29506,7 @@
       </p:sp>
       <p:sp>
         <p:nvSpPr>
-          <p:cNvPr id="30" name="Oval 29"/>
+          <p:cNvPr id="38" name="Oval 37"/>
           <p:cNvSpPr/>
           <p:nvPr/>
         </p:nvSpPr>
@@ -28458,7 +29550,7 @@
       </p:sp>
       <p:sp>
         <p:nvSpPr>
-          <p:cNvPr id="31" name="TextBox 30"/>
+          <p:cNvPr id="39" name="TextBox 38"/>
           <p:cNvSpPr txBox="1"/>
           <p:nvPr/>
         </p:nvSpPr>
@@ -28494,14 +29586,62 @@
       </p:sp>
       <p:sp>
         <p:nvSpPr>
-          <p:cNvPr id="32" name="TextBox 31"/>
-          <p:cNvSpPr txBox="1"/>
-          <p:nvPr/>
-        </p:nvSpPr>
-        <p:spPr>
-          <a:xfrm>
-            <a:off x="594361" y="2386584"/>
-            <a:ext cx="4733391" cy="1005840"/>
+          <p:cNvPr id="40" name="Rounded Rectangle 39"/>
+          <p:cNvSpPr/>
+          <p:nvPr/>
+        </p:nvSpPr>
+        <p:spPr>
+          <a:xfrm>
+            <a:off x="594361" y="2752344"/>
+            <a:ext cx="1325880" cy="274320"/>
+          </a:xfrm>
+          <a:prstGeom prst="roundRect">
+            <a:avLst>
+              <a:gd name="adj" fmla="val 50000"/>
+            </a:avLst>
+          </a:prstGeom>
+          <a:solidFill>
+            <a:srgbClr val="F4F6FB"/>
+          </a:solidFill>
+          <a:ln w="15875">
+            <a:solidFill>
+              <a:srgbClr val="F0C000"/>
+            </a:solidFill>
+          </a:ln>
+          <a:effectLst/>
+        </p:spPr>
+        <p:style>
+          <a:lnRef idx="1">
+            <a:schemeClr val="accent1"/>
+          </a:lnRef>
+          <a:fillRef idx="3">
+            <a:schemeClr val="accent1"/>
+          </a:fillRef>
+          <a:effectRef idx="2">
+            <a:schemeClr val="accent1"/>
+          </a:effectRef>
+          <a:fontRef idx="minor">
+            <a:schemeClr val="lt1"/>
+          </a:fontRef>
+        </p:style>
+        <p:txBody>
+          <a:bodyPr rtlCol="0" anchor="ctr"/>
+          <a:lstStyle/>
+          <a:p>
+            <a:pPr algn="ctr"/>
+          </a:p>
+        </p:txBody>
+      </p:sp>
+      <p:sp>
+        <p:nvSpPr>
+          <p:cNvPr id="41" name="TextBox 40"/>
+          <p:cNvSpPr txBox="1"/>
+          <p:nvPr/>
+        </p:nvSpPr>
+        <p:spPr>
+          <a:xfrm>
+            <a:off x="594361" y="2752344"/>
+            <a:ext cx="1325880" cy="274320"/>
           </a:xfrm>
           <a:prstGeom prst="rect">
             <a:avLst/>
@@ -28514,6 +29654,42 @@
           </a:bodyPr>
           <a:lstStyle/>
           <a:p>
+            <a:pPr algn="ctr" rtl="1"/>
+            <a:r>
+              <a:rPr sz="900" b="1">
+                <a:solidFill>
+                  <a:srgbClr val="1C3C7A"/>
+                </a:solidFill>
+                <a:latin typeface="Heebo"/>
+                <a:cs typeface="Heebo"/>
+              </a:rPr>
+              <a:t>חינוך</a:t>
+            </a:r>
+          </a:p>
+        </p:txBody>
+      </p:sp>
+      <p:sp>
+        <p:nvSpPr>
+          <p:cNvPr id="42" name="TextBox 41"/>
+          <p:cNvSpPr txBox="1"/>
+          <p:nvPr/>
+        </p:nvSpPr>
+        <p:spPr>
+          <a:xfrm>
+            <a:off x="2011681" y="2386584"/>
+            <a:ext cx="3316071" cy="1005840"/>
+          </a:xfrm>
+          <a:prstGeom prst="rect">
+            <a:avLst/>
+          </a:prstGeom>
+          <a:noFill/>
+        </p:spPr>
+        <p:txBody>
+          <a:bodyPr wrap="square" anchor="ctr" lIns="36576" rIns="36576" tIns="0" bIns="0">
+            <a:spAutoFit/>
+          </a:bodyPr>
+          <a:lstStyle/>
+          <a:p>
             <a:pPr algn="r" rtl="1"/>
             <a:r>
               <a:rPr sz="1200" b="1">
@@ -28530,7 +29706,7 @@
       </p:sp>
       <p:sp>
         <p:nvSpPr>
-          <p:cNvPr id="33" name="Rounded Rectangle 32"/>
+          <p:cNvPr id="43" name="Rounded Rectangle 42"/>
           <p:cNvSpPr/>
           <p:nvPr/>
         </p:nvSpPr>
@@ -28578,7 +29754,7 @@
       </p:sp>
       <p:sp>
         <p:nvSpPr>
-          <p:cNvPr id="34" name="Rectangle 33"/>
+          <p:cNvPr id="44" name="Rectangle 43"/>
           <p:cNvSpPr/>
           <p:nvPr/>
         </p:nvSpPr>
@@ -28622,7 +29798,7 @@
       </p:sp>
       <p:sp>
         <p:nvSpPr>
-          <p:cNvPr id="35" name="Oval 34"/>
+          <p:cNvPr id="45" name="Oval 44"/>
           <p:cNvSpPr/>
           <p:nvPr/>
         </p:nvSpPr>
@@ -28666,7 +29842,7 @@
       </p:sp>
       <p:sp>
         <p:nvSpPr>
-          <p:cNvPr id="36" name="TextBox 35"/>
+          <p:cNvPr id="46" name="TextBox 45"/>
           <p:cNvSpPr txBox="1"/>
           <p:nvPr/>
         </p:nvSpPr>
@@ -28702,14 +29878,98 @@
       </p:sp>
       <p:sp>
         <p:nvSpPr>
-          <p:cNvPr id="37" name="TextBox 36"/>
-          <p:cNvSpPr txBox="1"/>
-          <p:nvPr/>
-        </p:nvSpPr>
-        <p:spPr>
-          <a:xfrm>
-            <a:off x="594361" y="3538728"/>
-            <a:ext cx="4733391" cy="1005840"/>
+          <p:cNvPr id="47" name="Rounded Rectangle 46"/>
+          <p:cNvSpPr/>
+          <p:nvPr/>
+        </p:nvSpPr>
+        <p:spPr>
+          <a:xfrm>
+            <a:off x="594361" y="3904488"/>
+            <a:ext cx="1325880" cy="274320"/>
+          </a:xfrm>
+          <a:prstGeom prst="roundRect">
+            <a:avLst>
+              <a:gd name="adj" fmla="val 50000"/>
+            </a:avLst>
+          </a:prstGeom>
+          <a:solidFill>
+            <a:srgbClr val="F4F6FB"/>
+          </a:solidFill>
+          <a:ln w="15875">
+            <a:solidFill>
+              <a:srgbClr val="F0C000"/>
+            </a:solidFill>
+          </a:ln>
+          <a:effectLst/>
+        </p:spPr>
+        <p:style>
+          <a:lnRef idx="1">
+            <a:schemeClr val="accent1"/>
+          </a:lnRef>
+          <a:fillRef idx="3">
+            <a:schemeClr val="accent1"/>
+          </a:fillRef>
+          <a:effectRef idx="2">
+            <a:schemeClr val="accent1"/>
+          </a:effectRef>
+          <a:fontRef idx="minor">
+            <a:schemeClr val="lt1"/>
+          </a:fontRef>
+        </p:style>
+        <p:txBody>
+          <a:bodyPr rtlCol="0" anchor="ctr"/>
+          <a:lstStyle/>
+          <a:p>
+            <a:pPr algn="ctr"/>
+          </a:p>
+        </p:txBody>
+      </p:sp>
+      <p:sp>
+        <p:nvSpPr>
+          <p:cNvPr id="48" name="TextBox 47"/>
+          <p:cNvSpPr txBox="1"/>
+          <p:nvPr/>
+        </p:nvSpPr>
+        <p:spPr>
+          <a:xfrm>
+            <a:off x="594361" y="3904488"/>
+            <a:ext cx="1325880" cy="274320"/>
+          </a:xfrm>
+          <a:prstGeom prst="rect">
+            <a:avLst/>
+          </a:prstGeom>
+          <a:noFill/>
+        </p:spPr>
+        <p:txBody>
+          <a:bodyPr wrap="square" anchor="ctr" lIns="36576" rIns="36576" tIns="0" bIns="0">
+            <a:spAutoFit/>
+          </a:bodyPr>
+          <a:lstStyle/>
+          <a:p>
+            <a:pPr algn="ctr" rtl="1"/>
+            <a:r>
+              <a:rPr sz="900" b="1">
+                <a:solidFill>
+                  <a:srgbClr val="1C3C7A"/>
+                </a:solidFill>
+                <a:latin typeface="Heebo"/>
+                <a:cs typeface="Heebo"/>
+              </a:rPr>
+              <a:t>ריבונות</a:t>
+            </a:r>
+          </a:p>
+        </p:txBody>
+      </p:sp>
+      <p:sp>
+        <p:nvSpPr>
+          <p:cNvPr id="49" name="TextBox 48"/>
+          <p:cNvSpPr txBox="1"/>
+          <p:nvPr/>
+        </p:nvSpPr>
+        <p:spPr>
+          <a:xfrm>
+            <a:off x="2011681" y="3538728"/>
+            <a:ext cx="3316071" cy="1005840"/>
           </a:xfrm>
           <a:prstGeom prst="rect">
             <a:avLst/>
@@ -28881,7 +30141,7 @@
                 <a:latin typeface="Heebo"/>
                 <a:cs typeface="Heebo"/>
               </a:rPr>
-              <a:t>תוכניות כנסת 26 · אתיקה, חינוך והתיישבות</a:t>
+              <a:t>תוכניות כנסת 26 · טל קופל</a:t>
             </a:r>
           </a:p>
         </p:txBody>
@@ -28917,7 +30177,7 @@
                 <a:latin typeface="Heebo"/>
                 <a:cs typeface="Heebo"/>
               </a:rPr>
-              <a:t>טל קופל</a:t>
+              <a:t>אתיקה, חינוך והתיישבות</a:t>
             </a:r>
           </a:p>
         </p:txBody>
@@ -29166,14 +30426,62 @@
       </p:sp>
       <p:sp>
         <p:nvSpPr>
-          <p:cNvPr id="12" name="TextBox 11"/>
-          <p:cNvSpPr txBox="1"/>
-          <p:nvPr/>
-        </p:nvSpPr>
-        <p:spPr>
-          <a:xfrm>
-            <a:off x="594360" y="1234440"/>
-            <a:ext cx="10362895" cy="934516"/>
+          <p:cNvPr id="12" name="Rounded Rectangle 11"/>
+          <p:cNvSpPr/>
+          <p:nvPr/>
+        </p:nvSpPr>
+        <p:spPr>
+          <a:xfrm>
+            <a:off x="594360" y="1537106"/>
+            <a:ext cx="1737360" cy="329184"/>
+          </a:xfrm>
+          <a:prstGeom prst="roundRect">
+            <a:avLst>
+              <a:gd name="adj" fmla="val 50000"/>
+            </a:avLst>
+          </a:prstGeom>
+          <a:solidFill>
+            <a:srgbClr val="F4F6FB"/>
+          </a:solidFill>
+          <a:ln w="15875">
+            <a:solidFill>
+              <a:srgbClr val="F0C000"/>
+            </a:solidFill>
+          </a:ln>
+          <a:effectLst/>
+        </p:spPr>
+        <p:style>
+          <a:lnRef idx="1">
+            <a:schemeClr val="accent1"/>
+          </a:lnRef>
+          <a:fillRef idx="3">
+            <a:schemeClr val="accent1"/>
+          </a:fillRef>
+          <a:effectRef idx="2">
+            <a:schemeClr val="accent1"/>
+          </a:effectRef>
+          <a:fontRef idx="minor">
+            <a:schemeClr val="lt1"/>
+          </a:fontRef>
+        </p:style>
+        <p:txBody>
+          <a:bodyPr rtlCol="0" anchor="ctr"/>
+          <a:lstStyle/>
+          <a:p>
+            <a:pPr algn="ctr"/>
+          </a:p>
+        </p:txBody>
+      </p:sp>
+      <p:sp>
+        <p:nvSpPr>
+          <p:cNvPr id="13" name="TextBox 12"/>
+          <p:cNvSpPr txBox="1"/>
+          <p:nvPr/>
+        </p:nvSpPr>
+        <p:spPr>
+          <a:xfrm>
+            <a:off x="594360" y="1537106"/>
+            <a:ext cx="1737360" cy="329184"/>
           </a:xfrm>
           <a:prstGeom prst="rect">
             <a:avLst/>
@@ -29186,6 +30494,42 @@
           </a:bodyPr>
           <a:lstStyle/>
           <a:p>
+            <a:pPr algn="ctr" rtl="1"/>
+            <a:r>
+              <a:rPr sz="1100" b="1">
+                <a:solidFill>
+                  <a:srgbClr val="1C3C7A"/>
+                </a:solidFill>
+                <a:latin typeface="Heebo"/>
+                <a:cs typeface="Heebo"/>
+              </a:rPr>
+              <a:t>התיישבות</a:t>
+            </a:r>
+          </a:p>
+        </p:txBody>
+      </p:sp>
+      <p:sp>
+        <p:nvSpPr>
+          <p:cNvPr id="14" name="TextBox 13"/>
+          <p:cNvSpPr txBox="1"/>
+          <p:nvPr/>
+        </p:nvSpPr>
+        <p:spPr>
+          <a:xfrm>
+            <a:off x="2423160" y="1234440"/>
+            <a:ext cx="8534095" cy="934516"/>
+          </a:xfrm>
+          <a:prstGeom prst="rect">
+            <a:avLst/>
+          </a:prstGeom>
+          <a:noFill/>
+        </p:spPr>
+        <p:txBody>
+          <a:bodyPr wrap="square" anchor="ctr" lIns="36576" rIns="36576" tIns="0" bIns="0">
+            <a:spAutoFit/>
+          </a:bodyPr>
+          <a:lstStyle/>
+          <a:p>
             <a:pPr algn="r" rtl="1"/>
             <a:r>
               <a:rPr sz="1600" b="1">
@@ -29195,14 +30539,14 @@
                 <a:latin typeface="Heebo"/>
                 <a:cs typeface="Heebo"/>
               </a:rPr>
-              <a:t>התיישבות: ייהוד הגליל והנגב וגרעיני נח״ל</a:t>
-            </a:r>
-          </a:p>
-        </p:txBody>
-      </p:sp>
-      <p:sp>
-        <p:nvSpPr>
-          <p:cNvPr id="13" name="Rounded Rectangle 12"/>
+              <a:t>ייהוד הגליל והנגב וגרעיני נח״ל</a:t>
+            </a:r>
+          </a:p>
+        </p:txBody>
+      </p:sp>
+      <p:sp>
+        <p:nvSpPr>
+          <p:cNvPr id="15" name="Rounded Rectangle 14"/>
           <p:cNvSpPr/>
           <p:nvPr/>
         </p:nvSpPr>
@@ -29250,7 +30594,7 @@
       </p:sp>
       <p:sp>
         <p:nvSpPr>
-          <p:cNvPr id="14" name="Rectangle 13"/>
+          <p:cNvPr id="16" name="Rectangle 15"/>
           <p:cNvSpPr/>
           <p:nvPr/>
         </p:nvSpPr>
@@ -29294,7 +30638,7 @@
       </p:sp>
       <p:sp>
         <p:nvSpPr>
-          <p:cNvPr id="15" name="Oval 14"/>
+          <p:cNvPr id="17" name="Oval 16"/>
           <p:cNvSpPr/>
           <p:nvPr/>
         </p:nvSpPr>
@@ -29338,7 +30682,7 @@
       </p:sp>
       <p:sp>
         <p:nvSpPr>
-          <p:cNvPr id="16" name="TextBox 15"/>
+          <p:cNvPr id="18" name="TextBox 17"/>
           <p:cNvSpPr txBox="1"/>
           <p:nvPr/>
         </p:nvSpPr>
@@ -29374,14 +30718,62 @@
       </p:sp>
       <p:sp>
         <p:nvSpPr>
-          <p:cNvPr id="17" name="TextBox 16"/>
-          <p:cNvSpPr txBox="1"/>
-          <p:nvPr/>
-        </p:nvSpPr>
-        <p:spPr>
-          <a:xfrm>
-            <a:off x="594360" y="2315260"/>
-            <a:ext cx="10362895" cy="934516"/>
+          <p:cNvPr id="19" name="Rounded Rectangle 18"/>
+          <p:cNvSpPr/>
+          <p:nvPr/>
+        </p:nvSpPr>
+        <p:spPr>
+          <a:xfrm>
+            <a:off x="594360" y="2617926"/>
+            <a:ext cx="1737360" cy="329184"/>
+          </a:xfrm>
+          <a:prstGeom prst="roundRect">
+            <a:avLst>
+              <a:gd name="adj" fmla="val 50000"/>
+            </a:avLst>
+          </a:prstGeom>
+          <a:solidFill>
+            <a:srgbClr val="F4F6FB"/>
+          </a:solidFill>
+          <a:ln w="15875">
+            <a:solidFill>
+              <a:srgbClr val="F0C000"/>
+            </a:solidFill>
+          </a:ln>
+          <a:effectLst/>
+        </p:spPr>
+        <p:style>
+          <a:lnRef idx="1">
+            <a:schemeClr val="accent1"/>
+          </a:lnRef>
+          <a:fillRef idx="3">
+            <a:schemeClr val="accent1"/>
+          </a:fillRef>
+          <a:effectRef idx="2">
+            <a:schemeClr val="accent1"/>
+          </a:effectRef>
+          <a:fontRef idx="minor">
+            <a:schemeClr val="lt1"/>
+          </a:fontRef>
+        </p:style>
+        <p:txBody>
+          <a:bodyPr rtlCol="0" anchor="ctr"/>
+          <a:lstStyle/>
+          <a:p>
+            <a:pPr algn="ctr"/>
+          </a:p>
+        </p:txBody>
+      </p:sp>
+      <p:sp>
+        <p:nvSpPr>
+          <p:cNvPr id="20" name="TextBox 19"/>
+          <p:cNvSpPr txBox="1"/>
+          <p:nvPr/>
+        </p:nvSpPr>
+        <p:spPr>
+          <a:xfrm>
+            <a:off x="594360" y="2617926"/>
+            <a:ext cx="1737360" cy="329184"/>
           </a:xfrm>
           <a:prstGeom prst="rect">
             <a:avLst/>
@@ -29394,6 +30786,42 @@
           </a:bodyPr>
           <a:lstStyle/>
           <a:p>
+            <a:pPr algn="ctr" rtl="1"/>
+            <a:r>
+              <a:rPr sz="1100" b="1">
+                <a:solidFill>
+                  <a:srgbClr val="1C3C7A"/>
+                </a:solidFill>
+                <a:latin typeface="Heebo"/>
+                <a:cs typeface="Heebo"/>
+              </a:rPr>
+              <a:t>זהות יהודית בצה״ל</a:t>
+            </a:r>
+          </a:p>
+        </p:txBody>
+      </p:sp>
+      <p:sp>
+        <p:nvSpPr>
+          <p:cNvPr id="21" name="TextBox 20"/>
+          <p:cNvSpPr txBox="1"/>
+          <p:nvPr/>
+        </p:nvSpPr>
+        <p:spPr>
+          <a:xfrm>
+            <a:off x="2423160" y="2315260"/>
+            <a:ext cx="8534095" cy="934516"/>
+          </a:xfrm>
+          <a:prstGeom prst="rect">
+            <a:avLst/>
+          </a:prstGeom>
+          <a:noFill/>
+        </p:spPr>
+        <p:txBody>
+          <a:bodyPr wrap="square" anchor="ctr" lIns="36576" rIns="36576" tIns="0" bIns="0">
+            <a:spAutoFit/>
+          </a:bodyPr>
+          <a:lstStyle/>
+          <a:p>
             <a:pPr algn="r" rtl="1"/>
             <a:r>
               <a:rPr sz="1600" b="1">
@@ -29403,14 +30831,14 @@
                 <a:latin typeface="Heebo"/>
                 <a:cs typeface="Heebo"/>
               </a:rPr>
-              <a:t>זהות יהודית בצה״ל: קוד אתי חדש וחיל חינוך</a:t>
-            </a:r>
-          </a:p>
-        </p:txBody>
-      </p:sp>
-      <p:sp>
-        <p:nvSpPr>
-          <p:cNvPr id="18" name="Rounded Rectangle 17"/>
+              <a:t>קוד אתי חדש וחיל חינוך</a:t>
+            </a:r>
+          </a:p>
+        </p:txBody>
+      </p:sp>
+      <p:sp>
+        <p:nvSpPr>
+          <p:cNvPr id="22" name="Rounded Rectangle 21"/>
           <p:cNvSpPr/>
           <p:nvPr/>
         </p:nvSpPr>
@@ -29458,7 +30886,7 @@
       </p:sp>
       <p:sp>
         <p:nvSpPr>
-          <p:cNvPr id="19" name="Rectangle 18"/>
+          <p:cNvPr id="23" name="Rectangle 22"/>
           <p:cNvSpPr/>
           <p:nvPr/>
         </p:nvSpPr>
@@ -29502,7 +30930,7 @@
       </p:sp>
       <p:sp>
         <p:nvSpPr>
-          <p:cNvPr id="20" name="Oval 19"/>
+          <p:cNvPr id="24" name="Oval 23"/>
           <p:cNvSpPr/>
           <p:nvPr/>
         </p:nvSpPr>
@@ -29546,7 +30974,7 @@
       </p:sp>
       <p:sp>
         <p:nvSpPr>
-          <p:cNvPr id="21" name="TextBox 20"/>
+          <p:cNvPr id="25" name="TextBox 24"/>
           <p:cNvSpPr txBox="1"/>
           <p:nvPr/>
         </p:nvSpPr>
@@ -29582,14 +31010,62 @@
       </p:sp>
       <p:sp>
         <p:nvSpPr>
-          <p:cNvPr id="22" name="TextBox 21"/>
-          <p:cNvSpPr txBox="1"/>
-          <p:nvPr/>
-        </p:nvSpPr>
-        <p:spPr>
-          <a:xfrm>
-            <a:off x="594360" y="3396080"/>
-            <a:ext cx="10362895" cy="934516"/>
+          <p:cNvPr id="26" name="Rounded Rectangle 25"/>
+          <p:cNvSpPr/>
+          <p:nvPr/>
+        </p:nvSpPr>
+        <p:spPr>
+          <a:xfrm>
+            <a:off x="594360" y="3698746"/>
+            <a:ext cx="1737360" cy="329184"/>
+          </a:xfrm>
+          <a:prstGeom prst="roundRect">
+            <a:avLst>
+              <a:gd name="adj" fmla="val 50000"/>
+            </a:avLst>
+          </a:prstGeom>
+          <a:solidFill>
+            <a:srgbClr val="F4F6FB"/>
+          </a:solidFill>
+          <a:ln w="15875">
+            <a:solidFill>
+              <a:srgbClr val="F0C000"/>
+            </a:solidFill>
+          </a:ln>
+          <a:effectLst/>
+        </p:spPr>
+        <p:style>
+          <a:lnRef idx="1">
+            <a:schemeClr val="accent1"/>
+          </a:lnRef>
+          <a:fillRef idx="3">
+            <a:schemeClr val="accent1"/>
+          </a:fillRef>
+          <a:effectRef idx="2">
+            <a:schemeClr val="accent1"/>
+          </a:effectRef>
+          <a:fontRef idx="minor">
+            <a:schemeClr val="lt1"/>
+          </a:fontRef>
+        </p:style>
+        <p:txBody>
+          <a:bodyPr rtlCol="0" anchor="ctr"/>
+          <a:lstStyle/>
+          <a:p>
+            <a:pPr algn="ctr"/>
+          </a:p>
+        </p:txBody>
+      </p:sp>
+      <p:sp>
+        <p:nvSpPr>
+          <p:cNvPr id="27" name="TextBox 26"/>
+          <p:cNvSpPr txBox="1"/>
+          <p:nvPr/>
+        </p:nvSpPr>
+        <p:spPr>
+          <a:xfrm>
+            <a:off x="594360" y="3698746"/>
+            <a:ext cx="1737360" cy="329184"/>
           </a:xfrm>
           <a:prstGeom prst="rect">
             <a:avLst/>
@@ -29602,6 +31078,42 @@
           </a:bodyPr>
           <a:lstStyle/>
           <a:p>
+            <a:pPr algn="ctr" rtl="1"/>
+            <a:r>
+              <a:rPr sz="1100" b="1">
+                <a:solidFill>
+                  <a:srgbClr val="1C3C7A"/>
+                </a:solidFill>
+                <a:latin typeface="Heebo"/>
+                <a:cs typeface="Heebo"/>
+              </a:rPr>
+              <a:t>מילואים וגבורה</a:t>
+            </a:r>
+          </a:p>
+        </p:txBody>
+      </p:sp>
+      <p:sp>
+        <p:nvSpPr>
+          <p:cNvPr id="28" name="TextBox 27"/>
+          <p:cNvSpPr txBox="1"/>
+          <p:nvPr/>
+        </p:nvSpPr>
+        <p:spPr>
+          <a:xfrm>
+            <a:off x="2423160" y="3396080"/>
+            <a:ext cx="8534095" cy="934516"/>
+          </a:xfrm>
+          <a:prstGeom prst="rect">
+            <a:avLst/>
+          </a:prstGeom>
+          <a:noFill/>
+        </p:spPr>
+        <p:txBody>
+          <a:bodyPr wrap="square" anchor="ctr" lIns="36576" rIns="36576" tIns="0" bIns="0">
+            <a:spAutoFit/>
+          </a:bodyPr>
+          <a:lstStyle/>
+          <a:p>
             <a:pPr algn="r" rtl="1"/>
             <a:r>
               <a:rPr sz="1600" b="1">
@@ -29611,14 +31123,14 @@
                 <a:latin typeface="Heebo"/>
                 <a:cs typeface="Heebo"/>
               </a:rPr>
-              <a:t>מילואים וגבורה: תגמול המילואים ושדולת הגבורה</a:t>
-            </a:r>
-          </a:p>
-        </p:txBody>
-      </p:sp>
-      <p:sp>
-        <p:nvSpPr>
-          <p:cNvPr id="23" name="Rounded Rectangle 22"/>
+              <a:t>תגמול המילואים ושדולת הגבורה</a:t>
+            </a:r>
+          </a:p>
+        </p:txBody>
+      </p:sp>
+      <p:sp>
+        <p:nvSpPr>
+          <p:cNvPr id="29" name="Rounded Rectangle 28"/>
           <p:cNvSpPr/>
           <p:nvPr/>
         </p:nvSpPr>
@@ -29666,7 +31178,7 @@
       </p:sp>
       <p:sp>
         <p:nvSpPr>
-          <p:cNvPr id="24" name="Rectangle 23"/>
+          <p:cNvPr id="30" name="Rectangle 29"/>
           <p:cNvSpPr/>
           <p:nvPr/>
         </p:nvSpPr>
@@ -29710,7 +31222,7 @@
       </p:sp>
       <p:sp>
         <p:nvSpPr>
-          <p:cNvPr id="25" name="Oval 24"/>
+          <p:cNvPr id="31" name="Oval 30"/>
           <p:cNvSpPr/>
           <p:nvPr/>
         </p:nvSpPr>
@@ -29754,7 +31266,7 @@
       </p:sp>
       <p:sp>
         <p:nvSpPr>
-          <p:cNvPr id="26" name="TextBox 25"/>
+          <p:cNvPr id="32" name="TextBox 31"/>
           <p:cNvSpPr txBox="1"/>
           <p:nvPr/>
         </p:nvSpPr>
@@ -29790,14 +31302,62 @@
       </p:sp>
       <p:sp>
         <p:nvSpPr>
-          <p:cNvPr id="27" name="TextBox 26"/>
-          <p:cNvSpPr txBox="1"/>
-          <p:nvPr/>
-        </p:nvSpPr>
-        <p:spPr>
-          <a:xfrm>
-            <a:off x="594360" y="4476900"/>
-            <a:ext cx="10362895" cy="934516"/>
+          <p:cNvPr id="33" name="Rounded Rectangle 32"/>
+          <p:cNvSpPr/>
+          <p:nvPr/>
+        </p:nvSpPr>
+        <p:spPr>
+          <a:xfrm>
+            <a:off x="594360" y="4779566"/>
+            <a:ext cx="1737360" cy="329184"/>
+          </a:xfrm>
+          <a:prstGeom prst="roundRect">
+            <a:avLst>
+              <a:gd name="adj" fmla="val 50000"/>
+            </a:avLst>
+          </a:prstGeom>
+          <a:solidFill>
+            <a:srgbClr val="F4F6FB"/>
+          </a:solidFill>
+          <a:ln w="15875">
+            <a:solidFill>
+              <a:srgbClr val="F0C000"/>
+            </a:solidFill>
+          </a:ln>
+          <a:effectLst/>
+        </p:spPr>
+        <p:style>
+          <a:lnRef idx="1">
+            <a:schemeClr val="accent1"/>
+          </a:lnRef>
+          <a:fillRef idx="3">
+            <a:schemeClr val="accent1"/>
+          </a:fillRef>
+          <a:effectRef idx="2">
+            <a:schemeClr val="accent1"/>
+          </a:effectRef>
+          <a:fontRef idx="minor">
+            <a:schemeClr val="lt1"/>
+          </a:fontRef>
+        </p:style>
+        <p:txBody>
+          <a:bodyPr rtlCol="0" anchor="ctr"/>
+          <a:lstStyle/>
+          <a:p>
+            <a:pPr algn="ctr"/>
+          </a:p>
+        </p:txBody>
+      </p:sp>
+      <p:sp>
+        <p:nvSpPr>
+          <p:cNvPr id="34" name="TextBox 33"/>
+          <p:cNvSpPr txBox="1"/>
+          <p:nvPr/>
+        </p:nvSpPr>
+        <p:spPr>
+          <a:xfrm>
+            <a:off x="594360" y="4779566"/>
+            <a:ext cx="1737360" cy="329184"/>
           </a:xfrm>
           <a:prstGeom prst="rect">
             <a:avLst/>
@@ -29810,6 +31370,42 @@
           </a:bodyPr>
           <a:lstStyle/>
           <a:p>
+            <a:pPr algn="ctr" rtl="1"/>
+            <a:r>
+              <a:rPr sz="1100" b="1">
+                <a:solidFill>
+                  <a:srgbClr val="1C3C7A"/>
+                </a:solidFill>
+                <a:latin typeface="Heebo"/>
+                <a:cs typeface="Heebo"/>
+              </a:rPr>
+              <a:t>זהות בחינוך</a:t>
+            </a:r>
+          </a:p>
+        </p:txBody>
+      </p:sp>
+      <p:sp>
+        <p:nvSpPr>
+          <p:cNvPr id="35" name="TextBox 34"/>
+          <p:cNvSpPr txBox="1"/>
+          <p:nvPr/>
+        </p:nvSpPr>
+        <p:spPr>
+          <a:xfrm>
+            <a:off x="2423160" y="4476900"/>
+            <a:ext cx="8534095" cy="934516"/>
+          </a:xfrm>
+          <a:prstGeom prst="rect">
+            <a:avLst/>
+          </a:prstGeom>
+          <a:noFill/>
+        </p:spPr>
+        <p:txBody>
+          <a:bodyPr wrap="square" anchor="ctr" lIns="36576" rIns="36576" tIns="0" bIns="0">
+            <a:spAutoFit/>
+          </a:bodyPr>
+          <a:lstStyle/>
+          <a:p>
             <a:pPr algn="r" rtl="1"/>
             <a:r>
               <a:rPr sz="1600" b="1">
@@ -29819,14 +31415,14 @@
                 <a:latin typeface="Heebo"/>
                 <a:cs typeface="Heebo"/>
               </a:rPr>
-              <a:t>זהות בחינוך: חוק חינוך ממלכתי, תנ״ך, היסטוריה וחינוך ביתי</a:t>
-            </a:r>
-          </a:p>
-        </p:txBody>
-      </p:sp>
-      <p:sp>
-        <p:nvSpPr>
-          <p:cNvPr id="28" name="Rounded Rectangle 27"/>
+              <a:t>חוק חינוך ממלכתי, תנ״ך, היסטוריה וחינוך ביתי</a:t>
+            </a:r>
+          </a:p>
+        </p:txBody>
+      </p:sp>
+      <p:sp>
+        <p:nvSpPr>
+          <p:cNvPr id="36" name="Rounded Rectangle 35"/>
           <p:cNvSpPr/>
           <p:nvPr/>
         </p:nvSpPr>
@@ -29874,7 +31470,7 @@
       </p:sp>
       <p:sp>
         <p:nvSpPr>
-          <p:cNvPr id="29" name="Rectangle 28"/>
+          <p:cNvPr id="37" name="Rectangle 36"/>
           <p:cNvSpPr/>
           <p:nvPr/>
         </p:nvSpPr>
@@ -29918,7 +31514,7 @@
       </p:sp>
       <p:sp>
         <p:nvSpPr>
-          <p:cNvPr id="30" name="Oval 29"/>
+          <p:cNvPr id="38" name="Oval 37"/>
           <p:cNvSpPr/>
           <p:nvPr/>
         </p:nvSpPr>
@@ -29962,7 +31558,7 @@
       </p:sp>
       <p:sp>
         <p:nvSpPr>
-          <p:cNvPr id="31" name="TextBox 30"/>
+          <p:cNvPr id="39" name="TextBox 38"/>
           <p:cNvSpPr txBox="1"/>
           <p:nvPr/>
         </p:nvSpPr>
@@ -29998,14 +31594,62 @@
       </p:sp>
       <p:sp>
         <p:nvSpPr>
-          <p:cNvPr id="32" name="TextBox 31"/>
-          <p:cNvSpPr txBox="1"/>
-          <p:nvPr/>
-        </p:nvSpPr>
-        <p:spPr>
-          <a:xfrm>
-            <a:off x="594360" y="5557720"/>
-            <a:ext cx="10362895" cy="934516"/>
+          <p:cNvPr id="40" name="Rounded Rectangle 39"/>
+          <p:cNvSpPr/>
+          <p:nvPr/>
+        </p:nvSpPr>
+        <p:spPr>
+          <a:xfrm>
+            <a:off x="594360" y="5860386"/>
+            <a:ext cx="1737360" cy="329184"/>
+          </a:xfrm>
+          <a:prstGeom prst="roundRect">
+            <a:avLst>
+              <a:gd name="adj" fmla="val 50000"/>
+            </a:avLst>
+          </a:prstGeom>
+          <a:solidFill>
+            <a:srgbClr val="F4F6FB"/>
+          </a:solidFill>
+          <a:ln w="15875">
+            <a:solidFill>
+              <a:srgbClr val="F0C000"/>
+            </a:solidFill>
+          </a:ln>
+          <a:effectLst/>
+        </p:spPr>
+        <p:style>
+          <a:lnRef idx="1">
+            <a:schemeClr val="accent1"/>
+          </a:lnRef>
+          <a:fillRef idx="3">
+            <a:schemeClr val="accent1"/>
+          </a:fillRef>
+          <a:effectRef idx="2">
+            <a:schemeClr val="accent1"/>
+          </a:effectRef>
+          <a:fontRef idx="minor">
+            <a:schemeClr val="lt1"/>
+          </a:fontRef>
+        </p:style>
+        <p:txBody>
+          <a:bodyPr rtlCol="0" anchor="ctr"/>
+          <a:lstStyle/>
+          <a:p>
+            <a:pPr algn="ctr"/>
+          </a:p>
+        </p:txBody>
+      </p:sp>
+      <p:sp>
+        <p:nvSpPr>
+          <p:cNvPr id="41" name="TextBox 40"/>
+          <p:cNvSpPr txBox="1"/>
+          <p:nvPr/>
+        </p:nvSpPr>
+        <p:spPr>
+          <a:xfrm>
+            <a:off x="594360" y="5860386"/>
+            <a:ext cx="1737360" cy="329184"/>
           </a:xfrm>
           <a:prstGeom prst="rect">
             <a:avLst/>
@@ -30018,6 +31662,42 @@
           </a:bodyPr>
           <a:lstStyle/>
           <a:p>
+            <a:pPr algn="ctr" rtl="1"/>
+            <a:r>
+              <a:rPr sz="1100" b="1">
+                <a:solidFill>
+                  <a:srgbClr val="1C3C7A"/>
+                </a:solidFill>
+                <a:latin typeface="Heebo"/>
+                <a:cs typeface="Heebo"/>
+              </a:rPr>
+              <a:t>אקדמיה ומחקר</a:t>
+            </a:r>
+          </a:p>
+        </p:txBody>
+      </p:sp>
+      <p:sp>
+        <p:nvSpPr>
+          <p:cNvPr id="42" name="TextBox 41"/>
+          <p:cNvSpPr txBox="1"/>
+          <p:nvPr/>
+        </p:nvSpPr>
+        <p:spPr>
+          <a:xfrm>
+            <a:off x="2423160" y="5557720"/>
+            <a:ext cx="8534095" cy="934516"/>
+          </a:xfrm>
+          <a:prstGeom prst="rect">
+            <a:avLst/>
+          </a:prstGeom>
+          <a:noFill/>
+        </p:spPr>
+        <p:txBody>
+          <a:bodyPr wrap="square" anchor="ctr" lIns="36576" rIns="36576" tIns="0" bIns="0">
+            <a:spAutoFit/>
+          </a:bodyPr>
+          <a:lstStyle/>
+          <a:p>
             <a:pPr algn="r" rtl="1"/>
             <a:r>
               <a:rPr sz="1600" b="1">
@@ -30027,7 +31707,7 @@
                 <a:latin typeface="Heebo"/>
                 <a:cs typeface="Heebo"/>
               </a:rPr>
-              <a:t>אקדמיה ומחקר: הפרדת ות״ת מהמל״ג ומוסד מחקר לאומי</a:t>
+              <a:t>הפרדת ות״ת מהמל״ג ומוסד מחקר לאומי</a:t>
             </a:r>
           </a:p>
         </p:txBody>

</xml_diff>

<commit_message>
Stage A: CEO 10,000
Co-Authored-By: Claude Opus 5.5 <noreply@anthropic.com>
Claude-Session: https://claude.ai/code/session_01W7Er83FuNT4pLFShWidYHn
</commit_message>
<xml_diff>
--- a/presentation/out/koach-hitarvut.pptx
+++ b/presentation/out/koach-hitarvut.pptx
@@ -9349,7 +9349,7 @@
                 <a:latin typeface="Heebo"/>
                 <a:cs typeface="Heebo"/>
               </a:rPr>
-              <a:t>12,000 ₪</a:t>
+              <a:t>10,000 ₪</a:t>
             </a:r>
           </a:p>
         </p:txBody>
@@ -10559,7 +10559,7 @@
                 <a:latin typeface="Heebo"/>
                 <a:cs typeface="Heebo"/>
               </a:rPr>
-              <a:t>22,750 ₪</a:t>
+              <a:t>20,750 ₪</a:t>
             </a:r>
           </a:p>
         </p:txBody>
@@ -10595,7 +10595,7 @@
                 <a:latin typeface="Heebo"/>
                 <a:cs typeface="Heebo"/>
               </a:rPr>
-              <a:t>273,000 ₪ בשנה</a:t>
+              <a:t>249,000 ₪ בשנה</a:t>
             </a:r>
           </a:p>
         </p:txBody>
@@ -10795,7 +10795,7 @@
                 <a:latin typeface="Heebo"/>
                 <a:cs typeface="Heebo"/>
               </a:rPr>
-              <a:t>1,750 ₪</a:t>
+              <a:t>1,600 ₪</a:t>
             </a:r>
           </a:p>
         </p:txBody>
@@ -11599,7 +11599,7 @@
                 <a:latin typeface="Heebo"/>
                 <a:cs typeface="Heebo"/>
               </a:rPr>
-              <a:t>+3,000</a:t>
+              <a:t>+5,000</a:t>
             </a:r>
           </a:p>
         </p:txBody>

</xml_diff>

<commit_message>
Costs slide: highlight initial ideal model in gold, drop badge and funding lines
Co-Authored-By: Claude Opus 5.5 <noreply@anthropic.com>
Claude-Session: https://claude.ai/code/session_01W7Er83FuNT4pLFShWidYHn
</commit_message>
<xml_diff>
--- a/presentation/out/koach-hitarvut.pptx
+++ b/presentation/out/koach-hitarvut.pptx
@@ -13435,9 +13435,9 @@
           <a:solidFill>
             <a:srgbClr val="FFFFFF"/>
           </a:solidFill>
-          <a:ln w="15875">
+          <a:ln w="38100">
             <a:solidFill>
-              <a:srgbClr val="C5CDDD"/>
+              <a:srgbClr val="F0C000"/>
             </a:solidFill>
           </a:ln>
           <a:effectLst/>
@@ -13481,7 +13481,7 @@
             </a:avLst>
           </a:prstGeom>
           <a:solidFill>
-            <a:srgbClr val="4A5568"/>
+            <a:srgbClr val="F0C000"/>
           </a:solidFill>
           <a:ln>
             <a:noFill/>
@@ -13536,12 +13536,12 @@
             <a:r>
               <a:rPr sz="2000" b="1">
                 <a:solidFill>
-                  <a:srgbClr val="FFFFFF"/>
-                </a:solidFill>
-                <a:latin typeface="Heebo"/>
-                <a:cs typeface="Heebo"/>
-              </a:rPr>
-              <a:t>מודל אידיאלי</a:t>
+                  <a:srgbClr val="122755"/>
+                </a:solidFill>
+                <a:latin typeface="Heebo"/>
+                <a:cs typeface="Heebo"/>
+              </a:rPr>
+              <a:t>מודל אידיאלי התחלתי</a:t>
             </a:r>
           </a:p>
         </p:txBody>
@@ -13572,7 +13572,7 @@
             <a:r>
               <a:rPr sz="1000" b="0">
                 <a:solidFill>
-                  <a:srgbClr val="F0C000"/>
+                  <a:srgbClr val="122755"/>
                 </a:solidFill>
                 <a:latin typeface="Heebo"/>
                 <a:cs typeface="Heebo"/>
@@ -14463,1212 +14463,13 @@
       </p:sp>
       <p:sp>
         <p:nvSpPr>
-          <p:cNvPr id="35" name="TextBox 34"/>
-          <p:cNvSpPr txBox="1"/>
-          <p:nvPr/>
-        </p:nvSpPr>
-        <p:spPr>
-          <a:xfrm>
-            <a:off x="8325917" y="6080760"/>
-            <a:ext cx="3271418" cy="274320"/>
-          </a:xfrm>
-          <a:prstGeom prst="rect">
-            <a:avLst/>
-          </a:prstGeom>
-          <a:noFill/>
-        </p:spPr>
-        <p:txBody>
-          <a:bodyPr wrap="square" anchor="ctr" lIns="36576" rIns="36576" tIns="0" bIns="0">
-            <a:spAutoFit/>
-          </a:bodyPr>
-          <a:lstStyle/>
-          <a:p>
-            <a:pPr algn="r" rtl="1"/>
-            <a:r>
-              <a:rPr sz="1100" b="1">
-                <a:solidFill>
-                  <a:srgbClr val="1C3C7A"/>
-                </a:solidFill>
-                <a:latin typeface="Heebo"/>
-                <a:cs typeface="Heebo"/>
-              </a:rPr>
-              <a:t>מימון: כ-6 שותפים מייסדים</a:t>
-            </a:r>
-          </a:p>
-        </p:txBody>
-      </p:sp>
-      <p:sp>
-        <p:nvSpPr>
-          <p:cNvPr id="36" name="Rounded Rectangle 35"/>
+          <p:cNvPr id="35" name="Rounded Rectangle 34"/>
           <p:cNvSpPr/>
           <p:nvPr/>
         </p:nvSpPr>
         <p:spPr>
           <a:xfrm>
             <a:off x="4277259" y="1188720"/>
-            <a:ext cx="3637178" cy="5120640"/>
-          </a:xfrm>
-          <a:prstGeom prst="roundRect">
-            <a:avLst>
-              <a:gd name="adj" fmla="val 5000"/>
-            </a:avLst>
-          </a:prstGeom>
-          <a:solidFill>
-            <a:srgbClr val="FFFFFF"/>
-          </a:solidFill>
-          <a:ln w="38100">
-            <a:solidFill>
-              <a:srgbClr val="F0C000"/>
-            </a:solidFill>
-          </a:ln>
-          <a:effectLst/>
-        </p:spPr>
-        <p:style>
-          <a:lnRef idx="1">
-            <a:schemeClr val="accent1"/>
-          </a:lnRef>
-          <a:fillRef idx="3">
-            <a:schemeClr val="accent1"/>
-          </a:fillRef>
-          <a:effectRef idx="2">
-            <a:schemeClr val="accent1"/>
-          </a:effectRef>
-          <a:fontRef idx="minor">
-            <a:schemeClr val="lt1"/>
-          </a:fontRef>
-        </p:style>
-        <p:txBody>
-          <a:bodyPr rtlCol="0" anchor="ctr"/>
-          <a:lstStyle/>
-          <a:p>
-            <a:pPr algn="ctr"/>
-          </a:p>
-        </p:txBody>
-      </p:sp>
-      <p:sp>
-        <p:nvSpPr>
-          <p:cNvPr id="37" name="Rounded Rectangle 36"/>
-          <p:cNvSpPr/>
-          <p:nvPr/>
-        </p:nvSpPr>
-        <p:spPr>
-          <a:xfrm>
-            <a:off x="4277259" y="1188720"/>
-            <a:ext cx="3637178" cy="868680"/>
-          </a:xfrm>
-          <a:prstGeom prst="roundRect">
-            <a:avLst>
-              <a:gd name="adj" fmla="val 12000"/>
-            </a:avLst>
-          </a:prstGeom>
-          <a:solidFill>
-            <a:srgbClr val="1C3C7A"/>
-          </a:solidFill>
-          <a:ln>
-            <a:noFill/>
-          </a:ln>
-          <a:effectLst/>
-        </p:spPr>
-        <p:style>
-          <a:lnRef idx="1">
-            <a:schemeClr val="accent1"/>
-          </a:lnRef>
-          <a:fillRef idx="3">
-            <a:schemeClr val="accent1"/>
-          </a:fillRef>
-          <a:effectRef idx="2">
-            <a:schemeClr val="accent1"/>
-          </a:effectRef>
-          <a:fontRef idx="minor">
-            <a:schemeClr val="lt1"/>
-          </a:fontRef>
-        </p:style>
-        <p:txBody>
-          <a:bodyPr rtlCol="0" anchor="ctr"/>
-          <a:lstStyle/>
-          <a:p>
-            <a:pPr algn="ctr"/>
-          </a:p>
-        </p:txBody>
-      </p:sp>
-      <p:sp>
-        <p:nvSpPr>
-          <p:cNvPr id="38" name="TextBox 37"/>
-          <p:cNvSpPr txBox="1"/>
-          <p:nvPr/>
-        </p:nvSpPr>
-        <p:spPr>
-          <a:xfrm>
-            <a:off x="4277259" y="1280160"/>
-            <a:ext cx="3637178" cy="384048"/>
-          </a:xfrm>
-          <a:prstGeom prst="rect">
-            <a:avLst/>
-          </a:prstGeom>
-          <a:noFill/>
-        </p:spPr>
-        <p:txBody>
-          <a:bodyPr wrap="square" anchor="ctr" lIns="36576" rIns="36576" tIns="0" bIns="0">
-            <a:spAutoFit/>
-          </a:bodyPr>
-          <a:lstStyle/>
-          <a:p>
-            <a:pPr algn="ctr" rtl="1"/>
-            <a:r>
-              <a:rPr sz="2000" b="1">
-                <a:solidFill>
-                  <a:srgbClr val="FFFFFF"/>
-                </a:solidFill>
-                <a:latin typeface="Heebo"/>
-                <a:cs typeface="Heebo"/>
-              </a:rPr>
-              <a:t>מודל ביניים</a:t>
-            </a:r>
-          </a:p>
-        </p:txBody>
-      </p:sp>
-      <p:sp>
-        <p:nvSpPr>
-          <p:cNvPr id="39" name="TextBox 38"/>
-          <p:cNvSpPr txBox="1"/>
-          <p:nvPr/>
-        </p:nvSpPr>
-        <p:spPr>
-          <a:xfrm>
-            <a:off x="4368699" y="1664208"/>
-            <a:ext cx="3454298" cy="329184"/>
-          </a:xfrm>
-          <a:prstGeom prst="rect">
-            <a:avLst/>
-          </a:prstGeom>
-          <a:noFill/>
-        </p:spPr>
-        <p:txBody>
-          <a:bodyPr wrap="square" anchor="ctr" lIns="36576" rIns="36576" tIns="0" bIns="0">
-            <a:spAutoFit/>
-          </a:bodyPr>
-          <a:lstStyle/>
-          <a:p>
-            <a:pPr algn="ctr" rtl="1"/>
-            <a:r>
-              <a:rPr sz="1000" b="0">
-                <a:solidFill>
-                  <a:srgbClr val="F0C000"/>
-                </a:solidFill>
-                <a:latin typeface="Heebo"/>
-                <a:cs typeface="Heebo"/>
-              </a:rPr>
-              <a:t>בלי נציג 4 · דירקטוריון ואקטיביסטים משלימים</a:t>
-            </a:r>
-          </a:p>
-        </p:txBody>
-      </p:sp>
-      <p:sp>
-        <p:nvSpPr>
-          <p:cNvPr id="40" name="Rounded Rectangle 39"/>
-          <p:cNvSpPr/>
-          <p:nvPr/>
-        </p:nvSpPr>
-        <p:spPr>
-          <a:xfrm>
-            <a:off x="5455768" y="1033272"/>
-            <a:ext cx="1280160" cy="310896"/>
-          </a:xfrm>
-          <a:prstGeom prst="roundRect">
-            <a:avLst>
-              <a:gd name="adj" fmla="val 50000"/>
-            </a:avLst>
-          </a:prstGeom>
-          <a:solidFill>
-            <a:srgbClr val="F0C000"/>
-          </a:solidFill>
-          <a:ln>
-            <a:noFill/>
-          </a:ln>
-          <a:effectLst/>
-        </p:spPr>
-        <p:style>
-          <a:lnRef idx="1">
-            <a:schemeClr val="accent1"/>
-          </a:lnRef>
-          <a:fillRef idx="3">
-            <a:schemeClr val="accent1"/>
-          </a:fillRef>
-          <a:effectRef idx="2">
-            <a:schemeClr val="accent1"/>
-          </a:effectRef>
-          <a:fontRef idx="minor">
-            <a:schemeClr val="lt1"/>
-          </a:fontRef>
-        </p:style>
-        <p:txBody>
-          <a:bodyPr rtlCol="0" anchor="ctr"/>
-          <a:lstStyle/>
-          <a:p>
-            <a:pPr algn="ctr"/>
-          </a:p>
-        </p:txBody>
-      </p:sp>
-      <p:sp>
-        <p:nvSpPr>
-          <p:cNvPr id="41" name="TextBox 40"/>
-          <p:cNvSpPr txBox="1"/>
-          <p:nvPr/>
-        </p:nvSpPr>
-        <p:spPr>
-          <a:xfrm>
-            <a:off x="5455768" y="1033272"/>
-            <a:ext cx="1280160" cy="310896"/>
-          </a:xfrm>
-          <a:prstGeom prst="rect">
-            <a:avLst/>
-          </a:prstGeom>
-          <a:noFill/>
-        </p:spPr>
-        <p:txBody>
-          <a:bodyPr wrap="square" anchor="ctr" lIns="36576" rIns="36576" tIns="0" bIns="0">
-            <a:spAutoFit/>
-          </a:bodyPr>
-          <a:lstStyle/>
-          <a:p>
-            <a:pPr algn="ctr" rtl="1"/>
-            <a:r>
-              <a:rPr sz="1200" b="1">
-                <a:solidFill>
-                  <a:srgbClr val="122755"/>
-                </a:solidFill>
-                <a:latin typeface="Heebo"/>
-                <a:cs typeface="Heebo"/>
-              </a:rPr>
-              <a:t>המלצה</a:t>
-            </a:r>
-          </a:p>
-        </p:txBody>
-      </p:sp>
-      <p:sp>
-        <p:nvSpPr>
-          <p:cNvPr id="42" name="TextBox 41"/>
-          <p:cNvSpPr txBox="1"/>
-          <p:nvPr/>
-        </p:nvSpPr>
-        <p:spPr>
-          <a:xfrm>
-            <a:off x="4277259" y="2148840"/>
-            <a:ext cx="3637178" cy="640080"/>
-          </a:xfrm>
-          <a:prstGeom prst="rect">
-            <a:avLst/>
-          </a:prstGeom>
-          <a:noFill/>
-        </p:spPr>
-        <p:txBody>
-          <a:bodyPr wrap="square" anchor="ctr" lIns="36576" rIns="36576" tIns="0" bIns="0">
-            <a:spAutoFit/>
-          </a:bodyPr>
-          <a:lstStyle/>
-          <a:p>
-            <a:pPr algn="ctr" rtl="1"/>
-            <a:r>
-              <a:rPr sz="3600" b="1">
-                <a:solidFill>
-                  <a:srgbClr val="1C3C7A"/>
-                </a:solidFill>
-                <a:latin typeface="Heebo"/>
-                <a:cs typeface="Heebo"/>
-              </a:rPr>
-              <a:t>23,050 ₪</a:t>
-            </a:r>
-          </a:p>
-        </p:txBody>
-      </p:sp>
-      <p:sp>
-        <p:nvSpPr>
-          <p:cNvPr id="43" name="TextBox 42"/>
-          <p:cNvSpPr txBox="1"/>
-          <p:nvPr/>
-        </p:nvSpPr>
-        <p:spPr>
-          <a:xfrm>
-            <a:off x="4277259" y="2743200"/>
-            <a:ext cx="3637178" cy="274320"/>
-          </a:xfrm>
-          <a:prstGeom prst="rect">
-            <a:avLst/>
-          </a:prstGeom>
-          <a:noFill/>
-        </p:spPr>
-        <p:txBody>
-          <a:bodyPr wrap="square" anchor="ctr" lIns="36576" rIns="36576" tIns="0" bIns="0">
-            <a:spAutoFit/>
-          </a:bodyPr>
-          <a:lstStyle/>
-          <a:p>
-            <a:pPr algn="ctr" rtl="1"/>
-            <a:r>
-              <a:rPr sz="1200" b="0">
-                <a:solidFill>
-                  <a:srgbClr val="8A94A8"/>
-                </a:solidFill>
-                <a:latin typeface="Heebo"/>
-                <a:cs typeface="Heebo"/>
-              </a:rPr>
-              <a:t>לחודש · 276,600 ₪ בשנה</a:t>
-            </a:r>
-          </a:p>
-        </p:txBody>
-      </p:sp>
-      <p:sp>
-        <p:nvSpPr>
-          <p:cNvPr id="44" name="Rounded Rectangle 43"/>
-          <p:cNvSpPr/>
-          <p:nvPr/>
-        </p:nvSpPr>
-        <p:spPr>
-          <a:xfrm>
-            <a:off x="6141568" y="3108960"/>
-            <a:ext cx="1589989" cy="658368"/>
-          </a:xfrm>
-          <a:prstGeom prst="roundRect">
-            <a:avLst>
-              <a:gd name="adj" fmla="val 15000"/>
-            </a:avLst>
-          </a:prstGeom>
-          <a:solidFill>
-            <a:srgbClr val="F4F6FB"/>
-          </a:solidFill>
-          <a:ln>
-            <a:noFill/>
-          </a:ln>
-          <a:effectLst/>
-        </p:spPr>
-        <p:style>
-          <a:lnRef idx="1">
-            <a:schemeClr val="accent1"/>
-          </a:lnRef>
-          <a:fillRef idx="3">
-            <a:schemeClr val="accent1"/>
-          </a:fillRef>
-          <a:effectRef idx="2">
-            <a:schemeClr val="accent1"/>
-          </a:effectRef>
-          <a:fontRef idx="minor">
-            <a:schemeClr val="lt1"/>
-          </a:fontRef>
-        </p:style>
-        <p:txBody>
-          <a:bodyPr rtlCol="0" anchor="ctr"/>
-          <a:lstStyle/>
-          <a:p>
-            <a:pPr algn="ctr"/>
-          </a:p>
-        </p:txBody>
-      </p:sp>
-      <p:sp>
-        <p:nvSpPr>
-          <p:cNvPr id="45" name="TextBox 44"/>
-          <p:cNvSpPr txBox="1"/>
-          <p:nvPr/>
-        </p:nvSpPr>
-        <p:spPr>
-          <a:xfrm>
-            <a:off x="6141568" y="3136392"/>
-            <a:ext cx="1589989" cy="347472"/>
-          </a:xfrm>
-          <a:prstGeom prst="rect">
-            <a:avLst/>
-          </a:prstGeom>
-          <a:noFill/>
-        </p:spPr>
-        <p:txBody>
-          <a:bodyPr wrap="square" anchor="ctr" lIns="36576" rIns="36576" tIns="0" bIns="0">
-            <a:spAutoFit/>
-          </a:bodyPr>
-          <a:lstStyle/>
-          <a:p>
-            <a:pPr algn="ctr" rtl="1"/>
-            <a:r>
-              <a:rPr sz="1700" b="1">
-                <a:solidFill>
-                  <a:srgbClr val="1C3C7A"/>
-                </a:solidFill>
-                <a:latin typeface="Heebo"/>
-                <a:cs typeface="Heebo"/>
-              </a:rPr>
-              <a:t>16</a:t>
-            </a:r>
-          </a:p>
-        </p:txBody>
-      </p:sp>
-      <p:sp>
-        <p:nvSpPr>
-          <p:cNvPr id="46" name="TextBox 45"/>
-          <p:cNvSpPr txBox="1"/>
-          <p:nvPr/>
-        </p:nvSpPr>
-        <p:spPr>
-          <a:xfrm>
-            <a:off x="6141568" y="3474720"/>
-            <a:ext cx="1589989" cy="256032"/>
-          </a:xfrm>
-          <a:prstGeom prst="rect">
-            <a:avLst/>
-          </a:prstGeom>
-          <a:noFill/>
-        </p:spPr>
-        <p:txBody>
-          <a:bodyPr wrap="square" anchor="ctr" lIns="36576" rIns="36576" tIns="0" bIns="0">
-            <a:spAutoFit/>
-          </a:bodyPr>
-          <a:lstStyle/>
-          <a:p>
-            <a:pPr algn="ctr" rtl="1"/>
-            <a:r>
-              <a:rPr sz="1000" b="0">
-                <a:solidFill>
-                  <a:srgbClr val="8A94A8"/>
-                </a:solidFill>
-                <a:latin typeface="Heebo"/>
-                <a:cs typeface="Heebo"/>
-              </a:rPr>
-              <a:t>דיונים בחודש</a:t>
-            </a:r>
-          </a:p>
-        </p:txBody>
-      </p:sp>
-      <p:sp>
-        <p:nvSpPr>
-          <p:cNvPr id="47" name="Rounded Rectangle 46"/>
-          <p:cNvSpPr/>
-          <p:nvPr/>
-        </p:nvSpPr>
-        <p:spPr>
-          <a:xfrm>
-            <a:off x="4460139" y="3108960"/>
-            <a:ext cx="1589989" cy="658368"/>
-          </a:xfrm>
-          <a:prstGeom prst="roundRect">
-            <a:avLst>
-              <a:gd name="adj" fmla="val 15000"/>
-            </a:avLst>
-          </a:prstGeom>
-          <a:solidFill>
-            <a:srgbClr val="F4F6FB"/>
-          </a:solidFill>
-          <a:ln>
-            <a:noFill/>
-          </a:ln>
-          <a:effectLst/>
-        </p:spPr>
-        <p:style>
-          <a:lnRef idx="1">
-            <a:schemeClr val="accent1"/>
-          </a:lnRef>
-          <a:fillRef idx="3">
-            <a:schemeClr val="accent1"/>
-          </a:fillRef>
-          <a:effectRef idx="2">
-            <a:schemeClr val="accent1"/>
-          </a:effectRef>
-          <a:fontRef idx="minor">
-            <a:schemeClr val="lt1"/>
-          </a:fontRef>
-        </p:style>
-        <p:txBody>
-          <a:bodyPr rtlCol="0" anchor="ctr"/>
-          <a:lstStyle/>
-          <a:p>
-            <a:pPr algn="ctr"/>
-          </a:p>
-        </p:txBody>
-      </p:sp>
-      <p:sp>
-        <p:nvSpPr>
-          <p:cNvPr id="48" name="TextBox 47"/>
-          <p:cNvSpPr txBox="1"/>
-          <p:nvPr/>
-        </p:nvSpPr>
-        <p:spPr>
-          <a:xfrm>
-            <a:off x="4460139" y="3136392"/>
-            <a:ext cx="1589989" cy="347472"/>
-          </a:xfrm>
-          <a:prstGeom prst="rect">
-            <a:avLst/>
-          </a:prstGeom>
-          <a:noFill/>
-        </p:spPr>
-        <p:txBody>
-          <a:bodyPr wrap="square" anchor="ctr" lIns="36576" rIns="36576" tIns="0" bIns="0">
-            <a:spAutoFit/>
-          </a:bodyPr>
-          <a:lstStyle/>
-          <a:p>
-            <a:pPr algn="ctr" rtl="1"/>
-            <a:r>
-              <a:rPr sz="1700" b="1">
-                <a:solidFill>
-                  <a:srgbClr val="1C3C7A"/>
-                </a:solidFill>
-                <a:latin typeface="Heebo"/>
-                <a:cs typeface="Heebo"/>
-              </a:rPr>
-              <a:t>1,440 ₪</a:t>
-            </a:r>
-          </a:p>
-        </p:txBody>
-      </p:sp>
-      <p:sp>
-        <p:nvSpPr>
-          <p:cNvPr id="49" name="TextBox 48"/>
-          <p:cNvSpPr txBox="1"/>
-          <p:nvPr/>
-        </p:nvSpPr>
-        <p:spPr>
-          <a:xfrm>
-            <a:off x="4460139" y="3474720"/>
-            <a:ext cx="1589989" cy="256032"/>
-          </a:xfrm>
-          <a:prstGeom prst="rect">
-            <a:avLst/>
-          </a:prstGeom>
-          <a:noFill/>
-        </p:spPr>
-        <p:txBody>
-          <a:bodyPr wrap="square" anchor="ctr" lIns="36576" rIns="36576" tIns="0" bIns="0">
-            <a:spAutoFit/>
-          </a:bodyPr>
-          <a:lstStyle/>
-          <a:p>
-            <a:pPr algn="ctr" rtl="1"/>
-            <a:r>
-              <a:rPr sz="1000" b="0">
-                <a:solidFill>
-                  <a:srgbClr val="8A94A8"/>
-                </a:solidFill>
-                <a:latin typeface="Heebo"/>
-                <a:cs typeface="Heebo"/>
-              </a:rPr>
-              <a:t>לדיון</a:t>
-            </a:r>
-          </a:p>
-        </p:txBody>
-      </p:sp>
-      <p:sp>
-        <p:nvSpPr>
-          <p:cNvPr id="50" name="TextBox 49"/>
-          <p:cNvSpPr txBox="1"/>
-          <p:nvPr/>
-        </p:nvSpPr>
-        <p:spPr>
-          <a:xfrm>
-            <a:off x="5511699" y="3931920"/>
-            <a:ext cx="2219858" cy="310896"/>
-          </a:xfrm>
-          <a:prstGeom prst="rect">
-            <a:avLst/>
-          </a:prstGeom>
-          <a:noFill/>
-        </p:spPr>
-        <p:txBody>
-          <a:bodyPr wrap="square" anchor="ctr" lIns="36576" rIns="36576" tIns="0" bIns="0">
-            <a:spAutoFit/>
-          </a:bodyPr>
-          <a:lstStyle/>
-          <a:p>
-            <a:pPr algn="r" rtl="1"/>
-            <a:r>
-              <a:rPr sz="1100" b="0">
-                <a:solidFill>
-                  <a:srgbClr val="1A2233"/>
-                </a:solidFill>
-                <a:latin typeface="Heebo"/>
-                <a:cs typeface="Heebo"/>
-              </a:rPr>
-              <a:t>מנכ״ל</a:t>
-            </a:r>
-          </a:p>
-        </p:txBody>
-      </p:sp>
-      <p:sp>
-        <p:nvSpPr>
-          <p:cNvPr id="51" name="TextBox 50"/>
-          <p:cNvSpPr txBox="1"/>
-          <p:nvPr/>
-        </p:nvSpPr>
-        <p:spPr>
-          <a:xfrm>
-            <a:off x="4414419" y="3931920"/>
-            <a:ext cx="1097280" cy="310896"/>
-          </a:xfrm>
-          <a:prstGeom prst="rect">
-            <a:avLst/>
-          </a:prstGeom>
-          <a:noFill/>
-        </p:spPr>
-        <p:txBody>
-          <a:bodyPr wrap="square" anchor="ctr" lIns="36576" rIns="36576" tIns="0" bIns="0">
-            <a:spAutoFit/>
-          </a:bodyPr>
-          <a:lstStyle/>
-          <a:p>
-            <a:pPr algn="l" rtl="1"/>
-            <a:r>
-              <a:rPr sz="1100" b="1">
-                <a:solidFill>
-                  <a:srgbClr val="1C3C7A"/>
-                </a:solidFill>
-                <a:latin typeface="Heebo"/>
-                <a:cs typeface="Heebo"/>
-              </a:rPr>
-              <a:t>12,000 ₪</a:t>
-            </a:r>
-          </a:p>
-        </p:txBody>
-      </p:sp>
-      <p:cxnSp>
-        <p:nvCxnSpPr>
-          <p:cNvPr id="52" name="Connector 51"/>
-          <p:cNvCxnSpPr/>
-          <p:nvPr/>
-        </p:nvCxnSpPr>
-        <p:spPr>
-          <a:xfrm>
-            <a:off x="4460139" y="4270248"/>
-            <a:ext cx="3271418" cy="0"/>
-          </a:xfrm>
-          <a:prstGeom prst="line">
-            <a:avLst/>
-          </a:prstGeom>
-          <a:ln w="9525">
-            <a:solidFill>
-              <a:srgbClr val="C5CDDD"/>
-            </a:solidFill>
-          </a:ln>
-        </p:spPr>
-        <p:style>
-          <a:lnRef idx="2">
-            <a:schemeClr val="accent1"/>
-          </a:lnRef>
-          <a:fillRef idx="0">
-            <a:schemeClr val="accent1"/>
-          </a:fillRef>
-          <a:effectRef idx="1">
-            <a:schemeClr val="accent1"/>
-          </a:effectRef>
-          <a:fontRef idx="minor">
-            <a:schemeClr val="tx1"/>
-          </a:fontRef>
-        </p:style>
-      </p:cxnSp>
-      <p:sp>
-        <p:nvSpPr>
-          <p:cNvPr id="53" name="TextBox 52"/>
-          <p:cNvSpPr txBox="1"/>
-          <p:nvPr/>
-        </p:nvSpPr>
-        <p:spPr>
-          <a:xfrm>
-            <a:off x="5511699" y="4297680"/>
-            <a:ext cx="2219858" cy="310896"/>
-          </a:xfrm>
-          <a:prstGeom prst="rect">
-            <a:avLst/>
-          </a:prstGeom>
-          <a:noFill/>
-        </p:spPr>
-        <p:txBody>
-          <a:bodyPr wrap="square" anchor="ctr" lIns="36576" rIns="36576" tIns="0" bIns="0">
-            <a:spAutoFit/>
-          </a:bodyPr>
-          <a:lstStyle/>
-          <a:p>
-            <a:pPr algn="r" rtl="1"/>
-            <a:r>
-              <a:rPr sz="1100" b="0">
-                <a:solidFill>
-                  <a:srgbClr val="1A2233"/>
-                </a:solidFill>
-                <a:latin typeface="Heebo"/>
-                <a:cs typeface="Heebo"/>
-              </a:rPr>
-              <a:t>עוזר מנכ״ל · חצי משרה</a:t>
-            </a:r>
-          </a:p>
-        </p:txBody>
-      </p:sp>
-      <p:sp>
-        <p:nvSpPr>
-          <p:cNvPr id="54" name="TextBox 53"/>
-          <p:cNvSpPr txBox="1"/>
-          <p:nvPr/>
-        </p:nvSpPr>
-        <p:spPr>
-          <a:xfrm>
-            <a:off x="4414419" y="4297680"/>
-            <a:ext cx="1097280" cy="310896"/>
-          </a:xfrm>
-          <a:prstGeom prst="rect">
-            <a:avLst/>
-          </a:prstGeom>
-          <a:noFill/>
-        </p:spPr>
-        <p:txBody>
-          <a:bodyPr wrap="square" anchor="ctr" lIns="36576" rIns="36576" tIns="0" bIns="0">
-            <a:spAutoFit/>
-          </a:bodyPr>
-          <a:lstStyle/>
-          <a:p>
-            <a:pPr algn="l" rtl="1"/>
-            <a:r>
-              <a:rPr sz="1100" b="1">
-                <a:solidFill>
-                  <a:srgbClr val="1C3C7A"/>
-                </a:solidFill>
-                <a:latin typeface="Heebo"/>
-                <a:cs typeface="Heebo"/>
-              </a:rPr>
-              <a:t>5,000 ₪</a:t>
-            </a:r>
-          </a:p>
-        </p:txBody>
-      </p:sp>
-      <p:cxnSp>
-        <p:nvCxnSpPr>
-          <p:cNvPr id="55" name="Connector 54"/>
-          <p:cNvCxnSpPr/>
-          <p:nvPr/>
-        </p:nvCxnSpPr>
-        <p:spPr>
-          <a:xfrm>
-            <a:off x="4460139" y="4636008"/>
-            <a:ext cx="3271418" cy="0"/>
-          </a:xfrm>
-          <a:prstGeom prst="line">
-            <a:avLst/>
-          </a:prstGeom>
-          <a:ln w="9525">
-            <a:solidFill>
-              <a:srgbClr val="C5CDDD"/>
-            </a:solidFill>
-          </a:ln>
-        </p:spPr>
-        <p:style>
-          <a:lnRef idx="2">
-            <a:schemeClr val="accent1"/>
-          </a:lnRef>
-          <a:fillRef idx="0">
-            <a:schemeClr val="accent1"/>
-          </a:fillRef>
-          <a:effectRef idx="1">
-            <a:schemeClr val="accent1"/>
-          </a:effectRef>
-          <a:fontRef idx="minor">
-            <a:schemeClr val="tx1"/>
-          </a:fontRef>
-        </p:style>
-      </p:cxnSp>
-      <p:sp>
-        <p:nvSpPr>
-          <p:cNvPr id="56" name="TextBox 55"/>
-          <p:cNvSpPr txBox="1"/>
-          <p:nvPr/>
-        </p:nvSpPr>
-        <p:spPr>
-          <a:xfrm>
-            <a:off x="5511699" y="4663440"/>
-            <a:ext cx="2219858" cy="310896"/>
-          </a:xfrm>
-          <a:prstGeom prst="rect">
-            <a:avLst/>
-          </a:prstGeom>
-          <a:noFill/>
-        </p:spPr>
-        <p:txBody>
-          <a:bodyPr wrap="square" anchor="ctr" lIns="36576" rIns="36576" tIns="0" bIns="0">
-            <a:spAutoFit/>
-          </a:bodyPr>
-          <a:lstStyle/>
-          <a:p>
-            <a:pPr algn="r" rtl="1"/>
-            <a:r>
-              <a:rPr sz="1100" b="0">
-                <a:solidFill>
-                  <a:srgbClr val="1A2233"/>
-                </a:solidFill>
-                <a:latin typeface="Heebo"/>
-                <a:cs typeface="Heebo"/>
-              </a:rPr>
-              <a:t>מנהל תוכן · חצי משרה</a:t>
-            </a:r>
-          </a:p>
-        </p:txBody>
-      </p:sp>
-      <p:sp>
-        <p:nvSpPr>
-          <p:cNvPr id="57" name="TextBox 56"/>
-          <p:cNvSpPr txBox="1"/>
-          <p:nvPr/>
-        </p:nvSpPr>
-        <p:spPr>
-          <a:xfrm>
-            <a:off x="4414419" y="4663440"/>
-            <a:ext cx="1097280" cy="310896"/>
-          </a:xfrm>
-          <a:prstGeom prst="rect">
-            <a:avLst/>
-          </a:prstGeom>
-          <a:noFill/>
-        </p:spPr>
-        <p:txBody>
-          <a:bodyPr wrap="square" anchor="ctr" lIns="36576" rIns="36576" tIns="0" bIns="0">
-            <a:spAutoFit/>
-          </a:bodyPr>
-          <a:lstStyle/>
-          <a:p>
-            <a:pPr algn="l" rtl="1"/>
-            <a:r>
-              <a:rPr sz="1100" b="1">
-                <a:solidFill>
-                  <a:srgbClr val="1C3C7A"/>
-                </a:solidFill>
-                <a:latin typeface="Heebo"/>
-                <a:cs typeface="Heebo"/>
-              </a:rPr>
-              <a:t>5,000 ₪</a:t>
-            </a:r>
-          </a:p>
-        </p:txBody>
-      </p:sp>
-      <p:cxnSp>
-        <p:nvCxnSpPr>
-          <p:cNvPr id="58" name="Connector 57"/>
-          <p:cNvCxnSpPr/>
-          <p:nvPr/>
-        </p:nvCxnSpPr>
-        <p:spPr>
-          <a:xfrm>
-            <a:off x="4460139" y="5001768"/>
-            <a:ext cx="3271418" cy="0"/>
-          </a:xfrm>
-          <a:prstGeom prst="line">
-            <a:avLst/>
-          </a:prstGeom>
-          <a:ln w="9525">
-            <a:solidFill>
-              <a:srgbClr val="C5CDDD"/>
-            </a:solidFill>
-          </a:ln>
-        </p:spPr>
-        <p:style>
-          <a:lnRef idx="2">
-            <a:schemeClr val="accent1"/>
-          </a:lnRef>
-          <a:fillRef idx="0">
-            <a:schemeClr val="accent1"/>
-          </a:fillRef>
-          <a:effectRef idx="1">
-            <a:schemeClr val="accent1"/>
-          </a:effectRef>
-          <a:fontRef idx="minor">
-            <a:schemeClr val="tx1"/>
-          </a:fontRef>
-        </p:style>
-      </p:cxnSp>
-      <p:sp>
-        <p:nvSpPr>
-          <p:cNvPr id="59" name="TextBox 58"/>
-          <p:cNvSpPr txBox="1"/>
-          <p:nvPr/>
-        </p:nvSpPr>
-        <p:spPr>
-          <a:xfrm>
-            <a:off x="5511699" y="5029200"/>
-            <a:ext cx="2219858" cy="310896"/>
-          </a:xfrm>
-          <a:prstGeom prst="rect">
-            <a:avLst/>
-          </a:prstGeom>
-          <a:noFill/>
-        </p:spPr>
-        <p:txBody>
-          <a:bodyPr wrap="square" anchor="ctr" lIns="36576" rIns="36576" tIns="0" bIns="0">
-            <a:spAutoFit/>
-          </a:bodyPr>
-          <a:lstStyle/>
-          <a:p>
-            <a:pPr algn="r" rtl="1"/>
-            <a:r>
-              <a:rPr sz="1100" b="0">
-                <a:solidFill>
-                  <a:srgbClr val="1A2233"/>
-                </a:solidFill>
-                <a:latin typeface="Heebo"/>
-                <a:cs typeface="Heebo"/>
-              </a:rPr>
-              <a:t>חברי דירקטוריון · 3 דיונים</a:t>
-            </a:r>
-          </a:p>
-        </p:txBody>
-      </p:sp>
-      <p:sp>
-        <p:nvSpPr>
-          <p:cNvPr id="60" name="TextBox 59"/>
-          <p:cNvSpPr txBox="1"/>
-          <p:nvPr/>
-        </p:nvSpPr>
-        <p:spPr>
-          <a:xfrm>
-            <a:off x="4414419" y="5029200"/>
-            <a:ext cx="1097280" cy="310896"/>
-          </a:xfrm>
-          <a:prstGeom prst="rect">
-            <a:avLst/>
-          </a:prstGeom>
-          <a:noFill/>
-        </p:spPr>
-        <p:txBody>
-          <a:bodyPr wrap="square" anchor="ctr" lIns="36576" rIns="36576" tIns="0" bIns="0">
-            <a:spAutoFit/>
-          </a:bodyPr>
-          <a:lstStyle/>
-          <a:p>
-            <a:pPr algn="l" rtl="1"/>
-            <a:r>
-              <a:rPr sz="1100" b="1">
-                <a:solidFill>
-                  <a:srgbClr val="1C3C7A"/>
-                </a:solidFill>
-                <a:latin typeface="Heebo"/>
-                <a:cs typeface="Heebo"/>
-              </a:rPr>
-              <a:t>1,050 ₪</a:t>
-            </a:r>
-          </a:p>
-        </p:txBody>
-      </p:sp>
-      <p:cxnSp>
-        <p:nvCxnSpPr>
-          <p:cNvPr id="61" name="Connector 60"/>
-          <p:cNvCxnSpPr/>
-          <p:nvPr/>
-        </p:nvCxnSpPr>
-        <p:spPr>
-          <a:xfrm>
-            <a:off x="4460139" y="5367528"/>
-            <a:ext cx="3271418" cy="0"/>
-          </a:xfrm>
-          <a:prstGeom prst="line">
-            <a:avLst/>
-          </a:prstGeom>
-          <a:ln w="9525">
-            <a:solidFill>
-              <a:srgbClr val="C5CDDD"/>
-            </a:solidFill>
-          </a:ln>
-        </p:spPr>
-        <p:style>
-          <a:lnRef idx="2">
-            <a:schemeClr val="accent1"/>
-          </a:lnRef>
-          <a:fillRef idx="0">
-            <a:schemeClr val="accent1"/>
-          </a:fillRef>
-          <a:effectRef idx="1">
-            <a:schemeClr val="accent1"/>
-          </a:effectRef>
-          <a:fontRef idx="minor">
-            <a:schemeClr val="tx1"/>
-          </a:fontRef>
-        </p:style>
-      </p:cxnSp>
-      <p:sp>
-        <p:nvSpPr>
-          <p:cNvPr id="62" name="TextBox 61"/>
-          <p:cNvSpPr txBox="1"/>
-          <p:nvPr/>
-        </p:nvSpPr>
-        <p:spPr>
-          <a:xfrm>
-            <a:off x="5511699" y="5394960"/>
-            <a:ext cx="2219858" cy="310896"/>
-          </a:xfrm>
-          <a:prstGeom prst="rect">
-            <a:avLst/>
-          </a:prstGeom>
-          <a:noFill/>
-        </p:spPr>
-        <p:txBody>
-          <a:bodyPr wrap="square" anchor="ctr" lIns="36576" rIns="36576" tIns="0" bIns="0">
-            <a:spAutoFit/>
-          </a:bodyPr>
-          <a:lstStyle/>
-          <a:p>
-            <a:pPr algn="r" rtl="1"/>
-            <a:r>
-              <a:rPr sz="1100" b="0">
-                <a:solidFill>
-                  <a:srgbClr val="1A2233"/>
-                </a:solidFill>
-                <a:latin typeface="Heebo"/>
-                <a:cs typeface="Heebo"/>
-              </a:rPr>
-              <a:t>אקטיביסטים · 3 דיונים</a:t>
-            </a:r>
-          </a:p>
-        </p:txBody>
-      </p:sp>
-      <p:sp>
-        <p:nvSpPr>
-          <p:cNvPr id="63" name="TextBox 62"/>
-          <p:cNvSpPr txBox="1"/>
-          <p:nvPr/>
-        </p:nvSpPr>
-        <p:spPr>
-          <a:xfrm>
-            <a:off x="4414419" y="5394960"/>
-            <a:ext cx="1097280" cy="310896"/>
-          </a:xfrm>
-          <a:prstGeom prst="rect">
-            <a:avLst/>
-          </a:prstGeom>
-          <a:noFill/>
-        </p:spPr>
-        <p:txBody>
-          <a:bodyPr wrap="square" anchor="ctr" lIns="36576" rIns="36576" tIns="0" bIns="0">
-            <a:spAutoFit/>
-          </a:bodyPr>
-          <a:lstStyle/>
-          <a:p>
-            <a:pPr algn="l" rtl="1"/>
-            <a:r>
-              <a:rPr sz="1100" b="0">
-                <a:solidFill>
-                  <a:srgbClr val="8A94A8"/>
-                </a:solidFill>
-                <a:latin typeface="Heebo"/>
-                <a:cs typeface="Heebo"/>
-              </a:rPr>
-              <a:t>בהתנדבות</a:t>
-            </a:r>
-          </a:p>
-        </p:txBody>
-      </p:sp>
-      <p:cxnSp>
-        <p:nvCxnSpPr>
-          <p:cNvPr id="64" name="Connector 63"/>
-          <p:cNvCxnSpPr/>
-          <p:nvPr/>
-        </p:nvCxnSpPr>
-        <p:spPr>
-          <a:xfrm>
-            <a:off x="4460139" y="5733288"/>
-            <a:ext cx="3271418" cy="0"/>
-          </a:xfrm>
-          <a:prstGeom prst="line">
-            <a:avLst/>
-          </a:prstGeom>
-          <a:ln w="9525">
-            <a:solidFill>
-              <a:srgbClr val="C5CDDD"/>
-            </a:solidFill>
-          </a:ln>
-        </p:spPr>
-        <p:style>
-          <a:lnRef idx="2">
-            <a:schemeClr val="accent1"/>
-          </a:lnRef>
-          <a:fillRef idx="0">
-            <a:schemeClr val="accent1"/>
-          </a:fillRef>
-          <a:effectRef idx="1">
-            <a:schemeClr val="accent1"/>
-          </a:effectRef>
-          <a:fontRef idx="minor">
-            <a:schemeClr val="tx1"/>
-          </a:fontRef>
-        </p:style>
-      </p:cxnSp>
-      <p:sp>
-        <p:nvSpPr>
-          <p:cNvPr id="65" name="TextBox 64"/>
-          <p:cNvSpPr txBox="1"/>
-          <p:nvPr/>
-        </p:nvSpPr>
-        <p:spPr>
-          <a:xfrm>
-            <a:off x="4460139" y="5806440"/>
-            <a:ext cx="3271418" cy="256032"/>
-          </a:xfrm>
-          <a:prstGeom prst="rect">
-            <a:avLst/>
-          </a:prstGeom>
-          <a:noFill/>
-        </p:spPr>
-        <p:txBody>
-          <a:bodyPr wrap="square" anchor="ctr" lIns="36576" rIns="36576" tIns="0" bIns="0">
-            <a:spAutoFit/>
-          </a:bodyPr>
-          <a:lstStyle/>
-          <a:p>
-            <a:pPr algn="r" rtl="1"/>
-            <a:r>
-              <a:rPr sz="1000" b="0">
-                <a:solidFill>
-                  <a:srgbClr val="8A94A8"/>
-                </a:solidFill>
-                <a:latin typeface="Heebo"/>
-                <a:cs typeface="Heebo"/>
-              </a:rPr>
-              <a:t>תעריף: 300 ₪ חצי יום · 450 ₪ יום מלא</a:t>
-            </a:r>
-          </a:p>
-        </p:txBody>
-      </p:sp>
-      <p:sp>
-        <p:nvSpPr>
-          <p:cNvPr id="66" name="TextBox 65"/>
-          <p:cNvSpPr txBox="1"/>
-          <p:nvPr/>
-        </p:nvSpPr>
-        <p:spPr>
-          <a:xfrm>
-            <a:off x="4460139" y="6080760"/>
-            <a:ext cx="3271418" cy="274320"/>
-          </a:xfrm>
-          <a:prstGeom prst="rect">
-            <a:avLst/>
-          </a:prstGeom>
-          <a:noFill/>
-        </p:spPr>
-        <p:txBody>
-          <a:bodyPr wrap="square" anchor="ctr" lIns="36576" rIns="36576" tIns="0" bIns="0">
-            <a:spAutoFit/>
-          </a:bodyPr>
-          <a:lstStyle/>
-          <a:p>
-            <a:pPr algn="r" rtl="1"/>
-            <a:r>
-              <a:rPr sz="1100" b="1">
-                <a:solidFill>
-                  <a:srgbClr val="1C3C7A"/>
-                </a:solidFill>
-                <a:latin typeface="Heebo"/>
-                <a:cs typeface="Heebo"/>
-              </a:rPr>
-              <a:t>מימון: כ-5 שותפים מייסדים</a:t>
-            </a:r>
-          </a:p>
-        </p:txBody>
-      </p:sp>
-      <p:sp>
-        <p:nvSpPr>
-          <p:cNvPr id="67" name="Rounded Rectangle 66"/>
-          <p:cNvSpPr/>
-          <p:nvPr/>
-        </p:nvSpPr>
-        <p:spPr>
-          <a:xfrm>
-            <a:off x="411481" y="1188720"/>
             <a:ext cx="3637178" cy="5120640"/>
           </a:xfrm>
           <a:prstGeom prst="roundRect">
@@ -15710,13 +14511,13 @@
       </p:sp>
       <p:sp>
         <p:nvSpPr>
-          <p:cNvPr id="68" name="Rounded Rectangle 67"/>
+          <p:cNvPr id="36" name="Rounded Rectangle 35"/>
           <p:cNvSpPr/>
           <p:nvPr/>
         </p:nvSpPr>
         <p:spPr>
           <a:xfrm>
-            <a:off x="411481" y="1188720"/>
+            <a:off x="4277259" y="1188720"/>
             <a:ext cx="3637178" cy="868680"/>
           </a:xfrm>
           <a:prstGeom prst="roundRect">
@@ -15756,13 +14557,13 @@
       </p:sp>
       <p:sp>
         <p:nvSpPr>
-          <p:cNvPr id="69" name="TextBox 68"/>
-          <p:cNvSpPr txBox="1"/>
-          <p:nvPr/>
-        </p:nvSpPr>
-        <p:spPr>
-          <a:xfrm>
-            <a:off x="411481" y="1280160"/>
+          <p:cNvPr id="37" name="TextBox 36"/>
+          <p:cNvSpPr txBox="1"/>
+          <p:nvPr/>
+        </p:nvSpPr>
+        <p:spPr>
+          <a:xfrm>
+            <a:off x="4277259" y="1280160"/>
             <a:ext cx="3637178" cy="384048"/>
           </a:xfrm>
           <a:prstGeom prst="rect">
@@ -15785,20 +14586,20 @@
                 <a:latin typeface="Heebo"/>
                 <a:cs typeface="Heebo"/>
               </a:rPr>
-              <a:t>מודל רזה</a:t>
-            </a:r>
-          </a:p>
-        </p:txBody>
-      </p:sp>
-      <p:sp>
-        <p:nvSpPr>
-          <p:cNvPr id="70" name="TextBox 69"/>
-          <p:cNvSpPr txBox="1"/>
-          <p:nvPr/>
-        </p:nvSpPr>
-        <p:spPr>
-          <a:xfrm>
-            <a:off x="502921" y="1664208"/>
+              <a:t>מודל ביניים</a:t>
+            </a:r>
+          </a:p>
+        </p:txBody>
+      </p:sp>
+      <p:sp>
+        <p:nvSpPr>
+          <p:cNvPr id="38" name="TextBox 37"/>
+          <p:cNvSpPr txBox="1"/>
+          <p:nvPr/>
+        </p:nvSpPr>
+        <p:spPr>
+          <a:xfrm>
+            <a:off x="4368699" y="1664208"/>
             <a:ext cx="3454298" cy="329184"/>
           </a:xfrm>
           <a:prstGeom prst="rect">
@@ -15821,20 +14622,20 @@
                 <a:latin typeface="Heebo"/>
                 <a:cs typeface="Heebo"/>
               </a:rPr>
-              <a:t>מינימום דיונים · איש תוכן משותף עם 'על המשמעות'</a:t>
-            </a:r>
-          </a:p>
-        </p:txBody>
-      </p:sp>
-      <p:sp>
-        <p:nvSpPr>
-          <p:cNvPr id="71" name="TextBox 70"/>
-          <p:cNvSpPr txBox="1"/>
-          <p:nvPr/>
-        </p:nvSpPr>
-        <p:spPr>
-          <a:xfrm>
-            <a:off x="411481" y="2148840"/>
+              <a:t>בלי נציג 4 · דירקטוריון ואקטיביסטים משלימים</a:t>
+            </a:r>
+          </a:p>
+        </p:txBody>
+      </p:sp>
+      <p:sp>
+        <p:nvSpPr>
+          <p:cNvPr id="39" name="TextBox 38"/>
+          <p:cNvSpPr txBox="1"/>
+          <p:nvPr/>
+        </p:nvSpPr>
+        <p:spPr>
+          <a:xfrm>
+            <a:off x="4277259" y="2148840"/>
             <a:ext cx="3637178" cy="640080"/>
           </a:xfrm>
           <a:prstGeom prst="rect">
@@ -15857,20 +14658,20 @@
                 <a:latin typeface="Heebo"/>
                 <a:cs typeface="Heebo"/>
               </a:rPr>
-              <a:t>18,250 ₪</a:t>
-            </a:r>
-          </a:p>
-        </p:txBody>
-      </p:sp>
-      <p:sp>
-        <p:nvSpPr>
-          <p:cNvPr id="72" name="TextBox 71"/>
-          <p:cNvSpPr txBox="1"/>
-          <p:nvPr/>
-        </p:nvSpPr>
-        <p:spPr>
-          <a:xfrm>
-            <a:off x="411481" y="2743200"/>
+              <a:t>23,050 ₪</a:t>
+            </a:r>
+          </a:p>
+        </p:txBody>
+      </p:sp>
+      <p:sp>
+        <p:nvSpPr>
+          <p:cNvPr id="40" name="TextBox 39"/>
+          <p:cNvSpPr txBox="1"/>
+          <p:nvPr/>
+        </p:nvSpPr>
+        <p:spPr>
+          <a:xfrm>
+            <a:off x="4277259" y="2743200"/>
             <a:ext cx="3637178" cy="274320"/>
           </a:xfrm>
           <a:prstGeom prst="rect">
@@ -15893,20 +14694,20 @@
                 <a:latin typeface="Heebo"/>
                 <a:cs typeface="Heebo"/>
               </a:rPr>
-              <a:t>לחודש · 219,000 ₪ בשנה</a:t>
-            </a:r>
-          </a:p>
-        </p:txBody>
-      </p:sp>
-      <p:sp>
-        <p:nvSpPr>
-          <p:cNvPr id="73" name="Rounded Rectangle 72"/>
+              <a:t>לחודש · 276,600 ₪ בשנה</a:t>
+            </a:r>
+          </a:p>
+        </p:txBody>
+      </p:sp>
+      <p:sp>
+        <p:nvSpPr>
+          <p:cNvPr id="41" name="Rounded Rectangle 40"/>
           <p:cNvSpPr/>
           <p:nvPr/>
         </p:nvSpPr>
         <p:spPr>
           <a:xfrm>
-            <a:off x="2275790" y="3108960"/>
+            <a:off x="6141568" y="3108960"/>
             <a:ext cx="1589989" cy="658368"/>
           </a:xfrm>
           <a:prstGeom prst="roundRect">
@@ -15946,13 +14747,13 @@
       </p:sp>
       <p:sp>
         <p:nvSpPr>
-          <p:cNvPr id="74" name="TextBox 73"/>
-          <p:cNvSpPr txBox="1"/>
-          <p:nvPr/>
-        </p:nvSpPr>
-        <p:spPr>
-          <a:xfrm>
-            <a:off x="2275790" y="3136392"/>
+          <p:cNvPr id="42" name="TextBox 41"/>
+          <p:cNvSpPr txBox="1"/>
+          <p:nvPr/>
+        </p:nvSpPr>
+        <p:spPr>
+          <a:xfrm>
+            <a:off x="6141568" y="3136392"/>
             <a:ext cx="1589989" cy="347472"/>
           </a:xfrm>
           <a:prstGeom prst="rect">
@@ -15975,20 +14776,20 @@
                 <a:latin typeface="Heebo"/>
                 <a:cs typeface="Heebo"/>
               </a:rPr>
-              <a:t>13</a:t>
-            </a:r>
-          </a:p>
-        </p:txBody>
-      </p:sp>
-      <p:sp>
-        <p:nvSpPr>
-          <p:cNvPr id="75" name="TextBox 74"/>
-          <p:cNvSpPr txBox="1"/>
-          <p:nvPr/>
-        </p:nvSpPr>
-        <p:spPr>
-          <a:xfrm>
-            <a:off x="2275790" y="3474720"/>
+              <a:t>16</a:t>
+            </a:r>
+          </a:p>
+        </p:txBody>
+      </p:sp>
+      <p:sp>
+        <p:nvSpPr>
+          <p:cNvPr id="43" name="TextBox 42"/>
+          <p:cNvSpPr txBox="1"/>
+          <p:nvPr/>
+        </p:nvSpPr>
+        <p:spPr>
+          <a:xfrm>
+            <a:off x="6141568" y="3474720"/>
             <a:ext cx="1589989" cy="256032"/>
           </a:xfrm>
           <a:prstGeom prst="rect">
@@ -16018,13 +14819,13 @@
       </p:sp>
       <p:sp>
         <p:nvSpPr>
-          <p:cNvPr id="76" name="Rounded Rectangle 75"/>
+          <p:cNvPr id="44" name="Rounded Rectangle 43"/>
           <p:cNvSpPr/>
           <p:nvPr/>
         </p:nvSpPr>
         <p:spPr>
           <a:xfrm>
-            <a:off x="594361" y="3108960"/>
+            <a:off x="4460139" y="3108960"/>
             <a:ext cx="1589989" cy="658368"/>
           </a:xfrm>
           <a:prstGeom prst="roundRect">
@@ -16064,13 +14865,13 @@
       </p:sp>
       <p:sp>
         <p:nvSpPr>
-          <p:cNvPr id="77" name="TextBox 76"/>
-          <p:cNvSpPr txBox="1"/>
-          <p:nvPr/>
-        </p:nvSpPr>
-        <p:spPr>
-          <a:xfrm>
-            <a:off x="594361" y="3136392"/>
+          <p:cNvPr id="45" name="TextBox 44"/>
+          <p:cNvSpPr txBox="1"/>
+          <p:nvPr/>
+        </p:nvSpPr>
+        <p:spPr>
+          <a:xfrm>
+            <a:off x="4460139" y="3136392"/>
             <a:ext cx="1589989" cy="347472"/>
           </a:xfrm>
           <a:prstGeom prst="rect">
@@ -16093,20 +14894,20 @@
                 <a:latin typeface="Heebo"/>
                 <a:cs typeface="Heebo"/>
               </a:rPr>
-              <a:t>1,400 ₪</a:t>
-            </a:r>
-          </a:p>
-        </p:txBody>
-      </p:sp>
-      <p:sp>
-        <p:nvSpPr>
-          <p:cNvPr id="78" name="TextBox 77"/>
-          <p:cNvSpPr txBox="1"/>
-          <p:nvPr/>
-        </p:nvSpPr>
-        <p:spPr>
-          <a:xfrm>
-            <a:off x="594361" y="3474720"/>
+              <a:t>1,440 ₪</a:t>
+            </a:r>
+          </a:p>
+        </p:txBody>
+      </p:sp>
+      <p:sp>
+        <p:nvSpPr>
+          <p:cNvPr id="46" name="TextBox 45"/>
+          <p:cNvSpPr txBox="1"/>
+          <p:nvPr/>
+        </p:nvSpPr>
+        <p:spPr>
+          <a:xfrm>
+            <a:off x="4460139" y="3474720"/>
             <a:ext cx="1589989" cy="256032"/>
           </a:xfrm>
           <a:prstGeom prst="rect">
@@ -16136,13 +14937,13 @@
       </p:sp>
       <p:sp>
         <p:nvSpPr>
-          <p:cNvPr id="79" name="TextBox 78"/>
-          <p:cNvSpPr txBox="1"/>
-          <p:nvPr/>
-        </p:nvSpPr>
-        <p:spPr>
-          <a:xfrm>
-            <a:off x="1645921" y="3931920"/>
+          <p:cNvPr id="47" name="TextBox 46"/>
+          <p:cNvSpPr txBox="1"/>
+          <p:nvPr/>
+        </p:nvSpPr>
+        <p:spPr>
+          <a:xfrm>
+            <a:off x="5511699" y="3931920"/>
             <a:ext cx="2219858" cy="310896"/>
           </a:xfrm>
           <a:prstGeom prst="rect">
@@ -16172,13 +14973,13 @@
       </p:sp>
       <p:sp>
         <p:nvSpPr>
-          <p:cNvPr id="80" name="TextBox 79"/>
-          <p:cNvSpPr txBox="1"/>
-          <p:nvPr/>
-        </p:nvSpPr>
-        <p:spPr>
-          <a:xfrm>
-            <a:off x="548641" y="3931920"/>
+          <p:cNvPr id="48" name="TextBox 47"/>
+          <p:cNvSpPr txBox="1"/>
+          <p:nvPr/>
+        </p:nvSpPr>
+        <p:spPr>
+          <a:xfrm>
+            <a:off x="4414419" y="3931920"/>
             <a:ext cx="1097280" cy="310896"/>
           </a:xfrm>
           <a:prstGeom prst="rect">
@@ -16201,20 +15002,20 @@
                 <a:latin typeface="Heebo"/>
                 <a:cs typeface="Heebo"/>
               </a:rPr>
-              <a:t>10,000 ₪</a:t>
+              <a:t>12,000 ₪</a:t>
             </a:r>
           </a:p>
         </p:txBody>
       </p:sp>
       <p:cxnSp>
         <p:nvCxnSpPr>
-          <p:cNvPr id="81" name="Connector 80"/>
+          <p:cNvPr id="49" name="Connector 48"/>
           <p:cNvCxnSpPr/>
           <p:nvPr/>
         </p:nvCxnSpPr>
         <p:spPr>
           <a:xfrm>
-            <a:off x="594361" y="4270248"/>
+            <a:off x="4460139" y="4270248"/>
             <a:ext cx="3271418" cy="0"/>
           </a:xfrm>
           <a:prstGeom prst="line">
@@ -16243,13 +15044,13 @@
       </p:cxnSp>
       <p:sp>
         <p:nvSpPr>
-          <p:cNvPr id="82" name="TextBox 81"/>
-          <p:cNvSpPr txBox="1"/>
-          <p:nvPr/>
-        </p:nvSpPr>
-        <p:spPr>
-          <a:xfrm>
-            <a:off x="1645921" y="4297680"/>
+          <p:cNvPr id="50" name="TextBox 49"/>
+          <p:cNvSpPr txBox="1"/>
+          <p:nvPr/>
+        </p:nvSpPr>
+        <p:spPr>
+          <a:xfrm>
+            <a:off x="5511699" y="4297680"/>
             <a:ext cx="2219858" cy="310896"/>
           </a:xfrm>
           <a:prstGeom prst="rect">
@@ -16279,13 +15080,13 @@
       </p:sp>
       <p:sp>
         <p:nvSpPr>
-          <p:cNvPr id="83" name="TextBox 82"/>
-          <p:cNvSpPr txBox="1"/>
-          <p:nvPr/>
-        </p:nvSpPr>
-        <p:spPr>
-          <a:xfrm>
-            <a:off x="548641" y="4297680"/>
+          <p:cNvPr id="51" name="TextBox 50"/>
+          <p:cNvSpPr txBox="1"/>
+          <p:nvPr/>
+        </p:nvSpPr>
+        <p:spPr>
+          <a:xfrm>
+            <a:off x="4414419" y="4297680"/>
             <a:ext cx="1097280" cy="310896"/>
           </a:xfrm>
           <a:prstGeom prst="rect">
@@ -16315,13 +15116,13 @@
       </p:sp>
       <p:cxnSp>
         <p:nvCxnSpPr>
-          <p:cNvPr id="84" name="Connector 83"/>
+          <p:cNvPr id="52" name="Connector 51"/>
           <p:cNvCxnSpPr/>
           <p:nvPr/>
         </p:nvCxnSpPr>
         <p:spPr>
           <a:xfrm>
-            <a:off x="594361" y="4636008"/>
+            <a:off x="4460139" y="4636008"/>
             <a:ext cx="3271418" cy="0"/>
           </a:xfrm>
           <a:prstGeom prst="line">
@@ -16350,13 +15151,13 @@
       </p:cxnSp>
       <p:sp>
         <p:nvSpPr>
-          <p:cNvPr id="85" name="TextBox 84"/>
-          <p:cNvSpPr txBox="1"/>
-          <p:nvPr/>
-        </p:nvSpPr>
-        <p:spPr>
-          <a:xfrm>
-            <a:off x="1645921" y="4663440"/>
+          <p:cNvPr id="53" name="TextBox 52"/>
+          <p:cNvSpPr txBox="1"/>
+          <p:nvPr/>
+        </p:nvSpPr>
+        <p:spPr>
+          <a:xfrm>
+            <a:off x="5511699" y="4663440"/>
             <a:ext cx="2219858" cy="310896"/>
           </a:xfrm>
           <a:prstGeom prst="rect">
@@ -16379,20 +15180,20 @@
                 <a:latin typeface="Heebo"/>
                 <a:cs typeface="Heebo"/>
               </a:rPr>
-              <a:t>מנהל תוכן · משותף</a:t>
-            </a:r>
-          </a:p>
-        </p:txBody>
-      </p:sp>
-      <p:sp>
-        <p:nvSpPr>
-          <p:cNvPr id="86" name="TextBox 85"/>
-          <p:cNvSpPr txBox="1"/>
-          <p:nvPr/>
-        </p:nvSpPr>
-        <p:spPr>
-          <a:xfrm>
-            <a:off x="548641" y="4663440"/>
+              <a:t>מנהל תוכן · חצי משרה</a:t>
+            </a:r>
+          </a:p>
+        </p:txBody>
+      </p:sp>
+      <p:sp>
+        <p:nvSpPr>
+          <p:cNvPr id="54" name="TextBox 53"/>
+          <p:cNvSpPr txBox="1"/>
+          <p:nvPr/>
+        </p:nvSpPr>
+        <p:spPr>
+          <a:xfrm>
+            <a:off x="4414419" y="4663440"/>
             <a:ext cx="1097280" cy="310896"/>
           </a:xfrm>
           <a:prstGeom prst="rect">
@@ -16415,20 +15216,20 @@
                 <a:latin typeface="Heebo"/>
                 <a:cs typeface="Heebo"/>
               </a:rPr>
-              <a:t>2,500 ₪</a:t>
+              <a:t>5,000 ₪</a:t>
             </a:r>
           </a:p>
         </p:txBody>
       </p:sp>
       <p:cxnSp>
         <p:nvCxnSpPr>
-          <p:cNvPr id="87" name="Connector 86"/>
+          <p:cNvPr id="55" name="Connector 54"/>
           <p:cNvCxnSpPr/>
           <p:nvPr/>
         </p:nvCxnSpPr>
         <p:spPr>
           <a:xfrm>
-            <a:off x="594361" y="5001768"/>
+            <a:off x="4460139" y="5001768"/>
             <a:ext cx="3271418" cy="0"/>
           </a:xfrm>
           <a:prstGeom prst="line">
@@ -16457,13 +15258,13 @@
       </p:cxnSp>
       <p:sp>
         <p:nvSpPr>
-          <p:cNvPr id="88" name="TextBox 87"/>
-          <p:cNvSpPr txBox="1"/>
-          <p:nvPr/>
-        </p:nvSpPr>
-        <p:spPr>
-          <a:xfrm>
-            <a:off x="1645921" y="5029200"/>
+          <p:cNvPr id="56" name="TextBox 55"/>
+          <p:cNvSpPr txBox="1"/>
+          <p:nvPr/>
+        </p:nvSpPr>
+        <p:spPr>
+          <a:xfrm>
+            <a:off x="5511699" y="5029200"/>
             <a:ext cx="2219858" cy="310896"/>
           </a:xfrm>
           <a:prstGeom prst="rect">
@@ -16486,20 +15287,20 @@
                 <a:latin typeface="Heebo"/>
                 <a:cs typeface="Heebo"/>
               </a:rPr>
-              <a:t>חברי דירקטוריון · 2 דיונים</a:t>
-            </a:r>
-          </a:p>
-        </p:txBody>
-      </p:sp>
-      <p:sp>
-        <p:nvSpPr>
-          <p:cNvPr id="89" name="TextBox 88"/>
-          <p:cNvSpPr txBox="1"/>
-          <p:nvPr/>
-        </p:nvSpPr>
-        <p:spPr>
-          <a:xfrm>
-            <a:off x="548641" y="5029200"/>
+              <a:t>חברי דירקטוריון · 3 דיונים</a:t>
+            </a:r>
+          </a:p>
+        </p:txBody>
+      </p:sp>
+      <p:sp>
+        <p:nvSpPr>
+          <p:cNvPr id="57" name="TextBox 56"/>
+          <p:cNvSpPr txBox="1"/>
+          <p:nvPr/>
+        </p:nvSpPr>
+        <p:spPr>
+          <a:xfrm>
+            <a:off x="4414419" y="5029200"/>
             <a:ext cx="1097280" cy="310896"/>
           </a:xfrm>
           <a:prstGeom prst="rect">
@@ -16522,20 +15323,20 @@
                 <a:latin typeface="Heebo"/>
                 <a:cs typeface="Heebo"/>
               </a:rPr>
-              <a:t>750 ₪</a:t>
+              <a:t>1,050 ₪</a:t>
             </a:r>
           </a:p>
         </p:txBody>
       </p:sp>
       <p:cxnSp>
         <p:nvCxnSpPr>
-          <p:cNvPr id="90" name="Connector 89"/>
+          <p:cNvPr id="58" name="Connector 57"/>
           <p:cNvCxnSpPr/>
           <p:nvPr/>
         </p:nvCxnSpPr>
         <p:spPr>
           <a:xfrm>
-            <a:off x="594361" y="5367528"/>
+            <a:off x="4460139" y="5367528"/>
             <a:ext cx="3271418" cy="0"/>
           </a:xfrm>
           <a:prstGeom prst="line">
@@ -16564,13 +15365,13 @@
       </p:cxnSp>
       <p:sp>
         <p:nvSpPr>
-          <p:cNvPr id="91" name="TextBox 90"/>
-          <p:cNvSpPr txBox="1"/>
-          <p:nvPr/>
-        </p:nvSpPr>
-        <p:spPr>
-          <a:xfrm>
-            <a:off x="1645921" y="5394960"/>
+          <p:cNvPr id="59" name="TextBox 58"/>
+          <p:cNvSpPr txBox="1"/>
+          <p:nvPr/>
+        </p:nvSpPr>
+        <p:spPr>
+          <a:xfrm>
+            <a:off x="5511699" y="5394960"/>
             <a:ext cx="2219858" cy="310896"/>
           </a:xfrm>
           <a:prstGeom prst="rect">
@@ -16593,20 +15394,20 @@
                 <a:latin typeface="Heebo"/>
                 <a:cs typeface="Heebo"/>
               </a:rPr>
-              <a:t>אקטיביסטים · 2 דיונים</a:t>
-            </a:r>
-          </a:p>
-        </p:txBody>
-      </p:sp>
-      <p:sp>
-        <p:nvSpPr>
-          <p:cNvPr id="92" name="TextBox 91"/>
-          <p:cNvSpPr txBox="1"/>
-          <p:nvPr/>
-        </p:nvSpPr>
-        <p:spPr>
-          <a:xfrm>
-            <a:off x="548641" y="5394960"/>
+              <a:t>אקטיביסטים · 3 דיונים</a:t>
+            </a:r>
+          </a:p>
+        </p:txBody>
+      </p:sp>
+      <p:sp>
+        <p:nvSpPr>
+          <p:cNvPr id="60" name="TextBox 59"/>
+          <p:cNvSpPr txBox="1"/>
+          <p:nvPr/>
+        </p:nvSpPr>
+        <p:spPr>
+          <a:xfrm>
+            <a:off x="4414419" y="5394960"/>
             <a:ext cx="1097280" cy="310896"/>
           </a:xfrm>
           <a:prstGeom prst="rect">
@@ -16636,13 +15437,13 @@
       </p:sp>
       <p:cxnSp>
         <p:nvCxnSpPr>
-          <p:cNvPr id="93" name="Connector 92"/>
+          <p:cNvPr id="61" name="Connector 60"/>
           <p:cNvCxnSpPr/>
           <p:nvPr/>
         </p:nvCxnSpPr>
         <p:spPr>
           <a:xfrm>
-            <a:off x="594361" y="5733288"/>
+            <a:off x="4460139" y="5733288"/>
             <a:ext cx="3271418" cy="0"/>
           </a:xfrm>
           <a:prstGeom prst="line">
@@ -16671,7 +15472,1052 @@
       </p:cxnSp>
       <p:sp>
         <p:nvSpPr>
-          <p:cNvPr id="94" name="TextBox 93"/>
+          <p:cNvPr id="62" name="TextBox 61"/>
+          <p:cNvSpPr txBox="1"/>
+          <p:nvPr/>
+        </p:nvSpPr>
+        <p:spPr>
+          <a:xfrm>
+            <a:off x="4460139" y="5806440"/>
+            <a:ext cx="3271418" cy="256032"/>
+          </a:xfrm>
+          <a:prstGeom prst="rect">
+            <a:avLst/>
+          </a:prstGeom>
+          <a:noFill/>
+        </p:spPr>
+        <p:txBody>
+          <a:bodyPr wrap="square" anchor="ctr" lIns="36576" rIns="36576" tIns="0" bIns="0">
+            <a:spAutoFit/>
+          </a:bodyPr>
+          <a:lstStyle/>
+          <a:p>
+            <a:pPr algn="r" rtl="1"/>
+            <a:r>
+              <a:rPr sz="1000" b="0">
+                <a:solidFill>
+                  <a:srgbClr val="8A94A8"/>
+                </a:solidFill>
+                <a:latin typeface="Heebo"/>
+                <a:cs typeface="Heebo"/>
+              </a:rPr>
+              <a:t>תעריף: 300 ₪ חצי יום · 450 ₪ יום מלא</a:t>
+            </a:r>
+          </a:p>
+        </p:txBody>
+      </p:sp>
+      <p:sp>
+        <p:nvSpPr>
+          <p:cNvPr id="63" name="Rounded Rectangle 62"/>
+          <p:cNvSpPr/>
+          <p:nvPr/>
+        </p:nvSpPr>
+        <p:spPr>
+          <a:xfrm>
+            <a:off x="411481" y="1188720"/>
+            <a:ext cx="3637178" cy="5120640"/>
+          </a:xfrm>
+          <a:prstGeom prst="roundRect">
+            <a:avLst>
+              <a:gd name="adj" fmla="val 5000"/>
+            </a:avLst>
+          </a:prstGeom>
+          <a:solidFill>
+            <a:srgbClr val="FFFFFF"/>
+          </a:solidFill>
+          <a:ln w="15875">
+            <a:solidFill>
+              <a:srgbClr val="C5CDDD"/>
+            </a:solidFill>
+          </a:ln>
+          <a:effectLst/>
+        </p:spPr>
+        <p:style>
+          <a:lnRef idx="1">
+            <a:schemeClr val="accent1"/>
+          </a:lnRef>
+          <a:fillRef idx="3">
+            <a:schemeClr val="accent1"/>
+          </a:fillRef>
+          <a:effectRef idx="2">
+            <a:schemeClr val="accent1"/>
+          </a:effectRef>
+          <a:fontRef idx="minor">
+            <a:schemeClr val="lt1"/>
+          </a:fontRef>
+        </p:style>
+        <p:txBody>
+          <a:bodyPr rtlCol="0" anchor="ctr"/>
+          <a:lstStyle/>
+          <a:p>
+            <a:pPr algn="ctr"/>
+          </a:p>
+        </p:txBody>
+      </p:sp>
+      <p:sp>
+        <p:nvSpPr>
+          <p:cNvPr id="64" name="Rounded Rectangle 63"/>
+          <p:cNvSpPr/>
+          <p:nvPr/>
+        </p:nvSpPr>
+        <p:spPr>
+          <a:xfrm>
+            <a:off x="411481" y="1188720"/>
+            <a:ext cx="3637178" cy="868680"/>
+          </a:xfrm>
+          <a:prstGeom prst="roundRect">
+            <a:avLst>
+              <a:gd name="adj" fmla="val 12000"/>
+            </a:avLst>
+          </a:prstGeom>
+          <a:solidFill>
+            <a:srgbClr val="4A5568"/>
+          </a:solidFill>
+          <a:ln>
+            <a:noFill/>
+          </a:ln>
+          <a:effectLst/>
+        </p:spPr>
+        <p:style>
+          <a:lnRef idx="1">
+            <a:schemeClr val="accent1"/>
+          </a:lnRef>
+          <a:fillRef idx="3">
+            <a:schemeClr val="accent1"/>
+          </a:fillRef>
+          <a:effectRef idx="2">
+            <a:schemeClr val="accent1"/>
+          </a:effectRef>
+          <a:fontRef idx="minor">
+            <a:schemeClr val="lt1"/>
+          </a:fontRef>
+        </p:style>
+        <p:txBody>
+          <a:bodyPr rtlCol="0" anchor="ctr"/>
+          <a:lstStyle/>
+          <a:p>
+            <a:pPr algn="ctr"/>
+          </a:p>
+        </p:txBody>
+      </p:sp>
+      <p:sp>
+        <p:nvSpPr>
+          <p:cNvPr id="65" name="TextBox 64"/>
+          <p:cNvSpPr txBox="1"/>
+          <p:nvPr/>
+        </p:nvSpPr>
+        <p:spPr>
+          <a:xfrm>
+            <a:off x="411481" y="1280160"/>
+            <a:ext cx="3637178" cy="384048"/>
+          </a:xfrm>
+          <a:prstGeom prst="rect">
+            <a:avLst/>
+          </a:prstGeom>
+          <a:noFill/>
+        </p:spPr>
+        <p:txBody>
+          <a:bodyPr wrap="square" anchor="ctr" lIns="36576" rIns="36576" tIns="0" bIns="0">
+            <a:spAutoFit/>
+          </a:bodyPr>
+          <a:lstStyle/>
+          <a:p>
+            <a:pPr algn="ctr" rtl="1"/>
+            <a:r>
+              <a:rPr sz="2000" b="1">
+                <a:solidFill>
+                  <a:srgbClr val="FFFFFF"/>
+                </a:solidFill>
+                <a:latin typeface="Heebo"/>
+                <a:cs typeface="Heebo"/>
+              </a:rPr>
+              <a:t>מודל רזה</a:t>
+            </a:r>
+          </a:p>
+        </p:txBody>
+      </p:sp>
+      <p:sp>
+        <p:nvSpPr>
+          <p:cNvPr id="66" name="TextBox 65"/>
+          <p:cNvSpPr txBox="1"/>
+          <p:nvPr/>
+        </p:nvSpPr>
+        <p:spPr>
+          <a:xfrm>
+            <a:off x="502921" y="1664208"/>
+            <a:ext cx="3454298" cy="329184"/>
+          </a:xfrm>
+          <a:prstGeom prst="rect">
+            <a:avLst/>
+          </a:prstGeom>
+          <a:noFill/>
+        </p:spPr>
+        <p:txBody>
+          <a:bodyPr wrap="square" anchor="ctr" lIns="36576" rIns="36576" tIns="0" bIns="0">
+            <a:spAutoFit/>
+          </a:bodyPr>
+          <a:lstStyle/>
+          <a:p>
+            <a:pPr algn="ctr" rtl="1"/>
+            <a:r>
+              <a:rPr sz="1000" b="0">
+                <a:solidFill>
+                  <a:srgbClr val="F0C000"/>
+                </a:solidFill>
+                <a:latin typeface="Heebo"/>
+                <a:cs typeface="Heebo"/>
+              </a:rPr>
+              <a:t>מינימום דיונים · איש תוכן משותף עם 'על המשמעות'</a:t>
+            </a:r>
+          </a:p>
+        </p:txBody>
+      </p:sp>
+      <p:sp>
+        <p:nvSpPr>
+          <p:cNvPr id="67" name="TextBox 66"/>
+          <p:cNvSpPr txBox="1"/>
+          <p:nvPr/>
+        </p:nvSpPr>
+        <p:spPr>
+          <a:xfrm>
+            <a:off x="411481" y="2148840"/>
+            <a:ext cx="3637178" cy="640080"/>
+          </a:xfrm>
+          <a:prstGeom prst="rect">
+            <a:avLst/>
+          </a:prstGeom>
+          <a:noFill/>
+        </p:spPr>
+        <p:txBody>
+          <a:bodyPr wrap="square" anchor="ctr" lIns="36576" rIns="36576" tIns="0" bIns="0">
+            <a:spAutoFit/>
+          </a:bodyPr>
+          <a:lstStyle/>
+          <a:p>
+            <a:pPr algn="ctr" rtl="1"/>
+            <a:r>
+              <a:rPr sz="3600" b="1">
+                <a:solidFill>
+                  <a:srgbClr val="1C3C7A"/>
+                </a:solidFill>
+                <a:latin typeface="Heebo"/>
+                <a:cs typeface="Heebo"/>
+              </a:rPr>
+              <a:t>18,250 ₪</a:t>
+            </a:r>
+          </a:p>
+        </p:txBody>
+      </p:sp>
+      <p:sp>
+        <p:nvSpPr>
+          <p:cNvPr id="68" name="TextBox 67"/>
+          <p:cNvSpPr txBox="1"/>
+          <p:nvPr/>
+        </p:nvSpPr>
+        <p:spPr>
+          <a:xfrm>
+            <a:off x="411481" y="2743200"/>
+            <a:ext cx="3637178" cy="274320"/>
+          </a:xfrm>
+          <a:prstGeom prst="rect">
+            <a:avLst/>
+          </a:prstGeom>
+          <a:noFill/>
+        </p:spPr>
+        <p:txBody>
+          <a:bodyPr wrap="square" anchor="ctr" lIns="36576" rIns="36576" tIns="0" bIns="0">
+            <a:spAutoFit/>
+          </a:bodyPr>
+          <a:lstStyle/>
+          <a:p>
+            <a:pPr algn="ctr" rtl="1"/>
+            <a:r>
+              <a:rPr sz="1200" b="0">
+                <a:solidFill>
+                  <a:srgbClr val="8A94A8"/>
+                </a:solidFill>
+                <a:latin typeface="Heebo"/>
+                <a:cs typeface="Heebo"/>
+              </a:rPr>
+              <a:t>לחודש · 219,000 ₪ בשנה</a:t>
+            </a:r>
+          </a:p>
+        </p:txBody>
+      </p:sp>
+      <p:sp>
+        <p:nvSpPr>
+          <p:cNvPr id="69" name="Rounded Rectangle 68"/>
+          <p:cNvSpPr/>
+          <p:nvPr/>
+        </p:nvSpPr>
+        <p:spPr>
+          <a:xfrm>
+            <a:off x="2275790" y="3108960"/>
+            <a:ext cx="1589989" cy="658368"/>
+          </a:xfrm>
+          <a:prstGeom prst="roundRect">
+            <a:avLst>
+              <a:gd name="adj" fmla="val 15000"/>
+            </a:avLst>
+          </a:prstGeom>
+          <a:solidFill>
+            <a:srgbClr val="F4F6FB"/>
+          </a:solidFill>
+          <a:ln>
+            <a:noFill/>
+          </a:ln>
+          <a:effectLst/>
+        </p:spPr>
+        <p:style>
+          <a:lnRef idx="1">
+            <a:schemeClr val="accent1"/>
+          </a:lnRef>
+          <a:fillRef idx="3">
+            <a:schemeClr val="accent1"/>
+          </a:fillRef>
+          <a:effectRef idx="2">
+            <a:schemeClr val="accent1"/>
+          </a:effectRef>
+          <a:fontRef idx="minor">
+            <a:schemeClr val="lt1"/>
+          </a:fontRef>
+        </p:style>
+        <p:txBody>
+          <a:bodyPr rtlCol="0" anchor="ctr"/>
+          <a:lstStyle/>
+          <a:p>
+            <a:pPr algn="ctr"/>
+          </a:p>
+        </p:txBody>
+      </p:sp>
+      <p:sp>
+        <p:nvSpPr>
+          <p:cNvPr id="70" name="TextBox 69"/>
+          <p:cNvSpPr txBox="1"/>
+          <p:nvPr/>
+        </p:nvSpPr>
+        <p:spPr>
+          <a:xfrm>
+            <a:off x="2275790" y="3136392"/>
+            <a:ext cx="1589989" cy="347472"/>
+          </a:xfrm>
+          <a:prstGeom prst="rect">
+            <a:avLst/>
+          </a:prstGeom>
+          <a:noFill/>
+        </p:spPr>
+        <p:txBody>
+          <a:bodyPr wrap="square" anchor="ctr" lIns="36576" rIns="36576" tIns="0" bIns="0">
+            <a:spAutoFit/>
+          </a:bodyPr>
+          <a:lstStyle/>
+          <a:p>
+            <a:pPr algn="ctr" rtl="1"/>
+            <a:r>
+              <a:rPr sz="1700" b="1">
+                <a:solidFill>
+                  <a:srgbClr val="1C3C7A"/>
+                </a:solidFill>
+                <a:latin typeface="Heebo"/>
+                <a:cs typeface="Heebo"/>
+              </a:rPr>
+              <a:t>13</a:t>
+            </a:r>
+          </a:p>
+        </p:txBody>
+      </p:sp>
+      <p:sp>
+        <p:nvSpPr>
+          <p:cNvPr id="71" name="TextBox 70"/>
+          <p:cNvSpPr txBox="1"/>
+          <p:nvPr/>
+        </p:nvSpPr>
+        <p:spPr>
+          <a:xfrm>
+            <a:off x="2275790" y="3474720"/>
+            <a:ext cx="1589989" cy="256032"/>
+          </a:xfrm>
+          <a:prstGeom prst="rect">
+            <a:avLst/>
+          </a:prstGeom>
+          <a:noFill/>
+        </p:spPr>
+        <p:txBody>
+          <a:bodyPr wrap="square" anchor="ctr" lIns="36576" rIns="36576" tIns="0" bIns="0">
+            <a:spAutoFit/>
+          </a:bodyPr>
+          <a:lstStyle/>
+          <a:p>
+            <a:pPr algn="ctr" rtl="1"/>
+            <a:r>
+              <a:rPr sz="1000" b="0">
+                <a:solidFill>
+                  <a:srgbClr val="8A94A8"/>
+                </a:solidFill>
+                <a:latin typeface="Heebo"/>
+                <a:cs typeface="Heebo"/>
+              </a:rPr>
+              <a:t>דיונים בחודש</a:t>
+            </a:r>
+          </a:p>
+        </p:txBody>
+      </p:sp>
+      <p:sp>
+        <p:nvSpPr>
+          <p:cNvPr id="72" name="Rounded Rectangle 71"/>
+          <p:cNvSpPr/>
+          <p:nvPr/>
+        </p:nvSpPr>
+        <p:spPr>
+          <a:xfrm>
+            <a:off x="594361" y="3108960"/>
+            <a:ext cx="1589989" cy="658368"/>
+          </a:xfrm>
+          <a:prstGeom prst="roundRect">
+            <a:avLst>
+              <a:gd name="adj" fmla="val 15000"/>
+            </a:avLst>
+          </a:prstGeom>
+          <a:solidFill>
+            <a:srgbClr val="F4F6FB"/>
+          </a:solidFill>
+          <a:ln>
+            <a:noFill/>
+          </a:ln>
+          <a:effectLst/>
+        </p:spPr>
+        <p:style>
+          <a:lnRef idx="1">
+            <a:schemeClr val="accent1"/>
+          </a:lnRef>
+          <a:fillRef idx="3">
+            <a:schemeClr val="accent1"/>
+          </a:fillRef>
+          <a:effectRef idx="2">
+            <a:schemeClr val="accent1"/>
+          </a:effectRef>
+          <a:fontRef idx="minor">
+            <a:schemeClr val="lt1"/>
+          </a:fontRef>
+        </p:style>
+        <p:txBody>
+          <a:bodyPr rtlCol="0" anchor="ctr"/>
+          <a:lstStyle/>
+          <a:p>
+            <a:pPr algn="ctr"/>
+          </a:p>
+        </p:txBody>
+      </p:sp>
+      <p:sp>
+        <p:nvSpPr>
+          <p:cNvPr id="73" name="TextBox 72"/>
+          <p:cNvSpPr txBox="1"/>
+          <p:nvPr/>
+        </p:nvSpPr>
+        <p:spPr>
+          <a:xfrm>
+            <a:off x="594361" y="3136392"/>
+            <a:ext cx="1589989" cy="347472"/>
+          </a:xfrm>
+          <a:prstGeom prst="rect">
+            <a:avLst/>
+          </a:prstGeom>
+          <a:noFill/>
+        </p:spPr>
+        <p:txBody>
+          <a:bodyPr wrap="square" anchor="ctr" lIns="36576" rIns="36576" tIns="0" bIns="0">
+            <a:spAutoFit/>
+          </a:bodyPr>
+          <a:lstStyle/>
+          <a:p>
+            <a:pPr algn="ctr" rtl="1"/>
+            <a:r>
+              <a:rPr sz="1700" b="1">
+                <a:solidFill>
+                  <a:srgbClr val="1C3C7A"/>
+                </a:solidFill>
+                <a:latin typeface="Heebo"/>
+                <a:cs typeface="Heebo"/>
+              </a:rPr>
+              <a:t>1,400 ₪</a:t>
+            </a:r>
+          </a:p>
+        </p:txBody>
+      </p:sp>
+      <p:sp>
+        <p:nvSpPr>
+          <p:cNvPr id="74" name="TextBox 73"/>
+          <p:cNvSpPr txBox="1"/>
+          <p:nvPr/>
+        </p:nvSpPr>
+        <p:spPr>
+          <a:xfrm>
+            <a:off x="594361" y="3474720"/>
+            <a:ext cx="1589989" cy="256032"/>
+          </a:xfrm>
+          <a:prstGeom prst="rect">
+            <a:avLst/>
+          </a:prstGeom>
+          <a:noFill/>
+        </p:spPr>
+        <p:txBody>
+          <a:bodyPr wrap="square" anchor="ctr" lIns="36576" rIns="36576" tIns="0" bIns="0">
+            <a:spAutoFit/>
+          </a:bodyPr>
+          <a:lstStyle/>
+          <a:p>
+            <a:pPr algn="ctr" rtl="1"/>
+            <a:r>
+              <a:rPr sz="1000" b="0">
+                <a:solidFill>
+                  <a:srgbClr val="8A94A8"/>
+                </a:solidFill>
+                <a:latin typeface="Heebo"/>
+                <a:cs typeface="Heebo"/>
+              </a:rPr>
+              <a:t>לדיון</a:t>
+            </a:r>
+          </a:p>
+        </p:txBody>
+      </p:sp>
+      <p:sp>
+        <p:nvSpPr>
+          <p:cNvPr id="75" name="TextBox 74"/>
+          <p:cNvSpPr txBox="1"/>
+          <p:nvPr/>
+        </p:nvSpPr>
+        <p:spPr>
+          <a:xfrm>
+            <a:off x="1645921" y="3931920"/>
+            <a:ext cx="2219858" cy="310896"/>
+          </a:xfrm>
+          <a:prstGeom prst="rect">
+            <a:avLst/>
+          </a:prstGeom>
+          <a:noFill/>
+        </p:spPr>
+        <p:txBody>
+          <a:bodyPr wrap="square" anchor="ctr" lIns="36576" rIns="36576" tIns="0" bIns="0">
+            <a:spAutoFit/>
+          </a:bodyPr>
+          <a:lstStyle/>
+          <a:p>
+            <a:pPr algn="r" rtl="1"/>
+            <a:r>
+              <a:rPr sz="1100" b="0">
+                <a:solidFill>
+                  <a:srgbClr val="1A2233"/>
+                </a:solidFill>
+                <a:latin typeface="Heebo"/>
+                <a:cs typeface="Heebo"/>
+              </a:rPr>
+              <a:t>מנכ״ל</a:t>
+            </a:r>
+          </a:p>
+        </p:txBody>
+      </p:sp>
+      <p:sp>
+        <p:nvSpPr>
+          <p:cNvPr id="76" name="TextBox 75"/>
+          <p:cNvSpPr txBox="1"/>
+          <p:nvPr/>
+        </p:nvSpPr>
+        <p:spPr>
+          <a:xfrm>
+            <a:off x="548641" y="3931920"/>
+            <a:ext cx="1097280" cy="310896"/>
+          </a:xfrm>
+          <a:prstGeom prst="rect">
+            <a:avLst/>
+          </a:prstGeom>
+          <a:noFill/>
+        </p:spPr>
+        <p:txBody>
+          <a:bodyPr wrap="square" anchor="ctr" lIns="36576" rIns="36576" tIns="0" bIns="0">
+            <a:spAutoFit/>
+          </a:bodyPr>
+          <a:lstStyle/>
+          <a:p>
+            <a:pPr algn="l" rtl="1"/>
+            <a:r>
+              <a:rPr sz="1100" b="1">
+                <a:solidFill>
+                  <a:srgbClr val="1C3C7A"/>
+                </a:solidFill>
+                <a:latin typeface="Heebo"/>
+                <a:cs typeface="Heebo"/>
+              </a:rPr>
+              <a:t>10,000 ₪</a:t>
+            </a:r>
+          </a:p>
+        </p:txBody>
+      </p:sp>
+      <p:cxnSp>
+        <p:nvCxnSpPr>
+          <p:cNvPr id="77" name="Connector 76"/>
+          <p:cNvCxnSpPr/>
+          <p:nvPr/>
+        </p:nvCxnSpPr>
+        <p:spPr>
+          <a:xfrm>
+            <a:off x="594361" y="4270248"/>
+            <a:ext cx="3271418" cy="0"/>
+          </a:xfrm>
+          <a:prstGeom prst="line">
+            <a:avLst/>
+          </a:prstGeom>
+          <a:ln w="9525">
+            <a:solidFill>
+              <a:srgbClr val="C5CDDD"/>
+            </a:solidFill>
+          </a:ln>
+        </p:spPr>
+        <p:style>
+          <a:lnRef idx="2">
+            <a:schemeClr val="accent1"/>
+          </a:lnRef>
+          <a:fillRef idx="0">
+            <a:schemeClr val="accent1"/>
+          </a:fillRef>
+          <a:effectRef idx="1">
+            <a:schemeClr val="accent1"/>
+          </a:effectRef>
+          <a:fontRef idx="minor">
+            <a:schemeClr val="tx1"/>
+          </a:fontRef>
+        </p:style>
+      </p:cxnSp>
+      <p:sp>
+        <p:nvSpPr>
+          <p:cNvPr id="78" name="TextBox 77"/>
+          <p:cNvSpPr txBox="1"/>
+          <p:nvPr/>
+        </p:nvSpPr>
+        <p:spPr>
+          <a:xfrm>
+            <a:off x="1645921" y="4297680"/>
+            <a:ext cx="2219858" cy="310896"/>
+          </a:xfrm>
+          <a:prstGeom prst="rect">
+            <a:avLst/>
+          </a:prstGeom>
+          <a:noFill/>
+        </p:spPr>
+        <p:txBody>
+          <a:bodyPr wrap="square" anchor="ctr" lIns="36576" rIns="36576" tIns="0" bIns="0">
+            <a:spAutoFit/>
+          </a:bodyPr>
+          <a:lstStyle/>
+          <a:p>
+            <a:pPr algn="r" rtl="1"/>
+            <a:r>
+              <a:rPr sz="1100" b="0">
+                <a:solidFill>
+                  <a:srgbClr val="1A2233"/>
+                </a:solidFill>
+                <a:latin typeface="Heebo"/>
+                <a:cs typeface="Heebo"/>
+              </a:rPr>
+              <a:t>עוזר מנכ״ל · חצי משרה</a:t>
+            </a:r>
+          </a:p>
+        </p:txBody>
+      </p:sp>
+      <p:sp>
+        <p:nvSpPr>
+          <p:cNvPr id="79" name="TextBox 78"/>
+          <p:cNvSpPr txBox="1"/>
+          <p:nvPr/>
+        </p:nvSpPr>
+        <p:spPr>
+          <a:xfrm>
+            <a:off x="548641" y="4297680"/>
+            <a:ext cx="1097280" cy="310896"/>
+          </a:xfrm>
+          <a:prstGeom prst="rect">
+            <a:avLst/>
+          </a:prstGeom>
+          <a:noFill/>
+        </p:spPr>
+        <p:txBody>
+          <a:bodyPr wrap="square" anchor="ctr" lIns="36576" rIns="36576" tIns="0" bIns="0">
+            <a:spAutoFit/>
+          </a:bodyPr>
+          <a:lstStyle/>
+          <a:p>
+            <a:pPr algn="l" rtl="1"/>
+            <a:r>
+              <a:rPr sz="1100" b="1">
+                <a:solidFill>
+                  <a:srgbClr val="1C3C7A"/>
+                </a:solidFill>
+                <a:latin typeface="Heebo"/>
+                <a:cs typeface="Heebo"/>
+              </a:rPr>
+              <a:t>5,000 ₪</a:t>
+            </a:r>
+          </a:p>
+        </p:txBody>
+      </p:sp>
+      <p:cxnSp>
+        <p:nvCxnSpPr>
+          <p:cNvPr id="80" name="Connector 79"/>
+          <p:cNvCxnSpPr/>
+          <p:nvPr/>
+        </p:nvCxnSpPr>
+        <p:spPr>
+          <a:xfrm>
+            <a:off x="594361" y="4636008"/>
+            <a:ext cx="3271418" cy="0"/>
+          </a:xfrm>
+          <a:prstGeom prst="line">
+            <a:avLst/>
+          </a:prstGeom>
+          <a:ln w="9525">
+            <a:solidFill>
+              <a:srgbClr val="C5CDDD"/>
+            </a:solidFill>
+          </a:ln>
+        </p:spPr>
+        <p:style>
+          <a:lnRef idx="2">
+            <a:schemeClr val="accent1"/>
+          </a:lnRef>
+          <a:fillRef idx="0">
+            <a:schemeClr val="accent1"/>
+          </a:fillRef>
+          <a:effectRef idx="1">
+            <a:schemeClr val="accent1"/>
+          </a:effectRef>
+          <a:fontRef idx="minor">
+            <a:schemeClr val="tx1"/>
+          </a:fontRef>
+        </p:style>
+      </p:cxnSp>
+      <p:sp>
+        <p:nvSpPr>
+          <p:cNvPr id="81" name="TextBox 80"/>
+          <p:cNvSpPr txBox="1"/>
+          <p:nvPr/>
+        </p:nvSpPr>
+        <p:spPr>
+          <a:xfrm>
+            <a:off x="1645921" y="4663440"/>
+            <a:ext cx="2219858" cy="310896"/>
+          </a:xfrm>
+          <a:prstGeom prst="rect">
+            <a:avLst/>
+          </a:prstGeom>
+          <a:noFill/>
+        </p:spPr>
+        <p:txBody>
+          <a:bodyPr wrap="square" anchor="ctr" lIns="36576" rIns="36576" tIns="0" bIns="0">
+            <a:spAutoFit/>
+          </a:bodyPr>
+          <a:lstStyle/>
+          <a:p>
+            <a:pPr algn="r" rtl="1"/>
+            <a:r>
+              <a:rPr sz="1100" b="0">
+                <a:solidFill>
+                  <a:srgbClr val="1A2233"/>
+                </a:solidFill>
+                <a:latin typeface="Heebo"/>
+                <a:cs typeface="Heebo"/>
+              </a:rPr>
+              <a:t>מנהל תוכן · משותף</a:t>
+            </a:r>
+          </a:p>
+        </p:txBody>
+      </p:sp>
+      <p:sp>
+        <p:nvSpPr>
+          <p:cNvPr id="82" name="TextBox 81"/>
+          <p:cNvSpPr txBox="1"/>
+          <p:nvPr/>
+        </p:nvSpPr>
+        <p:spPr>
+          <a:xfrm>
+            <a:off x="548641" y="4663440"/>
+            <a:ext cx="1097280" cy="310896"/>
+          </a:xfrm>
+          <a:prstGeom prst="rect">
+            <a:avLst/>
+          </a:prstGeom>
+          <a:noFill/>
+        </p:spPr>
+        <p:txBody>
+          <a:bodyPr wrap="square" anchor="ctr" lIns="36576" rIns="36576" tIns="0" bIns="0">
+            <a:spAutoFit/>
+          </a:bodyPr>
+          <a:lstStyle/>
+          <a:p>
+            <a:pPr algn="l" rtl="1"/>
+            <a:r>
+              <a:rPr sz="1100" b="1">
+                <a:solidFill>
+                  <a:srgbClr val="1C3C7A"/>
+                </a:solidFill>
+                <a:latin typeface="Heebo"/>
+                <a:cs typeface="Heebo"/>
+              </a:rPr>
+              <a:t>2,500 ₪</a:t>
+            </a:r>
+          </a:p>
+        </p:txBody>
+      </p:sp>
+      <p:cxnSp>
+        <p:nvCxnSpPr>
+          <p:cNvPr id="83" name="Connector 82"/>
+          <p:cNvCxnSpPr/>
+          <p:nvPr/>
+        </p:nvCxnSpPr>
+        <p:spPr>
+          <a:xfrm>
+            <a:off x="594361" y="5001768"/>
+            <a:ext cx="3271418" cy="0"/>
+          </a:xfrm>
+          <a:prstGeom prst="line">
+            <a:avLst/>
+          </a:prstGeom>
+          <a:ln w="9525">
+            <a:solidFill>
+              <a:srgbClr val="C5CDDD"/>
+            </a:solidFill>
+          </a:ln>
+        </p:spPr>
+        <p:style>
+          <a:lnRef idx="2">
+            <a:schemeClr val="accent1"/>
+          </a:lnRef>
+          <a:fillRef idx="0">
+            <a:schemeClr val="accent1"/>
+          </a:fillRef>
+          <a:effectRef idx="1">
+            <a:schemeClr val="accent1"/>
+          </a:effectRef>
+          <a:fontRef idx="minor">
+            <a:schemeClr val="tx1"/>
+          </a:fontRef>
+        </p:style>
+      </p:cxnSp>
+      <p:sp>
+        <p:nvSpPr>
+          <p:cNvPr id="84" name="TextBox 83"/>
+          <p:cNvSpPr txBox="1"/>
+          <p:nvPr/>
+        </p:nvSpPr>
+        <p:spPr>
+          <a:xfrm>
+            <a:off x="1645921" y="5029200"/>
+            <a:ext cx="2219858" cy="310896"/>
+          </a:xfrm>
+          <a:prstGeom prst="rect">
+            <a:avLst/>
+          </a:prstGeom>
+          <a:noFill/>
+        </p:spPr>
+        <p:txBody>
+          <a:bodyPr wrap="square" anchor="ctr" lIns="36576" rIns="36576" tIns="0" bIns="0">
+            <a:spAutoFit/>
+          </a:bodyPr>
+          <a:lstStyle/>
+          <a:p>
+            <a:pPr algn="r" rtl="1"/>
+            <a:r>
+              <a:rPr sz="1100" b="0">
+                <a:solidFill>
+                  <a:srgbClr val="1A2233"/>
+                </a:solidFill>
+                <a:latin typeface="Heebo"/>
+                <a:cs typeface="Heebo"/>
+              </a:rPr>
+              <a:t>חברי דירקטוריון · 2 דיונים</a:t>
+            </a:r>
+          </a:p>
+        </p:txBody>
+      </p:sp>
+      <p:sp>
+        <p:nvSpPr>
+          <p:cNvPr id="85" name="TextBox 84"/>
+          <p:cNvSpPr txBox="1"/>
+          <p:nvPr/>
+        </p:nvSpPr>
+        <p:spPr>
+          <a:xfrm>
+            <a:off x="548641" y="5029200"/>
+            <a:ext cx="1097280" cy="310896"/>
+          </a:xfrm>
+          <a:prstGeom prst="rect">
+            <a:avLst/>
+          </a:prstGeom>
+          <a:noFill/>
+        </p:spPr>
+        <p:txBody>
+          <a:bodyPr wrap="square" anchor="ctr" lIns="36576" rIns="36576" tIns="0" bIns="0">
+            <a:spAutoFit/>
+          </a:bodyPr>
+          <a:lstStyle/>
+          <a:p>
+            <a:pPr algn="l" rtl="1"/>
+            <a:r>
+              <a:rPr sz="1100" b="1">
+                <a:solidFill>
+                  <a:srgbClr val="1C3C7A"/>
+                </a:solidFill>
+                <a:latin typeface="Heebo"/>
+                <a:cs typeface="Heebo"/>
+              </a:rPr>
+              <a:t>750 ₪</a:t>
+            </a:r>
+          </a:p>
+        </p:txBody>
+      </p:sp>
+      <p:cxnSp>
+        <p:nvCxnSpPr>
+          <p:cNvPr id="86" name="Connector 85"/>
+          <p:cNvCxnSpPr/>
+          <p:nvPr/>
+        </p:nvCxnSpPr>
+        <p:spPr>
+          <a:xfrm>
+            <a:off x="594361" y="5367528"/>
+            <a:ext cx="3271418" cy="0"/>
+          </a:xfrm>
+          <a:prstGeom prst="line">
+            <a:avLst/>
+          </a:prstGeom>
+          <a:ln w="9525">
+            <a:solidFill>
+              <a:srgbClr val="C5CDDD"/>
+            </a:solidFill>
+          </a:ln>
+        </p:spPr>
+        <p:style>
+          <a:lnRef idx="2">
+            <a:schemeClr val="accent1"/>
+          </a:lnRef>
+          <a:fillRef idx="0">
+            <a:schemeClr val="accent1"/>
+          </a:fillRef>
+          <a:effectRef idx="1">
+            <a:schemeClr val="accent1"/>
+          </a:effectRef>
+          <a:fontRef idx="minor">
+            <a:schemeClr val="tx1"/>
+          </a:fontRef>
+        </p:style>
+      </p:cxnSp>
+      <p:sp>
+        <p:nvSpPr>
+          <p:cNvPr id="87" name="TextBox 86"/>
+          <p:cNvSpPr txBox="1"/>
+          <p:nvPr/>
+        </p:nvSpPr>
+        <p:spPr>
+          <a:xfrm>
+            <a:off x="1645921" y="5394960"/>
+            <a:ext cx="2219858" cy="310896"/>
+          </a:xfrm>
+          <a:prstGeom prst="rect">
+            <a:avLst/>
+          </a:prstGeom>
+          <a:noFill/>
+        </p:spPr>
+        <p:txBody>
+          <a:bodyPr wrap="square" anchor="ctr" lIns="36576" rIns="36576" tIns="0" bIns="0">
+            <a:spAutoFit/>
+          </a:bodyPr>
+          <a:lstStyle/>
+          <a:p>
+            <a:pPr algn="r" rtl="1"/>
+            <a:r>
+              <a:rPr sz="1100" b="0">
+                <a:solidFill>
+                  <a:srgbClr val="1A2233"/>
+                </a:solidFill>
+                <a:latin typeface="Heebo"/>
+                <a:cs typeface="Heebo"/>
+              </a:rPr>
+              <a:t>אקטיביסטים · 2 דיונים</a:t>
+            </a:r>
+          </a:p>
+        </p:txBody>
+      </p:sp>
+      <p:sp>
+        <p:nvSpPr>
+          <p:cNvPr id="88" name="TextBox 87"/>
+          <p:cNvSpPr txBox="1"/>
+          <p:nvPr/>
+        </p:nvSpPr>
+        <p:spPr>
+          <a:xfrm>
+            <a:off x="548641" y="5394960"/>
+            <a:ext cx="1097280" cy="310896"/>
+          </a:xfrm>
+          <a:prstGeom prst="rect">
+            <a:avLst/>
+          </a:prstGeom>
+          <a:noFill/>
+        </p:spPr>
+        <p:txBody>
+          <a:bodyPr wrap="square" anchor="ctr" lIns="36576" rIns="36576" tIns="0" bIns="0">
+            <a:spAutoFit/>
+          </a:bodyPr>
+          <a:lstStyle/>
+          <a:p>
+            <a:pPr algn="l" rtl="1"/>
+            <a:r>
+              <a:rPr sz="1100" b="0">
+                <a:solidFill>
+                  <a:srgbClr val="8A94A8"/>
+                </a:solidFill>
+                <a:latin typeface="Heebo"/>
+                <a:cs typeface="Heebo"/>
+              </a:rPr>
+              <a:t>בהתנדבות</a:t>
+            </a:r>
+          </a:p>
+        </p:txBody>
+      </p:sp>
+      <p:cxnSp>
+        <p:nvCxnSpPr>
+          <p:cNvPr id="89" name="Connector 88"/>
+          <p:cNvCxnSpPr/>
+          <p:nvPr/>
+        </p:nvCxnSpPr>
+        <p:spPr>
+          <a:xfrm>
+            <a:off x="594361" y="5733288"/>
+            <a:ext cx="3271418" cy="0"/>
+          </a:xfrm>
+          <a:prstGeom prst="line">
+            <a:avLst/>
+          </a:prstGeom>
+          <a:ln w="9525">
+            <a:solidFill>
+              <a:srgbClr val="C5CDDD"/>
+            </a:solidFill>
+          </a:ln>
+        </p:spPr>
+        <p:style>
+          <a:lnRef idx="2">
+            <a:schemeClr val="accent1"/>
+          </a:lnRef>
+          <a:fillRef idx="0">
+            <a:schemeClr val="accent1"/>
+          </a:fillRef>
+          <a:effectRef idx="1">
+            <a:schemeClr val="accent1"/>
+          </a:effectRef>
+          <a:fontRef idx="minor">
+            <a:schemeClr val="tx1"/>
+          </a:fontRef>
+        </p:style>
+      </p:cxnSp>
+      <p:sp>
+        <p:nvSpPr>
+          <p:cNvPr id="90" name="TextBox 89"/>
           <p:cNvSpPr txBox="1"/>
           <p:nvPr/>
         </p:nvSpPr>
@@ -16707,43 +16553,7 @@
       </p:sp>
       <p:sp>
         <p:nvSpPr>
-          <p:cNvPr id="95" name="TextBox 94"/>
-          <p:cNvSpPr txBox="1"/>
-          <p:nvPr/>
-        </p:nvSpPr>
-        <p:spPr>
-          <a:xfrm>
-            <a:off x="594361" y="6080760"/>
-            <a:ext cx="3271418" cy="274320"/>
-          </a:xfrm>
-          <a:prstGeom prst="rect">
-            <a:avLst/>
-          </a:prstGeom>
-          <a:noFill/>
-        </p:spPr>
-        <p:txBody>
-          <a:bodyPr wrap="square" anchor="ctr" lIns="36576" rIns="36576" tIns="0" bIns="0">
-            <a:spAutoFit/>
-          </a:bodyPr>
-          <a:lstStyle/>
-          <a:p>
-            <a:pPr algn="r" rtl="1"/>
-            <a:r>
-              <a:rPr sz="1100" b="1">
-                <a:solidFill>
-                  <a:srgbClr val="1C3C7A"/>
-                </a:solidFill>
-                <a:latin typeface="Heebo"/>
-                <a:cs typeface="Heebo"/>
-              </a:rPr>
-              <a:t>מימון: כ-4 שותפים מייסדים</a:t>
-            </a:r>
-          </a:p>
-        </p:txBody>
-      </p:sp>
-      <p:sp>
-        <p:nvSpPr>
-          <p:cNvPr id="96" name="TextBox 95"/>
+          <p:cNvPr id="91" name="TextBox 90"/>
           <p:cNvSpPr txBox="1"/>
           <p:nvPr/>
         </p:nvSpPr>
@@ -16772,7 +16582,7 @@
                 <a:latin typeface="Heebo"/>
                 <a:cs typeface="Heebo"/>
               </a:rPr>
-              <a:t>כל נותני השירות פרילנסרים · תמיר דורטל ללא שכר · שותף מייסד = 5,000 ₪ בחודש</a:t>
+              <a:t>כל נותני השירות פרילנסרים · תמיר דורטל ללא שכר</a:t>
             </a:r>
           </a:p>
         </p:txBody>

</xml_diff>

<commit_message>
Activity slide: board member instead of named third rep
Co-Authored-By: Claude Opus 5.5 <noreply@anthropic.com>
Claude-Session: https://claude.ai/code/session_01W7Er83FuNT4pLFShWidYHn
</commit_message>
<xml_diff>
--- a/presentation/out/koach-hitarvut.pptx
+++ b/presentation/out/koach-hitarvut.pptx
@@ -32836,16 +32836,16 @@
         </p:nvSpPr>
         <p:spPr>
           <a:xfrm>
-            <a:off x="7699822" y="4764024"/>
-            <a:ext cx="1238211" cy="261518"/>
-          </a:xfrm>
-          <a:prstGeom prst="rect">
-            <a:avLst/>
-          </a:prstGeom>
-          <a:noFill/>
-        </p:spPr>
-        <p:txBody>
-          <a:bodyPr wrap="square" anchor="b" lIns="36576" rIns="36576" tIns="0" bIns="0">
+            <a:off x="7699822" y="4709160"/>
+            <a:ext cx="1238211" cy="502920"/>
+          </a:xfrm>
+          <a:prstGeom prst="rect">
+            <a:avLst/>
+          </a:prstGeom>
+          <a:noFill/>
+        </p:spPr>
+        <p:txBody>
+          <a:bodyPr wrap="square" anchor="ctr" lIns="36576" rIns="36576" tIns="0" bIns="0">
             <a:spAutoFit/>
           </a:bodyPr>
           <a:lstStyle/>
@@ -32859,50 +32859,14 @@
                 <a:latin typeface="Heebo"/>
                 <a:cs typeface="Heebo"/>
               </a:rPr>
-              <a:t>ד״ר אמיר רובין</a:t>
-            </a:r>
-          </a:p>
-        </p:txBody>
-      </p:sp>
-      <p:sp>
-        <p:nvSpPr>
-          <p:cNvPr id="50" name="TextBox 49"/>
-          <p:cNvSpPr txBox="1"/>
-          <p:nvPr/>
-        </p:nvSpPr>
-        <p:spPr>
-          <a:xfrm>
-            <a:off x="7699822" y="4985766"/>
-            <a:ext cx="1238211" cy="201168"/>
-          </a:xfrm>
-          <a:prstGeom prst="rect">
-            <a:avLst/>
-          </a:prstGeom>
-          <a:noFill/>
-        </p:spPr>
-        <p:txBody>
-          <a:bodyPr wrap="square" anchor="t" lIns="36576" rIns="36576" tIns="0" bIns="0">
-            <a:spAutoFit/>
-          </a:bodyPr>
-          <a:lstStyle/>
-          <a:p>
-            <a:pPr algn="ctr" rtl="1"/>
-            <a:r>
-              <a:rPr sz="900" b="0">
-                <a:solidFill>
-                  <a:srgbClr val="8A94A8"/>
-                </a:solidFill>
-                <a:latin typeface="Heebo"/>
-                <a:cs typeface="Heebo"/>
-              </a:rPr>
-              <a:t>או עו״ד אודליה קדמי</a:t>
-            </a:r>
-          </a:p>
-        </p:txBody>
-      </p:sp>
-      <p:sp>
-        <p:nvSpPr>
-          <p:cNvPr id="51" name="Rounded Rectangle 50"/>
+              <a:t>חבר דירקטוריון</a:t>
+            </a:r>
+          </a:p>
+        </p:txBody>
+      </p:sp>
+      <p:sp>
+        <p:nvSpPr>
+          <p:cNvPr id="50" name="Rounded Rectangle 49"/>
           <p:cNvSpPr/>
           <p:nvPr/>
         </p:nvSpPr>
@@ -32949,7 +32913,7 @@
       </p:sp>
       <p:sp>
         <p:nvSpPr>
-          <p:cNvPr id="52" name="TextBox 51"/>
+          <p:cNvPr id="51" name="TextBox 50"/>
           <p:cNvSpPr txBox="1"/>
           <p:nvPr/>
         </p:nvSpPr>
@@ -32985,7 +32949,7 @@
       </p:sp>
       <p:sp>
         <p:nvSpPr>
-          <p:cNvPr id="53" name="TextBox 52"/>
+          <p:cNvPr id="52" name="TextBox 51"/>
           <p:cNvSpPr txBox="1"/>
           <p:nvPr/>
         </p:nvSpPr>
@@ -33021,7 +32985,7 @@
       </p:sp>
       <p:sp>
         <p:nvSpPr>
-          <p:cNvPr id="54" name="Rounded Rectangle 53"/>
+          <p:cNvPr id="53" name="Rounded Rectangle 52"/>
           <p:cNvSpPr/>
           <p:nvPr/>
         </p:nvSpPr>
@@ -33067,7 +33031,7 @@
       </p:sp>
       <p:sp>
         <p:nvSpPr>
-          <p:cNvPr id="55" name="TextBox 54"/>
+          <p:cNvPr id="54" name="TextBox 53"/>
           <p:cNvSpPr txBox="1"/>
           <p:nvPr/>
         </p:nvSpPr>
@@ -33103,7 +33067,7 @@
       </p:sp>
       <p:sp>
         <p:nvSpPr>
-          <p:cNvPr id="56" name="Rounded Rectangle 55"/>
+          <p:cNvPr id="55" name="Rounded Rectangle 54"/>
           <p:cNvSpPr/>
           <p:nvPr/>
         </p:nvSpPr>
@@ -33151,7 +33115,7 @@
       </p:sp>
       <p:sp>
         <p:nvSpPr>
-          <p:cNvPr id="57" name="TextBox 56"/>
+          <p:cNvPr id="56" name="TextBox 55"/>
           <p:cNvSpPr txBox="1"/>
           <p:nvPr/>
         </p:nvSpPr>
@@ -33187,7 +33151,7 @@
       </p:sp>
       <p:sp>
         <p:nvSpPr>
-          <p:cNvPr id="58" name="TextBox 57"/>
+          <p:cNvPr id="57" name="TextBox 56"/>
           <p:cNvSpPr txBox="1"/>
           <p:nvPr/>
         </p:nvSpPr>
@@ -33223,7 +33187,7 @@
       </p:sp>
       <p:sp>
         <p:nvSpPr>
-          <p:cNvPr id="59" name="TextBox 58"/>
+          <p:cNvPr id="58" name="TextBox 57"/>
           <p:cNvSpPr txBox="1"/>
           <p:nvPr/>
         </p:nvSpPr>
@@ -33259,7 +33223,7 @@
       </p:sp>
       <p:sp>
         <p:nvSpPr>
-          <p:cNvPr id="60" name="TextBox 59"/>
+          <p:cNvPr id="59" name="TextBox 58"/>
           <p:cNvSpPr txBox="1"/>
           <p:nvPr/>
         </p:nvSpPr>

</xml_diff>

<commit_message>
Noga: NII transfers tagged national security
Co-Authored-By: Claude Opus 5.5 <noreply@anthropic.com>
Claude-Session: https://claude.ai/code/session_01W7Er83FuNT4pLFShWidYHn
</commit_message>
<xml_diff>
--- a/presentation/out/koach-hitarvut.pptx
+++ b/presentation/out/koach-hitarvut.pptx
@@ -27389,7 +27389,7 @@
                 <a:latin typeface="Heebo"/>
                 <a:cs typeface="Heebo"/>
               </a:rPr>
-              <a:t>חקיקה · ביטחון אישי, ריבונות, צה״ל וחינוך</a:t>
+              <a:t>חקיקה · ביטחון אישי ולאומי, ריבונות, צה״ל וחינוך</a:t>
             </a:r>
           </a:p>
         </p:txBody>
@@ -28299,7 +28299,7 @@
                 <a:latin typeface="Heebo"/>
                 <a:cs typeface="Heebo"/>
               </a:rPr>
-              <a:t>רווחה</a:t>
+              <a:t>ביטחון לאומי</a:t>
             </a:r>
           </a:p>
         </p:txBody>

</xml_diff>

<commit_message>
Move daily Knesset pay from week section to budget (deck and site)
Co-Authored-By: Claude Opus 5.5 <noreply@anthropic.com>
Claude-Session: https://claude.ai/code/session_01W7Er83FuNT4pLFShWidYHn
</commit_message>
<xml_diff>
--- a/presentation/out/koach-hitarvut.pptx
+++ b/presentation/out/koach-hitarvut.pptx
@@ -10454,6 +10454,88 @@
         </p:nvSpPr>
         <p:spPr>
           <a:xfrm>
+            <a:off x="5440680" y="5230368"/>
+            <a:ext cx="6339535" cy="457200"/>
+          </a:xfrm>
+          <a:prstGeom prst="roundRect">
+            <a:avLst>
+              <a:gd name="adj" fmla="val 30000"/>
+            </a:avLst>
+          </a:prstGeom>
+          <a:solidFill>
+            <a:srgbClr val="F0C000"/>
+          </a:solidFill>
+          <a:ln>
+            <a:noFill/>
+          </a:ln>
+          <a:effectLst/>
+        </p:spPr>
+        <p:style>
+          <a:lnRef idx="1">
+            <a:schemeClr val="accent1"/>
+          </a:lnRef>
+          <a:fillRef idx="3">
+            <a:schemeClr val="accent1"/>
+          </a:fillRef>
+          <a:effectRef idx="2">
+            <a:schemeClr val="accent1"/>
+          </a:effectRef>
+          <a:fontRef idx="minor">
+            <a:schemeClr val="lt1"/>
+          </a:fontRef>
+        </p:style>
+        <p:txBody>
+          <a:bodyPr rtlCol="0" anchor="ctr"/>
+          <a:lstStyle/>
+          <a:p>
+            <a:pPr algn="ctr"/>
+          </a:p>
+        </p:txBody>
+      </p:sp>
+      <p:sp>
+        <p:nvSpPr>
+          <p:cNvPr id="42" name="TextBox 41"/>
+          <p:cNvSpPr txBox="1"/>
+          <p:nvPr/>
+        </p:nvSpPr>
+        <p:spPr>
+          <a:xfrm>
+            <a:off x="5623560" y="5230368"/>
+            <a:ext cx="5973775" cy="457200"/>
+          </a:xfrm>
+          <a:prstGeom prst="rect">
+            <a:avLst/>
+          </a:prstGeom>
+          <a:noFill/>
+        </p:spPr>
+        <p:txBody>
+          <a:bodyPr wrap="square" anchor="ctr" lIns="36576" rIns="36576" tIns="0" bIns="0">
+            <a:spAutoFit/>
+          </a:bodyPr>
+          <a:lstStyle/>
+          <a:p>
+            <a:pPr algn="ctr" rtl="1"/>
+            <a:r>
+              <a:rPr sz="1300" b="1">
+                <a:solidFill>
+                  <a:srgbClr val="122755"/>
+                </a:solidFill>
+                <a:latin typeface="Heebo"/>
+                <a:cs typeface="Heebo"/>
+              </a:rPr>
+              <a:t>תגמול ליום כנסת: 300 ₪ חצי יום · 450 ₪ יום מלא</a:t>
+            </a:r>
+          </a:p>
+        </p:txBody>
+      </p:sp>
+      <p:sp>
+        <p:nvSpPr>
+          <p:cNvPr id="43" name="Rounded Rectangle 42"/>
+          <p:cNvSpPr/>
+          <p:nvPr/>
+        </p:nvSpPr>
+        <p:spPr>
+          <a:xfrm>
             <a:off x="411480" y="1188720"/>
             <a:ext cx="4754880" cy="2331720"/>
           </a:xfrm>
@@ -10494,7 +10576,7 @@
       </p:sp>
       <p:sp>
         <p:nvSpPr>
-          <p:cNvPr id="42" name="TextBox 41"/>
+          <p:cNvPr id="44" name="TextBox 43"/>
           <p:cNvSpPr txBox="1"/>
           <p:nvPr/>
         </p:nvSpPr>
@@ -10530,7 +10612,7 @@
       </p:sp>
       <p:sp>
         <p:nvSpPr>
-          <p:cNvPr id="43" name="TextBox 42"/>
+          <p:cNvPr id="45" name="TextBox 44"/>
           <p:cNvSpPr txBox="1"/>
           <p:nvPr/>
         </p:nvSpPr>
@@ -10566,7 +10648,7 @@
       </p:sp>
       <p:sp>
         <p:nvSpPr>
-          <p:cNvPr id="44" name="TextBox 43"/>
+          <p:cNvPr id="46" name="TextBox 45"/>
           <p:cNvSpPr txBox="1"/>
           <p:nvPr/>
         </p:nvSpPr>
@@ -10602,7 +10684,7 @@
       </p:sp>
       <p:sp>
         <p:nvSpPr>
-          <p:cNvPr id="45" name="Rounded Rectangle 44"/>
+          <p:cNvPr id="47" name="Rounded Rectangle 46"/>
           <p:cNvSpPr/>
           <p:nvPr/>
         </p:nvSpPr>
@@ -10648,7 +10730,7 @@
       </p:sp>
       <p:sp>
         <p:nvSpPr>
-          <p:cNvPr id="46" name="TextBox 45"/>
+          <p:cNvPr id="48" name="TextBox 47"/>
           <p:cNvSpPr txBox="1"/>
           <p:nvPr/>
         </p:nvSpPr>
@@ -10684,7 +10766,7 @@
       </p:sp>
       <p:sp>
         <p:nvSpPr>
-          <p:cNvPr id="47" name="TextBox 46"/>
+          <p:cNvPr id="49" name="TextBox 48"/>
           <p:cNvSpPr txBox="1"/>
           <p:nvPr/>
         </p:nvSpPr>
@@ -10720,7 +10802,7 @@
       </p:sp>
       <p:sp>
         <p:nvSpPr>
-          <p:cNvPr id="48" name="Rounded Rectangle 47"/>
+          <p:cNvPr id="50" name="Rounded Rectangle 49"/>
           <p:cNvSpPr/>
           <p:nvPr/>
         </p:nvSpPr>
@@ -10768,7 +10850,7 @@
       </p:sp>
       <p:sp>
         <p:nvSpPr>
-          <p:cNvPr id="49" name="TextBox 48"/>
+          <p:cNvPr id="51" name="TextBox 50"/>
           <p:cNvSpPr txBox="1"/>
           <p:nvPr/>
         </p:nvSpPr>
@@ -10804,7 +10886,7 @@
       </p:sp>
       <p:sp>
         <p:nvSpPr>
-          <p:cNvPr id="50" name="TextBox 49"/>
+          <p:cNvPr id="52" name="TextBox 51"/>
           <p:cNvSpPr txBox="1"/>
           <p:nvPr/>
         </p:nvSpPr>
@@ -10840,49 +10922,13 @@
       </p:sp>
       <p:sp>
         <p:nvSpPr>
-          <p:cNvPr id="51" name="TextBox 50"/>
+          <p:cNvPr id="53" name="TextBox 52"/>
           <p:cNvSpPr txBox="1"/>
           <p:nvPr/>
         </p:nvSpPr>
         <p:spPr>
           <a:xfrm>
             <a:off x="640080" y="5056632"/>
-            <a:ext cx="4297680" cy="548640"/>
-          </a:xfrm>
-          <a:prstGeom prst="rect">
-            <a:avLst/>
-          </a:prstGeom>
-          <a:noFill/>
-        </p:spPr>
-        <p:txBody>
-          <a:bodyPr wrap="square" anchor="t" lIns="36576" rIns="36576" tIns="0" bIns="0">
-            <a:spAutoFit/>
-          </a:bodyPr>
-          <a:lstStyle/>
-          <a:p>
-            <a:pPr algn="r" rtl="1"/>
-            <a:r>
-              <a:rPr sz="1200" b="0">
-                <a:solidFill>
-                  <a:srgbClr val="1A2233"/>
-                </a:solidFill>
-                <a:latin typeface="Heebo"/>
-                <a:cs typeface="Heebo"/>
-              </a:rPr>
-              <a:t>• תעריף פתיחה ליום כנסת: 300 ₪ חצי יום · 450 ₪ יום מלא</a:t>
-            </a:r>
-          </a:p>
-        </p:txBody>
-      </p:sp>
-      <p:sp>
-        <p:nvSpPr>
-          <p:cNvPr id="52" name="TextBox 51"/>
-          <p:cNvSpPr txBox="1"/>
-          <p:nvPr/>
-        </p:nvSpPr>
-        <p:spPr>
-          <a:xfrm>
-            <a:off x="640080" y="5678424"/>
             <a:ext cx="4297680" cy="548640"/>
           </a:xfrm>
           <a:prstGeom prst="rect">
@@ -12504,6 +12550,88 @@
         </p:nvSpPr>
         <p:spPr>
           <a:xfrm>
+            <a:off x="5440680" y="5230368"/>
+            <a:ext cx="6339535" cy="457200"/>
+          </a:xfrm>
+          <a:prstGeom prst="roundRect">
+            <a:avLst>
+              <a:gd name="adj" fmla="val 30000"/>
+            </a:avLst>
+          </a:prstGeom>
+          <a:solidFill>
+            <a:srgbClr val="F0C000"/>
+          </a:solidFill>
+          <a:ln>
+            <a:noFill/>
+          </a:ln>
+          <a:effectLst/>
+        </p:spPr>
+        <p:style>
+          <a:lnRef idx="1">
+            <a:schemeClr val="accent1"/>
+          </a:lnRef>
+          <a:fillRef idx="3">
+            <a:schemeClr val="accent1"/>
+          </a:fillRef>
+          <a:effectRef idx="2">
+            <a:schemeClr val="accent1"/>
+          </a:effectRef>
+          <a:fontRef idx="minor">
+            <a:schemeClr val="lt1"/>
+          </a:fontRef>
+        </p:style>
+        <p:txBody>
+          <a:bodyPr rtlCol="0" anchor="ctr"/>
+          <a:lstStyle/>
+          <a:p>
+            <a:pPr algn="ctr"/>
+          </a:p>
+        </p:txBody>
+      </p:sp>
+      <p:sp>
+        <p:nvSpPr>
+          <p:cNvPr id="42" name="TextBox 41"/>
+          <p:cNvSpPr txBox="1"/>
+          <p:nvPr/>
+        </p:nvSpPr>
+        <p:spPr>
+          <a:xfrm>
+            <a:off x="5623560" y="5230368"/>
+            <a:ext cx="5973775" cy="457200"/>
+          </a:xfrm>
+          <a:prstGeom prst="rect">
+            <a:avLst/>
+          </a:prstGeom>
+          <a:noFill/>
+        </p:spPr>
+        <p:txBody>
+          <a:bodyPr wrap="square" anchor="ctr" lIns="36576" rIns="36576" tIns="0" bIns="0">
+            <a:spAutoFit/>
+          </a:bodyPr>
+          <a:lstStyle/>
+          <a:p>
+            <a:pPr algn="ctr" rtl="1"/>
+            <a:r>
+              <a:rPr sz="1300" b="1">
+                <a:solidFill>
+                  <a:srgbClr val="122755"/>
+                </a:solidFill>
+                <a:latin typeface="Heebo"/>
+                <a:cs typeface="Heebo"/>
+              </a:rPr>
+              <a:t>תגמול ליום כנסת: 400 ₪ חצי יום · 600 ₪ יום מלא</a:t>
+            </a:r>
+          </a:p>
+        </p:txBody>
+      </p:sp>
+      <p:sp>
+        <p:nvSpPr>
+          <p:cNvPr id="43" name="Rounded Rectangle 42"/>
+          <p:cNvSpPr/>
+          <p:nvPr/>
+        </p:nvSpPr>
+        <p:spPr>
+          <a:xfrm>
             <a:off x="411480" y="1188720"/>
             <a:ext cx="4754880" cy="2331720"/>
           </a:xfrm>
@@ -12544,7 +12672,7 @@
       </p:sp>
       <p:sp>
         <p:nvSpPr>
-          <p:cNvPr id="42" name="TextBox 41"/>
+          <p:cNvPr id="44" name="TextBox 43"/>
           <p:cNvSpPr txBox="1"/>
           <p:nvPr/>
         </p:nvSpPr>
@@ -12580,7 +12708,7 @@
       </p:sp>
       <p:sp>
         <p:nvSpPr>
-          <p:cNvPr id="43" name="TextBox 42"/>
+          <p:cNvPr id="45" name="TextBox 44"/>
           <p:cNvSpPr txBox="1"/>
           <p:nvPr/>
         </p:nvSpPr>
@@ -12616,7 +12744,7 @@
       </p:sp>
       <p:sp>
         <p:nvSpPr>
-          <p:cNvPr id="44" name="TextBox 43"/>
+          <p:cNvPr id="46" name="TextBox 45"/>
           <p:cNvSpPr txBox="1"/>
           <p:nvPr/>
         </p:nvSpPr>
@@ -12652,7 +12780,7 @@
       </p:sp>
       <p:sp>
         <p:nvSpPr>
-          <p:cNvPr id="45" name="Rounded Rectangle 44"/>
+          <p:cNvPr id="47" name="Rounded Rectangle 46"/>
           <p:cNvSpPr/>
           <p:nvPr/>
         </p:nvSpPr>
@@ -12698,7 +12826,7 @@
       </p:sp>
       <p:sp>
         <p:nvSpPr>
-          <p:cNvPr id="46" name="TextBox 45"/>
+          <p:cNvPr id="48" name="TextBox 47"/>
           <p:cNvSpPr txBox="1"/>
           <p:nvPr/>
         </p:nvSpPr>
@@ -12734,7 +12862,7 @@
       </p:sp>
       <p:sp>
         <p:nvSpPr>
-          <p:cNvPr id="47" name="TextBox 46"/>
+          <p:cNvPr id="49" name="TextBox 48"/>
           <p:cNvSpPr txBox="1"/>
           <p:nvPr/>
         </p:nvSpPr>
@@ -12770,7 +12898,7 @@
       </p:sp>
       <p:sp>
         <p:nvSpPr>
-          <p:cNvPr id="48" name="Rounded Rectangle 47"/>
+          <p:cNvPr id="50" name="Rounded Rectangle 49"/>
           <p:cNvSpPr/>
           <p:nvPr/>
         </p:nvSpPr>
@@ -12818,7 +12946,7 @@
       </p:sp>
       <p:sp>
         <p:nvSpPr>
-          <p:cNvPr id="49" name="TextBox 48"/>
+          <p:cNvPr id="51" name="TextBox 50"/>
           <p:cNvSpPr txBox="1"/>
           <p:nvPr/>
         </p:nvSpPr>
@@ -12854,7 +12982,7 @@
       </p:sp>
       <p:sp>
         <p:nvSpPr>
-          <p:cNvPr id="50" name="TextBox 49"/>
+          <p:cNvPr id="52" name="TextBox 51"/>
           <p:cNvSpPr txBox="1"/>
           <p:nvPr/>
         </p:nvSpPr>
@@ -12890,7 +13018,7 @@
       </p:sp>
       <p:sp>
         <p:nvSpPr>
-          <p:cNvPr id="51" name="TextBox 50"/>
+          <p:cNvPr id="53" name="TextBox 52"/>
           <p:cNvSpPr txBox="1"/>
           <p:nvPr/>
         </p:nvSpPr>
@@ -12926,7 +13054,7 @@
       </p:sp>
       <p:sp>
         <p:nvSpPr>
-          <p:cNvPr id="52" name="TextBox 51"/>
+          <p:cNvPr id="54" name="TextBox 53"/>
           <p:cNvSpPr txBox="1"/>
           <p:nvPr/>
         </p:nvSpPr>
@@ -31160,8 +31288,8 @@
         </p:nvSpPr>
         <p:spPr>
           <a:xfrm>
-            <a:off x="8112557" y="1143000"/>
-            <a:ext cx="3667658" cy="868680"/>
+            <a:off x="6187288" y="1143000"/>
+            <a:ext cx="5592927" cy="868680"/>
           </a:xfrm>
           <a:prstGeom prst="roundRect">
             <a:avLst>
@@ -31206,8 +31334,8 @@
         </p:nvSpPr>
         <p:spPr>
           <a:xfrm>
-            <a:off x="8112557" y="1234440"/>
-            <a:ext cx="3667658" cy="438912"/>
+            <a:off x="6187288" y="1234440"/>
+            <a:ext cx="5592927" cy="438912"/>
           </a:xfrm>
           <a:prstGeom prst="rect">
             <a:avLst/>
@@ -31242,8 +31370,8 @@
         </p:nvSpPr>
         <p:spPr>
           <a:xfrm>
-            <a:off x="8112557" y="1691640"/>
-            <a:ext cx="3667658" cy="256032"/>
+            <a:off x="6187288" y="1691640"/>
+            <a:ext cx="5592927" cy="256032"/>
           </a:xfrm>
           <a:prstGeom prst="rect">
             <a:avLst/>
@@ -31278,8 +31406,8 @@
         </p:nvSpPr>
         <p:spPr>
           <a:xfrm>
-            <a:off x="4262019" y="1143000"/>
-            <a:ext cx="3667658" cy="868680"/>
+            <a:off x="411481" y="1143000"/>
+            <a:ext cx="5592927" cy="868680"/>
           </a:xfrm>
           <a:prstGeom prst="roundRect">
             <a:avLst>
@@ -31324,8 +31452,8 @@
         </p:nvSpPr>
         <p:spPr>
           <a:xfrm>
-            <a:off x="4262019" y="1234440"/>
-            <a:ext cx="3667658" cy="438912"/>
+            <a:off x="411481" y="1234440"/>
+            <a:ext cx="5592927" cy="438912"/>
           </a:xfrm>
           <a:prstGeom prst="rect">
             <a:avLst/>
@@ -31360,8 +31488,8 @@
         </p:nvSpPr>
         <p:spPr>
           <a:xfrm>
-            <a:off x="4262019" y="1691640"/>
-            <a:ext cx="3667658" cy="256032"/>
+            <a:off x="411481" y="1691640"/>
+            <a:ext cx="5592927" cy="256032"/>
           </a:xfrm>
           <a:prstGeom prst="rect">
             <a:avLst/>
@@ -31391,124 +31519,6 @@
       <p:sp>
         <p:nvSpPr>
           <p:cNvPr id="13" name="Rounded Rectangle 12"/>
-          <p:cNvSpPr/>
-          <p:nvPr/>
-        </p:nvSpPr>
-        <p:spPr>
-          <a:xfrm>
-            <a:off x="411481" y="1143000"/>
-            <a:ext cx="3667658" cy="868680"/>
-          </a:xfrm>
-          <a:prstGeom prst="roundRect">
-            <a:avLst>
-              <a:gd name="adj" fmla="val 14000"/>
-            </a:avLst>
-          </a:prstGeom>
-          <a:solidFill>
-            <a:srgbClr val="1C3C7A"/>
-          </a:solidFill>
-          <a:ln>
-            <a:noFill/>
-          </a:ln>
-          <a:effectLst/>
-        </p:spPr>
-        <p:style>
-          <a:lnRef idx="1">
-            <a:schemeClr val="accent1"/>
-          </a:lnRef>
-          <a:fillRef idx="3">
-            <a:schemeClr val="accent1"/>
-          </a:fillRef>
-          <a:effectRef idx="2">
-            <a:schemeClr val="accent1"/>
-          </a:effectRef>
-          <a:fontRef idx="minor">
-            <a:schemeClr val="lt1"/>
-          </a:fontRef>
-        </p:style>
-        <p:txBody>
-          <a:bodyPr rtlCol="0" anchor="ctr"/>
-          <a:lstStyle/>
-          <a:p>
-            <a:pPr algn="ctr"/>
-          </a:p>
-        </p:txBody>
-      </p:sp>
-      <p:sp>
-        <p:nvSpPr>
-          <p:cNvPr id="14" name="TextBox 13"/>
-          <p:cNvSpPr txBox="1"/>
-          <p:nvPr/>
-        </p:nvSpPr>
-        <p:spPr>
-          <a:xfrm>
-            <a:off x="411481" y="1234440"/>
-            <a:ext cx="3667658" cy="438912"/>
-          </a:xfrm>
-          <a:prstGeom prst="rect">
-            <a:avLst/>
-          </a:prstGeom>
-          <a:noFill/>
-        </p:spPr>
-        <p:txBody>
-          <a:bodyPr wrap="square" anchor="b" lIns="36576" rIns="36576" tIns="0" bIns="0">
-            <a:spAutoFit/>
-          </a:bodyPr>
-          <a:lstStyle/>
-          <a:p>
-            <a:pPr algn="ctr" rtl="1"/>
-            <a:r>
-              <a:rPr sz="2200" b="1">
-                <a:solidFill>
-                  <a:srgbClr val="FFFFFF"/>
-                </a:solidFill>
-                <a:latin typeface="Heebo"/>
-                <a:cs typeface="Heebo"/>
-              </a:rPr>
-              <a:t>בין 400 ל-600 ₪</a:t>
-            </a:r>
-          </a:p>
-        </p:txBody>
-      </p:sp>
-      <p:sp>
-        <p:nvSpPr>
-          <p:cNvPr id="15" name="TextBox 14"/>
-          <p:cNvSpPr txBox="1"/>
-          <p:nvPr/>
-        </p:nvSpPr>
-        <p:spPr>
-          <a:xfrm>
-            <a:off x="411481" y="1691640"/>
-            <a:ext cx="3667658" cy="256032"/>
-          </a:xfrm>
-          <a:prstGeom prst="rect">
-            <a:avLst/>
-          </a:prstGeom>
-          <a:noFill/>
-        </p:spPr>
-        <p:txBody>
-          <a:bodyPr wrap="square" anchor="t" lIns="36576" rIns="36576" tIns="0" bIns="0">
-            <a:spAutoFit/>
-          </a:bodyPr>
-          <a:lstStyle/>
-          <a:p>
-            <a:pPr algn="ctr" rtl="1"/>
-            <a:r>
-              <a:rPr sz="1200" b="0">
-                <a:solidFill>
-                  <a:srgbClr val="F0C000"/>
-                </a:solidFill>
-                <a:latin typeface="Heebo"/>
-                <a:cs typeface="Heebo"/>
-              </a:rPr>
-              <a:t>תגמול ליום כנסת · יום מלא או חצי יום</a:t>
-            </a:r>
-          </a:p>
-        </p:txBody>
-      </p:sp>
-      <p:sp>
-        <p:nvSpPr>
-          <p:cNvPr id="16" name="Rounded Rectangle 15"/>
           <p:cNvSpPr/>
           <p:nvPr/>
         </p:nvSpPr>
@@ -31556,7 +31566,7 @@
       </p:sp>
       <p:sp>
         <p:nvSpPr>
-          <p:cNvPr id="17" name="TextBox 16"/>
+          <p:cNvPr id="14" name="TextBox 13"/>
           <p:cNvSpPr txBox="1"/>
           <p:nvPr/>
         </p:nvSpPr>
@@ -31592,7 +31602,7 @@
       </p:sp>
       <p:sp>
         <p:nvSpPr>
-          <p:cNvPr id="18" name="TextBox 17"/>
+          <p:cNvPr id="15" name="TextBox 14"/>
           <p:cNvSpPr txBox="1"/>
           <p:nvPr/>
         </p:nvSpPr>
@@ -31628,7 +31638,7 @@
       </p:sp>
       <p:sp>
         <p:nvSpPr>
-          <p:cNvPr id="19" name="TextBox 18"/>
+          <p:cNvPr id="16" name="TextBox 15"/>
           <p:cNvSpPr txBox="1"/>
           <p:nvPr/>
         </p:nvSpPr>
@@ -31664,7 +31674,7 @@
       </p:sp>
       <p:sp>
         <p:nvSpPr>
-          <p:cNvPr id="20" name="Rounded Rectangle 19"/>
+          <p:cNvPr id="17" name="Rounded Rectangle 16"/>
           <p:cNvSpPr/>
           <p:nvPr/>
         </p:nvSpPr>
@@ -31710,7 +31720,7 @@
       </p:sp>
       <p:sp>
         <p:nvSpPr>
-          <p:cNvPr id="21" name="TextBox 20"/>
+          <p:cNvPr id="18" name="TextBox 17"/>
           <p:cNvSpPr txBox="1"/>
           <p:nvPr/>
         </p:nvSpPr>
@@ -31746,7 +31756,7 @@
       </p:sp>
       <p:sp>
         <p:nvSpPr>
-          <p:cNvPr id="22" name="TextBox 21"/>
+          <p:cNvPr id="19" name="TextBox 18"/>
           <p:cNvSpPr txBox="1"/>
           <p:nvPr/>
         </p:nvSpPr>
@@ -31782,7 +31792,7 @@
       </p:sp>
       <p:sp>
         <p:nvSpPr>
-          <p:cNvPr id="23" name="TextBox 22"/>
+          <p:cNvPr id="20" name="TextBox 19"/>
           <p:cNvSpPr txBox="1"/>
           <p:nvPr/>
         </p:nvSpPr>
@@ -31818,7 +31828,7 @@
       </p:sp>
       <p:sp>
         <p:nvSpPr>
-          <p:cNvPr id="24" name="Rounded Rectangle 23"/>
+          <p:cNvPr id="21" name="Rounded Rectangle 20"/>
           <p:cNvSpPr/>
           <p:nvPr/>
         </p:nvSpPr>
@@ -31864,7 +31874,7 @@
       </p:sp>
       <p:sp>
         <p:nvSpPr>
-          <p:cNvPr id="25" name="TextBox 24"/>
+          <p:cNvPr id="22" name="TextBox 21"/>
           <p:cNvSpPr txBox="1"/>
           <p:nvPr/>
         </p:nvSpPr>
@@ -31900,7 +31910,7 @@
       </p:sp>
       <p:sp>
         <p:nvSpPr>
-          <p:cNvPr id="26" name="TextBox 25"/>
+          <p:cNvPr id="23" name="TextBox 22"/>
           <p:cNvSpPr txBox="1"/>
           <p:nvPr/>
         </p:nvSpPr>
@@ -31936,7 +31946,7 @@
       </p:sp>
       <p:sp>
         <p:nvSpPr>
-          <p:cNvPr id="27" name="TextBox 26"/>
+          <p:cNvPr id="24" name="TextBox 23"/>
           <p:cNvSpPr txBox="1"/>
           <p:nvPr/>
         </p:nvSpPr>
@@ -31972,7 +31982,7 @@
       </p:sp>
       <p:sp>
         <p:nvSpPr>
-          <p:cNvPr id="28" name="Rounded Rectangle 27"/>
+          <p:cNvPr id="25" name="Rounded Rectangle 24"/>
           <p:cNvSpPr/>
           <p:nvPr/>
         </p:nvSpPr>
@@ -32018,7 +32028,7 @@
       </p:sp>
       <p:sp>
         <p:nvSpPr>
-          <p:cNvPr id="29" name="TextBox 28"/>
+          <p:cNvPr id="26" name="TextBox 25"/>
           <p:cNvSpPr txBox="1"/>
           <p:nvPr/>
         </p:nvSpPr>
@@ -32054,7 +32064,7 @@
       </p:sp>
       <p:sp>
         <p:nvSpPr>
-          <p:cNvPr id="30" name="TextBox 29"/>
+          <p:cNvPr id="27" name="TextBox 26"/>
           <p:cNvSpPr txBox="1"/>
           <p:nvPr/>
         </p:nvSpPr>
@@ -32090,7 +32100,7 @@
       </p:sp>
       <p:sp>
         <p:nvSpPr>
-          <p:cNvPr id="31" name="TextBox 30"/>
+          <p:cNvPr id="28" name="TextBox 27"/>
           <p:cNvSpPr txBox="1"/>
           <p:nvPr/>
         </p:nvSpPr>
@@ -32126,7 +32136,7 @@
       </p:sp>
       <p:sp>
         <p:nvSpPr>
-          <p:cNvPr id="32" name="Rounded Rectangle 31"/>
+          <p:cNvPr id="29" name="Rounded Rectangle 28"/>
           <p:cNvSpPr/>
           <p:nvPr/>
         </p:nvSpPr>
@@ -32172,7 +32182,7 @@
       </p:sp>
       <p:sp>
         <p:nvSpPr>
-          <p:cNvPr id="33" name="TextBox 32"/>
+          <p:cNvPr id="30" name="TextBox 29"/>
           <p:cNvSpPr txBox="1"/>
           <p:nvPr/>
         </p:nvSpPr>
@@ -32208,7 +32218,7 @@
       </p:sp>
       <p:sp>
         <p:nvSpPr>
-          <p:cNvPr id="34" name="TextBox 33"/>
+          <p:cNvPr id="31" name="TextBox 30"/>
           <p:cNvSpPr txBox="1"/>
           <p:nvPr/>
         </p:nvSpPr>
@@ -32244,7 +32254,7 @@
       </p:sp>
       <p:sp>
         <p:nvSpPr>
-          <p:cNvPr id="35" name="TextBox 34"/>
+          <p:cNvPr id="32" name="TextBox 31"/>
           <p:cNvSpPr txBox="1"/>
           <p:nvPr/>
         </p:nvSpPr>
@@ -32280,7 +32290,7 @@
       </p:sp>
       <p:sp>
         <p:nvSpPr>
-          <p:cNvPr id="36" name="Rounded Rectangle 35"/>
+          <p:cNvPr id="33" name="Rounded Rectangle 32"/>
           <p:cNvSpPr/>
           <p:nvPr/>
         </p:nvSpPr>
@@ -32326,7 +32336,7 @@
       </p:sp>
       <p:sp>
         <p:nvSpPr>
-          <p:cNvPr id="37" name="TextBox 36"/>
+          <p:cNvPr id="34" name="TextBox 33"/>
           <p:cNvSpPr txBox="1"/>
           <p:nvPr/>
         </p:nvSpPr>
@@ -32362,7 +32372,7 @@
       </p:sp>
       <p:sp>
         <p:nvSpPr>
-          <p:cNvPr id="38" name="TextBox 37"/>
+          <p:cNvPr id="35" name="TextBox 34"/>
           <p:cNvSpPr txBox="1"/>
           <p:nvPr/>
         </p:nvSpPr>
@@ -32398,7 +32408,7 @@
       </p:sp>
       <p:sp>
         <p:nvSpPr>
-          <p:cNvPr id="39" name="Rounded Rectangle 38"/>
+          <p:cNvPr id="36" name="Rounded Rectangle 35"/>
           <p:cNvSpPr/>
           <p:nvPr/>
         </p:nvSpPr>
@@ -32446,7 +32456,7 @@
       </p:sp>
       <p:sp>
         <p:nvSpPr>
-          <p:cNvPr id="40" name="TextBox 39"/>
+          <p:cNvPr id="37" name="TextBox 36"/>
           <p:cNvSpPr txBox="1"/>
           <p:nvPr/>
         </p:nvSpPr>
@@ -32482,7 +32492,7 @@
       </p:sp>
       <p:sp>
         <p:nvSpPr>
-          <p:cNvPr id="41" name="Rounded Rectangle 40"/>
+          <p:cNvPr id="38" name="Rounded Rectangle 37"/>
           <p:cNvSpPr/>
           <p:nvPr/>
         </p:nvSpPr>
@@ -32530,7 +32540,7 @@
       </p:sp>
       <p:sp>
         <p:nvSpPr>
-          <p:cNvPr id="42" name="Rectangle 41"/>
+          <p:cNvPr id="39" name="Rectangle 38"/>
           <p:cNvSpPr/>
           <p:nvPr/>
         </p:nvSpPr>
@@ -32574,7 +32584,7 @@
       </p:sp>
       <p:sp>
         <p:nvSpPr>
-          <p:cNvPr id="43" name="TextBox 42"/>
+          <p:cNvPr id="40" name="TextBox 39"/>
           <p:cNvSpPr txBox="1"/>
           <p:nvPr/>
         </p:nvSpPr>
@@ -32610,7 +32620,7 @@
       </p:sp>
       <p:sp>
         <p:nvSpPr>
-          <p:cNvPr id="44" name="Rounded Rectangle 43"/>
+          <p:cNvPr id="41" name="Rounded Rectangle 40"/>
           <p:cNvSpPr/>
           <p:nvPr/>
         </p:nvSpPr>
@@ -32658,7 +32668,7 @@
       </p:sp>
       <p:sp>
         <p:nvSpPr>
-          <p:cNvPr id="45" name="Rectangle 44"/>
+          <p:cNvPr id="42" name="Rectangle 41"/>
           <p:cNvSpPr/>
           <p:nvPr/>
         </p:nvSpPr>
@@ -32702,7 +32712,7 @@
       </p:sp>
       <p:sp>
         <p:nvSpPr>
-          <p:cNvPr id="46" name="TextBox 45"/>
+          <p:cNvPr id="43" name="TextBox 42"/>
           <p:cNvSpPr txBox="1"/>
           <p:nvPr/>
         </p:nvSpPr>
@@ -32738,7 +32748,7 @@
       </p:sp>
       <p:sp>
         <p:nvSpPr>
-          <p:cNvPr id="47" name="Rounded Rectangle 46"/>
+          <p:cNvPr id="44" name="Rounded Rectangle 43"/>
           <p:cNvSpPr/>
           <p:nvPr/>
         </p:nvSpPr>
@@ -32786,7 +32796,7 @@
       </p:sp>
       <p:sp>
         <p:nvSpPr>
-          <p:cNvPr id="48" name="Rectangle 47"/>
+          <p:cNvPr id="45" name="Rectangle 44"/>
           <p:cNvSpPr/>
           <p:nvPr/>
         </p:nvSpPr>
@@ -32830,7 +32840,7 @@
       </p:sp>
       <p:sp>
         <p:nvSpPr>
-          <p:cNvPr id="49" name="TextBox 48"/>
+          <p:cNvPr id="46" name="TextBox 45"/>
           <p:cNvSpPr txBox="1"/>
           <p:nvPr/>
         </p:nvSpPr>
@@ -32866,7 +32876,7 @@
       </p:sp>
       <p:sp>
         <p:nvSpPr>
-          <p:cNvPr id="50" name="Rounded Rectangle 49"/>
+          <p:cNvPr id="47" name="Rounded Rectangle 46"/>
           <p:cNvSpPr/>
           <p:nvPr/>
         </p:nvSpPr>
@@ -32913,7 +32923,7 @@
       </p:sp>
       <p:sp>
         <p:nvSpPr>
-          <p:cNvPr id="51" name="TextBox 50"/>
+          <p:cNvPr id="48" name="TextBox 47"/>
           <p:cNvSpPr txBox="1"/>
           <p:nvPr/>
         </p:nvSpPr>
@@ -32949,7 +32959,7 @@
       </p:sp>
       <p:sp>
         <p:nvSpPr>
-          <p:cNvPr id="52" name="TextBox 51"/>
+          <p:cNvPr id="49" name="TextBox 48"/>
           <p:cNvSpPr txBox="1"/>
           <p:nvPr/>
         </p:nvSpPr>
@@ -32985,7 +32995,7 @@
       </p:sp>
       <p:sp>
         <p:nvSpPr>
-          <p:cNvPr id="53" name="Rounded Rectangle 52"/>
+          <p:cNvPr id="50" name="Rounded Rectangle 49"/>
           <p:cNvSpPr/>
           <p:nvPr/>
         </p:nvSpPr>
@@ -33031,7 +33041,7 @@
       </p:sp>
       <p:sp>
         <p:nvSpPr>
-          <p:cNvPr id="54" name="TextBox 53"/>
+          <p:cNvPr id="51" name="TextBox 50"/>
           <p:cNvSpPr txBox="1"/>
           <p:nvPr/>
         </p:nvSpPr>
@@ -33067,7 +33077,7 @@
       </p:sp>
       <p:sp>
         <p:nvSpPr>
-          <p:cNvPr id="55" name="Rounded Rectangle 54"/>
+          <p:cNvPr id="52" name="Rounded Rectangle 51"/>
           <p:cNvSpPr/>
           <p:nvPr/>
         </p:nvSpPr>
@@ -33115,7 +33125,7 @@
       </p:sp>
       <p:sp>
         <p:nvSpPr>
-          <p:cNvPr id="56" name="TextBox 55"/>
+          <p:cNvPr id="53" name="TextBox 52"/>
           <p:cNvSpPr txBox="1"/>
           <p:nvPr/>
         </p:nvSpPr>
@@ -33151,7 +33161,7 @@
       </p:sp>
       <p:sp>
         <p:nvSpPr>
-          <p:cNvPr id="57" name="TextBox 56"/>
+          <p:cNvPr id="54" name="TextBox 53"/>
           <p:cNvSpPr txBox="1"/>
           <p:nvPr/>
         </p:nvSpPr>
@@ -33187,7 +33197,7 @@
       </p:sp>
       <p:sp>
         <p:nvSpPr>
-          <p:cNvPr id="58" name="TextBox 57"/>
+          <p:cNvPr id="55" name="TextBox 54"/>
           <p:cNvSpPr txBox="1"/>
           <p:nvPr/>
         </p:nvSpPr>
@@ -33223,7 +33233,7 @@
       </p:sp>
       <p:sp>
         <p:nvSpPr>
-          <p:cNvPr id="59" name="TextBox 58"/>
+          <p:cNvPr id="56" name="TextBox 55"/>
           <p:cNvSpPr txBox="1"/>
           <p:nvPr/>
         </p:nvSpPr>

</xml_diff>

<commit_message>
Rename CEO and assistant roles to manager
Co-Authored-By: Claude Opus 5.5 <noreply@anthropic.com>
Claude-Session: https://claude.ai/code/session_01W7Er83FuNT4pLFShWidYHn
</commit_message>
<xml_diff>
--- a/presentation/out/koach-hitarvut.pptx
+++ b/presentation/out/koach-hitarvut.pptx
@@ -4401,7 +4401,7 @@
                 <a:latin typeface="Heebo"/>
                 <a:cs typeface="Heebo"/>
               </a:rPr>
-              <a:t>מנכ״ל</a:t>
+              <a:t>מנהל</a:t>
             </a:r>
           </a:p>
         </p:txBody>
@@ -9313,7 +9313,7 @@
                 <a:latin typeface="Heebo"/>
                 <a:cs typeface="Heebo"/>
               </a:rPr>
-              <a:t>מנכ״ל · אדם קורגן</a:t>
+              <a:t>מנהל · אדם קורגן</a:t>
             </a:r>
           </a:p>
         </p:txBody>
@@ -9515,7 +9515,7 @@
                 <a:latin typeface="Heebo"/>
                 <a:cs typeface="Heebo"/>
               </a:rPr>
-              <a:t>עוזר מנכ״ל · חצי משרה</a:t>
+              <a:t>מנהל · חצי משרה</a:t>
             </a:r>
           </a:p>
         </p:txBody>
@@ -11409,7 +11409,7 @@
                 <a:latin typeface="Heebo"/>
                 <a:cs typeface="Heebo"/>
               </a:rPr>
-              <a:t>מנכ״ל · אדם קורגן</a:t>
+              <a:t>מנהל · אדם קורגן</a:t>
             </a:r>
           </a:p>
         </p:txBody>
@@ -11611,7 +11611,7 @@
                 <a:latin typeface="Heebo"/>
                 <a:cs typeface="Heebo"/>
               </a:rPr>
-              <a:t>עוזר מנכ״ל · חצי משרה</a:t>
+              <a:t>מנהל · חצי משרה</a:t>
             </a:r>
           </a:p>
         </p:txBody>
@@ -13695,7 +13695,7 @@
                 <a:latin typeface="Heebo"/>
                 <a:cs typeface="Heebo"/>
               </a:rPr>
-              <a:t>מנכ״ל</a:t>
+              <a:t>מנהל · אדם קורגן</a:t>
             </a:r>
           </a:p>
         </p:txBody>
@@ -13802,7 +13802,7 @@
                 <a:latin typeface="Heebo"/>
                 <a:cs typeface="Heebo"/>
               </a:rPr>
-              <a:t>עוזר מנכ״ל · חצי משרה</a:t>
+              <a:t>מנהל · חצי משרה</a:t>
             </a:r>
           </a:p>
         </p:txBody>
@@ -14622,7 +14622,7 @@
                 <a:latin typeface="Heebo"/>
                 <a:cs typeface="Heebo"/>
               </a:rPr>
-              <a:t>מנכ״ל</a:t>
+              <a:t>מנהל · אדם קורגן</a:t>
             </a:r>
           </a:p>
         </p:txBody>
@@ -14729,7 +14729,7 @@
                 <a:latin typeface="Heebo"/>
                 <a:cs typeface="Heebo"/>
               </a:rPr>
-              <a:t>עוזר מנכ״ל · חצי משרה</a:t>
+              <a:t>מנהל · חצי משרה</a:t>
             </a:r>
           </a:p>
         </p:txBody>
@@ -15549,7 +15549,7 @@
                 <a:latin typeface="Heebo"/>
                 <a:cs typeface="Heebo"/>
               </a:rPr>
-              <a:t>מנכ״ל</a:t>
+              <a:t>מנהל · אדם קורגן</a:t>
             </a:r>
           </a:p>
         </p:txBody>
@@ -15656,7 +15656,7 @@
                 <a:latin typeface="Heebo"/>
                 <a:cs typeface="Heebo"/>
               </a:rPr>
-              <a:t>עוזר מנכ״ל · חצי משרה</a:t>
+              <a:t>מנהל · חצי משרה</a:t>
             </a:r>
           </a:p>
         </p:txBody>
@@ -17391,7 +17391,7 @@
                 <a:latin typeface="Heebo"/>
                 <a:cs typeface="Heebo"/>
               </a:rPr>
-              <a:t>מנכ״ל</a:t>
+              <a:t>מנהל</a:t>
             </a:r>
           </a:p>
         </p:txBody>
@@ -23131,7 +23131,7 @@
                 <a:latin typeface="Heebo"/>
                 <a:cs typeface="Heebo"/>
               </a:rPr>
-              <a:t>מנכ״ל אדם קורגן + עוזר מנכ״ל (לאיוש)</a:t>
+              <a:t>מנהל אדם קורגן + מנהל נוסף (לאיוש)</a:t>
             </a:r>
           </a:p>
         </p:txBody>
@@ -32988,7 +32988,7 @@
                 <a:latin typeface="Heebo"/>
                 <a:cs typeface="Heebo"/>
               </a:rPr>
-              <a:t>נציג רביעי: איש קבוע. תפקיד חדש, או בשילוב עם איש התוכן או עוזר המנכ״ל</a:t>
+              <a:t>נציג רביעי: איש קבוע. תפקיד חדש, או בשילוב עם איש התוכן או המנהל הנוסף</a:t>
             </a:r>
           </a:p>
         </p:txBody>

</xml_diff>